<commit_message>
docs(tfm): slide del problema y sangrado de la portada
</commit_message>
<xml_diff>
--- a/docs/presentacion/tfm-intelligent-automotive-diagnostics.pptx
+++ b/docs/presentacion/tfm-intelligent-automotive-diagnostics.pptx
@@ -6,9 +6,10 @@
   </p:sldMasterIdLst>
   <p:sldIdLst>
     <p:sldId id="256" r:id="rId2"/>
+    <p:sldId id="257" r:id="rId3"/>
   </p:sldIdLst>
   <p:notesMasterIdLst>
-    <p:notesMasterId r:id="rId3"/>
+    <p:notesMasterId r:id="rId4"/>
   </p:notesMasterIdLst>
   <p:sldSz cx="12192000" cy="6858000"/>
   <p:notesSz cx="6858000" cy="12192000"/>
@@ -503,9 +504,9 @@
             <a:r>
               <a:rPr lang="en-US" dirty="0"/>
               <a:t>Buenos días. Soy Jesús Ángel Novillo y presento mi Trabajo Fin de Máster del Máster en Desarrollo con IA de BIG school.
-El proyecto se llama Intelligent Automotive Diagnostics. Es una herramienta de diagnóstico de averías de automóvil que se conecta al coche por el puerto OBD-II, lee sus datos reales, y razona sobre ellos con un modelo de lenguaje.
-Lo que ven a la derecha no es una maqueta: es la aplicación funcionando contra un vehículo, mostrando tres averías que acaba de leer de la centralita.
-[~15 segundos. No entretenerse: la portada solo abre.]</a:t>
+El proyecto se llama Intelligent Automotive Diagnostics: una herramienta que se conecta al coche por el puerto OBD-II, lee sus datos reales y razona sobre ellos con un modelo de lenguaje.
+Lo de la derecha no es una maqueta: es la aplicación funcionando, mostrando tres averías que acaba de leer de la centralita.
+[~15 s. La portada solo abre: no entretenerse.]</a:t>
             </a:r>
             <a:endParaRPr lang="en-US" dirty="0"/>
           </a:p>
@@ -529,6 +530,98 @@
             <a:fld id="{F7021451-1387-4CA6-816F-3879F97B5CBC}" type="slidenum">
               <a:rPr lang="en-US"/>
               <a:t>1</a:t>
+            </a:fld>
+            <a:endParaRPr lang="en-US"/>
+          </a:p>
+        </p:txBody>
+      </p:sp>
+    </p:spTree>
+    <p:extLst>
+      <p:ext uri="{BB962C8B-B14F-4D97-AF65-F5344CB8AC3E}">
+        <p14:creationId xmlns:p14="http://schemas.microsoft.com/office/powerpoint/2010/main" val="1024086991"/>
+      </p:ext>
+    </p:extLst>
+  </p:cSld>
+  <p:clrMapOvr>
+    <a:masterClrMapping/>
+  </p:clrMapOvr>
+</p:notes>
+</file>
+
+<file path=ppt/notesSlides/notesSlide2.xml><?xml version="1.0" encoding="utf-8"?>
+<p:notes xmlns:a="http://schemas.openxmlformats.org/drawingml/2006/main" xmlns:r="http://schemas.openxmlformats.org/officeDocument/2006/relationships" xmlns:p="http://schemas.openxmlformats.org/presentationml/2006/main">
+  <p:cSld>
+    <p:spTree>
+      <p:nvGrpSpPr>
+        <p:cNvPr id="1" name=""/>
+        <p:cNvGrpSpPr/>
+        <p:nvPr/>
+      </p:nvGrpSpPr>
+      <p:grpSpPr>
+        <a:xfrm>
+          <a:off x="0" y="0"/>
+          <a:ext cx="0" cy="0"/>
+          <a:chOff x="0" y="0"/>
+          <a:chExt cx="0" cy="0"/>
+        </a:xfrm>
+      </p:grpSpPr>
+      <p:sp>
+        <p:nvSpPr>
+          <p:cNvPr id="2" name="Slide Image Placeholder 1"/>
+          <p:cNvSpPr>
+            <a:spLocks noGrp="1" noRot="1" noChangeAspect="1"/>
+          </p:cNvSpPr>
+          <p:nvPr>
+            <p:ph type="sldImg"/>
+          </p:nvPr>
+        </p:nvSpPr>
+        <p:spPr/>
+      </p:sp>
+      <p:sp>
+        <p:nvSpPr>
+          <p:cNvPr id="3" name="Notes Placeholder 2"/>
+          <p:cNvSpPr>
+            <a:spLocks noGrp="1"/>
+          </p:cNvSpPr>
+          <p:nvPr>
+            <p:ph type="body" idx="1"/>
+          </p:nvPr>
+        </p:nvSpPr>
+        <p:spPr/>
+        <p:txBody>
+          <a:bodyPr/>
+          <a:lstStyle/>
+          <a:p>
+            <a:r>
+              <a:rPr lang="en-US" dirty="0"/>
+              <a:t>Un mecánico conecta el escáner y obtiene un código: P0401, P2002. Eso es el síntoma que la centralita ha registrado. No es la avería.
+Del código a la causa hay un salto, y ese salto lo da la experiencia. Los mismos dos códigos pueden ser una EGR sucia, o pueden ser un motor que consume aceite y ha ido saturando el filtro de partículas. Son reparaciones distintas y facturas muy distintas.
+Y aquí está lo que a mí me parece el problema de verdad: cuando el mecánico acierta, ese conocimiento no queda en ningún sitio. Se queda en su cabeza. Seis meses después entra otro coche con los mismos códigos y se vuelve a empezar de cero.
+El diagnóstico no es un problema de lectura de datos. Es un problema de interpretación, y de memoria.
+[~45 s. Apoyarse en el tercer bloque: es el que abre la slide siguiente.]</a:t>
+            </a:r>
+            <a:endParaRPr lang="en-US" dirty="0"/>
+          </a:p>
+        </p:txBody>
+      </p:sp>
+      <p:sp>
+        <p:nvSpPr>
+          <p:cNvPr id="4" name="Slide Number Placeholder 3"/>
+          <p:cNvSpPr>
+            <a:spLocks noGrp="1"/>
+          </p:cNvSpPr>
+          <p:nvPr>
+            <p:ph type="sldNum" sz="quarter" idx="10"/>
+          </p:nvPr>
+        </p:nvSpPr>
+        <p:spPr/>
+        <p:txBody>
+          <a:bodyPr/>
+          <a:lstStyle/>
+          <a:p>
+            <a:fld id="{F7021451-1387-4CA6-816F-3879F97B5CBC}" type="slidenum">
+              <a:rPr lang="en-US"/>
+              <a:t>2</a:t>
             </a:fld>
             <a:endParaRPr lang="en-US"/>
           </a:p>
@@ -886,8 +979,8 @@
         </p:nvSpPr>
         <p:spPr>
           <a:xfrm>
-            <a:off x="6720840" y="0"/>
-            <a:ext cx="5440680" cy="6858000"/>
+            <a:off x="6720840" y="-91440"/>
+            <a:ext cx="5760720" cy="7040880"/>
           </a:xfrm>
           <a:prstGeom prst="rect">
             <a:avLst/>
@@ -1017,7 +1110,7 @@
           <a:bodyPr wrap="square" lIns="0" tIns="0" rIns="0" bIns="0" rtlCol="0" anchor="ctr"/>
           <a:lstStyle/>
           <a:p>
-            <a:pPr algn="l" indent="0" marL="0">
+            <a:pPr indent="0" marL="0">
               <a:lnSpc>
                 <a:spcPts val="4600"/>
               </a:lnSpc>
@@ -1035,7 +1128,7 @@
               <a:t>Intelligent Automotive
 </a:t>
             </a:r>
-            <a:pPr algn="l" indent="0" marL="0">
+            <a:pPr indent="0" marL="0">
               <a:lnSpc>
                 <a:spcPts val="4600"/>
               </a:lnSpc>
@@ -1176,47 +1269,16 @@
           </a:p>
         </p:txBody>
       </p:sp>
-      <p:pic>
-        <p:nvPicPr>
-          <p:cNvPr id="10" name="Image 0" descr="/home/user/intelligent-automotive-diagnostics/docs/presentacion/capturas/recortes/03-codigos-dtc.png">    </p:cNvPr>
-          <p:cNvPicPr>
-            <a:picLocks noChangeAspect="1"/>
-          </p:cNvPicPr>
-          <p:nvPr/>
-        </p:nvPicPr>
-        <p:blipFill>
-          <a:blip r:embed="rId1"/>
-          <a:stretch>
-            <a:fillRect/>
-          </a:stretch>
-        </p:blipFill>
-        <p:spPr>
-          <a:xfrm>
-            <a:off x="7269480" y="2606040"/>
-            <a:ext cx="5852160" cy="1828800"/>
-          </a:xfrm>
-          <a:prstGeom prst="rect">
-            <a:avLst/>
-          </a:prstGeom>
-          <a:effectLst>
-            <a:outerShdw sx="100000" sy="100000" kx="0" ky="0" algn="bl" rotWithShape="0" blurRad="279400" dist="76200" dir="8100000">
-              <a:srgbClr val="000000">
-                <a:alpha val="45000"/>
-              </a:srgbClr>
-            </a:outerShdw>
-          </a:effectLst>
-        </p:spPr>
-      </p:pic>
-      <p:sp>
-        <p:nvSpPr>
-          <p:cNvPr id="11" name="Text 8"/>
-          <p:cNvSpPr/>
-          <p:nvPr/>
-        </p:nvSpPr>
-        <p:spPr>
-          <a:xfrm>
-            <a:off x="7269480" y="2057400"/>
-            <a:ext cx="4572000" cy="274320"/>
+      <p:sp>
+        <p:nvSpPr>
+          <p:cNvPr id="10" name="Text 8"/>
+          <p:cNvSpPr/>
+          <p:nvPr/>
+        </p:nvSpPr>
+        <p:spPr>
+          <a:xfrm>
+            <a:off x="7114032" y="2148840"/>
+            <a:ext cx="4663440" cy="274320"/>
           </a:xfrm>
           <a:prstGeom prst="rect">
             <a:avLst/>
@@ -1241,6 +1303,823 @@
                 <a:cs typeface="Calibri" pitchFamily="34" charset="-120"/>
               </a:rPr>
               <a:t>LA HERRAMIENTA, EN FUNCIONAMIENTO</a:t>
+            </a:r>
+            <a:endParaRPr lang="en-US" sz="1000" dirty="0"/>
+          </a:p>
+        </p:txBody>
+      </p:sp>
+      <p:pic>
+        <p:nvPicPr>
+          <p:cNvPr id="11" name="Image 0" descr="/home/user/intelligent-automotive-diagnostics/docs/presentacion/capturas/recortes/03-codigos-dtc.png">    </p:cNvPr>
+          <p:cNvPicPr>
+            <a:picLocks noChangeAspect="1"/>
+          </p:cNvPicPr>
+          <p:nvPr/>
+        </p:nvPicPr>
+        <p:blipFill>
+          <a:blip r:embed="rId1"/>
+          <a:stretch>
+            <a:fillRect/>
+          </a:stretch>
+        </p:blipFill>
+        <p:spPr>
+          <a:xfrm>
+            <a:off x="7114032" y="2697480"/>
+            <a:ext cx="4654296" cy="1453896"/>
+          </a:xfrm>
+          <a:prstGeom prst="rect">
+            <a:avLst/>
+          </a:prstGeom>
+          <a:effectLst>
+            <a:outerShdw sx="100000" sy="100000" kx="0" ky="0" algn="bl" rotWithShape="0" blurRad="254000" dist="63500" dir="8100000">
+              <a:srgbClr val="000000">
+                <a:alpha val="50000"/>
+              </a:srgbClr>
+            </a:outerShdw>
+          </a:effectLst>
+        </p:spPr>
+      </p:pic>
+    </p:spTree>
+  </p:cSld>
+  <p:clrMapOvr>
+    <a:masterClrMapping/>
+  </p:clrMapOvr>
+</p:sld>
+</file>
+
+<file path=ppt/slides/slide2.xml><?xml version="1.0" encoding="utf-8"?>
+<p:sld xmlns:a="http://schemas.openxmlformats.org/drawingml/2006/main" xmlns:r="http://schemas.openxmlformats.org/officeDocument/2006/relationships" xmlns:p="http://schemas.openxmlformats.org/presentationml/2006/main">
+  <p:cSld name="Slide 2">
+    <p:bg>
+      <p:bgPr>
+        <a:solidFill>
+          <a:srgbClr val="FFFFFF"/>
+        </a:solidFill>
+      </p:bgPr>
+    </p:bg>
+    <p:spTree>
+      <p:nvGrpSpPr>
+        <p:cNvPr id="1" name=""/>
+        <p:cNvGrpSpPr/>
+        <p:nvPr/>
+      </p:nvGrpSpPr>
+      <p:grpSpPr>
+        <a:xfrm>
+          <a:off x="0" y="0"/>
+          <a:ext cx="0" cy="0"/>
+          <a:chOff x="0" y="0"/>
+          <a:chExt cx="0" cy="0"/>
+        </a:xfrm>
+      </p:grpSpPr>
+      <p:sp>
+        <p:nvSpPr>
+          <p:cNvPr id="2" name="Text 0"/>
+          <p:cNvSpPr/>
+          <p:nvPr/>
+        </p:nvSpPr>
+        <p:spPr>
+          <a:xfrm>
+            <a:off x="777240" y="566928"/>
+            <a:ext cx="7315200" cy="256032"/>
+          </a:xfrm>
+          <a:prstGeom prst="rect">
+            <a:avLst/>
+          </a:prstGeom>
+          <a:noFill/>
+          <a:ln/>
+        </p:spPr>
+        <p:txBody>
+          <a:bodyPr wrap="square" lIns="0" tIns="0" rIns="0" bIns="0" rtlCol="0" anchor="ctr"/>
+          <a:lstStyle/>
+          <a:p>
+            <a:pPr indent="0" marL="0">
+              <a:buNone/>
+            </a:pPr>
+            <a:r>
+              <a:rPr lang="en-US" sz="1100" b="1" spc="250" kern="0" dirty="0">
+                <a:solidFill>
+                  <a:srgbClr val="202CFC"/>
+                </a:solidFill>
+                <a:latin typeface="Calibri" pitchFamily="34" charset="0"/>
+                <a:ea typeface="Calibri" pitchFamily="34" charset="-122"/>
+                <a:cs typeface="Calibri" pitchFamily="34" charset="-120"/>
+              </a:rPr>
+              <a:t>EL PROBLEMA</a:t>
+            </a:r>
+            <a:endParaRPr lang="en-US" sz="1100" dirty="0"/>
+          </a:p>
+        </p:txBody>
+      </p:sp>
+      <p:sp>
+        <p:nvSpPr>
+          <p:cNvPr id="3" name="Text 1"/>
+          <p:cNvSpPr/>
+          <p:nvPr/>
+        </p:nvSpPr>
+        <p:spPr>
+          <a:xfrm>
+            <a:off x="777240" y="896112"/>
+            <a:ext cx="10607040" cy="658368"/>
+          </a:xfrm>
+          <a:prstGeom prst="rect">
+            <a:avLst/>
+          </a:prstGeom>
+          <a:noFill/>
+          <a:ln/>
+        </p:spPr>
+        <p:txBody>
+          <a:bodyPr wrap="square" lIns="0" tIns="0" rIns="0" bIns="0" rtlCol="0" anchor="ctr"/>
+          <a:lstStyle/>
+          <a:p>
+            <a:pPr indent="0" marL="0">
+              <a:buNone/>
+            </a:pPr>
+            <a:r>
+              <a:rPr lang="en-US" sz="3600" b="1" dirty="0">
+                <a:solidFill>
+                  <a:srgbClr val="1A1C2E"/>
+                </a:solidFill>
+                <a:latin typeface="Arial" pitchFamily="34" charset="0"/>
+                <a:ea typeface="Arial" pitchFamily="34" charset="-122"/>
+                <a:cs typeface="Arial" pitchFamily="34" charset="-120"/>
+              </a:rPr>
+              <a:t>El código no es el diagnóstico</a:t>
+            </a:r>
+            <a:endParaRPr lang="en-US" sz="3600" dirty="0"/>
+          </a:p>
+        </p:txBody>
+      </p:sp>
+      <p:sp>
+        <p:nvSpPr>
+          <p:cNvPr id="4" name="Shape 2"/>
+          <p:cNvSpPr/>
+          <p:nvPr/>
+        </p:nvSpPr>
+        <p:spPr>
+          <a:xfrm>
+            <a:off x="685800" y="2057400"/>
+            <a:ext cx="3383280" cy="2880360"/>
+          </a:xfrm>
+          <a:prstGeom prst="roundRect">
+            <a:avLst>
+              <a:gd name="adj" fmla="val 3175"/>
+            </a:avLst>
+          </a:prstGeom>
+          <a:solidFill>
+            <a:srgbClr val="F3F4F9"/>
+          </a:solidFill>
+          <a:ln/>
+        </p:spPr>
+      </p:sp>
+      <p:sp>
+        <p:nvSpPr>
+          <p:cNvPr id="5" name="Shape 3"/>
+          <p:cNvSpPr/>
+          <p:nvPr/>
+        </p:nvSpPr>
+        <p:spPr>
+          <a:xfrm>
+            <a:off x="978408" y="2350008"/>
+            <a:ext cx="384048" cy="384048"/>
+          </a:xfrm>
+          <a:prstGeom prst="ellipse">
+            <a:avLst/>
+          </a:prstGeom>
+          <a:solidFill>
+            <a:srgbClr val="202CFC"/>
+          </a:solidFill>
+          <a:ln/>
+        </p:spPr>
+      </p:sp>
+      <p:sp>
+        <p:nvSpPr>
+          <p:cNvPr id="6" name="Text 4"/>
+          <p:cNvSpPr/>
+          <p:nvPr/>
+        </p:nvSpPr>
+        <p:spPr>
+          <a:xfrm>
+            <a:off x="978408" y="2350008"/>
+            <a:ext cx="384048" cy="384048"/>
+          </a:xfrm>
+          <a:prstGeom prst="rect">
+            <a:avLst/>
+          </a:prstGeom>
+          <a:noFill/>
+          <a:ln/>
+        </p:spPr>
+        <p:txBody>
+          <a:bodyPr wrap="square" lIns="0" tIns="0" rIns="0" bIns="0" rtlCol="0" anchor="ctr"/>
+          <a:lstStyle/>
+          <a:p>
+            <a:pPr algn="ctr" indent="0" marL="0">
+              <a:buNone/>
+            </a:pPr>
+            <a:r>
+              <a:rPr lang="en-US" sz="1400" b="1" dirty="0">
+                <a:solidFill>
+                  <a:srgbClr val="FFFFFF"/>
+                </a:solidFill>
+                <a:latin typeface="Arial" pitchFamily="34" charset="0"/>
+                <a:ea typeface="Arial" pitchFamily="34" charset="-122"/>
+                <a:cs typeface="Arial" pitchFamily="34" charset="-120"/>
+              </a:rPr>
+              <a:t>1</a:t>
+            </a:r>
+            <a:endParaRPr lang="en-US" sz="1400" dirty="0"/>
+          </a:p>
+        </p:txBody>
+      </p:sp>
+      <p:sp>
+        <p:nvSpPr>
+          <p:cNvPr id="7" name="Text 5"/>
+          <p:cNvSpPr/>
+          <p:nvPr/>
+        </p:nvSpPr>
+        <p:spPr>
+          <a:xfrm>
+            <a:off x="978408" y="2926080"/>
+            <a:ext cx="2798064" cy="566928"/>
+          </a:xfrm>
+          <a:prstGeom prst="rect">
+            <a:avLst/>
+          </a:prstGeom>
+          <a:noFill/>
+          <a:ln/>
+        </p:spPr>
+        <p:txBody>
+          <a:bodyPr wrap="square" lIns="0" tIns="0" rIns="0" bIns="0" rtlCol="0" anchor="t"/>
+          <a:lstStyle/>
+          <a:p>
+            <a:pPr indent="0" marL="0">
+              <a:buNone/>
+            </a:pPr>
+            <a:r>
+              <a:rPr lang="en-US" sz="1200" b="1" spc="50" kern="0" dirty="0">
+                <a:solidFill>
+                  <a:srgbClr val="1A1C2E"/>
+                </a:solidFill>
+                <a:latin typeface="Arial" pitchFamily="34" charset="0"/>
+                <a:ea typeface="Arial" pitchFamily="34" charset="-122"/>
+                <a:cs typeface="Arial" pitchFamily="34" charset="-120"/>
+              </a:rPr>
+              <a:t>EL ESCÁNER DEVUELVE UN CÓDIGO</a:t>
+            </a:r>
+            <a:endParaRPr lang="en-US" sz="1200" dirty="0"/>
+          </a:p>
+        </p:txBody>
+      </p:sp>
+      <p:sp>
+        <p:nvSpPr>
+          <p:cNvPr id="8" name="Text 6"/>
+          <p:cNvSpPr/>
+          <p:nvPr/>
+        </p:nvSpPr>
+        <p:spPr>
+          <a:xfrm>
+            <a:off x="978408" y="3538728"/>
+            <a:ext cx="2798064" cy="1234440"/>
+          </a:xfrm>
+          <a:prstGeom prst="rect">
+            <a:avLst/>
+          </a:prstGeom>
+          <a:noFill/>
+          <a:ln/>
+        </p:spPr>
+        <p:txBody>
+          <a:bodyPr wrap="square" lIns="0" tIns="0" rIns="0" bIns="0" rtlCol="0" anchor="t"/>
+          <a:lstStyle/>
+          <a:p>
+            <a:pPr indent="0" marL="0">
+              <a:lnSpc>
+                <a:spcPts val="1700"/>
+              </a:lnSpc>
+              <a:buNone/>
+            </a:pPr>
+            <a:r>
+              <a:rPr lang="en-US" sz="1200" dirty="0">
+                <a:solidFill>
+                  <a:srgbClr val="5A5F73"/>
+                </a:solidFill>
+                <a:latin typeface="Calibri" pitchFamily="34" charset="0"/>
+                <a:ea typeface="Calibri" pitchFamily="34" charset="-122"/>
+                <a:cs typeface="Calibri" pitchFamily="34" charset="-120"/>
+              </a:rPr>
+              <a:t>P0401, P2002. Eso es lo que la centralita ha registrado: el síntoma. No es la avería que hay que reparar.</a:t>
+            </a:r>
+            <a:endParaRPr lang="en-US" sz="1200" dirty="0"/>
+          </a:p>
+        </p:txBody>
+      </p:sp>
+      <p:sp>
+        <p:nvSpPr>
+          <p:cNvPr id="9" name="Shape 7"/>
+          <p:cNvSpPr/>
+          <p:nvPr/>
+        </p:nvSpPr>
+        <p:spPr>
+          <a:xfrm>
+            <a:off x="4389120" y="2057400"/>
+            <a:ext cx="3383280" cy="2880360"/>
+          </a:xfrm>
+          <a:prstGeom prst="roundRect">
+            <a:avLst>
+              <a:gd name="adj" fmla="val 3175"/>
+            </a:avLst>
+          </a:prstGeom>
+          <a:solidFill>
+            <a:srgbClr val="F3F4F9"/>
+          </a:solidFill>
+          <a:ln/>
+        </p:spPr>
+      </p:sp>
+      <p:sp>
+        <p:nvSpPr>
+          <p:cNvPr id="10" name="Shape 8"/>
+          <p:cNvSpPr/>
+          <p:nvPr/>
+        </p:nvSpPr>
+        <p:spPr>
+          <a:xfrm>
+            <a:off x="4681728" y="2350008"/>
+            <a:ext cx="384048" cy="384048"/>
+          </a:xfrm>
+          <a:prstGeom prst="ellipse">
+            <a:avLst/>
+          </a:prstGeom>
+          <a:solidFill>
+            <a:srgbClr val="202CFC"/>
+          </a:solidFill>
+          <a:ln/>
+        </p:spPr>
+      </p:sp>
+      <p:sp>
+        <p:nvSpPr>
+          <p:cNvPr id="11" name="Text 9"/>
+          <p:cNvSpPr/>
+          <p:nvPr/>
+        </p:nvSpPr>
+        <p:spPr>
+          <a:xfrm>
+            <a:off x="4681728" y="2350008"/>
+            <a:ext cx="384048" cy="384048"/>
+          </a:xfrm>
+          <a:prstGeom prst="rect">
+            <a:avLst/>
+          </a:prstGeom>
+          <a:noFill/>
+          <a:ln/>
+        </p:spPr>
+        <p:txBody>
+          <a:bodyPr wrap="square" lIns="0" tIns="0" rIns="0" bIns="0" rtlCol="0" anchor="ctr"/>
+          <a:lstStyle/>
+          <a:p>
+            <a:pPr algn="ctr" indent="0" marL="0">
+              <a:buNone/>
+            </a:pPr>
+            <a:r>
+              <a:rPr lang="en-US" sz="1400" b="1" dirty="0">
+                <a:solidFill>
+                  <a:srgbClr val="FFFFFF"/>
+                </a:solidFill>
+                <a:latin typeface="Arial" pitchFamily="34" charset="0"/>
+                <a:ea typeface="Arial" pitchFamily="34" charset="-122"/>
+                <a:cs typeface="Arial" pitchFamily="34" charset="-120"/>
+              </a:rPr>
+              <a:t>2</a:t>
+            </a:r>
+            <a:endParaRPr lang="en-US" sz="1400" dirty="0"/>
+          </a:p>
+        </p:txBody>
+      </p:sp>
+      <p:sp>
+        <p:nvSpPr>
+          <p:cNvPr id="12" name="Text 10"/>
+          <p:cNvSpPr/>
+          <p:nvPr/>
+        </p:nvSpPr>
+        <p:spPr>
+          <a:xfrm>
+            <a:off x="4681728" y="2926080"/>
+            <a:ext cx="2798064" cy="566928"/>
+          </a:xfrm>
+          <a:prstGeom prst="rect">
+            <a:avLst/>
+          </a:prstGeom>
+          <a:noFill/>
+          <a:ln/>
+        </p:spPr>
+        <p:txBody>
+          <a:bodyPr wrap="square" lIns="0" tIns="0" rIns="0" bIns="0" rtlCol="0" anchor="t"/>
+          <a:lstStyle/>
+          <a:p>
+            <a:pPr indent="0" marL="0">
+              <a:buNone/>
+            </a:pPr>
+            <a:r>
+              <a:rPr lang="en-US" sz="1200" b="1" spc="50" kern="0" dirty="0">
+                <a:solidFill>
+                  <a:srgbClr val="1A1C2E"/>
+                </a:solidFill>
+                <a:latin typeface="Arial" pitchFamily="34" charset="0"/>
+                <a:ea typeface="Arial" pitchFamily="34" charset="-122"/>
+                <a:cs typeface="Arial" pitchFamily="34" charset="-120"/>
+              </a:rPr>
+              <a:t>INTERPRETARLO ES OFICIO</a:t>
+            </a:r>
+            <a:endParaRPr lang="en-US" sz="1200" dirty="0"/>
+          </a:p>
+        </p:txBody>
+      </p:sp>
+      <p:sp>
+        <p:nvSpPr>
+          <p:cNvPr id="13" name="Text 11"/>
+          <p:cNvSpPr/>
+          <p:nvPr/>
+        </p:nvSpPr>
+        <p:spPr>
+          <a:xfrm>
+            <a:off x="4681728" y="3538728"/>
+            <a:ext cx="2798064" cy="1234440"/>
+          </a:xfrm>
+          <a:prstGeom prst="rect">
+            <a:avLst/>
+          </a:prstGeom>
+          <a:noFill/>
+          <a:ln/>
+        </p:spPr>
+        <p:txBody>
+          <a:bodyPr wrap="square" lIns="0" tIns="0" rIns="0" bIns="0" rtlCol="0" anchor="t"/>
+          <a:lstStyle/>
+          <a:p>
+            <a:pPr indent="0" marL="0">
+              <a:lnSpc>
+                <a:spcPts val="1700"/>
+              </a:lnSpc>
+              <a:buNone/>
+            </a:pPr>
+            <a:r>
+              <a:rPr lang="en-US" sz="1200" dirty="0">
+                <a:solidFill>
+                  <a:srgbClr val="5A5F73"/>
+                </a:solidFill>
+                <a:latin typeface="Calibri" pitchFamily="34" charset="0"/>
+                <a:ea typeface="Calibri" pitchFamily="34" charset="-122"/>
+                <a:cs typeface="Calibri" pitchFamily="34" charset="-120"/>
+              </a:rPr>
+              <a:t>¿Válvula EGR obstruida? ¿O un consumo de aceite que ha ido saturando el filtro de partículas? El código no lo dice. Lo dice la experiencia del mecánico.</a:t>
+            </a:r>
+            <a:endParaRPr lang="en-US" sz="1200" dirty="0"/>
+          </a:p>
+        </p:txBody>
+      </p:sp>
+      <p:sp>
+        <p:nvSpPr>
+          <p:cNvPr id="14" name="Shape 12"/>
+          <p:cNvSpPr/>
+          <p:nvPr/>
+        </p:nvSpPr>
+        <p:spPr>
+          <a:xfrm>
+            <a:off x="8092440" y="2057400"/>
+            <a:ext cx="3383280" cy="2880360"/>
+          </a:xfrm>
+          <a:prstGeom prst="roundRect">
+            <a:avLst>
+              <a:gd name="adj" fmla="val 3175"/>
+            </a:avLst>
+          </a:prstGeom>
+          <a:solidFill>
+            <a:srgbClr val="F3F4F9"/>
+          </a:solidFill>
+          <a:ln/>
+        </p:spPr>
+      </p:sp>
+      <p:sp>
+        <p:nvSpPr>
+          <p:cNvPr id="15" name="Shape 13"/>
+          <p:cNvSpPr/>
+          <p:nvPr/>
+        </p:nvSpPr>
+        <p:spPr>
+          <a:xfrm>
+            <a:off x="8385048" y="2350008"/>
+            <a:ext cx="384048" cy="384048"/>
+          </a:xfrm>
+          <a:prstGeom prst="ellipse">
+            <a:avLst/>
+          </a:prstGeom>
+          <a:solidFill>
+            <a:srgbClr val="202CFC"/>
+          </a:solidFill>
+          <a:ln/>
+        </p:spPr>
+      </p:sp>
+      <p:sp>
+        <p:nvSpPr>
+          <p:cNvPr id="16" name="Text 14"/>
+          <p:cNvSpPr/>
+          <p:nvPr/>
+        </p:nvSpPr>
+        <p:spPr>
+          <a:xfrm>
+            <a:off x="8385048" y="2350008"/>
+            <a:ext cx="384048" cy="384048"/>
+          </a:xfrm>
+          <a:prstGeom prst="rect">
+            <a:avLst/>
+          </a:prstGeom>
+          <a:noFill/>
+          <a:ln/>
+        </p:spPr>
+        <p:txBody>
+          <a:bodyPr wrap="square" lIns="0" tIns="0" rIns="0" bIns="0" rtlCol="0" anchor="ctr"/>
+          <a:lstStyle/>
+          <a:p>
+            <a:pPr algn="ctr" indent="0" marL="0">
+              <a:buNone/>
+            </a:pPr>
+            <a:r>
+              <a:rPr lang="en-US" sz="1400" b="1" dirty="0">
+                <a:solidFill>
+                  <a:srgbClr val="FFFFFF"/>
+                </a:solidFill>
+                <a:latin typeface="Arial" pitchFamily="34" charset="0"/>
+                <a:ea typeface="Arial" pitchFamily="34" charset="-122"/>
+                <a:cs typeface="Arial" pitchFamily="34" charset="-120"/>
+              </a:rPr>
+              <a:t>3</a:t>
+            </a:r>
+            <a:endParaRPr lang="en-US" sz="1400" dirty="0"/>
+          </a:p>
+        </p:txBody>
+      </p:sp>
+      <p:sp>
+        <p:nvSpPr>
+          <p:cNvPr id="17" name="Text 15"/>
+          <p:cNvSpPr/>
+          <p:nvPr/>
+        </p:nvSpPr>
+        <p:spPr>
+          <a:xfrm>
+            <a:off x="8385048" y="2926080"/>
+            <a:ext cx="2798064" cy="566928"/>
+          </a:xfrm>
+          <a:prstGeom prst="rect">
+            <a:avLst/>
+          </a:prstGeom>
+          <a:noFill/>
+          <a:ln/>
+        </p:spPr>
+        <p:txBody>
+          <a:bodyPr wrap="square" lIns="0" tIns="0" rIns="0" bIns="0" rtlCol="0" anchor="t"/>
+          <a:lstStyle/>
+          <a:p>
+            <a:pPr indent="0" marL="0">
+              <a:buNone/>
+            </a:pPr>
+            <a:r>
+              <a:rPr lang="en-US" sz="1200" b="1" spc="50" kern="0" dirty="0">
+                <a:solidFill>
+                  <a:srgbClr val="1A1C2E"/>
+                </a:solidFill>
+                <a:latin typeface="Arial" pitchFamily="34" charset="0"/>
+                <a:ea typeface="Arial" pitchFamily="34" charset="-122"/>
+                <a:cs typeface="Arial" pitchFamily="34" charset="-120"/>
+              </a:rPr>
+              <a:t>Y ESA EXPERIENCIA NO SE GUARDA</a:t>
+            </a:r>
+            <a:endParaRPr lang="en-US" sz="1200" dirty="0"/>
+          </a:p>
+        </p:txBody>
+      </p:sp>
+      <p:sp>
+        <p:nvSpPr>
+          <p:cNvPr id="18" name="Text 16"/>
+          <p:cNvSpPr/>
+          <p:nvPr/>
+        </p:nvSpPr>
+        <p:spPr>
+          <a:xfrm>
+            <a:off x="8385048" y="3538728"/>
+            <a:ext cx="2798064" cy="1234440"/>
+          </a:xfrm>
+          <a:prstGeom prst="rect">
+            <a:avLst/>
+          </a:prstGeom>
+          <a:noFill/>
+          <a:ln/>
+        </p:spPr>
+        <p:txBody>
+          <a:bodyPr wrap="square" lIns="0" tIns="0" rIns="0" bIns="0" rtlCol="0" anchor="t"/>
+          <a:lstStyle/>
+          <a:p>
+            <a:pPr indent="0" marL="0">
+              <a:lnSpc>
+                <a:spcPts val="1700"/>
+              </a:lnSpc>
+              <a:buNone/>
+            </a:pPr>
+            <a:r>
+              <a:rPr lang="en-US" sz="1200" dirty="0">
+                <a:solidFill>
+                  <a:srgbClr val="5A5F73"/>
+                </a:solidFill>
+                <a:latin typeface="Calibri" pitchFamily="34" charset="0"/>
+                <a:ea typeface="Calibri" pitchFamily="34" charset="-122"/>
+                <a:cs typeface="Calibri" pitchFamily="34" charset="-120"/>
+              </a:rPr>
+              <a:t>Cuando acierta, el hallazgo se queda en su cabeza. Seis meses después entra otro coche con los mismos códigos y se empieza de cero.</a:t>
+            </a:r>
+            <a:endParaRPr lang="en-US" sz="1200" dirty="0"/>
+          </a:p>
+        </p:txBody>
+      </p:sp>
+      <p:sp>
+        <p:nvSpPr>
+          <p:cNvPr id="19" name="Text 17"/>
+          <p:cNvSpPr/>
+          <p:nvPr/>
+        </p:nvSpPr>
+        <p:spPr>
+          <a:xfrm>
+            <a:off x="777240" y="5440680"/>
+            <a:ext cx="10607040" cy="457200"/>
+          </a:xfrm>
+          <a:prstGeom prst="rect">
+            <a:avLst/>
+          </a:prstGeom>
+          <a:noFill/>
+          <a:ln/>
+        </p:spPr>
+        <p:txBody>
+          <a:bodyPr wrap="square" lIns="0" tIns="0" rIns="0" bIns="0" rtlCol="0" anchor="ctr"/>
+          <a:lstStyle/>
+          <a:p>
+            <a:pPr indent="0" marL="0">
+              <a:buNone/>
+            </a:pPr>
+            <a:r>
+              <a:rPr lang="en-US" sz="1700" b="1" dirty="0">
+                <a:solidFill>
+                  <a:srgbClr val="1A1C2E"/>
+                </a:solidFill>
+                <a:latin typeface="Arial" pitchFamily="34" charset="0"/>
+                <a:ea typeface="Arial" pitchFamily="34" charset="-122"/>
+                <a:cs typeface="Arial" pitchFamily="34" charset="-120"/>
+              </a:rPr>
+              <a:t>El problema no es leer el coche. Es el salto del síntoma a la causa — y que ese salto </a:t>
+            </a:r>
+            <a:pPr indent="0" marL="0">
+              <a:buNone/>
+            </a:pPr>
+            <a:r>
+              <a:rPr lang="en-US" sz="1700" b="1" dirty="0">
+                <a:solidFill>
+                  <a:srgbClr val="202CFC"/>
+                </a:solidFill>
+                <a:latin typeface="Arial" pitchFamily="34" charset="0"/>
+                <a:ea typeface="Arial" pitchFamily="34" charset="-122"/>
+                <a:cs typeface="Arial" pitchFamily="34" charset="-120"/>
+              </a:rPr>
+              <a:t>no se acumula.</a:t>
+            </a:r>
+            <a:endParaRPr lang="en-US" sz="1700" dirty="0"/>
+          </a:p>
+        </p:txBody>
+      </p:sp>
+      <p:sp>
+        <p:nvSpPr>
+          <p:cNvPr id="20" name="Shape 18"/>
+          <p:cNvSpPr/>
+          <p:nvPr/>
+        </p:nvSpPr>
+        <p:spPr>
+          <a:xfrm>
+            <a:off x="777240" y="6263640"/>
+            <a:ext cx="219456" cy="219456"/>
+          </a:xfrm>
+          <a:prstGeom prst="rect">
+            <a:avLst/>
+          </a:prstGeom>
+          <a:solidFill>
+            <a:srgbClr val="202CFC"/>
+          </a:solidFill>
+          <a:ln/>
+        </p:spPr>
+      </p:sp>
+      <p:sp>
+        <p:nvSpPr>
+          <p:cNvPr id="21" name="Text 19"/>
+          <p:cNvSpPr/>
+          <p:nvPr/>
+        </p:nvSpPr>
+        <p:spPr>
+          <a:xfrm>
+            <a:off x="777240" y="6263640"/>
+            <a:ext cx="219456" cy="219456"/>
+          </a:xfrm>
+          <a:prstGeom prst="rect">
+            <a:avLst/>
+          </a:prstGeom>
+          <a:noFill/>
+          <a:ln/>
+        </p:spPr>
+        <p:txBody>
+          <a:bodyPr wrap="square" lIns="0" tIns="0" rIns="0" bIns="0" rtlCol="0" anchor="ctr"/>
+          <a:lstStyle/>
+          <a:p>
+            <a:pPr algn="ctr" indent="0" marL="0">
+              <a:buNone/>
+            </a:pPr>
+            <a:r>
+              <a:rPr lang="en-US" sz="816" b="1" dirty="0">
+                <a:solidFill>
+                  <a:srgbClr val="FFFFFF"/>
+                </a:solidFill>
+                <a:latin typeface="Arial" pitchFamily="34" charset="0"/>
+                <a:ea typeface="Arial" pitchFamily="34" charset="-122"/>
+                <a:cs typeface="Arial" pitchFamily="34" charset="-120"/>
+              </a:rPr>
+              <a:t>BIG</a:t>
+            </a:r>
+            <a:endParaRPr lang="en-US" sz="816" dirty="0"/>
+          </a:p>
+        </p:txBody>
+      </p:sp>
+      <p:sp>
+        <p:nvSpPr>
+          <p:cNvPr id="22" name="Text 20"/>
+          <p:cNvSpPr/>
+          <p:nvPr/>
+        </p:nvSpPr>
+        <p:spPr>
+          <a:xfrm>
+            <a:off x="1078992" y="6263640"/>
+            <a:ext cx="658368" cy="219456"/>
+          </a:xfrm>
+          <a:prstGeom prst="rect">
+            <a:avLst/>
+          </a:prstGeom>
+          <a:noFill/>
+          <a:ln/>
+        </p:spPr>
+        <p:txBody>
+          <a:bodyPr wrap="square" lIns="0" tIns="0" rIns="0" bIns="0" rtlCol="0" anchor="ctr"/>
+          <a:lstStyle/>
+          <a:p>
+            <a:pPr algn="l" indent="0" marL="0">
+              <a:buNone/>
+            </a:pPr>
+            <a:r>
+              <a:rPr lang="en-US" sz="816" dirty="0">
+                <a:solidFill>
+                  <a:srgbClr val="1A1C2E"/>
+                </a:solidFill>
+                <a:latin typeface="Arial" pitchFamily="34" charset="0"/>
+                <a:ea typeface="Arial" pitchFamily="34" charset="-122"/>
+                <a:cs typeface="Arial" pitchFamily="34" charset="-120"/>
+              </a:rPr>
+              <a:t>school</a:t>
+            </a:r>
+            <a:endParaRPr lang="en-US" sz="816" dirty="0"/>
+          </a:p>
+        </p:txBody>
+      </p:sp>
+      <p:sp>
+        <p:nvSpPr>
+          <p:cNvPr id="23" name="Text 21"/>
+          <p:cNvSpPr/>
+          <p:nvPr/>
+        </p:nvSpPr>
+        <p:spPr>
+          <a:xfrm>
+            <a:off x="11064240" y="6263640"/>
+            <a:ext cx="320040" cy="219456"/>
+          </a:xfrm>
+          <a:prstGeom prst="rect">
+            <a:avLst/>
+          </a:prstGeom>
+          <a:noFill/>
+          <a:ln/>
+        </p:spPr>
+        <p:txBody>
+          <a:bodyPr wrap="square" lIns="0" tIns="0" rIns="0" bIns="0" rtlCol="0" anchor="ctr"/>
+          <a:lstStyle/>
+          <a:p>
+            <a:pPr algn="r" indent="0" marL="0">
+              <a:buNone/>
+            </a:pPr>
+            <a:r>
+              <a:rPr lang="en-US" sz="1000" dirty="0">
+                <a:solidFill>
+                  <a:srgbClr val="5A5F73"/>
+                </a:solidFill>
+                <a:latin typeface="Calibri" pitchFamily="34" charset="0"/>
+                <a:ea typeface="Calibri" pitchFamily="34" charset="-122"/>
+                <a:cs typeface="Calibri" pitchFamily="34" charset="-120"/>
+              </a:rPr>
+              <a:t>2</a:t>
             </a:r>
             <a:endParaRPr lang="en-US" sz="1000" dirty="0"/>
           </a:p>

</xml_diff>

<commit_message>
docs(tfm): reescribir el problema y anadir el objetivo
</commit_message>
<xml_diff>
--- a/docs/presentacion/tfm-intelligent-automotive-diagnostics.pptx
+++ b/docs/presentacion/tfm-intelligent-automotive-diagnostics.pptx
@@ -7,9 +7,10 @@
   <p:sldIdLst>
     <p:sldId id="256" r:id="rId2"/>
     <p:sldId id="257" r:id="rId3"/>
+    <p:sldId id="258" r:id="rId4"/>
   </p:sldIdLst>
   <p:notesMasterIdLst>
-    <p:notesMasterId r:id="rId4"/>
+    <p:notesMasterId r:id="rId5"/>
   </p:notesMasterIdLst>
   <p:sldSz cx="12192000" cy="6858000"/>
   <p:notesSz cx="6858000" cy="12192000"/>
@@ -594,11 +595,10 @@
           <a:p>
             <a:r>
               <a:rPr lang="en-US" dirty="0"/>
-              <a:t>Un mecánico conecta el escáner y obtiene un código: P0401, P2002. Eso es el síntoma que la centralita ha registrado. No es la avería.
-Del código a la causa hay un salto, y ese salto lo da la experiencia. Los mismos dos códigos pueden ser una EGR sucia, o pueden ser un motor que consume aceite y ha ido saturando el filtro de partículas. Son reparaciones distintas y facturas muy distintas.
-Y aquí está lo que a mí me parece el problema de verdad: cuando el mecánico acierta, ese conocimiento no queda en ningún sitio. Se queda en su cabeza. Seis meses después entra otro coche con los mismos códigos y se vuelve a empezar de cero.
-El diagnóstico no es un problema de lectura de datos. Es un problema de interpretación, y de memoria.
-[~45 s. Apoyarse en el tercer bloque: es el que abre la slide siguiente.]</a:t>
+              <a:t>Cuando un mecánico conecta el escáner a un coche, lo que le sale son códigos. Por ejemplo P0401 y P2002. Eso le dice lo que ha registrado la centralita, pero no le dice qué está roto.
+A partir de ahí el trabajo lo pone él. Esos dos códigos pueden ser una válvula EGR sucia, o pueden ser un motor que consume aceite y ha ido saturando el filtro de partículas. Son dos reparaciones distintas, y decidir cuál es depende de la experiencia que tenga.
+Y luego está lo otro: cuando da con el fallo, eso no queda registrado en ninguna parte. Se queda en su cabeza. El siguiente coche con esos mismos códigos igual entra en otro taller, y allí se empieza otra vez desde el código.
+[~45 s]</a:t>
             </a:r>
             <a:endParaRPr lang="en-US" dirty="0"/>
           </a:p>
@@ -622,6 +622,97 @@
             <a:fld id="{F7021451-1387-4CA6-816F-3879F97B5CBC}" type="slidenum">
               <a:rPr lang="en-US"/>
               <a:t>2</a:t>
+            </a:fld>
+            <a:endParaRPr lang="en-US"/>
+          </a:p>
+        </p:txBody>
+      </p:sp>
+    </p:spTree>
+    <p:extLst>
+      <p:ext uri="{BB962C8B-B14F-4D97-AF65-F5344CB8AC3E}">
+        <p14:creationId xmlns:p14="http://schemas.microsoft.com/office/powerpoint/2010/main" val="1024086991"/>
+      </p:ext>
+    </p:extLst>
+  </p:cSld>
+  <p:clrMapOvr>
+    <a:masterClrMapping/>
+  </p:clrMapOvr>
+</p:notes>
+</file>
+
+<file path=ppt/notesSlides/notesSlide3.xml><?xml version="1.0" encoding="utf-8"?>
+<p:notes xmlns:a="http://schemas.openxmlformats.org/drawingml/2006/main" xmlns:r="http://schemas.openxmlformats.org/officeDocument/2006/relationships" xmlns:p="http://schemas.openxmlformats.org/presentationml/2006/main">
+  <p:cSld>
+    <p:spTree>
+      <p:nvGrpSpPr>
+        <p:cNvPr id="1" name=""/>
+        <p:cNvGrpSpPr/>
+        <p:nvPr/>
+      </p:nvGrpSpPr>
+      <p:grpSpPr>
+        <a:xfrm>
+          <a:off x="0" y="0"/>
+          <a:ext cx="0" cy="0"/>
+          <a:chOff x="0" y="0"/>
+          <a:chExt cx="0" cy="0"/>
+        </a:xfrm>
+      </p:grpSpPr>
+      <p:sp>
+        <p:nvSpPr>
+          <p:cNvPr id="2" name="Slide Image Placeholder 1"/>
+          <p:cNvSpPr>
+            <a:spLocks noGrp="1" noRot="1" noChangeAspect="1"/>
+          </p:cNvSpPr>
+          <p:nvPr>
+            <p:ph type="sldImg"/>
+          </p:nvPr>
+        </p:nvSpPr>
+        <p:spPr/>
+      </p:sp>
+      <p:sp>
+        <p:nvSpPr>
+          <p:cNvPr id="3" name="Notes Placeholder 2"/>
+          <p:cNvSpPr>
+            <a:spLocks noGrp="1"/>
+          </p:cNvSpPr>
+          <p:nvPr>
+            <p:ph type="body" idx="1"/>
+          </p:nvPr>
+        </p:nvSpPr>
+        <p:spPr/>
+        <p:txBody>
+          <a:bodyPr/>
+          <a:lstStyle/>
+          <a:p>
+            <a:r>
+              <a:rPr lang="en-US" dirty="0"/>
+              <a:t>El objetivo de la aplicación es ayudar al mecánico a diagnosticar. A investigar un fallo: qué le pasa al coche, si está bien o está mal, y por dónde seguir mirando.
+Dicho de otra forma: mejorar la visión que tiene del vehículo cuando conecta la herramienta. Eso ya lo hace desde el primer coche.
+Y luego está lo que aporta con el tiempo. Esto está pensado para que se conecten más talleres, se registren más coches, más averías y más diagnósticos. Como todo eso se guarda en una base vectorial, cuando llega un coche nuevo el sistema puede comparar con casos que ya se resolvieron antes y dar una valoración más real. No pasa de un día para otro: lo va haciendo poco a poco.
+[~55 s. Es la promesa de la charla: decirla despacio.]</a:t>
+            </a:r>
+            <a:endParaRPr lang="en-US" dirty="0"/>
+          </a:p>
+        </p:txBody>
+      </p:sp>
+      <p:sp>
+        <p:nvSpPr>
+          <p:cNvPr id="4" name="Slide Number Placeholder 3"/>
+          <p:cNvSpPr>
+            <a:spLocks noGrp="1"/>
+          </p:cNvSpPr>
+          <p:nvPr>
+            <p:ph type="sldNum" sz="quarter" idx="10"/>
+          </p:nvPr>
+        </p:nvSpPr>
+        <p:spPr/>
+        <p:txBody>
+          <a:bodyPr/>
+          <a:lstStyle/>
+          <a:p>
+            <a:fld id="{F7021451-1387-4CA6-816F-3879F97B5CBC}" type="slidenum">
+              <a:rPr lang="en-US"/>
+              <a:t>3</a:t>
             </a:fld>
             <a:endParaRPr lang="en-US"/>
           </a:p>
@@ -1418,24 +1509,24 @@
         </p:nvSpPr>
         <p:spPr>
           <a:xfrm>
-            <a:off x="777240" y="896112"/>
-            <a:ext cx="10607040" cy="658368"/>
-          </a:xfrm>
-          <a:prstGeom prst="rect">
-            <a:avLst/>
-          </a:prstGeom>
-          <a:noFill/>
-          <a:ln/>
-        </p:spPr>
-        <p:txBody>
-          <a:bodyPr wrap="square" lIns="0" tIns="0" rIns="0" bIns="0" rtlCol="0" anchor="ctr"/>
+            <a:off x="777240" y="877824"/>
+            <a:ext cx="10607040" cy="1051560"/>
+          </a:xfrm>
+          <a:prstGeom prst="rect">
+            <a:avLst/>
+          </a:prstGeom>
+          <a:noFill/>
+          <a:ln/>
+        </p:spPr>
+        <p:txBody>
+          <a:bodyPr wrap="square" lIns="0" tIns="0" rIns="0" bIns="0" rtlCol="0" anchor="t"/>
           <a:lstStyle/>
           <a:p>
             <a:pPr indent="0" marL="0">
               <a:buNone/>
             </a:pPr>
             <a:r>
-              <a:rPr lang="en-US" sz="3600" b="1" dirty="0">
+              <a:rPr lang="en-US" sz="3400" b="1" dirty="0">
                 <a:solidFill>
                   <a:srgbClr val="1A1C2E"/>
                 </a:solidFill>
@@ -1443,9 +1534,9 @@
                 <a:ea typeface="Arial" pitchFamily="34" charset="-122"/>
                 <a:cs typeface="Arial" pitchFamily="34" charset="-120"/>
               </a:rPr>
-              <a:t>El código no es el diagnóstico</a:t>
-            </a:r>
-            <a:endParaRPr lang="en-US" sz="3600" dirty="0"/>
+              <a:t>Lo que ve hoy un mecánico</a:t>
+            </a:r>
+            <a:endParaRPr lang="en-US" sz="3400" dirty="0"/>
           </a:p>
         </p:txBody>
       </p:sp>
@@ -1555,7 +1646,7 @@
               <a:buNone/>
             </a:pPr>
             <a:r>
-              <a:rPr lang="en-US" sz="1200" b="1" spc="50" kern="0" dirty="0">
+              <a:rPr lang="en-US" sz="1300" b="1" dirty="0">
                 <a:solidFill>
                   <a:srgbClr val="1A1C2E"/>
                 </a:solidFill>
@@ -1563,9 +1654,9 @@
                 <a:ea typeface="Arial" pitchFamily="34" charset="-122"/>
                 <a:cs typeface="Arial" pitchFamily="34" charset="-120"/>
               </a:rPr>
-              <a:t>EL ESCÁNER DEVUELVE UN CÓDIGO</a:t>
-            </a:r>
-            <a:endParaRPr lang="en-US" sz="1200" dirty="0"/>
+              <a:t>Conecta el escáner y salen códigos</a:t>
+            </a:r>
+            <a:endParaRPr lang="en-US" sz="1300" dirty="0"/>
           </a:p>
         </p:txBody>
       </p:sp>
@@ -1605,7 +1696,7 @@
                 <a:ea typeface="Calibri" pitchFamily="34" charset="-122"/>
                 <a:cs typeface="Calibri" pitchFamily="34" charset="-120"/>
               </a:rPr>
-              <a:t>P0401, P2002. Eso es lo que la centralita ha registrado: el síntoma. No es la avería que hay que reparar.</a:t>
+              <a:t>P0401, P2002. Le dicen qué ha registrado la centralita, pero no qué está roto ni por dónde empezar a mirar.</a:t>
             </a:r>
             <a:endParaRPr lang="en-US" sz="1200" dirty="0"/>
           </a:p>
@@ -1717,7 +1808,7 @@
               <a:buNone/>
             </a:pPr>
             <a:r>
-              <a:rPr lang="en-US" sz="1200" b="1" spc="50" kern="0" dirty="0">
+              <a:rPr lang="en-US" sz="1300" b="1" dirty="0">
                 <a:solidFill>
                   <a:srgbClr val="1A1C2E"/>
                 </a:solidFill>
@@ -1725,9 +1816,9 @@
                 <a:ea typeface="Arial" pitchFamily="34" charset="-122"/>
                 <a:cs typeface="Arial" pitchFamily="34" charset="-120"/>
               </a:rPr>
-              <a:t>INTERPRETARLO ES OFICIO</a:t>
-            </a:r>
-            <a:endParaRPr lang="en-US" sz="1200" dirty="0"/>
+              <a:t>El resto lo pone él</a:t>
+            </a:r>
+            <a:endParaRPr lang="en-US" sz="1300" dirty="0"/>
           </a:p>
         </p:txBody>
       </p:sp>
@@ -1767,7 +1858,7 @@
                 <a:ea typeface="Calibri" pitchFamily="34" charset="-122"/>
                 <a:cs typeface="Calibri" pitchFamily="34" charset="-120"/>
               </a:rPr>
-              <a:t>¿Válvula EGR obstruida? ¿O un consumo de aceite que ha ido saturando el filtro de partículas? El código no lo dice. Lo dice la experiencia del mecánico.</a:t>
+              <a:t>Con esos códigos tiene que decidir si es la válvula EGR, si el coche consume aceite y ha saturado el filtro, o si hay que mirar otra cosa. Eso depende de su experiencia.</a:t>
             </a:r>
             <a:endParaRPr lang="en-US" sz="1200" dirty="0"/>
           </a:p>
@@ -1879,7 +1970,7 @@
               <a:buNone/>
             </a:pPr>
             <a:r>
-              <a:rPr lang="en-US" sz="1200" b="1" spc="50" kern="0" dirty="0">
+              <a:rPr lang="en-US" sz="1300" b="1" dirty="0">
                 <a:solidFill>
                   <a:srgbClr val="1A1C2E"/>
                 </a:solidFill>
@@ -1887,9 +1978,9 @@
                 <a:ea typeface="Arial" pitchFamily="34" charset="-122"/>
                 <a:cs typeface="Arial" pitchFamily="34" charset="-120"/>
               </a:rPr>
-              <a:t>Y ESA EXPERIENCIA NO SE GUARDA</a:t>
-            </a:r>
-            <a:endParaRPr lang="en-US" sz="1200" dirty="0"/>
+              <a:t>Y lo que averigua no queda en ningún sitio</a:t>
+            </a:r>
+            <a:endParaRPr lang="en-US" sz="1300" dirty="0"/>
           </a:p>
         </p:txBody>
       </p:sp>
@@ -1929,7 +2020,7 @@
                 <a:ea typeface="Calibri" pitchFamily="34" charset="-122"/>
                 <a:cs typeface="Calibri" pitchFamily="34" charset="-120"/>
               </a:rPr>
-              <a:t>Cuando acierta, el hallazgo se queda en su cabeza. Seis meses después entra otro coche con los mismos códigos y se empieza de cero.</a:t>
+              <a:t>Si acierta, lo sabe él. El siguiente coche con esos mismos códigos igual entra en otro taller, y allí se empieza otra vez desde el código.</a:t>
             </a:r>
             <a:endParaRPr lang="en-US" sz="1200" dirty="0"/>
           </a:p>
@@ -1968,7 +2059,7 @@
                 <a:ea typeface="Arial" pitchFamily="34" charset="-122"/>
                 <a:cs typeface="Arial" pitchFamily="34" charset="-120"/>
               </a:rPr>
-              <a:t>El problema no es leer el coche. Es el salto del síntoma a la causa — y que ese salto </a:t>
+              <a:t>El código es igual para todos. Lo que cambia es </a:t>
             </a:r>
             <a:pPr indent="0" marL="0">
               <a:buNone/>
@@ -1982,7 +2073,7 @@
                 <a:ea typeface="Arial" pitchFamily="34" charset="-122"/>
                 <a:cs typeface="Arial" pitchFamily="34" charset="-120"/>
               </a:rPr>
-              <a:t>no se acumula.</a:t>
+              <a:t>lo que cada mecánico sabe hacer con él.</a:t>
             </a:r>
             <a:endParaRPr lang="en-US" sz="1700" dirty="0"/>
           </a:p>
@@ -2120,6 +2211,576 @@
                 <a:cs typeface="Calibri" pitchFamily="34" charset="-120"/>
               </a:rPr>
               <a:t>2</a:t>
+            </a:r>
+            <a:endParaRPr lang="en-US" sz="1000" dirty="0"/>
+          </a:p>
+        </p:txBody>
+      </p:sp>
+    </p:spTree>
+  </p:cSld>
+  <p:clrMapOvr>
+    <a:masterClrMapping/>
+  </p:clrMapOvr>
+</p:sld>
+</file>
+
+<file path=ppt/slides/slide3.xml><?xml version="1.0" encoding="utf-8"?>
+<p:sld xmlns:a="http://schemas.openxmlformats.org/drawingml/2006/main" xmlns:r="http://schemas.openxmlformats.org/officeDocument/2006/relationships" xmlns:p="http://schemas.openxmlformats.org/presentationml/2006/main">
+  <p:cSld name="Slide 3">
+    <p:bg>
+      <p:bgPr>
+        <a:solidFill>
+          <a:srgbClr val="FFFFFF"/>
+        </a:solidFill>
+      </p:bgPr>
+    </p:bg>
+    <p:spTree>
+      <p:nvGrpSpPr>
+        <p:cNvPr id="1" name=""/>
+        <p:cNvGrpSpPr/>
+        <p:nvPr/>
+      </p:nvGrpSpPr>
+      <p:grpSpPr>
+        <a:xfrm>
+          <a:off x="0" y="0"/>
+          <a:ext cx="0" cy="0"/>
+          <a:chOff x="0" y="0"/>
+          <a:chExt cx="0" cy="0"/>
+        </a:xfrm>
+      </p:grpSpPr>
+      <p:sp>
+        <p:nvSpPr>
+          <p:cNvPr id="2" name="Text 0"/>
+          <p:cNvSpPr/>
+          <p:nvPr/>
+        </p:nvSpPr>
+        <p:spPr>
+          <a:xfrm>
+            <a:off x="777240" y="566928"/>
+            <a:ext cx="7315200" cy="256032"/>
+          </a:xfrm>
+          <a:prstGeom prst="rect">
+            <a:avLst/>
+          </a:prstGeom>
+          <a:noFill/>
+          <a:ln/>
+        </p:spPr>
+        <p:txBody>
+          <a:bodyPr wrap="square" lIns="0" tIns="0" rIns="0" bIns="0" rtlCol="0" anchor="ctr"/>
+          <a:lstStyle/>
+          <a:p>
+            <a:pPr indent="0" marL="0">
+              <a:buNone/>
+            </a:pPr>
+            <a:r>
+              <a:rPr lang="en-US" sz="1100" b="1" spc="250" kern="0" dirty="0">
+                <a:solidFill>
+                  <a:srgbClr val="202CFC"/>
+                </a:solidFill>
+                <a:latin typeface="Calibri" pitchFamily="34" charset="0"/>
+                <a:ea typeface="Calibri" pitchFamily="34" charset="-122"/>
+                <a:cs typeface="Calibri" pitchFamily="34" charset="-120"/>
+              </a:rPr>
+              <a:t>EL OBJETIVO</a:t>
+            </a:r>
+            <a:endParaRPr lang="en-US" sz="1100" dirty="0"/>
+          </a:p>
+        </p:txBody>
+      </p:sp>
+      <p:sp>
+        <p:nvSpPr>
+          <p:cNvPr id="3" name="Text 1"/>
+          <p:cNvSpPr/>
+          <p:nvPr/>
+        </p:nvSpPr>
+        <p:spPr>
+          <a:xfrm>
+            <a:off x="777240" y="877824"/>
+            <a:ext cx="10607040" cy="1051560"/>
+          </a:xfrm>
+          <a:prstGeom prst="rect">
+            <a:avLst/>
+          </a:prstGeom>
+          <a:noFill/>
+          <a:ln/>
+        </p:spPr>
+        <p:txBody>
+          <a:bodyPr wrap="square" lIns="0" tIns="0" rIns="0" bIns="0" rtlCol="0" anchor="t"/>
+          <a:lstStyle/>
+          <a:p>
+            <a:pPr indent="0" marL="0">
+              <a:buNone/>
+            </a:pPr>
+            <a:r>
+              <a:rPr lang="en-US" sz="3400" b="1" dirty="0">
+                <a:solidFill>
+                  <a:srgbClr val="1A1C2E"/>
+                </a:solidFill>
+                <a:latin typeface="Arial" pitchFamily="34" charset="0"/>
+                <a:ea typeface="Arial" pitchFamily="34" charset="-122"/>
+                <a:cs typeface="Arial" pitchFamily="34" charset="-120"/>
+              </a:rPr>
+              <a:t>Que el mecánico vea más del coche</a:t>
+            </a:r>
+            <a:endParaRPr lang="en-US" sz="3400" dirty="0"/>
+          </a:p>
+        </p:txBody>
+      </p:sp>
+      <p:sp>
+        <p:nvSpPr>
+          <p:cNvPr id="4" name="Text 2"/>
+          <p:cNvSpPr/>
+          <p:nvPr/>
+        </p:nvSpPr>
+        <p:spPr>
+          <a:xfrm>
+            <a:off x="777240" y="1965960"/>
+            <a:ext cx="10607040" cy="365760"/>
+          </a:xfrm>
+          <a:prstGeom prst="rect">
+            <a:avLst/>
+          </a:prstGeom>
+          <a:noFill/>
+          <a:ln/>
+        </p:spPr>
+        <p:txBody>
+          <a:bodyPr wrap="square" lIns="0" tIns="0" rIns="0" bIns="0" rtlCol="0" anchor="t"/>
+          <a:lstStyle/>
+          <a:p>
+            <a:pPr indent="0" marL="0">
+              <a:buNone/>
+            </a:pPr>
+            <a:r>
+              <a:rPr lang="en-US" sz="1600" dirty="0">
+                <a:solidFill>
+                  <a:srgbClr val="5A5F73"/>
+                </a:solidFill>
+                <a:latin typeface="Calibri" pitchFamily="34" charset="0"/>
+                <a:ea typeface="Calibri" pitchFamily="34" charset="-122"/>
+                <a:cs typeface="Calibri" pitchFamily="34" charset="-120"/>
+              </a:rPr>
+              <a:t>Ayudarle a investigar un fallo: qué le pasa al vehículo, si está bien o está mal, y por dónde seguir mirando.</a:t>
+            </a:r>
+            <a:endParaRPr lang="en-US" sz="1600" dirty="0"/>
+          </a:p>
+        </p:txBody>
+      </p:sp>
+      <p:sp>
+        <p:nvSpPr>
+          <p:cNvPr id="5" name="Shape 3"/>
+          <p:cNvSpPr/>
+          <p:nvPr/>
+        </p:nvSpPr>
+        <p:spPr>
+          <a:xfrm>
+            <a:off x="777240" y="2697480"/>
+            <a:ext cx="5074920" cy="2697480"/>
+          </a:xfrm>
+          <a:prstGeom prst="roundRect">
+            <a:avLst>
+              <a:gd name="adj" fmla="val 2712"/>
+            </a:avLst>
+          </a:prstGeom>
+          <a:solidFill>
+            <a:srgbClr val="F3F4F9"/>
+          </a:solidFill>
+          <a:ln/>
+        </p:spPr>
+      </p:sp>
+      <p:sp>
+        <p:nvSpPr>
+          <p:cNvPr id="6" name="Text 4"/>
+          <p:cNvSpPr/>
+          <p:nvPr/>
+        </p:nvSpPr>
+        <p:spPr>
+          <a:xfrm>
+            <a:off x="1143000" y="3063240"/>
+            <a:ext cx="4343400" cy="274320"/>
+          </a:xfrm>
+          <a:prstGeom prst="rect">
+            <a:avLst/>
+          </a:prstGeom>
+          <a:noFill/>
+          <a:ln/>
+        </p:spPr>
+        <p:txBody>
+          <a:bodyPr wrap="square" lIns="0" tIns="0" rIns="0" bIns="0" rtlCol="0" anchor="ctr"/>
+          <a:lstStyle/>
+          <a:p>
+            <a:pPr indent="0" marL="0">
+              <a:buNone/>
+            </a:pPr>
+            <a:r>
+              <a:rPr lang="en-US" sz="1100" b="1" spc="200" kern="0" dirty="0">
+                <a:solidFill>
+                  <a:srgbClr val="202CFC"/>
+                </a:solidFill>
+                <a:latin typeface="Calibri" pitchFamily="34" charset="0"/>
+                <a:ea typeface="Calibri" pitchFamily="34" charset="-122"/>
+                <a:cs typeface="Calibri" pitchFamily="34" charset="-120"/>
+              </a:rPr>
+              <a:t>DESDE EL PRIMER COCHE</a:t>
+            </a:r>
+            <a:endParaRPr lang="en-US" sz="1100" dirty="0"/>
+          </a:p>
+        </p:txBody>
+      </p:sp>
+      <p:sp>
+        <p:nvSpPr>
+          <p:cNvPr id="7" name="Text 5"/>
+          <p:cNvSpPr/>
+          <p:nvPr/>
+        </p:nvSpPr>
+        <p:spPr>
+          <a:xfrm>
+            <a:off x="1143000" y="3429000"/>
+            <a:ext cx="4343400" cy="365760"/>
+          </a:xfrm>
+          <a:prstGeom prst="rect">
+            <a:avLst/>
+          </a:prstGeom>
+          <a:noFill/>
+          <a:ln/>
+        </p:spPr>
+        <p:txBody>
+          <a:bodyPr wrap="square" lIns="0" tIns="0" rIns="0" bIns="0" rtlCol="0" anchor="t"/>
+          <a:lstStyle/>
+          <a:p>
+            <a:pPr indent="0" marL="0">
+              <a:buNone/>
+            </a:pPr>
+            <a:r>
+              <a:rPr lang="en-US" sz="1900" b="1" dirty="0">
+                <a:solidFill>
+                  <a:srgbClr val="1A1C2E"/>
+                </a:solidFill>
+                <a:latin typeface="Arial" pitchFamily="34" charset="0"/>
+                <a:ea typeface="Arial" pitchFamily="34" charset="-122"/>
+                <a:cs typeface="Arial" pitchFamily="34" charset="-120"/>
+              </a:rPr>
+              <a:t>Le ayuda a investigar el fallo</a:t>
+            </a:r>
+            <a:endParaRPr lang="en-US" sz="1900" dirty="0"/>
+          </a:p>
+        </p:txBody>
+      </p:sp>
+      <p:sp>
+        <p:nvSpPr>
+          <p:cNvPr id="8" name="Text 6"/>
+          <p:cNvSpPr/>
+          <p:nvPr/>
+        </p:nvSpPr>
+        <p:spPr>
+          <a:xfrm>
+            <a:off x="1143000" y="3977640"/>
+            <a:ext cx="4343400" cy="1280160"/>
+          </a:xfrm>
+          <a:prstGeom prst="rect">
+            <a:avLst/>
+          </a:prstGeom>
+          <a:noFill/>
+          <a:ln/>
+        </p:spPr>
+        <p:txBody>
+          <a:bodyPr wrap="square" lIns="0" tIns="0" rIns="0" bIns="0" rtlCol="0" anchor="t"/>
+          <a:lstStyle/>
+          <a:p>
+            <a:pPr indent="0" marL="0">
+              <a:lnSpc>
+                <a:spcPts val="1900"/>
+              </a:lnSpc>
+              <a:buNone/>
+            </a:pPr>
+            <a:r>
+              <a:rPr lang="en-US" sz="1300" dirty="0">
+                <a:solidFill>
+                  <a:srgbClr val="5A5F73"/>
+                </a:solidFill>
+                <a:latin typeface="Calibri" pitchFamily="34" charset="0"/>
+                <a:ea typeface="Calibri" pitchFamily="34" charset="-122"/>
+                <a:cs typeface="Calibri" pitchFamily="34" charset="-120"/>
+              </a:rPr>
+              <a:t>La herramienta lee el coche, cruza lo que encuentra y le dice qué está pasando y por dónde seguir mirando: si el coche está bien, si está mal, y qué conviene revisar. No le devuelve una tabla de códigos, le devuelve una lectura del vehículo.</a:t>
+            </a:r>
+            <a:endParaRPr lang="en-US" sz="1300" dirty="0"/>
+          </a:p>
+        </p:txBody>
+      </p:sp>
+      <p:sp>
+        <p:nvSpPr>
+          <p:cNvPr id="9" name="Shape 7"/>
+          <p:cNvSpPr/>
+          <p:nvPr/>
+        </p:nvSpPr>
+        <p:spPr>
+          <a:xfrm>
+            <a:off x="6309360" y="2697480"/>
+            <a:ext cx="5074920" cy="2697480"/>
+          </a:xfrm>
+          <a:prstGeom prst="roundRect">
+            <a:avLst>
+              <a:gd name="adj" fmla="val 2712"/>
+            </a:avLst>
+          </a:prstGeom>
+          <a:solidFill>
+            <a:srgbClr val="1A1C2E"/>
+          </a:solidFill>
+          <a:ln/>
+        </p:spPr>
+      </p:sp>
+      <p:sp>
+        <p:nvSpPr>
+          <p:cNvPr id="10" name="Text 8"/>
+          <p:cNvSpPr/>
+          <p:nvPr/>
+        </p:nvSpPr>
+        <p:spPr>
+          <a:xfrm>
+            <a:off x="6675120" y="3063240"/>
+            <a:ext cx="4343400" cy="274320"/>
+          </a:xfrm>
+          <a:prstGeom prst="rect">
+            <a:avLst/>
+          </a:prstGeom>
+          <a:noFill/>
+          <a:ln/>
+        </p:spPr>
+        <p:txBody>
+          <a:bodyPr wrap="square" lIns="0" tIns="0" rIns="0" bIns="0" rtlCol="0" anchor="ctr"/>
+          <a:lstStyle/>
+          <a:p>
+            <a:pPr indent="0" marL="0">
+              <a:buNone/>
+            </a:pPr>
+            <a:r>
+              <a:rPr lang="en-US" sz="1100" b="1" spc="200" kern="0" dirty="0">
+                <a:solidFill>
+                  <a:srgbClr val="8A93FF"/>
+                </a:solidFill>
+                <a:latin typeface="Calibri" pitchFamily="34" charset="0"/>
+                <a:ea typeface="Calibri" pitchFamily="34" charset="-122"/>
+                <a:cs typeface="Calibri" pitchFamily="34" charset="-120"/>
+              </a:rPr>
+              <a:t>SEGÚN SE VAN CONECTANDO TALLERES</a:t>
+            </a:r>
+            <a:endParaRPr lang="en-US" sz="1100" dirty="0"/>
+          </a:p>
+        </p:txBody>
+      </p:sp>
+      <p:sp>
+        <p:nvSpPr>
+          <p:cNvPr id="11" name="Text 9"/>
+          <p:cNvSpPr/>
+          <p:nvPr/>
+        </p:nvSpPr>
+        <p:spPr>
+          <a:xfrm>
+            <a:off x="6675120" y="3429000"/>
+            <a:ext cx="4343400" cy="365760"/>
+          </a:xfrm>
+          <a:prstGeom prst="rect">
+            <a:avLst/>
+          </a:prstGeom>
+          <a:noFill/>
+          <a:ln/>
+        </p:spPr>
+        <p:txBody>
+          <a:bodyPr wrap="square" lIns="0" tIns="0" rIns="0" bIns="0" rtlCol="0" anchor="t"/>
+          <a:lstStyle/>
+          <a:p>
+            <a:pPr indent="0" marL="0">
+              <a:buNone/>
+            </a:pPr>
+            <a:r>
+              <a:rPr lang="en-US" sz="1900" b="1" dirty="0">
+                <a:solidFill>
+                  <a:srgbClr val="FFFFFF"/>
+                </a:solidFill>
+                <a:latin typeface="Arial" pitchFamily="34" charset="0"/>
+                <a:ea typeface="Arial" pitchFamily="34" charset="-122"/>
+                <a:cs typeface="Arial" pitchFamily="34" charset="-120"/>
+              </a:rPr>
+              <a:t>Y va mejorando con el uso</a:t>
+            </a:r>
+            <a:endParaRPr lang="en-US" sz="1900" dirty="0"/>
+          </a:p>
+        </p:txBody>
+      </p:sp>
+      <p:sp>
+        <p:nvSpPr>
+          <p:cNvPr id="12" name="Text 10"/>
+          <p:cNvSpPr/>
+          <p:nvPr/>
+        </p:nvSpPr>
+        <p:spPr>
+          <a:xfrm>
+            <a:off x="6675120" y="3977640"/>
+            <a:ext cx="4343400" cy="1280160"/>
+          </a:xfrm>
+          <a:prstGeom prst="rect">
+            <a:avLst/>
+          </a:prstGeom>
+          <a:noFill/>
+          <a:ln/>
+        </p:spPr>
+        <p:txBody>
+          <a:bodyPr wrap="square" lIns="0" tIns="0" rIns="0" bIns="0" rtlCol="0" anchor="t"/>
+          <a:lstStyle/>
+          <a:p>
+            <a:pPr indent="0" marL="0">
+              <a:lnSpc>
+                <a:spcPts val="1900"/>
+              </a:lnSpc>
+              <a:buNone/>
+            </a:pPr>
+            <a:r>
+              <a:rPr lang="en-US" sz="1300" dirty="0">
+                <a:solidFill>
+                  <a:srgbClr val="B8BCCC"/>
+                </a:solidFill>
+                <a:latin typeface="Calibri" pitchFamily="34" charset="0"/>
+                <a:ea typeface="Calibri" pitchFamily="34" charset="-122"/>
+                <a:cs typeface="Calibri" pitchFamily="34" charset="-120"/>
+              </a:rPr>
+              <a:t>Cada diagnóstico que se cierra se guarda en una base de datos vectorial. Cuantos más talleres conectados, más coches registrados y más averías resueltas, más casos reales tiene para comparar. Es una mejora lenta, pero se acumula.</a:t>
+            </a:r>
+            <a:endParaRPr lang="en-US" sz="1300" dirty="0"/>
+          </a:p>
+        </p:txBody>
+      </p:sp>
+      <p:sp>
+        <p:nvSpPr>
+          <p:cNvPr id="13" name="Shape 11"/>
+          <p:cNvSpPr/>
+          <p:nvPr/>
+        </p:nvSpPr>
+        <p:spPr>
+          <a:xfrm>
+            <a:off x="777240" y="6263640"/>
+            <a:ext cx="219456" cy="219456"/>
+          </a:xfrm>
+          <a:prstGeom prst="rect">
+            <a:avLst/>
+          </a:prstGeom>
+          <a:solidFill>
+            <a:srgbClr val="202CFC"/>
+          </a:solidFill>
+          <a:ln/>
+        </p:spPr>
+      </p:sp>
+      <p:sp>
+        <p:nvSpPr>
+          <p:cNvPr id="14" name="Text 12"/>
+          <p:cNvSpPr/>
+          <p:nvPr/>
+        </p:nvSpPr>
+        <p:spPr>
+          <a:xfrm>
+            <a:off x="777240" y="6263640"/>
+            <a:ext cx="219456" cy="219456"/>
+          </a:xfrm>
+          <a:prstGeom prst="rect">
+            <a:avLst/>
+          </a:prstGeom>
+          <a:noFill/>
+          <a:ln/>
+        </p:spPr>
+        <p:txBody>
+          <a:bodyPr wrap="square" lIns="0" tIns="0" rIns="0" bIns="0" rtlCol="0" anchor="ctr"/>
+          <a:lstStyle/>
+          <a:p>
+            <a:pPr algn="ctr" indent="0" marL="0">
+              <a:buNone/>
+            </a:pPr>
+            <a:r>
+              <a:rPr lang="en-US" sz="816" b="1" dirty="0">
+                <a:solidFill>
+                  <a:srgbClr val="FFFFFF"/>
+                </a:solidFill>
+                <a:latin typeface="Arial" pitchFamily="34" charset="0"/>
+                <a:ea typeface="Arial" pitchFamily="34" charset="-122"/>
+                <a:cs typeface="Arial" pitchFamily="34" charset="-120"/>
+              </a:rPr>
+              <a:t>BIG</a:t>
+            </a:r>
+            <a:endParaRPr lang="en-US" sz="816" dirty="0"/>
+          </a:p>
+        </p:txBody>
+      </p:sp>
+      <p:sp>
+        <p:nvSpPr>
+          <p:cNvPr id="15" name="Text 13"/>
+          <p:cNvSpPr/>
+          <p:nvPr/>
+        </p:nvSpPr>
+        <p:spPr>
+          <a:xfrm>
+            <a:off x="1078992" y="6263640"/>
+            <a:ext cx="658368" cy="219456"/>
+          </a:xfrm>
+          <a:prstGeom prst="rect">
+            <a:avLst/>
+          </a:prstGeom>
+          <a:noFill/>
+          <a:ln/>
+        </p:spPr>
+        <p:txBody>
+          <a:bodyPr wrap="square" lIns="0" tIns="0" rIns="0" bIns="0" rtlCol="0" anchor="ctr"/>
+          <a:lstStyle/>
+          <a:p>
+            <a:pPr algn="l" indent="0" marL="0">
+              <a:buNone/>
+            </a:pPr>
+            <a:r>
+              <a:rPr lang="en-US" sz="816" dirty="0">
+                <a:solidFill>
+                  <a:srgbClr val="1A1C2E"/>
+                </a:solidFill>
+                <a:latin typeface="Arial" pitchFamily="34" charset="0"/>
+                <a:ea typeface="Arial" pitchFamily="34" charset="-122"/>
+                <a:cs typeface="Arial" pitchFamily="34" charset="-120"/>
+              </a:rPr>
+              <a:t>school</a:t>
+            </a:r>
+            <a:endParaRPr lang="en-US" sz="816" dirty="0"/>
+          </a:p>
+        </p:txBody>
+      </p:sp>
+      <p:sp>
+        <p:nvSpPr>
+          <p:cNvPr id="16" name="Text 14"/>
+          <p:cNvSpPr/>
+          <p:nvPr/>
+        </p:nvSpPr>
+        <p:spPr>
+          <a:xfrm>
+            <a:off x="11064240" y="6263640"/>
+            <a:ext cx="320040" cy="219456"/>
+          </a:xfrm>
+          <a:prstGeom prst="rect">
+            <a:avLst/>
+          </a:prstGeom>
+          <a:noFill/>
+          <a:ln/>
+        </p:spPr>
+        <p:txBody>
+          <a:bodyPr wrap="square" lIns="0" tIns="0" rIns="0" bIns="0" rtlCol="0" anchor="ctr"/>
+          <a:lstStyle/>
+          <a:p>
+            <a:pPr algn="r" indent="0" marL="0">
+              <a:buNone/>
+            </a:pPr>
+            <a:r>
+              <a:rPr lang="en-US" sz="1000" dirty="0">
+                <a:solidFill>
+                  <a:srgbClr val="5A5F73"/>
+                </a:solidFill>
+                <a:latin typeface="Calibri" pitchFamily="34" charset="0"/>
+                <a:ea typeface="Calibri" pitchFamily="34" charset="-122"/>
+                <a:cs typeface="Calibri" pitchFamily="34" charset="-120"/>
+              </a:rPr>
+              <a:t>3</a:t>
             </a:r>
             <a:endParaRPr lang="en-US" sz="1000" dirty="0"/>
           </a:p>

</xml_diff>

<commit_message>
docs(tfm): aligerar problema y objetivo, anadir arquitectura
</commit_message>
<xml_diff>
--- a/docs/presentacion/tfm-intelligent-automotive-diagnostics.pptx
+++ b/docs/presentacion/tfm-intelligent-automotive-diagnostics.pptx
@@ -8,9 +8,10 @@
     <p:sldId id="256" r:id="rId2"/>
     <p:sldId id="257" r:id="rId3"/>
     <p:sldId id="258" r:id="rId4"/>
+    <p:sldId id="259" r:id="rId5"/>
   </p:sldIdLst>
   <p:notesMasterIdLst>
-    <p:notesMasterId r:id="rId5"/>
+    <p:notesMasterId r:id="rId6"/>
   </p:notesMasterIdLst>
   <p:sldSz cx="12192000" cy="6858000"/>
   <p:notesSz cx="6858000" cy="12192000"/>
@@ -507,7 +508,7 @@
               <a:t>Buenos días. Soy Jesús Ángel Novillo y presento mi Trabajo Fin de Máster del Máster en Desarrollo con IA de BIG school.
 El proyecto se llama Intelligent Automotive Diagnostics: una herramienta que se conecta al coche por el puerto OBD-II, lee sus datos reales y razona sobre ellos con un modelo de lenguaje.
 Lo de la derecha no es una maqueta: es la aplicación funcionando, mostrando tres averías que acaba de leer de la centralita.
-[~15 s. La portada solo abre: no entretenerse.]</a:t>
+[~15 s]</a:t>
             </a:r>
             <a:endParaRPr lang="en-US" dirty="0"/>
           </a:p>
@@ -595,9 +596,9 @@
           <a:p>
             <a:r>
               <a:rPr lang="en-US" dirty="0"/>
-              <a:t>Cuando un mecánico conecta el escáner a un coche, lo que le sale son códigos. Por ejemplo P0401 y P2002. Eso le dice lo que ha registrado la centralita, pero no le dice qué está roto.
-A partir de ahí el trabajo lo pone él. Esos dos códigos pueden ser una válvula EGR sucia, o pueden ser un motor que consume aceite y ha ido saturando el filtro de partículas. Son dos reparaciones distintas, y decidir cuál es depende de la experiencia que tenga.
-Y luego está lo otro: cuando da con el fallo, eso no queda registrado en ninguna parte. Se queda en su cabeza. El siguiente coche con esos mismos códigos igual entra en otro taller, y allí se empieza otra vez desde el código.
+              <a:t>Cuando un mecánico conecta el escáner a un coche, lo que le sale son códigos. P0401, P2002. Eso le dice lo que ha registrado la centralita, pero no le dice qué está roto.
+A partir de ahí el trabajo lo pone él. Esos dos códigos pueden ser una válvula EGR sucia, o pueden ser un motor que consume aceite y ha ido saturando el filtro de partículas. Son dos reparaciones distintas y decidir cuál es depende de su experiencia.
+Y luego está lo otro: cuando da con el fallo, eso no queda en ninguna parte. Se queda en su cabeza. El siguiente coche con esos mismos códigos igual entra en otro taller, y allí se empieza otra vez desde el código.
 [~45 s]</a:t>
             </a:r>
             <a:endParaRPr lang="en-US" dirty="0"/>
@@ -686,10 +687,9 @@
           <a:p>
             <a:r>
               <a:rPr lang="en-US" dirty="0"/>
-              <a:t>El objetivo de la aplicación es ayudar al mecánico a diagnosticar. A investigar un fallo: qué le pasa al coche, si está bien o está mal, y por dónde seguir mirando.
-Dicho de otra forma: mejorar la visión que tiene del vehículo cuando conecta la herramienta. Eso ya lo hace desde el primer coche.
-Y luego está lo que aporta con el tiempo. Esto está pensado para que se conecten más talleres, se registren más coches, más averías y más diagnósticos. Como todo eso se guarda en una base vectorial, cuando llega un coche nuevo el sistema puede comparar con casos que ya se resolvieron antes y dar una valoración más real. No pasa de un día para otro: lo va haciendo poco a poco.
-[~55 s. Es la promesa de la charla: decirla despacio.]</a:t>
+              <a:t>El objetivo de la aplicación es ayudar al mecánico a diagnosticar. A investigar un fallo: qué le pasa al coche, si está bien o está mal, y por dónde seguir mirando. Dicho de otra forma, mejorar la visión que tiene del vehículo cuando conecta la herramienta. Eso ya lo hace desde el primer coche.
+Y luego está lo que aporta con el tiempo. Esto está pensado para que se conecten más talleres, se registren más coches, más averías y más diagnósticos. Como todo eso se guarda en una base vectorial, cuando llega un coche nuevo el sistema puede comparar con casos que ya se resolvieron y dar una valoración más real. No pasa de un día para otro: lo va haciendo poco a poco.
+[~55 s]</a:t>
             </a:r>
             <a:endParaRPr lang="en-US" dirty="0"/>
           </a:p>
@@ -713,6 +713,97 @@
             <a:fld id="{F7021451-1387-4CA6-816F-3879F97B5CBC}" type="slidenum">
               <a:rPr lang="en-US"/>
               <a:t>3</a:t>
+            </a:fld>
+            <a:endParaRPr lang="en-US"/>
+          </a:p>
+        </p:txBody>
+      </p:sp>
+    </p:spTree>
+    <p:extLst>
+      <p:ext uri="{BB962C8B-B14F-4D97-AF65-F5344CB8AC3E}">
+        <p14:creationId xmlns:p14="http://schemas.microsoft.com/office/powerpoint/2010/main" val="1024086991"/>
+      </p:ext>
+    </p:extLst>
+  </p:cSld>
+  <p:clrMapOvr>
+    <a:masterClrMapping/>
+  </p:clrMapOvr>
+</p:notes>
+</file>
+
+<file path=ppt/notesSlides/notesSlide4.xml><?xml version="1.0" encoding="utf-8"?>
+<p:notes xmlns:a="http://schemas.openxmlformats.org/drawingml/2006/main" xmlns:r="http://schemas.openxmlformats.org/officeDocument/2006/relationships" xmlns:p="http://schemas.openxmlformats.org/presentationml/2006/main">
+  <p:cSld>
+    <p:spTree>
+      <p:nvGrpSpPr>
+        <p:cNvPr id="1" name=""/>
+        <p:cNvGrpSpPr/>
+        <p:nvPr/>
+      </p:nvGrpSpPr>
+      <p:grpSpPr>
+        <a:xfrm>
+          <a:off x="0" y="0"/>
+          <a:ext cx="0" cy="0"/>
+          <a:chOff x="0" y="0"/>
+          <a:chExt cx="0" cy="0"/>
+        </a:xfrm>
+      </p:grpSpPr>
+      <p:sp>
+        <p:nvSpPr>
+          <p:cNvPr id="2" name="Slide Image Placeholder 1"/>
+          <p:cNvSpPr>
+            <a:spLocks noGrp="1" noRot="1" noChangeAspect="1"/>
+          </p:cNvSpPr>
+          <p:nvPr>
+            <p:ph type="sldImg"/>
+          </p:nvPr>
+        </p:nvSpPr>
+        <p:spPr/>
+      </p:sp>
+      <p:sp>
+        <p:nvSpPr>
+          <p:cNvPr id="3" name="Notes Placeholder 2"/>
+          <p:cNvSpPr>
+            <a:spLocks noGrp="1"/>
+          </p:cNvSpPr>
+          <p:nvPr>
+            <p:ph type="body" idx="1"/>
+          </p:nvPr>
+        </p:nvSpPr>
+        <p:spPr/>
+        <p:txBody>
+          <a:bodyPr/>
+          <a:lstStyle/>
+          <a:p>
+            <a:r>
+              <a:rPr lang="en-US" dirty="0"/>
+              <a:t>¿Por qué Clean Architecture y hexagonal? Porque esto es una herramienta que va a seguir evolucionando.
+Ahora mismo funciona con SQLite, porque era lo más rápido para desarrollar el proyecto. Pero en un futuro tendrá que usar PostgreSQL. La gracia de esta arquitectura es que para hacer ese cambio solo se toca la parte de infraestructura, la de persistencia. El dominio y los casos de uso no se enteran.
+Y lo mismo pasa con el resto: si cambio de modelo de lenguaje, si cambio la forma de acceder al coche, o cualquier otra parte de la aplicación. Al final solo se toca una capa.
+[~80 s. Es la slide que más se repregunta: ir despacio.]</a:t>
+            </a:r>
+            <a:endParaRPr lang="en-US" dirty="0"/>
+          </a:p>
+        </p:txBody>
+      </p:sp>
+      <p:sp>
+        <p:nvSpPr>
+          <p:cNvPr id="4" name="Slide Number Placeholder 3"/>
+          <p:cNvSpPr>
+            <a:spLocks noGrp="1"/>
+          </p:cNvSpPr>
+          <p:nvPr>
+            <p:ph type="sldNum" sz="quarter" idx="10"/>
+          </p:nvPr>
+        </p:nvSpPr>
+        <p:spPr/>
+        <p:txBody>
+          <a:bodyPr/>
+          <a:lstStyle/>
+          <a:p>
+            <a:fld id="{F7021451-1387-4CA6-816F-3879F97B5CBC}" type="slidenum">
+              <a:rPr lang="en-US"/>
+              <a:t>4</a:t>
             </a:fld>
             <a:endParaRPr lang="en-US"/>
           </a:p>
@@ -1548,12 +1639,12 @@
         </p:nvSpPr>
         <p:spPr>
           <a:xfrm>
-            <a:off x="685800" y="2057400"/>
-            <a:ext cx="3383280" cy="2880360"/>
+            <a:off x="685800" y="2331720"/>
+            <a:ext cx="3383280" cy="2194560"/>
           </a:xfrm>
           <a:prstGeom prst="roundRect">
             <a:avLst>
-              <a:gd name="adj" fmla="val 3175"/>
+              <a:gd name="adj" fmla="val 4167"/>
             </a:avLst>
           </a:prstGeom>
           <a:solidFill>
@@ -1570,7 +1661,7 @@
         </p:nvSpPr>
         <p:spPr>
           <a:xfrm>
-            <a:off x="978408" y="2350008"/>
+            <a:off x="1005840" y="2651760"/>
             <a:ext cx="384048" cy="384048"/>
           </a:xfrm>
           <a:prstGeom prst="ellipse">
@@ -1590,7 +1681,7 @@
         </p:nvSpPr>
         <p:spPr>
           <a:xfrm>
-            <a:off x="978408" y="2350008"/>
+            <a:off x="1005840" y="2651760"/>
             <a:ext cx="384048" cy="384048"/>
           </a:xfrm>
           <a:prstGeom prst="rect">
@@ -1629,8 +1720,8 @@
         </p:nvSpPr>
         <p:spPr>
           <a:xfrm>
-            <a:off x="978408" y="2926080"/>
-            <a:ext cx="2798064" cy="566928"/>
+            <a:off x="1005840" y="3246120"/>
+            <a:ext cx="2743200" cy="365760"/>
           </a:xfrm>
           <a:prstGeom prst="rect">
             <a:avLst/>
@@ -1646,7 +1737,7 @@
               <a:buNone/>
             </a:pPr>
             <a:r>
-              <a:rPr lang="en-US" sz="1300" b="1" dirty="0">
+              <a:rPr lang="en-US" sz="1700" b="1" dirty="0">
                 <a:solidFill>
                   <a:srgbClr val="1A1C2E"/>
                 </a:solidFill>
@@ -1654,9 +1745,9 @@
                 <a:ea typeface="Arial" pitchFamily="34" charset="-122"/>
                 <a:cs typeface="Arial" pitchFamily="34" charset="-120"/>
               </a:rPr>
-              <a:t>Conecta el escáner y salen códigos</a:t>
-            </a:r>
-            <a:endParaRPr lang="en-US" sz="1300" dirty="0"/>
+              <a:t>Salen códigos</a:t>
+            </a:r>
+            <a:endParaRPr lang="en-US" sz="1700" dirty="0"/>
           </a:p>
         </p:txBody>
       </p:sp>
@@ -1668,8 +1759,8 @@
         </p:nvSpPr>
         <p:spPr>
           <a:xfrm>
-            <a:off x="978408" y="3538728"/>
-            <a:ext cx="2798064" cy="1234440"/>
+            <a:off x="1005840" y="3703320"/>
+            <a:ext cx="2743200" cy="685800"/>
           </a:xfrm>
           <a:prstGeom prst="rect">
             <a:avLst/>
@@ -1683,12 +1774,12 @@
           <a:p>
             <a:pPr indent="0" marL="0">
               <a:lnSpc>
-                <a:spcPts val="1700"/>
+                <a:spcPts val="1900"/>
               </a:lnSpc>
               <a:buNone/>
             </a:pPr>
             <a:r>
-              <a:rPr lang="en-US" sz="1200" dirty="0">
+              <a:rPr lang="en-US" sz="1300" dirty="0">
                 <a:solidFill>
                   <a:srgbClr val="5A5F73"/>
                 </a:solidFill>
@@ -1696,9 +1787,29 @@
                 <a:ea typeface="Calibri" pitchFamily="34" charset="-122"/>
                 <a:cs typeface="Calibri" pitchFamily="34" charset="-120"/>
               </a:rPr>
-              <a:t>P0401, P2002. Le dicen qué ha registrado la centralita, pero no qué está roto ni por dónde empezar a mirar.</a:t>
-            </a:r>
-            <a:endParaRPr lang="en-US" sz="1200" dirty="0"/>
+              <a:t>P0401, P2002.</a:t>
+            </a:r>
+            <a:endParaRPr lang="en-US" sz="1300" dirty="0"/>
+          </a:p>
+          <a:p>
+            <a:pPr indent="0" marL="0">
+              <a:lnSpc>
+                <a:spcPts val="1900"/>
+              </a:lnSpc>
+              <a:buNone/>
+            </a:pPr>
+            <a:r>
+              <a:rPr lang="en-US" sz="1300" dirty="0">
+                <a:solidFill>
+                  <a:srgbClr val="5A5F73"/>
+                </a:solidFill>
+                <a:latin typeface="Calibri" pitchFamily="34" charset="0"/>
+                <a:ea typeface="Calibri" pitchFamily="34" charset="-122"/>
+                <a:cs typeface="Calibri" pitchFamily="34" charset="-120"/>
+              </a:rPr>
+              <a:t>Lo que ha registrado la centralita.</a:t>
+            </a:r>
+            <a:endParaRPr lang="en-US" sz="1300" dirty="0"/>
           </a:p>
         </p:txBody>
       </p:sp>
@@ -1710,12 +1821,12 @@
         </p:nvSpPr>
         <p:spPr>
           <a:xfrm>
-            <a:off x="4389120" y="2057400"/>
-            <a:ext cx="3383280" cy="2880360"/>
+            <a:off x="4389120" y="2331720"/>
+            <a:ext cx="3383280" cy="2194560"/>
           </a:xfrm>
           <a:prstGeom prst="roundRect">
             <a:avLst>
-              <a:gd name="adj" fmla="val 3175"/>
+              <a:gd name="adj" fmla="val 4167"/>
             </a:avLst>
           </a:prstGeom>
           <a:solidFill>
@@ -1732,7 +1843,7 @@
         </p:nvSpPr>
         <p:spPr>
           <a:xfrm>
-            <a:off x="4681728" y="2350008"/>
+            <a:off x="4709160" y="2651760"/>
             <a:ext cx="384048" cy="384048"/>
           </a:xfrm>
           <a:prstGeom prst="ellipse">
@@ -1752,7 +1863,7 @@
         </p:nvSpPr>
         <p:spPr>
           <a:xfrm>
-            <a:off x="4681728" y="2350008"/>
+            <a:off x="4709160" y="2651760"/>
             <a:ext cx="384048" cy="384048"/>
           </a:xfrm>
           <a:prstGeom prst="rect">
@@ -1791,8 +1902,8 @@
         </p:nvSpPr>
         <p:spPr>
           <a:xfrm>
-            <a:off x="4681728" y="2926080"/>
-            <a:ext cx="2798064" cy="566928"/>
+            <a:off x="4709160" y="3246120"/>
+            <a:ext cx="2743200" cy="365760"/>
           </a:xfrm>
           <a:prstGeom prst="rect">
             <a:avLst/>
@@ -1808,7 +1919,7 @@
               <a:buNone/>
             </a:pPr>
             <a:r>
-              <a:rPr lang="en-US" sz="1300" b="1" dirty="0">
+              <a:rPr lang="en-US" sz="1700" b="1" dirty="0">
                 <a:solidFill>
                   <a:srgbClr val="1A1C2E"/>
                 </a:solidFill>
@@ -1816,9 +1927,9 @@
                 <a:ea typeface="Arial" pitchFamily="34" charset="-122"/>
                 <a:cs typeface="Arial" pitchFamily="34" charset="-120"/>
               </a:rPr>
-              <a:t>El resto lo pone él</a:t>
-            </a:r>
-            <a:endParaRPr lang="en-US" sz="1300" dirty="0"/>
+              <a:t>Pero no la avería</a:t>
+            </a:r>
+            <a:endParaRPr lang="en-US" sz="1700" dirty="0"/>
           </a:p>
         </p:txBody>
       </p:sp>
@@ -1830,8 +1941,8 @@
         </p:nvSpPr>
         <p:spPr>
           <a:xfrm>
-            <a:off x="4681728" y="3538728"/>
-            <a:ext cx="2798064" cy="1234440"/>
+            <a:off x="4709160" y="3703320"/>
+            <a:ext cx="2743200" cy="685800"/>
           </a:xfrm>
           <a:prstGeom prst="rect">
             <a:avLst/>
@@ -1845,12 +1956,12 @@
           <a:p>
             <a:pPr indent="0" marL="0">
               <a:lnSpc>
-                <a:spcPts val="1700"/>
+                <a:spcPts val="1900"/>
               </a:lnSpc>
               <a:buNone/>
             </a:pPr>
             <a:r>
-              <a:rPr lang="en-US" sz="1200" dirty="0">
+              <a:rPr lang="en-US" sz="1300" dirty="0">
                 <a:solidFill>
                   <a:srgbClr val="5A5F73"/>
                 </a:solidFill>
@@ -1858,9 +1969,29 @@
                 <a:ea typeface="Calibri" pitchFamily="34" charset="-122"/>
                 <a:cs typeface="Calibri" pitchFamily="34" charset="-120"/>
               </a:rPr>
-              <a:t>Con esos códigos tiene que decidir si es la válvula EGR, si el coche consume aceite y ha saturado el filtro, o si hay que mirar otra cosa. Eso depende de su experiencia.</a:t>
-            </a:r>
-            <a:endParaRPr lang="en-US" sz="1200" dirty="0"/>
+              <a:t>¿EGR sucia? ¿Consume aceite?</a:t>
+            </a:r>
+            <a:endParaRPr lang="en-US" sz="1300" dirty="0"/>
+          </a:p>
+          <a:p>
+            <a:pPr indent="0" marL="0">
+              <a:lnSpc>
+                <a:spcPts val="1900"/>
+              </a:lnSpc>
+              <a:buNone/>
+            </a:pPr>
+            <a:r>
+              <a:rPr lang="en-US" sz="1300" dirty="0">
+                <a:solidFill>
+                  <a:srgbClr val="5A5F73"/>
+                </a:solidFill>
+                <a:latin typeface="Calibri" pitchFamily="34" charset="0"/>
+                <a:ea typeface="Calibri" pitchFamily="34" charset="-122"/>
+                <a:cs typeface="Calibri" pitchFamily="34" charset="-120"/>
+              </a:rPr>
+              <a:t>Lo decide su experiencia.</a:t>
+            </a:r>
+            <a:endParaRPr lang="en-US" sz="1300" dirty="0"/>
           </a:p>
         </p:txBody>
       </p:sp>
@@ -1872,12 +2003,12 @@
         </p:nvSpPr>
         <p:spPr>
           <a:xfrm>
-            <a:off x="8092440" y="2057400"/>
-            <a:ext cx="3383280" cy="2880360"/>
+            <a:off x="8092440" y="2331720"/>
+            <a:ext cx="3383280" cy="2194560"/>
           </a:xfrm>
           <a:prstGeom prst="roundRect">
             <a:avLst>
-              <a:gd name="adj" fmla="val 3175"/>
+              <a:gd name="adj" fmla="val 4167"/>
             </a:avLst>
           </a:prstGeom>
           <a:solidFill>
@@ -1894,7 +2025,7 @@
         </p:nvSpPr>
         <p:spPr>
           <a:xfrm>
-            <a:off x="8385048" y="2350008"/>
+            <a:off x="8412480" y="2651760"/>
             <a:ext cx="384048" cy="384048"/>
           </a:xfrm>
           <a:prstGeom prst="ellipse">
@@ -1914,7 +2045,7 @@
         </p:nvSpPr>
         <p:spPr>
           <a:xfrm>
-            <a:off x="8385048" y="2350008"/>
+            <a:off x="8412480" y="2651760"/>
             <a:ext cx="384048" cy="384048"/>
           </a:xfrm>
           <a:prstGeom prst="rect">
@@ -1953,8 +2084,8 @@
         </p:nvSpPr>
         <p:spPr>
           <a:xfrm>
-            <a:off x="8385048" y="2926080"/>
-            <a:ext cx="2798064" cy="566928"/>
+            <a:off x="8412480" y="3246120"/>
+            <a:ext cx="2743200" cy="365760"/>
           </a:xfrm>
           <a:prstGeom prst="rect">
             <a:avLst/>
@@ -1970,7 +2101,7 @@
               <a:buNone/>
             </a:pPr>
             <a:r>
-              <a:rPr lang="en-US" sz="1300" b="1" dirty="0">
+              <a:rPr lang="en-US" sz="1700" b="1" dirty="0">
                 <a:solidFill>
                   <a:srgbClr val="1A1C2E"/>
                 </a:solidFill>
@@ -1978,9 +2109,9 @@
                 <a:ea typeface="Arial" pitchFamily="34" charset="-122"/>
                 <a:cs typeface="Arial" pitchFamily="34" charset="-120"/>
               </a:rPr>
-              <a:t>Y lo que averigua no queda en ningún sitio</a:t>
-            </a:r>
-            <a:endParaRPr lang="en-US" sz="1300" dirty="0"/>
+              <a:t>Y no queda registrado</a:t>
+            </a:r>
+            <a:endParaRPr lang="en-US" sz="1700" dirty="0"/>
           </a:p>
         </p:txBody>
       </p:sp>
@@ -1992,8 +2123,8 @@
         </p:nvSpPr>
         <p:spPr>
           <a:xfrm>
-            <a:off x="8385048" y="3538728"/>
-            <a:ext cx="2798064" cy="1234440"/>
+            <a:off x="8412480" y="3703320"/>
+            <a:ext cx="2743200" cy="685800"/>
           </a:xfrm>
           <a:prstGeom prst="rect">
             <a:avLst/>
@@ -2007,12 +2138,12 @@
           <a:p>
             <a:pPr indent="0" marL="0">
               <a:lnSpc>
-                <a:spcPts val="1700"/>
+                <a:spcPts val="1900"/>
               </a:lnSpc>
               <a:buNone/>
             </a:pPr>
             <a:r>
-              <a:rPr lang="en-US" sz="1200" dirty="0">
+              <a:rPr lang="en-US" sz="1300" dirty="0">
                 <a:solidFill>
                   <a:srgbClr val="5A5F73"/>
                 </a:solidFill>
@@ -2020,9 +2151,29 @@
                 <a:ea typeface="Calibri" pitchFamily="34" charset="-122"/>
                 <a:cs typeface="Calibri" pitchFamily="34" charset="-120"/>
               </a:rPr>
-              <a:t>Si acierta, lo sabe él. El siguiente coche con esos mismos códigos igual entra en otro taller, y allí se empieza otra vez desde el código.</a:t>
-            </a:r>
-            <a:endParaRPr lang="en-US" sz="1200" dirty="0"/>
+              <a:t>El siguiente coche</a:t>
+            </a:r>
+            <a:endParaRPr lang="en-US" sz="1300" dirty="0"/>
+          </a:p>
+          <a:p>
+            <a:pPr indent="0" marL="0">
+              <a:lnSpc>
+                <a:spcPts val="1900"/>
+              </a:lnSpc>
+              <a:buNone/>
+            </a:pPr>
+            <a:r>
+              <a:rPr lang="en-US" sz="1300" dirty="0">
+                <a:solidFill>
+                  <a:srgbClr val="5A5F73"/>
+                </a:solidFill>
+                <a:latin typeface="Calibri" pitchFamily="34" charset="0"/>
+                <a:ea typeface="Calibri" pitchFamily="34" charset="-122"/>
+                <a:cs typeface="Calibri" pitchFamily="34" charset="-120"/>
+              </a:rPr>
+              <a:t>empieza otra vez desde el código.</a:t>
+            </a:r>
+            <a:endParaRPr lang="en-US" sz="1300" dirty="0"/>
           </a:p>
         </p:txBody>
       </p:sp>
@@ -2034,8 +2185,8 @@
         </p:nvSpPr>
         <p:spPr>
           <a:xfrm>
-            <a:off x="777240" y="5440680"/>
-            <a:ext cx="10607040" cy="457200"/>
+            <a:off x="777240" y="5074920"/>
+            <a:ext cx="10607040" cy="411480"/>
           </a:xfrm>
           <a:prstGeom prst="rect">
             <a:avLst/>
@@ -2051,7 +2202,7 @@
               <a:buNone/>
             </a:pPr>
             <a:r>
-              <a:rPr lang="en-US" sz="1700" b="1" dirty="0">
+              <a:rPr lang="en-US" sz="1800" b="1" dirty="0">
                 <a:solidFill>
                   <a:srgbClr val="1A1C2E"/>
                 </a:solidFill>
@@ -2059,23 +2210,9 @@
                 <a:ea typeface="Arial" pitchFamily="34" charset="-122"/>
                 <a:cs typeface="Arial" pitchFamily="34" charset="-120"/>
               </a:rPr>
-              <a:t>El código es igual para todos. Lo que cambia es </a:t>
-            </a:r>
-            <a:pPr indent="0" marL="0">
-              <a:buNone/>
-            </a:pPr>
-            <a:r>
-              <a:rPr lang="en-US" sz="1700" b="1" dirty="0">
-                <a:solidFill>
-                  <a:srgbClr val="202CFC"/>
-                </a:solidFill>
-                <a:latin typeface="Arial" pitchFamily="34" charset="0"/>
-                <a:ea typeface="Arial" pitchFamily="34" charset="-122"/>
-                <a:cs typeface="Arial" pitchFamily="34" charset="-120"/>
-              </a:rPr>
-              <a:t>lo que cada mecánico sabe hacer con él.</a:t>
-            </a:r>
-            <a:endParaRPr lang="en-US" sz="1700" dirty="0"/>
+              <a:t>Lo que sabe el mecánico no se guarda en ningún sitio.</a:t>
+            </a:r>
+            <a:endParaRPr lang="en-US" sz="1800" dirty="0"/>
           </a:p>
         </p:txBody>
       </p:sp>
@@ -2328,57 +2465,829 @@
       </p:sp>
       <p:sp>
         <p:nvSpPr>
-          <p:cNvPr id="4" name="Text 2"/>
-          <p:cNvSpPr/>
-          <p:nvPr/>
-        </p:nvSpPr>
-        <p:spPr>
-          <a:xfrm>
-            <a:off x="777240" y="1965960"/>
-            <a:ext cx="10607040" cy="365760"/>
-          </a:xfrm>
-          <a:prstGeom prst="rect">
-            <a:avLst/>
-          </a:prstGeom>
-          <a:noFill/>
-          <a:ln/>
-        </p:spPr>
-        <p:txBody>
-          <a:bodyPr wrap="square" lIns="0" tIns="0" rIns="0" bIns="0" rtlCol="0" anchor="t"/>
+          <p:cNvPr id="4" name="Shape 2"/>
+          <p:cNvSpPr/>
+          <p:nvPr/>
+        </p:nvSpPr>
+        <p:spPr>
+          <a:xfrm>
+            <a:off x="777240" y="2377440"/>
+            <a:ext cx="5074920" cy="2286000"/>
+          </a:xfrm>
+          <a:prstGeom prst="roundRect">
+            <a:avLst>
+              <a:gd name="adj" fmla="val 3200"/>
+            </a:avLst>
+          </a:prstGeom>
+          <a:solidFill>
+            <a:srgbClr val="F3F4F9"/>
+          </a:solidFill>
+          <a:ln/>
+        </p:spPr>
+      </p:sp>
+      <p:sp>
+        <p:nvSpPr>
+          <p:cNvPr id="5" name="Text 3"/>
+          <p:cNvSpPr/>
+          <p:nvPr/>
+        </p:nvSpPr>
+        <p:spPr>
+          <a:xfrm>
+            <a:off x="1188720" y="2788920"/>
+            <a:ext cx="4251960" cy="274320"/>
+          </a:xfrm>
+          <a:prstGeom prst="rect">
+            <a:avLst/>
+          </a:prstGeom>
+          <a:noFill/>
+          <a:ln/>
+        </p:spPr>
+        <p:txBody>
+          <a:bodyPr wrap="square" lIns="0" tIns="0" rIns="0" bIns="0" rtlCol="0" anchor="ctr"/>
           <a:lstStyle/>
           <a:p>
             <a:pPr indent="0" marL="0">
               <a:buNone/>
             </a:pPr>
             <a:r>
-              <a:rPr lang="en-US" sz="1600" dirty="0">
-                <a:solidFill>
-                  <a:srgbClr val="5A5F73"/>
+              <a:rPr lang="en-US" sz="1100" b="1" spc="200" kern="0" dirty="0">
+                <a:solidFill>
+                  <a:srgbClr val="202CFC"/>
                 </a:solidFill>
                 <a:latin typeface="Calibri" pitchFamily="34" charset="0"/>
                 <a:ea typeface="Calibri" pitchFamily="34" charset="-122"/>
                 <a:cs typeface="Calibri" pitchFamily="34" charset="-120"/>
               </a:rPr>
-              <a:t>Ayudarle a investigar un fallo: qué le pasa al vehículo, si está bien o está mal, y por dónde seguir mirando.</a:t>
-            </a:r>
-            <a:endParaRPr lang="en-US" sz="1600" dirty="0"/>
-          </a:p>
-        </p:txBody>
-      </p:sp>
-      <p:sp>
-        <p:nvSpPr>
-          <p:cNvPr id="5" name="Shape 3"/>
-          <p:cNvSpPr/>
-          <p:nvPr/>
-        </p:nvSpPr>
-        <p:spPr>
-          <a:xfrm>
-            <a:off x="777240" y="2697480"/>
-            <a:ext cx="5074920" cy="2697480"/>
+              <a:t>DESDE EL PRIMER COCHE</a:t>
+            </a:r>
+            <a:endParaRPr lang="en-US" sz="1100" dirty="0"/>
+          </a:p>
+        </p:txBody>
+      </p:sp>
+      <p:sp>
+        <p:nvSpPr>
+          <p:cNvPr id="6" name="Text 4"/>
+          <p:cNvSpPr/>
+          <p:nvPr/>
+        </p:nvSpPr>
+        <p:spPr>
+          <a:xfrm>
+            <a:off x="1188720" y="3200400"/>
+            <a:ext cx="4251960" cy="411480"/>
+          </a:xfrm>
+          <a:prstGeom prst="rect">
+            <a:avLst/>
+          </a:prstGeom>
+          <a:noFill/>
+          <a:ln/>
+        </p:spPr>
+        <p:txBody>
+          <a:bodyPr wrap="square" lIns="0" tIns="0" rIns="0" bIns="0" rtlCol="0" anchor="t"/>
+          <a:lstStyle/>
+          <a:p>
+            <a:pPr indent="0" marL="0">
+              <a:buNone/>
+            </a:pPr>
+            <a:r>
+              <a:rPr lang="en-US" sz="2000" b="1" dirty="0">
+                <a:solidFill>
+                  <a:srgbClr val="1A1C2E"/>
+                </a:solidFill>
+                <a:latin typeface="Arial" pitchFamily="34" charset="0"/>
+                <a:ea typeface="Arial" pitchFamily="34" charset="-122"/>
+                <a:cs typeface="Arial" pitchFamily="34" charset="-120"/>
+              </a:rPr>
+              <a:t>Le ayuda a investigar el fallo</a:t>
+            </a:r>
+            <a:endParaRPr lang="en-US" sz="2000" dirty="0"/>
+          </a:p>
+        </p:txBody>
+      </p:sp>
+      <p:sp>
+        <p:nvSpPr>
+          <p:cNvPr id="7" name="Text 5"/>
+          <p:cNvSpPr/>
+          <p:nvPr/>
+        </p:nvSpPr>
+        <p:spPr>
+          <a:xfrm>
+            <a:off x="1188720" y="3749040"/>
+            <a:ext cx="4251960" cy="731520"/>
+          </a:xfrm>
+          <a:prstGeom prst="rect">
+            <a:avLst/>
+          </a:prstGeom>
+          <a:noFill/>
+          <a:ln/>
+        </p:spPr>
+        <p:txBody>
+          <a:bodyPr wrap="square" lIns="0" tIns="0" rIns="0" bIns="0" rtlCol="0" anchor="t"/>
+          <a:lstStyle/>
+          <a:p>
+            <a:pPr indent="0" marL="0">
+              <a:lnSpc>
+                <a:spcPts val="2100"/>
+              </a:lnSpc>
+              <a:buNone/>
+            </a:pPr>
+            <a:r>
+              <a:rPr lang="en-US" sz="1400" dirty="0">
+                <a:solidFill>
+                  <a:srgbClr val="5A5F73"/>
+                </a:solidFill>
+                <a:latin typeface="Calibri" pitchFamily="34" charset="0"/>
+                <a:ea typeface="Calibri" pitchFamily="34" charset="-122"/>
+                <a:cs typeface="Calibri" pitchFamily="34" charset="-120"/>
+              </a:rPr>
+              <a:t>Qué le pasa al coche, si está bien o mal,</a:t>
+            </a:r>
+            <a:endParaRPr lang="en-US" sz="1400" dirty="0"/>
+          </a:p>
+          <a:p>
+            <a:pPr indent="0" marL="0">
+              <a:lnSpc>
+                <a:spcPts val="2100"/>
+              </a:lnSpc>
+              <a:buNone/>
+            </a:pPr>
+            <a:r>
+              <a:rPr lang="en-US" sz="1400" dirty="0">
+                <a:solidFill>
+                  <a:srgbClr val="5A5F73"/>
+                </a:solidFill>
+                <a:latin typeface="Calibri" pitchFamily="34" charset="0"/>
+                <a:ea typeface="Calibri" pitchFamily="34" charset="-122"/>
+                <a:cs typeface="Calibri" pitchFamily="34" charset="-120"/>
+              </a:rPr>
+              <a:t>y por dónde seguir mirando.</a:t>
+            </a:r>
+            <a:endParaRPr lang="en-US" sz="1400" dirty="0"/>
+          </a:p>
+        </p:txBody>
+      </p:sp>
+      <p:sp>
+        <p:nvSpPr>
+          <p:cNvPr id="8" name="Shape 6"/>
+          <p:cNvSpPr/>
+          <p:nvPr/>
+        </p:nvSpPr>
+        <p:spPr>
+          <a:xfrm>
+            <a:off x="6309360" y="2377440"/>
+            <a:ext cx="5074920" cy="2286000"/>
           </a:xfrm>
           <a:prstGeom prst="roundRect">
             <a:avLst>
-              <a:gd name="adj" fmla="val 2712"/>
+              <a:gd name="adj" fmla="val 3200"/>
+            </a:avLst>
+          </a:prstGeom>
+          <a:solidFill>
+            <a:srgbClr val="1A1C2E"/>
+          </a:solidFill>
+          <a:ln/>
+        </p:spPr>
+      </p:sp>
+      <p:sp>
+        <p:nvSpPr>
+          <p:cNvPr id="9" name="Text 7"/>
+          <p:cNvSpPr/>
+          <p:nvPr/>
+        </p:nvSpPr>
+        <p:spPr>
+          <a:xfrm>
+            <a:off x="6720840" y="2788920"/>
+            <a:ext cx="4251960" cy="274320"/>
+          </a:xfrm>
+          <a:prstGeom prst="rect">
+            <a:avLst/>
+          </a:prstGeom>
+          <a:noFill/>
+          <a:ln/>
+        </p:spPr>
+        <p:txBody>
+          <a:bodyPr wrap="square" lIns="0" tIns="0" rIns="0" bIns="0" rtlCol="0" anchor="ctr"/>
+          <a:lstStyle/>
+          <a:p>
+            <a:pPr indent="0" marL="0">
+              <a:buNone/>
+            </a:pPr>
+            <a:r>
+              <a:rPr lang="en-US" sz="1100" b="1" spc="200" kern="0" dirty="0">
+                <a:solidFill>
+                  <a:srgbClr val="8A93FF"/>
+                </a:solidFill>
+                <a:latin typeface="Calibri" pitchFamily="34" charset="0"/>
+                <a:ea typeface="Calibri" pitchFamily="34" charset="-122"/>
+                <a:cs typeface="Calibri" pitchFamily="34" charset="-120"/>
+              </a:rPr>
+              <a:t>SEGÚN SE CONECTEN MÁS TALLERES</a:t>
+            </a:r>
+            <a:endParaRPr lang="en-US" sz="1100" dirty="0"/>
+          </a:p>
+        </p:txBody>
+      </p:sp>
+      <p:sp>
+        <p:nvSpPr>
+          <p:cNvPr id="10" name="Text 8"/>
+          <p:cNvSpPr/>
+          <p:nvPr/>
+        </p:nvSpPr>
+        <p:spPr>
+          <a:xfrm>
+            <a:off x="6720840" y="3200400"/>
+            <a:ext cx="4251960" cy="411480"/>
+          </a:xfrm>
+          <a:prstGeom prst="rect">
+            <a:avLst/>
+          </a:prstGeom>
+          <a:noFill/>
+          <a:ln/>
+        </p:spPr>
+        <p:txBody>
+          <a:bodyPr wrap="square" lIns="0" tIns="0" rIns="0" bIns="0" rtlCol="0" anchor="t"/>
+          <a:lstStyle/>
+          <a:p>
+            <a:pPr indent="0" marL="0">
+              <a:buNone/>
+            </a:pPr>
+            <a:r>
+              <a:rPr lang="en-US" sz="2000" b="1" dirty="0">
+                <a:solidFill>
+                  <a:srgbClr val="FFFFFF"/>
+                </a:solidFill>
+                <a:latin typeface="Arial" pitchFamily="34" charset="0"/>
+                <a:ea typeface="Arial" pitchFamily="34" charset="-122"/>
+                <a:cs typeface="Arial" pitchFamily="34" charset="-120"/>
+              </a:rPr>
+              <a:t>Y va mejorando con el uso</a:t>
+            </a:r>
+            <a:endParaRPr lang="en-US" sz="2000" dirty="0"/>
+          </a:p>
+        </p:txBody>
+      </p:sp>
+      <p:sp>
+        <p:nvSpPr>
+          <p:cNvPr id="11" name="Text 9"/>
+          <p:cNvSpPr/>
+          <p:nvPr/>
+        </p:nvSpPr>
+        <p:spPr>
+          <a:xfrm>
+            <a:off x="6720840" y="3749040"/>
+            <a:ext cx="4251960" cy="731520"/>
+          </a:xfrm>
+          <a:prstGeom prst="rect">
+            <a:avLst/>
+          </a:prstGeom>
+          <a:noFill/>
+          <a:ln/>
+        </p:spPr>
+        <p:txBody>
+          <a:bodyPr wrap="square" lIns="0" tIns="0" rIns="0" bIns="0" rtlCol="0" anchor="t"/>
+          <a:lstStyle/>
+          <a:p>
+            <a:pPr indent="0" marL="0">
+              <a:lnSpc>
+                <a:spcPts val="2100"/>
+              </a:lnSpc>
+              <a:buNone/>
+            </a:pPr>
+            <a:r>
+              <a:rPr lang="en-US" sz="1400" dirty="0">
+                <a:solidFill>
+                  <a:srgbClr val="B8BCCC"/>
+                </a:solidFill>
+                <a:latin typeface="Calibri" pitchFamily="34" charset="0"/>
+                <a:ea typeface="Calibri" pitchFamily="34" charset="-122"/>
+                <a:cs typeface="Calibri" pitchFamily="34" charset="-120"/>
+              </a:rPr>
+              <a:t>Cada diagnóstico se guarda.</a:t>
+            </a:r>
+            <a:endParaRPr lang="en-US" sz="1400" dirty="0"/>
+          </a:p>
+          <a:p>
+            <a:pPr indent="0" marL="0">
+              <a:lnSpc>
+                <a:spcPts val="2100"/>
+              </a:lnSpc>
+              <a:buNone/>
+            </a:pPr>
+            <a:r>
+              <a:rPr lang="en-US" sz="1400" dirty="0">
+                <a:solidFill>
+                  <a:srgbClr val="B8BCCC"/>
+                </a:solidFill>
+                <a:latin typeface="Calibri" pitchFamily="34" charset="0"/>
+                <a:ea typeface="Calibri" pitchFamily="34" charset="-122"/>
+                <a:cs typeface="Calibri" pitchFamily="34" charset="-120"/>
+              </a:rPr>
+              <a:t>Más casos reales con los que comparar.</a:t>
+            </a:r>
+            <a:endParaRPr lang="en-US" sz="1400" dirty="0"/>
+          </a:p>
+        </p:txBody>
+      </p:sp>
+      <p:sp>
+        <p:nvSpPr>
+          <p:cNvPr id="12" name="Shape 10"/>
+          <p:cNvSpPr/>
+          <p:nvPr/>
+        </p:nvSpPr>
+        <p:spPr>
+          <a:xfrm>
+            <a:off x="777240" y="6263640"/>
+            <a:ext cx="219456" cy="219456"/>
+          </a:xfrm>
+          <a:prstGeom prst="rect">
+            <a:avLst/>
+          </a:prstGeom>
+          <a:solidFill>
+            <a:srgbClr val="202CFC"/>
+          </a:solidFill>
+          <a:ln/>
+        </p:spPr>
+      </p:sp>
+      <p:sp>
+        <p:nvSpPr>
+          <p:cNvPr id="13" name="Text 11"/>
+          <p:cNvSpPr/>
+          <p:nvPr/>
+        </p:nvSpPr>
+        <p:spPr>
+          <a:xfrm>
+            <a:off x="777240" y="6263640"/>
+            <a:ext cx="219456" cy="219456"/>
+          </a:xfrm>
+          <a:prstGeom prst="rect">
+            <a:avLst/>
+          </a:prstGeom>
+          <a:noFill/>
+          <a:ln/>
+        </p:spPr>
+        <p:txBody>
+          <a:bodyPr wrap="square" lIns="0" tIns="0" rIns="0" bIns="0" rtlCol="0" anchor="ctr"/>
+          <a:lstStyle/>
+          <a:p>
+            <a:pPr algn="ctr" indent="0" marL="0">
+              <a:buNone/>
+            </a:pPr>
+            <a:r>
+              <a:rPr lang="en-US" sz="816" b="1" dirty="0">
+                <a:solidFill>
+                  <a:srgbClr val="FFFFFF"/>
+                </a:solidFill>
+                <a:latin typeface="Arial" pitchFamily="34" charset="0"/>
+                <a:ea typeface="Arial" pitchFamily="34" charset="-122"/>
+                <a:cs typeface="Arial" pitchFamily="34" charset="-120"/>
+              </a:rPr>
+              <a:t>BIG</a:t>
+            </a:r>
+            <a:endParaRPr lang="en-US" sz="816" dirty="0"/>
+          </a:p>
+        </p:txBody>
+      </p:sp>
+      <p:sp>
+        <p:nvSpPr>
+          <p:cNvPr id="14" name="Text 12"/>
+          <p:cNvSpPr/>
+          <p:nvPr/>
+        </p:nvSpPr>
+        <p:spPr>
+          <a:xfrm>
+            <a:off x="1078992" y="6263640"/>
+            <a:ext cx="658368" cy="219456"/>
+          </a:xfrm>
+          <a:prstGeom prst="rect">
+            <a:avLst/>
+          </a:prstGeom>
+          <a:noFill/>
+          <a:ln/>
+        </p:spPr>
+        <p:txBody>
+          <a:bodyPr wrap="square" lIns="0" tIns="0" rIns="0" bIns="0" rtlCol="0" anchor="ctr"/>
+          <a:lstStyle/>
+          <a:p>
+            <a:pPr algn="l" indent="0" marL="0">
+              <a:buNone/>
+            </a:pPr>
+            <a:r>
+              <a:rPr lang="en-US" sz="816" dirty="0">
+                <a:solidFill>
+                  <a:srgbClr val="1A1C2E"/>
+                </a:solidFill>
+                <a:latin typeface="Arial" pitchFamily="34" charset="0"/>
+                <a:ea typeface="Arial" pitchFamily="34" charset="-122"/>
+                <a:cs typeface="Arial" pitchFamily="34" charset="-120"/>
+              </a:rPr>
+              <a:t>school</a:t>
+            </a:r>
+            <a:endParaRPr lang="en-US" sz="816" dirty="0"/>
+          </a:p>
+        </p:txBody>
+      </p:sp>
+      <p:sp>
+        <p:nvSpPr>
+          <p:cNvPr id="15" name="Text 13"/>
+          <p:cNvSpPr/>
+          <p:nvPr/>
+        </p:nvSpPr>
+        <p:spPr>
+          <a:xfrm>
+            <a:off x="11064240" y="6263640"/>
+            <a:ext cx="320040" cy="219456"/>
+          </a:xfrm>
+          <a:prstGeom prst="rect">
+            <a:avLst/>
+          </a:prstGeom>
+          <a:noFill/>
+          <a:ln/>
+        </p:spPr>
+        <p:txBody>
+          <a:bodyPr wrap="square" lIns="0" tIns="0" rIns="0" bIns="0" rtlCol="0" anchor="ctr"/>
+          <a:lstStyle/>
+          <a:p>
+            <a:pPr algn="r" indent="0" marL="0">
+              <a:buNone/>
+            </a:pPr>
+            <a:r>
+              <a:rPr lang="en-US" sz="1000" dirty="0">
+                <a:solidFill>
+                  <a:srgbClr val="5A5F73"/>
+                </a:solidFill>
+                <a:latin typeface="Calibri" pitchFamily="34" charset="0"/>
+                <a:ea typeface="Calibri" pitchFamily="34" charset="-122"/>
+                <a:cs typeface="Calibri" pitchFamily="34" charset="-120"/>
+              </a:rPr>
+              <a:t>3</a:t>
+            </a:r>
+            <a:endParaRPr lang="en-US" sz="1000" dirty="0"/>
+          </a:p>
+        </p:txBody>
+      </p:sp>
+    </p:spTree>
+  </p:cSld>
+  <p:clrMapOvr>
+    <a:masterClrMapping/>
+  </p:clrMapOvr>
+</p:sld>
+</file>
+
+<file path=ppt/slides/slide4.xml><?xml version="1.0" encoding="utf-8"?>
+<p:sld xmlns:a="http://schemas.openxmlformats.org/drawingml/2006/main" xmlns:r="http://schemas.openxmlformats.org/officeDocument/2006/relationships" xmlns:p="http://schemas.openxmlformats.org/presentationml/2006/main">
+  <p:cSld name="Slide 4">
+    <p:bg>
+      <p:bgPr>
+        <a:solidFill>
+          <a:srgbClr val="FFFFFF"/>
+        </a:solidFill>
+      </p:bgPr>
+    </p:bg>
+    <p:spTree>
+      <p:nvGrpSpPr>
+        <p:cNvPr id="1" name=""/>
+        <p:cNvGrpSpPr/>
+        <p:nvPr/>
+      </p:nvGrpSpPr>
+      <p:grpSpPr>
+        <a:xfrm>
+          <a:off x="0" y="0"/>
+          <a:ext cx="0" cy="0"/>
+          <a:chOff x="0" y="0"/>
+          <a:chExt cx="0" cy="0"/>
+        </a:xfrm>
+      </p:grpSpPr>
+      <p:sp>
+        <p:nvSpPr>
+          <p:cNvPr id="2" name="Text 0"/>
+          <p:cNvSpPr/>
+          <p:nvPr/>
+        </p:nvSpPr>
+        <p:spPr>
+          <a:xfrm>
+            <a:off x="777240" y="566928"/>
+            <a:ext cx="7315200" cy="256032"/>
+          </a:xfrm>
+          <a:prstGeom prst="rect">
+            <a:avLst/>
+          </a:prstGeom>
+          <a:noFill/>
+          <a:ln/>
+        </p:spPr>
+        <p:txBody>
+          <a:bodyPr wrap="square" lIns="0" tIns="0" rIns="0" bIns="0" rtlCol="0" anchor="ctr"/>
+          <a:lstStyle/>
+          <a:p>
+            <a:pPr indent="0" marL="0">
+              <a:buNone/>
+            </a:pPr>
+            <a:r>
+              <a:rPr lang="en-US" sz="1100" b="1" spc="250" kern="0" dirty="0">
+                <a:solidFill>
+                  <a:srgbClr val="202CFC"/>
+                </a:solidFill>
+                <a:latin typeface="Calibri" pitchFamily="34" charset="0"/>
+                <a:ea typeface="Calibri" pitchFamily="34" charset="-122"/>
+                <a:cs typeface="Calibri" pitchFamily="34" charset="-120"/>
+              </a:rPr>
+              <a:t>LA ARQUITECTURA</a:t>
+            </a:r>
+            <a:endParaRPr lang="en-US" sz="1100" dirty="0"/>
+          </a:p>
+        </p:txBody>
+      </p:sp>
+      <p:sp>
+        <p:nvSpPr>
+          <p:cNvPr id="3" name="Text 1"/>
+          <p:cNvSpPr/>
+          <p:nvPr/>
+        </p:nvSpPr>
+        <p:spPr>
+          <a:xfrm>
+            <a:off x="777240" y="877824"/>
+            <a:ext cx="10607040" cy="1051560"/>
+          </a:xfrm>
+          <a:prstGeom prst="rect">
+            <a:avLst/>
+          </a:prstGeom>
+          <a:noFill/>
+          <a:ln/>
+        </p:spPr>
+        <p:txBody>
+          <a:bodyPr wrap="square" lIns="0" tIns="0" rIns="0" bIns="0" rtlCol="0" anchor="t"/>
+          <a:lstStyle/>
+          <a:p>
+            <a:pPr indent="0" marL="0">
+              <a:buNone/>
+            </a:pPr>
+            <a:r>
+              <a:rPr lang="en-US" sz="3400" b="1" dirty="0">
+                <a:solidFill>
+                  <a:srgbClr val="1A1C2E"/>
+                </a:solidFill>
+                <a:latin typeface="Arial" pitchFamily="34" charset="0"/>
+                <a:ea typeface="Arial" pitchFamily="34" charset="-122"/>
+                <a:cs typeface="Arial" pitchFamily="34" charset="-120"/>
+              </a:rPr>
+              <a:t>Esto va a seguir cambiando</a:t>
+            </a:r>
+            <a:endParaRPr lang="en-US" sz="3400" dirty="0"/>
+          </a:p>
+        </p:txBody>
+      </p:sp>
+      <p:sp>
+        <p:nvSpPr>
+          <p:cNvPr id="4" name="Text 2"/>
+          <p:cNvSpPr/>
+          <p:nvPr/>
+        </p:nvSpPr>
+        <p:spPr>
+          <a:xfrm>
+            <a:off x="777240" y="1874520"/>
+            <a:ext cx="10607040" cy="365760"/>
+          </a:xfrm>
+          <a:prstGeom prst="rect">
+            <a:avLst/>
+          </a:prstGeom>
+          <a:noFill/>
+          <a:ln/>
+        </p:spPr>
+        <p:txBody>
+          <a:bodyPr wrap="square" lIns="0" tIns="0" rIns="0" bIns="0" rtlCol="0" anchor="t"/>
+          <a:lstStyle/>
+          <a:p>
+            <a:pPr indent="0" marL="0">
+              <a:buNone/>
+            </a:pPr>
+            <a:r>
+              <a:rPr lang="en-US" sz="1600" dirty="0">
+                <a:solidFill>
+                  <a:srgbClr val="5A5F73"/>
+                </a:solidFill>
+                <a:latin typeface="Calibri" pitchFamily="34" charset="0"/>
+                <a:ea typeface="Calibri" pitchFamily="34" charset="-122"/>
+                <a:cs typeface="Calibri" pitchFamily="34" charset="-120"/>
+              </a:rPr>
+              <a:t>Clean Architecture + Hexagonal. Cambiar una pieza es tocar una sola capa.</a:t>
+            </a:r>
+            <a:endParaRPr lang="en-US" sz="1600" dirty="0"/>
+          </a:p>
+        </p:txBody>
+      </p:sp>
+      <p:sp>
+        <p:nvSpPr>
+          <p:cNvPr id="5" name="Shape 3"/>
+          <p:cNvSpPr/>
+          <p:nvPr/>
+        </p:nvSpPr>
+        <p:spPr>
+          <a:xfrm>
+            <a:off x="777240" y="2697480"/>
+            <a:ext cx="3931920" cy="2651760"/>
+          </a:xfrm>
+          <a:prstGeom prst="roundRect">
+            <a:avLst>
+              <a:gd name="adj" fmla="val 2759"/>
+            </a:avLst>
+          </a:prstGeom>
+          <a:solidFill>
+            <a:srgbClr val="1A1C2E"/>
+          </a:solidFill>
+          <a:ln/>
+        </p:spPr>
+      </p:sp>
+      <p:sp>
+        <p:nvSpPr>
+          <p:cNvPr id="6" name="Text 4"/>
+          <p:cNvSpPr/>
+          <p:nvPr/>
+        </p:nvSpPr>
+        <p:spPr>
+          <a:xfrm>
+            <a:off x="1188720" y="3108960"/>
+            <a:ext cx="3108960" cy="274320"/>
+          </a:xfrm>
+          <a:prstGeom prst="rect">
+            <a:avLst/>
+          </a:prstGeom>
+          <a:noFill/>
+          <a:ln/>
+        </p:spPr>
+        <p:txBody>
+          <a:bodyPr wrap="square" lIns="0" tIns="0" rIns="0" bIns="0" rtlCol="0" anchor="ctr"/>
+          <a:lstStyle/>
+          <a:p>
+            <a:pPr indent="0" marL="0">
+              <a:buNone/>
+            </a:pPr>
+            <a:r>
+              <a:rPr lang="en-US" sz="1100" b="1" spc="200" kern="0" dirty="0">
+                <a:solidFill>
+                  <a:srgbClr val="8A93FF"/>
+                </a:solidFill>
+                <a:latin typeface="Calibri" pitchFamily="34" charset="0"/>
+                <a:ea typeface="Calibri" pitchFamily="34" charset="-122"/>
+                <a:cs typeface="Calibri" pitchFamily="34" charset="-120"/>
+              </a:rPr>
+              <a:t>EL NÚCLEO</a:t>
+            </a:r>
+            <a:endParaRPr lang="en-US" sz="1100" dirty="0"/>
+          </a:p>
+        </p:txBody>
+      </p:sp>
+      <p:sp>
+        <p:nvSpPr>
+          <p:cNvPr id="7" name="Text 5"/>
+          <p:cNvSpPr/>
+          <p:nvPr/>
+        </p:nvSpPr>
+        <p:spPr>
+          <a:xfrm>
+            <a:off x="1188720" y="3520440"/>
+            <a:ext cx="3108960" cy="822960"/>
+          </a:xfrm>
+          <a:prstGeom prst="rect">
+            <a:avLst/>
+          </a:prstGeom>
+          <a:noFill/>
+          <a:ln/>
+        </p:spPr>
+        <p:txBody>
+          <a:bodyPr wrap="square" lIns="0" tIns="0" rIns="0" bIns="0" rtlCol="0" anchor="t"/>
+          <a:lstStyle/>
+          <a:p>
+            <a:pPr indent="0" marL="0">
+              <a:lnSpc>
+                <a:spcPts val="2800"/>
+              </a:lnSpc>
+              <a:buNone/>
+            </a:pPr>
+            <a:r>
+              <a:rPr lang="en-US" sz="2200" b="1" dirty="0">
+                <a:solidFill>
+                  <a:srgbClr val="FFFFFF"/>
+                </a:solidFill>
+                <a:latin typeface="Arial" pitchFamily="34" charset="0"/>
+                <a:ea typeface="Arial" pitchFamily="34" charset="-122"/>
+                <a:cs typeface="Arial" pitchFamily="34" charset="-120"/>
+              </a:rPr>
+              <a:t>Dominio y</a:t>
+            </a:r>
+            <a:endParaRPr lang="en-US" sz="2200" dirty="0"/>
+          </a:p>
+          <a:p>
+            <a:pPr indent="0" marL="0">
+              <a:lnSpc>
+                <a:spcPts val="2800"/>
+              </a:lnSpc>
+              <a:buNone/>
+            </a:pPr>
+            <a:r>
+              <a:rPr lang="en-US" sz="2200" b="1" dirty="0">
+                <a:solidFill>
+                  <a:srgbClr val="FFFFFF"/>
+                </a:solidFill>
+                <a:latin typeface="Arial" pitchFamily="34" charset="0"/>
+                <a:ea typeface="Arial" pitchFamily="34" charset="-122"/>
+                <a:cs typeface="Arial" pitchFamily="34" charset="-120"/>
+              </a:rPr>
+              <a:t>casos de uso</a:t>
+            </a:r>
+            <a:endParaRPr lang="en-US" sz="2200" dirty="0"/>
+          </a:p>
+        </p:txBody>
+      </p:sp>
+      <p:sp>
+        <p:nvSpPr>
+          <p:cNvPr id="8" name="Text 6"/>
+          <p:cNvSpPr/>
+          <p:nvPr/>
+        </p:nvSpPr>
+        <p:spPr>
+          <a:xfrm>
+            <a:off x="1188720" y="4526280"/>
+            <a:ext cx="3108960" cy="365760"/>
+          </a:xfrm>
+          <a:prstGeom prst="rect">
+            <a:avLst/>
+          </a:prstGeom>
+          <a:noFill/>
+          <a:ln/>
+        </p:spPr>
+        <p:txBody>
+          <a:bodyPr wrap="square" lIns="0" tIns="0" rIns="0" bIns="0" rtlCol="0" anchor="t"/>
+          <a:lstStyle/>
+          <a:p>
+            <a:pPr indent="0" marL="0">
+              <a:buNone/>
+            </a:pPr>
+            <a:r>
+              <a:rPr lang="en-US" sz="1500" dirty="0">
+                <a:solidFill>
+                  <a:srgbClr val="B8BCCC"/>
+                </a:solidFill>
+                <a:latin typeface="Calibri" pitchFamily="34" charset="0"/>
+                <a:ea typeface="Calibri" pitchFamily="34" charset="-122"/>
+                <a:cs typeface="Calibri" pitchFamily="34" charset="-120"/>
+              </a:rPr>
+              <a:t>No se toca.</a:t>
+            </a:r>
+            <a:endParaRPr lang="en-US" sz="1500" dirty="0"/>
+          </a:p>
+        </p:txBody>
+      </p:sp>
+      <p:sp>
+        <p:nvSpPr>
+          <p:cNvPr id="9" name="Text 7"/>
+          <p:cNvSpPr/>
+          <p:nvPr/>
+        </p:nvSpPr>
+        <p:spPr>
+          <a:xfrm>
+            <a:off x="5486400" y="2395728"/>
+            <a:ext cx="5897880" cy="274320"/>
+          </a:xfrm>
+          <a:prstGeom prst="rect">
+            <a:avLst/>
+          </a:prstGeom>
+          <a:noFill/>
+          <a:ln/>
+        </p:spPr>
+        <p:txBody>
+          <a:bodyPr wrap="square" lIns="0" tIns="0" rIns="0" bIns="0" rtlCol="0" anchor="ctr"/>
+          <a:lstStyle/>
+          <a:p>
+            <a:pPr indent="0" marL="0">
+              <a:buNone/>
+            </a:pPr>
+            <a:r>
+              <a:rPr lang="en-US" sz="1100" b="1" spc="200" kern="0" dirty="0">
+                <a:solidFill>
+                  <a:srgbClr val="202CFC"/>
+                </a:solidFill>
+                <a:latin typeface="Calibri" pitchFamily="34" charset="0"/>
+                <a:ea typeface="Calibri" pitchFamily="34" charset="-122"/>
+                <a:cs typeface="Calibri" pitchFamily="34" charset="-120"/>
+              </a:rPr>
+              <a:t>INFRAESTRUCTURA — LO QUE SE CAMBIA</a:t>
+            </a:r>
+            <a:endParaRPr lang="en-US" sz="1100" dirty="0"/>
+          </a:p>
+        </p:txBody>
+      </p:sp>
+      <p:sp>
+        <p:nvSpPr>
+          <p:cNvPr id="10" name="Shape 8"/>
+          <p:cNvSpPr/>
+          <p:nvPr/>
+        </p:nvSpPr>
+        <p:spPr>
+          <a:xfrm>
+            <a:off x="5486400" y="2697480"/>
+            <a:ext cx="5897880" cy="749808"/>
+          </a:xfrm>
+          <a:prstGeom prst="roundRect">
+            <a:avLst>
+              <a:gd name="adj" fmla="val 12195"/>
             </a:avLst>
           </a:prstGeom>
           <a:solidFill>
@@ -2389,14 +3298,14 @@
       </p:sp>
       <p:sp>
         <p:nvSpPr>
-          <p:cNvPr id="6" name="Text 4"/>
-          <p:cNvSpPr/>
-          <p:nvPr/>
-        </p:nvSpPr>
-        <p:spPr>
-          <a:xfrm>
-            <a:off x="1143000" y="3063240"/>
-            <a:ext cx="4343400" cy="274320"/>
+          <p:cNvPr id="11" name="Text 9"/>
+          <p:cNvSpPr/>
+          <p:nvPr/>
+        </p:nvSpPr>
+        <p:spPr>
+          <a:xfrm>
+            <a:off x="5852160" y="2697480"/>
+            <a:ext cx="2377440" cy="749808"/>
           </a:xfrm>
           <a:prstGeom prst="rect">
             <a:avLst/>
@@ -2412,7 +3321,46 @@
               <a:buNone/>
             </a:pPr>
             <a:r>
-              <a:rPr lang="en-US" sz="1100" b="1" spc="200" kern="0" dirty="0">
+              <a:rPr lang="en-US" sz="1300" b="1" dirty="0">
+                <a:solidFill>
+                  <a:srgbClr val="1A1C2E"/>
+                </a:solidFill>
+                <a:latin typeface="Arial" pitchFamily="34" charset="0"/>
+                <a:ea typeface="Arial" pitchFamily="34" charset="-122"/>
+                <a:cs typeface="Arial" pitchFamily="34" charset="-120"/>
+              </a:rPr>
+              <a:t>Persistencia</a:t>
+            </a:r>
+            <a:endParaRPr lang="en-US" sz="1300" dirty="0"/>
+          </a:p>
+        </p:txBody>
+      </p:sp>
+      <p:sp>
+        <p:nvSpPr>
+          <p:cNvPr id="12" name="Text 10"/>
+          <p:cNvSpPr/>
+          <p:nvPr/>
+        </p:nvSpPr>
+        <p:spPr>
+          <a:xfrm>
+            <a:off x="8229600" y="2697480"/>
+            <a:ext cx="2788920" cy="749808"/>
+          </a:xfrm>
+          <a:prstGeom prst="rect">
+            <a:avLst/>
+          </a:prstGeom>
+          <a:noFill/>
+          <a:ln/>
+        </p:spPr>
+        <p:txBody>
+          <a:bodyPr wrap="square" lIns="0" tIns="0" rIns="0" bIns="0" rtlCol="0" anchor="ctr"/>
+          <a:lstStyle/>
+          <a:p>
+            <a:pPr algn="r" indent="0" marL="0">
+              <a:buNone/>
+            </a:pPr>
+            <a:r>
+              <a:rPr lang="en-US" sz="1400" dirty="0">
                 <a:solidFill>
                   <a:srgbClr val="202CFC"/>
                 </a:solidFill>
@@ -2420,38 +3368,60 @@
                 <a:ea typeface="Calibri" pitchFamily="34" charset="-122"/>
                 <a:cs typeface="Calibri" pitchFamily="34" charset="-120"/>
               </a:rPr>
-              <a:t>DESDE EL PRIMER COCHE</a:t>
-            </a:r>
-            <a:endParaRPr lang="en-US" sz="1100" dirty="0"/>
-          </a:p>
-        </p:txBody>
-      </p:sp>
-      <p:sp>
-        <p:nvSpPr>
-          <p:cNvPr id="7" name="Text 5"/>
-          <p:cNvSpPr/>
-          <p:nvPr/>
-        </p:nvSpPr>
-        <p:spPr>
-          <a:xfrm>
-            <a:off x="1143000" y="3429000"/>
-            <a:ext cx="4343400" cy="365760"/>
-          </a:xfrm>
-          <a:prstGeom prst="rect">
-            <a:avLst/>
-          </a:prstGeom>
-          <a:noFill/>
-          <a:ln/>
-        </p:spPr>
-        <p:txBody>
-          <a:bodyPr wrap="square" lIns="0" tIns="0" rIns="0" bIns="0" rtlCol="0" anchor="t"/>
+              <a:t>SQLite  →  PostgreSQL</a:t>
+            </a:r>
+            <a:endParaRPr lang="en-US" sz="1400" dirty="0"/>
+          </a:p>
+        </p:txBody>
+      </p:sp>
+      <p:sp>
+        <p:nvSpPr>
+          <p:cNvPr id="13" name="Shape 11"/>
+          <p:cNvSpPr/>
+          <p:nvPr/>
+        </p:nvSpPr>
+        <p:spPr>
+          <a:xfrm>
+            <a:off x="5486400" y="3648456"/>
+            <a:ext cx="5897880" cy="749808"/>
+          </a:xfrm>
+          <a:prstGeom prst="roundRect">
+            <a:avLst>
+              <a:gd name="adj" fmla="val 12195"/>
+            </a:avLst>
+          </a:prstGeom>
+          <a:solidFill>
+            <a:srgbClr val="F3F4F9"/>
+          </a:solidFill>
+          <a:ln/>
+        </p:spPr>
+      </p:sp>
+      <p:sp>
+        <p:nvSpPr>
+          <p:cNvPr id="14" name="Text 12"/>
+          <p:cNvSpPr/>
+          <p:nvPr/>
+        </p:nvSpPr>
+        <p:spPr>
+          <a:xfrm>
+            <a:off x="5852160" y="3648456"/>
+            <a:ext cx="2377440" cy="749808"/>
+          </a:xfrm>
+          <a:prstGeom prst="rect">
+            <a:avLst/>
+          </a:prstGeom>
+          <a:noFill/>
+          <a:ln/>
+        </p:spPr>
+        <p:txBody>
+          <a:bodyPr wrap="square" lIns="0" tIns="0" rIns="0" bIns="0" rtlCol="0" anchor="ctr"/>
           <a:lstStyle/>
           <a:p>
             <a:pPr indent="0" marL="0">
               <a:buNone/>
             </a:pPr>
             <a:r>
-              <a:rPr lang="en-US" sz="1900" b="1" dirty="0">
+              <a:rPr lang="en-US" sz="1300" b="1" dirty="0">
                 <a:solidFill>
                   <a:srgbClr val="1A1C2E"/>
                 </a:solidFill>
@@ -2459,86 +3429,83 @@
                 <a:ea typeface="Arial" pitchFamily="34" charset="-122"/>
                 <a:cs typeface="Arial" pitchFamily="34" charset="-120"/>
               </a:rPr>
-              <a:t>Le ayuda a investigar el fallo</a:t>
-            </a:r>
-            <a:endParaRPr lang="en-US" sz="1900" dirty="0"/>
-          </a:p>
-        </p:txBody>
-      </p:sp>
-      <p:sp>
-        <p:nvSpPr>
-          <p:cNvPr id="8" name="Text 6"/>
-          <p:cNvSpPr/>
-          <p:nvPr/>
-        </p:nvSpPr>
-        <p:spPr>
-          <a:xfrm>
-            <a:off x="1143000" y="3977640"/>
-            <a:ext cx="4343400" cy="1280160"/>
-          </a:xfrm>
-          <a:prstGeom prst="rect">
-            <a:avLst/>
-          </a:prstGeom>
-          <a:noFill/>
-          <a:ln/>
-        </p:spPr>
-        <p:txBody>
-          <a:bodyPr wrap="square" lIns="0" tIns="0" rIns="0" bIns="0" rtlCol="0" anchor="t"/>
-          <a:lstStyle/>
-          <a:p>
-            <a:pPr indent="0" marL="0">
-              <a:lnSpc>
-                <a:spcPts val="1900"/>
-              </a:lnSpc>
-              <a:buNone/>
-            </a:pPr>
-            <a:r>
-              <a:rPr lang="en-US" sz="1300" dirty="0">
-                <a:solidFill>
-                  <a:srgbClr val="5A5F73"/>
+              <a:t>Modelo de lenguaje</a:t>
+            </a:r>
+            <a:endParaRPr lang="en-US" sz="1300" dirty="0"/>
+          </a:p>
+        </p:txBody>
+      </p:sp>
+      <p:sp>
+        <p:nvSpPr>
+          <p:cNvPr id="15" name="Text 13"/>
+          <p:cNvSpPr/>
+          <p:nvPr/>
+        </p:nvSpPr>
+        <p:spPr>
+          <a:xfrm>
+            <a:off x="8229600" y="3648456"/>
+            <a:ext cx="2788920" cy="749808"/>
+          </a:xfrm>
+          <a:prstGeom prst="rect">
+            <a:avLst/>
+          </a:prstGeom>
+          <a:noFill/>
+          <a:ln/>
+        </p:spPr>
+        <p:txBody>
+          <a:bodyPr wrap="square" lIns="0" tIns="0" rIns="0" bIns="0" rtlCol="0" anchor="ctr"/>
+          <a:lstStyle/>
+          <a:p>
+            <a:pPr algn="r" indent="0" marL="0">
+              <a:buNone/>
+            </a:pPr>
+            <a:r>
+              <a:rPr lang="en-US" sz="1400" dirty="0">
+                <a:solidFill>
+                  <a:srgbClr val="202CFC"/>
                 </a:solidFill>
                 <a:latin typeface="Calibri" pitchFamily="34" charset="0"/>
                 <a:ea typeface="Calibri" pitchFamily="34" charset="-122"/>
                 <a:cs typeface="Calibri" pitchFamily="34" charset="-120"/>
               </a:rPr>
-              <a:t>La herramienta lee el coche, cruza lo que encuentra y le dice qué está pasando y por dónde seguir mirando: si el coche está bien, si está mal, y qué conviene revisar. No le devuelve una tabla de códigos, le devuelve una lectura del vehículo.</a:t>
-            </a:r>
-            <a:endParaRPr lang="en-US" sz="1300" dirty="0"/>
-          </a:p>
-        </p:txBody>
-      </p:sp>
-      <p:sp>
-        <p:nvSpPr>
-          <p:cNvPr id="9" name="Shape 7"/>
-          <p:cNvSpPr/>
-          <p:nvPr/>
-        </p:nvSpPr>
-        <p:spPr>
-          <a:xfrm>
-            <a:off x="6309360" y="2697480"/>
-            <a:ext cx="5074920" cy="2697480"/>
+              <a:t>OpenAI  ↔  Anthropic</a:t>
+            </a:r>
+            <a:endParaRPr lang="en-US" sz="1400" dirty="0"/>
+          </a:p>
+        </p:txBody>
+      </p:sp>
+      <p:sp>
+        <p:nvSpPr>
+          <p:cNvPr id="16" name="Shape 14"/>
+          <p:cNvSpPr/>
+          <p:nvPr/>
+        </p:nvSpPr>
+        <p:spPr>
+          <a:xfrm>
+            <a:off x="5486400" y="4599432"/>
+            <a:ext cx="5897880" cy="749808"/>
           </a:xfrm>
           <a:prstGeom prst="roundRect">
             <a:avLst>
-              <a:gd name="adj" fmla="val 2712"/>
+              <a:gd name="adj" fmla="val 12195"/>
             </a:avLst>
           </a:prstGeom>
           <a:solidFill>
-            <a:srgbClr val="1A1C2E"/>
+            <a:srgbClr val="F3F4F9"/>
           </a:solidFill>
           <a:ln/>
         </p:spPr>
       </p:sp>
       <p:sp>
         <p:nvSpPr>
-          <p:cNvPr id="10" name="Text 8"/>
-          <p:cNvSpPr/>
-          <p:nvPr/>
-        </p:nvSpPr>
-        <p:spPr>
-          <a:xfrm>
-            <a:off x="6675120" y="3063240"/>
-            <a:ext cx="4343400" cy="274320"/>
+          <p:cNvPr id="17" name="Text 15"/>
+          <p:cNvSpPr/>
+          <p:nvPr/>
+        </p:nvSpPr>
+        <p:spPr>
+          <a:xfrm>
+            <a:off x="5852160" y="4599432"/>
+            <a:ext cx="2377440" cy="749808"/>
           </a:xfrm>
           <a:prstGeom prst="rect">
             <a:avLst/>
@@ -2554,46 +3521,144 @@
               <a:buNone/>
             </a:pPr>
             <a:r>
-              <a:rPr lang="en-US" sz="1100" b="1" spc="200" kern="0" dirty="0">
-                <a:solidFill>
-                  <a:srgbClr val="8A93FF"/>
+              <a:rPr lang="en-US" sz="1300" b="1" dirty="0">
+                <a:solidFill>
+                  <a:srgbClr val="1A1C2E"/>
+                </a:solidFill>
+                <a:latin typeface="Arial" pitchFamily="34" charset="0"/>
+                <a:ea typeface="Arial" pitchFamily="34" charset="-122"/>
+                <a:cs typeface="Arial" pitchFamily="34" charset="-120"/>
+              </a:rPr>
+              <a:t>Acceso al coche</a:t>
+            </a:r>
+            <a:endParaRPr lang="en-US" sz="1300" dirty="0"/>
+          </a:p>
+        </p:txBody>
+      </p:sp>
+      <p:sp>
+        <p:nvSpPr>
+          <p:cNvPr id="18" name="Text 16"/>
+          <p:cNvSpPr/>
+          <p:nvPr/>
+        </p:nvSpPr>
+        <p:spPr>
+          <a:xfrm>
+            <a:off x="8229600" y="4599432"/>
+            <a:ext cx="2788920" cy="749808"/>
+          </a:xfrm>
+          <a:prstGeom prst="rect">
+            <a:avLst/>
+          </a:prstGeom>
+          <a:noFill/>
+          <a:ln/>
+        </p:spPr>
+        <p:txBody>
+          <a:bodyPr wrap="square" lIns="0" tIns="0" rIns="0" bIns="0" rtlCol="0" anchor="ctr"/>
+          <a:lstStyle/>
+          <a:p>
+            <a:pPr algn="r" indent="0" marL="0">
+              <a:buNone/>
+            </a:pPr>
+            <a:r>
+              <a:rPr lang="en-US" sz="1400" dirty="0">
+                <a:solidFill>
+                  <a:srgbClr val="202CFC"/>
                 </a:solidFill>
                 <a:latin typeface="Calibri" pitchFamily="34" charset="0"/>
                 <a:ea typeface="Calibri" pitchFamily="34" charset="-122"/>
                 <a:cs typeface="Calibri" pitchFamily="34" charset="-120"/>
               </a:rPr>
-              <a:t>SEGÚN SE VAN CONECTANDO TALLERES</a:t>
-            </a:r>
-            <a:endParaRPr lang="en-US" sz="1100" dirty="0"/>
-          </a:p>
-        </p:txBody>
-      </p:sp>
-      <p:sp>
-        <p:nvSpPr>
-          <p:cNvPr id="11" name="Text 9"/>
-          <p:cNvSpPr/>
-          <p:nvPr/>
-        </p:nvSpPr>
-        <p:spPr>
-          <a:xfrm>
-            <a:off x="6675120" y="3429000"/>
-            <a:ext cx="4343400" cy="365760"/>
-          </a:xfrm>
-          <a:prstGeom prst="rect">
-            <a:avLst/>
-          </a:prstGeom>
-          <a:noFill/>
-          <a:ln/>
-        </p:spPr>
-        <p:txBody>
-          <a:bodyPr wrap="square" lIns="0" tIns="0" rIns="0" bIns="0" rtlCol="0" anchor="t"/>
+              <a:t>Emulador  ↔  cable OBD</a:t>
+            </a:r>
+            <a:endParaRPr lang="en-US" sz="1400" dirty="0"/>
+          </a:p>
+        </p:txBody>
+      </p:sp>
+      <p:sp>
+        <p:nvSpPr>
+          <p:cNvPr id="19" name="Text 17"/>
+          <p:cNvSpPr/>
+          <p:nvPr/>
+        </p:nvSpPr>
+        <p:spPr>
+          <a:xfrm>
+            <a:off x="777240" y="5669280"/>
+            <a:ext cx="10607040" cy="365760"/>
+          </a:xfrm>
+          <a:prstGeom prst="rect">
+            <a:avLst/>
+          </a:prstGeom>
+          <a:noFill/>
+          <a:ln/>
+        </p:spPr>
+        <p:txBody>
+          <a:bodyPr wrap="square" lIns="0" tIns="0" rIns="0" bIns="0" rtlCol="0" anchor="ctr"/>
           <a:lstStyle/>
           <a:p>
             <a:pPr indent="0" marL="0">
               <a:buNone/>
             </a:pPr>
             <a:r>
-              <a:rPr lang="en-US" sz="1900" b="1" dirty="0">
+              <a:rPr lang="en-US" sz="1400" dirty="0">
+                <a:solidFill>
+                  <a:srgbClr val="5A5F73"/>
+                </a:solidFill>
+                <a:latin typeface="Calibri" pitchFamily="34" charset="0"/>
+                <a:ea typeface="Calibri" pitchFamily="34" charset="-122"/>
+                <a:cs typeface="Calibri" pitchFamily="34" charset="-120"/>
+              </a:rPr>
+              <a:t>Hoy SQLite porque era lo más rápido para desarrollar. El día que toque Postgres, se cambia el adaptador.</a:t>
+            </a:r>
+            <a:endParaRPr lang="en-US" sz="1400" dirty="0"/>
+          </a:p>
+        </p:txBody>
+      </p:sp>
+      <p:sp>
+        <p:nvSpPr>
+          <p:cNvPr id="20" name="Shape 18"/>
+          <p:cNvSpPr/>
+          <p:nvPr/>
+        </p:nvSpPr>
+        <p:spPr>
+          <a:xfrm>
+            <a:off x="777240" y="6263640"/>
+            <a:ext cx="219456" cy="219456"/>
+          </a:xfrm>
+          <a:prstGeom prst="rect">
+            <a:avLst/>
+          </a:prstGeom>
+          <a:solidFill>
+            <a:srgbClr val="202CFC"/>
+          </a:solidFill>
+          <a:ln/>
+        </p:spPr>
+      </p:sp>
+      <p:sp>
+        <p:nvSpPr>
+          <p:cNvPr id="21" name="Text 19"/>
+          <p:cNvSpPr/>
+          <p:nvPr/>
+        </p:nvSpPr>
+        <p:spPr>
+          <a:xfrm>
+            <a:off x="777240" y="6263640"/>
+            <a:ext cx="219456" cy="219456"/>
+          </a:xfrm>
+          <a:prstGeom prst="rect">
+            <a:avLst/>
+          </a:prstGeom>
+          <a:noFill/>
+          <a:ln/>
+        </p:spPr>
+        <p:txBody>
+          <a:bodyPr wrap="square" lIns="0" tIns="0" rIns="0" bIns="0" rtlCol="0" anchor="ctr"/>
+          <a:lstStyle/>
+          <a:p>
+            <a:pPr algn="ctr" indent="0" marL="0">
+              <a:buNone/>
+            </a:pPr>
+            <a:r>
+              <a:rPr lang="en-US" sz="816" b="1" dirty="0">
                 <a:solidFill>
                   <a:srgbClr val="FFFFFF"/>
                 </a:solidFill>
@@ -2601,186 +3666,85 @@
                 <a:ea typeface="Arial" pitchFamily="34" charset="-122"/>
                 <a:cs typeface="Arial" pitchFamily="34" charset="-120"/>
               </a:rPr>
-              <a:t>Y va mejorando con el uso</a:t>
-            </a:r>
-            <a:endParaRPr lang="en-US" sz="1900" dirty="0"/>
-          </a:p>
-        </p:txBody>
-      </p:sp>
-      <p:sp>
-        <p:nvSpPr>
-          <p:cNvPr id="12" name="Text 10"/>
-          <p:cNvSpPr/>
-          <p:nvPr/>
-        </p:nvSpPr>
-        <p:spPr>
-          <a:xfrm>
-            <a:off x="6675120" y="3977640"/>
-            <a:ext cx="4343400" cy="1280160"/>
-          </a:xfrm>
-          <a:prstGeom prst="rect">
-            <a:avLst/>
-          </a:prstGeom>
-          <a:noFill/>
-          <a:ln/>
-        </p:spPr>
-        <p:txBody>
-          <a:bodyPr wrap="square" lIns="0" tIns="0" rIns="0" bIns="0" rtlCol="0" anchor="t"/>
-          <a:lstStyle/>
-          <a:p>
-            <a:pPr indent="0" marL="0">
-              <a:lnSpc>
-                <a:spcPts val="1900"/>
-              </a:lnSpc>
-              <a:buNone/>
-            </a:pPr>
-            <a:r>
-              <a:rPr lang="en-US" sz="1300" dirty="0">
-                <a:solidFill>
-                  <a:srgbClr val="B8BCCC"/>
+              <a:t>BIG</a:t>
+            </a:r>
+            <a:endParaRPr lang="en-US" sz="816" dirty="0"/>
+          </a:p>
+        </p:txBody>
+      </p:sp>
+      <p:sp>
+        <p:nvSpPr>
+          <p:cNvPr id="22" name="Text 20"/>
+          <p:cNvSpPr/>
+          <p:nvPr/>
+        </p:nvSpPr>
+        <p:spPr>
+          <a:xfrm>
+            <a:off x="1078992" y="6263640"/>
+            <a:ext cx="658368" cy="219456"/>
+          </a:xfrm>
+          <a:prstGeom prst="rect">
+            <a:avLst/>
+          </a:prstGeom>
+          <a:noFill/>
+          <a:ln/>
+        </p:spPr>
+        <p:txBody>
+          <a:bodyPr wrap="square" lIns="0" tIns="0" rIns="0" bIns="0" rtlCol="0" anchor="ctr"/>
+          <a:lstStyle/>
+          <a:p>
+            <a:pPr algn="l" indent="0" marL="0">
+              <a:buNone/>
+            </a:pPr>
+            <a:r>
+              <a:rPr lang="en-US" sz="816" dirty="0">
+                <a:solidFill>
+                  <a:srgbClr val="1A1C2E"/>
+                </a:solidFill>
+                <a:latin typeface="Arial" pitchFamily="34" charset="0"/>
+                <a:ea typeface="Arial" pitchFamily="34" charset="-122"/>
+                <a:cs typeface="Arial" pitchFamily="34" charset="-120"/>
+              </a:rPr>
+              <a:t>school</a:t>
+            </a:r>
+            <a:endParaRPr lang="en-US" sz="816" dirty="0"/>
+          </a:p>
+        </p:txBody>
+      </p:sp>
+      <p:sp>
+        <p:nvSpPr>
+          <p:cNvPr id="23" name="Text 21"/>
+          <p:cNvSpPr/>
+          <p:nvPr/>
+        </p:nvSpPr>
+        <p:spPr>
+          <a:xfrm>
+            <a:off x="11064240" y="6263640"/>
+            <a:ext cx="320040" cy="219456"/>
+          </a:xfrm>
+          <a:prstGeom prst="rect">
+            <a:avLst/>
+          </a:prstGeom>
+          <a:noFill/>
+          <a:ln/>
+        </p:spPr>
+        <p:txBody>
+          <a:bodyPr wrap="square" lIns="0" tIns="0" rIns="0" bIns="0" rtlCol="0" anchor="ctr"/>
+          <a:lstStyle/>
+          <a:p>
+            <a:pPr algn="r" indent="0" marL="0">
+              <a:buNone/>
+            </a:pPr>
+            <a:r>
+              <a:rPr lang="en-US" sz="1000" dirty="0">
+                <a:solidFill>
+                  <a:srgbClr val="5A5F73"/>
                 </a:solidFill>
                 <a:latin typeface="Calibri" pitchFamily="34" charset="0"/>
                 <a:ea typeface="Calibri" pitchFamily="34" charset="-122"/>
                 <a:cs typeface="Calibri" pitchFamily="34" charset="-120"/>
               </a:rPr>
-              <a:t>Cada diagnóstico que se cierra se guarda en una base de datos vectorial. Cuantos más talleres conectados, más coches registrados y más averías resueltas, más casos reales tiene para comparar. Es una mejora lenta, pero se acumula.</a:t>
-            </a:r>
-            <a:endParaRPr lang="en-US" sz="1300" dirty="0"/>
-          </a:p>
-        </p:txBody>
-      </p:sp>
-      <p:sp>
-        <p:nvSpPr>
-          <p:cNvPr id="13" name="Shape 11"/>
-          <p:cNvSpPr/>
-          <p:nvPr/>
-        </p:nvSpPr>
-        <p:spPr>
-          <a:xfrm>
-            <a:off x="777240" y="6263640"/>
-            <a:ext cx="219456" cy="219456"/>
-          </a:xfrm>
-          <a:prstGeom prst="rect">
-            <a:avLst/>
-          </a:prstGeom>
-          <a:solidFill>
-            <a:srgbClr val="202CFC"/>
-          </a:solidFill>
-          <a:ln/>
-        </p:spPr>
-      </p:sp>
-      <p:sp>
-        <p:nvSpPr>
-          <p:cNvPr id="14" name="Text 12"/>
-          <p:cNvSpPr/>
-          <p:nvPr/>
-        </p:nvSpPr>
-        <p:spPr>
-          <a:xfrm>
-            <a:off x="777240" y="6263640"/>
-            <a:ext cx="219456" cy="219456"/>
-          </a:xfrm>
-          <a:prstGeom prst="rect">
-            <a:avLst/>
-          </a:prstGeom>
-          <a:noFill/>
-          <a:ln/>
-        </p:spPr>
-        <p:txBody>
-          <a:bodyPr wrap="square" lIns="0" tIns="0" rIns="0" bIns="0" rtlCol="0" anchor="ctr"/>
-          <a:lstStyle/>
-          <a:p>
-            <a:pPr algn="ctr" indent="0" marL="0">
-              <a:buNone/>
-            </a:pPr>
-            <a:r>
-              <a:rPr lang="en-US" sz="816" b="1" dirty="0">
-                <a:solidFill>
-                  <a:srgbClr val="FFFFFF"/>
-                </a:solidFill>
-                <a:latin typeface="Arial" pitchFamily="34" charset="0"/>
-                <a:ea typeface="Arial" pitchFamily="34" charset="-122"/>
-                <a:cs typeface="Arial" pitchFamily="34" charset="-120"/>
-              </a:rPr>
-              <a:t>BIG</a:t>
-            </a:r>
-            <a:endParaRPr lang="en-US" sz="816" dirty="0"/>
-          </a:p>
-        </p:txBody>
-      </p:sp>
-      <p:sp>
-        <p:nvSpPr>
-          <p:cNvPr id="15" name="Text 13"/>
-          <p:cNvSpPr/>
-          <p:nvPr/>
-        </p:nvSpPr>
-        <p:spPr>
-          <a:xfrm>
-            <a:off x="1078992" y="6263640"/>
-            <a:ext cx="658368" cy="219456"/>
-          </a:xfrm>
-          <a:prstGeom prst="rect">
-            <a:avLst/>
-          </a:prstGeom>
-          <a:noFill/>
-          <a:ln/>
-        </p:spPr>
-        <p:txBody>
-          <a:bodyPr wrap="square" lIns="0" tIns="0" rIns="0" bIns="0" rtlCol="0" anchor="ctr"/>
-          <a:lstStyle/>
-          <a:p>
-            <a:pPr algn="l" indent="0" marL="0">
-              <a:buNone/>
-            </a:pPr>
-            <a:r>
-              <a:rPr lang="en-US" sz="816" dirty="0">
-                <a:solidFill>
-                  <a:srgbClr val="1A1C2E"/>
-                </a:solidFill>
-                <a:latin typeface="Arial" pitchFamily="34" charset="0"/>
-                <a:ea typeface="Arial" pitchFamily="34" charset="-122"/>
-                <a:cs typeface="Arial" pitchFamily="34" charset="-120"/>
-              </a:rPr>
-              <a:t>school</a:t>
-            </a:r>
-            <a:endParaRPr lang="en-US" sz="816" dirty="0"/>
-          </a:p>
-        </p:txBody>
-      </p:sp>
-      <p:sp>
-        <p:nvSpPr>
-          <p:cNvPr id="16" name="Text 14"/>
-          <p:cNvSpPr/>
-          <p:nvPr/>
-        </p:nvSpPr>
-        <p:spPr>
-          <a:xfrm>
-            <a:off x="11064240" y="6263640"/>
-            <a:ext cx="320040" cy="219456"/>
-          </a:xfrm>
-          <a:prstGeom prst="rect">
-            <a:avLst/>
-          </a:prstGeom>
-          <a:noFill/>
-          <a:ln/>
-        </p:spPr>
-        <p:txBody>
-          <a:bodyPr wrap="square" lIns="0" tIns="0" rIns="0" bIns="0" rtlCol="0" anchor="ctr"/>
-          <a:lstStyle/>
-          <a:p>
-            <a:pPr algn="r" indent="0" marL="0">
-              <a:buNone/>
-            </a:pPr>
-            <a:r>
-              <a:rPr lang="en-US" sz="1000" dirty="0">
-                <a:solidFill>
-                  <a:srgbClr val="5A5F73"/>
-                </a:solidFill>
-                <a:latin typeface="Calibri" pitchFamily="34" charset="0"/>
-                <a:ea typeface="Calibri" pitchFamily="34" charset="-122"/>
-                <a:cs typeface="Calibri" pitchFamily="34" charset="-120"/>
-              </a:rPr>
-              <a:t>3</a:t>
+              <a:t>4</a:t>
             </a:r>
             <a:endParaRPr lang="en-US" sz="1000" dirty="0"/>
           </a:p>

</xml_diff>

<commit_message>
docs(tfm): slide del problema con la salida del escaner
</commit_message>
<xml_diff>
--- a/docs/presentacion/tfm-intelligent-automotive-diagnostics.pptx
+++ b/docs/presentacion/tfm-intelligent-automotive-diagnostics.pptx
@@ -6,9 +6,10 @@
   </p:sldMasterIdLst>
   <p:sldIdLst>
     <p:sldId id="256" r:id="rId2"/>
+    <p:sldId id="257" r:id="rId3"/>
   </p:sldIdLst>
   <p:notesMasterIdLst>
-    <p:notesMasterId r:id="rId3"/>
+    <p:notesMasterId r:id="rId4"/>
   </p:notesMasterIdLst>
   <p:sldSz cx="12192000" cy="6858000"/>
   <p:notesSz cx="6858000" cy="12192000"/>
@@ -547,6 +548,97 @@
 </p:notes>
 </file>
 
+<file path=ppt/notesSlides/notesSlide2.xml><?xml version="1.0" encoding="utf-8"?>
+<p:notes xmlns:a="http://schemas.openxmlformats.org/drawingml/2006/main" xmlns:r="http://schemas.openxmlformats.org/officeDocument/2006/relationships" xmlns:p="http://schemas.openxmlformats.org/presentationml/2006/main">
+  <p:cSld>
+    <p:spTree>
+      <p:nvGrpSpPr>
+        <p:cNvPr id="1" name=""/>
+        <p:cNvGrpSpPr/>
+        <p:nvPr/>
+      </p:nvGrpSpPr>
+      <p:grpSpPr>
+        <a:xfrm>
+          <a:off x="0" y="0"/>
+          <a:ext cx="0" cy="0"/>
+          <a:chOff x="0" y="0"/>
+          <a:chExt cx="0" cy="0"/>
+        </a:xfrm>
+      </p:grpSpPr>
+      <p:sp>
+        <p:nvSpPr>
+          <p:cNvPr id="2" name="Slide Image Placeholder 1"/>
+          <p:cNvSpPr>
+            <a:spLocks noGrp="1" noRot="1" noChangeAspect="1"/>
+          </p:cNvSpPr>
+          <p:nvPr>
+            <p:ph type="sldImg"/>
+          </p:nvPr>
+        </p:nvSpPr>
+        <p:spPr/>
+      </p:sp>
+      <p:sp>
+        <p:nvSpPr>
+          <p:cNvPr id="3" name="Notes Placeholder 2"/>
+          <p:cNvSpPr>
+            <a:spLocks noGrp="1"/>
+          </p:cNvSpPr>
+          <p:nvPr>
+            <p:ph type="body" idx="1"/>
+          </p:nvPr>
+        </p:nvSpPr>
+        <p:spPr/>
+        <p:txBody>
+          <a:bodyPr/>
+          <a:lstStyle/>
+          <a:p>
+            <a:r>
+              <a:rPr lang="en-US" dirty="0"/>
+              <a:t>Hoy llegas con una máquina de diagnosis, la conectas, y te da diez códigos de error. Cada uno te dice una cosa: válvula EGR obstruida, filtro de partículas lleno.
+Vale. Pero esa válvula se ha obstruido por alguna circunstancia, y ese filtro se ha llenado por alguna circunstancia. Y eso la máquina no te lo dice.
+El mecánico se queda con la lista delante y el trabajo de averiguar el porqué sigue entero por hacer.
+[~45 s]</a:t>
+            </a:r>
+            <a:endParaRPr lang="en-US" dirty="0"/>
+          </a:p>
+        </p:txBody>
+      </p:sp>
+      <p:sp>
+        <p:nvSpPr>
+          <p:cNvPr id="4" name="Slide Number Placeholder 3"/>
+          <p:cNvSpPr>
+            <a:spLocks noGrp="1"/>
+          </p:cNvSpPr>
+          <p:nvPr>
+            <p:ph type="sldNum" sz="quarter" idx="10"/>
+          </p:nvPr>
+        </p:nvSpPr>
+        <p:spPr/>
+        <p:txBody>
+          <a:bodyPr/>
+          <a:lstStyle/>
+          <a:p>
+            <a:fld id="{F7021451-1387-4CA6-816F-3879F97B5CBC}" type="slidenum">
+              <a:rPr lang="en-US"/>
+              <a:t>2</a:t>
+            </a:fld>
+            <a:endParaRPr lang="en-US"/>
+          </a:p>
+        </p:txBody>
+      </p:sp>
+    </p:spTree>
+    <p:extLst>
+      <p:ext uri="{BB962C8B-B14F-4D97-AF65-F5344CB8AC3E}">
+        <p14:creationId xmlns:p14="http://schemas.microsoft.com/office/powerpoint/2010/main" val="1024086991"/>
+      </p:ext>
+    </p:extLst>
+  </p:cSld>
+  <p:clrMapOvr>
+    <a:masterClrMapping/>
+  </p:clrMapOvr>
+</p:notes>
+</file>
+
 <file path=ppt/slideLayouts/slideLayout1.xml><?xml version="1.0" encoding="utf-8"?>
 <p:sldLayout xmlns:a="http://schemas.openxmlformats.org/drawingml/2006/main" xmlns:r="http://schemas.openxmlformats.org/officeDocument/2006/relationships" xmlns:p="http://schemas.openxmlformats.org/presentationml/2006/main" preserve="1">
   <p:cSld name="DEFAULT">
@@ -1246,6 +1338,678 @@
           </a:effectLst>
         </p:spPr>
       </p:pic>
+    </p:spTree>
+  </p:cSld>
+  <p:clrMapOvr>
+    <a:masterClrMapping/>
+  </p:clrMapOvr>
+</p:sld>
+</file>
+
+<file path=ppt/slides/slide2.xml><?xml version="1.0" encoding="utf-8"?>
+<p:sld xmlns:a="http://schemas.openxmlformats.org/drawingml/2006/main" xmlns:r="http://schemas.openxmlformats.org/officeDocument/2006/relationships" xmlns:p="http://schemas.openxmlformats.org/presentationml/2006/main">
+  <p:cSld name="Slide 2">
+    <p:bg>
+      <p:bgPr>
+        <a:solidFill>
+          <a:srgbClr val="FFFFFF"/>
+        </a:solidFill>
+      </p:bgPr>
+    </p:bg>
+    <p:spTree>
+      <p:nvGrpSpPr>
+        <p:cNvPr id="1" name=""/>
+        <p:cNvGrpSpPr/>
+        <p:nvPr/>
+      </p:nvGrpSpPr>
+      <p:grpSpPr>
+        <a:xfrm>
+          <a:off x="0" y="0"/>
+          <a:ext cx="0" cy="0"/>
+          <a:chOff x="0" y="0"/>
+          <a:chExt cx="0" cy="0"/>
+        </a:xfrm>
+      </p:grpSpPr>
+      <p:sp>
+        <p:nvSpPr>
+          <p:cNvPr id="2" name="Text 0"/>
+          <p:cNvSpPr/>
+          <p:nvPr/>
+        </p:nvSpPr>
+        <p:spPr>
+          <a:xfrm>
+            <a:off x="777240" y="685800"/>
+            <a:ext cx="10607040" cy="822960"/>
+          </a:xfrm>
+          <a:prstGeom prst="rect">
+            <a:avLst/>
+          </a:prstGeom>
+          <a:noFill/>
+          <a:ln/>
+        </p:spPr>
+        <p:txBody>
+          <a:bodyPr wrap="square" lIns="0" tIns="0" rIns="0" bIns="0" rtlCol="0" anchor="t"/>
+          <a:lstStyle/>
+          <a:p>
+            <a:pPr indent="0" marL="0">
+              <a:buNone/>
+            </a:pPr>
+            <a:r>
+              <a:rPr lang="en-US" sz="3400" b="1" dirty="0">
+                <a:solidFill>
+                  <a:srgbClr val="1A1C2E"/>
+                </a:solidFill>
+                <a:latin typeface="Arial" pitchFamily="34" charset="0"/>
+                <a:ea typeface="Arial" pitchFamily="34" charset="-122"/>
+                <a:cs typeface="Arial" pitchFamily="34" charset="-120"/>
+              </a:rPr>
+              <a:t>Lo que te da la máquina</a:t>
+            </a:r>
+            <a:endParaRPr lang="en-US" sz="3400" dirty="0"/>
+          </a:p>
+        </p:txBody>
+      </p:sp>
+      <p:sp>
+        <p:nvSpPr>
+          <p:cNvPr id="3" name="Shape 1"/>
+          <p:cNvSpPr/>
+          <p:nvPr/>
+        </p:nvSpPr>
+        <p:spPr>
+          <a:xfrm>
+            <a:off x="777240" y="1920240"/>
+            <a:ext cx="5943600" cy="3246120"/>
+          </a:xfrm>
+          <a:prstGeom prst="roundRect">
+            <a:avLst>
+              <a:gd name="adj" fmla="val 1690"/>
+            </a:avLst>
+          </a:prstGeom>
+          <a:solidFill>
+            <a:srgbClr val="1A1C2E"/>
+          </a:solidFill>
+          <a:ln/>
+        </p:spPr>
+      </p:sp>
+      <p:sp>
+        <p:nvSpPr>
+          <p:cNvPr id="4" name="Text 2"/>
+          <p:cNvSpPr/>
+          <p:nvPr/>
+        </p:nvSpPr>
+        <p:spPr>
+          <a:xfrm>
+            <a:off x="1188720" y="2304288"/>
+            <a:ext cx="5120640" cy="256032"/>
+          </a:xfrm>
+          <a:prstGeom prst="rect">
+            <a:avLst/>
+          </a:prstGeom>
+          <a:noFill/>
+          <a:ln/>
+        </p:spPr>
+        <p:txBody>
+          <a:bodyPr wrap="square" lIns="0" tIns="0" rIns="0" bIns="0" rtlCol="0" anchor="ctr"/>
+          <a:lstStyle/>
+          <a:p>
+            <a:pPr indent="0" marL="0">
+              <a:buNone/>
+            </a:pPr>
+            <a:r>
+              <a:rPr lang="en-US" sz="1000" b="1" spc="200" kern="0" dirty="0">
+                <a:solidFill>
+                  <a:srgbClr val="8A93FF"/>
+                </a:solidFill>
+                <a:latin typeface="Calibri" pitchFamily="34" charset="0"/>
+                <a:ea typeface="Calibri" pitchFamily="34" charset="-122"/>
+                <a:cs typeface="Calibri" pitchFamily="34" charset="-120"/>
+              </a:rPr>
+              <a:t>SALIDA DEL ESCÁNER</a:t>
+            </a:r>
+            <a:endParaRPr lang="en-US" sz="1000" dirty="0"/>
+          </a:p>
+        </p:txBody>
+      </p:sp>
+      <p:sp>
+        <p:nvSpPr>
+          <p:cNvPr id="5" name="Text 3"/>
+          <p:cNvSpPr/>
+          <p:nvPr/>
+        </p:nvSpPr>
+        <p:spPr>
+          <a:xfrm>
+            <a:off x="1188720" y="2880360"/>
+            <a:ext cx="1051560" cy="365760"/>
+          </a:xfrm>
+          <a:prstGeom prst="rect">
+            <a:avLst/>
+          </a:prstGeom>
+          <a:noFill/>
+          <a:ln/>
+        </p:spPr>
+        <p:txBody>
+          <a:bodyPr wrap="square" lIns="0" tIns="0" rIns="0" bIns="0" rtlCol="0" anchor="ctr"/>
+          <a:lstStyle/>
+          <a:p>
+            <a:pPr indent="0" marL="0">
+              <a:buNone/>
+            </a:pPr>
+            <a:r>
+              <a:rPr lang="en-US" sz="1500" b="1" dirty="0">
+                <a:solidFill>
+                  <a:srgbClr val="FFFFFF"/>
+                </a:solidFill>
+                <a:latin typeface="Courier New" pitchFamily="34" charset="0"/>
+                <a:ea typeface="Courier New" pitchFamily="34" charset="-122"/>
+                <a:cs typeface="Courier New" pitchFamily="34" charset="-120"/>
+              </a:rPr>
+              <a:t>P0301</a:t>
+            </a:r>
+            <a:endParaRPr lang="en-US" sz="1500" dirty="0"/>
+          </a:p>
+        </p:txBody>
+      </p:sp>
+      <p:sp>
+        <p:nvSpPr>
+          <p:cNvPr id="6" name="Text 4"/>
+          <p:cNvSpPr/>
+          <p:nvPr/>
+        </p:nvSpPr>
+        <p:spPr>
+          <a:xfrm>
+            <a:off x="2377440" y="2880360"/>
+            <a:ext cx="3931920" cy="365760"/>
+          </a:xfrm>
+          <a:prstGeom prst="rect">
+            <a:avLst/>
+          </a:prstGeom>
+          <a:noFill/>
+          <a:ln/>
+        </p:spPr>
+        <p:txBody>
+          <a:bodyPr wrap="square" lIns="0" tIns="0" rIns="0" bIns="0" rtlCol="0" anchor="ctr"/>
+          <a:lstStyle/>
+          <a:p>
+            <a:pPr indent="0" marL="0">
+              <a:buNone/>
+            </a:pPr>
+            <a:r>
+              <a:rPr lang="en-US" sz="1400" dirty="0">
+                <a:solidFill>
+                  <a:srgbClr val="B8BCCC"/>
+                </a:solidFill>
+                <a:latin typeface="Calibri" pitchFamily="34" charset="0"/>
+                <a:ea typeface="Calibri" pitchFamily="34" charset="-122"/>
+                <a:cs typeface="Calibri" pitchFamily="34" charset="-120"/>
+              </a:rPr>
+              <a:t>Fallo de encendido en el cilindro 1</a:t>
+            </a:r>
+            <a:endParaRPr lang="en-US" sz="1400" dirty="0"/>
+          </a:p>
+        </p:txBody>
+      </p:sp>
+      <p:sp>
+        <p:nvSpPr>
+          <p:cNvPr id="7" name="Text 5"/>
+          <p:cNvSpPr/>
+          <p:nvPr/>
+        </p:nvSpPr>
+        <p:spPr>
+          <a:xfrm>
+            <a:off x="1188720" y="3538728"/>
+            <a:ext cx="1051560" cy="365760"/>
+          </a:xfrm>
+          <a:prstGeom prst="rect">
+            <a:avLst/>
+          </a:prstGeom>
+          <a:noFill/>
+          <a:ln/>
+        </p:spPr>
+        <p:txBody>
+          <a:bodyPr wrap="square" lIns="0" tIns="0" rIns="0" bIns="0" rtlCol="0" anchor="ctr"/>
+          <a:lstStyle/>
+          <a:p>
+            <a:pPr indent="0" marL="0">
+              <a:buNone/>
+            </a:pPr>
+            <a:r>
+              <a:rPr lang="en-US" sz="1500" b="1" dirty="0">
+                <a:solidFill>
+                  <a:srgbClr val="FFFFFF"/>
+                </a:solidFill>
+                <a:latin typeface="Courier New" pitchFamily="34" charset="0"/>
+                <a:ea typeface="Courier New" pitchFamily="34" charset="-122"/>
+                <a:cs typeface="Courier New" pitchFamily="34" charset="-120"/>
+              </a:rPr>
+              <a:t>P0401</a:t>
+            </a:r>
+            <a:endParaRPr lang="en-US" sz="1500" dirty="0"/>
+          </a:p>
+        </p:txBody>
+      </p:sp>
+      <p:sp>
+        <p:nvSpPr>
+          <p:cNvPr id="8" name="Text 6"/>
+          <p:cNvSpPr/>
+          <p:nvPr/>
+        </p:nvSpPr>
+        <p:spPr>
+          <a:xfrm>
+            <a:off x="2377440" y="3538728"/>
+            <a:ext cx="3931920" cy="365760"/>
+          </a:xfrm>
+          <a:prstGeom prst="rect">
+            <a:avLst/>
+          </a:prstGeom>
+          <a:noFill/>
+          <a:ln/>
+        </p:spPr>
+        <p:txBody>
+          <a:bodyPr wrap="square" lIns="0" tIns="0" rIns="0" bIns="0" rtlCol="0" anchor="ctr"/>
+          <a:lstStyle/>
+          <a:p>
+            <a:pPr indent="0" marL="0">
+              <a:buNone/>
+            </a:pPr>
+            <a:r>
+              <a:rPr lang="en-US" sz="1400" dirty="0">
+                <a:solidFill>
+                  <a:srgbClr val="B8BCCC"/>
+                </a:solidFill>
+                <a:latin typeface="Calibri" pitchFamily="34" charset="0"/>
+                <a:ea typeface="Calibri" pitchFamily="34" charset="-122"/>
+                <a:cs typeface="Calibri" pitchFamily="34" charset="-120"/>
+              </a:rPr>
+              <a:t>Flujo de EGR insuficiente</a:t>
+            </a:r>
+            <a:endParaRPr lang="en-US" sz="1400" dirty="0"/>
+          </a:p>
+        </p:txBody>
+      </p:sp>
+      <p:sp>
+        <p:nvSpPr>
+          <p:cNvPr id="9" name="Text 7"/>
+          <p:cNvSpPr/>
+          <p:nvPr/>
+        </p:nvSpPr>
+        <p:spPr>
+          <a:xfrm>
+            <a:off x="1188720" y="4197096"/>
+            <a:ext cx="1051560" cy="365760"/>
+          </a:xfrm>
+          <a:prstGeom prst="rect">
+            <a:avLst/>
+          </a:prstGeom>
+          <a:noFill/>
+          <a:ln/>
+        </p:spPr>
+        <p:txBody>
+          <a:bodyPr wrap="square" lIns="0" tIns="0" rIns="0" bIns="0" rtlCol="0" anchor="ctr"/>
+          <a:lstStyle/>
+          <a:p>
+            <a:pPr indent="0" marL="0">
+              <a:buNone/>
+            </a:pPr>
+            <a:r>
+              <a:rPr lang="en-US" sz="1500" b="1" dirty="0">
+                <a:solidFill>
+                  <a:srgbClr val="FFFFFF"/>
+                </a:solidFill>
+                <a:latin typeface="Courier New" pitchFamily="34" charset="0"/>
+                <a:ea typeface="Courier New" pitchFamily="34" charset="-122"/>
+                <a:cs typeface="Courier New" pitchFamily="34" charset="-120"/>
+              </a:rPr>
+              <a:t>P2002</a:t>
+            </a:r>
+            <a:endParaRPr lang="en-US" sz="1500" dirty="0"/>
+          </a:p>
+        </p:txBody>
+      </p:sp>
+      <p:sp>
+        <p:nvSpPr>
+          <p:cNvPr id="10" name="Text 8"/>
+          <p:cNvSpPr/>
+          <p:nvPr/>
+        </p:nvSpPr>
+        <p:spPr>
+          <a:xfrm>
+            <a:off x="2377440" y="4197096"/>
+            <a:ext cx="3931920" cy="365760"/>
+          </a:xfrm>
+          <a:prstGeom prst="rect">
+            <a:avLst/>
+          </a:prstGeom>
+          <a:noFill/>
+          <a:ln/>
+        </p:spPr>
+        <p:txBody>
+          <a:bodyPr wrap="square" lIns="0" tIns="0" rIns="0" bIns="0" rtlCol="0" anchor="ctr"/>
+          <a:lstStyle/>
+          <a:p>
+            <a:pPr indent="0" marL="0">
+              <a:buNone/>
+            </a:pPr>
+            <a:r>
+              <a:rPr lang="en-US" sz="1400" dirty="0">
+                <a:solidFill>
+                  <a:srgbClr val="B8BCCC"/>
+                </a:solidFill>
+                <a:latin typeface="Calibri" pitchFamily="34" charset="0"/>
+                <a:ea typeface="Calibri" pitchFamily="34" charset="-122"/>
+                <a:cs typeface="Calibri" pitchFamily="34" charset="-120"/>
+              </a:rPr>
+              <a:t>Filtro de partículas por debajo del umbral</a:t>
+            </a:r>
+            <a:endParaRPr lang="en-US" sz="1400" dirty="0"/>
+          </a:p>
+        </p:txBody>
+      </p:sp>
+      <p:sp>
+        <p:nvSpPr>
+          <p:cNvPr id="11" name="Text 9"/>
+          <p:cNvSpPr/>
+          <p:nvPr/>
+        </p:nvSpPr>
+        <p:spPr>
+          <a:xfrm>
+            <a:off x="1188720" y="4663440"/>
+            <a:ext cx="5120640" cy="274320"/>
+          </a:xfrm>
+          <a:prstGeom prst="rect">
+            <a:avLst/>
+          </a:prstGeom>
+          <a:noFill/>
+          <a:ln/>
+        </p:spPr>
+        <p:txBody>
+          <a:bodyPr wrap="square" lIns="0" tIns="0" rIns="0" bIns="0" rtlCol="0" anchor="ctr"/>
+          <a:lstStyle/>
+          <a:p>
+            <a:pPr indent="0" marL="0">
+              <a:buNone/>
+            </a:pPr>
+            <a:r>
+              <a:rPr lang="en-US" sz="1200" i="1" dirty="0">
+                <a:solidFill>
+                  <a:srgbClr val="6E7488"/>
+                </a:solidFill>
+                <a:latin typeface="Calibri" pitchFamily="34" charset="0"/>
+                <a:ea typeface="Calibri" pitchFamily="34" charset="-122"/>
+                <a:cs typeface="Calibri" pitchFamily="34" charset="-120"/>
+              </a:rPr>
+              <a:t>…y así hasta diez.</a:t>
+            </a:r>
+            <a:endParaRPr lang="en-US" sz="1200" dirty="0"/>
+          </a:p>
+        </p:txBody>
+      </p:sp>
+      <p:sp>
+        <p:nvSpPr>
+          <p:cNvPr id="12" name="Text 10"/>
+          <p:cNvSpPr/>
+          <p:nvPr/>
+        </p:nvSpPr>
+        <p:spPr>
+          <a:xfrm>
+            <a:off x="7178040" y="2331720"/>
+            <a:ext cx="4206240" cy="822960"/>
+          </a:xfrm>
+          <a:prstGeom prst="rect">
+            <a:avLst/>
+          </a:prstGeom>
+          <a:noFill/>
+          <a:ln/>
+        </p:spPr>
+        <p:txBody>
+          <a:bodyPr wrap="square" lIns="0" tIns="0" rIns="0" bIns="0" rtlCol="0" anchor="t"/>
+          <a:lstStyle/>
+          <a:p>
+            <a:pPr indent="0" marL="0">
+              <a:buNone/>
+            </a:pPr>
+            <a:r>
+              <a:rPr lang="en-US" sz="4600" b="1" dirty="0">
+                <a:solidFill>
+                  <a:srgbClr val="202CFC"/>
+                </a:solidFill>
+                <a:latin typeface="Arial" pitchFamily="34" charset="0"/>
+                <a:ea typeface="Arial" pitchFamily="34" charset="-122"/>
+                <a:cs typeface="Arial" pitchFamily="34" charset="-120"/>
+              </a:rPr>
+              <a:t>¿Por qué?</a:t>
+            </a:r>
+            <a:endParaRPr lang="en-US" sz="4600" dirty="0"/>
+          </a:p>
+        </p:txBody>
+      </p:sp>
+      <p:sp>
+        <p:nvSpPr>
+          <p:cNvPr id="13" name="Text 11"/>
+          <p:cNvSpPr/>
+          <p:nvPr/>
+        </p:nvSpPr>
+        <p:spPr>
+          <a:xfrm>
+            <a:off x="7178040" y="3337560"/>
+            <a:ext cx="4206240" cy="1737360"/>
+          </a:xfrm>
+          <a:prstGeom prst="rect">
+            <a:avLst/>
+          </a:prstGeom>
+          <a:noFill/>
+          <a:ln/>
+        </p:spPr>
+        <p:txBody>
+          <a:bodyPr wrap="square" lIns="0" tIns="0" rIns="0" bIns="0" rtlCol="0" anchor="t"/>
+          <a:lstStyle/>
+          <a:p>
+            <a:pPr indent="0" marL="0">
+              <a:lnSpc>
+                <a:spcPts val="2600"/>
+              </a:lnSpc>
+              <a:buNone/>
+            </a:pPr>
+            <a:r>
+              <a:rPr lang="en-US" sz="1700" dirty="0">
+                <a:solidFill>
+                  <a:srgbClr val="1A1C2E"/>
+                </a:solidFill>
+                <a:latin typeface="Calibri" pitchFamily="34" charset="0"/>
+                <a:ea typeface="Calibri" pitchFamily="34" charset="-122"/>
+                <a:cs typeface="Calibri" pitchFamily="34" charset="-120"/>
+              </a:rPr>
+              <a:t>La válvula se obstruye por algo.</a:t>
+            </a:r>
+            <a:endParaRPr lang="en-US" sz="1700" dirty="0"/>
+          </a:p>
+          <a:p>
+            <a:pPr indent="0" marL="0">
+              <a:lnSpc>
+                <a:spcPts val="2600"/>
+              </a:lnSpc>
+              <a:buNone/>
+            </a:pPr>
+            <a:r>
+              <a:rPr lang="en-US" sz="1700" dirty="0">
+                <a:solidFill>
+                  <a:srgbClr val="1A1C2E"/>
+                </a:solidFill>
+                <a:latin typeface="Calibri" pitchFamily="34" charset="0"/>
+                <a:ea typeface="Calibri" pitchFamily="34" charset="-122"/>
+                <a:cs typeface="Calibri" pitchFamily="34" charset="-120"/>
+              </a:rPr>
+              <a:t>El filtro se llena por algo.</a:t>
+            </a:r>
+            <a:endParaRPr lang="en-US" sz="1700" dirty="0"/>
+          </a:p>
+          <a:p>
+            <a:pPr indent="0" marL="0">
+              <a:lnSpc>
+                <a:spcPts val="2600"/>
+              </a:lnSpc>
+              <a:buNone/>
+            </a:pPr>
+            <a:endParaRPr lang="en-US" sz="1700" dirty="0"/>
+          </a:p>
+          <a:p>
+            <a:pPr indent="0" marL="0">
+              <a:lnSpc>
+                <a:spcPts val="2600"/>
+              </a:lnSpc>
+              <a:buNone/>
+            </a:pPr>
+            <a:r>
+              <a:rPr lang="en-US" sz="1700" dirty="0">
+                <a:solidFill>
+                  <a:srgbClr val="1A1C2E"/>
+                </a:solidFill>
+                <a:latin typeface="Calibri" pitchFamily="34" charset="0"/>
+                <a:ea typeface="Calibri" pitchFamily="34" charset="-122"/>
+                <a:cs typeface="Calibri" pitchFamily="34" charset="-120"/>
+              </a:rPr>
+              <a:t>Eso la máquina no te lo dice.</a:t>
+            </a:r>
+            <a:endParaRPr lang="en-US" sz="1700" dirty="0"/>
+          </a:p>
+        </p:txBody>
+      </p:sp>
+      <p:sp>
+        <p:nvSpPr>
+          <p:cNvPr id="14" name="Shape 12"/>
+          <p:cNvSpPr/>
+          <p:nvPr/>
+        </p:nvSpPr>
+        <p:spPr>
+          <a:xfrm>
+            <a:off x="777240" y="6263640"/>
+            <a:ext cx="219456" cy="219456"/>
+          </a:xfrm>
+          <a:prstGeom prst="rect">
+            <a:avLst/>
+          </a:prstGeom>
+          <a:solidFill>
+            <a:srgbClr val="202CFC"/>
+          </a:solidFill>
+          <a:ln/>
+        </p:spPr>
+      </p:sp>
+      <p:sp>
+        <p:nvSpPr>
+          <p:cNvPr id="15" name="Text 13"/>
+          <p:cNvSpPr/>
+          <p:nvPr/>
+        </p:nvSpPr>
+        <p:spPr>
+          <a:xfrm>
+            <a:off x="777240" y="6263640"/>
+            <a:ext cx="219456" cy="219456"/>
+          </a:xfrm>
+          <a:prstGeom prst="rect">
+            <a:avLst/>
+          </a:prstGeom>
+          <a:noFill/>
+          <a:ln/>
+        </p:spPr>
+        <p:txBody>
+          <a:bodyPr wrap="square" lIns="0" tIns="0" rIns="0" bIns="0" rtlCol="0" anchor="ctr"/>
+          <a:lstStyle/>
+          <a:p>
+            <a:pPr algn="ctr" indent="0" marL="0">
+              <a:buNone/>
+            </a:pPr>
+            <a:r>
+              <a:rPr lang="en-US" sz="816" b="1" dirty="0">
+                <a:solidFill>
+                  <a:srgbClr val="FFFFFF"/>
+                </a:solidFill>
+                <a:latin typeface="Arial" pitchFamily="34" charset="0"/>
+                <a:ea typeface="Arial" pitchFamily="34" charset="-122"/>
+                <a:cs typeface="Arial" pitchFamily="34" charset="-120"/>
+              </a:rPr>
+              <a:t>BIG</a:t>
+            </a:r>
+            <a:endParaRPr lang="en-US" sz="816" dirty="0"/>
+          </a:p>
+        </p:txBody>
+      </p:sp>
+      <p:sp>
+        <p:nvSpPr>
+          <p:cNvPr id="16" name="Text 14"/>
+          <p:cNvSpPr/>
+          <p:nvPr/>
+        </p:nvSpPr>
+        <p:spPr>
+          <a:xfrm>
+            <a:off x="1078992" y="6263640"/>
+            <a:ext cx="658368" cy="219456"/>
+          </a:xfrm>
+          <a:prstGeom prst="rect">
+            <a:avLst/>
+          </a:prstGeom>
+          <a:noFill/>
+          <a:ln/>
+        </p:spPr>
+        <p:txBody>
+          <a:bodyPr wrap="square" lIns="0" tIns="0" rIns="0" bIns="0" rtlCol="0" anchor="ctr"/>
+          <a:lstStyle/>
+          <a:p>
+            <a:pPr algn="l" indent="0" marL="0">
+              <a:buNone/>
+            </a:pPr>
+            <a:r>
+              <a:rPr lang="en-US" sz="816" dirty="0">
+                <a:solidFill>
+                  <a:srgbClr val="1A1C2E"/>
+                </a:solidFill>
+                <a:latin typeface="Arial" pitchFamily="34" charset="0"/>
+                <a:ea typeface="Arial" pitchFamily="34" charset="-122"/>
+                <a:cs typeface="Arial" pitchFamily="34" charset="-120"/>
+              </a:rPr>
+              <a:t>school</a:t>
+            </a:r>
+            <a:endParaRPr lang="en-US" sz="816" dirty="0"/>
+          </a:p>
+        </p:txBody>
+      </p:sp>
+      <p:sp>
+        <p:nvSpPr>
+          <p:cNvPr id="17" name="Text 15"/>
+          <p:cNvSpPr/>
+          <p:nvPr/>
+        </p:nvSpPr>
+        <p:spPr>
+          <a:xfrm>
+            <a:off x="11064240" y="6263640"/>
+            <a:ext cx="320040" cy="219456"/>
+          </a:xfrm>
+          <a:prstGeom prst="rect">
+            <a:avLst/>
+          </a:prstGeom>
+          <a:noFill/>
+          <a:ln/>
+        </p:spPr>
+        <p:txBody>
+          <a:bodyPr wrap="square" lIns="0" tIns="0" rIns="0" bIns="0" rtlCol="0" anchor="ctr"/>
+          <a:lstStyle/>
+          <a:p>
+            <a:pPr algn="r" indent="0" marL="0">
+              <a:buNone/>
+            </a:pPr>
+            <a:r>
+              <a:rPr lang="en-US" sz="1000" dirty="0">
+                <a:solidFill>
+                  <a:srgbClr val="5A5F73"/>
+                </a:solidFill>
+                <a:latin typeface="Calibri" pitchFamily="34" charset="0"/>
+                <a:ea typeface="Calibri" pitchFamily="34" charset="-122"/>
+                <a:cs typeface="Calibri" pitchFamily="34" charset="-120"/>
+              </a:rPr>
+              <a:t>2</a:t>
+            </a:r>
+            <a:endParaRPr lang="en-US" sz="1000" dirty="0"/>
+          </a:p>
+        </p:txBody>
+      </p:sp>
     </p:spTree>
   </p:cSld>
   <p:clrMapOvr>

</xml_diff>

<commit_message>
docs(tfm): problema en dos columnas, sin cuadros
</commit_message>
<xml_diff>
--- a/docs/presentacion/tfm-intelligent-automotive-diagnostics.pptx
+++ b/docs/presentacion/tfm-intelligent-automotive-diagnostics.pptx
@@ -596,7 +596,7 @@
               <a:rPr lang="en-US" dirty="0"/>
               <a:t>Hoy llegas con una máquina de diagnosis, la conectas, y te da diez códigos de error. Cada uno te dice una cosa: válvula EGR obstruida, filtro de partículas lleno.
 Vale. Pero esa válvula se ha obstruido por alguna circunstancia, y ese filtro se ha llenado por alguna circunstancia. Y eso la máquina no te lo dice.
-El mecánico se queda con la lista delante y el trabajo de averiguar el porqué sigue entero por hacer.
+Te deja la lista delante, y el trabajo de averiguar el porqué sigue entero por hacer.
 [~45 s]</a:t>
             </a:r>
             <a:endParaRPr lang="en-US" dirty="0"/>
@@ -1411,36 +1411,14 @@
       </p:sp>
       <p:sp>
         <p:nvSpPr>
-          <p:cNvPr id="3" name="Shape 1"/>
+          <p:cNvPr id="3" name="Text 1"/>
           <p:cNvSpPr/>
           <p:nvPr/>
         </p:nvSpPr>
         <p:spPr>
           <a:xfrm>
-            <a:off x="777240" y="1920240"/>
-            <a:ext cx="5943600" cy="3246120"/>
-          </a:xfrm>
-          <a:prstGeom prst="roundRect">
-            <a:avLst>
-              <a:gd name="adj" fmla="val 1690"/>
-            </a:avLst>
-          </a:prstGeom>
-          <a:solidFill>
-            <a:srgbClr val="1A1C2E"/>
-          </a:solidFill>
-          <a:ln/>
-        </p:spPr>
-      </p:sp>
-      <p:sp>
-        <p:nvSpPr>
-          <p:cNvPr id="4" name="Text 2"/>
-          <p:cNvSpPr/>
-          <p:nvPr/>
-        </p:nvSpPr>
-        <p:spPr>
-          <a:xfrm>
-            <a:off x="1188720" y="2304288"/>
-            <a:ext cx="5120640" cy="256032"/>
+            <a:off x="777240" y="2011680"/>
+            <a:ext cx="4846320" cy="365760"/>
           </a:xfrm>
           <a:prstGeom prst="rect">
             <a:avLst/>
@@ -1449,326 +1427,14 @@
           <a:ln/>
         </p:spPr>
         <p:txBody>
-          <a:bodyPr wrap="square" lIns="0" tIns="0" rIns="0" bIns="0" rtlCol="0" anchor="ctr"/>
+          <a:bodyPr wrap="square" lIns="0" tIns="0" rIns="0" bIns="0" rtlCol="0" anchor="t"/>
           <a:lstStyle/>
           <a:p>
             <a:pPr indent="0" marL="0">
               <a:buNone/>
             </a:pPr>
             <a:r>
-              <a:rPr lang="en-US" sz="1000" b="1" spc="200" kern="0" dirty="0">
-                <a:solidFill>
-                  <a:srgbClr val="8A93FF"/>
-                </a:solidFill>
-                <a:latin typeface="Calibri" pitchFamily="34" charset="0"/>
-                <a:ea typeface="Calibri" pitchFamily="34" charset="-122"/>
-                <a:cs typeface="Calibri" pitchFamily="34" charset="-120"/>
-              </a:rPr>
-              <a:t>SALIDA DEL ESCÁNER</a:t>
-            </a:r>
-            <a:endParaRPr lang="en-US" sz="1000" dirty="0"/>
-          </a:p>
-        </p:txBody>
-      </p:sp>
-      <p:sp>
-        <p:nvSpPr>
-          <p:cNvPr id="5" name="Text 3"/>
-          <p:cNvSpPr/>
-          <p:nvPr/>
-        </p:nvSpPr>
-        <p:spPr>
-          <a:xfrm>
-            <a:off x="1188720" y="2880360"/>
-            <a:ext cx="1051560" cy="365760"/>
-          </a:xfrm>
-          <a:prstGeom prst="rect">
-            <a:avLst/>
-          </a:prstGeom>
-          <a:noFill/>
-          <a:ln/>
-        </p:spPr>
-        <p:txBody>
-          <a:bodyPr wrap="square" lIns="0" tIns="0" rIns="0" bIns="0" rtlCol="0" anchor="ctr"/>
-          <a:lstStyle/>
-          <a:p>
-            <a:pPr indent="0" marL="0">
-              <a:buNone/>
-            </a:pPr>
-            <a:r>
-              <a:rPr lang="en-US" sz="1500" b="1" dirty="0">
-                <a:solidFill>
-                  <a:srgbClr val="FFFFFF"/>
-                </a:solidFill>
-                <a:latin typeface="Courier New" pitchFamily="34" charset="0"/>
-                <a:ea typeface="Courier New" pitchFamily="34" charset="-122"/>
-                <a:cs typeface="Courier New" pitchFamily="34" charset="-120"/>
-              </a:rPr>
-              <a:t>P0301</a:t>
-            </a:r>
-            <a:endParaRPr lang="en-US" sz="1500" dirty="0"/>
-          </a:p>
-        </p:txBody>
-      </p:sp>
-      <p:sp>
-        <p:nvSpPr>
-          <p:cNvPr id="6" name="Text 4"/>
-          <p:cNvSpPr/>
-          <p:nvPr/>
-        </p:nvSpPr>
-        <p:spPr>
-          <a:xfrm>
-            <a:off x="2377440" y="2880360"/>
-            <a:ext cx="3931920" cy="365760"/>
-          </a:xfrm>
-          <a:prstGeom prst="rect">
-            <a:avLst/>
-          </a:prstGeom>
-          <a:noFill/>
-          <a:ln/>
-        </p:spPr>
-        <p:txBody>
-          <a:bodyPr wrap="square" lIns="0" tIns="0" rIns="0" bIns="0" rtlCol="0" anchor="ctr"/>
-          <a:lstStyle/>
-          <a:p>
-            <a:pPr indent="0" marL="0">
-              <a:buNone/>
-            </a:pPr>
-            <a:r>
-              <a:rPr lang="en-US" sz="1400" dirty="0">
-                <a:solidFill>
-                  <a:srgbClr val="B8BCCC"/>
-                </a:solidFill>
-                <a:latin typeface="Calibri" pitchFamily="34" charset="0"/>
-                <a:ea typeface="Calibri" pitchFamily="34" charset="-122"/>
-                <a:cs typeface="Calibri" pitchFamily="34" charset="-120"/>
-              </a:rPr>
-              <a:t>Fallo de encendido en el cilindro 1</a:t>
-            </a:r>
-            <a:endParaRPr lang="en-US" sz="1400" dirty="0"/>
-          </a:p>
-        </p:txBody>
-      </p:sp>
-      <p:sp>
-        <p:nvSpPr>
-          <p:cNvPr id="7" name="Text 5"/>
-          <p:cNvSpPr/>
-          <p:nvPr/>
-        </p:nvSpPr>
-        <p:spPr>
-          <a:xfrm>
-            <a:off x="1188720" y="3538728"/>
-            <a:ext cx="1051560" cy="365760"/>
-          </a:xfrm>
-          <a:prstGeom prst="rect">
-            <a:avLst/>
-          </a:prstGeom>
-          <a:noFill/>
-          <a:ln/>
-        </p:spPr>
-        <p:txBody>
-          <a:bodyPr wrap="square" lIns="0" tIns="0" rIns="0" bIns="0" rtlCol="0" anchor="ctr"/>
-          <a:lstStyle/>
-          <a:p>
-            <a:pPr indent="0" marL="0">
-              <a:buNone/>
-            </a:pPr>
-            <a:r>
-              <a:rPr lang="en-US" sz="1500" b="1" dirty="0">
-                <a:solidFill>
-                  <a:srgbClr val="FFFFFF"/>
-                </a:solidFill>
-                <a:latin typeface="Courier New" pitchFamily="34" charset="0"/>
-                <a:ea typeface="Courier New" pitchFamily="34" charset="-122"/>
-                <a:cs typeface="Courier New" pitchFamily="34" charset="-120"/>
-              </a:rPr>
-              <a:t>P0401</a:t>
-            </a:r>
-            <a:endParaRPr lang="en-US" sz="1500" dirty="0"/>
-          </a:p>
-        </p:txBody>
-      </p:sp>
-      <p:sp>
-        <p:nvSpPr>
-          <p:cNvPr id="8" name="Text 6"/>
-          <p:cNvSpPr/>
-          <p:nvPr/>
-        </p:nvSpPr>
-        <p:spPr>
-          <a:xfrm>
-            <a:off x="2377440" y="3538728"/>
-            <a:ext cx="3931920" cy="365760"/>
-          </a:xfrm>
-          <a:prstGeom prst="rect">
-            <a:avLst/>
-          </a:prstGeom>
-          <a:noFill/>
-          <a:ln/>
-        </p:spPr>
-        <p:txBody>
-          <a:bodyPr wrap="square" lIns="0" tIns="0" rIns="0" bIns="0" rtlCol="0" anchor="ctr"/>
-          <a:lstStyle/>
-          <a:p>
-            <a:pPr indent="0" marL="0">
-              <a:buNone/>
-            </a:pPr>
-            <a:r>
-              <a:rPr lang="en-US" sz="1400" dirty="0">
-                <a:solidFill>
-                  <a:srgbClr val="B8BCCC"/>
-                </a:solidFill>
-                <a:latin typeface="Calibri" pitchFamily="34" charset="0"/>
-                <a:ea typeface="Calibri" pitchFamily="34" charset="-122"/>
-                <a:cs typeface="Calibri" pitchFamily="34" charset="-120"/>
-              </a:rPr>
-              <a:t>Flujo de EGR insuficiente</a:t>
-            </a:r>
-            <a:endParaRPr lang="en-US" sz="1400" dirty="0"/>
-          </a:p>
-        </p:txBody>
-      </p:sp>
-      <p:sp>
-        <p:nvSpPr>
-          <p:cNvPr id="9" name="Text 7"/>
-          <p:cNvSpPr/>
-          <p:nvPr/>
-        </p:nvSpPr>
-        <p:spPr>
-          <a:xfrm>
-            <a:off x="1188720" y="4197096"/>
-            <a:ext cx="1051560" cy="365760"/>
-          </a:xfrm>
-          <a:prstGeom prst="rect">
-            <a:avLst/>
-          </a:prstGeom>
-          <a:noFill/>
-          <a:ln/>
-        </p:spPr>
-        <p:txBody>
-          <a:bodyPr wrap="square" lIns="0" tIns="0" rIns="0" bIns="0" rtlCol="0" anchor="ctr"/>
-          <a:lstStyle/>
-          <a:p>
-            <a:pPr indent="0" marL="0">
-              <a:buNone/>
-            </a:pPr>
-            <a:r>
-              <a:rPr lang="en-US" sz="1500" b="1" dirty="0">
-                <a:solidFill>
-                  <a:srgbClr val="FFFFFF"/>
-                </a:solidFill>
-                <a:latin typeface="Courier New" pitchFamily="34" charset="0"/>
-                <a:ea typeface="Courier New" pitchFamily="34" charset="-122"/>
-                <a:cs typeface="Courier New" pitchFamily="34" charset="-120"/>
-              </a:rPr>
-              <a:t>P2002</a:t>
-            </a:r>
-            <a:endParaRPr lang="en-US" sz="1500" dirty="0"/>
-          </a:p>
-        </p:txBody>
-      </p:sp>
-      <p:sp>
-        <p:nvSpPr>
-          <p:cNvPr id="10" name="Text 8"/>
-          <p:cNvSpPr/>
-          <p:nvPr/>
-        </p:nvSpPr>
-        <p:spPr>
-          <a:xfrm>
-            <a:off x="2377440" y="4197096"/>
-            <a:ext cx="3931920" cy="365760"/>
-          </a:xfrm>
-          <a:prstGeom prst="rect">
-            <a:avLst/>
-          </a:prstGeom>
-          <a:noFill/>
-          <a:ln/>
-        </p:spPr>
-        <p:txBody>
-          <a:bodyPr wrap="square" lIns="0" tIns="0" rIns="0" bIns="0" rtlCol="0" anchor="ctr"/>
-          <a:lstStyle/>
-          <a:p>
-            <a:pPr indent="0" marL="0">
-              <a:buNone/>
-            </a:pPr>
-            <a:r>
-              <a:rPr lang="en-US" sz="1400" dirty="0">
-                <a:solidFill>
-                  <a:srgbClr val="B8BCCC"/>
-                </a:solidFill>
-                <a:latin typeface="Calibri" pitchFamily="34" charset="0"/>
-                <a:ea typeface="Calibri" pitchFamily="34" charset="-122"/>
-                <a:cs typeface="Calibri" pitchFamily="34" charset="-120"/>
-              </a:rPr>
-              <a:t>Filtro de partículas por debajo del umbral</a:t>
-            </a:r>
-            <a:endParaRPr lang="en-US" sz="1400" dirty="0"/>
-          </a:p>
-        </p:txBody>
-      </p:sp>
-      <p:sp>
-        <p:nvSpPr>
-          <p:cNvPr id="11" name="Text 9"/>
-          <p:cNvSpPr/>
-          <p:nvPr/>
-        </p:nvSpPr>
-        <p:spPr>
-          <a:xfrm>
-            <a:off x="1188720" y="4663440"/>
-            <a:ext cx="5120640" cy="274320"/>
-          </a:xfrm>
-          <a:prstGeom prst="rect">
-            <a:avLst/>
-          </a:prstGeom>
-          <a:noFill/>
-          <a:ln/>
-        </p:spPr>
-        <p:txBody>
-          <a:bodyPr wrap="square" lIns="0" tIns="0" rIns="0" bIns="0" rtlCol="0" anchor="ctr"/>
-          <a:lstStyle/>
-          <a:p>
-            <a:pPr indent="0" marL="0">
-              <a:buNone/>
-            </a:pPr>
-            <a:r>
-              <a:rPr lang="en-US" sz="1200" i="1" dirty="0">
-                <a:solidFill>
-                  <a:srgbClr val="6E7488"/>
-                </a:solidFill>
-                <a:latin typeface="Calibri" pitchFamily="34" charset="0"/>
-                <a:ea typeface="Calibri" pitchFamily="34" charset="-122"/>
-                <a:cs typeface="Calibri" pitchFamily="34" charset="-120"/>
-              </a:rPr>
-              <a:t>…y así hasta diez.</a:t>
-            </a:r>
-            <a:endParaRPr lang="en-US" sz="1200" dirty="0"/>
-          </a:p>
-        </p:txBody>
-      </p:sp>
-      <p:sp>
-        <p:nvSpPr>
-          <p:cNvPr id="12" name="Text 10"/>
-          <p:cNvSpPr/>
-          <p:nvPr/>
-        </p:nvSpPr>
-        <p:spPr>
-          <a:xfrm>
-            <a:off x="7178040" y="2331720"/>
-            <a:ext cx="4206240" cy="822960"/>
-          </a:xfrm>
-          <a:prstGeom prst="rect">
-            <a:avLst/>
-          </a:prstGeom>
-          <a:noFill/>
-          <a:ln/>
-        </p:spPr>
-        <p:txBody>
-          <a:bodyPr wrap="square" lIns="0" tIns="0" rIns="0" bIns="0" rtlCol="0" anchor="t"/>
-          <a:lstStyle/>
-          <a:p>
-            <a:pPr indent="0" marL="0">
-              <a:buNone/>
-            </a:pPr>
-            <a:r>
-              <a:rPr lang="en-US" sz="4600" b="1" dirty="0">
+              <a:rPr lang="en-US" sz="2000" b="1" dirty="0">
                 <a:solidFill>
                   <a:srgbClr val="202CFC"/>
                 </a:solidFill>
@@ -1776,22 +1442,22 @@
                 <a:ea typeface="Arial" pitchFamily="34" charset="-122"/>
                 <a:cs typeface="Arial" pitchFamily="34" charset="-120"/>
               </a:rPr>
-              <a:t>¿Por qué?</a:t>
-            </a:r>
-            <a:endParaRPr lang="en-US" sz="4600" dirty="0"/>
-          </a:p>
-        </p:txBody>
-      </p:sp>
-      <p:sp>
-        <p:nvSpPr>
-          <p:cNvPr id="13" name="Text 11"/>
+              <a:t>Te da</a:t>
+            </a:r>
+            <a:endParaRPr lang="en-US" sz="2000" dirty="0"/>
+          </a:p>
+        </p:txBody>
+      </p:sp>
+      <p:sp>
+        <p:nvSpPr>
+          <p:cNvPr id="4" name="Text 2"/>
           <p:cNvSpPr/>
           <p:nvPr/>
         </p:nvSpPr>
         <p:spPr>
           <a:xfrm>
-            <a:off x="7178040" y="3337560"/>
-            <a:ext cx="4206240" cy="1737360"/>
+            <a:off x="777240" y="2606040"/>
+            <a:ext cx="4846320" cy="2377440"/>
           </a:xfrm>
           <a:prstGeom prst="rect">
             <a:avLst/>
@@ -1803,14 +1469,18 @@
           <a:bodyPr wrap="square" lIns="0" tIns="0" rIns="0" bIns="0" rtlCol="0" anchor="t"/>
           <a:lstStyle/>
           <a:p>
-            <a:pPr indent="0" marL="0">
+            <a:pPr marL="342900" indent="-342900">
               <a:lnSpc>
-                <a:spcPts val="2600"/>
+                <a:spcPts val="2200"/>
               </a:lnSpc>
-              <a:buNone/>
+              <a:spcAft>
+                <a:spcPts val="1000"/>
+              </a:spcAft>
+              <a:buSzPct val="100000"/>
+              <a:buChar char="•"/>
             </a:pPr>
             <a:r>
-              <a:rPr lang="en-US" sz="1700" dirty="0">
+              <a:rPr lang="en-US" sz="1600" dirty="0">
                 <a:solidFill>
                   <a:srgbClr val="1A1C2E"/>
                 </a:solidFill>
@@ -1818,19 +1488,23 @@
                 <a:ea typeface="Calibri" pitchFamily="34" charset="-122"/>
                 <a:cs typeface="Calibri" pitchFamily="34" charset="-120"/>
               </a:rPr>
-              <a:t>La válvula se obstruye por algo.</a:t>
-            </a:r>
-            <a:endParaRPr lang="en-US" sz="1700" dirty="0"/>
-          </a:p>
-          <a:p>
-            <a:pPr indent="0" marL="0">
+              <a:t>P0301   Fallo de encendido en el cilindro 1</a:t>
+            </a:r>
+            <a:endParaRPr lang="en-US" sz="1600" dirty="0"/>
+          </a:p>
+          <a:p>
+            <a:pPr marL="342900" indent="-342900">
               <a:lnSpc>
-                <a:spcPts val="2600"/>
+                <a:spcPts val="2200"/>
               </a:lnSpc>
-              <a:buNone/>
+              <a:spcAft>
+                <a:spcPts val="1000"/>
+              </a:spcAft>
+              <a:buSzPct val="100000"/>
+              <a:buChar char="•"/>
             </a:pPr>
             <a:r>
-              <a:rPr lang="en-US" sz="1700" dirty="0">
+              <a:rPr lang="en-US" sz="1600" dirty="0">
                 <a:solidFill>
                   <a:srgbClr val="1A1C2E"/>
                 </a:solidFill>
@@ -1838,28 +1512,23 @@
                 <a:ea typeface="Calibri" pitchFamily="34" charset="-122"/>
                 <a:cs typeface="Calibri" pitchFamily="34" charset="-120"/>
               </a:rPr>
-              <a:t>El filtro se llena por algo.</a:t>
-            </a:r>
-            <a:endParaRPr lang="en-US" sz="1700" dirty="0"/>
-          </a:p>
-          <a:p>
-            <a:pPr indent="0" marL="0">
+              <a:t>P0401   Válvula EGR obstruida</a:t>
+            </a:r>
+            <a:endParaRPr lang="en-US" sz="1600" dirty="0"/>
+          </a:p>
+          <a:p>
+            <a:pPr marL="342900" indent="-342900">
               <a:lnSpc>
-                <a:spcPts val="2600"/>
+                <a:spcPts val="2200"/>
               </a:lnSpc>
-              <a:buNone/>
+              <a:spcAft>
+                <a:spcPts val="1000"/>
+              </a:spcAft>
+              <a:buSzPct val="100000"/>
+              <a:buChar char="•"/>
             </a:pPr>
-            <a:endParaRPr lang="en-US" sz="1700" dirty="0"/>
-          </a:p>
-          <a:p>
-            <a:pPr indent="0" marL="0">
-              <a:lnSpc>
-                <a:spcPts val="2600"/>
-              </a:lnSpc>
-              <a:buNone/>
-            </a:pPr>
-            <a:r>
-              <a:rPr lang="en-US" sz="1700" dirty="0">
+            <a:r>
+              <a:rPr lang="en-US" sz="1600" dirty="0">
                 <a:solidFill>
                   <a:srgbClr val="1A1C2E"/>
                 </a:solidFill>
@@ -1867,20 +1536,201 @@
                 <a:ea typeface="Calibri" pitchFamily="34" charset="-122"/>
                 <a:cs typeface="Calibri" pitchFamily="34" charset="-120"/>
               </a:rPr>
-              <a:t>Eso la máquina no te lo dice.</a:t>
-            </a:r>
-            <a:endParaRPr lang="en-US" sz="1700" dirty="0"/>
-          </a:p>
-        </p:txBody>
-      </p:sp>
-      <p:sp>
-        <p:nvSpPr>
-          <p:cNvPr id="14" name="Shape 12"/>
+              <a:t>P2002   Filtro de partículas lleno</a:t>
+            </a:r>
+            <a:endParaRPr lang="en-US" sz="1600" dirty="0"/>
+          </a:p>
+          <a:p>
+            <a:pPr marL="342900" indent="-342900">
+              <a:lnSpc>
+                <a:spcPts val="2200"/>
+              </a:lnSpc>
+              <a:spcAft>
+                <a:spcPts val="1000"/>
+              </a:spcAft>
+              <a:buSzPct val="100000"/>
+              <a:buChar char="•"/>
+            </a:pPr>
+            <a:r>
+              <a:rPr lang="en-US" sz="1600" dirty="0">
+                <a:solidFill>
+                  <a:srgbClr val="1A1C2E"/>
+                </a:solidFill>
+                <a:latin typeface="Calibri" pitchFamily="34" charset="0"/>
+                <a:ea typeface="Calibri" pitchFamily="34" charset="-122"/>
+                <a:cs typeface="Calibri" pitchFamily="34" charset="-120"/>
+              </a:rPr>
+              <a:t>Y así hasta diez</a:t>
+            </a:r>
+            <a:endParaRPr lang="en-US" sz="1600" dirty="0"/>
+          </a:p>
+        </p:txBody>
+      </p:sp>
+      <p:sp>
+        <p:nvSpPr>
+          <p:cNvPr id="5" name="Text 3"/>
           <p:cNvSpPr/>
           <p:nvPr/>
         </p:nvSpPr>
         <p:spPr>
           <a:xfrm>
+            <a:off x="6537960" y="2011680"/>
+            <a:ext cx="4846320" cy="365760"/>
+          </a:xfrm>
+          <a:prstGeom prst="rect">
+            <a:avLst/>
+          </a:prstGeom>
+          <a:noFill/>
+          <a:ln/>
+        </p:spPr>
+        <p:txBody>
+          <a:bodyPr wrap="square" lIns="0" tIns="0" rIns="0" bIns="0" rtlCol="0" anchor="t"/>
+          <a:lstStyle/>
+          <a:p>
+            <a:pPr indent="0" marL="0">
+              <a:buNone/>
+            </a:pPr>
+            <a:r>
+              <a:rPr lang="en-US" sz="2000" b="1" dirty="0">
+                <a:solidFill>
+                  <a:srgbClr val="202CFC"/>
+                </a:solidFill>
+                <a:latin typeface="Arial" pitchFamily="34" charset="0"/>
+                <a:ea typeface="Arial" pitchFamily="34" charset="-122"/>
+                <a:cs typeface="Arial" pitchFamily="34" charset="-120"/>
+              </a:rPr>
+              <a:t>No te da</a:t>
+            </a:r>
+            <a:endParaRPr lang="en-US" sz="2000" dirty="0"/>
+          </a:p>
+        </p:txBody>
+      </p:sp>
+      <p:sp>
+        <p:nvSpPr>
+          <p:cNvPr id="6" name="Text 4"/>
+          <p:cNvSpPr/>
+          <p:nvPr/>
+        </p:nvSpPr>
+        <p:spPr>
+          <a:xfrm>
+            <a:off x="6537960" y="2606040"/>
+            <a:ext cx="4846320" cy="2377440"/>
+          </a:xfrm>
+          <a:prstGeom prst="rect">
+            <a:avLst/>
+          </a:prstGeom>
+          <a:noFill/>
+          <a:ln/>
+        </p:spPr>
+        <p:txBody>
+          <a:bodyPr wrap="square" lIns="0" tIns="0" rIns="0" bIns="0" rtlCol="0" anchor="t"/>
+          <a:lstStyle/>
+          <a:p>
+            <a:pPr marL="342900" indent="-342900">
+              <a:lnSpc>
+                <a:spcPts val="2200"/>
+              </a:lnSpc>
+              <a:spcAft>
+                <a:spcPts val="1000"/>
+              </a:spcAft>
+              <a:buSzPct val="100000"/>
+              <a:buChar char="•"/>
+            </a:pPr>
+            <a:r>
+              <a:rPr lang="en-US" sz="1600" dirty="0">
+                <a:solidFill>
+                  <a:srgbClr val="1A1C2E"/>
+                </a:solidFill>
+                <a:latin typeface="Calibri" pitchFamily="34" charset="0"/>
+                <a:ea typeface="Calibri" pitchFamily="34" charset="-122"/>
+                <a:cs typeface="Calibri" pitchFamily="34" charset="-120"/>
+              </a:rPr>
+              <a:t>Por qué se ha obstruido la válvula</a:t>
+            </a:r>
+            <a:endParaRPr lang="en-US" sz="1600" dirty="0"/>
+          </a:p>
+          <a:p>
+            <a:pPr marL="342900" indent="-342900">
+              <a:lnSpc>
+                <a:spcPts val="2200"/>
+              </a:lnSpc>
+              <a:spcAft>
+                <a:spcPts val="1000"/>
+              </a:spcAft>
+              <a:buSzPct val="100000"/>
+              <a:buChar char="•"/>
+            </a:pPr>
+            <a:r>
+              <a:rPr lang="en-US" sz="1600" dirty="0">
+                <a:solidFill>
+                  <a:srgbClr val="1A1C2E"/>
+                </a:solidFill>
+                <a:latin typeface="Calibri" pitchFamily="34" charset="0"/>
+                <a:ea typeface="Calibri" pitchFamily="34" charset="-122"/>
+                <a:cs typeface="Calibri" pitchFamily="34" charset="-120"/>
+              </a:rPr>
+              <a:t>Por qué se ha llenado el filtro</a:t>
+            </a:r>
+            <a:endParaRPr lang="en-US" sz="1600" dirty="0"/>
+          </a:p>
+          <a:p>
+            <a:pPr marL="342900" indent="-342900">
+              <a:lnSpc>
+                <a:spcPts val="2200"/>
+              </a:lnSpc>
+              <a:spcAft>
+                <a:spcPts val="1000"/>
+              </a:spcAft>
+              <a:buSzPct val="100000"/>
+              <a:buChar char="•"/>
+            </a:pPr>
+            <a:r>
+              <a:rPr lang="en-US" sz="1600" dirty="0">
+                <a:solidFill>
+                  <a:srgbClr val="1A1C2E"/>
+                </a:solidFill>
+                <a:latin typeface="Calibri" pitchFamily="34" charset="0"/>
+                <a:ea typeface="Calibri" pitchFamily="34" charset="-122"/>
+                <a:cs typeface="Calibri" pitchFamily="34" charset="-120"/>
+              </a:rPr>
+              <a:t>Qué tiene que ver un código con otro</a:t>
+            </a:r>
+            <a:endParaRPr lang="en-US" sz="1600" dirty="0"/>
+          </a:p>
+          <a:p>
+            <a:pPr marL="342900" indent="-342900">
+              <a:lnSpc>
+                <a:spcPts val="2200"/>
+              </a:lnSpc>
+              <a:spcAft>
+                <a:spcPts val="1000"/>
+              </a:spcAft>
+              <a:buSzPct val="100000"/>
+              <a:buChar char="•"/>
+            </a:pPr>
+            <a:r>
+              <a:rPr lang="en-US" sz="1600" dirty="0">
+                <a:solidFill>
+                  <a:srgbClr val="1A1C2E"/>
+                </a:solidFill>
+                <a:latin typeface="Calibri" pitchFamily="34" charset="0"/>
+                <a:ea typeface="Calibri" pitchFamily="34" charset="-122"/>
+                <a:cs typeface="Calibri" pitchFamily="34" charset="-120"/>
+              </a:rPr>
+              <a:t>Por dónde empezar a mirar</a:t>
+            </a:r>
+            <a:endParaRPr lang="en-US" sz="1600" dirty="0"/>
+          </a:p>
+        </p:txBody>
+      </p:sp>
+      <p:sp>
+        <p:nvSpPr>
+          <p:cNvPr id="7" name="Shape 5"/>
+          <p:cNvSpPr/>
+          <p:nvPr/>
+        </p:nvSpPr>
+        <p:spPr>
+          <a:xfrm>
             <a:off x="777240" y="6263640"/>
             <a:ext cx="219456" cy="219456"/>
           </a:xfrm>
@@ -1895,7 +1745,7 @@
       </p:sp>
       <p:sp>
         <p:nvSpPr>
-          <p:cNvPr id="15" name="Text 13"/>
+          <p:cNvPr id="8" name="Text 6"/>
           <p:cNvSpPr/>
           <p:nvPr/>
         </p:nvSpPr>
@@ -1934,7 +1784,7 @@
       </p:sp>
       <p:sp>
         <p:nvSpPr>
-          <p:cNvPr id="16" name="Text 14"/>
+          <p:cNvPr id="9" name="Text 7"/>
           <p:cNvSpPr/>
           <p:nvPr/>
         </p:nvSpPr>
@@ -1973,7 +1823,7 @@
       </p:sp>
       <p:sp>
         <p:nvSpPr>
-          <p:cNvPr id="17" name="Text 15"/>
+          <p:cNvPr id="10" name="Text 8"/>
           <p:cNvSpPr/>
           <p:nvPr/>
         </p:nvSpPr>

</xml_diff>

<commit_message>
docs(tfm): slide del objetivo y marcar el problema validado
</commit_message>
<xml_diff>
--- a/docs/presentacion/tfm-intelligent-automotive-diagnostics.pptx
+++ b/docs/presentacion/tfm-intelligent-automotive-diagnostics.pptx
@@ -7,9 +7,10 @@
   <p:sldIdLst>
     <p:sldId id="256" r:id="rId2"/>
     <p:sldId id="257" r:id="rId3"/>
+    <p:sldId id="258" r:id="rId4"/>
   </p:sldIdLst>
   <p:notesMasterIdLst>
-    <p:notesMasterId r:id="rId4"/>
+    <p:notesMasterId r:id="rId5"/>
   </p:notesMasterIdLst>
   <p:sldSz cx="12192000" cy="6858000"/>
   <p:notesSz cx="6858000" cy="12192000"/>
@@ -621,6 +622,97 @@
             <a:fld id="{F7021451-1387-4CA6-816F-3879F97B5CBC}" type="slidenum">
               <a:rPr lang="en-US"/>
               <a:t>2</a:t>
+            </a:fld>
+            <a:endParaRPr lang="en-US"/>
+          </a:p>
+        </p:txBody>
+      </p:sp>
+    </p:spTree>
+    <p:extLst>
+      <p:ext uri="{BB962C8B-B14F-4D97-AF65-F5344CB8AC3E}">
+        <p14:creationId xmlns:p14="http://schemas.microsoft.com/office/powerpoint/2010/main" val="1024086991"/>
+      </p:ext>
+    </p:extLst>
+  </p:cSld>
+  <p:clrMapOvr>
+    <a:masterClrMapping/>
+  </p:clrMapOvr>
+</p:notes>
+</file>
+
+<file path=ppt/notesSlides/notesSlide3.xml><?xml version="1.0" encoding="utf-8"?>
+<p:notes xmlns:a="http://schemas.openxmlformats.org/drawingml/2006/main" xmlns:r="http://schemas.openxmlformats.org/officeDocument/2006/relationships" xmlns:p="http://schemas.openxmlformats.org/presentationml/2006/main">
+  <p:cSld>
+    <p:spTree>
+      <p:nvGrpSpPr>
+        <p:cNvPr id="1" name=""/>
+        <p:cNvGrpSpPr/>
+        <p:nvPr/>
+      </p:nvGrpSpPr>
+      <p:grpSpPr>
+        <a:xfrm>
+          <a:off x="0" y="0"/>
+          <a:ext cx="0" cy="0"/>
+          <a:chOff x="0" y="0"/>
+          <a:chExt cx="0" cy="0"/>
+        </a:xfrm>
+      </p:grpSpPr>
+      <p:sp>
+        <p:nvSpPr>
+          <p:cNvPr id="2" name="Slide Image Placeholder 1"/>
+          <p:cNvSpPr>
+            <a:spLocks noGrp="1" noRot="1" noChangeAspect="1"/>
+          </p:cNvSpPr>
+          <p:nvPr>
+            <p:ph type="sldImg"/>
+          </p:nvPr>
+        </p:nvSpPr>
+        <p:spPr/>
+      </p:sp>
+      <p:sp>
+        <p:nvSpPr>
+          <p:cNvPr id="3" name="Notes Placeholder 2"/>
+          <p:cNvSpPr>
+            <a:spLocks noGrp="1"/>
+          </p:cNvSpPr>
+          <p:nvPr>
+            <p:ph type="body" idx="1"/>
+          </p:nvPr>
+        </p:nvSpPr>
+        <p:spPr/>
+        <p:txBody>
+          <a:bodyPr/>
+          <a:lstStyle/>
+          <a:p>
+            <a:r>
+              <a:rPr lang="en-US" dirty="0"/>
+              <a:t>¿Cuál es la gracia que tiene esta aplicación con la IA? Que con esos dos códigos y esos datos, el agente dice: vale, tengo el P0401, que es la válvula EGR obstruida, y el P2002, que es el filtro de partículas lleno. Voy a mirar a ver por qué puede ser esto.
+Y hace una diagnosis: esto se produce, puede ser por esto o puede ser por lo otro. Le da al mecánico una serie de opciones.
+Y además le dice qué pasos puede seguir para llegar a determinar de dónde viene el problema. Eso es lo que hace la aplicación.
+[~55 s]</a:t>
+            </a:r>
+            <a:endParaRPr lang="en-US" dirty="0"/>
+          </a:p>
+        </p:txBody>
+      </p:sp>
+      <p:sp>
+        <p:nvSpPr>
+          <p:cNvPr id="4" name="Slide Number Placeholder 3"/>
+          <p:cNvSpPr>
+            <a:spLocks noGrp="1"/>
+          </p:cNvSpPr>
+          <p:nvPr>
+            <p:ph type="sldNum" sz="quarter" idx="10"/>
+          </p:nvPr>
+        </p:nvSpPr>
+        <p:spPr/>
+        <p:txBody>
+          <a:bodyPr/>
+          <a:lstStyle/>
+          <a:p>
+            <a:fld id="{F7021451-1387-4CA6-816F-3879F97B5CBC}" type="slidenum">
+              <a:rPr lang="en-US"/>
+              <a:t>3</a:t>
             </a:fld>
             <a:endParaRPr lang="en-US"/>
           </a:p>
@@ -1868,6 +1960,347 @@
 </p:sld>
 </file>
 
+<file path=ppt/slides/slide3.xml><?xml version="1.0" encoding="utf-8"?>
+<p:sld xmlns:a="http://schemas.openxmlformats.org/drawingml/2006/main" xmlns:r="http://schemas.openxmlformats.org/officeDocument/2006/relationships" xmlns:p="http://schemas.openxmlformats.org/presentationml/2006/main">
+  <p:cSld name="Slide 3">
+    <p:bg>
+      <p:bgPr>
+        <a:solidFill>
+          <a:srgbClr val="FFFFFF"/>
+        </a:solidFill>
+      </p:bgPr>
+    </p:bg>
+    <p:spTree>
+      <p:nvGrpSpPr>
+        <p:cNvPr id="1" name=""/>
+        <p:cNvGrpSpPr/>
+        <p:nvPr/>
+      </p:nvGrpSpPr>
+      <p:grpSpPr>
+        <a:xfrm>
+          <a:off x="0" y="0"/>
+          <a:ext cx="0" cy="0"/>
+          <a:chOff x="0" y="0"/>
+          <a:chExt cx="0" cy="0"/>
+        </a:xfrm>
+      </p:grpSpPr>
+      <p:sp>
+        <p:nvSpPr>
+          <p:cNvPr id="2" name="Text 0"/>
+          <p:cNvSpPr/>
+          <p:nvPr/>
+        </p:nvSpPr>
+        <p:spPr>
+          <a:xfrm>
+            <a:off x="777240" y="685800"/>
+            <a:ext cx="10607040" cy="822960"/>
+          </a:xfrm>
+          <a:prstGeom prst="rect">
+            <a:avLst/>
+          </a:prstGeom>
+          <a:noFill/>
+          <a:ln/>
+        </p:spPr>
+        <p:txBody>
+          <a:bodyPr wrap="square" lIns="0" tIns="0" rIns="0" bIns="0" rtlCol="0" anchor="t"/>
+          <a:lstStyle/>
+          <a:p>
+            <a:pPr indent="0" marL="0">
+              <a:buNone/>
+            </a:pPr>
+            <a:r>
+              <a:rPr lang="en-US" sz="3400" b="1" dirty="0">
+                <a:solidFill>
+                  <a:srgbClr val="1A1C2E"/>
+                </a:solidFill>
+                <a:latin typeface="Arial" pitchFamily="34" charset="0"/>
+                <a:ea typeface="Arial" pitchFamily="34" charset="-122"/>
+                <a:cs typeface="Arial" pitchFamily="34" charset="-120"/>
+              </a:rPr>
+              <a:t>Lo que hace la aplicación</a:t>
+            </a:r>
+            <a:endParaRPr lang="en-US" sz="3400" dirty="0"/>
+          </a:p>
+        </p:txBody>
+      </p:sp>
+      <p:sp>
+        <p:nvSpPr>
+          <p:cNvPr id="3" name="Text 1"/>
+          <p:cNvSpPr/>
+          <p:nvPr/>
+        </p:nvSpPr>
+        <p:spPr>
+          <a:xfrm>
+            <a:off x="777240" y="1600200"/>
+            <a:ext cx="10607040" cy="365760"/>
+          </a:xfrm>
+          <a:prstGeom prst="rect">
+            <a:avLst/>
+          </a:prstGeom>
+          <a:noFill/>
+          <a:ln/>
+        </p:spPr>
+        <p:txBody>
+          <a:bodyPr wrap="square" lIns="0" tIns="0" rIns="0" bIns="0" rtlCol="0" anchor="t"/>
+          <a:lstStyle/>
+          <a:p>
+            <a:pPr indent="0" marL="0">
+              <a:buNone/>
+            </a:pPr>
+            <a:r>
+              <a:rPr lang="en-US" sz="1700" dirty="0">
+                <a:solidFill>
+                  <a:srgbClr val="5A5F73"/>
+                </a:solidFill>
+                <a:latin typeface="Calibri" pitchFamily="34" charset="0"/>
+                <a:ea typeface="Calibri" pitchFamily="34" charset="-122"/>
+                <a:cs typeface="Calibri" pitchFamily="34" charset="-120"/>
+              </a:rPr>
+              <a:t>Con esos mismos códigos y los datos del coche.</a:t>
+            </a:r>
+            <a:endParaRPr lang="en-US" sz="1700" dirty="0"/>
+          </a:p>
+        </p:txBody>
+      </p:sp>
+      <p:sp>
+        <p:nvSpPr>
+          <p:cNvPr id="4" name="Text 2"/>
+          <p:cNvSpPr/>
+          <p:nvPr/>
+        </p:nvSpPr>
+        <p:spPr>
+          <a:xfrm>
+            <a:off x="777240" y="2606040"/>
+            <a:ext cx="10058400" cy="2377440"/>
+          </a:xfrm>
+          <a:prstGeom prst="rect">
+            <a:avLst/>
+          </a:prstGeom>
+          <a:noFill/>
+          <a:ln/>
+        </p:spPr>
+        <p:txBody>
+          <a:bodyPr wrap="square" lIns="0" tIns="0" rIns="0" bIns="0" rtlCol="0" anchor="t"/>
+          <a:lstStyle/>
+          <a:p>
+            <a:pPr marL="342900" indent="-342900">
+              <a:lnSpc>
+                <a:spcPts val="2800"/>
+              </a:lnSpc>
+              <a:spcAft>
+                <a:spcPts val="2200"/>
+              </a:spcAft>
+              <a:buSzPct val="100000"/>
+              <a:buChar char="•"/>
+            </a:pPr>
+            <a:r>
+              <a:rPr lang="en-US" sz="2000" dirty="0">
+                <a:solidFill>
+                  <a:srgbClr val="1A1C2E"/>
+                </a:solidFill>
+                <a:latin typeface="Calibri" pitchFamily="34" charset="0"/>
+                <a:ea typeface="Calibri" pitchFamily="34" charset="-122"/>
+                <a:cs typeface="Calibri" pitchFamily="34" charset="-120"/>
+              </a:rPr>
+              <a:t>Investiga por qué puede estar pasando eso</a:t>
+            </a:r>
+            <a:endParaRPr lang="en-US" sz="2000" dirty="0"/>
+          </a:p>
+          <a:p>
+            <a:pPr marL="342900" indent="-342900">
+              <a:lnSpc>
+                <a:spcPts val="2800"/>
+              </a:lnSpc>
+              <a:spcAft>
+                <a:spcPts val="2200"/>
+              </a:spcAft>
+              <a:buSzPct val="100000"/>
+              <a:buChar char="•"/>
+            </a:pPr>
+            <a:r>
+              <a:rPr lang="en-US" sz="2000" dirty="0">
+                <a:solidFill>
+                  <a:srgbClr val="1A1C2E"/>
+                </a:solidFill>
+                <a:latin typeface="Calibri" pitchFamily="34" charset="0"/>
+                <a:ea typeface="Calibri" pitchFamily="34" charset="-122"/>
+                <a:cs typeface="Calibri" pitchFamily="34" charset="-120"/>
+              </a:rPr>
+              <a:t>Le da al mecánico una serie de opciones, no una sola causa</a:t>
+            </a:r>
+            <a:endParaRPr lang="en-US" sz="2000" dirty="0"/>
+          </a:p>
+          <a:p>
+            <a:pPr marL="342900" indent="-342900">
+              <a:lnSpc>
+                <a:spcPts val="2800"/>
+              </a:lnSpc>
+              <a:spcAft>
+                <a:spcPts val="2200"/>
+              </a:spcAft>
+              <a:buSzPct val="100000"/>
+              <a:buChar char="•"/>
+            </a:pPr>
+            <a:r>
+              <a:rPr lang="en-US" sz="2000" dirty="0">
+                <a:solidFill>
+                  <a:srgbClr val="1A1C2E"/>
+                </a:solidFill>
+                <a:latin typeface="Calibri" pitchFamily="34" charset="0"/>
+                <a:ea typeface="Calibri" pitchFamily="34" charset="-122"/>
+                <a:cs typeface="Calibri" pitchFamily="34" charset="-120"/>
+              </a:rPr>
+              <a:t>Y los pasos a seguir para determinar de dónde viene el problema</a:t>
+            </a:r>
+            <a:endParaRPr lang="en-US" sz="2000" dirty="0"/>
+          </a:p>
+        </p:txBody>
+      </p:sp>
+      <p:sp>
+        <p:nvSpPr>
+          <p:cNvPr id="5" name="Shape 3"/>
+          <p:cNvSpPr/>
+          <p:nvPr/>
+        </p:nvSpPr>
+        <p:spPr>
+          <a:xfrm>
+            <a:off x="777240" y="6263640"/>
+            <a:ext cx="219456" cy="219456"/>
+          </a:xfrm>
+          <a:prstGeom prst="rect">
+            <a:avLst/>
+          </a:prstGeom>
+          <a:solidFill>
+            <a:srgbClr val="202CFC"/>
+          </a:solidFill>
+          <a:ln/>
+        </p:spPr>
+      </p:sp>
+      <p:sp>
+        <p:nvSpPr>
+          <p:cNvPr id="6" name="Text 4"/>
+          <p:cNvSpPr/>
+          <p:nvPr/>
+        </p:nvSpPr>
+        <p:spPr>
+          <a:xfrm>
+            <a:off x="777240" y="6263640"/>
+            <a:ext cx="219456" cy="219456"/>
+          </a:xfrm>
+          <a:prstGeom prst="rect">
+            <a:avLst/>
+          </a:prstGeom>
+          <a:noFill/>
+          <a:ln/>
+        </p:spPr>
+        <p:txBody>
+          <a:bodyPr wrap="square" lIns="0" tIns="0" rIns="0" bIns="0" rtlCol="0" anchor="ctr"/>
+          <a:lstStyle/>
+          <a:p>
+            <a:pPr algn="ctr" indent="0" marL="0">
+              <a:buNone/>
+            </a:pPr>
+            <a:r>
+              <a:rPr lang="en-US" sz="816" b="1" dirty="0">
+                <a:solidFill>
+                  <a:srgbClr val="FFFFFF"/>
+                </a:solidFill>
+                <a:latin typeface="Arial" pitchFamily="34" charset="0"/>
+                <a:ea typeface="Arial" pitchFamily="34" charset="-122"/>
+                <a:cs typeface="Arial" pitchFamily="34" charset="-120"/>
+              </a:rPr>
+              <a:t>BIG</a:t>
+            </a:r>
+            <a:endParaRPr lang="en-US" sz="816" dirty="0"/>
+          </a:p>
+        </p:txBody>
+      </p:sp>
+      <p:sp>
+        <p:nvSpPr>
+          <p:cNvPr id="7" name="Text 5"/>
+          <p:cNvSpPr/>
+          <p:nvPr/>
+        </p:nvSpPr>
+        <p:spPr>
+          <a:xfrm>
+            <a:off x="1078992" y="6263640"/>
+            <a:ext cx="658368" cy="219456"/>
+          </a:xfrm>
+          <a:prstGeom prst="rect">
+            <a:avLst/>
+          </a:prstGeom>
+          <a:noFill/>
+          <a:ln/>
+        </p:spPr>
+        <p:txBody>
+          <a:bodyPr wrap="square" lIns="0" tIns="0" rIns="0" bIns="0" rtlCol="0" anchor="ctr"/>
+          <a:lstStyle/>
+          <a:p>
+            <a:pPr algn="l" indent="0" marL="0">
+              <a:buNone/>
+            </a:pPr>
+            <a:r>
+              <a:rPr lang="en-US" sz="816" dirty="0">
+                <a:solidFill>
+                  <a:srgbClr val="1A1C2E"/>
+                </a:solidFill>
+                <a:latin typeface="Arial" pitchFamily="34" charset="0"/>
+                <a:ea typeface="Arial" pitchFamily="34" charset="-122"/>
+                <a:cs typeface="Arial" pitchFamily="34" charset="-120"/>
+              </a:rPr>
+              <a:t>school</a:t>
+            </a:r>
+            <a:endParaRPr lang="en-US" sz="816" dirty="0"/>
+          </a:p>
+        </p:txBody>
+      </p:sp>
+      <p:sp>
+        <p:nvSpPr>
+          <p:cNvPr id="8" name="Text 6"/>
+          <p:cNvSpPr/>
+          <p:nvPr/>
+        </p:nvSpPr>
+        <p:spPr>
+          <a:xfrm>
+            <a:off x="11064240" y="6263640"/>
+            <a:ext cx="320040" cy="219456"/>
+          </a:xfrm>
+          <a:prstGeom prst="rect">
+            <a:avLst/>
+          </a:prstGeom>
+          <a:noFill/>
+          <a:ln/>
+        </p:spPr>
+        <p:txBody>
+          <a:bodyPr wrap="square" lIns="0" tIns="0" rIns="0" bIns="0" rtlCol="0" anchor="ctr"/>
+          <a:lstStyle/>
+          <a:p>
+            <a:pPr algn="r" indent="0" marL="0">
+              <a:buNone/>
+            </a:pPr>
+            <a:r>
+              <a:rPr lang="en-US" sz="1000" dirty="0">
+                <a:solidFill>
+                  <a:srgbClr val="5A5F73"/>
+                </a:solidFill>
+                <a:latin typeface="Calibri" pitchFamily="34" charset="0"/>
+                <a:ea typeface="Calibri" pitchFamily="34" charset="-122"/>
+                <a:cs typeface="Calibri" pitchFamily="34" charset="-120"/>
+              </a:rPr>
+              <a:t>3</a:t>
+            </a:r>
+            <a:endParaRPr lang="en-US" sz="1000" dirty="0"/>
+          </a:p>
+        </p:txBody>
+      </p:sp>
+    </p:spTree>
+  </p:cSld>
+  <p:clrMapOvr>
+    <a:masterClrMapping/>
+  </p:clrMapOvr>
+</p:sld>
+</file>
+
 <file path=ppt/theme/theme1.xml><?xml version="1.0" encoding="utf-8"?>
 <a:theme xmlns:a="http://schemas.openxmlformats.org/drawingml/2006/main" name="Office Theme">
   <a:themeElements>

</xml_diff>

<commit_message>
docs(tfm): slide de arquitectura resumiendo el ADR-001
</commit_message>
<xml_diff>
--- a/docs/presentacion/tfm-intelligent-automotive-diagnostics.pptx
+++ b/docs/presentacion/tfm-intelligent-automotive-diagnostics.pptx
@@ -8,9 +8,10 @@
     <p:sldId id="256" r:id="rId2"/>
     <p:sldId id="257" r:id="rId3"/>
     <p:sldId id="258" r:id="rId4"/>
+    <p:sldId id="259" r:id="rId5"/>
   </p:sldIdLst>
   <p:notesMasterIdLst>
-    <p:notesMasterId r:id="rId5"/>
+    <p:notesMasterId r:id="rId6"/>
   </p:notesMasterIdLst>
   <p:sldSz cx="12192000" cy="6858000"/>
   <p:notesSz cx="6858000" cy="12192000"/>
@@ -713,6 +714,98 @@
             <a:fld id="{F7021451-1387-4CA6-816F-3879F97B5CBC}" type="slidenum">
               <a:rPr lang="en-US"/>
               <a:t>3</a:t>
+            </a:fld>
+            <a:endParaRPr lang="en-US"/>
+          </a:p>
+        </p:txBody>
+      </p:sp>
+    </p:spTree>
+    <p:extLst>
+      <p:ext uri="{BB962C8B-B14F-4D97-AF65-F5344CB8AC3E}">
+        <p14:creationId xmlns:p14="http://schemas.microsoft.com/office/powerpoint/2010/main" val="1024086991"/>
+      </p:ext>
+    </p:extLst>
+  </p:cSld>
+  <p:clrMapOvr>
+    <a:masterClrMapping/>
+  </p:clrMapOvr>
+</p:notes>
+</file>
+
+<file path=ppt/notesSlides/notesSlide4.xml><?xml version="1.0" encoding="utf-8"?>
+<p:notes xmlns:a="http://schemas.openxmlformats.org/drawingml/2006/main" xmlns:r="http://schemas.openxmlformats.org/officeDocument/2006/relationships" xmlns:p="http://schemas.openxmlformats.org/presentationml/2006/main">
+  <p:cSld>
+    <p:spTree>
+      <p:nvGrpSpPr>
+        <p:cNvPr id="1" name=""/>
+        <p:cNvGrpSpPr/>
+        <p:nvPr/>
+      </p:nvGrpSpPr>
+      <p:grpSpPr>
+        <a:xfrm>
+          <a:off x="0" y="0"/>
+          <a:ext cx="0" cy="0"/>
+          <a:chOff x="0" y="0"/>
+          <a:chExt cx="0" cy="0"/>
+        </a:xfrm>
+      </p:grpSpPr>
+      <p:sp>
+        <p:nvSpPr>
+          <p:cNvPr id="2" name="Slide Image Placeholder 1"/>
+          <p:cNvSpPr>
+            <a:spLocks noGrp="1" noRot="1" noChangeAspect="1"/>
+          </p:cNvSpPr>
+          <p:nvPr>
+            <p:ph type="sldImg"/>
+          </p:nvPr>
+        </p:nvSpPr>
+        <p:spPr/>
+      </p:sp>
+      <p:sp>
+        <p:nvSpPr>
+          <p:cNvPr id="3" name="Notes Placeholder 2"/>
+          <p:cNvSpPr>
+            <a:spLocks noGrp="1"/>
+          </p:cNvSpPr>
+          <p:nvPr>
+            <p:ph type="body" idx="1"/>
+          </p:nvPr>
+        </p:nvSpPr>
+        <p:spPr/>
+        <p:txBody>
+          <a:bodyPr/>
+          <a:lstStyle/>
+          <a:p>
+            <a:r>
+              <a:rPr lang="en-US" dirty="0"/>
+              <a:t>La arquitectura se eligió en el ADR-001 del proyecto, y ahí están escritas las razones.
+El proyecto necesitaba cuatro cosas: poder testear sin levantar servidores, poder cambiar de proveedor de IA sin tocar la lógica del core, poder cambiar el framework web desde un solo punto, y que la arquitectura fuera fácil de explicar aquí, en la defensa.
+Con esas cuatro condiciones se adoptó Clean Architecture con puertos y adaptadores, y el MCP entra como un adaptador más de infraestructura.
+El ADR también deja escrito lo que cuesta, y lo digo porque es parte de la decisión: hay más ficheros que en un monolito, y la inyección manual del composition root crece cada vez que se añade un adaptador.
+[~80 s]</a:t>
+            </a:r>
+            <a:endParaRPr lang="en-US" dirty="0"/>
+          </a:p>
+        </p:txBody>
+      </p:sp>
+      <p:sp>
+        <p:nvSpPr>
+          <p:cNvPr id="4" name="Slide Number Placeholder 3"/>
+          <p:cNvSpPr>
+            <a:spLocks noGrp="1"/>
+          </p:cNvSpPr>
+          <p:nvPr>
+            <p:ph type="sldNum" sz="quarter" idx="10"/>
+          </p:nvPr>
+        </p:nvSpPr>
+        <p:spPr/>
+        <p:txBody>
+          <a:bodyPr/>
+          <a:lstStyle/>
+          <a:p>
+            <a:fld id="{F7021451-1387-4CA6-816F-3879F97B5CBC}" type="slidenum">
+              <a:rPr lang="en-US"/>
+              <a:t>4</a:t>
             </a:fld>
             <a:endParaRPr lang="en-US"/>
           </a:p>
@@ -2301,6 +2394,519 @@
 </p:sld>
 </file>
 
+<file path=ppt/slides/slide4.xml><?xml version="1.0" encoding="utf-8"?>
+<p:sld xmlns:a="http://schemas.openxmlformats.org/drawingml/2006/main" xmlns:r="http://schemas.openxmlformats.org/officeDocument/2006/relationships" xmlns:p="http://schemas.openxmlformats.org/presentationml/2006/main">
+  <p:cSld name="Slide 4">
+    <p:bg>
+      <p:bgPr>
+        <a:solidFill>
+          <a:srgbClr val="FFFFFF"/>
+        </a:solidFill>
+      </p:bgPr>
+    </p:bg>
+    <p:spTree>
+      <p:nvGrpSpPr>
+        <p:cNvPr id="1" name=""/>
+        <p:cNvGrpSpPr/>
+        <p:nvPr/>
+      </p:nvGrpSpPr>
+      <p:grpSpPr>
+        <a:xfrm>
+          <a:off x="0" y="0"/>
+          <a:ext cx="0" cy="0"/>
+          <a:chOff x="0" y="0"/>
+          <a:chExt cx="0" cy="0"/>
+        </a:xfrm>
+      </p:grpSpPr>
+      <p:sp>
+        <p:nvSpPr>
+          <p:cNvPr id="2" name="Text 0"/>
+          <p:cNvSpPr/>
+          <p:nvPr/>
+        </p:nvSpPr>
+        <p:spPr>
+          <a:xfrm>
+            <a:off x="777240" y="685800"/>
+            <a:ext cx="10607040" cy="822960"/>
+          </a:xfrm>
+          <a:prstGeom prst="rect">
+            <a:avLst/>
+          </a:prstGeom>
+          <a:noFill/>
+          <a:ln/>
+        </p:spPr>
+        <p:txBody>
+          <a:bodyPr wrap="square" lIns="0" tIns="0" rIns="0" bIns="0" rtlCol="0" anchor="t"/>
+          <a:lstStyle/>
+          <a:p>
+            <a:pPr indent="0" marL="0">
+              <a:buNone/>
+            </a:pPr>
+            <a:r>
+              <a:rPr lang="en-US" sz="3400" b="1" dirty="0">
+                <a:solidFill>
+                  <a:srgbClr val="1A1C2E"/>
+                </a:solidFill>
+                <a:latin typeface="Arial" pitchFamily="34" charset="0"/>
+                <a:ea typeface="Arial" pitchFamily="34" charset="-122"/>
+                <a:cs typeface="Arial" pitchFamily="34" charset="-120"/>
+              </a:rPr>
+              <a:t>Por qué Clean Architecture + Hexagonal</a:t>
+            </a:r>
+            <a:endParaRPr lang="en-US" sz="3400" dirty="0"/>
+          </a:p>
+        </p:txBody>
+      </p:sp>
+      <p:sp>
+        <p:nvSpPr>
+          <p:cNvPr id="3" name="Text 1"/>
+          <p:cNvSpPr/>
+          <p:nvPr/>
+        </p:nvSpPr>
+        <p:spPr>
+          <a:xfrm>
+            <a:off x="777240" y="1600200"/>
+            <a:ext cx="10607040" cy="365760"/>
+          </a:xfrm>
+          <a:prstGeom prst="rect">
+            <a:avLst/>
+          </a:prstGeom>
+          <a:noFill/>
+          <a:ln/>
+        </p:spPr>
+        <p:txBody>
+          <a:bodyPr wrap="square" lIns="0" tIns="0" rIns="0" bIns="0" rtlCol="0" anchor="t"/>
+          <a:lstStyle/>
+          <a:p>
+            <a:pPr indent="0" marL="0">
+              <a:buNone/>
+            </a:pPr>
+            <a:r>
+              <a:rPr lang="en-US" sz="1700" dirty="0">
+                <a:solidFill>
+                  <a:srgbClr val="5A5F73"/>
+                </a:solidFill>
+                <a:latin typeface="Calibri" pitchFamily="34" charset="0"/>
+                <a:ea typeface="Calibri" pitchFamily="34" charset="-122"/>
+                <a:cs typeface="Calibri" pitchFamily="34" charset="-120"/>
+              </a:rPr>
+              <a:t>Decidido en el ADR-001 del proyecto.</a:t>
+            </a:r>
+            <a:endParaRPr lang="en-US" sz="1700" dirty="0"/>
+          </a:p>
+        </p:txBody>
+      </p:sp>
+      <p:sp>
+        <p:nvSpPr>
+          <p:cNvPr id="4" name="Text 2"/>
+          <p:cNvSpPr/>
+          <p:nvPr/>
+        </p:nvSpPr>
+        <p:spPr>
+          <a:xfrm>
+            <a:off x="777240" y="2331720"/>
+            <a:ext cx="4846320" cy="365760"/>
+          </a:xfrm>
+          <a:prstGeom prst="rect">
+            <a:avLst/>
+          </a:prstGeom>
+          <a:noFill/>
+          <a:ln/>
+        </p:spPr>
+        <p:txBody>
+          <a:bodyPr wrap="square" lIns="0" tIns="0" rIns="0" bIns="0" rtlCol="0" anchor="t"/>
+          <a:lstStyle/>
+          <a:p>
+            <a:pPr indent="0" marL="0">
+              <a:buNone/>
+            </a:pPr>
+            <a:r>
+              <a:rPr lang="en-US" sz="2000" b="1" dirty="0">
+                <a:solidFill>
+                  <a:srgbClr val="202CFC"/>
+                </a:solidFill>
+                <a:latin typeface="Arial" pitchFamily="34" charset="0"/>
+                <a:ea typeface="Arial" pitchFamily="34" charset="-122"/>
+                <a:cs typeface="Arial" pitchFamily="34" charset="-120"/>
+              </a:rPr>
+              <a:t>Lo que se buscaba</a:t>
+            </a:r>
+            <a:endParaRPr lang="en-US" sz="2000" dirty="0"/>
+          </a:p>
+        </p:txBody>
+      </p:sp>
+      <p:sp>
+        <p:nvSpPr>
+          <p:cNvPr id="5" name="Text 3"/>
+          <p:cNvSpPr/>
+          <p:nvPr/>
+        </p:nvSpPr>
+        <p:spPr>
+          <a:xfrm>
+            <a:off x="777240" y="2926080"/>
+            <a:ext cx="4846320" cy="2377440"/>
+          </a:xfrm>
+          <a:prstGeom prst="rect">
+            <a:avLst/>
+          </a:prstGeom>
+          <a:noFill/>
+          <a:ln/>
+        </p:spPr>
+        <p:txBody>
+          <a:bodyPr wrap="square" lIns="0" tIns="0" rIns="0" bIns="0" rtlCol="0" anchor="t"/>
+          <a:lstStyle/>
+          <a:p>
+            <a:pPr marL="342900" indent="-342900">
+              <a:lnSpc>
+                <a:spcPts val="2200"/>
+              </a:lnSpc>
+              <a:spcAft>
+                <a:spcPts val="1200"/>
+              </a:spcAft>
+              <a:buSzPct val="100000"/>
+              <a:buChar char="•"/>
+            </a:pPr>
+            <a:r>
+              <a:rPr lang="en-US" sz="1600" dirty="0">
+                <a:solidFill>
+                  <a:srgbClr val="1A1C2E"/>
+                </a:solidFill>
+                <a:latin typeface="Calibri" pitchFamily="34" charset="0"/>
+                <a:ea typeface="Calibri" pitchFamily="34" charset="-122"/>
+                <a:cs typeface="Calibri" pitchFamily="34" charset="-120"/>
+              </a:rPr>
+              <a:t>Poder testear sin levantar servidores</a:t>
+            </a:r>
+            <a:endParaRPr lang="en-US" sz="1600" dirty="0"/>
+          </a:p>
+          <a:p>
+            <a:pPr marL="342900" indent="-342900">
+              <a:lnSpc>
+                <a:spcPts val="2200"/>
+              </a:lnSpc>
+              <a:spcAft>
+                <a:spcPts val="1200"/>
+              </a:spcAft>
+              <a:buSzPct val="100000"/>
+              <a:buChar char="•"/>
+            </a:pPr>
+            <a:r>
+              <a:rPr lang="en-US" sz="1600" dirty="0">
+                <a:solidFill>
+                  <a:srgbClr val="1A1C2E"/>
+                </a:solidFill>
+                <a:latin typeface="Calibri" pitchFamily="34" charset="0"/>
+                <a:ea typeface="Calibri" pitchFamily="34" charset="-122"/>
+                <a:cs typeface="Calibri" pitchFamily="34" charset="-120"/>
+              </a:rPr>
+              <a:t>Cambiar de proveedor de IA sin tocar la lógica del core</a:t>
+            </a:r>
+            <a:endParaRPr lang="en-US" sz="1600" dirty="0"/>
+          </a:p>
+          <a:p>
+            <a:pPr marL="342900" indent="-342900">
+              <a:lnSpc>
+                <a:spcPts val="2200"/>
+              </a:lnSpc>
+              <a:spcAft>
+                <a:spcPts val="1200"/>
+              </a:spcAft>
+              <a:buSzPct val="100000"/>
+              <a:buChar char="•"/>
+            </a:pPr>
+            <a:r>
+              <a:rPr lang="en-US" sz="1600" dirty="0">
+                <a:solidFill>
+                  <a:srgbClr val="1A1C2E"/>
+                </a:solidFill>
+                <a:latin typeface="Calibri" pitchFamily="34" charset="0"/>
+                <a:ea typeface="Calibri" pitchFamily="34" charset="-122"/>
+                <a:cs typeface="Calibri" pitchFamily="34" charset="-120"/>
+              </a:rPr>
+              <a:t>Cambiar el framework web desde un solo punto</a:t>
+            </a:r>
+            <a:endParaRPr lang="en-US" sz="1600" dirty="0"/>
+          </a:p>
+          <a:p>
+            <a:pPr marL="342900" indent="-342900">
+              <a:lnSpc>
+                <a:spcPts val="2200"/>
+              </a:lnSpc>
+              <a:spcAft>
+                <a:spcPts val="1200"/>
+              </a:spcAft>
+              <a:buSzPct val="100000"/>
+              <a:buChar char="•"/>
+            </a:pPr>
+            <a:r>
+              <a:rPr lang="en-US" sz="1600" dirty="0">
+                <a:solidFill>
+                  <a:srgbClr val="1A1C2E"/>
+                </a:solidFill>
+                <a:latin typeface="Calibri" pitchFamily="34" charset="0"/>
+                <a:ea typeface="Calibri" pitchFamily="34" charset="-122"/>
+                <a:cs typeface="Calibri" pitchFamily="34" charset="-120"/>
+              </a:rPr>
+              <a:t>Que fuera fácil de explicar en la defensa</a:t>
+            </a:r>
+            <a:endParaRPr lang="en-US" sz="1600" dirty="0"/>
+          </a:p>
+        </p:txBody>
+      </p:sp>
+      <p:sp>
+        <p:nvSpPr>
+          <p:cNvPr id="6" name="Text 4"/>
+          <p:cNvSpPr/>
+          <p:nvPr/>
+        </p:nvSpPr>
+        <p:spPr>
+          <a:xfrm>
+            <a:off x="6537960" y="2331720"/>
+            <a:ext cx="4846320" cy="365760"/>
+          </a:xfrm>
+          <a:prstGeom prst="rect">
+            <a:avLst/>
+          </a:prstGeom>
+          <a:noFill/>
+          <a:ln/>
+        </p:spPr>
+        <p:txBody>
+          <a:bodyPr wrap="square" lIns="0" tIns="0" rIns="0" bIns="0" rtlCol="0" anchor="t"/>
+          <a:lstStyle/>
+          <a:p>
+            <a:pPr indent="0" marL="0">
+              <a:buNone/>
+            </a:pPr>
+            <a:r>
+              <a:rPr lang="en-US" sz="2000" b="1" dirty="0">
+                <a:solidFill>
+                  <a:srgbClr val="202CFC"/>
+                </a:solidFill>
+                <a:latin typeface="Arial" pitchFamily="34" charset="0"/>
+                <a:ea typeface="Arial" pitchFamily="34" charset="-122"/>
+                <a:cs typeface="Arial" pitchFamily="34" charset="-120"/>
+              </a:rPr>
+              <a:t>Lo que cuesta</a:t>
+            </a:r>
+            <a:endParaRPr lang="en-US" sz="2000" dirty="0"/>
+          </a:p>
+        </p:txBody>
+      </p:sp>
+      <p:sp>
+        <p:nvSpPr>
+          <p:cNvPr id="7" name="Text 5"/>
+          <p:cNvSpPr/>
+          <p:nvPr/>
+        </p:nvSpPr>
+        <p:spPr>
+          <a:xfrm>
+            <a:off x="6537960" y="2926080"/>
+            <a:ext cx="4846320" cy="2377440"/>
+          </a:xfrm>
+          <a:prstGeom prst="rect">
+            <a:avLst/>
+          </a:prstGeom>
+          <a:noFill/>
+          <a:ln/>
+        </p:spPr>
+        <p:txBody>
+          <a:bodyPr wrap="square" lIns="0" tIns="0" rIns="0" bIns="0" rtlCol="0" anchor="t"/>
+          <a:lstStyle/>
+          <a:p>
+            <a:pPr marL="342900" indent="-342900">
+              <a:lnSpc>
+                <a:spcPts val="2200"/>
+              </a:lnSpc>
+              <a:spcAft>
+                <a:spcPts val="1200"/>
+              </a:spcAft>
+              <a:buSzPct val="100000"/>
+              <a:buChar char="•"/>
+            </a:pPr>
+            <a:r>
+              <a:rPr lang="en-US" sz="1600" dirty="0">
+                <a:solidFill>
+                  <a:srgbClr val="1A1C2E"/>
+                </a:solidFill>
+                <a:latin typeface="Calibri" pitchFamily="34" charset="0"/>
+                <a:ea typeface="Calibri" pitchFamily="34" charset="-122"/>
+                <a:cs typeface="Calibri" pitchFamily="34" charset="-120"/>
+              </a:rPr>
+              <a:t>Más ficheros que un enfoque monolítico</a:t>
+            </a:r>
+            <a:endParaRPr lang="en-US" sz="1600" dirty="0"/>
+          </a:p>
+          <a:p>
+            <a:pPr marL="342900" indent="-342900">
+              <a:lnSpc>
+                <a:spcPts val="2200"/>
+              </a:lnSpc>
+              <a:spcAft>
+                <a:spcPts val="1200"/>
+              </a:spcAft>
+              <a:buSzPct val="100000"/>
+              <a:buChar char="•"/>
+            </a:pPr>
+            <a:r>
+              <a:rPr lang="en-US" sz="1600" dirty="0">
+                <a:solidFill>
+                  <a:srgbClr val="1A1C2E"/>
+                </a:solidFill>
+                <a:latin typeface="Calibri" pitchFamily="34" charset="0"/>
+                <a:ea typeface="Calibri" pitchFamily="34" charset="-122"/>
+                <a:cs typeface="Calibri" pitchFamily="34" charset="-120"/>
+              </a:rPr>
+              <a:t>La inyección manual crece con cada adaptador nuevo</a:t>
+            </a:r>
+            <a:endParaRPr lang="en-US" sz="1600" dirty="0"/>
+          </a:p>
+        </p:txBody>
+      </p:sp>
+      <p:sp>
+        <p:nvSpPr>
+          <p:cNvPr id="8" name="Shape 6"/>
+          <p:cNvSpPr/>
+          <p:nvPr/>
+        </p:nvSpPr>
+        <p:spPr>
+          <a:xfrm>
+            <a:off x="777240" y="6263640"/>
+            <a:ext cx="219456" cy="219456"/>
+          </a:xfrm>
+          <a:prstGeom prst="rect">
+            <a:avLst/>
+          </a:prstGeom>
+          <a:solidFill>
+            <a:srgbClr val="202CFC"/>
+          </a:solidFill>
+          <a:ln/>
+        </p:spPr>
+      </p:sp>
+      <p:sp>
+        <p:nvSpPr>
+          <p:cNvPr id="9" name="Text 7"/>
+          <p:cNvSpPr/>
+          <p:nvPr/>
+        </p:nvSpPr>
+        <p:spPr>
+          <a:xfrm>
+            <a:off x="777240" y="6263640"/>
+            <a:ext cx="219456" cy="219456"/>
+          </a:xfrm>
+          <a:prstGeom prst="rect">
+            <a:avLst/>
+          </a:prstGeom>
+          <a:noFill/>
+          <a:ln/>
+        </p:spPr>
+        <p:txBody>
+          <a:bodyPr wrap="square" lIns="0" tIns="0" rIns="0" bIns="0" rtlCol="0" anchor="ctr"/>
+          <a:lstStyle/>
+          <a:p>
+            <a:pPr algn="ctr" indent="0" marL="0">
+              <a:buNone/>
+            </a:pPr>
+            <a:r>
+              <a:rPr lang="en-US" sz="816" b="1" dirty="0">
+                <a:solidFill>
+                  <a:srgbClr val="FFFFFF"/>
+                </a:solidFill>
+                <a:latin typeface="Arial" pitchFamily="34" charset="0"/>
+                <a:ea typeface="Arial" pitchFamily="34" charset="-122"/>
+                <a:cs typeface="Arial" pitchFamily="34" charset="-120"/>
+              </a:rPr>
+              <a:t>BIG</a:t>
+            </a:r>
+            <a:endParaRPr lang="en-US" sz="816" dirty="0"/>
+          </a:p>
+        </p:txBody>
+      </p:sp>
+      <p:sp>
+        <p:nvSpPr>
+          <p:cNvPr id="10" name="Text 8"/>
+          <p:cNvSpPr/>
+          <p:nvPr/>
+        </p:nvSpPr>
+        <p:spPr>
+          <a:xfrm>
+            <a:off x="1078992" y="6263640"/>
+            <a:ext cx="658368" cy="219456"/>
+          </a:xfrm>
+          <a:prstGeom prst="rect">
+            <a:avLst/>
+          </a:prstGeom>
+          <a:noFill/>
+          <a:ln/>
+        </p:spPr>
+        <p:txBody>
+          <a:bodyPr wrap="square" lIns="0" tIns="0" rIns="0" bIns="0" rtlCol="0" anchor="ctr"/>
+          <a:lstStyle/>
+          <a:p>
+            <a:pPr algn="l" indent="0" marL="0">
+              <a:buNone/>
+            </a:pPr>
+            <a:r>
+              <a:rPr lang="en-US" sz="816" dirty="0">
+                <a:solidFill>
+                  <a:srgbClr val="1A1C2E"/>
+                </a:solidFill>
+                <a:latin typeface="Arial" pitchFamily="34" charset="0"/>
+                <a:ea typeface="Arial" pitchFamily="34" charset="-122"/>
+                <a:cs typeface="Arial" pitchFamily="34" charset="-120"/>
+              </a:rPr>
+              <a:t>school</a:t>
+            </a:r>
+            <a:endParaRPr lang="en-US" sz="816" dirty="0"/>
+          </a:p>
+        </p:txBody>
+      </p:sp>
+      <p:sp>
+        <p:nvSpPr>
+          <p:cNvPr id="11" name="Text 9"/>
+          <p:cNvSpPr/>
+          <p:nvPr/>
+        </p:nvSpPr>
+        <p:spPr>
+          <a:xfrm>
+            <a:off x="11064240" y="6263640"/>
+            <a:ext cx="320040" cy="219456"/>
+          </a:xfrm>
+          <a:prstGeom prst="rect">
+            <a:avLst/>
+          </a:prstGeom>
+          <a:noFill/>
+          <a:ln/>
+        </p:spPr>
+        <p:txBody>
+          <a:bodyPr wrap="square" lIns="0" tIns="0" rIns="0" bIns="0" rtlCol="0" anchor="ctr"/>
+          <a:lstStyle/>
+          <a:p>
+            <a:pPr algn="r" indent="0" marL="0">
+              <a:buNone/>
+            </a:pPr>
+            <a:r>
+              <a:rPr lang="en-US" sz="1000" dirty="0">
+                <a:solidFill>
+                  <a:srgbClr val="5A5F73"/>
+                </a:solidFill>
+                <a:latin typeface="Calibri" pitchFamily="34" charset="0"/>
+                <a:ea typeface="Calibri" pitchFamily="34" charset="-122"/>
+                <a:cs typeface="Calibri" pitchFamily="34" charset="-120"/>
+              </a:rPr>
+              <a:t>4</a:t>
+            </a:r>
+            <a:endParaRPr lang="en-US" sz="1000" dirty="0"/>
+          </a:p>
+        </p:txBody>
+      </p:sp>
+    </p:spTree>
+  </p:cSld>
+  <p:clrMapOvr>
+    <a:masterClrMapping/>
+  </p:clrMapOvr>
+</p:sld>
+</file>
+
 <file path=ppt/theme/theme1.xml><?xml version="1.0" encoding="utf-8"?>
 <a:theme xmlns:a="http://schemas.openxmlformats.org/drawingml/2006/main" name="Office Theme">
   <a:themeElements>

</xml_diff>

<commit_message>
docs(tfm): arquitectura por coste del cambio, no por objetivos
</commit_message>
<xml_diff>
--- a/docs/presentacion/tfm-intelligent-automotive-diagnostics.pptx
+++ b/docs/presentacion/tfm-intelligent-automotive-diagnostics.pptx
@@ -778,10 +778,11 @@
           <a:p>
             <a:r>
               <a:rPr lang="en-US" dirty="0"/>
-              <a:t>La arquitectura se eligió en el ADR-001 del proyecto, y ahí están escritas las razones.
-El proyecto necesitaba cuatro cosas: poder testear sin levantar servidores, poder cambiar de proveedor de IA sin tocar la lógica del core, poder cambiar el framework web desde un solo punto, y que la arquitectura fuera fácil de explicar aquí, en la defensa.
-Con esas cuatro condiciones se adoptó Clean Architecture con puertos y adaptadores, y el MCP entra como un adaptador más de infraestructura.
-El ADR también deja escrito lo que cuesta, y lo digo porque es parte de la decisión: hay más ficheros que en un monolito, y la inyección manual del composition root crece cada vez que se añade un adaptador.
+              <a:t>¿Por qué Clean Architecture y hexagonal? Porque esto es una herramienta que va a seguir evolucionando, y lo que decide si una arquitectura es mejor o peor aquí es qué te cuesta cada cambio.
+Ahora mismo funciona con SQLite, porque era lo más rápido para desarrollar el proyecto. Pero en un futuro tendrá que usar PostgreSQL. Si tuviera la lógica mezclada con el acceso a datos, ese cambio me obligaría a tocar media aplicación. Como está detrás de un puerto, se cambia el adaptador y ya está.
+Y lo mismo con el resto: cambiar de proveedor de LLM, cambiar el framework web, o cambiar la forma de acceder al coche. El dominio y los casos de uso no se enteran.
+La otra razón es que se testea sin levantar nada, porque los tests hablan con los puertos y no con la base de datos real.
+Está todo escrito en el ADR-001, con sus contras: hay más ficheros que en un monolito, y la inyección manual del composition root crece con cada adaptador nuevo.
 [~80 s]</a:t>
             </a:r>
             <a:endParaRPr lang="en-US" dirty="0"/>
@@ -2451,7 +2452,7 @@
                 <a:ea typeface="Arial" pitchFamily="34" charset="-122"/>
                 <a:cs typeface="Arial" pitchFamily="34" charset="-120"/>
               </a:rPr>
-              <a:t>Por qué Clean Architecture + Hexagonal</a:t>
+              <a:t>Por qué esta arquitectura</a:t>
             </a:r>
             <a:endParaRPr lang="en-US" sz="3400" dirty="0"/>
           </a:p>
@@ -2490,7 +2491,7 @@
                 <a:ea typeface="Calibri" pitchFamily="34" charset="-122"/>
                 <a:cs typeface="Calibri" pitchFamily="34" charset="-120"/>
               </a:rPr>
-              <a:t>Decidido en el ADR-001 del proyecto.</a:t>
+              <a:t>La herramienta va a seguir cambiando. La pregunta es qué cuesta cada cambio.</a:t>
             </a:r>
             <a:endParaRPr lang="en-US" sz="1700" dirty="0"/>
           </a:p>
@@ -2523,13 +2524,13 @@
             <a:r>
               <a:rPr lang="en-US" sz="2000" b="1" dirty="0">
                 <a:solidFill>
-                  <a:srgbClr val="202CFC"/>
+                  <a:srgbClr val="5A5F73"/>
                 </a:solidFill>
                 <a:latin typeface="Arial" pitchFamily="34" charset="0"/>
                 <a:ea typeface="Arial" pitchFamily="34" charset="-122"/>
                 <a:cs typeface="Arial" pitchFamily="34" charset="-120"/>
               </a:rPr>
-              <a:t>Lo que se buscaba</a:t>
+              <a:t>Con todo junto</a:t>
             </a:r>
             <a:endParaRPr lang="en-US" sz="2000" dirty="0"/>
           </a:p>
@@ -2544,7 +2545,7 @@
         <p:spPr>
           <a:xfrm>
             <a:off x="777240" y="2926080"/>
-            <a:ext cx="4846320" cy="2377440"/>
+            <a:ext cx="4846320" cy="2560320"/>
           </a:xfrm>
           <a:prstGeom prst="rect">
             <a:avLst/>
@@ -2575,7 +2576,7 @@
                 <a:ea typeface="Calibri" pitchFamily="34" charset="-122"/>
                 <a:cs typeface="Calibri" pitchFamily="34" charset="-120"/>
               </a:rPr>
-              <a:t>Poder testear sin levantar servidores</a:t>
+              <a:t>Pasar de SQLite a PostgreSQL toca media aplicación</a:t>
             </a:r>
             <a:endParaRPr lang="en-US" sz="1600" dirty="0"/>
           </a:p>
@@ -2599,7 +2600,7 @@
                 <a:ea typeface="Calibri" pitchFamily="34" charset="-122"/>
                 <a:cs typeface="Calibri" pitchFamily="34" charset="-120"/>
               </a:rPr>
-              <a:t>Cambiar de proveedor de IA sin tocar la lógica del core</a:t>
+              <a:t>Cambiar de proveedor de IA, lo mismo</a:t>
             </a:r>
             <a:endParaRPr lang="en-US" sz="1600" dirty="0"/>
           </a:p>
@@ -2623,7 +2624,7 @@
                 <a:ea typeface="Calibri" pitchFamily="34" charset="-122"/>
                 <a:cs typeface="Calibri" pitchFamily="34" charset="-120"/>
               </a:rPr>
-              <a:t>Cambiar el framework web desde un solo punto</a:t>
+              <a:t>Cambiar el framework web, lo mismo</a:t>
             </a:r>
             <a:endParaRPr lang="en-US" sz="1600" dirty="0"/>
           </a:p>
@@ -2647,7 +2648,7 @@
                 <a:ea typeface="Calibri" pitchFamily="34" charset="-122"/>
                 <a:cs typeface="Calibri" pitchFamily="34" charset="-120"/>
               </a:rPr>
-              <a:t>Que fuera fácil de explicar en la defensa</a:t>
+              <a:t>Para testear hay que levantar servidor y base de datos</a:t>
             </a:r>
             <a:endParaRPr lang="en-US" sz="1600" dirty="0"/>
           </a:p>
@@ -2686,7 +2687,7 @@
                 <a:ea typeface="Arial" pitchFamily="34" charset="-122"/>
                 <a:cs typeface="Arial" pitchFamily="34" charset="-120"/>
               </a:rPr>
-              <a:t>Lo que cuesta</a:t>
+              <a:t>Con puertos y adaptadores</a:t>
             </a:r>
             <a:endParaRPr lang="en-US" sz="2000" dirty="0"/>
           </a:p>
@@ -2701,7 +2702,7 @@
         <p:spPr>
           <a:xfrm>
             <a:off x="6537960" y="2926080"/>
-            <a:ext cx="4846320" cy="2377440"/>
+            <a:ext cx="4846320" cy="2560320"/>
           </a:xfrm>
           <a:prstGeom prst="rect">
             <a:avLst/>
@@ -2732,7 +2733,7 @@
                 <a:ea typeface="Calibri" pitchFamily="34" charset="-122"/>
                 <a:cs typeface="Calibri" pitchFamily="34" charset="-120"/>
               </a:rPr>
-              <a:t>Más ficheros que un enfoque monolítico</a:t>
+              <a:t>Pasar de SQLite a PostgreSQL toca un adaptador</a:t>
             </a:r>
             <a:endParaRPr lang="en-US" sz="1600" dirty="0"/>
           </a:p>
@@ -2756,15 +2757,102 @@
                 <a:ea typeface="Calibri" pitchFamily="34" charset="-122"/>
                 <a:cs typeface="Calibri" pitchFamily="34" charset="-120"/>
               </a:rPr>
-              <a:t>La inyección manual crece con cada adaptador nuevo</a:t>
+              <a:t>Cambiar de proveedor de IA toca otro</a:t>
             </a:r>
             <a:endParaRPr lang="en-US" sz="1600" dirty="0"/>
           </a:p>
-        </p:txBody>
-      </p:sp>
-      <p:sp>
-        <p:nvSpPr>
-          <p:cNvPr id="8" name="Shape 6"/>
+          <a:p>
+            <a:pPr marL="342900" indent="-342900">
+              <a:lnSpc>
+                <a:spcPts val="2200"/>
+              </a:lnSpc>
+              <a:spcAft>
+                <a:spcPts val="1200"/>
+              </a:spcAft>
+              <a:buSzPct val="100000"/>
+              <a:buChar char="•"/>
+            </a:pPr>
+            <a:r>
+              <a:rPr lang="en-US" sz="1600" dirty="0">
+                <a:solidFill>
+                  <a:srgbClr val="1A1C2E"/>
+                </a:solidFill>
+                <a:latin typeface="Calibri" pitchFamily="34" charset="0"/>
+                <a:ea typeface="Calibri" pitchFamily="34" charset="-122"/>
+                <a:cs typeface="Calibri" pitchFamily="34" charset="-120"/>
+              </a:rPr>
+              <a:t>El framework web se cambia desde un solo punto</a:t>
+            </a:r>
+            <a:endParaRPr lang="en-US" sz="1600" dirty="0"/>
+          </a:p>
+          <a:p>
+            <a:pPr marL="342900" indent="-342900">
+              <a:lnSpc>
+                <a:spcPts val="2200"/>
+              </a:lnSpc>
+              <a:spcAft>
+                <a:spcPts val="1200"/>
+              </a:spcAft>
+              <a:buSzPct val="100000"/>
+              <a:buChar char="•"/>
+            </a:pPr>
+            <a:r>
+              <a:rPr lang="en-US" sz="1600" dirty="0">
+                <a:solidFill>
+                  <a:srgbClr val="1A1C2E"/>
+                </a:solidFill>
+                <a:latin typeface="Calibri" pitchFamily="34" charset="0"/>
+                <a:ea typeface="Calibri" pitchFamily="34" charset="-122"/>
+                <a:cs typeface="Calibri" pitchFamily="34" charset="-120"/>
+              </a:rPr>
+              <a:t>Los tests corren contra el puerto, sin levantar nada</a:t>
+            </a:r>
+            <a:endParaRPr lang="en-US" sz="1600" dirty="0"/>
+          </a:p>
+        </p:txBody>
+      </p:sp>
+      <p:sp>
+        <p:nvSpPr>
+          <p:cNvPr id="8" name="Text 6"/>
+          <p:cNvSpPr/>
+          <p:nvPr/>
+        </p:nvSpPr>
+        <p:spPr>
+          <a:xfrm>
+            <a:off x="777240" y="5669280"/>
+            <a:ext cx="10607040" cy="365760"/>
+          </a:xfrm>
+          <a:prstGeom prst="rect">
+            <a:avLst/>
+          </a:prstGeom>
+          <a:noFill/>
+          <a:ln/>
+        </p:spPr>
+        <p:txBody>
+          <a:bodyPr wrap="square" lIns="0" tIns="0" rIns="0" bIns="0" rtlCol="0" anchor="ctr"/>
+          <a:lstStyle/>
+          <a:p>
+            <a:pPr indent="0" marL="0">
+              <a:buNone/>
+            </a:pPr>
+            <a:r>
+              <a:rPr lang="en-US" sz="1500" dirty="0">
+                <a:solidFill>
+                  <a:srgbClr val="5A5F73"/>
+                </a:solidFill>
+                <a:latin typeface="Calibri" pitchFamily="34" charset="0"/>
+                <a:ea typeface="Calibri" pitchFamily="34" charset="-122"/>
+                <a:cs typeface="Calibri" pitchFamily="34" charset="-120"/>
+              </a:rPr>
+              <a:t>El dominio y los casos de uso no se enteran de ninguno de esos cambios.</a:t>
+            </a:r>
+            <a:endParaRPr lang="en-US" sz="1500" dirty="0"/>
+          </a:p>
+        </p:txBody>
+      </p:sp>
+      <p:sp>
+        <p:nvSpPr>
+          <p:cNvPr id="9" name="Shape 7"/>
           <p:cNvSpPr/>
           <p:nvPr/>
         </p:nvSpPr>
@@ -2784,7 +2872,7 @@
       </p:sp>
       <p:sp>
         <p:nvSpPr>
-          <p:cNvPr id="9" name="Text 7"/>
+          <p:cNvPr id="10" name="Text 8"/>
           <p:cNvSpPr/>
           <p:nvPr/>
         </p:nvSpPr>
@@ -2823,7 +2911,7 @@
       </p:sp>
       <p:sp>
         <p:nvSpPr>
-          <p:cNvPr id="10" name="Text 8"/>
+          <p:cNvPr id="11" name="Text 9"/>
           <p:cNvSpPr/>
           <p:nvPr/>
         </p:nvSpPr>
@@ -2862,7 +2950,7 @@
       </p:sp>
       <p:sp>
         <p:nvSpPr>
-          <p:cNvPr id="11" name="Text 9"/>
+          <p:cNvPr id="12" name="Text 10"/>
           <p:cNvSpPr/>
           <p:nvPr/>
         </p:nvSpPr>

</xml_diff>

<commit_message>
docs(tfm): justificar la arquitectura frente a las alternativas
</commit_message>
<xml_diff>
--- a/docs/presentacion/tfm-intelligent-automotive-diagnostics.pptx
+++ b/docs/presentacion/tfm-intelligent-automotive-diagnostics.pptx
@@ -778,11 +778,10 @@
           <a:p>
             <a:r>
               <a:rPr lang="en-US" dirty="0"/>
-              <a:t>¿Por qué Clean Architecture y hexagonal? Porque esto es una herramienta que va a seguir evolucionando, y lo que decide si una arquitectura es mejor o peor aquí es qué te cuesta cada cambio.
-Ahora mismo funciona con SQLite, porque era lo más rápido para desarrollar el proyecto. Pero en un futuro tendrá que usar PostgreSQL. Si tuviera la lógica mezclada con el acceso a datos, ese cambio me obligaría a tocar media aplicación. Como está detrás de un puerto, se cambia el adaptador y ya está.
-Y lo mismo con el resto: cambiar de proveedor de LLM, cambiar el framework web, o cambiar la forma de acceder al coche. El dominio y los casos de uso no se enteran.
-La otra razón es que se testea sin levantar nada, porque los tests hablan con los puertos y no con la base de datos real.
-Está todo escrito en el ADR-001, con sus contras: hay más ficheros que en un monolito, y la inyección manual del composition root crece con cada adaptador nuevo.
+              <a:t>¿Por qué Clean Architecture y no otra cosa? Porque en este proyecto el dominio no es algo que me haya inventado yo: son normas. SAE J1979, ISO 15031, ISO 15765-4 para el bus CAN, ISO 3779 para el VIN. Las fórmulas que convierten cada PID en una magnitud física, y la decodificación del bastidor. Eso no lo cambia nadie, y no puede estar mezclado con el acceso a datos ni con el modelo de lenguaje.
+Con Clean Architecture eso vive en el dominio, aislado, y lo que sí cambia —la base de datos, el LLM, el transporte OBD, el framework web— vive fuera, en adaptadores.
+¿Y por qué no una arquitectura orientada a eventos? Porque aquí no hay varios servicios que desacoplar: es un solo proceso. Y el flujo es síncrono: el mecánico pregunta y se queda esperando la respuesta. Meter un broker y colas me traería consistencia eventual y mucha más superficie de depuración, sin ganar nada a cambio.
+Y hay una razón práctica: soy un solo programador. Cuantas más piezas móviles, más sitio donde romper.
 [~80 s]</a:t>
             </a:r>
             <a:endParaRPr lang="en-US" dirty="0"/>
@@ -2452,7 +2451,7 @@
                 <a:ea typeface="Arial" pitchFamily="34" charset="-122"/>
                 <a:cs typeface="Arial" pitchFamily="34" charset="-120"/>
               </a:rPr>
-              <a:t>Por qué esta arquitectura</a:t>
+              <a:t>Por qué esta arquitectura y no otra</a:t>
             </a:r>
             <a:endParaRPr lang="en-US" sz="3400" dirty="0"/>
           </a:p>
@@ -2491,7 +2490,7 @@
                 <a:ea typeface="Calibri" pitchFamily="34" charset="-122"/>
                 <a:cs typeface="Calibri" pitchFamily="34" charset="-120"/>
               </a:rPr>
-              <a:t>La herramienta va a seguir cambiando. La pregunta es qué cuesta cada cambio.</a:t>
+              <a:t>Aquí el dominio son normas. Y las normas no las cambia nadie.</a:t>
             </a:r>
             <a:endParaRPr lang="en-US" sz="1700" dirty="0"/>
           </a:p>
@@ -2524,13 +2523,13 @@
             <a:r>
               <a:rPr lang="en-US" sz="2000" b="1" dirty="0">
                 <a:solidFill>
-                  <a:srgbClr val="5A5F73"/>
+                  <a:srgbClr val="202CFC"/>
                 </a:solidFill>
                 <a:latin typeface="Arial" pitchFamily="34" charset="0"/>
                 <a:ea typeface="Arial" pitchFamily="34" charset="-122"/>
                 <a:cs typeface="Arial" pitchFamily="34" charset="-120"/>
               </a:rPr>
-              <a:t>Con todo junto</a:t>
+              <a:t>Por qué Clean + Hexagonal</a:t>
             </a:r>
             <a:endParaRPr lang="en-US" sz="2000" dirty="0"/>
           </a:p>
@@ -2545,7 +2544,7 @@
         <p:spPr>
           <a:xfrm>
             <a:off x="777240" y="2926080"/>
-            <a:ext cx="4846320" cy="2560320"/>
+            <a:ext cx="4846320" cy="2651760"/>
           </a:xfrm>
           <a:prstGeom prst="rect">
             <a:avLst/>
@@ -2576,7 +2575,7 @@
                 <a:ea typeface="Calibri" pitchFamily="34" charset="-122"/>
                 <a:cs typeface="Calibri" pitchFamily="34" charset="-120"/>
               </a:rPr>
-              <a:t>Pasar de SQLite a PostgreSQL toca media aplicación</a:t>
+              <a:t>SAE J1979, ISO 15031, ISO 15765-4, ISO 3779</a:t>
             </a:r>
             <a:endParaRPr lang="en-US" sz="1600" dirty="0"/>
           </a:p>
@@ -2600,7 +2599,7 @@
                 <a:ea typeface="Calibri" pitchFamily="34" charset="-122"/>
                 <a:cs typeface="Calibri" pitchFamily="34" charset="-120"/>
               </a:rPr>
-              <a:t>Cambiar de proveedor de IA, lo mismo</a:t>
+              <a:t>Las fórmulas de conversión de cada PID</a:t>
             </a:r>
             <a:endParaRPr lang="en-US" sz="1600" dirty="0"/>
           </a:p>
@@ -2624,7 +2623,7 @@
                 <a:ea typeface="Calibri" pitchFamily="34" charset="-122"/>
                 <a:cs typeface="Calibri" pitchFamily="34" charset="-120"/>
               </a:rPr>
-              <a:t>Cambiar el framework web, lo mismo</a:t>
+              <a:t>La decodificación del VIN</a:t>
             </a:r>
             <a:endParaRPr lang="en-US" sz="1600" dirty="0"/>
           </a:p>
@@ -2648,7 +2647,7 @@
                 <a:ea typeface="Calibri" pitchFamily="34" charset="-122"/>
                 <a:cs typeface="Calibri" pitchFamily="34" charset="-120"/>
               </a:rPr>
-              <a:t>Para testear hay que levantar servidor y base de datos</a:t>
+              <a:t>Todo eso vive en el dominio, sin mezclarse con la base de datos ni con el LLM</a:t>
             </a:r>
             <a:endParaRPr lang="en-US" sz="1600" dirty="0"/>
           </a:p>
@@ -2681,13 +2680,13 @@
             <a:r>
               <a:rPr lang="en-US" sz="2000" b="1" dirty="0">
                 <a:solidFill>
-                  <a:srgbClr val="202CFC"/>
+                  <a:srgbClr val="5A5F73"/>
                 </a:solidFill>
                 <a:latin typeface="Arial" pitchFamily="34" charset="0"/>
                 <a:ea typeface="Arial" pitchFamily="34" charset="-122"/>
                 <a:cs typeface="Arial" pitchFamily="34" charset="-120"/>
               </a:rPr>
-              <a:t>Con puertos y adaptadores</a:t>
+              <a:t>Por qué no orientada a eventos</a:t>
             </a:r>
             <a:endParaRPr lang="en-US" sz="2000" dirty="0"/>
           </a:p>
@@ -2702,7 +2701,7 @@
         <p:spPr>
           <a:xfrm>
             <a:off x="6537960" y="2926080"/>
-            <a:ext cx="4846320" cy="2560320"/>
+            <a:ext cx="4846320" cy="2651760"/>
           </a:xfrm>
           <a:prstGeom prst="rect">
             <a:avLst/>
@@ -2733,7 +2732,7 @@
                 <a:ea typeface="Calibri" pitchFamily="34" charset="-122"/>
                 <a:cs typeface="Calibri" pitchFamily="34" charset="-120"/>
               </a:rPr>
-              <a:t>Pasar de SQLite a PostgreSQL toca un adaptador</a:t>
+              <a:t>No hay varios servicios que desacoplar: es un proceso</a:t>
             </a:r>
             <a:endParaRPr lang="en-US" sz="1600" dirty="0"/>
           </a:p>
@@ -2757,7 +2756,7 @@
                 <a:ea typeface="Calibri" pitchFamily="34" charset="-122"/>
                 <a:cs typeface="Calibri" pitchFamily="34" charset="-120"/>
               </a:rPr>
-              <a:t>Cambiar de proveedor de IA toca otro</a:t>
+              <a:t>El mecánico pregunta y espera respuesta: el flujo es síncrono</a:t>
             </a:r>
             <a:endParaRPr lang="en-US" sz="1600" dirty="0"/>
           </a:p>
@@ -2781,7 +2780,7 @@
                 <a:ea typeface="Calibri" pitchFamily="34" charset="-122"/>
                 <a:cs typeface="Calibri" pitchFamily="34" charset="-120"/>
               </a:rPr>
-              <a:t>El framework web se cambia desde un solo punto</a:t>
+              <a:t>Añadiría broker, colas y consistencia eventual sin ganar nada</a:t>
             </a:r>
             <a:endParaRPr lang="en-US" sz="1600" dirty="0"/>
           </a:p>
@@ -2805,7 +2804,7 @@
                 <a:ea typeface="Calibri" pitchFamily="34" charset="-122"/>
                 <a:cs typeface="Calibri" pitchFamily="34" charset="-120"/>
               </a:rPr>
-              <a:t>Los tests corren contra el puerto, sin levantar nada</a:t>
+              <a:t>Un solo programador: más piezas es más sitio donde romper</a:t>
             </a:r>
             <a:endParaRPr lang="en-US" sz="1600" dirty="0"/>
           </a:p>
@@ -2813,46 +2812,7 @@
       </p:sp>
       <p:sp>
         <p:nvSpPr>
-          <p:cNvPr id="8" name="Text 6"/>
-          <p:cNvSpPr/>
-          <p:nvPr/>
-        </p:nvSpPr>
-        <p:spPr>
-          <a:xfrm>
-            <a:off x="777240" y="5669280"/>
-            <a:ext cx="10607040" cy="365760"/>
-          </a:xfrm>
-          <a:prstGeom prst="rect">
-            <a:avLst/>
-          </a:prstGeom>
-          <a:noFill/>
-          <a:ln/>
-        </p:spPr>
-        <p:txBody>
-          <a:bodyPr wrap="square" lIns="0" tIns="0" rIns="0" bIns="0" rtlCol="0" anchor="ctr"/>
-          <a:lstStyle/>
-          <a:p>
-            <a:pPr indent="0" marL="0">
-              <a:buNone/>
-            </a:pPr>
-            <a:r>
-              <a:rPr lang="en-US" sz="1500" dirty="0">
-                <a:solidFill>
-                  <a:srgbClr val="5A5F73"/>
-                </a:solidFill>
-                <a:latin typeface="Calibri" pitchFamily="34" charset="0"/>
-                <a:ea typeface="Calibri" pitchFamily="34" charset="-122"/>
-                <a:cs typeface="Calibri" pitchFamily="34" charset="-120"/>
-              </a:rPr>
-              <a:t>El dominio y los casos de uso no se enteran de ninguno de esos cambios.</a:t>
-            </a:r>
-            <a:endParaRPr lang="en-US" sz="1500" dirty="0"/>
-          </a:p>
-        </p:txBody>
-      </p:sp>
-      <p:sp>
-        <p:nvSpPr>
-          <p:cNvPr id="9" name="Shape 7"/>
+          <p:cNvPr id="8" name="Shape 6"/>
           <p:cNvSpPr/>
           <p:nvPr/>
         </p:nvSpPr>
@@ -2872,7 +2832,7 @@
       </p:sp>
       <p:sp>
         <p:nvSpPr>
-          <p:cNvPr id="10" name="Text 8"/>
+          <p:cNvPr id="9" name="Text 7"/>
           <p:cNvSpPr/>
           <p:nvPr/>
         </p:nvSpPr>
@@ -2911,7 +2871,7 @@
       </p:sp>
       <p:sp>
         <p:nvSpPr>
-          <p:cNvPr id="11" name="Text 9"/>
+          <p:cNvPr id="10" name="Text 8"/>
           <p:cNvSpPr/>
           <p:nvPr/>
         </p:nvSpPr>
@@ -2950,7 +2910,7 @@
       </p:sp>
       <p:sp>
         <p:nvSpPr>
-          <p:cNvPr id="12" name="Text 10"/>
+          <p:cNvPr id="11" name="Text 9"/>
           <p:cNvSpPr/>
           <p:nvPr/>
         </p:nvSpPr>

</xml_diff>

<commit_message>
docs(tfm): slide de las tres capas
</commit_message>
<xml_diff>
--- a/docs/presentacion/tfm-intelligent-automotive-diagnostics.pptx
+++ b/docs/presentacion/tfm-intelligent-automotive-diagnostics.pptx
@@ -9,9 +9,10 @@
     <p:sldId id="257" r:id="rId3"/>
     <p:sldId id="258" r:id="rId4"/>
     <p:sldId id="259" r:id="rId5"/>
+    <p:sldId id="260" r:id="rId6"/>
   </p:sldIdLst>
   <p:notesMasterIdLst>
-    <p:notesMasterId r:id="rId6"/>
+    <p:notesMasterId r:id="rId7"/>
   </p:notesMasterIdLst>
   <p:sldSz cx="12192000" cy="6858000"/>
   <p:notesSz cx="6858000" cy="12192000"/>
@@ -806,6 +807,99 @@
             <a:fld id="{F7021451-1387-4CA6-816F-3879F97B5CBC}" type="slidenum">
               <a:rPr lang="en-US"/>
               <a:t>4</a:t>
+            </a:fld>
+            <a:endParaRPr lang="en-US"/>
+          </a:p>
+        </p:txBody>
+      </p:sp>
+    </p:spTree>
+    <p:extLst>
+      <p:ext uri="{BB962C8B-B14F-4D97-AF65-F5344CB8AC3E}">
+        <p14:creationId xmlns:p14="http://schemas.microsoft.com/office/powerpoint/2010/main" val="1024086991"/>
+      </p:ext>
+    </p:extLst>
+  </p:cSld>
+  <p:clrMapOvr>
+    <a:masterClrMapping/>
+  </p:clrMapOvr>
+</p:notes>
+</file>
+
+<file path=ppt/notesSlides/notesSlide5.xml><?xml version="1.0" encoding="utf-8"?>
+<p:notes xmlns:a="http://schemas.openxmlformats.org/drawingml/2006/main" xmlns:r="http://schemas.openxmlformats.org/officeDocument/2006/relationships" xmlns:p="http://schemas.openxmlformats.org/presentationml/2006/main">
+  <p:cSld>
+    <p:spTree>
+      <p:nvGrpSpPr>
+        <p:cNvPr id="1" name=""/>
+        <p:cNvGrpSpPr/>
+        <p:nvPr/>
+      </p:nvGrpSpPr>
+      <p:grpSpPr>
+        <a:xfrm>
+          <a:off x="0" y="0"/>
+          <a:ext cx="0" cy="0"/>
+          <a:chOff x="0" y="0"/>
+          <a:chExt cx="0" cy="0"/>
+        </a:xfrm>
+      </p:grpSpPr>
+      <p:sp>
+        <p:nvSpPr>
+          <p:cNvPr id="2" name="Slide Image Placeholder 1"/>
+          <p:cNvSpPr>
+            <a:spLocks noGrp="1" noRot="1" noChangeAspect="1"/>
+          </p:cNvSpPr>
+          <p:nvPr>
+            <p:ph type="sldImg"/>
+          </p:nvPr>
+        </p:nvSpPr>
+        <p:spPr/>
+      </p:sp>
+      <p:sp>
+        <p:nvSpPr>
+          <p:cNvPr id="3" name="Notes Placeholder 2"/>
+          <p:cNvSpPr>
+            <a:spLocks noGrp="1"/>
+          </p:cNvSpPr>
+          <p:nvPr>
+            <p:ph type="body" idx="1"/>
+          </p:nvPr>
+        </p:nvSpPr>
+        <p:spPr/>
+        <p:txBody>
+          <a:bodyPr/>
+          <a:lstStyle/>
+          <a:p>
+            <a:r>
+              <a:rPr lang="en-US" dirty="0"/>
+              <a:t>Tres capas, y las dependencias van siempre hacia dentro.
+En el dominio están los value objects y los catálogos: el VIN, el código DTC, el código de PID, las fórmulas, y las tablas de referencia. Es lo que dicen las normas. Esta capa no importa absolutamente nada de las otras dos.
+En aplicación están los casos de uso —identificar el vehículo, leer telemetría, barrer las ECUs, ejecutar el diagnóstico determinista y el cognitivo— y los puertos, que son interfaces. Aquí se dice QUÉ hace falta, no CÓMO se consigue. Esta capa solo conoce el dominio.
+Y en infraestructura está el cómo: Express, Drizzle sobre SQLite, LanceDB para los vectores, el servidor MCP, los clientes de Anthropic y OpenAI, y el transporte del ELM327 con su simulador. Todo eso implementa los puertos de la capa de aplicación.
+La consecuencia práctica es la de la slide anterior: el dominio no sabe que existe SQLite, ni Express, ni ningún modelo de lenguaje.
+[~70 s]</a:t>
+            </a:r>
+            <a:endParaRPr lang="en-US" dirty="0"/>
+          </a:p>
+        </p:txBody>
+      </p:sp>
+      <p:sp>
+        <p:nvSpPr>
+          <p:cNvPr id="4" name="Slide Number Placeholder 3"/>
+          <p:cNvSpPr>
+            <a:spLocks noGrp="1"/>
+          </p:cNvSpPr>
+          <p:nvPr>
+            <p:ph type="sldNum" sz="quarter" idx="10"/>
+          </p:nvPr>
+        </p:nvSpPr>
+        <p:spPr/>
+        <p:txBody>
+          <a:bodyPr/>
+          <a:lstStyle/>
+          <a:p>
+            <a:fld id="{F7021451-1387-4CA6-816F-3879F97B5CBC}" type="slidenum">
+              <a:rPr lang="en-US"/>
+              <a:t>5</a:t>
             </a:fld>
             <a:endParaRPr lang="en-US"/>
           </a:p>
@@ -2955,6 +3049,808 @@
 </p:sld>
 </file>
 
+<file path=ppt/slides/slide5.xml><?xml version="1.0" encoding="utf-8"?>
+<p:sld xmlns:a="http://schemas.openxmlformats.org/drawingml/2006/main" xmlns:r="http://schemas.openxmlformats.org/officeDocument/2006/relationships" xmlns:p="http://schemas.openxmlformats.org/presentationml/2006/main">
+  <p:cSld name="Slide 5">
+    <p:bg>
+      <p:bgPr>
+        <a:solidFill>
+          <a:srgbClr val="FFFFFF"/>
+        </a:solidFill>
+      </p:bgPr>
+    </p:bg>
+    <p:spTree>
+      <p:nvGrpSpPr>
+        <p:cNvPr id="1" name=""/>
+        <p:cNvGrpSpPr/>
+        <p:nvPr/>
+      </p:nvGrpSpPr>
+      <p:grpSpPr>
+        <a:xfrm>
+          <a:off x="0" y="0"/>
+          <a:ext cx="0" cy="0"/>
+          <a:chOff x="0" y="0"/>
+          <a:chExt cx="0" cy="0"/>
+        </a:xfrm>
+      </p:grpSpPr>
+      <p:sp>
+        <p:nvSpPr>
+          <p:cNvPr id="2" name="Text 0"/>
+          <p:cNvSpPr/>
+          <p:nvPr/>
+        </p:nvSpPr>
+        <p:spPr>
+          <a:xfrm>
+            <a:off x="777240" y="685800"/>
+            <a:ext cx="10607040" cy="822960"/>
+          </a:xfrm>
+          <a:prstGeom prst="rect">
+            <a:avLst/>
+          </a:prstGeom>
+          <a:noFill/>
+          <a:ln/>
+        </p:spPr>
+        <p:txBody>
+          <a:bodyPr wrap="square" lIns="0" tIns="0" rIns="0" bIns="0" rtlCol="0" anchor="t"/>
+          <a:lstStyle/>
+          <a:p>
+            <a:pPr indent="0" marL="0">
+              <a:buNone/>
+            </a:pPr>
+            <a:r>
+              <a:rPr lang="en-US" sz="3400" b="1" dirty="0">
+                <a:solidFill>
+                  <a:srgbClr val="1A1C2E"/>
+                </a:solidFill>
+                <a:latin typeface="Arial" pitchFamily="34" charset="0"/>
+                <a:ea typeface="Arial" pitchFamily="34" charset="-122"/>
+                <a:cs typeface="Arial" pitchFamily="34" charset="-120"/>
+              </a:rPr>
+              <a:t>Las tres capas</a:t>
+            </a:r>
+            <a:endParaRPr lang="en-US" sz="3400" dirty="0"/>
+          </a:p>
+        </p:txBody>
+      </p:sp>
+      <p:sp>
+        <p:nvSpPr>
+          <p:cNvPr id="3" name="Text 1"/>
+          <p:cNvSpPr/>
+          <p:nvPr/>
+        </p:nvSpPr>
+        <p:spPr>
+          <a:xfrm>
+            <a:off x="777240" y="1600200"/>
+            <a:ext cx="10607040" cy="365760"/>
+          </a:xfrm>
+          <a:prstGeom prst="rect">
+            <a:avLst/>
+          </a:prstGeom>
+          <a:noFill/>
+          <a:ln/>
+        </p:spPr>
+        <p:txBody>
+          <a:bodyPr wrap="square" lIns="0" tIns="0" rIns="0" bIns="0" rtlCol="0" anchor="t"/>
+          <a:lstStyle/>
+          <a:p>
+            <a:pPr indent="0" marL="0">
+              <a:buNone/>
+            </a:pPr>
+            <a:r>
+              <a:rPr lang="en-US" sz="1700" dirty="0">
+                <a:solidFill>
+                  <a:srgbClr val="5A5F73"/>
+                </a:solidFill>
+                <a:latin typeface="Calibri" pitchFamily="34" charset="0"/>
+                <a:ea typeface="Calibri" pitchFamily="34" charset="-122"/>
+                <a:cs typeface="Calibri" pitchFamily="34" charset="-120"/>
+              </a:rPr>
+              <a:t>Las flechas van hacia dentro: dominio  ←  aplicación  ←  infraestructura.</a:t>
+            </a:r>
+            <a:endParaRPr lang="en-US" sz="1700" dirty="0"/>
+          </a:p>
+        </p:txBody>
+      </p:sp>
+      <p:sp>
+        <p:nvSpPr>
+          <p:cNvPr id="4" name="Text 2"/>
+          <p:cNvSpPr/>
+          <p:nvPr/>
+        </p:nvSpPr>
+        <p:spPr>
+          <a:xfrm>
+            <a:off x="777240" y="2377440"/>
+            <a:ext cx="3291840" cy="365760"/>
+          </a:xfrm>
+          <a:prstGeom prst="rect">
+            <a:avLst/>
+          </a:prstGeom>
+          <a:noFill/>
+          <a:ln/>
+        </p:spPr>
+        <p:txBody>
+          <a:bodyPr wrap="square" lIns="0" tIns="0" rIns="0" bIns="0" rtlCol="0" anchor="t"/>
+          <a:lstStyle/>
+          <a:p>
+            <a:pPr indent="0" marL="0">
+              <a:buNone/>
+            </a:pPr>
+            <a:r>
+              <a:rPr lang="en-US" sz="2000" b="1" dirty="0">
+                <a:solidFill>
+                  <a:srgbClr val="202CFC"/>
+                </a:solidFill>
+                <a:latin typeface="Arial" pitchFamily="34" charset="0"/>
+                <a:ea typeface="Arial" pitchFamily="34" charset="-122"/>
+                <a:cs typeface="Arial" pitchFamily="34" charset="-120"/>
+              </a:rPr>
+              <a:t>Dominio</a:t>
+            </a:r>
+            <a:endParaRPr lang="en-US" sz="2000" dirty="0"/>
+          </a:p>
+        </p:txBody>
+      </p:sp>
+      <p:sp>
+        <p:nvSpPr>
+          <p:cNvPr id="5" name="Text 3"/>
+          <p:cNvSpPr/>
+          <p:nvPr/>
+        </p:nvSpPr>
+        <p:spPr>
+          <a:xfrm>
+            <a:off x="777240" y="2788920"/>
+            <a:ext cx="3291840" cy="292608"/>
+          </a:xfrm>
+          <a:prstGeom prst="rect">
+            <a:avLst/>
+          </a:prstGeom>
+          <a:noFill/>
+          <a:ln/>
+        </p:spPr>
+        <p:txBody>
+          <a:bodyPr wrap="square" lIns="0" tIns="0" rIns="0" bIns="0" rtlCol="0" anchor="t"/>
+          <a:lstStyle/>
+          <a:p>
+            <a:pPr indent="0" marL="0">
+              <a:buNone/>
+            </a:pPr>
+            <a:r>
+              <a:rPr lang="en-US" sz="1300" i="1" dirty="0">
+                <a:solidFill>
+                  <a:srgbClr val="5A5F73"/>
+                </a:solidFill>
+                <a:latin typeface="Calibri" pitchFamily="34" charset="0"/>
+                <a:ea typeface="Calibri" pitchFamily="34" charset="-122"/>
+                <a:cs typeface="Calibri" pitchFamily="34" charset="-120"/>
+              </a:rPr>
+              <a:t>No importa nada de fuera</a:t>
+            </a:r>
+            <a:endParaRPr lang="en-US" sz="1300" dirty="0"/>
+          </a:p>
+        </p:txBody>
+      </p:sp>
+      <p:sp>
+        <p:nvSpPr>
+          <p:cNvPr id="6" name="Text 4"/>
+          <p:cNvSpPr/>
+          <p:nvPr/>
+        </p:nvSpPr>
+        <p:spPr>
+          <a:xfrm>
+            <a:off x="777240" y="3246120"/>
+            <a:ext cx="3291840" cy="2286000"/>
+          </a:xfrm>
+          <a:prstGeom prst="rect">
+            <a:avLst/>
+          </a:prstGeom>
+          <a:noFill/>
+          <a:ln/>
+        </p:spPr>
+        <p:txBody>
+          <a:bodyPr wrap="square" lIns="0" tIns="0" rIns="0" bIns="0" rtlCol="0" anchor="t"/>
+          <a:lstStyle/>
+          <a:p>
+            <a:pPr marL="342900" indent="-342900">
+              <a:lnSpc>
+                <a:spcPts val="2000"/>
+              </a:lnSpc>
+              <a:spcAft>
+                <a:spcPts val="1200"/>
+              </a:spcAft>
+              <a:buSzPct val="100000"/>
+              <a:buChar char="•"/>
+            </a:pPr>
+            <a:r>
+              <a:rPr lang="en-US" sz="1400" dirty="0">
+                <a:solidFill>
+                  <a:srgbClr val="1A1C2E"/>
+                </a:solidFill>
+                <a:latin typeface="Calibri" pitchFamily="34" charset="0"/>
+                <a:ea typeface="Calibri" pitchFamily="34" charset="-122"/>
+                <a:cs typeface="Calibri" pitchFamily="34" charset="-120"/>
+              </a:rPr>
+              <a:t>Vin, DtcCode, PidCode, Formula</a:t>
+            </a:r>
+            <a:endParaRPr lang="en-US" sz="1400" dirty="0"/>
+          </a:p>
+          <a:p>
+            <a:pPr marL="342900" indent="-342900">
+              <a:lnSpc>
+                <a:spcPts val="2000"/>
+              </a:lnSpc>
+              <a:spcAft>
+                <a:spcPts val="1200"/>
+              </a:spcAft>
+              <a:buSzPct val="100000"/>
+              <a:buChar char="•"/>
+            </a:pPr>
+            <a:r>
+              <a:rPr lang="en-US" sz="1400" dirty="0">
+                <a:solidFill>
+                  <a:srgbClr val="1A1C2E"/>
+                </a:solidFill>
+                <a:latin typeface="Calibri" pitchFamily="34" charset="0"/>
+                <a:ea typeface="Calibri" pitchFamily="34" charset="-122"/>
+                <a:cs typeface="Calibri" pitchFamily="34" charset="-120"/>
+              </a:rPr>
+              <a:t>Catálogos de PID, DTC y direcciones de ECU</a:t>
+            </a:r>
+            <a:endParaRPr lang="en-US" sz="1400" dirty="0"/>
+          </a:p>
+          <a:p>
+            <a:pPr marL="342900" indent="-342900">
+              <a:lnSpc>
+                <a:spcPts val="2000"/>
+              </a:lnSpc>
+              <a:spcAft>
+                <a:spcPts val="1200"/>
+              </a:spcAft>
+              <a:buSzPct val="100000"/>
+              <a:buChar char="•"/>
+            </a:pPr>
+            <a:r>
+              <a:rPr lang="en-US" sz="1400" dirty="0">
+                <a:solidFill>
+                  <a:srgbClr val="1A1C2E"/>
+                </a:solidFill>
+                <a:latin typeface="Calibri" pitchFamily="34" charset="0"/>
+                <a:ea typeface="Calibri" pitchFamily="34" charset="-122"/>
+                <a:cs typeface="Calibri" pitchFamily="34" charset="-120"/>
+              </a:rPr>
+              <a:t>Las normas SAE J1979 e ISO</a:t>
+            </a:r>
+            <a:endParaRPr lang="en-US" sz="1400" dirty="0"/>
+          </a:p>
+        </p:txBody>
+      </p:sp>
+      <p:sp>
+        <p:nvSpPr>
+          <p:cNvPr id="7" name="Text 5"/>
+          <p:cNvSpPr/>
+          <p:nvPr/>
+        </p:nvSpPr>
+        <p:spPr>
+          <a:xfrm>
+            <a:off x="4434840" y="2377440"/>
+            <a:ext cx="3291840" cy="365760"/>
+          </a:xfrm>
+          <a:prstGeom prst="rect">
+            <a:avLst/>
+          </a:prstGeom>
+          <a:noFill/>
+          <a:ln/>
+        </p:spPr>
+        <p:txBody>
+          <a:bodyPr wrap="square" lIns="0" tIns="0" rIns="0" bIns="0" rtlCol="0" anchor="t"/>
+          <a:lstStyle/>
+          <a:p>
+            <a:pPr indent="0" marL="0">
+              <a:buNone/>
+            </a:pPr>
+            <a:r>
+              <a:rPr lang="en-US" sz="2000" b="1" dirty="0">
+                <a:solidFill>
+                  <a:srgbClr val="202CFC"/>
+                </a:solidFill>
+                <a:latin typeface="Arial" pitchFamily="34" charset="0"/>
+                <a:ea typeface="Arial" pitchFamily="34" charset="-122"/>
+                <a:cs typeface="Arial" pitchFamily="34" charset="-120"/>
+              </a:rPr>
+              <a:t>Aplicación</a:t>
+            </a:r>
+            <a:endParaRPr lang="en-US" sz="2000" dirty="0"/>
+          </a:p>
+        </p:txBody>
+      </p:sp>
+      <p:sp>
+        <p:nvSpPr>
+          <p:cNvPr id="8" name="Text 6"/>
+          <p:cNvSpPr/>
+          <p:nvPr/>
+        </p:nvSpPr>
+        <p:spPr>
+          <a:xfrm>
+            <a:off x="4434840" y="2788920"/>
+            <a:ext cx="3291840" cy="292608"/>
+          </a:xfrm>
+          <a:prstGeom prst="rect">
+            <a:avLst/>
+          </a:prstGeom>
+          <a:noFill/>
+          <a:ln/>
+        </p:spPr>
+        <p:txBody>
+          <a:bodyPr wrap="square" lIns="0" tIns="0" rIns="0" bIns="0" rtlCol="0" anchor="t"/>
+          <a:lstStyle/>
+          <a:p>
+            <a:pPr indent="0" marL="0">
+              <a:buNone/>
+            </a:pPr>
+            <a:r>
+              <a:rPr lang="en-US" sz="1300" i="1" dirty="0">
+                <a:solidFill>
+                  <a:srgbClr val="5A5F73"/>
+                </a:solidFill>
+                <a:latin typeface="Calibri" pitchFamily="34" charset="0"/>
+                <a:ea typeface="Calibri" pitchFamily="34" charset="-122"/>
+                <a:cs typeface="Calibri" pitchFamily="34" charset="-120"/>
+              </a:rPr>
+              <a:t>Solo conoce el dominio</a:t>
+            </a:r>
+            <a:endParaRPr lang="en-US" sz="1300" dirty="0"/>
+          </a:p>
+        </p:txBody>
+      </p:sp>
+      <p:sp>
+        <p:nvSpPr>
+          <p:cNvPr id="9" name="Text 7"/>
+          <p:cNvSpPr/>
+          <p:nvPr/>
+        </p:nvSpPr>
+        <p:spPr>
+          <a:xfrm>
+            <a:off x="4434840" y="3246120"/>
+            <a:ext cx="3291840" cy="2286000"/>
+          </a:xfrm>
+          <a:prstGeom prst="rect">
+            <a:avLst/>
+          </a:prstGeom>
+          <a:noFill/>
+          <a:ln/>
+        </p:spPr>
+        <p:txBody>
+          <a:bodyPr wrap="square" lIns="0" tIns="0" rIns="0" bIns="0" rtlCol="0" anchor="t"/>
+          <a:lstStyle/>
+          <a:p>
+            <a:pPr marL="342900" indent="-342900">
+              <a:lnSpc>
+                <a:spcPts val="2000"/>
+              </a:lnSpc>
+              <a:spcAft>
+                <a:spcPts val="1200"/>
+              </a:spcAft>
+              <a:buSzPct val="100000"/>
+              <a:buChar char="•"/>
+            </a:pPr>
+            <a:r>
+              <a:rPr lang="en-US" sz="1400" dirty="0">
+                <a:solidFill>
+                  <a:srgbClr val="1A1C2E"/>
+                </a:solidFill>
+                <a:latin typeface="Calibri" pitchFamily="34" charset="0"/>
+                <a:ea typeface="Calibri" pitchFamily="34" charset="-122"/>
+                <a:cs typeface="Calibri" pitchFamily="34" charset="-120"/>
+              </a:rPr>
+              <a:t>IdentifyVehicle, GetLiveData, GetEcuInfo</a:t>
+            </a:r>
+            <a:endParaRPr lang="en-US" sz="1400" dirty="0"/>
+          </a:p>
+          <a:p>
+            <a:pPr marL="342900" indent="-342900">
+              <a:lnSpc>
+                <a:spcPts val="2000"/>
+              </a:lnSpc>
+              <a:spcAft>
+                <a:spcPts val="1200"/>
+              </a:spcAft>
+              <a:buSzPct val="100000"/>
+              <a:buChar char="•"/>
+            </a:pPr>
+            <a:r>
+              <a:rPr lang="en-US" sz="1400" dirty="0">
+                <a:solidFill>
+                  <a:srgbClr val="1A1C2E"/>
+                </a:solidFill>
+                <a:latin typeface="Calibri" pitchFamily="34" charset="0"/>
+                <a:ea typeface="Calibri" pitchFamily="34" charset="-122"/>
+                <a:cs typeface="Calibri" pitchFamily="34" charset="-120"/>
+              </a:rPr>
+              <a:t>ProcessVehicleDiagnosis, ExecuteCognitiveDiagnosis</a:t>
+            </a:r>
+            <a:endParaRPr lang="en-US" sz="1400" dirty="0"/>
+          </a:p>
+          <a:p>
+            <a:pPr marL="342900" indent="-342900">
+              <a:lnSpc>
+                <a:spcPts val="2000"/>
+              </a:lnSpc>
+              <a:spcAft>
+                <a:spcPts val="1200"/>
+              </a:spcAft>
+              <a:buSzPct val="100000"/>
+              <a:buChar char="•"/>
+            </a:pPr>
+            <a:r>
+              <a:rPr lang="en-US" sz="1400" dirty="0">
+                <a:solidFill>
+                  <a:srgbClr val="1A1C2E"/>
+                </a:solidFill>
+                <a:latin typeface="Calibri" pitchFamily="34" charset="0"/>
+                <a:ea typeface="Calibri" pitchFamily="34" charset="-122"/>
+                <a:cs typeface="Calibri" pitchFamily="34" charset="-120"/>
+              </a:rPr>
+              <a:t>Los puertos: ObdRepository, LlmClientPort…</a:t>
+            </a:r>
+            <a:endParaRPr lang="en-US" sz="1400" dirty="0"/>
+          </a:p>
+        </p:txBody>
+      </p:sp>
+      <p:sp>
+        <p:nvSpPr>
+          <p:cNvPr id="10" name="Text 8"/>
+          <p:cNvSpPr/>
+          <p:nvPr/>
+        </p:nvSpPr>
+        <p:spPr>
+          <a:xfrm>
+            <a:off x="8092440" y="2377440"/>
+            <a:ext cx="3291840" cy="365760"/>
+          </a:xfrm>
+          <a:prstGeom prst="rect">
+            <a:avLst/>
+          </a:prstGeom>
+          <a:noFill/>
+          <a:ln/>
+        </p:spPr>
+        <p:txBody>
+          <a:bodyPr wrap="square" lIns="0" tIns="0" rIns="0" bIns="0" rtlCol="0" anchor="t"/>
+          <a:lstStyle/>
+          <a:p>
+            <a:pPr indent="0" marL="0">
+              <a:buNone/>
+            </a:pPr>
+            <a:r>
+              <a:rPr lang="en-US" sz="2000" b="1" dirty="0">
+                <a:solidFill>
+                  <a:srgbClr val="202CFC"/>
+                </a:solidFill>
+                <a:latin typeface="Arial" pitchFamily="34" charset="0"/>
+                <a:ea typeface="Arial" pitchFamily="34" charset="-122"/>
+                <a:cs typeface="Arial" pitchFamily="34" charset="-120"/>
+              </a:rPr>
+              <a:t>Infraestructura</a:t>
+            </a:r>
+            <a:endParaRPr lang="en-US" sz="2000" dirty="0"/>
+          </a:p>
+        </p:txBody>
+      </p:sp>
+      <p:sp>
+        <p:nvSpPr>
+          <p:cNvPr id="11" name="Text 9"/>
+          <p:cNvSpPr/>
+          <p:nvPr/>
+        </p:nvSpPr>
+        <p:spPr>
+          <a:xfrm>
+            <a:off x="8092440" y="2788920"/>
+            <a:ext cx="3291840" cy="292608"/>
+          </a:xfrm>
+          <a:prstGeom prst="rect">
+            <a:avLst/>
+          </a:prstGeom>
+          <a:noFill/>
+          <a:ln/>
+        </p:spPr>
+        <p:txBody>
+          <a:bodyPr wrap="square" lIns="0" tIns="0" rIns="0" bIns="0" rtlCol="0" anchor="t"/>
+          <a:lstStyle/>
+          <a:p>
+            <a:pPr indent="0" marL="0">
+              <a:buNone/>
+            </a:pPr>
+            <a:r>
+              <a:rPr lang="en-US" sz="1300" i="1" dirty="0">
+                <a:solidFill>
+                  <a:srgbClr val="5A5F73"/>
+                </a:solidFill>
+                <a:latin typeface="Calibri" pitchFamily="34" charset="0"/>
+                <a:ea typeface="Calibri" pitchFamily="34" charset="-122"/>
+                <a:cs typeface="Calibri" pitchFamily="34" charset="-120"/>
+              </a:rPr>
+              <a:t>Implementa los puertos</a:t>
+            </a:r>
+            <a:endParaRPr lang="en-US" sz="1300" dirty="0"/>
+          </a:p>
+        </p:txBody>
+      </p:sp>
+      <p:sp>
+        <p:nvSpPr>
+          <p:cNvPr id="12" name="Text 10"/>
+          <p:cNvSpPr/>
+          <p:nvPr/>
+        </p:nvSpPr>
+        <p:spPr>
+          <a:xfrm>
+            <a:off x="8092440" y="3246120"/>
+            <a:ext cx="3291840" cy="2286000"/>
+          </a:xfrm>
+          <a:prstGeom prst="rect">
+            <a:avLst/>
+          </a:prstGeom>
+          <a:noFill/>
+          <a:ln/>
+        </p:spPr>
+        <p:txBody>
+          <a:bodyPr wrap="square" lIns="0" tIns="0" rIns="0" bIns="0" rtlCol="0" anchor="t"/>
+          <a:lstStyle/>
+          <a:p>
+            <a:pPr marL="342900" indent="-342900">
+              <a:lnSpc>
+                <a:spcPts val="2000"/>
+              </a:lnSpc>
+              <a:spcAft>
+                <a:spcPts val="1200"/>
+              </a:spcAft>
+              <a:buSzPct val="100000"/>
+              <a:buChar char="•"/>
+            </a:pPr>
+            <a:r>
+              <a:rPr lang="en-US" sz="1400" dirty="0">
+                <a:solidFill>
+                  <a:srgbClr val="1A1C2E"/>
+                </a:solidFill>
+                <a:latin typeface="Calibri" pitchFamily="34" charset="0"/>
+                <a:ea typeface="Calibri" pitchFamily="34" charset="-122"/>
+                <a:cs typeface="Calibri" pitchFamily="34" charset="-120"/>
+              </a:rPr>
+              <a:t>Express, Drizzle + SQLite, LanceDB</a:t>
+            </a:r>
+            <a:endParaRPr lang="en-US" sz="1400" dirty="0"/>
+          </a:p>
+          <a:p>
+            <a:pPr marL="342900" indent="-342900">
+              <a:lnSpc>
+                <a:spcPts val="2000"/>
+              </a:lnSpc>
+              <a:spcAft>
+                <a:spcPts val="1200"/>
+              </a:spcAft>
+              <a:buSzPct val="100000"/>
+              <a:buChar char="•"/>
+            </a:pPr>
+            <a:r>
+              <a:rPr lang="en-US" sz="1400" dirty="0">
+                <a:solidFill>
+                  <a:srgbClr val="1A1C2E"/>
+                </a:solidFill>
+                <a:latin typeface="Calibri" pitchFamily="34" charset="0"/>
+                <a:ea typeface="Calibri" pitchFamily="34" charset="-122"/>
+                <a:cs typeface="Calibri" pitchFamily="34" charset="-120"/>
+              </a:rPr>
+              <a:t>Servidor MCP, clientes de Anthropic y OpenAI</a:t>
+            </a:r>
+            <a:endParaRPr lang="en-US" sz="1400" dirty="0"/>
+          </a:p>
+          <a:p>
+            <a:pPr marL="342900" indent="-342900">
+              <a:lnSpc>
+                <a:spcPts val="2000"/>
+              </a:lnSpc>
+              <a:spcAft>
+                <a:spcPts val="1200"/>
+              </a:spcAft>
+              <a:buSzPct val="100000"/>
+              <a:buChar char="•"/>
+            </a:pPr>
+            <a:r>
+              <a:rPr lang="en-US" sz="1400" dirty="0">
+                <a:solidFill>
+                  <a:srgbClr val="1A1C2E"/>
+                </a:solidFill>
+                <a:latin typeface="Calibri" pitchFamily="34" charset="0"/>
+                <a:ea typeface="Calibri" pitchFamily="34" charset="-122"/>
+                <a:cs typeface="Calibri" pitchFamily="34" charset="-120"/>
+              </a:rPr>
+              <a:t>Transporte ELM327 y simulador</a:t>
+            </a:r>
+            <a:endParaRPr lang="en-US" sz="1400" dirty="0"/>
+          </a:p>
+        </p:txBody>
+      </p:sp>
+      <p:sp>
+        <p:nvSpPr>
+          <p:cNvPr id="13" name="Text 11"/>
+          <p:cNvSpPr/>
+          <p:nvPr/>
+        </p:nvSpPr>
+        <p:spPr>
+          <a:xfrm>
+            <a:off x="777240" y="5669280"/>
+            <a:ext cx="10607040" cy="365760"/>
+          </a:xfrm>
+          <a:prstGeom prst="rect">
+            <a:avLst/>
+          </a:prstGeom>
+          <a:noFill/>
+          <a:ln/>
+        </p:spPr>
+        <p:txBody>
+          <a:bodyPr wrap="square" lIns="0" tIns="0" rIns="0" bIns="0" rtlCol="0" anchor="ctr"/>
+          <a:lstStyle/>
+          <a:p>
+            <a:pPr indent="0" marL="0">
+              <a:buNone/>
+            </a:pPr>
+            <a:r>
+              <a:rPr lang="en-US" sz="1500" dirty="0">
+                <a:solidFill>
+                  <a:srgbClr val="5A5F73"/>
+                </a:solidFill>
+                <a:latin typeface="Calibri" pitchFamily="34" charset="0"/>
+                <a:ea typeface="Calibri" pitchFamily="34" charset="-122"/>
+                <a:cs typeface="Calibri" pitchFamily="34" charset="-120"/>
+              </a:rPr>
+              <a:t>El dominio no sabe que existe SQLite, ni Express, ni ningún LLM.</a:t>
+            </a:r>
+            <a:endParaRPr lang="en-US" sz="1500" dirty="0"/>
+          </a:p>
+        </p:txBody>
+      </p:sp>
+      <p:sp>
+        <p:nvSpPr>
+          <p:cNvPr id="14" name="Shape 12"/>
+          <p:cNvSpPr/>
+          <p:nvPr/>
+        </p:nvSpPr>
+        <p:spPr>
+          <a:xfrm>
+            <a:off x="777240" y="6263640"/>
+            <a:ext cx="219456" cy="219456"/>
+          </a:xfrm>
+          <a:prstGeom prst="rect">
+            <a:avLst/>
+          </a:prstGeom>
+          <a:solidFill>
+            <a:srgbClr val="202CFC"/>
+          </a:solidFill>
+          <a:ln/>
+        </p:spPr>
+      </p:sp>
+      <p:sp>
+        <p:nvSpPr>
+          <p:cNvPr id="15" name="Text 13"/>
+          <p:cNvSpPr/>
+          <p:nvPr/>
+        </p:nvSpPr>
+        <p:spPr>
+          <a:xfrm>
+            <a:off x="777240" y="6263640"/>
+            <a:ext cx="219456" cy="219456"/>
+          </a:xfrm>
+          <a:prstGeom prst="rect">
+            <a:avLst/>
+          </a:prstGeom>
+          <a:noFill/>
+          <a:ln/>
+        </p:spPr>
+        <p:txBody>
+          <a:bodyPr wrap="square" lIns="0" tIns="0" rIns="0" bIns="0" rtlCol="0" anchor="ctr"/>
+          <a:lstStyle/>
+          <a:p>
+            <a:pPr algn="ctr" indent="0" marL="0">
+              <a:buNone/>
+            </a:pPr>
+            <a:r>
+              <a:rPr lang="en-US" sz="816" b="1" dirty="0">
+                <a:solidFill>
+                  <a:srgbClr val="FFFFFF"/>
+                </a:solidFill>
+                <a:latin typeface="Arial" pitchFamily="34" charset="0"/>
+                <a:ea typeface="Arial" pitchFamily="34" charset="-122"/>
+                <a:cs typeface="Arial" pitchFamily="34" charset="-120"/>
+              </a:rPr>
+              <a:t>BIG</a:t>
+            </a:r>
+            <a:endParaRPr lang="en-US" sz="816" dirty="0"/>
+          </a:p>
+        </p:txBody>
+      </p:sp>
+      <p:sp>
+        <p:nvSpPr>
+          <p:cNvPr id="16" name="Text 14"/>
+          <p:cNvSpPr/>
+          <p:nvPr/>
+        </p:nvSpPr>
+        <p:spPr>
+          <a:xfrm>
+            <a:off x="1078992" y="6263640"/>
+            <a:ext cx="658368" cy="219456"/>
+          </a:xfrm>
+          <a:prstGeom prst="rect">
+            <a:avLst/>
+          </a:prstGeom>
+          <a:noFill/>
+          <a:ln/>
+        </p:spPr>
+        <p:txBody>
+          <a:bodyPr wrap="square" lIns="0" tIns="0" rIns="0" bIns="0" rtlCol="0" anchor="ctr"/>
+          <a:lstStyle/>
+          <a:p>
+            <a:pPr algn="l" indent="0" marL="0">
+              <a:buNone/>
+            </a:pPr>
+            <a:r>
+              <a:rPr lang="en-US" sz="816" dirty="0">
+                <a:solidFill>
+                  <a:srgbClr val="1A1C2E"/>
+                </a:solidFill>
+                <a:latin typeface="Arial" pitchFamily="34" charset="0"/>
+                <a:ea typeface="Arial" pitchFamily="34" charset="-122"/>
+                <a:cs typeface="Arial" pitchFamily="34" charset="-120"/>
+              </a:rPr>
+              <a:t>school</a:t>
+            </a:r>
+            <a:endParaRPr lang="en-US" sz="816" dirty="0"/>
+          </a:p>
+        </p:txBody>
+      </p:sp>
+      <p:sp>
+        <p:nvSpPr>
+          <p:cNvPr id="17" name="Text 15"/>
+          <p:cNvSpPr/>
+          <p:nvPr/>
+        </p:nvSpPr>
+        <p:spPr>
+          <a:xfrm>
+            <a:off x="11064240" y="6263640"/>
+            <a:ext cx="320040" cy="219456"/>
+          </a:xfrm>
+          <a:prstGeom prst="rect">
+            <a:avLst/>
+          </a:prstGeom>
+          <a:noFill/>
+          <a:ln/>
+        </p:spPr>
+        <p:txBody>
+          <a:bodyPr wrap="square" lIns="0" tIns="0" rIns="0" bIns="0" rtlCol="0" anchor="ctr"/>
+          <a:lstStyle/>
+          <a:p>
+            <a:pPr algn="r" indent="0" marL="0">
+              <a:buNone/>
+            </a:pPr>
+            <a:r>
+              <a:rPr lang="en-US" sz="1000" dirty="0">
+                <a:solidFill>
+                  <a:srgbClr val="5A5F73"/>
+                </a:solidFill>
+                <a:latin typeface="Calibri" pitchFamily="34" charset="0"/>
+                <a:ea typeface="Calibri" pitchFamily="34" charset="-122"/>
+                <a:cs typeface="Calibri" pitchFamily="34" charset="-120"/>
+              </a:rPr>
+              <a:t>5</a:t>
+            </a:r>
+            <a:endParaRPr lang="en-US" sz="1000" dirty="0"/>
+          </a:p>
+        </p:txBody>
+      </p:sp>
+    </p:spTree>
+  </p:cSld>
+  <p:clrMapOvr>
+    <a:masterClrMapping/>
+  </p:clrMapOvr>
+</p:sld>
+</file>
+
 <file path=ppt/theme/theme1.xml><?xml version="1.0" encoding="utf-8"?>
 <a:theme xmlns:a="http://schemas.openxmlformats.org/drawingml/2006/main" name="Office Theme">
   <a:themeElements>

</xml_diff>

<commit_message>
docs(tfm): fundir las tres capas como ejemplo en la de arquitectura
</commit_message>
<xml_diff>
--- a/docs/presentacion/tfm-intelligent-automotive-diagnostics.pptx
+++ b/docs/presentacion/tfm-intelligent-automotive-diagnostics.pptx
@@ -9,10 +9,9 @@
     <p:sldId id="257" r:id="rId3"/>
     <p:sldId id="258" r:id="rId4"/>
     <p:sldId id="259" r:id="rId5"/>
-    <p:sldId id="260" r:id="rId6"/>
   </p:sldIdLst>
   <p:notesMasterIdLst>
-    <p:notesMasterId r:id="rId7"/>
+    <p:notesMasterId r:id="rId6"/>
   </p:notesMasterIdLst>
   <p:sldSz cx="12192000" cy="6858000"/>
   <p:notesSz cx="6858000" cy="12192000"/>
@@ -780,9 +779,9 @@
             <a:r>
               <a:rPr lang="en-US" dirty="0"/>
               <a:t>¿Por qué Clean Architecture y no otra cosa? Porque en este proyecto el dominio no es algo que me haya inventado yo: son normas. SAE J1979, ISO 15031, ISO 15765-4 para el bus CAN, ISO 3779 para el VIN. Las fórmulas que convierten cada PID en una magnitud física, y la decodificación del bastidor. Eso no lo cambia nadie, y no puede estar mezclado con el acceso a datos ni con el modelo de lenguaje.
-Con Clean Architecture eso vive en el dominio, aislado, y lo que sí cambia —la base de datos, el LLM, el transporte OBD, el framework web— vive fuera, en adaptadores.
-¿Y por qué no una arquitectura orientada a eventos? Porque aquí no hay varios servicios que desacoplar: es un solo proceso. Y el flujo es síncrono: el mecánico pregunta y se queda esperando la respuesta. Meter un broker y colas me traería consistencia eventual y mucha más superficie de depuración, sin ganar nada a cambio.
-Y hay una razón práctica: soy un solo programador. Cuantas más piezas móviles, más sitio donde romper.
+¿Y por qué no orientada a eventos? Porque aquí no hay varios servicios que desacoplar: es un solo proceso. El flujo es síncrono, el mecánico pregunta y se queda esperando. Un broker y colas me traerían consistencia eventual y mucha más superficie de depuración sin ganar nada. Y soy un solo programador: cuantas más piezas móviles, más sitio donde romper.
+Abajo está el ejemplo concreto de este proyecto. En el dominio, los value objects y los catálogos. En aplicación, los casos de uso y los puertos, que dicen qué hace falta pero no cómo. Y en infraestructura el cómo: Express, Drizzle sobre SQLite, LanceDB, el servidor MCP y el transporte del ELM327.
+El dominio no sabe que existe SQLite, ni Express, ni ningún modelo de lenguaje.
 [~80 s]</a:t>
             </a:r>
             <a:endParaRPr lang="en-US" dirty="0"/>
@@ -807,99 +806,6 @@
             <a:fld id="{F7021451-1387-4CA6-816F-3879F97B5CBC}" type="slidenum">
               <a:rPr lang="en-US"/>
               <a:t>4</a:t>
-            </a:fld>
-            <a:endParaRPr lang="en-US"/>
-          </a:p>
-        </p:txBody>
-      </p:sp>
-    </p:spTree>
-    <p:extLst>
-      <p:ext uri="{BB962C8B-B14F-4D97-AF65-F5344CB8AC3E}">
-        <p14:creationId xmlns:p14="http://schemas.microsoft.com/office/powerpoint/2010/main" val="1024086991"/>
-      </p:ext>
-    </p:extLst>
-  </p:cSld>
-  <p:clrMapOvr>
-    <a:masterClrMapping/>
-  </p:clrMapOvr>
-</p:notes>
-</file>
-
-<file path=ppt/notesSlides/notesSlide5.xml><?xml version="1.0" encoding="utf-8"?>
-<p:notes xmlns:a="http://schemas.openxmlformats.org/drawingml/2006/main" xmlns:r="http://schemas.openxmlformats.org/officeDocument/2006/relationships" xmlns:p="http://schemas.openxmlformats.org/presentationml/2006/main">
-  <p:cSld>
-    <p:spTree>
-      <p:nvGrpSpPr>
-        <p:cNvPr id="1" name=""/>
-        <p:cNvGrpSpPr/>
-        <p:nvPr/>
-      </p:nvGrpSpPr>
-      <p:grpSpPr>
-        <a:xfrm>
-          <a:off x="0" y="0"/>
-          <a:ext cx="0" cy="0"/>
-          <a:chOff x="0" y="0"/>
-          <a:chExt cx="0" cy="0"/>
-        </a:xfrm>
-      </p:grpSpPr>
-      <p:sp>
-        <p:nvSpPr>
-          <p:cNvPr id="2" name="Slide Image Placeholder 1"/>
-          <p:cNvSpPr>
-            <a:spLocks noGrp="1" noRot="1" noChangeAspect="1"/>
-          </p:cNvSpPr>
-          <p:nvPr>
-            <p:ph type="sldImg"/>
-          </p:nvPr>
-        </p:nvSpPr>
-        <p:spPr/>
-      </p:sp>
-      <p:sp>
-        <p:nvSpPr>
-          <p:cNvPr id="3" name="Notes Placeholder 2"/>
-          <p:cNvSpPr>
-            <a:spLocks noGrp="1"/>
-          </p:cNvSpPr>
-          <p:nvPr>
-            <p:ph type="body" idx="1"/>
-          </p:nvPr>
-        </p:nvSpPr>
-        <p:spPr/>
-        <p:txBody>
-          <a:bodyPr/>
-          <a:lstStyle/>
-          <a:p>
-            <a:r>
-              <a:rPr lang="en-US" dirty="0"/>
-              <a:t>Tres capas, y las dependencias van siempre hacia dentro.
-En el dominio están los value objects y los catálogos: el VIN, el código DTC, el código de PID, las fórmulas, y las tablas de referencia. Es lo que dicen las normas. Esta capa no importa absolutamente nada de las otras dos.
-En aplicación están los casos de uso —identificar el vehículo, leer telemetría, barrer las ECUs, ejecutar el diagnóstico determinista y el cognitivo— y los puertos, que son interfaces. Aquí se dice QUÉ hace falta, no CÓMO se consigue. Esta capa solo conoce el dominio.
-Y en infraestructura está el cómo: Express, Drizzle sobre SQLite, LanceDB para los vectores, el servidor MCP, los clientes de Anthropic y OpenAI, y el transporte del ELM327 con su simulador. Todo eso implementa los puertos de la capa de aplicación.
-La consecuencia práctica es la de la slide anterior: el dominio no sabe que existe SQLite, ni Express, ni ningún modelo de lenguaje.
-[~70 s]</a:t>
-            </a:r>
-            <a:endParaRPr lang="en-US" dirty="0"/>
-          </a:p>
-        </p:txBody>
-      </p:sp>
-      <p:sp>
-        <p:nvSpPr>
-          <p:cNvPr id="4" name="Slide Number Placeholder 3"/>
-          <p:cNvSpPr>
-            <a:spLocks noGrp="1"/>
-          </p:cNvSpPr>
-          <p:nvPr>
-            <p:ph type="sldNum" sz="quarter" idx="10"/>
-          </p:nvPr>
-        </p:nvSpPr>
-        <p:spPr/>
-        <p:txBody>
-          <a:bodyPr/>
-          <a:lstStyle/>
-          <a:p>
-            <a:fld id="{F7021451-1387-4CA6-816F-3879F97B5CBC}" type="slidenum">
-              <a:rPr lang="en-US"/>
-              <a:t>5</a:t>
             </a:fld>
             <a:endParaRPr lang="en-US"/>
           </a:p>
@@ -2520,8 +2426,8 @@
         </p:nvSpPr>
         <p:spPr>
           <a:xfrm>
-            <a:off x="777240" y="685800"/>
-            <a:ext cx="10607040" cy="822960"/>
+            <a:off x="777240" y="640080"/>
+            <a:ext cx="10607040" cy="777240"/>
           </a:xfrm>
           <a:prstGeom prst="rect">
             <a:avLst/>
@@ -2559,7 +2465,7 @@
         </p:nvSpPr>
         <p:spPr>
           <a:xfrm>
-            <a:off x="777240" y="1600200"/>
+            <a:off x="777240" y="1508760"/>
             <a:ext cx="10607040" cy="365760"/>
           </a:xfrm>
           <a:prstGeom prst="rect">
@@ -2598,7 +2504,7 @@
         </p:nvSpPr>
         <p:spPr>
           <a:xfrm>
-            <a:off x="777240" y="2331720"/>
+            <a:off x="777240" y="2148840"/>
             <a:ext cx="4846320" cy="365760"/>
           </a:xfrm>
           <a:prstGeom prst="rect">
@@ -2615,7 +2521,7 @@
               <a:buNone/>
             </a:pPr>
             <a:r>
-              <a:rPr lang="en-US" sz="2000" b="1" dirty="0">
+              <a:rPr lang="en-US" sz="1900" b="1" dirty="0">
                 <a:solidFill>
                   <a:srgbClr val="202CFC"/>
                 </a:solidFill>
@@ -2625,7 +2531,7 @@
               </a:rPr>
               <a:t>Por qué Clean + Hexagonal</a:t>
             </a:r>
-            <a:endParaRPr lang="en-US" sz="2000" dirty="0"/>
+            <a:endParaRPr lang="en-US" sz="1900" dirty="0"/>
           </a:p>
         </p:txBody>
       </p:sp>
@@ -2637,8 +2543,8 @@
         </p:nvSpPr>
         <p:spPr>
           <a:xfrm>
-            <a:off x="777240" y="2926080"/>
-            <a:ext cx="4846320" cy="2651760"/>
+            <a:off x="777240" y="2697480"/>
+            <a:ext cx="4846320" cy="1828800"/>
           </a:xfrm>
           <a:prstGeom prst="rect">
             <a:avLst/>
@@ -2652,16 +2558,16 @@
           <a:p>
             <a:pPr marL="342900" indent="-342900">
               <a:lnSpc>
-                <a:spcPts val="2200"/>
+                <a:spcPts val="2100"/>
               </a:lnSpc>
               <a:spcAft>
-                <a:spcPts val="1200"/>
+                <a:spcPts val="1000"/>
               </a:spcAft>
               <a:buSzPct val="100000"/>
               <a:buChar char="•"/>
             </a:pPr>
             <a:r>
-              <a:rPr lang="en-US" sz="1600" dirty="0">
+              <a:rPr lang="en-US" sz="1500" dirty="0">
                 <a:solidFill>
                   <a:srgbClr val="1A1C2E"/>
                 </a:solidFill>
@@ -2669,23 +2575,23 @@
                 <a:ea typeface="Calibri" pitchFamily="34" charset="-122"/>
                 <a:cs typeface="Calibri" pitchFamily="34" charset="-120"/>
               </a:rPr>
-              <a:t>SAE J1979, ISO 15031, ISO 15765-4, ISO 3779</a:t>
-            </a:r>
-            <a:endParaRPr lang="en-US" sz="1600" dirty="0"/>
+              <a:t>El dominio son normas: SAE J1979, ISO 15031, ISO 3779</a:t>
+            </a:r>
+            <a:endParaRPr lang="en-US" sz="1500" dirty="0"/>
           </a:p>
           <a:p>
             <a:pPr marL="342900" indent="-342900">
               <a:lnSpc>
-                <a:spcPts val="2200"/>
+                <a:spcPts val="2100"/>
               </a:lnSpc>
               <a:spcAft>
-                <a:spcPts val="1200"/>
+                <a:spcPts val="1000"/>
               </a:spcAft>
               <a:buSzPct val="100000"/>
               <a:buChar char="•"/>
             </a:pPr>
             <a:r>
-              <a:rPr lang="en-US" sz="1600" dirty="0">
+              <a:rPr lang="en-US" sz="1500" dirty="0">
                 <a:solidFill>
                   <a:srgbClr val="1A1C2E"/>
                 </a:solidFill>
@@ -2693,23 +2599,23 @@
                 <a:ea typeface="Calibri" pitchFamily="34" charset="-122"/>
                 <a:cs typeface="Calibri" pitchFamily="34" charset="-120"/>
               </a:rPr>
-              <a:t>Las fórmulas de conversión de cada PID</a:t>
-            </a:r>
-            <a:endParaRPr lang="en-US" sz="1600" dirty="0"/>
+              <a:t>Las fórmulas de cada PID y la decodificación del VIN</a:t>
+            </a:r>
+            <a:endParaRPr lang="en-US" sz="1500" dirty="0"/>
           </a:p>
           <a:p>
             <a:pPr marL="342900" indent="-342900">
               <a:lnSpc>
-                <a:spcPts val="2200"/>
+                <a:spcPts val="2100"/>
               </a:lnSpc>
               <a:spcAft>
-                <a:spcPts val="1200"/>
+                <a:spcPts val="1000"/>
               </a:spcAft>
               <a:buSzPct val="100000"/>
               <a:buChar char="•"/>
             </a:pPr>
             <a:r>
-              <a:rPr lang="en-US" sz="1600" dirty="0">
+              <a:rPr lang="en-US" sz="1500" dirty="0">
                 <a:solidFill>
                   <a:srgbClr val="1A1C2E"/>
                 </a:solidFill>
@@ -2717,23 +2623,84 @@
                 <a:ea typeface="Calibri" pitchFamily="34" charset="-122"/>
                 <a:cs typeface="Calibri" pitchFamily="34" charset="-120"/>
               </a:rPr>
-              <a:t>La decodificación del VIN</a:t>
-            </a:r>
-            <a:endParaRPr lang="en-US" sz="1600" dirty="0"/>
-          </a:p>
+              <a:t>Nada de eso se mezcla con la base de datos ni con el LLM</a:t>
+            </a:r>
+            <a:endParaRPr lang="en-US" sz="1500" dirty="0"/>
+          </a:p>
+        </p:txBody>
+      </p:sp>
+      <p:sp>
+        <p:nvSpPr>
+          <p:cNvPr id="6" name="Text 4"/>
+          <p:cNvSpPr/>
+          <p:nvPr/>
+        </p:nvSpPr>
+        <p:spPr>
+          <a:xfrm>
+            <a:off x="6537960" y="2148840"/>
+            <a:ext cx="4846320" cy="365760"/>
+          </a:xfrm>
+          <a:prstGeom prst="rect">
+            <a:avLst/>
+          </a:prstGeom>
+          <a:noFill/>
+          <a:ln/>
+        </p:spPr>
+        <p:txBody>
+          <a:bodyPr wrap="square" lIns="0" tIns="0" rIns="0" bIns="0" rtlCol="0" anchor="t"/>
+          <a:lstStyle/>
+          <a:p>
+            <a:pPr indent="0" marL="0">
+              <a:buNone/>
+            </a:pPr>
+            <a:r>
+              <a:rPr lang="en-US" sz="1900" b="1" dirty="0">
+                <a:solidFill>
+                  <a:srgbClr val="5A5F73"/>
+                </a:solidFill>
+                <a:latin typeface="Arial" pitchFamily="34" charset="0"/>
+                <a:ea typeface="Arial" pitchFamily="34" charset="-122"/>
+                <a:cs typeface="Arial" pitchFamily="34" charset="-120"/>
+              </a:rPr>
+              <a:t>Por qué no orientada a eventos</a:t>
+            </a:r>
+            <a:endParaRPr lang="en-US" sz="1900" dirty="0"/>
+          </a:p>
+        </p:txBody>
+      </p:sp>
+      <p:sp>
+        <p:nvSpPr>
+          <p:cNvPr id="7" name="Text 5"/>
+          <p:cNvSpPr/>
+          <p:nvPr/>
+        </p:nvSpPr>
+        <p:spPr>
+          <a:xfrm>
+            <a:off x="6537960" y="2697480"/>
+            <a:ext cx="4846320" cy="1828800"/>
+          </a:xfrm>
+          <a:prstGeom prst="rect">
+            <a:avLst/>
+          </a:prstGeom>
+          <a:noFill/>
+          <a:ln/>
+        </p:spPr>
+        <p:txBody>
+          <a:bodyPr wrap="square" lIns="0" tIns="0" rIns="0" bIns="0" rtlCol="0" anchor="t"/>
+          <a:lstStyle/>
           <a:p>
             <a:pPr marL="342900" indent="-342900">
               <a:lnSpc>
-                <a:spcPts val="2200"/>
+                <a:spcPts val="2100"/>
               </a:lnSpc>
               <a:spcAft>
-                <a:spcPts val="1200"/>
+                <a:spcPts val="1000"/>
               </a:spcAft>
               <a:buSzPct val="100000"/>
               <a:buChar char="•"/>
             </a:pPr>
             <a:r>
-              <a:rPr lang="en-US" sz="1600" dirty="0">
+              <a:rPr lang="en-US" sz="1500" dirty="0">
                 <a:solidFill>
                   <a:srgbClr val="1A1C2E"/>
                 </a:solidFill>
@@ -2741,22 +2708,70 @@
                 <a:ea typeface="Calibri" pitchFamily="34" charset="-122"/>
                 <a:cs typeface="Calibri" pitchFamily="34" charset="-120"/>
               </a:rPr>
-              <a:t>Todo eso vive en el dominio, sin mezclarse con la base de datos ni con el LLM</a:t>
-            </a:r>
-            <a:endParaRPr lang="en-US" sz="1600" dirty="0"/>
-          </a:p>
-        </p:txBody>
-      </p:sp>
-      <p:sp>
-        <p:nvSpPr>
-          <p:cNvPr id="6" name="Text 4"/>
-          <p:cNvSpPr/>
-          <p:nvPr/>
-        </p:nvSpPr>
-        <p:spPr>
-          <a:xfrm>
-            <a:off x="6537960" y="2331720"/>
-            <a:ext cx="4846320" cy="365760"/>
+              <a:t>Es un proceso: no hay servicios que desacoplar</a:t>
+            </a:r>
+            <a:endParaRPr lang="en-US" sz="1500" dirty="0"/>
+          </a:p>
+          <a:p>
+            <a:pPr marL="342900" indent="-342900">
+              <a:lnSpc>
+                <a:spcPts val="2100"/>
+              </a:lnSpc>
+              <a:spcAft>
+                <a:spcPts val="1000"/>
+              </a:spcAft>
+              <a:buSzPct val="100000"/>
+              <a:buChar char="•"/>
+            </a:pPr>
+            <a:r>
+              <a:rPr lang="en-US" sz="1500" dirty="0">
+                <a:solidFill>
+                  <a:srgbClr val="1A1C2E"/>
+                </a:solidFill>
+                <a:latin typeface="Calibri" pitchFamily="34" charset="0"/>
+                <a:ea typeface="Calibri" pitchFamily="34" charset="-122"/>
+                <a:cs typeface="Calibri" pitchFamily="34" charset="-120"/>
+              </a:rPr>
+              <a:t>El mecánico pregunta y espera: el flujo es síncrono</a:t>
+            </a:r>
+            <a:endParaRPr lang="en-US" sz="1500" dirty="0"/>
+          </a:p>
+          <a:p>
+            <a:pPr marL="342900" indent="-342900">
+              <a:lnSpc>
+                <a:spcPts val="2100"/>
+              </a:lnSpc>
+              <a:spcAft>
+                <a:spcPts val="1000"/>
+              </a:spcAft>
+              <a:buSzPct val="100000"/>
+              <a:buChar char="•"/>
+            </a:pPr>
+            <a:r>
+              <a:rPr lang="en-US" sz="1500" dirty="0">
+                <a:solidFill>
+                  <a:srgbClr val="1A1C2E"/>
+                </a:solidFill>
+                <a:latin typeface="Calibri" pitchFamily="34" charset="0"/>
+                <a:ea typeface="Calibri" pitchFamily="34" charset="-122"/>
+                <a:cs typeface="Calibri" pitchFamily="34" charset="-120"/>
+              </a:rPr>
+              <a:t>Un solo programador: más piezas es más sitio donde romper</a:t>
+            </a:r>
+            <a:endParaRPr lang="en-US" sz="1500" dirty="0"/>
+          </a:p>
+        </p:txBody>
+      </p:sp>
+      <p:sp>
+        <p:nvSpPr>
+          <p:cNvPr id="8" name="Text 6"/>
+          <p:cNvSpPr/>
+          <p:nvPr/>
+        </p:nvSpPr>
+        <p:spPr>
+          <a:xfrm>
+            <a:off x="777240" y="4709160"/>
+            <a:ext cx="10607040" cy="292608"/>
           </a:xfrm>
           <a:prstGeom prst="rect">
             <a:avLst/>
@@ -2772,141 +2787,257 @@
               <a:buNone/>
             </a:pPr>
             <a:r>
-              <a:rPr lang="en-US" sz="2000" b="1" dirty="0">
-                <a:solidFill>
-                  <a:srgbClr val="5A5F73"/>
+              <a:rPr lang="en-US" sz="1500" b="1" dirty="0">
+                <a:solidFill>
+                  <a:srgbClr val="1A1C2E"/>
                 </a:solidFill>
                 <a:latin typeface="Arial" pitchFamily="34" charset="0"/>
                 <a:ea typeface="Arial" pitchFamily="34" charset="-122"/>
                 <a:cs typeface="Arial" pitchFamily="34" charset="-120"/>
               </a:rPr>
-              <a:t>Por qué no orientada a eventos</a:t>
-            </a:r>
-            <a:endParaRPr lang="en-US" sz="2000" dirty="0"/>
-          </a:p>
-        </p:txBody>
-      </p:sp>
-      <p:sp>
-        <p:nvSpPr>
-          <p:cNvPr id="7" name="Text 5"/>
-          <p:cNvSpPr/>
-          <p:nvPr/>
-        </p:nvSpPr>
-        <p:spPr>
-          <a:xfrm>
-            <a:off x="6537960" y="2926080"/>
-            <a:ext cx="4846320" cy="2651760"/>
-          </a:xfrm>
-          <a:prstGeom prst="rect">
-            <a:avLst/>
-          </a:prstGeom>
-          <a:noFill/>
-          <a:ln/>
-        </p:spPr>
-        <p:txBody>
-          <a:bodyPr wrap="square" lIns="0" tIns="0" rIns="0" bIns="0" rtlCol="0" anchor="t"/>
-          <a:lstStyle/>
-          <a:p>
-            <a:pPr marL="342900" indent="-342900">
-              <a:lnSpc>
-                <a:spcPts val="2200"/>
-              </a:lnSpc>
-              <a:spcAft>
-                <a:spcPts val="1200"/>
-              </a:spcAft>
-              <a:buSzPct val="100000"/>
-              <a:buChar char="•"/>
-            </a:pPr>
-            <a:r>
-              <a:rPr lang="en-US" sz="1600" dirty="0">
-                <a:solidFill>
-                  <a:srgbClr val="1A1C2E"/>
+              <a:t>En este proyecto</a:t>
+            </a:r>
+            <a:endParaRPr lang="en-US" sz="1500" dirty="0"/>
+          </a:p>
+        </p:txBody>
+      </p:sp>
+      <p:sp>
+        <p:nvSpPr>
+          <p:cNvPr id="9" name="Text 7"/>
+          <p:cNvSpPr/>
+          <p:nvPr/>
+        </p:nvSpPr>
+        <p:spPr>
+          <a:xfrm>
+            <a:off x="777240" y="5120640"/>
+            <a:ext cx="1737360" cy="310896"/>
+          </a:xfrm>
+          <a:prstGeom prst="rect">
+            <a:avLst/>
+          </a:prstGeom>
+          <a:noFill/>
+          <a:ln/>
+        </p:spPr>
+        <p:txBody>
+          <a:bodyPr wrap="square" lIns="0" tIns="0" rIns="0" bIns="0" rtlCol="0" anchor="ctr"/>
+          <a:lstStyle/>
+          <a:p>
+            <a:pPr indent="0" marL="0">
+              <a:buNone/>
+            </a:pPr>
+            <a:r>
+              <a:rPr lang="en-US" sz="1400" b="1" dirty="0">
+                <a:solidFill>
+                  <a:srgbClr val="202CFC"/>
                 </a:solidFill>
                 <a:latin typeface="Calibri" pitchFamily="34" charset="0"/>
                 <a:ea typeface="Calibri" pitchFamily="34" charset="-122"/>
                 <a:cs typeface="Calibri" pitchFamily="34" charset="-120"/>
               </a:rPr>
-              <a:t>No hay varios servicios que desacoplar: es un proceso</a:t>
-            </a:r>
-            <a:endParaRPr lang="en-US" sz="1600" dirty="0"/>
-          </a:p>
-          <a:p>
-            <a:pPr marL="342900" indent="-342900">
-              <a:lnSpc>
-                <a:spcPts val="2200"/>
-              </a:lnSpc>
-              <a:spcAft>
-                <a:spcPts val="1200"/>
-              </a:spcAft>
-              <a:buSzPct val="100000"/>
-              <a:buChar char="•"/>
-            </a:pPr>
-            <a:r>
-              <a:rPr lang="en-US" sz="1600" dirty="0">
-                <a:solidFill>
-                  <a:srgbClr val="1A1C2E"/>
+              <a:t>Dominio</a:t>
+            </a:r>
+            <a:endParaRPr lang="en-US" sz="1400" dirty="0"/>
+          </a:p>
+        </p:txBody>
+      </p:sp>
+      <p:sp>
+        <p:nvSpPr>
+          <p:cNvPr id="10" name="Text 8"/>
+          <p:cNvSpPr/>
+          <p:nvPr/>
+        </p:nvSpPr>
+        <p:spPr>
+          <a:xfrm>
+            <a:off x="2560320" y="5120640"/>
+            <a:ext cx="8778240" cy="310896"/>
+          </a:xfrm>
+          <a:prstGeom prst="rect">
+            <a:avLst/>
+          </a:prstGeom>
+          <a:noFill/>
+          <a:ln/>
+        </p:spPr>
+        <p:txBody>
+          <a:bodyPr wrap="square" lIns="0" tIns="0" rIns="0" bIns="0" rtlCol="0" anchor="ctr"/>
+          <a:lstStyle/>
+          <a:p>
+            <a:pPr indent="0" marL="0">
+              <a:buNone/>
+            </a:pPr>
+            <a:r>
+              <a:rPr lang="en-US" sz="1400" dirty="0">
+                <a:solidFill>
+                  <a:srgbClr val="5A5F73"/>
                 </a:solidFill>
                 <a:latin typeface="Calibri" pitchFamily="34" charset="0"/>
                 <a:ea typeface="Calibri" pitchFamily="34" charset="-122"/>
                 <a:cs typeface="Calibri" pitchFamily="34" charset="-120"/>
               </a:rPr>
-              <a:t>El mecánico pregunta y espera respuesta: el flujo es síncrono</a:t>
-            </a:r>
-            <a:endParaRPr lang="en-US" sz="1600" dirty="0"/>
-          </a:p>
-          <a:p>
-            <a:pPr marL="342900" indent="-342900">
-              <a:lnSpc>
-                <a:spcPts val="2200"/>
-              </a:lnSpc>
-              <a:spcAft>
-                <a:spcPts val="1200"/>
-              </a:spcAft>
-              <a:buSzPct val="100000"/>
-              <a:buChar char="•"/>
-            </a:pPr>
-            <a:r>
-              <a:rPr lang="en-US" sz="1600" dirty="0">
-                <a:solidFill>
-                  <a:srgbClr val="1A1C2E"/>
+              <a:t>Vin, DtcCode, PidCode, Formula, catálogos de PID y DTC</a:t>
+            </a:r>
+            <a:endParaRPr lang="en-US" sz="1400" dirty="0"/>
+          </a:p>
+        </p:txBody>
+      </p:sp>
+      <p:sp>
+        <p:nvSpPr>
+          <p:cNvPr id="11" name="Text 9"/>
+          <p:cNvSpPr/>
+          <p:nvPr/>
+        </p:nvSpPr>
+        <p:spPr>
+          <a:xfrm>
+            <a:off x="777240" y="5486400"/>
+            <a:ext cx="1737360" cy="310896"/>
+          </a:xfrm>
+          <a:prstGeom prst="rect">
+            <a:avLst/>
+          </a:prstGeom>
+          <a:noFill/>
+          <a:ln/>
+        </p:spPr>
+        <p:txBody>
+          <a:bodyPr wrap="square" lIns="0" tIns="0" rIns="0" bIns="0" rtlCol="0" anchor="ctr"/>
+          <a:lstStyle/>
+          <a:p>
+            <a:pPr indent="0" marL="0">
+              <a:buNone/>
+            </a:pPr>
+            <a:r>
+              <a:rPr lang="en-US" sz="1400" b="1" dirty="0">
+                <a:solidFill>
+                  <a:srgbClr val="202CFC"/>
                 </a:solidFill>
                 <a:latin typeface="Calibri" pitchFamily="34" charset="0"/>
                 <a:ea typeface="Calibri" pitchFamily="34" charset="-122"/>
                 <a:cs typeface="Calibri" pitchFamily="34" charset="-120"/>
               </a:rPr>
-              <a:t>Añadiría broker, colas y consistencia eventual sin ganar nada</a:t>
-            </a:r>
-            <a:endParaRPr lang="en-US" sz="1600" dirty="0"/>
-          </a:p>
-          <a:p>
-            <a:pPr marL="342900" indent="-342900">
-              <a:lnSpc>
-                <a:spcPts val="2200"/>
-              </a:lnSpc>
-              <a:spcAft>
-                <a:spcPts val="1200"/>
-              </a:spcAft>
-              <a:buSzPct val="100000"/>
-              <a:buChar char="•"/>
-            </a:pPr>
-            <a:r>
-              <a:rPr lang="en-US" sz="1600" dirty="0">
-                <a:solidFill>
-                  <a:srgbClr val="1A1C2E"/>
+              <a:t>Aplicación</a:t>
+            </a:r>
+            <a:endParaRPr lang="en-US" sz="1400" dirty="0"/>
+          </a:p>
+        </p:txBody>
+      </p:sp>
+      <p:sp>
+        <p:nvSpPr>
+          <p:cNvPr id="12" name="Text 10"/>
+          <p:cNvSpPr/>
+          <p:nvPr/>
+        </p:nvSpPr>
+        <p:spPr>
+          <a:xfrm>
+            <a:off x="2560320" y="5486400"/>
+            <a:ext cx="8778240" cy="310896"/>
+          </a:xfrm>
+          <a:prstGeom prst="rect">
+            <a:avLst/>
+          </a:prstGeom>
+          <a:noFill/>
+          <a:ln/>
+        </p:spPr>
+        <p:txBody>
+          <a:bodyPr wrap="square" lIns="0" tIns="0" rIns="0" bIns="0" rtlCol="0" anchor="ctr"/>
+          <a:lstStyle/>
+          <a:p>
+            <a:pPr indent="0" marL="0">
+              <a:buNone/>
+            </a:pPr>
+            <a:r>
+              <a:rPr lang="en-US" sz="1400" dirty="0">
+                <a:solidFill>
+                  <a:srgbClr val="5A5F73"/>
                 </a:solidFill>
                 <a:latin typeface="Calibri" pitchFamily="34" charset="0"/>
                 <a:ea typeface="Calibri" pitchFamily="34" charset="-122"/>
                 <a:cs typeface="Calibri" pitchFamily="34" charset="-120"/>
               </a:rPr>
-              <a:t>Un solo programador: más piezas es más sitio donde romper</a:t>
-            </a:r>
-            <a:endParaRPr lang="en-US" sz="1600" dirty="0"/>
-          </a:p>
-        </p:txBody>
-      </p:sp>
-      <p:sp>
-        <p:nvSpPr>
-          <p:cNvPr id="8" name="Shape 6"/>
+              <a:t>IdentifyVehicle, ExecuteCognitiveDiagnosis, ObdRepository, LlmClientPort</a:t>
+            </a:r>
+            <a:endParaRPr lang="en-US" sz="1400" dirty="0"/>
+          </a:p>
+        </p:txBody>
+      </p:sp>
+      <p:sp>
+        <p:nvSpPr>
+          <p:cNvPr id="13" name="Text 11"/>
+          <p:cNvSpPr/>
+          <p:nvPr/>
+        </p:nvSpPr>
+        <p:spPr>
+          <a:xfrm>
+            <a:off x="777240" y="5852160"/>
+            <a:ext cx="1737360" cy="310896"/>
+          </a:xfrm>
+          <a:prstGeom prst="rect">
+            <a:avLst/>
+          </a:prstGeom>
+          <a:noFill/>
+          <a:ln/>
+        </p:spPr>
+        <p:txBody>
+          <a:bodyPr wrap="square" lIns="0" tIns="0" rIns="0" bIns="0" rtlCol="0" anchor="ctr"/>
+          <a:lstStyle/>
+          <a:p>
+            <a:pPr indent="0" marL="0">
+              <a:buNone/>
+            </a:pPr>
+            <a:r>
+              <a:rPr lang="en-US" sz="1400" b="1" dirty="0">
+                <a:solidFill>
+                  <a:srgbClr val="202CFC"/>
+                </a:solidFill>
+                <a:latin typeface="Calibri" pitchFamily="34" charset="0"/>
+                <a:ea typeface="Calibri" pitchFamily="34" charset="-122"/>
+                <a:cs typeface="Calibri" pitchFamily="34" charset="-120"/>
+              </a:rPr>
+              <a:t>Infraestructura</a:t>
+            </a:r>
+            <a:endParaRPr lang="en-US" sz="1400" dirty="0"/>
+          </a:p>
+        </p:txBody>
+      </p:sp>
+      <p:sp>
+        <p:nvSpPr>
+          <p:cNvPr id="14" name="Text 12"/>
+          <p:cNvSpPr/>
+          <p:nvPr/>
+        </p:nvSpPr>
+        <p:spPr>
+          <a:xfrm>
+            <a:off x="2560320" y="5852160"/>
+            <a:ext cx="8778240" cy="310896"/>
+          </a:xfrm>
+          <a:prstGeom prst="rect">
+            <a:avLst/>
+          </a:prstGeom>
+          <a:noFill/>
+          <a:ln/>
+        </p:spPr>
+        <p:txBody>
+          <a:bodyPr wrap="square" lIns="0" tIns="0" rIns="0" bIns="0" rtlCol="0" anchor="ctr"/>
+          <a:lstStyle/>
+          <a:p>
+            <a:pPr indent="0" marL="0">
+              <a:buNone/>
+            </a:pPr>
+            <a:r>
+              <a:rPr lang="en-US" sz="1400" dirty="0">
+                <a:solidFill>
+                  <a:srgbClr val="5A5F73"/>
+                </a:solidFill>
+                <a:latin typeface="Calibri" pitchFamily="34" charset="0"/>
+                <a:ea typeface="Calibri" pitchFamily="34" charset="-122"/>
+                <a:cs typeface="Calibri" pitchFamily="34" charset="-120"/>
+              </a:rPr>
+              <a:t>Express, Drizzle + SQLite, LanceDB, servidor MCP, transporte ELM327</a:t>
+            </a:r>
+            <a:endParaRPr lang="en-US" sz="1400" dirty="0"/>
+          </a:p>
+        </p:txBody>
+      </p:sp>
+      <p:sp>
+        <p:nvSpPr>
+          <p:cNvPr id="15" name="Shape 13"/>
           <p:cNvSpPr/>
           <p:nvPr/>
         </p:nvSpPr>
@@ -2926,7 +3057,7 @@
       </p:sp>
       <p:sp>
         <p:nvSpPr>
-          <p:cNvPr id="9" name="Text 7"/>
+          <p:cNvPr id="16" name="Text 14"/>
           <p:cNvSpPr/>
           <p:nvPr/>
         </p:nvSpPr>
@@ -2965,7 +3096,7 @@
       </p:sp>
       <p:sp>
         <p:nvSpPr>
-          <p:cNvPr id="10" name="Text 8"/>
+          <p:cNvPr id="17" name="Text 15"/>
           <p:cNvSpPr/>
           <p:nvPr/>
         </p:nvSpPr>
@@ -3004,7 +3135,7 @@
       </p:sp>
       <p:sp>
         <p:nvSpPr>
-          <p:cNvPr id="11" name="Text 9"/>
+          <p:cNvPr id="18" name="Text 16"/>
           <p:cNvSpPr/>
           <p:nvPr/>
         </p:nvSpPr>
@@ -3036,808 +3167,6 @@
                 <a:cs typeface="Calibri" pitchFamily="34" charset="-120"/>
               </a:rPr>
               <a:t>4</a:t>
-            </a:r>
-            <a:endParaRPr lang="en-US" sz="1000" dirty="0"/>
-          </a:p>
-        </p:txBody>
-      </p:sp>
-    </p:spTree>
-  </p:cSld>
-  <p:clrMapOvr>
-    <a:masterClrMapping/>
-  </p:clrMapOvr>
-</p:sld>
-</file>
-
-<file path=ppt/slides/slide5.xml><?xml version="1.0" encoding="utf-8"?>
-<p:sld xmlns:a="http://schemas.openxmlformats.org/drawingml/2006/main" xmlns:r="http://schemas.openxmlformats.org/officeDocument/2006/relationships" xmlns:p="http://schemas.openxmlformats.org/presentationml/2006/main">
-  <p:cSld name="Slide 5">
-    <p:bg>
-      <p:bgPr>
-        <a:solidFill>
-          <a:srgbClr val="FFFFFF"/>
-        </a:solidFill>
-      </p:bgPr>
-    </p:bg>
-    <p:spTree>
-      <p:nvGrpSpPr>
-        <p:cNvPr id="1" name=""/>
-        <p:cNvGrpSpPr/>
-        <p:nvPr/>
-      </p:nvGrpSpPr>
-      <p:grpSpPr>
-        <a:xfrm>
-          <a:off x="0" y="0"/>
-          <a:ext cx="0" cy="0"/>
-          <a:chOff x="0" y="0"/>
-          <a:chExt cx="0" cy="0"/>
-        </a:xfrm>
-      </p:grpSpPr>
-      <p:sp>
-        <p:nvSpPr>
-          <p:cNvPr id="2" name="Text 0"/>
-          <p:cNvSpPr/>
-          <p:nvPr/>
-        </p:nvSpPr>
-        <p:spPr>
-          <a:xfrm>
-            <a:off x="777240" y="685800"/>
-            <a:ext cx="10607040" cy="822960"/>
-          </a:xfrm>
-          <a:prstGeom prst="rect">
-            <a:avLst/>
-          </a:prstGeom>
-          <a:noFill/>
-          <a:ln/>
-        </p:spPr>
-        <p:txBody>
-          <a:bodyPr wrap="square" lIns="0" tIns="0" rIns="0" bIns="0" rtlCol="0" anchor="t"/>
-          <a:lstStyle/>
-          <a:p>
-            <a:pPr indent="0" marL="0">
-              <a:buNone/>
-            </a:pPr>
-            <a:r>
-              <a:rPr lang="en-US" sz="3400" b="1" dirty="0">
-                <a:solidFill>
-                  <a:srgbClr val="1A1C2E"/>
-                </a:solidFill>
-                <a:latin typeface="Arial" pitchFamily="34" charset="0"/>
-                <a:ea typeface="Arial" pitchFamily="34" charset="-122"/>
-                <a:cs typeface="Arial" pitchFamily="34" charset="-120"/>
-              </a:rPr>
-              <a:t>Las tres capas</a:t>
-            </a:r>
-            <a:endParaRPr lang="en-US" sz="3400" dirty="0"/>
-          </a:p>
-        </p:txBody>
-      </p:sp>
-      <p:sp>
-        <p:nvSpPr>
-          <p:cNvPr id="3" name="Text 1"/>
-          <p:cNvSpPr/>
-          <p:nvPr/>
-        </p:nvSpPr>
-        <p:spPr>
-          <a:xfrm>
-            <a:off x="777240" y="1600200"/>
-            <a:ext cx="10607040" cy="365760"/>
-          </a:xfrm>
-          <a:prstGeom prst="rect">
-            <a:avLst/>
-          </a:prstGeom>
-          <a:noFill/>
-          <a:ln/>
-        </p:spPr>
-        <p:txBody>
-          <a:bodyPr wrap="square" lIns="0" tIns="0" rIns="0" bIns="0" rtlCol="0" anchor="t"/>
-          <a:lstStyle/>
-          <a:p>
-            <a:pPr indent="0" marL="0">
-              <a:buNone/>
-            </a:pPr>
-            <a:r>
-              <a:rPr lang="en-US" sz="1700" dirty="0">
-                <a:solidFill>
-                  <a:srgbClr val="5A5F73"/>
-                </a:solidFill>
-                <a:latin typeface="Calibri" pitchFamily="34" charset="0"/>
-                <a:ea typeface="Calibri" pitchFamily="34" charset="-122"/>
-                <a:cs typeface="Calibri" pitchFamily="34" charset="-120"/>
-              </a:rPr>
-              <a:t>Las flechas van hacia dentro: dominio  ←  aplicación  ←  infraestructura.</a:t>
-            </a:r>
-            <a:endParaRPr lang="en-US" sz="1700" dirty="0"/>
-          </a:p>
-        </p:txBody>
-      </p:sp>
-      <p:sp>
-        <p:nvSpPr>
-          <p:cNvPr id="4" name="Text 2"/>
-          <p:cNvSpPr/>
-          <p:nvPr/>
-        </p:nvSpPr>
-        <p:spPr>
-          <a:xfrm>
-            <a:off x="777240" y="2377440"/>
-            <a:ext cx="3291840" cy="365760"/>
-          </a:xfrm>
-          <a:prstGeom prst="rect">
-            <a:avLst/>
-          </a:prstGeom>
-          <a:noFill/>
-          <a:ln/>
-        </p:spPr>
-        <p:txBody>
-          <a:bodyPr wrap="square" lIns="0" tIns="0" rIns="0" bIns="0" rtlCol="0" anchor="t"/>
-          <a:lstStyle/>
-          <a:p>
-            <a:pPr indent="0" marL="0">
-              <a:buNone/>
-            </a:pPr>
-            <a:r>
-              <a:rPr lang="en-US" sz="2000" b="1" dirty="0">
-                <a:solidFill>
-                  <a:srgbClr val="202CFC"/>
-                </a:solidFill>
-                <a:latin typeface="Arial" pitchFamily="34" charset="0"/>
-                <a:ea typeface="Arial" pitchFamily="34" charset="-122"/>
-                <a:cs typeface="Arial" pitchFamily="34" charset="-120"/>
-              </a:rPr>
-              <a:t>Dominio</a:t>
-            </a:r>
-            <a:endParaRPr lang="en-US" sz="2000" dirty="0"/>
-          </a:p>
-        </p:txBody>
-      </p:sp>
-      <p:sp>
-        <p:nvSpPr>
-          <p:cNvPr id="5" name="Text 3"/>
-          <p:cNvSpPr/>
-          <p:nvPr/>
-        </p:nvSpPr>
-        <p:spPr>
-          <a:xfrm>
-            <a:off x="777240" y="2788920"/>
-            <a:ext cx="3291840" cy="292608"/>
-          </a:xfrm>
-          <a:prstGeom prst="rect">
-            <a:avLst/>
-          </a:prstGeom>
-          <a:noFill/>
-          <a:ln/>
-        </p:spPr>
-        <p:txBody>
-          <a:bodyPr wrap="square" lIns="0" tIns="0" rIns="0" bIns="0" rtlCol="0" anchor="t"/>
-          <a:lstStyle/>
-          <a:p>
-            <a:pPr indent="0" marL="0">
-              <a:buNone/>
-            </a:pPr>
-            <a:r>
-              <a:rPr lang="en-US" sz="1300" i="1" dirty="0">
-                <a:solidFill>
-                  <a:srgbClr val="5A5F73"/>
-                </a:solidFill>
-                <a:latin typeface="Calibri" pitchFamily="34" charset="0"/>
-                <a:ea typeface="Calibri" pitchFamily="34" charset="-122"/>
-                <a:cs typeface="Calibri" pitchFamily="34" charset="-120"/>
-              </a:rPr>
-              <a:t>No importa nada de fuera</a:t>
-            </a:r>
-            <a:endParaRPr lang="en-US" sz="1300" dirty="0"/>
-          </a:p>
-        </p:txBody>
-      </p:sp>
-      <p:sp>
-        <p:nvSpPr>
-          <p:cNvPr id="6" name="Text 4"/>
-          <p:cNvSpPr/>
-          <p:nvPr/>
-        </p:nvSpPr>
-        <p:spPr>
-          <a:xfrm>
-            <a:off x="777240" y="3246120"/>
-            <a:ext cx="3291840" cy="2286000"/>
-          </a:xfrm>
-          <a:prstGeom prst="rect">
-            <a:avLst/>
-          </a:prstGeom>
-          <a:noFill/>
-          <a:ln/>
-        </p:spPr>
-        <p:txBody>
-          <a:bodyPr wrap="square" lIns="0" tIns="0" rIns="0" bIns="0" rtlCol="0" anchor="t"/>
-          <a:lstStyle/>
-          <a:p>
-            <a:pPr marL="342900" indent="-342900">
-              <a:lnSpc>
-                <a:spcPts val="2000"/>
-              </a:lnSpc>
-              <a:spcAft>
-                <a:spcPts val="1200"/>
-              </a:spcAft>
-              <a:buSzPct val="100000"/>
-              <a:buChar char="•"/>
-            </a:pPr>
-            <a:r>
-              <a:rPr lang="en-US" sz="1400" dirty="0">
-                <a:solidFill>
-                  <a:srgbClr val="1A1C2E"/>
-                </a:solidFill>
-                <a:latin typeface="Calibri" pitchFamily="34" charset="0"/>
-                <a:ea typeface="Calibri" pitchFamily="34" charset="-122"/>
-                <a:cs typeface="Calibri" pitchFamily="34" charset="-120"/>
-              </a:rPr>
-              <a:t>Vin, DtcCode, PidCode, Formula</a:t>
-            </a:r>
-            <a:endParaRPr lang="en-US" sz="1400" dirty="0"/>
-          </a:p>
-          <a:p>
-            <a:pPr marL="342900" indent="-342900">
-              <a:lnSpc>
-                <a:spcPts val="2000"/>
-              </a:lnSpc>
-              <a:spcAft>
-                <a:spcPts val="1200"/>
-              </a:spcAft>
-              <a:buSzPct val="100000"/>
-              <a:buChar char="•"/>
-            </a:pPr>
-            <a:r>
-              <a:rPr lang="en-US" sz="1400" dirty="0">
-                <a:solidFill>
-                  <a:srgbClr val="1A1C2E"/>
-                </a:solidFill>
-                <a:latin typeface="Calibri" pitchFamily="34" charset="0"/>
-                <a:ea typeface="Calibri" pitchFamily="34" charset="-122"/>
-                <a:cs typeface="Calibri" pitchFamily="34" charset="-120"/>
-              </a:rPr>
-              <a:t>Catálogos de PID, DTC y direcciones de ECU</a:t>
-            </a:r>
-            <a:endParaRPr lang="en-US" sz="1400" dirty="0"/>
-          </a:p>
-          <a:p>
-            <a:pPr marL="342900" indent="-342900">
-              <a:lnSpc>
-                <a:spcPts val="2000"/>
-              </a:lnSpc>
-              <a:spcAft>
-                <a:spcPts val="1200"/>
-              </a:spcAft>
-              <a:buSzPct val="100000"/>
-              <a:buChar char="•"/>
-            </a:pPr>
-            <a:r>
-              <a:rPr lang="en-US" sz="1400" dirty="0">
-                <a:solidFill>
-                  <a:srgbClr val="1A1C2E"/>
-                </a:solidFill>
-                <a:latin typeface="Calibri" pitchFamily="34" charset="0"/>
-                <a:ea typeface="Calibri" pitchFamily="34" charset="-122"/>
-                <a:cs typeface="Calibri" pitchFamily="34" charset="-120"/>
-              </a:rPr>
-              <a:t>Las normas SAE J1979 e ISO</a:t>
-            </a:r>
-            <a:endParaRPr lang="en-US" sz="1400" dirty="0"/>
-          </a:p>
-        </p:txBody>
-      </p:sp>
-      <p:sp>
-        <p:nvSpPr>
-          <p:cNvPr id="7" name="Text 5"/>
-          <p:cNvSpPr/>
-          <p:nvPr/>
-        </p:nvSpPr>
-        <p:spPr>
-          <a:xfrm>
-            <a:off x="4434840" y="2377440"/>
-            <a:ext cx="3291840" cy="365760"/>
-          </a:xfrm>
-          <a:prstGeom prst="rect">
-            <a:avLst/>
-          </a:prstGeom>
-          <a:noFill/>
-          <a:ln/>
-        </p:spPr>
-        <p:txBody>
-          <a:bodyPr wrap="square" lIns="0" tIns="0" rIns="0" bIns="0" rtlCol="0" anchor="t"/>
-          <a:lstStyle/>
-          <a:p>
-            <a:pPr indent="0" marL="0">
-              <a:buNone/>
-            </a:pPr>
-            <a:r>
-              <a:rPr lang="en-US" sz="2000" b="1" dirty="0">
-                <a:solidFill>
-                  <a:srgbClr val="202CFC"/>
-                </a:solidFill>
-                <a:latin typeface="Arial" pitchFamily="34" charset="0"/>
-                <a:ea typeface="Arial" pitchFamily="34" charset="-122"/>
-                <a:cs typeface="Arial" pitchFamily="34" charset="-120"/>
-              </a:rPr>
-              <a:t>Aplicación</a:t>
-            </a:r>
-            <a:endParaRPr lang="en-US" sz="2000" dirty="0"/>
-          </a:p>
-        </p:txBody>
-      </p:sp>
-      <p:sp>
-        <p:nvSpPr>
-          <p:cNvPr id="8" name="Text 6"/>
-          <p:cNvSpPr/>
-          <p:nvPr/>
-        </p:nvSpPr>
-        <p:spPr>
-          <a:xfrm>
-            <a:off x="4434840" y="2788920"/>
-            <a:ext cx="3291840" cy="292608"/>
-          </a:xfrm>
-          <a:prstGeom prst="rect">
-            <a:avLst/>
-          </a:prstGeom>
-          <a:noFill/>
-          <a:ln/>
-        </p:spPr>
-        <p:txBody>
-          <a:bodyPr wrap="square" lIns="0" tIns="0" rIns="0" bIns="0" rtlCol="0" anchor="t"/>
-          <a:lstStyle/>
-          <a:p>
-            <a:pPr indent="0" marL="0">
-              <a:buNone/>
-            </a:pPr>
-            <a:r>
-              <a:rPr lang="en-US" sz="1300" i="1" dirty="0">
-                <a:solidFill>
-                  <a:srgbClr val="5A5F73"/>
-                </a:solidFill>
-                <a:latin typeface="Calibri" pitchFamily="34" charset="0"/>
-                <a:ea typeface="Calibri" pitchFamily="34" charset="-122"/>
-                <a:cs typeface="Calibri" pitchFamily="34" charset="-120"/>
-              </a:rPr>
-              <a:t>Solo conoce el dominio</a:t>
-            </a:r>
-            <a:endParaRPr lang="en-US" sz="1300" dirty="0"/>
-          </a:p>
-        </p:txBody>
-      </p:sp>
-      <p:sp>
-        <p:nvSpPr>
-          <p:cNvPr id="9" name="Text 7"/>
-          <p:cNvSpPr/>
-          <p:nvPr/>
-        </p:nvSpPr>
-        <p:spPr>
-          <a:xfrm>
-            <a:off x="4434840" y="3246120"/>
-            <a:ext cx="3291840" cy="2286000"/>
-          </a:xfrm>
-          <a:prstGeom prst="rect">
-            <a:avLst/>
-          </a:prstGeom>
-          <a:noFill/>
-          <a:ln/>
-        </p:spPr>
-        <p:txBody>
-          <a:bodyPr wrap="square" lIns="0" tIns="0" rIns="0" bIns="0" rtlCol="0" anchor="t"/>
-          <a:lstStyle/>
-          <a:p>
-            <a:pPr marL="342900" indent="-342900">
-              <a:lnSpc>
-                <a:spcPts val="2000"/>
-              </a:lnSpc>
-              <a:spcAft>
-                <a:spcPts val="1200"/>
-              </a:spcAft>
-              <a:buSzPct val="100000"/>
-              <a:buChar char="•"/>
-            </a:pPr>
-            <a:r>
-              <a:rPr lang="en-US" sz="1400" dirty="0">
-                <a:solidFill>
-                  <a:srgbClr val="1A1C2E"/>
-                </a:solidFill>
-                <a:latin typeface="Calibri" pitchFamily="34" charset="0"/>
-                <a:ea typeface="Calibri" pitchFamily="34" charset="-122"/>
-                <a:cs typeface="Calibri" pitchFamily="34" charset="-120"/>
-              </a:rPr>
-              <a:t>IdentifyVehicle, GetLiveData, GetEcuInfo</a:t>
-            </a:r>
-            <a:endParaRPr lang="en-US" sz="1400" dirty="0"/>
-          </a:p>
-          <a:p>
-            <a:pPr marL="342900" indent="-342900">
-              <a:lnSpc>
-                <a:spcPts val="2000"/>
-              </a:lnSpc>
-              <a:spcAft>
-                <a:spcPts val="1200"/>
-              </a:spcAft>
-              <a:buSzPct val="100000"/>
-              <a:buChar char="•"/>
-            </a:pPr>
-            <a:r>
-              <a:rPr lang="en-US" sz="1400" dirty="0">
-                <a:solidFill>
-                  <a:srgbClr val="1A1C2E"/>
-                </a:solidFill>
-                <a:latin typeface="Calibri" pitchFamily="34" charset="0"/>
-                <a:ea typeface="Calibri" pitchFamily="34" charset="-122"/>
-                <a:cs typeface="Calibri" pitchFamily="34" charset="-120"/>
-              </a:rPr>
-              <a:t>ProcessVehicleDiagnosis, ExecuteCognitiveDiagnosis</a:t>
-            </a:r>
-            <a:endParaRPr lang="en-US" sz="1400" dirty="0"/>
-          </a:p>
-          <a:p>
-            <a:pPr marL="342900" indent="-342900">
-              <a:lnSpc>
-                <a:spcPts val="2000"/>
-              </a:lnSpc>
-              <a:spcAft>
-                <a:spcPts val="1200"/>
-              </a:spcAft>
-              <a:buSzPct val="100000"/>
-              <a:buChar char="•"/>
-            </a:pPr>
-            <a:r>
-              <a:rPr lang="en-US" sz="1400" dirty="0">
-                <a:solidFill>
-                  <a:srgbClr val="1A1C2E"/>
-                </a:solidFill>
-                <a:latin typeface="Calibri" pitchFamily="34" charset="0"/>
-                <a:ea typeface="Calibri" pitchFamily="34" charset="-122"/>
-                <a:cs typeface="Calibri" pitchFamily="34" charset="-120"/>
-              </a:rPr>
-              <a:t>Los puertos: ObdRepository, LlmClientPort…</a:t>
-            </a:r>
-            <a:endParaRPr lang="en-US" sz="1400" dirty="0"/>
-          </a:p>
-        </p:txBody>
-      </p:sp>
-      <p:sp>
-        <p:nvSpPr>
-          <p:cNvPr id="10" name="Text 8"/>
-          <p:cNvSpPr/>
-          <p:nvPr/>
-        </p:nvSpPr>
-        <p:spPr>
-          <a:xfrm>
-            <a:off x="8092440" y="2377440"/>
-            <a:ext cx="3291840" cy="365760"/>
-          </a:xfrm>
-          <a:prstGeom prst="rect">
-            <a:avLst/>
-          </a:prstGeom>
-          <a:noFill/>
-          <a:ln/>
-        </p:spPr>
-        <p:txBody>
-          <a:bodyPr wrap="square" lIns="0" tIns="0" rIns="0" bIns="0" rtlCol="0" anchor="t"/>
-          <a:lstStyle/>
-          <a:p>
-            <a:pPr indent="0" marL="0">
-              <a:buNone/>
-            </a:pPr>
-            <a:r>
-              <a:rPr lang="en-US" sz="2000" b="1" dirty="0">
-                <a:solidFill>
-                  <a:srgbClr val="202CFC"/>
-                </a:solidFill>
-                <a:latin typeface="Arial" pitchFamily="34" charset="0"/>
-                <a:ea typeface="Arial" pitchFamily="34" charset="-122"/>
-                <a:cs typeface="Arial" pitchFamily="34" charset="-120"/>
-              </a:rPr>
-              <a:t>Infraestructura</a:t>
-            </a:r>
-            <a:endParaRPr lang="en-US" sz="2000" dirty="0"/>
-          </a:p>
-        </p:txBody>
-      </p:sp>
-      <p:sp>
-        <p:nvSpPr>
-          <p:cNvPr id="11" name="Text 9"/>
-          <p:cNvSpPr/>
-          <p:nvPr/>
-        </p:nvSpPr>
-        <p:spPr>
-          <a:xfrm>
-            <a:off x="8092440" y="2788920"/>
-            <a:ext cx="3291840" cy="292608"/>
-          </a:xfrm>
-          <a:prstGeom prst="rect">
-            <a:avLst/>
-          </a:prstGeom>
-          <a:noFill/>
-          <a:ln/>
-        </p:spPr>
-        <p:txBody>
-          <a:bodyPr wrap="square" lIns="0" tIns="0" rIns="0" bIns="0" rtlCol="0" anchor="t"/>
-          <a:lstStyle/>
-          <a:p>
-            <a:pPr indent="0" marL="0">
-              <a:buNone/>
-            </a:pPr>
-            <a:r>
-              <a:rPr lang="en-US" sz="1300" i="1" dirty="0">
-                <a:solidFill>
-                  <a:srgbClr val="5A5F73"/>
-                </a:solidFill>
-                <a:latin typeface="Calibri" pitchFamily="34" charset="0"/>
-                <a:ea typeface="Calibri" pitchFamily="34" charset="-122"/>
-                <a:cs typeface="Calibri" pitchFamily="34" charset="-120"/>
-              </a:rPr>
-              <a:t>Implementa los puertos</a:t>
-            </a:r>
-            <a:endParaRPr lang="en-US" sz="1300" dirty="0"/>
-          </a:p>
-        </p:txBody>
-      </p:sp>
-      <p:sp>
-        <p:nvSpPr>
-          <p:cNvPr id="12" name="Text 10"/>
-          <p:cNvSpPr/>
-          <p:nvPr/>
-        </p:nvSpPr>
-        <p:spPr>
-          <a:xfrm>
-            <a:off x="8092440" y="3246120"/>
-            <a:ext cx="3291840" cy="2286000"/>
-          </a:xfrm>
-          <a:prstGeom prst="rect">
-            <a:avLst/>
-          </a:prstGeom>
-          <a:noFill/>
-          <a:ln/>
-        </p:spPr>
-        <p:txBody>
-          <a:bodyPr wrap="square" lIns="0" tIns="0" rIns="0" bIns="0" rtlCol="0" anchor="t"/>
-          <a:lstStyle/>
-          <a:p>
-            <a:pPr marL="342900" indent="-342900">
-              <a:lnSpc>
-                <a:spcPts val="2000"/>
-              </a:lnSpc>
-              <a:spcAft>
-                <a:spcPts val="1200"/>
-              </a:spcAft>
-              <a:buSzPct val="100000"/>
-              <a:buChar char="•"/>
-            </a:pPr>
-            <a:r>
-              <a:rPr lang="en-US" sz="1400" dirty="0">
-                <a:solidFill>
-                  <a:srgbClr val="1A1C2E"/>
-                </a:solidFill>
-                <a:latin typeface="Calibri" pitchFamily="34" charset="0"/>
-                <a:ea typeface="Calibri" pitchFamily="34" charset="-122"/>
-                <a:cs typeface="Calibri" pitchFamily="34" charset="-120"/>
-              </a:rPr>
-              <a:t>Express, Drizzle + SQLite, LanceDB</a:t>
-            </a:r>
-            <a:endParaRPr lang="en-US" sz="1400" dirty="0"/>
-          </a:p>
-          <a:p>
-            <a:pPr marL="342900" indent="-342900">
-              <a:lnSpc>
-                <a:spcPts val="2000"/>
-              </a:lnSpc>
-              <a:spcAft>
-                <a:spcPts val="1200"/>
-              </a:spcAft>
-              <a:buSzPct val="100000"/>
-              <a:buChar char="•"/>
-            </a:pPr>
-            <a:r>
-              <a:rPr lang="en-US" sz="1400" dirty="0">
-                <a:solidFill>
-                  <a:srgbClr val="1A1C2E"/>
-                </a:solidFill>
-                <a:latin typeface="Calibri" pitchFamily="34" charset="0"/>
-                <a:ea typeface="Calibri" pitchFamily="34" charset="-122"/>
-                <a:cs typeface="Calibri" pitchFamily="34" charset="-120"/>
-              </a:rPr>
-              <a:t>Servidor MCP, clientes de Anthropic y OpenAI</a:t>
-            </a:r>
-            <a:endParaRPr lang="en-US" sz="1400" dirty="0"/>
-          </a:p>
-          <a:p>
-            <a:pPr marL="342900" indent="-342900">
-              <a:lnSpc>
-                <a:spcPts val="2000"/>
-              </a:lnSpc>
-              <a:spcAft>
-                <a:spcPts val="1200"/>
-              </a:spcAft>
-              <a:buSzPct val="100000"/>
-              <a:buChar char="•"/>
-            </a:pPr>
-            <a:r>
-              <a:rPr lang="en-US" sz="1400" dirty="0">
-                <a:solidFill>
-                  <a:srgbClr val="1A1C2E"/>
-                </a:solidFill>
-                <a:latin typeface="Calibri" pitchFamily="34" charset="0"/>
-                <a:ea typeface="Calibri" pitchFamily="34" charset="-122"/>
-                <a:cs typeface="Calibri" pitchFamily="34" charset="-120"/>
-              </a:rPr>
-              <a:t>Transporte ELM327 y simulador</a:t>
-            </a:r>
-            <a:endParaRPr lang="en-US" sz="1400" dirty="0"/>
-          </a:p>
-        </p:txBody>
-      </p:sp>
-      <p:sp>
-        <p:nvSpPr>
-          <p:cNvPr id="13" name="Text 11"/>
-          <p:cNvSpPr/>
-          <p:nvPr/>
-        </p:nvSpPr>
-        <p:spPr>
-          <a:xfrm>
-            <a:off x="777240" y="5669280"/>
-            <a:ext cx="10607040" cy="365760"/>
-          </a:xfrm>
-          <a:prstGeom prst="rect">
-            <a:avLst/>
-          </a:prstGeom>
-          <a:noFill/>
-          <a:ln/>
-        </p:spPr>
-        <p:txBody>
-          <a:bodyPr wrap="square" lIns="0" tIns="0" rIns="0" bIns="0" rtlCol="0" anchor="ctr"/>
-          <a:lstStyle/>
-          <a:p>
-            <a:pPr indent="0" marL="0">
-              <a:buNone/>
-            </a:pPr>
-            <a:r>
-              <a:rPr lang="en-US" sz="1500" dirty="0">
-                <a:solidFill>
-                  <a:srgbClr val="5A5F73"/>
-                </a:solidFill>
-                <a:latin typeface="Calibri" pitchFamily="34" charset="0"/>
-                <a:ea typeface="Calibri" pitchFamily="34" charset="-122"/>
-                <a:cs typeface="Calibri" pitchFamily="34" charset="-120"/>
-              </a:rPr>
-              <a:t>El dominio no sabe que existe SQLite, ni Express, ni ningún LLM.</a:t>
-            </a:r>
-            <a:endParaRPr lang="en-US" sz="1500" dirty="0"/>
-          </a:p>
-        </p:txBody>
-      </p:sp>
-      <p:sp>
-        <p:nvSpPr>
-          <p:cNvPr id="14" name="Shape 12"/>
-          <p:cNvSpPr/>
-          <p:nvPr/>
-        </p:nvSpPr>
-        <p:spPr>
-          <a:xfrm>
-            <a:off x="777240" y="6263640"/>
-            <a:ext cx="219456" cy="219456"/>
-          </a:xfrm>
-          <a:prstGeom prst="rect">
-            <a:avLst/>
-          </a:prstGeom>
-          <a:solidFill>
-            <a:srgbClr val="202CFC"/>
-          </a:solidFill>
-          <a:ln/>
-        </p:spPr>
-      </p:sp>
-      <p:sp>
-        <p:nvSpPr>
-          <p:cNvPr id="15" name="Text 13"/>
-          <p:cNvSpPr/>
-          <p:nvPr/>
-        </p:nvSpPr>
-        <p:spPr>
-          <a:xfrm>
-            <a:off x="777240" y="6263640"/>
-            <a:ext cx="219456" cy="219456"/>
-          </a:xfrm>
-          <a:prstGeom prst="rect">
-            <a:avLst/>
-          </a:prstGeom>
-          <a:noFill/>
-          <a:ln/>
-        </p:spPr>
-        <p:txBody>
-          <a:bodyPr wrap="square" lIns="0" tIns="0" rIns="0" bIns="0" rtlCol="0" anchor="ctr"/>
-          <a:lstStyle/>
-          <a:p>
-            <a:pPr algn="ctr" indent="0" marL="0">
-              <a:buNone/>
-            </a:pPr>
-            <a:r>
-              <a:rPr lang="en-US" sz="816" b="1" dirty="0">
-                <a:solidFill>
-                  <a:srgbClr val="FFFFFF"/>
-                </a:solidFill>
-                <a:latin typeface="Arial" pitchFamily="34" charset="0"/>
-                <a:ea typeface="Arial" pitchFamily="34" charset="-122"/>
-                <a:cs typeface="Arial" pitchFamily="34" charset="-120"/>
-              </a:rPr>
-              <a:t>BIG</a:t>
-            </a:r>
-            <a:endParaRPr lang="en-US" sz="816" dirty="0"/>
-          </a:p>
-        </p:txBody>
-      </p:sp>
-      <p:sp>
-        <p:nvSpPr>
-          <p:cNvPr id="16" name="Text 14"/>
-          <p:cNvSpPr/>
-          <p:nvPr/>
-        </p:nvSpPr>
-        <p:spPr>
-          <a:xfrm>
-            <a:off x="1078992" y="6263640"/>
-            <a:ext cx="658368" cy="219456"/>
-          </a:xfrm>
-          <a:prstGeom prst="rect">
-            <a:avLst/>
-          </a:prstGeom>
-          <a:noFill/>
-          <a:ln/>
-        </p:spPr>
-        <p:txBody>
-          <a:bodyPr wrap="square" lIns="0" tIns="0" rIns="0" bIns="0" rtlCol="0" anchor="ctr"/>
-          <a:lstStyle/>
-          <a:p>
-            <a:pPr algn="l" indent="0" marL="0">
-              <a:buNone/>
-            </a:pPr>
-            <a:r>
-              <a:rPr lang="en-US" sz="816" dirty="0">
-                <a:solidFill>
-                  <a:srgbClr val="1A1C2E"/>
-                </a:solidFill>
-                <a:latin typeface="Arial" pitchFamily="34" charset="0"/>
-                <a:ea typeface="Arial" pitchFamily="34" charset="-122"/>
-                <a:cs typeface="Arial" pitchFamily="34" charset="-120"/>
-              </a:rPr>
-              <a:t>school</a:t>
-            </a:r>
-            <a:endParaRPr lang="en-US" sz="816" dirty="0"/>
-          </a:p>
-        </p:txBody>
-      </p:sp>
-      <p:sp>
-        <p:nvSpPr>
-          <p:cNvPr id="17" name="Text 15"/>
-          <p:cNvSpPr/>
-          <p:nvPr/>
-        </p:nvSpPr>
-        <p:spPr>
-          <a:xfrm>
-            <a:off x="11064240" y="6263640"/>
-            <a:ext cx="320040" cy="219456"/>
-          </a:xfrm>
-          <a:prstGeom prst="rect">
-            <a:avLst/>
-          </a:prstGeom>
-          <a:noFill/>
-          <a:ln/>
-        </p:spPr>
-        <p:txBody>
-          <a:bodyPr wrap="square" lIns="0" tIns="0" rIns="0" bIns="0" rtlCol="0" anchor="ctr"/>
-          <a:lstStyle/>
-          <a:p>
-            <a:pPr algn="r" indent="0" marL="0">
-              <a:buNone/>
-            </a:pPr>
-            <a:r>
-              <a:rPr lang="en-US" sz="1000" dirty="0">
-                <a:solidFill>
-                  <a:srgbClr val="5A5F73"/>
-                </a:solidFill>
-                <a:latin typeface="Calibri" pitchFamily="34" charset="0"/>
-                <a:ea typeface="Calibri" pitchFamily="34" charset="-122"/>
-                <a:cs typeface="Calibri" pitchFamily="34" charset="-120"/>
-              </a:rPr>
-              <a:t>5</a:t>
             </a:r>
             <a:endParaRPr lang="en-US" sz="1000" dirty="0"/>
           </a:p>

</xml_diff>

<commit_message>
docs(tfm): diagrama del flujo OBD-II con un PID real
</commit_message>
<xml_diff>
--- a/docs/presentacion/tfm-intelligent-automotive-diagnostics.pptx
+++ b/docs/presentacion/tfm-intelligent-automotive-diagnostics.pptx
@@ -9,9 +9,10 @@
     <p:sldId id="257" r:id="rId3"/>
     <p:sldId id="258" r:id="rId4"/>
     <p:sldId id="259" r:id="rId5"/>
+    <p:sldId id="260" r:id="rId6"/>
   </p:sldIdLst>
   <p:notesMasterIdLst>
-    <p:notesMasterId r:id="rId6"/>
+    <p:notesMasterId r:id="rId7"/>
   </p:notesMasterIdLst>
   <p:sldSz cx="12192000" cy="6858000"/>
   <p:notesSz cx="6858000" cy="12192000"/>
@@ -806,6 +807,100 @@
             <a:fld id="{F7021451-1387-4CA6-816F-3879F97B5CBC}" type="slidenum">
               <a:rPr lang="en-US"/>
               <a:t>4</a:t>
+            </a:fld>
+            <a:endParaRPr lang="en-US"/>
+          </a:p>
+        </p:txBody>
+      </p:sp>
+    </p:spTree>
+    <p:extLst>
+      <p:ext uri="{BB962C8B-B14F-4D97-AF65-F5344CB8AC3E}">
+        <p14:creationId xmlns:p14="http://schemas.microsoft.com/office/powerpoint/2010/main" val="1024086991"/>
+      </p:ext>
+    </p:extLst>
+  </p:cSld>
+  <p:clrMapOvr>
+    <a:masterClrMapping/>
+  </p:clrMapOvr>
+</p:notes>
+</file>
+
+<file path=ppt/notesSlides/notesSlide5.xml><?xml version="1.0" encoding="utf-8"?>
+<p:notes xmlns:a="http://schemas.openxmlformats.org/drawingml/2006/main" xmlns:r="http://schemas.openxmlformats.org/officeDocument/2006/relationships" xmlns:p="http://schemas.openxmlformats.org/presentationml/2006/main">
+  <p:cSld>
+    <p:spTree>
+      <p:nvGrpSpPr>
+        <p:cNvPr id="1" name=""/>
+        <p:cNvGrpSpPr/>
+        <p:nvPr/>
+      </p:nvGrpSpPr>
+      <p:grpSpPr>
+        <a:xfrm>
+          <a:off x="0" y="0"/>
+          <a:ext cx="0" cy="0"/>
+          <a:chOff x="0" y="0"/>
+          <a:chExt cx="0" cy="0"/>
+        </a:xfrm>
+      </p:grpSpPr>
+      <p:sp>
+        <p:nvSpPr>
+          <p:cNvPr id="2" name="Slide Image Placeholder 1"/>
+          <p:cNvSpPr>
+            <a:spLocks noGrp="1" noRot="1" noChangeAspect="1"/>
+          </p:cNvSpPr>
+          <p:nvPr>
+            <p:ph type="sldImg"/>
+          </p:nvPr>
+        </p:nvSpPr>
+        <p:spPr/>
+      </p:sp>
+      <p:sp>
+        <p:nvSpPr>
+          <p:cNvPr id="3" name="Notes Placeholder 2"/>
+          <p:cNvSpPr>
+            <a:spLocks noGrp="1"/>
+          </p:cNvSpPr>
+          <p:nvPr>
+            <p:ph type="body" idx="1"/>
+          </p:nvPr>
+        </p:nvSpPr>
+        <p:spPr/>
+        <p:txBody>
+          <a:bodyPr/>
+          <a:lstStyle/>
+          <a:p>
+            <a:r>
+              <a:rPr lang="en-US" dirty="0"/>
+              <a:t>Esto es todo lo que hay que entender del OBD-II para seguir el resto de la charla.
+La aplicación quiere saber a cuántas revoluciones está el motor. Manda dos bytes: 01 0C. El 01 es el modo, que en la norma significa "dame un dato en vivo", y el 0C es el PID concreto, las revoluciones.
+Eso sale por el adaptador ELM327, que es el cachivache que se enchufa al conector del coche, entra en el bus CAN, y llega a la centralita del motor.
+La centralita contesta 41 0C 0B B8. El 41 es el 01 más cuarenta, que es como la norma marca que es una respuesta. El 0C confirma qué PID contesta. Y los dos últimos bytes son el dato en crudo.
+Ese dato no son revoluciones todavía. Hay que aplicarle la fórmula del PID: A por 256 más B, dividido entre 4. Con 0B y B8, eso da 750 revoluciones.
+Esa fórmula la fija la SAE J1979, y por eso está en el dominio y no en el código que habla con el cable.
+[~70 s]</a:t>
+            </a:r>
+            <a:endParaRPr lang="en-US" dirty="0"/>
+          </a:p>
+        </p:txBody>
+      </p:sp>
+      <p:sp>
+        <p:nvSpPr>
+          <p:cNvPr id="4" name="Slide Number Placeholder 3"/>
+          <p:cNvSpPr>
+            <a:spLocks noGrp="1"/>
+          </p:cNvSpPr>
+          <p:nvPr>
+            <p:ph type="sldNum" sz="quarter" idx="10"/>
+          </p:nvPr>
+        </p:nvSpPr>
+        <p:spPr/>
+        <p:txBody>
+          <a:bodyPr/>
+          <a:lstStyle/>
+          <a:p>
+            <a:fld id="{F7021451-1387-4CA6-816F-3879F97B5CBC}" type="slidenum">
+              <a:rPr lang="en-US"/>
+              <a:t>5</a:t>
             </a:fld>
             <a:endParaRPr lang="en-US"/>
           </a:p>
@@ -3180,6 +3275,987 @@
 </p:sld>
 </file>
 
+<file path=ppt/slides/slide5.xml><?xml version="1.0" encoding="utf-8"?>
+<p:sld xmlns:a="http://schemas.openxmlformats.org/drawingml/2006/main" xmlns:r="http://schemas.openxmlformats.org/officeDocument/2006/relationships" xmlns:p="http://schemas.openxmlformats.org/presentationml/2006/main">
+  <p:cSld name="Slide 5">
+    <p:bg>
+      <p:bgPr>
+        <a:solidFill>
+          <a:srgbClr val="FFFFFF"/>
+        </a:solidFill>
+      </p:bgPr>
+    </p:bg>
+    <p:spTree>
+      <p:nvGrpSpPr>
+        <p:cNvPr id="1" name=""/>
+        <p:cNvGrpSpPr/>
+        <p:nvPr/>
+      </p:nvGrpSpPr>
+      <p:grpSpPr>
+        <a:xfrm>
+          <a:off x="0" y="0"/>
+          <a:ext cx="0" cy="0"/>
+          <a:chOff x="0" y="0"/>
+          <a:chExt cx="0" cy="0"/>
+        </a:xfrm>
+      </p:grpSpPr>
+      <p:sp>
+        <p:nvSpPr>
+          <p:cNvPr id="2" name="Text 0"/>
+          <p:cNvSpPr/>
+          <p:nvPr/>
+        </p:nvSpPr>
+        <p:spPr>
+          <a:xfrm>
+            <a:off x="777240" y="640080"/>
+            <a:ext cx="10607040" cy="777240"/>
+          </a:xfrm>
+          <a:prstGeom prst="rect">
+            <a:avLst/>
+          </a:prstGeom>
+          <a:noFill/>
+          <a:ln/>
+        </p:spPr>
+        <p:txBody>
+          <a:bodyPr wrap="square" lIns="0" tIns="0" rIns="0" bIns="0" rtlCol="0" anchor="t"/>
+          <a:lstStyle/>
+          <a:p>
+            <a:pPr indent="0" marL="0">
+              <a:buNone/>
+            </a:pPr>
+            <a:r>
+              <a:rPr lang="en-US" sz="3400" b="1" dirty="0">
+                <a:solidFill>
+                  <a:srgbClr val="1A1C2E"/>
+                </a:solidFill>
+                <a:latin typeface="Arial" pitchFamily="34" charset="0"/>
+                <a:ea typeface="Arial" pitchFamily="34" charset="-122"/>
+                <a:cs typeface="Arial" pitchFamily="34" charset="-120"/>
+              </a:rPr>
+              <a:t>Cómo se lee el coche</a:t>
+            </a:r>
+            <a:endParaRPr lang="en-US" sz="3400" dirty="0"/>
+          </a:p>
+        </p:txBody>
+      </p:sp>
+      <p:sp>
+        <p:nvSpPr>
+          <p:cNvPr id="3" name="Text 1"/>
+          <p:cNvSpPr/>
+          <p:nvPr/>
+        </p:nvSpPr>
+        <p:spPr>
+          <a:xfrm>
+            <a:off x="777240" y="1508760"/>
+            <a:ext cx="10607040" cy="365760"/>
+          </a:xfrm>
+          <a:prstGeom prst="rect">
+            <a:avLst/>
+          </a:prstGeom>
+          <a:noFill/>
+          <a:ln/>
+        </p:spPr>
+        <p:txBody>
+          <a:bodyPr wrap="square" lIns="0" tIns="0" rIns="0" bIns="0" rtlCol="0" anchor="t"/>
+          <a:lstStyle/>
+          <a:p>
+            <a:pPr indent="0" marL="0">
+              <a:buNone/>
+            </a:pPr>
+            <a:r>
+              <a:rPr lang="en-US" sz="1700" dirty="0">
+                <a:solidFill>
+                  <a:srgbClr val="5A5F73"/>
+                </a:solidFill>
+                <a:latin typeface="Calibri" pitchFamily="34" charset="0"/>
+                <a:ea typeface="Calibri" pitchFamily="34" charset="-122"/>
+                <a:cs typeface="Calibri" pitchFamily="34" charset="-120"/>
+              </a:rPr>
+              <a:t>Un ejemplo: pedirle las revoluciones del motor.</a:t>
+            </a:r>
+            <a:endParaRPr lang="en-US" sz="1700" dirty="0"/>
+          </a:p>
+        </p:txBody>
+      </p:sp>
+      <p:sp>
+        <p:nvSpPr>
+          <p:cNvPr id="4" name="Shape 2"/>
+          <p:cNvSpPr/>
+          <p:nvPr/>
+        </p:nvSpPr>
+        <p:spPr>
+          <a:xfrm>
+            <a:off x="777240" y="2331720"/>
+            <a:ext cx="2194560" cy="1051560"/>
+          </a:xfrm>
+          <a:prstGeom prst="roundRect">
+            <a:avLst>
+              <a:gd name="adj" fmla="val 5217"/>
+            </a:avLst>
+          </a:prstGeom>
+          <a:solidFill>
+            <a:srgbClr val="FFFFFF"/>
+          </a:solidFill>
+          <a:ln w="12700">
+            <a:solidFill>
+              <a:srgbClr val="C9CCD8"/>
+            </a:solidFill>
+            <a:prstDash val="solid"/>
+          </a:ln>
+        </p:spPr>
+      </p:sp>
+      <p:sp>
+        <p:nvSpPr>
+          <p:cNvPr id="5" name="Text 3"/>
+          <p:cNvSpPr/>
+          <p:nvPr/>
+        </p:nvSpPr>
+        <p:spPr>
+          <a:xfrm>
+            <a:off x="777240" y="2331720"/>
+            <a:ext cx="2194560" cy="1051560"/>
+          </a:xfrm>
+          <a:prstGeom prst="rect">
+            <a:avLst/>
+          </a:prstGeom>
+          <a:noFill/>
+          <a:ln/>
+        </p:spPr>
+        <p:txBody>
+          <a:bodyPr wrap="square" lIns="0" tIns="0" rIns="0" bIns="0" rtlCol="0" anchor="ctr"/>
+          <a:lstStyle/>
+          <a:p>
+            <a:pPr algn="ctr" indent="0" marL="0">
+              <a:lnSpc>
+                <a:spcPts val="2000"/>
+              </a:lnSpc>
+              <a:buNone/>
+            </a:pPr>
+            <a:r>
+              <a:rPr lang="en-US" sz="1500" dirty="0">
+                <a:solidFill>
+                  <a:srgbClr val="1A1C2E"/>
+                </a:solidFill>
+                <a:latin typeface="Calibri" pitchFamily="34" charset="0"/>
+                <a:ea typeface="Calibri" pitchFamily="34" charset="-122"/>
+                <a:cs typeface="Calibri" pitchFamily="34" charset="-120"/>
+              </a:rPr>
+              <a:t>La aplicación</a:t>
+            </a:r>
+            <a:endParaRPr lang="en-US" sz="1500" dirty="0"/>
+          </a:p>
+        </p:txBody>
+      </p:sp>
+      <p:sp>
+        <p:nvSpPr>
+          <p:cNvPr id="6" name="Shape 4"/>
+          <p:cNvSpPr/>
+          <p:nvPr/>
+        </p:nvSpPr>
+        <p:spPr>
+          <a:xfrm>
+            <a:off x="3081528" y="2857500"/>
+            <a:ext cx="374904" cy="0"/>
+          </a:xfrm>
+          <a:prstGeom prst="line">
+            <a:avLst/>
+          </a:prstGeom>
+          <a:noFill/>
+          <a:ln w="19050">
+            <a:solidFill>
+              <a:srgbClr val="202CFC"/>
+            </a:solidFill>
+            <a:prstDash val="solid"/>
+            <a:tailEnd type="triangle"/>
+          </a:ln>
+        </p:spPr>
+      </p:sp>
+      <p:sp>
+        <p:nvSpPr>
+          <p:cNvPr id="7" name="Shape 5"/>
+          <p:cNvSpPr/>
+          <p:nvPr/>
+        </p:nvSpPr>
+        <p:spPr>
+          <a:xfrm>
+            <a:off x="3566160" y="2331720"/>
+            <a:ext cx="2194560" cy="1051560"/>
+          </a:xfrm>
+          <a:prstGeom prst="roundRect">
+            <a:avLst>
+              <a:gd name="adj" fmla="val 5217"/>
+            </a:avLst>
+          </a:prstGeom>
+          <a:solidFill>
+            <a:srgbClr val="FFFFFF"/>
+          </a:solidFill>
+          <a:ln w="12700">
+            <a:solidFill>
+              <a:srgbClr val="C9CCD8"/>
+            </a:solidFill>
+            <a:prstDash val="solid"/>
+          </a:ln>
+        </p:spPr>
+      </p:sp>
+      <p:sp>
+        <p:nvSpPr>
+          <p:cNvPr id="8" name="Text 6"/>
+          <p:cNvSpPr/>
+          <p:nvPr/>
+        </p:nvSpPr>
+        <p:spPr>
+          <a:xfrm>
+            <a:off x="3566160" y="2331720"/>
+            <a:ext cx="2194560" cy="1051560"/>
+          </a:xfrm>
+          <a:prstGeom prst="rect">
+            <a:avLst/>
+          </a:prstGeom>
+          <a:noFill/>
+          <a:ln/>
+        </p:spPr>
+        <p:txBody>
+          <a:bodyPr wrap="square" lIns="0" tIns="0" rIns="0" bIns="0" rtlCol="0" anchor="ctr"/>
+          <a:lstStyle/>
+          <a:p>
+            <a:pPr algn="ctr" indent="0" marL="0">
+              <a:lnSpc>
+                <a:spcPts val="2000"/>
+              </a:lnSpc>
+              <a:buNone/>
+            </a:pPr>
+            <a:r>
+              <a:rPr lang="en-US" sz="1500" dirty="0">
+                <a:solidFill>
+                  <a:srgbClr val="1A1C2E"/>
+                </a:solidFill>
+                <a:latin typeface="Calibri" pitchFamily="34" charset="0"/>
+                <a:ea typeface="Calibri" pitchFamily="34" charset="-122"/>
+                <a:cs typeface="Calibri" pitchFamily="34" charset="-120"/>
+              </a:rPr>
+              <a:t>Adaptador</a:t>
+            </a:r>
+            <a:endParaRPr lang="en-US" sz="1500" dirty="0"/>
+          </a:p>
+          <a:p>
+            <a:pPr algn="ctr" indent="0" marL="0">
+              <a:lnSpc>
+                <a:spcPts val="2000"/>
+              </a:lnSpc>
+              <a:buNone/>
+            </a:pPr>
+            <a:r>
+              <a:rPr lang="en-US" sz="1500" dirty="0">
+                <a:solidFill>
+                  <a:srgbClr val="1A1C2E"/>
+                </a:solidFill>
+                <a:latin typeface="Calibri" pitchFamily="34" charset="0"/>
+                <a:ea typeface="Calibri" pitchFamily="34" charset="-122"/>
+                <a:cs typeface="Calibri" pitchFamily="34" charset="-120"/>
+              </a:rPr>
+              <a:t>ELM327</a:t>
+            </a:r>
+            <a:endParaRPr lang="en-US" sz="1500" dirty="0"/>
+          </a:p>
+        </p:txBody>
+      </p:sp>
+      <p:sp>
+        <p:nvSpPr>
+          <p:cNvPr id="9" name="Shape 7"/>
+          <p:cNvSpPr/>
+          <p:nvPr/>
+        </p:nvSpPr>
+        <p:spPr>
+          <a:xfrm>
+            <a:off x="5870448" y="2857500"/>
+            <a:ext cx="374904" cy="0"/>
+          </a:xfrm>
+          <a:prstGeom prst="line">
+            <a:avLst/>
+          </a:prstGeom>
+          <a:noFill/>
+          <a:ln w="19050">
+            <a:solidFill>
+              <a:srgbClr val="202CFC"/>
+            </a:solidFill>
+            <a:prstDash val="solid"/>
+            <a:tailEnd type="triangle"/>
+          </a:ln>
+        </p:spPr>
+      </p:sp>
+      <p:sp>
+        <p:nvSpPr>
+          <p:cNvPr id="10" name="Shape 8"/>
+          <p:cNvSpPr/>
+          <p:nvPr/>
+        </p:nvSpPr>
+        <p:spPr>
+          <a:xfrm>
+            <a:off x="6355080" y="2331720"/>
+            <a:ext cx="2194560" cy="1051560"/>
+          </a:xfrm>
+          <a:prstGeom prst="roundRect">
+            <a:avLst>
+              <a:gd name="adj" fmla="val 5217"/>
+            </a:avLst>
+          </a:prstGeom>
+          <a:solidFill>
+            <a:srgbClr val="FFFFFF"/>
+          </a:solidFill>
+          <a:ln w="12700">
+            <a:solidFill>
+              <a:srgbClr val="C9CCD8"/>
+            </a:solidFill>
+            <a:prstDash val="solid"/>
+          </a:ln>
+        </p:spPr>
+      </p:sp>
+      <p:sp>
+        <p:nvSpPr>
+          <p:cNvPr id="11" name="Text 9"/>
+          <p:cNvSpPr/>
+          <p:nvPr/>
+        </p:nvSpPr>
+        <p:spPr>
+          <a:xfrm>
+            <a:off x="6355080" y="2331720"/>
+            <a:ext cx="2194560" cy="1051560"/>
+          </a:xfrm>
+          <a:prstGeom prst="rect">
+            <a:avLst/>
+          </a:prstGeom>
+          <a:noFill/>
+          <a:ln/>
+        </p:spPr>
+        <p:txBody>
+          <a:bodyPr wrap="square" lIns="0" tIns="0" rIns="0" bIns="0" rtlCol="0" anchor="ctr"/>
+          <a:lstStyle/>
+          <a:p>
+            <a:pPr algn="ctr" indent="0" marL="0">
+              <a:lnSpc>
+                <a:spcPts val="2000"/>
+              </a:lnSpc>
+              <a:buNone/>
+            </a:pPr>
+            <a:r>
+              <a:rPr lang="en-US" sz="1500" dirty="0">
+                <a:solidFill>
+                  <a:srgbClr val="1A1C2E"/>
+                </a:solidFill>
+                <a:latin typeface="Calibri" pitchFamily="34" charset="0"/>
+                <a:ea typeface="Calibri" pitchFamily="34" charset="-122"/>
+                <a:cs typeface="Calibri" pitchFamily="34" charset="-120"/>
+              </a:rPr>
+              <a:t>Bus CAN</a:t>
+            </a:r>
+            <a:endParaRPr lang="en-US" sz="1500" dirty="0"/>
+          </a:p>
+          <a:p>
+            <a:pPr algn="ctr" indent="0" marL="0">
+              <a:lnSpc>
+                <a:spcPts val="2000"/>
+              </a:lnSpc>
+              <a:buNone/>
+            </a:pPr>
+            <a:r>
+              <a:rPr lang="en-US" sz="1500" dirty="0">
+                <a:solidFill>
+                  <a:srgbClr val="1A1C2E"/>
+                </a:solidFill>
+                <a:latin typeface="Calibri" pitchFamily="34" charset="0"/>
+                <a:ea typeface="Calibri" pitchFamily="34" charset="-122"/>
+                <a:cs typeface="Calibri" pitchFamily="34" charset="-120"/>
+              </a:rPr>
+              <a:t>del coche</a:t>
+            </a:r>
+            <a:endParaRPr lang="en-US" sz="1500" dirty="0"/>
+          </a:p>
+        </p:txBody>
+      </p:sp>
+      <p:sp>
+        <p:nvSpPr>
+          <p:cNvPr id="12" name="Shape 10"/>
+          <p:cNvSpPr/>
+          <p:nvPr/>
+        </p:nvSpPr>
+        <p:spPr>
+          <a:xfrm>
+            <a:off x="8659368" y="2857500"/>
+            <a:ext cx="374904" cy="0"/>
+          </a:xfrm>
+          <a:prstGeom prst="line">
+            <a:avLst/>
+          </a:prstGeom>
+          <a:noFill/>
+          <a:ln w="19050">
+            <a:solidFill>
+              <a:srgbClr val="202CFC"/>
+            </a:solidFill>
+            <a:prstDash val="solid"/>
+            <a:tailEnd type="triangle"/>
+          </a:ln>
+        </p:spPr>
+      </p:sp>
+      <p:sp>
+        <p:nvSpPr>
+          <p:cNvPr id="13" name="Shape 11"/>
+          <p:cNvSpPr/>
+          <p:nvPr/>
+        </p:nvSpPr>
+        <p:spPr>
+          <a:xfrm>
+            <a:off x="9144000" y="2331720"/>
+            <a:ext cx="2194560" cy="1051560"/>
+          </a:xfrm>
+          <a:prstGeom prst="roundRect">
+            <a:avLst>
+              <a:gd name="adj" fmla="val 5217"/>
+            </a:avLst>
+          </a:prstGeom>
+          <a:solidFill>
+            <a:srgbClr val="FFFFFF"/>
+          </a:solidFill>
+          <a:ln w="12700">
+            <a:solidFill>
+              <a:srgbClr val="C9CCD8"/>
+            </a:solidFill>
+            <a:prstDash val="solid"/>
+          </a:ln>
+        </p:spPr>
+      </p:sp>
+      <p:sp>
+        <p:nvSpPr>
+          <p:cNvPr id="14" name="Text 12"/>
+          <p:cNvSpPr/>
+          <p:nvPr/>
+        </p:nvSpPr>
+        <p:spPr>
+          <a:xfrm>
+            <a:off x="9144000" y="2331720"/>
+            <a:ext cx="2194560" cy="1051560"/>
+          </a:xfrm>
+          <a:prstGeom prst="rect">
+            <a:avLst/>
+          </a:prstGeom>
+          <a:noFill/>
+          <a:ln/>
+        </p:spPr>
+        <p:txBody>
+          <a:bodyPr wrap="square" lIns="0" tIns="0" rIns="0" bIns="0" rtlCol="0" anchor="ctr"/>
+          <a:lstStyle/>
+          <a:p>
+            <a:pPr algn="ctr" indent="0" marL="0">
+              <a:lnSpc>
+                <a:spcPts val="2000"/>
+              </a:lnSpc>
+              <a:buNone/>
+            </a:pPr>
+            <a:r>
+              <a:rPr lang="en-US" sz="1500" dirty="0">
+                <a:solidFill>
+                  <a:srgbClr val="1A1C2E"/>
+                </a:solidFill>
+                <a:latin typeface="Calibri" pitchFamily="34" charset="0"/>
+                <a:ea typeface="Calibri" pitchFamily="34" charset="-122"/>
+                <a:cs typeface="Calibri" pitchFamily="34" charset="-120"/>
+              </a:rPr>
+              <a:t>Centralita</a:t>
+            </a:r>
+            <a:endParaRPr lang="en-US" sz="1500" dirty="0"/>
+          </a:p>
+          <a:p>
+            <a:pPr algn="ctr" indent="0" marL="0">
+              <a:lnSpc>
+                <a:spcPts val="2000"/>
+              </a:lnSpc>
+              <a:buNone/>
+            </a:pPr>
+            <a:r>
+              <a:rPr lang="en-US" sz="1500" dirty="0">
+                <a:solidFill>
+                  <a:srgbClr val="1A1C2E"/>
+                </a:solidFill>
+                <a:latin typeface="Calibri" pitchFamily="34" charset="0"/>
+                <a:ea typeface="Calibri" pitchFamily="34" charset="-122"/>
+                <a:cs typeface="Calibri" pitchFamily="34" charset="-120"/>
+              </a:rPr>
+              <a:t>del motor</a:t>
+            </a:r>
+            <a:endParaRPr lang="en-US" sz="1500" dirty="0"/>
+          </a:p>
+        </p:txBody>
+      </p:sp>
+      <p:sp>
+        <p:nvSpPr>
+          <p:cNvPr id="15" name="Text 13"/>
+          <p:cNvSpPr/>
+          <p:nvPr/>
+        </p:nvSpPr>
+        <p:spPr>
+          <a:xfrm>
+            <a:off x="777240" y="3977640"/>
+            <a:ext cx="1005840" cy="301752"/>
+          </a:xfrm>
+          <a:prstGeom prst="rect">
+            <a:avLst/>
+          </a:prstGeom>
+          <a:noFill/>
+          <a:ln/>
+        </p:spPr>
+        <p:txBody>
+          <a:bodyPr wrap="square" lIns="0" tIns="0" rIns="0" bIns="0" rtlCol="0" anchor="ctr"/>
+          <a:lstStyle/>
+          <a:p>
+            <a:pPr indent="0" marL="0">
+              <a:buNone/>
+            </a:pPr>
+            <a:r>
+              <a:rPr lang="en-US" sz="1400" b="1" dirty="0">
+                <a:solidFill>
+                  <a:srgbClr val="5A5F73"/>
+                </a:solidFill>
+                <a:latin typeface="Calibri" pitchFamily="34" charset="0"/>
+                <a:ea typeface="Calibri" pitchFamily="34" charset="-122"/>
+                <a:cs typeface="Calibri" pitchFamily="34" charset="-120"/>
+              </a:rPr>
+              <a:t>Va</a:t>
+            </a:r>
+            <a:endParaRPr lang="en-US" sz="1400" dirty="0"/>
+          </a:p>
+        </p:txBody>
+      </p:sp>
+      <p:sp>
+        <p:nvSpPr>
+          <p:cNvPr id="16" name="Text 14"/>
+          <p:cNvSpPr/>
+          <p:nvPr/>
+        </p:nvSpPr>
+        <p:spPr>
+          <a:xfrm>
+            <a:off x="1828800" y="3977640"/>
+            <a:ext cx="2743200" cy="301752"/>
+          </a:xfrm>
+          <a:prstGeom prst="rect">
+            <a:avLst/>
+          </a:prstGeom>
+          <a:noFill/>
+          <a:ln/>
+        </p:spPr>
+        <p:txBody>
+          <a:bodyPr wrap="square" lIns="0" tIns="0" rIns="0" bIns="0" rtlCol="0" anchor="ctr"/>
+          <a:lstStyle/>
+          <a:p>
+            <a:pPr indent="0" marL="0">
+              <a:buNone/>
+            </a:pPr>
+            <a:r>
+              <a:rPr lang="en-US" sz="1600" b="1" dirty="0">
+                <a:solidFill>
+                  <a:srgbClr val="1A1C2E"/>
+                </a:solidFill>
+                <a:latin typeface="Courier New" pitchFamily="34" charset="0"/>
+                <a:ea typeface="Courier New" pitchFamily="34" charset="-122"/>
+                <a:cs typeface="Courier New" pitchFamily="34" charset="-120"/>
+              </a:rPr>
+              <a:t>01 0C</a:t>
+            </a:r>
+            <a:endParaRPr lang="en-US" sz="1600" dirty="0"/>
+          </a:p>
+        </p:txBody>
+      </p:sp>
+      <p:sp>
+        <p:nvSpPr>
+          <p:cNvPr id="17" name="Text 15"/>
+          <p:cNvSpPr/>
+          <p:nvPr/>
+        </p:nvSpPr>
+        <p:spPr>
+          <a:xfrm>
+            <a:off x="4206240" y="3977640"/>
+            <a:ext cx="6858000" cy="301752"/>
+          </a:xfrm>
+          <a:prstGeom prst="rect">
+            <a:avLst/>
+          </a:prstGeom>
+          <a:noFill/>
+          <a:ln/>
+        </p:spPr>
+        <p:txBody>
+          <a:bodyPr wrap="square" lIns="0" tIns="0" rIns="0" bIns="0" rtlCol="0" anchor="ctr"/>
+          <a:lstStyle/>
+          <a:p>
+            <a:pPr indent="0" marL="0">
+              <a:buNone/>
+            </a:pPr>
+            <a:r>
+              <a:rPr lang="en-US" sz="1400" dirty="0">
+                <a:solidFill>
+                  <a:srgbClr val="5A5F73"/>
+                </a:solidFill>
+                <a:latin typeface="Calibri" pitchFamily="34" charset="0"/>
+                <a:ea typeface="Calibri" pitchFamily="34" charset="-122"/>
+                <a:cs typeface="Calibri" pitchFamily="34" charset="-120"/>
+              </a:rPr>
+              <a:t>modo 01, PID 0C — revoluciones</a:t>
+            </a:r>
+            <a:endParaRPr lang="en-US" sz="1400" dirty="0"/>
+          </a:p>
+        </p:txBody>
+      </p:sp>
+      <p:sp>
+        <p:nvSpPr>
+          <p:cNvPr id="18" name="Text 16"/>
+          <p:cNvSpPr/>
+          <p:nvPr/>
+        </p:nvSpPr>
+        <p:spPr>
+          <a:xfrm>
+            <a:off x="777240" y="4434840"/>
+            <a:ext cx="1005840" cy="301752"/>
+          </a:xfrm>
+          <a:prstGeom prst="rect">
+            <a:avLst/>
+          </a:prstGeom>
+          <a:noFill/>
+          <a:ln/>
+        </p:spPr>
+        <p:txBody>
+          <a:bodyPr wrap="square" lIns="0" tIns="0" rIns="0" bIns="0" rtlCol="0" anchor="ctr"/>
+          <a:lstStyle/>
+          <a:p>
+            <a:pPr indent="0" marL="0">
+              <a:buNone/>
+            </a:pPr>
+            <a:r>
+              <a:rPr lang="en-US" sz="1400" b="1" dirty="0">
+                <a:solidFill>
+                  <a:srgbClr val="5A5F73"/>
+                </a:solidFill>
+                <a:latin typeface="Calibri" pitchFamily="34" charset="0"/>
+                <a:ea typeface="Calibri" pitchFamily="34" charset="-122"/>
+                <a:cs typeface="Calibri" pitchFamily="34" charset="-120"/>
+              </a:rPr>
+              <a:t>Vuelve</a:t>
+            </a:r>
+            <a:endParaRPr lang="en-US" sz="1400" dirty="0"/>
+          </a:p>
+        </p:txBody>
+      </p:sp>
+      <p:sp>
+        <p:nvSpPr>
+          <p:cNvPr id="19" name="Text 17"/>
+          <p:cNvSpPr/>
+          <p:nvPr/>
+        </p:nvSpPr>
+        <p:spPr>
+          <a:xfrm>
+            <a:off x="1828800" y="4434840"/>
+            <a:ext cx="2743200" cy="301752"/>
+          </a:xfrm>
+          <a:prstGeom prst="rect">
+            <a:avLst/>
+          </a:prstGeom>
+          <a:noFill/>
+          <a:ln/>
+        </p:spPr>
+        <p:txBody>
+          <a:bodyPr wrap="square" lIns="0" tIns="0" rIns="0" bIns="0" rtlCol="0" anchor="ctr"/>
+          <a:lstStyle/>
+          <a:p>
+            <a:pPr indent="0" marL="0">
+              <a:buNone/>
+            </a:pPr>
+            <a:r>
+              <a:rPr lang="en-US" sz="1600" b="1" dirty="0">
+                <a:solidFill>
+                  <a:srgbClr val="1A1C2E"/>
+                </a:solidFill>
+                <a:latin typeface="Courier New" pitchFamily="34" charset="0"/>
+                <a:ea typeface="Courier New" pitchFamily="34" charset="-122"/>
+                <a:cs typeface="Courier New" pitchFamily="34" charset="-120"/>
+              </a:rPr>
+              <a:t>41 0C 0B B8</a:t>
+            </a:r>
+            <a:endParaRPr lang="en-US" sz="1600" dirty="0"/>
+          </a:p>
+        </p:txBody>
+      </p:sp>
+      <p:sp>
+        <p:nvSpPr>
+          <p:cNvPr id="20" name="Text 18"/>
+          <p:cNvSpPr/>
+          <p:nvPr/>
+        </p:nvSpPr>
+        <p:spPr>
+          <a:xfrm>
+            <a:off x="4206240" y="4434840"/>
+            <a:ext cx="6858000" cy="301752"/>
+          </a:xfrm>
+          <a:prstGeom prst="rect">
+            <a:avLst/>
+          </a:prstGeom>
+          <a:noFill/>
+          <a:ln/>
+        </p:spPr>
+        <p:txBody>
+          <a:bodyPr wrap="square" lIns="0" tIns="0" rIns="0" bIns="0" rtlCol="0" anchor="ctr"/>
+          <a:lstStyle/>
+          <a:p>
+            <a:pPr indent="0" marL="0">
+              <a:buNone/>
+            </a:pPr>
+            <a:r>
+              <a:rPr lang="en-US" sz="1400" dirty="0">
+                <a:solidFill>
+                  <a:srgbClr val="5A5F73"/>
+                </a:solidFill>
+                <a:latin typeface="Calibri" pitchFamily="34" charset="0"/>
+                <a:ea typeface="Calibri" pitchFamily="34" charset="-122"/>
+                <a:cs typeface="Calibri" pitchFamily="34" charset="-120"/>
+              </a:rPr>
+              <a:t>los dos bytes de datos son A = 0B y B = B8</a:t>
+            </a:r>
+            <a:endParaRPr lang="en-US" sz="1400" dirty="0"/>
+          </a:p>
+        </p:txBody>
+      </p:sp>
+      <p:sp>
+        <p:nvSpPr>
+          <p:cNvPr id="21" name="Text 19"/>
+          <p:cNvSpPr/>
+          <p:nvPr/>
+        </p:nvSpPr>
+        <p:spPr>
+          <a:xfrm>
+            <a:off x="777240" y="5166360"/>
+            <a:ext cx="10607040" cy="411480"/>
+          </a:xfrm>
+          <a:prstGeom prst="rect">
+            <a:avLst/>
+          </a:prstGeom>
+          <a:noFill/>
+          <a:ln/>
+        </p:spPr>
+        <p:txBody>
+          <a:bodyPr wrap="square" lIns="0" tIns="0" rIns="0" bIns="0" rtlCol="0" anchor="ctr"/>
+          <a:lstStyle/>
+          <a:p>
+            <a:pPr indent="0" marL="0">
+              <a:buNone/>
+            </a:pPr>
+            <a:r>
+              <a:rPr lang="en-US" sz="1900" b="1" dirty="0">
+                <a:solidFill>
+                  <a:srgbClr val="1A1C2E"/>
+                </a:solidFill>
+                <a:latin typeface="Arial" pitchFamily="34" charset="0"/>
+                <a:ea typeface="Arial" pitchFamily="34" charset="-122"/>
+                <a:cs typeface="Arial" pitchFamily="34" charset="-120"/>
+              </a:rPr>
+              <a:t>(A × 256 + B) / 4   =   (11 × 256 + 184) / 4   =   </a:t>
+            </a:r>
+            <a:pPr indent="0" marL="0">
+              <a:buNone/>
+            </a:pPr>
+            <a:r>
+              <a:rPr lang="en-US" sz="1900" b="1" dirty="0">
+                <a:solidFill>
+                  <a:srgbClr val="202CFC"/>
+                </a:solidFill>
+                <a:latin typeface="Arial" pitchFamily="34" charset="0"/>
+                <a:ea typeface="Arial" pitchFamily="34" charset="-122"/>
+                <a:cs typeface="Arial" pitchFamily="34" charset="-120"/>
+              </a:rPr>
+              <a:t>750 rpm</a:t>
+            </a:r>
+            <a:endParaRPr lang="en-US" sz="1900" dirty="0"/>
+          </a:p>
+        </p:txBody>
+      </p:sp>
+      <p:sp>
+        <p:nvSpPr>
+          <p:cNvPr id="22" name="Text 20"/>
+          <p:cNvSpPr/>
+          <p:nvPr/>
+        </p:nvSpPr>
+        <p:spPr>
+          <a:xfrm>
+            <a:off x="777240" y="5669280"/>
+            <a:ext cx="10607040" cy="320040"/>
+          </a:xfrm>
+          <a:prstGeom prst="rect">
+            <a:avLst/>
+          </a:prstGeom>
+          <a:noFill/>
+          <a:ln/>
+        </p:spPr>
+        <p:txBody>
+          <a:bodyPr wrap="square" lIns="0" tIns="0" rIns="0" bIns="0" rtlCol="0" anchor="ctr"/>
+          <a:lstStyle/>
+          <a:p>
+            <a:pPr indent="0" marL="0">
+              <a:buNone/>
+            </a:pPr>
+            <a:r>
+              <a:rPr lang="en-US" sz="1400" dirty="0">
+                <a:solidFill>
+                  <a:srgbClr val="5A5F73"/>
+                </a:solidFill>
+                <a:latin typeface="Calibri" pitchFamily="34" charset="0"/>
+                <a:ea typeface="Calibri" pitchFamily="34" charset="-122"/>
+                <a:cs typeface="Calibri" pitchFamily="34" charset="-120"/>
+              </a:rPr>
+              <a:t>La fórmula la fija la SAE J1979 y vive en el dominio.</a:t>
+            </a:r>
+            <a:endParaRPr lang="en-US" sz="1400" dirty="0"/>
+          </a:p>
+        </p:txBody>
+      </p:sp>
+      <p:sp>
+        <p:nvSpPr>
+          <p:cNvPr id="23" name="Shape 21"/>
+          <p:cNvSpPr/>
+          <p:nvPr/>
+        </p:nvSpPr>
+        <p:spPr>
+          <a:xfrm>
+            <a:off x="777240" y="6263640"/>
+            <a:ext cx="219456" cy="219456"/>
+          </a:xfrm>
+          <a:prstGeom prst="rect">
+            <a:avLst/>
+          </a:prstGeom>
+          <a:solidFill>
+            <a:srgbClr val="202CFC"/>
+          </a:solidFill>
+          <a:ln/>
+        </p:spPr>
+      </p:sp>
+      <p:sp>
+        <p:nvSpPr>
+          <p:cNvPr id="24" name="Text 22"/>
+          <p:cNvSpPr/>
+          <p:nvPr/>
+        </p:nvSpPr>
+        <p:spPr>
+          <a:xfrm>
+            <a:off x="777240" y="6263640"/>
+            <a:ext cx="219456" cy="219456"/>
+          </a:xfrm>
+          <a:prstGeom prst="rect">
+            <a:avLst/>
+          </a:prstGeom>
+          <a:noFill/>
+          <a:ln/>
+        </p:spPr>
+        <p:txBody>
+          <a:bodyPr wrap="square" lIns="0" tIns="0" rIns="0" bIns="0" rtlCol="0" anchor="ctr"/>
+          <a:lstStyle/>
+          <a:p>
+            <a:pPr algn="ctr" indent="0" marL="0">
+              <a:buNone/>
+            </a:pPr>
+            <a:r>
+              <a:rPr lang="en-US" sz="816" b="1" dirty="0">
+                <a:solidFill>
+                  <a:srgbClr val="FFFFFF"/>
+                </a:solidFill>
+                <a:latin typeface="Arial" pitchFamily="34" charset="0"/>
+                <a:ea typeface="Arial" pitchFamily="34" charset="-122"/>
+                <a:cs typeface="Arial" pitchFamily="34" charset="-120"/>
+              </a:rPr>
+              <a:t>BIG</a:t>
+            </a:r>
+            <a:endParaRPr lang="en-US" sz="816" dirty="0"/>
+          </a:p>
+        </p:txBody>
+      </p:sp>
+      <p:sp>
+        <p:nvSpPr>
+          <p:cNvPr id="25" name="Text 23"/>
+          <p:cNvSpPr/>
+          <p:nvPr/>
+        </p:nvSpPr>
+        <p:spPr>
+          <a:xfrm>
+            <a:off x="1078992" y="6263640"/>
+            <a:ext cx="658368" cy="219456"/>
+          </a:xfrm>
+          <a:prstGeom prst="rect">
+            <a:avLst/>
+          </a:prstGeom>
+          <a:noFill/>
+          <a:ln/>
+        </p:spPr>
+        <p:txBody>
+          <a:bodyPr wrap="square" lIns="0" tIns="0" rIns="0" bIns="0" rtlCol="0" anchor="ctr"/>
+          <a:lstStyle/>
+          <a:p>
+            <a:pPr algn="l" indent="0" marL="0">
+              <a:buNone/>
+            </a:pPr>
+            <a:r>
+              <a:rPr lang="en-US" sz="816" dirty="0">
+                <a:solidFill>
+                  <a:srgbClr val="1A1C2E"/>
+                </a:solidFill>
+                <a:latin typeface="Arial" pitchFamily="34" charset="0"/>
+                <a:ea typeface="Arial" pitchFamily="34" charset="-122"/>
+                <a:cs typeface="Arial" pitchFamily="34" charset="-120"/>
+              </a:rPr>
+              <a:t>school</a:t>
+            </a:r>
+            <a:endParaRPr lang="en-US" sz="816" dirty="0"/>
+          </a:p>
+        </p:txBody>
+      </p:sp>
+      <p:sp>
+        <p:nvSpPr>
+          <p:cNvPr id="26" name="Text 24"/>
+          <p:cNvSpPr/>
+          <p:nvPr/>
+        </p:nvSpPr>
+        <p:spPr>
+          <a:xfrm>
+            <a:off x="11064240" y="6263640"/>
+            <a:ext cx="320040" cy="219456"/>
+          </a:xfrm>
+          <a:prstGeom prst="rect">
+            <a:avLst/>
+          </a:prstGeom>
+          <a:noFill/>
+          <a:ln/>
+        </p:spPr>
+        <p:txBody>
+          <a:bodyPr wrap="square" lIns="0" tIns="0" rIns="0" bIns="0" rtlCol="0" anchor="ctr"/>
+          <a:lstStyle/>
+          <a:p>
+            <a:pPr algn="r" indent="0" marL="0">
+              <a:buNone/>
+            </a:pPr>
+            <a:r>
+              <a:rPr lang="en-US" sz="1000" dirty="0">
+                <a:solidFill>
+                  <a:srgbClr val="5A5F73"/>
+                </a:solidFill>
+                <a:latin typeface="Calibri" pitchFamily="34" charset="0"/>
+                <a:ea typeface="Calibri" pitchFamily="34" charset="-122"/>
+                <a:cs typeface="Calibri" pitchFamily="34" charset="-120"/>
+              </a:rPr>
+              <a:t>5</a:t>
+            </a:r>
+            <a:endParaRPr lang="en-US" sz="1000" dirty="0"/>
+          </a:p>
+        </p:txBody>
+      </p:sp>
+    </p:spTree>
+  </p:cSld>
+  <p:clrMapOvr>
+    <a:masterClrMapping/>
+  </p:clrMapOvr>
+</p:sld>
+</file>
+
 <file path=ppt/theme/theme1.xml><?xml version="1.0" encoding="utf-8"?>
 <a:theme xmlns:a="http://schemas.openxmlformats.org/drawingml/2006/main" name="Office Theme">
   <a:themeElements>

</xml_diff>

<commit_message>
docs(tfm): slide de las dos bases de datos
</commit_message>
<xml_diff>
--- a/docs/presentacion/tfm-intelligent-automotive-diagnostics.pptx
+++ b/docs/presentacion/tfm-intelligent-automotive-diagnostics.pptx
@@ -10,9 +10,10 @@
     <p:sldId id="258" r:id="rId4"/>
     <p:sldId id="259" r:id="rId5"/>
     <p:sldId id="260" r:id="rId6"/>
+    <p:sldId id="261" r:id="rId7"/>
   </p:sldIdLst>
   <p:notesMasterIdLst>
-    <p:notesMasterId r:id="rId7"/>
+    <p:notesMasterId r:id="rId8"/>
   </p:notesMasterIdLst>
   <p:sldSz cx="12192000" cy="6858000"/>
   <p:notesSz cx="6858000" cy="12192000"/>
@@ -901,6 +902,98 @@
             <a:fld id="{F7021451-1387-4CA6-816F-3879F97B5CBC}" type="slidenum">
               <a:rPr lang="en-US"/>
               <a:t>5</a:t>
+            </a:fld>
+            <a:endParaRPr lang="en-US"/>
+          </a:p>
+        </p:txBody>
+      </p:sp>
+    </p:spTree>
+    <p:extLst>
+      <p:ext uri="{BB962C8B-B14F-4D97-AF65-F5344CB8AC3E}">
+        <p14:creationId xmlns:p14="http://schemas.microsoft.com/office/powerpoint/2010/main" val="1024086991"/>
+      </p:ext>
+    </p:extLst>
+  </p:cSld>
+  <p:clrMapOvr>
+    <a:masterClrMapping/>
+  </p:clrMapOvr>
+</p:notes>
+</file>
+
+<file path=ppt/notesSlides/notesSlide6.xml><?xml version="1.0" encoding="utf-8"?>
+<p:notes xmlns:a="http://schemas.openxmlformats.org/drawingml/2006/main" xmlns:r="http://schemas.openxmlformats.org/officeDocument/2006/relationships" xmlns:p="http://schemas.openxmlformats.org/presentationml/2006/main">
+  <p:cSld>
+    <p:spTree>
+      <p:nvGrpSpPr>
+        <p:cNvPr id="1" name=""/>
+        <p:cNvGrpSpPr/>
+        <p:nvPr/>
+      </p:nvGrpSpPr>
+      <p:grpSpPr>
+        <a:xfrm>
+          <a:off x="0" y="0"/>
+          <a:ext cx="0" cy="0"/>
+          <a:chOff x="0" y="0"/>
+          <a:chExt cx="0" cy="0"/>
+        </a:xfrm>
+      </p:grpSpPr>
+      <p:sp>
+        <p:nvSpPr>
+          <p:cNvPr id="2" name="Slide Image Placeholder 1"/>
+          <p:cNvSpPr>
+            <a:spLocks noGrp="1" noRot="1" noChangeAspect="1"/>
+          </p:cNvSpPr>
+          <p:nvPr>
+            <p:ph type="sldImg"/>
+          </p:nvPr>
+        </p:nvSpPr>
+        <p:spPr/>
+      </p:sp>
+      <p:sp>
+        <p:nvSpPr>
+          <p:cNvPr id="3" name="Notes Placeholder 2"/>
+          <p:cNvSpPr>
+            <a:spLocks noGrp="1"/>
+          </p:cNvSpPr>
+          <p:nvPr>
+            <p:ph type="body" idx="1"/>
+          </p:nvPr>
+        </p:nvSpPr>
+        <p:spPr/>
+        <p:txBody>
+          <a:bodyPr/>
+          <a:lstStyle/>
+          <a:p>
+            <a:r>
+              <a:rPr lang="en-US" dirty="0"/>
+              <a:t>Hay dos bases de datos, y no es por capricho: son dos preguntas distintas.
+A SQLite le pregunto cosas exactas. Qué usuario es este, qué vehículo tiene este VIN, qué ECUs se le descubrieron, qué sesiones de diagnóstico tiene y cuál fue el informe de cada una. Son trece tablas con sus claves y sus relaciones, y siempre sé por qué clave preguntar.
+A LanceDB le pregunto por parecido. Ahí están los PIDs, los DTCs y los diagnósticos ya resueltos, convertidos en vectores de 384 dimensiones. Cuando llega un coche nuevo no tengo una clave por la que buscar: lo que quiero es "enséñame casos que se parezcan a este", y eso una consulta SQL no lo resuelve.
+Las dos son embebidas, sin servidor. En el ADR-002 está escrito por qué se descartó PostgreSQL: a esta escala habría añadido un servicio, una red y un backup que gestionar sin resolver ningún problema que yo tuviera. Y como los repositorios están detrás de puertos, migrar el día de mañana es cambiar el driver, no la aplicación.
+[~60 s]</a:t>
+            </a:r>
+            <a:endParaRPr lang="en-US" dirty="0"/>
+          </a:p>
+        </p:txBody>
+      </p:sp>
+      <p:sp>
+        <p:nvSpPr>
+          <p:cNvPr id="4" name="Slide Number Placeholder 3"/>
+          <p:cNvSpPr>
+            <a:spLocks noGrp="1"/>
+          </p:cNvSpPr>
+          <p:nvPr>
+            <p:ph type="sldNum" sz="quarter" idx="10"/>
+          </p:nvPr>
+        </p:nvSpPr>
+        <p:spPr/>
+        <p:txBody>
+          <a:bodyPr/>
+          <a:lstStyle/>
+          <a:p>
+            <a:fld id="{F7021451-1387-4CA6-816F-3879F97B5CBC}" type="slidenum">
+              <a:rPr lang="en-US"/>
+              <a:t>6</a:t>
             </a:fld>
             <a:endParaRPr lang="en-US"/>
           </a:p>
@@ -4256,6 +4349,687 @@
 </p:sld>
 </file>
 
+<file path=ppt/slides/slide6.xml><?xml version="1.0" encoding="utf-8"?>
+<p:sld xmlns:a="http://schemas.openxmlformats.org/drawingml/2006/main" xmlns:r="http://schemas.openxmlformats.org/officeDocument/2006/relationships" xmlns:p="http://schemas.openxmlformats.org/presentationml/2006/main">
+  <p:cSld name="Slide 6">
+    <p:bg>
+      <p:bgPr>
+        <a:solidFill>
+          <a:srgbClr val="FFFFFF"/>
+        </a:solidFill>
+      </p:bgPr>
+    </p:bg>
+    <p:spTree>
+      <p:nvGrpSpPr>
+        <p:cNvPr id="1" name=""/>
+        <p:cNvGrpSpPr/>
+        <p:nvPr/>
+      </p:nvGrpSpPr>
+      <p:grpSpPr>
+        <a:xfrm>
+          <a:off x="0" y="0"/>
+          <a:ext cx="0" cy="0"/>
+          <a:chOff x="0" y="0"/>
+          <a:chExt cx="0" cy="0"/>
+        </a:xfrm>
+      </p:grpSpPr>
+      <p:sp>
+        <p:nvSpPr>
+          <p:cNvPr id="2" name="Text 0"/>
+          <p:cNvSpPr/>
+          <p:nvPr/>
+        </p:nvSpPr>
+        <p:spPr>
+          <a:xfrm>
+            <a:off x="777240" y="640080"/>
+            <a:ext cx="10607040" cy="777240"/>
+          </a:xfrm>
+          <a:prstGeom prst="rect">
+            <a:avLst/>
+          </a:prstGeom>
+          <a:noFill/>
+          <a:ln/>
+        </p:spPr>
+        <p:txBody>
+          <a:bodyPr wrap="square" lIns="0" tIns="0" rIns="0" bIns="0" rtlCol="0" anchor="t"/>
+          <a:lstStyle/>
+          <a:p>
+            <a:pPr indent="0" marL="0">
+              <a:buNone/>
+            </a:pPr>
+            <a:r>
+              <a:rPr lang="en-US" sz="3400" b="1" dirty="0">
+                <a:solidFill>
+                  <a:srgbClr val="1A1C2E"/>
+                </a:solidFill>
+                <a:latin typeface="Arial" pitchFamily="34" charset="0"/>
+                <a:ea typeface="Arial" pitchFamily="34" charset="-122"/>
+                <a:cs typeface="Arial" pitchFamily="34" charset="-120"/>
+              </a:rPr>
+              <a:t>Dos bases de datos</a:t>
+            </a:r>
+            <a:endParaRPr lang="en-US" sz="3400" dirty="0"/>
+          </a:p>
+        </p:txBody>
+      </p:sp>
+      <p:sp>
+        <p:nvSpPr>
+          <p:cNvPr id="3" name="Text 1"/>
+          <p:cNvSpPr/>
+          <p:nvPr/>
+        </p:nvSpPr>
+        <p:spPr>
+          <a:xfrm>
+            <a:off x="777240" y="1508760"/>
+            <a:ext cx="10607040" cy="365760"/>
+          </a:xfrm>
+          <a:prstGeom prst="rect">
+            <a:avLst/>
+          </a:prstGeom>
+          <a:noFill/>
+          <a:ln/>
+        </p:spPr>
+        <p:txBody>
+          <a:bodyPr wrap="square" lIns="0" tIns="0" rIns="0" bIns="0" rtlCol="0" anchor="t"/>
+          <a:lstStyle/>
+          <a:p>
+            <a:pPr indent="0" marL="0">
+              <a:buNone/>
+            </a:pPr>
+            <a:r>
+              <a:rPr lang="en-US" sz="1700" dirty="0">
+                <a:solidFill>
+                  <a:srgbClr val="5A5F73"/>
+                </a:solidFill>
+                <a:latin typeface="Calibri" pitchFamily="34" charset="0"/>
+                <a:ea typeface="Calibri" pitchFamily="34" charset="-122"/>
+                <a:cs typeface="Calibri" pitchFamily="34" charset="-120"/>
+              </a:rPr>
+              <a:t>Porque hay dos preguntas distintas que hacerle a los datos.</a:t>
+            </a:r>
+            <a:endParaRPr lang="en-US" sz="1700" dirty="0"/>
+          </a:p>
+        </p:txBody>
+      </p:sp>
+      <p:sp>
+        <p:nvSpPr>
+          <p:cNvPr id="4" name="Text 2"/>
+          <p:cNvSpPr/>
+          <p:nvPr/>
+        </p:nvSpPr>
+        <p:spPr>
+          <a:xfrm>
+            <a:off x="777240" y="2240280"/>
+            <a:ext cx="4846320" cy="365760"/>
+          </a:xfrm>
+          <a:prstGeom prst="rect">
+            <a:avLst/>
+          </a:prstGeom>
+          <a:noFill/>
+          <a:ln/>
+        </p:spPr>
+        <p:txBody>
+          <a:bodyPr wrap="square" lIns="0" tIns="0" rIns="0" bIns="0" rtlCol="0" anchor="t"/>
+          <a:lstStyle/>
+          <a:p>
+            <a:pPr indent="0" marL="0">
+              <a:buNone/>
+            </a:pPr>
+            <a:r>
+              <a:rPr lang="en-US" sz="2000" b="1" dirty="0">
+                <a:solidFill>
+                  <a:srgbClr val="202CFC"/>
+                </a:solidFill>
+                <a:latin typeface="Arial" pitchFamily="34" charset="0"/>
+                <a:ea typeface="Arial" pitchFamily="34" charset="-122"/>
+                <a:cs typeface="Arial" pitchFamily="34" charset="-120"/>
+              </a:rPr>
+              <a:t>SQLite</a:t>
+            </a:r>
+            <a:endParaRPr lang="en-US" sz="2000" dirty="0"/>
+          </a:p>
+        </p:txBody>
+      </p:sp>
+      <p:sp>
+        <p:nvSpPr>
+          <p:cNvPr id="5" name="Text 3"/>
+          <p:cNvSpPr/>
+          <p:nvPr/>
+        </p:nvSpPr>
+        <p:spPr>
+          <a:xfrm>
+            <a:off x="777240" y="2670048"/>
+            <a:ext cx="4846320" cy="320040"/>
+          </a:xfrm>
+          <a:prstGeom prst="rect">
+            <a:avLst/>
+          </a:prstGeom>
+          <a:noFill/>
+          <a:ln/>
+        </p:spPr>
+        <p:txBody>
+          <a:bodyPr wrap="square" lIns="0" tIns="0" rIns="0" bIns="0" rtlCol="0" anchor="t"/>
+          <a:lstStyle/>
+          <a:p>
+            <a:pPr indent="0" marL="0">
+              <a:buNone/>
+            </a:pPr>
+            <a:r>
+              <a:rPr lang="en-US" sz="1500" i="1" dirty="0">
+                <a:solidFill>
+                  <a:srgbClr val="5A5F73"/>
+                </a:solidFill>
+                <a:latin typeface="Calibri" pitchFamily="34" charset="0"/>
+                <a:ea typeface="Calibri" pitchFamily="34" charset="-122"/>
+                <a:cs typeface="Calibri" pitchFamily="34" charset="-120"/>
+              </a:rPr>
+              <a:t>«¿Qué es esto exactamente?»</a:t>
+            </a:r>
+            <a:endParaRPr lang="en-US" sz="1500" dirty="0"/>
+          </a:p>
+        </p:txBody>
+      </p:sp>
+      <p:sp>
+        <p:nvSpPr>
+          <p:cNvPr id="6" name="Text 4"/>
+          <p:cNvSpPr/>
+          <p:nvPr/>
+        </p:nvSpPr>
+        <p:spPr>
+          <a:xfrm>
+            <a:off x="777240" y="3200400"/>
+            <a:ext cx="4846320" cy="2194560"/>
+          </a:xfrm>
+          <a:prstGeom prst="rect">
+            <a:avLst/>
+          </a:prstGeom>
+          <a:noFill/>
+          <a:ln/>
+        </p:spPr>
+        <p:txBody>
+          <a:bodyPr wrap="square" lIns="0" tIns="0" rIns="0" bIns="0" rtlCol="0" anchor="t"/>
+          <a:lstStyle/>
+          <a:p>
+            <a:pPr marL="342900" indent="-342900">
+              <a:lnSpc>
+                <a:spcPts val="2100"/>
+              </a:lnSpc>
+              <a:spcAft>
+                <a:spcPts val="1100"/>
+              </a:spcAft>
+              <a:buSzPct val="100000"/>
+              <a:buChar char="•"/>
+            </a:pPr>
+            <a:r>
+              <a:rPr lang="en-US" sz="1500" dirty="0">
+                <a:solidFill>
+                  <a:srgbClr val="1A1C2E"/>
+                </a:solidFill>
+                <a:latin typeface="Calibri" pitchFamily="34" charset="0"/>
+                <a:ea typeface="Calibri" pitchFamily="34" charset="-122"/>
+                <a:cs typeface="Calibri" pitchFamily="34" charset="-120"/>
+              </a:rPr>
+              <a:t>Usuarios, vehículos, ECUs y sesiones</a:t>
+            </a:r>
+            <a:endParaRPr lang="en-US" sz="1500" dirty="0"/>
+          </a:p>
+          <a:p>
+            <a:pPr marL="342900" indent="-342900">
+              <a:lnSpc>
+                <a:spcPts val="2100"/>
+              </a:lnSpc>
+              <a:spcAft>
+                <a:spcPts val="1100"/>
+              </a:spcAft>
+              <a:buSzPct val="100000"/>
+              <a:buChar char="•"/>
+            </a:pPr>
+            <a:r>
+              <a:rPr lang="en-US" sz="1500" dirty="0">
+                <a:solidFill>
+                  <a:srgbClr val="1A1C2E"/>
+                </a:solidFill>
+                <a:latin typeface="Calibri" pitchFamily="34" charset="0"/>
+                <a:ea typeface="Calibri" pitchFamily="34" charset="-122"/>
+                <a:cs typeface="Calibri" pitchFamily="34" charset="-120"/>
+              </a:rPr>
+              <a:t>13 tablas con sus claves y relaciones</a:t>
+            </a:r>
+            <a:endParaRPr lang="en-US" sz="1500" dirty="0"/>
+          </a:p>
+          <a:p>
+            <a:pPr marL="342900" indent="-342900">
+              <a:lnSpc>
+                <a:spcPts val="2100"/>
+              </a:lnSpc>
+              <a:spcAft>
+                <a:spcPts val="1100"/>
+              </a:spcAft>
+              <a:buSzPct val="100000"/>
+              <a:buChar char="•"/>
+            </a:pPr>
+            <a:r>
+              <a:rPr lang="en-US" sz="1500" dirty="0">
+                <a:solidFill>
+                  <a:srgbClr val="1A1C2E"/>
+                </a:solidFill>
+                <a:latin typeface="Calibri" pitchFamily="34" charset="0"/>
+                <a:ea typeface="Calibri" pitchFamily="34" charset="-122"/>
+                <a:cs typeface="Calibri" pitchFamily="34" charset="-120"/>
+              </a:rPr>
+              <a:t>El informe de cada sesión, congelado</a:t>
+            </a:r>
+            <a:endParaRPr lang="en-US" sz="1500" dirty="0"/>
+          </a:p>
+          <a:p>
+            <a:pPr marL="342900" indent="-342900">
+              <a:lnSpc>
+                <a:spcPts val="2100"/>
+              </a:lnSpc>
+              <a:spcAft>
+                <a:spcPts val="1100"/>
+              </a:spcAft>
+              <a:buSzPct val="100000"/>
+              <a:buChar char="•"/>
+            </a:pPr>
+            <a:r>
+              <a:rPr lang="en-US" sz="1500" dirty="0">
+                <a:solidFill>
+                  <a:srgbClr val="1A1C2E"/>
+                </a:solidFill>
+                <a:latin typeface="Calibri" pitchFamily="34" charset="0"/>
+                <a:ea typeface="Calibri" pitchFamily="34" charset="-122"/>
+                <a:cs typeface="Calibri" pitchFamily="34" charset="-120"/>
+              </a:rPr>
+              <a:t>Se responde con una clave: este VIN, este usuario</a:t>
+            </a:r>
+            <a:endParaRPr lang="en-US" sz="1500" dirty="0"/>
+          </a:p>
+        </p:txBody>
+      </p:sp>
+      <p:sp>
+        <p:nvSpPr>
+          <p:cNvPr id="7" name="Text 5"/>
+          <p:cNvSpPr/>
+          <p:nvPr/>
+        </p:nvSpPr>
+        <p:spPr>
+          <a:xfrm>
+            <a:off x="6537960" y="2240280"/>
+            <a:ext cx="4846320" cy="365760"/>
+          </a:xfrm>
+          <a:prstGeom prst="rect">
+            <a:avLst/>
+          </a:prstGeom>
+          <a:noFill/>
+          <a:ln/>
+        </p:spPr>
+        <p:txBody>
+          <a:bodyPr wrap="square" lIns="0" tIns="0" rIns="0" bIns="0" rtlCol="0" anchor="t"/>
+          <a:lstStyle/>
+          <a:p>
+            <a:pPr indent="0" marL="0">
+              <a:buNone/>
+            </a:pPr>
+            <a:r>
+              <a:rPr lang="en-US" sz="2000" b="1" dirty="0">
+                <a:solidFill>
+                  <a:srgbClr val="202CFC"/>
+                </a:solidFill>
+                <a:latin typeface="Arial" pitchFamily="34" charset="0"/>
+                <a:ea typeface="Arial" pitchFamily="34" charset="-122"/>
+                <a:cs typeface="Arial" pitchFamily="34" charset="-120"/>
+              </a:rPr>
+              <a:t>LanceDB</a:t>
+            </a:r>
+            <a:endParaRPr lang="en-US" sz="2000" dirty="0"/>
+          </a:p>
+        </p:txBody>
+      </p:sp>
+      <p:sp>
+        <p:nvSpPr>
+          <p:cNvPr id="8" name="Text 6"/>
+          <p:cNvSpPr/>
+          <p:nvPr/>
+        </p:nvSpPr>
+        <p:spPr>
+          <a:xfrm>
+            <a:off x="6537960" y="2670048"/>
+            <a:ext cx="4846320" cy="320040"/>
+          </a:xfrm>
+          <a:prstGeom prst="rect">
+            <a:avLst/>
+          </a:prstGeom>
+          <a:noFill/>
+          <a:ln/>
+        </p:spPr>
+        <p:txBody>
+          <a:bodyPr wrap="square" lIns="0" tIns="0" rIns="0" bIns="0" rtlCol="0" anchor="t"/>
+          <a:lstStyle/>
+          <a:p>
+            <a:pPr indent="0" marL="0">
+              <a:buNone/>
+            </a:pPr>
+            <a:r>
+              <a:rPr lang="en-US" sz="1500" i="1" dirty="0">
+                <a:solidFill>
+                  <a:srgbClr val="5A5F73"/>
+                </a:solidFill>
+                <a:latin typeface="Calibri" pitchFamily="34" charset="0"/>
+                <a:ea typeface="Calibri" pitchFamily="34" charset="-122"/>
+                <a:cs typeface="Calibri" pitchFamily="34" charset="-120"/>
+              </a:rPr>
+              <a:t>«¿Qué se parece a esto?»</a:t>
+            </a:r>
+            <a:endParaRPr lang="en-US" sz="1500" dirty="0"/>
+          </a:p>
+        </p:txBody>
+      </p:sp>
+      <p:sp>
+        <p:nvSpPr>
+          <p:cNvPr id="9" name="Text 7"/>
+          <p:cNvSpPr/>
+          <p:nvPr/>
+        </p:nvSpPr>
+        <p:spPr>
+          <a:xfrm>
+            <a:off x="6537960" y="3200400"/>
+            <a:ext cx="4846320" cy="2194560"/>
+          </a:xfrm>
+          <a:prstGeom prst="rect">
+            <a:avLst/>
+          </a:prstGeom>
+          <a:noFill/>
+          <a:ln/>
+        </p:spPr>
+        <p:txBody>
+          <a:bodyPr wrap="square" lIns="0" tIns="0" rIns="0" bIns="0" rtlCol="0" anchor="t"/>
+          <a:lstStyle/>
+          <a:p>
+            <a:pPr marL="342900" indent="-342900">
+              <a:lnSpc>
+                <a:spcPts val="2100"/>
+              </a:lnSpc>
+              <a:spcAft>
+                <a:spcPts val="1100"/>
+              </a:spcAft>
+              <a:buSzPct val="100000"/>
+              <a:buChar char="•"/>
+            </a:pPr>
+            <a:r>
+              <a:rPr lang="en-US" sz="1500" dirty="0">
+                <a:solidFill>
+                  <a:srgbClr val="1A1C2E"/>
+                </a:solidFill>
+                <a:latin typeface="Calibri" pitchFamily="34" charset="0"/>
+                <a:ea typeface="Calibri" pitchFamily="34" charset="-122"/>
+                <a:cs typeface="Calibri" pitchFamily="34" charset="-120"/>
+              </a:rPr>
+              <a:t>PIDs, DTCs y diagnósticos ya resueltos</a:t>
+            </a:r>
+            <a:endParaRPr lang="en-US" sz="1500" dirty="0"/>
+          </a:p>
+          <a:p>
+            <a:pPr marL="342900" indent="-342900">
+              <a:lnSpc>
+                <a:spcPts val="2100"/>
+              </a:lnSpc>
+              <a:spcAft>
+                <a:spcPts val="1100"/>
+              </a:spcAft>
+              <a:buSzPct val="100000"/>
+              <a:buChar char="•"/>
+            </a:pPr>
+            <a:r>
+              <a:rPr lang="en-US" sz="1500" dirty="0">
+                <a:solidFill>
+                  <a:srgbClr val="1A1C2E"/>
+                </a:solidFill>
+                <a:latin typeface="Calibri" pitchFamily="34" charset="0"/>
+                <a:ea typeface="Calibri" pitchFamily="34" charset="-122"/>
+                <a:cs typeface="Calibri" pitchFamily="34" charset="-120"/>
+              </a:rPr>
+              <a:t>El texto se convierte en vectores de 384 dimensiones</a:t>
+            </a:r>
+            <a:endParaRPr lang="en-US" sz="1500" dirty="0"/>
+          </a:p>
+          <a:p>
+            <a:pPr marL="342900" indent="-342900">
+              <a:lnSpc>
+                <a:spcPts val="2100"/>
+              </a:lnSpc>
+              <a:spcAft>
+                <a:spcPts val="1100"/>
+              </a:spcAft>
+              <a:buSzPct val="100000"/>
+              <a:buChar char="•"/>
+            </a:pPr>
+            <a:r>
+              <a:rPr lang="en-US" sz="1500" dirty="0">
+                <a:solidFill>
+                  <a:srgbClr val="1A1C2E"/>
+                </a:solidFill>
+                <a:latin typeface="Calibri" pitchFamily="34" charset="0"/>
+                <a:ea typeface="Calibri" pitchFamily="34" charset="-122"/>
+                <a:cs typeface="Calibri" pitchFamily="34" charset="-120"/>
+              </a:rPr>
+              <a:t>Busca por significado, no por palabra exacta</a:t>
+            </a:r>
+            <a:endParaRPr lang="en-US" sz="1500" dirty="0"/>
+          </a:p>
+          <a:p>
+            <a:pPr marL="342900" indent="-342900">
+              <a:lnSpc>
+                <a:spcPts val="2100"/>
+              </a:lnSpc>
+              <a:spcAft>
+                <a:spcPts val="1100"/>
+              </a:spcAft>
+              <a:buSzPct val="100000"/>
+              <a:buChar char="•"/>
+            </a:pPr>
+            <a:r>
+              <a:rPr lang="en-US" sz="1500" dirty="0">
+                <a:solidFill>
+                  <a:srgbClr val="1A1C2E"/>
+                </a:solidFill>
+                <a:latin typeface="Calibri" pitchFamily="34" charset="0"/>
+                <a:ea typeface="Calibri" pitchFamily="34" charset="-122"/>
+                <a:cs typeface="Calibri" pitchFamily="34" charset="-120"/>
+              </a:rPr>
+              <a:t>No hay clave que valga: no sabes qué buscas hasta verlo</a:t>
+            </a:r>
+            <a:endParaRPr lang="en-US" sz="1500" dirty="0"/>
+          </a:p>
+        </p:txBody>
+      </p:sp>
+      <p:sp>
+        <p:nvSpPr>
+          <p:cNvPr id="10" name="Text 8"/>
+          <p:cNvSpPr/>
+          <p:nvPr/>
+        </p:nvSpPr>
+        <p:spPr>
+          <a:xfrm>
+            <a:off x="777240" y="5623560"/>
+            <a:ext cx="10607040" cy="411480"/>
+          </a:xfrm>
+          <a:prstGeom prst="rect">
+            <a:avLst/>
+          </a:prstGeom>
+          <a:noFill/>
+          <a:ln/>
+        </p:spPr>
+        <p:txBody>
+          <a:bodyPr wrap="square" lIns="0" tIns="0" rIns="0" bIns="0" rtlCol="0" anchor="t"/>
+          <a:lstStyle/>
+          <a:p>
+            <a:pPr indent="0" marL="0">
+              <a:lnSpc>
+                <a:spcPts val="1900"/>
+              </a:lnSpc>
+              <a:buNone/>
+            </a:pPr>
+            <a:r>
+              <a:rPr lang="en-US" sz="1400" dirty="0">
+                <a:solidFill>
+                  <a:srgbClr val="5A5F73"/>
+                </a:solidFill>
+                <a:latin typeface="Calibri" pitchFamily="34" charset="0"/>
+                <a:ea typeface="Calibri" pitchFamily="34" charset="-122"/>
+                <a:cs typeface="Calibri" pitchFamily="34" charset="-120"/>
+              </a:rPr>
+              <a:t>Las dos van embebidas, sin servidor que mantener. PostgreSQL se descartó por eso: un servicio más sin resolver ningún problema a esta escala.</a:t>
+            </a:r>
+            <a:endParaRPr lang="en-US" sz="1400" dirty="0"/>
+          </a:p>
+        </p:txBody>
+      </p:sp>
+      <p:sp>
+        <p:nvSpPr>
+          <p:cNvPr id="11" name="Shape 9"/>
+          <p:cNvSpPr/>
+          <p:nvPr/>
+        </p:nvSpPr>
+        <p:spPr>
+          <a:xfrm>
+            <a:off x="777240" y="6263640"/>
+            <a:ext cx="219456" cy="219456"/>
+          </a:xfrm>
+          <a:prstGeom prst="rect">
+            <a:avLst/>
+          </a:prstGeom>
+          <a:solidFill>
+            <a:srgbClr val="202CFC"/>
+          </a:solidFill>
+          <a:ln/>
+        </p:spPr>
+      </p:sp>
+      <p:sp>
+        <p:nvSpPr>
+          <p:cNvPr id="12" name="Text 10"/>
+          <p:cNvSpPr/>
+          <p:nvPr/>
+        </p:nvSpPr>
+        <p:spPr>
+          <a:xfrm>
+            <a:off x="777240" y="6263640"/>
+            <a:ext cx="219456" cy="219456"/>
+          </a:xfrm>
+          <a:prstGeom prst="rect">
+            <a:avLst/>
+          </a:prstGeom>
+          <a:noFill/>
+          <a:ln/>
+        </p:spPr>
+        <p:txBody>
+          <a:bodyPr wrap="square" lIns="0" tIns="0" rIns="0" bIns="0" rtlCol="0" anchor="ctr"/>
+          <a:lstStyle/>
+          <a:p>
+            <a:pPr algn="ctr" indent="0" marL="0">
+              <a:buNone/>
+            </a:pPr>
+            <a:r>
+              <a:rPr lang="en-US" sz="816" b="1" dirty="0">
+                <a:solidFill>
+                  <a:srgbClr val="FFFFFF"/>
+                </a:solidFill>
+                <a:latin typeface="Arial" pitchFamily="34" charset="0"/>
+                <a:ea typeface="Arial" pitchFamily="34" charset="-122"/>
+                <a:cs typeface="Arial" pitchFamily="34" charset="-120"/>
+              </a:rPr>
+              <a:t>BIG</a:t>
+            </a:r>
+            <a:endParaRPr lang="en-US" sz="816" dirty="0"/>
+          </a:p>
+        </p:txBody>
+      </p:sp>
+      <p:sp>
+        <p:nvSpPr>
+          <p:cNvPr id="13" name="Text 11"/>
+          <p:cNvSpPr/>
+          <p:nvPr/>
+        </p:nvSpPr>
+        <p:spPr>
+          <a:xfrm>
+            <a:off x="1078992" y="6263640"/>
+            <a:ext cx="658368" cy="219456"/>
+          </a:xfrm>
+          <a:prstGeom prst="rect">
+            <a:avLst/>
+          </a:prstGeom>
+          <a:noFill/>
+          <a:ln/>
+        </p:spPr>
+        <p:txBody>
+          <a:bodyPr wrap="square" lIns="0" tIns="0" rIns="0" bIns="0" rtlCol="0" anchor="ctr"/>
+          <a:lstStyle/>
+          <a:p>
+            <a:pPr algn="l" indent="0" marL="0">
+              <a:buNone/>
+            </a:pPr>
+            <a:r>
+              <a:rPr lang="en-US" sz="816" dirty="0">
+                <a:solidFill>
+                  <a:srgbClr val="1A1C2E"/>
+                </a:solidFill>
+                <a:latin typeface="Arial" pitchFamily="34" charset="0"/>
+                <a:ea typeface="Arial" pitchFamily="34" charset="-122"/>
+                <a:cs typeface="Arial" pitchFamily="34" charset="-120"/>
+              </a:rPr>
+              <a:t>school</a:t>
+            </a:r>
+            <a:endParaRPr lang="en-US" sz="816" dirty="0"/>
+          </a:p>
+        </p:txBody>
+      </p:sp>
+      <p:sp>
+        <p:nvSpPr>
+          <p:cNvPr id="14" name="Text 12"/>
+          <p:cNvSpPr/>
+          <p:nvPr/>
+        </p:nvSpPr>
+        <p:spPr>
+          <a:xfrm>
+            <a:off x="11064240" y="6263640"/>
+            <a:ext cx="320040" cy="219456"/>
+          </a:xfrm>
+          <a:prstGeom prst="rect">
+            <a:avLst/>
+          </a:prstGeom>
+          <a:noFill/>
+          <a:ln/>
+        </p:spPr>
+        <p:txBody>
+          <a:bodyPr wrap="square" lIns="0" tIns="0" rIns="0" bIns="0" rtlCol="0" anchor="ctr"/>
+          <a:lstStyle/>
+          <a:p>
+            <a:pPr algn="r" indent="0" marL="0">
+              <a:buNone/>
+            </a:pPr>
+            <a:r>
+              <a:rPr lang="en-US" sz="1000" dirty="0">
+                <a:solidFill>
+                  <a:srgbClr val="5A5F73"/>
+                </a:solidFill>
+                <a:latin typeface="Calibri" pitchFamily="34" charset="0"/>
+                <a:ea typeface="Calibri" pitchFamily="34" charset="-122"/>
+                <a:cs typeface="Calibri" pitchFamily="34" charset="-120"/>
+              </a:rPr>
+              <a:t>6</a:t>
+            </a:r>
+            <a:endParaRPr lang="en-US" sz="1000" dirty="0"/>
+          </a:p>
+        </p:txBody>
+      </p:sp>
+    </p:spTree>
+  </p:cSld>
+  <p:clrMapOvr>
+    <a:masterClrMapping/>
+  </p:clrMapOvr>
+</p:sld>
+</file>
+
 <file path=ppt/theme/theme1.xml><?xml version="1.0" encoding="utf-8"?>
 <a:theme xmlns:a="http://schemas.openxmlformats.org/drawingml/2006/main" name="Office Theme">
   <a:themeElements>

</xml_diff>

<commit_message>
docs(tfm): justificar cada base de datos y las descartadas
</commit_message>
<xml_diff>
--- a/docs/presentacion/tfm-intelligent-automotive-diagnostics.pptx
+++ b/docs/presentacion/tfm-intelligent-automotive-diagnostics.pptx
@@ -966,10 +966,11 @@
           <a:p>
             <a:r>
               <a:rPr lang="en-US" dirty="0"/>
-              <a:t>Hay dos bases de datos, y no es por capricho: son dos preguntas distintas.
-A SQLite le pregunto cosas exactas. Qué usuario es este, qué vehículo tiene este VIN, qué ECUs se le descubrieron, qué sesiones de diagnóstico tiene y cuál fue el informe de cada una. Son trece tablas con sus claves y sus relaciones, y siempre sé por qué clave preguntar.
-A LanceDB le pregunto por parecido. Ahí están los PIDs, los DTCs y los diagnósticos ya resueltos, convertidos en vectores de 384 dimensiones. Cuando llega un coche nuevo no tengo una clave por la que buscar: lo que quiero es "enséñame casos que se parezcan a este", y eso una consulta SQL no lo resuelve.
-Las dos son embebidas, sin servidor. En el ADR-002 está escrito por qué se descartó PostgreSQL: a esta escala habría añadido un servicio, una red y un backup que gestionar sin resolver ningún problema que yo tuviera. Y como los repositorios están detrás de puertos, migrar el día de mañana es cambiar el driver, no la aplicación.
+              <a:t>Hay dos bases de datos porque hay dos cosas que hacer con los datos, y una sola no las cubre.
+En SQLite van los datos del taller: usuarios, vehículos, las ECUs que se le han descubierto a cada uno, las sesiones de diagnóstico y el informe de cada una. Eso es relacional de manual, un vehículo tiene ECUs, que tienen sesiones, que tienen lecturas. Por eso se descartó MongoDB, porque no son documentos sueltos. Y se descartó PostgreSQL porque a esta escala solo añadía un servicio, una red y un backup que gestionar, sin resolver ningún problema que yo tuviera.
+En LanceDB va lo que el sistema aprende: PIDs, DTCs y diagnósticos ya resueltos. Y ahí la pregunta no es "dame el registro con esta clave", sino "enséñame casos que se parezcan a este". Eso con SQL no se hace.
+Y ojo, tampoco basta con el buscador de texto de SQLite, que también existe: busca palabras, no significado. Si el mecánico escribe "presión de aceite", el buscador de texto no encuentra una ficha que ponga "oil pressure", y la búsqueda vectorial sí, porque compara el sentido.
+Las dos son embebidas, un fichero y un directorio en disco. Y los embeddings se calculan con un modelo que corre en la propia máquina, así que no hay API key ni coste por consulta.
 [~60 s]</a:t>
             </a:r>
             <a:endParaRPr lang="en-US" dirty="0"/>
@@ -4406,7 +4407,7 @@
                 <a:ea typeface="Arial" pitchFamily="34" charset="-122"/>
                 <a:cs typeface="Arial" pitchFamily="34" charset="-120"/>
               </a:rPr>
-              <a:t>Dos bases de datos</a:t>
+              <a:t>Por qué dos bases de datos</a:t>
             </a:r>
             <a:endParaRPr lang="en-US" sz="3400" dirty="0"/>
           </a:p>
@@ -4445,7 +4446,7 @@
                 <a:ea typeface="Calibri" pitchFamily="34" charset="-122"/>
                 <a:cs typeface="Calibri" pitchFamily="34" charset="-120"/>
               </a:rPr>
-              <a:t>Porque hay dos preguntas distintas que hacerle a los datos.</a:t>
+              <a:t>Y por qué no una sola.</a:t>
             </a:r>
             <a:endParaRPr lang="en-US" sz="1700" dirty="0"/>
           </a:p>
@@ -4459,7 +4460,7 @@
         </p:nvSpPr>
         <p:spPr>
           <a:xfrm>
-            <a:off x="777240" y="2240280"/>
+            <a:off x="777240" y="2194560"/>
             <a:ext cx="4846320" cy="365760"/>
           </a:xfrm>
           <a:prstGeom prst="rect">
@@ -4476,7 +4477,7 @@
               <a:buNone/>
             </a:pPr>
             <a:r>
-              <a:rPr lang="en-US" sz="2000" b="1" dirty="0">
+              <a:rPr lang="en-US" sz="1900" b="1" dirty="0">
                 <a:solidFill>
                   <a:srgbClr val="202CFC"/>
                 </a:solidFill>
@@ -4484,9 +4485,9 @@
                 <a:ea typeface="Arial" pitchFamily="34" charset="-122"/>
                 <a:cs typeface="Arial" pitchFamily="34" charset="-120"/>
               </a:rPr>
-              <a:t>SQLite</a:t>
-            </a:r>
-            <a:endParaRPr lang="en-US" sz="2000" dirty="0"/>
+              <a:t>SQLite, para los datos del taller</a:t>
+            </a:r>
+            <a:endParaRPr lang="en-US" sz="1900" dirty="0"/>
           </a:p>
         </p:txBody>
       </p:sp>
@@ -4498,47 +4499,8 @@
         </p:nvSpPr>
         <p:spPr>
           <a:xfrm>
-            <a:off x="777240" y="2670048"/>
-            <a:ext cx="4846320" cy="320040"/>
-          </a:xfrm>
-          <a:prstGeom prst="rect">
-            <a:avLst/>
-          </a:prstGeom>
-          <a:noFill/>
-          <a:ln/>
-        </p:spPr>
-        <p:txBody>
-          <a:bodyPr wrap="square" lIns="0" tIns="0" rIns="0" bIns="0" rtlCol="0" anchor="t"/>
-          <a:lstStyle/>
-          <a:p>
-            <a:pPr indent="0" marL="0">
-              <a:buNone/>
-            </a:pPr>
-            <a:r>
-              <a:rPr lang="en-US" sz="1500" i="1" dirty="0">
-                <a:solidFill>
-                  <a:srgbClr val="5A5F73"/>
-                </a:solidFill>
-                <a:latin typeface="Calibri" pitchFamily="34" charset="0"/>
-                <a:ea typeface="Calibri" pitchFamily="34" charset="-122"/>
-                <a:cs typeface="Calibri" pitchFamily="34" charset="-120"/>
-              </a:rPr>
-              <a:t>«¿Qué es esto exactamente?»</a:t>
-            </a:r>
-            <a:endParaRPr lang="en-US" sz="1500" dirty="0"/>
-          </a:p>
-        </p:txBody>
-      </p:sp>
-      <p:sp>
-        <p:nvSpPr>
-          <p:cNvPr id="6" name="Text 4"/>
-          <p:cNvSpPr/>
-          <p:nvPr/>
-        </p:nvSpPr>
-        <p:spPr>
-          <a:xfrm>
-            <a:off x="777240" y="3200400"/>
-            <a:ext cx="4846320" cy="2194560"/>
+            <a:off x="777240" y="2743200"/>
+            <a:ext cx="4846320" cy="2651760"/>
           </a:xfrm>
           <a:prstGeom prst="rect">
             <a:avLst/>
@@ -4569,7 +4531,7 @@
                 <a:ea typeface="Calibri" pitchFamily="34" charset="-122"/>
                 <a:cs typeface="Calibri" pitchFamily="34" charset="-120"/>
               </a:rPr>
-              <a:t>Usuarios, vehículos, ECUs y sesiones</a:t>
+              <a:t>Los datos son relacionales: un vehículo tiene ECUs, sesiones y lecturas</a:t>
             </a:r>
             <a:endParaRPr lang="en-US" sz="1500" dirty="0"/>
           </a:p>
@@ -4593,7 +4555,7 @@
                 <a:ea typeface="Calibri" pitchFamily="34" charset="-122"/>
                 <a:cs typeface="Calibri" pitchFamily="34" charset="-120"/>
               </a:rPr>
-              <a:t>13 tablas con sus claves y relaciones</a:t>
+              <a:t>Es un fichero en disco: no hay servidor que levantar</a:t>
             </a:r>
             <a:endParaRPr lang="en-US" sz="1500" dirty="0"/>
           </a:p>
@@ -4617,7 +4579,7 @@
                 <a:ea typeface="Calibri" pitchFamily="34" charset="-122"/>
                 <a:cs typeface="Calibri" pitchFamily="34" charset="-120"/>
               </a:rPr>
-              <a:t>El informe de cada sesión, congelado</a:t>
+              <a:t>MongoDB no vale: esto tiene relaciones, no son documentos sueltos</a:t>
             </a:r>
             <a:endParaRPr lang="en-US" sz="1500" dirty="0"/>
           </a:p>
@@ -4641,7 +4603,7 @@
                 <a:ea typeface="Calibri" pitchFamily="34" charset="-122"/>
                 <a:cs typeface="Calibri" pitchFamily="34" charset="-120"/>
               </a:rPr>
-              <a:t>Se responde con una clave: este VIN, este usuario</a:t>
+              <a:t>PostgreSQL no compensa: un servicio, una red y un backup más que mantener</a:t>
             </a:r>
             <a:endParaRPr lang="en-US" sz="1500" dirty="0"/>
           </a:p>
@@ -4649,13 +4611,13 @@
       </p:sp>
       <p:sp>
         <p:nvSpPr>
-          <p:cNvPr id="7" name="Text 5"/>
-          <p:cNvSpPr/>
-          <p:nvPr/>
-        </p:nvSpPr>
-        <p:spPr>
-          <a:xfrm>
-            <a:off x="6537960" y="2240280"/>
+          <p:cNvPr id="6" name="Text 4"/>
+          <p:cNvSpPr/>
+          <p:nvPr/>
+        </p:nvSpPr>
+        <p:spPr>
+          <a:xfrm>
+            <a:off x="6537960" y="2194560"/>
             <a:ext cx="4846320" cy="365760"/>
           </a:xfrm>
           <a:prstGeom prst="rect">
@@ -4672,7 +4634,7 @@
               <a:buNone/>
             </a:pPr>
             <a:r>
-              <a:rPr lang="en-US" sz="2000" b="1" dirty="0">
+              <a:rPr lang="en-US" sz="1900" b="1" dirty="0">
                 <a:solidFill>
                   <a:srgbClr val="202CFC"/>
                 </a:solidFill>
@@ -4680,61 +4642,22 @@
                 <a:ea typeface="Arial" pitchFamily="34" charset="-122"/>
                 <a:cs typeface="Arial" pitchFamily="34" charset="-120"/>
               </a:rPr>
-              <a:t>LanceDB</a:t>
-            </a:r>
-            <a:endParaRPr lang="en-US" sz="2000" dirty="0"/>
-          </a:p>
-        </p:txBody>
-      </p:sp>
-      <p:sp>
-        <p:nvSpPr>
-          <p:cNvPr id="8" name="Text 6"/>
-          <p:cNvSpPr/>
-          <p:nvPr/>
-        </p:nvSpPr>
-        <p:spPr>
-          <a:xfrm>
-            <a:off x="6537960" y="2670048"/>
-            <a:ext cx="4846320" cy="320040"/>
-          </a:xfrm>
-          <a:prstGeom prst="rect">
-            <a:avLst/>
-          </a:prstGeom>
-          <a:noFill/>
-          <a:ln/>
-        </p:spPr>
-        <p:txBody>
-          <a:bodyPr wrap="square" lIns="0" tIns="0" rIns="0" bIns="0" rtlCol="0" anchor="t"/>
-          <a:lstStyle/>
-          <a:p>
-            <a:pPr indent="0" marL="0">
-              <a:buNone/>
-            </a:pPr>
-            <a:r>
-              <a:rPr lang="en-US" sz="1500" i="1" dirty="0">
-                <a:solidFill>
-                  <a:srgbClr val="5A5F73"/>
-                </a:solidFill>
-                <a:latin typeface="Calibri" pitchFamily="34" charset="0"/>
-                <a:ea typeface="Calibri" pitchFamily="34" charset="-122"/>
-                <a:cs typeface="Calibri" pitchFamily="34" charset="-120"/>
-              </a:rPr>
-              <a:t>«¿Qué se parece a esto?»</a:t>
-            </a:r>
-            <a:endParaRPr lang="en-US" sz="1500" dirty="0"/>
-          </a:p>
-        </p:txBody>
-      </p:sp>
-      <p:sp>
-        <p:nvSpPr>
-          <p:cNvPr id="9" name="Text 7"/>
-          <p:cNvSpPr/>
-          <p:nvPr/>
-        </p:nvSpPr>
-        <p:spPr>
-          <a:xfrm>
-            <a:off x="6537960" y="3200400"/>
-            <a:ext cx="4846320" cy="2194560"/>
+              <a:t>LanceDB, para lo que aprende</a:t>
+            </a:r>
+            <a:endParaRPr lang="en-US" sz="1900" dirty="0"/>
+          </a:p>
+        </p:txBody>
+      </p:sp>
+      <p:sp>
+        <p:nvSpPr>
+          <p:cNvPr id="7" name="Text 5"/>
+          <p:cNvSpPr/>
+          <p:nvPr/>
+        </p:nvSpPr>
+        <p:spPr>
+          <a:xfrm>
+            <a:off x="6537960" y="2743200"/>
+            <a:ext cx="4846320" cy="2651760"/>
           </a:xfrm>
           <a:prstGeom prst="rect">
             <a:avLst/>
@@ -4765,7 +4688,7 @@
                 <a:ea typeface="Calibri" pitchFamily="34" charset="-122"/>
                 <a:cs typeface="Calibri" pitchFamily="34" charset="-120"/>
               </a:rPr>
-              <a:t>PIDs, DTCs y diagnósticos ya resueltos</a:t>
+              <a:t>Hay que buscar por parecido, y para eso no hay clave ni consulta SQL</a:t>
             </a:r>
             <a:endParaRPr lang="en-US" sz="1500" dirty="0"/>
           </a:p>
@@ -4789,7 +4712,7 @@
                 <a:ea typeface="Calibri" pitchFamily="34" charset="-122"/>
                 <a:cs typeface="Calibri" pitchFamily="34" charset="-120"/>
               </a:rPr>
-              <a:t>El texto se convierte en vectores de 384 dimensiones</a:t>
+              <a:t>El buscador de texto de SQLite no llega: «presión de aceite» no encuentra «oil pressure»</a:t>
             </a:r>
             <a:endParaRPr lang="en-US" sz="1500" dirty="0"/>
           </a:p>
@@ -4813,7 +4736,7 @@
                 <a:ea typeface="Calibri" pitchFamily="34" charset="-122"/>
                 <a:cs typeface="Calibri" pitchFamily="34" charset="-120"/>
               </a:rPr>
-              <a:t>Busca por significado, no por palabra exacta</a:t>
+              <a:t>Va embebida igual que SQLite: un directorio en disco</a:t>
             </a:r>
             <a:endParaRPr lang="en-US" sz="1500" dirty="0"/>
           </a:p>
@@ -4837,7 +4760,7 @@
                 <a:ea typeface="Calibri" pitchFamily="34" charset="-122"/>
                 <a:cs typeface="Calibri" pitchFamily="34" charset="-120"/>
               </a:rPr>
-              <a:t>No hay clave que valga: no sabes qué buscas hasta verlo</a:t>
+              <a:t>Los embeddings se calculan en local: sin API key y sin coste por consulta</a:t>
             </a:r>
             <a:endParaRPr lang="en-US" sz="1500" dirty="0"/>
           </a:p>
@@ -4845,49 +4768,7 @@
       </p:sp>
       <p:sp>
         <p:nvSpPr>
-          <p:cNvPr id="10" name="Text 8"/>
-          <p:cNvSpPr/>
-          <p:nvPr/>
-        </p:nvSpPr>
-        <p:spPr>
-          <a:xfrm>
-            <a:off x="777240" y="5623560"/>
-            <a:ext cx="10607040" cy="411480"/>
-          </a:xfrm>
-          <a:prstGeom prst="rect">
-            <a:avLst/>
-          </a:prstGeom>
-          <a:noFill/>
-          <a:ln/>
-        </p:spPr>
-        <p:txBody>
-          <a:bodyPr wrap="square" lIns="0" tIns="0" rIns="0" bIns="0" rtlCol="0" anchor="t"/>
-          <a:lstStyle/>
-          <a:p>
-            <a:pPr indent="0" marL="0">
-              <a:lnSpc>
-                <a:spcPts val="1900"/>
-              </a:lnSpc>
-              <a:buNone/>
-            </a:pPr>
-            <a:r>
-              <a:rPr lang="en-US" sz="1400" dirty="0">
-                <a:solidFill>
-                  <a:srgbClr val="5A5F73"/>
-                </a:solidFill>
-                <a:latin typeface="Calibri" pitchFamily="34" charset="0"/>
-                <a:ea typeface="Calibri" pitchFamily="34" charset="-122"/>
-                <a:cs typeface="Calibri" pitchFamily="34" charset="-120"/>
-              </a:rPr>
-              <a:t>Las dos van embebidas, sin servidor que mantener. PostgreSQL se descartó por eso: un servicio más sin resolver ningún problema a esta escala.</a:t>
-            </a:r>
-            <a:endParaRPr lang="en-US" sz="1400" dirty="0"/>
-          </a:p>
-        </p:txBody>
-      </p:sp>
-      <p:sp>
-        <p:nvSpPr>
-          <p:cNvPr id="11" name="Shape 9"/>
+          <p:cNvPr id="8" name="Shape 6"/>
           <p:cNvSpPr/>
           <p:nvPr/>
         </p:nvSpPr>
@@ -4907,7 +4788,7 @@
       </p:sp>
       <p:sp>
         <p:nvSpPr>
-          <p:cNvPr id="12" name="Text 10"/>
+          <p:cNvPr id="9" name="Text 7"/>
           <p:cNvSpPr/>
           <p:nvPr/>
         </p:nvSpPr>
@@ -4946,7 +4827,7 @@
       </p:sp>
       <p:sp>
         <p:nvSpPr>
-          <p:cNvPr id="13" name="Text 11"/>
+          <p:cNvPr id="10" name="Text 8"/>
           <p:cNvSpPr/>
           <p:nvPr/>
         </p:nvSpPr>
@@ -4985,7 +4866,7 @@
       </p:sp>
       <p:sp>
         <p:nvSpPr>
-          <p:cNvPr id="14" name="Text 12"/>
+          <p:cNvPr id="11" name="Text 9"/>
           <p:cNvSpPr/>
           <p:nvPr/>
         </p:nvSpPr>

</xml_diff>

<commit_message>
docs(tfm): que guarda la vectorial y la escala de confianza
</commit_message>
<xml_diff>
--- a/docs/presentacion/tfm-intelligent-automotive-diagnostics.pptx
+++ b/docs/presentacion/tfm-intelligent-automotive-diagnostics.pptx
@@ -966,12 +966,13 @@
           <a:p>
             <a:r>
               <a:rPr lang="en-US" dirty="0"/>
-              <a:t>Hay dos bases de datos porque hay dos cosas que hacer con los datos, y una sola no las cubre.
-En SQLite van los datos del taller: usuarios, vehículos, las ECUs que se le han descubierto a cada uno, las sesiones de diagnóstico y el informe de cada una. Eso es relacional de manual, un vehículo tiene ECUs, que tienen sesiones, que tienen lecturas. Por eso se descartó MongoDB, porque no son documentos sueltos. Y se descartó PostgreSQL porque a esta escala solo añadía un servicio, una red y un backup que gestionar, sin resolver ningún problema que yo tuviera.
-En LanceDB va lo que el sistema aprende: PIDs, DTCs y diagnósticos ya resueltos. Y ahí la pregunta no es "dame el registro con esta clave", sino "enséñame casos que se parezcan a este". Eso con SQL no se hace.
-Y ojo, tampoco basta con el buscador de texto de SQLite, que también existe: busca palabras, no significado. Si el mecánico escribe "presión de aceite", el buscador de texto no encuentra una ficha que ponga "oil pressure", y la búsqueda vectorial sí, porque compara el sentido.
-Las dos son embebidas, un fichero y un directorio en disco. Y los embeddings se calculan con un modelo que corre en la propia máquina, así que no hay API key ni coste por consulta.
-[~60 s]</a:t>
+              <a:t>En la base vectorial no van los datos del taller: esos están en SQLite. Aquí va solo lo que el sistema aprende, y son tres colecciones.
+La primera son PIDs propietarios. Cada fabricante se inventa los suyos fuera de la norma, y es imposible traerlos todos precargados: cuando el agente descubre uno, lo guarda con su fórmula. La segunda son DTCs específicos de un fabricante, los que no están en el estándar. Y la tercera son casos resueltos: los síntomas, los PIDs que estaban implicados y cómo acabó.
+Cada entrada es un texto que se convierte en vector, y lleva pegados el fabricante y el modelo para poder filtrar. Si estoy con un Audi, no quiero que me salgan casos de una Kawasaki.
+Y lo importante: cada dato lleva de dónde salió, porque no todas las fuentes valen igual. Si lo encontró el agente buscando en internet, entra con 0,3. Si viene de un diagnóstico anterior, con 0,5. Si lo aportó el mecánico a mano, con 0,8, porque una persona que está delante del coche sabe más que una web. Y si se ha leído del propio coche por OBD, es un hecho: 1,0.
+Además, validar contra el coche sube lo de la web a 0,7 y lo del mecánico a 0,9.
+Para eso sirve todo esto: para que el agente sepa de qué fiarse cuando le llegan dos respuestas que se contradicen.
+[~70 s]</a:t>
             </a:r>
             <a:endParaRPr lang="en-US" dirty="0"/>
           </a:p>
@@ -4407,7 +4408,7 @@
                 <a:ea typeface="Arial" pitchFamily="34" charset="-122"/>
                 <a:cs typeface="Arial" pitchFamily="34" charset="-120"/>
               </a:rPr>
-              <a:t>Por qué dos bases de datos</a:t>
+              <a:t>Qué se guarda en la base vectorial</a:t>
             </a:r>
             <a:endParaRPr lang="en-US" sz="3400" dirty="0"/>
           </a:p>
@@ -4446,7 +4447,7 @@
                 <a:ea typeface="Calibri" pitchFamily="34" charset="-122"/>
                 <a:cs typeface="Calibri" pitchFamily="34" charset="-120"/>
               </a:rPr>
-              <a:t>Y por qué no una sola.</a:t>
+              <a:t>Los datos del taller van en SQLite. Aquí solo va lo que el sistema aprende.</a:t>
             </a:r>
             <a:endParaRPr lang="en-US" sz="1700" dirty="0"/>
           </a:p>
@@ -4485,7 +4486,7 @@
                 <a:ea typeface="Arial" pitchFamily="34" charset="-122"/>
                 <a:cs typeface="Arial" pitchFamily="34" charset="-120"/>
               </a:rPr>
-              <a:t>SQLite, para los datos del taller</a:t>
+              <a:t>Tres colecciones</a:t>
             </a:r>
             <a:endParaRPr lang="en-US" sz="1900" dirty="0"/>
           </a:p>
@@ -4531,7 +4532,7 @@
                 <a:ea typeface="Calibri" pitchFamily="34" charset="-122"/>
                 <a:cs typeface="Calibri" pitchFamily="34" charset="-120"/>
               </a:rPr>
-              <a:t>Los datos son relacionales: un vehículo tiene ECUs, sesiones y lecturas</a:t>
+              <a:t>PIDs propietarios que no están en la norma, con su fórmula</a:t>
             </a:r>
             <a:endParaRPr lang="en-US" sz="1500" dirty="0"/>
           </a:p>
@@ -4555,7 +4556,7 @@
                 <a:ea typeface="Calibri" pitchFamily="34" charset="-122"/>
                 <a:cs typeface="Calibri" pitchFamily="34" charset="-120"/>
               </a:rPr>
-              <a:t>Es un fichero en disco: no hay servidor que levantar</a:t>
+              <a:t>DTCs específicos de un fabricante</a:t>
             </a:r>
             <a:endParaRPr lang="en-US" sz="1500" dirty="0"/>
           </a:p>
@@ -4579,7 +4580,7 @@
                 <a:ea typeface="Calibri" pitchFamily="34" charset="-122"/>
                 <a:cs typeface="Calibri" pitchFamily="34" charset="-120"/>
               </a:rPr>
-              <a:t>MongoDB no vale: esto tiene relaciones, no son documentos sueltos</a:t>
+              <a:t>Casos resueltos: síntomas, PIDs implicados y solución</a:t>
             </a:r>
             <a:endParaRPr lang="en-US" sz="1500" dirty="0"/>
           </a:p>
@@ -4603,7 +4604,7 @@
                 <a:ea typeface="Calibri" pitchFamily="34" charset="-122"/>
                 <a:cs typeface="Calibri" pitchFamily="34" charset="-120"/>
               </a:rPr>
-              <a:t>PostgreSQL no compensa: un servicio, una red y un backup más que mantener</a:t>
+              <a:t>Cada entrada es un texto vectorizado, más fabricante y modelo para filtrar</a:t>
             </a:r>
             <a:endParaRPr lang="en-US" sz="1500" dirty="0"/>
           </a:p>
@@ -4642,7 +4643,7 @@
                 <a:ea typeface="Arial" pitchFamily="34" charset="-122"/>
                 <a:cs typeface="Arial" pitchFamily="34" charset="-120"/>
               </a:rPr>
-              <a:t>LanceDB, para lo que aprende</a:t>
+              <a:t>Cada dato lleva de dónde salió</a:t>
             </a:r>
             <a:endParaRPr lang="en-US" sz="1900" dirty="0"/>
           </a:p>
@@ -4656,8 +4657,320 @@
         </p:nvSpPr>
         <p:spPr>
           <a:xfrm>
-            <a:off x="6537960" y="2743200"/>
-            <a:ext cx="4846320" cy="2651760"/>
+            <a:off x="6537960" y="2788920"/>
+            <a:ext cx="685800" cy="347472"/>
+          </a:xfrm>
+          <a:prstGeom prst="rect">
+            <a:avLst/>
+          </a:prstGeom>
+          <a:noFill/>
+          <a:ln/>
+        </p:spPr>
+        <p:txBody>
+          <a:bodyPr wrap="square" lIns="0" tIns="0" rIns="0" bIns="0" rtlCol="0" anchor="ctr"/>
+          <a:lstStyle/>
+          <a:p>
+            <a:pPr indent="0" marL="0">
+              <a:buNone/>
+            </a:pPr>
+            <a:r>
+              <a:rPr lang="en-US" sz="1800" b="1" dirty="0">
+                <a:solidFill>
+                  <a:srgbClr val="1A1C2E"/>
+                </a:solidFill>
+                <a:latin typeface="Arial" pitchFamily="34" charset="0"/>
+                <a:ea typeface="Arial" pitchFamily="34" charset="-122"/>
+                <a:cs typeface="Arial" pitchFamily="34" charset="-120"/>
+              </a:rPr>
+              <a:t>0,3</a:t>
+            </a:r>
+            <a:endParaRPr lang="en-US" sz="1800" dirty="0"/>
+          </a:p>
+        </p:txBody>
+      </p:sp>
+      <p:sp>
+        <p:nvSpPr>
+          <p:cNvPr id="8" name="Text 6"/>
+          <p:cNvSpPr/>
+          <p:nvPr/>
+        </p:nvSpPr>
+        <p:spPr>
+          <a:xfrm>
+            <a:off x="7315200" y="2788920"/>
+            <a:ext cx="4069080" cy="347472"/>
+          </a:xfrm>
+          <a:prstGeom prst="rect">
+            <a:avLst/>
+          </a:prstGeom>
+          <a:noFill/>
+          <a:ln/>
+        </p:spPr>
+        <p:txBody>
+          <a:bodyPr wrap="square" lIns="0" tIns="0" rIns="0" bIns="0" rtlCol="0" anchor="ctr"/>
+          <a:lstStyle/>
+          <a:p>
+            <a:pPr indent="0" marL="0">
+              <a:buNone/>
+            </a:pPr>
+            <a:r>
+              <a:rPr lang="en-US" sz="1500" dirty="0">
+                <a:solidFill>
+                  <a:srgbClr val="1A1C2E"/>
+                </a:solidFill>
+                <a:latin typeface="Calibri" pitchFamily="34" charset="0"/>
+                <a:ea typeface="Calibri" pitchFamily="34" charset="-122"/>
+                <a:cs typeface="Calibri" pitchFamily="34" charset="-120"/>
+              </a:rPr>
+              <a:t>lo encontró el agente en internet</a:t>
+            </a:r>
+            <a:endParaRPr lang="en-US" sz="1500" dirty="0"/>
+          </a:p>
+        </p:txBody>
+      </p:sp>
+      <p:sp>
+        <p:nvSpPr>
+          <p:cNvPr id="9" name="Text 7"/>
+          <p:cNvSpPr/>
+          <p:nvPr/>
+        </p:nvSpPr>
+        <p:spPr>
+          <a:xfrm>
+            <a:off x="6537960" y="3264408"/>
+            <a:ext cx="685800" cy="347472"/>
+          </a:xfrm>
+          <a:prstGeom prst="rect">
+            <a:avLst/>
+          </a:prstGeom>
+          <a:noFill/>
+          <a:ln/>
+        </p:spPr>
+        <p:txBody>
+          <a:bodyPr wrap="square" lIns="0" tIns="0" rIns="0" bIns="0" rtlCol="0" anchor="ctr"/>
+          <a:lstStyle/>
+          <a:p>
+            <a:pPr indent="0" marL="0">
+              <a:buNone/>
+            </a:pPr>
+            <a:r>
+              <a:rPr lang="en-US" sz="1800" b="1" dirty="0">
+                <a:solidFill>
+                  <a:srgbClr val="1A1C2E"/>
+                </a:solidFill>
+                <a:latin typeface="Arial" pitchFamily="34" charset="0"/>
+                <a:ea typeface="Arial" pitchFamily="34" charset="-122"/>
+                <a:cs typeface="Arial" pitchFamily="34" charset="-120"/>
+              </a:rPr>
+              <a:t>0,5</a:t>
+            </a:r>
+            <a:endParaRPr lang="en-US" sz="1800" dirty="0"/>
+          </a:p>
+        </p:txBody>
+      </p:sp>
+      <p:sp>
+        <p:nvSpPr>
+          <p:cNvPr id="10" name="Text 8"/>
+          <p:cNvSpPr/>
+          <p:nvPr/>
+        </p:nvSpPr>
+        <p:spPr>
+          <a:xfrm>
+            <a:off x="7315200" y="3264408"/>
+            <a:ext cx="4069080" cy="347472"/>
+          </a:xfrm>
+          <a:prstGeom prst="rect">
+            <a:avLst/>
+          </a:prstGeom>
+          <a:noFill/>
+          <a:ln/>
+        </p:spPr>
+        <p:txBody>
+          <a:bodyPr wrap="square" lIns="0" tIns="0" rIns="0" bIns="0" rtlCol="0" anchor="ctr"/>
+          <a:lstStyle/>
+          <a:p>
+            <a:pPr indent="0" marL="0">
+              <a:buNone/>
+            </a:pPr>
+            <a:r>
+              <a:rPr lang="en-US" sz="1500" dirty="0">
+                <a:solidFill>
+                  <a:srgbClr val="1A1C2E"/>
+                </a:solidFill>
+                <a:latin typeface="Calibri" pitchFamily="34" charset="0"/>
+                <a:ea typeface="Calibri" pitchFamily="34" charset="-122"/>
+                <a:cs typeface="Calibri" pitchFamily="34" charset="-120"/>
+              </a:rPr>
+              <a:t>viene de un diagnóstico anterior</a:t>
+            </a:r>
+            <a:endParaRPr lang="en-US" sz="1500" dirty="0"/>
+          </a:p>
+        </p:txBody>
+      </p:sp>
+      <p:sp>
+        <p:nvSpPr>
+          <p:cNvPr id="11" name="Text 9"/>
+          <p:cNvSpPr/>
+          <p:nvPr/>
+        </p:nvSpPr>
+        <p:spPr>
+          <a:xfrm>
+            <a:off x="6537960" y="3739896"/>
+            <a:ext cx="685800" cy="347472"/>
+          </a:xfrm>
+          <a:prstGeom prst="rect">
+            <a:avLst/>
+          </a:prstGeom>
+          <a:noFill/>
+          <a:ln/>
+        </p:spPr>
+        <p:txBody>
+          <a:bodyPr wrap="square" lIns="0" tIns="0" rIns="0" bIns="0" rtlCol="0" anchor="ctr"/>
+          <a:lstStyle/>
+          <a:p>
+            <a:pPr indent="0" marL="0">
+              <a:buNone/>
+            </a:pPr>
+            <a:r>
+              <a:rPr lang="en-US" sz="1800" b="1" dirty="0">
+                <a:solidFill>
+                  <a:srgbClr val="1A1C2E"/>
+                </a:solidFill>
+                <a:latin typeface="Arial" pitchFamily="34" charset="0"/>
+                <a:ea typeface="Arial" pitchFamily="34" charset="-122"/>
+                <a:cs typeface="Arial" pitchFamily="34" charset="-120"/>
+              </a:rPr>
+              <a:t>0,8</a:t>
+            </a:r>
+            <a:endParaRPr lang="en-US" sz="1800" dirty="0"/>
+          </a:p>
+        </p:txBody>
+      </p:sp>
+      <p:sp>
+        <p:nvSpPr>
+          <p:cNvPr id="12" name="Text 10"/>
+          <p:cNvSpPr/>
+          <p:nvPr/>
+        </p:nvSpPr>
+        <p:spPr>
+          <a:xfrm>
+            <a:off x="7315200" y="3739896"/>
+            <a:ext cx="4069080" cy="347472"/>
+          </a:xfrm>
+          <a:prstGeom prst="rect">
+            <a:avLst/>
+          </a:prstGeom>
+          <a:noFill/>
+          <a:ln/>
+        </p:spPr>
+        <p:txBody>
+          <a:bodyPr wrap="square" lIns="0" tIns="0" rIns="0" bIns="0" rtlCol="0" anchor="ctr"/>
+          <a:lstStyle/>
+          <a:p>
+            <a:pPr indent="0" marL="0">
+              <a:buNone/>
+            </a:pPr>
+            <a:r>
+              <a:rPr lang="en-US" sz="1500" dirty="0">
+                <a:solidFill>
+                  <a:srgbClr val="1A1C2E"/>
+                </a:solidFill>
+                <a:latin typeface="Calibri" pitchFamily="34" charset="0"/>
+                <a:ea typeface="Calibri" pitchFamily="34" charset="-122"/>
+                <a:cs typeface="Calibri" pitchFamily="34" charset="-120"/>
+              </a:rPr>
+              <a:t>lo aportó el mecánico a mano</a:t>
+            </a:r>
+            <a:endParaRPr lang="en-US" sz="1500" dirty="0"/>
+          </a:p>
+        </p:txBody>
+      </p:sp>
+      <p:sp>
+        <p:nvSpPr>
+          <p:cNvPr id="13" name="Text 11"/>
+          <p:cNvSpPr/>
+          <p:nvPr/>
+        </p:nvSpPr>
+        <p:spPr>
+          <a:xfrm>
+            <a:off x="6537960" y="4215384"/>
+            <a:ext cx="685800" cy="347472"/>
+          </a:xfrm>
+          <a:prstGeom prst="rect">
+            <a:avLst/>
+          </a:prstGeom>
+          <a:noFill/>
+          <a:ln/>
+        </p:spPr>
+        <p:txBody>
+          <a:bodyPr wrap="square" lIns="0" tIns="0" rIns="0" bIns="0" rtlCol="0" anchor="ctr"/>
+          <a:lstStyle/>
+          <a:p>
+            <a:pPr indent="0" marL="0">
+              <a:buNone/>
+            </a:pPr>
+            <a:r>
+              <a:rPr lang="en-US" sz="1800" b="1" dirty="0">
+                <a:solidFill>
+                  <a:srgbClr val="1A1C2E"/>
+                </a:solidFill>
+                <a:latin typeface="Arial" pitchFamily="34" charset="0"/>
+                <a:ea typeface="Arial" pitchFamily="34" charset="-122"/>
+                <a:cs typeface="Arial" pitchFamily="34" charset="-120"/>
+              </a:rPr>
+              <a:t>1,0</a:t>
+            </a:r>
+            <a:endParaRPr lang="en-US" sz="1800" dirty="0"/>
+          </a:p>
+        </p:txBody>
+      </p:sp>
+      <p:sp>
+        <p:nvSpPr>
+          <p:cNvPr id="14" name="Text 12"/>
+          <p:cNvSpPr/>
+          <p:nvPr/>
+        </p:nvSpPr>
+        <p:spPr>
+          <a:xfrm>
+            <a:off x="7315200" y="4215384"/>
+            <a:ext cx="4069080" cy="347472"/>
+          </a:xfrm>
+          <a:prstGeom prst="rect">
+            <a:avLst/>
+          </a:prstGeom>
+          <a:noFill/>
+          <a:ln/>
+        </p:spPr>
+        <p:txBody>
+          <a:bodyPr wrap="square" lIns="0" tIns="0" rIns="0" bIns="0" rtlCol="0" anchor="ctr"/>
+          <a:lstStyle/>
+          <a:p>
+            <a:pPr indent="0" marL="0">
+              <a:buNone/>
+            </a:pPr>
+            <a:r>
+              <a:rPr lang="en-US" sz="1500" dirty="0">
+                <a:solidFill>
+                  <a:srgbClr val="1A1C2E"/>
+                </a:solidFill>
+                <a:latin typeface="Calibri" pitchFamily="34" charset="0"/>
+                <a:ea typeface="Calibri" pitchFamily="34" charset="-122"/>
+                <a:cs typeface="Calibri" pitchFamily="34" charset="-120"/>
+              </a:rPr>
+              <a:t>se ha leído del coche por OBD</a:t>
+            </a:r>
+            <a:endParaRPr lang="en-US" sz="1500" dirty="0"/>
+          </a:p>
+        </p:txBody>
+      </p:sp>
+      <p:sp>
+        <p:nvSpPr>
+          <p:cNvPr id="15" name="Text 13"/>
+          <p:cNvSpPr/>
+          <p:nvPr/>
+        </p:nvSpPr>
+        <p:spPr>
+          <a:xfrm>
+            <a:off x="6537960" y="4846320"/>
+            <a:ext cx="4846320" cy="365760"/>
           </a:xfrm>
           <a:prstGeom prst="rect">
             <a:avLst/>
@@ -4669,106 +4982,66 @@
           <a:bodyPr wrap="square" lIns="0" tIns="0" rIns="0" bIns="0" rtlCol="0" anchor="t"/>
           <a:lstStyle/>
           <a:p>
-            <a:pPr marL="342900" indent="-342900">
-              <a:lnSpc>
-                <a:spcPts val="2100"/>
-              </a:lnSpc>
-              <a:spcAft>
-                <a:spcPts val="1100"/>
-              </a:spcAft>
-              <a:buSzPct val="100000"/>
-              <a:buChar char="•"/>
+            <a:pPr indent="0" marL="0">
+              <a:buNone/>
+            </a:pPr>
+            <a:r>
+              <a:rPr lang="en-US" sz="1400" dirty="0">
+                <a:solidFill>
+                  <a:srgbClr val="5A5F73"/>
+                </a:solidFill>
+                <a:latin typeface="Calibri" pitchFamily="34" charset="0"/>
+                <a:ea typeface="Calibri" pitchFamily="34" charset="-122"/>
+                <a:cs typeface="Calibri" pitchFamily="34" charset="-120"/>
+              </a:rPr>
+              <a:t>Validar contra el coche sube la web a 0,7 y al mecánico a 0,9.</a:t>
+            </a:r>
+            <a:endParaRPr lang="en-US" sz="1400" dirty="0"/>
+          </a:p>
+        </p:txBody>
+      </p:sp>
+      <p:sp>
+        <p:nvSpPr>
+          <p:cNvPr id="16" name="Text 14"/>
+          <p:cNvSpPr/>
+          <p:nvPr/>
+        </p:nvSpPr>
+        <p:spPr>
+          <a:xfrm>
+            <a:off x="777240" y="5623560"/>
+            <a:ext cx="10607040" cy="365760"/>
+          </a:xfrm>
+          <a:prstGeom prst="rect">
+            <a:avLst/>
+          </a:prstGeom>
+          <a:noFill/>
+          <a:ln/>
+        </p:spPr>
+        <p:txBody>
+          <a:bodyPr wrap="square" lIns="0" tIns="0" rIns="0" bIns="0" rtlCol="0" anchor="t"/>
+          <a:lstStyle/>
+          <a:p>
+            <a:pPr indent="0" marL="0">
+              <a:buNone/>
             </a:pPr>
             <a:r>
               <a:rPr lang="en-US" sz="1500" dirty="0">
                 <a:solidFill>
-                  <a:srgbClr val="1A1C2E"/>
-                </a:solidFill>
-                <a:latin typeface="Calibri" pitchFamily="34" charset="0"/>
-                <a:ea typeface="Calibri" pitchFamily="34" charset="-122"/>
-                <a:cs typeface="Calibri" pitchFamily="34" charset="-120"/>
-              </a:rPr>
-              <a:t>Hay que buscar por parecido, y para eso no hay clave ni consulta SQL</a:t>
+                  <a:srgbClr val="5A5F73"/>
+                </a:solidFill>
+                <a:latin typeface="Calibri" pitchFamily="34" charset="0"/>
+                <a:ea typeface="Calibri" pitchFamily="34" charset="-122"/>
+                <a:cs typeface="Calibri" pitchFamily="34" charset="-120"/>
+              </a:rPr>
+              <a:t>Así el agente sabe de qué fiarse: lo que dijo un mecánico pesa más que lo que encontró en una web.</a:t>
             </a:r>
             <a:endParaRPr lang="en-US" sz="1500" dirty="0"/>
           </a:p>
-          <a:p>
-            <a:pPr marL="342900" indent="-342900">
-              <a:lnSpc>
-                <a:spcPts val="2100"/>
-              </a:lnSpc>
-              <a:spcAft>
-                <a:spcPts val="1100"/>
-              </a:spcAft>
-              <a:buSzPct val="100000"/>
-              <a:buChar char="•"/>
-            </a:pPr>
-            <a:r>
-              <a:rPr lang="en-US" sz="1500" dirty="0">
-                <a:solidFill>
-                  <a:srgbClr val="1A1C2E"/>
-                </a:solidFill>
-                <a:latin typeface="Calibri" pitchFamily="34" charset="0"/>
-                <a:ea typeface="Calibri" pitchFamily="34" charset="-122"/>
-                <a:cs typeface="Calibri" pitchFamily="34" charset="-120"/>
-              </a:rPr>
-              <a:t>El buscador de texto de SQLite no llega: «presión de aceite» no encuentra «oil pressure»</a:t>
-            </a:r>
-            <a:endParaRPr lang="en-US" sz="1500" dirty="0"/>
-          </a:p>
-          <a:p>
-            <a:pPr marL="342900" indent="-342900">
-              <a:lnSpc>
-                <a:spcPts val="2100"/>
-              </a:lnSpc>
-              <a:spcAft>
-                <a:spcPts val="1100"/>
-              </a:spcAft>
-              <a:buSzPct val="100000"/>
-              <a:buChar char="•"/>
-            </a:pPr>
-            <a:r>
-              <a:rPr lang="en-US" sz="1500" dirty="0">
-                <a:solidFill>
-                  <a:srgbClr val="1A1C2E"/>
-                </a:solidFill>
-                <a:latin typeface="Calibri" pitchFamily="34" charset="0"/>
-                <a:ea typeface="Calibri" pitchFamily="34" charset="-122"/>
-                <a:cs typeface="Calibri" pitchFamily="34" charset="-120"/>
-              </a:rPr>
-              <a:t>Va embebida igual que SQLite: un directorio en disco</a:t>
-            </a:r>
-            <a:endParaRPr lang="en-US" sz="1500" dirty="0"/>
-          </a:p>
-          <a:p>
-            <a:pPr marL="342900" indent="-342900">
-              <a:lnSpc>
-                <a:spcPts val="2100"/>
-              </a:lnSpc>
-              <a:spcAft>
-                <a:spcPts val="1100"/>
-              </a:spcAft>
-              <a:buSzPct val="100000"/>
-              <a:buChar char="•"/>
-            </a:pPr>
-            <a:r>
-              <a:rPr lang="en-US" sz="1500" dirty="0">
-                <a:solidFill>
-                  <a:srgbClr val="1A1C2E"/>
-                </a:solidFill>
-                <a:latin typeface="Calibri" pitchFamily="34" charset="0"/>
-                <a:ea typeface="Calibri" pitchFamily="34" charset="-122"/>
-                <a:cs typeface="Calibri" pitchFamily="34" charset="-120"/>
-              </a:rPr>
-              <a:t>Los embeddings se calculan en local: sin API key y sin coste por consulta</a:t>
-            </a:r>
-            <a:endParaRPr lang="en-US" sz="1500" dirty="0"/>
-          </a:p>
-        </p:txBody>
-      </p:sp>
-      <p:sp>
-        <p:nvSpPr>
-          <p:cNvPr id="8" name="Shape 6"/>
+        </p:txBody>
+      </p:sp>
+      <p:sp>
+        <p:nvSpPr>
+          <p:cNvPr id="17" name="Shape 15"/>
           <p:cNvSpPr/>
           <p:nvPr/>
         </p:nvSpPr>
@@ -4788,7 +5061,7 @@
       </p:sp>
       <p:sp>
         <p:nvSpPr>
-          <p:cNvPr id="9" name="Text 7"/>
+          <p:cNvPr id="18" name="Text 16"/>
           <p:cNvSpPr/>
           <p:nvPr/>
         </p:nvSpPr>
@@ -4827,7 +5100,7 @@
       </p:sp>
       <p:sp>
         <p:nvSpPr>
-          <p:cNvPr id="10" name="Text 8"/>
+          <p:cNvPr id="19" name="Text 17"/>
           <p:cNvSpPr/>
           <p:nvPr/>
         </p:nvSpPr>
@@ -4866,7 +5139,7 @@
       </p:sp>
       <p:sp>
         <p:nvSpPr>
-          <p:cNvPr id="11" name="Text 9"/>
+          <p:cNvPr id="20" name="Text 18"/>
           <p:cNvSpPr/>
           <p:nvPr/>
         </p:nvSpPr>

</xml_diff>

<commit_message>
docs(tfm): ejemplo real de entrada e indice de confianza
</commit_message>
<xml_diff>
--- a/docs/presentacion/tfm-intelligent-automotive-diagnostics.pptx
+++ b/docs/presentacion/tfm-intelligent-automotive-diagnostics.pptx
@@ -966,12 +966,10 @@
           <a:p>
             <a:r>
               <a:rPr lang="en-US" dirty="0"/>
-              <a:t>En la base vectorial no van los datos del taller: esos están en SQLite. Aquí va solo lo que el sistema aprende, y son tres colecciones.
-La primera son PIDs propietarios. Cada fabricante se inventa los suyos fuera de la norma, y es imposible traerlos todos precargados: cuando el agente descubre uno, lo guarda con su fórmula. La segunda son DTCs específicos de un fabricante, los que no están en el estándar. Y la tercera son casos resueltos: los síntomas, los PIDs que estaban implicados y cómo acabó.
-Cada entrada es un texto que se convierte en vector, y lleva pegados el fabricante y el modelo para poder filtrar. Si estoy con un Audi, no quiero que me salgan casos de una Kawasaki.
-Y lo importante: cada dato lleva de dónde salió, porque no todas las fuentes valen igual. Si lo encontró el agente buscando en internet, entra con 0,3. Si viene de un diagnóstico anterior, con 0,5. Si lo aportó el mecánico a mano, con 0,8, porque una persona que está delante del coche sabe más que una web. Y si se ha leído del propio coche por OBD, es un hecho: 1,0.
-Además, validar contra el coche sube lo de la web a 0,7 y lo del mecánico a 0,9.
-Para eso sirve todo esto: para que el agente sepa de qué fiarse cuando le llegan dos respuestas que se contradicen.
+              <a:t>En la base vectorial no van los datos del taller: esos están en SQLite. Aquí va solo lo que el sistema aprende. Hay PIDs propietarios, que cada fabricante se inventa fuera de la norma y es imposible traer precargados; DTCs específicos de una marca; y casos resueltos.
+A la izquierda tenéis un caso resuelto tal cual se guarda. El campo embeddedText es el texto que se convierte en vector, y es lo que luego permite encontrarlo por parecido. Los síntomas y los PIDs implicados van aparte, y el fabricante y el modelo también, para poder filtrar: si estoy con un Audi no quiero que me salgan casos de una Kawasaki.
+Y luego está el índice de confianza, que se lo ponemos nosotros al guardar según de dónde venga el dato. Si lo encontró el agente en internet entra con 0,3. Si viene de un diagnóstico anterior, 0,5. Si lo aportó el mecánico a mano, 0,8, porque una persona delante del coche sabe más que una web cualquiera. Y si se ha leído del propio coche por OBD es un hecho: 1,0. Comprobar un dato contra el coche sube la web a 0,7 y al mecánico a 0,9.
+Ese índice no es decorativo: es lo que pondera las búsquedas. Cuando al agente le llegan dos respuestas que se contradicen, gana la que más confianza tiene.
 [~70 s]</a:t>
             </a:r>
             <a:endParaRPr lang="en-US" dirty="0"/>
@@ -4383,8 +4381,8 @@
         </p:nvSpPr>
         <p:spPr>
           <a:xfrm>
-            <a:off x="777240" y="640080"/>
-            <a:ext cx="10607040" cy="777240"/>
+            <a:off x="777240" y="594360"/>
+            <a:ext cx="10607040" cy="731520"/>
           </a:xfrm>
           <a:prstGeom prst="rect">
             <a:avLst/>
@@ -4422,7 +4420,7 @@
         </p:nvSpPr>
         <p:spPr>
           <a:xfrm>
-            <a:off x="777240" y="1508760"/>
+            <a:off x="777240" y="1417320"/>
             <a:ext cx="10607040" cy="365760"/>
           </a:xfrm>
           <a:prstGeom prst="rect">
@@ -4439,7 +4437,7 @@
               <a:buNone/>
             </a:pPr>
             <a:r>
-              <a:rPr lang="en-US" sz="1700" dirty="0">
+              <a:rPr lang="en-US" sz="1600" dirty="0">
                 <a:solidFill>
                   <a:srgbClr val="5A5F73"/>
                 </a:solidFill>
@@ -4449,7 +4447,7 @@
               </a:rPr>
               <a:t>Los datos del taller van en SQLite. Aquí solo va lo que el sistema aprende.</a:t>
             </a:r>
-            <a:endParaRPr lang="en-US" sz="1700" dirty="0"/>
+            <a:endParaRPr lang="en-US" sz="1600" dirty="0"/>
           </a:p>
         </p:txBody>
       </p:sp>
@@ -4461,8 +4459,8 @@
         </p:nvSpPr>
         <p:spPr>
           <a:xfrm>
-            <a:off x="777240" y="2194560"/>
-            <a:ext cx="4846320" cy="365760"/>
+            <a:off x="777240" y="2057400"/>
+            <a:ext cx="6492240" cy="320040"/>
           </a:xfrm>
           <a:prstGeom prst="rect">
             <a:avLst/>
@@ -4478,7 +4476,7 @@
               <a:buNone/>
             </a:pPr>
             <a:r>
-              <a:rPr lang="en-US" sz="1900" b="1" dirty="0">
+              <a:rPr lang="en-US" sz="1800" b="1" dirty="0">
                 <a:solidFill>
                   <a:srgbClr val="202CFC"/>
                 </a:solidFill>
@@ -4486,9 +4484,9 @@
                 <a:ea typeface="Arial" pitchFamily="34" charset="-122"/>
                 <a:cs typeface="Arial" pitchFamily="34" charset="-120"/>
               </a:rPr>
-              <a:t>Tres colecciones</a:t>
-            </a:r>
-            <a:endParaRPr lang="en-US" sz="1900" dirty="0"/>
+              <a:t>Colecciones</a:t>
+            </a:r>
+            <a:endParaRPr lang="en-US" sz="1800" dirty="0"/>
           </a:p>
         </p:txBody>
       </p:sp>
@@ -4500,8 +4498,8 @@
         </p:nvSpPr>
         <p:spPr>
           <a:xfrm>
-            <a:off x="777240" y="2743200"/>
-            <a:ext cx="4846320" cy="2651760"/>
+            <a:off x="777240" y="2487168"/>
+            <a:ext cx="6492240" cy="1051560"/>
           </a:xfrm>
           <a:prstGeom prst="rect">
             <a:avLst/>
@@ -4515,16 +4513,16 @@
           <a:p>
             <a:pPr marL="342900" indent="-342900">
               <a:lnSpc>
-                <a:spcPts val="2100"/>
+                <a:spcPts val="1900"/>
               </a:lnSpc>
               <a:spcAft>
-                <a:spcPts val="1100"/>
+                <a:spcPts val="700"/>
               </a:spcAft>
               <a:buSzPct val="100000"/>
               <a:buChar char="•"/>
             </a:pPr>
             <a:r>
-              <a:rPr lang="en-US" sz="1500" dirty="0">
+              <a:rPr lang="en-US" sz="1400" dirty="0">
                 <a:solidFill>
                   <a:srgbClr val="1A1C2E"/>
                 </a:solidFill>
@@ -4534,21 +4532,21 @@
               </a:rPr>
               <a:t>PIDs propietarios que no están en la norma, con su fórmula</a:t>
             </a:r>
-            <a:endParaRPr lang="en-US" sz="1500" dirty="0"/>
+            <a:endParaRPr lang="en-US" sz="1400" dirty="0"/>
           </a:p>
           <a:p>
             <a:pPr marL="342900" indent="-342900">
               <a:lnSpc>
-                <a:spcPts val="2100"/>
+                <a:spcPts val="1900"/>
               </a:lnSpc>
               <a:spcAft>
-                <a:spcPts val="1100"/>
+                <a:spcPts val="700"/>
               </a:spcAft>
               <a:buSzPct val="100000"/>
               <a:buChar char="•"/>
             </a:pPr>
             <a:r>
-              <a:rPr lang="en-US" sz="1500" dirty="0">
+              <a:rPr lang="en-US" sz="1400" dirty="0">
                 <a:solidFill>
                   <a:srgbClr val="1A1C2E"/>
                 </a:solidFill>
@@ -4558,21 +4556,21 @@
               </a:rPr>
               <a:t>DTCs específicos de un fabricante</a:t>
             </a:r>
-            <a:endParaRPr lang="en-US" sz="1500" dirty="0"/>
+            <a:endParaRPr lang="en-US" sz="1400" dirty="0"/>
           </a:p>
           <a:p>
             <a:pPr marL="342900" indent="-342900">
               <a:lnSpc>
-                <a:spcPts val="2100"/>
+                <a:spcPts val="1900"/>
               </a:lnSpc>
               <a:spcAft>
-                <a:spcPts val="1100"/>
+                <a:spcPts val="700"/>
               </a:spcAft>
               <a:buSzPct val="100000"/>
               <a:buChar char="•"/>
             </a:pPr>
             <a:r>
-              <a:rPr lang="en-US" sz="1500" dirty="0">
+              <a:rPr lang="en-US" sz="1400" dirty="0">
                 <a:solidFill>
                   <a:srgbClr val="1A1C2E"/>
                 </a:solidFill>
@@ -4582,44 +4580,491 @@
               </a:rPr>
               <a:t>Casos resueltos: síntomas, PIDs implicados y solución</a:t>
             </a:r>
+            <a:endParaRPr lang="en-US" sz="1400" dirty="0"/>
+          </a:p>
+        </p:txBody>
+      </p:sp>
+      <p:sp>
+        <p:nvSpPr>
+          <p:cNvPr id="6" name="Text 4"/>
+          <p:cNvSpPr/>
+          <p:nvPr/>
+        </p:nvSpPr>
+        <p:spPr>
+          <a:xfrm>
+            <a:off x="777240" y="3703320"/>
+            <a:ext cx="6492240" cy="320040"/>
+          </a:xfrm>
+          <a:prstGeom prst="rect">
+            <a:avLst/>
+          </a:prstGeom>
+          <a:noFill/>
+          <a:ln/>
+        </p:spPr>
+        <p:txBody>
+          <a:bodyPr wrap="square" lIns="0" tIns="0" rIns="0" bIns="0" rtlCol="0" anchor="t"/>
+          <a:lstStyle/>
+          <a:p>
+            <a:pPr indent="0" marL="0">
+              <a:buNone/>
+            </a:pPr>
+            <a:r>
+              <a:rPr lang="en-US" sz="1500" b="1" dirty="0">
+                <a:solidFill>
+                  <a:srgbClr val="1A1C2E"/>
+                </a:solidFill>
+                <a:latin typeface="Arial" pitchFamily="34" charset="0"/>
+                <a:ea typeface="Arial" pitchFamily="34" charset="-122"/>
+                <a:cs typeface="Arial" pitchFamily="34" charset="-120"/>
+              </a:rPr>
+              <a:t>Un caso resuelto, tal cual se guarda</a:t>
+            </a:r>
             <a:endParaRPr lang="en-US" sz="1500" dirty="0"/>
           </a:p>
-          <a:p>
-            <a:pPr marL="342900" indent="-342900">
+        </p:txBody>
+      </p:sp>
+      <p:sp>
+        <p:nvSpPr>
+          <p:cNvPr id="7" name="Text 5"/>
+          <p:cNvSpPr/>
+          <p:nvPr/>
+        </p:nvSpPr>
+        <p:spPr>
+          <a:xfrm>
+            <a:off x="777240" y="4069080"/>
+            <a:ext cx="1600200" cy="274320"/>
+          </a:xfrm>
+          <a:prstGeom prst="rect">
+            <a:avLst/>
+          </a:prstGeom>
+          <a:noFill/>
+          <a:ln/>
+        </p:spPr>
+        <p:txBody>
+          <a:bodyPr wrap="square" lIns="0" tIns="0" rIns="0" bIns="0" rtlCol="0" anchor="ctr"/>
+          <a:lstStyle/>
+          <a:p>
+            <a:pPr indent="0" marL="0">
+              <a:buNone/>
+            </a:pPr>
+            <a:r>
+              <a:rPr lang="en-US" sz="1200" b="1" dirty="0">
+                <a:solidFill>
+                  <a:srgbClr val="202CFC"/>
+                </a:solidFill>
+                <a:latin typeface="Courier New" pitchFamily="34" charset="0"/>
+                <a:ea typeface="Courier New" pitchFamily="34" charset="-122"/>
+                <a:cs typeface="Courier New" pitchFamily="34" charset="-120"/>
+              </a:rPr>
+              <a:t>embeddedText</a:t>
+            </a:r>
+            <a:endParaRPr lang="en-US" sz="1200" dirty="0"/>
+          </a:p>
+        </p:txBody>
+      </p:sp>
+      <p:sp>
+        <p:nvSpPr>
+          <p:cNvPr id="8" name="Text 6"/>
+          <p:cNvSpPr/>
+          <p:nvPr/>
+        </p:nvSpPr>
+        <p:spPr>
+          <a:xfrm>
+            <a:off x="2468880" y="4069080"/>
+            <a:ext cx="4800600" cy="274320"/>
+          </a:xfrm>
+          <a:prstGeom prst="rect">
+            <a:avLst/>
+          </a:prstGeom>
+          <a:noFill/>
+          <a:ln/>
+        </p:spPr>
+        <p:txBody>
+          <a:bodyPr wrap="square" lIns="0" tIns="0" rIns="0" bIns="0" rtlCol="0" anchor="ctr"/>
+          <a:lstStyle/>
+          <a:p>
+            <a:pPr indent="0" marL="0">
+              <a:buNone/>
+            </a:pPr>
+            <a:r>
+              <a:rPr lang="en-US" sz="1200" dirty="0">
+                <a:solidFill>
+                  <a:srgbClr val="1A1C2E"/>
+                </a:solidFill>
+                <a:latin typeface="Courier New" pitchFamily="34" charset="0"/>
+                <a:ea typeface="Courier New" pitchFamily="34" charset="-122"/>
+                <a:cs typeface="Courier New" pitchFamily="34" charset="-120"/>
+              </a:rPr>
+              <a:t>"Audi A3 2.0 TDI con P0401 y P2002: EGR obstruida</a:t>
+            </a:r>
+            <a:endParaRPr lang="en-US" sz="1200" dirty="0"/>
+          </a:p>
+        </p:txBody>
+      </p:sp>
+      <p:sp>
+        <p:nvSpPr>
+          <p:cNvPr id="9" name="Text 7"/>
+          <p:cNvSpPr/>
+          <p:nvPr/>
+        </p:nvSpPr>
+        <p:spPr>
+          <a:xfrm>
+            <a:off x="2468880" y="4370832"/>
+            <a:ext cx="4800600" cy="274320"/>
+          </a:xfrm>
+          <a:prstGeom prst="rect">
+            <a:avLst/>
+          </a:prstGeom>
+          <a:noFill/>
+          <a:ln/>
+        </p:spPr>
+        <p:txBody>
+          <a:bodyPr wrap="square" lIns="0" tIns="0" rIns="0" bIns="0" rtlCol="0" anchor="ctr"/>
+          <a:lstStyle/>
+          <a:p>
+            <a:pPr indent="0" marL="0">
+              <a:buNone/>
+            </a:pPr>
+            <a:r>
+              <a:rPr lang="en-US" sz="1200" dirty="0">
+                <a:solidFill>
+                  <a:srgbClr val="1A1C2E"/>
+                </a:solidFill>
+                <a:latin typeface="Courier New" pitchFamily="34" charset="0"/>
+                <a:ea typeface="Courier New" pitchFamily="34" charset="-122"/>
+                <a:cs typeface="Courier New" pitchFamily="34" charset="-120"/>
+              </a:rPr>
+              <a:t> por carbonilla de un motor que consume aceite"</a:t>
+            </a:r>
+            <a:endParaRPr lang="en-US" sz="1200" dirty="0"/>
+          </a:p>
+        </p:txBody>
+      </p:sp>
+      <p:sp>
+        <p:nvSpPr>
+          <p:cNvPr id="10" name="Text 8"/>
+          <p:cNvSpPr/>
+          <p:nvPr/>
+        </p:nvSpPr>
+        <p:spPr>
+          <a:xfrm>
+            <a:off x="777240" y="4672584"/>
+            <a:ext cx="1600200" cy="274320"/>
+          </a:xfrm>
+          <a:prstGeom prst="rect">
+            <a:avLst/>
+          </a:prstGeom>
+          <a:noFill/>
+          <a:ln/>
+        </p:spPr>
+        <p:txBody>
+          <a:bodyPr wrap="square" lIns="0" tIns="0" rIns="0" bIns="0" rtlCol="0" anchor="ctr"/>
+          <a:lstStyle/>
+          <a:p>
+            <a:pPr indent="0" marL="0">
+              <a:buNone/>
+            </a:pPr>
+            <a:r>
+              <a:rPr lang="en-US" sz="1200" b="1" dirty="0">
+                <a:solidFill>
+                  <a:srgbClr val="202CFC"/>
+                </a:solidFill>
+                <a:latin typeface="Courier New" pitchFamily="34" charset="0"/>
+                <a:ea typeface="Courier New" pitchFamily="34" charset="-122"/>
+                <a:cs typeface="Courier New" pitchFamily="34" charset="-120"/>
+              </a:rPr>
+              <a:t>symptoms</a:t>
+            </a:r>
+            <a:endParaRPr lang="en-US" sz="1200" dirty="0"/>
+          </a:p>
+        </p:txBody>
+      </p:sp>
+      <p:sp>
+        <p:nvSpPr>
+          <p:cNvPr id="11" name="Text 9"/>
+          <p:cNvSpPr/>
+          <p:nvPr/>
+        </p:nvSpPr>
+        <p:spPr>
+          <a:xfrm>
+            <a:off x="2468880" y="4672584"/>
+            <a:ext cx="4800600" cy="274320"/>
+          </a:xfrm>
+          <a:prstGeom prst="rect">
+            <a:avLst/>
+          </a:prstGeom>
+          <a:noFill/>
+          <a:ln/>
+        </p:spPr>
+        <p:txBody>
+          <a:bodyPr wrap="square" lIns="0" tIns="0" rIns="0" bIns="0" rtlCol="0" anchor="ctr"/>
+          <a:lstStyle/>
+          <a:p>
+            <a:pPr indent="0" marL="0">
+              <a:buNone/>
+            </a:pPr>
+            <a:r>
+              <a:rPr lang="en-US" sz="1200" dirty="0">
+                <a:solidFill>
+                  <a:srgbClr val="1A1C2E"/>
+                </a:solidFill>
+                <a:latin typeface="Courier New" pitchFamily="34" charset="0"/>
+                <a:ea typeface="Courier New" pitchFamily="34" charset="-122"/>
+                <a:cs typeface="Courier New" pitchFamily="34" charset="-120"/>
+              </a:rPr>
+              <a:t>ralentí inestable · pérdida de potencia</a:t>
+            </a:r>
+            <a:endParaRPr lang="en-US" sz="1200" dirty="0"/>
+          </a:p>
+        </p:txBody>
+      </p:sp>
+      <p:sp>
+        <p:nvSpPr>
+          <p:cNvPr id="12" name="Text 10"/>
+          <p:cNvSpPr/>
+          <p:nvPr/>
+        </p:nvSpPr>
+        <p:spPr>
+          <a:xfrm>
+            <a:off x="777240" y="4974336"/>
+            <a:ext cx="1600200" cy="274320"/>
+          </a:xfrm>
+          <a:prstGeom prst="rect">
+            <a:avLst/>
+          </a:prstGeom>
+          <a:noFill/>
+          <a:ln/>
+        </p:spPr>
+        <p:txBody>
+          <a:bodyPr wrap="square" lIns="0" tIns="0" rIns="0" bIns="0" rtlCol="0" anchor="ctr"/>
+          <a:lstStyle/>
+          <a:p>
+            <a:pPr indent="0" marL="0">
+              <a:buNone/>
+            </a:pPr>
+            <a:r>
+              <a:rPr lang="en-US" sz="1200" b="1" dirty="0">
+                <a:solidFill>
+                  <a:srgbClr val="202CFC"/>
+                </a:solidFill>
+                <a:latin typeface="Courier New" pitchFamily="34" charset="0"/>
+                <a:ea typeface="Courier New" pitchFamily="34" charset="-122"/>
+                <a:cs typeface="Courier New" pitchFamily="34" charset="-120"/>
+              </a:rPr>
+              <a:t>pidsInvolved</a:t>
+            </a:r>
+            <a:endParaRPr lang="en-US" sz="1200" dirty="0"/>
+          </a:p>
+        </p:txBody>
+      </p:sp>
+      <p:sp>
+        <p:nvSpPr>
+          <p:cNvPr id="13" name="Text 11"/>
+          <p:cNvSpPr/>
+          <p:nvPr/>
+        </p:nvSpPr>
+        <p:spPr>
+          <a:xfrm>
+            <a:off x="2468880" y="4974336"/>
+            <a:ext cx="4800600" cy="274320"/>
+          </a:xfrm>
+          <a:prstGeom prst="rect">
+            <a:avLst/>
+          </a:prstGeom>
+          <a:noFill/>
+          <a:ln/>
+        </p:spPr>
+        <p:txBody>
+          <a:bodyPr wrap="square" lIns="0" tIns="0" rIns="0" bIns="0" rtlCol="0" anchor="ctr"/>
+          <a:lstStyle/>
+          <a:p>
+            <a:pPr indent="0" marL="0">
+              <a:buNone/>
+            </a:pPr>
+            <a:r>
+              <a:rPr lang="en-US" sz="1200" dirty="0">
+                <a:solidFill>
+                  <a:srgbClr val="1A1C2E"/>
+                </a:solidFill>
+                <a:latin typeface="Courier New" pitchFamily="34" charset="0"/>
+                <a:ea typeface="Courier New" pitchFamily="34" charset="-122"/>
+                <a:cs typeface="Courier New" pitchFamily="34" charset="-120"/>
+              </a:rPr>
+              <a:t>010C · 0105 · 22F40C</a:t>
+            </a:r>
+            <a:endParaRPr lang="en-US" sz="1200" dirty="0"/>
+          </a:p>
+        </p:txBody>
+      </p:sp>
+      <p:sp>
+        <p:nvSpPr>
+          <p:cNvPr id="14" name="Text 12"/>
+          <p:cNvSpPr/>
+          <p:nvPr/>
+        </p:nvSpPr>
+        <p:spPr>
+          <a:xfrm>
+            <a:off x="777240" y="5276088"/>
+            <a:ext cx="1600200" cy="274320"/>
+          </a:xfrm>
+          <a:prstGeom prst="rect">
+            <a:avLst/>
+          </a:prstGeom>
+          <a:noFill/>
+          <a:ln/>
+        </p:spPr>
+        <p:txBody>
+          <a:bodyPr wrap="square" lIns="0" tIns="0" rIns="0" bIns="0" rtlCol="0" anchor="ctr"/>
+          <a:lstStyle/>
+          <a:p>
+            <a:pPr indent="0" marL="0">
+              <a:buNone/>
+            </a:pPr>
+            <a:r>
+              <a:rPr lang="en-US" sz="1200" b="1" dirty="0">
+                <a:solidFill>
+                  <a:srgbClr val="202CFC"/>
+                </a:solidFill>
+                <a:latin typeface="Courier New" pitchFamily="34" charset="0"/>
+                <a:ea typeface="Courier New" pitchFamily="34" charset="-122"/>
+                <a:cs typeface="Courier New" pitchFamily="34" charset="-120"/>
+              </a:rPr>
+              <a:t>confidence</a:t>
+            </a:r>
+            <a:endParaRPr lang="en-US" sz="1200" dirty="0"/>
+          </a:p>
+        </p:txBody>
+      </p:sp>
+      <p:sp>
+        <p:nvSpPr>
+          <p:cNvPr id="15" name="Text 13"/>
+          <p:cNvSpPr/>
+          <p:nvPr/>
+        </p:nvSpPr>
+        <p:spPr>
+          <a:xfrm>
+            <a:off x="2468880" y="5276088"/>
+            <a:ext cx="4800600" cy="274320"/>
+          </a:xfrm>
+          <a:prstGeom prst="rect">
+            <a:avLst/>
+          </a:prstGeom>
+          <a:noFill/>
+          <a:ln/>
+        </p:spPr>
+        <p:txBody>
+          <a:bodyPr wrap="square" lIns="0" tIns="0" rIns="0" bIns="0" rtlCol="0" anchor="ctr"/>
+          <a:lstStyle/>
+          <a:p>
+            <a:pPr indent="0" marL="0">
+              <a:buNone/>
+            </a:pPr>
+            <a:r>
+              <a:rPr lang="en-US" sz="1200" dirty="0">
+                <a:solidFill>
+                  <a:srgbClr val="1A1C2E"/>
+                </a:solidFill>
+                <a:latin typeface="Courier New" pitchFamily="34" charset="0"/>
+                <a:ea typeface="Courier New" pitchFamily="34" charset="-122"/>
+                <a:cs typeface="Courier New" pitchFamily="34" charset="-120"/>
+              </a:rPr>
+              <a:t>0,5   ·   manufacturer Audi · model A3</a:t>
+            </a:r>
+            <a:endParaRPr lang="en-US" sz="1200" dirty="0"/>
+          </a:p>
+        </p:txBody>
+      </p:sp>
+      <p:sp>
+        <p:nvSpPr>
+          <p:cNvPr id="16" name="Text 14"/>
+          <p:cNvSpPr/>
+          <p:nvPr/>
+        </p:nvSpPr>
+        <p:spPr>
+          <a:xfrm>
+            <a:off x="7635240" y="2057400"/>
+            <a:ext cx="3749040" cy="320040"/>
+          </a:xfrm>
+          <a:prstGeom prst="rect">
+            <a:avLst/>
+          </a:prstGeom>
+          <a:noFill/>
+          <a:ln/>
+        </p:spPr>
+        <p:txBody>
+          <a:bodyPr wrap="square" lIns="0" tIns="0" rIns="0" bIns="0" rtlCol="0" anchor="t"/>
+          <a:lstStyle/>
+          <a:p>
+            <a:pPr indent="0" marL="0">
+              <a:buNone/>
+            </a:pPr>
+            <a:r>
+              <a:rPr lang="en-US" sz="1800" b="1" dirty="0">
+                <a:solidFill>
+                  <a:srgbClr val="202CFC"/>
+                </a:solidFill>
+                <a:latin typeface="Arial" pitchFamily="34" charset="0"/>
+                <a:ea typeface="Arial" pitchFamily="34" charset="-122"/>
+                <a:cs typeface="Arial" pitchFamily="34" charset="-120"/>
+              </a:rPr>
+              <a:t>Índice de confianza</a:t>
+            </a:r>
+            <a:endParaRPr lang="en-US" sz="1800" dirty="0"/>
+          </a:p>
+        </p:txBody>
+      </p:sp>
+      <p:sp>
+        <p:nvSpPr>
+          <p:cNvPr id="17" name="Text 15"/>
+          <p:cNvSpPr/>
+          <p:nvPr/>
+        </p:nvSpPr>
+        <p:spPr>
+          <a:xfrm>
+            <a:off x="7635240" y="2450592"/>
+            <a:ext cx="3749040" cy="502920"/>
+          </a:xfrm>
+          <a:prstGeom prst="rect">
+            <a:avLst/>
+          </a:prstGeom>
+          <a:noFill/>
+          <a:ln/>
+        </p:spPr>
+        <p:txBody>
+          <a:bodyPr wrap="square" lIns="0" tIns="0" rIns="0" bIns="0" rtlCol="0" anchor="t"/>
+          <a:lstStyle/>
+          <a:p>
+            <a:pPr indent="0" marL="0">
               <a:lnSpc>
-                <a:spcPts val="2100"/>
+                <a:spcPts val="1800"/>
               </a:lnSpc>
-              <a:spcAft>
-                <a:spcPts val="1100"/>
-              </a:spcAft>
-              <a:buSzPct val="100000"/>
-              <a:buChar char="•"/>
-            </a:pPr>
-            <a:r>
-              <a:rPr lang="en-US" sz="1500" dirty="0">
-                <a:solidFill>
-                  <a:srgbClr val="1A1C2E"/>
+              <a:buNone/>
+            </a:pPr>
+            <a:r>
+              <a:rPr lang="en-US" sz="1300" dirty="0">
+                <a:solidFill>
+                  <a:srgbClr val="5A5F73"/>
                 </a:solidFill>
                 <a:latin typeface="Calibri" pitchFamily="34" charset="0"/>
                 <a:ea typeface="Calibri" pitchFamily="34" charset="-122"/>
                 <a:cs typeface="Calibri" pitchFamily="34" charset="-120"/>
               </a:rPr>
-              <a:t>Cada entrada es un texto vectorizado, más fabricante y modelo para filtrar</a:t>
-            </a:r>
-            <a:endParaRPr lang="en-US" sz="1500" dirty="0"/>
-          </a:p>
-        </p:txBody>
-      </p:sp>
-      <p:sp>
-        <p:nvSpPr>
-          <p:cNvPr id="6" name="Text 4"/>
-          <p:cNvSpPr/>
-          <p:nvPr/>
-        </p:nvSpPr>
-        <p:spPr>
-          <a:xfrm>
-            <a:off x="6537960" y="2194560"/>
-            <a:ext cx="4846320" cy="365760"/>
+              <a:t>Se lo ponemos nosotros al guardar, según de dónde salga el dato.</a:t>
+            </a:r>
+            <a:endParaRPr lang="en-US" sz="1300" dirty="0"/>
+          </a:p>
+        </p:txBody>
+      </p:sp>
+      <p:sp>
+        <p:nvSpPr>
+          <p:cNvPr id="18" name="Text 16"/>
+          <p:cNvSpPr/>
+          <p:nvPr/>
+        </p:nvSpPr>
+        <p:spPr>
+          <a:xfrm>
+            <a:off x="7635240" y="3108960"/>
+            <a:ext cx="640080" cy="310896"/>
           </a:xfrm>
           <a:prstGeom prst="rect">
             <a:avLst/>
@@ -4635,46 +5080,88 @@
               <a:buNone/>
             </a:pPr>
             <a:r>
-              <a:rPr lang="en-US" sz="1900" b="1" dirty="0">
-                <a:solidFill>
-                  <a:srgbClr val="202CFC"/>
+              <a:rPr lang="en-US" sz="1700" b="1" dirty="0">
+                <a:solidFill>
+                  <a:srgbClr val="1A1C2E"/>
                 </a:solidFill>
                 <a:latin typeface="Arial" pitchFamily="34" charset="0"/>
                 <a:ea typeface="Arial" pitchFamily="34" charset="-122"/>
                 <a:cs typeface="Arial" pitchFamily="34" charset="-120"/>
               </a:rPr>
-              <a:t>Cada dato lleva de dónde salió</a:t>
-            </a:r>
-            <a:endParaRPr lang="en-US" sz="1900" dirty="0"/>
-          </a:p>
-        </p:txBody>
-      </p:sp>
-      <p:sp>
-        <p:nvSpPr>
-          <p:cNvPr id="7" name="Text 5"/>
-          <p:cNvSpPr/>
-          <p:nvPr/>
-        </p:nvSpPr>
-        <p:spPr>
-          <a:xfrm>
-            <a:off x="6537960" y="2788920"/>
-            <a:ext cx="685800" cy="347472"/>
-          </a:xfrm>
-          <a:prstGeom prst="rect">
-            <a:avLst/>
-          </a:prstGeom>
-          <a:noFill/>
-          <a:ln/>
-        </p:spPr>
-        <p:txBody>
-          <a:bodyPr wrap="square" lIns="0" tIns="0" rIns="0" bIns="0" rtlCol="0" anchor="ctr"/>
+              <a:t>0,3</a:t>
+            </a:r>
+            <a:endParaRPr lang="en-US" sz="1700" dirty="0"/>
+          </a:p>
+        </p:txBody>
+      </p:sp>
+      <p:sp>
+        <p:nvSpPr>
+          <p:cNvPr id="19" name="Text 17"/>
+          <p:cNvSpPr/>
+          <p:nvPr/>
+        </p:nvSpPr>
+        <p:spPr>
+          <a:xfrm>
+            <a:off x="8321040" y="3108960"/>
+            <a:ext cx="3063240" cy="502920"/>
+          </a:xfrm>
+          <a:prstGeom prst="rect">
+            <a:avLst/>
+          </a:prstGeom>
+          <a:noFill/>
+          <a:ln/>
+        </p:spPr>
+        <p:txBody>
+          <a:bodyPr wrap="square" lIns="0" tIns="0" rIns="0" bIns="0" rtlCol="0" anchor="t"/>
           <a:lstStyle/>
           <a:p>
             <a:pPr indent="0" marL="0">
-              <a:buNone/>
-            </a:pPr>
-            <a:r>
-              <a:rPr lang="en-US" sz="1800" b="1" dirty="0">
+              <a:lnSpc>
+                <a:spcPts val="1700"/>
+              </a:lnSpc>
+              <a:buNone/>
+            </a:pPr>
+            <a:r>
+              <a:rPr lang="en-US" sz="1300" dirty="0">
+                <a:solidFill>
+                  <a:srgbClr val="1A1C2E"/>
+                </a:solidFill>
+                <a:latin typeface="Calibri" pitchFamily="34" charset="0"/>
+                <a:ea typeface="Calibri" pitchFamily="34" charset="-122"/>
+                <a:cs typeface="Calibri" pitchFamily="34" charset="-120"/>
+              </a:rPr>
+              <a:t>lo encontró el agente en internet</a:t>
+            </a:r>
+            <a:endParaRPr lang="en-US" sz="1300" dirty="0"/>
+          </a:p>
+        </p:txBody>
+      </p:sp>
+      <p:sp>
+        <p:nvSpPr>
+          <p:cNvPr id="20" name="Text 18"/>
+          <p:cNvSpPr/>
+          <p:nvPr/>
+        </p:nvSpPr>
+        <p:spPr>
+          <a:xfrm>
+            <a:off x="7635240" y="3675888"/>
+            <a:ext cx="640080" cy="310896"/>
+          </a:xfrm>
+          <a:prstGeom prst="rect">
+            <a:avLst/>
+          </a:prstGeom>
+          <a:noFill/>
+          <a:ln/>
+        </p:spPr>
+        <p:txBody>
+          <a:bodyPr wrap="square" lIns="0" tIns="0" rIns="0" bIns="0" rtlCol="0" anchor="t"/>
+          <a:lstStyle/>
+          <a:p>
+            <a:pPr indent="0" marL="0">
+              <a:buNone/>
+            </a:pPr>
+            <a:r>
+              <a:rPr lang="en-US" sz="1700" b="1" dirty="0">
                 <a:solidFill>
                   <a:srgbClr val="1A1C2E"/>
                 </a:solidFill>
@@ -4682,38 +5169,41 @@
                 <a:ea typeface="Arial" pitchFamily="34" charset="-122"/>
                 <a:cs typeface="Arial" pitchFamily="34" charset="-120"/>
               </a:rPr>
-              <a:t>0,3</a:t>
-            </a:r>
-            <a:endParaRPr lang="en-US" sz="1800" dirty="0"/>
-          </a:p>
-        </p:txBody>
-      </p:sp>
-      <p:sp>
-        <p:nvSpPr>
-          <p:cNvPr id="8" name="Text 6"/>
-          <p:cNvSpPr/>
-          <p:nvPr/>
-        </p:nvSpPr>
-        <p:spPr>
-          <a:xfrm>
-            <a:off x="7315200" y="2788920"/>
-            <a:ext cx="4069080" cy="347472"/>
-          </a:xfrm>
-          <a:prstGeom prst="rect">
-            <a:avLst/>
-          </a:prstGeom>
-          <a:noFill/>
-          <a:ln/>
-        </p:spPr>
-        <p:txBody>
-          <a:bodyPr wrap="square" lIns="0" tIns="0" rIns="0" bIns="0" rtlCol="0" anchor="ctr"/>
+              <a:t>0,5</a:t>
+            </a:r>
+            <a:endParaRPr lang="en-US" sz="1700" dirty="0"/>
+          </a:p>
+        </p:txBody>
+      </p:sp>
+      <p:sp>
+        <p:nvSpPr>
+          <p:cNvPr id="21" name="Text 19"/>
+          <p:cNvSpPr/>
+          <p:nvPr/>
+        </p:nvSpPr>
+        <p:spPr>
+          <a:xfrm>
+            <a:off x="8321040" y="3675888"/>
+            <a:ext cx="3063240" cy="502920"/>
+          </a:xfrm>
+          <a:prstGeom prst="rect">
+            <a:avLst/>
+          </a:prstGeom>
+          <a:noFill/>
+          <a:ln/>
+        </p:spPr>
+        <p:txBody>
+          <a:bodyPr wrap="square" lIns="0" tIns="0" rIns="0" bIns="0" rtlCol="0" anchor="t"/>
           <a:lstStyle/>
           <a:p>
             <a:pPr indent="0" marL="0">
-              <a:buNone/>
-            </a:pPr>
-            <a:r>
-              <a:rPr lang="en-US" sz="1500" dirty="0">
+              <a:lnSpc>
+                <a:spcPts val="1700"/>
+              </a:lnSpc>
+              <a:buNone/>
+            </a:pPr>
+            <a:r>
+              <a:rPr lang="en-US" sz="1300" dirty="0">
                 <a:solidFill>
                   <a:srgbClr val="1A1C2E"/>
                 </a:solidFill>
@@ -4721,38 +5211,38 @@
                 <a:ea typeface="Calibri" pitchFamily="34" charset="-122"/>
                 <a:cs typeface="Calibri" pitchFamily="34" charset="-120"/>
               </a:rPr>
-              <a:t>lo encontró el agente en internet</a:t>
-            </a:r>
-            <a:endParaRPr lang="en-US" sz="1500" dirty="0"/>
-          </a:p>
-        </p:txBody>
-      </p:sp>
-      <p:sp>
-        <p:nvSpPr>
-          <p:cNvPr id="9" name="Text 7"/>
-          <p:cNvSpPr/>
-          <p:nvPr/>
-        </p:nvSpPr>
-        <p:spPr>
-          <a:xfrm>
-            <a:off x="6537960" y="3264408"/>
-            <a:ext cx="685800" cy="347472"/>
-          </a:xfrm>
-          <a:prstGeom prst="rect">
-            <a:avLst/>
-          </a:prstGeom>
-          <a:noFill/>
-          <a:ln/>
-        </p:spPr>
-        <p:txBody>
-          <a:bodyPr wrap="square" lIns="0" tIns="0" rIns="0" bIns="0" rtlCol="0" anchor="ctr"/>
+              <a:t>viene de un diagnóstico anterior</a:t>
+            </a:r>
+            <a:endParaRPr lang="en-US" sz="1300" dirty="0"/>
+          </a:p>
+        </p:txBody>
+      </p:sp>
+      <p:sp>
+        <p:nvSpPr>
+          <p:cNvPr id="22" name="Text 20"/>
+          <p:cNvSpPr/>
+          <p:nvPr/>
+        </p:nvSpPr>
+        <p:spPr>
+          <a:xfrm>
+            <a:off x="7635240" y="4242816"/>
+            <a:ext cx="640080" cy="310896"/>
+          </a:xfrm>
+          <a:prstGeom prst="rect">
+            <a:avLst/>
+          </a:prstGeom>
+          <a:noFill/>
+          <a:ln/>
+        </p:spPr>
+        <p:txBody>
+          <a:bodyPr wrap="square" lIns="0" tIns="0" rIns="0" bIns="0" rtlCol="0" anchor="t"/>
           <a:lstStyle/>
           <a:p>
             <a:pPr indent="0" marL="0">
               <a:buNone/>
             </a:pPr>
             <a:r>
-              <a:rPr lang="en-US" sz="1800" b="1" dirty="0">
+              <a:rPr lang="en-US" sz="1700" b="1" dirty="0">
                 <a:solidFill>
                   <a:srgbClr val="1A1C2E"/>
                 </a:solidFill>
@@ -4760,38 +5250,41 @@
                 <a:ea typeface="Arial" pitchFamily="34" charset="-122"/>
                 <a:cs typeface="Arial" pitchFamily="34" charset="-120"/>
               </a:rPr>
-              <a:t>0,5</a:t>
-            </a:r>
-            <a:endParaRPr lang="en-US" sz="1800" dirty="0"/>
-          </a:p>
-        </p:txBody>
-      </p:sp>
-      <p:sp>
-        <p:nvSpPr>
-          <p:cNvPr id="10" name="Text 8"/>
-          <p:cNvSpPr/>
-          <p:nvPr/>
-        </p:nvSpPr>
-        <p:spPr>
-          <a:xfrm>
-            <a:off x="7315200" y="3264408"/>
-            <a:ext cx="4069080" cy="347472"/>
-          </a:xfrm>
-          <a:prstGeom prst="rect">
-            <a:avLst/>
-          </a:prstGeom>
-          <a:noFill/>
-          <a:ln/>
-        </p:spPr>
-        <p:txBody>
-          <a:bodyPr wrap="square" lIns="0" tIns="0" rIns="0" bIns="0" rtlCol="0" anchor="ctr"/>
+              <a:t>0,8</a:t>
+            </a:r>
+            <a:endParaRPr lang="en-US" sz="1700" dirty="0"/>
+          </a:p>
+        </p:txBody>
+      </p:sp>
+      <p:sp>
+        <p:nvSpPr>
+          <p:cNvPr id="23" name="Text 21"/>
+          <p:cNvSpPr/>
+          <p:nvPr/>
+        </p:nvSpPr>
+        <p:spPr>
+          <a:xfrm>
+            <a:off x="8321040" y="4242816"/>
+            <a:ext cx="3063240" cy="502920"/>
+          </a:xfrm>
+          <a:prstGeom prst="rect">
+            <a:avLst/>
+          </a:prstGeom>
+          <a:noFill/>
+          <a:ln/>
+        </p:spPr>
+        <p:txBody>
+          <a:bodyPr wrap="square" lIns="0" tIns="0" rIns="0" bIns="0" rtlCol="0" anchor="t"/>
           <a:lstStyle/>
           <a:p>
             <a:pPr indent="0" marL="0">
-              <a:buNone/>
-            </a:pPr>
-            <a:r>
-              <a:rPr lang="en-US" sz="1500" dirty="0">
+              <a:lnSpc>
+                <a:spcPts val="1700"/>
+              </a:lnSpc>
+              <a:buNone/>
+            </a:pPr>
+            <a:r>
+              <a:rPr lang="en-US" sz="1300" dirty="0">
                 <a:solidFill>
                   <a:srgbClr val="1A1C2E"/>
                 </a:solidFill>
@@ -4799,38 +5292,38 @@
                 <a:ea typeface="Calibri" pitchFamily="34" charset="-122"/>
                 <a:cs typeface="Calibri" pitchFamily="34" charset="-120"/>
               </a:rPr>
-              <a:t>viene de un diagnóstico anterior</a:t>
-            </a:r>
-            <a:endParaRPr lang="en-US" sz="1500" dirty="0"/>
-          </a:p>
-        </p:txBody>
-      </p:sp>
-      <p:sp>
-        <p:nvSpPr>
-          <p:cNvPr id="11" name="Text 9"/>
-          <p:cNvSpPr/>
-          <p:nvPr/>
-        </p:nvSpPr>
-        <p:spPr>
-          <a:xfrm>
-            <a:off x="6537960" y="3739896"/>
-            <a:ext cx="685800" cy="347472"/>
-          </a:xfrm>
-          <a:prstGeom prst="rect">
-            <a:avLst/>
-          </a:prstGeom>
-          <a:noFill/>
-          <a:ln/>
-        </p:spPr>
-        <p:txBody>
-          <a:bodyPr wrap="square" lIns="0" tIns="0" rIns="0" bIns="0" rtlCol="0" anchor="ctr"/>
+              <a:t>lo aportó el mecánico a mano</a:t>
+            </a:r>
+            <a:endParaRPr lang="en-US" sz="1300" dirty="0"/>
+          </a:p>
+        </p:txBody>
+      </p:sp>
+      <p:sp>
+        <p:nvSpPr>
+          <p:cNvPr id="24" name="Text 22"/>
+          <p:cNvSpPr/>
+          <p:nvPr/>
+        </p:nvSpPr>
+        <p:spPr>
+          <a:xfrm>
+            <a:off x="7635240" y="4809744"/>
+            <a:ext cx="640080" cy="310896"/>
+          </a:xfrm>
+          <a:prstGeom prst="rect">
+            <a:avLst/>
+          </a:prstGeom>
+          <a:noFill/>
+          <a:ln/>
+        </p:spPr>
+        <p:txBody>
+          <a:bodyPr wrap="square" lIns="0" tIns="0" rIns="0" bIns="0" rtlCol="0" anchor="t"/>
           <a:lstStyle/>
           <a:p>
             <a:pPr indent="0" marL="0">
               <a:buNone/>
             </a:pPr>
             <a:r>
-              <a:rPr lang="en-US" sz="1800" b="1" dirty="0">
+              <a:rPr lang="en-US" sz="1700" b="1" dirty="0">
                 <a:solidFill>
                   <a:srgbClr val="1A1C2E"/>
                 </a:solidFill>
@@ -4838,38 +5331,41 @@
                 <a:ea typeface="Arial" pitchFamily="34" charset="-122"/>
                 <a:cs typeface="Arial" pitchFamily="34" charset="-120"/>
               </a:rPr>
-              <a:t>0,8</a:t>
-            </a:r>
-            <a:endParaRPr lang="en-US" sz="1800" dirty="0"/>
-          </a:p>
-        </p:txBody>
-      </p:sp>
-      <p:sp>
-        <p:nvSpPr>
-          <p:cNvPr id="12" name="Text 10"/>
-          <p:cNvSpPr/>
-          <p:nvPr/>
-        </p:nvSpPr>
-        <p:spPr>
-          <a:xfrm>
-            <a:off x="7315200" y="3739896"/>
-            <a:ext cx="4069080" cy="347472"/>
-          </a:xfrm>
-          <a:prstGeom prst="rect">
-            <a:avLst/>
-          </a:prstGeom>
-          <a:noFill/>
-          <a:ln/>
-        </p:spPr>
-        <p:txBody>
-          <a:bodyPr wrap="square" lIns="0" tIns="0" rIns="0" bIns="0" rtlCol="0" anchor="ctr"/>
+              <a:t>1,0</a:t>
+            </a:r>
+            <a:endParaRPr lang="en-US" sz="1700" dirty="0"/>
+          </a:p>
+        </p:txBody>
+      </p:sp>
+      <p:sp>
+        <p:nvSpPr>
+          <p:cNvPr id="25" name="Text 23"/>
+          <p:cNvSpPr/>
+          <p:nvPr/>
+        </p:nvSpPr>
+        <p:spPr>
+          <a:xfrm>
+            <a:off x="8321040" y="4809744"/>
+            <a:ext cx="3063240" cy="502920"/>
+          </a:xfrm>
+          <a:prstGeom prst="rect">
+            <a:avLst/>
+          </a:prstGeom>
+          <a:noFill/>
+          <a:ln/>
+        </p:spPr>
+        <p:txBody>
+          <a:bodyPr wrap="square" lIns="0" tIns="0" rIns="0" bIns="0" rtlCol="0" anchor="t"/>
           <a:lstStyle/>
           <a:p>
             <a:pPr indent="0" marL="0">
-              <a:buNone/>
-            </a:pPr>
-            <a:r>
-              <a:rPr lang="en-US" sz="1500" dirty="0">
+              <a:lnSpc>
+                <a:spcPts val="1700"/>
+              </a:lnSpc>
+              <a:buNone/>
+            </a:pPr>
+            <a:r>
+              <a:rPr lang="en-US" sz="1300" dirty="0">
                 <a:solidFill>
                   <a:srgbClr val="1A1C2E"/>
                 </a:solidFill>
@@ -4877,22 +5373,123 @@
                 <a:ea typeface="Calibri" pitchFamily="34" charset="-122"/>
                 <a:cs typeface="Calibri" pitchFamily="34" charset="-120"/>
               </a:rPr>
-              <a:t>lo aportó el mecánico a mano</a:t>
-            </a:r>
-            <a:endParaRPr lang="en-US" sz="1500" dirty="0"/>
-          </a:p>
-        </p:txBody>
-      </p:sp>
-      <p:sp>
-        <p:nvSpPr>
-          <p:cNvPr id="13" name="Text 11"/>
-          <p:cNvSpPr/>
-          <p:nvPr/>
-        </p:nvSpPr>
-        <p:spPr>
-          <a:xfrm>
-            <a:off x="6537960" y="4215384"/>
-            <a:ext cx="685800" cy="347472"/>
+              <a:t>se ha leído del coche por OBD</a:t>
+            </a:r>
+            <a:endParaRPr lang="en-US" sz="1300" dirty="0"/>
+          </a:p>
+        </p:txBody>
+      </p:sp>
+      <p:sp>
+        <p:nvSpPr>
+          <p:cNvPr id="26" name="Text 24"/>
+          <p:cNvSpPr/>
+          <p:nvPr/>
+        </p:nvSpPr>
+        <p:spPr>
+          <a:xfrm>
+            <a:off x="7635240" y="5440680"/>
+            <a:ext cx="3749040" cy="457200"/>
+          </a:xfrm>
+          <a:prstGeom prst="rect">
+            <a:avLst/>
+          </a:prstGeom>
+          <a:noFill/>
+          <a:ln/>
+        </p:spPr>
+        <p:txBody>
+          <a:bodyPr wrap="square" lIns="0" tIns="0" rIns="0" bIns="0" rtlCol="0" anchor="t"/>
+          <a:lstStyle/>
+          <a:p>
+            <a:pPr indent="0" marL="0">
+              <a:lnSpc>
+                <a:spcPts val="1700"/>
+              </a:lnSpc>
+              <a:buNone/>
+            </a:pPr>
+            <a:r>
+              <a:rPr lang="en-US" sz="1300" dirty="0">
+                <a:solidFill>
+                  <a:srgbClr val="5A5F73"/>
+                </a:solidFill>
+                <a:latin typeface="Calibri" pitchFamily="34" charset="0"/>
+                <a:ea typeface="Calibri" pitchFamily="34" charset="-122"/>
+                <a:cs typeface="Calibri" pitchFamily="34" charset="-120"/>
+              </a:rPr>
+              <a:t>Validar contra el coche sube la web a 0,7 y al mecánico a 0,9.</a:t>
+            </a:r>
+            <a:endParaRPr lang="en-US" sz="1300" dirty="0"/>
+          </a:p>
+        </p:txBody>
+      </p:sp>
+      <p:sp>
+        <p:nvSpPr>
+          <p:cNvPr id="27" name="Text 25"/>
+          <p:cNvSpPr/>
+          <p:nvPr/>
+        </p:nvSpPr>
+        <p:spPr>
+          <a:xfrm>
+            <a:off x="777240" y="5779008"/>
+            <a:ext cx="6492240" cy="292608"/>
+          </a:xfrm>
+          <a:prstGeom prst="rect">
+            <a:avLst/>
+          </a:prstGeom>
+          <a:noFill/>
+          <a:ln/>
+        </p:spPr>
+        <p:txBody>
+          <a:bodyPr wrap="square" lIns="0" tIns="0" rIns="0" bIns="0" rtlCol="0" anchor="t"/>
+          <a:lstStyle/>
+          <a:p>
+            <a:pPr indent="0" marL="0">
+              <a:buNone/>
+            </a:pPr>
+            <a:r>
+              <a:rPr lang="en-US" sz="1300" dirty="0">
+                <a:solidFill>
+                  <a:srgbClr val="5A5F73"/>
+                </a:solidFill>
+                <a:latin typeface="Calibri" pitchFamily="34" charset="0"/>
+                <a:ea typeface="Calibri" pitchFamily="34" charset="-122"/>
+                <a:cs typeface="Calibri" pitchFamily="34" charset="-120"/>
+              </a:rPr>
+              <a:t>Ese índice pondera las búsquedas: gana la respuesta con más confianza.</a:t>
+            </a:r>
+            <a:endParaRPr lang="en-US" sz="1300" dirty="0"/>
+          </a:p>
+        </p:txBody>
+      </p:sp>
+      <p:sp>
+        <p:nvSpPr>
+          <p:cNvPr id="28" name="Shape 26"/>
+          <p:cNvSpPr/>
+          <p:nvPr/>
+        </p:nvSpPr>
+        <p:spPr>
+          <a:xfrm>
+            <a:off x="777240" y="6263640"/>
+            <a:ext cx="219456" cy="219456"/>
+          </a:xfrm>
+          <a:prstGeom prst="rect">
+            <a:avLst/>
+          </a:prstGeom>
+          <a:solidFill>
+            <a:srgbClr val="202CFC"/>
+          </a:solidFill>
+          <a:ln/>
+        </p:spPr>
+      </p:sp>
+      <p:sp>
+        <p:nvSpPr>
+          <p:cNvPr id="29" name="Text 27"/>
+          <p:cNvSpPr/>
+          <p:nvPr/>
+        </p:nvSpPr>
+        <p:spPr>
+          <a:xfrm>
+            <a:off x="777240" y="6263640"/>
+            <a:ext cx="219456" cy="219456"/>
           </a:xfrm>
           <a:prstGeom prst="rect">
             <a:avLst/>
@@ -4904,34 +5501,34 @@
           <a:bodyPr wrap="square" lIns="0" tIns="0" rIns="0" bIns="0" rtlCol="0" anchor="ctr"/>
           <a:lstStyle/>
           <a:p>
-            <a:pPr indent="0" marL="0">
-              <a:buNone/>
-            </a:pPr>
-            <a:r>
-              <a:rPr lang="en-US" sz="1800" b="1" dirty="0">
-                <a:solidFill>
-                  <a:srgbClr val="1A1C2E"/>
+            <a:pPr algn="ctr" indent="0" marL="0">
+              <a:buNone/>
+            </a:pPr>
+            <a:r>
+              <a:rPr lang="en-US" sz="816" b="1" dirty="0">
+                <a:solidFill>
+                  <a:srgbClr val="FFFFFF"/>
                 </a:solidFill>
                 <a:latin typeface="Arial" pitchFamily="34" charset="0"/>
                 <a:ea typeface="Arial" pitchFamily="34" charset="-122"/>
                 <a:cs typeface="Arial" pitchFamily="34" charset="-120"/>
               </a:rPr>
-              <a:t>1,0</a:t>
-            </a:r>
-            <a:endParaRPr lang="en-US" sz="1800" dirty="0"/>
-          </a:p>
-        </p:txBody>
-      </p:sp>
-      <p:sp>
-        <p:nvSpPr>
-          <p:cNvPr id="14" name="Text 12"/>
-          <p:cNvSpPr/>
-          <p:nvPr/>
-        </p:nvSpPr>
-        <p:spPr>
-          <a:xfrm>
-            <a:off x="7315200" y="4215384"/>
-            <a:ext cx="4069080" cy="347472"/>
+              <a:t>BIG</a:t>
+            </a:r>
+            <a:endParaRPr lang="en-US" sz="816" dirty="0"/>
+          </a:p>
+        </p:txBody>
+      </p:sp>
+      <p:sp>
+        <p:nvSpPr>
+          <p:cNvPr id="30" name="Text 28"/>
+          <p:cNvSpPr/>
+          <p:nvPr/>
+        </p:nvSpPr>
+        <p:spPr>
+          <a:xfrm>
+            <a:off x="1078992" y="6263640"/>
+            <a:ext cx="658368" cy="219456"/>
           </a:xfrm>
           <a:prstGeom prst="rect">
             <a:avLst/>
@@ -4943,156 +5540,19 @@
           <a:bodyPr wrap="square" lIns="0" tIns="0" rIns="0" bIns="0" rtlCol="0" anchor="ctr"/>
           <a:lstStyle/>
           <a:p>
-            <a:pPr indent="0" marL="0">
-              <a:buNone/>
-            </a:pPr>
-            <a:r>
-              <a:rPr lang="en-US" sz="1500" dirty="0">
+            <a:pPr algn="l" indent="0" marL="0">
+              <a:buNone/>
+            </a:pPr>
+            <a:r>
+              <a:rPr lang="en-US" sz="816" dirty="0">
                 <a:solidFill>
                   <a:srgbClr val="1A1C2E"/>
-                </a:solidFill>
-                <a:latin typeface="Calibri" pitchFamily="34" charset="0"/>
-                <a:ea typeface="Calibri" pitchFamily="34" charset="-122"/>
-                <a:cs typeface="Calibri" pitchFamily="34" charset="-120"/>
-              </a:rPr>
-              <a:t>se ha leído del coche por OBD</a:t>
-            </a:r>
-            <a:endParaRPr lang="en-US" sz="1500" dirty="0"/>
-          </a:p>
-        </p:txBody>
-      </p:sp>
-      <p:sp>
-        <p:nvSpPr>
-          <p:cNvPr id="15" name="Text 13"/>
-          <p:cNvSpPr/>
-          <p:nvPr/>
-        </p:nvSpPr>
-        <p:spPr>
-          <a:xfrm>
-            <a:off x="6537960" y="4846320"/>
-            <a:ext cx="4846320" cy="365760"/>
-          </a:xfrm>
-          <a:prstGeom prst="rect">
-            <a:avLst/>
-          </a:prstGeom>
-          <a:noFill/>
-          <a:ln/>
-        </p:spPr>
-        <p:txBody>
-          <a:bodyPr wrap="square" lIns="0" tIns="0" rIns="0" bIns="0" rtlCol="0" anchor="t"/>
-          <a:lstStyle/>
-          <a:p>
-            <a:pPr indent="0" marL="0">
-              <a:buNone/>
-            </a:pPr>
-            <a:r>
-              <a:rPr lang="en-US" sz="1400" dirty="0">
-                <a:solidFill>
-                  <a:srgbClr val="5A5F73"/>
-                </a:solidFill>
-                <a:latin typeface="Calibri" pitchFamily="34" charset="0"/>
-                <a:ea typeface="Calibri" pitchFamily="34" charset="-122"/>
-                <a:cs typeface="Calibri" pitchFamily="34" charset="-120"/>
-              </a:rPr>
-              <a:t>Validar contra el coche sube la web a 0,7 y al mecánico a 0,9.</a:t>
-            </a:r>
-            <a:endParaRPr lang="en-US" sz="1400" dirty="0"/>
-          </a:p>
-        </p:txBody>
-      </p:sp>
-      <p:sp>
-        <p:nvSpPr>
-          <p:cNvPr id="16" name="Text 14"/>
-          <p:cNvSpPr/>
-          <p:nvPr/>
-        </p:nvSpPr>
-        <p:spPr>
-          <a:xfrm>
-            <a:off x="777240" y="5623560"/>
-            <a:ext cx="10607040" cy="365760"/>
-          </a:xfrm>
-          <a:prstGeom prst="rect">
-            <a:avLst/>
-          </a:prstGeom>
-          <a:noFill/>
-          <a:ln/>
-        </p:spPr>
-        <p:txBody>
-          <a:bodyPr wrap="square" lIns="0" tIns="0" rIns="0" bIns="0" rtlCol="0" anchor="t"/>
-          <a:lstStyle/>
-          <a:p>
-            <a:pPr indent="0" marL="0">
-              <a:buNone/>
-            </a:pPr>
-            <a:r>
-              <a:rPr lang="en-US" sz="1500" dirty="0">
-                <a:solidFill>
-                  <a:srgbClr val="5A5F73"/>
-                </a:solidFill>
-                <a:latin typeface="Calibri" pitchFamily="34" charset="0"/>
-                <a:ea typeface="Calibri" pitchFamily="34" charset="-122"/>
-                <a:cs typeface="Calibri" pitchFamily="34" charset="-120"/>
-              </a:rPr>
-              <a:t>Así el agente sabe de qué fiarse: lo que dijo un mecánico pesa más que lo que encontró en una web.</a:t>
-            </a:r>
-            <a:endParaRPr lang="en-US" sz="1500" dirty="0"/>
-          </a:p>
-        </p:txBody>
-      </p:sp>
-      <p:sp>
-        <p:nvSpPr>
-          <p:cNvPr id="17" name="Shape 15"/>
-          <p:cNvSpPr/>
-          <p:nvPr/>
-        </p:nvSpPr>
-        <p:spPr>
-          <a:xfrm>
-            <a:off x="777240" y="6263640"/>
-            <a:ext cx="219456" cy="219456"/>
-          </a:xfrm>
-          <a:prstGeom prst="rect">
-            <a:avLst/>
-          </a:prstGeom>
-          <a:solidFill>
-            <a:srgbClr val="202CFC"/>
-          </a:solidFill>
-          <a:ln/>
-        </p:spPr>
-      </p:sp>
-      <p:sp>
-        <p:nvSpPr>
-          <p:cNvPr id="18" name="Text 16"/>
-          <p:cNvSpPr/>
-          <p:nvPr/>
-        </p:nvSpPr>
-        <p:spPr>
-          <a:xfrm>
-            <a:off x="777240" y="6263640"/>
-            <a:ext cx="219456" cy="219456"/>
-          </a:xfrm>
-          <a:prstGeom prst="rect">
-            <a:avLst/>
-          </a:prstGeom>
-          <a:noFill/>
-          <a:ln/>
-        </p:spPr>
-        <p:txBody>
-          <a:bodyPr wrap="square" lIns="0" tIns="0" rIns="0" bIns="0" rtlCol="0" anchor="ctr"/>
-          <a:lstStyle/>
-          <a:p>
-            <a:pPr algn="ctr" indent="0" marL="0">
-              <a:buNone/>
-            </a:pPr>
-            <a:r>
-              <a:rPr lang="en-US" sz="816" b="1" dirty="0">
-                <a:solidFill>
-                  <a:srgbClr val="FFFFFF"/>
                 </a:solidFill>
                 <a:latin typeface="Arial" pitchFamily="34" charset="0"/>
                 <a:ea typeface="Arial" pitchFamily="34" charset="-122"/>
                 <a:cs typeface="Arial" pitchFamily="34" charset="-120"/>
               </a:rPr>
-              <a:t>BIG</a:t>
+              <a:t>school</a:t>
             </a:r>
             <a:endParaRPr lang="en-US" sz="816" dirty="0"/>
           </a:p>
@@ -5100,46 +5560,7 @@
       </p:sp>
       <p:sp>
         <p:nvSpPr>
-          <p:cNvPr id="19" name="Text 17"/>
-          <p:cNvSpPr/>
-          <p:nvPr/>
-        </p:nvSpPr>
-        <p:spPr>
-          <a:xfrm>
-            <a:off x="1078992" y="6263640"/>
-            <a:ext cx="658368" cy="219456"/>
-          </a:xfrm>
-          <a:prstGeom prst="rect">
-            <a:avLst/>
-          </a:prstGeom>
-          <a:noFill/>
-          <a:ln/>
-        </p:spPr>
-        <p:txBody>
-          <a:bodyPr wrap="square" lIns="0" tIns="0" rIns="0" bIns="0" rtlCol="0" anchor="ctr"/>
-          <a:lstStyle/>
-          <a:p>
-            <a:pPr algn="l" indent="0" marL="0">
-              <a:buNone/>
-            </a:pPr>
-            <a:r>
-              <a:rPr lang="en-US" sz="816" dirty="0">
-                <a:solidFill>
-                  <a:srgbClr val="1A1C2E"/>
-                </a:solidFill>
-                <a:latin typeface="Arial" pitchFamily="34" charset="0"/>
-                <a:ea typeface="Arial" pitchFamily="34" charset="-122"/>
-                <a:cs typeface="Arial" pitchFamily="34" charset="-120"/>
-              </a:rPr>
-              <a:t>school</a:t>
-            </a:r>
-            <a:endParaRPr lang="en-US" sz="816" dirty="0"/>
-          </a:p>
-        </p:txBody>
-      </p:sp>
-      <p:sp>
-        <p:nvSpPr>
-          <p:cNvPr id="20" name="Text 18"/>
+          <p:cNvPr id="31" name="Text 29"/>
           <p:cNvSpPr/>
           <p:nvPr/>
         </p:nvSpPr>

</xml_diff>

<commit_message>
docs(tfm): partir la persistencia en tres slides
</commit_message>
<xml_diff>
--- a/docs/presentacion/tfm-intelligent-automotive-diagnostics.pptx
+++ b/docs/presentacion/tfm-intelligent-automotive-diagnostics.pptx
@@ -11,9 +11,11 @@
     <p:sldId id="259" r:id="rId5"/>
     <p:sldId id="260" r:id="rId6"/>
     <p:sldId id="261" r:id="rId7"/>
+    <p:sldId id="262" r:id="rId8"/>
+    <p:sldId id="263" r:id="rId9"/>
   </p:sldIdLst>
   <p:notesMasterIdLst>
-    <p:notesMasterId r:id="rId8"/>
+    <p:notesMasterId r:id="rId10"/>
   </p:notesMasterIdLst>
   <p:sldSz cx="12192000" cy="6858000"/>
   <p:notesSz cx="6858000" cy="12192000"/>
@@ -966,11 +968,12 @@
           <a:p>
             <a:r>
               <a:rPr lang="en-US" dirty="0"/>
-              <a:t>En la base vectorial no van los datos del taller: esos están en SQLite. Aquí va solo lo que el sistema aprende. Hay PIDs propietarios, que cada fabricante se inventa fuera de la norma y es imposible traer precargados; DTCs específicos de una marca; y casos resueltos.
-A la izquierda tenéis un caso resuelto tal cual se guarda. El campo embeddedText es el texto que se convierte en vector, y es lo que luego permite encontrarlo por parecido. Los síntomas y los PIDs implicados van aparte, y el fabricante y el modelo también, para poder filtrar: si estoy con un Audi no quiero que me salgan casos de una Kawasaki.
-Y luego está el índice de confianza, que se lo ponemos nosotros al guardar según de dónde venga el dato. Si lo encontró el agente en internet entra con 0,3. Si viene de un diagnóstico anterior, 0,5. Si lo aportó el mecánico a mano, 0,8, porque una persona delante del coche sabe más que una web cualquiera. Y si se ha leído del propio coche por OBD es un hecho: 1,0. Comprobar un dato contra el coche sube la web a 0,7 y al mecánico a 0,9.
-Ese índice no es decorativo: es lo que pondera las búsquedas. Cuando al agente le llegan dos respuestas que se contradicen, gana la que más confianza tiene.
-[~70 s]</a:t>
+              <a:t>El proyecto tiene dos bases de datos, y cada una guarda una cosa distinta.
+En SQLite va el dato que ya se conoce y que es seguro: los usuarios, que pueden ser particulares o talleres, los vehículos, las ECUs que se les han descubierto, las sesiones de diagnóstico, y los catálogos que vienen de la norma. Todo eso se consulta por una clave: dame el vehículo con este VIN, dame las sesiones de este usuario.
+En la vectorial va lo que el sistema descubre: PIDs y DTCs propietarios que no están en la norma, y los diagnósticos ya resueltos. Ahí no hay clave por la que preguntar, porque lo que quiero es "enséñame algo parecido a esto".
+Y no vale con una sola. SQLite tiene buscador de texto, pero busca palabras: si el mecánico escribe "presión de aceite", no encuentra una ficha que ponga "oil pressure". La búsqueda vectorial sí, porque compara significado.
+Las dos son embebidas: un fichero y un directorio en disco. Cero servidores.
+[~55 s]</a:t>
             </a:r>
             <a:endParaRPr lang="en-US" dirty="0"/>
           </a:p>
@@ -994,6 +997,190 @@
             <a:fld id="{F7021451-1387-4CA6-816F-3879F97B5CBC}" type="slidenum">
               <a:rPr lang="en-US"/>
               <a:t>6</a:t>
+            </a:fld>
+            <a:endParaRPr lang="en-US"/>
+          </a:p>
+        </p:txBody>
+      </p:sp>
+    </p:spTree>
+    <p:extLst>
+      <p:ext uri="{BB962C8B-B14F-4D97-AF65-F5344CB8AC3E}">
+        <p14:creationId xmlns:p14="http://schemas.microsoft.com/office/powerpoint/2010/main" val="1024086991"/>
+      </p:ext>
+    </p:extLst>
+  </p:cSld>
+  <p:clrMapOvr>
+    <a:masterClrMapping/>
+  </p:clrMapOvr>
+</p:notes>
+</file>
+
+<file path=ppt/notesSlides/notesSlide7.xml><?xml version="1.0" encoding="utf-8"?>
+<p:notes xmlns:a="http://schemas.openxmlformats.org/drawingml/2006/main" xmlns:r="http://schemas.openxmlformats.org/officeDocument/2006/relationships" xmlns:p="http://schemas.openxmlformats.org/presentationml/2006/main">
+  <p:cSld>
+    <p:spTree>
+      <p:nvGrpSpPr>
+        <p:cNvPr id="1" name=""/>
+        <p:cNvGrpSpPr/>
+        <p:nvPr/>
+      </p:nvGrpSpPr>
+      <p:grpSpPr>
+        <a:xfrm>
+          <a:off x="0" y="0"/>
+          <a:ext cx="0" cy="0"/>
+          <a:chOff x="0" y="0"/>
+          <a:chExt cx="0" cy="0"/>
+        </a:xfrm>
+      </p:grpSpPr>
+      <p:sp>
+        <p:nvSpPr>
+          <p:cNvPr id="2" name="Slide Image Placeholder 1"/>
+          <p:cNvSpPr>
+            <a:spLocks noGrp="1" noRot="1" noChangeAspect="1"/>
+          </p:cNvSpPr>
+          <p:nvPr>
+            <p:ph type="sldImg"/>
+          </p:nvPr>
+        </p:nvSpPr>
+        <p:spPr/>
+      </p:sp>
+      <p:sp>
+        <p:nvSpPr>
+          <p:cNvPr id="3" name="Notes Placeholder 2"/>
+          <p:cNvSpPr>
+            <a:spLocks noGrp="1"/>
+          </p:cNvSpPr>
+          <p:nvPr>
+            <p:ph type="body" idx="1"/>
+          </p:nvPr>
+        </p:nvSpPr>
+        <p:spPr/>
+        <p:txBody>
+          <a:bodyPr/>
+          <a:lstStyle/>
+          <a:p>
+            <a:r>
+              <a:rPr lang="en-US" dirty="0"/>
+              <a:t>En SQLite hay trece tablas, y ahí está todo lo que se puede pedir por una clave exacta.
+Los usuarios, que pueden ser particulares o talleres, con su rol. Los vehículos, identificados por su VIN, y las ECUs que se le han descubierto a cada uno en el bus. Las sesiones de diagnóstico, y de cada una el informe congelado, tal como salió ese día. Las lecturas de PID, guardando tanto el hexadecimal crudo que devolvió la centralita como el valor ya convertido. Y los logs y la auditoría de cada petición HTTP, que es requisito de OWASP.
+Al arrancar, la base se siembra: veinte PIDs de la norma SAE J1979, veintitrés códigos DTC estándar y veintisiete fabricantes por su código WMI, que es lo que permite sacar la marca de un VIN. De ahí parte el sistema, y todo lo que aprenda después va a la base vectorial.
+Es un fichero en disco, sin servidor. PostgreSQL se descartó porque a esta escala solo añadía un servicio, una red y un backup que mantener, sin resolver ningún problema que yo tuviera.
+[~60 s]</a:t>
+            </a:r>
+            <a:endParaRPr lang="en-US" dirty="0"/>
+          </a:p>
+        </p:txBody>
+      </p:sp>
+      <p:sp>
+        <p:nvSpPr>
+          <p:cNvPr id="4" name="Slide Number Placeholder 3"/>
+          <p:cNvSpPr>
+            <a:spLocks noGrp="1"/>
+          </p:cNvSpPr>
+          <p:nvPr>
+            <p:ph type="sldNum" sz="quarter" idx="10"/>
+          </p:nvPr>
+        </p:nvSpPr>
+        <p:spPr/>
+        <p:txBody>
+          <a:bodyPr/>
+          <a:lstStyle/>
+          <a:p>
+            <a:fld id="{F7021451-1387-4CA6-816F-3879F97B5CBC}" type="slidenum">
+              <a:rPr lang="en-US"/>
+              <a:t>7</a:t>
+            </a:fld>
+            <a:endParaRPr lang="en-US"/>
+          </a:p>
+        </p:txBody>
+      </p:sp>
+    </p:spTree>
+    <p:extLst>
+      <p:ext uri="{BB962C8B-B14F-4D97-AF65-F5344CB8AC3E}">
+        <p14:creationId xmlns:p14="http://schemas.microsoft.com/office/powerpoint/2010/main" val="1024086991"/>
+      </p:ext>
+    </p:extLst>
+  </p:cSld>
+  <p:clrMapOvr>
+    <a:masterClrMapping/>
+  </p:clrMapOvr>
+</p:notes>
+</file>
+
+<file path=ppt/notesSlides/notesSlide8.xml><?xml version="1.0" encoding="utf-8"?>
+<p:notes xmlns:a="http://schemas.openxmlformats.org/drawingml/2006/main" xmlns:r="http://schemas.openxmlformats.org/officeDocument/2006/relationships" xmlns:p="http://schemas.openxmlformats.org/presentationml/2006/main">
+  <p:cSld>
+    <p:spTree>
+      <p:nvGrpSpPr>
+        <p:cNvPr id="1" name=""/>
+        <p:cNvGrpSpPr/>
+        <p:nvPr/>
+      </p:nvGrpSpPr>
+      <p:grpSpPr>
+        <a:xfrm>
+          <a:off x="0" y="0"/>
+          <a:ext cx="0" cy="0"/>
+          <a:chOff x="0" y="0"/>
+          <a:chExt cx="0" cy="0"/>
+        </a:xfrm>
+      </p:grpSpPr>
+      <p:sp>
+        <p:nvSpPr>
+          <p:cNvPr id="2" name="Slide Image Placeholder 1"/>
+          <p:cNvSpPr>
+            <a:spLocks noGrp="1" noRot="1" noChangeAspect="1"/>
+          </p:cNvSpPr>
+          <p:nvPr>
+            <p:ph type="sldImg"/>
+          </p:nvPr>
+        </p:nvSpPr>
+        <p:spPr/>
+      </p:sp>
+      <p:sp>
+        <p:nvSpPr>
+          <p:cNvPr id="3" name="Notes Placeholder 2"/>
+          <p:cNvSpPr>
+            <a:spLocks noGrp="1"/>
+          </p:cNvSpPr>
+          <p:nvPr>
+            <p:ph type="body" idx="1"/>
+          </p:nvPr>
+        </p:nvSpPr>
+        <p:spPr/>
+        <p:txBody>
+          <a:bodyPr/>
+          <a:lstStyle/>
+          <a:p>
+            <a:r>
+              <a:rPr lang="en-US" dirty="0"/>
+              <a:t>En la base vectorial no van los datos del taller: esos están en SQLite. Aquí va solo lo que el sistema aprende. Hay PIDs propietarios, que cada fabricante se inventa fuera de la norma y es imposible traer precargados; DTCs específicos de una marca; y casos resueltos.
+A la izquierda tenéis un caso resuelto tal cual se guarda. El campo embeddedText es el texto que se convierte en vector, y es lo que luego permite encontrarlo por parecido. Los síntomas y los PIDs implicados van aparte, y el fabricante y el modelo también, para poder filtrar: si estoy con un Audi no quiero que me salgan casos de una Kawasaki.
+Y luego está el índice de confianza, que se lo ponemos nosotros al guardar según de dónde venga el dato. Si lo encontró el agente en internet entra con 0,3. Si viene de un diagnóstico anterior, 0,5. Si lo aportó el mecánico a mano, 0,8, porque una persona delante del coche sabe más que una web cualquiera. Y si se ha leído del propio coche por OBD es un hecho: 1,0. Comprobar un dato contra el coche sube la web a 0,7 y al mecánico a 0,9.
+Ese índice no es decorativo: es lo que pondera las búsquedas. Cuando al agente le llegan dos respuestas que se contradicen, gana la que más confianza tiene.
+[~70 s]</a:t>
+            </a:r>
+            <a:endParaRPr lang="en-US" dirty="0"/>
+          </a:p>
+        </p:txBody>
+      </p:sp>
+      <p:sp>
+        <p:nvSpPr>
+          <p:cNvPr id="4" name="Slide Number Placeholder 3"/>
+          <p:cNvSpPr>
+            <a:spLocks noGrp="1"/>
+          </p:cNvSpPr>
+          <p:nvPr>
+            <p:ph type="sldNum" sz="quarter" idx="10"/>
+          </p:nvPr>
+        </p:nvSpPr>
+        <p:spPr/>
+        <p:txBody>
+          <a:bodyPr/>
+          <a:lstStyle/>
+          <a:p>
+            <a:fld id="{F7021451-1387-4CA6-816F-3879F97B5CBC}" type="slidenum">
+              <a:rPr lang="en-US"/>
+              <a:t>8</a:t>
             </a:fld>
             <a:endParaRPr lang="en-US"/>
           </a:p>
@@ -4381,6 +4568,1382 @@
         </p:nvSpPr>
         <p:spPr>
           <a:xfrm>
+            <a:off x="777240" y="640080"/>
+            <a:ext cx="10607040" cy="777240"/>
+          </a:xfrm>
+          <a:prstGeom prst="rect">
+            <a:avLst/>
+          </a:prstGeom>
+          <a:noFill/>
+          <a:ln/>
+        </p:spPr>
+        <p:txBody>
+          <a:bodyPr wrap="square" lIns="0" tIns="0" rIns="0" bIns="0" rtlCol="0" anchor="t"/>
+          <a:lstStyle/>
+          <a:p>
+            <a:pPr indent="0" marL="0">
+              <a:buNone/>
+            </a:pPr>
+            <a:r>
+              <a:rPr lang="en-US" sz="3400" b="1" dirty="0">
+                <a:solidFill>
+                  <a:srgbClr val="1A1C2E"/>
+                </a:solidFill>
+                <a:latin typeface="Arial" pitchFamily="34" charset="0"/>
+                <a:ea typeface="Arial" pitchFamily="34" charset="-122"/>
+                <a:cs typeface="Arial" pitchFamily="34" charset="-120"/>
+              </a:rPr>
+              <a:t>Dos bases de datos</a:t>
+            </a:r>
+            <a:endParaRPr lang="en-US" sz="3400" dirty="0"/>
+          </a:p>
+        </p:txBody>
+      </p:sp>
+      <p:sp>
+        <p:nvSpPr>
+          <p:cNvPr id="3" name="Text 1"/>
+          <p:cNvSpPr/>
+          <p:nvPr/>
+        </p:nvSpPr>
+        <p:spPr>
+          <a:xfrm>
+            <a:off x="777240" y="1508760"/>
+            <a:ext cx="10607040" cy="365760"/>
+          </a:xfrm>
+          <a:prstGeom prst="rect">
+            <a:avLst/>
+          </a:prstGeom>
+          <a:noFill/>
+          <a:ln/>
+        </p:spPr>
+        <p:txBody>
+          <a:bodyPr wrap="square" lIns="0" tIns="0" rIns="0" bIns="0" rtlCol="0" anchor="t"/>
+          <a:lstStyle/>
+          <a:p>
+            <a:pPr indent="0" marL="0">
+              <a:buNone/>
+            </a:pPr>
+            <a:r>
+              <a:rPr lang="en-US" sz="1700" dirty="0">
+                <a:solidFill>
+                  <a:srgbClr val="5A5F73"/>
+                </a:solidFill>
+                <a:latin typeface="Calibri" pitchFamily="34" charset="0"/>
+                <a:ea typeface="Calibri" pitchFamily="34" charset="-122"/>
+                <a:cs typeface="Calibri" pitchFamily="34" charset="-120"/>
+              </a:rPr>
+              <a:t>Una para el dato que ya se conoce. Otra para lo que el sistema descubre.</a:t>
+            </a:r>
+            <a:endParaRPr lang="en-US" sz="1700" dirty="0"/>
+          </a:p>
+        </p:txBody>
+      </p:sp>
+      <p:sp>
+        <p:nvSpPr>
+          <p:cNvPr id="4" name="Text 2"/>
+          <p:cNvSpPr/>
+          <p:nvPr/>
+        </p:nvSpPr>
+        <p:spPr>
+          <a:xfrm>
+            <a:off x="777240" y="2286000"/>
+            <a:ext cx="4846320" cy="365760"/>
+          </a:xfrm>
+          <a:prstGeom prst="rect">
+            <a:avLst/>
+          </a:prstGeom>
+          <a:noFill/>
+          <a:ln/>
+        </p:spPr>
+        <p:txBody>
+          <a:bodyPr wrap="square" lIns="0" tIns="0" rIns="0" bIns="0" rtlCol="0" anchor="t"/>
+          <a:lstStyle/>
+          <a:p>
+            <a:pPr indent="0" marL="0">
+              <a:buNone/>
+            </a:pPr>
+            <a:r>
+              <a:rPr lang="en-US" sz="2000" b="1" dirty="0">
+                <a:solidFill>
+                  <a:srgbClr val="202CFC"/>
+                </a:solidFill>
+                <a:latin typeface="Arial" pitchFamily="34" charset="0"/>
+                <a:ea typeface="Arial" pitchFamily="34" charset="-122"/>
+                <a:cs typeface="Arial" pitchFamily="34" charset="-120"/>
+              </a:rPr>
+              <a:t>SQLite</a:t>
+            </a:r>
+            <a:endParaRPr lang="en-US" sz="2000" dirty="0"/>
+          </a:p>
+        </p:txBody>
+      </p:sp>
+      <p:sp>
+        <p:nvSpPr>
+          <p:cNvPr id="5" name="Text 3"/>
+          <p:cNvSpPr/>
+          <p:nvPr/>
+        </p:nvSpPr>
+        <p:spPr>
+          <a:xfrm>
+            <a:off x="777240" y="2834640"/>
+            <a:ext cx="4846320" cy="1737360"/>
+          </a:xfrm>
+          <a:prstGeom prst="rect">
+            <a:avLst/>
+          </a:prstGeom>
+          <a:noFill/>
+          <a:ln/>
+        </p:spPr>
+        <p:txBody>
+          <a:bodyPr wrap="square" lIns="0" tIns="0" rIns="0" bIns="0" rtlCol="0" anchor="t"/>
+          <a:lstStyle/>
+          <a:p>
+            <a:pPr marL="342900" indent="-342900">
+              <a:lnSpc>
+                <a:spcPts val="2200"/>
+              </a:lnSpc>
+              <a:spcAft>
+                <a:spcPts val="1200"/>
+              </a:spcAft>
+              <a:buSzPct val="100000"/>
+              <a:buChar char="•"/>
+            </a:pPr>
+            <a:r>
+              <a:rPr lang="en-US" sz="1600" dirty="0">
+                <a:solidFill>
+                  <a:srgbClr val="1A1C2E"/>
+                </a:solidFill>
+                <a:latin typeface="Calibri" pitchFamily="34" charset="0"/>
+                <a:ea typeface="Calibri" pitchFamily="34" charset="-122"/>
+                <a:cs typeface="Calibri" pitchFamily="34" charset="-120"/>
+              </a:rPr>
+              <a:t>Usuarios, talleres, vehículos, ECUs y sesiones</a:t>
+            </a:r>
+            <a:endParaRPr lang="en-US" sz="1600" dirty="0"/>
+          </a:p>
+          <a:p>
+            <a:pPr marL="342900" indent="-342900">
+              <a:lnSpc>
+                <a:spcPts val="2200"/>
+              </a:lnSpc>
+              <a:spcAft>
+                <a:spcPts val="1200"/>
+              </a:spcAft>
+              <a:buSzPct val="100000"/>
+              <a:buChar char="•"/>
+            </a:pPr>
+            <a:r>
+              <a:rPr lang="en-US" sz="1600" dirty="0">
+                <a:solidFill>
+                  <a:srgbClr val="1A1C2E"/>
+                </a:solidFill>
+                <a:latin typeface="Calibri" pitchFamily="34" charset="0"/>
+                <a:ea typeface="Calibri" pitchFamily="34" charset="-122"/>
+                <a:cs typeface="Calibri" pitchFamily="34" charset="-120"/>
+              </a:rPr>
+              <a:t>Los catálogos que vienen de la norma</a:t>
+            </a:r>
+            <a:endParaRPr lang="en-US" sz="1600" dirty="0"/>
+          </a:p>
+          <a:p>
+            <a:pPr marL="342900" indent="-342900">
+              <a:lnSpc>
+                <a:spcPts val="2200"/>
+              </a:lnSpc>
+              <a:spcAft>
+                <a:spcPts val="1200"/>
+              </a:spcAft>
+              <a:buSzPct val="100000"/>
+              <a:buChar char="•"/>
+            </a:pPr>
+            <a:r>
+              <a:rPr lang="en-US" sz="1600" dirty="0">
+                <a:solidFill>
+                  <a:srgbClr val="1A1C2E"/>
+                </a:solidFill>
+                <a:latin typeface="Calibri" pitchFamily="34" charset="0"/>
+                <a:ea typeface="Calibri" pitchFamily="34" charset="-122"/>
+                <a:cs typeface="Calibri" pitchFamily="34" charset="-120"/>
+              </a:rPr>
+              <a:t>Se consulta por clave: este VIN, este usuario</a:t>
+            </a:r>
+            <a:endParaRPr lang="en-US" sz="1600" dirty="0"/>
+          </a:p>
+        </p:txBody>
+      </p:sp>
+      <p:sp>
+        <p:nvSpPr>
+          <p:cNvPr id="6" name="Text 4"/>
+          <p:cNvSpPr/>
+          <p:nvPr/>
+        </p:nvSpPr>
+        <p:spPr>
+          <a:xfrm>
+            <a:off x="6537960" y="2286000"/>
+            <a:ext cx="4846320" cy="365760"/>
+          </a:xfrm>
+          <a:prstGeom prst="rect">
+            <a:avLst/>
+          </a:prstGeom>
+          <a:noFill/>
+          <a:ln/>
+        </p:spPr>
+        <p:txBody>
+          <a:bodyPr wrap="square" lIns="0" tIns="0" rIns="0" bIns="0" rtlCol="0" anchor="t"/>
+          <a:lstStyle/>
+          <a:p>
+            <a:pPr indent="0" marL="0">
+              <a:buNone/>
+            </a:pPr>
+            <a:r>
+              <a:rPr lang="en-US" sz="2000" b="1" dirty="0">
+                <a:solidFill>
+                  <a:srgbClr val="202CFC"/>
+                </a:solidFill>
+                <a:latin typeface="Arial" pitchFamily="34" charset="0"/>
+                <a:ea typeface="Arial" pitchFamily="34" charset="-122"/>
+                <a:cs typeface="Arial" pitchFamily="34" charset="-120"/>
+              </a:rPr>
+              <a:t>LanceDB, vectorial</a:t>
+            </a:r>
+            <a:endParaRPr lang="en-US" sz="2000" dirty="0"/>
+          </a:p>
+        </p:txBody>
+      </p:sp>
+      <p:sp>
+        <p:nvSpPr>
+          <p:cNvPr id="7" name="Text 5"/>
+          <p:cNvSpPr/>
+          <p:nvPr/>
+        </p:nvSpPr>
+        <p:spPr>
+          <a:xfrm>
+            <a:off x="6537960" y="2834640"/>
+            <a:ext cx="4846320" cy="1737360"/>
+          </a:xfrm>
+          <a:prstGeom prst="rect">
+            <a:avLst/>
+          </a:prstGeom>
+          <a:noFill/>
+          <a:ln/>
+        </p:spPr>
+        <p:txBody>
+          <a:bodyPr wrap="square" lIns="0" tIns="0" rIns="0" bIns="0" rtlCol="0" anchor="t"/>
+          <a:lstStyle/>
+          <a:p>
+            <a:pPr marL="342900" indent="-342900">
+              <a:lnSpc>
+                <a:spcPts val="2200"/>
+              </a:lnSpc>
+              <a:spcAft>
+                <a:spcPts val="1200"/>
+              </a:spcAft>
+              <a:buSzPct val="100000"/>
+              <a:buChar char="•"/>
+            </a:pPr>
+            <a:r>
+              <a:rPr lang="en-US" sz="1600" dirty="0">
+                <a:solidFill>
+                  <a:srgbClr val="1A1C2E"/>
+                </a:solidFill>
+                <a:latin typeface="Calibri" pitchFamily="34" charset="0"/>
+                <a:ea typeface="Calibri" pitchFamily="34" charset="-122"/>
+                <a:cs typeface="Calibri" pitchFamily="34" charset="-120"/>
+              </a:rPr>
+              <a:t>PIDs y DTCs propietarios que se van descubriendo</a:t>
+            </a:r>
+            <a:endParaRPr lang="en-US" sz="1600" dirty="0"/>
+          </a:p>
+          <a:p>
+            <a:pPr marL="342900" indent="-342900">
+              <a:lnSpc>
+                <a:spcPts val="2200"/>
+              </a:lnSpc>
+              <a:spcAft>
+                <a:spcPts val="1200"/>
+              </a:spcAft>
+              <a:buSzPct val="100000"/>
+              <a:buChar char="•"/>
+            </a:pPr>
+            <a:r>
+              <a:rPr lang="en-US" sz="1600" dirty="0">
+                <a:solidFill>
+                  <a:srgbClr val="1A1C2E"/>
+                </a:solidFill>
+                <a:latin typeface="Calibri" pitchFamily="34" charset="0"/>
+                <a:ea typeface="Calibri" pitchFamily="34" charset="-122"/>
+                <a:cs typeface="Calibri" pitchFamily="34" charset="-120"/>
+              </a:rPr>
+              <a:t>Los diagnósticos ya resueltos</a:t>
+            </a:r>
+            <a:endParaRPr lang="en-US" sz="1600" dirty="0"/>
+          </a:p>
+          <a:p>
+            <a:pPr marL="342900" indent="-342900">
+              <a:lnSpc>
+                <a:spcPts val="2200"/>
+              </a:lnSpc>
+              <a:spcAft>
+                <a:spcPts val="1200"/>
+              </a:spcAft>
+              <a:buSzPct val="100000"/>
+              <a:buChar char="•"/>
+            </a:pPr>
+            <a:r>
+              <a:rPr lang="en-US" sz="1600" dirty="0">
+                <a:solidFill>
+                  <a:srgbClr val="1A1C2E"/>
+                </a:solidFill>
+                <a:latin typeface="Calibri" pitchFamily="34" charset="0"/>
+                <a:ea typeface="Calibri" pitchFamily="34" charset="-122"/>
+                <a:cs typeface="Calibri" pitchFamily="34" charset="-120"/>
+              </a:rPr>
+              <a:t>Se consulta por parecido, no por clave</a:t>
+            </a:r>
+            <a:endParaRPr lang="en-US" sz="1600" dirty="0"/>
+          </a:p>
+        </p:txBody>
+      </p:sp>
+      <p:sp>
+        <p:nvSpPr>
+          <p:cNvPr id="8" name="Text 6"/>
+          <p:cNvSpPr/>
+          <p:nvPr/>
+        </p:nvSpPr>
+        <p:spPr>
+          <a:xfrm>
+            <a:off x="777240" y="5029200"/>
+            <a:ext cx="10607040" cy="320040"/>
+          </a:xfrm>
+          <a:prstGeom prst="rect">
+            <a:avLst/>
+          </a:prstGeom>
+          <a:noFill/>
+          <a:ln/>
+        </p:spPr>
+        <p:txBody>
+          <a:bodyPr wrap="square" lIns="0" tIns="0" rIns="0" bIns="0" rtlCol="0" anchor="t"/>
+          <a:lstStyle/>
+          <a:p>
+            <a:pPr indent="0" marL="0">
+              <a:buNone/>
+            </a:pPr>
+            <a:r>
+              <a:rPr lang="en-US" sz="1600" b="1" dirty="0">
+                <a:solidFill>
+                  <a:srgbClr val="1A1C2E"/>
+                </a:solidFill>
+                <a:latin typeface="Arial" pitchFamily="34" charset="0"/>
+                <a:ea typeface="Arial" pitchFamily="34" charset="-122"/>
+                <a:cs typeface="Arial" pitchFamily="34" charset="-120"/>
+              </a:rPr>
+              <a:t>No vale con una sola: el buscador de texto de SQLite busca palabras, no significado.</a:t>
+            </a:r>
+            <a:endParaRPr lang="en-US" sz="1600" dirty="0"/>
+          </a:p>
+        </p:txBody>
+      </p:sp>
+      <p:sp>
+        <p:nvSpPr>
+          <p:cNvPr id="9" name="Text 7"/>
+          <p:cNvSpPr/>
+          <p:nvPr/>
+        </p:nvSpPr>
+        <p:spPr>
+          <a:xfrm>
+            <a:off x="777240" y="5440680"/>
+            <a:ext cx="10607040" cy="548640"/>
+          </a:xfrm>
+          <a:prstGeom prst="rect">
+            <a:avLst/>
+          </a:prstGeom>
+          <a:noFill/>
+          <a:ln/>
+        </p:spPr>
+        <p:txBody>
+          <a:bodyPr wrap="square" lIns="0" tIns="0" rIns="0" bIns="0" rtlCol="0" anchor="t"/>
+          <a:lstStyle/>
+          <a:p>
+            <a:pPr indent="0" marL="0">
+              <a:lnSpc>
+                <a:spcPts val="2100"/>
+              </a:lnSpc>
+              <a:buNone/>
+            </a:pPr>
+            <a:r>
+              <a:rPr lang="en-US" sz="1500" dirty="0">
+                <a:solidFill>
+                  <a:srgbClr val="5A5F73"/>
+                </a:solidFill>
+                <a:latin typeface="Calibri" pitchFamily="34" charset="0"/>
+                <a:ea typeface="Calibri" pitchFamily="34" charset="-122"/>
+                <a:cs typeface="Calibri" pitchFamily="34" charset="-120"/>
+              </a:rPr>
+              <a:t>«Presión de aceite» no encuentra «oil pressure». Las dos van embebidas: un fichero y un directorio en disco, sin servidor que levantar.</a:t>
+            </a:r>
+            <a:endParaRPr lang="en-US" sz="1500" dirty="0"/>
+          </a:p>
+        </p:txBody>
+      </p:sp>
+      <p:sp>
+        <p:nvSpPr>
+          <p:cNvPr id="10" name="Shape 8"/>
+          <p:cNvSpPr/>
+          <p:nvPr/>
+        </p:nvSpPr>
+        <p:spPr>
+          <a:xfrm>
+            <a:off x="777240" y="6263640"/>
+            <a:ext cx="219456" cy="219456"/>
+          </a:xfrm>
+          <a:prstGeom prst="rect">
+            <a:avLst/>
+          </a:prstGeom>
+          <a:solidFill>
+            <a:srgbClr val="202CFC"/>
+          </a:solidFill>
+          <a:ln/>
+        </p:spPr>
+      </p:sp>
+      <p:sp>
+        <p:nvSpPr>
+          <p:cNvPr id="11" name="Text 9"/>
+          <p:cNvSpPr/>
+          <p:nvPr/>
+        </p:nvSpPr>
+        <p:spPr>
+          <a:xfrm>
+            <a:off x="777240" y="6263640"/>
+            <a:ext cx="219456" cy="219456"/>
+          </a:xfrm>
+          <a:prstGeom prst="rect">
+            <a:avLst/>
+          </a:prstGeom>
+          <a:noFill/>
+          <a:ln/>
+        </p:spPr>
+        <p:txBody>
+          <a:bodyPr wrap="square" lIns="0" tIns="0" rIns="0" bIns="0" rtlCol="0" anchor="ctr"/>
+          <a:lstStyle/>
+          <a:p>
+            <a:pPr algn="ctr" indent="0" marL="0">
+              <a:buNone/>
+            </a:pPr>
+            <a:r>
+              <a:rPr lang="en-US" sz="816" b="1" dirty="0">
+                <a:solidFill>
+                  <a:srgbClr val="FFFFFF"/>
+                </a:solidFill>
+                <a:latin typeface="Arial" pitchFamily="34" charset="0"/>
+                <a:ea typeface="Arial" pitchFamily="34" charset="-122"/>
+                <a:cs typeface="Arial" pitchFamily="34" charset="-120"/>
+              </a:rPr>
+              <a:t>BIG</a:t>
+            </a:r>
+            <a:endParaRPr lang="en-US" sz="816" dirty="0"/>
+          </a:p>
+        </p:txBody>
+      </p:sp>
+      <p:sp>
+        <p:nvSpPr>
+          <p:cNvPr id="12" name="Text 10"/>
+          <p:cNvSpPr/>
+          <p:nvPr/>
+        </p:nvSpPr>
+        <p:spPr>
+          <a:xfrm>
+            <a:off x="1078992" y="6263640"/>
+            <a:ext cx="658368" cy="219456"/>
+          </a:xfrm>
+          <a:prstGeom prst="rect">
+            <a:avLst/>
+          </a:prstGeom>
+          <a:noFill/>
+          <a:ln/>
+        </p:spPr>
+        <p:txBody>
+          <a:bodyPr wrap="square" lIns="0" tIns="0" rIns="0" bIns="0" rtlCol="0" anchor="ctr"/>
+          <a:lstStyle/>
+          <a:p>
+            <a:pPr algn="l" indent="0" marL="0">
+              <a:buNone/>
+            </a:pPr>
+            <a:r>
+              <a:rPr lang="en-US" sz="816" dirty="0">
+                <a:solidFill>
+                  <a:srgbClr val="1A1C2E"/>
+                </a:solidFill>
+                <a:latin typeface="Arial" pitchFamily="34" charset="0"/>
+                <a:ea typeface="Arial" pitchFamily="34" charset="-122"/>
+                <a:cs typeface="Arial" pitchFamily="34" charset="-120"/>
+              </a:rPr>
+              <a:t>school</a:t>
+            </a:r>
+            <a:endParaRPr lang="en-US" sz="816" dirty="0"/>
+          </a:p>
+        </p:txBody>
+      </p:sp>
+      <p:sp>
+        <p:nvSpPr>
+          <p:cNvPr id="13" name="Text 11"/>
+          <p:cNvSpPr/>
+          <p:nvPr/>
+        </p:nvSpPr>
+        <p:spPr>
+          <a:xfrm>
+            <a:off x="11064240" y="6263640"/>
+            <a:ext cx="320040" cy="219456"/>
+          </a:xfrm>
+          <a:prstGeom prst="rect">
+            <a:avLst/>
+          </a:prstGeom>
+          <a:noFill/>
+          <a:ln/>
+        </p:spPr>
+        <p:txBody>
+          <a:bodyPr wrap="square" lIns="0" tIns="0" rIns="0" bIns="0" rtlCol="0" anchor="ctr"/>
+          <a:lstStyle/>
+          <a:p>
+            <a:pPr algn="r" indent="0" marL="0">
+              <a:buNone/>
+            </a:pPr>
+            <a:r>
+              <a:rPr lang="en-US" sz="1000" dirty="0">
+                <a:solidFill>
+                  <a:srgbClr val="5A5F73"/>
+                </a:solidFill>
+                <a:latin typeface="Calibri" pitchFamily="34" charset="0"/>
+                <a:ea typeface="Calibri" pitchFamily="34" charset="-122"/>
+                <a:cs typeface="Calibri" pitchFamily="34" charset="-120"/>
+              </a:rPr>
+              <a:t>6</a:t>
+            </a:r>
+            <a:endParaRPr lang="en-US" sz="1000" dirty="0"/>
+          </a:p>
+        </p:txBody>
+      </p:sp>
+    </p:spTree>
+  </p:cSld>
+  <p:clrMapOvr>
+    <a:masterClrMapping/>
+  </p:clrMapOvr>
+</p:sld>
+</file>
+
+<file path=ppt/slides/slide7.xml><?xml version="1.0" encoding="utf-8"?>
+<p:sld xmlns:a="http://schemas.openxmlformats.org/drawingml/2006/main" xmlns:r="http://schemas.openxmlformats.org/officeDocument/2006/relationships" xmlns:p="http://schemas.openxmlformats.org/presentationml/2006/main">
+  <p:cSld name="Slide 7">
+    <p:bg>
+      <p:bgPr>
+        <a:solidFill>
+          <a:srgbClr val="FFFFFF"/>
+        </a:solidFill>
+      </p:bgPr>
+    </p:bg>
+    <p:spTree>
+      <p:nvGrpSpPr>
+        <p:cNvPr id="1" name=""/>
+        <p:cNvGrpSpPr/>
+        <p:nvPr/>
+      </p:nvGrpSpPr>
+      <p:grpSpPr>
+        <a:xfrm>
+          <a:off x="0" y="0"/>
+          <a:ext cx="0" cy="0"/>
+          <a:chOff x="0" y="0"/>
+          <a:chExt cx="0" cy="0"/>
+        </a:xfrm>
+      </p:grpSpPr>
+      <p:sp>
+        <p:nvSpPr>
+          <p:cNvPr id="2" name="Text 0"/>
+          <p:cNvSpPr/>
+          <p:nvPr/>
+        </p:nvSpPr>
+        <p:spPr>
+          <a:xfrm>
+            <a:off x="777240" y="640080"/>
+            <a:ext cx="10607040" cy="777240"/>
+          </a:xfrm>
+          <a:prstGeom prst="rect">
+            <a:avLst/>
+          </a:prstGeom>
+          <a:noFill/>
+          <a:ln/>
+        </p:spPr>
+        <p:txBody>
+          <a:bodyPr wrap="square" lIns="0" tIns="0" rIns="0" bIns="0" rtlCol="0" anchor="t"/>
+          <a:lstStyle/>
+          <a:p>
+            <a:pPr indent="0" marL="0">
+              <a:buNone/>
+            </a:pPr>
+            <a:r>
+              <a:rPr lang="en-US" sz="3400" b="1" dirty="0">
+                <a:solidFill>
+                  <a:srgbClr val="1A1C2E"/>
+                </a:solidFill>
+                <a:latin typeface="Arial" pitchFamily="34" charset="0"/>
+                <a:ea typeface="Arial" pitchFamily="34" charset="-122"/>
+                <a:cs typeface="Arial" pitchFamily="34" charset="-120"/>
+              </a:rPr>
+              <a:t>SQLite: el dato que ya se conoce</a:t>
+            </a:r>
+            <a:endParaRPr lang="en-US" sz="3400" dirty="0"/>
+          </a:p>
+        </p:txBody>
+      </p:sp>
+      <p:sp>
+        <p:nvSpPr>
+          <p:cNvPr id="3" name="Text 1"/>
+          <p:cNvSpPr/>
+          <p:nvPr/>
+        </p:nvSpPr>
+        <p:spPr>
+          <a:xfrm>
+            <a:off x="777240" y="1508760"/>
+            <a:ext cx="10607040" cy="365760"/>
+          </a:xfrm>
+          <a:prstGeom prst="rect">
+            <a:avLst/>
+          </a:prstGeom>
+          <a:noFill/>
+          <a:ln/>
+        </p:spPr>
+        <p:txBody>
+          <a:bodyPr wrap="square" lIns="0" tIns="0" rIns="0" bIns="0" rtlCol="0" anchor="t"/>
+          <a:lstStyle/>
+          <a:p>
+            <a:pPr indent="0" marL="0">
+              <a:buNone/>
+            </a:pPr>
+            <a:r>
+              <a:rPr lang="en-US" sz="1700" dirty="0">
+                <a:solidFill>
+                  <a:srgbClr val="5A5F73"/>
+                </a:solidFill>
+                <a:latin typeface="Calibri" pitchFamily="34" charset="0"/>
+                <a:ea typeface="Calibri" pitchFamily="34" charset="-122"/>
+                <a:cs typeface="Calibri" pitchFamily="34" charset="-120"/>
+              </a:rPr>
+              <a:t>13 tablas. Todo lo que se puede pedir por una clave exacta.</a:t>
+            </a:r>
+            <a:endParaRPr lang="en-US" sz="1700" dirty="0"/>
+          </a:p>
+        </p:txBody>
+      </p:sp>
+      <p:sp>
+        <p:nvSpPr>
+          <p:cNvPr id="4" name="Text 2"/>
+          <p:cNvSpPr/>
+          <p:nvPr/>
+        </p:nvSpPr>
+        <p:spPr>
+          <a:xfrm>
+            <a:off x="777240" y="2286000"/>
+            <a:ext cx="4846320" cy="365760"/>
+          </a:xfrm>
+          <a:prstGeom prst="rect">
+            <a:avLst/>
+          </a:prstGeom>
+          <a:noFill/>
+          <a:ln/>
+        </p:spPr>
+        <p:txBody>
+          <a:bodyPr wrap="square" lIns="0" tIns="0" rIns="0" bIns="0" rtlCol="0" anchor="t"/>
+          <a:lstStyle/>
+          <a:p>
+            <a:pPr indent="0" marL="0">
+              <a:buNone/>
+            </a:pPr>
+            <a:r>
+              <a:rPr lang="en-US" sz="1900" b="1" dirty="0">
+                <a:solidFill>
+                  <a:srgbClr val="202CFC"/>
+                </a:solidFill>
+                <a:latin typeface="Arial" pitchFamily="34" charset="0"/>
+                <a:ea typeface="Arial" pitchFamily="34" charset="-122"/>
+                <a:cs typeface="Arial" pitchFamily="34" charset="-120"/>
+              </a:rPr>
+              <a:t>Qué guarda</a:t>
+            </a:r>
+            <a:endParaRPr lang="en-US" sz="1900" dirty="0"/>
+          </a:p>
+        </p:txBody>
+      </p:sp>
+      <p:sp>
+        <p:nvSpPr>
+          <p:cNvPr id="5" name="Text 3"/>
+          <p:cNvSpPr/>
+          <p:nvPr/>
+        </p:nvSpPr>
+        <p:spPr>
+          <a:xfrm>
+            <a:off x="777240" y="2834640"/>
+            <a:ext cx="4846320" cy="2743200"/>
+          </a:xfrm>
+          <a:prstGeom prst="rect">
+            <a:avLst/>
+          </a:prstGeom>
+          <a:noFill/>
+          <a:ln/>
+        </p:spPr>
+        <p:txBody>
+          <a:bodyPr wrap="square" lIns="0" tIns="0" rIns="0" bIns="0" rtlCol="0" anchor="t"/>
+          <a:lstStyle/>
+          <a:p>
+            <a:pPr marL="342900" indent="-342900">
+              <a:lnSpc>
+                <a:spcPts val="2100"/>
+              </a:lnSpc>
+              <a:spcAft>
+                <a:spcPts val="1100"/>
+              </a:spcAft>
+              <a:buSzPct val="100000"/>
+              <a:buChar char="•"/>
+            </a:pPr>
+            <a:r>
+              <a:rPr lang="en-US" sz="1500" dirty="0">
+                <a:solidFill>
+                  <a:srgbClr val="1A1C2E"/>
+                </a:solidFill>
+                <a:latin typeface="Calibri" pitchFamily="34" charset="0"/>
+                <a:ea typeface="Calibri" pitchFamily="34" charset="-122"/>
+                <a:cs typeface="Calibri" pitchFamily="34" charset="-120"/>
+              </a:rPr>
+              <a:t>Usuarios: particulares o talleres, con su rol</a:t>
+            </a:r>
+            <a:endParaRPr lang="en-US" sz="1500" dirty="0"/>
+          </a:p>
+          <a:p>
+            <a:pPr marL="342900" indent="-342900">
+              <a:lnSpc>
+                <a:spcPts val="2100"/>
+              </a:lnSpc>
+              <a:spcAft>
+                <a:spcPts val="1100"/>
+              </a:spcAft>
+              <a:buSzPct val="100000"/>
+              <a:buChar char="•"/>
+            </a:pPr>
+            <a:r>
+              <a:rPr lang="en-US" sz="1500" dirty="0">
+                <a:solidFill>
+                  <a:srgbClr val="1A1C2E"/>
+                </a:solidFill>
+                <a:latin typeface="Calibri" pitchFamily="34" charset="0"/>
+                <a:ea typeface="Calibri" pitchFamily="34" charset="-122"/>
+                <a:cs typeface="Calibri" pitchFamily="34" charset="-120"/>
+              </a:rPr>
+              <a:t>Vehículos por VIN y las ECUs de cada uno</a:t>
+            </a:r>
+            <a:endParaRPr lang="en-US" sz="1500" dirty="0"/>
+          </a:p>
+          <a:p>
+            <a:pPr marL="342900" indent="-342900">
+              <a:lnSpc>
+                <a:spcPts val="2100"/>
+              </a:lnSpc>
+              <a:spcAft>
+                <a:spcPts val="1100"/>
+              </a:spcAft>
+              <a:buSzPct val="100000"/>
+              <a:buChar char="•"/>
+            </a:pPr>
+            <a:r>
+              <a:rPr lang="en-US" sz="1500" dirty="0">
+                <a:solidFill>
+                  <a:srgbClr val="1A1C2E"/>
+                </a:solidFill>
+                <a:latin typeface="Calibri" pitchFamily="34" charset="0"/>
+                <a:ea typeface="Calibri" pitchFamily="34" charset="-122"/>
+                <a:cs typeface="Calibri" pitchFamily="34" charset="-120"/>
+              </a:rPr>
+              <a:t>Sesiones de diagnóstico, con el informe congelado</a:t>
+            </a:r>
+            <a:endParaRPr lang="en-US" sz="1500" dirty="0"/>
+          </a:p>
+          <a:p>
+            <a:pPr marL="342900" indent="-342900">
+              <a:lnSpc>
+                <a:spcPts val="2100"/>
+              </a:lnSpc>
+              <a:spcAft>
+                <a:spcPts val="1100"/>
+              </a:spcAft>
+              <a:buSzPct val="100000"/>
+              <a:buChar char="•"/>
+            </a:pPr>
+            <a:r>
+              <a:rPr lang="en-US" sz="1500" dirty="0">
+                <a:solidFill>
+                  <a:srgbClr val="1A1C2E"/>
+                </a:solidFill>
+                <a:latin typeface="Calibri" pitchFamily="34" charset="0"/>
+                <a:ea typeface="Calibri" pitchFamily="34" charset="-122"/>
+                <a:cs typeface="Calibri" pitchFamily="34" charset="-120"/>
+              </a:rPr>
+              <a:t>Lecturas de PID: el hexadecimal crudo y el valor ya convertido</a:t>
+            </a:r>
+            <a:endParaRPr lang="en-US" sz="1500" dirty="0"/>
+          </a:p>
+          <a:p>
+            <a:pPr marL="342900" indent="-342900">
+              <a:lnSpc>
+                <a:spcPts val="2100"/>
+              </a:lnSpc>
+              <a:spcAft>
+                <a:spcPts val="1100"/>
+              </a:spcAft>
+              <a:buSzPct val="100000"/>
+              <a:buChar char="•"/>
+            </a:pPr>
+            <a:r>
+              <a:rPr lang="en-US" sz="1500" dirty="0">
+                <a:solidFill>
+                  <a:srgbClr val="1A1C2E"/>
+                </a:solidFill>
+                <a:latin typeface="Calibri" pitchFamily="34" charset="0"/>
+                <a:ea typeface="Calibri" pitchFamily="34" charset="-122"/>
+                <a:cs typeface="Calibri" pitchFamily="34" charset="-120"/>
+              </a:rPr>
+              <a:t>Logs y auditoría de cada petición</a:t>
+            </a:r>
+            <a:endParaRPr lang="en-US" sz="1500" dirty="0"/>
+          </a:p>
+        </p:txBody>
+      </p:sp>
+      <p:sp>
+        <p:nvSpPr>
+          <p:cNvPr id="6" name="Text 4"/>
+          <p:cNvSpPr/>
+          <p:nvPr/>
+        </p:nvSpPr>
+        <p:spPr>
+          <a:xfrm>
+            <a:off x="6537960" y="2286000"/>
+            <a:ext cx="4846320" cy="365760"/>
+          </a:xfrm>
+          <a:prstGeom prst="rect">
+            <a:avLst/>
+          </a:prstGeom>
+          <a:noFill/>
+          <a:ln/>
+        </p:spPr>
+        <p:txBody>
+          <a:bodyPr wrap="square" lIns="0" tIns="0" rIns="0" bIns="0" rtlCol="0" anchor="t"/>
+          <a:lstStyle/>
+          <a:p>
+            <a:pPr indent="0" marL="0">
+              <a:buNone/>
+            </a:pPr>
+            <a:r>
+              <a:rPr lang="en-US" sz="1900" b="1" dirty="0">
+                <a:solidFill>
+                  <a:srgbClr val="202CFC"/>
+                </a:solidFill>
+                <a:latin typeface="Arial" pitchFamily="34" charset="0"/>
+                <a:ea typeface="Arial" pitchFamily="34" charset="-122"/>
+                <a:cs typeface="Arial" pitchFamily="34" charset="-120"/>
+              </a:rPr>
+              <a:t>Lo que viene sembrado al arrancar</a:t>
+            </a:r>
+            <a:endParaRPr lang="en-US" sz="1900" dirty="0"/>
+          </a:p>
+        </p:txBody>
+      </p:sp>
+      <p:sp>
+        <p:nvSpPr>
+          <p:cNvPr id="7" name="Text 5"/>
+          <p:cNvSpPr/>
+          <p:nvPr/>
+        </p:nvSpPr>
+        <p:spPr>
+          <a:xfrm>
+            <a:off x="6537960" y="2880360"/>
+            <a:ext cx="685800" cy="347472"/>
+          </a:xfrm>
+          <a:prstGeom prst="rect">
+            <a:avLst/>
+          </a:prstGeom>
+          <a:noFill/>
+          <a:ln/>
+        </p:spPr>
+        <p:txBody>
+          <a:bodyPr wrap="square" lIns="0" tIns="0" rIns="0" bIns="0" rtlCol="0" anchor="ctr"/>
+          <a:lstStyle/>
+          <a:p>
+            <a:pPr indent="0" marL="0">
+              <a:buNone/>
+            </a:pPr>
+            <a:r>
+              <a:rPr lang="en-US" sz="2000" b="1" dirty="0">
+                <a:solidFill>
+                  <a:srgbClr val="1A1C2E"/>
+                </a:solidFill>
+                <a:latin typeface="Arial" pitchFamily="34" charset="0"/>
+                <a:ea typeface="Arial" pitchFamily="34" charset="-122"/>
+                <a:cs typeface="Arial" pitchFamily="34" charset="-120"/>
+              </a:rPr>
+              <a:t>20</a:t>
+            </a:r>
+            <a:endParaRPr lang="en-US" sz="2000" dirty="0"/>
+          </a:p>
+        </p:txBody>
+      </p:sp>
+      <p:sp>
+        <p:nvSpPr>
+          <p:cNvPr id="8" name="Text 6"/>
+          <p:cNvSpPr/>
+          <p:nvPr/>
+        </p:nvSpPr>
+        <p:spPr>
+          <a:xfrm>
+            <a:off x="7315200" y="2880360"/>
+            <a:ext cx="4069080" cy="347472"/>
+          </a:xfrm>
+          <a:prstGeom prst="rect">
+            <a:avLst/>
+          </a:prstGeom>
+          <a:noFill/>
+          <a:ln/>
+        </p:spPr>
+        <p:txBody>
+          <a:bodyPr wrap="square" lIns="0" tIns="0" rIns="0" bIns="0" rtlCol="0" anchor="ctr"/>
+          <a:lstStyle/>
+          <a:p>
+            <a:pPr indent="0" marL="0">
+              <a:buNone/>
+            </a:pPr>
+            <a:r>
+              <a:rPr lang="en-US" sz="1500" dirty="0">
+                <a:solidFill>
+                  <a:srgbClr val="1A1C2E"/>
+                </a:solidFill>
+                <a:latin typeface="Calibri" pitchFamily="34" charset="0"/>
+                <a:ea typeface="Calibri" pitchFamily="34" charset="-122"/>
+                <a:cs typeface="Calibri" pitchFamily="34" charset="-120"/>
+              </a:rPr>
+              <a:t>PIDs de la norma SAE J1979</a:t>
+            </a:r>
+            <a:endParaRPr lang="en-US" sz="1500" dirty="0"/>
+          </a:p>
+        </p:txBody>
+      </p:sp>
+      <p:sp>
+        <p:nvSpPr>
+          <p:cNvPr id="9" name="Text 7"/>
+          <p:cNvSpPr/>
+          <p:nvPr/>
+        </p:nvSpPr>
+        <p:spPr>
+          <a:xfrm>
+            <a:off x="6537960" y="3447288"/>
+            <a:ext cx="685800" cy="347472"/>
+          </a:xfrm>
+          <a:prstGeom prst="rect">
+            <a:avLst/>
+          </a:prstGeom>
+          <a:noFill/>
+          <a:ln/>
+        </p:spPr>
+        <p:txBody>
+          <a:bodyPr wrap="square" lIns="0" tIns="0" rIns="0" bIns="0" rtlCol="0" anchor="ctr"/>
+          <a:lstStyle/>
+          <a:p>
+            <a:pPr indent="0" marL="0">
+              <a:buNone/>
+            </a:pPr>
+            <a:r>
+              <a:rPr lang="en-US" sz="2000" b="1" dirty="0">
+                <a:solidFill>
+                  <a:srgbClr val="1A1C2E"/>
+                </a:solidFill>
+                <a:latin typeface="Arial" pitchFamily="34" charset="0"/>
+                <a:ea typeface="Arial" pitchFamily="34" charset="-122"/>
+                <a:cs typeface="Arial" pitchFamily="34" charset="-120"/>
+              </a:rPr>
+              <a:t>23</a:t>
+            </a:r>
+            <a:endParaRPr lang="en-US" sz="2000" dirty="0"/>
+          </a:p>
+        </p:txBody>
+      </p:sp>
+      <p:sp>
+        <p:nvSpPr>
+          <p:cNvPr id="10" name="Text 8"/>
+          <p:cNvSpPr/>
+          <p:nvPr/>
+        </p:nvSpPr>
+        <p:spPr>
+          <a:xfrm>
+            <a:off x="7315200" y="3447288"/>
+            <a:ext cx="4069080" cy="347472"/>
+          </a:xfrm>
+          <a:prstGeom prst="rect">
+            <a:avLst/>
+          </a:prstGeom>
+          <a:noFill/>
+          <a:ln/>
+        </p:spPr>
+        <p:txBody>
+          <a:bodyPr wrap="square" lIns="0" tIns="0" rIns="0" bIns="0" rtlCol="0" anchor="ctr"/>
+          <a:lstStyle/>
+          <a:p>
+            <a:pPr indent="0" marL="0">
+              <a:buNone/>
+            </a:pPr>
+            <a:r>
+              <a:rPr lang="en-US" sz="1500" dirty="0">
+                <a:solidFill>
+                  <a:srgbClr val="1A1C2E"/>
+                </a:solidFill>
+                <a:latin typeface="Calibri" pitchFamily="34" charset="0"/>
+                <a:ea typeface="Calibri" pitchFamily="34" charset="-122"/>
+                <a:cs typeface="Calibri" pitchFamily="34" charset="-120"/>
+              </a:rPr>
+              <a:t>códigos DTC estándar</a:t>
+            </a:r>
+            <a:endParaRPr lang="en-US" sz="1500" dirty="0"/>
+          </a:p>
+        </p:txBody>
+      </p:sp>
+      <p:sp>
+        <p:nvSpPr>
+          <p:cNvPr id="11" name="Text 9"/>
+          <p:cNvSpPr/>
+          <p:nvPr/>
+        </p:nvSpPr>
+        <p:spPr>
+          <a:xfrm>
+            <a:off x="6537960" y="4014216"/>
+            <a:ext cx="685800" cy="347472"/>
+          </a:xfrm>
+          <a:prstGeom prst="rect">
+            <a:avLst/>
+          </a:prstGeom>
+          <a:noFill/>
+          <a:ln/>
+        </p:spPr>
+        <p:txBody>
+          <a:bodyPr wrap="square" lIns="0" tIns="0" rIns="0" bIns="0" rtlCol="0" anchor="ctr"/>
+          <a:lstStyle/>
+          <a:p>
+            <a:pPr indent="0" marL="0">
+              <a:buNone/>
+            </a:pPr>
+            <a:r>
+              <a:rPr lang="en-US" sz="2000" b="1" dirty="0">
+                <a:solidFill>
+                  <a:srgbClr val="1A1C2E"/>
+                </a:solidFill>
+                <a:latin typeface="Arial" pitchFamily="34" charset="0"/>
+                <a:ea typeface="Arial" pitchFamily="34" charset="-122"/>
+                <a:cs typeface="Arial" pitchFamily="34" charset="-120"/>
+              </a:rPr>
+              <a:t>27</a:t>
+            </a:r>
+            <a:endParaRPr lang="en-US" sz="2000" dirty="0"/>
+          </a:p>
+        </p:txBody>
+      </p:sp>
+      <p:sp>
+        <p:nvSpPr>
+          <p:cNvPr id="12" name="Text 10"/>
+          <p:cNvSpPr/>
+          <p:nvPr/>
+        </p:nvSpPr>
+        <p:spPr>
+          <a:xfrm>
+            <a:off x="7315200" y="4014216"/>
+            <a:ext cx="4069080" cy="347472"/>
+          </a:xfrm>
+          <a:prstGeom prst="rect">
+            <a:avLst/>
+          </a:prstGeom>
+          <a:noFill/>
+          <a:ln/>
+        </p:spPr>
+        <p:txBody>
+          <a:bodyPr wrap="square" lIns="0" tIns="0" rIns="0" bIns="0" rtlCol="0" anchor="ctr"/>
+          <a:lstStyle/>
+          <a:p>
+            <a:pPr indent="0" marL="0">
+              <a:buNone/>
+            </a:pPr>
+            <a:r>
+              <a:rPr lang="en-US" sz="1500" dirty="0">
+                <a:solidFill>
+                  <a:srgbClr val="1A1C2E"/>
+                </a:solidFill>
+                <a:latin typeface="Calibri" pitchFamily="34" charset="0"/>
+                <a:ea typeface="Calibri" pitchFamily="34" charset="-122"/>
+                <a:cs typeface="Calibri" pitchFamily="34" charset="-120"/>
+              </a:rPr>
+              <a:t>fabricantes, por su código WMI</a:t>
+            </a:r>
+            <a:endParaRPr lang="en-US" sz="1500" dirty="0"/>
+          </a:p>
+        </p:txBody>
+      </p:sp>
+      <p:sp>
+        <p:nvSpPr>
+          <p:cNvPr id="13" name="Text 11"/>
+          <p:cNvSpPr/>
+          <p:nvPr/>
+        </p:nvSpPr>
+        <p:spPr>
+          <a:xfrm>
+            <a:off x="6537960" y="4754880"/>
+            <a:ext cx="4846320" cy="548640"/>
+          </a:xfrm>
+          <a:prstGeom prst="rect">
+            <a:avLst/>
+          </a:prstGeom>
+          <a:noFill/>
+          <a:ln/>
+        </p:spPr>
+        <p:txBody>
+          <a:bodyPr wrap="square" lIns="0" tIns="0" rIns="0" bIns="0" rtlCol="0" anchor="t"/>
+          <a:lstStyle/>
+          <a:p>
+            <a:pPr indent="0" marL="0">
+              <a:lnSpc>
+                <a:spcPts val="1900"/>
+              </a:lnSpc>
+              <a:buNone/>
+            </a:pPr>
+            <a:r>
+              <a:rPr lang="en-US" sz="1400" dirty="0">
+                <a:solidFill>
+                  <a:srgbClr val="5A5F73"/>
+                </a:solidFill>
+                <a:latin typeface="Calibri" pitchFamily="34" charset="0"/>
+                <a:ea typeface="Calibri" pitchFamily="34" charset="-122"/>
+                <a:cs typeface="Calibri" pitchFamily="34" charset="-120"/>
+              </a:rPr>
+              <a:t>De ahí arranca. Todo lo que el sistema aprenda después va a la vectorial.</a:t>
+            </a:r>
+            <a:endParaRPr lang="en-US" sz="1400" dirty="0"/>
+          </a:p>
+        </p:txBody>
+      </p:sp>
+      <p:sp>
+        <p:nvSpPr>
+          <p:cNvPr id="14" name="Text 12"/>
+          <p:cNvSpPr/>
+          <p:nvPr/>
+        </p:nvSpPr>
+        <p:spPr>
+          <a:xfrm>
+            <a:off x="777240" y="5715000"/>
+            <a:ext cx="10607040" cy="365760"/>
+          </a:xfrm>
+          <a:prstGeom prst="rect">
+            <a:avLst/>
+          </a:prstGeom>
+          <a:noFill/>
+          <a:ln/>
+        </p:spPr>
+        <p:txBody>
+          <a:bodyPr wrap="square" lIns="0" tIns="0" rIns="0" bIns="0" rtlCol="0" anchor="t"/>
+          <a:lstStyle/>
+          <a:p>
+            <a:pPr indent="0" marL="0">
+              <a:buNone/>
+            </a:pPr>
+            <a:r>
+              <a:rPr lang="en-US" sz="1400" dirty="0">
+                <a:solidFill>
+                  <a:srgbClr val="5A5F73"/>
+                </a:solidFill>
+                <a:latin typeface="Calibri" pitchFamily="34" charset="0"/>
+                <a:ea typeface="Calibri" pitchFamily="34" charset="-122"/>
+                <a:cs typeface="Calibri" pitchFamily="34" charset="-120"/>
+              </a:rPr>
+              <a:t>Es un fichero en disco. PostgreSQL se descartó: a esta escala solo añadía un servicio, una red y un backup que mantener.</a:t>
+            </a:r>
+            <a:endParaRPr lang="en-US" sz="1400" dirty="0"/>
+          </a:p>
+        </p:txBody>
+      </p:sp>
+      <p:sp>
+        <p:nvSpPr>
+          <p:cNvPr id="15" name="Shape 13"/>
+          <p:cNvSpPr/>
+          <p:nvPr/>
+        </p:nvSpPr>
+        <p:spPr>
+          <a:xfrm>
+            <a:off x="777240" y="6263640"/>
+            <a:ext cx="219456" cy="219456"/>
+          </a:xfrm>
+          <a:prstGeom prst="rect">
+            <a:avLst/>
+          </a:prstGeom>
+          <a:solidFill>
+            <a:srgbClr val="202CFC"/>
+          </a:solidFill>
+          <a:ln/>
+        </p:spPr>
+      </p:sp>
+      <p:sp>
+        <p:nvSpPr>
+          <p:cNvPr id="16" name="Text 14"/>
+          <p:cNvSpPr/>
+          <p:nvPr/>
+        </p:nvSpPr>
+        <p:spPr>
+          <a:xfrm>
+            <a:off x="777240" y="6263640"/>
+            <a:ext cx="219456" cy="219456"/>
+          </a:xfrm>
+          <a:prstGeom prst="rect">
+            <a:avLst/>
+          </a:prstGeom>
+          <a:noFill/>
+          <a:ln/>
+        </p:spPr>
+        <p:txBody>
+          <a:bodyPr wrap="square" lIns="0" tIns="0" rIns="0" bIns="0" rtlCol="0" anchor="ctr"/>
+          <a:lstStyle/>
+          <a:p>
+            <a:pPr algn="ctr" indent="0" marL="0">
+              <a:buNone/>
+            </a:pPr>
+            <a:r>
+              <a:rPr lang="en-US" sz="816" b="1" dirty="0">
+                <a:solidFill>
+                  <a:srgbClr val="FFFFFF"/>
+                </a:solidFill>
+                <a:latin typeface="Arial" pitchFamily="34" charset="0"/>
+                <a:ea typeface="Arial" pitchFamily="34" charset="-122"/>
+                <a:cs typeface="Arial" pitchFamily="34" charset="-120"/>
+              </a:rPr>
+              <a:t>BIG</a:t>
+            </a:r>
+            <a:endParaRPr lang="en-US" sz="816" dirty="0"/>
+          </a:p>
+        </p:txBody>
+      </p:sp>
+      <p:sp>
+        <p:nvSpPr>
+          <p:cNvPr id="17" name="Text 15"/>
+          <p:cNvSpPr/>
+          <p:nvPr/>
+        </p:nvSpPr>
+        <p:spPr>
+          <a:xfrm>
+            <a:off x="1078992" y="6263640"/>
+            <a:ext cx="658368" cy="219456"/>
+          </a:xfrm>
+          <a:prstGeom prst="rect">
+            <a:avLst/>
+          </a:prstGeom>
+          <a:noFill/>
+          <a:ln/>
+        </p:spPr>
+        <p:txBody>
+          <a:bodyPr wrap="square" lIns="0" tIns="0" rIns="0" bIns="0" rtlCol="0" anchor="ctr"/>
+          <a:lstStyle/>
+          <a:p>
+            <a:pPr algn="l" indent="0" marL="0">
+              <a:buNone/>
+            </a:pPr>
+            <a:r>
+              <a:rPr lang="en-US" sz="816" dirty="0">
+                <a:solidFill>
+                  <a:srgbClr val="1A1C2E"/>
+                </a:solidFill>
+                <a:latin typeface="Arial" pitchFamily="34" charset="0"/>
+                <a:ea typeface="Arial" pitchFamily="34" charset="-122"/>
+                <a:cs typeface="Arial" pitchFamily="34" charset="-120"/>
+              </a:rPr>
+              <a:t>school</a:t>
+            </a:r>
+            <a:endParaRPr lang="en-US" sz="816" dirty="0"/>
+          </a:p>
+        </p:txBody>
+      </p:sp>
+      <p:sp>
+        <p:nvSpPr>
+          <p:cNvPr id="18" name="Text 16"/>
+          <p:cNvSpPr/>
+          <p:nvPr/>
+        </p:nvSpPr>
+        <p:spPr>
+          <a:xfrm>
+            <a:off x="11064240" y="6263640"/>
+            <a:ext cx="320040" cy="219456"/>
+          </a:xfrm>
+          <a:prstGeom prst="rect">
+            <a:avLst/>
+          </a:prstGeom>
+          <a:noFill/>
+          <a:ln/>
+        </p:spPr>
+        <p:txBody>
+          <a:bodyPr wrap="square" lIns="0" tIns="0" rIns="0" bIns="0" rtlCol="0" anchor="ctr"/>
+          <a:lstStyle/>
+          <a:p>
+            <a:pPr algn="r" indent="0" marL="0">
+              <a:buNone/>
+            </a:pPr>
+            <a:r>
+              <a:rPr lang="en-US" sz="1000" dirty="0">
+                <a:solidFill>
+                  <a:srgbClr val="5A5F73"/>
+                </a:solidFill>
+                <a:latin typeface="Calibri" pitchFamily="34" charset="0"/>
+                <a:ea typeface="Calibri" pitchFamily="34" charset="-122"/>
+                <a:cs typeface="Calibri" pitchFamily="34" charset="-120"/>
+              </a:rPr>
+              <a:t>7</a:t>
+            </a:r>
+            <a:endParaRPr lang="en-US" sz="1000" dirty="0"/>
+          </a:p>
+        </p:txBody>
+      </p:sp>
+    </p:spTree>
+  </p:cSld>
+  <p:clrMapOvr>
+    <a:masterClrMapping/>
+  </p:clrMapOvr>
+</p:sld>
+</file>
+
+<file path=ppt/slides/slide8.xml><?xml version="1.0" encoding="utf-8"?>
+<p:sld xmlns:a="http://schemas.openxmlformats.org/drawingml/2006/main" xmlns:r="http://schemas.openxmlformats.org/officeDocument/2006/relationships" xmlns:p="http://schemas.openxmlformats.org/presentationml/2006/main">
+  <p:cSld name="Slide 8">
+    <p:bg>
+      <p:bgPr>
+        <a:solidFill>
+          <a:srgbClr val="FFFFFF"/>
+        </a:solidFill>
+      </p:bgPr>
+    </p:bg>
+    <p:spTree>
+      <p:nvGrpSpPr>
+        <p:cNvPr id="1" name=""/>
+        <p:cNvGrpSpPr/>
+        <p:nvPr/>
+      </p:nvGrpSpPr>
+      <p:grpSpPr>
+        <a:xfrm>
+          <a:off x="0" y="0"/>
+          <a:ext cx="0" cy="0"/>
+          <a:chOff x="0" y="0"/>
+          <a:chExt cx="0" cy="0"/>
+        </a:xfrm>
+      </p:grpSpPr>
+      <p:sp>
+        <p:nvSpPr>
+          <p:cNvPr id="2" name="Text 0"/>
+          <p:cNvSpPr/>
+          <p:nvPr/>
+        </p:nvSpPr>
+        <p:spPr>
+          <a:xfrm>
             <a:off x="777240" y="594360"/>
             <a:ext cx="10607040" cy="731520"/>
           </a:xfrm>
@@ -5591,7 +7154,7 @@
                 <a:ea typeface="Calibri" pitchFamily="34" charset="-122"/>
                 <a:cs typeface="Calibri" pitchFamily="34" charset="-120"/>
               </a:rPr>
-              <a:t>6</a:t>
+              <a:t>8</a:t>
             </a:r>
             <a:endParaRPr lang="en-US" sz="1000" dirty="0"/>
           </a:p>

</xml_diff>

<commit_message>
docs(tfm): corregir donde se guarda un PID descubierto
</commit_message>
<xml_diff>
--- a/docs/presentacion/tfm-intelligent-automotive-diagnostics.pptx
+++ b/docs/presentacion/tfm-intelligent-automotive-diagnostics.pptx
@@ -970,7 +970,7 @@
               <a:rPr lang="en-US" dirty="0"/>
               <a:t>El proyecto tiene dos bases de datos, y cada una guarda una cosa distinta.
 En SQLite va el dato que ya se conoce y que es seguro: los usuarios, que pueden ser particulares o talleres, los vehículos, las ECUs que se les han descubierto, las sesiones de diagnóstico, y los catálogos que vienen de la norma. Todo eso se consulta por una clave: dame el vehículo con este VIN, dame las sesiones de este usuario.
-En la vectorial va lo que el sistema descubre: PIDs y DTCs propietarios que no están en la norma, y los diagnósticos ya resueltos. Ahí no hay clave por la que preguntar, porque lo que quiero es "enséñame algo parecido a esto".
+En la vectorial va ese mismo conocimiento pero indexado por significado, más los diagnósticos ya resueltos, que solo están ahí. La diferencia no es qué se guarda, es cómo se busca: en SQLite pregunto por una clave, y en la vectorial pido "enséñame algo parecido a esto".
 Y no vale con una sola. SQLite tiene buscador de texto, pero busca palabras: si el mecánico escribe "presión de aceite", no encuentra una ficha que ponga "oil pressure". La búsqueda vectorial sí, porque compara significado.
 Las dos son embebidas: un fichero y un directorio en disco. Cero servidores.
 [~55 s]</a:t>
@@ -1063,7 +1063,7 @@
               <a:rPr lang="en-US" dirty="0"/>
               <a:t>En SQLite hay trece tablas, y ahí está todo lo que se puede pedir por una clave exacta.
 Los usuarios, que pueden ser particulares o talleres, con su rol. Los vehículos, identificados por su VIN, y las ECUs que se le han descubierto a cada uno en el bus. Las sesiones de diagnóstico, y de cada una el informe congelado, tal como salió ese día. Las lecturas de PID, guardando tanto el hexadecimal crudo que devolvió la centralita como el valor ya convertido. Y los logs y la auditoría de cada petición HTTP, que es requisito de OWASP.
-Al arrancar, la base se siembra: veinte PIDs de la norma SAE J1979, veintitrés códigos DTC estándar y veintisiete fabricantes por su código WMI, que es lo que permite sacar la marca de un VIN. De ahí parte el sistema, y todo lo que aprenda después va a la base vectorial.
+Al arrancar, la base se siembra: veinte PIDs de la norma SAE J1979, veintitrés códigos DTC estándar y veintisiete fabricantes por su código WMI, que es lo que permite sacar la marca de un VIN. Pero el catálogo no se queda ahí: cuando el agente lee un PID que no conoce, se inserta solo en esta base con confianza 0,3 y una fórmula asumida, marcado como auto-descubierto. Vale como pista, no como dato confirmado, hasta que se valida contra el coche.
 Es un fichero en disco, sin servidor. PostgreSQL se descartó porque a esta escala solo añadía un servicio, una red y un backup que mantener, sin resolver ningún problema que yo tuviera.
 [~60 s]</a:t>
             </a:r>
@@ -4632,7 +4632,7 @@
                 <a:ea typeface="Calibri" pitchFamily="34" charset="-122"/>
                 <a:cs typeface="Calibri" pitchFamily="34" charset="-120"/>
               </a:rPr>
-              <a:t>Una para el dato que ya se conoce. Otra para lo que el sistema descubre.</a:t>
+              <a:t>En una se busca por clave. En la otra, por parecido.</a:t>
             </a:r>
             <a:endParaRPr lang="en-US" sz="1700" dirty="0"/>
           </a:p>
@@ -4741,7 +4741,7 @@
                 <a:ea typeface="Calibri" pitchFamily="34" charset="-122"/>
                 <a:cs typeface="Calibri" pitchFamily="34" charset="-120"/>
               </a:rPr>
-              <a:t>Los catálogos que vienen de la norma</a:t>
+              <a:t>Los catálogos de PID, DTC y ECU: los de la norma y los que se descubren</a:t>
             </a:r>
             <a:endParaRPr lang="en-US" sz="1600" dirty="0"/>
           </a:p>
@@ -4765,7 +4765,7 @@
                 <a:ea typeface="Calibri" pitchFamily="34" charset="-122"/>
                 <a:cs typeface="Calibri" pitchFamily="34" charset="-120"/>
               </a:rPr>
-              <a:t>Se consulta por clave: este VIN, este usuario</a:t>
+              <a:t>Se consulta por clave: este VIN, este PID</a:t>
             </a:r>
             <a:endParaRPr lang="en-US" sz="1600" dirty="0"/>
           </a:p>
@@ -4850,7 +4850,7 @@
                 <a:ea typeface="Calibri" pitchFamily="34" charset="-122"/>
                 <a:cs typeface="Calibri" pitchFamily="34" charset="-120"/>
               </a:rPr>
-              <a:t>PIDs y DTCs propietarios que se van descubriendo</a:t>
+              <a:t>Ese mismo conocimiento, indexado por significado</a:t>
             </a:r>
             <a:endParaRPr lang="en-US" sz="1600" dirty="0"/>
           </a:p>
@@ -4874,7 +4874,7 @@
                 <a:ea typeface="Calibri" pitchFamily="34" charset="-122"/>
                 <a:cs typeface="Calibri" pitchFamily="34" charset="-120"/>
               </a:rPr>
-              <a:t>Los diagnósticos ya resueltos</a:t>
+              <a:t>Y los diagnósticos ya resueltos, que aquí no están</a:t>
             </a:r>
             <a:endParaRPr lang="en-US" sz="1600" dirty="0"/>
           </a:p>
@@ -5187,7 +5187,7 @@
                 <a:ea typeface="Arial" pitchFamily="34" charset="-122"/>
                 <a:cs typeface="Arial" pitchFamily="34" charset="-120"/>
               </a:rPr>
-              <a:t>SQLite: el dato que ya se conoce</a:t>
+              <a:t>SQLite: el catálogo y los datos del taller</a:t>
             </a:r>
             <a:endParaRPr lang="en-US" sz="3400" dirty="0"/>
           </a:p>
@@ -5722,7 +5722,7 @@
                 <a:ea typeface="Calibri" pitchFamily="34" charset="-122"/>
                 <a:cs typeface="Calibri" pitchFamily="34" charset="-120"/>
               </a:rPr>
-              <a:t>De ahí arranca. Todo lo que el sistema aprenda después va a la vectorial.</a:t>
+              <a:t>Y crece solo: un PID que se lee y no está en el catálogo se inserta aquí con confianza 0,3.</a:t>
             </a:r>
             <a:endParaRPr lang="en-US" sz="1400" dirty="0"/>
           </a:p>

</xml_diff>

<commit_message>
docs(tfm): quitar las lineas de cierre de las diapositivas
</commit_message>
<xml_diff>
--- a/docs/presentacion/tfm-intelligent-automotive-diagnostics.pptx
+++ b/docs/presentacion/tfm-intelligent-automotive-diagnostics.pptx
@@ -4354,46 +4354,7 @@
       </p:sp>
       <p:sp>
         <p:nvSpPr>
-          <p:cNvPr id="22" name="Text 20"/>
-          <p:cNvSpPr/>
-          <p:nvPr/>
-        </p:nvSpPr>
-        <p:spPr>
-          <a:xfrm>
-            <a:off x="777240" y="5669280"/>
-            <a:ext cx="10607040" cy="320040"/>
-          </a:xfrm>
-          <a:prstGeom prst="rect">
-            <a:avLst/>
-          </a:prstGeom>
-          <a:noFill/>
-          <a:ln/>
-        </p:spPr>
-        <p:txBody>
-          <a:bodyPr wrap="square" lIns="0" tIns="0" rIns="0" bIns="0" rtlCol="0" anchor="ctr"/>
-          <a:lstStyle/>
-          <a:p>
-            <a:pPr indent="0" marL="0">
-              <a:buNone/>
-            </a:pPr>
-            <a:r>
-              <a:rPr lang="en-US" sz="1400" dirty="0">
-                <a:solidFill>
-                  <a:srgbClr val="5A5F73"/>
-                </a:solidFill>
-                <a:latin typeface="Calibri" pitchFamily="34" charset="0"/>
-                <a:ea typeface="Calibri" pitchFamily="34" charset="-122"/>
-                <a:cs typeface="Calibri" pitchFamily="34" charset="-120"/>
-              </a:rPr>
-              <a:t>La fórmula la fija la SAE J1979 y vive en el dominio.</a:t>
-            </a:r>
-            <a:endParaRPr lang="en-US" sz="1400" dirty="0"/>
-          </a:p>
-        </p:txBody>
-      </p:sp>
-      <p:sp>
-        <p:nvSpPr>
-          <p:cNvPr id="23" name="Shape 21"/>
+          <p:cNvPr id="22" name="Shape 20"/>
           <p:cNvSpPr/>
           <p:nvPr/>
         </p:nvSpPr>
@@ -4413,7 +4374,7 @@
       </p:sp>
       <p:sp>
         <p:nvSpPr>
-          <p:cNvPr id="24" name="Text 22"/>
+          <p:cNvPr id="23" name="Text 21"/>
           <p:cNvSpPr/>
           <p:nvPr/>
         </p:nvSpPr>
@@ -4452,7 +4413,7 @@
       </p:sp>
       <p:sp>
         <p:nvSpPr>
-          <p:cNvPr id="25" name="Text 23"/>
+          <p:cNvPr id="24" name="Text 22"/>
           <p:cNvSpPr/>
           <p:nvPr/>
         </p:nvSpPr>
@@ -4491,7 +4452,7 @@
       </p:sp>
       <p:sp>
         <p:nvSpPr>
-          <p:cNvPr id="26" name="Text 24"/>
+          <p:cNvPr id="25" name="Text 23"/>
           <p:cNvSpPr/>
           <p:nvPr/>
         </p:nvSpPr>
@@ -4902,119 +4863,101 @@
             </a:r>
             <a:endParaRPr lang="en-US" sz="1600" dirty="0"/>
           </a:p>
-        </p:txBody>
-      </p:sp>
-      <p:sp>
-        <p:nvSpPr>
-          <p:cNvPr id="8" name="Text 6"/>
-          <p:cNvSpPr/>
-          <p:nvPr/>
-        </p:nvSpPr>
-        <p:spPr>
-          <a:xfrm>
-            <a:off x="777240" y="5029200"/>
-            <a:ext cx="10607040" cy="320040"/>
-          </a:xfrm>
-          <a:prstGeom prst="rect">
-            <a:avLst/>
-          </a:prstGeom>
-          <a:noFill/>
-          <a:ln/>
-        </p:spPr>
-        <p:txBody>
-          <a:bodyPr wrap="square" lIns="0" tIns="0" rIns="0" bIns="0" rtlCol="0" anchor="t"/>
-          <a:lstStyle/>
-          <a:p>
-            <a:pPr indent="0" marL="0">
-              <a:buNone/>
-            </a:pPr>
-            <a:r>
-              <a:rPr lang="en-US" sz="1600" b="1" dirty="0">
-                <a:solidFill>
-                  <a:srgbClr val="1A1C2E"/>
+          <a:p>
+            <a:pPr marL="342900" indent="-342900">
+              <a:lnSpc>
+                <a:spcPts val="2200"/>
+              </a:lnSpc>
+              <a:spcAft>
+                <a:spcPts val="1200"/>
+              </a:spcAft>
+              <a:buSzPct val="100000"/>
+              <a:buChar char="•"/>
+            </a:pPr>
+            <a:r>
+              <a:rPr lang="en-US" sz="1600" dirty="0">
+                <a:solidFill>
+                  <a:srgbClr val="1A1C2E"/>
+                </a:solidFill>
+                <a:latin typeface="Calibri" pitchFamily="34" charset="0"/>
+                <a:ea typeface="Calibri" pitchFamily="34" charset="-122"/>
+                <a:cs typeface="Calibri" pitchFamily="34" charset="-120"/>
+              </a:rPr>
+              <a:t>El buscador de texto de SQLite no llega: «presión de aceite» no encuentra «oil pressure»</a:t>
+            </a:r>
+            <a:endParaRPr lang="en-US" sz="1600" dirty="0"/>
+          </a:p>
+        </p:txBody>
+      </p:sp>
+      <p:sp>
+        <p:nvSpPr>
+          <p:cNvPr id="8" name="Shape 6"/>
+          <p:cNvSpPr/>
+          <p:nvPr/>
+        </p:nvSpPr>
+        <p:spPr>
+          <a:xfrm>
+            <a:off x="777240" y="6263640"/>
+            <a:ext cx="219456" cy="219456"/>
+          </a:xfrm>
+          <a:prstGeom prst="rect">
+            <a:avLst/>
+          </a:prstGeom>
+          <a:solidFill>
+            <a:srgbClr val="202CFC"/>
+          </a:solidFill>
+          <a:ln/>
+        </p:spPr>
+      </p:sp>
+      <p:sp>
+        <p:nvSpPr>
+          <p:cNvPr id="9" name="Text 7"/>
+          <p:cNvSpPr/>
+          <p:nvPr/>
+        </p:nvSpPr>
+        <p:spPr>
+          <a:xfrm>
+            <a:off x="777240" y="6263640"/>
+            <a:ext cx="219456" cy="219456"/>
+          </a:xfrm>
+          <a:prstGeom prst="rect">
+            <a:avLst/>
+          </a:prstGeom>
+          <a:noFill/>
+          <a:ln/>
+        </p:spPr>
+        <p:txBody>
+          <a:bodyPr wrap="square" lIns="0" tIns="0" rIns="0" bIns="0" rtlCol="0" anchor="ctr"/>
+          <a:lstStyle/>
+          <a:p>
+            <a:pPr algn="ctr" indent="0" marL="0">
+              <a:buNone/>
+            </a:pPr>
+            <a:r>
+              <a:rPr lang="en-US" sz="816" b="1" dirty="0">
+                <a:solidFill>
+                  <a:srgbClr val="FFFFFF"/>
                 </a:solidFill>
                 <a:latin typeface="Arial" pitchFamily="34" charset="0"/>
                 <a:ea typeface="Arial" pitchFamily="34" charset="-122"/>
                 <a:cs typeface="Arial" pitchFamily="34" charset="-120"/>
               </a:rPr>
-              <a:t>No vale con una sola: el buscador de texto de SQLite busca palabras, no significado.</a:t>
-            </a:r>
-            <a:endParaRPr lang="en-US" sz="1600" dirty="0"/>
-          </a:p>
-        </p:txBody>
-      </p:sp>
-      <p:sp>
-        <p:nvSpPr>
-          <p:cNvPr id="9" name="Text 7"/>
-          <p:cNvSpPr/>
-          <p:nvPr/>
-        </p:nvSpPr>
-        <p:spPr>
-          <a:xfrm>
-            <a:off x="777240" y="5440680"/>
-            <a:ext cx="10607040" cy="548640"/>
-          </a:xfrm>
-          <a:prstGeom prst="rect">
-            <a:avLst/>
-          </a:prstGeom>
-          <a:noFill/>
-          <a:ln/>
-        </p:spPr>
-        <p:txBody>
-          <a:bodyPr wrap="square" lIns="0" tIns="0" rIns="0" bIns="0" rtlCol="0" anchor="t"/>
-          <a:lstStyle/>
-          <a:p>
-            <a:pPr indent="0" marL="0">
-              <a:lnSpc>
-                <a:spcPts val="2100"/>
-              </a:lnSpc>
-              <a:buNone/>
-            </a:pPr>
-            <a:r>
-              <a:rPr lang="en-US" sz="1500" dirty="0">
-                <a:solidFill>
-                  <a:srgbClr val="5A5F73"/>
-                </a:solidFill>
-                <a:latin typeface="Calibri" pitchFamily="34" charset="0"/>
-                <a:ea typeface="Calibri" pitchFamily="34" charset="-122"/>
-                <a:cs typeface="Calibri" pitchFamily="34" charset="-120"/>
-              </a:rPr>
-              <a:t>«Presión de aceite» no encuentra «oil pressure». Las dos van embebidas: un fichero y un directorio en disco, sin servidor que levantar.</a:t>
-            </a:r>
-            <a:endParaRPr lang="en-US" sz="1500" dirty="0"/>
-          </a:p>
-        </p:txBody>
-      </p:sp>
-      <p:sp>
-        <p:nvSpPr>
-          <p:cNvPr id="10" name="Shape 8"/>
-          <p:cNvSpPr/>
-          <p:nvPr/>
-        </p:nvSpPr>
-        <p:spPr>
-          <a:xfrm>
-            <a:off x="777240" y="6263640"/>
-            <a:ext cx="219456" cy="219456"/>
-          </a:xfrm>
-          <a:prstGeom prst="rect">
-            <a:avLst/>
-          </a:prstGeom>
-          <a:solidFill>
-            <a:srgbClr val="202CFC"/>
-          </a:solidFill>
-          <a:ln/>
-        </p:spPr>
-      </p:sp>
-      <p:sp>
-        <p:nvSpPr>
-          <p:cNvPr id="11" name="Text 9"/>
-          <p:cNvSpPr/>
-          <p:nvPr/>
-        </p:nvSpPr>
-        <p:spPr>
-          <a:xfrm>
-            <a:off x="777240" y="6263640"/>
-            <a:ext cx="219456" cy="219456"/>
+              <a:t>BIG</a:t>
+            </a:r>
+            <a:endParaRPr lang="en-US" sz="816" dirty="0"/>
+          </a:p>
+        </p:txBody>
+      </p:sp>
+      <p:sp>
+        <p:nvSpPr>
+          <p:cNvPr id="10" name="Text 8"/>
+          <p:cNvSpPr/>
+          <p:nvPr/>
+        </p:nvSpPr>
+        <p:spPr>
+          <a:xfrm>
+            <a:off x="1078992" y="6263640"/>
+            <a:ext cx="658368" cy="219456"/>
           </a:xfrm>
           <a:prstGeom prst="rect">
             <a:avLst/>
@@ -5026,19 +4969,19 @@
           <a:bodyPr wrap="square" lIns="0" tIns="0" rIns="0" bIns="0" rtlCol="0" anchor="ctr"/>
           <a:lstStyle/>
           <a:p>
-            <a:pPr algn="ctr" indent="0" marL="0">
-              <a:buNone/>
-            </a:pPr>
-            <a:r>
-              <a:rPr lang="en-US" sz="816" b="1" dirty="0">
-                <a:solidFill>
-                  <a:srgbClr val="FFFFFF"/>
+            <a:pPr algn="l" indent="0" marL="0">
+              <a:buNone/>
+            </a:pPr>
+            <a:r>
+              <a:rPr lang="en-US" sz="816" dirty="0">
+                <a:solidFill>
+                  <a:srgbClr val="1A1C2E"/>
                 </a:solidFill>
                 <a:latin typeface="Arial" pitchFamily="34" charset="0"/>
                 <a:ea typeface="Arial" pitchFamily="34" charset="-122"/>
                 <a:cs typeface="Arial" pitchFamily="34" charset="-120"/>
               </a:rPr>
-              <a:t>BIG</a:t>
+              <a:t>school</a:t>
             </a:r>
             <a:endParaRPr lang="en-US" sz="816" dirty="0"/>
           </a:p>
@@ -5046,46 +4989,7 @@
       </p:sp>
       <p:sp>
         <p:nvSpPr>
-          <p:cNvPr id="12" name="Text 10"/>
-          <p:cNvSpPr/>
-          <p:nvPr/>
-        </p:nvSpPr>
-        <p:spPr>
-          <a:xfrm>
-            <a:off x="1078992" y="6263640"/>
-            <a:ext cx="658368" cy="219456"/>
-          </a:xfrm>
-          <a:prstGeom prst="rect">
-            <a:avLst/>
-          </a:prstGeom>
-          <a:noFill/>
-          <a:ln/>
-        </p:spPr>
-        <p:txBody>
-          <a:bodyPr wrap="square" lIns="0" tIns="0" rIns="0" bIns="0" rtlCol="0" anchor="ctr"/>
-          <a:lstStyle/>
-          <a:p>
-            <a:pPr algn="l" indent="0" marL="0">
-              <a:buNone/>
-            </a:pPr>
-            <a:r>
-              <a:rPr lang="en-US" sz="816" dirty="0">
-                <a:solidFill>
-                  <a:srgbClr val="1A1C2E"/>
-                </a:solidFill>
-                <a:latin typeface="Arial" pitchFamily="34" charset="0"/>
-                <a:ea typeface="Arial" pitchFamily="34" charset="-122"/>
-                <a:cs typeface="Arial" pitchFamily="34" charset="-120"/>
-              </a:rPr>
-              <a:t>school</a:t>
-            </a:r>
-            <a:endParaRPr lang="en-US" sz="816" dirty="0"/>
-          </a:p>
-        </p:txBody>
-      </p:sp>
-      <p:sp>
-        <p:nvSpPr>
-          <p:cNvPr id="13" name="Text 11"/>
+          <p:cNvPr id="11" name="Text 9"/>
           <p:cNvSpPr/>
           <p:nvPr/>
         </p:nvSpPr>
@@ -5411,6 +5315,30 @@
             </a:r>
             <a:endParaRPr lang="en-US" sz="1500" dirty="0"/>
           </a:p>
+          <a:p>
+            <a:pPr marL="342900" indent="-342900">
+              <a:lnSpc>
+                <a:spcPts val="2100"/>
+              </a:lnSpc>
+              <a:spcAft>
+                <a:spcPts val="1100"/>
+              </a:spcAft>
+              <a:buSzPct val="100000"/>
+              <a:buChar char="•"/>
+            </a:pPr>
+            <a:r>
+              <a:rPr lang="en-US" sz="1500" dirty="0">
+                <a:solidFill>
+                  <a:srgbClr val="1A1C2E"/>
+                </a:solidFill>
+                <a:latin typeface="Calibri" pitchFamily="34" charset="0"/>
+                <a:ea typeface="Calibri" pitchFamily="34" charset="-122"/>
+                <a:cs typeface="Calibri" pitchFamily="34" charset="-120"/>
+              </a:rPr>
+              <a:t>Y crece solo: un PID leído que no esté en el catálogo se inserta con confianza 0,3</a:t>
+            </a:r>
+            <a:endParaRPr lang="en-US" sz="1500" dirty="0"/>
+          </a:p>
         </p:txBody>
       </p:sp>
       <p:sp>
@@ -5688,88 +5616,7 @@
       </p:sp>
       <p:sp>
         <p:nvSpPr>
-          <p:cNvPr id="13" name="Text 11"/>
-          <p:cNvSpPr/>
-          <p:nvPr/>
-        </p:nvSpPr>
-        <p:spPr>
-          <a:xfrm>
-            <a:off x="6537960" y="4754880"/>
-            <a:ext cx="4846320" cy="548640"/>
-          </a:xfrm>
-          <a:prstGeom prst="rect">
-            <a:avLst/>
-          </a:prstGeom>
-          <a:noFill/>
-          <a:ln/>
-        </p:spPr>
-        <p:txBody>
-          <a:bodyPr wrap="square" lIns="0" tIns="0" rIns="0" bIns="0" rtlCol="0" anchor="t"/>
-          <a:lstStyle/>
-          <a:p>
-            <a:pPr indent="0" marL="0">
-              <a:lnSpc>
-                <a:spcPts val="1900"/>
-              </a:lnSpc>
-              <a:buNone/>
-            </a:pPr>
-            <a:r>
-              <a:rPr lang="en-US" sz="1400" dirty="0">
-                <a:solidFill>
-                  <a:srgbClr val="5A5F73"/>
-                </a:solidFill>
-                <a:latin typeface="Calibri" pitchFamily="34" charset="0"/>
-                <a:ea typeface="Calibri" pitchFamily="34" charset="-122"/>
-                <a:cs typeface="Calibri" pitchFamily="34" charset="-120"/>
-              </a:rPr>
-              <a:t>Y crece solo: un PID que se lee y no está en el catálogo se inserta aquí con confianza 0,3.</a:t>
-            </a:r>
-            <a:endParaRPr lang="en-US" sz="1400" dirty="0"/>
-          </a:p>
-        </p:txBody>
-      </p:sp>
-      <p:sp>
-        <p:nvSpPr>
-          <p:cNvPr id="14" name="Text 12"/>
-          <p:cNvSpPr/>
-          <p:nvPr/>
-        </p:nvSpPr>
-        <p:spPr>
-          <a:xfrm>
-            <a:off x="777240" y="5715000"/>
-            <a:ext cx="10607040" cy="365760"/>
-          </a:xfrm>
-          <a:prstGeom prst="rect">
-            <a:avLst/>
-          </a:prstGeom>
-          <a:noFill/>
-          <a:ln/>
-        </p:spPr>
-        <p:txBody>
-          <a:bodyPr wrap="square" lIns="0" tIns="0" rIns="0" bIns="0" rtlCol="0" anchor="t"/>
-          <a:lstStyle/>
-          <a:p>
-            <a:pPr indent="0" marL="0">
-              <a:buNone/>
-            </a:pPr>
-            <a:r>
-              <a:rPr lang="en-US" sz="1400" dirty="0">
-                <a:solidFill>
-                  <a:srgbClr val="5A5F73"/>
-                </a:solidFill>
-                <a:latin typeface="Calibri" pitchFamily="34" charset="0"/>
-                <a:ea typeface="Calibri" pitchFamily="34" charset="-122"/>
-                <a:cs typeface="Calibri" pitchFamily="34" charset="-120"/>
-              </a:rPr>
-              <a:t>Es un fichero en disco. PostgreSQL se descartó: a esta escala solo añadía un servicio, una red y un backup que mantener.</a:t>
-            </a:r>
-            <a:endParaRPr lang="en-US" sz="1400" dirty="0"/>
-          </a:p>
-        </p:txBody>
-      </p:sp>
-      <p:sp>
-        <p:nvSpPr>
-          <p:cNvPr id="15" name="Shape 13"/>
+          <p:cNvPr id="13" name="Shape 11"/>
           <p:cNvSpPr/>
           <p:nvPr/>
         </p:nvSpPr>
@@ -5789,7 +5636,7 @@
       </p:sp>
       <p:sp>
         <p:nvSpPr>
-          <p:cNvPr id="16" name="Text 14"/>
+          <p:cNvPr id="14" name="Text 12"/>
           <p:cNvSpPr/>
           <p:nvPr/>
         </p:nvSpPr>
@@ -5828,7 +5675,7 @@
       </p:sp>
       <p:sp>
         <p:nvSpPr>
-          <p:cNvPr id="17" name="Text 15"/>
+          <p:cNvPr id="15" name="Text 13"/>
           <p:cNvSpPr/>
           <p:nvPr/>
         </p:nvSpPr>
@@ -5867,7 +5714,7 @@
       </p:sp>
       <p:sp>
         <p:nvSpPr>
-          <p:cNvPr id="18" name="Text 16"/>
+          <p:cNvPr id="16" name="Text 14"/>
           <p:cNvSpPr/>
           <p:nvPr/>
         </p:nvSpPr>
@@ -6612,7 +6459,7 @@
                 <a:ea typeface="Calibri" pitchFamily="34" charset="-122"/>
                 <a:cs typeface="Calibri" pitchFamily="34" charset="-120"/>
               </a:rPr>
-              <a:t>Se lo ponemos nosotros al guardar, según de dónde salga el dato.</a:t>
+              <a:t>Se lo ponemos nosotros al guardar, según de dónde salga el dato. Es lo que pondera las búsquedas.</a:t>
             </a:r>
             <a:endParaRPr lang="en-US" sz="1300" dirty="0"/>
           </a:p>
@@ -6986,46 +6833,7 @@
       </p:sp>
       <p:sp>
         <p:nvSpPr>
-          <p:cNvPr id="27" name="Text 25"/>
-          <p:cNvSpPr/>
-          <p:nvPr/>
-        </p:nvSpPr>
-        <p:spPr>
-          <a:xfrm>
-            <a:off x="777240" y="5779008"/>
-            <a:ext cx="6492240" cy="292608"/>
-          </a:xfrm>
-          <a:prstGeom prst="rect">
-            <a:avLst/>
-          </a:prstGeom>
-          <a:noFill/>
-          <a:ln/>
-        </p:spPr>
-        <p:txBody>
-          <a:bodyPr wrap="square" lIns="0" tIns="0" rIns="0" bIns="0" rtlCol="0" anchor="t"/>
-          <a:lstStyle/>
-          <a:p>
-            <a:pPr indent="0" marL="0">
-              <a:buNone/>
-            </a:pPr>
-            <a:r>
-              <a:rPr lang="en-US" sz="1300" dirty="0">
-                <a:solidFill>
-                  <a:srgbClr val="5A5F73"/>
-                </a:solidFill>
-                <a:latin typeface="Calibri" pitchFamily="34" charset="0"/>
-                <a:ea typeface="Calibri" pitchFamily="34" charset="-122"/>
-                <a:cs typeface="Calibri" pitchFamily="34" charset="-120"/>
-              </a:rPr>
-              <a:t>Ese índice pondera las búsquedas: gana la respuesta con más confianza.</a:t>
-            </a:r>
-            <a:endParaRPr lang="en-US" sz="1300" dirty="0"/>
-          </a:p>
-        </p:txBody>
-      </p:sp>
-      <p:sp>
-        <p:nvSpPr>
-          <p:cNvPr id="28" name="Shape 26"/>
+          <p:cNvPr id="27" name="Shape 25"/>
           <p:cNvSpPr/>
           <p:nvPr/>
         </p:nvSpPr>
@@ -7045,7 +6853,7 @@
       </p:sp>
       <p:sp>
         <p:nvSpPr>
-          <p:cNvPr id="29" name="Text 27"/>
+          <p:cNvPr id="28" name="Text 26"/>
           <p:cNvSpPr/>
           <p:nvPr/>
         </p:nvSpPr>
@@ -7084,7 +6892,7 @@
       </p:sp>
       <p:sp>
         <p:nvSpPr>
-          <p:cNvPr id="30" name="Text 28"/>
+          <p:cNvPr id="29" name="Text 27"/>
           <p:cNvSpPr/>
           <p:nvPr/>
         </p:nvSpPr>
@@ -7123,7 +6931,7 @@
       </p:sp>
       <p:sp>
         <p:nvSpPr>
-          <p:cNvPr id="31" name="Text 29"/>
+          <p:cNvPr id="30" name="Text 28"/>
           <p:cNvSpPr/>
           <p:nvPr/>
         </p:nvSpPr>

</xml_diff>

<commit_message>
docs(tfm): slide de los dos diagnosticos
</commit_message>
<xml_diff>
--- a/docs/presentacion/tfm-intelligent-automotive-diagnostics.pptx
+++ b/docs/presentacion/tfm-intelligent-automotive-diagnostics.pptx
@@ -13,9 +13,10 @@
     <p:sldId id="261" r:id="rId7"/>
     <p:sldId id="262" r:id="rId8"/>
     <p:sldId id="263" r:id="rId9"/>
+    <p:sldId id="264" r:id="rId10"/>
   </p:sldIdLst>
   <p:notesMasterIdLst>
-    <p:notesMasterId r:id="rId10"/>
+    <p:notesMasterId r:id="rId11"/>
   </p:notesMasterIdLst>
   <p:sldSz cx="12192000" cy="6858000"/>
   <p:notesSz cx="6858000" cy="12192000"/>
@@ -1181,6 +1182,98 @@
             <a:fld id="{F7021451-1387-4CA6-816F-3879F97B5CBC}" type="slidenum">
               <a:rPr lang="en-US"/>
               <a:t>8</a:t>
+            </a:fld>
+            <a:endParaRPr lang="en-US"/>
+          </a:p>
+        </p:txBody>
+      </p:sp>
+    </p:spTree>
+    <p:extLst>
+      <p:ext uri="{BB962C8B-B14F-4D97-AF65-F5344CB8AC3E}">
+        <p14:creationId xmlns:p14="http://schemas.microsoft.com/office/powerpoint/2010/main" val="1024086991"/>
+      </p:ext>
+    </p:extLst>
+  </p:cSld>
+  <p:clrMapOvr>
+    <a:masterClrMapping/>
+  </p:clrMapOvr>
+</p:notes>
+</file>
+
+<file path=ppt/notesSlides/notesSlide9.xml><?xml version="1.0" encoding="utf-8"?>
+<p:notes xmlns:a="http://schemas.openxmlformats.org/drawingml/2006/main" xmlns:r="http://schemas.openxmlformats.org/officeDocument/2006/relationships" xmlns:p="http://schemas.openxmlformats.org/presentationml/2006/main">
+  <p:cSld>
+    <p:spTree>
+      <p:nvGrpSpPr>
+        <p:cNvPr id="1" name=""/>
+        <p:cNvGrpSpPr/>
+        <p:nvPr/>
+      </p:nvGrpSpPr>
+      <p:grpSpPr>
+        <a:xfrm>
+          <a:off x="0" y="0"/>
+          <a:ext cx="0" cy="0"/>
+          <a:chOff x="0" y="0"/>
+          <a:chExt cx="0" cy="0"/>
+        </a:xfrm>
+      </p:grpSpPr>
+      <p:sp>
+        <p:nvSpPr>
+          <p:cNvPr id="2" name="Slide Image Placeholder 1"/>
+          <p:cNvSpPr>
+            <a:spLocks noGrp="1" noRot="1" noChangeAspect="1"/>
+          </p:cNvSpPr>
+          <p:nvPr>
+            <p:ph type="sldImg"/>
+          </p:nvPr>
+        </p:nvSpPr>
+        <p:spPr/>
+      </p:sp>
+      <p:sp>
+        <p:nvSpPr>
+          <p:cNvPr id="3" name="Notes Placeholder 2"/>
+          <p:cNvSpPr>
+            <a:spLocks noGrp="1"/>
+          </p:cNvSpPr>
+          <p:nvPr>
+            <p:ph type="body" idx="1"/>
+          </p:nvPr>
+        </p:nvSpPr>
+        <p:spPr/>
+        <p:txBody>
+          <a:bodyPr/>
+          <a:lstStyle/>
+          <a:p>
+            <a:r>
+              <a:rPr lang="en-US" dirty="0"/>
+              <a:t>El sistema hace dos diagnósticos distintos, y conviven.
+El determinista es el de toda la vida. Lee cuatro PIDs fijos —revoluciones, temperatura de refrigerante, velocidad y temperatura de admisión—, los códigos de avería y el freeze frame. Y la criticidad no me la invento: sale de una regla en el dominio, computeSeverity. Si no hay códigos es baja; si hay freeze frame es crítica, porque significa que la centralita congeló el momento del fallo; y si hay códigos sin freeze frame es alta. Solo necesita el coche conectado, responde al momento, y no aprende nada.
+El cognitivo es el otro. Ahí no hay una lista fija de PIDs: el agente decide qué le hace falta leer y va llamando a las herramientas según lo que encuentra. A cambio necesita tres cosas: el coche, la API del modelo y los índices vectoriales. Tarda más, con un límite de sesenta segundos. Y es el único que aprende: indexa los PIDs y DTCs nuevos y guarda el caso resuelto.
+Por eso conviven. Si no hay modelo configurado, o si no hay internet en el taller, el determinista sigue funcionando.
+[~65 s]</a:t>
+            </a:r>
+            <a:endParaRPr lang="en-US" dirty="0"/>
+          </a:p>
+        </p:txBody>
+      </p:sp>
+      <p:sp>
+        <p:nvSpPr>
+          <p:cNvPr id="4" name="Slide Number Placeholder 3"/>
+          <p:cNvSpPr>
+            <a:spLocks noGrp="1"/>
+          </p:cNvSpPr>
+          <p:nvPr>
+            <p:ph type="sldNum" sz="quarter" idx="10"/>
+          </p:nvPr>
+        </p:nvSpPr>
+        <p:spPr/>
+        <p:txBody>
+          <a:bodyPr/>
+          <a:lstStyle/>
+          <a:p>
+            <a:fld id="{F7021451-1387-4CA6-816F-3879F97B5CBC}" type="slidenum">
+              <a:rPr lang="en-US"/>
+              <a:t>9</a:t>
             </a:fld>
             <a:endParaRPr lang="en-US"/>
           </a:p>
@@ -6976,6 +7069,615 @@
 </p:sld>
 </file>
 
+<file path=ppt/slides/slide9.xml><?xml version="1.0" encoding="utf-8"?>
+<p:sld xmlns:a="http://schemas.openxmlformats.org/drawingml/2006/main" xmlns:r="http://schemas.openxmlformats.org/officeDocument/2006/relationships" xmlns:p="http://schemas.openxmlformats.org/presentationml/2006/main">
+  <p:cSld name="Slide 9">
+    <p:bg>
+      <p:bgPr>
+        <a:solidFill>
+          <a:srgbClr val="FFFFFF"/>
+        </a:solidFill>
+      </p:bgPr>
+    </p:bg>
+    <p:spTree>
+      <p:nvGrpSpPr>
+        <p:cNvPr id="1" name=""/>
+        <p:cNvGrpSpPr/>
+        <p:nvPr/>
+      </p:nvGrpSpPr>
+      <p:grpSpPr>
+        <a:xfrm>
+          <a:off x="0" y="0"/>
+          <a:ext cx="0" cy="0"/>
+          <a:chOff x="0" y="0"/>
+          <a:chExt cx="0" cy="0"/>
+        </a:xfrm>
+      </p:grpSpPr>
+      <p:sp>
+        <p:nvSpPr>
+          <p:cNvPr id="2" name="Text 0"/>
+          <p:cNvSpPr/>
+          <p:nvPr/>
+        </p:nvSpPr>
+        <p:spPr>
+          <a:xfrm>
+            <a:off x="777240" y="640080"/>
+            <a:ext cx="10607040" cy="777240"/>
+          </a:xfrm>
+          <a:prstGeom prst="rect">
+            <a:avLst/>
+          </a:prstGeom>
+          <a:noFill/>
+          <a:ln/>
+        </p:spPr>
+        <p:txBody>
+          <a:bodyPr wrap="square" lIns="0" tIns="0" rIns="0" bIns="0" rtlCol="0" anchor="t"/>
+          <a:lstStyle/>
+          <a:p>
+            <a:pPr indent="0" marL="0">
+              <a:buNone/>
+            </a:pPr>
+            <a:r>
+              <a:rPr lang="en-US" sz="3400" b="1" dirty="0">
+                <a:solidFill>
+                  <a:srgbClr val="1A1C2E"/>
+                </a:solidFill>
+                <a:latin typeface="Arial" pitchFamily="34" charset="0"/>
+                <a:ea typeface="Arial" pitchFamily="34" charset="-122"/>
+                <a:cs typeface="Arial" pitchFamily="34" charset="-120"/>
+              </a:rPr>
+              <a:t>Dos diagnósticos</a:t>
+            </a:r>
+            <a:endParaRPr lang="en-US" sz="3400" dirty="0"/>
+          </a:p>
+        </p:txBody>
+      </p:sp>
+      <p:sp>
+        <p:nvSpPr>
+          <p:cNvPr id="3" name="Text 1"/>
+          <p:cNvSpPr/>
+          <p:nvPr/>
+        </p:nvSpPr>
+        <p:spPr>
+          <a:xfrm>
+            <a:off x="777240" y="1508760"/>
+            <a:ext cx="10607040" cy="365760"/>
+          </a:xfrm>
+          <a:prstGeom prst="rect">
+            <a:avLst/>
+          </a:prstGeom>
+          <a:noFill/>
+          <a:ln/>
+        </p:spPr>
+        <p:txBody>
+          <a:bodyPr wrap="square" lIns="0" tIns="0" rIns="0" bIns="0" rtlCol="0" anchor="t"/>
+          <a:lstStyle/>
+          <a:p>
+            <a:pPr indent="0" marL="0">
+              <a:buNone/>
+            </a:pPr>
+            <a:r>
+              <a:rPr lang="en-US" sz="1700" dirty="0">
+                <a:solidFill>
+                  <a:srgbClr val="5A5F73"/>
+                </a:solidFill>
+                <a:latin typeface="Calibri" pitchFamily="34" charset="0"/>
+                <a:ea typeface="Calibri" pitchFamily="34" charset="-122"/>
+                <a:cs typeface="Calibri" pitchFamily="34" charset="-120"/>
+              </a:rPr>
+              <a:t>El determinista está siempre. El cognitivo, solo si hay un modelo configurado.</a:t>
+            </a:r>
+            <a:endParaRPr lang="en-US" sz="1700" dirty="0"/>
+          </a:p>
+        </p:txBody>
+      </p:sp>
+      <p:sp>
+        <p:nvSpPr>
+          <p:cNvPr id="4" name="Text 2"/>
+          <p:cNvSpPr/>
+          <p:nvPr/>
+        </p:nvSpPr>
+        <p:spPr>
+          <a:xfrm>
+            <a:off x="777240" y="2240280"/>
+            <a:ext cx="4846320" cy="365760"/>
+          </a:xfrm>
+          <a:prstGeom prst="rect">
+            <a:avLst/>
+          </a:prstGeom>
+          <a:noFill/>
+          <a:ln/>
+        </p:spPr>
+        <p:txBody>
+          <a:bodyPr wrap="square" lIns="0" tIns="0" rIns="0" bIns="0" rtlCol="0" anchor="t"/>
+          <a:lstStyle/>
+          <a:p>
+            <a:pPr indent="0" marL="0">
+              <a:buNone/>
+            </a:pPr>
+            <a:r>
+              <a:rPr lang="en-US" sz="2000" b="1" dirty="0">
+                <a:solidFill>
+                  <a:srgbClr val="202CFC"/>
+                </a:solidFill>
+                <a:latin typeface="Arial" pitchFamily="34" charset="0"/>
+                <a:ea typeface="Arial" pitchFamily="34" charset="-122"/>
+                <a:cs typeface="Arial" pitchFamily="34" charset="-120"/>
+              </a:rPr>
+              <a:t>Determinista</a:t>
+            </a:r>
+            <a:endParaRPr lang="en-US" sz="2000" dirty="0"/>
+          </a:p>
+        </p:txBody>
+      </p:sp>
+      <p:sp>
+        <p:nvSpPr>
+          <p:cNvPr id="5" name="Text 3"/>
+          <p:cNvSpPr/>
+          <p:nvPr/>
+        </p:nvSpPr>
+        <p:spPr>
+          <a:xfrm>
+            <a:off x="777240" y="2788920"/>
+            <a:ext cx="4846320" cy="2834640"/>
+          </a:xfrm>
+          <a:prstGeom prst="rect">
+            <a:avLst/>
+          </a:prstGeom>
+          <a:noFill/>
+          <a:ln/>
+        </p:spPr>
+        <p:txBody>
+          <a:bodyPr wrap="square" lIns="0" tIns="0" rIns="0" bIns="0" rtlCol="0" anchor="t"/>
+          <a:lstStyle/>
+          <a:p>
+            <a:pPr marL="342900" indent="-342900">
+              <a:lnSpc>
+                <a:spcPts val="2100"/>
+              </a:lnSpc>
+              <a:spcAft>
+                <a:spcPts val="1100"/>
+              </a:spcAft>
+              <a:buSzPct val="100000"/>
+              <a:buChar char="•"/>
+            </a:pPr>
+            <a:r>
+              <a:rPr lang="en-US" sz="1500" dirty="0">
+                <a:solidFill>
+                  <a:srgbClr val="1A1C2E"/>
+                </a:solidFill>
+                <a:latin typeface="Calibri" pitchFamily="34" charset="0"/>
+                <a:ea typeface="Calibri" pitchFamily="34" charset="-122"/>
+                <a:cs typeface="Calibri" pitchFamily="34" charset="-120"/>
+              </a:rPr>
+              <a:t>Lee cuatro PIDs fijos: revoluciones, refrigerante, velocidad y admisión</a:t>
+            </a:r>
+            <a:endParaRPr lang="en-US" sz="1500" dirty="0"/>
+          </a:p>
+          <a:p>
+            <a:pPr marL="342900" indent="-342900">
+              <a:lnSpc>
+                <a:spcPts val="2100"/>
+              </a:lnSpc>
+              <a:spcAft>
+                <a:spcPts val="1100"/>
+              </a:spcAft>
+              <a:buSzPct val="100000"/>
+              <a:buChar char="•"/>
+            </a:pPr>
+            <a:r>
+              <a:rPr lang="en-US" sz="1500" dirty="0">
+                <a:solidFill>
+                  <a:srgbClr val="1A1C2E"/>
+                </a:solidFill>
+                <a:latin typeface="Calibri" pitchFamily="34" charset="0"/>
+                <a:ea typeface="Calibri" pitchFamily="34" charset="-122"/>
+                <a:cs typeface="Calibri" pitchFamily="34" charset="-120"/>
+              </a:rPr>
+              <a:t>Más los DTCs y el freeze frame</a:t>
+            </a:r>
+            <a:endParaRPr lang="en-US" sz="1500" dirty="0"/>
+          </a:p>
+          <a:p>
+            <a:pPr marL="342900" indent="-342900">
+              <a:lnSpc>
+                <a:spcPts val="2100"/>
+              </a:lnSpc>
+              <a:spcAft>
+                <a:spcPts val="1100"/>
+              </a:spcAft>
+              <a:buSzPct val="100000"/>
+              <a:buChar char="•"/>
+            </a:pPr>
+            <a:r>
+              <a:rPr lang="en-US" sz="1500" dirty="0">
+                <a:solidFill>
+                  <a:srgbClr val="1A1C2E"/>
+                </a:solidFill>
+                <a:latin typeface="Calibri" pitchFamily="34" charset="0"/>
+                <a:ea typeface="Calibri" pitchFamily="34" charset="-122"/>
+                <a:cs typeface="Calibri" pitchFamily="34" charset="-120"/>
+              </a:rPr>
+              <a:t>La criticidad sale de una regla: sin DTCs es baja, con freeze frame es crítica</a:t>
+            </a:r>
+            <a:endParaRPr lang="en-US" sz="1500" dirty="0"/>
+          </a:p>
+          <a:p>
+            <a:pPr marL="342900" indent="-342900">
+              <a:lnSpc>
+                <a:spcPts val="2100"/>
+              </a:lnSpc>
+              <a:spcAft>
+                <a:spcPts val="1100"/>
+              </a:spcAft>
+              <a:buSzPct val="100000"/>
+              <a:buChar char="•"/>
+            </a:pPr>
+            <a:r>
+              <a:rPr lang="en-US" sz="1500" dirty="0">
+                <a:solidFill>
+                  <a:srgbClr val="1A1C2E"/>
+                </a:solidFill>
+                <a:latin typeface="Calibri" pitchFamily="34" charset="0"/>
+                <a:ea typeface="Calibri" pitchFamily="34" charset="-122"/>
+                <a:cs typeface="Calibri" pitchFamily="34" charset="-120"/>
+              </a:rPr>
+              <a:t>Solo necesita el coche, y responde al momento</a:t>
+            </a:r>
+            <a:endParaRPr lang="en-US" sz="1500" dirty="0"/>
+          </a:p>
+          <a:p>
+            <a:pPr marL="342900" indent="-342900">
+              <a:lnSpc>
+                <a:spcPts val="2100"/>
+              </a:lnSpc>
+              <a:spcAft>
+                <a:spcPts val="1100"/>
+              </a:spcAft>
+              <a:buSzPct val="100000"/>
+              <a:buChar char="•"/>
+            </a:pPr>
+            <a:r>
+              <a:rPr lang="en-US" sz="1500" dirty="0">
+                <a:solidFill>
+                  <a:srgbClr val="1A1C2E"/>
+                </a:solidFill>
+                <a:latin typeface="Calibri" pitchFamily="34" charset="0"/>
+                <a:ea typeface="Calibri" pitchFamily="34" charset="-122"/>
+                <a:cs typeface="Calibri" pitchFamily="34" charset="-120"/>
+              </a:rPr>
+              <a:t>No aprende nada</a:t>
+            </a:r>
+            <a:endParaRPr lang="en-US" sz="1500" dirty="0"/>
+          </a:p>
+        </p:txBody>
+      </p:sp>
+      <p:sp>
+        <p:nvSpPr>
+          <p:cNvPr id="6" name="Text 4"/>
+          <p:cNvSpPr/>
+          <p:nvPr/>
+        </p:nvSpPr>
+        <p:spPr>
+          <a:xfrm>
+            <a:off x="6537960" y="2240280"/>
+            <a:ext cx="4846320" cy="365760"/>
+          </a:xfrm>
+          <a:prstGeom prst="rect">
+            <a:avLst/>
+          </a:prstGeom>
+          <a:noFill/>
+          <a:ln/>
+        </p:spPr>
+        <p:txBody>
+          <a:bodyPr wrap="square" lIns="0" tIns="0" rIns="0" bIns="0" rtlCol="0" anchor="t"/>
+          <a:lstStyle/>
+          <a:p>
+            <a:pPr indent="0" marL="0">
+              <a:buNone/>
+            </a:pPr>
+            <a:r>
+              <a:rPr lang="en-US" sz="2000" b="1" dirty="0">
+                <a:solidFill>
+                  <a:srgbClr val="202CFC"/>
+                </a:solidFill>
+                <a:latin typeface="Arial" pitchFamily="34" charset="0"/>
+                <a:ea typeface="Arial" pitchFamily="34" charset="-122"/>
+                <a:cs typeface="Arial" pitchFamily="34" charset="-120"/>
+              </a:rPr>
+              <a:t>Cognitivo</a:t>
+            </a:r>
+            <a:endParaRPr lang="en-US" sz="2000" dirty="0"/>
+          </a:p>
+        </p:txBody>
+      </p:sp>
+      <p:sp>
+        <p:nvSpPr>
+          <p:cNvPr id="7" name="Text 5"/>
+          <p:cNvSpPr/>
+          <p:nvPr/>
+        </p:nvSpPr>
+        <p:spPr>
+          <a:xfrm>
+            <a:off x="6537960" y="2788920"/>
+            <a:ext cx="4846320" cy="2834640"/>
+          </a:xfrm>
+          <a:prstGeom prst="rect">
+            <a:avLst/>
+          </a:prstGeom>
+          <a:noFill/>
+          <a:ln/>
+        </p:spPr>
+        <p:txBody>
+          <a:bodyPr wrap="square" lIns="0" tIns="0" rIns="0" bIns="0" rtlCol="0" anchor="t"/>
+          <a:lstStyle/>
+          <a:p>
+            <a:pPr marL="342900" indent="-342900">
+              <a:lnSpc>
+                <a:spcPts val="2100"/>
+              </a:lnSpc>
+              <a:spcAft>
+                <a:spcPts val="1100"/>
+              </a:spcAft>
+              <a:buSzPct val="100000"/>
+              <a:buChar char="•"/>
+            </a:pPr>
+            <a:r>
+              <a:rPr lang="en-US" sz="1500" dirty="0">
+                <a:solidFill>
+                  <a:srgbClr val="1A1C2E"/>
+                </a:solidFill>
+                <a:latin typeface="Calibri" pitchFamily="34" charset="0"/>
+                <a:ea typeface="Calibri" pitchFamily="34" charset="-122"/>
+                <a:cs typeface="Calibri" pitchFamily="34" charset="-120"/>
+              </a:rPr>
+              <a:t>El agente decide qué PIDs le hace falta leer</a:t>
+            </a:r>
+            <a:endParaRPr lang="en-US" sz="1500" dirty="0"/>
+          </a:p>
+          <a:p>
+            <a:pPr marL="342900" indent="-342900">
+              <a:lnSpc>
+                <a:spcPts val="2100"/>
+              </a:lnSpc>
+              <a:spcAft>
+                <a:spcPts val="1100"/>
+              </a:spcAft>
+              <a:buSzPct val="100000"/>
+              <a:buChar char="•"/>
+            </a:pPr>
+            <a:r>
+              <a:rPr lang="en-US" sz="1500" dirty="0">
+                <a:solidFill>
+                  <a:srgbClr val="1A1C2E"/>
+                </a:solidFill>
+                <a:latin typeface="Calibri" pitchFamily="34" charset="0"/>
+                <a:ea typeface="Calibri" pitchFamily="34" charset="-122"/>
+                <a:cs typeface="Calibri" pitchFamily="34" charset="-120"/>
+              </a:rPr>
+              <a:t>Razona sobre lo que va encontrando, llamando a herramientas</a:t>
+            </a:r>
+            <a:endParaRPr lang="en-US" sz="1500" dirty="0"/>
+          </a:p>
+          <a:p>
+            <a:pPr marL="342900" indent="-342900">
+              <a:lnSpc>
+                <a:spcPts val="2100"/>
+              </a:lnSpc>
+              <a:spcAft>
+                <a:spcPts val="1100"/>
+              </a:spcAft>
+              <a:buSzPct val="100000"/>
+              <a:buChar char="•"/>
+            </a:pPr>
+            <a:r>
+              <a:rPr lang="en-US" sz="1500" dirty="0">
+                <a:solidFill>
+                  <a:srgbClr val="1A1C2E"/>
+                </a:solidFill>
+                <a:latin typeface="Calibri" pitchFamily="34" charset="0"/>
+                <a:ea typeface="Calibri" pitchFamily="34" charset="-122"/>
+                <a:cs typeface="Calibri" pitchFamily="34" charset="-120"/>
+              </a:rPr>
+              <a:t>Necesita el coche, la API del modelo y los índices vectoriales</a:t>
+            </a:r>
+            <a:endParaRPr lang="en-US" sz="1500" dirty="0"/>
+          </a:p>
+          <a:p>
+            <a:pPr marL="342900" indent="-342900">
+              <a:lnSpc>
+                <a:spcPts val="2100"/>
+              </a:lnSpc>
+              <a:spcAft>
+                <a:spcPts val="1100"/>
+              </a:spcAft>
+              <a:buSzPct val="100000"/>
+              <a:buChar char="•"/>
+            </a:pPr>
+            <a:r>
+              <a:rPr lang="en-US" sz="1500" dirty="0">
+                <a:solidFill>
+                  <a:srgbClr val="1A1C2E"/>
+                </a:solidFill>
+                <a:latin typeface="Calibri" pitchFamily="34" charset="0"/>
+                <a:ea typeface="Calibri" pitchFamily="34" charset="-122"/>
+                <a:cs typeface="Calibri" pitchFamily="34" charset="-120"/>
+              </a:rPr>
+              <a:t>Hasta 60 segundos de límite</a:t>
+            </a:r>
+            <a:endParaRPr lang="en-US" sz="1500" dirty="0"/>
+          </a:p>
+          <a:p>
+            <a:pPr marL="342900" indent="-342900">
+              <a:lnSpc>
+                <a:spcPts val="2100"/>
+              </a:lnSpc>
+              <a:spcAft>
+                <a:spcPts val="1100"/>
+              </a:spcAft>
+              <a:buSzPct val="100000"/>
+              <a:buChar char="•"/>
+            </a:pPr>
+            <a:r>
+              <a:rPr lang="en-US" sz="1500" dirty="0">
+                <a:solidFill>
+                  <a:srgbClr val="1A1C2E"/>
+                </a:solidFill>
+                <a:latin typeface="Calibri" pitchFamily="34" charset="0"/>
+                <a:ea typeface="Calibri" pitchFamily="34" charset="-122"/>
+                <a:cs typeface="Calibri" pitchFamily="34" charset="-120"/>
+              </a:rPr>
+              <a:t>Y aprende: indexa PIDs, DTCs y el caso resuelto</a:t>
+            </a:r>
+            <a:endParaRPr lang="en-US" sz="1500" dirty="0"/>
+          </a:p>
+        </p:txBody>
+      </p:sp>
+      <p:sp>
+        <p:nvSpPr>
+          <p:cNvPr id="8" name="Shape 6"/>
+          <p:cNvSpPr/>
+          <p:nvPr/>
+        </p:nvSpPr>
+        <p:spPr>
+          <a:xfrm>
+            <a:off x="777240" y="6263640"/>
+            <a:ext cx="219456" cy="219456"/>
+          </a:xfrm>
+          <a:prstGeom prst="rect">
+            <a:avLst/>
+          </a:prstGeom>
+          <a:solidFill>
+            <a:srgbClr val="202CFC"/>
+          </a:solidFill>
+          <a:ln/>
+        </p:spPr>
+      </p:sp>
+      <p:sp>
+        <p:nvSpPr>
+          <p:cNvPr id="9" name="Text 7"/>
+          <p:cNvSpPr/>
+          <p:nvPr/>
+        </p:nvSpPr>
+        <p:spPr>
+          <a:xfrm>
+            <a:off x="777240" y="6263640"/>
+            <a:ext cx="219456" cy="219456"/>
+          </a:xfrm>
+          <a:prstGeom prst="rect">
+            <a:avLst/>
+          </a:prstGeom>
+          <a:noFill/>
+          <a:ln/>
+        </p:spPr>
+        <p:txBody>
+          <a:bodyPr wrap="square" lIns="0" tIns="0" rIns="0" bIns="0" rtlCol="0" anchor="ctr"/>
+          <a:lstStyle/>
+          <a:p>
+            <a:pPr algn="ctr" indent="0" marL="0">
+              <a:buNone/>
+            </a:pPr>
+            <a:r>
+              <a:rPr lang="en-US" sz="816" b="1" dirty="0">
+                <a:solidFill>
+                  <a:srgbClr val="FFFFFF"/>
+                </a:solidFill>
+                <a:latin typeface="Arial" pitchFamily="34" charset="0"/>
+                <a:ea typeface="Arial" pitchFamily="34" charset="-122"/>
+                <a:cs typeface="Arial" pitchFamily="34" charset="-120"/>
+              </a:rPr>
+              <a:t>BIG</a:t>
+            </a:r>
+            <a:endParaRPr lang="en-US" sz="816" dirty="0"/>
+          </a:p>
+        </p:txBody>
+      </p:sp>
+      <p:sp>
+        <p:nvSpPr>
+          <p:cNvPr id="10" name="Text 8"/>
+          <p:cNvSpPr/>
+          <p:nvPr/>
+        </p:nvSpPr>
+        <p:spPr>
+          <a:xfrm>
+            <a:off x="1078992" y="6263640"/>
+            <a:ext cx="658368" cy="219456"/>
+          </a:xfrm>
+          <a:prstGeom prst="rect">
+            <a:avLst/>
+          </a:prstGeom>
+          <a:noFill/>
+          <a:ln/>
+        </p:spPr>
+        <p:txBody>
+          <a:bodyPr wrap="square" lIns="0" tIns="0" rIns="0" bIns="0" rtlCol="0" anchor="ctr"/>
+          <a:lstStyle/>
+          <a:p>
+            <a:pPr algn="l" indent="0" marL="0">
+              <a:buNone/>
+            </a:pPr>
+            <a:r>
+              <a:rPr lang="en-US" sz="816" dirty="0">
+                <a:solidFill>
+                  <a:srgbClr val="1A1C2E"/>
+                </a:solidFill>
+                <a:latin typeface="Arial" pitchFamily="34" charset="0"/>
+                <a:ea typeface="Arial" pitchFamily="34" charset="-122"/>
+                <a:cs typeface="Arial" pitchFamily="34" charset="-120"/>
+              </a:rPr>
+              <a:t>school</a:t>
+            </a:r>
+            <a:endParaRPr lang="en-US" sz="816" dirty="0"/>
+          </a:p>
+        </p:txBody>
+      </p:sp>
+      <p:sp>
+        <p:nvSpPr>
+          <p:cNvPr id="11" name="Text 9"/>
+          <p:cNvSpPr/>
+          <p:nvPr/>
+        </p:nvSpPr>
+        <p:spPr>
+          <a:xfrm>
+            <a:off x="11064240" y="6263640"/>
+            <a:ext cx="320040" cy="219456"/>
+          </a:xfrm>
+          <a:prstGeom prst="rect">
+            <a:avLst/>
+          </a:prstGeom>
+          <a:noFill/>
+          <a:ln/>
+        </p:spPr>
+        <p:txBody>
+          <a:bodyPr wrap="square" lIns="0" tIns="0" rIns="0" bIns="0" rtlCol="0" anchor="ctr"/>
+          <a:lstStyle/>
+          <a:p>
+            <a:pPr algn="r" indent="0" marL="0">
+              <a:buNone/>
+            </a:pPr>
+            <a:r>
+              <a:rPr lang="en-US" sz="1000" dirty="0">
+                <a:solidFill>
+                  <a:srgbClr val="5A5F73"/>
+                </a:solidFill>
+                <a:latin typeface="Calibri" pitchFamily="34" charset="0"/>
+                <a:ea typeface="Calibri" pitchFamily="34" charset="-122"/>
+                <a:cs typeface="Calibri" pitchFamily="34" charset="-120"/>
+              </a:rPr>
+              <a:t>9</a:t>
+            </a:r>
+            <a:endParaRPr lang="en-US" sz="1000" dirty="0"/>
+          </a:p>
+        </p:txBody>
+      </p:sp>
+    </p:spTree>
+  </p:cSld>
+  <p:clrMapOvr>
+    <a:masterClrMapping/>
+  </p:clrMapOvr>
+</p:sld>
+</file>
+
 <file path=ppt/theme/theme1.xml><?xml version="1.0" encoding="utf-8"?>
 <a:theme xmlns:a="http://schemas.openxmlformats.org/drawingml/2006/main" name="Office Theme">
   <a:themeElements>

</xml_diff>

<commit_message>
docs(tfm): slide del MCP y mover los dos diagnosticos tras la IA
</commit_message>
<xml_diff>
--- a/docs/presentacion/tfm-intelligent-automotive-diagnostics.pptx
+++ b/docs/presentacion/tfm-intelligent-automotive-diagnostics.pptx
@@ -14,9 +14,10 @@
     <p:sldId id="262" r:id="rId8"/>
     <p:sldId id="263" r:id="rId9"/>
     <p:sldId id="264" r:id="rId10"/>
+    <p:sldId id="265" r:id="rId11"/>
   </p:sldIdLst>
   <p:notesMasterIdLst>
-    <p:notesMasterId r:id="rId11"/>
+    <p:notesMasterId r:id="rId12"/>
   </p:notesMasterIdLst>
   <p:sldSz cx="12192000" cy="6858000"/>
   <p:notesSz cx="6858000" cy="12192000"/>
@@ -555,6 +556,98 @@
 </p:notes>
 </file>
 
+<file path=ppt/notesSlides/notesSlide10.xml><?xml version="1.0" encoding="utf-8"?>
+<p:notes xmlns:a="http://schemas.openxmlformats.org/drawingml/2006/main" xmlns:r="http://schemas.openxmlformats.org/officeDocument/2006/relationships" xmlns:p="http://schemas.openxmlformats.org/presentationml/2006/main">
+  <p:cSld>
+    <p:spTree>
+      <p:nvGrpSpPr>
+        <p:cNvPr id="1" name=""/>
+        <p:cNvGrpSpPr/>
+        <p:nvPr/>
+      </p:nvGrpSpPr>
+      <p:grpSpPr>
+        <a:xfrm>
+          <a:off x="0" y="0"/>
+          <a:ext cx="0" cy="0"/>
+          <a:chOff x="0" y="0"/>
+          <a:chExt cx="0" cy="0"/>
+        </a:xfrm>
+      </p:grpSpPr>
+      <p:sp>
+        <p:nvSpPr>
+          <p:cNvPr id="2" name="Slide Image Placeholder 1"/>
+          <p:cNvSpPr>
+            <a:spLocks noGrp="1" noRot="1" noChangeAspect="1"/>
+          </p:cNvSpPr>
+          <p:nvPr>
+            <p:ph type="sldImg"/>
+          </p:nvPr>
+        </p:nvSpPr>
+        <p:spPr/>
+      </p:sp>
+      <p:sp>
+        <p:nvSpPr>
+          <p:cNvPr id="3" name="Notes Placeholder 2"/>
+          <p:cNvSpPr>
+            <a:spLocks noGrp="1"/>
+          </p:cNvSpPr>
+          <p:nvPr>
+            <p:ph type="body" idx="1"/>
+          </p:nvPr>
+        </p:nvSpPr>
+        <p:spPr/>
+        <p:txBody>
+          <a:bodyPr/>
+          <a:lstStyle/>
+          <a:p>
+            <a:r>
+              <a:rPr lang="en-US" dirty="0"/>
+              <a:t>El sistema hace dos diagnósticos distintos, y conviven.
+El determinista es el de toda la vida. Lee cuatro PIDs fijos —revoluciones, temperatura de refrigerante, velocidad y temperatura de admisión—, los códigos de avería y el freeze frame. Y la criticidad no me la invento: sale de una regla en el dominio, computeSeverity. Si no hay códigos es baja; si hay freeze frame es crítica, porque significa que la centralita congeló el momento del fallo; y si hay códigos sin freeze frame es alta. Solo necesita el coche conectado, responde al momento, y no aprende nada.
+El cognitivo es el otro. Ahí no hay una lista fija de PIDs: el agente decide qué le hace falta leer y va llamando a las herramientas según lo que encuentra. A cambio necesita tres cosas: el coche, la API del modelo y los índices vectoriales. Tarda más, con un límite de sesenta segundos. Y es el único que aprende: indexa los PIDs y DTCs nuevos y guarda el caso resuelto.
+Por eso conviven. Si no hay modelo configurado, o si no hay internet en el taller, el determinista sigue funcionando.
+[~65 s]</a:t>
+            </a:r>
+            <a:endParaRPr lang="en-US" dirty="0"/>
+          </a:p>
+        </p:txBody>
+      </p:sp>
+      <p:sp>
+        <p:nvSpPr>
+          <p:cNvPr id="4" name="Slide Number Placeholder 3"/>
+          <p:cNvSpPr>
+            <a:spLocks noGrp="1"/>
+          </p:cNvSpPr>
+          <p:nvPr>
+            <p:ph type="sldNum" sz="quarter" idx="10"/>
+          </p:nvPr>
+        </p:nvSpPr>
+        <p:spPr/>
+        <p:txBody>
+          <a:bodyPr/>
+          <a:lstStyle/>
+          <a:p>
+            <a:fld id="{F7021451-1387-4CA6-816F-3879F97B5CBC}" type="slidenum">
+              <a:rPr lang="en-US"/>
+              <a:t>10</a:t>
+            </a:fld>
+            <a:endParaRPr lang="en-US"/>
+          </a:p>
+        </p:txBody>
+      </p:sp>
+    </p:spTree>
+    <p:extLst>
+      <p:ext uri="{BB962C8B-B14F-4D97-AF65-F5344CB8AC3E}">
+        <p14:creationId xmlns:p14="http://schemas.microsoft.com/office/powerpoint/2010/main" val="1024086991"/>
+      </p:ext>
+    </p:extLst>
+  </p:cSld>
+  <p:clrMapOvr>
+    <a:masterClrMapping/>
+  </p:clrMapOvr>
+</p:notes>
+</file>
+
 <file path=ppt/notesSlides/notesSlide2.xml><?xml version="1.0" encoding="utf-8"?>
 <p:notes xmlns:a="http://schemas.openxmlformats.org/drawingml/2006/main" xmlns:r="http://schemas.openxmlformats.org/officeDocument/2006/relationships" xmlns:p="http://schemas.openxmlformats.org/presentationml/2006/main">
   <p:cSld>
@@ -1246,11 +1339,11 @@
           <a:p>
             <a:r>
               <a:rPr lang="en-US" dirty="0"/>
-              <a:t>El sistema hace dos diagnósticos distintos, y conviven.
-El determinista es el de toda la vida. Lee cuatro PIDs fijos —revoluciones, temperatura de refrigerante, velocidad y temperatura de admisión—, los códigos de avería y el freeze frame. Y la criticidad no me la invento: sale de una regla en el dominio, computeSeverity. Si no hay códigos es baja; si hay freeze frame es crítica, porque significa que la centralita congeló el momento del fallo; y si hay códigos sin freeze frame es alta. Solo necesita el coche conectado, responde al momento, y no aprende nada.
-El cognitivo es el otro. Ahí no hay una lista fija de PIDs: el agente decide qué le hace falta leer y va llamando a las herramientas según lo que encuentra. A cambio necesita tres cosas: el coche, la API del modelo y los índices vectoriales. Tarda más, con un límite de sesenta segundos. Y es el único que aprende: indexa los PIDs y DTCs nuevos y guarda el caso resuelto.
-Por eso conviven. Si no hay modelo configurado, o si no hay internet en el taller, el determinista sigue funcionando.
-[~65 s]</a:t>
+              <a:t>El modelo no toca el coche directamente. Lo que hace es pedir herramientas, y el sistema decide si las ejecuta y con qué argumentos. Ese contrato es el MCP, el Model Context Protocol.
+Hay dieciséis herramientas. Siete son de diagnóstico: leer el bastidor, leer un PID, pedir los códigos de avería, el freeze frame o la información de las centralitas. Ocho son de conocimiento, y son las que hablan con la base vectorial: buscar casos parecidos e indexar lo que se aprende. Y una es de búsqueda web, que lleva un presupuesto limitado por diagnóstico para que el agente no se vaya a internet sin control.
+¿Por qué MCP y no montarme yo las llamadas a medida? Por tres razones. Primero, es un protocolo: el mismo servidor sirve a cualquier cliente que lo hable, no solo al mío. Segundo, cada herramienta declara su esquema, así que los argumentos que manda el modelo se validan antes de ejecutar nada. Y tercero, el servidor MCP vive en la capa de infraestructura: es un adaptador más. El modelo nunca ve el dominio, ve herramientas.
+La consecuencia es la de siempre: si mañana cambio de modelo, las herramientas no se tocan.
+[~70 s]</a:t>
             </a:r>
             <a:endParaRPr lang="en-US" dirty="0"/>
           </a:p>
@@ -1999,6 +2092,615 @@
 </p:sld>
 </file>
 
+<file path=ppt/slides/slide10.xml><?xml version="1.0" encoding="utf-8"?>
+<p:sld xmlns:a="http://schemas.openxmlformats.org/drawingml/2006/main" xmlns:r="http://schemas.openxmlformats.org/officeDocument/2006/relationships" xmlns:p="http://schemas.openxmlformats.org/presentationml/2006/main">
+  <p:cSld name="Slide 10">
+    <p:bg>
+      <p:bgPr>
+        <a:solidFill>
+          <a:srgbClr val="FFFFFF"/>
+        </a:solidFill>
+      </p:bgPr>
+    </p:bg>
+    <p:spTree>
+      <p:nvGrpSpPr>
+        <p:cNvPr id="1" name=""/>
+        <p:cNvGrpSpPr/>
+        <p:nvPr/>
+      </p:nvGrpSpPr>
+      <p:grpSpPr>
+        <a:xfrm>
+          <a:off x="0" y="0"/>
+          <a:ext cx="0" cy="0"/>
+          <a:chOff x="0" y="0"/>
+          <a:chExt cx="0" cy="0"/>
+        </a:xfrm>
+      </p:grpSpPr>
+      <p:sp>
+        <p:nvSpPr>
+          <p:cNvPr id="2" name="Text 0"/>
+          <p:cNvSpPr/>
+          <p:nvPr/>
+        </p:nvSpPr>
+        <p:spPr>
+          <a:xfrm>
+            <a:off x="777240" y="640080"/>
+            <a:ext cx="10607040" cy="777240"/>
+          </a:xfrm>
+          <a:prstGeom prst="rect">
+            <a:avLst/>
+          </a:prstGeom>
+          <a:noFill/>
+          <a:ln/>
+        </p:spPr>
+        <p:txBody>
+          <a:bodyPr wrap="square" lIns="0" tIns="0" rIns="0" bIns="0" rtlCol="0" anchor="t"/>
+          <a:lstStyle/>
+          <a:p>
+            <a:pPr indent="0" marL="0">
+              <a:buNone/>
+            </a:pPr>
+            <a:r>
+              <a:rPr lang="en-US" sz="3400" b="1" dirty="0">
+                <a:solidFill>
+                  <a:srgbClr val="1A1C2E"/>
+                </a:solidFill>
+                <a:latin typeface="Arial" pitchFamily="34" charset="0"/>
+                <a:ea typeface="Arial" pitchFamily="34" charset="-122"/>
+                <a:cs typeface="Arial" pitchFamily="34" charset="-120"/>
+              </a:rPr>
+              <a:t>Dos diagnósticos</a:t>
+            </a:r>
+            <a:endParaRPr lang="en-US" sz="3400" dirty="0"/>
+          </a:p>
+        </p:txBody>
+      </p:sp>
+      <p:sp>
+        <p:nvSpPr>
+          <p:cNvPr id="3" name="Text 1"/>
+          <p:cNvSpPr/>
+          <p:nvPr/>
+        </p:nvSpPr>
+        <p:spPr>
+          <a:xfrm>
+            <a:off x="777240" y="1508760"/>
+            <a:ext cx="10607040" cy="365760"/>
+          </a:xfrm>
+          <a:prstGeom prst="rect">
+            <a:avLst/>
+          </a:prstGeom>
+          <a:noFill/>
+          <a:ln/>
+        </p:spPr>
+        <p:txBody>
+          <a:bodyPr wrap="square" lIns="0" tIns="0" rIns="0" bIns="0" rtlCol="0" anchor="t"/>
+          <a:lstStyle/>
+          <a:p>
+            <a:pPr indent="0" marL="0">
+              <a:buNone/>
+            </a:pPr>
+            <a:r>
+              <a:rPr lang="en-US" sz="1700" dirty="0">
+                <a:solidFill>
+                  <a:srgbClr val="5A5F73"/>
+                </a:solidFill>
+                <a:latin typeface="Calibri" pitchFamily="34" charset="0"/>
+                <a:ea typeface="Calibri" pitchFamily="34" charset="-122"/>
+                <a:cs typeface="Calibri" pitchFamily="34" charset="-120"/>
+              </a:rPr>
+              <a:t>El determinista está siempre. El cognitivo, solo si hay un modelo configurado.</a:t>
+            </a:r>
+            <a:endParaRPr lang="en-US" sz="1700" dirty="0"/>
+          </a:p>
+        </p:txBody>
+      </p:sp>
+      <p:sp>
+        <p:nvSpPr>
+          <p:cNvPr id="4" name="Text 2"/>
+          <p:cNvSpPr/>
+          <p:nvPr/>
+        </p:nvSpPr>
+        <p:spPr>
+          <a:xfrm>
+            <a:off x="777240" y="2240280"/>
+            <a:ext cx="4846320" cy="365760"/>
+          </a:xfrm>
+          <a:prstGeom prst="rect">
+            <a:avLst/>
+          </a:prstGeom>
+          <a:noFill/>
+          <a:ln/>
+        </p:spPr>
+        <p:txBody>
+          <a:bodyPr wrap="square" lIns="0" tIns="0" rIns="0" bIns="0" rtlCol="0" anchor="t"/>
+          <a:lstStyle/>
+          <a:p>
+            <a:pPr indent="0" marL="0">
+              <a:buNone/>
+            </a:pPr>
+            <a:r>
+              <a:rPr lang="en-US" sz="2000" b="1" dirty="0">
+                <a:solidFill>
+                  <a:srgbClr val="202CFC"/>
+                </a:solidFill>
+                <a:latin typeface="Arial" pitchFamily="34" charset="0"/>
+                <a:ea typeface="Arial" pitchFamily="34" charset="-122"/>
+                <a:cs typeface="Arial" pitchFamily="34" charset="-120"/>
+              </a:rPr>
+              <a:t>Determinista</a:t>
+            </a:r>
+            <a:endParaRPr lang="en-US" sz="2000" dirty="0"/>
+          </a:p>
+        </p:txBody>
+      </p:sp>
+      <p:sp>
+        <p:nvSpPr>
+          <p:cNvPr id="5" name="Text 3"/>
+          <p:cNvSpPr/>
+          <p:nvPr/>
+        </p:nvSpPr>
+        <p:spPr>
+          <a:xfrm>
+            <a:off x="777240" y="2788920"/>
+            <a:ext cx="4846320" cy="2834640"/>
+          </a:xfrm>
+          <a:prstGeom prst="rect">
+            <a:avLst/>
+          </a:prstGeom>
+          <a:noFill/>
+          <a:ln/>
+        </p:spPr>
+        <p:txBody>
+          <a:bodyPr wrap="square" lIns="0" tIns="0" rIns="0" bIns="0" rtlCol="0" anchor="t"/>
+          <a:lstStyle/>
+          <a:p>
+            <a:pPr marL="342900" indent="-342900">
+              <a:lnSpc>
+                <a:spcPts val="2100"/>
+              </a:lnSpc>
+              <a:spcAft>
+                <a:spcPts val="1100"/>
+              </a:spcAft>
+              <a:buSzPct val="100000"/>
+              <a:buChar char="•"/>
+            </a:pPr>
+            <a:r>
+              <a:rPr lang="en-US" sz="1500" dirty="0">
+                <a:solidFill>
+                  <a:srgbClr val="1A1C2E"/>
+                </a:solidFill>
+                <a:latin typeface="Calibri" pitchFamily="34" charset="0"/>
+                <a:ea typeface="Calibri" pitchFamily="34" charset="-122"/>
+                <a:cs typeface="Calibri" pitchFamily="34" charset="-120"/>
+              </a:rPr>
+              <a:t>Lee cuatro PIDs fijos: revoluciones, refrigerante, velocidad y admisión</a:t>
+            </a:r>
+            <a:endParaRPr lang="en-US" sz="1500" dirty="0"/>
+          </a:p>
+          <a:p>
+            <a:pPr marL="342900" indent="-342900">
+              <a:lnSpc>
+                <a:spcPts val="2100"/>
+              </a:lnSpc>
+              <a:spcAft>
+                <a:spcPts val="1100"/>
+              </a:spcAft>
+              <a:buSzPct val="100000"/>
+              <a:buChar char="•"/>
+            </a:pPr>
+            <a:r>
+              <a:rPr lang="en-US" sz="1500" dirty="0">
+                <a:solidFill>
+                  <a:srgbClr val="1A1C2E"/>
+                </a:solidFill>
+                <a:latin typeface="Calibri" pitchFamily="34" charset="0"/>
+                <a:ea typeface="Calibri" pitchFamily="34" charset="-122"/>
+                <a:cs typeface="Calibri" pitchFamily="34" charset="-120"/>
+              </a:rPr>
+              <a:t>Más los DTCs y el freeze frame</a:t>
+            </a:r>
+            <a:endParaRPr lang="en-US" sz="1500" dirty="0"/>
+          </a:p>
+          <a:p>
+            <a:pPr marL="342900" indent="-342900">
+              <a:lnSpc>
+                <a:spcPts val="2100"/>
+              </a:lnSpc>
+              <a:spcAft>
+                <a:spcPts val="1100"/>
+              </a:spcAft>
+              <a:buSzPct val="100000"/>
+              <a:buChar char="•"/>
+            </a:pPr>
+            <a:r>
+              <a:rPr lang="en-US" sz="1500" dirty="0">
+                <a:solidFill>
+                  <a:srgbClr val="1A1C2E"/>
+                </a:solidFill>
+                <a:latin typeface="Calibri" pitchFamily="34" charset="0"/>
+                <a:ea typeface="Calibri" pitchFamily="34" charset="-122"/>
+                <a:cs typeface="Calibri" pitchFamily="34" charset="-120"/>
+              </a:rPr>
+              <a:t>La criticidad sale de una regla: sin DTCs es baja, con freeze frame es crítica</a:t>
+            </a:r>
+            <a:endParaRPr lang="en-US" sz="1500" dirty="0"/>
+          </a:p>
+          <a:p>
+            <a:pPr marL="342900" indent="-342900">
+              <a:lnSpc>
+                <a:spcPts val="2100"/>
+              </a:lnSpc>
+              <a:spcAft>
+                <a:spcPts val="1100"/>
+              </a:spcAft>
+              <a:buSzPct val="100000"/>
+              <a:buChar char="•"/>
+            </a:pPr>
+            <a:r>
+              <a:rPr lang="en-US" sz="1500" dirty="0">
+                <a:solidFill>
+                  <a:srgbClr val="1A1C2E"/>
+                </a:solidFill>
+                <a:latin typeface="Calibri" pitchFamily="34" charset="0"/>
+                <a:ea typeface="Calibri" pitchFamily="34" charset="-122"/>
+                <a:cs typeface="Calibri" pitchFamily="34" charset="-120"/>
+              </a:rPr>
+              <a:t>Solo necesita el coche, y responde al momento</a:t>
+            </a:r>
+            <a:endParaRPr lang="en-US" sz="1500" dirty="0"/>
+          </a:p>
+          <a:p>
+            <a:pPr marL="342900" indent="-342900">
+              <a:lnSpc>
+                <a:spcPts val="2100"/>
+              </a:lnSpc>
+              <a:spcAft>
+                <a:spcPts val="1100"/>
+              </a:spcAft>
+              <a:buSzPct val="100000"/>
+              <a:buChar char="•"/>
+            </a:pPr>
+            <a:r>
+              <a:rPr lang="en-US" sz="1500" dirty="0">
+                <a:solidFill>
+                  <a:srgbClr val="1A1C2E"/>
+                </a:solidFill>
+                <a:latin typeface="Calibri" pitchFamily="34" charset="0"/>
+                <a:ea typeface="Calibri" pitchFamily="34" charset="-122"/>
+                <a:cs typeface="Calibri" pitchFamily="34" charset="-120"/>
+              </a:rPr>
+              <a:t>No aprende nada</a:t>
+            </a:r>
+            <a:endParaRPr lang="en-US" sz="1500" dirty="0"/>
+          </a:p>
+        </p:txBody>
+      </p:sp>
+      <p:sp>
+        <p:nvSpPr>
+          <p:cNvPr id="6" name="Text 4"/>
+          <p:cNvSpPr/>
+          <p:nvPr/>
+        </p:nvSpPr>
+        <p:spPr>
+          <a:xfrm>
+            <a:off x="6537960" y="2240280"/>
+            <a:ext cx="4846320" cy="365760"/>
+          </a:xfrm>
+          <a:prstGeom prst="rect">
+            <a:avLst/>
+          </a:prstGeom>
+          <a:noFill/>
+          <a:ln/>
+        </p:spPr>
+        <p:txBody>
+          <a:bodyPr wrap="square" lIns="0" tIns="0" rIns="0" bIns="0" rtlCol="0" anchor="t"/>
+          <a:lstStyle/>
+          <a:p>
+            <a:pPr indent="0" marL="0">
+              <a:buNone/>
+            </a:pPr>
+            <a:r>
+              <a:rPr lang="en-US" sz="2000" b="1" dirty="0">
+                <a:solidFill>
+                  <a:srgbClr val="202CFC"/>
+                </a:solidFill>
+                <a:latin typeface="Arial" pitchFamily="34" charset="0"/>
+                <a:ea typeface="Arial" pitchFamily="34" charset="-122"/>
+                <a:cs typeface="Arial" pitchFamily="34" charset="-120"/>
+              </a:rPr>
+              <a:t>Cognitivo</a:t>
+            </a:r>
+            <a:endParaRPr lang="en-US" sz="2000" dirty="0"/>
+          </a:p>
+        </p:txBody>
+      </p:sp>
+      <p:sp>
+        <p:nvSpPr>
+          <p:cNvPr id="7" name="Text 5"/>
+          <p:cNvSpPr/>
+          <p:nvPr/>
+        </p:nvSpPr>
+        <p:spPr>
+          <a:xfrm>
+            <a:off x="6537960" y="2788920"/>
+            <a:ext cx="4846320" cy="2834640"/>
+          </a:xfrm>
+          <a:prstGeom prst="rect">
+            <a:avLst/>
+          </a:prstGeom>
+          <a:noFill/>
+          <a:ln/>
+        </p:spPr>
+        <p:txBody>
+          <a:bodyPr wrap="square" lIns="0" tIns="0" rIns="0" bIns="0" rtlCol="0" anchor="t"/>
+          <a:lstStyle/>
+          <a:p>
+            <a:pPr marL="342900" indent="-342900">
+              <a:lnSpc>
+                <a:spcPts val="2100"/>
+              </a:lnSpc>
+              <a:spcAft>
+                <a:spcPts val="1100"/>
+              </a:spcAft>
+              <a:buSzPct val="100000"/>
+              <a:buChar char="•"/>
+            </a:pPr>
+            <a:r>
+              <a:rPr lang="en-US" sz="1500" dirty="0">
+                <a:solidFill>
+                  <a:srgbClr val="1A1C2E"/>
+                </a:solidFill>
+                <a:latin typeface="Calibri" pitchFamily="34" charset="0"/>
+                <a:ea typeface="Calibri" pitchFamily="34" charset="-122"/>
+                <a:cs typeface="Calibri" pitchFamily="34" charset="-120"/>
+              </a:rPr>
+              <a:t>El agente decide qué PIDs le hace falta leer</a:t>
+            </a:r>
+            <a:endParaRPr lang="en-US" sz="1500" dirty="0"/>
+          </a:p>
+          <a:p>
+            <a:pPr marL="342900" indent="-342900">
+              <a:lnSpc>
+                <a:spcPts val="2100"/>
+              </a:lnSpc>
+              <a:spcAft>
+                <a:spcPts val="1100"/>
+              </a:spcAft>
+              <a:buSzPct val="100000"/>
+              <a:buChar char="•"/>
+            </a:pPr>
+            <a:r>
+              <a:rPr lang="en-US" sz="1500" dirty="0">
+                <a:solidFill>
+                  <a:srgbClr val="1A1C2E"/>
+                </a:solidFill>
+                <a:latin typeface="Calibri" pitchFamily="34" charset="0"/>
+                <a:ea typeface="Calibri" pitchFamily="34" charset="-122"/>
+                <a:cs typeface="Calibri" pitchFamily="34" charset="-120"/>
+              </a:rPr>
+              <a:t>Razona sobre lo que va encontrando, llamando a herramientas</a:t>
+            </a:r>
+            <a:endParaRPr lang="en-US" sz="1500" dirty="0"/>
+          </a:p>
+          <a:p>
+            <a:pPr marL="342900" indent="-342900">
+              <a:lnSpc>
+                <a:spcPts val="2100"/>
+              </a:lnSpc>
+              <a:spcAft>
+                <a:spcPts val="1100"/>
+              </a:spcAft>
+              <a:buSzPct val="100000"/>
+              <a:buChar char="•"/>
+            </a:pPr>
+            <a:r>
+              <a:rPr lang="en-US" sz="1500" dirty="0">
+                <a:solidFill>
+                  <a:srgbClr val="1A1C2E"/>
+                </a:solidFill>
+                <a:latin typeface="Calibri" pitchFamily="34" charset="0"/>
+                <a:ea typeface="Calibri" pitchFamily="34" charset="-122"/>
+                <a:cs typeface="Calibri" pitchFamily="34" charset="-120"/>
+              </a:rPr>
+              <a:t>Necesita el coche, la API del modelo y los índices vectoriales</a:t>
+            </a:r>
+            <a:endParaRPr lang="en-US" sz="1500" dirty="0"/>
+          </a:p>
+          <a:p>
+            <a:pPr marL="342900" indent="-342900">
+              <a:lnSpc>
+                <a:spcPts val="2100"/>
+              </a:lnSpc>
+              <a:spcAft>
+                <a:spcPts val="1100"/>
+              </a:spcAft>
+              <a:buSzPct val="100000"/>
+              <a:buChar char="•"/>
+            </a:pPr>
+            <a:r>
+              <a:rPr lang="en-US" sz="1500" dirty="0">
+                <a:solidFill>
+                  <a:srgbClr val="1A1C2E"/>
+                </a:solidFill>
+                <a:latin typeface="Calibri" pitchFamily="34" charset="0"/>
+                <a:ea typeface="Calibri" pitchFamily="34" charset="-122"/>
+                <a:cs typeface="Calibri" pitchFamily="34" charset="-120"/>
+              </a:rPr>
+              <a:t>Hasta 60 segundos de límite</a:t>
+            </a:r>
+            <a:endParaRPr lang="en-US" sz="1500" dirty="0"/>
+          </a:p>
+          <a:p>
+            <a:pPr marL="342900" indent="-342900">
+              <a:lnSpc>
+                <a:spcPts val="2100"/>
+              </a:lnSpc>
+              <a:spcAft>
+                <a:spcPts val="1100"/>
+              </a:spcAft>
+              <a:buSzPct val="100000"/>
+              <a:buChar char="•"/>
+            </a:pPr>
+            <a:r>
+              <a:rPr lang="en-US" sz="1500" dirty="0">
+                <a:solidFill>
+                  <a:srgbClr val="1A1C2E"/>
+                </a:solidFill>
+                <a:latin typeface="Calibri" pitchFamily="34" charset="0"/>
+                <a:ea typeface="Calibri" pitchFamily="34" charset="-122"/>
+                <a:cs typeface="Calibri" pitchFamily="34" charset="-120"/>
+              </a:rPr>
+              <a:t>Y aprende: indexa PIDs, DTCs y el caso resuelto</a:t>
+            </a:r>
+            <a:endParaRPr lang="en-US" sz="1500" dirty="0"/>
+          </a:p>
+        </p:txBody>
+      </p:sp>
+      <p:sp>
+        <p:nvSpPr>
+          <p:cNvPr id="8" name="Shape 6"/>
+          <p:cNvSpPr/>
+          <p:nvPr/>
+        </p:nvSpPr>
+        <p:spPr>
+          <a:xfrm>
+            <a:off x="777240" y="6263640"/>
+            <a:ext cx="219456" cy="219456"/>
+          </a:xfrm>
+          <a:prstGeom prst="rect">
+            <a:avLst/>
+          </a:prstGeom>
+          <a:solidFill>
+            <a:srgbClr val="202CFC"/>
+          </a:solidFill>
+          <a:ln/>
+        </p:spPr>
+      </p:sp>
+      <p:sp>
+        <p:nvSpPr>
+          <p:cNvPr id="9" name="Text 7"/>
+          <p:cNvSpPr/>
+          <p:nvPr/>
+        </p:nvSpPr>
+        <p:spPr>
+          <a:xfrm>
+            <a:off x="777240" y="6263640"/>
+            <a:ext cx="219456" cy="219456"/>
+          </a:xfrm>
+          <a:prstGeom prst="rect">
+            <a:avLst/>
+          </a:prstGeom>
+          <a:noFill/>
+          <a:ln/>
+        </p:spPr>
+        <p:txBody>
+          <a:bodyPr wrap="square" lIns="0" tIns="0" rIns="0" bIns="0" rtlCol="0" anchor="ctr"/>
+          <a:lstStyle/>
+          <a:p>
+            <a:pPr algn="ctr" indent="0" marL="0">
+              <a:buNone/>
+            </a:pPr>
+            <a:r>
+              <a:rPr lang="en-US" sz="816" b="1" dirty="0">
+                <a:solidFill>
+                  <a:srgbClr val="FFFFFF"/>
+                </a:solidFill>
+                <a:latin typeface="Arial" pitchFamily="34" charset="0"/>
+                <a:ea typeface="Arial" pitchFamily="34" charset="-122"/>
+                <a:cs typeface="Arial" pitchFamily="34" charset="-120"/>
+              </a:rPr>
+              <a:t>BIG</a:t>
+            </a:r>
+            <a:endParaRPr lang="en-US" sz="816" dirty="0"/>
+          </a:p>
+        </p:txBody>
+      </p:sp>
+      <p:sp>
+        <p:nvSpPr>
+          <p:cNvPr id="10" name="Text 8"/>
+          <p:cNvSpPr/>
+          <p:nvPr/>
+        </p:nvSpPr>
+        <p:spPr>
+          <a:xfrm>
+            <a:off x="1078992" y="6263640"/>
+            <a:ext cx="658368" cy="219456"/>
+          </a:xfrm>
+          <a:prstGeom prst="rect">
+            <a:avLst/>
+          </a:prstGeom>
+          <a:noFill/>
+          <a:ln/>
+        </p:spPr>
+        <p:txBody>
+          <a:bodyPr wrap="square" lIns="0" tIns="0" rIns="0" bIns="0" rtlCol="0" anchor="ctr"/>
+          <a:lstStyle/>
+          <a:p>
+            <a:pPr algn="l" indent="0" marL="0">
+              <a:buNone/>
+            </a:pPr>
+            <a:r>
+              <a:rPr lang="en-US" sz="816" dirty="0">
+                <a:solidFill>
+                  <a:srgbClr val="1A1C2E"/>
+                </a:solidFill>
+                <a:latin typeface="Arial" pitchFamily="34" charset="0"/>
+                <a:ea typeface="Arial" pitchFamily="34" charset="-122"/>
+                <a:cs typeface="Arial" pitchFamily="34" charset="-120"/>
+              </a:rPr>
+              <a:t>school</a:t>
+            </a:r>
+            <a:endParaRPr lang="en-US" sz="816" dirty="0"/>
+          </a:p>
+        </p:txBody>
+      </p:sp>
+      <p:sp>
+        <p:nvSpPr>
+          <p:cNvPr id="11" name="Text 9"/>
+          <p:cNvSpPr/>
+          <p:nvPr/>
+        </p:nvSpPr>
+        <p:spPr>
+          <a:xfrm>
+            <a:off x="11064240" y="6263640"/>
+            <a:ext cx="320040" cy="219456"/>
+          </a:xfrm>
+          <a:prstGeom prst="rect">
+            <a:avLst/>
+          </a:prstGeom>
+          <a:noFill/>
+          <a:ln/>
+        </p:spPr>
+        <p:txBody>
+          <a:bodyPr wrap="square" lIns="0" tIns="0" rIns="0" bIns="0" rtlCol="0" anchor="ctr"/>
+          <a:lstStyle/>
+          <a:p>
+            <a:pPr algn="r" indent="0" marL="0">
+              <a:buNone/>
+            </a:pPr>
+            <a:r>
+              <a:rPr lang="en-US" sz="1000" dirty="0">
+                <a:solidFill>
+                  <a:srgbClr val="5A5F73"/>
+                </a:solidFill>
+                <a:latin typeface="Calibri" pitchFamily="34" charset="0"/>
+                <a:ea typeface="Calibri" pitchFamily="34" charset="-122"/>
+                <a:cs typeface="Calibri" pitchFamily="34" charset="-120"/>
+              </a:rPr>
+              <a:t>10</a:t>
+            </a:r>
+            <a:endParaRPr lang="en-US" sz="1000" dirty="0"/>
+          </a:p>
+        </p:txBody>
+      </p:sp>
+    </p:spTree>
+  </p:cSld>
+  <p:clrMapOvr>
+    <a:masterClrMapping/>
+  </p:clrMapOvr>
+</p:sld>
+</file>
+
 <file path=ppt/slides/slide2.xml><?xml version="1.0" encoding="utf-8"?>
 <p:sld xmlns:a="http://schemas.openxmlformats.org/drawingml/2006/main" xmlns:r="http://schemas.openxmlformats.org/officeDocument/2006/relationships" xmlns:p="http://schemas.openxmlformats.org/presentationml/2006/main">
   <p:cSld name="Slide 2">
@@ -7126,7 +7828,7 @@
                 <a:ea typeface="Arial" pitchFamily="34" charset="-122"/>
                 <a:cs typeface="Arial" pitchFamily="34" charset="-120"/>
               </a:rPr>
-              <a:t>Dos diagnósticos</a:t>
+              <a:t>MCP: las herramientas del agente</a:t>
             </a:r>
             <a:endParaRPr lang="en-US" sz="3400" dirty="0"/>
           </a:p>
@@ -7165,7 +7867,7 @@
                 <a:ea typeface="Calibri" pitchFamily="34" charset="-122"/>
                 <a:cs typeface="Calibri" pitchFamily="34" charset="-120"/>
               </a:rPr>
-              <a:t>El determinista está siempre. El cognitivo, solo si hay un modelo configurado.</a:t>
+              <a:t>El modelo no toca el coche. Pide una herramienta, y el sistema decide si se ejecuta.</a:t>
             </a:r>
             <a:endParaRPr lang="en-US" sz="1700" dirty="0"/>
           </a:p>
@@ -7204,7 +7906,7 @@
                 <a:ea typeface="Arial" pitchFamily="34" charset="-122"/>
                 <a:cs typeface="Arial" pitchFamily="34" charset="-120"/>
               </a:rPr>
-              <a:t>Determinista</a:t>
+              <a:t>16 herramientas</a:t>
             </a:r>
             <a:endParaRPr lang="en-US" sz="2000" dirty="0"/>
           </a:p>
@@ -7219,6 +7921,288 @@
         <p:spPr>
           <a:xfrm>
             <a:off x="777240" y="2788920"/>
+            <a:ext cx="548640" cy="365760"/>
+          </a:xfrm>
+          <a:prstGeom prst="rect">
+            <a:avLst/>
+          </a:prstGeom>
+          <a:noFill/>
+          <a:ln/>
+        </p:spPr>
+        <p:txBody>
+          <a:bodyPr wrap="square" lIns="0" tIns="0" rIns="0" bIns="0" rtlCol="0" anchor="t"/>
+          <a:lstStyle/>
+          <a:p>
+            <a:pPr indent="0" marL="0">
+              <a:buNone/>
+            </a:pPr>
+            <a:r>
+              <a:rPr lang="en-US" sz="2000" b="1" dirty="0">
+                <a:solidFill>
+                  <a:srgbClr val="1A1C2E"/>
+                </a:solidFill>
+                <a:latin typeface="Arial" pitchFamily="34" charset="0"/>
+                <a:ea typeface="Arial" pitchFamily="34" charset="-122"/>
+                <a:cs typeface="Arial" pitchFamily="34" charset="-120"/>
+              </a:rPr>
+              <a:t>7</a:t>
+            </a:r>
+            <a:endParaRPr lang="en-US" sz="2000" dirty="0"/>
+          </a:p>
+        </p:txBody>
+      </p:sp>
+      <p:sp>
+        <p:nvSpPr>
+          <p:cNvPr id="6" name="Text 4"/>
+          <p:cNvSpPr/>
+          <p:nvPr/>
+        </p:nvSpPr>
+        <p:spPr>
+          <a:xfrm>
+            <a:off x="1417320" y="2788920"/>
+            <a:ext cx="4206240" cy="731520"/>
+          </a:xfrm>
+          <a:prstGeom prst="rect">
+            <a:avLst/>
+          </a:prstGeom>
+          <a:noFill/>
+          <a:ln/>
+        </p:spPr>
+        <p:txBody>
+          <a:bodyPr wrap="square" lIns="0" tIns="0" rIns="0" bIns="0" rtlCol="0" anchor="t"/>
+          <a:lstStyle/>
+          <a:p>
+            <a:pPr indent="0" marL="0">
+              <a:lnSpc>
+                <a:spcPts val="2100"/>
+              </a:lnSpc>
+              <a:buNone/>
+            </a:pPr>
+            <a:r>
+              <a:rPr lang="en-US" sz="1500" dirty="0">
+                <a:solidFill>
+                  <a:srgbClr val="1A1C2E"/>
+                </a:solidFill>
+                <a:latin typeface="Calibri" pitchFamily="34" charset="0"/>
+                <a:ea typeface="Calibri" pitchFamily="34" charset="-122"/>
+                <a:cs typeface="Calibri" pitchFamily="34" charset="-120"/>
+              </a:rPr>
+              <a:t>de diagnóstico: leer el VIN, un PID, los DTCs, el freeze frame, las ECUs</a:t>
+            </a:r>
+            <a:endParaRPr lang="en-US" sz="1500" dirty="0"/>
+          </a:p>
+        </p:txBody>
+      </p:sp>
+      <p:sp>
+        <p:nvSpPr>
+          <p:cNvPr id="7" name="Text 5"/>
+          <p:cNvSpPr/>
+          <p:nvPr/>
+        </p:nvSpPr>
+        <p:spPr>
+          <a:xfrm>
+            <a:off x="777240" y="3566160"/>
+            <a:ext cx="548640" cy="365760"/>
+          </a:xfrm>
+          <a:prstGeom prst="rect">
+            <a:avLst/>
+          </a:prstGeom>
+          <a:noFill/>
+          <a:ln/>
+        </p:spPr>
+        <p:txBody>
+          <a:bodyPr wrap="square" lIns="0" tIns="0" rIns="0" bIns="0" rtlCol="0" anchor="t"/>
+          <a:lstStyle/>
+          <a:p>
+            <a:pPr indent="0" marL="0">
+              <a:buNone/>
+            </a:pPr>
+            <a:r>
+              <a:rPr lang="en-US" sz="2000" b="1" dirty="0">
+                <a:solidFill>
+                  <a:srgbClr val="1A1C2E"/>
+                </a:solidFill>
+                <a:latin typeface="Arial" pitchFamily="34" charset="0"/>
+                <a:ea typeface="Arial" pitchFamily="34" charset="-122"/>
+                <a:cs typeface="Arial" pitchFamily="34" charset="-120"/>
+              </a:rPr>
+              <a:t>8</a:t>
+            </a:r>
+            <a:endParaRPr lang="en-US" sz="2000" dirty="0"/>
+          </a:p>
+        </p:txBody>
+      </p:sp>
+      <p:sp>
+        <p:nvSpPr>
+          <p:cNvPr id="8" name="Text 6"/>
+          <p:cNvSpPr/>
+          <p:nvPr/>
+        </p:nvSpPr>
+        <p:spPr>
+          <a:xfrm>
+            <a:off x="1417320" y="3566160"/>
+            <a:ext cx="4206240" cy="731520"/>
+          </a:xfrm>
+          <a:prstGeom prst="rect">
+            <a:avLst/>
+          </a:prstGeom>
+          <a:noFill/>
+          <a:ln/>
+        </p:spPr>
+        <p:txBody>
+          <a:bodyPr wrap="square" lIns="0" tIns="0" rIns="0" bIns="0" rtlCol="0" anchor="t"/>
+          <a:lstStyle/>
+          <a:p>
+            <a:pPr indent="0" marL="0">
+              <a:lnSpc>
+                <a:spcPts val="2100"/>
+              </a:lnSpc>
+              <a:buNone/>
+            </a:pPr>
+            <a:r>
+              <a:rPr lang="en-US" sz="1500" dirty="0">
+                <a:solidFill>
+                  <a:srgbClr val="1A1C2E"/>
+                </a:solidFill>
+                <a:latin typeface="Calibri" pitchFamily="34" charset="0"/>
+                <a:ea typeface="Calibri" pitchFamily="34" charset="-122"/>
+                <a:cs typeface="Calibri" pitchFamily="34" charset="-120"/>
+              </a:rPr>
+              <a:t>de conocimiento: buscar parecidos e indexar lo aprendido</a:t>
+            </a:r>
+            <a:endParaRPr lang="en-US" sz="1500" dirty="0"/>
+          </a:p>
+        </p:txBody>
+      </p:sp>
+      <p:sp>
+        <p:nvSpPr>
+          <p:cNvPr id="9" name="Text 7"/>
+          <p:cNvSpPr/>
+          <p:nvPr/>
+        </p:nvSpPr>
+        <p:spPr>
+          <a:xfrm>
+            <a:off x="777240" y="4343400"/>
+            <a:ext cx="548640" cy="365760"/>
+          </a:xfrm>
+          <a:prstGeom prst="rect">
+            <a:avLst/>
+          </a:prstGeom>
+          <a:noFill/>
+          <a:ln/>
+        </p:spPr>
+        <p:txBody>
+          <a:bodyPr wrap="square" lIns="0" tIns="0" rIns="0" bIns="0" rtlCol="0" anchor="t"/>
+          <a:lstStyle/>
+          <a:p>
+            <a:pPr indent="0" marL="0">
+              <a:buNone/>
+            </a:pPr>
+            <a:r>
+              <a:rPr lang="en-US" sz="2000" b="1" dirty="0">
+                <a:solidFill>
+                  <a:srgbClr val="1A1C2E"/>
+                </a:solidFill>
+                <a:latin typeface="Arial" pitchFamily="34" charset="0"/>
+                <a:ea typeface="Arial" pitchFamily="34" charset="-122"/>
+                <a:cs typeface="Arial" pitchFamily="34" charset="-120"/>
+              </a:rPr>
+              <a:t>1</a:t>
+            </a:r>
+            <a:endParaRPr lang="en-US" sz="2000" dirty="0"/>
+          </a:p>
+        </p:txBody>
+      </p:sp>
+      <p:sp>
+        <p:nvSpPr>
+          <p:cNvPr id="10" name="Text 8"/>
+          <p:cNvSpPr/>
+          <p:nvPr/>
+        </p:nvSpPr>
+        <p:spPr>
+          <a:xfrm>
+            <a:off x="1417320" y="4343400"/>
+            <a:ext cx="4206240" cy="731520"/>
+          </a:xfrm>
+          <a:prstGeom prst="rect">
+            <a:avLst/>
+          </a:prstGeom>
+          <a:noFill/>
+          <a:ln/>
+        </p:spPr>
+        <p:txBody>
+          <a:bodyPr wrap="square" lIns="0" tIns="0" rIns="0" bIns="0" rtlCol="0" anchor="t"/>
+          <a:lstStyle/>
+          <a:p>
+            <a:pPr indent="0" marL="0">
+              <a:lnSpc>
+                <a:spcPts val="2100"/>
+              </a:lnSpc>
+              <a:buNone/>
+            </a:pPr>
+            <a:r>
+              <a:rPr lang="en-US" sz="1500" dirty="0">
+                <a:solidFill>
+                  <a:srgbClr val="1A1C2E"/>
+                </a:solidFill>
+                <a:latin typeface="Calibri" pitchFamily="34" charset="0"/>
+                <a:ea typeface="Calibri" pitchFamily="34" charset="-122"/>
+                <a:cs typeface="Calibri" pitchFamily="34" charset="-120"/>
+              </a:rPr>
+              <a:t>de búsqueda web, con presupuesto limitado por diagnóstico</a:t>
+            </a:r>
+            <a:endParaRPr lang="en-US" sz="1500" dirty="0"/>
+          </a:p>
+        </p:txBody>
+      </p:sp>
+      <p:sp>
+        <p:nvSpPr>
+          <p:cNvPr id="11" name="Text 9"/>
+          <p:cNvSpPr/>
+          <p:nvPr/>
+        </p:nvSpPr>
+        <p:spPr>
+          <a:xfrm>
+            <a:off x="6537960" y="2240280"/>
+            <a:ext cx="4846320" cy="365760"/>
+          </a:xfrm>
+          <a:prstGeom prst="rect">
+            <a:avLst/>
+          </a:prstGeom>
+          <a:noFill/>
+          <a:ln/>
+        </p:spPr>
+        <p:txBody>
+          <a:bodyPr wrap="square" lIns="0" tIns="0" rIns="0" bIns="0" rtlCol="0" anchor="t"/>
+          <a:lstStyle/>
+          <a:p>
+            <a:pPr indent="0" marL="0">
+              <a:buNone/>
+            </a:pPr>
+            <a:r>
+              <a:rPr lang="en-US" sz="2000" b="1" dirty="0">
+                <a:solidFill>
+                  <a:srgbClr val="202CFC"/>
+                </a:solidFill>
+                <a:latin typeface="Arial" pitchFamily="34" charset="0"/>
+                <a:ea typeface="Arial" pitchFamily="34" charset="-122"/>
+                <a:cs typeface="Arial" pitchFamily="34" charset="-120"/>
+              </a:rPr>
+              <a:t>Por qué MCP y no llamadas a medida</a:t>
+            </a:r>
+            <a:endParaRPr lang="en-US" sz="2000" dirty="0"/>
+          </a:p>
+        </p:txBody>
+      </p:sp>
+      <p:sp>
+        <p:nvSpPr>
+          <p:cNvPr id="12" name="Text 10"/>
+          <p:cNvSpPr/>
+          <p:nvPr/>
+        </p:nvSpPr>
+        <p:spPr>
+          <a:xfrm>
+            <a:off x="6537960" y="2788920"/>
             <a:ext cx="4846320" cy="2834640"/>
           </a:xfrm>
           <a:prstGeom prst="rect">
@@ -7250,7 +8234,7 @@
                 <a:ea typeface="Calibri" pitchFamily="34" charset="-122"/>
                 <a:cs typeface="Calibri" pitchFamily="34" charset="-120"/>
               </a:rPr>
-              <a:t>Lee cuatro PIDs fijos: revoluciones, refrigerante, velocidad y admisión</a:t>
+              <a:t>Es un protocolo: el mismo servidor sirve a cualquier cliente que lo hable</a:t>
             </a:r>
             <a:endParaRPr lang="en-US" sz="1500" dirty="0"/>
           </a:p>
@@ -7274,7 +8258,7 @@
                 <a:ea typeface="Calibri" pitchFamily="34" charset="-122"/>
                 <a:cs typeface="Calibri" pitchFamily="34" charset="-120"/>
               </a:rPr>
-              <a:t>Más los DTCs y el freeze frame</a:t>
+              <a:t>Cada herramienta declara su esquema, y los argumentos se validan antes de ejecutarla</a:t>
             </a:r>
             <a:endParaRPr lang="en-US" sz="1500" dirty="0"/>
           </a:p>
@@ -7298,7 +8282,7 @@
                 <a:ea typeface="Calibri" pitchFamily="34" charset="-122"/>
                 <a:cs typeface="Calibri" pitchFamily="34" charset="-120"/>
               </a:rPr>
-              <a:t>La criticidad sale de una regla: sin DTCs es baja, con freeze frame es crítica</a:t>
+              <a:t>El servidor vive en infraestructura: el modelo nunca ve el dominio</a:t>
             </a:r>
             <a:endParaRPr lang="en-US" sz="1500" dirty="0"/>
           </a:p>
@@ -7322,247 +8306,81 @@
                 <a:ea typeface="Calibri" pitchFamily="34" charset="-122"/>
                 <a:cs typeface="Calibri" pitchFamily="34" charset="-120"/>
               </a:rPr>
-              <a:t>Solo necesita el coche, y responde al momento</a:t>
+              <a:t>Si mañana cambio de modelo, las herramientas no se tocan</a:t>
             </a:r>
             <a:endParaRPr lang="en-US" sz="1500" dirty="0"/>
           </a:p>
-          <a:p>
-            <a:pPr marL="342900" indent="-342900">
-              <a:lnSpc>
-                <a:spcPts val="2100"/>
-              </a:lnSpc>
-              <a:spcAft>
-                <a:spcPts val="1100"/>
-              </a:spcAft>
-              <a:buSzPct val="100000"/>
-              <a:buChar char="•"/>
-            </a:pPr>
-            <a:r>
-              <a:rPr lang="en-US" sz="1500" dirty="0">
-                <a:solidFill>
-                  <a:srgbClr val="1A1C2E"/>
-                </a:solidFill>
-                <a:latin typeface="Calibri" pitchFamily="34" charset="0"/>
-                <a:ea typeface="Calibri" pitchFamily="34" charset="-122"/>
-                <a:cs typeface="Calibri" pitchFamily="34" charset="-120"/>
-              </a:rPr>
-              <a:t>No aprende nada</a:t>
-            </a:r>
-            <a:endParaRPr lang="en-US" sz="1500" dirty="0"/>
-          </a:p>
-        </p:txBody>
-      </p:sp>
-      <p:sp>
-        <p:nvSpPr>
-          <p:cNvPr id="6" name="Text 4"/>
-          <p:cNvSpPr/>
-          <p:nvPr/>
-        </p:nvSpPr>
-        <p:spPr>
-          <a:xfrm>
-            <a:off x="6537960" y="2240280"/>
-            <a:ext cx="4846320" cy="365760"/>
-          </a:xfrm>
-          <a:prstGeom prst="rect">
-            <a:avLst/>
-          </a:prstGeom>
-          <a:noFill/>
-          <a:ln/>
-        </p:spPr>
-        <p:txBody>
-          <a:bodyPr wrap="square" lIns="0" tIns="0" rIns="0" bIns="0" rtlCol="0" anchor="t"/>
-          <a:lstStyle/>
-          <a:p>
-            <a:pPr indent="0" marL="0">
-              <a:buNone/>
-            </a:pPr>
-            <a:r>
-              <a:rPr lang="en-US" sz="2000" b="1" dirty="0">
-                <a:solidFill>
-                  <a:srgbClr val="202CFC"/>
+        </p:txBody>
+      </p:sp>
+      <p:sp>
+        <p:nvSpPr>
+          <p:cNvPr id="13" name="Shape 11"/>
+          <p:cNvSpPr/>
+          <p:nvPr/>
+        </p:nvSpPr>
+        <p:spPr>
+          <a:xfrm>
+            <a:off x="777240" y="6263640"/>
+            <a:ext cx="219456" cy="219456"/>
+          </a:xfrm>
+          <a:prstGeom prst="rect">
+            <a:avLst/>
+          </a:prstGeom>
+          <a:solidFill>
+            <a:srgbClr val="202CFC"/>
+          </a:solidFill>
+          <a:ln/>
+        </p:spPr>
+      </p:sp>
+      <p:sp>
+        <p:nvSpPr>
+          <p:cNvPr id="14" name="Text 12"/>
+          <p:cNvSpPr/>
+          <p:nvPr/>
+        </p:nvSpPr>
+        <p:spPr>
+          <a:xfrm>
+            <a:off x="777240" y="6263640"/>
+            <a:ext cx="219456" cy="219456"/>
+          </a:xfrm>
+          <a:prstGeom prst="rect">
+            <a:avLst/>
+          </a:prstGeom>
+          <a:noFill/>
+          <a:ln/>
+        </p:spPr>
+        <p:txBody>
+          <a:bodyPr wrap="square" lIns="0" tIns="0" rIns="0" bIns="0" rtlCol="0" anchor="ctr"/>
+          <a:lstStyle/>
+          <a:p>
+            <a:pPr algn="ctr" indent="0" marL="0">
+              <a:buNone/>
+            </a:pPr>
+            <a:r>
+              <a:rPr lang="en-US" sz="816" b="1" dirty="0">
+                <a:solidFill>
+                  <a:srgbClr val="FFFFFF"/>
                 </a:solidFill>
                 <a:latin typeface="Arial" pitchFamily="34" charset="0"/>
                 <a:ea typeface="Arial" pitchFamily="34" charset="-122"/>
                 <a:cs typeface="Arial" pitchFamily="34" charset="-120"/>
               </a:rPr>
-              <a:t>Cognitivo</a:t>
-            </a:r>
-            <a:endParaRPr lang="en-US" sz="2000" dirty="0"/>
-          </a:p>
-        </p:txBody>
-      </p:sp>
-      <p:sp>
-        <p:nvSpPr>
-          <p:cNvPr id="7" name="Text 5"/>
-          <p:cNvSpPr/>
-          <p:nvPr/>
-        </p:nvSpPr>
-        <p:spPr>
-          <a:xfrm>
-            <a:off x="6537960" y="2788920"/>
-            <a:ext cx="4846320" cy="2834640"/>
-          </a:xfrm>
-          <a:prstGeom prst="rect">
-            <a:avLst/>
-          </a:prstGeom>
-          <a:noFill/>
-          <a:ln/>
-        </p:spPr>
-        <p:txBody>
-          <a:bodyPr wrap="square" lIns="0" tIns="0" rIns="0" bIns="0" rtlCol="0" anchor="t"/>
-          <a:lstStyle/>
-          <a:p>
-            <a:pPr marL="342900" indent="-342900">
-              <a:lnSpc>
-                <a:spcPts val="2100"/>
-              </a:lnSpc>
-              <a:spcAft>
-                <a:spcPts val="1100"/>
-              </a:spcAft>
-              <a:buSzPct val="100000"/>
-              <a:buChar char="•"/>
-            </a:pPr>
-            <a:r>
-              <a:rPr lang="en-US" sz="1500" dirty="0">
-                <a:solidFill>
-                  <a:srgbClr val="1A1C2E"/>
-                </a:solidFill>
-                <a:latin typeface="Calibri" pitchFamily="34" charset="0"/>
-                <a:ea typeface="Calibri" pitchFamily="34" charset="-122"/>
-                <a:cs typeface="Calibri" pitchFamily="34" charset="-120"/>
-              </a:rPr>
-              <a:t>El agente decide qué PIDs le hace falta leer</a:t>
-            </a:r>
-            <a:endParaRPr lang="en-US" sz="1500" dirty="0"/>
-          </a:p>
-          <a:p>
-            <a:pPr marL="342900" indent="-342900">
-              <a:lnSpc>
-                <a:spcPts val="2100"/>
-              </a:lnSpc>
-              <a:spcAft>
-                <a:spcPts val="1100"/>
-              </a:spcAft>
-              <a:buSzPct val="100000"/>
-              <a:buChar char="•"/>
-            </a:pPr>
-            <a:r>
-              <a:rPr lang="en-US" sz="1500" dirty="0">
-                <a:solidFill>
-                  <a:srgbClr val="1A1C2E"/>
-                </a:solidFill>
-                <a:latin typeface="Calibri" pitchFamily="34" charset="0"/>
-                <a:ea typeface="Calibri" pitchFamily="34" charset="-122"/>
-                <a:cs typeface="Calibri" pitchFamily="34" charset="-120"/>
-              </a:rPr>
-              <a:t>Razona sobre lo que va encontrando, llamando a herramientas</a:t>
-            </a:r>
-            <a:endParaRPr lang="en-US" sz="1500" dirty="0"/>
-          </a:p>
-          <a:p>
-            <a:pPr marL="342900" indent="-342900">
-              <a:lnSpc>
-                <a:spcPts val="2100"/>
-              </a:lnSpc>
-              <a:spcAft>
-                <a:spcPts val="1100"/>
-              </a:spcAft>
-              <a:buSzPct val="100000"/>
-              <a:buChar char="•"/>
-            </a:pPr>
-            <a:r>
-              <a:rPr lang="en-US" sz="1500" dirty="0">
-                <a:solidFill>
-                  <a:srgbClr val="1A1C2E"/>
-                </a:solidFill>
-                <a:latin typeface="Calibri" pitchFamily="34" charset="0"/>
-                <a:ea typeface="Calibri" pitchFamily="34" charset="-122"/>
-                <a:cs typeface="Calibri" pitchFamily="34" charset="-120"/>
-              </a:rPr>
-              <a:t>Necesita el coche, la API del modelo y los índices vectoriales</a:t>
-            </a:r>
-            <a:endParaRPr lang="en-US" sz="1500" dirty="0"/>
-          </a:p>
-          <a:p>
-            <a:pPr marL="342900" indent="-342900">
-              <a:lnSpc>
-                <a:spcPts val="2100"/>
-              </a:lnSpc>
-              <a:spcAft>
-                <a:spcPts val="1100"/>
-              </a:spcAft>
-              <a:buSzPct val="100000"/>
-              <a:buChar char="•"/>
-            </a:pPr>
-            <a:r>
-              <a:rPr lang="en-US" sz="1500" dirty="0">
-                <a:solidFill>
-                  <a:srgbClr val="1A1C2E"/>
-                </a:solidFill>
-                <a:latin typeface="Calibri" pitchFamily="34" charset="0"/>
-                <a:ea typeface="Calibri" pitchFamily="34" charset="-122"/>
-                <a:cs typeface="Calibri" pitchFamily="34" charset="-120"/>
-              </a:rPr>
-              <a:t>Hasta 60 segundos de límite</a:t>
-            </a:r>
-            <a:endParaRPr lang="en-US" sz="1500" dirty="0"/>
-          </a:p>
-          <a:p>
-            <a:pPr marL="342900" indent="-342900">
-              <a:lnSpc>
-                <a:spcPts val="2100"/>
-              </a:lnSpc>
-              <a:spcAft>
-                <a:spcPts val="1100"/>
-              </a:spcAft>
-              <a:buSzPct val="100000"/>
-              <a:buChar char="•"/>
-            </a:pPr>
-            <a:r>
-              <a:rPr lang="en-US" sz="1500" dirty="0">
-                <a:solidFill>
-                  <a:srgbClr val="1A1C2E"/>
-                </a:solidFill>
-                <a:latin typeface="Calibri" pitchFamily="34" charset="0"/>
-                <a:ea typeface="Calibri" pitchFamily="34" charset="-122"/>
-                <a:cs typeface="Calibri" pitchFamily="34" charset="-120"/>
-              </a:rPr>
-              <a:t>Y aprende: indexa PIDs, DTCs y el caso resuelto</a:t>
-            </a:r>
-            <a:endParaRPr lang="en-US" sz="1500" dirty="0"/>
-          </a:p>
-        </p:txBody>
-      </p:sp>
-      <p:sp>
-        <p:nvSpPr>
-          <p:cNvPr id="8" name="Shape 6"/>
-          <p:cNvSpPr/>
-          <p:nvPr/>
-        </p:nvSpPr>
-        <p:spPr>
-          <a:xfrm>
-            <a:off x="777240" y="6263640"/>
-            <a:ext cx="219456" cy="219456"/>
-          </a:xfrm>
-          <a:prstGeom prst="rect">
-            <a:avLst/>
-          </a:prstGeom>
-          <a:solidFill>
-            <a:srgbClr val="202CFC"/>
-          </a:solidFill>
-          <a:ln/>
-        </p:spPr>
-      </p:sp>
-      <p:sp>
-        <p:nvSpPr>
-          <p:cNvPr id="9" name="Text 7"/>
-          <p:cNvSpPr/>
-          <p:nvPr/>
-        </p:nvSpPr>
-        <p:spPr>
-          <a:xfrm>
-            <a:off x="777240" y="6263640"/>
-            <a:ext cx="219456" cy="219456"/>
+              <a:t>BIG</a:t>
+            </a:r>
+            <a:endParaRPr lang="en-US" sz="816" dirty="0"/>
+          </a:p>
+        </p:txBody>
+      </p:sp>
+      <p:sp>
+        <p:nvSpPr>
+          <p:cNvPr id="15" name="Text 13"/>
+          <p:cNvSpPr/>
+          <p:nvPr/>
+        </p:nvSpPr>
+        <p:spPr>
+          <a:xfrm>
+            <a:off x="1078992" y="6263640"/>
+            <a:ext cx="658368" cy="219456"/>
           </a:xfrm>
           <a:prstGeom prst="rect">
             <a:avLst/>
@@ -7574,19 +8392,19 @@
           <a:bodyPr wrap="square" lIns="0" tIns="0" rIns="0" bIns="0" rtlCol="0" anchor="ctr"/>
           <a:lstStyle/>
           <a:p>
-            <a:pPr algn="ctr" indent="0" marL="0">
-              <a:buNone/>
-            </a:pPr>
-            <a:r>
-              <a:rPr lang="en-US" sz="816" b="1" dirty="0">
-                <a:solidFill>
-                  <a:srgbClr val="FFFFFF"/>
+            <a:pPr algn="l" indent="0" marL="0">
+              <a:buNone/>
+            </a:pPr>
+            <a:r>
+              <a:rPr lang="en-US" sz="816" dirty="0">
+                <a:solidFill>
+                  <a:srgbClr val="1A1C2E"/>
                 </a:solidFill>
                 <a:latin typeface="Arial" pitchFamily="34" charset="0"/>
                 <a:ea typeface="Arial" pitchFamily="34" charset="-122"/>
                 <a:cs typeface="Arial" pitchFamily="34" charset="-120"/>
               </a:rPr>
-              <a:t>BIG</a:t>
+              <a:t>school</a:t>
             </a:r>
             <a:endParaRPr lang="en-US" sz="816" dirty="0"/>
           </a:p>
@@ -7594,46 +8412,7 @@
       </p:sp>
       <p:sp>
         <p:nvSpPr>
-          <p:cNvPr id="10" name="Text 8"/>
-          <p:cNvSpPr/>
-          <p:nvPr/>
-        </p:nvSpPr>
-        <p:spPr>
-          <a:xfrm>
-            <a:off x="1078992" y="6263640"/>
-            <a:ext cx="658368" cy="219456"/>
-          </a:xfrm>
-          <a:prstGeom prst="rect">
-            <a:avLst/>
-          </a:prstGeom>
-          <a:noFill/>
-          <a:ln/>
-        </p:spPr>
-        <p:txBody>
-          <a:bodyPr wrap="square" lIns="0" tIns="0" rIns="0" bIns="0" rtlCol="0" anchor="ctr"/>
-          <a:lstStyle/>
-          <a:p>
-            <a:pPr algn="l" indent="0" marL="0">
-              <a:buNone/>
-            </a:pPr>
-            <a:r>
-              <a:rPr lang="en-US" sz="816" dirty="0">
-                <a:solidFill>
-                  <a:srgbClr val="1A1C2E"/>
-                </a:solidFill>
-                <a:latin typeface="Arial" pitchFamily="34" charset="0"/>
-                <a:ea typeface="Arial" pitchFamily="34" charset="-122"/>
-                <a:cs typeface="Arial" pitchFamily="34" charset="-120"/>
-              </a:rPr>
-              <a:t>school</a:t>
-            </a:r>
-            <a:endParaRPr lang="en-US" sz="816" dirty="0"/>
-          </a:p>
-        </p:txBody>
-      </p:sp>
-      <p:sp>
-        <p:nvSpPr>
-          <p:cNvPr id="11" name="Text 9"/>
+          <p:cNvPr id="16" name="Text 14"/>
           <p:cNvSpPr/>
           <p:nvPr/>
         </p:nvSpPr>

</xml_diff>

<commit_message>
docs(tfm): el MCP acota lo que el modelo puede hacer
</commit_message>
<xml_diff>
--- a/docs/presentacion/tfm-intelligent-automotive-diagnostics.pptx
+++ b/docs/presentacion/tfm-intelligent-automotive-diagnostics.pptx
@@ -1341,9 +1341,11 @@
               <a:rPr lang="en-US" dirty="0"/>
               <a:t>El modelo no toca el coche directamente. Lo que hace es pedir herramientas, y el sistema decide si las ejecuta y con qué argumentos. Ese contrato es el MCP, el Model Context Protocol.
 Hay dieciséis herramientas. Siete son de diagnóstico: leer el bastidor, leer un PID, pedir los códigos de avería, el freeze frame o la información de las centralitas. Ocho son de conocimiento, y son las que hablan con la base vectorial: buscar casos parecidos e indexar lo que se aprende. Y una es de búsqueda web, que lleva un presupuesto limitado por diagnóstico para que el agente no se vaya a internet sin control.
-¿Por qué MCP y no montarme yo las llamadas a medida? Por tres razones. Primero, es un protocolo: el mismo servidor sirve a cualquier cliente que lo hable, no solo al mío. Segundo, cada herramienta declara su esquema, así que los argumentos que manda el modelo se validan antes de ejecutar nada. Y tercero, el servidor MCP vive en la capa de infraestructura: es un adaptador más. El modelo nunca ve el dominio, ve herramientas.
-La consecuencia es la de siempre: si mañana cambio de modelo, las herramientas no se tocan.
-[~70 s]</a:t>
+¿Y por qué MCP? Primero, porque es el estándar que existe hoy para que un modelo pida herramientas. No es un protocolo de propósito general: sirve exactamente para esto, y por eso encaja.
+Y segundo, que para mí es lo importante: el modelo solo puede actuar a través de esas dieciséis herramientas. No hay otra puerta. No ejecuta código, no consulta la base de datos por su cuenta, no llama a ningún otro endpoint. Si quiere saber a cuántas revoluciones está el motor, tiene que pedir la herramienta de leer un PID, y ahí es donde yo decido si se ejecuta y con qué argumentos. Eso acota lo que el agente puede hacer, que en un sistema que se conecta a un coche de verdad no es un detalle menor.
+Además, cada herramienta declara su esquema, así que los argumentos que manda el modelo se validan antes de ejecutar nada. Y el servidor MCP vive en la capa de infraestructura: es un adaptador más, el modelo nunca ve el dominio. Como es un protocolo, ese mismo servidor serviría a cualquier otro cliente que lo hable.
+La consecuencia de todo esto es la de siempre: si mañana cambio de modelo, las herramientas no se tocan.
+[~75 s]</a:t>
             </a:r>
             <a:endParaRPr lang="en-US" dirty="0"/>
           </a:p>
@@ -8234,7 +8236,7 @@
                 <a:ea typeface="Calibri" pitchFamily="34" charset="-122"/>
                 <a:cs typeface="Calibri" pitchFamily="34" charset="-120"/>
               </a:rPr>
-              <a:t>Es un protocolo: el mismo servidor sirve a cualquier cliente que lo hable</a:t>
+              <a:t>Es el estándar con el que un modelo pide herramientas, y solo sirve para eso</a:t>
             </a:r>
             <a:endParaRPr lang="en-US" sz="1500" dirty="0"/>
           </a:p>
@@ -8258,7 +8260,7 @@
                 <a:ea typeface="Calibri" pitchFamily="34" charset="-122"/>
                 <a:cs typeface="Calibri" pitchFamily="34" charset="-120"/>
               </a:rPr>
-              <a:t>Cada herramienta declara su esquema, y los argumentos se validan antes de ejecutarla</a:t>
+              <a:t>El modelo solo actúa por ahí: no hay otra puerta al sistema</a:t>
             </a:r>
             <a:endParaRPr lang="en-US" sz="1500" dirty="0"/>
           </a:p>
@@ -8282,7 +8284,7 @@
                 <a:ea typeface="Calibri" pitchFamily="34" charset="-122"/>
                 <a:cs typeface="Calibri" pitchFamily="34" charset="-120"/>
               </a:rPr>
-              <a:t>El servidor vive en infraestructura: el modelo nunca ve el dominio</a:t>
+              <a:t>Cada herramienta declara su esquema, y los argumentos se validan antes de ejecutarla</a:t>
             </a:r>
             <a:endParaRPr lang="en-US" sz="1500" dirty="0"/>
           </a:p>
@@ -8306,7 +8308,31 @@
                 <a:ea typeface="Calibri" pitchFamily="34" charset="-122"/>
                 <a:cs typeface="Calibri" pitchFamily="34" charset="-120"/>
               </a:rPr>
-              <a:t>Si mañana cambio de modelo, las herramientas no se tocan</a:t>
+              <a:t>El servidor vive en infraestructura: el modelo nunca ve el dominio</a:t>
+            </a:r>
+            <a:endParaRPr lang="en-US" sz="1500" dirty="0"/>
+          </a:p>
+          <a:p>
+            <a:pPr marL="342900" indent="-342900">
+              <a:lnSpc>
+                <a:spcPts val="2100"/>
+              </a:lnSpc>
+              <a:spcAft>
+                <a:spcPts val="1100"/>
+              </a:spcAft>
+              <a:buSzPct val="100000"/>
+              <a:buChar char="•"/>
+            </a:pPr>
+            <a:r>
+              <a:rPr lang="en-US" sz="1500" dirty="0">
+                <a:solidFill>
+                  <a:srgbClr val="1A1C2E"/>
+                </a:solidFill>
+                <a:latin typeface="Calibri" pitchFamily="34" charset="0"/>
+                <a:ea typeface="Calibri" pitchFamily="34" charset="-122"/>
+                <a:cs typeface="Calibri" pitchFamily="34" charset="-120"/>
+              </a:rPr>
+              <a:t>Cambiar de modelo no toca las herramientas</a:t>
             </a:r>
             <a:endParaRPr lang="en-US" sz="1500" dirty="0"/>
           </a:p>

</xml_diff>

<commit_message>
docs(tfm): listar las 16 tools MCP por su nombre
</commit_message>
<xml_diff>
--- a/docs/presentacion/tfm-intelligent-automotive-diagnostics.pptx
+++ b/docs/presentacion/tfm-intelligent-automotive-diagnostics.pptx
@@ -1340,11 +1340,10 @@
             <a:r>
               <a:rPr lang="en-US" dirty="0"/>
               <a:t>El modelo no toca el coche directamente. Lo que hace es pedir herramientas, y el sistema decide si las ejecuta y con qué argumentos. Ese contrato es el MCP, el Model Context Protocol.
-Hay dieciséis herramientas. Siete son de diagnóstico: leer el bastidor, leer un PID, pedir los códigos de avería, el freeze frame o la información de las centralitas. Ocho son de conocimiento, y son las que hablan con la base vectorial: buscar casos parecidos e indexar lo que se aprende. Y una es de búsqueda web, que lleva un presupuesto limitado por diagnóstico para que el agente no se vaya a internet sin control.
-¿Y por qué MCP? Primero, porque es el estándar que existe hoy para que un modelo pida herramientas. No es un protocolo de propósito general: sirve exactamente para esto, y por eso encaja.
-Y segundo, que para mí es lo importante: el modelo solo puede actuar a través de esas dieciséis herramientas. No hay otra puerta. No ejecuta código, no consulta la base de datos por su cuenta, no llama a ningún otro endpoint. Si quiere saber a cuántas revoluciones está el motor, tiene que pedir la herramienta de leer un PID, y ahí es donde yo decido si se ejecuta y con qué argumentos. Eso acota lo que el agente puede hacer, que en un sistema que se conecta a un coche de verdad no es un detalle menor.
-Además, cada herramienta declara su esquema, así que los argumentos que manda el modelo se validan antes de ejecutar nada. Y el servidor MCP vive en la capa de infraestructura: es un adaptador más, el modelo nunca ve el dominio. Como es un protocolo, ese mismo servidor serviría a cualquier otro cliente que lo hable.
-La consecuencia de todo esto es la de siempre: si mañana cambio de modelo, las herramientas no se tocan.
+A la izquierda están las dieciséis que he construido, con su nombre. Siete son de diagnóstico: leer el bastidor, leer un PID, preguntar qué PIDs soporta el coche, los códigos de avería, el freeze frame, la información del vehículo y la de las centralitas. Ocho son de conocimiento, y van por parejas: cuatro para buscar parecidos y cuatro para indexar lo aprendido, de PIDs, DTCs, diagnósticos y ECUs. Y una de búsqueda web, con un presupuesto limitado por diagnóstico para que el agente no se vaya a internet sin control.
+¿Y por qué MCP? Primero, porque es el estándar que existe hoy para que un modelo pida herramientas. No es un protocolo de propósito general: sirve exactamente para esto.
+Y segundo, que para mí es lo importante: el modelo solo puede actuar a través de esas dieciséis. No hay otra puerta. No ejecuta código, no consulta la base de datos por su cuenta, no llama a ningún otro endpoint. Si quiere saber a cuántas revoluciones está el motor, tiene que pedir la herramienta de leer un PID, y ahí decido yo si se ejecuta y con qué argumentos. Eso acota lo que el agente puede hacer, y en un sistema que se conecta a un coche de verdad no es un detalle menor.
+Además, cada herramienta declara su esquema, así que los argumentos se validan antes de ejecutar nada. Y el servidor MCP vive en infraestructura: es un adaptador más, el modelo nunca ve el dominio. Como es un protocolo, ese mismo servidor serviría a cualquier otro cliente que lo hable.
 [~75 s]</a:t>
             </a:r>
             <a:endParaRPr lang="en-US" dirty="0"/>
@@ -7883,8 +7882,8 @@
         </p:nvSpPr>
         <p:spPr>
           <a:xfrm>
-            <a:off x="777240" y="2240280"/>
-            <a:ext cx="4846320" cy="365760"/>
+            <a:off x="777240" y="2194560"/>
+            <a:ext cx="5943600" cy="365760"/>
           </a:xfrm>
           <a:prstGeom prst="rect">
             <a:avLst/>
@@ -7900,7 +7899,7 @@
               <a:buNone/>
             </a:pPr>
             <a:r>
-              <a:rPr lang="en-US" sz="2000" b="1" dirty="0">
+              <a:rPr lang="en-US" sz="1900" b="1" dirty="0">
                 <a:solidFill>
                   <a:srgbClr val="202CFC"/>
                 </a:solidFill>
@@ -7908,9 +7907,9 @@
                 <a:ea typeface="Arial" pitchFamily="34" charset="-122"/>
                 <a:cs typeface="Arial" pitchFamily="34" charset="-120"/>
               </a:rPr>
-              <a:t>16 herramientas</a:t>
-            </a:r>
-            <a:endParaRPr lang="en-US" sz="2000" dirty="0"/>
+              <a:t>Las 16 herramientas</a:t>
+            </a:r>
+            <a:endParaRPr lang="en-US" sz="1900" dirty="0"/>
           </a:p>
         </p:txBody>
       </p:sp>
@@ -7922,8 +7921,8 @@
         </p:nvSpPr>
         <p:spPr>
           <a:xfrm>
-            <a:off x="777240" y="2788920"/>
-            <a:ext cx="548640" cy="365760"/>
+            <a:off x="777240" y="2697480"/>
+            <a:ext cx="5943600" cy="274320"/>
           </a:xfrm>
           <a:prstGeom prst="rect">
             <a:avLst/>
@@ -7939,30 +7938,420 @@
               <a:buNone/>
             </a:pPr>
             <a:r>
-              <a:rPr lang="en-US" sz="2000" b="1" dirty="0">
-                <a:solidFill>
-                  <a:srgbClr val="1A1C2E"/>
+              <a:rPr lang="en-US" sz="1300" b="1" dirty="0">
+                <a:solidFill>
+                  <a:srgbClr val="1A1C2E"/>
+                </a:solidFill>
+                <a:latin typeface="Calibri" pitchFamily="34" charset="0"/>
+                <a:ea typeface="Calibri" pitchFamily="34" charset="-122"/>
+                <a:cs typeface="Calibri" pitchFamily="34" charset="-120"/>
+              </a:rPr>
+              <a:t>Diagnóstico · 7</a:t>
+            </a:r>
+            <a:endParaRPr lang="en-US" sz="1300" dirty="0"/>
+          </a:p>
+        </p:txBody>
+      </p:sp>
+      <p:sp>
+        <p:nvSpPr>
+          <p:cNvPr id="6" name="Text 4"/>
+          <p:cNvSpPr/>
+          <p:nvPr/>
+        </p:nvSpPr>
+        <p:spPr>
+          <a:xfrm>
+            <a:off x="914400" y="3008376"/>
+            <a:ext cx="5806440" cy="256032"/>
+          </a:xfrm>
+          <a:prstGeom prst="rect">
+            <a:avLst/>
+          </a:prstGeom>
+          <a:noFill/>
+          <a:ln/>
+        </p:spPr>
+        <p:txBody>
+          <a:bodyPr wrap="square" lIns="0" tIns="0" rIns="0" bIns="0" rtlCol="0" anchor="t"/>
+          <a:lstStyle/>
+          <a:p>
+            <a:pPr indent="0" marL="0">
+              <a:buNone/>
+            </a:pPr>
+            <a:r>
+              <a:rPr lang="en-US" sz="1100" dirty="0">
+                <a:solidFill>
+                  <a:srgbClr val="5A5F73"/>
+                </a:solidFill>
+                <a:latin typeface="Courier New" pitchFamily="34" charset="0"/>
+                <a:ea typeface="Courier New" pitchFamily="34" charset="-122"/>
+                <a:cs typeface="Courier New" pitchFamily="34" charset="-120"/>
+              </a:rPr>
+              <a:t>read_vin   read_pid   get_available_pids</a:t>
+            </a:r>
+            <a:endParaRPr lang="en-US" sz="1100" dirty="0"/>
+          </a:p>
+        </p:txBody>
+      </p:sp>
+      <p:sp>
+        <p:nvSpPr>
+          <p:cNvPr id="7" name="Text 5"/>
+          <p:cNvSpPr/>
+          <p:nvPr/>
+        </p:nvSpPr>
+        <p:spPr>
+          <a:xfrm>
+            <a:off x="914400" y="3273552"/>
+            <a:ext cx="5806440" cy="256032"/>
+          </a:xfrm>
+          <a:prstGeom prst="rect">
+            <a:avLst/>
+          </a:prstGeom>
+          <a:noFill/>
+          <a:ln/>
+        </p:spPr>
+        <p:txBody>
+          <a:bodyPr wrap="square" lIns="0" tIns="0" rIns="0" bIns="0" rtlCol="0" anchor="t"/>
+          <a:lstStyle/>
+          <a:p>
+            <a:pPr indent="0" marL="0">
+              <a:buNone/>
+            </a:pPr>
+            <a:r>
+              <a:rPr lang="en-US" sz="1100" dirty="0">
+                <a:solidFill>
+                  <a:srgbClr val="5A5F73"/>
+                </a:solidFill>
+                <a:latin typeface="Courier New" pitchFamily="34" charset="0"/>
+                <a:ea typeface="Courier New" pitchFamily="34" charset="-122"/>
+                <a:cs typeface="Courier New" pitchFamily="34" charset="-120"/>
+              </a:rPr>
+              <a:t>get_dtc_codes   get_freeze_frame</a:t>
+            </a:r>
+            <a:endParaRPr lang="en-US" sz="1100" dirty="0"/>
+          </a:p>
+        </p:txBody>
+      </p:sp>
+      <p:sp>
+        <p:nvSpPr>
+          <p:cNvPr id="8" name="Text 6"/>
+          <p:cNvSpPr/>
+          <p:nvPr/>
+        </p:nvSpPr>
+        <p:spPr>
+          <a:xfrm>
+            <a:off x="914400" y="3538728"/>
+            <a:ext cx="5806440" cy="256032"/>
+          </a:xfrm>
+          <a:prstGeom prst="rect">
+            <a:avLst/>
+          </a:prstGeom>
+          <a:noFill/>
+          <a:ln/>
+        </p:spPr>
+        <p:txBody>
+          <a:bodyPr wrap="square" lIns="0" tIns="0" rIns="0" bIns="0" rtlCol="0" anchor="t"/>
+          <a:lstStyle/>
+          <a:p>
+            <a:pPr indent="0" marL="0">
+              <a:buNone/>
+            </a:pPr>
+            <a:r>
+              <a:rPr lang="en-US" sz="1100" dirty="0">
+                <a:solidFill>
+                  <a:srgbClr val="5A5F73"/>
+                </a:solidFill>
+                <a:latin typeface="Courier New" pitchFamily="34" charset="0"/>
+                <a:ea typeface="Courier New" pitchFamily="34" charset="-122"/>
+                <a:cs typeface="Courier New" pitchFamily="34" charset="-120"/>
+              </a:rPr>
+              <a:t>get_vehicle_info   get_ecu_info</a:t>
+            </a:r>
+            <a:endParaRPr lang="en-US" sz="1100" dirty="0"/>
+          </a:p>
+        </p:txBody>
+      </p:sp>
+      <p:sp>
+        <p:nvSpPr>
+          <p:cNvPr id="9" name="Text 7"/>
+          <p:cNvSpPr/>
+          <p:nvPr/>
+        </p:nvSpPr>
+        <p:spPr>
+          <a:xfrm>
+            <a:off x="777240" y="3968496"/>
+            <a:ext cx="5943600" cy="274320"/>
+          </a:xfrm>
+          <a:prstGeom prst="rect">
+            <a:avLst/>
+          </a:prstGeom>
+          <a:noFill/>
+          <a:ln/>
+        </p:spPr>
+        <p:txBody>
+          <a:bodyPr wrap="square" lIns="0" tIns="0" rIns="0" bIns="0" rtlCol="0" anchor="t"/>
+          <a:lstStyle/>
+          <a:p>
+            <a:pPr indent="0" marL="0">
+              <a:buNone/>
+            </a:pPr>
+            <a:r>
+              <a:rPr lang="en-US" sz="1300" b="1" dirty="0">
+                <a:solidFill>
+                  <a:srgbClr val="1A1C2E"/>
+                </a:solidFill>
+                <a:latin typeface="Calibri" pitchFamily="34" charset="0"/>
+                <a:ea typeface="Calibri" pitchFamily="34" charset="-122"/>
+                <a:cs typeface="Calibri" pitchFamily="34" charset="-120"/>
+              </a:rPr>
+              <a:t>Conocimiento · 8</a:t>
+            </a:r>
+            <a:endParaRPr lang="en-US" sz="1300" dirty="0"/>
+          </a:p>
+        </p:txBody>
+      </p:sp>
+      <p:sp>
+        <p:nvSpPr>
+          <p:cNvPr id="10" name="Text 8"/>
+          <p:cNvSpPr/>
+          <p:nvPr/>
+        </p:nvSpPr>
+        <p:spPr>
+          <a:xfrm>
+            <a:off x="914400" y="4279392"/>
+            <a:ext cx="5806440" cy="256032"/>
+          </a:xfrm>
+          <a:prstGeom prst="rect">
+            <a:avLst/>
+          </a:prstGeom>
+          <a:noFill/>
+          <a:ln/>
+        </p:spPr>
+        <p:txBody>
+          <a:bodyPr wrap="square" lIns="0" tIns="0" rIns="0" bIns="0" rtlCol="0" anchor="t"/>
+          <a:lstStyle/>
+          <a:p>
+            <a:pPr indent="0" marL="0">
+              <a:buNone/>
+            </a:pPr>
+            <a:r>
+              <a:rPr lang="en-US" sz="1100" dirty="0">
+                <a:solidFill>
+                  <a:srgbClr val="5A5F73"/>
+                </a:solidFill>
+                <a:latin typeface="Courier New" pitchFamily="34" charset="0"/>
+                <a:ea typeface="Courier New" pitchFamily="34" charset="-122"/>
+                <a:cs typeface="Courier New" pitchFamily="34" charset="-120"/>
+              </a:rPr>
+              <a:t>search_similar_pids   search_similar_dtcs</a:t>
+            </a:r>
+            <a:endParaRPr lang="en-US" sz="1100" dirty="0"/>
+          </a:p>
+        </p:txBody>
+      </p:sp>
+      <p:sp>
+        <p:nvSpPr>
+          <p:cNvPr id="11" name="Text 9"/>
+          <p:cNvSpPr/>
+          <p:nvPr/>
+        </p:nvSpPr>
+        <p:spPr>
+          <a:xfrm>
+            <a:off x="914400" y="4544568"/>
+            <a:ext cx="5806440" cy="256032"/>
+          </a:xfrm>
+          <a:prstGeom prst="rect">
+            <a:avLst/>
+          </a:prstGeom>
+          <a:noFill/>
+          <a:ln/>
+        </p:spPr>
+        <p:txBody>
+          <a:bodyPr wrap="square" lIns="0" tIns="0" rIns="0" bIns="0" rtlCol="0" anchor="t"/>
+          <a:lstStyle/>
+          <a:p>
+            <a:pPr indent="0" marL="0">
+              <a:buNone/>
+            </a:pPr>
+            <a:r>
+              <a:rPr lang="en-US" sz="1100" dirty="0">
+                <a:solidFill>
+                  <a:srgbClr val="5A5F73"/>
+                </a:solidFill>
+                <a:latin typeface="Courier New" pitchFamily="34" charset="0"/>
+                <a:ea typeface="Courier New" pitchFamily="34" charset="-122"/>
+                <a:cs typeface="Courier New" pitchFamily="34" charset="-120"/>
+              </a:rPr>
+              <a:t>search_similar_diagnoses   search_similar_ecus</a:t>
+            </a:r>
+            <a:endParaRPr lang="en-US" sz="1100" dirty="0"/>
+          </a:p>
+        </p:txBody>
+      </p:sp>
+      <p:sp>
+        <p:nvSpPr>
+          <p:cNvPr id="12" name="Text 10"/>
+          <p:cNvSpPr/>
+          <p:nvPr/>
+        </p:nvSpPr>
+        <p:spPr>
+          <a:xfrm>
+            <a:off x="914400" y="4809744"/>
+            <a:ext cx="5806440" cy="256032"/>
+          </a:xfrm>
+          <a:prstGeom prst="rect">
+            <a:avLst/>
+          </a:prstGeom>
+          <a:noFill/>
+          <a:ln/>
+        </p:spPr>
+        <p:txBody>
+          <a:bodyPr wrap="square" lIns="0" tIns="0" rIns="0" bIns="0" rtlCol="0" anchor="t"/>
+          <a:lstStyle/>
+          <a:p>
+            <a:pPr indent="0" marL="0">
+              <a:buNone/>
+            </a:pPr>
+            <a:r>
+              <a:rPr lang="en-US" sz="1100" dirty="0">
+                <a:solidFill>
+                  <a:srgbClr val="5A5F73"/>
+                </a:solidFill>
+                <a:latin typeface="Courier New" pitchFamily="34" charset="0"/>
+                <a:ea typeface="Courier New" pitchFamily="34" charset="-122"/>
+                <a:cs typeface="Courier New" pitchFamily="34" charset="-120"/>
+              </a:rPr>
+              <a:t>index_pid   index_dtc   index_diagnosis   index_ecu</a:t>
+            </a:r>
+            <a:endParaRPr lang="en-US" sz="1100" dirty="0"/>
+          </a:p>
+        </p:txBody>
+      </p:sp>
+      <p:sp>
+        <p:nvSpPr>
+          <p:cNvPr id="13" name="Text 11"/>
+          <p:cNvSpPr/>
+          <p:nvPr/>
+        </p:nvSpPr>
+        <p:spPr>
+          <a:xfrm>
+            <a:off x="777240" y="5239512"/>
+            <a:ext cx="5943600" cy="274320"/>
+          </a:xfrm>
+          <a:prstGeom prst="rect">
+            <a:avLst/>
+          </a:prstGeom>
+          <a:noFill/>
+          <a:ln/>
+        </p:spPr>
+        <p:txBody>
+          <a:bodyPr wrap="square" lIns="0" tIns="0" rIns="0" bIns="0" rtlCol="0" anchor="t"/>
+          <a:lstStyle/>
+          <a:p>
+            <a:pPr indent="0" marL="0">
+              <a:buNone/>
+            </a:pPr>
+            <a:r>
+              <a:rPr lang="en-US" sz="1300" b="1" dirty="0">
+                <a:solidFill>
+                  <a:srgbClr val="1A1C2E"/>
+                </a:solidFill>
+                <a:latin typeface="Calibri" pitchFamily="34" charset="0"/>
+                <a:ea typeface="Calibri" pitchFamily="34" charset="-122"/>
+                <a:cs typeface="Calibri" pitchFamily="34" charset="-120"/>
+              </a:rPr>
+              <a:t>Web · 1</a:t>
+            </a:r>
+            <a:endParaRPr lang="en-US" sz="1300" dirty="0"/>
+          </a:p>
+        </p:txBody>
+      </p:sp>
+      <p:sp>
+        <p:nvSpPr>
+          <p:cNvPr id="14" name="Text 12"/>
+          <p:cNvSpPr/>
+          <p:nvPr/>
+        </p:nvSpPr>
+        <p:spPr>
+          <a:xfrm>
+            <a:off x="914400" y="5550408"/>
+            <a:ext cx="5806440" cy="256032"/>
+          </a:xfrm>
+          <a:prstGeom prst="rect">
+            <a:avLst/>
+          </a:prstGeom>
+          <a:noFill/>
+          <a:ln/>
+        </p:spPr>
+        <p:txBody>
+          <a:bodyPr wrap="square" lIns="0" tIns="0" rIns="0" bIns="0" rtlCol="0" anchor="t"/>
+          <a:lstStyle/>
+          <a:p>
+            <a:pPr indent="0" marL="0">
+              <a:buNone/>
+            </a:pPr>
+            <a:r>
+              <a:rPr lang="en-US" sz="1100" dirty="0">
+                <a:solidFill>
+                  <a:srgbClr val="5A5F73"/>
+                </a:solidFill>
+                <a:latin typeface="Courier New" pitchFamily="34" charset="0"/>
+                <a:ea typeface="Courier New" pitchFamily="34" charset="-122"/>
+                <a:cs typeface="Courier New" pitchFamily="34" charset="-120"/>
+              </a:rPr>
+              <a:t>web_search</a:t>
+            </a:r>
+            <a:endParaRPr lang="en-US" sz="1100" dirty="0"/>
+          </a:p>
+        </p:txBody>
+      </p:sp>
+      <p:sp>
+        <p:nvSpPr>
+          <p:cNvPr id="15" name="Text 13"/>
+          <p:cNvSpPr/>
+          <p:nvPr/>
+        </p:nvSpPr>
+        <p:spPr>
+          <a:xfrm>
+            <a:off x="7086600" y="2194560"/>
+            <a:ext cx="4297680" cy="365760"/>
+          </a:xfrm>
+          <a:prstGeom prst="rect">
+            <a:avLst/>
+          </a:prstGeom>
+          <a:noFill/>
+          <a:ln/>
+        </p:spPr>
+        <p:txBody>
+          <a:bodyPr wrap="square" lIns="0" tIns="0" rIns="0" bIns="0" rtlCol="0" anchor="t"/>
+          <a:lstStyle/>
+          <a:p>
+            <a:pPr indent="0" marL="0">
+              <a:buNone/>
+            </a:pPr>
+            <a:r>
+              <a:rPr lang="en-US" sz="1900" b="1" dirty="0">
+                <a:solidFill>
+                  <a:srgbClr val="202CFC"/>
                 </a:solidFill>
                 <a:latin typeface="Arial" pitchFamily="34" charset="0"/>
                 <a:ea typeface="Arial" pitchFamily="34" charset="-122"/>
                 <a:cs typeface="Arial" pitchFamily="34" charset="-120"/>
               </a:rPr>
-              <a:t>7</a:t>
-            </a:r>
-            <a:endParaRPr lang="en-US" sz="2000" dirty="0"/>
-          </a:p>
-        </p:txBody>
-      </p:sp>
-      <p:sp>
-        <p:nvSpPr>
-          <p:cNvPr id="6" name="Text 4"/>
-          <p:cNvSpPr/>
-          <p:nvPr/>
-        </p:nvSpPr>
-        <p:spPr>
-          <a:xfrm>
-            <a:off x="1417320" y="2788920"/>
-            <a:ext cx="4206240" cy="731520"/>
+              <a:t>Por qué MCP</a:t>
+            </a:r>
+            <a:endParaRPr lang="en-US" sz="1900" dirty="0"/>
+          </a:p>
+        </p:txBody>
+      </p:sp>
+      <p:sp>
+        <p:nvSpPr>
+          <p:cNvPr id="16" name="Text 14"/>
+          <p:cNvSpPr/>
+          <p:nvPr/>
+        </p:nvSpPr>
+        <p:spPr>
+          <a:xfrm>
+            <a:off x="7086600" y="2697480"/>
+            <a:ext cx="4297680" cy="3200400"/>
           </a:xfrm>
           <a:prstGeom prst="rect">
             <a:avLst/>
@@ -7974,134 +8363,212 @@
           <a:bodyPr wrap="square" lIns="0" tIns="0" rIns="0" bIns="0" rtlCol="0" anchor="t"/>
           <a:lstStyle/>
           <a:p>
-            <a:pPr indent="0" marL="0">
+            <a:pPr marL="342900" indent="-342900">
               <a:lnSpc>
-                <a:spcPts val="2100"/>
+                <a:spcPts val="2000"/>
               </a:lnSpc>
-              <a:buNone/>
-            </a:pPr>
-            <a:r>
-              <a:rPr lang="en-US" sz="1500" dirty="0">
-                <a:solidFill>
-                  <a:srgbClr val="1A1C2E"/>
-                </a:solidFill>
-                <a:latin typeface="Calibri" pitchFamily="34" charset="0"/>
-                <a:ea typeface="Calibri" pitchFamily="34" charset="-122"/>
-                <a:cs typeface="Calibri" pitchFamily="34" charset="-120"/>
-              </a:rPr>
-              <a:t>de diagnóstico: leer el VIN, un PID, los DTCs, el freeze frame, las ECUs</a:t>
-            </a:r>
-            <a:endParaRPr lang="en-US" sz="1500" dirty="0"/>
-          </a:p>
-        </p:txBody>
-      </p:sp>
-      <p:sp>
-        <p:nvSpPr>
-          <p:cNvPr id="7" name="Text 5"/>
-          <p:cNvSpPr/>
-          <p:nvPr/>
-        </p:nvSpPr>
-        <p:spPr>
-          <a:xfrm>
-            <a:off x="777240" y="3566160"/>
-            <a:ext cx="548640" cy="365760"/>
-          </a:xfrm>
-          <a:prstGeom prst="rect">
-            <a:avLst/>
-          </a:prstGeom>
-          <a:noFill/>
-          <a:ln/>
-        </p:spPr>
-        <p:txBody>
-          <a:bodyPr wrap="square" lIns="0" tIns="0" rIns="0" bIns="0" rtlCol="0" anchor="t"/>
-          <a:lstStyle/>
-          <a:p>
-            <a:pPr indent="0" marL="0">
-              <a:buNone/>
-            </a:pPr>
-            <a:r>
-              <a:rPr lang="en-US" sz="2000" b="1" dirty="0">
-                <a:solidFill>
-                  <a:srgbClr val="1A1C2E"/>
+              <a:spcAft>
+                <a:spcPts val="1000"/>
+              </a:spcAft>
+              <a:buSzPct val="100000"/>
+              <a:buChar char="•"/>
+            </a:pPr>
+            <a:r>
+              <a:rPr lang="en-US" sz="1400" dirty="0">
+                <a:solidFill>
+                  <a:srgbClr val="1A1C2E"/>
+                </a:solidFill>
+                <a:latin typeface="Calibri" pitchFamily="34" charset="0"/>
+                <a:ea typeface="Calibri" pitchFamily="34" charset="-122"/>
+                <a:cs typeface="Calibri" pitchFamily="34" charset="-120"/>
+              </a:rPr>
+              <a:t>Es el estándar con el que un modelo pide herramientas, y solo sirve para eso</a:t>
+            </a:r>
+            <a:endParaRPr lang="en-US" sz="1400" dirty="0"/>
+          </a:p>
+          <a:p>
+            <a:pPr marL="342900" indent="-342900">
+              <a:lnSpc>
+                <a:spcPts val="2000"/>
+              </a:lnSpc>
+              <a:spcAft>
+                <a:spcPts val="1000"/>
+              </a:spcAft>
+              <a:buSzPct val="100000"/>
+              <a:buChar char="•"/>
+            </a:pPr>
+            <a:r>
+              <a:rPr lang="en-US" sz="1400" dirty="0">
+                <a:solidFill>
+                  <a:srgbClr val="1A1C2E"/>
+                </a:solidFill>
+                <a:latin typeface="Calibri" pitchFamily="34" charset="0"/>
+                <a:ea typeface="Calibri" pitchFamily="34" charset="-122"/>
+                <a:cs typeface="Calibri" pitchFamily="34" charset="-120"/>
+              </a:rPr>
+              <a:t>El modelo solo actúa por ahí: no hay otra puerta al sistema</a:t>
+            </a:r>
+            <a:endParaRPr lang="en-US" sz="1400" dirty="0"/>
+          </a:p>
+          <a:p>
+            <a:pPr marL="342900" indent="-342900">
+              <a:lnSpc>
+                <a:spcPts val="2000"/>
+              </a:lnSpc>
+              <a:spcAft>
+                <a:spcPts val="1000"/>
+              </a:spcAft>
+              <a:buSzPct val="100000"/>
+              <a:buChar char="•"/>
+            </a:pPr>
+            <a:r>
+              <a:rPr lang="en-US" sz="1400" dirty="0">
+                <a:solidFill>
+                  <a:srgbClr val="1A1C2E"/>
+                </a:solidFill>
+                <a:latin typeface="Calibri" pitchFamily="34" charset="0"/>
+                <a:ea typeface="Calibri" pitchFamily="34" charset="-122"/>
+                <a:cs typeface="Calibri" pitchFamily="34" charset="-120"/>
+              </a:rPr>
+              <a:t>Cada herramienta declara su esquema, y los argumentos se validan antes de ejecutarla</a:t>
+            </a:r>
+            <a:endParaRPr lang="en-US" sz="1400" dirty="0"/>
+          </a:p>
+          <a:p>
+            <a:pPr marL="342900" indent="-342900">
+              <a:lnSpc>
+                <a:spcPts val="2000"/>
+              </a:lnSpc>
+              <a:spcAft>
+                <a:spcPts val="1000"/>
+              </a:spcAft>
+              <a:buSzPct val="100000"/>
+              <a:buChar char="•"/>
+            </a:pPr>
+            <a:r>
+              <a:rPr lang="en-US" sz="1400" dirty="0">
+                <a:solidFill>
+                  <a:srgbClr val="1A1C2E"/>
+                </a:solidFill>
+                <a:latin typeface="Calibri" pitchFamily="34" charset="0"/>
+                <a:ea typeface="Calibri" pitchFamily="34" charset="-122"/>
+                <a:cs typeface="Calibri" pitchFamily="34" charset="-120"/>
+              </a:rPr>
+              <a:t>El servidor vive en infraestructura: el modelo nunca ve el dominio</a:t>
+            </a:r>
+            <a:endParaRPr lang="en-US" sz="1400" dirty="0"/>
+          </a:p>
+          <a:p>
+            <a:pPr marL="342900" indent="-342900">
+              <a:lnSpc>
+                <a:spcPts val="2000"/>
+              </a:lnSpc>
+              <a:spcAft>
+                <a:spcPts val="1000"/>
+              </a:spcAft>
+              <a:buSzPct val="100000"/>
+              <a:buChar char="•"/>
+            </a:pPr>
+            <a:r>
+              <a:rPr lang="en-US" sz="1400" dirty="0">
+                <a:solidFill>
+                  <a:srgbClr val="1A1C2E"/>
+                </a:solidFill>
+                <a:latin typeface="Calibri" pitchFamily="34" charset="0"/>
+                <a:ea typeface="Calibri" pitchFamily="34" charset="-122"/>
+                <a:cs typeface="Calibri" pitchFamily="34" charset="-120"/>
+              </a:rPr>
+              <a:t>Cambiar de modelo no toca las herramientas</a:t>
+            </a:r>
+            <a:endParaRPr lang="en-US" sz="1400" dirty="0"/>
+          </a:p>
+        </p:txBody>
+      </p:sp>
+      <p:sp>
+        <p:nvSpPr>
+          <p:cNvPr id="17" name="Shape 15"/>
+          <p:cNvSpPr/>
+          <p:nvPr/>
+        </p:nvSpPr>
+        <p:spPr>
+          <a:xfrm>
+            <a:off x="777240" y="6263640"/>
+            <a:ext cx="219456" cy="219456"/>
+          </a:xfrm>
+          <a:prstGeom prst="rect">
+            <a:avLst/>
+          </a:prstGeom>
+          <a:solidFill>
+            <a:srgbClr val="202CFC"/>
+          </a:solidFill>
+          <a:ln/>
+        </p:spPr>
+      </p:sp>
+      <p:sp>
+        <p:nvSpPr>
+          <p:cNvPr id="18" name="Text 16"/>
+          <p:cNvSpPr/>
+          <p:nvPr/>
+        </p:nvSpPr>
+        <p:spPr>
+          <a:xfrm>
+            <a:off x="777240" y="6263640"/>
+            <a:ext cx="219456" cy="219456"/>
+          </a:xfrm>
+          <a:prstGeom prst="rect">
+            <a:avLst/>
+          </a:prstGeom>
+          <a:noFill/>
+          <a:ln/>
+        </p:spPr>
+        <p:txBody>
+          <a:bodyPr wrap="square" lIns="0" tIns="0" rIns="0" bIns="0" rtlCol="0" anchor="ctr"/>
+          <a:lstStyle/>
+          <a:p>
+            <a:pPr algn="ctr" indent="0" marL="0">
+              <a:buNone/>
+            </a:pPr>
+            <a:r>
+              <a:rPr lang="en-US" sz="816" b="1" dirty="0">
+                <a:solidFill>
+                  <a:srgbClr val="FFFFFF"/>
                 </a:solidFill>
                 <a:latin typeface="Arial" pitchFamily="34" charset="0"/>
                 <a:ea typeface="Arial" pitchFamily="34" charset="-122"/>
                 <a:cs typeface="Arial" pitchFamily="34" charset="-120"/>
               </a:rPr>
-              <a:t>8</a:t>
-            </a:r>
-            <a:endParaRPr lang="en-US" sz="2000" dirty="0"/>
-          </a:p>
-        </p:txBody>
-      </p:sp>
-      <p:sp>
-        <p:nvSpPr>
-          <p:cNvPr id="8" name="Text 6"/>
-          <p:cNvSpPr/>
-          <p:nvPr/>
-        </p:nvSpPr>
-        <p:spPr>
-          <a:xfrm>
-            <a:off x="1417320" y="3566160"/>
-            <a:ext cx="4206240" cy="731520"/>
-          </a:xfrm>
-          <a:prstGeom prst="rect">
-            <a:avLst/>
-          </a:prstGeom>
-          <a:noFill/>
-          <a:ln/>
-        </p:spPr>
-        <p:txBody>
-          <a:bodyPr wrap="square" lIns="0" tIns="0" rIns="0" bIns="0" rtlCol="0" anchor="t"/>
-          <a:lstStyle/>
-          <a:p>
-            <a:pPr indent="0" marL="0">
-              <a:lnSpc>
-                <a:spcPts val="2100"/>
-              </a:lnSpc>
-              <a:buNone/>
-            </a:pPr>
-            <a:r>
-              <a:rPr lang="en-US" sz="1500" dirty="0">
-                <a:solidFill>
-                  <a:srgbClr val="1A1C2E"/>
-                </a:solidFill>
-                <a:latin typeface="Calibri" pitchFamily="34" charset="0"/>
-                <a:ea typeface="Calibri" pitchFamily="34" charset="-122"/>
-                <a:cs typeface="Calibri" pitchFamily="34" charset="-120"/>
-              </a:rPr>
-              <a:t>de conocimiento: buscar parecidos e indexar lo aprendido</a:t>
-            </a:r>
-            <a:endParaRPr lang="en-US" sz="1500" dirty="0"/>
-          </a:p>
-        </p:txBody>
-      </p:sp>
-      <p:sp>
-        <p:nvSpPr>
-          <p:cNvPr id="9" name="Text 7"/>
-          <p:cNvSpPr/>
-          <p:nvPr/>
-        </p:nvSpPr>
-        <p:spPr>
-          <a:xfrm>
-            <a:off x="777240" y="4343400"/>
-            <a:ext cx="548640" cy="365760"/>
-          </a:xfrm>
-          <a:prstGeom prst="rect">
-            <a:avLst/>
-          </a:prstGeom>
-          <a:noFill/>
-          <a:ln/>
-        </p:spPr>
-        <p:txBody>
-          <a:bodyPr wrap="square" lIns="0" tIns="0" rIns="0" bIns="0" rtlCol="0" anchor="t"/>
-          <a:lstStyle/>
-          <a:p>
-            <a:pPr indent="0" marL="0">
-              <a:buNone/>
-            </a:pPr>
-            <a:r>
-              <a:rPr lang="en-US" sz="2000" b="1" dirty="0">
+              <a:t>BIG</a:t>
+            </a:r>
+            <a:endParaRPr lang="en-US" sz="816" dirty="0"/>
+          </a:p>
+        </p:txBody>
+      </p:sp>
+      <p:sp>
+        <p:nvSpPr>
+          <p:cNvPr id="19" name="Text 17"/>
+          <p:cNvSpPr/>
+          <p:nvPr/>
+        </p:nvSpPr>
+        <p:spPr>
+          <a:xfrm>
+            <a:off x="1078992" y="6263640"/>
+            <a:ext cx="658368" cy="219456"/>
+          </a:xfrm>
+          <a:prstGeom prst="rect">
+            <a:avLst/>
+          </a:prstGeom>
+          <a:noFill/>
+          <a:ln/>
+        </p:spPr>
+        <p:txBody>
+          <a:bodyPr wrap="square" lIns="0" tIns="0" rIns="0" bIns="0" rtlCol="0" anchor="ctr"/>
+          <a:lstStyle/>
+          <a:p>
+            <a:pPr algn="l" indent="0" marL="0">
+              <a:buNone/>
+            </a:pPr>
+            <a:r>
+              <a:rPr lang="en-US" sz="816" dirty="0">
                 <a:solidFill>
                   <a:srgbClr val="1A1C2E"/>
                 </a:solidFill>
@@ -8109,289 +8576,7 @@
                 <a:ea typeface="Arial" pitchFamily="34" charset="-122"/>
                 <a:cs typeface="Arial" pitchFamily="34" charset="-120"/>
               </a:rPr>
-              <a:t>1</a:t>
-            </a:r>
-            <a:endParaRPr lang="en-US" sz="2000" dirty="0"/>
-          </a:p>
-        </p:txBody>
-      </p:sp>
-      <p:sp>
-        <p:nvSpPr>
-          <p:cNvPr id="10" name="Text 8"/>
-          <p:cNvSpPr/>
-          <p:nvPr/>
-        </p:nvSpPr>
-        <p:spPr>
-          <a:xfrm>
-            <a:off x="1417320" y="4343400"/>
-            <a:ext cx="4206240" cy="731520"/>
-          </a:xfrm>
-          <a:prstGeom prst="rect">
-            <a:avLst/>
-          </a:prstGeom>
-          <a:noFill/>
-          <a:ln/>
-        </p:spPr>
-        <p:txBody>
-          <a:bodyPr wrap="square" lIns="0" tIns="0" rIns="0" bIns="0" rtlCol="0" anchor="t"/>
-          <a:lstStyle/>
-          <a:p>
-            <a:pPr indent="0" marL="0">
-              <a:lnSpc>
-                <a:spcPts val="2100"/>
-              </a:lnSpc>
-              <a:buNone/>
-            </a:pPr>
-            <a:r>
-              <a:rPr lang="en-US" sz="1500" dirty="0">
-                <a:solidFill>
-                  <a:srgbClr val="1A1C2E"/>
-                </a:solidFill>
-                <a:latin typeface="Calibri" pitchFamily="34" charset="0"/>
-                <a:ea typeface="Calibri" pitchFamily="34" charset="-122"/>
-                <a:cs typeface="Calibri" pitchFamily="34" charset="-120"/>
-              </a:rPr>
-              <a:t>de búsqueda web, con presupuesto limitado por diagnóstico</a:t>
-            </a:r>
-            <a:endParaRPr lang="en-US" sz="1500" dirty="0"/>
-          </a:p>
-        </p:txBody>
-      </p:sp>
-      <p:sp>
-        <p:nvSpPr>
-          <p:cNvPr id="11" name="Text 9"/>
-          <p:cNvSpPr/>
-          <p:nvPr/>
-        </p:nvSpPr>
-        <p:spPr>
-          <a:xfrm>
-            <a:off x="6537960" y="2240280"/>
-            <a:ext cx="4846320" cy="365760"/>
-          </a:xfrm>
-          <a:prstGeom prst="rect">
-            <a:avLst/>
-          </a:prstGeom>
-          <a:noFill/>
-          <a:ln/>
-        </p:spPr>
-        <p:txBody>
-          <a:bodyPr wrap="square" lIns="0" tIns="0" rIns="0" bIns="0" rtlCol="0" anchor="t"/>
-          <a:lstStyle/>
-          <a:p>
-            <a:pPr indent="0" marL="0">
-              <a:buNone/>
-            </a:pPr>
-            <a:r>
-              <a:rPr lang="en-US" sz="2000" b="1" dirty="0">
-                <a:solidFill>
-                  <a:srgbClr val="202CFC"/>
-                </a:solidFill>
-                <a:latin typeface="Arial" pitchFamily="34" charset="0"/>
-                <a:ea typeface="Arial" pitchFamily="34" charset="-122"/>
-                <a:cs typeface="Arial" pitchFamily="34" charset="-120"/>
-              </a:rPr>
-              <a:t>Por qué MCP y no llamadas a medida</a:t>
-            </a:r>
-            <a:endParaRPr lang="en-US" sz="2000" dirty="0"/>
-          </a:p>
-        </p:txBody>
-      </p:sp>
-      <p:sp>
-        <p:nvSpPr>
-          <p:cNvPr id="12" name="Text 10"/>
-          <p:cNvSpPr/>
-          <p:nvPr/>
-        </p:nvSpPr>
-        <p:spPr>
-          <a:xfrm>
-            <a:off x="6537960" y="2788920"/>
-            <a:ext cx="4846320" cy="2834640"/>
-          </a:xfrm>
-          <a:prstGeom prst="rect">
-            <a:avLst/>
-          </a:prstGeom>
-          <a:noFill/>
-          <a:ln/>
-        </p:spPr>
-        <p:txBody>
-          <a:bodyPr wrap="square" lIns="0" tIns="0" rIns="0" bIns="0" rtlCol="0" anchor="t"/>
-          <a:lstStyle/>
-          <a:p>
-            <a:pPr marL="342900" indent="-342900">
-              <a:lnSpc>
-                <a:spcPts val="2100"/>
-              </a:lnSpc>
-              <a:spcAft>
-                <a:spcPts val="1100"/>
-              </a:spcAft>
-              <a:buSzPct val="100000"/>
-              <a:buChar char="•"/>
-            </a:pPr>
-            <a:r>
-              <a:rPr lang="en-US" sz="1500" dirty="0">
-                <a:solidFill>
-                  <a:srgbClr val="1A1C2E"/>
-                </a:solidFill>
-                <a:latin typeface="Calibri" pitchFamily="34" charset="0"/>
-                <a:ea typeface="Calibri" pitchFamily="34" charset="-122"/>
-                <a:cs typeface="Calibri" pitchFamily="34" charset="-120"/>
-              </a:rPr>
-              <a:t>Es el estándar con el que un modelo pide herramientas, y solo sirve para eso</a:t>
-            </a:r>
-            <a:endParaRPr lang="en-US" sz="1500" dirty="0"/>
-          </a:p>
-          <a:p>
-            <a:pPr marL="342900" indent="-342900">
-              <a:lnSpc>
-                <a:spcPts val="2100"/>
-              </a:lnSpc>
-              <a:spcAft>
-                <a:spcPts val="1100"/>
-              </a:spcAft>
-              <a:buSzPct val="100000"/>
-              <a:buChar char="•"/>
-            </a:pPr>
-            <a:r>
-              <a:rPr lang="en-US" sz="1500" dirty="0">
-                <a:solidFill>
-                  <a:srgbClr val="1A1C2E"/>
-                </a:solidFill>
-                <a:latin typeface="Calibri" pitchFamily="34" charset="0"/>
-                <a:ea typeface="Calibri" pitchFamily="34" charset="-122"/>
-                <a:cs typeface="Calibri" pitchFamily="34" charset="-120"/>
-              </a:rPr>
-              <a:t>El modelo solo actúa por ahí: no hay otra puerta al sistema</a:t>
-            </a:r>
-            <a:endParaRPr lang="en-US" sz="1500" dirty="0"/>
-          </a:p>
-          <a:p>
-            <a:pPr marL="342900" indent="-342900">
-              <a:lnSpc>
-                <a:spcPts val="2100"/>
-              </a:lnSpc>
-              <a:spcAft>
-                <a:spcPts val="1100"/>
-              </a:spcAft>
-              <a:buSzPct val="100000"/>
-              <a:buChar char="•"/>
-            </a:pPr>
-            <a:r>
-              <a:rPr lang="en-US" sz="1500" dirty="0">
-                <a:solidFill>
-                  <a:srgbClr val="1A1C2E"/>
-                </a:solidFill>
-                <a:latin typeface="Calibri" pitchFamily="34" charset="0"/>
-                <a:ea typeface="Calibri" pitchFamily="34" charset="-122"/>
-                <a:cs typeface="Calibri" pitchFamily="34" charset="-120"/>
-              </a:rPr>
-              <a:t>Cada herramienta declara su esquema, y los argumentos se validan antes de ejecutarla</a:t>
-            </a:r>
-            <a:endParaRPr lang="en-US" sz="1500" dirty="0"/>
-          </a:p>
-          <a:p>
-            <a:pPr marL="342900" indent="-342900">
-              <a:lnSpc>
-                <a:spcPts val="2100"/>
-              </a:lnSpc>
-              <a:spcAft>
-                <a:spcPts val="1100"/>
-              </a:spcAft>
-              <a:buSzPct val="100000"/>
-              <a:buChar char="•"/>
-            </a:pPr>
-            <a:r>
-              <a:rPr lang="en-US" sz="1500" dirty="0">
-                <a:solidFill>
-                  <a:srgbClr val="1A1C2E"/>
-                </a:solidFill>
-                <a:latin typeface="Calibri" pitchFamily="34" charset="0"/>
-                <a:ea typeface="Calibri" pitchFamily="34" charset="-122"/>
-                <a:cs typeface="Calibri" pitchFamily="34" charset="-120"/>
-              </a:rPr>
-              <a:t>El servidor vive en infraestructura: el modelo nunca ve el dominio</a:t>
-            </a:r>
-            <a:endParaRPr lang="en-US" sz="1500" dirty="0"/>
-          </a:p>
-          <a:p>
-            <a:pPr marL="342900" indent="-342900">
-              <a:lnSpc>
-                <a:spcPts val="2100"/>
-              </a:lnSpc>
-              <a:spcAft>
-                <a:spcPts val="1100"/>
-              </a:spcAft>
-              <a:buSzPct val="100000"/>
-              <a:buChar char="•"/>
-            </a:pPr>
-            <a:r>
-              <a:rPr lang="en-US" sz="1500" dirty="0">
-                <a:solidFill>
-                  <a:srgbClr val="1A1C2E"/>
-                </a:solidFill>
-                <a:latin typeface="Calibri" pitchFamily="34" charset="0"/>
-                <a:ea typeface="Calibri" pitchFamily="34" charset="-122"/>
-                <a:cs typeface="Calibri" pitchFamily="34" charset="-120"/>
-              </a:rPr>
-              <a:t>Cambiar de modelo no toca las herramientas</a:t>
-            </a:r>
-            <a:endParaRPr lang="en-US" sz="1500" dirty="0"/>
-          </a:p>
-        </p:txBody>
-      </p:sp>
-      <p:sp>
-        <p:nvSpPr>
-          <p:cNvPr id="13" name="Shape 11"/>
-          <p:cNvSpPr/>
-          <p:nvPr/>
-        </p:nvSpPr>
-        <p:spPr>
-          <a:xfrm>
-            <a:off x="777240" y="6263640"/>
-            <a:ext cx="219456" cy="219456"/>
-          </a:xfrm>
-          <a:prstGeom prst="rect">
-            <a:avLst/>
-          </a:prstGeom>
-          <a:solidFill>
-            <a:srgbClr val="202CFC"/>
-          </a:solidFill>
-          <a:ln/>
-        </p:spPr>
-      </p:sp>
-      <p:sp>
-        <p:nvSpPr>
-          <p:cNvPr id="14" name="Text 12"/>
-          <p:cNvSpPr/>
-          <p:nvPr/>
-        </p:nvSpPr>
-        <p:spPr>
-          <a:xfrm>
-            <a:off x="777240" y="6263640"/>
-            <a:ext cx="219456" cy="219456"/>
-          </a:xfrm>
-          <a:prstGeom prst="rect">
-            <a:avLst/>
-          </a:prstGeom>
-          <a:noFill/>
-          <a:ln/>
-        </p:spPr>
-        <p:txBody>
-          <a:bodyPr wrap="square" lIns="0" tIns="0" rIns="0" bIns="0" rtlCol="0" anchor="ctr"/>
-          <a:lstStyle/>
-          <a:p>
-            <a:pPr algn="ctr" indent="0" marL="0">
-              <a:buNone/>
-            </a:pPr>
-            <a:r>
-              <a:rPr lang="en-US" sz="816" b="1" dirty="0">
-                <a:solidFill>
-                  <a:srgbClr val="FFFFFF"/>
-                </a:solidFill>
-                <a:latin typeface="Arial" pitchFamily="34" charset="0"/>
-                <a:ea typeface="Arial" pitchFamily="34" charset="-122"/>
-                <a:cs typeface="Arial" pitchFamily="34" charset="-120"/>
-              </a:rPr>
-              <a:t>BIG</a:t>
+              <a:t>school</a:t>
             </a:r>
             <a:endParaRPr lang="en-US" sz="816" dirty="0"/>
           </a:p>
@@ -8399,46 +8584,7 @@
       </p:sp>
       <p:sp>
         <p:nvSpPr>
-          <p:cNvPr id="15" name="Text 13"/>
-          <p:cNvSpPr/>
-          <p:nvPr/>
-        </p:nvSpPr>
-        <p:spPr>
-          <a:xfrm>
-            <a:off x="1078992" y="6263640"/>
-            <a:ext cx="658368" cy="219456"/>
-          </a:xfrm>
-          <a:prstGeom prst="rect">
-            <a:avLst/>
-          </a:prstGeom>
-          <a:noFill/>
-          <a:ln/>
-        </p:spPr>
-        <p:txBody>
-          <a:bodyPr wrap="square" lIns="0" tIns="0" rIns="0" bIns="0" rtlCol="0" anchor="ctr"/>
-          <a:lstStyle/>
-          <a:p>
-            <a:pPr algn="l" indent="0" marL="0">
-              <a:buNone/>
-            </a:pPr>
-            <a:r>
-              <a:rPr lang="en-US" sz="816" dirty="0">
-                <a:solidFill>
-                  <a:srgbClr val="1A1C2E"/>
-                </a:solidFill>
-                <a:latin typeface="Arial" pitchFamily="34" charset="0"/>
-                <a:ea typeface="Arial" pitchFamily="34" charset="-122"/>
-                <a:cs typeface="Arial" pitchFamily="34" charset="-120"/>
-              </a:rPr>
-              <a:t>school</a:t>
-            </a:r>
-            <a:endParaRPr lang="en-US" sz="816" dirty="0"/>
-          </a:p>
-        </p:txBody>
-      </p:sp>
-      <p:sp>
-        <p:nvSpPr>
-          <p:cNvPr id="16" name="Text 14"/>
+          <p:cNvPr id="20" name="Text 18"/>
           <p:cNvSpPr/>
           <p:nvPr/>
         </p:nvSpPr>

</xml_diff>

<commit_message>
docs(tfm): el ciclo del agente y los bloques del prompt
</commit_message>
<xml_diff>
--- a/docs/presentacion/tfm-intelligent-automotive-diagnostics.pptx
+++ b/docs/presentacion/tfm-intelligent-automotive-diagnostics.pptx
@@ -15,9 +15,10 @@
     <p:sldId id="263" r:id="rId9"/>
     <p:sldId id="264" r:id="rId10"/>
     <p:sldId id="265" r:id="rId11"/>
+    <p:sldId id="266" r:id="rId12"/>
   </p:sldIdLst>
   <p:notesMasterIdLst>
-    <p:notesMasterId r:id="rId12"/>
+    <p:notesMasterId r:id="rId13"/>
   </p:notesMasterIdLst>
   <p:sldSz cx="12192000" cy="6858000"/>
   <p:notesSz cx="6858000" cy="12192000"/>
@@ -602,11 +603,14 @@
           <a:p>
             <a:r>
               <a:rPr lang="en-US" dirty="0"/>
-              <a:t>El sistema hace dos diagnósticos distintos, y conviven.
-El determinista es el de toda la vida. Lee cuatro PIDs fijos —revoluciones, temperatura de refrigerante, velocidad y temperatura de admisión—, los códigos de avería y el freeze frame. Y la criticidad no me la invento: sale de una regla en el dominio, computeSeverity. Si no hay códigos es baja; si hay freeze frame es crítica, porque significa que la centralita congeló el momento del fallo; y si hay códigos sin freeze frame es alta. Solo necesita el coche conectado, responde al momento, y no aprende nada.
-El cognitivo es el otro. Ahí no hay una lista fija de PIDs: el agente decide qué le hace falta leer y va llamando a las herramientas según lo que encuentra. A cambio necesita tres cosas: el coche, la API del modelo y los índices vectoriales. Tarda más, con un límite de sesenta segundos. Y es el único que aprende: indexa los PIDs y DTCs nuevos y guarda el caso resuelto.
-Por eso conviven. Si no hay modelo configurado, o si no hay internet en el taller, el determinista sigue funcionando.
-[~65 s]</a:t>
+              <a:t>Este es el recorrido completo, desde que el mecánico le da al botón.
+Lo primero que pasa no lo hace la IA: el flujo determinista lee los PIDs generales del modo 01, los códigos de avería y el freeze frame. Eso está ahí sí o sí.
+Cuando el mecánico entra al chat, antes de llamar al modelo el sistema hace una búsqueda en la base vectorial de casos parecidos a este, y los mete en el prompt. Van etiquetados como "muy similar", "similar" o "relacionado", nunca con el número de distancia, porque cuando le pasaba el número el modelo lo repetía en la respuesta y eso es ruido para el mecánico. Y van envueltos en una marca de contenido no fiable, porque ese catálogo lo alimentan otros usuarios.
+A partir de ahí empieza el ciclo. El modelo pide herramientas, el sistema las ejecuta y le devuelve el resultado, y el modelo decide qué pedir después. Ese bucle tiene dos topes: diez vueltas como máximo y sesenta segundos.
+Cuando termina, devuelve dos cosas: la explicación en lenguaje normal para el mecánico, y un bloque JSON con la severidad, la confianza y las recomendaciones, que es lo que la aplicación pinta en pantalla. Si no hay explicación, se lanza un error a propósito y no se guarda nada: un caso vacío en el catálogo volvería luego como "caso similar" y contaminaría los diagnósticos siguientes.
+Y por último el caso se indexa con confianza 0,5, que es la de diagnóstico anterior.
+El system prompt tiene once bloques. No es solo decirle "eres un mecánico": hay bloques de exploración, de consultar el catálogo antes de inventar, de aprendizaje para PIDs, DTCs y ECUs, de ámbito, de no revelar sus propias tripas, de contenido no fiable y del formato de salida.
+[~80 s]</a:t>
             </a:r>
             <a:endParaRPr lang="en-US" dirty="0"/>
           </a:p>
@@ -630,6 +634,98 @@
             <a:fld id="{F7021451-1387-4CA6-816F-3879F97B5CBC}" type="slidenum">
               <a:rPr lang="en-US"/>
               <a:t>10</a:t>
+            </a:fld>
+            <a:endParaRPr lang="en-US"/>
+          </a:p>
+        </p:txBody>
+      </p:sp>
+    </p:spTree>
+    <p:extLst>
+      <p:ext uri="{BB962C8B-B14F-4D97-AF65-F5344CB8AC3E}">
+        <p14:creationId xmlns:p14="http://schemas.microsoft.com/office/powerpoint/2010/main" val="1024086991"/>
+      </p:ext>
+    </p:extLst>
+  </p:cSld>
+  <p:clrMapOvr>
+    <a:masterClrMapping/>
+  </p:clrMapOvr>
+</p:notes>
+</file>
+
+<file path=ppt/notesSlides/notesSlide11.xml><?xml version="1.0" encoding="utf-8"?>
+<p:notes xmlns:a="http://schemas.openxmlformats.org/drawingml/2006/main" xmlns:r="http://schemas.openxmlformats.org/officeDocument/2006/relationships" xmlns:p="http://schemas.openxmlformats.org/presentationml/2006/main">
+  <p:cSld>
+    <p:spTree>
+      <p:nvGrpSpPr>
+        <p:cNvPr id="1" name=""/>
+        <p:cNvGrpSpPr/>
+        <p:nvPr/>
+      </p:nvGrpSpPr>
+      <p:grpSpPr>
+        <a:xfrm>
+          <a:off x="0" y="0"/>
+          <a:ext cx="0" cy="0"/>
+          <a:chOff x="0" y="0"/>
+          <a:chExt cx="0" cy="0"/>
+        </a:xfrm>
+      </p:grpSpPr>
+      <p:sp>
+        <p:nvSpPr>
+          <p:cNvPr id="2" name="Slide Image Placeholder 1"/>
+          <p:cNvSpPr>
+            <a:spLocks noGrp="1" noRot="1" noChangeAspect="1"/>
+          </p:cNvSpPr>
+          <p:nvPr>
+            <p:ph type="sldImg"/>
+          </p:nvPr>
+        </p:nvSpPr>
+        <p:spPr/>
+      </p:sp>
+      <p:sp>
+        <p:nvSpPr>
+          <p:cNvPr id="3" name="Notes Placeholder 2"/>
+          <p:cNvSpPr>
+            <a:spLocks noGrp="1"/>
+          </p:cNvSpPr>
+          <p:nvPr>
+            <p:ph type="body" idx="1"/>
+          </p:nvPr>
+        </p:nvSpPr>
+        <p:spPr/>
+        <p:txBody>
+          <a:bodyPr/>
+          <a:lstStyle/>
+          <a:p>
+            <a:r>
+              <a:rPr lang="en-US" dirty="0"/>
+              <a:t>El sistema hace dos diagnósticos distintos, y conviven.
+El determinista es el de toda la vida. Lee cuatro PIDs fijos —revoluciones, temperatura de refrigerante, velocidad y temperatura de admisión—, los códigos de avería y el freeze frame. Y la criticidad no me la invento: sale de una regla en el dominio, computeSeverity. Si no hay códigos es baja; si hay freeze frame es crítica, porque significa que la centralita congeló el momento del fallo; y si hay códigos sin freeze frame es alta. Solo necesita el coche conectado, responde al momento, y no aprende nada.
+El cognitivo es el otro. Ahí no hay una lista fija de PIDs: el agente decide qué le hace falta leer y va llamando a las herramientas según lo que encuentra. A cambio necesita tres cosas: el coche, la API del modelo y los índices vectoriales. Tarda más, con un límite de sesenta segundos. Y es el único que aprende: indexa los PIDs y DTCs nuevos y guarda el caso resuelto.
+Por eso conviven. Si no hay modelo configurado, o si no hay internet en el taller, el determinista sigue funcionando.
+[~65 s]</a:t>
+            </a:r>
+            <a:endParaRPr lang="en-US" dirty="0"/>
+          </a:p>
+        </p:txBody>
+      </p:sp>
+      <p:sp>
+        <p:nvSpPr>
+          <p:cNvPr id="4" name="Slide Number Placeholder 3"/>
+          <p:cNvSpPr>
+            <a:spLocks noGrp="1"/>
+          </p:cNvSpPr>
+          <p:nvPr>
+            <p:ph type="sldNum" sz="quarter" idx="10"/>
+          </p:nvPr>
+        </p:nvSpPr>
+        <p:spPr/>
+        <p:txBody>
+          <a:bodyPr/>
+          <a:lstStyle/>
+          <a:p>
+            <a:fld id="{F7021451-1387-4CA6-816F-3879F97B5CBC}" type="slidenum">
+              <a:rPr lang="en-US"/>
+              <a:t>11</a:t>
             </a:fld>
             <a:endParaRPr lang="en-US"/>
           </a:p>
@@ -2150,6 +2246,983 @@
                 <a:ea typeface="Arial" pitchFamily="34" charset="-122"/>
                 <a:cs typeface="Arial" pitchFamily="34" charset="-120"/>
               </a:rPr>
+              <a:t>Cómo razona el agente</a:t>
+            </a:r>
+            <a:endParaRPr lang="en-US" sz="3400" dirty="0"/>
+          </a:p>
+        </p:txBody>
+      </p:sp>
+      <p:sp>
+        <p:nvSpPr>
+          <p:cNvPr id="3" name="Text 1"/>
+          <p:cNvSpPr/>
+          <p:nvPr/>
+        </p:nvSpPr>
+        <p:spPr>
+          <a:xfrm>
+            <a:off x="777240" y="1508760"/>
+            <a:ext cx="10607040" cy="365760"/>
+          </a:xfrm>
+          <a:prstGeom prst="rect">
+            <a:avLst/>
+          </a:prstGeom>
+          <a:noFill/>
+          <a:ln/>
+        </p:spPr>
+        <p:txBody>
+          <a:bodyPr wrap="square" lIns="0" tIns="0" rIns="0" bIns="0" rtlCol="0" anchor="t"/>
+          <a:lstStyle/>
+          <a:p>
+            <a:pPr indent="0" marL="0">
+              <a:buNone/>
+            </a:pPr>
+            <a:r>
+              <a:rPr lang="en-US" sz="1700" dirty="0">
+                <a:solidFill>
+                  <a:srgbClr val="5A5F73"/>
+                </a:solidFill>
+                <a:latin typeface="Calibri" pitchFamily="34" charset="0"/>
+                <a:ea typeface="Calibri" pitchFamily="34" charset="-122"/>
+                <a:cs typeface="Calibri" pitchFamily="34" charset="-120"/>
+              </a:rPr>
+              <a:t>Del botón de iniciar diagnóstico a la respuesta que lee el mecánico.</a:t>
+            </a:r>
+            <a:endParaRPr lang="en-US" sz="1700" dirty="0"/>
+          </a:p>
+        </p:txBody>
+      </p:sp>
+      <p:sp>
+        <p:nvSpPr>
+          <p:cNvPr id="4" name="Text 2"/>
+          <p:cNvSpPr/>
+          <p:nvPr/>
+        </p:nvSpPr>
+        <p:spPr>
+          <a:xfrm>
+            <a:off x="777240" y="2194560"/>
+            <a:ext cx="5943600" cy="365760"/>
+          </a:xfrm>
+          <a:prstGeom prst="rect">
+            <a:avLst/>
+          </a:prstGeom>
+          <a:noFill/>
+          <a:ln/>
+        </p:spPr>
+        <p:txBody>
+          <a:bodyPr wrap="square" lIns="0" tIns="0" rIns="0" bIns="0" rtlCol="0" anchor="t"/>
+          <a:lstStyle/>
+          <a:p>
+            <a:pPr indent="0" marL="0">
+              <a:buNone/>
+            </a:pPr>
+            <a:r>
+              <a:rPr lang="en-US" sz="1900" b="1" dirty="0">
+                <a:solidFill>
+                  <a:srgbClr val="202CFC"/>
+                </a:solidFill>
+                <a:latin typeface="Arial" pitchFamily="34" charset="0"/>
+                <a:ea typeface="Arial" pitchFamily="34" charset="-122"/>
+                <a:cs typeface="Arial" pitchFamily="34" charset="-120"/>
+              </a:rPr>
+              <a:t>El ciclo</a:t>
+            </a:r>
+            <a:endParaRPr lang="en-US" sz="1900" dirty="0"/>
+          </a:p>
+        </p:txBody>
+      </p:sp>
+      <p:sp>
+        <p:nvSpPr>
+          <p:cNvPr id="5" name="Text 3"/>
+          <p:cNvSpPr/>
+          <p:nvPr/>
+        </p:nvSpPr>
+        <p:spPr>
+          <a:xfrm>
+            <a:off x="777240" y="2651760"/>
+            <a:ext cx="365760" cy="502920"/>
+          </a:xfrm>
+          <a:prstGeom prst="rect">
+            <a:avLst/>
+          </a:prstGeom>
+          <a:noFill/>
+          <a:ln/>
+        </p:spPr>
+        <p:txBody>
+          <a:bodyPr wrap="square" lIns="0" tIns="0" rIns="0" bIns="0" rtlCol="0" anchor="t"/>
+          <a:lstStyle/>
+          <a:p>
+            <a:pPr indent="0" marL="0">
+              <a:buNone/>
+            </a:pPr>
+            <a:r>
+              <a:rPr lang="en-US" sz="1500" b="1" dirty="0">
+                <a:solidFill>
+                  <a:srgbClr val="202CFC"/>
+                </a:solidFill>
+                <a:latin typeface="Arial" pitchFamily="34" charset="0"/>
+                <a:ea typeface="Arial" pitchFamily="34" charset="-122"/>
+                <a:cs typeface="Arial" pitchFamily="34" charset="-120"/>
+              </a:rPr>
+              <a:t>1</a:t>
+            </a:r>
+            <a:endParaRPr lang="en-US" sz="1500" dirty="0"/>
+          </a:p>
+        </p:txBody>
+      </p:sp>
+      <p:sp>
+        <p:nvSpPr>
+          <p:cNvPr id="6" name="Text 4"/>
+          <p:cNvSpPr/>
+          <p:nvPr/>
+        </p:nvSpPr>
+        <p:spPr>
+          <a:xfrm>
+            <a:off x="1188720" y="2651760"/>
+            <a:ext cx="5532120" cy="548640"/>
+          </a:xfrm>
+          <a:prstGeom prst="rect">
+            <a:avLst/>
+          </a:prstGeom>
+          <a:noFill/>
+          <a:ln/>
+        </p:spPr>
+        <p:txBody>
+          <a:bodyPr wrap="square" lIns="0" tIns="0" rIns="0" bIns="0" rtlCol="0" anchor="t"/>
+          <a:lstStyle/>
+          <a:p>
+            <a:pPr indent="0" marL="0">
+              <a:lnSpc>
+                <a:spcPts val="1900"/>
+              </a:lnSpc>
+              <a:buNone/>
+            </a:pPr>
+            <a:r>
+              <a:rPr lang="en-US" sz="1400" dirty="0">
+                <a:solidFill>
+                  <a:srgbClr val="1A1C2E"/>
+                </a:solidFill>
+                <a:latin typeface="Calibri" pitchFamily="34" charset="0"/>
+                <a:ea typeface="Calibri" pitchFamily="34" charset="-122"/>
+                <a:cs typeface="Calibri" pitchFamily="34" charset="-120"/>
+              </a:rPr>
+              <a:t>Al iniciar el diagnóstico se leen los PIDs generales, los DTCs y el freeze frame</a:t>
+            </a:r>
+            <a:endParaRPr lang="en-US" sz="1400" dirty="0"/>
+          </a:p>
+        </p:txBody>
+      </p:sp>
+      <p:sp>
+        <p:nvSpPr>
+          <p:cNvPr id="7" name="Text 5"/>
+          <p:cNvSpPr/>
+          <p:nvPr/>
+        </p:nvSpPr>
+        <p:spPr>
+          <a:xfrm>
+            <a:off x="777240" y="3218688"/>
+            <a:ext cx="365760" cy="502920"/>
+          </a:xfrm>
+          <a:prstGeom prst="rect">
+            <a:avLst/>
+          </a:prstGeom>
+          <a:noFill/>
+          <a:ln/>
+        </p:spPr>
+        <p:txBody>
+          <a:bodyPr wrap="square" lIns="0" tIns="0" rIns="0" bIns="0" rtlCol="0" anchor="t"/>
+          <a:lstStyle/>
+          <a:p>
+            <a:pPr indent="0" marL="0">
+              <a:buNone/>
+            </a:pPr>
+            <a:r>
+              <a:rPr lang="en-US" sz="1500" b="1" dirty="0">
+                <a:solidFill>
+                  <a:srgbClr val="202CFC"/>
+                </a:solidFill>
+                <a:latin typeface="Arial" pitchFamily="34" charset="0"/>
+                <a:ea typeface="Arial" pitchFamily="34" charset="-122"/>
+                <a:cs typeface="Arial" pitchFamily="34" charset="-120"/>
+              </a:rPr>
+              <a:t>2</a:t>
+            </a:r>
+            <a:endParaRPr lang="en-US" sz="1500" dirty="0"/>
+          </a:p>
+        </p:txBody>
+      </p:sp>
+      <p:sp>
+        <p:nvSpPr>
+          <p:cNvPr id="8" name="Text 6"/>
+          <p:cNvSpPr/>
+          <p:nvPr/>
+        </p:nvSpPr>
+        <p:spPr>
+          <a:xfrm>
+            <a:off x="1188720" y="3218688"/>
+            <a:ext cx="5532120" cy="548640"/>
+          </a:xfrm>
+          <a:prstGeom prst="rect">
+            <a:avLst/>
+          </a:prstGeom>
+          <a:noFill/>
+          <a:ln/>
+        </p:spPr>
+        <p:txBody>
+          <a:bodyPr wrap="square" lIns="0" tIns="0" rIns="0" bIns="0" rtlCol="0" anchor="t"/>
+          <a:lstStyle/>
+          <a:p>
+            <a:pPr indent="0" marL="0">
+              <a:lnSpc>
+                <a:spcPts val="1900"/>
+              </a:lnSpc>
+              <a:buNone/>
+            </a:pPr>
+            <a:r>
+              <a:rPr lang="en-US" sz="1400" dirty="0">
+                <a:solidFill>
+                  <a:srgbClr val="1A1C2E"/>
+                </a:solidFill>
+                <a:latin typeface="Calibri" pitchFamily="34" charset="0"/>
+                <a:ea typeface="Calibri" pitchFamily="34" charset="-122"/>
+                <a:cs typeface="Calibri" pitchFamily="34" charset="-120"/>
+              </a:rPr>
+              <a:t>Antes de llamar al modelo se buscan casos parecidos en la vectorial, y entran en el prompt</a:t>
+            </a:r>
+            <a:endParaRPr lang="en-US" sz="1400" dirty="0"/>
+          </a:p>
+        </p:txBody>
+      </p:sp>
+      <p:sp>
+        <p:nvSpPr>
+          <p:cNvPr id="9" name="Text 7"/>
+          <p:cNvSpPr/>
+          <p:nvPr/>
+        </p:nvSpPr>
+        <p:spPr>
+          <a:xfrm>
+            <a:off x="777240" y="3785616"/>
+            <a:ext cx="365760" cy="502920"/>
+          </a:xfrm>
+          <a:prstGeom prst="rect">
+            <a:avLst/>
+          </a:prstGeom>
+          <a:noFill/>
+          <a:ln/>
+        </p:spPr>
+        <p:txBody>
+          <a:bodyPr wrap="square" lIns="0" tIns="0" rIns="0" bIns="0" rtlCol="0" anchor="t"/>
+          <a:lstStyle/>
+          <a:p>
+            <a:pPr indent="0" marL="0">
+              <a:buNone/>
+            </a:pPr>
+            <a:r>
+              <a:rPr lang="en-US" sz="1500" b="1" dirty="0">
+                <a:solidFill>
+                  <a:srgbClr val="202CFC"/>
+                </a:solidFill>
+                <a:latin typeface="Arial" pitchFamily="34" charset="0"/>
+                <a:ea typeface="Arial" pitchFamily="34" charset="-122"/>
+                <a:cs typeface="Arial" pitchFamily="34" charset="-120"/>
+              </a:rPr>
+              <a:t>3</a:t>
+            </a:r>
+            <a:endParaRPr lang="en-US" sz="1500" dirty="0"/>
+          </a:p>
+        </p:txBody>
+      </p:sp>
+      <p:sp>
+        <p:nvSpPr>
+          <p:cNvPr id="10" name="Text 8"/>
+          <p:cNvSpPr/>
+          <p:nvPr/>
+        </p:nvSpPr>
+        <p:spPr>
+          <a:xfrm>
+            <a:off x="1188720" y="3785616"/>
+            <a:ext cx="5532120" cy="548640"/>
+          </a:xfrm>
+          <a:prstGeom prst="rect">
+            <a:avLst/>
+          </a:prstGeom>
+          <a:noFill/>
+          <a:ln/>
+        </p:spPr>
+        <p:txBody>
+          <a:bodyPr wrap="square" lIns="0" tIns="0" rIns="0" bIns="0" rtlCol="0" anchor="t"/>
+          <a:lstStyle/>
+          <a:p>
+            <a:pPr indent="0" marL="0">
+              <a:lnSpc>
+                <a:spcPts val="1900"/>
+              </a:lnSpc>
+              <a:buNone/>
+            </a:pPr>
+            <a:r>
+              <a:rPr lang="en-US" sz="1400" dirty="0">
+                <a:solidFill>
+                  <a:srgbClr val="1A1C2E"/>
+                </a:solidFill>
+                <a:latin typeface="Calibri" pitchFamily="34" charset="0"/>
+                <a:ea typeface="Calibri" pitchFamily="34" charset="-122"/>
+                <a:cs typeface="Calibri" pitchFamily="34" charset="-120"/>
+              </a:rPr>
+              <a:t>El modelo pide herramientas: mira el catálogo, lee más PIDs, busca lo que no conoce</a:t>
+            </a:r>
+            <a:endParaRPr lang="en-US" sz="1400" dirty="0"/>
+          </a:p>
+        </p:txBody>
+      </p:sp>
+      <p:sp>
+        <p:nvSpPr>
+          <p:cNvPr id="11" name="Text 9"/>
+          <p:cNvSpPr/>
+          <p:nvPr/>
+        </p:nvSpPr>
+        <p:spPr>
+          <a:xfrm>
+            <a:off x="777240" y="4352544"/>
+            <a:ext cx="365760" cy="502920"/>
+          </a:xfrm>
+          <a:prstGeom prst="rect">
+            <a:avLst/>
+          </a:prstGeom>
+          <a:noFill/>
+          <a:ln/>
+        </p:spPr>
+        <p:txBody>
+          <a:bodyPr wrap="square" lIns="0" tIns="0" rIns="0" bIns="0" rtlCol="0" anchor="t"/>
+          <a:lstStyle/>
+          <a:p>
+            <a:pPr indent="0" marL="0">
+              <a:buNone/>
+            </a:pPr>
+            <a:r>
+              <a:rPr lang="en-US" sz="1500" b="1" dirty="0">
+                <a:solidFill>
+                  <a:srgbClr val="202CFC"/>
+                </a:solidFill>
+                <a:latin typeface="Arial" pitchFamily="34" charset="0"/>
+                <a:ea typeface="Arial" pitchFamily="34" charset="-122"/>
+                <a:cs typeface="Arial" pitchFamily="34" charset="-120"/>
+              </a:rPr>
+              <a:t>4</a:t>
+            </a:r>
+            <a:endParaRPr lang="en-US" sz="1500" dirty="0"/>
+          </a:p>
+        </p:txBody>
+      </p:sp>
+      <p:sp>
+        <p:nvSpPr>
+          <p:cNvPr id="12" name="Text 10"/>
+          <p:cNvSpPr/>
+          <p:nvPr/>
+        </p:nvSpPr>
+        <p:spPr>
+          <a:xfrm>
+            <a:off x="1188720" y="4352544"/>
+            <a:ext cx="5532120" cy="548640"/>
+          </a:xfrm>
+          <a:prstGeom prst="rect">
+            <a:avLst/>
+          </a:prstGeom>
+          <a:noFill/>
+          <a:ln/>
+        </p:spPr>
+        <p:txBody>
+          <a:bodyPr wrap="square" lIns="0" tIns="0" rIns="0" bIns="0" rtlCol="0" anchor="t"/>
+          <a:lstStyle/>
+          <a:p>
+            <a:pPr indent="0" marL="0">
+              <a:lnSpc>
+                <a:spcPts val="1900"/>
+              </a:lnSpc>
+              <a:buNone/>
+            </a:pPr>
+            <a:r>
+              <a:rPr lang="en-US" sz="1400" dirty="0">
+                <a:solidFill>
+                  <a:srgbClr val="1A1C2E"/>
+                </a:solidFill>
+                <a:latin typeface="Calibri" pitchFamily="34" charset="0"/>
+                <a:ea typeface="Calibri" pitchFamily="34" charset="-122"/>
+                <a:cs typeface="Calibri" pitchFamily="34" charset="-120"/>
+              </a:rPr>
+              <a:t>Máximo 10 vueltas de ese ciclo, y 60 segundos de límite</a:t>
+            </a:r>
+            <a:endParaRPr lang="en-US" sz="1400" dirty="0"/>
+          </a:p>
+        </p:txBody>
+      </p:sp>
+      <p:sp>
+        <p:nvSpPr>
+          <p:cNvPr id="13" name="Text 11"/>
+          <p:cNvSpPr/>
+          <p:nvPr/>
+        </p:nvSpPr>
+        <p:spPr>
+          <a:xfrm>
+            <a:off x="777240" y="4919472"/>
+            <a:ext cx="365760" cy="502920"/>
+          </a:xfrm>
+          <a:prstGeom prst="rect">
+            <a:avLst/>
+          </a:prstGeom>
+          <a:noFill/>
+          <a:ln/>
+        </p:spPr>
+        <p:txBody>
+          <a:bodyPr wrap="square" lIns="0" tIns="0" rIns="0" bIns="0" rtlCol="0" anchor="t"/>
+          <a:lstStyle/>
+          <a:p>
+            <a:pPr indent="0" marL="0">
+              <a:buNone/>
+            </a:pPr>
+            <a:r>
+              <a:rPr lang="en-US" sz="1500" b="1" dirty="0">
+                <a:solidFill>
+                  <a:srgbClr val="202CFC"/>
+                </a:solidFill>
+                <a:latin typeface="Arial" pitchFamily="34" charset="0"/>
+                <a:ea typeface="Arial" pitchFamily="34" charset="-122"/>
+                <a:cs typeface="Arial" pitchFamily="34" charset="-120"/>
+              </a:rPr>
+              <a:t>5</a:t>
+            </a:r>
+            <a:endParaRPr lang="en-US" sz="1500" dirty="0"/>
+          </a:p>
+        </p:txBody>
+      </p:sp>
+      <p:sp>
+        <p:nvSpPr>
+          <p:cNvPr id="14" name="Text 12"/>
+          <p:cNvSpPr/>
+          <p:nvPr/>
+        </p:nvSpPr>
+        <p:spPr>
+          <a:xfrm>
+            <a:off x="1188720" y="4919472"/>
+            <a:ext cx="5532120" cy="548640"/>
+          </a:xfrm>
+          <a:prstGeom prst="rect">
+            <a:avLst/>
+          </a:prstGeom>
+          <a:noFill/>
+          <a:ln/>
+        </p:spPr>
+        <p:txBody>
+          <a:bodyPr wrap="square" lIns="0" tIns="0" rIns="0" bIns="0" rtlCol="0" anchor="t"/>
+          <a:lstStyle/>
+          <a:p>
+            <a:pPr indent="0" marL="0">
+              <a:lnSpc>
+                <a:spcPts val="1900"/>
+              </a:lnSpc>
+              <a:buNone/>
+            </a:pPr>
+            <a:r>
+              <a:rPr lang="en-US" sz="1400" dirty="0">
+                <a:solidFill>
+                  <a:srgbClr val="1A1C2E"/>
+                </a:solidFill>
+                <a:latin typeface="Calibri" pitchFamily="34" charset="0"/>
+                <a:ea typeface="Calibri" pitchFamily="34" charset="-122"/>
+                <a:cs typeface="Calibri" pitchFamily="34" charset="-120"/>
+              </a:rPr>
+              <a:t>Devuelve la explicación para el mecánico y un bloque JSON con severidad, confianza y recomendaciones</a:t>
+            </a:r>
+            <a:endParaRPr lang="en-US" sz="1400" dirty="0"/>
+          </a:p>
+        </p:txBody>
+      </p:sp>
+      <p:sp>
+        <p:nvSpPr>
+          <p:cNvPr id="15" name="Text 13"/>
+          <p:cNvSpPr/>
+          <p:nvPr/>
+        </p:nvSpPr>
+        <p:spPr>
+          <a:xfrm>
+            <a:off x="777240" y="5486400"/>
+            <a:ext cx="365760" cy="502920"/>
+          </a:xfrm>
+          <a:prstGeom prst="rect">
+            <a:avLst/>
+          </a:prstGeom>
+          <a:noFill/>
+          <a:ln/>
+        </p:spPr>
+        <p:txBody>
+          <a:bodyPr wrap="square" lIns="0" tIns="0" rIns="0" bIns="0" rtlCol="0" anchor="t"/>
+          <a:lstStyle/>
+          <a:p>
+            <a:pPr indent="0" marL="0">
+              <a:buNone/>
+            </a:pPr>
+            <a:r>
+              <a:rPr lang="en-US" sz="1500" b="1" dirty="0">
+                <a:solidFill>
+                  <a:srgbClr val="202CFC"/>
+                </a:solidFill>
+                <a:latin typeface="Arial" pitchFamily="34" charset="0"/>
+                <a:ea typeface="Arial" pitchFamily="34" charset="-122"/>
+                <a:cs typeface="Arial" pitchFamily="34" charset="-120"/>
+              </a:rPr>
+              <a:t>6</a:t>
+            </a:r>
+            <a:endParaRPr lang="en-US" sz="1500" dirty="0"/>
+          </a:p>
+        </p:txBody>
+      </p:sp>
+      <p:sp>
+        <p:nvSpPr>
+          <p:cNvPr id="16" name="Text 14"/>
+          <p:cNvSpPr/>
+          <p:nvPr/>
+        </p:nvSpPr>
+        <p:spPr>
+          <a:xfrm>
+            <a:off x="1188720" y="5486400"/>
+            <a:ext cx="5532120" cy="548640"/>
+          </a:xfrm>
+          <a:prstGeom prst="rect">
+            <a:avLst/>
+          </a:prstGeom>
+          <a:noFill/>
+          <a:ln/>
+        </p:spPr>
+        <p:txBody>
+          <a:bodyPr wrap="square" lIns="0" tIns="0" rIns="0" bIns="0" rtlCol="0" anchor="t"/>
+          <a:lstStyle/>
+          <a:p>
+            <a:pPr indent="0" marL="0">
+              <a:lnSpc>
+                <a:spcPts val="1900"/>
+              </a:lnSpc>
+              <a:buNone/>
+            </a:pPr>
+            <a:r>
+              <a:rPr lang="en-US" sz="1400" dirty="0">
+                <a:solidFill>
+                  <a:srgbClr val="1A1C2E"/>
+                </a:solidFill>
+                <a:latin typeface="Calibri" pitchFamily="34" charset="0"/>
+                <a:ea typeface="Calibri" pitchFamily="34" charset="-122"/>
+                <a:cs typeface="Calibri" pitchFamily="34" charset="-120"/>
+              </a:rPr>
+              <a:t>El caso resuelto se indexa con confianza 0,5, y la conversación sigue desde ahí</a:t>
+            </a:r>
+            <a:endParaRPr lang="en-US" sz="1400" dirty="0"/>
+          </a:p>
+        </p:txBody>
+      </p:sp>
+      <p:sp>
+        <p:nvSpPr>
+          <p:cNvPr id="17" name="Text 15"/>
+          <p:cNvSpPr/>
+          <p:nvPr/>
+        </p:nvSpPr>
+        <p:spPr>
+          <a:xfrm>
+            <a:off x="7086600" y="2194560"/>
+            <a:ext cx="4297680" cy="365760"/>
+          </a:xfrm>
+          <a:prstGeom prst="rect">
+            <a:avLst/>
+          </a:prstGeom>
+          <a:noFill/>
+          <a:ln/>
+        </p:spPr>
+        <p:txBody>
+          <a:bodyPr wrap="square" lIns="0" tIns="0" rIns="0" bIns="0" rtlCol="0" anchor="t"/>
+          <a:lstStyle/>
+          <a:p>
+            <a:pPr indent="0" marL="0">
+              <a:buNone/>
+            </a:pPr>
+            <a:r>
+              <a:rPr lang="en-US" sz="1900" b="1" dirty="0">
+                <a:solidFill>
+                  <a:srgbClr val="202CFC"/>
+                </a:solidFill>
+                <a:latin typeface="Arial" pitchFamily="34" charset="0"/>
+                <a:ea typeface="Arial" pitchFamily="34" charset="-122"/>
+                <a:cs typeface="Arial" pitchFamily="34" charset="-120"/>
+              </a:rPr>
+              <a:t>El prompt lleva 11 bloques</a:t>
+            </a:r>
+            <a:endParaRPr lang="en-US" sz="1900" dirty="0"/>
+          </a:p>
+        </p:txBody>
+      </p:sp>
+      <p:sp>
+        <p:nvSpPr>
+          <p:cNvPr id="18" name="Text 16"/>
+          <p:cNvSpPr/>
+          <p:nvPr/>
+        </p:nvSpPr>
+        <p:spPr>
+          <a:xfrm>
+            <a:off x="7086600" y="2651760"/>
+            <a:ext cx="4297680" cy="3291840"/>
+          </a:xfrm>
+          <a:prstGeom prst="rect">
+            <a:avLst/>
+          </a:prstGeom>
+          <a:noFill/>
+          <a:ln/>
+        </p:spPr>
+        <p:txBody>
+          <a:bodyPr wrap="square" lIns="0" tIns="0" rIns="0" bIns="0" rtlCol="0" anchor="t"/>
+          <a:lstStyle/>
+          <a:p>
+            <a:pPr marL="342900" indent="-342900">
+              <a:lnSpc>
+                <a:spcPts val="2000"/>
+              </a:lnSpc>
+              <a:spcAft>
+                <a:spcPts val="1000"/>
+              </a:spcAft>
+              <a:buSzPct val="100000"/>
+              <a:buChar char="•"/>
+            </a:pPr>
+            <a:r>
+              <a:rPr lang="en-US" sz="1400" dirty="0">
+                <a:solidFill>
+                  <a:srgbClr val="1A1C2E"/>
+                </a:solidFill>
+                <a:latin typeface="Calibri" pitchFamily="34" charset="0"/>
+                <a:ea typeface="Calibri" pitchFamily="34" charset="-122"/>
+                <a:cs typeface="Calibri" pitchFamily="34" charset="-120"/>
+              </a:rPr>
+              <a:t>Cómo explorar el coche y en qué orden</a:t>
+            </a:r>
+            <a:endParaRPr lang="en-US" sz="1400" dirty="0"/>
+          </a:p>
+          <a:p>
+            <a:pPr marL="342900" indent="-342900">
+              <a:lnSpc>
+                <a:spcPts val="2000"/>
+              </a:lnSpc>
+              <a:spcAft>
+                <a:spcPts val="1000"/>
+              </a:spcAft>
+              <a:buSzPct val="100000"/>
+              <a:buChar char="•"/>
+            </a:pPr>
+            <a:r>
+              <a:rPr lang="en-US" sz="1400" dirty="0">
+                <a:solidFill>
+                  <a:srgbClr val="1A1C2E"/>
+                </a:solidFill>
+                <a:latin typeface="Calibri" pitchFamily="34" charset="0"/>
+                <a:ea typeface="Calibri" pitchFamily="34" charset="-122"/>
+                <a:cs typeface="Calibri" pitchFamily="34" charset="-120"/>
+              </a:rPr>
+              <a:t>Consultar el catálogo antes de inventarse nada</a:t>
+            </a:r>
+            <a:endParaRPr lang="en-US" sz="1400" dirty="0"/>
+          </a:p>
+          <a:p>
+            <a:pPr marL="342900" indent="-342900">
+              <a:lnSpc>
+                <a:spcPts val="2000"/>
+              </a:lnSpc>
+              <a:spcAft>
+                <a:spcPts val="1000"/>
+              </a:spcAft>
+              <a:buSzPct val="100000"/>
+              <a:buChar char="•"/>
+            </a:pPr>
+            <a:r>
+              <a:rPr lang="en-US" sz="1400" dirty="0">
+                <a:solidFill>
+                  <a:srgbClr val="1A1C2E"/>
+                </a:solidFill>
+                <a:latin typeface="Calibri" pitchFamily="34" charset="0"/>
+                <a:ea typeface="Calibri" pitchFamily="34" charset="-122"/>
+                <a:cs typeface="Calibri" pitchFamily="34" charset="-120"/>
+              </a:rPr>
+              <a:t>Cómo aprender un PID, un DTC o una ECU nuevos</a:t>
+            </a:r>
+            <a:endParaRPr lang="en-US" sz="1400" dirty="0"/>
+          </a:p>
+          <a:p>
+            <a:pPr marL="342900" indent="-342900">
+              <a:lnSpc>
+                <a:spcPts val="2000"/>
+              </a:lnSpc>
+              <a:spcAft>
+                <a:spcPts val="1000"/>
+              </a:spcAft>
+              <a:buSzPct val="100000"/>
+              <a:buChar char="•"/>
+            </a:pPr>
+            <a:r>
+              <a:rPr lang="en-US" sz="1400" dirty="0">
+                <a:solidFill>
+                  <a:srgbClr val="1A1C2E"/>
+                </a:solidFill>
+                <a:latin typeface="Calibri" pitchFamily="34" charset="0"/>
+                <a:ea typeface="Calibri" pitchFamily="34" charset="-122"/>
+                <a:cs typeface="Calibri" pitchFamily="34" charset="-120"/>
+              </a:rPr>
+              <a:t>Qué queda fuera de su ámbito y no debe contestar</a:t>
+            </a:r>
+            <a:endParaRPr lang="en-US" sz="1400" dirty="0"/>
+          </a:p>
+          <a:p>
+            <a:pPr marL="342900" indent="-342900">
+              <a:lnSpc>
+                <a:spcPts val="2000"/>
+              </a:lnSpc>
+              <a:spcAft>
+                <a:spcPts val="1000"/>
+              </a:spcAft>
+              <a:buSzPct val="100000"/>
+              <a:buChar char="•"/>
+            </a:pPr>
+            <a:r>
+              <a:rPr lang="en-US" sz="1400" dirty="0">
+                <a:solidFill>
+                  <a:srgbClr val="1A1C2E"/>
+                </a:solidFill>
+                <a:latin typeface="Calibri" pitchFamily="34" charset="0"/>
+                <a:ea typeface="Calibri" pitchFamily="34" charset="-122"/>
+                <a:cs typeface="Calibri" pitchFamily="34" charset="-120"/>
+              </a:rPr>
+              <a:t>Que lo que llega de la web y del catálogo no es de fiar</a:t>
+            </a:r>
+            <a:endParaRPr lang="en-US" sz="1400" dirty="0"/>
+          </a:p>
+          <a:p>
+            <a:pPr marL="342900" indent="-342900">
+              <a:lnSpc>
+                <a:spcPts val="2000"/>
+              </a:lnSpc>
+              <a:spcAft>
+                <a:spcPts val="1000"/>
+              </a:spcAft>
+              <a:buSzPct val="100000"/>
+              <a:buChar char="•"/>
+            </a:pPr>
+            <a:r>
+              <a:rPr lang="en-US" sz="1400" dirty="0">
+                <a:solidFill>
+                  <a:srgbClr val="1A1C2E"/>
+                </a:solidFill>
+                <a:latin typeface="Calibri" pitchFamily="34" charset="0"/>
+                <a:ea typeface="Calibri" pitchFamily="34" charset="-122"/>
+                <a:cs typeface="Calibri" pitchFamily="34" charset="-120"/>
+              </a:rPr>
+              <a:t>Cómo hablarle a un mecánico, y cómo rematar en JSON</a:t>
+            </a:r>
+            <a:endParaRPr lang="en-US" sz="1400" dirty="0"/>
+          </a:p>
+        </p:txBody>
+      </p:sp>
+      <p:sp>
+        <p:nvSpPr>
+          <p:cNvPr id="19" name="Shape 17"/>
+          <p:cNvSpPr/>
+          <p:nvPr/>
+        </p:nvSpPr>
+        <p:spPr>
+          <a:xfrm>
+            <a:off x="777240" y="6263640"/>
+            <a:ext cx="219456" cy="219456"/>
+          </a:xfrm>
+          <a:prstGeom prst="rect">
+            <a:avLst/>
+          </a:prstGeom>
+          <a:solidFill>
+            <a:srgbClr val="202CFC"/>
+          </a:solidFill>
+          <a:ln/>
+        </p:spPr>
+      </p:sp>
+      <p:sp>
+        <p:nvSpPr>
+          <p:cNvPr id="20" name="Text 18"/>
+          <p:cNvSpPr/>
+          <p:nvPr/>
+        </p:nvSpPr>
+        <p:spPr>
+          <a:xfrm>
+            <a:off x="777240" y="6263640"/>
+            <a:ext cx="219456" cy="219456"/>
+          </a:xfrm>
+          <a:prstGeom prst="rect">
+            <a:avLst/>
+          </a:prstGeom>
+          <a:noFill/>
+          <a:ln/>
+        </p:spPr>
+        <p:txBody>
+          <a:bodyPr wrap="square" lIns="0" tIns="0" rIns="0" bIns="0" rtlCol="0" anchor="ctr"/>
+          <a:lstStyle/>
+          <a:p>
+            <a:pPr algn="ctr" indent="0" marL="0">
+              <a:buNone/>
+            </a:pPr>
+            <a:r>
+              <a:rPr lang="en-US" sz="816" b="1" dirty="0">
+                <a:solidFill>
+                  <a:srgbClr val="FFFFFF"/>
+                </a:solidFill>
+                <a:latin typeface="Arial" pitchFamily="34" charset="0"/>
+                <a:ea typeface="Arial" pitchFamily="34" charset="-122"/>
+                <a:cs typeface="Arial" pitchFamily="34" charset="-120"/>
+              </a:rPr>
+              <a:t>BIG</a:t>
+            </a:r>
+            <a:endParaRPr lang="en-US" sz="816" dirty="0"/>
+          </a:p>
+        </p:txBody>
+      </p:sp>
+      <p:sp>
+        <p:nvSpPr>
+          <p:cNvPr id="21" name="Text 19"/>
+          <p:cNvSpPr/>
+          <p:nvPr/>
+        </p:nvSpPr>
+        <p:spPr>
+          <a:xfrm>
+            <a:off x="1078992" y="6263640"/>
+            <a:ext cx="658368" cy="219456"/>
+          </a:xfrm>
+          <a:prstGeom prst="rect">
+            <a:avLst/>
+          </a:prstGeom>
+          <a:noFill/>
+          <a:ln/>
+        </p:spPr>
+        <p:txBody>
+          <a:bodyPr wrap="square" lIns="0" tIns="0" rIns="0" bIns="0" rtlCol="0" anchor="ctr"/>
+          <a:lstStyle/>
+          <a:p>
+            <a:pPr algn="l" indent="0" marL="0">
+              <a:buNone/>
+            </a:pPr>
+            <a:r>
+              <a:rPr lang="en-US" sz="816" dirty="0">
+                <a:solidFill>
+                  <a:srgbClr val="1A1C2E"/>
+                </a:solidFill>
+                <a:latin typeface="Arial" pitchFamily="34" charset="0"/>
+                <a:ea typeface="Arial" pitchFamily="34" charset="-122"/>
+                <a:cs typeface="Arial" pitchFamily="34" charset="-120"/>
+              </a:rPr>
+              <a:t>school</a:t>
+            </a:r>
+            <a:endParaRPr lang="en-US" sz="816" dirty="0"/>
+          </a:p>
+        </p:txBody>
+      </p:sp>
+      <p:sp>
+        <p:nvSpPr>
+          <p:cNvPr id="22" name="Text 20"/>
+          <p:cNvSpPr/>
+          <p:nvPr/>
+        </p:nvSpPr>
+        <p:spPr>
+          <a:xfrm>
+            <a:off x="11064240" y="6263640"/>
+            <a:ext cx="320040" cy="219456"/>
+          </a:xfrm>
+          <a:prstGeom prst="rect">
+            <a:avLst/>
+          </a:prstGeom>
+          <a:noFill/>
+          <a:ln/>
+        </p:spPr>
+        <p:txBody>
+          <a:bodyPr wrap="square" lIns="0" tIns="0" rIns="0" bIns="0" rtlCol="0" anchor="ctr"/>
+          <a:lstStyle/>
+          <a:p>
+            <a:pPr algn="r" indent="0" marL="0">
+              <a:buNone/>
+            </a:pPr>
+            <a:r>
+              <a:rPr lang="en-US" sz="1000" dirty="0">
+                <a:solidFill>
+                  <a:srgbClr val="5A5F73"/>
+                </a:solidFill>
+                <a:latin typeface="Calibri" pitchFamily="34" charset="0"/>
+                <a:ea typeface="Calibri" pitchFamily="34" charset="-122"/>
+                <a:cs typeface="Calibri" pitchFamily="34" charset="-120"/>
+              </a:rPr>
+              <a:t>10</a:t>
+            </a:r>
+            <a:endParaRPr lang="en-US" sz="1000" dirty="0"/>
+          </a:p>
+        </p:txBody>
+      </p:sp>
+    </p:spTree>
+  </p:cSld>
+  <p:clrMapOvr>
+    <a:masterClrMapping/>
+  </p:clrMapOvr>
+</p:sld>
+</file>
+
+<file path=ppt/slides/slide11.xml><?xml version="1.0" encoding="utf-8"?>
+<p:sld xmlns:a="http://schemas.openxmlformats.org/drawingml/2006/main" xmlns:r="http://schemas.openxmlformats.org/officeDocument/2006/relationships" xmlns:p="http://schemas.openxmlformats.org/presentationml/2006/main">
+  <p:cSld name="Slide 11">
+    <p:bg>
+      <p:bgPr>
+        <a:solidFill>
+          <a:srgbClr val="FFFFFF"/>
+        </a:solidFill>
+      </p:bgPr>
+    </p:bg>
+    <p:spTree>
+      <p:nvGrpSpPr>
+        <p:cNvPr id="1" name=""/>
+        <p:cNvGrpSpPr/>
+        <p:nvPr/>
+      </p:nvGrpSpPr>
+      <p:grpSpPr>
+        <a:xfrm>
+          <a:off x="0" y="0"/>
+          <a:ext cx="0" cy="0"/>
+          <a:chOff x="0" y="0"/>
+          <a:chExt cx="0" cy="0"/>
+        </a:xfrm>
+      </p:grpSpPr>
+      <p:sp>
+        <p:nvSpPr>
+          <p:cNvPr id="2" name="Text 0"/>
+          <p:cNvSpPr/>
+          <p:nvPr/>
+        </p:nvSpPr>
+        <p:spPr>
+          <a:xfrm>
+            <a:off x="777240" y="640080"/>
+            <a:ext cx="10607040" cy="777240"/>
+          </a:xfrm>
+          <a:prstGeom prst="rect">
+            <a:avLst/>
+          </a:prstGeom>
+          <a:noFill/>
+          <a:ln/>
+        </p:spPr>
+        <p:txBody>
+          <a:bodyPr wrap="square" lIns="0" tIns="0" rIns="0" bIns="0" rtlCol="0" anchor="t"/>
+          <a:lstStyle/>
+          <a:p>
+            <a:pPr indent="0" marL="0">
+              <a:buNone/>
+            </a:pPr>
+            <a:r>
+              <a:rPr lang="en-US" sz="3400" b="1" dirty="0">
+                <a:solidFill>
+                  <a:srgbClr val="1A1C2E"/>
+                </a:solidFill>
+                <a:latin typeface="Arial" pitchFamily="34" charset="0"/>
+                <a:ea typeface="Arial" pitchFamily="34" charset="-122"/>
+                <a:cs typeface="Arial" pitchFamily="34" charset="-120"/>
+              </a:rPr>
               <a:t>Dos diagnósticos</a:t>
             </a:r>
             <a:endParaRPr lang="en-US" sz="3400" dirty="0"/>
@@ -2688,7 +3761,7 @@
                 <a:ea typeface="Calibri" pitchFamily="34" charset="-122"/>
                 <a:cs typeface="Calibri" pitchFamily="34" charset="-120"/>
               </a:rPr>
-              <a:t>10</a:t>
+              <a:t>11</a:t>
             </a:r>
             <a:endParaRPr lang="en-US" sz="1000" dirty="0"/>
           </a:p>

</xml_diff>

<commit_message>
docs(tfm): proveedor intercambiable y aprendizaje del catalogo
</commit_message>
<xml_diff>
--- a/docs/presentacion/tfm-intelligent-automotive-diagnostics.pptx
+++ b/docs/presentacion/tfm-intelligent-automotive-diagnostics.pptx
@@ -16,9 +16,10 @@
     <p:sldId id="264" r:id="rId10"/>
     <p:sldId id="265" r:id="rId11"/>
     <p:sldId id="266" r:id="rId12"/>
+    <p:sldId id="267" r:id="rId13"/>
   </p:sldIdLst>
   <p:notesMasterIdLst>
-    <p:notesMasterId r:id="rId13"/>
+    <p:notesMasterId r:id="rId14"/>
   </p:notesMasterIdLst>
   <p:sldSz cx="12192000" cy="6858000"/>
   <p:notesSz cx="6858000" cy="12192000"/>
@@ -698,10 +699,10 @@
           <a:p>
             <a:r>
               <a:rPr lang="en-US" dirty="0"/>
-              <a:t>El sistema hace dos diagnósticos distintos, y conviven.
-El determinista es el de toda la vida. Lee cuatro PIDs fijos —revoluciones, temperatura de refrigerante, velocidad y temperatura de admisión—, los códigos de avería y el freeze frame. Y la criticidad no me la invento: sale de una regla en el dominio, computeSeverity. Si no hay códigos es baja; si hay freeze frame es crítica, porque significa que la centralita congeló el momento del fallo; y si hay códigos sin freeze frame es alta. Solo necesita el coche conectado, responde al momento, y no aprende nada.
-El cognitivo es el otro. Ahí no hay una lista fija de PIDs: el agente decide qué le hace falta leer y va llamando a las herramientas según lo que encuentra. A cambio necesita tres cosas: el coche, la API del modelo y los índices vectoriales. Tarda más, con un límite de sesenta segundos. Y es el único que aprende: indexa los PIDs y DTCs nuevos y guarda el caso resuelto.
-Por eso conviven. Si no hay modelo configurado, o si no hay internet en el taller, el determinista sigue funcionando.
+              <a:t>Dos cosas que van juntas: lo de fuera se sustituye, y lo que se aprende se queda.
+Cambiar de proveedor de modelo es una variable de entorno. Los dos clientes, el de Anthropic y el de OpenAI, implementan el mismo puerto, así que la capa de aplicación no se entera de cuál está detrás. Y el adaptador de OpenAI no vale solo para OpenAI: sirve para cualquier proveedor compatible con su API, o sea DeepSeek, Groq, Mistral o xAI, cambiando la URL base. Los embeddings no dependen ni de eso, porque el modelo corre en la propia máquina: sin clave, sin latencia de red y sin coste por consulta.
+La otra mitad es el aprendizaje. El agente se topa con un PID o un DTC que no está en el catálogo, lo valida contra el coche cuando se puede, y lo indexa con la confianza que le corresponde según de dónde salga. En el siguiente coche parecido, eso vuelve como caso similar.
+Y hay una pieza que quiero decir en voz alta porque está a medias a propósito. Tengo implementada y testeada la función que sube la confianza de un dato cada vez que se reutiliza con éxito, pero no la llamo desde ningún flujo. El motivo es que para subirla haría falta saber que el diagnóstico acertó de verdad, y ese dato el sistema no lo tiene: nadie le dice si el coche se arregló. Inventármelo habría degradado el catálogo, así que preferí dejarlo fuera de alcance y documentarlo.
 [~65 s]</a:t>
             </a:r>
             <a:endParaRPr lang="en-US" dirty="0"/>
@@ -726,6 +727,98 @@
             <a:fld id="{F7021451-1387-4CA6-816F-3879F97B5CBC}" type="slidenum">
               <a:rPr lang="en-US"/>
               <a:t>11</a:t>
+            </a:fld>
+            <a:endParaRPr lang="en-US"/>
+          </a:p>
+        </p:txBody>
+      </p:sp>
+    </p:spTree>
+    <p:extLst>
+      <p:ext uri="{BB962C8B-B14F-4D97-AF65-F5344CB8AC3E}">
+        <p14:creationId xmlns:p14="http://schemas.microsoft.com/office/powerpoint/2010/main" val="1024086991"/>
+      </p:ext>
+    </p:extLst>
+  </p:cSld>
+  <p:clrMapOvr>
+    <a:masterClrMapping/>
+  </p:clrMapOvr>
+</p:notes>
+</file>
+
+<file path=ppt/notesSlides/notesSlide12.xml><?xml version="1.0" encoding="utf-8"?>
+<p:notes xmlns:a="http://schemas.openxmlformats.org/drawingml/2006/main" xmlns:r="http://schemas.openxmlformats.org/officeDocument/2006/relationships" xmlns:p="http://schemas.openxmlformats.org/presentationml/2006/main">
+  <p:cSld>
+    <p:spTree>
+      <p:nvGrpSpPr>
+        <p:cNvPr id="1" name=""/>
+        <p:cNvGrpSpPr/>
+        <p:nvPr/>
+      </p:nvGrpSpPr>
+      <p:grpSpPr>
+        <a:xfrm>
+          <a:off x="0" y="0"/>
+          <a:ext cx="0" cy="0"/>
+          <a:chOff x="0" y="0"/>
+          <a:chExt cx="0" cy="0"/>
+        </a:xfrm>
+      </p:grpSpPr>
+      <p:sp>
+        <p:nvSpPr>
+          <p:cNvPr id="2" name="Slide Image Placeholder 1"/>
+          <p:cNvSpPr>
+            <a:spLocks noGrp="1" noRot="1" noChangeAspect="1"/>
+          </p:cNvSpPr>
+          <p:nvPr>
+            <p:ph type="sldImg"/>
+          </p:nvPr>
+        </p:nvSpPr>
+        <p:spPr/>
+      </p:sp>
+      <p:sp>
+        <p:nvSpPr>
+          <p:cNvPr id="3" name="Notes Placeholder 2"/>
+          <p:cNvSpPr>
+            <a:spLocks noGrp="1"/>
+          </p:cNvSpPr>
+          <p:nvPr>
+            <p:ph type="body" idx="1"/>
+          </p:nvPr>
+        </p:nvSpPr>
+        <p:spPr/>
+        <p:txBody>
+          <a:bodyPr/>
+          <a:lstStyle/>
+          <a:p>
+            <a:r>
+              <a:rPr lang="en-US" dirty="0"/>
+              <a:t>El sistema hace dos diagnósticos distintos, y conviven.
+El determinista es el de toda la vida. Lee cuatro PIDs fijos —revoluciones, temperatura de refrigerante, velocidad y temperatura de admisión—, los códigos de avería y el freeze frame. Y la criticidad no me la invento: sale de una regla en el dominio, computeSeverity. Si no hay códigos es baja; si hay freeze frame es crítica, porque significa que la centralita congeló el momento del fallo; y si hay códigos sin freeze frame es alta. Solo necesita el coche conectado, responde al momento, y no aprende nada.
+El cognitivo es el otro. Ahí no hay una lista fija de PIDs: el agente decide qué le hace falta leer y va llamando a las herramientas según lo que encuentra. A cambio necesita tres cosas: el coche, la API del modelo y los índices vectoriales. Tarda más, con un límite de sesenta segundos. Y es el único que aprende: indexa los PIDs y DTCs nuevos y guarda el caso resuelto.
+Por eso conviven. Si no hay modelo configurado, o si no hay internet en el taller, el determinista sigue funcionando.
+[~65 s]</a:t>
+            </a:r>
+            <a:endParaRPr lang="en-US" dirty="0"/>
+          </a:p>
+        </p:txBody>
+      </p:sp>
+      <p:sp>
+        <p:nvSpPr>
+          <p:cNvPr id="4" name="Slide Number Placeholder 3"/>
+          <p:cNvSpPr>
+            <a:spLocks noGrp="1"/>
+          </p:cNvSpPr>
+          <p:nvPr>
+            <p:ph type="sldNum" sz="quarter" idx="10"/>
+          </p:nvPr>
+        </p:nvSpPr>
+        <p:spPr/>
+        <p:txBody>
+          <a:bodyPr/>
+          <a:lstStyle/>
+          <a:p>
+            <a:fld id="{F7021451-1387-4CA6-816F-3879F97B5CBC}" type="slidenum">
+              <a:rPr lang="en-US"/>
+              <a:t>12</a:t>
             </a:fld>
             <a:endParaRPr lang="en-US"/>
           </a:p>
@@ -3223,7 +3316,7 @@
                 <a:ea typeface="Arial" pitchFamily="34" charset="-122"/>
                 <a:cs typeface="Arial" pitchFamily="34" charset="-120"/>
               </a:rPr>
-              <a:t>Dos diagnósticos</a:t>
+              <a:t>Cambiar de modelo, y aprender del uso</a:t>
             </a:r>
             <a:endParaRPr lang="en-US" sz="3400" dirty="0"/>
           </a:p>
@@ -3262,7 +3355,7 @@
                 <a:ea typeface="Calibri" pitchFamily="34" charset="-122"/>
                 <a:cs typeface="Calibri" pitchFamily="34" charset="-120"/>
               </a:rPr>
-              <a:t>El determinista está siempre. El cognitivo, solo si hay un modelo configurado.</a:t>
+              <a:t>Lo de fuera se sustituye. Lo que el sistema aprende se queda.</a:t>
             </a:r>
             <a:endParaRPr lang="en-US" sz="1700" dirty="0"/>
           </a:p>
@@ -3293,7 +3386,7 @@
               <a:buNone/>
             </a:pPr>
             <a:r>
-              <a:rPr lang="en-US" sz="2000" b="1" dirty="0">
+              <a:rPr lang="en-US" sz="1900" b="1" dirty="0">
                 <a:solidFill>
                   <a:srgbClr val="202CFC"/>
                 </a:solidFill>
@@ -3301,9 +3394,9 @@
                 <a:ea typeface="Arial" pitchFamily="34" charset="-122"/>
                 <a:cs typeface="Arial" pitchFamily="34" charset="-120"/>
               </a:rPr>
-              <a:t>Determinista</a:t>
-            </a:r>
-            <a:endParaRPr lang="en-US" sz="2000" dirty="0"/>
+              <a:t>Cambiar de proveedor</a:t>
+            </a:r>
+            <a:endParaRPr lang="en-US" sz="1900" dirty="0"/>
           </a:p>
         </p:txBody>
       </p:sp>
@@ -3347,7 +3440,7 @@
                 <a:ea typeface="Calibri" pitchFamily="34" charset="-122"/>
                 <a:cs typeface="Calibri" pitchFamily="34" charset="-120"/>
               </a:rPr>
-              <a:t>Lee cuatro PIDs fijos: revoluciones, refrigerante, velocidad y admisión</a:t>
+              <a:t>Una variable de entorno: LLM_PROVIDER = anthropic u openai</a:t>
             </a:r>
             <a:endParaRPr lang="en-US" sz="1500" dirty="0"/>
           </a:p>
@@ -3371,7 +3464,7 @@
                 <a:ea typeface="Calibri" pitchFamily="34" charset="-122"/>
                 <a:cs typeface="Calibri" pitchFamily="34" charset="-120"/>
               </a:rPr>
-              <a:t>Más los DTCs y el freeze frame</a:t>
+              <a:t>Los dos clientes implementan el mismo puerto, LlmClientPort</a:t>
             </a:r>
             <a:endParaRPr lang="en-US" sz="1500" dirty="0"/>
           </a:p>
@@ -3395,7 +3488,7 @@
                 <a:ea typeface="Calibri" pitchFamily="34" charset="-122"/>
                 <a:cs typeface="Calibri" pitchFamily="34" charset="-120"/>
               </a:rPr>
-              <a:t>La criticidad sale de una regla: sin DTCs es baja, con freeze frame es crítica</a:t>
+              <a:t>El adaptador de OpenAI sirve también para DeepSeek, Groq, Mistral o xAI</a:t>
             </a:r>
             <a:endParaRPr lang="en-US" sz="1500" dirty="0"/>
           </a:p>
@@ -3419,10 +3512,71 @@
                 <a:ea typeface="Calibri" pitchFamily="34" charset="-122"/>
                 <a:cs typeface="Calibri" pitchFamily="34" charset="-120"/>
               </a:rPr>
-              <a:t>Solo necesita el coche, y responde al momento</a:t>
+              <a:t>Los embeddings ni eso: el modelo corre en la propia máquina</a:t>
             </a:r>
             <a:endParaRPr lang="en-US" sz="1500" dirty="0"/>
           </a:p>
+        </p:txBody>
+      </p:sp>
+      <p:sp>
+        <p:nvSpPr>
+          <p:cNvPr id="6" name="Text 4"/>
+          <p:cNvSpPr/>
+          <p:nvPr/>
+        </p:nvSpPr>
+        <p:spPr>
+          <a:xfrm>
+            <a:off x="6537960" y="2240280"/>
+            <a:ext cx="4846320" cy="365760"/>
+          </a:xfrm>
+          <a:prstGeom prst="rect">
+            <a:avLst/>
+          </a:prstGeom>
+          <a:noFill/>
+          <a:ln/>
+        </p:spPr>
+        <p:txBody>
+          <a:bodyPr wrap="square" lIns="0" tIns="0" rIns="0" bIns="0" rtlCol="0" anchor="t"/>
+          <a:lstStyle/>
+          <a:p>
+            <a:pPr indent="0" marL="0">
+              <a:buNone/>
+            </a:pPr>
+            <a:r>
+              <a:rPr lang="en-US" sz="1900" b="1" dirty="0">
+                <a:solidFill>
+                  <a:srgbClr val="202CFC"/>
+                </a:solidFill>
+                <a:latin typeface="Arial" pitchFamily="34" charset="0"/>
+                <a:ea typeface="Arial" pitchFamily="34" charset="-122"/>
+                <a:cs typeface="Arial" pitchFamily="34" charset="-120"/>
+              </a:rPr>
+              <a:t>Aprender del uso</a:t>
+            </a:r>
+            <a:endParaRPr lang="en-US" sz="1900" dirty="0"/>
+          </a:p>
+        </p:txBody>
+      </p:sp>
+      <p:sp>
+        <p:nvSpPr>
+          <p:cNvPr id="7" name="Text 5"/>
+          <p:cNvSpPr/>
+          <p:nvPr/>
+        </p:nvSpPr>
+        <p:spPr>
+          <a:xfrm>
+            <a:off x="6537960" y="2788920"/>
+            <a:ext cx="4846320" cy="2834640"/>
+          </a:xfrm>
+          <a:prstGeom prst="rect">
+            <a:avLst/>
+          </a:prstGeom>
+          <a:noFill/>
+          <a:ln/>
+        </p:spPr>
+        <p:txBody>
+          <a:bodyPr wrap="square" lIns="0" tIns="0" rIns="0" bIns="0" rtlCol="0" anchor="t"/>
+          <a:lstStyle/>
           <a:p>
             <a:pPr marL="342900" indent="-342900">
               <a:lnSpc>
@@ -3443,71 +3597,10 @@
                 <a:ea typeface="Calibri" pitchFamily="34" charset="-122"/>
                 <a:cs typeface="Calibri" pitchFamily="34" charset="-120"/>
               </a:rPr>
-              <a:t>No aprende nada</a:t>
+              <a:t>El agente se topa con un PID o un DTC que no está en el catálogo</a:t>
             </a:r>
             <a:endParaRPr lang="en-US" sz="1500" dirty="0"/>
           </a:p>
-        </p:txBody>
-      </p:sp>
-      <p:sp>
-        <p:nvSpPr>
-          <p:cNvPr id="6" name="Text 4"/>
-          <p:cNvSpPr/>
-          <p:nvPr/>
-        </p:nvSpPr>
-        <p:spPr>
-          <a:xfrm>
-            <a:off x="6537960" y="2240280"/>
-            <a:ext cx="4846320" cy="365760"/>
-          </a:xfrm>
-          <a:prstGeom prst="rect">
-            <a:avLst/>
-          </a:prstGeom>
-          <a:noFill/>
-          <a:ln/>
-        </p:spPr>
-        <p:txBody>
-          <a:bodyPr wrap="square" lIns="0" tIns="0" rIns="0" bIns="0" rtlCol="0" anchor="t"/>
-          <a:lstStyle/>
-          <a:p>
-            <a:pPr indent="0" marL="0">
-              <a:buNone/>
-            </a:pPr>
-            <a:r>
-              <a:rPr lang="en-US" sz="2000" b="1" dirty="0">
-                <a:solidFill>
-                  <a:srgbClr val="202CFC"/>
-                </a:solidFill>
-                <a:latin typeface="Arial" pitchFamily="34" charset="0"/>
-                <a:ea typeface="Arial" pitchFamily="34" charset="-122"/>
-                <a:cs typeface="Arial" pitchFamily="34" charset="-120"/>
-              </a:rPr>
-              <a:t>Cognitivo</a:t>
-            </a:r>
-            <a:endParaRPr lang="en-US" sz="2000" dirty="0"/>
-          </a:p>
-        </p:txBody>
-      </p:sp>
-      <p:sp>
-        <p:nvSpPr>
-          <p:cNvPr id="7" name="Text 5"/>
-          <p:cNvSpPr/>
-          <p:nvPr/>
-        </p:nvSpPr>
-        <p:spPr>
-          <a:xfrm>
-            <a:off x="6537960" y="2788920"/>
-            <a:ext cx="4846320" cy="2834640"/>
-          </a:xfrm>
-          <a:prstGeom prst="rect">
-            <a:avLst/>
-          </a:prstGeom>
-          <a:noFill/>
-          <a:ln/>
-        </p:spPr>
-        <p:txBody>
-          <a:bodyPr wrap="square" lIns="0" tIns="0" rIns="0" bIns="0" rtlCol="0" anchor="t"/>
-          <a:lstStyle/>
           <a:p>
             <a:pPr marL="342900" indent="-342900">
               <a:lnSpc>
@@ -3528,7 +3621,7 @@
                 <a:ea typeface="Calibri" pitchFamily="34" charset="-122"/>
                 <a:cs typeface="Calibri" pitchFamily="34" charset="-120"/>
               </a:rPr>
-              <a:t>El agente decide qué PIDs le hace falta leer</a:t>
+              <a:t>Lo valida contra el coche cuando se puede</a:t>
             </a:r>
             <a:endParaRPr lang="en-US" sz="1500" dirty="0"/>
           </a:p>
@@ -3552,7 +3645,7 @@
                 <a:ea typeface="Calibri" pitchFamily="34" charset="-122"/>
                 <a:cs typeface="Calibri" pitchFamily="34" charset="-120"/>
               </a:rPr>
-              <a:t>Razona sobre lo que va encontrando, llamando a herramientas</a:t>
+              <a:t>Lo indexa con la confianza de su fuente</a:t>
             </a:r>
             <a:endParaRPr lang="en-US" sz="1500" dirty="0"/>
           </a:p>
@@ -3576,7 +3669,7 @@
                 <a:ea typeface="Calibri" pitchFamily="34" charset="-122"/>
                 <a:cs typeface="Calibri" pitchFamily="34" charset="-120"/>
               </a:rPr>
-              <a:t>Necesita el coche, la API del modelo y los índices vectoriales</a:t>
+              <a:t>Y en el siguiente coche vuelve como caso parecido</a:t>
             </a:r>
             <a:endParaRPr lang="en-US" sz="1500" dirty="0"/>
           </a:p>
@@ -3600,10 +3693,318 @@
                 <a:ea typeface="Calibri" pitchFamily="34" charset="-122"/>
                 <a:cs typeface="Calibri" pitchFamily="34" charset="-120"/>
               </a:rPr>
-              <a:t>Hasta 60 segundos de límite</a:t>
+              <a:t>Lo que no está: subir la confianza cuando un caso acierta. Habría que saber que acertó, y el sistema no lo sabe</a:t>
             </a:r>
             <a:endParaRPr lang="en-US" sz="1500" dirty="0"/>
           </a:p>
+        </p:txBody>
+      </p:sp>
+      <p:sp>
+        <p:nvSpPr>
+          <p:cNvPr id="8" name="Shape 6"/>
+          <p:cNvSpPr/>
+          <p:nvPr/>
+        </p:nvSpPr>
+        <p:spPr>
+          <a:xfrm>
+            <a:off x="777240" y="6263640"/>
+            <a:ext cx="219456" cy="219456"/>
+          </a:xfrm>
+          <a:prstGeom prst="rect">
+            <a:avLst/>
+          </a:prstGeom>
+          <a:solidFill>
+            <a:srgbClr val="202CFC"/>
+          </a:solidFill>
+          <a:ln/>
+        </p:spPr>
+      </p:sp>
+      <p:sp>
+        <p:nvSpPr>
+          <p:cNvPr id="9" name="Text 7"/>
+          <p:cNvSpPr/>
+          <p:nvPr/>
+        </p:nvSpPr>
+        <p:spPr>
+          <a:xfrm>
+            <a:off x="777240" y="6263640"/>
+            <a:ext cx="219456" cy="219456"/>
+          </a:xfrm>
+          <a:prstGeom prst="rect">
+            <a:avLst/>
+          </a:prstGeom>
+          <a:noFill/>
+          <a:ln/>
+        </p:spPr>
+        <p:txBody>
+          <a:bodyPr wrap="square" lIns="0" tIns="0" rIns="0" bIns="0" rtlCol="0" anchor="ctr"/>
+          <a:lstStyle/>
+          <a:p>
+            <a:pPr algn="ctr" indent="0" marL="0">
+              <a:buNone/>
+            </a:pPr>
+            <a:r>
+              <a:rPr lang="en-US" sz="816" b="1" dirty="0">
+                <a:solidFill>
+                  <a:srgbClr val="FFFFFF"/>
+                </a:solidFill>
+                <a:latin typeface="Arial" pitchFamily="34" charset="0"/>
+                <a:ea typeface="Arial" pitchFamily="34" charset="-122"/>
+                <a:cs typeface="Arial" pitchFamily="34" charset="-120"/>
+              </a:rPr>
+              <a:t>BIG</a:t>
+            </a:r>
+            <a:endParaRPr lang="en-US" sz="816" dirty="0"/>
+          </a:p>
+        </p:txBody>
+      </p:sp>
+      <p:sp>
+        <p:nvSpPr>
+          <p:cNvPr id="10" name="Text 8"/>
+          <p:cNvSpPr/>
+          <p:nvPr/>
+        </p:nvSpPr>
+        <p:spPr>
+          <a:xfrm>
+            <a:off x="1078992" y="6263640"/>
+            <a:ext cx="658368" cy="219456"/>
+          </a:xfrm>
+          <a:prstGeom prst="rect">
+            <a:avLst/>
+          </a:prstGeom>
+          <a:noFill/>
+          <a:ln/>
+        </p:spPr>
+        <p:txBody>
+          <a:bodyPr wrap="square" lIns="0" tIns="0" rIns="0" bIns="0" rtlCol="0" anchor="ctr"/>
+          <a:lstStyle/>
+          <a:p>
+            <a:pPr algn="l" indent="0" marL="0">
+              <a:buNone/>
+            </a:pPr>
+            <a:r>
+              <a:rPr lang="en-US" sz="816" dirty="0">
+                <a:solidFill>
+                  <a:srgbClr val="1A1C2E"/>
+                </a:solidFill>
+                <a:latin typeface="Arial" pitchFamily="34" charset="0"/>
+                <a:ea typeface="Arial" pitchFamily="34" charset="-122"/>
+                <a:cs typeface="Arial" pitchFamily="34" charset="-120"/>
+              </a:rPr>
+              <a:t>school</a:t>
+            </a:r>
+            <a:endParaRPr lang="en-US" sz="816" dirty="0"/>
+          </a:p>
+        </p:txBody>
+      </p:sp>
+      <p:sp>
+        <p:nvSpPr>
+          <p:cNvPr id="11" name="Text 9"/>
+          <p:cNvSpPr/>
+          <p:nvPr/>
+        </p:nvSpPr>
+        <p:spPr>
+          <a:xfrm>
+            <a:off x="11064240" y="6263640"/>
+            <a:ext cx="320040" cy="219456"/>
+          </a:xfrm>
+          <a:prstGeom prst="rect">
+            <a:avLst/>
+          </a:prstGeom>
+          <a:noFill/>
+          <a:ln/>
+        </p:spPr>
+        <p:txBody>
+          <a:bodyPr wrap="square" lIns="0" tIns="0" rIns="0" bIns="0" rtlCol="0" anchor="ctr"/>
+          <a:lstStyle/>
+          <a:p>
+            <a:pPr algn="r" indent="0" marL="0">
+              <a:buNone/>
+            </a:pPr>
+            <a:r>
+              <a:rPr lang="en-US" sz="1000" dirty="0">
+                <a:solidFill>
+                  <a:srgbClr val="5A5F73"/>
+                </a:solidFill>
+                <a:latin typeface="Calibri" pitchFamily="34" charset="0"/>
+                <a:ea typeface="Calibri" pitchFamily="34" charset="-122"/>
+                <a:cs typeface="Calibri" pitchFamily="34" charset="-120"/>
+              </a:rPr>
+              <a:t>11</a:t>
+            </a:r>
+            <a:endParaRPr lang="en-US" sz="1000" dirty="0"/>
+          </a:p>
+        </p:txBody>
+      </p:sp>
+    </p:spTree>
+  </p:cSld>
+  <p:clrMapOvr>
+    <a:masterClrMapping/>
+  </p:clrMapOvr>
+</p:sld>
+</file>
+
+<file path=ppt/slides/slide12.xml><?xml version="1.0" encoding="utf-8"?>
+<p:sld xmlns:a="http://schemas.openxmlformats.org/drawingml/2006/main" xmlns:r="http://schemas.openxmlformats.org/officeDocument/2006/relationships" xmlns:p="http://schemas.openxmlformats.org/presentationml/2006/main">
+  <p:cSld name="Slide 12">
+    <p:bg>
+      <p:bgPr>
+        <a:solidFill>
+          <a:srgbClr val="FFFFFF"/>
+        </a:solidFill>
+      </p:bgPr>
+    </p:bg>
+    <p:spTree>
+      <p:nvGrpSpPr>
+        <p:cNvPr id="1" name=""/>
+        <p:cNvGrpSpPr/>
+        <p:nvPr/>
+      </p:nvGrpSpPr>
+      <p:grpSpPr>
+        <a:xfrm>
+          <a:off x="0" y="0"/>
+          <a:ext cx="0" cy="0"/>
+          <a:chOff x="0" y="0"/>
+          <a:chExt cx="0" cy="0"/>
+        </a:xfrm>
+      </p:grpSpPr>
+      <p:sp>
+        <p:nvSpPr>
+          <p:cNvPr id="2" name="Text 0"/>
+          <p:cNvSpPr/>
+          <p:nvPr/>
+        </p:nvSpPr>
+        <p:spPr>
+          <a:xfrm>
+            <a:off x="777240" y="640080"/>
+            <a:ext cx="10607040" cy="777240"/>
+          </a:xfrm>
+          <a:prstGeom prst="rect">
+            <a:avLst/>
+          </a:prstGeom>
+          <a:noFill/>
+          <a:ln/>
+        </p:spPr>
+        <p:txBody>
+          <a:bodyPr wrap="square" lIns="0" tIns="0" rIns="0" bIns="0" rtlCol="0" anchor="t"/>
+          <a:lstStyle/>
+          <a:p>
+            <a:pPr indent="0" marL="0">
+              <a:buNone/>
+            </a:pPr>
+            <a:r>
+              <a:rPr lang="en-US" sz="3400" b="1" dirty="0">
+                <a:solidFill>
+                  <a:srgbClr val="1A1C2E"/>
+                </a:solidFill>
+                <a:latin typeface="Arial" pitchFamily="34" charset="0"/>
+                <a:ea typeface="Arial" pitchFamily="34" charset="-122"/>
+                <a:cs typeface="Arial" pitchFamily="34" charset="-120"/>
+              </a:rPr>
+              <a:t>Dos diagnósticos</a:t>
+            </a:r>
+            <a:endParaRPr lang="en-US" sz="3400" dirty="0"/>
+          </a:p>
+        </p:txBody>
+      </p:sp>
+      <p:sp>
+        <p:nvSpPr>
+          <p:cNvPr id="3" name="Text 1"/>
+          <p:cNvSpPr/>
+          <p:nvPr/>
+        </p:nvSpPr>
+        <p:spPr>
+          <a:xfrm>
+            <a:off x="777240" y="1508760"/>
+            <a:ext cx="10607040" cy="365760"/>
+          </a:xfrm>
+          <a:prstGeom prst="rect">
+            <a:avLst/>
+          </a:prstGeom>
+          <a:noFill/>
+          <a:ln/>
+        </p:spPr>
+        <p:txBody>
+          <a:bodyPr wrap="square" lIns="0" tIns="0" rIns="0" bIns="0" rtlCol="0" anchor="t"/>
+          <a:lstStyle/>
+          <a:p>
+            <a:pPr indent="0" marL="0">
+              <a:buNone/>
+            </a:pPr>
+            <a:r>
+              <a:rPr lang="en-US" sz="1700" dirty="0">
+                <a:solidFill>
+                  <a:srgbClr val="5A5F73"/>
+                </a:solidFill>
+                <a:latin typeface="Calibri" pitchFamily="34" charset="0"/>
+                <a:ea typeface="Calibri" pitchFamily="34" charset="-122"/>
+                <a:cs typeface="Calibri" pitchFamily="34" charset="-120"/>
+              </a:rPr>
+              <a:t>El determinista está siempre. El cognitivo, solo si hay un modelo configurado.</a:t>
+            </a:r>
+            <a:endParaRPr lang="en-US" sz="1700" dirty="0"/>
+          </a:p>
+        </p:txBody>
+      </p:sp>
+      <p:sp>
+        <p:nvSpPr>
+          <p:cNvPr id="4" name="Text 2"/>
+          <p:cNvSpPr/>
+          <p:nvPr/>
+        </p:nvSpPr>
+        <p:spPr>
+          <a:xfrm>
+            <a:off x="777240" y="2240280"/>
+            <a:ext cx="4846320" cy="365760"/>
+          </a:xfrm>
+          <a:prstGeom prst="rect">
+            <a:avLst/>
+          </a:prstGeom>
+          <a:noFill/>
+          <a:ln/>
+        </p:spPr>
+        <p:txBody>
+          <a:bodyPr wrap="square" lIns="0" tIns="0" rIns="0" bIns="0" rtlCol="0" anchor="t"/>
+          <a:lstStyle/>
+          <a:p>
+            <a:pPr indent="0" marL="0">
+              <a:buNone/>
+            </a:pPr>
+            <a:r>
+              <a:rPr lang="en-US" sz="2000" b="1" dirty="0">
+                <a:solidFill>
+                  <a:srgbClr val="202CFC"/>
+                </a:solidFill>
+                <a:latin typeface="Arial" pitchFamily="34" charset="0"/>
+                <a:ea typeface="Arial" pitchFamily="34" charset="-122"/>
+                <a:cs typeface="Arial" pitchFamily="34" charset="-120"/>
+              </a:rPr>
+              <a:t>Determinista</a:t>
+            </a:r>
+            <a:endParaRPr lang="en-US" sz="2000" dirty="0"/>
+          </a:p>
+        </p:txBody>
+      </p:sp>
+      <p:sp>
+        <p:nvSpPr>
+          <p:cNvPr id="5" name="Text 3"/>
+          <p:cNvSpPr/>
+          <p:nvPr/>
+        </p:nvSpPr>
+        <p:spPr>
+          <a:xfrm>
+            <a:off x="777240" y="2788920"/>
+            <a:ext cx="4846320" cy="2834640"/>
+          </a:xfrm>
+          <a:prstGeom prst="rect">
+            <a:avLst/>
+          </a:prstGeom>
+          <a:noFill/>
+          <a:ln/>
+        </p:spPr>
+        <p:txBody>
+          <a:bodyPr wrap="square" lIns="0" tIns="0" rIns="0" bIns="0" rtlCol="0" anchor="t"/>
+          <a:lstStyle/>
           <a:p>
             <a:pPr marL="342900" indent="-342900">
               <a:lnSpc>
@@ -3624,6 +4025,283 @@
                 <a:ea typeface="Calibri" pitchFamily="34" charset="-122"/>
                 <a:cs typeface="Calibri" pitchFamily="34" charset="-120"/>
               </a:rPr>
+              <a:t>Lee cuatro PIDs fijos: revoluciones, refrigerante, velocidad y admisión</a:t>
+            </a:r>
+            <a:endParaRPr lang="en-US" sz="1500" dirty="0"/>
+          </a:p>
+          <a:p>
+            <a:pPr marL="342900" indent="-342900">
+              <a:lnSpc>
+                <a:spcPts val="2100"/>
+              </a:lnSpc>
+              <a:spcAft>
+                <a:spcPts val="1100"/>
+              </a:spcAft>
+              <a:buSzPct val="100000"/>
+              <a:buChar char="•"/>
+            </a:pPr>
+            <a:r>
+              <a:rPr lang="en-US" sz="1500" dirty="0">
+                <a:solidFill>
+                  <a:srgbClr val="1A1C2E"/>
+                </a:solidFill>
+                <a:latin typeface="Calibri" pitchFamily="34" charset="0"/>
+                <a:ea typeface="Calibri" pitchFamily="34" charset="-122"/>
+                <a:cs typeface="Calibri" pitchFamily="34" charset="-120"/>
+              </a:rPr>
+              <a:t>Más los DTCs y el freeze frame</a:t>
+            </a:r>
+            <a:endParaRPr lang="en-US" sz="1500" dirty="0"/>
+          </a:p>
+          <a:p>
+            <a:pPr marL="342900" indent="-342900">
+              <a:lnSpc>
+                <a:spcPts val="2100"/>
+              </a:lnSpc>
+              <a:spcAft>
+                <a:spcPts val="1100"/>
+              </a:spcAft>
+              <a:buSzPct val="100000"/>
+              <a:buChar char="•"/>
+            </a:pPr>
+            <a:r>
+              <a:rPr lang="en-US" sz="1500" dirty="0">
+                <a:solidFill>
+                  <a:srgbClr val="1A1C2E"/>
+                </a:solidFill>
+                <a:latin typeface="Calibri" pitchFamily="34" charset="0"/>
+                <a:ea typeface="Calibri" pitchFamily="34" charset="-122"/>
+                <a:cs typeface="Calibri" pitchFamily="34" charset="-120"/>
+              </a:rPr>
+              <a:t>La criticidad sale de una regla: sin DTCs es baja, con freeze frame es crítica</a:t>
+            </a:r>
+            <a:endParaRPr lang="en-US" sz="1500" dirty="0"/>
+          </a:p>
+          <a:p>
+            <a:pPr marL="342900" indent="-342900">
+              <a:lnSpc>
+                <a:spcPts val="2100"/>
+              </a:lnSpc>
+              <a:spcAft>
+                <a:spcPts val="1100"/>
+              </a:spcAft>
+              <a:buSzPct val="100000"/>
+              <a:buChar char="•"/>
+            </a:pPr>
+            <a:r>
+              <a:rPr lang="en-US" sz="1500" dirty="0">
+                <a:solidFill>
+                  <a:srgbClr val="1A1C2E"/>
+                </a:solidFill>
+                <a:latin typeface="Calibri" pitchFamily="34" charset="0"/>
+                <a:ea typeface="Calibri" pitchFamily="34" charset="-122"/>
+                <a:cs typeface="Calibri" pitchFamily="34" charset="-120"/>
+              </a:rPr>
+              <a:t>Solo necesita el coche, y responde al momento</a:t>
+            </a:r>
+            <a:endParaRPr lang="en-US" sz="1500" dirty="0"/>
+          </a:p>
+          <a:p>
+            <a:pPr marL="342900" indent="-342900">
+              <a:lnSpc>
+                <a:spcPts val="2100"/>
+              </a:lnSpc>
+              <a:spcAft>
+                <a:spcPts val="1100"/>
+              </a:spcAft>
+              <a:buSzPct val="100000"/>
+              <a:buChar char="•"/>
+            </a:pPr>
+            <a:r>
+              <a:rPr lang="en-US" sz="1500" dirty="0">
+                <a:solidFill>
+                  <a:srgbClr val="1A1C2E"/>
+                </a:solidFill>
+                <a:latin typeface="Calibri" pitchFamily="34" charset="0"/>
+                <a:ea typeface="Calibri" pitchFamily="34" charset="-122"/>
+                <a:cs typeface="Calibri" pitchFamily="34" charset="-120"/>
+              </a:rPr>
+              <a:t>No aprende nada</a:t>
+            </a:r>
+            <a:endParaRPr lang="en-US" sz="1500" dirty="0"/>
+          </a:p>
+        </p:txBody>
+      </p:sp>
+      <p:sp>
+        <p:nvSpPr>
+          <p:cNvPr id="6" name="Text 4"/>
+          <p:cNvSpPr/>
+          <p:nvPr/>
+        </p:nvSpPr>
+        <p:spPr>
+          <a:xfrm>
+            <a:off x="6537960" y="2240280"/>
+            <a:ext cx="4846320" cy="365760"/>
+          </a:xfrm>
+          <a:prstGeom prst="rect">
+            <a:avLst/>
+          </a:prstGeom>
+          <a:noFill/>
+          <a:ln/>
+        </p:spPr>
+        <p:txBody>
+          <a:bodyPr wrap="square" lIns="0" tIns="0" rIns="0" bIns="0" rtlCol="0" anchor="t"/>
+          <a:lstStyle/>
+          <a:p>
+            <a:pPr indent="0" marL="0">
+              <a:buNone/>
+            </a:pPr>
+            <a:r>
+              <a:rPr lang="en-US" sz="2000" b="1" dirty="0">
+                <a:solidFill>
+                  <a:srgbClr val="202CFC"/>
+                </a:solidFill>
+                <a:latin typeface="Arial" pitchFamily="34" charset="0"/>
+                <a:ea typeface="Arial" pitchFamily="34" charset="-122"/>
+                <a:cs typeface="Arial" pitchFamily="34" charset="-120"/>
+              </a:rPr>
+              <a:t>Cognitivo</a:t>
+            </a:r>
+            <a:endParaRPr lang="en-US" sz="2000" dirty="0"/>
+          </a:p>
+        </p:txBody>
+      </p:sp>
+      <p:sp>
+        <p:nvSpPr>
+          <p:cNvPr id="7" name="Text 5"/>
+          <p:cNvSpPr/>
+          <p:nvPr/>
+        </p:nvSpPr>
+        <p:spPr>
+          <a:xfrm>
+            <a:off x="6537960" y="2788920"/>
+            <a:ext cx="4846320" cy="2834640"/>
+          </a:xfrm>
+          <a:prstGeom prst="rect">
+            <a:avLst/>
+          </a:prstGeom>
+          <a:noFill/>
+          <a:ln/>
+        </p:spPr>
+        <p:txBody>
+          <a:bodyPr wrap="square" lIns="0" tIns="0" rIns="0" bIns="0" rtlCol="0" anchor="t"/>
+          <a:lstStyle/>
+          <a:p>
+            <a:pPr marL="342900" indent="-342900">
+              <a:lnSpc>
+                <a:spcPts val="2100"/>
+              </a:lnSpc>
+              <a:spcAft>
+                <a:spcPts val="1100"/>
+              </a:spcAft>
+              <a:buSzPct val="100000"/>
+              <a:buChar char="•"/>
+            </a:pPr>
+            <a:r>
+              <a:rPr lang="en-US" sz="1500" dirty="0">
+                <a:solidFill>
+                  <a:srgbClr val="1A1C2E"/>
+                </a:solidFill>
+                <a:latin typeface="Calibri" pitchFamily="34" charset="0"/>
+                <a:ea typeface="Calibri" pitchFamily="34" charset="-122"/>
+                <a:cs typeface="Calibri" pitchFamily="34" charset="-120"/>
+              </a:rPr>
+              <a:t>El agente decide qué PIDs le hace falta leer</a:t>
+            </a:r>
+            <a:endParaRPr lang="en-US" sz="1500" dirty="0"/>
+          </a:p>
+          <a:p>
+            <a:pPr marL="342900" indent="-342900">
+              <a:lnSpc>
+                <a:spcPts val="2100"/>
+              </a:lnSpc>
+              <a:spcAft>
+                <a:spcPts val="1100"/>
+              </a:spcAft>
+              <a:buSzPct val="100000"/>
+              <a:buChar char="•"/>
+            </a:pPr>
+            <a:r>
+              <a:rPr lang="en-US" sz="1500" dirty="0">
+                <a:solidFill>
+                  <a:srgbClr val="1A1C2E"/>
+                </a:solidFill>
+                <a:latin typeface="Calibri" pitchFamily="34" charset="0"/>
+                <a:ea typeface="Calibri" pitchFamily="34" charset="-122"/>
+                <a:cs typeface="Calibri" pitchFamily="34" charset="-120"/>
+              </a:rPr>
+              <a:t>Razona sobre lo que va encontrando, llamando a herramientas</a:t>
+            </a:r>
+            <a:endParaRPr lang="en-US" sz="1500" dirty="0"/>
+          </a:p>
+          <a:p>
+            <a:pPr marL="342900" indent="-342900">
+              <a:lnSpc>
+                <a:spcPts val="2100"/>
+              </a:lnSpc>
+              <a:spcAft>
+                <a:spcPts val="1100"/>
+              </a:spcAft>
+              <a:buSzPct val="100000"/>
+              <a:buChar char="•"/>
+            </a:pPr>
+            <a:r>
+              <a:rPr lang="en-US" sz="1500" dirty="0">
+                <a:solidFill>
+                  <a:srgbClr val="1A1C2E"/>
+                </a:solidFill>
+                <a:latin typeface="Calibri" pitchFamily="34" charset="0"/>
+                <a:ea typeface="Calibri" pitchFamily="34" charset="-122"/>
+                <a:cs typeface="Calibri" pitchFamily="34" charset="-120"/>
+              </a:rPr>
+              <a:t>Necesita el coche, la API del modelo y los índices vectoriales</a:t>
+            </a:r>
+            <a:endParaRPr lang="en-US" sz="1500" dirty="0"/>
+          </a:p>
+          <a:p>
+            <a:pPr marL="342900" indent="-342900">
+              <a:lnSpc>
+                <a:spcPts val="2100"/>
+              </a:lnSpc>
+              <a:spcAft>
+                <a:spcPts val="1100"/>
+              </a:spcAft>
+              <a:buSzPct val="100000"/>
+              <a:buChar char="•"/>
+            </a:pPr>
+            <a:r>
+              <a:rPr lang="en-US" sz="1500" dirty="0">
+                <a:solidFill>
+                  <a:srgbClr val="1A1C2E"/>
+                </a:solidFill>
+                <a:latin typeface="Calibri" pitchFamily="34" charset="0"/>
+                <a:ea typeface="Calibri" pitchFamily="34" charset="-122"/>
+                <a:cs typeface="Calibri" pitchFamily="34" charset="-120"/>
+              </a:rPr>
+              <a:t>Hasta 60 segundos de límite</a:t>
+            </a:r>
+            <a:endParaRPr lang="en-US" sz="1500" dirty="0"/>
+          </a:p>
+          <a:p>
+            <a:pPr marL="342900" indent="-342900">
+              <a:lnSpc>
+                <a:spcPts val="2100"/>
+              </a:lnSpc>
+              <a:spcAft>
+                <a:spcPts val="1100"/>
+              </a:spcAft>
+              <a:buSzPct val="100000"/>
+              <a:buChar char="•"/>
+            </a:pPr>
+            <a:r>
+              <a:rPr lang="en-US" sz="1500" dirty="0">
+                <a:solidFill>
+                  <a:srgbClr val="1A1C2E"/>
+                </a:solidFill>
+                <a:latin typeface="Calibri" pitchFamily="34" charset="0"/>
+                <a:ea typeface="Calibri" pitchFamily="34" charset="-122"/>
+                <a:cs typeface="Calibri" pitchFamily="34" charset="-120"/>
+              </a:rPr>
               <a:t>Y aprende: indexa PIDs, DTCs y el caso resuelto</a:t>
             </a:r>
             <a:endParaRPr lang="en-US" sz="1500" dirty="0"/>
@@ -3761,7 +4439,7 @@
                 <a:ea typeface="Calibri" pitchFamily="34" charset="-122"/>
                 <a:cs typeface="Calibri" pitchFamily="34" charset="-120"/>
               </a:rPr>
-              <a:t>11</a:t>
+              <a:t>12</a:t>
             </a:r>
             <a:endParaRPr lang="en-US" sz="1000" dirty="0"/>
           </a:p>

</xml_diff>

<commit_message>
docs(tfm): detallar el modelo de embeddings junto al de lenguaje
</commit_message>
<xml_diff>
--- a/docs/presentacion/tfm-intelligent-automotive-diagnostics.pptx
+++ b/docs/presentacion/tfm-intelligent-automotive-diagnostics.pptx
@@ -699,10 +699,10 @@
           <a:p>
             <a:r>
               <a:rPr lang="en-US" dirty="0"/>
-              <a:t>Dos cosas que van juntas: lo de fuera se sustituye, y lo que se aprende se queda.
-Cambiar de proveedor de modelo es una variable de entorno. Los dos clientes, el de Anthropic y el de OpenAI, implementan el mismo puerto, así que la capa de aplicación no se entera de cuál está detrás. Y el adaptador de OpenAI no vale solo para OpenAI: sirve para cualquier proveedor compatible con su API, o sea DeepSeek, Groq, Mistral o xAI, cambiando la URL base. Los embeddings no dependen ni de eso, porque el modelo corre en la propia máquina: sin clave, sin latencia de red y sin coste por consulta.
-La otra mitad es el aprendizaje. El agente se topa con un PID o un DTC que no está en el catálogo, lo valida contra el coche cuando se puede, y lo indexa con la confianza que le corresponde según de dónde salga. En el siguiente coche parecido, eso vuelve como caso similar.
-Y hay una pieza que quiero decir en voz alta porque está a medias a propósito. Tengo implementada y testeada la función que sube la confianza de un dato cada vez que se reutiliza con éxito, pero no la llamo desde ningún flujo. El motivo es que para subirla haría falta saber que el diagnóstico acertó de verdad, y ese dato el sistema no lo tiene: nadie le dice si el coche se arregló. Inventármelo habría degradado el catálogo, así que preferí dejarlo fuera de alcance y documentarlo.
+              <a:t>Aquí hay dos modelos, y no hacen lo mismo.
+El de lenguaje es el que razona, y es intercambiable: una variable de entorno decide si va contra Anthropic o contra OpenAI. Los dos clientes implementan el mismo puerto, así que la capa de aplicación no se entera de cuál hay detrás. Y el adaptador de OpenAI no vale solo para OpenAI: sirve para cualquier proveedor compatible con su API —DeepSeek, Groq, Mistral, xAI— cambiando la URL base. Si no hay ninguno configurado, el diagnóstico determinista sigue funcionando.
+El de embeddings es distinto: no se cambia, va dentro. Es un modelo pequeño que corre en la propia máquina con transformers.js. Coge un texto —la descripción de un PID, la narrativa de un diagnóstico— y lo convierte en 384 números, normalizados, que es lo que se guarda en la base vectorial. Buscar por parecido es comparar esos vectores.
+Que corra en local significa tres cosas: no hace falta clave, no hay latencia de red y no se paga por consulta. Y como es multilingüe, español e inglés caen cerca en ese espacio: por eso "presión de aceite" encuentra una ficha que pone "oil pressure", que es justo lo que un buscador de texto no hace.
 [~65 s]</a:t>
             </a:r>
             <a:endParaRPr lang="en-US" dirty="0"/>
@@ -1440,6 +1440,7 @@
 A la izquierda tenéis un caso resuelto tal cual se guarda. El campo embeddedText es el texto que se convierte en vector, y es lo que luego permite encontrarlo por parecido. Los síntomas y los PIDs implicados van aparte, y el fabricante y el modelo también, para poder filtrar: si estoy con un Audi no quiero que me salgan casos de una Kawasaki.
 Y luego está el índice de confianza, que se lo ponemos nosotros al guardar según de dónde venga el dato. Si lo encontró el agente en internet entra con 0,3. Si viene de un diagnóstico anterior, 0,5. Si lo aportó el mecánico a mano, 0,8, porque una persona delante del coche sabe más que una web cualquiera. Y si se ha leído del propio coche por OBD es un hecho: 1,0. Comprobar un dato contra el coche sube la web a 0,7 y al mecánico a 0,9.
 Ese índice no es decorativo: es lo que pondera las búsquedas. Cuando al agente le llegan dos respuestas que se contradicen, gana la que más confianza tiene.
+[Si preguntan por el escalado] Hay dos mecanismos distintos y conviene no mezclarlos. Que el mecánico aporte o confirme un dato sube su confianza a 0,8, y validarlo contra el coche lo lleva a 0,9: eso está implementado y funciona. Lo que dejé fuera a propósito es subir la confianza de un caso cada vez que se reutiliza con acierto. La función existe y está testeada, pero no la llamo desde ningún flujo, porque para eso haría falta saber que el diagnóstico acertó de verdad, y nadie le dice al sistema si el coche se arregló. Inventármelo habría degradado el catálogo.
 [~70 s]</a:t>
             </a:r>
             <a:endParaRPr lang="en-US" dirty="0"/>
@@ -3316,7 +3317,7 @@
                 <a:ea typeface="Arial" pitchFamily="34" charset="-122"/>
                 <a:cs typeface="Arial" pitchFamily="34" charset="-120"/>
               </a:rPr>
-              <a:t>Cambiar de modelo, y aprender del uso</a:t>
+              <a:t>Los dos modelos</a:t>
             </a:r>
             <a:endParaRPr lang="en-US" sz="3400" dirty="0"/>
           </a:p>
@@ -3355,7 +3356,7 @@
                 <a:ea typeface="Calibri" pitchFamily="34" charset="-122"/>
                 <a:cs typeface="Calibri" pitchFamily="34" charset="-120"/>
               </a:rPr>
-              <a:t>Lo de fuera se sustituye. Lo que el sistema aprende se queda.</a:t>
+              <a:t>Uno razona y se puede cambiar. El otro convierte texto en vectores y va dentro.</a:t>
             </a:r>
             <a:endParaRPr lang="en-US" sz="1700" dirty="0"/>
           </a:p>
@@ -3394,7 +3395,7 @@
                 <a:ea typeface="Arial" pitchFamily="34" charset="-122"/>
                 <a:cs typeface="Arial" pitchFamily="34" charset="-120"/>
               </a:rPr>
-              <a:t>Cambiar de proveedor</a:t>
+              <a:t>El modelo de lenguaje</a:t>
             </a:r>
             <a:endParaRPr lang="en-US" sz="1900" dirty="0"/>
           </a:p>
@@ -3512,7 +3513,7 @@
                 <a:ea typeface="Calibri" pitchFamily="34" charset="-122"/>
                 <a:cs typeface="Calibri" pitchFamily="34" charset="-120"/>
               </a:rPr>
-              <a:t>Los embeddings ni eso: el modelo corre en la propia máquina</a:t>
+              <a:t>Sin proveedor configurado, el diagnóstico determinista sigue funcionando</a:t>
             </a:r>
             <a:endParaRPr lang="en-US" sz="1500" dirty="0"/>
           </a:p>
@@ -3551,7 +3552,7 @@
                 <a:ea typeface="Arial" pitchFamily="34" charset="-122"/>
                 <a:cs typeface="Arial" pitchFamily="34" charset="-120"/>
               </a:rPr>
-              <a:t>Aprender del uso</a:t>
+              <a:t>El modelo de embeddings</a:t>
             </a:r>
             <a:endParaRPr lang="en-US" sz="1900" dirty="0"/>
           </a:p>
@@ -3566,7 +3567,46 @@
         <p:spPr>
           <a:xfrm>
             <a:off x="6537960" y="2788920"/>
-            <a:ext cx="4846320" cy="2834640"/>
+            <a:ext cx="4846320" cy="274320"/>
+          </a:xfrm>
+          <a:prstGeom prst="rect">
+            <a:avLst/>
+          </a:prstGeom>
+          <a:noFill/>
+          <a:ln/>
+        </p:spPr>
+        <p:txBody>
+          <a:bodyPr wrap="square" lIns="0" tIns="0" rIns="0" bIns="0" rtlCol="0" anchor="t"/>
+          <a:lstStyle/>
+          <a:p>
+            <a:pPr indent="0" marL="0">
+              <a:buNone/>
+            </a:pPr>
+            <a:r>
+              <a:rPr lang="en-US" sz="1200" b="1" dirty="0">
+                <a:solidFill>
+                  <a:srgbClr val="1A1C2E"/>
+                </a:solidFill>
+                <a:latin typeface="Courier New" pitchFamily="34" charset="0"/>
+                <a:ea typeface="Courier New" pitchFamily="34" charset="-122"/>
+                <a:cs typeface="Courier New" pitchFamily="34" charset="-120"/>
+              </a:rPr>
+              <a:t>paraphrase-multilingual-MiniLM-L12-v2</a:t>
+            </a:r>
+            <a:endParaRPr lang="en-US" sz="1200" dirty="0"/>
+          </a:p>
+        </p:txBody>
+      </p:sp>
+      <p:sp>
+        <p:nvSpPr>
+          <p:cNvPr id="8" name="Text 6"/>
+          <p:cNvSpPr/>
+          <p:nvPr/>
+        </p:nvSpPr>
+        <p:spPr>
+          <a:xfrm>
+            <a:off x="6537960" y="3200400"/>
+            <a:ext cx="4846320" cy="2560320"/>
           </a:xfrm>
           <a:prstGeom prst="rect">
             <a:avLst/>
@@ -3597,7 +3637,7 @@
                 <a:ea typeface="Calibri" pitchFamily="34" charset="-122"/>
                 <a:cs typeface="Calibri" pitchFamily="34" charset="-120"/>
               </a:rPr>
-              <a:t>El agente se topa con un PID o un DTC que no está en el catálogo</a:t>
+              <a:t>Corre en la propia máquina, con transformers.js</a:t>
             </a:r>
             <a:endParaRPr lang="en-US" sz="1500" dirty="0"/>
           </a:p>
@@ -3621,7 +3661,7 @@
                 <a:ea typeface="Calibri" pitchFamily="34" charset="-122"/>
                 <a:cs typeface="Calibri" pitchFamily="34" charset="-120"/>
               </a:rPr>
-              <a:t>Lo valida contra el coche cuando se puede</a:t>
+              <a:t>Sin clave, sin red y sin coste por consulta</a:t>
             </a:r>
             <a:endParaRPr lang="en-US" sz="1500" dirty="0"/>
           </a:p>
@@ -3645,7 +3685,7 @@
                 <a:ea typeface="Calibri" pitchFamily="34" charset="-122"/>
                 <a:cs typeface="Calibri" pitchFamily="34" charset="-120"/>
               </a:rPr>
-              <a:t>Lo indexa con la confianza de su fuente</a:t>
+              <a:t>Convierte cada texto en 384 números, normalizados</a:t>
             </a:r>
             <a:endParaRPr lang="en-US" sz="1500" dirty="0"/>
           </a:p>
@@ -3669,39 +3709,15 @@
                 <a:ea typeface="Calibri" pitchFamily="34" charset="-122"/>
                 <a:cs typeface="Calibri" pitchFamily="34" charset="-120"/>
               </a:rPr>
-              <a:t>Y en el siguiente coche vuelve como caso parecido</a:t>
+              <a:t>Es multilingüe: por eso «presión de aceite» encuentra «oil pressure»</a:t>
             </a:r>
             <a:endParaRPr lang="en-US" sz="1500" dirty="0"/>
           </a:p>
-          <a:p>
-            <a:pPr marL="342900" indent="-342900">
-              <a:lnSpc>
-                <a:spcPts val="2100"/>
-              </a:lnSpc>
-              <a:spcAft>
-                <a:spcPts val="1100"/>
-              </a:spcAft>
-              <a:buSzPct val="100000"/>
-              <a:buChar char="•"/>
-            </a:pPr>
-            <a:r>
-              <a:rPr lang="en-US" sz="1500" dirty="0">
-                <a:solidFill>
-                  <a:srgbClr val="1A1C2E"/>
-                </a:solidFill>
-                <a:latin typeface="Calibri" pitchFamily="34" charset="0"/>
-                <a:ea typeface="Calibri" pitchFamily="34" charset="-122"/>
-                <a:cs typeface="Calibri" pitchFamily="34" charset="-120"/>
-              </a:rPr>
-              <a:t>Lo que no está: subir la confianza cuando un caso acierta. Habría que saber que acertó, y el sistema no lo sabe</a:t>
-            </a:r>
-            <a:endParaRPr lang="en-US" sz="1500" dirty="0"/>
-          </a:p>
-        </p:txBody>
-      </p:sp>
-      <p:sp>
-        <p:nvSpPr>
-          <p:cNvPr id="8" name="Shape 6"/>
+        </p:txBody>
+      </p:sp>
+      <p:sp>
+        <p:nvSpPr>
+          <p:cNvPr id="9" name="Shape 7"/>
           <p:cNvSpPr/>
           <p:nvPr/>
         </p:nvSpPr>
@@ -3721,7 +3737,7 @@
       </p:sp>
       <p:sp>
         <p:nvSpPr>
-          <p:cNvPr id="9" name="Text 7"/>
+          <p:cNvPr id="10" name="Text 8"/>
           <p:cNvSpPr/>
           <p:nvPr/>
         </p:nvSpPr>
@@ -3760,7 +3776,7 @@
       </p:sp>
       <p:sp>
         <p:nvSpPr>
-          <p:cNvPr id="10" name="Text 8"/>
+          <p:cNvPr id="11" name="Text 9"/>
           <p:cNvSpPr/>
           <p:nvPr/>
         </p:nvSpPr>
@@ -3799,7 +3815,7 @@
       </p:sp>
       <p:sp>
         <p:nvSpPr>
-          <p:cNvPr id="11" name="Text 9"/>
+          <p:cNvPr id="12" name="Text 10"/>
           <p:cNvSpPr/>
           <p:nvPr/>
         </p:nvSpPr>

</xml_diff>

<commit_message>
docs(tfm): slide de demo con capturas reales
</commit_message>
<xml_diff>
--- a/docs/presentacion/tfm-intelligent-automotive-diagnostics.pptx
+++ b/docs/presentacion/tfm-intelligent-automotive-diagnostics.pptx
@@ -17,9 +17,10 @@
     <p:sldId id="265" r:id="rId11"/>
     <p:sldId id="266" r:id="rId12"/>
     <p:sldId id="267" r:id="rId13"/>
+    <p:sldId id="268" r:id="rId14"/>
   </p:sldIdLst>
   <p:notesMasterIdLst>
-    <p:notesMasterId r:id="rId14"/>
+    <p:notesMasterId r:id="rId15"/>
   </p:notesMasterIdLst>
   <p:sldSz cx="12192000" cy="6858000"/>
   <p:notesSz cx="6858000" cy="12192000"/>
@@ -819,6 +820,99 @@
             <a:fld id="{F7021451-1387-4CA6-816F-3879F97B5CBC}" type="slidenum">
               <a:rPr lang="en-US"/>
               <a:t>12</a:t>
+            </a:fld>
+            <a:endParaRPr lang="en-US"/>
+          </a:p>
+        </p:txBody>
+      </p:sp>
+    </p:spTree>
+    <p:extLst>
+      <p:ext uri="{BB962C8B-B14F-4D97-AF65-F5344CB8AC3E}">
+        <p14:creationId xmlns:p14="http://schemas.microsoft.com/office/powerpoint/2010/main" val="1024086991"/>
+      </p:ext>
+    </p:extLst>
+  </p:cSld>
+  <p:clrMapOvr>
+    <a:masterClrMapping/>
+  </p:clrMapOvr>
+</p:notes>
+</file>
+
+<file path=ppt/notesSlides/notesSlide13.xml><?xml version="1.0" encoding="utf-8"?>
+<p:notes xmlns:a="http://schemas.openxmlformats.org/drawingml/2006/main" xmlns:r="http://schemas.openxmlformats.org/officeDocument/2006/relationships" xmlns:p="http://schemas.openxmlformats.org/presentationml/2006/main">
+  <p:cSld>
+    <p:spTree>
+      <p:nvGrpSpPr>
+        <p:cNvPr id="1" name=""/>
+        <p:cNvGrpSpPr/>
+        <p:nvPr/>
+      </p:nvGrpSpPr>
+      <p:grpSpPr>
+        <a:xfrm>
+          <a:off x="0" y="0"/>
+          <a:ext cx="0" cy="0"/>
+          <a:chOff x="0" y="0"/>
+          <a:chExt cx="0" cy="0"/>
+        </a:xfrm>
+      </p:grpSpPr>
+      <p:sp>
+        <p:nvSpPr>
+          <p:cNvPr id="2" name="Slide Image Placeholder 1"/>
+          <p:cNvSpPr>
+            <a:spLocks noGrp="1" noRot="1" noChangeAspect="1"/>
+          </p:cNvSpPr>
+          <p:nvPr>
+            <p:ph type="sldImg"/>
+          </p:nvPr>
+        </p:nvSpPr>
+        <p:spPr/>
+      </p:sp>
+      <p:sp>
+        <p:nvSpPr>
+          <p:cNvPr id="3" name="Notes Placeholder 2"/>
+          <p:cNvSpPr>
+            <a:spLocks noGrp="1"/>
+          </p:cNvSpPr>
+          <p:nvPr>
+            <p:ph type="body" idx="1"/>
+          </p:nvPr>
+        </p:nvSpPr>
+        <p:spPr/>
+        <p:txBody>
+          <a:bodyPr/>
+          <a:lstStyle/>
+          <a:p>
+            <a:r>
+              <a:rPr lang="en-US" dirty="0"/>
+              <a:t>Esto es la aplicación corriendo contra un Audi A3 2.0 TDI. Y quiero subrayar una cosa: nada de lo que se ve está escrito a mano. Todo sale del bus del coche.
+Arriba a la izquierda, la identificación. El sistema no sabe qué coche es: lo pregunta con el modo 09, saca el bastidor, decodifica el WMI y resuelve Audi, fabricado en Alemania. De ahí salen marca, modelo, año y motor.
+Al lado, la telemetría en vivo, y debajo los PIDs que este vehículo declara soportar, que no son una lista fija: se leen del bitmask del PID 00.
+Abajo a la izquierda, las averías. Tres códigos confirmados, y las tres pestañas son los servicios 03, 07 y 0A del estándar: almacenadas, pendientes y permanentes.
+Y a la derecha el informe, que se congela con la sesión: si dentro de seis meses alguien abre ese diagnóstico, ve exactamente lo que se vio ese día.
+[~2 min contando la demo. Si hay vídeo del coche real, va aquí.]</a:t>
+            </a:r>
+            <a:endParaRPr lang="en-US" dirty="0"/>
+          </a:p>
+        </p:txBody>
+      </p:sp>
+      <p:sp>
+        <p:nvSpPr>
+          <p:cNvPr id="4" name="Slide Number Placeholder 3"/>
+          <p:cNvSpPr>
+            <a:spLocks noGrp="1"/>
+          </p:cNvSpPr>
+          <p:nvPr>
+            <p:ph type="sldNum" sz="quarter" idx="10"/>
+          </p:nvPr>
+        </p:nvSpPr>
+        <p:spPr/>
+        <p:txBody>
+          <a:bodyPr/>
+          <a:lstStyle/>
+          <a:p>
+            <a:fld id="{F7021451-1387-4CA6-816F-3879F97B5CBC}" type="slidenum">
+              <a:rPr lang="en-US"/>
+              <a:t>13</a:t>
             </a:fld>
             <a:endParaRPr lang="en-US"/>
           </a:p>
@@ -4469,6 +4563,533 @@
 </p:sld>
 </file>
 
+<file path=ppt/slides/slide13.xml><?xml version="1.0" encoding="utf-8"?>
+<p:sld xmlns:a="http://schemas.openxmlformats.org/drawingml/2006/main" xmlns:r="http://schemas.openxmlformats.org/officeDocument/2006/relationships" xmlns:p="http://schemas.openxmlformats.org/presentationml/2006/main">
+  <p:cSld name="Slide 13">
+    <p:bg>
+      <p:bgPr>
+        <a:solidFill>
+          <a:srgbClr val="FFFFFF"/>
+        </a:solidFill>
+      </p:bgPr>
+    </p:bg>
+    <p:spTree>
+      <p:nvGrpSpPr>
+        <p:cNvPr id="1" name=""/>
+        <p:cNvGrpSpPr/>
+        <p:nvPr/>
+      </p:nvGrpSpPr>
+      <p:grpSpPr>
+        <a:xfrm>
+          <a:off x="0" y="0"/>
+          <a:ext cx="0" cy="0"/>
+          <a:chOff x="0" y="0"/>
+          <a:chExt cx="0" cy="0"/>
+        </a:xfrm>
+      </p:grpSpPr>
+      <p:sp>
+        <p:nvSpPr>
+          <p:cNvPr id="2" name="Text 0"/>
+          <p:cNvSpPr/>
+          <p:nvPr/>
+        </p:nvSpPr>
+        <p:spPr>
+          <a:xfrm>
+            <a:off x="777240" y="502920"/>
+            <a:ext cx="10607040" cy="685800"/>
+          </a:xfrm>
+          <a:prstGeom prst="rect">
+            <a:avLst/>
+          </a:prstGeom>
+          <a:noFill/>
+          <a:ln/>
+        </p:spPr>
+        <p:txBody>
+          <a:bodyPr wrap="square" lIns="0" tIns="0" rIns="0" bIns="0" rtlCol="0" anchor="t"/>
+          <a:lstStyle/>
+          <a:p>
+            <a:pPr indent="0" marL="0">
+              <a:buNone/>
+            </a:pPr>
+            <a:r>
+              <a:rPr lang="en-US" sz="3200" b="1" dirty="0">
+                <a:solidFill>
+                  <a:srgbClr val="1A1C2E"/>
+                </a:solidFill>
+                <a:latin typeface="Arial" pitchFamily="34" charset="0"/>
+                <a:ea typeface="Arial" pitchFamily="34" charset="-122"/>
+                <a:cs typeface="Arial" pitchFamily="34" charset="-120"/>
+              </a:rPr>
+              <a:t>La aplicación funcionando</a:t>
+            </a:r>
+            <a:endParaRPr lang="en-US" sz="3200" dirty="0"/>
+          </a:p>
+        </p:txBody>
+      </p:sp>
+      <p:sp>
+        <p:nvSpPr>
+          <p:cNvPr id="3" name="Text 1"/>
+          <p:cNvSpPr/>
+          <p:nvPr/>
+        </p:nvSpPr>
+        <p:spPr>
+          <a:xfrm>
+            <a:off x="777240" y="1261872"/>
+            <a:ext cx="10607040" cy="320040"/>
+          </a:xfrm>
+          <a:prstGeom prst="rect">
+            <a:avLst/>
+          </a:prstGeom>
+          <a:noFill/>
+          <a:ln/>
+        </p:spPr>
+        <p:txBody>
+          <a:bodyPr wrap="square" lIns="0" tIns="0" rIns="0" bIns="0" rtlCol="0" anchor="t"/>
+          <a:lstStyle/>
+          <a:p>
+            <a:pPr indent="0" marL="0">
+              <a:buNone/>
+            </a:pPr>
+            <a:r>
+              <a:rPr lang="en-US" sz="1500" dirty="0">
+                <a:solidFill>
+                  <a:srgbClr val="5A5F73"/>
+                </a:solidFill>
+                <a:latin typeface="Calibri" pitchFamily="34" charset="0"/>
+                <a:ea typeface="Calibri" pitchFamily="34" charset="-122"/>
+                <a:cs typeface="Calibri" pitchFamily="34" charset="-120"/>
+              </a:rPr>
+              <a:t>Audi A3 2.0 TDI. Todo lo que se ve viene leído del bus, nada está escrito a mano.</a:t>
+            </a:r>
+            <a:endParaRPr lang="en-US" sz="1500" dirty="0"/>
+          </a:p>
+        </p:txBody>
+      </p:sp>
+      <p:sp>
+        <p:nvSpPr>
+          <p:cNvPr id="4" name="Text 2"/>
+          <p:cNvSpPr/>
+          <p:nvPr/>
+        </p:nvSpPr>
+        <p:spPr>
+          <a:xfrm>
+            <a:off x="777240" y="1874520"/>
+            <a:ext cx="4572000" cy="256032"/>
+          </a:xfrm>
+          <a:prstGeom prst="rect">
+            <a:avLst/>
+          </a:prstGeom>
+          <a:noFill/>
+          <a:ln/>
+        </p:spPr>
+        <p:txBody>
+          <a:bodyPr wrap="square" lIns="0" tIns="0" rIns="0" bIns="0" rtlCol="0" anchor="t"/>
+          <a:lstStyle/>
+          <a:p>
+            <a:pPr indent="0" marL="0">
+              <a:buNone/>
+            </a:pPr>
+            <a:r>
+              <a:rPr lang="en-US" sz="1200" dirty="0">
+                <a:solidFill>
+                  <a:srgbClr val="1A1C2E"/>
+                </a:solidFill>
+                <a:latin typeface="Calibri" pitchFamily="34" charset="0"/>
+                <a:ea typeface="Calibri" pitchFamily="34" charset="-122"/>
+                <a:cs typeface="Calibri" pitchFamily="34" charset="-120"/>
+              </a:rPr>
+              <a:t>Lee el VIN del bus y saca marca, modelo y motor</a:t>
+            </a:r>
+            <a:endParaRPr lang="en-US" sz="1200" dirty="0"/>
+          </a:p>
+        </p:txBody>
+      </p:sp>
+      <p:pic>
+        <p:nvPicPr>
+          <p:cNvPr id="5" name="Image 0" descr="/home/user/intelligent-automotive-diagnostics/docs/presentacion/capturas/demo/01-identificacion-vin.png">    </p:cNvPr>
+          <p:cNvPicPr>
+            <a:picLocks noChangeAspect="1"/>
+          </p:cNvPicPr>
+          <p:nvPr/>
+        </p:nvPicPr>
+        <p:blipFill>
+          <a:blip r:embed="rId1"/>
+          <a:stretch>
+            <a:fillRect/>
+          </a:stretch>
+        </p:blipFill>
+        <p:spPr>
+          <a:xfrm>
+            <a:off x="777240" y="2176272"/>
+            <a:ext cx="4572000" cy="1714500"/>
+          </a:xfrm>
+          <a:prstGeom prst="rect">
+            <a:avLst/>
+          </a:prstGeom>
+          <a:effectLst>
+            <a:outerShdw sx="100000" sy="100000" kx="0" ky="0" algn="bl" rotWithShape="0" blurRad="152400" dist="38100" dir="5400000">
+              <a:srgbClr val="000000">
+                <a:alpha val="28000"/>
+              </a:srgbClr>
+            </a:outerShdw>
+          </a:effectLst>
+        </p:spPr>
+      </p:pic>
+      <p:sp>
+        <p:nvSpPr>
+          <p:cNvPr id="6" name="Text 3"/>
+          <p:cNvSpPr/>
+          <p:nvPr/>
+        </p:nvSpPr>
+        <p:spPr>
+          <a:xfrm>
+            <a:off x="6812280" y="1874520"/>
+            <a:ext cx="4572000" cy="256032"/>
+          </a:xfrm>
+          <a:prstGeom prst="rect">
+            <a:avLst/>
+          </a:prstGeom>
+          <a:noFill/>
+          <a:ln/>
+        </p:spPr>
+        <p:txBody>
+          <a:bodyPr wrap="square" lIns="0" tIns="0" rIns="0" bIns="0" rtlCol="0" anchor="t"/>
+          <a:lstStyle/>
+          <a:p>
+            <a:pPr indent="0" marL="0">
+              <a:buNone/>
+            </a:pPr>
+            <a:r>
+              <a:rPr lang="en-US" sz="1200" dirty="0">
+                <a:solidFill>
+                  <a:srgbClr val="1A1C2E"/>
+                </a:solidFill>
+                <a:latin typeface="Calibri" pitchFamily="34" charset="0"/>
+                <a:ea typeface="Calibri" pitchFamily="34" charset="-122"/>
+                <a:cs typeface="Calibri" pitchFamily="34" charset="-120"/>
+              </a:rPr>
+              <a:t>Telemetría en vivo y los PIDs que soporta</a:t>
+            </a:r>
+            <a:endParaRPr lang="en-US" sz="1200" dirty="0"/>
+          </a:p>
+        </p:txBody>
+      </p:sp>
+      <p:pic>
+        <p:nvPicPr>
+          <p:cNvPr id="7" name="Image 1" descr="/home/user/intelligent-automotive-diagnostics/docs/presentacion/capturas/demo/02-datos-vivo.png">    </p:cNvPr>
+          <p:cNvPicPr>
+            <a:picLocks noChangeAspect="1"/>
+          </p:cNvPicPr>
+          <p:nvPr/>
+        </p:nvPicPr>
+        <p:blipFill>
+          <a:blip r:embed="rId2"/>
+          <a:stretch>
+            <a:fillRect/>
+          </a:stretch>
+        </p:blipFill>
+        <p:spPr>
+          <a:xfrm>
+            <a:off x="6812280" y="2176272"/>
+            <a:ext cx="4572000" cy="1714500"/>
+          </a:xfrm>
+          <a:prstGeom prst="rect">
+            <a:avLst/>
+          </a:prstGeom>
+          <a:effectLst>
+            <a:outerShdw sx="100000" sy="100000" kx="0" ky="0" algn="bl" rotWithShape="0" blurRad="152400" dist="38100" dir="5400000">
+              <a:srgbClr val="000000">
+                <a:alpha val="28000"/>
+              </a:srgbClr>
+            </a:outerShdw>
+          </a:effectLst>
+        </p:spPr>
+      </p:pic>
+      <p:sp>
+        <p:nvSpPr>
+          <p:cNvPr id="8" name="Text 4"/>
+          <p:cNvSpPr/>
+          <p:nvPr/>
+        </p:nvSpPr>
+        <p:spPr>
+          <a:xfrm>
+            <a:off x="777240" y="4023360"/>
+            <a:ext cx="4572000" cy="256032"/>
+          </a:xfrm>
+          <a:prstGeom prst="rect">
+            <a:avLst/>
+          </a:prstGeom>
+          <a:noFill/>
+          <a:ln/>
+        </p:spPr>
+        <p:txBody>
+          <a:bodyPr wrap="square" lIns="0" tIns="0" rIns="0" bIns="0" rtlCol="0" anchor="t"/>
+          <a:lstStyle/>
+          <a:p>
+            <a:pPr indent="0" marL="0">
+              <a:buNone/>
+            </a:pPr>
+            <a:r>
+              <a:rPr lang="en-US" sz="1200" dirty="0">
+                <a:solidFill>
+                  <a:srgbClr val="1A1C2E"/>
+                </a:solidFill>
+                <a:latin typeface="Calibri" pitchFamily="34" charset="0"/>
+                <a:ea typeface="Calibri" pitchFamily="34" charset="-122"/>
+                <a:cs typeface="Calibri" pitchFamily="34" charset="-120"/>
+              </a:rPr>
+              <a:t>Las averías: modos 03, 07 y 0A</a:t>
+            </a:r>
+            <a:endParaRPr lang="en-US" sz="1200" dirty="0"/>
+          </a:p>
+        </p:txBody>
+      </p:sp>
+      <p:pic>
+        <p:nvPicPr>
+          <p:cNvPr id="9" name="Image 2" descr="/home/user/intelligent-automotive-diagnostics/docs/presentacion/capturas/demo/03-codigos-dtc.png">    </p:cNvPr>
+          <p:cNvPicPr>
+            <a:picLocks noChangeAspect="1"/>
+          </p:cNvPicPr>
+          <p:nvPr/>
+        </p:nvPicPr>
+        <p:blipFill>
+          <a:blip r:embed="rId3"/>
+          <a:stretch>
+            <a:fillRect/>
+          </a:stretch>
+        </p:blipFill>
+        <p:spPr>
+          <a:xfrm>
+            <a:off x="777240" y="4325112"/>
+            <a:ext cx="4572000" cy="1714500"/>
+          </a:xfrm>
+          <a:prstGeom prst="rect">
+            <a:avLst/>
+          </a:prstGeom>
+          <a:effectLst>
+            <a:outerShdw sx="100000" sy="100000" kx="0" ky="0" algn="bl" rotWithShape="0" blurRad="152400" dist="38100" dir="5400000">
+              <a:srgbClr val="000000">
+                <a:alpha val="28000"/>
+              </a:srgbClr>
+            </a:outerShdw>
+          </a:effectLst>
+        </p:spPr>
+      </p:pic>
+      <p:sp>
+        <p:nvSpPr>
+          <p:cNvPr id="10" name="Text 5"/>
+          <p:cNvSpPr/>
+          <p:nvPr/>
+        </p:nvSpPr>
+        <p:spPr>
+          <a:xfrm>
+            <a:off x="6812280" y="4023360"/>
+            <a:ext cx="4572000" cy="256032"/>
+          </a:xfrm>
+          <a:prstGeom prst="rect">
+            <a:avLst/>
+          </a:prstGeom>
+          <a:noFill/>
+          <a:ln/>
+        </p:spPr>
+        <p:txBody>
+          <a:bodyPr wrap="square" lIns="0" tIns="0" rIns="0" bIns="0" rtlCol="0" anchor="t"/>
+          <a:lstStyle/>
+          <a:p>
+            <a:pPr indent="0" marL="0">
+              <a:buNone/>
+            </a:pPr>
+            <a:r>
+              <a:rPr lang="en-US" sz="1200" dirty="0">
+                <a:solidFill>
+                  <a:srgbClr val="1A1C2E"/>
+                </a:solidFill>
+                <a:latin typeface="Calibri" pitchFamily="34" charset="0"/>
+                <a:ea typeface="Calibri" pitchFamily="34" charset="-122"/>
+                <a:cs typeface="Calibri" pitchFamily="34" charset="-120"/>
+              </a:rPr>
+              <a:t>El informe que se congela con la sesión</a:t>
+            </a:r>
+            <a:endParaRPr lang="en-US" sz="1200" dirty="0"/>
+          </a:p>
+        </p:txBody>
+      </p:sp>
+      <p:pic>
+        <p:nvPicPr>
+          <p:cNvPr id="11" name="Image 3" descr="/home/user/intelligent-automotive-diagnostics/docs/presentacion/capturas/demo/08-informe.png">    </p:cNvPr>
+          <p:cNvPicPr>
+            <a:picLocks noChangeAspect="1"/>
+          </p:cNvPicPr>
+          <p:nvPr/>
+        </p:nvPicPr>
+        <p:blipFill>
+          <a:blip r:embed="rId4"/>
+          <a:stretch>
+            <a:fillRect/>
+          </a:stretch>
+        </p:blipFill>
+        <p:spPr>
+          <a:xfrm>
+            <a:off x="6812280" y="4325112"/>
+            <a:ext cx="4572000" cy="1714500"/>
+          </a:xfrm>
+          <a:prstGeom prst="rect">
+            <a:avLst/>
+          </a:prstGeom>
+          <a:effectLst>
+            <a:outerShdw sx="100000" sy="100000" kx="0" ky="0" algn="bl" rotWithShape="0" blurRad="152400" dist="38100" dir="5400000">
+              <a:srgbClr val="000000">
+                <a:alpha val="28000"/>
+              </a:srgbClr>
+            </a:outerShdw>
+          </a:effectLst>
+        </p:spPr>
+      </p:pic>
+      <p:sp>
+        <p:nvSpPr>
+          <p:cNvPr id="12" name="Shape 6"/>
+          <p:cNvSpPr/>
+          <p:nvPr/>
+        </p:nvSpPr>
+        <p:spPr>
+          <a:xfrm>
+            <a:off x="777240" y="6263640"/>
+            <a:ext cx="219456" cy="219456"/>
+          </a:xfrm>
+          <a:prstGeom prst="rect">
+            <a:avLst/>
+          </a:prstGeom>
+          <a:solidFill>
+            <a:srgbClr val="202CFC"/>
+          </a:solidFill>
+          <a:ln/>
+        </p:spPr>
+      </p:sp>
+      <p:sp>
+        <p:nvSpPr>
+          <p:cNvPr id="13" name="Text 7"/>
+          <p:cNvSpPr/>
+          <p:nvPr/>
+        </p:nvSpPr>
+        <p:spPr>
+          <a:xfrm>
+            <a:off x="777240" y="6263640"/>
+            <a:ext cx="219456" cy="219456"/>
+          </a:xfrm>
+          <a:prstGeom prst="rect">
+            <a:avLst/>
+          </a:prstGeom>
+          <a:noFill/>
+          <a:ln/>
+        </p:spPr>
+        <p:txBody>
+          <a:bodyPr wrap="square" lIns="0" tIns="0" rIns="0" bIns="0" rtlCol="0" anchor="ctr"/>
+          <a:lstStyle/>
+          <a:p>
+            <a:pPr algn="ctr" indent="0" marL="0">
+              <a:buNone/>
+            </a:pPr>
+            <a:r>
+              <a:rPr lang="en-US" sz="816" b="1" dirty="0">
+                <a:solidFill>
+                  <a:srgbClr val="FFFFFF"/>
+                </a:solidFill>
+                <a:latin typeface="Arial" pitchFamily="34" charset="0"/>
+                <a:ea typeface="Arial" pitchFamily="34" charset="-122"/>
+                <a:cs typeface="Arial" pitchFamily="34" charset="-120"/>
+              </a:rPr>
+              <a:t>BIG</a:t>
+            </a:r>
+            <a:endParaRPr lang="en-US" sz="816" dirty="0"/>
+          </a:p>
+        </p:txBody>
+      </p:sp>
+      <p:sp>
+        <p:nvSpPr>
+          <p:cNvPr id="14" name="Text 8"/>
+          <p:cNvSpPr/>
+          <p:nvPr/>
+        </p:nvSpPr>
+        <p:spPr>
+          <a:xfrm>
+            <a:off x="1078992" y="6263640"/>
+            <a:ext cx="658368" cy="219456"/>
+          </a:xfrm>
+          <a:prstGeom prst="rect">
+            <a:avLst/>
+          </a:prstGeom>
+          <a:noFill/>
+          <a:ln/>
+        </p:spPr>
+        <p:txBody>
+          <a:bodyPr wrap="square" lIns="0" tIns="0" rIns="0" bIns="0" rtlCol="0" anchor="ctr"/>
+          <a:lstStyle/>
+          <a:p>
+            <a:pPr algn="l" indent="0" marL="0">
+              <a:buNone/>
+            </a:pPr>
+            <a:r>
+              <a:rPr lang="en-US" sz="816" dirty="0">
+                <a:solidFill>
+                  <a:srgbClr val="1A1C2E"/>
+                </a:solidFill>
+                <a:latin typeface="Arial" pitchFamily="34" charset="0"/>
+                <a:ea typeface="Arial" pitchFamily="34" charset="-122"/>
+                <a:cs typeface="Arial" pitchFamily="34" charset="-120"/>
+              </a:rPr>
+              <a:t>school</a:t>
+            </a:r>
+            <a:endParaRPr lang="en-US" sz="816" dirty="0"/>
+          </a:p>
+        </p:txBody>
+      </p:sp>
+      <p:sp>
+        <p:nvSpPr>
+          <p:cNvPr id="15" name="Text 9"/>
+          <p:cNvSpPr/>
+          <p:nvPr/>
+        </p:nvSpPr>
+        <p:spPr>
+          <a:xfrm>
+            <a:off x="11064240" y="6263640"/>
+            <a:ext cx="320040" cy="219456"/>
+          </a:xfrm>
+          <a:prstGeom prst="rect">
+            <a:avLst/>
+          </a:prstGeom>
+          <a:noFill/>
+          <a:ln/>
+        </p:spPr>
+        <p:txBody>
+          <a:bodyPr wrap="square" lIns="0" tIns="0" rIns="0" bIns="0" rtlCol="0" anchor="ctr"/>
+          <a:lstStyle/>
+          <a:p>
+            <a:pPr algn="r" indent="0" marL="0">
+              <a:buNone/>
+            </a:pPr>
+            <a:r>
+              <a:rPr lang="en-US" sz="1000" dirty="0">
+                <a:solidFill>
+                  <a:srgbClr val="5A5F73"/>
+                </a:solidFill>
+                <a:latin typeface="Calibri" pitchFamily="34" charset="0"/>
+                <a:ea typeface="Calibri" pitchFamily="34" charset="-122"/>
+                <a:cs typeface="Calibri" pitchFamily="34" charset="-120"/>
+              </a:rPr>
+              <a:t>13</a:t>
+            </a:r>
+            <a:endParaRPr lang="en-US" sz="1000" dirty="0"/>
+          </a:p>
+        </p:txBody>
+      </p:sp>
+    </p:spTree>
+  </p:cSld>
+  <p:clrMapOvr>
+    <a:masterClrMapping/>
+  </p:clrMapOvr>
+</p:sld>
+</file>
+
 <file path=ppt/slides/slide2.xml><?xml version="1.0" encoding="utf-8"?>
 <p:sld xmlns:a="http://schemas.openxmlformats.org/drawingml/2006/main" xmlns:r="http://schemas.openxmlformats.org/officeDocument/2006/relationships" xmlns:p="http://schemas.openxmlformats.org/presentationml/2006/main">
   <p:cSld name="Slide 2">

</xml_diff>

<commit_message>
docs(tfm): slide de calidad con cifras medidas hoy
</commit_message>
<xml_diff>
--- a/docs/presentacion/tfm-intelligent-automotive-diagnostics.pptx
+++ b/docs/presentacion/tfm-intelligent-automotive-diagnostics.pptx
@@ -18,9 +18,10 @@
     <p:sldId id="266" r:id="rId12"/>
     <p:sldId id="267" r:id="rId13"/>
     <p:sldId id="268" r:id="rId14"/>
+    <p:sldId id="269" r:id="rId15"/>
   </p:sldIdLst>
   <p:notesMasterIdLst>
-    <p:notesMasterId r:id="rId15"/>
+    <p:notesMasterId r:id="rId16"/>
   </p:notesMasterIdLst>
   <p:sldSz cx="12192000" cy="6858000"/>
   <p:notesSz cx="6858000" cy="12192000"/>
@@ -913,6 +914,100 @@
             <a:fld id="{F7021451-1387-4CA6-816F-3879F97B5CBC}" type="slidenum">
               <a:rPr lang="en-US"/>
               <a:t>13</a:t>
+            </a:fld>
+            <a:endParaRPr lang="en-US"/>
+          </a:p>
+        </p:txBody>
+      </p:sp>
+    </p:spTree>
+    <p:extLst>
+      <p:ext uri="{BB962C8B-B14F-4D97-AF65-F5344CB8AC3E}">
+        <p14:creationId xmlns:p14="http://schemas.microsoft.com/office/powerpoint/2010/main" val="1024086991"/>
+      </p:ext>
+    </p:extLst>
+  </p:cSld>
+  <p:clrMapOvr>
+    <a:masterClrMapping/>
+  </p:clrMapOvr>
+</p:notes>
+</file>
+
+<file path=ppt/notesSlides/notesSlide14.xml><?xml version="1.0" encoding="utf-8"?>
+<p:notes xmlns:a="http://schemas.openxmlformats.org/drawingml/2006/main" xmlns:r="http://schemas.openxmlformats.org/officeDocument/2006/relationships" xmlns:p="http://schemas.openxmlformats.org/presentationml/2006/main">
+  <p:cSld>
+    <p:spTree>
+      <p:nvGrpSpPr>
+        <p:cNvPr id="1" name=""/>
+        <p:cNvGrpSpPr/>
+        <p:nvPr/>
+      </p:nvGrpSpPr>
+      <p:grpSpPr>
+        <a:xfrm>
+          <a:off x="0" y="0"/>
+          <a:ext cx="0" cy="0"/>
+          <a:chOff x="0" y="0"/>
+          <a:chExt cx="0" cy="0"/>
+        </a:xfrm>
+      </p:grpSpPr>
+      <p:sp>
+        <p:nvSpPr>
+          <p:cNvPr id="2" name="Slide Image Placeholder 1"/>
+          <p:cNvSpPr>
+            <a:spLocks noGrp="1" noRot="1" noChangeAspect="1"/>
+          </p:cNvSpPr>
+          <p:nvPr>
+            <p:ph type="sldImg"/>
+          </p:nvPr>
+        </p:nvSpPr>
+        <p:spPr/>
+      </p:sp>
+      <p:sp>
+        <p:nvSpPr>
+          <p:cNvPr id="3" name="Notes Placeholder 2"/>
+          <p:cNvSpPr>
+            <a:spLocks noGrp="1"/>
+          </p:cNvSpPr>
+          <p:nvPr>
+            <p:ph type="body" idx="1"/>
+          </p:nvPr>
+        </p:nvSpPr>
+        <p:spPr/>
+        <p:txBody>
+          <a:bodyPr/>
+          <a:lstStyle/>
+          <a:p>
+            <a:r>
+              <a:rPr lang="en-US" dirty="0"/>
+              <a:t>Este proyecto lo he hecho yo solo, así que lo que avisa de las roturas no es un compañero: es el CI.
+El código se escribe con TDD, primero el test que falla y luego el código mínimo que lo pasa. Ahora mismo hay 2.171 pruebas en verde repartidas en 209 ficheros, entre el backend y el frontend.
+Y la cobertura no se mide de media, que es la trampa habitual: está configurada por fichero. Un fichero sin tests no puede esconderse detrás de otro que esté muy cubierto.
+Cada cambio va documentado con OpenSpec antes de escribirse: hay 45 cambios especificados y archivados, con su diseño, sus specs y sus tareas.
+En cada push, el CI corre lint, formato, los tests, el build y el typecheck, para las dos aplicaciones en paralelo sobre Node 22. Y pasa una auditoría de dependencias que tumba la build si aparece una vulnerabilidad crítica.
+En seguridad, el documento cubre las diez categorías del OWASP API Top 10 de 2023, una a una, con lo que hace el código en cada caso. Incluidos los riesgos residuales, que están escritos y asumidos, no escondidos.
+[~60 s]</a:t>
+            </a:r>
+            <a:endParaRPr lang="en-US" dirty="0"/>
+          </a:p>
+        </p:txBody>
+      </p:sp>
+      <p:sp>
+        <p:nvSpPr>
+          <p:cNvPr id="4" name="Slide Number Placeholder 3"/>
+          <p:cNvSpPr>
+            <a:spLocks noGrp="1"/>
+          </p:cNvSpPr>
+          <p:nvPr>
+            <p:ph type="sldNum" sz="quarter" idx="10"/>
+          </p:nvPr>
+        </p:nvSpPr>
+        <p:spPr/>
+        <p:txBody>
+          <a:bodyPr/>
+          <a:lstStyle/>
+          <a:p>
+            <a:fld id="{F7021451-1387-4CA6-816F-3879F97B5CBC}" type="slidenum">
+              <a:rPr lang="en-US"/>
+              <a:t>14</a:t>
             </a:fld>
             <a:endParaRPr lang="en-US"/>
           </a:p>
@@ -5090,6 +5185,567 @@
 </p:sld>
 </file>
 
+<file path=ppt/slides/slide14.xml><?xml version="1.0" encoding="utf-8"?>
+<p:sld xmlns:a="http://schemas.openxmlformats.org/drawingml/2006/main" xmlns:r="http://schemas.openxmlformats.org/officeDocument/2006/relationships" xmlns:p="http://schemas.openxmlformats.org/presentationml/2006/main">
+  <p:cSld name="Slide 14">
+    <p:bg>
+      <p:bgPr>
+        <a:solidFill>
+          <a:srgbClr val="FFFFFF"/>
+        </a:solidFill>
+      </p:bgPr>
+    </p:bg>
+    <p:spTree>
+      <p:nvGrpSpPr>
+        <p:cNvPr id="1" name=""/>
+        <p:cNvGrpSpPr/>
+        <p:nvPr/>
+      </p:nvGrpSpPr>
+      <p:grpSpPr>
+        <a:xfrm>
+          <a:off x="0" y="0"/>
+          <a:ext cx="0" cy="0"/>
+          <a:chOff x="0" y="0"/>
+          <a:chExt cx="0" cy="0"/>
+        </a:xfrm>
+      </p:grpSpPr>
+      <p:sp>
+        <p:nvSpPr>
+          <p:cNvPr id="2" name="Text 0"/>
+          <p:cNvSpPr/>
+          <p:nvPr/>
+        </p:nvSpPr>
+        <p:spPr>
+          <a:xfrm>
+            <a:off x="777240" y="640080"/>
+            <a:ext cx="10607040" cy="777240"/>
+          </a:xfrm>
+          <a:prstGeom prst="rect">
+            <a:avLst/>
+          </a:prstGeom>
+          <a:noFill/>
+          <a:ln/>
+        </p:spPr>
+        <p:txBody>
+          <a:bodyPr wrap="square" lIns="0" tIns="0" rIns="0" bIns="0" rtlCol="0" anchor="t"/>
+          <a:lstStyle/>
+          <a:p>
+            <a:pPr indent="0" marL="0">
+              <a:buNone/>
+            </a:pPr>
+            <a:r>
+              <a:rPr lang="en-US" sz="3400" b="1" dirty="0">
+                <a:solidFill>
+                  <a:srgbClr val="1A1C2E"/>
+                </a:solidFill>
+                <a:latin typeface="Arial" pitchFamily="34" charset="0"/>
+                <a:ea typeface="Arial" pitchFamily="34" charset="-122"/>
+                <a:cs typeface="Arial" pitchFamily="34" charset="-120"/>
+              </a:rPr>
+              <a:t>Cómo se sostiene esto</a:t>
+            </a:r>
+            <a:endParaRPr lang="en-US" sz="3400" dirty="0"/>
+          </a:p>
+        </p:txBody>
+      </p:sp>
+      <p:sp>
+        <p:nvSpPr>
+          <p:cNvPr id="3" name="Text 1"/>
+          <p:cNvSpPr/>
+          <p:nvPr/>
+        </p:nvSpPr>
+        <p:spPr>
+          <a:xfrm>
+            <a:off x="777240" y="1508760"/>
+            <a:ext cx="10607040" cy="365760"/>
+          </a:xfrm>
+          <a:prstGeom prst="rect">
+            <a:avLst/>
+          </a:prstGeom>
+          <a:noFill/>
+          <a:ln/>
+        </p:spPr>
+        <p:txBody>
+          <a:bodyPr wrap="square" lIns="0" tIns="0" rIns="0" bIns="0" rtlCol="0" anchor="t"/>
+          <a:lstStyle/>
+          <a:p>
+            <a:pPr indent="0" marL="0">
+              <a:buNone/>
+            </a:pPr>
+            <a:r>
+              <a:rPr lang="en-US" sz="1700" dirty="0">
+                <a:solidFill>
+                  <a:srgbClr val="5A5F73"/>
+                </a:solidFill>
+                <a:latin typeface="Calibri" pitchFamily="34" charset="0"/>
+                <a:ea typeface="Calibri" pitchFamily="34" charset="-122"/>
+                <a:cs typeface="Calibri" pitchFamily="34" charset="-120"/>
+              </a:rPr>
+              <a:t>Un solo programador, así que el que avisa de las roturas es el CI.</a:t>
+            </a:r>
+            <a:endParaRPr lang="en-US" sz="1700" dirty="0"/>
+          </a:p>
+        </p:txBody>
+      </p:sp>
+      <p:sp>
+        <p:nvSpPr>
+          <p:cNvPr id="4" name="Text 2"/>
+          <p:cNvSpPr/>
+          <p:nvPr/>
+        </p:nvSpPr>
+        <p:spPr>
+          <a:xfrm>
+            <a:off x="777240" y="2240280"/>
+            <a:ext cx="4846320" cy="365760"/>
+          </a:xfrm>
+          <a:prstGeom prst="rect">
+            <a:avLst/>
+          </a:prstGeom>
+          <a:noFill/>
+          <a:ln/>
+        </p:spPr>
+        <p:txBody>
+          <a:bodyPr wrap="square" lIns="0" tIns="0" rIns="0" bIns="0" rtlCol="0" anchor="t"/>
+          <a:lstStyle/>
+          <a:p>
+            <a:pPr indent="0" marL="0">
+              <a:buNone/>
+            </a:pPr>
+            <a:r>
+              <a:rPr lang="en-US" sz="1900" b="1" dirty="0">
+                <a:solidFill>
+                  <a:srgbClr val="202CFC"/>
+                </a:solidFill>
+                <a:latin typeface="Arial" pitchFamily="34" charset="0"/>
+                <a:ea typeface="Arial" pitchFamily="34" charset="-122"/>
+                <a:cs typeface="Arial" pitchFamily="34" charset="-120"/>
+              </a:rPr>
+              <a:t>Cómo se escribe</a:t>
+            </a:r>
+            <a:endParaRPr lang="en-US" sz="1900" dirty="0"/>
+          </a:p>
+        </p:txBody>
+      </p:sp>
+      <p:sp>
+        <p:nvSpPr>
+          <p:cNvPr id="5" name="Text 3"/>
+          <p:cNvSpPr/>
+          <p:nvPr/>
+        </p:nvSpPr>
+        <p:spPr>
+          <a:xfrm>
+            <a:off x="777240" y="2788920"/>
+            <a:ext cx="4846320" cy="2834640"/>
+          </a:xfrm>
+          <a:prstGeom prst="rect">
+            <a:avLst/>
+          </a:prstGeom>
+          <a:noFill/>
+          <a:ln/>
+        </p:spPr>
+        <p:txBody>
+          <a:bodyPr wrap="square" lIns="0" tIns="0" rIns="0" bIns="0" rtlCol="0" anchor="t"/>
+          <a:lstStyle/>
+          <a:p>
+            <a:pPr marL="342900" indent="-342900">
+              <a:lnSpc>
+                <a:spcPts val="2100"/>
+              </a:lnSpc>
+              <a:spcAft>
+                <a:spcPts val="1100"/>
+              </a:spcAft>
+              <a:buSzPct val="100000"/>
+              <a:buChar char="•"/>
+            </a:pPr>
+            <a:r>
+              <a:rPr lang="en-US" sz="1500" dirty="0">
+                <a:solidFill>
+                  <a:srgbClr val="1A1C2E"/>
+                </a:solidFill>
+                <a:latin typeface="Calibri" pitchFamily="34" charset="0"/>
+                <a:ea typeface="Calibri" pitchFamily="34" charset="-122"/>
+                <a:cs typeface="Calibri" pitchFamily="34" charset="-120"/>
+              </a:rPr>
+              <a:t>TDD: primero el test que falla, luego el código</a:t>
+            </a:r>
+            <a:endParaRPr lang="en-US" sz="1500" dirty="0"/>
+          </a:p>
+          <a:p>
+            <a:pPr marL="342900" indent="-342900">
+              <a:lnSpc>
+                <a:spcPts val="2100"/>
+              </a:lnSpc>
+              <a:spcAft>
+                <a:spcPts val="1100"/>
+              </a:spcAft>
+              <a:buSzPct val="100000"/>
+              <a:buChar char="•"/>
+            </a:pPr>
+            <a:r>
+              <a:rPr lang="en-US" sz="1500" dirty="0">
+                <a:solidFill>
+                  <a:srgbClr val="1A1C2E"/>
+                </a:solidFill>
+                <a:latin typeface="Calibri" pitchFamily="34" charset="0"/>
+                <a:ea typeface="Calibri" pitchFamily="34" charset="-122"/>
+                <a:cs typeface="Calibri" pitchFamily="34" charset="-120"/>
+              </a:rPr>
+              <a:t>2.171 pruebas en verde, en 209 ficheros</a:t>
+            </a:r>
+            <a:endParaRPr lang="en-US" sz="1500" dirty="0"/>
+          </a:p>
+          <a:p>
+            <a:pPr marL="342900" indent="-342900">
+              <a:lnSpc>
+                <a:spcPts val="2100"/>
+              </a:lnSpc>
+              <a:spcAft>
+                <a:spcPts val="1100"/>
+              </a:spcAft>
+              <a:buSzPct val="100000"/>
+              <a:buChar char="•"/>
+            </a:pPr>
+            <a:r>
+              <a:rPr lang="en-US" sz="1500" dirty="0">
+                <a:solidFill>
+                  <a:srgbClr val="1A1C2E"/>
+                </a:solidFill>
+                <a:latin typeface="Calibri" pitchFamily="34" charset="0"/>
+                <a:ea typeface="Calibri" pitchFamily="34" charset="-122"/>
+                <a:cs typeface="Calibri" pitchFamily="34" charset="-120"/>
+              </a:rPr>
+              <a:t>La cobertura se exige fichero a fichero, no de media</a:t>
+            </a:r>
+            <a:endParaRPr lang="en-US" sz="1500" dirty="0"/>
+          </a:p>
+          <a:p>
+            <a:pPr marL="342900" indent="-342900">
+              <a:lnSpc>
+                <a:spcPts val="2100"/>
+              </a:lnSpc>
+              <a:spcAft>
+                <a:spcPts val="1100"/>
+              </a:spcAft>
+              <a:buSzPct val="100000"/>
+              <a:buChar char="•"/>
+            </a:pPr>
+            <a:r>
+              <a:rPr lang="en-US" sz="1500" dirty="0">
+                <a:solidFill>
+                  <a:srgbClr val="1A1C2E"/>
+                </a:solidFill>
+                <a:latin typeface="Calibri" pitchFamily="34" charset="0"/>
+                <a:ea typeface="Calibri" pitchFamily="34" charset="-122"/>
+                <a:cs typeface="Calibri" pitchFamily="34" charset="-120"/>
+              </a:rPr>
+              <a:t>45 cambios especificados y archivados con OpenSpec</a:t>
+            </a:r>
+            <a:endParaRPr lang="en-US" sz="1500" dirty="0"/>
+          </a:p>
+        </p:txBody>
+      </p:sp>
+      <p:sp>
+        <p:nvSpPr>
+          <p:cNvPr id="6" name="Text 4"/>
+          <p:cNvSpPr/>
+          <p:nvPr/>
+        </p:nvSpPr>
+        <p:spPr>
+          <a:xfrm>
+            <a:off x="6537960" y="2240280"/>
+            <a:ext cx="4846320" cy="365760"/>
+          </a:xfrm>
+          <a:prstGeom prst="rect">
+            <a:avLst/>
+          </a:prstGeom>
+          <a:noFill/>
+          <a:ln/>
+        </p:spPr>
+        <p:txBody>
+          <a:bodyPr wrap="square" lIns="0" tIns="0" rIns="0" bIns="0" rtlCol="0" anchor="t"/>
+          <a:lstStyle/>
+          <a:p>
+            <a:pPr indent="0" marL="0">
+              <a:buNone/>
+            </a:pPr>
+            <a:r>
+              <a:rPr lang="en-US" sz="1900" b="1" dirty="0">
+                <a:solidFill>
+                  <a:srgbClr val="202CFC"/>
+                </a:solidFill>
+                <a:latin typeface="Arial" pitchFamily="34" charset="0"/>
+                <a:ea typeface="Arial" pitchFamily="34" charset="-122"/>
+                <a:cs typeface="Arial" pitchFamily="34" charset="-120"/>
+              </a:rPr>
+              <a:t>Qué se comprueba en cada push</a:t>
+            </a:r>
+            <a:endParaRPr lang="en-US" sz="1900" dirty="0"/>
+          </a:p>
+        </p:txBody>
+      </p:sp>
+      <p:sp>
+        <p:nvSpPr>
+          <p:cNvPr id="7" name="Text 5"/>
+          <p:cNvSpPr/>
+          <p:nvPr/>
+        </p:nvSpPr>
+        <p:spPr>
+          <a:xfrm>
+            <a:off x="6537960" y="2788920"/>
+            <a:ext cx="4846320" cy="2834640"/>
+          </a:xfrm>
+          <a:prstGeom prst="rect">
+            <a:avLst/>
+          </a:prstGeom>
+          <a:noFill/>
+          <a:ln/>
+        </p:spPr>
+        <p:txBody>
+          <a:bodyPr wrap="square" lIns="0" tIns="0" rIns="0" bIns="0" rtlCol="0" anchor="t"/>
+          <a:lstStyle/>
+          <a:p>
+            <a:pPr marL="342900" indent="-342900">
+              <a:lnSpc>
+                <a:spcPts val="2100"/>
+              </a:lnSpc>
+              <a:spcAft>
+                <a:spcPts val="1100"/>
+              </a:spcAft>
+              <a:buSzPct val="100000"/>
+              <a:buChar char="•"/>
+            </a:pPr>
+            <a:r>
+              <a:rPr lang="en-US" sz="1500" dirty="0">
+                <a:solidFill>
+                  <a:srgbClr val="1A1C2E"/>
+                </a:solidFill>
+                <a:latin typeface="Calibri" pitchFamily="34" charset="0"/>
+                <a:ea typeface="Calibri" pitchFamily="34" charset="-122"/>
+                <a:cs typeface="Calibri" pitchFamily="34" charset="-120"/>
+              </a:rPr>
+              <a:t>Lint, formato, tests, build y typecheck</a:t>
+            </a:r>
+            <a:endParaRPr lang="en-US" sz="1500" dirty="0"/>
+          </a:p>
+          <a:p>
+            <a:pPr marL="342900" indent="-342900">
+              <a:lnSpc>
+                <a:spcPts val="2100"/>
+              </a:lnSpc>
+              <a:spcAft>
+                <a:spcPts val="1100"/>
+              </a:spcAft>
+              <a:buSzPct val="100000"/>
+              <a:buChar char="•"/>
+            </a:pPr>
+            <a:r>
+              <a:rPr lang="en-US" sz="1500" dirty="0">
+                <a:solidFill>
+                  <a:srgbClr val="1A1C2E"/>
+                </a:solidFill>
+                <a:latin typeface="Calibri" pitchFamily="34" charset="0"/>
+                <a:ea typeface="Calibri" pitchFamily="34" charset="-122"/>
+                <a:cs typeface="Calibri" pitchFamily="34" charset="-120"/>
+              </a:rPr>
+              <a:t>Las dos apps en paralelo, sobre Node 22</a:t>
+            </a:r>
+            <a:endParaRPr lang="en-US" sz="1500" dirty="0"/>
+          </a:p>
+          <a:p>
+            <a:pPr marL="342900" indent="-342900">
+              <a:lnSpc>
+                <a:spcPts val="2100"/>
+              </a:lnSpc>
+              <a:spcAft>
+                <a:spcPts val="1100"/>
+              </a:spcAft>
+              <a:buSzPct val="100000"/>
+              <a:buChar char="•"/>
+            </a:pPr>
+            <a:r>
+              <a:rPr lang="en-US" sz="1500" dirty="0">
+                <a:solidFill>
+                  <a:srgbClr val="1A1C2E"/>
+                </a:solidFill>
+                <a:latin typeface="Calibri" pitchFamily="34" charset="0"/>
+                <a:ea typeface="Calibri" pitchFamily="34" charset="-122"/>
+                <a:cs typeface="Calibri" pitchFamily="34" charset="-120"/>
+              </a:rPr>
+              <a:t>Auditoría de dependencias que rompe si hay algo crítico</a:t>
+            </a:r>
+            <a:endParaRPr lang="en-US" sz="1500" dirty="0"/>
+          </a:p>
+          <a:p>
+            <a:pPr marL="342900" indent="-342900">
+              <a:lnSpc>
+                <a:spcPts val="2100"/>
+              </a:lnSpc>
+              <a:spcAft>
+                <a:spcPts val="1100"/>
+              </a:spcAft>
+              <a:buSzPct val="100000"/>
+              <a:buChar char="•"/>
+            </a:pPr>
+            <a:r>
+              <a:rPr lang="en-US" sz="1500" dirty="0">
+                <a:solidFill>
+                  <a:srgbClr val="1A1C2E"/>
+                </a:solidFill>
+                <a:latin typeface="Calibri" pitchFamily="34" charset="0"/>
+                <a:ea typeface="Calibri" pitchFamily="34" charset="-122"/>
+                <a:cs typeface="Calibri" pitchFamily="34" charset="-120"/>
+              </a:rPr>
+              <a:t>OWASP API Top 10 2023: las diez categorías, documentadas</a:t>
+            </a:r>
+            <a:endParaRPr lang="en-US" sz="1500" dirty="0"/>
+          </a:p>
+        </p:txBody>
+      </p:sp>
+      <p:sp>
+        <p:nvSpPr>
+          <p:cNvPr id="8" name="Shape 6"/>
+          <p:cNvSpPr/>
+          <p:nvPr/>
+        </p:nvSpPr>
+        <p:spPr>
+          <a:xfrm>
+            <a:off x="777240" y="6263640"/>
+            <a:ext cx="219456" cy="219456"/>
+          </a:xfrm>
+          <a:prstGeom prst="rect">
+            <a:avLst/>
+          </a:prstGeom>
+          <a:solidFill>
+            <a:srgbClr val="202CFC"/>
+          </a:solidFill>
+          <a:ln/>
+        </p:spPr>
+      </p:sp>
+      <p:sp>
+        <p:nvSpPr>
+          <p:cNvPr id="9" name="Text 7"/>
+          <p:cNvSpPr/>
+          <p:nvPr/>
+        </p:nvSpPr>
+        <p:spPr>
+          <a:xfrm>
+            <a:off x="777240" y="6263640"/>
+            <a:ext cx="219456" cy="219456"/>
+          </a:xfrm>
+          <a:prstGeom prst="rect">
+            <a:avLst/>
+          </a:prstGeom>
+          <a:noFill/>
+          <a:ln/>
+        </p:spPr>
+        <p:txBody>
+          <a:bodyPr wrap="square" lIns="0" tIns="0" rIns="0" bIns="0" rtlCol="0" anchor="ctr"/>
+          <a:lstStyle/>
+          <a:p>
+            <a:pPr algn="ctr" indent="0" marL="0">
+              <a:buNone/>
+            </a:pPr>
+            <a:r>
+              <a:rPr lang="en-US" sz="816" b="1" dirty="0">
+                <a:solidFill>
+                  <a:srgbClr val="FFFFFF"/>
+                </a:solidFill>
+                <a:latin typeface="Arial" pitchFamily="34" charset="0"/>
+                <a:ea typeface="Arial" pitchFamily="34" charset="-122"/>
+                <a:cs typeface="Arial" pitchFamily="34" charset="-120"/>
+              </a:rPr>
+              <a:t>BIG</a:t>
+            </a:r>
+            <a:endParaRPr lang="en-US" sz="816" dirty="0"/>
+          </a:p>
+        </p:txBody>
+      </p:sp>
+      <p:sp>
+        <p:nvSpPr>
+          <p:cNvPr id="10" name="Text 8"/>
+          <p:cNvSpPr/>
+          <p:nvPr/>
+        </p:nvSpPr>
+        <p:spPr>
+          <a:xfrm>
+            <a:off x="1078992" y="6263640"/>
+            <a:ext cx="658368" cy="219456"/>
+          </a:xfrm>
+          <a:prstGeom prst="rect">
+            <a:avLst/>
+          </a:prstGeom>
+          <a:noFill/>
+          <a:ln/>
+        </p:spPr>
+        <p:txBody>
+          <a:bodyPr wrap="square" lIns="0" tIns="0" rIns="0" bIns="0" rtlCol="0" anchor="ctr"/>
+          <a:lstStyle/>
+          <a:p>
+            <a:pPr algn="l" indent="0" marL="0">
+              <a:buNone/>
+            </a:pPr>
+            <a:r>
+              <a:rPr lang="en-US" sz="816" dirty="0">
+                <a:solidFill>
+                  <a:srgbClr val="1A1C2E"/>
+                </a:solidFill>
+                <a:latin typeface="Arial" pitchFamily="34" charset="0"/>
+                <a:ea typeface="Arial" pitchFamily="34" charset="-122"/>
+                <a:cs typeface="Arial" pitchFamily="34" charset="-120"/>
+              </a:rPr>
+              <a:t>school</a:t>
+            </a:r>
+            <a:endParaRPr lang="en-US" sz="816" dirty="0"/>
+          </a:p>
+        </p:txBody>
+      </p:sp>
+      <p:sp>
+        <p:nvSpPr>
+          <p:cNvPr id="11" name="Text 9"/>
+          <p:cNvSpPr/>
+          <p:nvPr/>
+        </p:nvSpPr>
+        <p:spPr>
+          <a:xfrm>
+            <a:off x="11064240" y="6263640"/>
+            <a:ext cx="320040" cy="219456"/>
+          </a:xfrm>
+          <a:prstGeom prst="rect">
+            <a:avLst/>
+          </a:prstGeom>
+          <a:noFill/>
+          <a:ln/>
+        </p:spPr>
+        <p:txBody>
+          <a:bodyPr wrap="square" lIns="0" tIns="0" rIns="0" bIns="0" rtlCol="0" anchor="ctr"/>
+          <a:lstStyle/>
+          <a:p>
+            <a:pPr algn="r" indent="0" marL="0">
+              <a:buNone/>
+            </a:pPr>
+            <a:r>
+              <a:rPr lang="en-US" sz="1000" dirty="0">
+                <a:solidFill>
+                  <a:srgbClr val="5A5F73"/>
+                </a:solidFill>
+                <a:latin typeface="Calibri" pitchFamily="34" charset="0"/>
+                <a:ea typeface="Calibri" pitchFamily="34" charset="-122"/>
+                <a:cs typeface="Calibri" pitchFamily="34" charset="-120"/>
+              </a:rPr>
+              <a:t>14</a:t>
+            </a:r>
+            <a:endParaRPr lang="en-US" sz="1000" dirty="0"/>
+          </a:p>
+        </p:txBody>
+      </p:sp>
+    </p:spTree>
+  </p:cSld>
+  <p:clrMapOvr>
+    <a:masterClrMapping/>
+  </p:clrMapOvr>
+</p:sld>
+</file>
+
 <file path=ppt/slides/slide2.xml><?xml version="1.0" encoding="utf-8"?>
 <p:sld xmlns:a="http://schemas.openxmlformats.org/drawingml/2006/main" xmlns:r="http://schemas.openxmlformats.org/officeDocument/2006/relationships" xmlns:p="http://schemas.openxmlformats.org/presentationml/2006/main">
   <p:cSld name="Slide 2">

</xml_diff>

<commit_message>
docs(tfm): cierre del deck y exportar el PDF
</commit_message>
<xml_diff>
--- a/docs/presentacion/tfm-intelligent-automotive-diagnostics.pptx
+++ b/docs/presentacion/tfm-intelligent-automotive-diagnostics.pptx
@@ -20,9 +20,10 @@
     <p:sldId id="268" r:id="rId14"/>
     <p:sldId id="269" r:id="rId15"/>
     <p:sldId id="270" r:id="rId16"/>
+    <p:sldId id="271" r:id="rId17"/>
   </p:sldIdLst>
   <p:notesMasterIdLst>
-    <p:notesMasterId r:id="rId17"/>
+    <p:notesMasterId r:id="rId18"/>
   </p:notesMasterIdLst>
   <p:sldSz cx="12192000" cy="6858000"/>
   <p:notesSz cx="6858000" cy="12192000"/>
@@ -1102,6 +1103,95 @@
             <a:fld id="{F7021451-1387-4CA6-816F-3879F97B5CBC}" type="slidenum">
               <a:rPr lang="en-US"/>
               <a:t>15</a:t>
+            </a:fld>
+            <a:endParaRPr lang="en-US"/>
+          </a:p>
+        </p:txBody>
+      </p:sp>
+    </p:spTree>
+    <p:extLst>
+      <p:ext uri="{BB962C8B-B14F-4D97-AF65-F5344CB8AC3E}">
+        <p14:creationId xmlns:p14="http://schemas.microsoft.com/office/powerpoint/2010/main" val="1024086991"/>
+      </p:ext>
+    </p:extLst>
+  </p:cSld>
+  <p:clrMapOvr>
+    <a:masterClrMapping/>
+  </p:clrMapOvr>
+</p:notes>
+</file>
+
+<file path=ppt/notesSlides/notesSlide16.xml><?xml version="1.0" encoding="utf-8"?>
+<p:notes xmlns:a="http://schemas.openxmlformats.org/drawingml/2006/main" xmlns:r="http://schemas.openxmlformats.org/officeDocument/2006/relationships" xmlns:p="http://schemas.openxmlformats.org/presentationml/2006/main">
+  <p:cSld>
+    <p:spTree>
+      <p:nvGrpSpPr>
+        <p:cNvPr id="1" name=""/>
+        <p:cNvGrpSpPr/>
+        <p:nvPr/>
+      </p:nvGrpSpPr>
+      <p:grpSpPr>
+        <a:xfrm>
+          <a:off x="0" y="0"/>
+          <a:ext cx="0" cy="0"/>
+          <a:chOff x="0" y="0"/>
+          <a:chExt cx="0" cy="0"/>
+        </a:xfrm>
+      </p:grpSpPr>
+      <p:sp>
+        <p:nvSpPr>
+          <p:cNvPr id="2" name="Slide Image Placeholder 1"/>
+          <p:cNvSpPr>
+            <a:spLocks noGrp="1" noRot="1" noChangeAspect="1"/>
+          </p:cNvSpPr>
+          <p:nvPr>
+            <p:ph type="sldImg"/>
+          </p:nvPr>
+        </p:nvSpPr>
+        <p:spPr/>
+      </p:sp>
+      <p:sp>
+        <p:nvSpPr>
+          <p:cNvPr id="3" name="Notes Placeholder 2"/>
+          <p:cNvSpPr>
+            <a:spLocks noGrp="1"/>
+          </p:cNvSpPr>
+          <p:nvPr>
+            <p:ph type="body" idx="1"/>
+          </p:nvPr>
+        </p:nvSpPr>
+        <p:spPr/>
+        <p:txBody>
+          <a:bodyPr/>
+          <a:lstStyle/>
+          <a:p>
+            <a:r>
+              <a:rPr lang="en-US" dirty="0"/>
+              <a:t>Y hasta aquí. Muchas gracias por la atención.
+[Quedarse callado y esperar las preguntas. El backup está detrás.]</a:t>
+            </a:r>
+            <a:endParaRPr lang="en-US" dirty="0"/>
+          </a:p>
+        </p:txBody>
+      </p:sp>
+      <p:sp>
+        <p:nvSpPr>
+          <p:cNvPr id="4" name="Slide Number Placeholder 3"/>
+          <p:cNvSpPr>
+            <a:spLocks noGrp="1"/>
+          </p:cNvSpPr>
+          <p:nvPr>
+            <p:ph type="sldNum" sz="quarter" idx="10"/>
+          </p:nvPr>
+        </p:nvSpPr>
+        <p:spPr/>
+        <p:txBody>
+          <a:bodyPr/>
+          <a:lstStyle/>
+          <a:p>
+            <a:fld id="{F7021451-1387-4CA6-816F-3879F97B5CBC}" type="slidenum">
+              <a:rPr lang="en-US"/>
+              <a:t>16</a:t>
             </a:fld>
             <a:endParaRPr lang="en-US"/>
           </a:p>
@@ -6353,6 +6443,343 @@
 </p:sld>
 </file>
 
+<file path=ppt/slides/slide16.xml><?xml version="1.0" encoding="utf-8"?>
+<p:sld xmlns:a="http://schemas.openxmlformats.org/drawingml/2006/main" xmlns:r="http://schemas.openxmlformats.org/officeDocument/2006/relationships" xmlns:p="http://schemas.openxmlformats.org/presentationml/2006/main">
+  <p:cSld name="Slide 16">
+    <p:bg>
+      <p:bgPr>
+        <a:solidFill>
+          <a:srgbClr val="FFFFFF"/>
+        </a:solidFill>
+      </p:bgPr>
+    </p:bg>
+    <p:spTree>
+      <p:nvGrpSpPr>
+        <p:cNvPr id="1" name=""/>
+        <p:cNvGrpSpPr/>
+        <p:nvPr/>
+      </p:nvGrpSpPr>
+      <p:grpSpPr>
+        <a:xfrm>
+          <a:off x="0" y="0"/>
+          <a:ext cx="0" cy="0"/>
+          <a:chOff x="0" y="0"/>
+          <a:chExt cx="0" cy="0"/>
+        </a:xfrm>
+      </p:grpSpPr>
+      <p:sp>
+        <p:nvSpPr>
+          <p:cNvPr id="2" name="Shape 0"/>
+          <p:cNvSpPr/>
+          <p:nvPr/>
+        </p:nvSpPr>
+        <p:spPr>
+          <a:xfrm>
+            <a:off x="6720840" y="-91440"/>
+            <a:ext cx="5760720" cy="7040880"/>
+          </a:xfrm>
+          <a:prstGeom prst="rect">
+            <a:avLst/>
+          </a:prstGeom>
+          <a:solidFill>
+            <a:srgbClr val="1A1C2E"/>
+          </a:solidFill>
+          <a:ln/>
+        </p:spPr>
+      </p:sp>
+      <p:sp>
+        <p:nvSpPr>
+          <p:cNvPr id="3" name="Shape 1"/>
+          <p:cNvSpPr/>
+          <p:nvPr/>
+        </p:nvSpPr>
+        <p:spPr>
+          <a:xfrm>
+            <a:off x="777240" y="685800"/>
+            <a:ext cx="475488" cy="475488"/>
+          </a:xfrm>
+          <a:prstGeom prst="rect">
+            <a:avLst/>
+          </a:prstGeom>
+          <a:solidFill>
+            <a:srgbClr val="202CFC"/>
+          </a:solidFill>
+          <a:ln/>
+        </p:spPr>
+      </p:sp>
+      <p:sp>
+        <p:nvSpPr>
+          <p:cNvPr id="4" name="Text 2"/>
+          <p:cNvSpPr/>
+          <p:nvPr/>
+        </p:nvSpPr>
+        <p:spPr>
+          <a:xfrm>
+            <a:off x="777240" y="685800"/>
+            <a:ext cx="475488" cy="475488"/>
+          </a:xfrm>
+          <a:prstGeom prst="rect">
+            <a:avLst/>
+          </a:prstGeom>
+          <a:noFill/>
+          <a:ln/>
+        </p:spPr>
+        <p:txBody>
+          <a:bodyPr wrap="square" lIns="0" tIns="0" rIns="0" bIns="0" rtlCol="0" anchor="ctr"/>
+          <a:lstStyle/>
+          <a:p>
+            <a:pPr algn="ctr" indent="0" marL="0">
+              <a:buNone/>
+            </a:pPr>
+            <a:r>
+              <a:rPr lang="en-US" sz="1768" b="1" dirty="0">
+                <a:solidFill>
+                  <a:srgbClr val="FFFFFF"/>
+                </a:solidFill>
+                <a:latin typeface="Arial" pitchFamily="34" charset="0"/>
+                <a:ea typeface="Arial" pitchFamily="34" charset="-122"/>
+                <a:cs typeface="Arial" pitchFamily="34" charset="-120"/>
+              </a:rPr>
+              <a:t>BIG</a:t>
+            </a:r>
+            <a:endParaRPr lang="en-US" sz="1768" dirty="0"/>
+          </a:p>
+        </p:txBody>
+      </p:sp>
+      <p:sp>
+        <p:nvSpPr>
+          <p:cNvPr id="5" name="Text 3"/>
+          <p:cNvSpPr/>
+          <p:nvPr/>
+        </p:nvSpPr>
+        <p:spPr>
+          <a:xfrm>
+            <a:off x="1335024" y="685800"/>
+            <a:ext cx="1426464" cy="475488"/>
+          </a:xfrm>
+          <a:prstGeom prst="rect">
+            <a:avLst/>
+          </a:prstGeom>
+          <a:noFill/>
+          <a:ln/>
+        </p:spPr>
+        <p:txBody>
+          <a:bodyPr wrap="square" lIns="0" tIns="0" rIns="0" bIns="0" rtlCol="0" anchor="ctr"/>
+          <a:lstStyle/>
+          <a:p>
+            <a:pPr algn="l" indent="0" marL="0">
+              <a:buNone/>
+            </a:pPr>
+            <a:r>
+              <a:rPr lang="en-US" sz="1768" dirty="0">
+                <a:solidFill>
+                  <a:srgbClr val="1A1C2E"/>
+                </a:solidFill>
+                <a:latin typeface="Arial" pitchFamily="34" charset="0"/>
+                <a:ea typeface="Arial" pitchFamily="34" charset="-122"/>
+                <a:cs typeface="Arial" pitchFamily="34" charset="-120"/>
+              </a:rPr>
+              <a:t>school</a:t>
+            </a:r>
+            <a:endParaRPr lang="en-US" sz="1768" dirty="0"/>
+          </a:p>
+        </p:txBody>
+      </p:sp>
+      <p:sp>
+        <p:nvSpPr>
+          <p:cNvPr id="6" name="Text 4"/>
+          <p:cNvSpPr/>
+          <p:nvPr/>
+        </p:nvSpPr>
+        <p:spPr>
+          <a:xfrm>
+            <a:off x="777240" y="2651760"/>
+            <a:ext cx="5577840" cy="914400"/>
+          </a:xfrm>
+          <a:prstGeom prst="rect">
+            <a:avLst/>
+          </a:prstGeom>
+          <a:noFill/>
+          <a:ln/>
+        </p:spPr>
+        <p:txBody>
+          <a:bodyPr wrap="square" lIns="0" tIns="0" rIns="0" bIns="0" rtlCol="0" anchor="t"/>
+          <a:lstStyle/>
+          <a:p>
+            <a:pPr indent="0" marL="0">
+              <a:buNone/>
+            </a:pPr>
+            <a:r>
+              <a:rPr lang="en-US" sz="4000" b="1" dirty="0">
+                <a:solidFill>
+                  <a:srgbClr val="1A1C2E"/>
+                </a:solidFill>
+                <a:latin typeface="Arial" pitchFamily="34" charset="0"/>
+                <a:ea typeface="Arial" pitchFamily="34" charset="-122"/>
+                <a:cs typeface="Arial" pitchFamily="34" charset="-120"/>
+              </a:rPr>
+              <a:t>Gracias por la atención</a:t>
+            </a:r>
+            <a:endParaRPr lang="en-US" sz="4000" dirty="0"/>
+          </a:p>
+        </p:txBody>
+      </p:sp>
+      <p:sp>
+        <p:nvSpPr>
+          <p:cNvPr id="7" name="Text 5"/>
+          <p:cNvSpPr/>
+          <p:nvPr/>
+        </p:nvSpPr>
+        <p:spPr>
+          <a:xfrm>
+            <a:off x="777240" y="5349240"/>
+            <a:ext cx="5486400" cy="320040"/>
+          </a:xfrm>
+          <a:prstGeom prst="rect">
+            <a:avLst/>
+          </a:prstGeom>
+          <a:noFill/>
+          <a:ln/>
+        </p:spPr>
+        <p:txBody>
+          <a:bodyPr wrap="square" lIns="0" tIns="0" rIns="0" bIns="0" rtlCol="0" anchor="ctr"/>
+          <a:lstStyle/>
+          <a:p>
+            <a:pPr indent="0" marL="0">
+              <a:buNone/>
+            </a:pPr>
+            <a:r>
+              <a:rPr lang="en-US" sz="1500" b="1" dirty="0">
+                <a:solidFill>
+                  <a:srgbClr val="1A1C2E"/>
+                </a:solidFill>
+                <a:latin typeface="Arial" pitchFamily="34" charset="0"/>
+                <a:ea typeface="Arial" pitchFamily="34" charset="-122"/>
+                <a:cs typeface="Arial" pitchFamily="34" charset="-120"/>
+              </a:rPr>
+              <a:t>Jesús Ángel Novillo Lucas-Vaquero</a:t>
+            </a:r>
+            <a:endParaRPr lang="en-US" sz="1500" dirty="0"/>
+          </a:p>
+        </p:txBody>
+      </p:sp>
+      <p:sp>
+        <p:nvSpPr>
+          <p:cNvPr id="8" name="Text 6"/>
+          <p:cNvSpPr/>
+          <p:nvPr/>
+        </p:nvSpPr>
+        <p:spPr>
+          <a:xfrm>
+            <a:off x="777240" y="5687568"/>
+            <a:ext cx="5669280" cy="320040"/>
+          </a:xfrm>
+          <a:prstGeom prst="rect">
+            <a:avLst/>
+          </a:prstGeom>
+          <a:noFill/>
+          <a:ln/>
+        </p:spPr>
+        <p:txBody>
+          <a:bodyPr wrap="square" lIns="0" tIns="0" rIns="0" bIns="0" rtlCol="0" anchor="ctr"/>
+          <a:lstStyle/>
+          <a:p>
+            <a:pPr indent="0" marL="0">
+              <a:buNone/>
+            </a:pPr>
+            <a:r>
+              <a:rPr lang="en-US" sz="1200" dirty="0">
+                <a:solidFill>
+                  <a:srgbClr val="5A5F73"/>
+                </a:solidFill>
+                <a:latin typeface="Calibri" pitchFamily="34" charset="0"/>
+                <a:ea typeface="Calibri" pitchFamily="34" charset="-122"/>
+                <a:cs typeface="Calibri" pitchFamily="34" charset="-120"/>
+              </a:rPr>
+              <a:t>Máster en Desarrollo con IA  ·  BIG school</a:t>
+            </a:r>
+            <a:endParaRPr lang="en-US" sz="1200" dirty="0"/>
+          </a:p>
+        </p:txBody>
+      </p:sp>
+      <p:sp>
+        <p:nvSpPr>
+          <p:cNvPr id="9" name="Text 7"/>
+          <p:cNvSpPr/>
+          <p:nvPr/>
+        </p:nvSpPr>
+        <p:spPr>
+          <a:xfrm>
+            <a:off x="7114032" y="2148840"/>
+            <a:ext cx="4663440" cy="274320"/>
+          </a:xfrm>
+          <a:prstGeom prst="rect">
+            <a:avLst/>
+          </a:prstGeom>
+          <a:noFill/>
+          <a:ln/>
+        </p:spPr>
+        <p:txBody>
+          <a:bodyPr wrap="square" lIns="0" tIns="0" rIns="0" bIns="0" rtlCol="0" anchor="ctr"/>
+          <a:lstStyle/>
+          <a:p>
+            <a:pPr indent="0" marL="0">
+              <a:buNone/>
+            </a:pPr>
+            <a:r>
+              <a:rPr lang="en-US" sz="1000" b="1" spc="200" kern="0" dirty="0">
+                <a:solidFill>
+                  <a:srgbClr val="FFFFFF"/>
+                </a:solidFill>
+                <a:latin typeface="Calibri" pitchFamily="34" charset="0"/>
+                <a:ea typeface="Calibri" pitchFamily="34" charset="-122"/>
+                <a:cs typeface="Calibri" pitchFamily="34" charset="-120"/>
+              </a:rPr>
+              <a:t>EL INFORME DE LA SESIÓN</a:t>
+            </a:r>
+            <a:endParaRPr lang="en-US" sz="1000" dirty="0"/>
+          </a:p>
+        </p:txBody>
+      </p:sp>
+      <p:pic>
+        <p:nvPicPr>
+          <p:cNvPr id="10" name="Image 0" descr="/home/user/intelligent-automotive-diagnostics/docs/presentacion/capturas/demo/08-informe.png">    </p:cNvPr>
+          <p:cNvPicPr>
+            <a:picLocks noChangeAspect="1"/>
+          </p:cNvPicPr>
+          <p:nvPr/>
+        </p:nvPicPr>
+        <p:blipFill>
+          <a:blip r:embed="rId1"/>
+          <a:stretch>
+            <a:fillRect/>
+          </a:stretch>
+        </p:blipFill>
+        <p:spPr>
+          <a:xfrm>
+            <a:off x="7114032" y="2697480"/>
+            <a:ext cx="4654296" cy="1746504"/>
+          </a:xfrm>
+          <a:prstGeom prst="rect">
+            <a:avLst/>
+          </a:prstGeom>
+          <a:effectLst>
+            <a:outerShdw sx="100000" sy="100000" kx="0" ky="0" algn="bl" rotWithShape="0" blurRad="254000" dist="63500" dir="8100000">
+              <a:srgbClr val="000000">
+                <a:alpha val="50000"/>
+              </a:srgbClr>
+            </a:outerShdw>
+          </a:effectLst>
+        </p:spPr>
+      </p:pic>
+    </p:spTree>
+  </p:cSld>
+  <p:clrMapOvr>
+    <a:masterClrMapping/>
+  </p:clrMapOvr>
+</p:sld>
+</file>
+
 <file path=ppt/slides/slide2.xml><?xml version="1.0" encoding="utf-8"?>
 <p:sld xmlns:a="http://schemas.openxmlformats.org/drawingml/2006/main" xmlns:r="http://schemas.openxmlformats.org/officeDocument/2006/relationships" xmlns:p="http://schemas.openxmlformats.org/presentationml/2006/main">
   <p:cSld name="Slide 2">

</xml_diff>

<commit_message>
docs(tfm): tiempo acumulado en las notas del ponente
</commit_message>
<xml_diff>
--- a/docs/presentacion/tfm-intelligent-automotive-diagnostics.pptx
+++ b/docs/presentacion/tfm-intelligent-automotive-diagnostics.pptx
@@ -522,7 +522,7 @@
               <a:t>Buenos días. Soy Jesús Ángel Novillo y presento mi Trabajo Fin de Máster del Máster en Desarrollo con IA de BIG school.
 El proyecto se llama Intelligent Automotive Diagnostics: una herramienta que se conecta al coche por el puerto OBD-II, lee sus datos reales y razona sobre ellos con un modelo de lenguaje.
 Lo de la derecha no es una maqueta: es la aplicación funcionando, mostrando tres averías que acaba de leer de la centralita.
-[~15 s]</a:t>
+[~15 s · acumulado 0:15]</a:t>
             </a:r>
             <a:endParaRPr lang="en-US" dirty="0"/>
           </a:p>
@@ -615,7 +615,7 @@
 ¿Y por qué MCP? Primero, porque es el estándar que existe hoy para que un modelo pida herramientas. No es un protocolo de propósito general: sirve exactamente para esto.
 Y segundo, que para mí es lo importante: el modelo solo puede actuar a través de esas dieciséis. No hay otra puerta. No ejecuta código, no consulta la base de datos por su cuenta, no llama a ningún otro endpoint. Si quiere saber a cuántas revoluciones está el motor, tiene que pedir la herramienta de leer un PID, y ahí decido yo si se ejecuta y con qué argumentos. Eso acota lo que el agente puede hacer, y en un sistema que se conecta a un coche de verdad no es un detalle menor.
 Además, cada herramienta declara su esquema, así que los argumentos se validan antes de ejecutar nada. Y el servidor MCP vive en infraestructura: es un adaptador más, el modelo nunca ve el dominio. Como es un protocolo, ese mismo servidor serviría a cualquier otro cliente que lo hable.
-[~75 s]</a:t>
+[~75 s · acumulado 9:45]</a:t>
             </a:r>
             <a:endParaRPr lang="en-US" dirty="0"/>
           </a:p>
@@ -710,7 +710,7 @@
 Cuando termina, devuelve dos cosas: la explicación en lenguaje normal para el mecánico, y un bloque JSON con la severidad, la confianza y las recomendaciones, que es lo que la aplicación pinta en pantalla. Si no hay explicación, se lanza un error a propósito y no se guarda nada: un caso vacío en el catálogo volvería luego como "caso similar" y contaminaría los diagnósticos siguientes.
 Y por último el caso se indexa con confianza 0,5, que es la de diagnóstico anterior.
 El system prompt tiene once bloques. No es solo decirle "eres un mecánico": hay bloques de exploración, de consultar el catálogo antes de inventar, de aprendizaje para PIDs, DTCs y ECUs, de ámbito, de no revelar sus propias tripas, de contenido no fiable y del formato de salida.
-[~80 s]</a:t>
+[~80 s · acumulado 11:05]</a:t>
             </a:r>
             <a:endParaRPr lang="en-US" dirty="0"/>
           </a:p>
@@ -802,7 +802,7 @@
 El de lenguaje es el que razona, y es intercambiable: una variable de entorno decide si va contra Anthropic o contra OpenAI. Los dos clientes implementan el mismo puerto, así que la capa de aplicación no se entera de cuál hay detrás. Y el adaptador de OpenAI no vale solo para OpenAI: sirve para cualquier proveedor compatible con su API —DeepSeek, Groq, Mistral, xAI— cambiando la URL base. Si no hay ninguno configurado, el diagnóstico determinista sigue funcionando.
 El de embeddings es distinto: no se cambia, va dentro. Es un modelo pequeño que corre en la propia máquina con transformers.js. Coge un texto —la descripción de un PID, la narrativa de un diagnóstico— y lo convierte en 384 números, normalizados, que es lo que se guarda en la base vectorial. Buscar por parecido es comparar esos vectores.
 Que corra en local significa tres cosas: no hace falta clave, no hay latencia de red y no se paga por consulta. Y como es multilingüe, español e inglés caen cerca en ese espacio: por eso "presión de aceite" encuentra una ficha que pone "oil pressure", que es justo lo que un buscador de texto no hace.
-[~65 s]</a:t>
+[~65 s · acumulado 12:10]</a:t>
             </a:r>
             <a:endParaRPr lang="en-US" dirty="0"/>
           </a:p>
@@ -894,7 +894,7 @@
 El determinista es el de toda la vida. Lee cuatro PIDs fijos —revoluciones, temperatura de refrigerante, velocidad y temperatura de admisión—, los códigos de avería y el freeze frame. Y la criticidad no me la invento: sale de una regla en el dominio, computeSeverity. Si no hay códigos es baja; si hay freeze frame es crítica, porque significa que la centralita congeló el momento del fallo; y si hay códigos sin freeze frame es alta. Solo necesita el coche conectado, responde al momento, y no aprende nada.
 El cognitivo es el otro. Ahí no hay una lista fija de PIDs: el agente decide qué le hace falta leer y va llamando a las herramientas según lo que encuentra. A cambio necesita tres cosas: el coche, la API del modelo y los índices vectoriales. Tarda más, con un límite de sesenta segundos. Y es el único que aprende: indexa los PIDs y DTCs nuevos y guarda el caso resuelto.
 Por eso conviven. Si no hay modelo configurado, o si no hay internet en el taller, el determinista sigue funcionando.
-[~65 s]</a:t>
+[~65 s · acumulado 13:15]</a:t>
             </a:r>
             <a:endParaRPr lang="en-US" dirty="0"/>
           </a:p>
@@ -987,7 +987,7 @@
 Al lado, la telemetría en vivo, y debajo los PIDs que este vehículo declara soportar, que no son una lista fija: se leen del bitmask del PID 00.
 Abajo a la izquierda, las averías. Tres códigos confirmados, y las tres pestañas son los servicios 03, 07 y 0A del estándar: almacenadas, pendientes y permanentes.
 Y a la derecha el informe, que se congela con la sesión: si dentro de seis meses alguien abre ese diagnóstico, ve exactamente lo que se vio ese día.
-[~2 min contando la demo. Si hay vídeo del coche real, va aquí.]</a:t>
+[~2 min contando la demo. Si hay vídeo del coche real, va aquí. · acumulado 15:15]</a:t>
             </a:r>
             <a:endParaRPr lang="en-US" dirty="0"/>
           </a:p>
@@ -1081,7 +1081,7 @@
 El agente usa el SDK oficial de MCP, y por debajo el de Anthropic o el de OpenAI según lo que esté configurado. El acceso al coche es un ELM327, por puerto serie o por TCP, y para la demo un emulador escrito en Python.
 La interfaz es React 19 con Vite y TanStack, y las pruebas son Vitest para unidad, supertest para los endpoints y Playwright para el extremo a extremo. Y la entrega va con GitHub Actions, Docker y Caddy delante.
 Lo importante no es la lista: es que todo lo que aparece de la tercera fila para abajo está detrás de un puerto, así que se puede sustituir sin tocar la lógica.
-[~55 s]</a:t>
+[~55 s · acumulado 16:10]</a:t>
             </a:r>
             <a:endParaRPr lang="en-US" dirty="0"/>
           </a:p>
@@ -1175,7 +1175,7 @@
 Cada cambio va documentado con OpenSpec antes de escribirse: hay 45 cambios especificados y archivados, con su diseño, sus specs y sus tareas.
 En cada push, el CI corre lint, formato, los tests, el build y el typecheck, para las dos aplicaciones en paralelo sobre Node 22. Y pasa una auditoría de dependencias que tumba la build si aparece una vulnerabilidad crítica.
 En seguridad, el documento cubre las diez categorías del OWASP API Top 10 de 2023, una a una, con lo que hace el código en cada caso. Incluidos los riesgos residuales, que están escritos y asumidos, no escondidos.
-[~60 s]</a:t>
+[~60 s · acumulado 17:10]</a:t>
             </a:r>
             <a:endParaRPr lang="en-US" dirty="0"/>
           </a:p>
@@ -1268,7 +1268,7 @@
 Pero hay una segunda parte, y la quiero decir igual de claro. La IA también se equivoca, y hay que estar encima de lo que se sube. No vale con fiarse.
 Y no lo digo en abstracto: preparando esta misma presentación encontré que el umbral de cobertura del núcleo apuntaba a un fichero que se había renombrado, así que llevaba semanas sin exigir nada. Estaba verde, y no comprobaba lo que decía comprobar. Lo he documentado en la deuda conocida del proyecto.
 Así que sí, acelera mucho. Pero no es todo tan bonito como parece: hay que dedicarle tiempo a revisar.
-[~45 s]</a:t>
+[~45 s · acumulado 17:55]</a:t>
             </a:r>
             <a:endParaRPr lang="en-US" dirty="0"/>
           </a:p>
@@ -1448,7 +1448,7 @@
               <a:t>Hoy llegas con una máquina de diagnosis, la conectas, y te da diez códigos de error. Cada uno te dice una cosa: válvula EGR obstruida, filtro de partículas lleno.
 Vale. Pero esa válvula se ha obstruido por alguna circunstancia, y ese filtro se ha llenado por alguna circunstancia. Y eso la máquina no te lo dice.
 Te deja la lista delante, y el trabajo de averiguar el porqué sigue entero por hacer.
-[~45 s]</a:t>
+[~45 s · acumulado 1:00]</a:t>
             </a:r>
             <a:endParaRPr lang="en-US" dirty="0"/>
           </a:p>
@@ -1539,7 +1539,7 @@
               <a:t>¿Cuál es la gracia que tiene esta aplicación con la IA? Que con esos dos códigos y esos datos, el agente dice: vale, tengo el P0401, que es la válvula EGR obstruida, y el P2002, que es el filtro de partículas lleno. Voy a mirar a ver por qué puede ser esto.
 Y hace una diagnosis: esto se produce, puede ser por esto o puede ser por lo otro. Le da al mecánico una serie de opciones.
 Y además le dice qué pasos puede seguir para llegar a determinar de dónde viene el problema. Eso es lo que hace la aplicación.
-[~55 s]</a:t>
+[~55 s · acumulado 1:55]</a:t>
             </a:r>
             <a:endParaRPr lang="en-US" dirty="0"/>
           </a:p>
@@ -1631,7 +1631,7 @@
 Arriba, leer el coche. A la izquierda el vehículo, que puede ser uno de verdad o uno de los tres emuladores que uso para la demo. Se conecta un adaptador ELM327, por cable USB, por WiFi o por TCP. La API tiene un transporte que negocia el protocolo del bus y va pidiendo modos y PIDs. Y lo que vuelve son bytes en crudo, así que el dominio aplica la fórmula de cada PID para convertirlos en magnitudes físicas.
 Abajo, razonar sobre lo leído. Antes de llamar al modelo se buscan casos parecidos en la base vectorial. El agente entra con esos casos, con las dieciséis herramientas MCP y con el modelo detrás, y va pidiendo lo que necesita. Sale un informe con narrativa, severidad y recomendaciones. Y ese caso se indexa.
 Esa flecha de vuelta es la clave del proyecto: lo que se aprende en un diagnóstico alimenta el siguiente. Cuantos más coches pasen, más casos reales hay con los que comparar.
-[~60 s]</a:t>
+[~60 s · acumulado 2:55]</a:t>
             </a:r>
             <a:endParaRPr lang="en-US" dirty="0"/>
           </a:p>
@@ -1723,7 +1723,7 @@
 ¿Y por qué no orientada a eventos? Porque aquí no hay varios servicios que desacoplar: es un solo proceso. El flujo es síncrono, el mecánico pregunta y se queda esperando. Un broker y colas me traerían consistencia eventual y mucha más superficie de depuración sin ganar nada. Y soy un solo programador: cuantas más piezas móviles, más sitio donde romper.
 Abajo está el ejemplo concreto de este proyecto. En el dominio, los value objects y los catálogos. En aplicación, los casos de uso y los puertos, que dicen qué hace falta pero no cómo. Y en infraestructura el cómo: Express, Drizzle sobre SQLite, LanceDB, el servidor MCP y el transporte del ELM327.
 El dominio no sabe que existe SQLite, ni Express, ni ningún modelo de lenguaje.
-[~80 s]</a:t>
+[~80 s · acumulado 4:15]</a:t>
             </a:r>
             <a:endParaRPr lang="en-US" dirty="0"/>
           </a:p>
@@ -1817,7 +1817,7 @@
 La centralita contesta 41 0C 0B B8. El 41 es el 01 más cuarenta, que es como la norma marca que es una respuesta. El 0C confirma qué PID contesta. Y los dos últimos bytes son el dato en crudo.
 Ese dato no son revoluciones todavía. Hay que aplicarle la fórmula del PID: A por 256 más B, dividido entre 4. Con 0B y B8, eso da 750 revoluciones.
 Esa fórmula la fija la SAE J1979, y por eso está en el dominio y no en el código que habla con el cable.
-[~70 s]</a:t>
+[~70 s · acumulado 5:25]</a:t>
             </a:r>
             <a:endParaRPr lang="en-US" dirty="0"/>
           </a:p>
@@ -1910,7 +1910,7 @@
 En la vectorial va ese mismo conocimiento pero indexado por significado, más los diagnósticos ya resueltos, que solo están ahí. La diferencia no es qué se guarda, es cómo se busca: en SQLite pregunto por una clave, y en la vectorial pido "enséñame algo parecido a esto".
 Y no vale con una sola. SQLite tiene buscador de texto, pero busca palabras: si el mecánico escribe "presión de aceite", no encuentra una ficha que ponga "oil pressure". La búsqueda vectorial sí, porque compara significado.
 Las dos son embebidas: un fichero y un directorio en disco. Cero servidores.
-[~55 s]</a:t>
+[~55 s · acumulado 6:20]</a:t>
             </a:r>
             <a:endParaRPr lang="en-US" dirty="0"/>
           </a:p>
@@ -2002,7 +2002,7 @@
 Los usuarios, que pueden ser particulares o talleres, con su rol. Los vehículos, identificados por su VIN, y las ECUs que se le han descubierto a cada uno en el bus. Las sesiones de diagnóstico, y de cada una el informe congelado, tal como salió ese día. Las lecturas de PID, guardando tanto el hexadecimal crudo que devolvió la centralita como el valor ya convertido. Y los logs y la auditoría de cada petición HTTP, que es requisito de OWASP.
 Al arrancar, la base se siembra: veinte PIDs de la norma SAE J1979, veintitrés códigos DTC estándar y veintisiete fabricantes por su código WMI, que es lo que permite sacar la marca de un VIN. Pero el catálogo no se queda ahí: cuando el agente lee un PID que no conoce, se inserta solo en esta base con confianza 0,3 y una fórmula asumida, marcado como auto-descubierto. Vale como pista, no como dato confirmado, hasta que se valida contra el coche.
 Es un fichero en disco, sin servidor. PostgreSQL se descartó porque a esta escala solo añadía un servicio, una red y un backup que mantener, sin resolver ningún problema que yo tuviera.
-[~60 s]</a:t>
+[~60 s · acumulado 7:20]</a:t>
             </a:r>
             <a:endParaRPr lang="en-US" dirty="0"/>
           </a:p>
@@ -2095,7 +2095,7 @@
 Y luego está el índice de confianza, que se lo ponemos nosotros al guardar según de dónde venga el dato. Si lo encontró el agente en internet entra con 0,3. Si viene de un diagnóstico anterior, 0,5. Si lo aportó el mecánico a mano, 0,8, porque una persona delante del coche sabe más que una web cualquiera. Y si se ha leído del propio coche por OBD es un hecho: 1,0. Comprobar un dato contra el coche sube la web a 0,7 y al mecánico a 0,9.
 Ese índice no es decorativo: es lo que pondera las búsquedas. Cuando al agente le llegan dos respuestas que se contradicen, gana la que más confianza tiene.
 [Si preguntan por el escalado] Hay dos mecanismos distintos y conviene no mezclarlos. Que el mecánico aporte o confirme un dato sube su confianza a 0,8, y validarlo contra el coche lo lleva a 0,9: eso está implementado y funciona. Lo que dejé fuera a propósito es subir la confianza de un caso cada vez que se reutiliza con acierto. La función existe y está testeada, pero no la llamo desde ningún flujo, porque para eso haría falta saber que el diagnóstico acertó de verdad, y nadie le dice al sistema si el coche se arregló. Inventármelo habría degradado el catálogo.
-[~70 s]</a:t>
+[~70 s · acumulado 8:30]</a:t>
             </a:r>
             <a:endParaRPr lang="en-US" dirty="0"/>
           </a:p>

</xml_diff>

<commit_message>
docs(tfm): diagrama general con las tres fases reales
</commit_message>
<xml_diff>
--- a/docs/presentacion/tfm-intelligent-automotive-diagnostics.pptx
+++ b/docs/presentacion/tfm-intelligent-automotive-diagnostics.pptx
@@ -1627,11 +1627,12 @@
           <a:p>
             <a:r>
               <a:rPr lang="en-US" dirty="0"/>
-              <a:t>Esta es la foto entera, para que se entienda dónde encaja cada cosa de lo que viene después.
-Arriba, leer el coche. A la izquierda el vehículo, que puede ser uno de verdad o uno de los tres emuladores que uso para la demo. Se conecta un adaptador ELM327, por cable USB, por WiFi o por TCP. La API tiene un transporte que negocia el protocolo del bus y va pidiendo modos y PIDs. Y lo que vuelve son bytes en crudo, así que el dominio aplica la fórmula de cada PID para convertirlos en magnitudes físicas.
-Abajo, razonar sobre lo leído. Antes de llamar al modelo se buscan casos parecidos en la base vectorial. El agente entra con esos casos, con las dieciséis herramientas MCP y con el modelo detrás, y va pidiendo lo que necesita. Sale un informe con narrativa, severidad y recomendaciones. Y ese caso se indexa.
-Esa flecha de vuelta es la clave del proyecto: lo que se aprende en un diagnóstico alimenta el siguiente. Cuantos más coches pasen, más casos reales hay con los que comparar.
-[~60 s · acumulado 2:55]</a:t>
+              <a:t>Esta es la foto entera, para que se entienda dónde encaja todo lo que viene después.
+La primera fase es identificar el coche. El mecánico entra con su sesión, elige el vehículo —por cable, por WiFi o uno de los emuladores— y el sistema le pregunta al coche el bastidor con el modo 09. De ahí resuelve la marca por una cascada: primero mira la base de datos, luego el catálogo de fabricantes, luego la web, y si nada funciona lo confirma el mecánico a mano y queda aprendido. Después hace un barrido del bus para ver qué centralitas contestan.
+La segunda fase es leer los datos: la telemetría con el modo 01 aplicando la fórmula de cada PID, los códigos de avería con los modos 03, 07 y 0A, y el freeze frame con el 02. Con eso el diagnóstico determinista calcula la severidad por regla, sin IA de por medio, y sale a pantalla. Todo eso queda guardado en SQLite con la sesión.
+La tercera fase es la de IA, y solo entra si hay modelo configurado. Antes de llamarlo se buscan casos parecidos en la base vectorial. El agente entra con esos casos y con las dieciséis herramientas MCP, y va pidiendo lo que le falta: el catálogo, más lecturas del coche, o la web si hace falta. Sale un informe con narrativa, severidad y recomendaciones.
+Y esa flecha de vuelta es la tesis del proyecto: el caso se indexa, y lo aprendido alimenta el siguiente diagnóstico.
+[~75 s · acumulado 2:55]</a:t>
             </a:r>
             <a:endParaRPr lang="en-US" dirty="0"/>
           </a:p>
@@ -9669,8 +9670,8 @@
         </p:nvSpPr>
         <p:spPr>
           <a:xfrm>
-            <a:off x="777240" y="548640"/>
-            <a:ext cx="10607040" cy="731520"/>
+            <a:off x="640080" y="457200"/>
+            <a:ext cx="10881360" cy="685800"/>
           </a:xfrm>
           <a:prstGeom prst="rect">
             <a:avLst/>
@@ -9686,7 +9687,7 @@
               <a:buNone/>
             </a:pPr>
             <a:r>
-              <a:rPr lang="en-US" sz="3400" b="1" dirty="0">
+              <a:rPr lang="en-US" sz="3200" b="1" dirty="0">
                 <a:solidFill>
                   <a:srgbClr val="1A1C2E"/>
                 </a:solidFill>
@@ -9696,7 +9697,7 @@
               </a:rPr>
               <a:t>El sistema de un vistazo</a:t>
             </a:r>
-            <a:endParaRPr lang="en-US" sz="3400" dirty="0"/>
+            <a:endParaRPr lang="en-US" sz="3200" dirty="0"/>
           </a:p>
         </p:txBody>
       </p:sp>
@@ -9708,8 +9709,8 @@
         </p:nvSpPr>
         <p:spPr>
           <a:xfrm>
-            <a:off x="777240" y="1371600"/>
-            <a:ext cx="10607040" cy="365760"/>
+            <a:off x="640080" y="1234440"/>
+            <a:ext cx="10881360" cy="320040"/>
           </a:xfrm>
           <a:prstGeom prst="rect">
             <a:avLst/>
@@ -9725,7 +9726,7 @@
               <a:buNone/>
             </a:pPr>
             <a:r>
-              <a:rPr lang="en-US" sz="1600" dirty="0">
+              <a:rPr lang="en-US" sz="1500" dirty="0">
                 <a:solidFill>
                   <a:srgbClr val="5A5F73"/>
                 </a:solidFill>
@@ -9735,7 +9736,7 @@
               </a:rPr>
               <a:t>Del conector del coche hasta la respuesta, y de vuelta al catálogo.</a:t>
             </a:r>
-            <a:endParaRPr lang="en-US" sz="1600" dirty="0"/>
+            <a:endParaRPr lang="en-US" sz="1500" dirty="0"/>
           </a:p>
         </p:txBody>
       </p:sp>
@@ -9747,8 +9748,8 @@
         </p:nvSpPr>
         <p:spPr>
           <a:xfrm>
-            <a:off x="777240" y="1947672"/>
-            <a:ext cx="10607040" cy="292608"/>
+            <a:off x="640080" y="1655064"/>
+            <a:ext cx="10881360" cy="256032"/>
           </a:xfrm>
           <a:prstGeom prst="rect">
             <a:avLst/>
@@ -9764,7 +9765,7 @@
               <a:buNone/>
             </a:pPr>
             <a:r>
-              <a:rPr lang="en-US" sz="1200" b="1" spc="150" kern="0" dirty="0">
+              <a:rPr lang="en-US" sz="1100" b="1" spc="140" kern="0" dirty="0">
                 <a:solidFill>
                   <a:srgbClr val="202CFC"/>
                 </a:solidFill>
@@ -9772,9 +9773,9 @@
                 <a:ea typeface="Calibri" pitchFamily="34" charset="-122"/>
                 <a:cs typeface="Calibri" pitchFamily="34" charset="-120"/>
               </a:rPr>
-              <a:t>1 · LEER EL COCHE</a:t>
-            </a:r>
-            <a:endParaRPr lang="en-US" sz="1200" dirty="0"/>
+              <a:t>1 · IDENTIFICAR EL COCHE</a:t>
+            </a:r>
+            <a:endParaRPr lang="en-US" sz="1100" dirty="0"/>
           </a:p>
         </p:txBody>
       </p:sp>
@@ -9786,12 +9787,12 @@
         </p:nvSpPr>
         <p:spPr>
           <a:xfrm>
-            <a:off x="777240" y="2331720"/>
-            <a:ext cx="2331720" cy="914400"/>
+            <a:off x="640080" y="1965960"/>
+            <a:ext cx="1920240" cy="749808"/>
           </a:xfrm>
           <a:prstGeom prst="roundRect">
             <a:avLst>
-              <a:gd name="adj" fmla="val 6000"/>
+              <a:gd name="adj" fmla="val 6098"/>
             </a:avLst>
           </a:prstGeom>
           <a:solidFill>
@@ -9813,8 +9814,8 @@
         </p:nvSpPr>
         <p:spPr>
           <a:xfrm>
-            <a:off x="886968" y="2459736"/>
-            <a:ext cx="2112264" cy="292608"/>
+            <a:off x="713232" y="2057400"/>
+            <a:ext cx="1773936" cy="256032"/>
           </a:xfrm>
           <a:prstGeom prst="rect">
             <a:avLst/>
@@ -9830,7 +9831,7 @@
               <a:buNone/>
             </a:pPr>
             <a:r>
-              <a:rPr lang="en-US" sz="1200" b="1" dirty="0">
+              <a:rPr lang="en-US" sz="1050" b="1" dirty="0">
                 <a:solidFill>
                   <a:srgbClr val="1A1C2E"/>
                 </a:solidFill>
@@ -9838,9 +9839,9 @@
                 <a:ea typeface="Arial" pitchFamily="34" charset="-122"/>
                 <a:cs typeface="Arial" pitchFamily="34" charset="-120"/>
               </a:rPr>
-              <a:t>El coche</a:t>
-            </a:r>
-            <a:endParaRPr lang="en-US" sz="1200" dirty="0"/>
+              <a:t>El mecánico</a:t>
+            </a:r>
+            <a:endParaRPr lang="en-US" sz="1050" dirty="0"/>
           </a:p>
         </p:txBody>
       </p:sp>
@@ -9852,8 +9853,8 @@
         </p:nvSpPr>
         <p:spPr>
           <a:xfrm>
-            <a:off x="886968" y="2752344"/>
-            <a:ext cx="2112264" cy="384048"/>
+            <a:off x="713232" y="2313432"/>
+            <a:ext cx="1773936" cy="347472"/>
           </a:xfrm>
           <a:prstGeom prst="rect">
             <a:avLst/>
@@ -9867,12 +9868,12 @@
           <a:p>
             <a:pPr algn="ctr" indent="0" marL="0">
               <a:lnSpc>
-                <a:spcPts val="1400"/>
+                <a:spcPts val="1100"/>
               </a:lnSpc>
               <a:buNone/>
             </a:pPr>
             <a:r>
-              <a:rPr lang="en-US" sz="1100" dirty="0">
+              <a:rPr lang="en-US" sz="900" dirty="0">
                 <a:solidFill>
                   <a:srgbClr val="5A5F73"/>
                 </a:solidFill>
@@ -9880,29 +9881,9 @@
                 <a:ea typeface="Calibri" pitchFamily="34" charset="-122"/>
                 <a:cs typeface="Calibri" pitchFamily="34" charset="-120"/>
               </a:rPr>
-              <a:t>o uno de los tres</a:t>
-            </a:r>
-            <a:endParaRPr lang="en-US" sz="1100" dirty="0"/>
-          </a:p>
-          <a:p>
-            <a:pPr algn="ctr" indent="0" marL="0">
-              <a:lnSpc>
-                <a:spcPts val="1400"/>
-              </a:lnSpc>
-              <a:buNone/>
-            </a:pPr>
-            <a:r>
-              <a:rPr lang="en-US" sz="1100" dirty="0">
-                <a:solidFill>
-                  <a:srgbClr val="5A5F73"/>
-                </a:solidFill>
-                <a:latin typeface="Calibri" pitchFamily="34" charset="0"/>
-                <a:ea typeface="Calibri" pitchFamily="34" charset="-122"/>
-                <a:cs typeface="Calibri" pitchFamily="34" charset="-120"/>
-              </a:rPr>
-              <a:t>emuladores ELM327</a:t>
-            </a:r>
-            <a:endParaRPr lang="en-US" sz="1100" dirty="0"/>
+              <a:t>React 19, sesión JWT</a:t>
+            </a:r>
+            <a:endParaRPr lang="en-US" sz="900" dirty="0"/>
           </a:p>
         </p:txBody>
       </p:sp>
@@ -9914,14 +9895,14 @@
         </p:nvSpPr>
         <p:spPr>
           <a:xfrm>
-            <a:off x="3182112" y="2788920"/>
-            <a:ext cx="256032" cy="0"/>
+            <a:off x="2615184" y="2340864"/>
+            <a:ext cx="210312" cy="0"/>
           </a:xfrm>
           <a:prstGeom prst="line">
             <a:avLst/>
           </a:prstGeom>
           <a:noFill/>
-          <a:ln w="19050">
+          <a:ln w="15875">
             <a:solidFill>
               <a:srgbClr val="202CFC"/>
             </a:solidFill>
@@ -9938,12 +9919,12 @@
         </p:nvSpPr>
         <p:spPr>
           <a:xfrm>
-            <a:off x="3511296" y="2331720"/>
-            <a:ext cx="2331720" cy="914400"/>
+            <a:off x="2880360" y="1965960"/>
+            <a:ext cx="1920240" cy="749808"/>
           </a:xfrm>
           <a:prstGeom prst="roundRect">
             <a:avLst>
-              <a:gd name="adj" fmla="val 6000"/>
+              <a:gd name="adj" fmla="val 6098"/>
             </a:avLst>
           </a:prstGeom>
           <a:solidFill>
@@ -9965,8 +9946,8 @@
         </p:nvSpPr>
         <p:spPr>
           <a:xfrm>
-            <a:off x="3621024" y="2459736"/>
-            <a:ext cx="2112264" cy="292608"/>
+            <a:off x="2953512" y="2057400"/>
+            <a:ext cx="1773936" cy="256032"/>
           </a:xfrm>
           <a:prstGeom prst="rect">
             <a:avLst/>
@@ -9982,7 +9963,7 @@
               <a:buNone/>
             </a:pPr>
             <a:r>
-              <a:rPr lang="en-US" sz="1200" b="1" dirty="0">
+              <a:rPr lang="en-US" sz="1050" b="1" dirty="0">
                 <a:solidFill>
                   <a:srgbClr val="1A1C2E"/>
                 </a:solidFill>
@@ -9990,9 +9971,9 @@
                 <a:ea typeface="Arial" pitchFamily="34" charset="-122"/>
                 <a:cs typeface="Arial" pitchFamily="34" charset="-120"/>
               </a:rPr>
-              <a:t>Adaptador ELM327</a:t>
-            </a:r>
-            <a:endParaRPr lang="en-US" sz="1200" dirty="0"/>
+              <a:t>Elige vehículo</a:t>
+            </a:r>
+            <a:endParaRPr lang="en-US" sz="1050" dirty="0"/>
           </a:p>
         </p:txBody>
       </p:sp>
@@ -10004,8 +9985,8 @@
         </p:nvSpPr>
         <p:spPr>
           <a:xfrm>
-            <a:off x="3621024" y="2752344"/>
-            <a:ext cx="2112264" cy="384048"/>
+            <a:off x="2953512" y="2313432"/>
+            <a:ext cx="1773936" cy="347472"/>
           </a:xfrm>
           <a:prstGeom prst="rect">
             <a:avLst/>
@@ -10019,12 +10000,12 @@
           <a:p>
             <a:pPr algn="ctr" indent="0" marL="0">
               <a:lnSpc>
-                <a:spcPts val="1400"/>
+                <a:spcPts val="1100"/>
               </a:lnSpc>
               <a:buNone/>
             </a:pPr>
             <a:r>
-              <a:rPr lang="en-US" sz="1100" dirty="0">
+              <a:rPr lang="en-US" sz="900" dirty="0">
                 <a:solidFill>
                   <a:srgbClr val="5A5F73"/>
                 </a:solidFill>
@@ -10032,19 +10013,19 @@
                 <a:ea typeface="Calibri" pitchFamily="34" charset="-122"/>
                 <a:cs typeface="Calibri" pitchFamily="34" charset="-120"/>
               </a:rPr>
-              <a:t>por cable USB,</a:t>
-            </a:r>
-            <a:endParaRPr lang="en-US" sz="1100" dirty="0"/>
+              <a:t>cable USB, WiFi</a:t>
+            </a:r>
+            <a:endParaRPr lang="en-US" sz="900" dirty="0"/>
           </a:p>
           <a:p>
             <a:pPr algn="ctr" indent="0" marL="0">
               <a:lnSpc>
-                <a:spcPts val="1400"/>
+                <a:spcPts val="1100"/>
               </a:lnSpc>
               <a:buNone/>
             </a:pPr>
             <a:r>
-              <a:rPr lang="en-US" sz="1100" dirty="0">
+              <a:rPr lang="en-US" sz="900" dirty="0">
                 <a:solidFill>
                   <a:srgbClr val="5A5F73"/>
                 </a:solidFill>
@@ -10052,9 +10033,9 @@
                 <a:ea typeface="Calibri" pitchFamily="34" charset="-122"/>
                 <a:cs typeface="Calibri" pitchFamily="34" charset="-120"/>
               </a:rPr>
-              <a:t>WiFi o TCP</a:t>
-            </a:r>
-            <a:endParaRPr lang="en-US" sz="1100" dirty="0"/>
+              <a:t>o emulador</a:t>
+            </a:r>
+            <a:endParaRPr lang="en-US" sz="900" dirty="0"/>
           </a:p>
         </p:txBody>
       </p:sp>
@@ -10066,14 +10047,14 @@
         </p:nvSpPr>
         <p:spPr>
           <a:xfrm>
-            <a:off x="5916168" y="2788920"/>
-            <a:ext cx="256032" cy="0"/>
+            <a:off x="4855464" y="2340864"/>
+            <a:ext cx="210312" cy="0"/>
           </a:xfrm>
           <a:prstGeom prst="line">
             <a:avLst/>
           </a:prstGeom>
           <a:noFill/>
-          <a:ln w="19050">
+          <a:ln w="15875">
             <a:solidFill>
               <a:srgbClr val="202CFC"/>
             </a:solidFill>
@@ -10090,12 +10071,12 @@
         </p:nvSpPr>
         <p:spPr>
           <a:xfrm>
-            <a:off x="6245352" y="2331720"/>
-            <a:ext cx="2331720" cy="914400"/>
+            <a:off x="5120640" y="1965960"/>
+            <a:ext cx="1920240" cy="749808"/>
           </a:xfrm>
           <a:prstGeom prst="roundRect">
             <a:avLst>
-              <a:gd name="adj" fmla="val 6000"/>
+              <a:gd name="adj" fmla="val 6098"/>
             </a:avLst>
           </a:prstGeom>
           <a:solidFill>
@@ -10117,8 +10098,8 @@
         </p:nvSpPr>
         <p:spPr>
           <a:xfrm>
-            <a:off x="6355080" y="2459736"/>
-            <a:ext cx="2112264" cy="292608"/>
+            <a:off x="5193792" y="2057400"/>
+            <a:ext cx="1773936" cy="256032"/>
           </a:xfrm>
           <a:prstGeom prst="rect">
             <a:avLst/>
@@ -10134,7 +10115,7 @@
               <a:buNone/>
             </a:pPr>
             <a:r>
-              <a:rPr lang="en-US" sz="1200" b="1" dirty="0">
+              <a:rPr lang="en-US" sz="1050" b="1" dirty="0">
                 <a:solidFill>
                   <a:srgbClr val="1A1C2E"/>
                 </a:solidFill>
@@ -10142,9 +10123,9 @@
                 <a:ea typeface="Arial" pitchFamily="34" charset="-122"/>
                 <a:cs typeface="Arial" pitchFamily="34" charset="-120"/>
               </a:rPr>
-              <a:t>Transporte OBD</a:t>
-            </a:r>
-            <a:endParaRPr lang="en-US" sz="1200" dirty="0"/>
+              <a:t>Lee el VIN</a:t>
+            </a:r>
+            <a:endParaRPr lang="en-US" sz="1050" dirty="0"/>
           </a:p>
         </p:txBody>
       </p:sp>
@@ -10156,8 +10137,8 @@
         </p:nvSpPr>
         <p:spPr>
           <a:xfrm>
-            <a:off x="6355080" y="2752344"/>
-            <a:ext cx="2112264" cy="384048"/>
+            <a:off x="5193792" y="2313432"/>
+            <a:ext cx="1773936" cy="347472"/>
           </a:xfrm>
           <a:prstGeom prst="rect">
             <a:avLst/>
@@ -10171,12 +10152,12 @@
           <a:p>
             <a:pPr algn="ctr" indent="0" marL="0">
               <a:lnSpc>
-                <a:spcPts val="1400"/>
+                <a:spcPts val="1100"/>
               </a:lnSpc>
               <a:buNone/>
             </a:pPr>
             <a:r>
-              <a:rPr lang="en-US" sz="1100" dirty="0">
+              <a:rPr lang="en-US" sz="900" dirty="0">
                 <a:solidFill>
                   <a:srgbClr val="5A5F73"/>
                 </a:solidFill>
@@ -10184,29 +10165,9 @@
                 <a:ea typeface="Calibri" pitchFamily="34" charset="-122"/>
                 <a:cs typeface="Calibri" pitchFamily="34" charset="-120"/>
               </a:rPr>
-              <a:t>negocia el protocolo</a:t>
-            </a:r>
-            <a:endParaRPr lang="en-US" sz="1100" dirty="0"/>
-          </a:p>
-          <a:p>
-            <a:pPr algn="ctr" indent="0" marL="0">
-              <a:lnSpc>
-                <a:spcPts val="1400"/>
-              </a:lnSpc>
-              <a:buNone/>
-            </a:pPr>
-            <a:r>
-              <a:rPr lang="en-US" sz="1100" dirty="0">
-                <a:solidFill>
-                  <a:srgbClr val="5A5F73"/>
-                </a:solidFill>
-                <a:latin typeface="Calibri" pitchFamily="34" charset="0"/>
-                <a:ea typeface="Calibri" pitchFamily="34" charset="-122"/>
-                <a:cs typeface="Calibri" pitchFamily="34" charset="-120"/>
-              </a:rPr>
-              <a:t>y pide modos y PIDs</a:t>
-            </a:r>
-            <a:endParaRPr lang="en-US" sz="1100" dirty="0"/>
+              <a:t>modo 09, ISO 3779</a:t>
+            </a:r>
+            <a:endParaRPr lang="en-US" sz="900" dirty="0"/>
           </a:p>
         </p:txBody>
       </p:sp>
@@ -10218,14 +10179,14 @@
         </p:nvSpPr>
         <p:spPr>
           <a:xfrm>
-            <a:off x="8650224" y="2788920"/>
-            <a:ext cx="256032" cy="0"/>
+            <a:off x="7095744" y="2340864"/>
+            <a:ext cx="210312" cy="0"/>
           </a:xfrm>
           <a:prstGeom prst="line">
             <a:avLst/>
           </a:prstGeom>
           <a:noFill/>
-          <a:ln w="19050">
+          <a:ln w="15875">
             <a:solidFill>
               <a:srgbClr val="202CFC"/>
             </a:solidFill>
@@ -10242,12 +10203,12 @@
         </p:nvSpPr>
         <p:spPr>
           <a:xfrm>
-            <a:off x="8979408" y="2331720"/>
-            <a:ext cx="2331720" cy="914400"/>
+            <a:off x="7360920" y="1965960"/>
+            <a:ext cx="1920240" cy="749808"/>
           </a:xfrm>
           <a:prstGeom prst="roundRect">
             <a:avLst>
-              <a:gd name="adj" fmla="val 6000"/>
+              <a:gd name="adj" fmla="val 6098"/>
             </a:avLst>
           </a:prstGeom>
           <a:solidFill>
@@ -10269,8 +10230,8 @@
         </p:nvSpPr>
         <p:spPr>
           <a:xfrm>
-            <a:off x="9089136" y="2459736"/>
-            <a:ext cx="2112264" cy="292608"/>
+            <a:off x="7434072" y="2057400"/>
+            <a:ext cx="1773936" cy="256032"/>
           </a:xfrm>
           <a:prstGeom prst="rect">
             <a:avLst/>
@@ -10286,7 +10247,7 @@
               <a:buNone/>
             </a:pPr>
             <a:r>
-              <a:rPr lang="en-US" sz="1200" b="1" dirty="0">
+              <a:rPr lang="en-US" sz="1050" b="1" dirty="0">
                 <a:solidFill>
                   <a:srgbClr val="1A1C2E"/>
                 </a:solidFill>
@@ -10294,9 +10255,9 @@
                 <a:ea typeface="Arial" pitchFamily="34" charset="-122"/>
                 <a:cs typeface="Arial" pitchFamily="34" charset="-120"/>
               </a:rPr>
-              <a:t>Dominio</a:t>
-            </a:r>
-            <a:endParaRPr lang="en-US" sz="1200" dirty="0"/>
+              <a:t>Resuelve la marca</a:t>
+            </a:r>
+            <a:endParaRPr lang="en-US" sz="1050" dirty="0"/>
           </a:p>
         </p:txBody>
       </p:sp>
@@ -10308,8 +10269,8 @@
         </p:nvSpPr>
         <p:spPr>
           <a:xfrm>
-            <a:off x="9089136" y="2752344"/>
-            <a:ext cx="2112264" cy="384048"/>
+            <a:off x="7434072" y="2313432"/>
+            <a:ext cx="1773936" cy="347472"/>
           </a:xfrm>
           <a:prstGeom prst="rect">
             <a:avLst/>
@@ -10323,12 +10284,12 @@
           <a:p>
             <a:pPr algn="ctr" indent="0" marL="0">
               <a:lnSpc>
-                <a:spcPts val="1400"/>
+                <a:spcPts val="1100"/>
               </a:lnSpc>
               <a:buNone/>
             </a:pPr>
             <a:r>
-              <a:rPr lang="en-US" sz="1100" dirty="0">
+              <a:rPr lang="en-US" sz="900" dirty="0">
                 <a:solidFill>
                   <a:srgbClr val="5A5F73"/>
                 </a:solidFill>
@@ -10336,19 +10297,19 @@
                 <a:ea typeface="Calibri" pitchFamily="34" charset="-122"/>
                 <a:cs typeface="Calibri" pitchFamily="34" charset="-120"/>
               </a:rPr>
-              <a:t>aplica la fórmula</a:t>
-            </a:r>
-            <a:endParaRPr lang="en-US" sz="1100" dirty="0"/>
+              <a:t>BBDD → catálogo →</a:t>
+            </a:r>
+            <a:endParaRPr lang="en-US" sz="900" dirty="0"/>
           </a:p>
           <a:p>
             <a:pPr algn="ctr" indent="0" marL="0">
               <a:lnSpc>
-                <a:spcPts val="1400"/>
+                <a:spcPts val="1100"/>
               </a:lnSpc>
               <a:buNone/>
             </a:pPr>
             <a:r>
-              <a:rPr lang="en-US" sz="1100" dirty="0">
+              <a:rPr lang="en-US" sz="900" dirty="0">
                 <a:solidFill>
                   <a:srgbClr val="5A5F73"/>
                 </a:solidFill>
@@ -10356,50 +10317,35 @@
                 <a:ea typeface="Calibri" pitchFamily="34" charset="-122"/>
                 <a:cs typeface="Calibri" pitchFamily="34" charset="-120"/>
               </a:rPr>
-              <a:t>de cada PID</a:t>
-            </a:r>
-            <a:endParaRPr lang="en-US" sz="1100" dirty="0"/>
-          </a:p>
-        </p:txBody>
-      </p:sp>
-      <p:sp>
-        <p:nvSpPr>
-          <p:cNvPr id="20" name="Text 18"/>
-          <p:cNvSpPr/>
-          <p:nvPr/>
-        </p:nvSpPr>
-        <p:spPr>
-          <a:xfrm>
-            <a:off x="777240" y="3959352"/>
-            <a:ext cx="10607040" cy="292608"/>
-          </a:xfrm>
-          <a:prstGeom prst="rect">
-            <a:avLst/>
-          </a:prstGeom>
-          <a:noFill/>
-          <a:ln/>
-        </p:spPr>
-        <p:txBody>
-          <a:bodyPr wrap="square" lIns="0" tIns="0" rIns="0" bIns="0" rtlCol="0" anchor="t"/>
-          <a:lstStyle/>
-          <a:p>
-            <a:pPr indent="0" marL="0">
-              <a:buNone/>
-            </a:pPr>
-            <a:r>
-              <a:rPr lang="en-US" sz="1200" b="1" spc="150" kern="0" dirty="0">
-                <a:solidFill>
-                  <a:srgbClr val="202CFC"/>
-                </a:solidFill>
-                <a:latin typeface="Calibri" pitchFamily="34" charset="0"/>
-                <a:ea typeface="Calibri" pitchFamily="34" charset="-122"/>
-                <a:cs typeface="Calibri" pitchFamily="34" charset="-120"/>
-              </a:rPr>
-              <a:t>2 · RAZONAR SOBRE LO LEÍDO</a:t>
-            </a:r>
-            <a:endParaRPr lang="en-US" sz="1200" dirty="0"/>
-          </a:p>
-        </p:txBody>
+              <a:t>web → mecánico</a:t>
+            </a:r>
+            <a:endParaRPr lang="en-US" sz="900" dirty="0"/>
+          </a:p>
+        </p:txBody>
+      </p:sp>
+      <p:sp>
+        <p:nvSpPr>
+          <p:cNvPr id="20" name="Shape 18"/>
+          <p:cNvSpPr/>
+          <p:nvPr/>
+        </p:nvSpPr>
+        <p:spPr>
+          <a:xfrm>
+            <a:off x="9336024" y="2340864"/>
+            <a:ext cx="210312" cy="0"/>
+          </a:xfrm>
+          <a:prstGeom prst="line">
+            <a:avLst/>
+          </a:prstGeom>
+          <a:noFill/>
+          <a:ln w="15875">
+            <a:solidFill>
+              <a:srgbClr val="202CFC"/>
+            </a:solidFill>
+            <a:prstDash val="solid"/>
+            <a:tailEnd type="triangle"/>
+          </a:ln>
+        </p:spPr>
       </p:sp>
       <p:sp>
         <p:nvSpPr>
@@ -10409,12 +10355,12 @@
         </p:nvSpPr>
         <p:spPr>
           <a:xfrm>
-            <a:off x="777240" y="4343400"/>
-            <a:ext cx="2331720" cy="914400"/>
+            <a:off x="9601200" y="1965960"/>
+            <a:ext cx="1920240" cy="749808"/>
           </a:xfrm>
           <a:prstGeom prst="roundRect">
             <a:avLst>
-              <a:gd name="adj" fmla="val 6000"/>
+              <a:gd name="adj" fmla="val 6098"/>
             </a:avLst>
           </a:prstGeom>
           <a:solidFill>
@@ -10436,8 +10382,8 @@
         </p:nvSpPr>
         <p:spPr>
           <a:xfrm>
-            <a:off x="886968" y="4471416"/>
-            <a:ext cx="2112264" cy="292608"/>
+            <a:off x="9674352" y="2057400"/>
+            <a:ext cx="1773936" cy="256032"/>
           </a:xfrm>
           <a:prstGeom prst="rect">
             <a:avLst/>
@@ -10453,7 +10399,7 @@
               <a:buNone/>
             </a:pPr>
             <a:r>
-              <a:rPr lang="en-US" sz="1200" b="1" dirty="0">
+              <a:rPr lang="en-US" sz="1050" b="1" dirty="0">
                 <a:solidFill>
                   <a:srgbClr val="1A1C2E"/>
                 </a:solidFill>
@@ -10461,9 +10407,9 @@
                 <a:ea typeface="Arial" pitchFamily="34" charset="-122"/>
                 <a:cs typeface="Arial" pitchFamily="34" charset="-120"/>
               </a:rPr>
-              <a:t>Casos parecidos</a:t>
-            </a:r>
-            <a:endParaRPr lang="en-US" sz="1200" dirty="0"/>
+              <a:t>Barrido del bus</a:t>
+            </a:r>
+            <a:endParaRPr lang="en-US" sz="1050" dirty="0"/>
           </a:p>
         </p:txBody>
       </p:sp>
@@ -10475,8 +10421,8 @@
         </p:nvSpPr>
         <p:spPr>
           <a:xfrm>
-            <a:off x="886968" y="4764024"/>
-            <a:ext cx="2112264" cy="384048"/>
+            <a:off x="9674352" y="2313432"/>
+            <a:ext cx="1773936" cy="347472"/>
           </a:xfrm>
           <a:prstGeom prst="rect">
             <a:avLst/>
@@ -10490,12 +10436,12 @@
           <a:p>
             <a:pPr algn="ctr" indent="0" marL="0">
               <a:lnSpc>
-                <a:spcPts val="1400"/>
+                <a:spcPts val="1100"/>
               </a:lnSpc>
               <a:buNone/>
             </a:pPr>
             <a:r>
-              <a:rPr lang="en-US" sz="1100" dirty="0">
+              <a:rPr lang="en-US" sz="900" dirty="0">
                 <a:solidFill>
                   <a:srgbClr val="5A5F73"/>
                 </a:solidFill>
@@ -10503,19 +10449,19 @@
                 <a:ea typeface="Calibri" pitchFamily="34" charset="-122"/>
                 <a:cs typeface="Calibri" pitchFamily="34" charset="-120"/>
               </a:rPr>
-              <a:t>búsqueda vectorial</a:t>
-            </a:r>
-            <a:endParaRPr lang="en-US" sz="1100" dirty="0"/>
+              <a:t>quién contesta,</a:t>
+            </a:r>
+            <a:endParaRPr lang="en-US" sz="900" dirty="0"/>
           </a:p>
           <a:p>
             <a:pPr algn="ctr" indent="0" marL="0">
               <a:lnSpc>
-                <a:spcPts val="1400"/>
+                <a:spcPts val="1100"/>
               </a:lnSpc>
               <a:buNone/>
             </a:pPr>
             <a:r>
-              <a:rPr lang="en-US" sz="1100" dirty="0">
+              <a:rPr lang="en-US" sz="900" dirty="0">
                 <a:solidFill>
                   <a:srgbClr val="5A5F73"/>
                 </a:solidFill>
@@ -10523,7 +10469,46 @@
                 <a:ea typeface="Calibri" pitchFamily="34" charset="-122"/>
                 <a:cs typeface="Calibri" pitchFamily="34" charset="-120"/>
               </a:rPr>
-              <a:t>en LanceDB</a:t>
+              <a:t>ISO 15765-4</a:t>
+            </a:r>
+            <a:endParaRPr lang="en-US" sz="900" dirty="0"/>
+          </a:p>
+        </p:txBody>
+      </p:sp>
+      <p:sp>
+        <p:nvSpPr>
+          <p:cNvPr id="24" name="Text 22"/>
+          <p:cNvSpPr/>
+          <p:nvPr/>
+        </p:nvSpPr>
+        <p:spPr>
+          <a:xfrm>
+            <a:off x="640080" y="3026664"/>
+            <a:ext cx="10881360" cy="256032"/>
+          </a:xfrm>
+          <a:prstGeom prst="rect">
+            <a:avLst/>
+          </a:prstGeom>
+          <a:noFill/>
+          <a:ln/>
+        </p:spPr>
+        <p:txBody>
+          <a:bodyPr wrap="square" lIns="0" tIns="0" rIns="0" bIns="0" rtlCol="0" anchor="t"/>
+          <a:lstStyle/>
+          <a:p>
+            <a:pPr indent="0" marL="0">
+              <a:buNone/>
+            </a:pPr>
+            <a:r>
+              <a:rPr lang="en-US" sz="1100" b="1" spc="140" kern="0" dirty="0">
+                <a:solidFill>
+                  <a:srgbClr val="202CFC"/>
+                </a:solidFill>
+                <a:latin typeface="Calibri" pitchFamily="34" charset="0"/>
+                <a:ea typeface="Calibri" pitchFamily="34" charset="-122"/>
+                <a:cs typeface="Calibri" pitchFamily="34" charset="-120"/>
+              </a:rPr>
+              <a:t>2 · LEER LOS DATOS</a:t>
             </a:r>
             <a:endParaRPr lang="en-US" sz="1100" dirty="0"/>
           </a:p>
@@ -10531,42 +10516,18 @@
       </p:sp>
       <p:sp>
         <p:nvSpPr>
-          <p:cNvPr id="24" name="Shape 22"/>
-          <p:cNvSpPr/>
-          <p:nvPr/>
-        </p:nvSpPr>
-        <p:spPr>
-          <a:xfrm>
-            <a:off x="3182112" y="4800600"/>
-            <a:ext cx="256032" cy="0"/>
-          </a:xfrm>
-          <a:prstGeom prst="line">
-            <a:avLst/>
-          </a:prstGeom>
-          <a:noFill/>
-          <a:ln w="19050">
-            <a:solidFill>
-              <a:srgbClr val="202CFC"/>
-            </a:solidFill>
-            <a:prstDash val="solid"/>
-            <a:tailEnd type="triangle"/>
-          </a:ln>
-        </p:spPr>
-      </p:sp>
-      <p:sp>
-        <p:nvSpPr>
           <p:cNvPr id="25" name="Shape 23"/>
           <p:cNvSpPr/>
           <p:nvPr/>
         </p:nvSpPr>
         <p:spPr>
           <a:xfrm>
-            <a:off x="3511296" y="4343400"/>
-            <a:ext cx="2331720" cy="914400"/>
+            <a:off x="640080" y="3337560"/>
+            <a:ext cx="1920240" cy="749808"/>
           </a:xfrm>
           <a:prstGeom prst="roundRect">
             <a:avLst>
-              <a:gd name="adj" fmla="val 6000"/>
+              <a:gd name="adj" fmla="val 6098"/>
             </a:avLst>
           </a:prstGeom>
           <a:solidFill>
@@ -10588,8 +10549,8 @@
         </p:nvSpPr>
         <p:spPr>
           <a:xfrm>
-            <a:off x="3621024" y="4471416"/>
-            <a:ext cx="2112264" cy="292608"/>
+            <a:off x="713232" y="3429000"/>
+            <a:ext cx="1773936" cy="256032"/>
           </a:xfrm>
           <a:prstGeom prst="rect">
             <a:avLst/>
@@ -10605,7 +10566,7 @@
               <a:buNone/>
             </a:pPr>
             <a:r>
-              <a:rPr lang="en-US" sz="1200" b="1" dirty="0">
+              <a:rPr lang="en-US" sz="1050" b="1" dirty="0">
                 <a:solidFill>
                   <a:srgbClr val="1A1C2E"/>
                 </a:solidFill>
@@ -10613,9 +10574,9 @@
                 <a:ea typeface="Arial" pitchFamily="34" charset="-122"/>
                 <a:cs typeface="Arial" pitchFamily="34" charset="-120"/>
               </a:rPr>
-              <a:t>Agente</a:t>
-            </a:r>
-            <a:endParaRPr lang="en-US" sz="1200" dirty="0"/>
+              <a:t>Telemetría</a:t>
+            </a:r>
+            <a:endParaRPr lang="en-US" sz="1050" dirty="0"/>
           </a:p>
         </p:txBody>
       </p:sp>
@@ -10627,8 +10588,8 @@
         </p:nvSpPr>
         <p:spPr>
           <a:xfrm>
-            <a:off x="3621024" y="4764024"/>
-            <a:ext cx="2112264" cy="384048"/>
+            <a:off x="713232" y="3685032"/>
+            <a:ext cx="1773936" cy="347472"/>
           </a:xfrm>
           <a:prstGeom prst="rect">
             <a:avLst/>
@@ -10642,12 +10603,12 @@
           <a:p>
             <a:pPr algn="ctr" indent="0" marL="0">
               <a:lnSpc>
-                <a:spcPts val="1400"/>
+                <a:spcPts val="1100"/>
               </a:lnSpc>
               <a:buNone/>
             </a:pPr>
             <a:r>
-              <a:rPr lang="en-US" sz="1100" dirty="0">
+              <a:rPr lang="en-US" sz="900" dirty="0">
                 <a:solidFill>
                   <a:srgbClr val="5A5F73"/>
                 </a:solidFill>
@@ -10655,19 +10616,19 @@
                 <a:ea typeface="Calibri" pitchFamily="34" charset="-122"/>
                 <a:cs typeface="Calibri" pitchFamily="34" charset="-120"/>
               </a:rPr>
-              <a:t>16 tools MCP</a:t>
-            </a:r>
-            <a:endParaRPr lang="en-US" sz="1100" dirty="0"/>
+              <a:t>modo 01 + la fórmula</a:t>
+            </a:r>
+            <a:endParaRPr lang="en-US" sz="900" dirty="0"/>
           </a:p>
           <a:p>
             <a:pPr algn="ctr" indent="0" marL="0">
               <a:lnSpc>
-                <a:spcPts val="1400"/>
+                <a:spcPts val="1100"/>
               </a:lnSpc>
               <a:buNone/>
             </a:pPr>
             <a:r>
-              <a:rPr lang="en-US" sz="1100" dirty="0">
+              <a:rPr lang="en-US" sz="900" dirty="0">
                 <a:solidFill>
                   <a:srgbClr val="5A5F73"/>
                 </a:solidFill>
@@ -10675,9 +10636,9 @@
                 <a:ea typeface="Calibri" pitchFamily="34" charset="-122"/>
                 <a:cs typeface="Calibri" pitchFamily="34" charset="-120"/>
               </a:rPr>
-              <a:t>+ el modelo</a:t>
-            </a:r>
-            <a:endParaRPr lang="en-US" sz="1100" dirty="0"/>
+              <a:t>de cada PID</a:t>
+            </a:r>
+            <a:endParaRPr lang="en-US" sz="900" dirty="0"/>
           </a:p>
         </p:txBody>
       </p:sp>
@@ -10689,14 +10650,14 @@
         </p:nvSpPr>
         <p:spPr>
           <a:xfrm>
-            <a:off x="5916168" y="4800600"/>
-            <a:ext cx="256032" cy="0"/>
+            <a:off x="2615184" y="3712464"/>
+            <a:ext cx="210312" cy="0"/>
           </a:xfrm>
           <a:prstGeom prst="line">
             <a:avLst/>
           </a:prstGeom>
           <a:noFill/>
-          <a:ln w="19050">
+          <a:ln w="15875">
             <a:solidFill>
               <a:srgbClr val="202CFC"/>
             </a:solidFill>
@@ -10713,12 +10674,12 @@
         </p:nvSpPr>
         <p:spPr>
           <a:xfrm>
-            <a:off x="6245352" y="4343400"/>
-            <a:ext cx="2331720" cy="914400"/>
+            <a:off x="2880360" y="3337560"/>
+            <a:ext cx="1920240" cy="749808"/>
           </a:xfrm>
           <a:prstGeom prst="roundRect">
             <a:avLst>
-              <a:gd name="adj" fmla="val 6000"/>
+              <a:gd name="adj" fmla="val 6098"/>
             </a:avLst>
           </a:prstGeom>
           <a:solidFill>
@@ -10740,8 +10701,8 @@
         </p:nvSpPr>
         <p:spPr>
           <a:xfrm>
-            <a:off x="6355080" y="4471416"/>
-            <a:ext cx="2112264" cy="292608"/>
+            <a:off x="2953512" y="3429000"/>
+            <a:ext cx="1773936" cy="256032"/>
           </a:xfrm>
           <a:prstGeom prst="rect">
             <a:avLst/>
@@ -10757,7 +10718,7 @@
               <a:buNone/>
             </a:pPr>
             <a:r>
-              <a:rPr lang="en-US" sz="1200" b="1" dirty="0">
+              <a:rPr lang="en-US" sz="1050" b="1" dirty="0">
                 <a:solidFill>
                   <a:srgbClr val="1A1C2E"/>
                 </a:solidFill>
@@ -10765,9 +10726,9 @@
                 <a:ea typeface="Arial" pitchFamily="34" charset="-122"/>
                 <a:cs typeface="Arial" pitchFamily="34" charset="-120"/>
               </a:rPr>
-              <a:t>Informe</a:t>
-            </a:r>
-            <a:endParaRPr lang="en-US" sz="1200" dirty="0"/>
+              <a:t>Códigos DTC</a:t>
+            </a:r>
+            <a:endParaRPr lang="en-US" sz="1050" dirty="0"/>
           </a:p>
         </p:txBody>
       </p:sp>
@@ -10779,8 +10740,8 @@
         </p:nvSpPr>
         <p:spPr>
           <a:xfrm>
-            <a:off x="6355080" y="4764024"/>
-            <a:ext cx="2112264" cy="384048"/>
+            <a:off x="2953512" y="3685032"/>
+            <a:ext cx="1773936" cy="347472"/>
           </a:xfrm>
           <a:prstGeom prst="rect">
             <a:avLst/>
@@ -10794,12 +10755,12 @@
           <a:p>
             <a:pPr algn="ctr" indent="0" marL="0">
               <a:lnSpc>
-                <a:spcPts val="1400"/>
+                <a:spcPts val="1100"/>
               </a:lnSpc>
               <a:buNone/>
             </a:pPr>
             <a:r>
-              <a:rPr lang="en-US" sz="1100" dirty="0">
+              <a:rPr lang="en-US" sz="900" dirty="0">
                 <a:solidFill>
                   <a:srgbClr val="5A5F73"/>
                 </a:solidFill>
@@ -10807,29 +10768,9 @@
                 <a:ea typeface="Calibri" pitchFamily="34" charset="-122"/>
                 <a:cs typeface="Calibri" pitchFamily="34" charset="-120"/>
               </a:rPr>
-              <a:t>narrativa, severidad</a:t>
-            </a:r>
-            <a:endParaRPr lang="en-US" sz="1100" dirty="0"/>
-          </a:p>
-          <a:p>
-            <a:pPr algn="ctr" indent="0" marL="0">
-              <a:lnSpc>
-                <a:spcPts val="1400"/>
-              </a:lnSpc>
-              <a:buNone/>
-            </a:pPr>
-            <a:r>
-              <a:rPr lang="en-US" sz="1100" dirty="0">
-                <a:solidFill>
-                  <a:srgbClr val="5A5F73"/>
-                </a:solidFill>
-                <a:latin typeface="Calibri" pitchFamily="34" charset="0"/>
-                <a:ea typeface="Calibri" pitchFamily="34" charset="-122"/>
-                <a:cs typeface="Calibri" pitchFamily="34" charset="-120"/>
-              </a:rPr>
-              <a:t>y recomendaciones</a:t>
-            </a:r>
-            <a:endParaRPr lang="en-US" sz="1100" dirty="0"/>
+              <a:t>modos 03, 07 y 0A</a:t>
+            </a:r>
+            <a:endParaRPr lang="en-US" sz="900" dirty="0"/>
           </a:p>
         </p:txBody>
       </p:sp>
@@ -10841,14 +10782,14 @@
         </p:nvSpPr>
         <p:spPr>
           <a:xfrm>
-            <a:off x="8650224" y="4800600"/>
-            <a:ext cx="256032" cy="0"/>
+            <a:off x="4855464" y="3712464"/>
+            <a:ext cx="210312" cy="0"/>
           </a:xfrm>
           <a:prstGeom prst="line">
             <a:avLst/>
           </a:prstGeom>
           <a:noFill/>
-          <a:ln w="19050">
+          <a:ln w="15875">
             <a:solidFill>
               <a:srgbClr val="202CFC"/>
             </a:solidFill>
@@ -10865,12 +10806,12 @@
         </p:nvSpPr>
         <p:spPr>
           <a:xfrm>
-            <a:off x="8979408" y="4343400"/>
-            <a:ext cx="2331720" cy="914400"/>
+            <a:off x="5120640" y="3337560"/>
+            <a:ext cx="1920240" cy="749808"/>
           </a:xfrm>
           <a:prstGeom prst="roundRect">
             <a:avLst>
-              <a:gd name="adj" fmla="val 6000"/>
+              <a:gd name="adj" fmla="val 6098"/>
             </a:avLst>
           </a:prstGeom>
           <a:solidFill>
@@ -10892,8 +10833,8 @@
         </p:nvSpPr>
         <p:spPr>
           <a:xfrm>
-            <a:off x="9089136" y="4471416"/>
-            <a:ext cx="2112264" cy="292608"/>
+            <a:off x="5193792" y="3429000"/>
+            <a:ext cx="1773936" cy="256032"/>
           </a:xfrm>
           <a:prstGeom prst="rect">
             <a:avLst/>
@@ -10909,7 +10850,7 @@
               <a:buNone/>
             </a:pPr>
             <a:r>
-              <a:rPr lang="en-US" sz="1200" b="1" dirty="0">
+              <a:rPr lang="en-US" sz="1050" b="1" dirty="0">
                 <a:solidFill>
                   <a:srgbClr val="1A1C2E"/>
                 </a:solidFill>
@@ -10917,9 +10858,9 @@
                 <a:ea typeface="Arial" pitchFamily="34" charset="-122"/>
                 <a:cs typeface="Arial" pitchFamily="34" charset="-120"/>
               </a:rPr>
-              <a:t>Se indexa</a:t>
-            </a:r>
-            <a:endParaRPr lang="en-US" sz="1200" dirty="0"/>
+              <a:t>Freeze frame</a:t>
+            </a:r>
+            <a:endParaRPr lang="en-US" sz="1050" dirty="0"/>
           </a:p>
         </p:txBody>
       </p:sp>
@@ -10931,8 +10872,8 @@
         </p:nvSpPr>
         <p:spPr>
           <a:xfrm>
-            <a:off x="9089136" y="4764024"/>
-            <a:ext cx="2112264" cy="384048"/>
+            <a:off x="5193792" y="3685032"/>
+            <a:ext cx="1773936" cy="347472"/>
           </a:xfrm>
           <a:prstGeom prst="rect">
             <a:avLst/>
@@ -10946,12 +10887,12 @@
           <a:p>
             <a:pPr algn="ctr" indent="0" marL="0">
               <a:lnSpc>
-                <a:spcPts val="1400"/>
+                <a:spcPts val="1100"/>
               </a:lnSpc>
               <a:buNone/>
             </a:pPr>
             <a:r>
-              <a:rPr lang="en-US" sz="1100" dirty="0">
+              <a:rPr lang="en-US" sz="900" dirty="0">
                 <a:solidFill>
                   <a:srgbClr val="5A5F73"/>
                 </a:solidFill>
@@ -10959,19 +10900,131 @@
                 <a:ea typeface="Calibri" pitchFamily="34" charset="-122"/>
                 <a:cs typeface="Calibri" pitchFamily="34" charset="-120"/>
               </a:rPr>
-              <a:t>el caso vuelve</a:t>
-            </a:r>
-            <a:endParaRPr lang="en-US" sz="1100" dirty="0"/>
-          </a:p>
+              <a:t>modo 02</a:t>
+            </a:r>
+            <a:endParaRPr lang="en-US" sz="900" dirty="0"/>
+          </a:p>
+        </p:txBody>
+      </p:sp>
+      <p:sp>
+        <p:nvSpPr>
+          <p:cNvPr id="36" name="Shape 34"/>
+          <p:cNvSpPr/>
+          <p:nvPr/>
+        </p:nvSpPr>
+        <p:spPr>
+          <a:xfrm>
+            <a:off x="7095744" y="3712464"/>
+            <a:ext cx="210312" cy="0"/>
+          </a:xfrm>
+          <a:prstGeom prst="line">
+            <a:avLst/>
+          </a:prstGeom>
+          <a:noFill/>
+          <a:ln w="15875">
+            <a:solidFill>
+              <a:srgbClr val="202CFC"/>
+            </a:solidFill>
+            <a:prstDash val="solid"/>
+            <a:tailEnd type="triangle"/>
+          </a:ln>
+        </p:spPr>
+      </p:sp>
+      <p:sp>
+        <p:nvSpPr>
+          <p:cNvPr id="37" name="Shape 35"/>
+          <p:cNvSpPr/>
+          <p:nvPr/>
+        </p:nvSpPr>
+        <p:spPr>
+          <a:xfrm>
+            <a:off x="7360920" y="3337560"/>
+            <a:ext cx="1920240" cy="749808"/>
+          </a:xfrm>
+          <a:prstGeom prst="roundRect">
+            <a:avLst>
+              <a:gd name="adj" fmla="val 6098"/>
+            </a:avLst>
+          </a:prstGeom>
+          <a:solidFill>
+            <a:srgbClr val="FFFFFF"/>
+          </a:solidFill>
+          <a:ln w="12700">
+            <a:solidFill>
+              <a:srgbClr val="C9CCD8"/>
+            </a:solidFill>
+            <a:prstDash val="solid"/>
+          </a:ln>
+        </p:spPr>
+      </p:sp>
+      <p:sp>
+        <p:nvSpPr>
+          <p:cNvPr id="38" name="Text 36"/>
+          <p:cNvSpPr/>
+          <p:nvPr/>
+        </p:nvSpPr>
+        <p:spPr>
+          <a:xfrm>
+            <a:off x="7434072" y="3429000"/>
+            <a:ext cx="1773936" cy="256032"/>
+          </a:xfrm>
+          <a:prstGeom prst="rect">
+            <a:avLst/>
+          </a:prstGeom>
+          <a:noFill/>
+          <a:ln/>
+        </p:spPr>
+        <p:txBody>
+          <a:bodyPr wrap="square" lIns="0" tIns="0" rIns="0" bIns="0" rtlCol="0" anchor="ctr"/>
+          <a:lstStyle/>
+          <a:p>
+            <a:pPr algn="ctr" indent="0" marL="0">
+              <a:buNone/>
+            </a:pPr>
+            <a:r>
+              <a:rPr lang="en-US" sz="1050" b="1" dirty="0">
+                <a:solidFill>
+                  <a:srgbClr val="1A1C2E"/>
+                </a:solidFill>
+                <a:latin typeface="Arial" pitchFamily="34" charset="0"/>
+                <a:ea typeface="Arial" pitchFamily="34" charset="-122"/>
+                <a:cs typeface="Arial" pitchFamily="34" charset="-120"/>
+              </a:rPr>
+              <a:t>Determinista</a:t>
+            </a:r>
+            <a:endParaRPr lang="en-US" sz="1050" dirty="0"/>
+          </a:p>
+        </p:txBody>
+      </p:sp>
+      <p:sp>
+        <p:nvSpPr>
+          <p:cNvPr id="39" name="Text 37"/>
+          <p:cNvSpPr/>
+          <p:nvPr/>
+        </p:nvSpPr>
+        <p:spPr>
+          <a:xfrm>
+            <a:off x="7434072" y="3685032"/>
+            <a:ext cx="1773936" cy="347472"/>
+          </a:xfrm>
+          <a:prstGeom prst="rect">
+            <a:avLst/>
+          </a:prstGeom>
+          <a:noFill/>
+          <a:ln/>
+        </p:spPr>
+        <p:txBody>
+          <a:bodyPr wrap="square" lIns="0" tIns="0" rIns="0" bIns="0" rtlCol="0" anchor="t"/>
+          <a:lstStyle/>
           <a:p>
             <a:pPr algn="ctr" indent="0" marL="0">
               <a:lnSpc>
-                <a:spcPts val="1400"/>
+                <a:spcPts val="1100"/>
               </a:lnSpc>
               <a:buNone/>
             </a:pPr>
             <a:r>
-              <a:rPr lang="en-US" sz="1100" dirty="0">
+              <a:rPr lang="en-US" sz="900" dirty="0">
                 <a:solidFill>
                   <a:srgbClr val="5A5F73"/>
                 </a:solidFill>
@@ -10979,22 +11032,969 @@
                 <a:ea typeface="Calibri" pitchFamily="34" charset="-122"/>
                 <a:cs typeface="Calibri" pitchFamily="34" charset="-120"/>
               </a:rPr>
+              <a:t>severidad por regla,</a:t>
+            </a:r>
+            <a:endParaRPr lang="en-US" sz="900" dirty="0"/>
+          </a:p>
+          <a:p>
+            <a:pPr algn="ctr" indent="0" marL="0">
+              <a:lnSpc>
+                <a:spcPts val="1100"/>
+              </a:lnSpc>
+              <a:buNone/>
+            </a:pPr>
+            <a:r>
+              <a:rPr lang="en-US" sz="900" dirty="0">
+                <a:solidFill>
+                  <a:srgbClr val="5A5F73"/>
+                </a:solidFill>
+                <a:latin typeface="Calibri" pitchFamily="34" charset="0"/>
+                <a:ea typeface="Calibri" pitchFamily="34" charset="-122"/>
+                <a:cs typeface="Calibri" pitchFamily="34" charset="-120"/>
+              </a:rPr>
+              <a:t>sin IA</a:t>
+            </a:r>
+            <a:endParaRPr lang="en-US" sz="900" dirty="0"/>
+          </a:p>
+        </p:txBody>
+      </p:sp>
+      <p:sp>
+        <p:nvSpPr>
+          <p:cNvPr id="40" name="Shape 38"/>
+          <p:cNvSpPr/>
+          <p:nvPr/>
+        </p:nvSpPr>
+        <p:spPr>
+          <a:xfrm>
+            <a:off x="9336024" y="3712464"/>
+            <a:ext cx="210312" cy="0"/>
+          </a:xfrm>
+          <a:prstGeom prst="line">
+            <a:avLst/>
+          </a:prstGeom>
+          <a:noFill/>
+          <a:ln w="15875">
+            <a:solidFill>
+              <a:srgbClr val="202CFC"/>
+            </a:solidFill>
+            <a:prstDash val="solid"/>
+            <a:tailEnd type="triangle"/>
+          </a:ln>
+        </p:spPr>
+      </p:sp>
+      <p:sp>
+        <p:nvSpPr>
+          <p:cNvPr id="41" name="Shape 39"/>
+          <p:cNvSpPr/>
+          <p:nvPr/>
+        </p:nvSpPr>
+        <p:spPr>
+          <a:xfrm>
+            <a:off x="9601200" y="3337560"/>
+            <a:ext cx="1920240" cy="749808"/>
+          </a:xfrm>
+          <a:prstGeom prst="roundRect">
+            <a:avLst>
+              <a:gd name="adj" fmla="val 6098"/>
+            </a:avLst>
+          </a:prstGeom>
+          <a:solidFill>
+            <a:srgbClr val="FFFFFF"/>
+          </a:solidFill>
+          <a:ln w="12700">
+            <a:solidFill>
+              <a:srgbClr val="C9CCD8"/>
+            </a:solidFill>
+            <a:prstDash val="solid"/>
+          </a:ln>
+        </p:spPr>
+      </p:sp>
+      <p:sp>
+        <p:nvSpPr>
+          <p:cNvPr id="42" name="Text 40"/>
+          <p:cNvSpPr/>
+          <p:nvPr/>
+        </p:nvSpPr>
+        <p:spPr>
+          <a:xfrm>
+            <a:off x="9674352" y="3429000"/>
+            <a:ext cx="1773936" cy="256032"/>
+          </a:xfrm>
+          <a:prstGeom prst="rect">
+            <a:avLst/>
+          </a:prstGeom>
+          <a:noFill/>
+          <a:ln/>
+        </p:spPr>
+        <p:txBody>
+          <a:bodyPr wrap="square" lIns="0" tIns="0" rIns="0" bIns="0" rtlCol="0" anchor="ctr"/>
+          <a:lstStyle/>
+          <a:p>
+            <a:pPr algn="ctr" indent="0" marL="0">
+              <a:buNone/>
+            </a:pPr>
+            <a:r>
+              <a:rPr lang="en-US" sz="1050" b="1" dirty="0">
+                <a:solidFill>
+                  <a:srgbClr val="1A1C2E"/>
+                </a:solidFill>
+                <a:latin typeface="Arial" pitchFamily="34" charset="0"/>
+                <a:ea typeface="Arial" pitchFamily="34" charset="-122"/>
+                <a:cs typeface="Arial" pitchFamily="34" charset="-120"/>
+              </a:rPr>
+              <a:t>A la pantalla</a:t>
+            </a:r>
+            <a:endParaRPr lang="en-US" sz="1050" dirty="0"/>
+          </a:p>
+        </p:txBody>
+      </p:sp>
+      <p:sp>
+        <p:nvSpPr>
+          <p:cNvPr id="43" name="Text 41"/>
+          <p:cNvSpPr/>
+          <p:nvPr/>
+        </p:nvSpPr>
+        <p:spPr>
+          <a:xfrm>
+            <a:off x="9674352" y="3685032"/>
+            <a:ext cx="1773936" cy="347472"/>
+          </a:xfrm>
+          <a:prstGeom prst="rect">
+            <a:avLst/>
+          </a:prstGeom>
+          <a:noFill/>
+          <a:ln/>
+        </p:spPr>
+        <p:txBody>
+          <a:bodyPr wrap="square" lIns="0" tIns="0" rIns="0" bIns="0" rtlCol="0" anchor="t"/>
+          <a:lstStyle/>
+          <a:p>
+            <a:pPr algn="ctr" indent="0" marL="0">
+              <a:lnSpc>
+                <a:spcPts val="1100"/>
+              </a:lnSpc>
+              <a:buNone/>
+            </a:pPr>
+            <a:r>
+              <a:rPr lang="en-US" sz="900" dirty="0">
+                <a:solidFill>
+                  <a:srgbClr val="5A5F73"/>
+                </a:solidFill>
+                <a:latin typeface="Calibri" pitchFamily="34" charset="0"/>
+                <a:ea typeface="Calibri" pitchFamily="34" charset="-122"/>
+                <a:cs typeface="Calibri" pitchFamily="34" charset="-120"/>
+              </a:rPr>
+              <a:t>y a SQLite,</a:t>
+            </a:r>
+            <a:endParaRPr lang="en-US" sz="900" dirty="0"/>
+          </a:p>
+          <a:p>
+            <a:pPr algn="ctr" indent="0" marL="0">
+              <a:lnSpc>
+                <a:spcPts val="1100"/>
+              </a:lnSpc>
+              <a:buNone/>
+            </a:pPr>
+            <a:r>
+              <a:rPr lang="en-US" sz="900" dirty="0">
+                <a:solidFill>
+                  <a:srgbClr val="5A5F73"/>
+                </a:solidFill>
+                <a:latin typeface="Calibri" pitchFamily="34" charset="0"/>
+                <a:ea typeface="Calibri" pitchFamily="34" charset="-122"/>
+                <a:cs typeface="Calibri" pitchFamily="34" charset="-120"/>
+              </a:rPr>
+              <a:t>con la sesión</a:t>
+            </a:r>
+            <a:endParaRPr lang="en-US" sz="900" dirty="0"/>
+          </a:p>
+        </p:txBody>
+      </p:sp>
+      <p:sp>
+        <p:nvSpPr>
+          <p:cNvPr id="44" name="Text 42"/>
+          <p:cNvSpPr/>
+          <p:nvPr/>
+        </p:nvSpPr>
+        <p:spPr>
+          <a:xfrm>
+            <a:off x="640080" y="4398264"/>
+            <a:ext cx="10881360" cy="256032"/>
+          </a:xfrm>
+          <a:prstGeom prst="rect">
+            <a:avLst/>
+          </a:prstGeom>
+          <a:noFill/>
+          <a:ln/>
+        </p:spPr>
+        <p:txBody>
+          <a:bodyPr wrap="square" lIns="0" tIns="0" rIns="0" bIns="0" rtlCol="0" anchor="t"/>
+          <a:lstStyle/>
+          <a:p>
+            <a:pPr indent="0" marL="0">
+              <a:buNone/>
+            </a:pPr>
+            <a:r>
+              <a:rPr lang="en-US" sz="1100" b="1" spc="140" kern="0" dirty="0">
+                <a:solidFill>
+                  <a:srgbClr val="202CFC"/>
+                </a:solidFill>
+                <a:latin typeface="Calibri" pitchFamily="34" charset="0"/>
+                <a:ea typeface="Calibri" pitchFamily="34" charset="-122"/>
+                <a:cs typeface="Calibri" pitchFamily="34" charset="-120"/>
+              </a:rPr>
+              <a:t>3 · RAZONAR CON IA</a:t>
+            </a:r>
+            <a:endParaRPr lang="en-US" sz="1100" dirty="0"/>
+          </a:p>
+        </p:txBody>
+      </p:sp>
+      <p:sp>
+        <p:nvSpPr>
+          <p:cNvPr id="45" name="Shape 43"/>
+          <p:cNvSpPr/>
+          <p:nvPr/>
+        </p:nvSpPr>
+        <p:spPr>
+          <a:xfrm>
+            <a:off x="640080" y="4709160"/>
+            <a:ext cx="1920240" cy="749808"/>
+          </a:xfrm>
+          <a:prstGeom prst="roundRect">
+            <a:avLst>
+              <a:gd name="adj" fmla="val 6098"/>
+            </a:avLst>
+          </a:prstGeom>
+          <a:solidFill>
+            <a:srgbClr val="FFFFFF"/>
+          </a:solidFill>
+          <a:ln w="12700">
+            <a:solidFill>
+              <a:srgbClr val="C9CCD8"/>
+            </a:solidFill>
+            <a:prstDash val="solid"/>
+          </a:ln>
+        </p:spPr>
+      </p:sp>
+      <p:sp>
+        <p:nvSpPr>
+          <p:cNvPr id="46" name="Text 44"/>
+          <p:cNvSpPr/>
+          <p:nvPr/>
+        </p:nvSpPr>
+        <p:spPr>
+          <a:xfrm>
+            <a:off x="713232" y="4800600"/>
+            <a:ext cx="1773936" cy="256032"/>
+          </a:xfrm>
+          <a:prstGeom prst="rect">
+            <a:avLst/>
+          </a:prstGeom>
+          <a:noFill/>
+          <a:ln/>
+        </p:spPr>
+        <p:txBody>
+          <a:bodyPr wrap="square" lIns="0" tIns="0" rIns="0" bIns="0" rtlCol="0" anchor="ctr"/>
+          <a:lstStyle/>
+          <a:p>
+            <a:pPr algn="ctr" indent="0" marL="0">
+              <a:buNone/>
+            </a:pPr>
+            <a:r>
+              <a:rPr lang="en-US" sz="1050" b="1" dirty="0">
+                <a:solidFill>
+                  <a:srgbClr val="1A1C2E"/>
+                </a:solidFill>
+                <a:latin typeface="Arial" pitchFamily="34" charset="0"/>
+                <a:ea typeface="Arial" pitchFamily="34" charset="-122"/>
+                <a:cs typeface="Arial" pitchFamily="34" charset="-120"/>
+              </a:rPr>
+              <a:t>Casos parecidos</a:t>
+            </a:r>
+            <a:endParaRPr lang="en-US" sz="1050" dirty="0"/>
+          </a:p>
+        </p:txBody>
+      </p:sp>
+      <p:sp>
+        <p:nvSpPr>
+          <p:cNvPr id="47" name="Text 45"/>
+          <p:cNvSpPr/>
+          <p:nvPr/>
+        </p:nvSpPr>
+        <p:spPr>
+          <a:xfrm>
+            <a:off x="713232" y="5056632"/>
+            <a:ext cx="1773936" cy="347472"/>
+          </a:xfrm>
+          <a:prstGeom prst="rect">
+            <a:avLst/>
+          </a:prstGeom>
+          <a:noFill/>
+          <a:ln/>
+        </p:spPr>
+        <p:txBody>
+          <a:bodyPr wrap="square" lIns="0" tIns="0" rIns="0" bIns="0" rtlCol="0" anchor="t"/>
+          <a:lstStyle/>
+          <a:p>
+            <a:pPr algn="ctr" indent="0" marL="0">
+              <a:lnSpc>
+                <a:spcPts val="1100"/>
+              </a:lnSpc>
+              <a:buNone/>
+            </a:pPr>
+            <a:r>
+              <a:rPr lang="en-US" sz="900" dirty="0">
+                <a:solidFill>
+                  <a:srgbClr val="5A5F73"/>
+                </a:solidFill>
+                <a:latin typeface="Calibri" pitchFamily="34" charset="0"/>
+                <a:ea typeface="Calibri" pitchFamily="34" charset="-122"/>
+                <a:cs typeface="Calibri" pitchFamily="34" charset="-120"/>
+              </a:rPr>
+              <a:t>búsqueda vectorial</a:t>
+            </a:r>
+            <a:endParaRPr lang="en-US" sz="900" dirty="0"/>
+          </a:p>
+          <a:p>
+            <a:pPr algn="ctr" indent="0" marL="0">
+              <a:lnSpc>
+                <a:spcPts val="1100"/>
+              </a:lnSpc>
+              <a:buNone/>
+            </a:pPr>
+            <a:r>
+              <a:rPr lang="en-US" sz="900" dirty="0">
+                <a:solidFill>
+                  <a:srgbClr val="5A5F73"/>
+                </a:solidFill>
+                <a:latin typeface="Calibri" pitchFamily="34" charset="0"/>
+                <a:ea typeface="Calibri" pitchFamily="34" charset="-122"/>
+                <a:cs typeface="Calibri" pitchFamily="34" charset="-120"/>
+              </a:rPr>
+              <a:t>en LanceDB</a:t>
+            </a:r>
+            <a:endParaRPr lang="en-US" sz="900" dirty="0"/>
+          </a:p>
+        </p:txBody>
+      </p:sp>
+      <p:sp>
+        <p:nvSpPr>
+          <p:cNvPr id="48" name="Shape 46"/>
+          <p:cNvSpPr/>
+          <p:nvPr/>
+        </p:nvSpPr>
+        <p:spPr>
+          <a:xfrm>
+            <a:off x="2615184" y="5084064"/>
+            <a:ext cx="210312" cy="0"/>
+          </a:xfrm>
+          <a:prstGeom prst="line">
+            <a:avLst/>
+          </a:prstGeom>
+          <a:noFill/>
+          <a:ln w="15875">
+            <a:solidFill>
+              <a:srgbClr val="202CFC"/>
+            </a:solidFill>
+            <a:prstDash val="solid"/>
+            <a:tailEnd type="triangle"/>
+          </a:ln>
+        </p:spPr>
+      </p:sp>
+      <p:sp>
+        <p:nvSpPr>
+          <p:cNvPr id="49" name="Shape 47"/>
+          <p:cNvSpPr/>
+          <p:nvPr/>
+        </p:nvSpPr>
+        <p:spPr>
+          <a:xfrm>
+            <a:off x="2880360" y="4709160"/>
+            <a:ext cx="1920240" cy="749808"/>
+          </a:xfrm>
+          <a:prstGeom prst="roundRect">
+            <a:avLst>
+              <a:gd name="adj" fmla="val 6098"/>
+            </a:avLst>
+          </a:prstGeom>
+          <a:solidFill>
+            <a:srgbClr val="FFFFFF"/>
+          </a:solidFill>
+          <a:ln w="12700">
+            <a:solidFill>
+              <a:srgbClr val="C9CCD8"/>
+            </a:solidFill>
+            <a:prstDash val="solid"/>
+          </a:ln>
+        </p:spPr>
+      </p:sp>
+      <p:sp>
+        <p:nvSpPr>
+          <p:cNvPr id="50" name="Text 48"/>
+          <p:cNvSpPr/>
+          <p:nvPr/>
+        </p:nvSpPr>
+        <p:spPr>
+          <a:xfrm>
+            <a:off x="2953512" y="4800600"/>
+            <a:ext cx="1773936" cy="256032"/>
+          </a:xfrm>
+          <a:prstGeom prst="rect">
+            <a:avLst/>
+          </a:prstGeom>
+          <a:noFill/>
+          <a:ln/>
+        </p:spPr>
+        <p:txBody>
+          <a:bodyPr wrap="square" lIns="0" tIns="0" rIns="0" bIns="0" rtlCol="0" anchor="ctr"/>
+          <a:lstStyle/>
+          <a:p>
+            <a:pPr algn="ctr" indent="0" marL="0">
+              <a:buNone/>
+            </a:pPr>
+            <a:r>
+              <a:rPr lang="en-US" sz="1050" b="1" dirty="0">
+                <a:solidFill>
+                  <a:srgbClr val="1A1C2E"/>
+                </a:solidFill>
+                <a:latin typeface="Arial" pitchFamily="34" charset="0"/>
+                <a:ea typeface="Arial" pitchFamily="34" charset="-122"/>
+                <a:cs typeface="Arial" pitchFamily="34" charset="-120"/>
+              </a:rPr>
+              <a:t>El agente</a:t>
+            </a:r>
+            <a:endParaRPr lang="en-US" sz="1050" dirty="0"/>
+          </a:p>
+        </p:txBody>
+      </p:sp>
+      <p:sp>
+        <p:nvSpPr>
+          <p:cNvPr id="51" name="Text 49"/>
+          <p:cNvSpPr/>
+          <p:nvPr/>
+        </p:nvSpPr>
+        <p:spPr>
+          <a:xfrm>
+            <a:off x="2953512" y="5056632"/>
+            <a:ext cx="1773936" cy="347472"/>
+          </a:xfrm>
+          <a:prstGeom prst="rect">
+            <a:avLst/>
+          </a:prstGeom>
+          <a:noFill/>
+          <a:ln/>
+        </p:spPr>
+        <p:txBody>
+          <a:bodyPr wrap="square" lIns="0" tIns="0" rIns="0" bIns="0" rtlCol="0" anchor="t"/>
+          <a:lstStyle/>
+          <a:p>
+            <a:pPr algn="ctr" indent="0" marL="0">
+              <a:lnSpc>
+                <a:spcPts val="1100"/>
+              </a:lnSpc>
+              <a:buNone/>
+            </a:pPr>
+            <a:r>
+              <a:rPr lang="en-US" sz="900" dirty="0">
+                <a:solidFill>
+                  <a:srgbClr val="5A5F73"/>
+                </a:solidFill>
+                <a:latin typeface="Calibri" pitchFamily="34" charset="0"/>
+                <a:ea typeface="Calibri" pitchFamily="34" charset="-122"/>
+                <a:cs typeface="Calibri" pitchFamily="34" charset="-120"/>
+              </a:rPr>
+              <a:t>16 herramientas MCP</a:t>
+            </a:r>
+            <a:endParaRPr lang="en-US" sz="900" dirty="0"/>
+          </a:p>
+          <a:p>
+            <a:pPr algn="ctr" indent="0" marL="0">
+              <a:lnSpc>
+                <a:spcPts val="1100"/>
+              </a:lnSpc>
+              <a:buNone/>
+            </a:pPr>
+            <a:r>
+              <a:rPr lang="en-US" sz="900" dirty="0">
+                <a:solidFill>
+                  <a:srgbClr val="5A5F73"/>
+                </a:solidFill>
+                <a:latin typeface="Calibri" pitchFamily="34" charset="0"/>
+                <a:ea typeface="Calibri" pitchFamily="34" charset="-122"/>
+                <a:cs typeface="Calibri" pitchFamily="34" charset="-120"/>
+              </a:rPr>
+              <a:t>+ el modelo</a:t>
+            </a:r>
+            <a:endParaRPr lang="en-US" sz="900" dirty="0"/>
+          </a:p>
+        </p:txBody>
+      </p:sp>
+      <p:sp>
+        <p:nvSpPr>
+          <p:cNvPr id="52" name="Shape 50"/>
+          <p:cNvSpPr/>
+          <p:nvPr/>
+        </p:nvSpPr>
+        <p:spPr>
+          <a:xfrm>
+            <a:off x="4855464" y="5084064"/>
+            <a:ext cx="210312" cy="0"/>
+          </a:xfrm>
+          <a:prstGeom prst="line">
+            <a:avLst/>
+          </a:prstGeom>
+          <a:noFill/>
+          <a:ln w="15875">
+            <a:solidFill>
+              <a:srgbClr val="202CFC"/>
+            </a:solidFill>
+            <a:prstDash val="solid"/>
+            <a:tailEnd type="triangle"/>
+          </a:ln>
+        </p:spPr>
+      </p:sp>
+      <p:sp>
+        <p:nvSpPr>
+          <p:cNvPr id="53" name="Shape 51"/>
+          <p:cNvSpPr/>
+          <p:nvPr/>
+        </p:nvSpPr>
+        <p:spPr>
+          <a:xfrm>
+            <a:off x="5120640" y="4709160"/>
+            <a:ext cx="1920240" cy="749808"/>
+          </a:xfrm>
+          <a:prstGeom prst="roundRect">
+            <a:avLst>
+              <a:gd name="adj" fmla="val 6098"/>
+            </a:avLst>
+          </a:prstGeom>
+          <a:solidFill>
+            <a:srgbClr val="FFFFFF"/>
+          </a:solidFill>
+          <a:ln w="12700">
+            <a:solidFill>
+              <a:srgbClr val="C9CCD8"/>
+            </a:solidFill>
+            <a:prstDash val="solid"/>
+          </a:ln>
+        </p:spPr>
+      </p:sp>
+      <p:sp>
+        <p:nvSpPr>
+          <p:cNvPr id="54" name="Text 52"/>
+          <p:cNvSpPr/>
+          <p:nvPr/>
+        </p:nvSpPr>
+        <p:spPr>
+          <a:xfrm>
+            <a:off x="5193792" y="4800600"/>
+            <a:ext cx="1773936" cy="256032"/>
+          </a:xfrm>
+          <a:prstGeom prst="rect">
+            <a:avLst/>
+          </a:prstGeom>
+          <a:noFill/>
+          <a:ln/>
+        </p:spPr>
+        <p:txBody>
+          <a:bodyPr wrap="square" lIns="0" tIns="0" rIns="0" bIns="0" rtlCol="0" anchor="ctr"/>
+          <a:lstStyle/>
+          <a:p>
+            <a:pPr algn="ctr" indent="0" marL="0">
+              <a:buNone/>
+            </a:pPr>
+            <a:r>
+              <a:rPr lang="en-US" sz="1050" b="1" dirty="0">
+                <a:solidFill>
+                  <a:srgbClr val="1A1C2E"/>
+                </a:solidFill>
+                <a:latin typeface="Arial" pitchFamily="34" charset="0"/>
+                <a:ea typeface="Arial" pitchFamily="34" charset="-122"/>
+                <a:cs typeface="Arial" pitchFamily="34" charset="-120"/>
+              </a:rPr>
+              <a:t>Busca lo que falta</a:t>
+            </a:r>
+            <a:endParaRPr lang="en-US" sz="1050" dirty="0"/>
+          </a:p>
+        </p:txBody>
+      </p:sp>
+      <p:sp>
+        <p:nvSpPr>
+          <p:cNvPr id="55" name="Text 53"/>
+          <p:cNvSpPr/>
+          <p:nvPr/>
+        </p:nvSpPr>
+        <p:spPr>
+          <a:xfrm>
+            <a:off x="5193792" y="5056632"/>
+            <a:ext cx="1773936" cy="347472"/>
+          </a:xfrm>
+          <a:prstGeom prst="rect">
+            <a:avLst/>
+          </a:prstGeom>
+          <a:noFill/>
+          <a:ln/>
+        </p:spPr>
+        <p:txBody>
+          <a:bodyPr wrap="square" lIns="0" tIns="0" rIns="0" bIns="0" rtlCol="0" anchor="t"/>
+          <a:lstStyle/>
+          <a:p>
+            <a:pPr algn="ctr" indent="0" marL="0">
+              <a:lnSpc>
+                <a:spcPts val="1100"/>
+              </a:lnSpc>
+              <a:buNone/>
+            </a:pPr>
+            <a:r>
+              <a:rPr lang="en-US" sz="900" dirty="0">
+                <a:solidFill>
+                  <a:srgbClr val="5A5F73"/>
+                </a:solidFill>
+                <a:latin typeface="Calibri" pitchFamily="34" charset="0"/>
+                <a:ea typeface="Calibri" pitchFamily="34" charset="-122"/>
+                <a:cs typeface="Calibri" pitchFamily="34" charset="-120"/>
+              </a:rPr>
+              <a:t>catálogo, el coche</a:t>
+            </a:r>
+            <a:endParaRPr lang="en-US" sz="900" dirty="0"/>
+          </a:p>
+          <a:p>
+            <a:pPr algn="ctr" indent="0" marL="0">
+              <a:lnSpc>
+                <a:spcPts val="1100"/>
+              </a:lnSpc>
+              <a:buNone/>
+            </a:pPr>
+            <a:r>
+              <a:rPr lang="en-US" sz="900" dirty="0">
+                <a:solidFill>
+                  <a:srgbClr val="5A5F73"/>
+                </a:solidFill>
+                <a:latin typeface="Calibri" pitchFamily="34" charset="0"/>
+                <a:ea typeface="Calibri" pitchFamily="34" charset="-122"/>
+                <a:cs typeface="Calibri" pitchFamily="34" charset="-120"/>
+              </a:rPr>
+              <a:t>o la web</a:t>
+            </a:r>
+            <a:endParaRPr lang="en-US" sz="900" dirty="0"/>
+          </a:p>
+        </p:txBody>
+      </p:sp>
+      <p:sp>
+        <p:nvSpPr>
+          <p:cNvPr id="56" name="Shape 54"/>
+          <p:cNvSpPr/>
+          <p:nvPr/>
+        </p:nvSpPr>
+        <p:spPr>
+          <a:xfrm>
+            <a:off x="7095744" y="5084064"/>
+            <a:ext cx="210312" cy="0"/>
+          </a:xfrm>
+          <a:prstGeom prst="line">
+            <a:avLst/>
+          </a:prstGeom>
+          <a:noFill/>
+          <a:ln w="15875">
+            <a:solidFill>
+              <a:srgbClr val="202CFC"/>
+            </a:solidFill>
+            <a:prstDash val="solid"/>
+            <a:tailEnd type="triangle"/>
+          </a:ln>
+        </p:spPr>
+      </p:sp>
+      <p:sp>
+        <p:nvSpPr>
+          <p:cNvPr id="57" name="Shape 55"/>
+          <p:cNvSpPr/>
+          <p:nvPr/>
+        </p:nvSpPr>
+        <p:spPr>
+          <a:xfrm>
+            <a:off x="7360920" y="4709160"/>
+            <a:ext cx="1920240" cy="749808"/>
+          </a:xfrm>
+          <a:prstGeom prst="roundRect">
+            <a:avLst>
+              <a:gd name="adj" fmla="val 6098"/>
+            </a:avLst>
+          </a:prstGeom>
+          <a:solidFill>
+            <a:srgbClr val="FFFFFF"/>
+          </a:solidFill>
+          <a:ln w="12700">
+            <a:solidFill>
+              <a:srgbClr val="C9CCD8"/>
+            </a:solidFill>
+            <a:prstDash val="solid"/>
+          </a:ln>
+        </p:spPr>
+      </p:sp>
+      <p:sp>
+        <p:nvSpPr>
+          <p:cNvPr id="58" name="Text 56"/>
+          <p:cNvSpPr/>
+          <p:nvPr/>
+        </p:nvSpPr>
+        <p:spPr>
+          <a:xfrm>
+            <a:off x="7434072" y="4800600"/>
+            <a:ext cx="1773936" cy="256032"/>
+          </a:xfrm>
+          <a:prstGeom prst="rect">
+            <a:avLst/>
+          </a:prstGeom>
+          <a:noFill/>
+          <a:ln/>
+        </p:spPr>
+        <p:txBody>
+          <a:bodyPr wrap="square" lIns="0" tIns="0" rIns="0" bIns="0" rtlCol="0" anchor="ctr"/>
+          <a:lstStyle/>
+          <a:p>
+            <a:pPr algn="ctr" indent="0" marL="0">
+              <a:buNone/>
+            </a:pPr>
+            <a:r>
+              <a:rPr lang="en-US" sz="1050" b="1" dirty="0">
+                <a:solidFill>
+                  <a:srgbClr val="1A1C2E"/>
+                </a:solidFill>
+                <a:latin typeface="Arial" pitchFamily="34" charset="0"/>
+                <a:ea typeface="Arial" pitchFamily="34" charset="-122"/>
+                <a:cs typeface="Arial" pitchFamily="34" charset="-120"/>
+              </a:rPr>
+              <a:t>Informe</a:t>
+            </a:r>
+            <a:endParaRPr lang="en-US" sz="1050" dirty="0"/>
+          </a:p>
+        </p:txBody>
+      </p:sp>
+      <p:sp>
+        <p:nvSpPr>
+          <p:cNvPr id="59" name="Text 57"/>
+          <p:cNvSpPr/>
+          <p:nvPr/>
+        </p:nvSpPr>
+        <p:spPr>
+          <a:xfrm>
+            <a:off x="7434072" y="5056632"/>
+            <a:ext cx="1773936" cy="347472"/>
+          </a:xfrm>
+          <a:prstGeom prst="rect">
+            <a:avLst/>
+          </a:prstGeom>
+          <a:noFill/>
+          <a:ln/>
+        </p:spPr>
+        <p:txBody>
+          <a:bodyPr wrap="square" lIns="0" tIns="0" rIns="0" bIns="0" rtlCol="0" anchor="t"/>
+          <a:lstStyle/>
+          <a:p>
+            <a:pPr algn="ctr" indent="0" marL="0">
+              <a:lnSpc>
+                <a:spcPts val="1100"/>
+              </a:lnSpc>
+              <a:buNone/>
+            </a:pPr>
+            <a:r>
+              <a:rPr lang="en-US" sz="900" dirty="0">
+                <a:solidFill>
+                  <a:srgbClr val="5A5F73"/>
+                </a:solidFill>
+                <a:latin typeface="Calibri" pitchFamily="34" charset="0"/>
+                <a:ea typeface="Calibri" pitchFamily="34" charset="-122"/>
+                <a:cs typeface="Calibri" pitchFamily="34" charset="-120"/>
+              </a:rPr>
+              <a:t>narrativa, severidad</a:t>
+            </a:r>
+            <a:endParaRPr lang="en-US" sz="900" dirty="0"/>
+          </a:p>
+          <a:p>
+            <a:pPr algn="ctr" indent="0" marL="0">
+              <a:lnSpc>
+                <a:spcPts val="1100"/>
+              </a:lnSpc>
+              <a:buNone/>
+            </a:pPr>
+            <a:r>
+              <a:rPr lang="en-US" sz="900" dirty="0">
+                <a:solidFill>
+                  <a:srgbClr val="5A5F73"/>
+                </a:solidFill>
+                <a:latin typeface="Calibri" pitchFamily="34" charset="0"/>
+                <a:ea typeface="Calibri" pitchFamily="34" charset="-122"/>
+                <a:cs typeface="Calibri" pitchFamily="34" charset="-120"/>
+              </a:rPr>
+              <a:t>y recomendaciones</a:t>
+            </a:r>
+            <a:endParaRPr lang="en-US" sz="900" dirty="0"/>
+          </a:p>
+        </p:txBody>
+      </p:sp>
+      <p:sp>
+        <p:nvSpPr>
+          <p:cNvPr id="60" name="Shape 58"/>
+          <p:cNvSpPr/>
+          <p:nvPr/>
+        </p:nvSpPr>
+        <p:spPr>
+          <a:xfrm>
+            <a:off x="9336024" y="5084064"/>
+            <a:ext cx="210312" cy="0"/>
+          </a:xfrm>
+          <a:prstGeom prst="line">
+            <a:avLst/>
+          </a:prstGeom>
+          <a:noFill/>
+          <a:ln w="15875">
+            <a:solidFill>
+              <a:srgbClr val="202CFC"/>
+            </a:solidFill>
+            <a:prstDash val="solid"/>
+            <a:tailEnd type="triangle"/>
+          </a:ln>
+        </p:spPr>
+      </p:sp>
+      <p:sp>
+        <p:nvSpPr>
+          <p:cNvPr id="61" name="Shape 59"/>
+          <p:cNvSpPr/>
+          <p:nvPr/>
+        </p:nvSpPr>
+        <p:spPr>
+          <a:xfrm>
+            <a:off x="9601200" y="4709160"/>
+            <a:ext cx="1920240" cy="749808"/>
+          </a:xfrm>
+          <a:prstGeom prst="roundRect">
+            <a:avLst>
+              <a:gd name="adj" fmla="val 6098"/>
+            </a:avLst>
+          </a:prstGeom>
+          <a:solidFill>
+            <a:srgbClr val="FFFFFF"/>
+          </a:solidFill>
+          <a:ln w="12700">
+            <a:solidFill>
+              <a:srgbClr val="C9CCD8"/>
+            </a:solidFill>
+            <a:prstDash val="solid"/>
+          </a:ln>
+        </p:spPr>
+      </p:sp>
+      <p:sp>
+        <p:nvSpPr>
+          <p:cNvPr id="62" name="Text 60"/>
+          <p:cNvSpPr/>
+          <p:nvPr/>
+        </p:nvSpPr>
+        <p:spPr>
+          <a:xfrm>
+            <a:off x="9674352" y="4800600"/>
+            <a:ext cx="1773936" cy="256032"/>
+          </a:xfrm>
+          <a:prstGeom prst="rect">
+            <a:avLst/>
+          </a:prstGeom>
+          <a:noFill/>
+          <a:ln/>
+        </p:spPr>
+        <p:txBody>
+          <a:bodyPr wrap="square" lIns="0" tIns="0" rIns="0" bIns="0" rtlCol="0" anchor="ctr"/>
+          <a:lstStyle/>
+          <a:p>
+            <a:pPr algn="ctr" indent="0" marL="0">
+              <a:buNone/>
+            </a:pPr>
+            <a:r>
+              <a:rPr lang="en-US" sz="1050" b="1" dirty="0">
+                <a:solidFill>
+                  <a:srgbClr val="1A1C2E"/>
+                </a:solidFill>
+                <a:latin typeface="Arial" pitchFamily="34" charset="0"/>
+                <a:ea typeface="Arial" pitchFamily="34" charset="-122"/>
+                <a:cs typeface="Arial" pitchFamily="34" charset="-120"/>
+              </a:rPr>
+              <a:t>Se indexa</a:t>
+            </a:r>
+            <a:endParaRPr lang="en-US" sz="1050" dirty="0"/>
+          </a:p>
+        </p:txBody>
+      </p:sp>
+      <p:sp>
+        <p:nvSpPr>
+          <p:cNvPr id="63" name="Text 61"/>
+          <p:cNvSpPr/>
+          <p:nvPr/>
+        </p:nvSpPr>
+        <p:spPr>
+          <a:xfrm>
+            <a:off x="9674352" y="5056632"/>
+            <a:ext cx="1773936" cy="347472"/>
+          </a:xfrm>
+          <a:prstGeom prst="rect">
+            <a:avLst/>
+          </a:prstGeom>
+          <a:noFill/>
+          <a:ln/>
+        </p:spPr>
+        <p:txBody>
+          <a:bodyPr wrap="square" lIns="0" tIns="0" rIns="0" bIns="0" rtlCol="0" anchor="t"/>
+          <a:lstStyle/>
+          <a:p>
+            <a:pPr algn="ctr" indent="0" marL="0">
+              <a:lnSpc>
+                <a:spcPts val="1100"/>
+              </a:lnSpc>
+              <a:buNone/>
+            </a:pPr>
+            <a:r>
+              <a:rPr lang="en-US" sz="900" dirty="0">
+                <a:solidFill>
+                  <a:srgbClr val="5A5F73"/>
+                </a:solidFill>
+                <a:latin typeface="Calibri" pitchFamily="34" charset="0"/>
+                <a:ea typeface="Calibri" pitchFamily="34" charset="-122"/>
+                <a:cs typeface="Calibri" pitchFamily="34" charset="-120"/>
+              </a:rPr>
+              <a:t>el caso vuelve</a:t>
+            </a:r>
+            <a:endParaRPr lang="en-US" sz="900" dirty="0"/>
+          </a:p>
+          <a:p>
+            <a:pPr algn="ctr" indent="0" marL="0">
+              <a:lnSpc>
+                <a:spcPts val="1100"/>
+              </a:lnSpc>
+              <a:buNone/>
+            </a:pPr>
+            <a:r>
+              <a:rPr lang="en-US" sz="900" dirty="0">
+                <a:solidFill>
+                  <a:srgbClr val="5A5F73"/>
+                </a:solidFill>
+                <a:latin typeface="Calibri" pitchFamily="34" charset="0"/>
+                <a:ea typeface="Calibri" pitchFamily="34" charset="-122"/>
+                <a:cs typeface="Calibri" pitchFamily="34" charset="-120"/>
+              </a:rPr>
               <a:t>al catálogo</a:t>
             </a:r>
-            <a:endParaRPr lang="en-US" sz="1100" dirty="0"/>
-          </a:p>
-        </p:txBody>
-      </p:sp>
-      <p:sp>
-        <p:nvSpPr>
-          <p:cNvPr id="36" name="Shape 34"/>
-          <p:cNvSpPr/>
-          <p:nvPr/>
-        </p:nvSpPr>
-        <p:spPr>
-          <a:xfrm>
-            <a:off x="1943100" y="5623560"/>
-            <a:ext cx="8202168" cy="0"/>
+            <a:endParaRPr lang="en-US" sz="900" dirty="0"/>
+          </a:p>
+        </p:txBody>
+      </p:sp>
+      <p:sp>
+        <p:nvSpPr>
+          <p:cNvPr id="64" name="Shape 62"/>
+          <p:cNvSpPr/>
+          <p:nvPr/>
+        </p:nvSpPr>
+        <p:spPr>
+          <a:xfrm>
+            <a:off x="1600200" y="5779008"/>
+            <a:ext cx="8961120" cy="0"/>
           </a:xfrm>
           <a:prstGeom prst="line">
             <a:avLst/>
@@ -11011,14 +12011,14 @@
       </p:sp>
       <p:sp>
         <p:nvSpPr>
-          <p:cNvPr id="37" name="Text 35"/>
-          <p:cNvSpPr/>
-          <p:nvPr/>
-        </p:nvSpPr>
-        <p:spPr>
-          <a:xfrm>
-            <a:off x="777240" y="5669280"/>
-            <a:ext cx="10607040" cy="274320"/>
+          <p:cNvPr id="65" name="Text 63"/>
+          <p:cNvSpPr/>
+          <p:nvPr/>
+        </p:nvSpPr>
+        <p:spPr>
+          <a:xfrm>
+            <a:off x="640080" y="5833872"/>
+            <a:ext cx="10881360" cy="256032"/>
           </a:xfrm>
           <a:prstGeom prst="rect">
             <a:avLst/>
@@ -11034,7 +12034,7 @@
               <a:buNone/>
             </a:pPr>
             <a:r>
-              <a:rPr lang="en-US" sz="1100" i="1" dirty="0">
+              <a:rPr lang="en-US" sz="1000" i="1" dirty="0">
                 <a:solidFill>
                   <a:srgbClr val="5A5F73"/>
                 </a:solidFill>
@@ -11044,13 +12044,13 @@
               </a:rPr>
               <a:t>lo aprendido alimenta el siguiente diagnóstico</a:t>
             </a:r>
-            <a:endParaRPr lang="en-US" sz="1100" dirty="0"/>
-          </a:p>
-        </p:txBody>
-      </p:sp>
-      <p:sp>
-        <p:nvSpPr>
-          <p:cNvPr id="38" name="Shape 36"/>
+            <a:endParaRPr lang="en-US" sz="1000" dirty="0"/>
+          </a:p>
+        </p:txBody>
+      </p:sp>
+      <p:sp>
+        <p:nvSpPr>
+          <p:cNvPr id="66" name="Shape 64"/>
           <p:cNvSpPr/>
           <p:nvPr/>
         </p:nvSpPr>
@@ -11070,7 +12070,7 @@
       </p:sp>
       <p:sp>
         <p:nvSpPr>
-          <p:cNvPr id="39" name="Text 37"/>
+          <p:cNvPr id="67" name="Text 65"/>
           <p:cNvSpPr/>
           <p:nvPr/>
         </p:nvSpPr>
@@ -11109,7 +12109,7 @@
       </p:sp>
       <p:sp>
         <p:nvSpPr>
-          <p:cNvPr id="40" name="Text 38"/>
+          <p:cNvPr id="68" name="Text 66"/>
           <p:cNvSpPr/>
           <p:nvPr/>
         </p:nvSpPr>
@@ -11148,7 +12148,7 @@
       </p:sp>
       <p:sp>
         <p:nvSpPr>
-          <p:cNvPr id="41" name="Text 39"/>
+          <p:cNvPr id="69" name="Text 67"/>
           <p:cNvSpPr/>
           <p:nvPr/>
         </p:nvSpPr>

</xml_diff>

<commit_message>
docs(tfm): el vistazo pasa a diagrama de componentes
</commit_message>
<xml_diff>
--- a/docs/presentacion/tfm-intelligent-automotive-diagnostics.pptx
+++ b/docs/presentacion/tfm-intelligent-automotive-diagnostics.pptx
@@ -1627,11 +1627,12 @@
           <a:p>
             <a:r>
               <a:rPr lang="en-US" dirty="0"/>
-              <a:t>Esta es la foto entera, para que se entienda dónde encaja todo lo que viene después.
-La primera fase es identificar el coche. El mecánico entra con su sesión, elige el vehículo —por cable, por WiFi o uno de los emuladores— y el sistema le pregunta al coche el bastidor con el modo 09. De ahí resuelve la marca por una cascada: primero mira la base de datos, luego el catálogo de fabricantes, luego la web, y si nada funciona lo confirma el mecánico a mano y queda aprendido. Después hace un barrido del bus para ver qué centralitas contestan.
-La segunda fase es leer los datos: la telemetría con el modo 01 aplicando la fórmula de cada PID, los códigos de avería con los modos 03, 07 y 0A, y el freeze frame con el 02. Con eso el diagnóstico determinista calcula la severidad por regla, sin IA de por medio, y sale a pantalla. Todo eso queda guardado en SQLite con la sesión.
-La tercera fase es la de IA, y solo entra si hay modelo configurado. Antes de llamarlo se buscan casos parecidos en la base vectorial. El agente entra con esos casos y con las dieciséis herramientas MCP, y va pidiendo lo que le falta: el catálogo, más lecturas del coche, o la web si hace falta. Sale un informe con narrativa, severidad y recomendaciones.
-Y esa flecha de vuelta es la tesis del proyecto: el caso se indexa, y lo aprendido alimenta el siguiente diagnóstico.
+              <a:t>Esta es la foto entera. Lo importante no es la lista de piezas, es quién llama a quién.
+Arriba el mecánico, con la interfaz en React y su sesión. Habla con la API, y las flechas son de ida y vuelta porque son peticiones y respuestas.
+En el centro, en oscuro, está el núcleo: los casos de uso y el dominio. Ahí viven las fórmulas de la SAE J1979, los catálogos y la decodificación del VIN. Ese bloque no sabe nada de lo que hay debajo.
+Debajo, los tres adaptadores. El transporte OBD, que habla con el ELM327 por puerto serie o por TCP y negocia el protocolo del bus. La persistencia, con SQLite para lo relacional y LanceDB para lo vectorial. Y el servidor MCP, que expone las dieciséis herramientas.
+Y abajo del todo, lo que hay al otro lado: el coche, con su bus CAN, o uno de los tres emuladores; y el modelo, Anthropic u OpenAI, más la búsqueda web.
+Fijaos en las flechas discontinuas del centro, que son lo que hace que esto sea un sistema y no una tubería: cuando el agente pide una herramienta, esa herramienta vuelve a entrar por los mismos adaptadores. Lee el coche por el mismo transporte y escribe en el mismo catálogo. No hay una puerta trasera para la IA.
 [~75 s · acumulado 2:55]</a:t>
             </a:r>
             <a:endParaRPr lang="en-US" dirty="0"/>
@@ -9670,8 +9671,8 @@
         </p:nvSpPr>
         <p:spPr>
           <a:xfrm>
-            <a:off x="640080" y="457200"/>
-            <a:ext cx="10881360" cy="685800"/>
+            <a:off x="640080" y="411480"/>
+            <a:ext cx="10881360" cy="640080"/>
           </a:xfrm>
           <a:prstGeom prst="rect">
             <a:avLst/>
@@ -9687,7 +9688,7 @@
               <a:buNone/>
             </a:pPr>
             <a:r>
-              <a:rPr lang="en-US" sz="3200" b="1" dirty="0">
+              <a:rPr lang="en-US" sz="3000" b="1" dirty="0">
                 <a:solidFill>
                   <a:srgbClr val="1A1C2E"/>
                 </a:solidFill>
@@ -9697,7 +9698,7 @@
               </a:rPr>
               <a:t>El sistema de un vistazo</a:t>
             </a:r>
-            <a:endParaRPr lang="en-US" sz="3200" dirty="0"/>
+            <a:endParaRPr lang="en-US" sz="3000" dirty="0"/>
           </a:p>
         </p:txBody>
       </p:sp>
@@ -9709,8 +9710,8 @@
         </p:nvSpPr>
         <p:spPr>
           <a:xfrm>
-            <a:off x="640080" y="1234440"/>
-            <a:ext cx="10881360" cy="320040"/>
+            <a:off x="640080" y="1115568"/>
+            <a:ext cx="10881360" cy="292608"/>
           </a:xfrm>
           <a:prstGeom prst="rect">
             <a:avLst/>
@@ -9726,7 +9727,7 @@
               <a:buNone/>
             </a:pPr>
             <a:r>
-              <a:rPr lang="en-US" sz="1500" dirty="0">
+              <a:rPr lang="en-US" sz="1400" dirty="0">
                 <a:solidFill>
                   <a:srgbClr val="5A5F73"/>
                 </a:solidFill>
@@ -9734,65 +9735,26 @@
                 <a:ea typeface="Calibri" pitchFamily="34" charset="-122"/>
                 <a:cs typeface="Calibri" pitchFamily="34" charset="-120"/>
               </a:rPr>
-              <a:t>Del conector del coche hasta la respuesta, y de vuelta al catálogo.</a:t>
-            </a:r>
-            <a:endParaRPr lang="en-US" sz="1500" dirty="0"/>
-          </a:p>
-        </p:txBody>
-      </p:sp>
-      <p:sp>
-        <p:nvSpPr>
-          <p:cNvPr id="4" name="Text 2"/>
-          <p:cNvSpPr/>
-          <p:nvPr/>
-        </p:nvSpPr>
-        <p:spPr>
-          <a:xfrm>
-            <a:off x="640080" y="1655064"/>
-            <a:ext cx="10881360" cy="256032"/>
-          </a:xfrm>
-          <a:prstGeom prst="rect">
-            <a:avLst/>
-          </a:prstGeom>
-          <a:noFill/>
-          <a:ln/>
-        </p:spPr>
-        <p:txBody>
-          <a:bodyPr wrap="square" lIns="0" tIns="0" rIns="0" bIns="0" rtlCol="0" anchor="t"/>
-          <a:lstStyle/>
-          <a:p>
-            <a:pPr indent="0" marL="0">
-              <a:buNone/>
-            </a:pPr>
-            <a:r>
-              <a:rPr lang="en-US" sz="1100" b="1" spc="140" kern="0" dirty="0">
-                <a:solidFill>
-                  <a:srgbClr val="202CFC"/>
-                </a:solidFill>
-                <a:latin typeface="Calibri" pitchFamily="34" charset="0"/>
-                <a:ea typeface="Calibri" pitchFamily="34" charset="-122"/>
-                <a:cs typeface="Calibri" pitchFamily="34" charset="-120"/>
-              </a:rPr>
-              <a:t>1 · IDENTIFICAR EL COCHE</a:t>
-            </a:r>
-            <a:endParaRPr lang="en-US" sz="1100" dirty="0"/>
-          </a:p>
-        </p:txBody>
-      </p:sp>
-      <p:sp>
-        <p:nvSpPr>
-          <p:cNvPr id="5" name="Shape 3"/>
-          <p:cNvSpPr/>
-          <p:nvPr/>
-        </p:nvSpPr>
-        <p:spPr>
-          <a:xfrm>
-            <a:off x="640080" y="1965960"/>
-            <a:ext cx="1920240" cy="749808"/>
+              <a:t>Quién llama a quién. Todo lo de fuera entra por un puerto.</a:t>
+            </a:r>
+            <a:endParaRPr lang="en-US" sz="1400" dirty="0"/>
+          </a:p>
+        </p:txBody>
+      </p:sp>
+      <p:sp>
+        <p:nvSpPr>
+          <p:cNvPr id="4" name="Shape 2"/>
+          <p:cNvSpPr/>
+          <p:nvPr/>
+        </p:nvSpPr>
+        <p:spPr>
+          <a:xfrm>
+            <a:off x="4709160" y="1572768"/>
+            <a:ext cx="2743200" cy="658368"/>
           </a:xfrm>
           <a:prstGeom prst="roundRect">
             <a:avLst>
-              <a:gd name="adj" fmla="val 6098"/>
+              <a:gd name="adj" fmla="val 6944"/>
             </a:avLst>
           </a:prstGeom>
           <a:solidFill>
@@ -9808,14 +9770,14 @@
       </p:sp>
       <p:sp>
         <p:nvSpPr>
-          <p:cNvPr id="6" name="Text 4"/>
-          <p:cNvSpPr/>
-          <p:nvPr/>
-        </p:nvSpPr>
-        <p:spPr>
-          <a:xfrm>
-            <a:off x="713232" y="2057400"/>
-            <a:ext cx="1773936" cy="256032"/>
+          <p:cNvPr id="5" name="Text 3"/>
+          <p:cNvSpPr/>
+          <p:nvPr/>
+        </p:nvSpPr>
+        <p:spPr>
+          <a:xfrm>
+            <a:off x="4782312" y="1664208"/>
+            <a:ext cx="2596896" cy="256032"/>
           </a:xfrm>
           <a:prstGeom prst="rect">
             <a:avLst/>
@@ -9831,7 +9793,7 @@
               <a:buNone/>
             </a:pPr>
             <a:r>
-              <a:rPr lang="en-US" sz="1050" b="1" dirty="0">
+              <a:rPr lang="en-US" sz="1100" b="1" dirty="0">
                 <a:solidFill>
                   <a:srgbClr val="1A1C2E"/>
                 </a:solidFill>
@@ -9841,20 +9803,20 @@
               </a:rPr>
               <a:t>El mecánico</a:t>
             </a:r>
-            <a:endParaRPr lang="en-US" sz="1050" dirty="0"/>
-          </a:p>
-        </p:txBody>
-      </p:sp>
-      <p:sp>
-        <p:nvSpPr>
-          <p:cNvPr id="7" name="Text 5"/>
-          <p:cNvSpPr/>
-          <p:nvPr/>
-        </p:nvSpPr>
-        <p:spPr>
-          <a:xfrm>
-            <a:off x="713232" y="2313432"/>
-            <a:ext cx="1773936" cy="347472"/>
+            <a:endParaRPr lang="en-US" sz="1100" dirty="0"/>
+          </a:p>
+        </p:txBody>
+      </p:sp>
+      <p:sp>
+        <p:nvSpPr>
+          <p:cNvPr id="6" name="Text 4"/>
+          <p:cNvSpPr/>
+          <p:nvPr/>
+        </p:nvSpPr>
+        <p:spPr>
+          <a:xfrm>
+            <a:off x="4782312" y="1920240"/>
+            <a:ext cx="2596896" cy="384048"/>
           </a:xfrm>
           <a:prstGeom prst="rect">
             <a:avLst/>
@@ -9881,7 +9843,7 @@
                 <a:ea typeface="Calibri" pitchFamily="34" charset="-122"/>
                 <a:cs typeface="Calibri" pitchFamily="34" charset="-120"/>
               </a:rPr>
-              <a:t>React 19, sesión JWT</a:t>
+              <a:t>React 19 · sesión JWT</a:t>
             </a:r>
             <a:endParaRPr lang="en-US" sz="900" dirty="0"/>
           </a:p>
@@ -9889,14 +9851,14 @@
       </p:sp>
       <p:sp>
         <p:nvSpPr>
-          <p:cNvPr id="8" name="Shape 6"/>
-          <p:cNvSpPr/>
-          <p:nvPr/>
-        </p:nvSpPr>
-        <p:spPr>
-          <a:xfrm>
-            <a:off x="2615184" y="2340864"/>
-            <a:ext cx="210312" cy="0"/>
+          <p:cNvPr id="7" name="Shape 5"/>
+          <p:cNvSpPr/>
+          <p:nvPr/>
+        </p:nvSpPr>
+        <p:spPr>
+          <a:xfrm>
+            <a:off x="6080760" y="2231136"/>
+            <a:ext cx="0" cy="310896"/>
           </a:xfrm>
           <a:prstGeom prst="line">
             <a:avLst/>
@@ -9907,24 +9869,208 @@
               <a:srgbClr val="202CFC"/>
             </a:solidFill>
             <a:prstDash val="solid"/>
+            <a:headEnd type="triangle"/>
             <a:tailEnd type="triangle"/>
           </a:ln>
         </p:spPr>
       </p:sp>
       <p:sp>
         <p:nvSpPr>
-          <p:cNvPr id="9" name="Shape 7"/>
-          <p:cNvSpPr/>
-          <p:nvPr/>
-        </p:nvSpPr>
-        <p:spPr>
-          <a:xfrm>
-            <a:off x="2880360" y="1965960"/>
-            <a:ext cx="1920240" cy="749808"/>
+          <p:cNvPr id="8" name="Shape 6"/>
+          <p:cNvSpPr/>
+          <p:nvPr/>
+        </p:nvSpPr>
+        <p:spPr>
+          <a:xfrm>
+            <a:off x="960120" y="2542032"/>
+            <a:ext cx="10881360" cy="777240"/>
           </a:xfrm>
           <a:prstGeom prst="roundRect">
             <a:avLst>
-              <a:gd name="adj" fmla="val 6098"/>
+              <a:gd name="adj" fmla="val 5882"/>
+            </a:avLst>
+          </a:prstGeom>
+          <a:solidFill>
+            <a:srgbClr val="1A1C2E"/>
+          </a:solidFill>
+          <a:ln w="12700">
+            <a:solidFill>
+              <a:srgbClr val="1A1C2E"/>
+            </a:solidFill>
+            <a:prstDash val="solid"/>
+          </a:ln>
+        </p:spPr>
+      </p:sp>
+      <p:sp>
+        <p:nvSpPr>
+          <p:cNvPr id="9" name="Text 7"/>
+          <p:cNvSpPr/>
+          <p:nvPr/>
+        </p:nvSpPr>
+        <p:spPr>
+          <a:xfrm>
+            <a:off x="1033272" y="2633472"/>
+            <a:ext cx="10735056" cy="256032"/>
+          </a:xfrm>
+          <a:prstGeom prst="rect">
+            <a:avLst/>
+          </a:prstGeom>
+          <a:noFill/>
+          <a:ln/>
+        </p:spPr>
+        <p:txBody>
+          <a:bodyPr wrap="square" lIns="0" tIns="0" rIns="0" bIns="0" rtlCol="0" anchor="ctr"/>
+          <a:lstStyle/>
+          <a:p>
+            <a:pPr algn="ctr" indent="0" marL="0">
+              <a:buNone/>
+            </a:pPr>
+            <a:r>
+              <a:rPr lang="en-US" sz="1100" b="1" dirty="0">
+                <a:solidFill>
+                  <a:srgbClr val="FFFFFF"/>
+                </a:solidFill>
+                <a:latin typeface="Arial" pitchFamily="34" charset="0"/>
+                <a:ea typeface="Arial" pitchFamily="34" charset="-122"/>
+                <a:cs typeface="Arial" pitchFamily="34" charset="-120"/>
+              </a:rPr>
+              <a:t>API: casos de uso + dominio</a:t>
+            </a:r>
+            <a:endParaRPr lang="en-US" sz="1100" dirty="0"/>
+          </a:p>
+        </p:txBody>
+      </p:sp>
+      <p:sp>
+        <p:nvSpPr>
+          <p:cNvPr id="10" name="Text 8"/>
+          <p:cNvSpPr/>
+          <p:nvPr/>
+        </p:nvSpPr>
+        <p:spPr>
+          <a:xfrm>
+            <a:off x="1033272" y="2889504"/>
+            <a:ext cx="10735056" cy="384048"/>
+          </a:xfrm>
+          <a:prstGeom prst="rect">
+            <a:avLst/>
+          </a:prstGeom>
+          <a:noFill/>
+          <a:ln/>
+        </p:spPr>
+        <p:txBody>
+          <a:bodyPr wrap="square" lIns="0" tIns="0" rIns="0" bIns="0" rtlCol="0" anchor="t"/>
+          <a:lstStyle/>
+          <a:p>
+            <a:pPr algn="ctr" indent="0" marL="0">
+              <a:lnSpc>
+                <a:spcPts val="1100"/>
+              </a:lnSpc>
+              <a:buNone/>
+            </a:pPr>
+            <a:r>
+              <a:rPr lang="en-US" sz="900" dirty="0">
+                <a:solidFill>
+                  <a:srgbClr val="B8BCCC"/>
+                </a:solidFill>
+                <a:latin typeface="Calibri" pitchFamily="34" charset="0"/>
+                <a:ea typeface="Calibri" pitchFamily="34" charset="-122"/>
+                <a:cs typeface="Calibri" pitchFamily="34" charset="-120"/>
+              </a:rPr>
+              <a:t>fórmulas SAE J1979 · catálogos · decodificación del VIN</a:t>
+            </a:r>
+            <a:endParaRPr lang="en-US" sz="900" dirty="0"/>
+          </a:p>
+        </p:txBody>
+      </p:sp>
+      <p:sp>
+        <p:nvSpPr>
+          <p:cNvPr id="11" name="Shape 9"/>
+          <p:cNvSpPr/>
+          <p:nvPr/>
+        </p:nvSpPr>
+        <p:spPr>
+          <a:xfrm>
+            <a:off x="2560320" y="3319272"/>
+            <a:ext cx="0" cy="475488"/>
+          </a:xfrm>
+          <a:prstGeom prst="line">
+            <a:avLst/>
+          </a:prstGeom>
+          <a:noFill/>
+          <a:ln w="15875">
+            <a:solidFill>
+              <a:srgbClr val="202CFC"/>
+            </a:solidFill>
+            <a:prstDash val="solid"/>
+            <a:headEnd type="triangle"/>
+            <a:tailEnd type="triangle"/>
+          </a:ln>
+        </p:spPr>
+      </p:sp>
+      <p:sp>
+        <p:nvSpPr>
+          <p:cNvPr id="12" name="Shape 10"/>
+          <p:cNvSpPr/>
+          <p:nvPr/>
+        </p:nvSpPr>
+        <p:spPr>
+          <a:xfrm>
+            <a:off x="6400800" y="3319272"/>
+            <a:ext cx="0" cy="475488"/>
+          </a:xfrm>
+          <a:prstGeom prst="line">
+            <a:avLst/>
+          </a:prstGeom>
+          <a:noFill/>
+          <a:ln w="15875">
+            <a:solidFill>
+              <a:srgbClr val="202CFC"/>
+            </a:solidFill>
+            <a:prstDash val="solid"/>
+            <a:headEnd type="triangle"/>
+            <a:tailEnd type="triangle"/>
+          </a:ln>
+        </p:spPr>
+      </p:sp>
+      <p:sp>
+        <p:nvSpPr>
+          <p:cNvPr id="13" name="Shape 11"/>
+          <p:cNvSpPr/>
+          <p:nvPr/>
+        </p:nvSpPr>
+        <p:spPr>
+          <a:xfrm>
+            <a:off x="10241280" y="3319272"/>
+            <a:ext cx="0" cy="475488"/>
+          </a:xfrm>
+          <a:prstGeom prst="line">
+            <a:avLst/>
+          </a:prstGeom>
+          <a:noFill/>
+          <a:ln w="15875">
+            <a:solidFill>
+              <a:srgbClr val="202CFC"/>
+            </a:solidFill>
+            <a:prstDash val="solid"/>
+            <a:headEnd type="triangle"/>
+            <a:tailEnd type="triangle"/>
+          </a:ln>
+        </p:spPr>
+      </p:sp>
+      <p:sp>
+        <p:nvSpPr>
+          <p:cNvPr id="14" name="Shape 12"/>
+          <p:cNvSpPr/>
+          <p:nvPr/>
+        </p:nvSpPr>
+        <p:spPr>
+          <a:xfrm>
+            <a:off x="960120" y="3794760"/>
+            <a:ext cx="3200400" cy="868680"/>
+          </a:xfrm>
+          <a:prstGeom prst="roundRect">
+            <a:avLst>
+              <a:gd name="adj" fmla="val 5263"/>
             </a:avLst>
           </a:prstGeom>
           <a:solidFill>
@@ -9940,14 +10086,14 @@
       </p:sp>
       <p:sp>
         <p:nvSpPr>
-          <p:cNvPr id="10" name="Text 8"/>
-          <p:cNvSpPr/>
-          <p:nvPr/>
-        </p:nvSpPr>
-        <p:spPr>
-          <a:xfrm>
-            <a:off x="2953512" y="2057400"/>
-            <a:ext cx="1773936" cy="256032"/>
+          <p:cNvPr id="15" name="Text 13"/>
+          <p:cNvSpPr/>
+          <p:nvPr/>
+        </p:nvSpPr>
+        <p:spPr>
+          <a:xfrm>
+            <a:off x="1033272" y="3886200"/>
+            <a:ext cx="3054096" cy="256032"/>
           </a:xfrm>
           <a:prstGeom prst="rect">
             <a:avLst/>
@@ -9963,7 +10109,7 @@
               <a:buNone/>
             </a:pPr>
             <a:r>
-              <a:rPr lang="en-US" sz="1050" b="1" dirty="0">
+              <a:rPr lang="en-US" sz="1100" b="1" dirty="0">
                 <a:solidFill>
                   <a:srgbClr val="1A1C2E"/>
                 </a:solidFill>
@@ -9971,22 +10117,22 @@
                 <a:ea typeface="Arial" pitchFamily="34" charset="-122"/>
                 <a:cs typeface="Arial" pitchFamily="34" charset="-120"/>
               </a:rPr>
-              <a:t>Elige vehículo</a:t>
-            </a:r>
-            <a:endParaRPr lang="en-US" sz="1050" dirty="0"/>
-          </a:p>
-        </p:txBody>
-      </p:sp>
-      <p:sp>
-        <p:nvSpPr>
-          <p:cNvPr id="11" name="Text 9"/>
-          <p:cNvSpPr/>
-          <p:nvPr/>
-        </p:nvSpPr>
-        <p:spPr>
-          <a:xfrm>
-            <a:off x="2953512" y="2313432"/>
-            <a:ext cx="1773936" cy="347472"/>
+              <a:t>Transporte OBD</a:t>
+            </a:r>
+            <a:endParaRPr lang="en-US" sz="1100" dirty="0"/>
+          </a:p>
+        </p:txBody>
+      </p:sp>
+      <p:sp>
+        <p:nvSpPr>
+          <p:cNvPr id="16" name="Text 14"/>
+          <p:cNvSpPr/>
+          <p:nvPr/>
+        </p:nvSpPr>
+        <p:spPr>
+          <a:xfrm>
+            <a:off x="1033272" y="4142232"/>
+            <a:ext cx="3054096" cy="384048"/>
           </a:xfrm>
           <a:prstGeom prst="rect">
             <a:avLst/>
@@ -10013,7 +10159,7 @@
                 <a:ea typeface="Calibri" pitchFamily="34" charset="-122"/>
                 <a:cs typeface="Calibri" pitchFamily="34" charset="-120"/>
               </a:rPr>
-              <a:t>cable USB, WiFi</a:t>
+              <a:t>ELM327 por serie o TCP</a:t>
             </a:r>
             <a:endParaRPr lang="en-US" sz="900" dirty="0"/>
           </a:p>
@@ -10033,7 +10179,7 @@
                 <a:ea typeface="Calibri" pitchFamily="34" charset="-122"/>
                 <a:cs typeface="Calibri" pitchFamily="34" charset="-120"/>
               </a:rPr>
-              <a:t>o emulador</a:t>
+              <a:t>negocia el protocolo</a:t>
             </a:r>
             <a:endParaRPr lang="en-US" sz="900" dirty="0"/>
           </a:p>
@@ -10041,42 +10187,18 @@
       </p:sp>
       <p:sp>
         <p:nvSpPr>
-          <p:cNvPr id="12" name="Shape 10"/>
-          <p:cNvSpPr/>
-          <p:nvPr/>
-        </p:nvSpPr>
-        <p:spPr>
-          <a:xfrm>
-            <a:off x="4855464" y="2340864"/>
-            <a:ext cx="210312" cy="0"/>
-          </a:xfrm>
-          <a:prstGeom prst="line">
-            <a:avLst/>
-          </a:prstGeom>
-          <a:noFill/>
-          <a:ln w="15875">
-            <a:solidFill>
-              <a:srgbClr val="202CFC"/>
-            </a:solidFill>
-            <a:prstDash val="solid"/>
-            <a:tailEnd type="triangle"/>
-          </a:ln>
-        </p:spPr>
-      </p:sp>
-      <p:sp>
-        <p:nvSpPr>
-          <p:cNvPr id="13" name="Shape 11"/>
-          <p:cNvSpPr/>
-          <p:nvPr/>
-        </p:nvSpPr>
-        <p:spPr>
-          <a:xfrm>
-            <a:off x="5120640" y="1965960"/>
-            <a:ext cx="1920240" cy="749808"/>
+          <p:cNvPr id="17" name="Shape 15"/>
+          <p:cNvSpPr/>
+          <p:nvPr/>
+        </p:nvSpPr>
+        <p:spPr>
+          <a:xfrm>
+            <a:off x="4800600" y="3794760"/>
+            <a:ext cx="3200400" cy="868680"/>
           </a:xfrm>
           <a:prstGeom prst="roundRect">
             <a:avLst>
-              <a:gd name="adj" fmla="val 6098"/>
+              <a:gd name="adj" fmla="val 5263"/>
             </a:avLst>
           </a:prstGeom>
           <a:solidFill>
@@ -10092,14 +10214,14 @@
       </p:sp>
       <p:sp>
         <p:nvSpPr>
-          <p:cNvPr id="14" name="Text 12"/>
-          <p:cNvSpPr/>
-          <p:nvPr/>
-        </p:nvSpPr>
-        <p:spPr>
-          <a:xfrm>
-            <a:off x="5193792" y="2057400"/>
-            <a:ext cx="1773936" cy="256032"/>
+          <p:cNvPr id="18" name="Text 16"/>
+          <p:cNvSpPr/>
+          <p:nvPr/>
+        </p:nvSpPr>
+        <p:spPr>
+          <a:xfrm>
+            <a:off x="4873752" y="3886200"/>
+            <a:ext cx="3054096" cy="256032"/>
           </a:xfrm>
           <a:prstGeom prst="rect">
             <a:avLst/>
@@ -10115,7 +10237,7 @@
               <a:buNone/>
             </a:pPr>
             <a:r>
-              <a:rPr lang="en-US" sz="1050" b="1" dirty="0">
+              <a:rPr lang="en-US" sz="1100" b="1" dirty="0">
                 <a:solidFill>
                   <a:srgbClr val="1A1C2E"/>
                 </a:solidFill>
@@ -10123,22 +10245,22 @@
                 <a:ea typeface="Arial" pitchFamily="34" charset="-122"/>
                 <a:cs typeface="Arial" pitchFamily="34" charset="-120"/>
               </a:rPr>
-              <a:t>Lee el VIN</a:t>
-            </a:r>
-            <a:endParaRPr lang="en-US" sz="1050" dirty="0"/>
-          </a:p>
-        </p:txBody>
-      </p:sp>
-      <p:sp>
-        <p:nvSpPr>
-          <p:cNvPr id="15" name="Text 13"/>
-          <p:cNvSpPr/>
-          <p:nvPr/>
-        </p:nvSpPr>
-        <p:spPr>
-          <a:xfrm>
-            <a:off x="5193792" y="2313432"/>
-            <a:ext cx="1773936" cy="347472"/>
+              <a:t>Persistencia</a:t>
+            </a:r>
+            <a:endParaRPr lang="en-US" sz="1100" dirty="0"/>
+          </a:p>
+        </p:txBody>
+      </p:sp>
+      <p:sp>
+        <p:nvSpPr>
+          <p:cNvPr id="19" name="Text 17"/>
+          <p:cNvSpPr/>
+          <p:nvPr/>
+        </p:nvSpPr>
+        <p:spPr>
+          <a:xfrm>
+            <a:off x="4873752" y="4142232"/>
+            <a:ext cx="3054096" cy="384048"/>
           </a:xfrm>
           <a:prstGeom prst="rect">
             <a:avLst/>
@@ -10165,50 +10287,46 @@
                 <a:ea typeface="Calibri" pitchFamily="34" charset="-122"/>
                 <a:cs typeface="Calibri" pitchFamily="34" charset="-120"/>
               </a:rPr>
-              <a:t>modo 09, ISO 3779</a:t>
+              <a:t>SQLite · 13 tablas</a:t>
             </a:r>
             <a:endParaRPr lang="en-US" sz="900" dirty="0"/>
           </a:p>
-        </p:txBody>
-      </p:sp>
-      <p:sp>
-        <p:nvSpPr>
-          <p:cNvPr id="16" name="Shape 14"/>
-          <p:cNvSpPr/>
-          <p:nvPr/>
-        </p:nvSpPr>
-        <p:spPr>
-          <a:xfrm>
-            <a:off x="7095744" y="2340864"/>
-            <a:ext cx="210312" cy="0"/>
-          </a:xfrm>
-          <a:prstGeom prst="line">
-            <a:avLst/>
-          </a:prstGeom>
-          <a:noFill/>
-          <a:ln w="15875">
-            <a:solidFill>
-              <a:srgbClr val="202CFC"/>
-            </a:solidFill>
-            <a:prstDash val="solid"/>
-            <a:tailEnd type="triangle"/>
-          </a:ln>
-        </p:spPr>
-      </p:sp>
-      <p:sp>
-        <p:nvSpPr>
-          <p:cNvPr id="17" name="Shape 15"/>
-          <p:cNvSpPr/>
-          <p:nvPr/>
-        </p:nvSpPr>
-        <p:spPr>
-          <a:xfrm>
-            <a:off x="7360920" y="1965960"/>
-            <a:ext cx="1920240" cy="749808"/>
+          <a:p>
+            <a:pPr algn="ctr" indent="0" marL="0">
+              <a:lnSpc>
+                <a:spcPts val="1100"/>
+              </a:lnSpc>
+              <a:buNone/>
+            </a:pPr>
+            <a:r>
+              <a:rPr lang="en-US" sz="900" dirty="0">
+                <a:solidFill>
+                  <a:srgbClr val="5A5F73"/>
+                </a:solidFill>
+                <a:latin typeface="Calibri" pitchFamily="34" charset="0"/>
+                <a:ea typeface="Calibri" pitchFamily="34" charset="-122"/>
+                <a:cs typeface="Calibri" pitchFamily="34" charset="-120"/>
+              </a:rPr>
+              <a:t>LanceDB · 4 índices</a:t>
+            </a:r>
+            <a:endParaRPr lang="en-US" sz="900" dirty="0"/>
+          </a:p>
+        </p:txBody>
+      </p:sp>
+      <p:sp>
+        <p:nvSpPr>
+          <p:cNvPr id="20" name="Shape 18"/>
+          <p:cNvSpPr/>
+          <p:nvPr/>
+        </p:nvSpPr>
+        <p:spPr>
+          <a:xfrm>
+            <a:off x="8641080" y="3794760"/>
+            <a:ext cx="3200400" cy="868680"/>
           </a:xfrm>
           <a:prstGeom prst="roundRect">
             <a:avLst>
-              <a:gd name="adj" fmla="val 6098"/>
+              <a:gd name="adj" fmla="val 5263"/>
             </a:avLst>
           </a:prstGeom>
           <a:solidFill>
@@ -10224,14 +10342,14 @@
       </p:sp>
       <p:sp>
         <p:nvSpPr>
-          <p:cNvPr id="18" name="Text 16"/>
-          <p:cNvSpPr/>
-          <p:nvPr/>
-        </p:nvSpPr>
-        <p:spPr>
-          <a:xfrm>
-            <a:off x="7434072" y="2057400"/>
-            <a:ext cx="1773936" cy="256032"/>
+          <p:cNvPr id="21" name="Text 19"/>
+          <p:cNvSpPr/>
+          <p:nvPr/>
+        </p:nvSpPr>
+        <p:spPr>
+          <a:xfrm>
+            <a:off x="8714232" y="3886200"/>
+            <a:ext cx="3054096" cy="256032"/>
           </a:xfrm>
           <a:prstGeom prst="rect">
             <a:avLst/>
@@ -10247,7 +10365,7 @@
               <a:buNone/>
             </a:pPr>
             <a:r>
-              <a:rPr lang="en-US" sz="1050" b="1" dirty="0">
+              <a:rPr lang="en-US" sz="1100" b="1" dirty="0">
                 <a:solidFill>
                   <a:srgbClr val="1A1C2E"/>
                 </a:solidFill>
@@ -10255,22 +10373,22 @@
                 <a:ea typeface="Arial" pitchFamily="34" charset="-122"/>
                 <a:cs typeface="Arial" pitchFamily="34" charset="-120"/>
               </a:rPr>
-              <a:t>Resuelve la marca</a:t>
-            </a:r>
-            <a:endParaRPr lang="en-US" sz="1050" dirty="0"/>
-          </a:p>
-        </p:txBody>
-      </p:sp>
-      <p:sp>
-        <p:nvSpPr>
-          <p:cNvPr id="19" name="Text 17"/>
-          <p:cNvSpPr/>
-          <p:nvPr/>
-        </p:nvSpPr>
-        <p:spPr>
-          <a:xfrm>
-            <a:off x="7434072" y="2313432"/>
-            <a:ext cx="1773936" cy="347472"/>
+              <a:t>Servidor MCP</a:t>
+            </a:r>
+            <a:endParaRPr lang="en-US" sz="1100" dirty="0"/>
+          </a:p>
+        </p:txBody>
+      </p:sp>
+      <p:sp>
+        <p:nvSpPr>
+          <p:cNvPr id="22" name="Text 20"/>
+          <p:cNvSpPr/>
+          <p:nvPr/>
+        </p:nvSpPr>
+        <p:spPr>
+          <a:xfrm>
+            <a:off x="8714232" y="4142232"/>
+            <a:ext cx="3054096" cy="384048"/>
           </a:xfrm>
           <a:prstGeom prst="rect">
             <a:avLst/>
@@ -10297,7 +10415,7 @@
                 <a:ea typeface="Calibri" pitchFamily="34" charset="-122"/>
                 <a:cs typeface="Calibri" pitchFamily="34" charset="-120"/>
               </a:rPr>
-              <a:t>BBDD → catálogo →</a:t>
+              <a:t>16 herramientas</a:t>
             </a:r>
             <a:endParaRPr lang="en-US" sz="900" dirty="0"/>
           </a:p>
@@ -10317,7 +10435,7 @@
                 <a:ea typeface="Calibri" pitchFamily="34" charset="-122"/>
                 <a:cs typeface="Calibri" pitchFamily="34" charset="-120"/>
               </a:rPr>
-              <a:t>web → mecánico</a:t>
+              <a:t>declaradas con su esquema</a:t>
             </a:r>
             <a:endParaRPr lang="en-US" sz="900" dirty="0"/>
           </a:p>
@@ -10325,14 +10443,62 @@
       </p:sp>
       <p:sp>
         <p:nvSpPr>
-          <p:cNvPr id="20" name="Shape 18"/>
-          <p:cNvSpPr/>
-          <p:nvPr/>
-        </p:nvSpPr>
-        <p:spPr>
-          <a:xfrm>
-            <a:off x="9336024" y="2340864"/>
-            <a:ext cx="210312" cy="0"/>
+          <p:cNvPr id="23" name="Shape 21"/>
+          <p:cNvSpPr/>
+          <p:nvPr/>
+        </p:nvSpPr>
+        <p:spPr>
+          <a:xfrm>
+            <a:off x="4233672" y="4233672"/>
+            <a:ext cx="493776" cy="0"/>
+          </a:xfrm>
+          <a:prstGeom prst="line">
+            <a:avLst/>
+          </a:prstGeom>
+          <a:noFill/>
+          <a:ln w="12700">
+            <a:solidFill>
+              <a:srgbClr val="9AA0B4"/>
+            </a:solidFill>
+            <a:prstDash val="dash"/>
+            <a:headEnd type="triangle"/>
+          </a:ln>
+        </p:spPr>
+      </p:sp>
+      <p:sp>
+        <p:nvSpPr>
+          <p:cNvPr id="24" name="Shape 22"/>
+          <p:cNvSpPr/>
+          <p:nvPr/>
+        </p:nvSpPr>
+        <p:spPr>
+          <a:xfrm>
+            <a:off x="8074152" y="4233672"/>
+            <a:ext cx="493776" cy="0"/>
+          </a:xfrm>
+          <a:prstGeom prst="line">
+            <a:avLst/>
+          </a:prstGeom>
+          <a:noFill/>
+          <a:ln w="12700">
+            <a:solidFill>
+              <a:srgbClr val="9AA0B4"/>
+            </a:solidFill>
+            <a:prstDash val="dash"/>
+            <a:headEnd type="triangle"/>
+          </a:ln>
+        </p:spPr>
+      </p:sp>
+      <p:sp>
+        <p:nvSpPr>
+          <p:cNvPr id="25" name="Shape 23"/>
+          <p:cNvSpPr/>
+          <p:nvPr/>
+        </p:nvSpPr>
+        <p:spPr>
+          <a:xfrm>
+            <a:off x="2560320" y="4663440"/>
+            <a:ext cx="0" cy="566928"/>
           </a:xfrm>
           <a:prstGeom prst="line">
             <a:avLst/>
@@ -10343,24 +10509,50 @@
               <a:srgbClr val="202CFC"/>
             </a:solidFill>
             <a:prstDash val="solid"/>
+            <a:headEnd type="triangle"/>
             <a:tailEnd type="triangle"/>
           </a:ln>
         </p:spPr>
       </p:sp>
       <p:sp>
         <p:nvSpPr>
-          <p:cNvPr id="21" name="Shape 19"/>
-          <p:cNvSpPr/>
-          <p:nvPr/>
-        </p:nvSpPr>
-        <p:spPr>
-          <a:xfrm>
-            <a:off x="9601200" y="1965960"/>
-            <a:ext cx="1920240" cy="749808"/>
+          <p:cNvPr id="26" name="Shape 24"/>
+          <p:cNvSpPr/>
+          <p:nvPr/>
+        </p:nvSpPr>
+        <p:spPr>
+          <a:xfrm>
+            <a:off x="10241280" y="4663440"/>
+            <a:ext cx="0" cy="566928"/>
+          </a:xfrm>
+          <a:prstGeom prst="line">
+            <a:avLst/>
+          </a:prstGeom>
+          <a:noFill/>
+          <a:ln w="15875">
+            <a:solidFill>
+              <a:srgbClr val="202CFC"/>
+            </a:solidFill>
+            <a:prstDash val="solid"/>
+            <a:headEnd type="triangle"/>
+            <a:tailEnd type="triangle"/>
+          </a:ln>
+        </p:spPr>
+      </p:sp>
+      <p:sp>
+        <p:nvSpPr>
+          <p:cNvPr id="27" name="Shape 25"/>
+          <p:cNvSpPr/>
+          <p:nvPr/>
+        </p:nvSpPr>
+        <p:spPr>
+          <a:xfrm>
+            <a:off x="960120" y="5230368"/>
+            <a:ext cx="3200400" cy="822960"/>
           </a:xfrm>
           <a:prstGeom prst="roundRect">
             <a:avLst>
-              <a:gd name="adj" fmla="val 6098"/>
+              <a:gd name="adj" fmla="val 5556"/>
             </a:avLst>
           </a:prstGeom>
           <a:solidFill>
@@ -10376,14 +10568,14 @@
       </p:sp>
       <p:sp>
         <p:nvSpPr>
-          <p:cNvPr id="22" name="Text 20"/>
-          <p:cNvSpPr/>
-          <p:nvPr/>
-        </p:nvSpPr>
-        <p:spPr>
-          <a:xfrm>
-            <a:off x="9674352" y="2057400"/>
-            <a:ext cx="1773936" cy="256032"/>
+          <p:cNvPr id="28" name="Text 26"/>
+          <p:cNvSpPr/>
+          <p:nvPr/>
+        </p:nvSpPr>
+        <p:spPr>
+          <a:xfrm>
+            <a:off x="1033272" y="5321808"/>
+            <a:ext cx="3054096" cy="256032"/>
           </a:xfrm>
           <a:prstGeom prst="rect">
             <a:avLst/>
@@ -10399,7 +10591,7 @@
               <a:buNone/>
             </a:pPr>
             <a:r>
-              <a:rPr lang="en-US" sz="1050" b="1" dirty="0">
+              <a:rPr lang="en-US" sz="1100" b="1" dirty="0">
                 <a:solidFill>
                   <a:srgbClr val="1A1C2E"/>
                 </a:solidFill>
@@ -10407,22 +10599,22 @@
                 <a:ea typeface="Arial" pitchFamily="34" charset="-122"/>
                 <a:cs typeface="Arial" pitchFamily="34" charset="-120"/>
               </a:rPr>
-              <a:t>Barrido del bus</a:t>
-            </a:r>
-            <a:endParaRPr lang="en-US" sz="1050" dirty="0"/>
-          </a:p>
-        </p:txBody>
-      </p:sp>
-      <p:sp>
-        <p:nvSpPr>
-          <p:cNvPr id="23" name="Text 21"/>
-          <p:cNvSpPr/>
-          <p:nvPr/>
-        </p:nvSpPr>
-        <p:spPr>
-          <a:xfrm>
-            <a:off x="9674352" y="2313432"/>
-            <a:ext cx="1773936" cy="347472"/>
+              <a:t>El coche</a:t>
+            </a:r>
+            <a:endParaRPr lang="en-US" sz="1100" dirty="0"/>
+          </a:p>
+        </p:txBody>
+      </p:sp>
+      <p:sp>
+        <p:nvSpPr>
+          <p:cNvPr id="29" name="Text 27"/>
+          <p:cNvSpPr/>
+          <p:nvPr/>
+        </p:nvSpPr>
+        <p:spPr>
+          <a:xfrm>
+            <a:off x="1033272" y="5577840"/>
+            <a:ext cx="3054096" cy="384048"/>
           </a:xfrm>
           <a:prstGeom prst="rect">
             <a:avLst/>
@@ -10449,7 +10641,7 @@
                 <a:ea typeface="Calibri" pitchFamily="34" charset="-122"/>
                 <a:cs typeface="Calibri" pitchFamily="34" charset="-120"/>
               </a:rPr>
-              <a:t>quién contesta,</a:t>
+              <a:t>bus CAN · ISO 15765-4</a:t>
             </a:r>
             <a:endParaRPr lang="en-US" sz="900" dirty="0"/>
           </a:p>
@@ -10469,7 +10661,7 @@
                 <a:ea typeface="Calibri" pitchFamily="34" charset="-122"/>
                 <a:cs typeface="Calibri" pitchFamily="34" charset="-120"/>
               </a:rPr>
-              <a:t>ISO 15765-4</a:t>
+              <a:t>o uno de los 3 emuladores</a:t>
             </a:r>
             <a:endParaRPr lang="en-US" sz="900" dirty="0"/>
           </a:p>
@@ -10477,57 +10669,18 @@
       </p:sp>
       <p:sp>
         <p:nvSpPr>
-          <p:cNvPr id="24" name="Text 22"/>
-          <p:cNvSpPr/>
-          <p:nvPr/>
-        </p:nvSpPr>
-        <p:spPr>
-          <a:xfrm>
-            <a:off x="640080" y="3026664"/>
-            <a:ext cx="10881360" cy="256032"/>
-          </a:xfrm>
-          <a:prstGeom prst="rect">
-            <a:avLst/>
-          </a:prstGeom>
-          <a:noFill/>
-          <a:ln/>
-        </p:spPr>
-        <p:txBody>
-          <a:bodyPr wrap="square" lIns="0" tIns="0" rIns="0" bIns="0" rtlCol="0" anchor="t"/>
-          <a:lstStyle/>
-          <a:p>
-            <a:pPr indent="0" marL="0">
-              <a:buNone/>
-            </a:pPr>
-            <a:r>
-              <a:rPr lang="en-US" sz="1100" b="1" spc="140" kern="0" dirty="0">
-                <a:solidFill>
-                  <a:srgbClr val="202CFC"/>
-                </a:solidFill>
-                <a:latin typeface="Calibri" pitchFamily="34" charset="0"/>
-                <a:ea typeface="Calibri" pitchFamily="34" charset="-122"/>
-                <a:cs typeface="Calibri" pitchFamily="34" charset="-120"/>
-              </a:rPr>
-              <a:t>2 · LEER LOS DATOS</a:t>
-            </a:r>
-            <a:endParaRPr lang="en-US" sz="1100" dirty="0"/>
-          </a:p>
-        </p:txBody>
-      </p:sp>
-      <p:sp>
-        <p:nvSpPr>
-          <p:cNvPr id="25" name="Shape 23"/>
-          <p:cNvSpPr/>
-          <p:nvPr/>
-        </p:nvSpPr>
-        <p:spPr>
-          <a:xfrm>
-            <a:off x="640080" y="3337560"/>
-            <a:ext cx="1920240" cy="749808"/>
+          <p:cNvPr id="30" name="Shape 28"/>
+          <p:cNvSpPr/>
+          <p:nvPr/>
+        </p:nvSpPr>
+        <p:spPr>
+          <a:xfrm>
+            <a:off x="8641080" y="5230368"/>
+            <a:ext cx="3200400" cy="822960"/>
           </a:xfrm>
           <a:prstGeom prst="roundRect">
             <a:avLst>
-              <a:gd name="adj" fmla="val 6098"/>
+              <a:gd name="adj" fmla="val 5556"/>
             </a:avLst>
           </a:prstGeom>
           <a:solidFill>
@@ -10543,14 +10696,14 @@
       </p:sp>
       <p:sp>
         <p:nvSpPr>
-          <p:cNvPr id="26" name="Text 24"/>
-          <p:cNvSpPr/>
-          <p:nvPr/>
-        </p:nvSpPr>
-        <p:spPr>
-          <a:xfrm>
-            <a:off x="713232" y="3429000"/>
-            <a:ext cx="1773936" cy="256032"/>
+          <p:cNvPr id="31" name="Text 29"/>
+          <p:cNvSpPr/>
+          <p:nvPr/>
+        </p:nvSpPr>
+        <p:spPr>
+          <a:xfrm>
+            <a:off x="8714232" y="5321808"/>
+            <a:ext cx="3054096" cy="256032"/>
           </a:xfrm>
           <a:prstGeom prst="rect">
             <a:avLst/>
@@ -10566,7 +10719,7 @@
               <a:buNone/>
             </a:pPr>
             <a:r>
-              <a:rPr lang="en-US" sz="1050" b="1" dirty="0">
+              <a:rPr lang="en-US" sz="1100" b="1" dirty="0">
                 <a:solidFill>
                   <a:srgbClr val="1A1C2E"/>
                 </a:solidFill>
@@ -10574,22 +10727,22 @@
                 <a:ea typeface="Arial" pitchFamily="34" charset="-122"/>
                 <a:cs typeface="Arial" pitchFamily="34" charset="-120"/>
               </a:rPr>
-              <a:t>Telemetría</a:t>
-            </a:r>
-            <a:endParaRPr lang="en-US" sz="1050" dirty="0"/>
-          </a:p>
-        </p:txBody>
-      </p:sp>
-      <p:sp>
-        <p:nvSpPr>
-          <p:cNvPr id="27" name="Text 25"/>
-          <p:cNvSpPr/>
-          <p:nvPr/>
-        </p:nvSpPr>
-        <p:spPr>
-          <a:xfrm>
-            <a:off x="713232" y="3685032"/>
-            <a:ext cx="1773936" cy="347472"/>
+              <a:t>El modelo</a:t>
+            </a:r>
+            <a:endParaRPr lang="en-US" sz="1100" dirty="0"/>
+          </a:p>
+        </p:txBody>
+      </p:sp>
+      <p:sp>
+        <p:nvSpPr>
+          <p:cNvPr id="32" name="Text 30"/>
+          <p:cNvSpPr/>
+          <p:nvPr/>
+        </p:nvSpPr>
+        <p:spPr>
+          <a:xfrm>
+            <a:off x="8714232" y="5577840"/>
+            <a:ext cx="3054096" cy="384048"/>
           </a:xfrm>
           <a:prstGeom prst="rect">
             <a:avLst/>
@@ -10616,7 +10769,7 @@
                 <a:ea typeface="Calibri" pitchFamily="34" charset="-122"/>
                 <a:cs typeface="Calibri" pitchFamily="34" charset="-120"/>
               </a:rPr>
-              <a:t>modo 01 + la fórmula</a:t>
+              <a:t>Anthropic u OpenAI</a:t>
             </a:r>
             <a:endParaRPr lang="en-US" sz="900" dirty="0"/>
           </a:p>
@@ -10636,7 +10789,7 @@
                 <a:ea typeface="Calibri" pitchFamily="34" charset="-122"/>
                 <a:cs typeface="Calibri" pitchFamily="34" charset="-120"/>
               </a:rPr>
-              <a:t>de cada PID</a:t>
+              <a:t>y búsqueda web con presupuesto</a:t>
             </a:r>
             <a:endParaRPr lang="en-US" sz="900" dirty="0"/>
           </a:p>
@@ -10644,104 +10797,14 @@
       </p:sp>
       <p:sp>
         <p:nvSpPr>
-          <p:cNvPr id="28" name="Shape 26"/>
-          <p:cNvSpPr/>
-          <p:nvPr/>
-        </p:nvSpPr>
-        <p:spPr>
-          <a:xfrm>
-            <a:off x="2615184" y="3712464"/>
-            <a:ext cx="210312" cy="0"/>
-          </a:xfrm>
-          <a:prstGeom prst="line">
-            <a:avLst/>
-          </a:prstGeom>
-          <a:noFill/>
-          <a:ln w="15875">
-            <a:solidFill>
-              <a:srgbClr val="202CFC"/>
-            </a:solidFill>
-            <a:prstDash val="solid"/>
-            <a:tailEnd type="triangle"/>
-          </a:ln>
-        </p:spPr>
-      </p:sp>
-      <p:sp>
-        <p:nvSpPr>
-          <p:cNvPr id="29" name="Shape 27"/>
-          <p:cNvSpPr/>
-          <p:nvPr/>
-        </p:nvSpPr>
-        <p:spPr>
-          <a:xfrm>
-            <a:off x="2880360" y="3337560"/>
-            <a:ext cx="1920240" cy="749808"/>
-          </a:xfrm>
-          <a:prstGeom prst="roundRect">
-            <a:avLst>
-              <a:gd name="adj" fmla="val 6098"/>
-            </a:avLst>
-          </a:prstGeom>
-          <a:solidFill>
-            <a:srgbClr val="FFFFFF"/>
-          </a:solidFill>
-          <a:ln w="12700">
-            <a:solidFill>
-              <a:srgbClr val="C9CCD8"/>
-            </a:solidFill>
-            <a:prstDash val="solid"/>
-          </a:ln>
-        </p:spPr>
-      </p:sp>
-      <p:sp>
-        <p:nvSpPr>
-          <p:cNvPr id="30" name="Text 28"/>
-          <p:cNvSpPr/>
-          <p:nvPr/>
-        </p:nvSpPr>
-        <p:spPr>
-          <a:xfrm>
-            <a:off x="2953512" y="3429000"/>
-            <a:ext cx="1773936" cy="256032"/>
-          </a:xfrm>
-          <a:prstGeom prst="rect">
-            <a:avLst/>
-          </a:prstGeom>
-          <a:noFill/>
-          <a:ln/>
-        </p:spPr>
-        <p:txBody>
-          <a:bodyPr wrap="square" lIns="0" tIns="0" rIns="0" bIns="0" rtlCol="0" anchor="ctr"/>
-          <a:lstStyle/>
-          <a:p>
-            <a:pPr algn="ctr" indent="0" marL="0">
-              <a:buNone/>
-            </a:pPr>
-            <a:r>
-              <a:rPr lang="en-US" sz="1050" b="1" dirty="0">
-                <a:solidFill>
-                  <a:srgbClr val="1A1C2E"/>
-                </a:solidFill>
-                <a:latin typeface="Arial" pitchFamily="34" charset="0"/>
-                <a:ea typeface="Arial" pitchFamily="34" charset="-122"/>
-                <a:cs typeface="Arial" pitchFamily="34" charset="-120"/>
-              </a:rPr>
-              <a:t>Códigos DTC</a:t>
-            </a:r>
-            <a:endParaRPr lang="en-US" sz="1050" dirty="0"/>
-          </a:p>
-        </p:txBody>
-      </p:sp>
-      <p:sp>
-        <p:nvSpPr>
-          <p:cNvPr id="31" name="Text 29"/>
-          <p:cNvSpPr/>
-          <p:nvPr/>
-        </p:nvSpPr>
-        <p:spPr>
-          <a:xfrm>
-            <a:off x="2953512" y="3685032"/>
-            <a:ext cx="1773936" cy="347472"/>
+          <p:cNvPr id="33" name="Text 31"/>
+          <p:cNvSpPr/>
+          <p:nvPr/>
+        </p:nvSpPr>
+        <p:spPr>
+          <a:xfrm>
+            <a:off x="4434840" y="6172200"/>
+            <a:ext cx="3931920" cy="548640"/>
           </a:xfrm>
           <a:prstGeom prst="rect">
             <a:avLst/>
@@ -10760,7 +10823,7 @@
               <a:buNone/>
             </a:pPr>
             <a:r>
-              <a:rPr lang="en-US" sz="900" dirty="0">
+              <a:rPr lang="en-US" sz="900" i="1" dirty="0">
                 <a:solidFill>
                   <a:srgbClr val="5A5F73"/>
                 </a:solidFill>
@@ -10768,7 +10831,7 @@
                 <a:ea typeface="Calibri" pitchFamily="34" charset="-122"/>
                 <a:cs typeface="Calibri" pitchFamily="34" charset="-120"/>
               </a:rPr>
-              <a:t>modos 03, 07 y 0A</a:t>
+              <a:t>Las herramientas del agente vuelven a entrar por los mismos adaptadores: leen el coche y escriben en el catálogo.</a:t>
             </a:r>
             <a:endParaRPr lang="en-US" sz="900" dirty="0"/>
           </a:p>
@@ -10776,65 +10839,34 @@
       </p:sp>
       <p:sp>
         <p:nvSpPr>
-          <p:cNvPr id="32" name="Shape 30"/>
-          <p:cNvSpPr/>
-          <p:nvPr/>
-        </p:nvSpPr>
-        <p:spPr>
-          <a:xfrm>
-            <a:off x="4855464" y="3712464"/>
-            <a:ext cx="210312" cy="0"/>
-          </a:xfrm>
-          <a:prstGeom prst="line">
-            <a:avLst/>
-          </a:prstGeom>
-          <a:noFill/>
-          <a:ln w="15875">
-            <a:solidFill>
-              <a:srgbClr val="202CFC"/>
-            </a:solidFill>
-            <a:prstDash val="solid"/>
-            <a:tailEnd type="triangle"/>
-          </a:ln>
-        </p:spPr>
-      </p:sp>
-      <p:sp>
-        <p:nvSpPr>
-          <p:cNvPr id="33" name="Shape 31"/>
-          <p:cNvSpPr/>
-          <p:nvPr/>
-        </p:nvSpPr>
-        <p:spPr>
-          <a:xfrm>
-            <a:off x="5120640" y="3337560"/>
-            <a:ext cx="1920240" cy="749808"/>
-          </a:xfrm>
-          <a:prstGeom prst="roundRect">
-            <a:avLst>
-              <a:gd name="adj" fmla="val 6098"/>
-            </a:avLst>
+          <p:cNvPr id="34" name="Shape 32"/>
+          <p:cNvSpPr/>
+          <p:nvPr/>
+        </p:nvSpPr>
+        <p:spPr>
+          <a:xfrm>
+            <a:off x="777240" y="6263640"/>
+            <a:ext cx="219456" cy="219456"/>
+          </a:xfrm>
+          <a:prstGeom prst="rect">
+            <a:avLst/>
           </a:prstGeom>
           <a:solidFill>
-            <a:srgbClr val="FFFFFF"/>
+            <a:srgbClr val="202CFC"/>
           </a:solidFill>
-          <a:ln w="12700">
-            <a:solidFill>
-              <a:srgbClr val="C9CCD8"/>
-            </a:solidFill>
-            <a:prstDash val="solid"/>
-          </a:ln>
-        </p:spPr>
-      </p:sp>
-      <p:sp>
-        <p:nvSpPr>
-          <p:cNvPr id="34" name="Text 32"/>
-          <p:cNvSpPr/>
-          <p:nvPr/>
-        </p:nvSpPr>
-        <p:spPr>
-          <a:xfrm>
-            <a:off x="5193792" y="3429000"/>
-            <a:ext cx="1773936" cy="256032"/>
+          <a:ln/>
+        </p:spPr>
+      </p:sp>
+      <p:sp>
+        <p:nvSpPr>
+          <p:cNvPr id="35" name="Text 33"/>
+          <p:cNvSpPr/>
+          <p:nvPr/>
+        </p:nvSpPr>
+        <p:spPr>
+          <a:xfrm>
+            <a:off x="777240" y="6263640"/>
+            <a:ext cx="219456" cy="219456"/>
           </a:xfrm>
           <a:prstGeom prst="rect">
             <a:avLst/>
@@ -10850,123 +10882,30 @@
               <a:buNone/>
             </a:pPr>
             <a:r>
-              <a:rPr lang="en-US" sz="1050" b="1" dirty="0">
-                <a:solidFill>
-                  <a:srgbClr val="1A1C2E"/>
+              <a:rPr lang="en-US" sz="816" b="1" dirty="0">
+                <a:solidFill>
+                  <a:srgbClr val="FFFFFF"/>
                 </a:solidFill>
                 <a:latin typeface="Arial" pitchFamily="34" charset="0"/>
                 <a:ea typeface="Arial" pitchFamily="34" charset="-122"/>
                 <a:cs typeface="Arial" pitchFamily="34" charset="-120"/>
               </a:rPr>
-              <a:t>Freeze frame</a:t>
-            </a:r>
-            <a:endParaRPr lang="en-US" sz="1050" dirty="0"/>
-          </a:p>
-        </p:txBody>
-      </p:sp>
-      <p:sp>
-        <p:nvSpPr>
-          <p:cNvPr id="35" name="Text 33"/>
-          <p:cNvSpPr/>
-          <p:nvPr/>
-        </p:nvSpPr>
-        <p:spPr>
-          <a:xfrm>
-            <a:off x="5193792" y="3685032"/>
-            <a:ext cx="1773936" cy="347472"/>
-          </a:xfrm>
-          <a:prstGeom prst="rect">
-            <a:avLst/>
-          </a:prstGeom>
-          <a:noFill/>
-          <a:ln/>
-        </p:spPr>
-        <p:txBody>
-          <a:bodyPr wrap="square" lIns="0" tIns="0" rIns="0" bIns="0" rtlCol="0" anchor="t"/>
-          <a:lstStyle/>
-          <a:p>
-            <a:pPr algn="ctr" indent="0" marL="0">
-              <a:lnSpc>
-                <a:spcPts val="1100"/>
-              </a:lnSpc>
-              <a:buNone/>
-            </a:pPr>
-            <a:r>
-              <a:rPr lang="en-US" sz="900" dirty="0">
-                <a:solidFill>
-                  <a:srgbClr val="5A5F73"/>
-                </a:solidFill>
-                <a:latin typeface="Calibri" pitchFamily="34" charset="0"/>
-                <a:ea typeface="Calibri" pitchFamily="34" charset="-122"/>
-                <a:cs typeface="Calibri" pitchFamily="34" charset="-120"/>
-              </a:rPr>
-              <a:t>modo 02</a:t>
-            </a:r>
-            <a:endParaRPr lang="en-US" sz="900" dirty="0"/>
-          </a:p>
-        </p:txBody>
-      </p:sp>
-      <p:sp>
-        <p:nvSpPr>
-          <p:cNvPr id="36" name="Shape 34"/>
-          <p:cNvSpPr/>
-          <p:nvPr/>
-        </p:nvSpPr>
-        <p:spPr>
-          <a:xfrm>
-            <a:off x="7095744" y="3712464"/>
-            <a:ext cx="210312" cy="0"/>
-          </a:xfrm>
-          <a:prstGeom prst="line">
-            <a:avLst/>
-          </a:prstGeom>
-          <a:noFill/>
-          <a:ln w="15875">
-            <a:solidFill>
-              <a:srgbClr val="202CFC"/>
-            </a:solidFill>
-            <a:prstDash val="solid"/>
-            <a:tailEnd type="triangle"/>
-          </a:ln>
-        </p:spPr>
-      </p:sp>
-      <p:sp>
-        <p:nvSpPr>
-          <p:cNvPr id="37" name="Shape 35"/>
-          <p:cNvSpPr/>
-          <p:nvPr/>
-        </p:nvSpPr>
-        <p:spPr>
-          <a:xfrm>
-            <a:off x="7360920" y="3337560"/>
-            <a:ext cx="1920240" cy="749808"/>
-          </a:xfrm>
-          <a:prstGeom prst="roundRect">
-            <a:avLst>
-              <a:gd name="adj" fmla="val 6098"/>
-            </a:avLst>
-          </a:prstGeom>
-          <a:solidFill>
-            <a:srgbClr val="FFFFFF"/>
-          </a:solidFill>
-          <a:ln w="12700">
-            <a:solidFill>
-              <a:srgbClr val="C9CCD8"/>
-            </a:solidFill>
-            <a:prstDash val="solid"/>
-          </a:ln>
-        </p:spPr>
-      </p:sp>
-      <p:sp>
-        <p:nvSpPr>
-          <p:cNvPr id="38" name="Text 36"/>
-          <p:cNvSpPr/>
-          <p:nvPr/>
-        </p:nvSpPr>
-        <p:spPr>
-          <a:xfrm>
-            <a:off x="7434072" y="3429000"/>
-            <a:ext cx="1773936" cy="256032"/>
+              <a:t>BIG</a:t>
+            </a:r>
+            <a:endParaRPr lang="en-US" sz="816" dirty="0"/>
+          </a:p>
+        </p:txBody>
+      </p:sp>
+      <p:sp>
+        <p:nvSpPr>
+          <p:cNvPr id="36" name="Text 34"/>
+          <p:cNvSpPr/>
+          <p:nvPr/>
+        </p:nvSpPr>
+        <p:spPr>
+          <a:xfrm>
+            <a:off x="1078992" y="6263640"/>
+            <a:ext cx="658368" cy="219456"/>
           </a:xfrm>
           <a:prstGeom prst="rect">
             <a:avLst/>
@@ -10978,11 +10917,11 @@
           <a:bodyPr wrap="square" lIns="0" tIns="0" rIns="0" bIns="0" rtlCol="0" anchor="ctr"/>
           <a:lstStyle/>
           <a:p>
-            <a:pPr algn="ctr" indent="0" marL="0">
-              <a:buNone/>
-            </a:pPr>
-            <a:r>
-              <a:rPr lang="en-US" sz="1050" b="1" dirty="0">
+            <a:pPr algn="l" indent="0" marL="0">
+              <a:buNone/>
+            </a:pPr>
+            <a:r>
+              <a:rPr lang="en-US" sz="816" dirty="0">
                 <a:solidFill>
                   <a:srgbClr val="1A1C2E"/>
                 </a:solidFill>
@@ -10990,1118 +10929,7 @@
                 <a:ea typeface="Arial" pitchFamily="34" charset="-122"/>
                 <a:cs typeface="Arial" pitchFamily="34" charset="-120"/>
               </a:rPr>
-              <a:t>Determinista</a:t>
-            </a:r>
-            <a:endParaRPr lang="en-US" sz="1050" dirty="0"/>
-          </a:p>
-        </p:txBody>
-      </p:sp>
-      <p:sp>
-        <p:nvSpPr>
-          <p:cNvPr id="39" name="Text 37"/>
-          <p:cNvSpPr/>
-          <p:nvPr/>
-        </p:nvSpPr>
-        <p:spPr>
-          <a:xfrm>
-            <a:off x="7434072" y="3685032"/>
-            <a:ext cx="1773936" cy="347472"/>
-          </a:xfrm>
-          <a:prstGeom prst="rect">
-            <a:avLst/>
-          </a:prstGeom>
-          <a:noFill/>
-          <a:ln/>
-        </p:spPr>
-        <p:txBody>
-          <a:bodyPr wrap="square" lIns="0" tIns="0" rIns="0" bIns="0" rtlCol="0" anchor="t"/>
-          <a:lstStyle/>
-          <a:p>
-            <a:pPr algn="ctr" indent="0" marL="0">
-              <a:lnSpc>
-                <a:spcPts val="1100"/>
-              </a:lnSpc>
-              <a:buNone/>
-            </a:pPr>
-            <a:r>
-              <a:rPr lang="en-US" sz="900" dirty="0">
-                <a:solidFill>
-                  <a:srgbClr val="5A5F73"/>
-                </a:solidFill>
-                <a:latin typeface="Calibri" pitchFamily="34" charset="0"/>
-                <a:ea typeface="Calibri" pitchFamily="34" charset="-122"/>
-                <a:cs typeface="Calibri" pitchFamily="34" charset="-120"/>
-              </a:rPr>
-              <a:t>severidad por regla,</a:t>
-            </a:r>
-            <a:endParaRPr lang="en-US" sz="900" dirty="0"/>
-          </a:p>
-          <a:p>
-            <a:pPr algn="ctr" indent="0" marL="0">
-              <a:lnSpc>
-                <a:spcPts val="1100"/>
-              </a:lnSpc>
-              <a:buNone/>
-            </a:pPr>
-            <a:r>
-              <a:rPr lang="en-US" sz="900" dirty="0">
-                <a:solidFill>
-                  <a:srgbClr val="5A5F73"/>
-                </a:solidFill>
-                <a:latin typeface="Calibri" pitchFamily="34" charset="0"/>
-                <a:ea typeface="Calibri" pitchFamily="34" charset="-122"/>
-                <a:cs typeface="Calibri" pitchFamily="34" charset="-120"/>
-              </a:rPr>
-              <a:t>sin IA</a:t>
-            </a:r>
-            <a:endParaRPr lang="en-US" sz="900" dirty="0"/>
-          </a:p>
-        </p:txBody>
-      </p:sp>
-      <p:sp>
-        <p:nvSpPr>
-          <p:cNvPr id="40" name="Shape 38"/>
-          <p:cNvSpPr/>
-          <p:nvPr/>
-        </p:nvSpPr>
-        <p:spPr>
-          <a:xfrm>
-            <a:off x="9336024" y="3712464"/>
-            <a:ext cx="210312" cy="0"/>
-          </a:xfrm>
-          <a:prstGeom prst="line">
-            <a:avLst/>
-          </a:prstGeom>
-          <a:noFill/>
-          <a:ln w="15875">
-            <a:solidFill>
-              <a:srgbClr val="202CFC"/>
-            </a:solidFill>
-            <a:prstDash val="solid"/>
-            <a:tailEnd type="triangle"/>
-          </a:ln>
-        </p:spPr>
-      </p:sp>
-      <p:sp>
-        <p:nvSpPr>
-          <p:cNvPr id="41" name="Shape 39"/>
-          <p:cNvSpPr/>
-          <p:nvPr/>
-        </p:nvSpPr>
-        <p:spPr>
-          <a:xfrm>
-            <a:off x="9601200" y="3337560"/>
-            <a:ext cx="1920240" cy="749808"/>
-          </a:xfrm>
-          <a:prstGeom prst="roundRect">
-            <a:avLst>
-              <a:gd name="adj" fmla="val 6098"/>
-            </a:avLst>
-          </a:prstGeom>
-          <a:solidFill>
-            <a:srgbClr val="FFFFFF"/>
-          </a:solidFill>
-          <a:ln w="12700">
-            <a:solidFill>
-              <a:srgbClr val="C9CCD8"/>
-            </a:solidFill>
-            <a:prstDash val="solid"/>
-          </a:ln>
-        </p:spPr>
-      </p:sp>
-      <p:sp>
-        <p:nvSpPr>
-          <p:cNvPr id="42" name="Text 40"/>
-          <p:cNvSpPr/>
-          <p:nvPr/>
-        </p:nvSpPr>
-        <p:spPr>
-          <a:xfrm>
-            <a:off x="9674352" y="3429000"/>
-            <a:ext cx="1773936" cy="256032"/>
-          </a:xfrm>
-          <a:prstGeom prst="rect">
-            <a:avLst/>
-          </a:prstGeom>
-          <a:noFill/>
-          <a:ln/>
-        </p:spPr>
-        <p:txBody>
-          <a:bodyPr wrap="square" lIns="0" tIns="0" rIns="0" bIns="0" rtlCol="0" anchor="ctr"/>
-          <a:lstStyle/>
-          <a:p>
-            <a:pPr algn="ctr" indent="0" marL="0">
-              <a:buNone/>
-            </a:pPr>
-            <a:r>
-              <a:rPr lang="en-US" sz="1050" b="1" dirty="0">
-                <a:solidFill>
-                  <a:srgbClr val="1A1C2E"/>
-                </a:solidFill>
-                <a:latin typeface="Arial" pitchFamily="34" charset="0"/>
-                <a:ea typeface="Arial" pitchFamily="34" charset="-122"/>
-                <a:cs typeface="Arial" pitchFamily="34" charset="-120"/>
-              </a:rPr>
-              <a:t>A la pantalla</a:t>
-            </a:r>
-            <a:endParaRPr lang="en-US" sz="1050" dirty="0"/>
-          </a:p>
-        </p:txBody>
-      </p:sp>
-      <p:sp>
-        <p:nvSpPr>
-          <p:cNvPr id="43" name="Text 41"/>
-          <p:cNvSpPr/>
-          <p:nvPr/>
-        </p:nvSpPr>
-        <p:spPr>
-          <a:xfrm>
-            <a:off x="9674352" y="3685032"/>
-            <a:ext cx="1773936" cy="347472"/>
-          </a:xfrm>
-          <a:prstGeom prst="rect">
-            <a:avLst/>
-          </a:prstGeom>
-          <a:noFill/>
-          <a:ln/>
-        </p:spPr>
-        <p:txBody>
-          <a:bodyPr wrap="square" lIns="0" tIns="0" rIns="0" bIns="0" rtlCol="0" anchor="t"/>
-          <a:lstStyle/>
-          <a:p>
-            <a:pPr algn="ctr" indent="0" marL="0">
-              <a:lnSpc>
-                <a:spcPts val="1100"/>
-              </a:lnSpc>
-              <a:buNone/>
-            </a:pPr>
-            <a:r>
-              <a:rPr lang="en-US" sz="900" dirty="0">
-                <a:solidFill>
-                  <a:srgbClr val="5A5F73"/>
-                </a:solidFill>
-                <a:latin typeface="Calibri" pitchFamily="34" charset="0"/>
-                <a:ea typeface="Calibri" pitchFamily="34" charset="-122"/>
-                <a:cs typeface="Calibri" pitchFamily="34" charset="-120"/>
-              </a:rPr>
-              <a:t>y a SQLite,</a:t>
-            </a:r>
-            <a:endParaRPr lang="en-US" sz="900" dirty="0"/>
-          </a:p>
-          <a:p>
-            <a:pPr algn="ctr" indent="0" marL="0">
-              <a:lnSpc>
-                <a:spcPts val="1100"/>
-              </a:lnSpc>
-              <a:buNone/>
-            </a:pPr>
-            <a:r>
-              <a:rPr lang="en-US" sz="900" dirty="0">
-                <a:solidFill>
-                  <a:srgbClr val="5A5F73"/>
-                </a:solidFill>
-                <a:latin typeface="Calibri" pitchFamily="34" charset="0"/>
-                <a:ea typeface="Calibri" pitchFamily="34" charset="-122"/>
-                <a:cs typeface="Calibri" pitchFamily="34" charset="-120"/>
-              </a:rPr>
-              <a:t>con la sesión</a:t>
-            </a:r>
-            <a:endParaRPr lang="en-US" sz="900" dirty="0"/>
-          </a:p>
-        </p:txBody>
-      </p:sp>
-      <p:sp>
-        <p:nvSpPr>
-          <p:cNvPr id="44" name="Text 42"/>
-          <p:cNvSpPr/>
-          <p:nvPr/>
-        </p:nvSpPr>
-        <p:spPr>
-          <a:xfrm>
-            <a:off x="640080" y="4398264"/>
-            <a:ext cx="10881360" cy="256032"/>
-          </a:xfrm>
-          <a:prstGeom prst="rect">
-            <a:avLst/>
-          </a:prstGeom>
-          <a:noFill/>
-          <a:ln/>
-        </p:spPr>
-        <p:txBody>
-          <a:bodyPr wrap="square" lIns="0" tIns="0" rIns="0" bIns="0" rtlCol="0" anchor="t"/>
-          <a:lstStyle/>
-          <a:p>
-            <a:pPr indent="0" marL="0">
-              <a:buNone/>
-            </a:pPr>
-            <a:r>
-              <a:rPr lang="en-US" sz="1100" b="1" spc="140" kern="0" dirty="0">
-                <a:solidFill>
-                  <a:srgbClr val="202CFC"/>
-                </a:solidFill>
-                <a:latin typeface="Calibri" pitchFamily="34" charset="0"/>
-                <a:ea typeface="Calibri" pitchFamily="34" charset="-122"/>
-                <a:cs typeface="Calibri" pitchFamily="34" charset="-120"/>
-              </a:rPr>
-              <a:t>3 · RAZONAR CON IA</a:t>
-            </a:r>
-            <a:endParaRPr lang="en-US" sz="1100" dirty="0"/>
-          </a:p>
-        </p:txBody>
-      </p:sp>
-      <p:sp>
-        <p:nvSpPr>
-          <p:cNvPr id="45" name="Shape 43"/>
-          <p:cNvSpPr/>
-          <p:nvPr/>
-        </p:nvSpPr>
-        <p:spPr>
-          <a:xfrm>
-            <a:off x="640080" y="4709160"/>
-            <a:ext cx="1920240" cy="749808"/>
-          </a:xfrm>
-          <a:prstGeom prst="roundRect">
-            <a:avLst>
-              <a:gd name="adj" fmla="val 6098"/>
-            </a:avLst>
-          </a:prstGeom>
-          <a:solidFill>
-            <a:srgbClr val="FFFFFF"/>
-          </a:solidFill>
-          <a:ln w="12700">
-            <a:solidFill>
-              <a:srgbClr val="C9CCD8"/>
-            </a:solidFill>
-            <a:prstDash val="solid"/>
-          </a:ln>
-        </p:spPr>
-      </p:sp>
-      <p:sp>
-        <p:nvSpPr>
-          <p:cNvPr id="46" name="Text 44"/>
-          <p:cNvSpPr/>
-          <p:nvPr/>
-        </p:nvSpPr>
-        <p:spPr>
-          <a:xfrm>
-            <a:off x="713232" y="4800600"/>
-            <a:ext cx="1773936" cy="256032"/>
-          </a:xfrm>
-          <a:prstGeom prst="rect">
-            <a:avLst/>
-          </a:prstGeom>
-          <a:noFill/>
-          <a:ln/>
-        </p:spPr>
-        <p:txBody>
-          <a:bodyPr wrap="square" lIns="0" tIns="0" rIns="0" bIns="0" rtlCol="0" anchor="ctr"/>
-          <a:lstStyle/>
-          <a:p>
-            <a:pPr algn="ctr" indent="0" marL="0">
-              <a:buNone/>
-            </a:pPr>
-            <a:r>
-              <a:rPr lang="en-US" sz="1050" b="1" dirty="0">
-                <a:solidFill>
-                  <a:srgbClr val="1A1C2E"/>
-                </a:solidFill>
-                <a:latin typeface="Arial" pitchFamily="34" charset="0"/>
-                <a:ea typeface="Arial" pitchFamily="34" charset="-122"/>
-                <a:cs typeface="Arial" pitchFamily="34" charset="-120"/>
-              </a:rPr>
-              <a:t>Casos parecidos</a:t>
-            </a:r>
-            <a:endParaRPr lang="en-US" sz="1050" dirty="0"/>
-          </a:p>
-        </p:txBody>
-      </p:sp>
-      <p:sp>
-        <p:nvSpPr>
-          <p:cNvPr id="47" name="Text 45"/>
-          <p:cNvSpPr/>
-          <p:nvPr/>
-        </p:nvSpPr>
-        <p:spPr>
-          <a:xfrm>
-            <a:off x="713232" y="5056632"/>
-            <a:ext cx="1773936" cy="347472"/>
-          </a:xfrm>
-          <a:prstGeom prst="rect">
-            <a:avLst/>
-          </a:prstGeom>
-          <a:noFill/>
-          <a:ln/>
-        </p:spPr>
-        <p:txBody>
-          <a:bodyPr wrap="square" lIns="0" tIns="0" rIns="0" bIns="0" rtlCol="0" anchor="t"/>
-          <a:lstStyle/>
-          <a:p>
-            <a:pPr algn="ctr" indent="0" marL="0">
-              <a:lnSpc>
-                <a:spcPts val="1100"/>
-              </a:lnSpc>
-              <a:buNone/>
-            </a:pPr>
-            <a:r>
-              <a:rPr lang="en-US" sz="900" dirty="0">
-                <a:solidFill>
-                  <a:srgbClr val="5A5F73"/>
-                </a:solidFill>
-                <a:latin typeface="Calibri" pitchFamily="34" charset="0"/>
-                <a:ea typeface="Calibri" pitchFamily="34" charset="-122"/>
-                <a:cs typeface="Calibri" pitchFamily="34" charset="-120"/>
-              </a:rPr>
-              <a:t>búsqueda vectorial</a:t>
-            </a:r>
-            <a:endParaRPr lang="en-US" sz="900" dirty="0"/>
-          </a:p>
-          <a:p>
-            <a:pPr algn="ctr" indent="0" marL="0">
-              <a:lnSpc>
-                <a:spcPts val="1100"/>
-              </a:lnSpc>
-              <a:buNone/>
-            </a:pPr>
-            <a:r>
-              <a:rPr lang="en-US" sz="900" dirty="0">
-                <a:solidFill>
-                  <a:srgbClr val="5A5F73"/>
-                </a:solidFill>
-                <a:latin typeface="Calibri" pitchFamily="34" charset="0"/>
-                <a:ea typeface="Calibri" pitchFamily="34" charset="-122"/>
-                <a:cs typeface="Calibri" pitchFamily="34" charset="-120"/>
-              </a:rPr>
-              <a:t>en LanceDB</a:t>
-            </a:r>
-            <a:endParaRPr lang="en-US" sz="900" dirty="0"/>
-          </a:p>
-        </p:txBody>
-      </p:sp>
-      <p:sp>
-        <p:nvSpPr>
-          <p:cNvPr id="48" name="Shape 46"/>
-          <p:cNvSpPr/>
-          <p:nvPr/>
-        </p:nvSpPr>
-        <p:spPr>
-          <a:xfrm>
-            <a:off x="2615184" y="5084064"/>
-            <a:ext cx="210312" cy="0"/>
-          </a:xfrm>
-          <a:prstGeom prst="line">
-            <a:avLst/>
-          </a:prstGeom>
-          <a:noFill/>
-          <a:ln w="15875">
-            <a:solidFill>
-              <a:srgbClr val="202CFC"/>
-            </a:solidFill>
-            <a:prstDash val="solid"/>
-            <a:tailEnd type="triangle"/>
-          </a:ln>
-        </p:spPr>
-      </p:sp>
-      <p:sp>
-        <p:nvSpPr>
-          <p:cNvPr id="49" name="Shape 47"/>
-          <p:cNvSpPr/>
-          <p:nvPr/>
-        </p:nvSpPr>
-        <p:spPr>
-          <a:xfrm>
-            <a:off x="2880360" y="4709160"/>
-            <a:ext cx="1920240" cy="749808"/>
-          </a:xfrm>
-          <a:prstGeom prst="roundRect">
-            <a:avLst>
-              <a:gd name="adj" fmla="val 6098"/>
-            </a:avLst>
-          </a:prstGeom>
-          <a:solidFill>
-            <a:srgbClr val="FFFFFF"/>
-          </a:solidFill>
-          <a:ln w="12700">
-            <a:solidFill>
-              <a:srgbClr val="C9CCD8"/>
-            </a:solidFill>
-            <a:prstDash val="solid"/>
-          </a:ln>
-        </p:spPr>
-      </p:sp>
-      <p:sp>
-        <p:nvSpPr>
-          <p:cNvPr id="50" name="Text 48"/>
-          <p:cNvSpPr/>
-          <p:nvPr/>
-        </p:nvSpPr>
-        <p:spPr>
-          <a:xfrm>
-            <a:off x="2953512" y="4800600"/>
-            <a:ext cx="1773936" cy="256032"/>
-          </a:xfrm>
-          <a:prstGeom prst="rect">
-            <a:avLst/>
-          </a:prstGeom>
-          <a:noFill/>
-          <a:ln/>
-        </p:spPr>
-        <p:txBody>
-          <a:bodyPr wrap="square" lIns="0" tIns="0" rIns="0" bIns="0" rtlCol="0" anchor="ctr"/>
-          <a:lstStyle/>
-          <a:p>
-            <a:pPr algn="ctr" indent="0" marL="0">
-              <a:buNone/>
-            </a:pPr>
-            <a:r>
-              <a:rPr lang="en-US" sz="1050" b="1" dirty="0">
-                <a:solidFill>
-                  <a:srgbClr val="1A1C2E"/>
-                </a:solidFill>
-                <a:latin typeface="Arial" pitchFamily="34" charset="0"/>
-                <a:ea typeface="Arial" pitchFamily="34" charset="-122"/>
-                <a:cs typeface="Arial" pitchFamily="34" charset="-120"/>
-              </a:rPr>
-              <a:t>El agente</a:t>
-            </a:r>
-            <a:endParaRPr lang="en-US" sz="1050" dirty="0"/>
-          </a:p>
-        </p:txBody>
-      </p:sp>
-      <p:sp>
-        <p:nvSpPr>
-          <p:cNvPr id="51" name="Text 49"/>
-          <p:cNvSpPr/>
-          <p:nvPr/>
-        </p:nvSpPr>
-        <p:spPr>
-          <a:xfrm>
-            <a:off x="2953512" y="5056632"/>
-            <a:ext cx="1773936" cy="347472"/>
-          </a:xfrm>
-          <a:prstGeom prst="rect">
-            <a:avLst/>
-          </a:prstGeom>
-          <a:noFill/>
-          <a:ln/>
-        </p:spPr>
-        <p:txBody>
-          <a:bodyPr wrap="square" lIns="0" tIns="0" rIns="0" bIns="0" rtlCol="0" anchor="t"/>
-          <a:lstStyle/>
-          <a:p>
-            <a:pPr algn="ctr" indent="0" marL="0">
-              <a:lnSpc>
-                <a:spcPts val="1100"/>
-              </a:lnSpc>
-              <a:buNone/>
-            </a:pPr>
-            <a:r>
-              <a:rPr lang="en-US" sz="900" dirty="0">
-                <a:solidFill>
-                  <a:srgbClr val="5A5F73"/>
-                </a:solidFill>
-                <a:latin typeface="Calibri" pitchFamily="34" charset="0"/>
-                <a:ea typeface="Calibri" pitchFamily="34" charset="-122"/>
-                <a:cs typeface="Calibri" pitchFamily="34" charset="-120"/>
-              </a:rPr>
-              <a:t>16 herramientas MCP</a:t>
-            </a:r>
-            <a:endParaRPr lang="en-US" sz="900" dirty="0"/>
-          </a:p>
-          <a:p>
-            <a:pPr algn="ctr" indent="0" marL="0">
-              <a:lnSpc>
-                <a:spcPts val="1100"/>
-              </a:lnSpc>
-              <a:buNone/>
-            </a:pPr>
-            <a:r>
-              <a:rPr lang="en-US" sz="900" dirty="0">
-                <a:solidFill>
-                  <a:srgbClr val="5A5F73"/>
-                </a:solidFill>
-                <a:latin typeface="Calibri" pitchFamily="34" charset="0"/>
-                <a:ea typeface="Calibri" pitchFamily="34" charset="-122"/>
-                <a:cs typeface="Calibri" pitchFamily="34" charset="-120"/>
-              </a:rPr>
-              <a:t>+ el modelo</a:t>
-            </a:r>
-            <a:endParaRPr lang="en-US" sz="900" dirty="0"/>
-          </a:p>
-        </p:txBody>
-      </p:sp>
-      <p:sp>
-        <p:nvSpPr>
-          <p:cNvPr id="52" name="Shape 50"/>
-          <p:cNvSpPr/>
-          <p:nvPr/>
-        </p:nvSpPr>
-        <p:spPr>
-          <a:xfrm>
-            <a:off x="4855464" y="5084064"/>
-            <a:ext cx="210312" cy="0"/>
-          </a:xfrm>
-          <a:prstGeom prst="line">
-            <a:avLst/>
-          </a:prstGeom>
-          <a:noFill/>
-          <a:ln w="15875">
-            <a:solidFill>
-              <a:srgbClr val="202CFC"/>
-            </a:solidFill>
-            <a:prstDash val="solid"/>
-            <a:tailEnd type="triangle"/>
-          </a:ln>
-        </p:spPr>
-      </p:sp>
-      <p:sp>
-        <p:nvSpPr>
-          <p:cNvPr id="53" name="Shape 51"/>
-          <p:cNvSpPr/>
-          <p:nvPr/>
-        </p:nvSpPr>
-        <p:spPr>
-          <a:xfrm>
-            <a:off x="5120640" y="4709160"/>
-            <a:ext cx="1920240" cy="749808"/>
-          </a:xfrm>
-          <a:prstGeom prst="roundRect">
-            <a:avLst>
-              <a:gd name="adj" fmla="val 6098"/>
-            </a:avLst>
-          </a:prstGeom>
-          <a:solidFill>
-            <a:srgbClr val="FFFFFF"/>
-          </a:solidFill>
-          <a:ln w="12700">
-            <a:solidFill>
-              <a:srgbClr val="C9CCD8"/>
-            </a:solidFill>
-            <a:prstDash val="solid"/>
-          </a:ln>
-        </p:spPr>
-      </p:sp>
-      <p:sp>
-        <p:nvSpPr>
-          <p:cNvPr id="54" name="Text 52"/>
-          <p:cNvSpPr/>
-          <p:nvPr/>
-        </p:nvSpPr>
-        <p:spPr>
-          <a:xfrm>
-            <a:off x="5193792" y="4800600"/>
-            <a:ext cx="1773936" cy="256032"/>
-          </a:xfrm>
-          <a:prstGeom prst="rect">
-            <a:avLst/>
-          </a:prstGeom>
-          <a:noFill/>
-          <a:ln/>
-        </p:spPr>
-        <p:txBody>
-          <a:bodyPr wrap="square" lIns="0" tIns="0" rIns="0" bIns="0" rtlCol="0" anchor="ctr"/>
-          <a:lstStyle/>
-          <a:p>
-            <a:pPr algn="ctr" indent="0" marL="0">
-              <a:buNone/>
-            </a:pPr>
-            <a:r>
-              <a:rPr lang="en-US" sz="1050" b="1" dirty="0">
-                <a:solidFill>
-                  <a:srgbClr val="1A1C2E"/>
-                </a:solidFill>
-                <a:latin typeface="Arial" pitchFamily="34" charset="0"/>
-                <a:ea typeface="Arial" pitchFamily="34" charset="-122"/>
-                <a:cs typeface="Arial" pitchFamily="34" charset="-120"/>
-              </a:rPr>
-              <a:t>Busca lo que falta</a:t>
-            </a:r>
-            <a:endParaRPr lang="en-US" sz="1050" dirty="0"/>
-          </a:p>
-        </p:txBody>
-      </p:sp>
-      <p:sp>
-        <p:nvSpPr>
-          <p:cNvPr id="55" name="Text 53"/>
-          <p:cNvSpPr/>
-          <p:nvPr/>
-        </p:nvSpPr>
-        <p:spPr>
-          <a:xfrm>
-            <a:off x="5193792" y="5056632"/>
-            <a:ext cx="1773936" cy="347472"/>
-          </a:xfrm>
-          <a:prstGeom prst="rect">
-            <a:avLst/>
-          </a:prstGeom>
-          <a:noFill/>
-          <a:ln/>
-        </p:spPr>
-        <p:txBody>
-          <a:bodyPr wrap="square" lIns="0" tIns="0" rIns="0" bIns="0" rtlCol="0" anchor="t"/>
-          <a:lstStyle/>
-          <a:p>
-            <a:pPr algn="ctr" indent="0" marL="0">
-              <a:lnSpc>
-                <a:spcPts val="1100"/>
-              </a:lnSpc>
-              <a:buNone/>
-            </a:pPr>
-            <a:r>
-              <a:rPr lang="en-US" sz="900" dirty="0">
-                <a:solidFill>
-                  <a:srgbClr val="5A5F73"/>
-                </a:solidFill>
-                <a:latin typeface="Calibri" pitchFamily="34" charset="0"/>
-                <a:ea typeface="Calibri" pitchFamily="34" charset="-122"/>
-                <a:cs typeface="Calibri" pitchFamily="34" charset="-120"/>
-              </a:rPr>
-              <a:t>catálogo, el coche</a:t>
-            </a:r>
-            <a:endParaRPr lang="en-US" sz="900" dirty="0"/>
-          </a:p>
-          <a:p>
-            <a:pPr algn="ctr" indent="0" marL="0">
-              <a:lnSpc>
-                <a:spcPts val="1100"/>
-              </a:lnSpc>
-              <a:buNone/>
-            </a:pPr>
-            <a:r>
-              <a:rPr lang="en-US" sz="900" dirty="0">
-                <a:solidFill>
-                  <a:srgbClr val="5A5F73"/>
-                </a:solidFill>
-                <a:latin typeface="Calibri" pitchFamily="34" charset="0"/>
-                <a:ea typeface="Calibri" pitchFamily="34" charset="-122"/>
-                <a:cs typeface="Calibri" pitchFamily="34" charset="-120"/>
-              </a:rPr>
-              <a:t>o la web</a:t>
-            </a:r>
-            <a:endParaRPr lang="en-US" sz="900" dirty="0"/>
-          </a:p>
-        </p:txBody>
-      </p:sp>
-      <p:sp>
-        <p:nvSpPr>
-          <p:cNvPr id="56" name="Shape 54"/>
-          <p:cNvSpPr/>
-          <p:nvPr/>
-        </p:nvSpPr>
-        <p:spPr>
-          <a:xfrm>
-            <a:off x="7095744" y="5084064"/>
-            <a:ext cx="210312" cy="0"/>
-          </a:xfrm>
-          <a:prstGeom prst="line">
-            <a:avLst/>
-          </a:prstGeom>
-          <a:noFill/>
-          <a:ln w="15875">
-            <a:solidFill>
-              <a:srgbClr val="202CFC"/>
-            </a:solidFill>
-            <a:prstDash val="solid"/>
-            <a:tailEnd type="triangle"/>
-          </a:ln>
-        </p:spPr>
-      </p:sp>
-      <p:sp>
-        <p:nvSpPr>
-          <p:cNvPr id="57" name="Shape 55"/>
-          <p:cNvSpPr/>
-          <p:nvPr/>
-        </p:nvSpPr>
-        <p:spPr>
-          <a:xfrm>
-            <a:off x="7360920" y="4709160"/>
-            <a:ext cx="1920240" cy="749808"/>
-          </a:xfrm>
-          <a:prstGeom prst="roundRect">
-            <a:avLst>
-              <a:gd name="adj" fmla="val 6098"/>
-            </a:avLst>
-          </a:prstGeom>
-          <a:solidFill>
-            <a:srgbClr val="FFFFFF"/>
-          </a:solidFill>
-          <a:ln w="12700">
-            <a:solidFill>
-              <a:srgbClr val="C9CCD8"/>
-            </a:solidFill>
-            <a:prstDash val="solid"/>
-          </a:ln>
-        </p:spPr>
-      </p:sp>
-      <p:sp>
-        <p:nvSpPr>
-          <p:cNvPr id="58" name="Text 56"/>
-          <p:cNvSpPr/>
-          <p:nvPr/>
-        </p:nvSpPr>
-        <p:spPr>
-          <a:xfrm>
-            <a:off x="7434072" y="4800600"/>
-            <a:ext cx="1773936" cy="256032"/>
-          </a:xfrm>
-          <a:prstGeom prst="rect">
-            <a:avLst/>
-          </a:prstGeom>
-          <a:noFill/>
-          <a:ln/>
-        </p:spPr>
-        <p:txBody>
-          <a:bodyPr wrap="square" lIns="0" tIns="0" rIns="0" bIns="0" rtlCol="0" anchor="ctr"/>
-          <a:lstStyle/>
-          <a:p>
-            <a:pPr algn="ctr" indent="0" marL="0">
-              <a:buNone/>
-            </a:pPr>
-            <a:r>
-              <a:rPr lang="en-US" sz="1050" b="1" dirty="0">
-                <a:solidFill>
-                  <a:srgbClr val="1A1C2E"/>
-                </a:solidFill>
-                <a:latin typeface="Arial" pitchFamily="34" charset="0"/>
-                <a:ea typeface="Arial" pitchFamily="34" charset="-122"/>
-                <a:cs typeface="Arial" pitchFamily="34" charset="-120"/>
-              </a:rPr>
-              <a:t>Informe</a:t>
-            </a:r>
-            <a:endParaRPr lang="en-US" sz="1050" dirty="0"/>
-          </a:p>
-        </p:txBody>
-      </p:sp>
-      <p:sp>
-        <p:nvSpPr>
-          <p:cNvPr id="59" name="Text 57"/>
-          <p:cNvSpPr/>
-          <p:nvPr/>
-        </p:nvSpPr>
-        <p:spPr>
-          <a:xfrm>
-            <a:off x="7434072" y="5056632"/>
-            <a:ext cx="1773936" cy="347472"/>
-          </a:xfrm>
-          <a:prstGeom prst="rect">
-            <a:avLst/>
-          </a:prstGeom>
-          <a:noFill/>
-          <a:ln/>
-        </p:spPr>
-        <p:txBody>
-          <a:bodyPr wrap="square" lIns="0" tIns="0" rIns="0" bIns="0" rtlCol="0" anchor="t"/>
-          <a:lstStyle/>
-          <a:p>
-            <a:pPr algn="ctr" indent="0" marL="0">
-              <a:lnSpc>
-                <a:spcPts val="1100"/>
-              </a:lnSpc>
-              <a:buNone/>
-            </a:pPr>
-            <a:r>
-              <a:rPr lang="en-US" sz="900" dirty="0">
-                <a:solidFill>
-                  <a:srgbClr val="5A5F73"/>
-                </a:solidFill>
-                <a:latin typeface="Calibri" pitchFamily="34" charset="0"/>
-                <a:ea typeface="Calibri" pitchFamily="34" charset="-122"/>
-                <a:cs typeface="Calibri" pitchFamily="34" charset="-120"/>
-              </a:rPr>
-              <a:t>narrativa, severidad</a:t>
-            </a:r>
-            <a:endParaRPr lang="en-US" sz="900" dirty="0"/>
-          </a:p>
-          <a:p>
-            <a:pPr algn="ctr" indent="0" marL="0">
-              <a:lnSpc>
-                <a:spcPts val="1100"/>
-              </a:lnSpc>
-              <a:buNone/>
-            </a:pPr>
-            <a:r>
-              <a:rPr lang="en-US" sz="900" dirty="0">
-                <a:solidFill>
-                  <a:srgbClr val="5A5F73"/>
-                </a:solidFill>
-                <a:latin typeface="Calibri" pitchFamily="34" charset="0"/>
-                <a:ea typeface="Calibri" pitchFamily="34" charset="-122"/>
-                <a:cs typeface="Calibri" pitchFamily="34" charset="-120"/>
-              </a:rPr>
-              <a:t>y recomendaciones</a:t>
-            </a:r>
-            <a:endParaRPr lang="en-US" sz="900" dirty="0"/>
-          </a:p>
-        </p:txBody>
-      </p:sp>
-      <p:sp>
-        <p:nvSpPr>
-          <p:cNvPr id="60" name="Shape 58"/>
-          <p:cNvSpPr/>
-          <p:nvPr/>
-        </p:nvSpPr>
-        <p:spPr>
-          <a:xfrm>
-            <a:off x="9336024" y="5084064"/>
-            <a:ext cx="210312" cy="0"/>
-          </a:xfrm>
-          <a:prstGeom prst="line">
-            <a:avLst/>
-          </a:prstGeom>
-          <a:noFill/>
-          <a:ln w="15875">
-            <a:solidFill>
-              <a:srgbClr val="202CFC"/>
-            </a:solidFill>
-            <a:prstDash val="solid"/>
-            <a:tailEnd type="triangle"/>
-          </a:ln>
-        </p:spPr>
-      </p:sp>
-      <p:sp>
-        <p:nvSpPr>
-          <p:cNvPr id="61" name="Shape 59"/>
-          <p:cNvSpPr/>
-          <p:nvPr/>
-        </p:nvSpPr>
-        <p:spPr>
-          <a:xfrm>
-            <a:off x="9601200" y="4709160"/>
-            <a:ext cx="1920240" cy="749808"/>
-          </a:xfrm>
-          <a:prstGeom prst="roundRect">
-            <a:avLst>
-              <a:gd name="adj" fmla="val 6098"/>
-            </a:avLst>
-          </a:prstGeom>
-          <a:solidFill>
-            <a:srgbClr val="FFFFFF"/>
-          </a:solidFill>
-          <a:ln w="12700">
-            <a:solidFill>
-              <a:srgbClr val="C9CCD8"/>
-            </a:solidFill>
-            <a:prstDash val="solid"/>
-          </a:ln>
-        </p:spPr>
-      </p:sp>
-      <p:sp>
-        <p:nvSpPr>
-          <p:cNvPr id="62" name="Text 60"/>
-          <p:cNvSpPr/>
-          <p:nvPr/>
-        </p:nvSpPr>
-        <p:spPr>
-          <a:xfrm>
-            <a:off x="9674352" y="4800600"/>
-            <a:ext cx="1773936" cy="256032"/>
-          </a:xfrm>
-          <a:prstGeom prst="rect">
-            <a:avLst/>
-          </a:prstGeom>
-          <a:noFill/>
-          <a:ln/>
-        </p:spPr>
-        <p:txBody>
-          <a:bodyPr wrap="square" lIns="0" tIns="0" rIns="0" bIns="0" rtlCol="0" anchor="ctr"/>
-          <a:lstStyle/>
-          <a:p>
-            <a:pPr algn="ctr" indent="0" marL="0">
-              <a:buNone/>
-            </a:pPr>
-            <a:r>
-              <a:rPr lang="en-US" sz="1050" b="1" dirty="0">
-                <a:solidFill>
-                  <a:srgbClr val="1A1C2E"/>
-                </a:solidFill>
-                <a:latin typeface="Arial" pitchFamily="34" charset="0"/>
-                <a:ea typeface="Arial" pitchFamily="34" charset="-122"/>
-                <a:cs typeface="Arial" pitchFamily="34" charset="-120"/>
-              </a:rPr>
-              <a:t>Se indexa</a:t>
-            </a:r>
-            <a:endParaRPr lang="en-US" sz="1050" dirty="0"/>
-          </a:p>
-        </p:txBody>
-      </p:sp>
-      <p:sp>
-        <p:nvSpPr>
-          <p:cNvPr id="63" name="Text 61"/>
-          <p:cNvSpPr/>
-          <p:nvPr/>
-        </p:nvSpPr>
-        <p:spPr>
-          <a:xfrm>
-            <a:off x="9674352" y="5056632"/>
-            <a:ext cx="1773936" cy="347472"/>
-          </a:xfrm>
-          <a:prstGeom prst="rect">
-            <a:avLst/>
-          </a:prstGeom>
-          <a:noFill/>
-          <a:ln/>
-        </p:spPr>
-        <p:txBody>
-          <a:bodyPr wrap="square" lIns="0" tIns="0" rIns="0" bIns="0" rtlCol="0" anchor="t"/>
-          <a:lstStyle/>
-          <a:p>
-            <a:pPr algn="ctr" indent="0" marL="0">
-              <a:lnSpc>
-                <a:spcPts val="1100"/>
-              </a:lnSpc>
-              <a:buNone/>
-            </a:pPr>
-            <a:r>
-              <a:rPr lang="en-US" sz="900" dirty="0">
-                <a:solidFill>
-                  <a:srgbClr val="5A5F73"/>
-                </a:solidFill>
-                <a:latin typeface="Calibri" pitchFamily="34" charset="0"/>
-                <a:ea typeface="Calibri" pitchFamily="34" charset="-122"/>
-                <a:cs typeface="Calibri" pitchFamily="34" charset="-120"/>
-              </a:rPr>
-              <a:t>el caso vuelve</a:t>
-            </a:r>
-            <a:endParaRPr lang="en-US" sz="900" dirty="0"/>
-          </a:p>
-          <a:p>
-            <a:pPr algn="ctr" indent="0" marL="0">
-              <a:lnSpc>
-                <a:spcPts val="1100"/>
-              </a:lnSpc>
-              <a:buNone/>
-            </a:pPr>
-            <a:r>
-              <a:rPr lang="en-US" sz="900" dirty="0">
-                <a:solidFill>
-                  <a:srgbClr val="5A5F73"/>
-                </a:solidFill>
-                <a:latin typeface="Calibri" pitchFamily="34" charset="0"/>
-                <a:ea typeface="Calibri" pitchFamily="34" charset="-122"/>
-                <a:cs typeface="Calibri" pitchFamily="34" charset="-120"/>
-              </a:rPr>
-              <a:t>al catálogo</a:t>
-            </a:r>
-            <a:endParaRPr lang="en-US" sz="900" dirty="0"/>
-          </a:p>
-        </p:txBody>
-      </p:sp>
-      <p:sp>
-        <p:nvSpPr>
-          <p:cNvPr id="64" name="Shape 62"/>
-          <p:cNvSpPr/>
-          <p:nvPr/>
-        </p:nvSpPr>
-        <p:spPr>
-          <a:xfrm>
-            <a:off x="1600200" y="5779008"/>
-            <a:ext cx="8961120" cy="0"/>
-          </a:xfrm>
-          <a:prstGeom prst="line">
-            <a:avLst/>
-          </a:prstGeom>
-          <a:noFill/>
-          <a:ln w="12700">
-            <a:solidFill>
-              <a:srgbClr val="C9CCD8"/>
-            </a:solidFill>
-            <a:prstDash val="dash"/>
-            <a:headEnd type="triangle"/>
-          </a:ln>
-        </p:spPr>
-      </p:sp>
-      <p:sp>
-        <p:nvSpPr>
-          <p:cNvPr id="65" name="Text 63"/>
-          <p:cNvSpPr/>
-          <p:nvPr/>
-        </p:nvSpPr>
-        <p:spPr>
-          <a:xfrm>
-            <a:off x="640080" y="5833872"/>
-            <a:ext cx="10881360" cy="256032"/>
-          </a:xfrm>
-          <a:prstGeom prst="rect">
-            <a:avLst/>
-          </a:prstGeom>
-          <a:noFill/>
-          <a:ln/>
-        </p:spPr>
-        <p:txBody>
-          <a:bodyPr wrap="square" lIns="0" tIns="0" rIns="0" bIns="0" rtlCol="0" anchor="ctr"/>
-          <a:lstStyle/>
-          <a:p>
-            <a:pPr algn="ctr" indent="0" marL="0">
-              <a:buNone/>
-            </a:pPr>
-            <a:r>
-              <a:rPr lang="en-US" sz="1000" i="1" dirty="0">
-                <a:solidFill>
-                  <a:srgbClr val="5A5F73"/>
-                </a:solidFill>
-                <a:latin typeface="Calibri" pitchFamily="34" charset="0"/>
-                <a:ea typeface="Calibri" pitchFamily="34" charset="-122"/>
-                <a:cs typeface="Calibri" pitchFamily="34" charset="-120"/>
-              </a:rPr>
-              <a:t>lo aprendido alimenta el siguiente diagnóstico</a:t>
-            </a:r>
-            <a:endParaRPr lang="en-US" sz="1000" dirty="0"/>
-          </a:p>
-        </p:txBody>
-      </p:sp>
-      <p:sp>
-        <p:nvSpPr>
-          <p:cNvPr id="66" name="Shape 64"/>
-          <p:cNvSpPr/>
-          <p:nvPr/>
-        </p:nvSpPr>
-        <p:spPr>
-          <a:xfrm>
-            <a:off x="777240" y="6263640"/>
-            <a:ext cx="219456" cy="219456"/>
-          </a:xfrm>
-          <a:prstGeom prst="rect">
-            <a:avLst/>
-          </a:prstGeom>
-          <a:solidFill>
-            <a:srgbClr val="202CFC"/>
-          </a:solidFill>
-          <a:ln/>
-        </p:spPr>
-      </p:sp>
-      <p:sp>
-        <p:nvSpPr>
-          <p:cNvPr id="67" name="Text 65"/>
-          <p:cNvSpPr/>
-          <p:nvPr/>
-        </p:nvSpPr>
-        <p:spPr>
-          <a:xfrm>
-            <a:off x="777240" y="6263640"/>
-            <a:ext cx="219456" cy="219456"/>
-          </a:xfrm>
-          <a:prstGeom prst="rect">
-            <a:avLst/>
-          </a:prstGeom>
-          <a:noFill/>
-          <a:ln/>
-        </p:spPr>
-        <p:txBody>
-          <a:bodyPr wrap="square" lIns="0" tIns="0" rIns="0" bIns="0" rtlCol="0" anchor="ctr"/>
-          <a:lstStyle/>
-          <a:p>
-            <a:pPr algn="ctr" indent="0" marL="0">
-              <a:buNone/>
-            </a:pPr>
-            <a:r>
-              <a:rPr lang="en-US" sz="816" b="1" dirty="0">
-                <a:solidFill>
-                  <a:srgbClr val="FFFFFF"/>
-                </a:solidFill>
-                <a:latin typeface="Arial" pitchFamily="34" charset="0"/>
-                <a:ea typeface="Arial" pitchFamily="34" charset="-122"/>
-                <a:cs typeface="Arial" pitchFamily="34" charset="-120"/>
-              </a:rPr>
-              <a:t>BIG</a:t>
+              <a:t>school</a:t>
             </a:r>
             <a:endParaRPr lang="en-US" sz="816" dirty="0"/>
           </a:p>
@@ -12109,46 +10937,7 @@
       </p:sp>
       <p:sp>
         <p:nvSpPr>
-          <p:cNvPr id="68" name="Text 66"/>
-          <p:cNvSpPr/>
-          <p:nvPr/>
-        </p:nvSpPr>
-        <p:spPr>
-          <a:xfrm>
-            <a:off x="1078992" y="6263640"/>
-            <a:ext cx="658368" cy="219456"/>
-          </a:xfrm>
-          <a:prstGeom prst="rect">
-            <a:avLst/>
-          </a:prstGeom>
-          <a:noFill/>
-          <a:ln/>
-        </p:spPr>
-        <p:txBody>
-          <a:bodyPr wrap="square" lIns="0" tIns="0" rIns="0" bIns="0" rtlCol="0" anchor="ctr"/>
-          <a:lstStyle/>
-          <a:p>
-            <a:pPr algn="l" indent="0" marL="0">
-              <a:buNone/>
-            </a:pPr>
-            <a:r>
-              <a:rPr lang="en-US" sz="816" dirty="0">
-                <a:solidFill>
-                  <a:srgbClr val="1A1C2E"/>
-                </a:solidFill>
-                <a:latin typeface="Arial" pitchFamily="34" charset="0"/>
-                <a:ea typeface="Arial" pitchFamily="34" charset="-122"/>
-                <a:cs typeface="Arial" pitchFamily="34" charset="-120"/>
-              </a:rPr>
-              <a:t>school</a:t>
-            </a:r>
-            <a:endParaRPr lang="en-US" sz="816" dirty="0"/>
-          </a:p>
-        </p:txBody>
-      </p:sp>
-      <p:sp>
-        <p:nvSpPr>
-          <p:cNvPr id="69" name="Text 67"/>
+          <p:cNvPr id="37" name="Text 35"/>
           <p:cNvSpPr/>
           <p:nvPr/>
         </p:nvSpPr>

</xml_diff>

<commit_message>
docs(tfm): anadir el punto fisico de conexion al diagrama
</commit_message>
<xml_diff>
--- a/docs/presentacion/tfm-intelligent-automotive-diagnostics.pptx
+++ b/docs/presentacion/tfm-intelligent-automotive-diagnostics.pptx
@@ -1627,13 +1627,13 @@
           <a:p>
             <a:r>
               <a:rPr lang="en-US" dirty="0"/>
-              <a:t>Esta es la foto entera. Lo importante no es la lista de piezas, es quién llama a quién.
-Arriba el mecánico, con la interfaz en React y su sesión. Habla con la API, y las flechas son de ida y vuelta porque son peticiones y respuestas.
-En el centro, en oscuro, está el núcleo: los casos de uso y el dominio. Ahí viven las fórmulas de la SAE J1979, los catálogos y la decodificación del VIN. Ese bloque no sabe nada de lo que hay debajo.
-Debajo, los tres adaptadores. El transporte OBD, que habla con el ELM327 por puerto serie o por TCP y negocia el protocolo del bus. La persistencia, con SQLite para lo relacional y LanceDB para lo vectorial. Y el servidor MCP, que expone las dieciséis herramientas.
-Y abajo del todo, lo que hay al otro lado: el coche, con su bus CAN, o uno de los tres emuladores; y el modelo, Anthropic u OpenAI, más la búsqueda web.
-Fijaos en las flechas discontinuas del centro, que son lo que hace que esto sea un sistema y no una tubería: cuando el agente pide una herramienta, esa herramienta vuelve a entrar por los mismos adaptadores. Lee el coche por el mismo transporte y escribe en el mismo catálogo. No hay una puerta trasera para la IA.
-[~75 s · acumulado 2:55]</a:t>
+              <a:t>Esta es la foto entera, de abajo a arriba.
+Abajo del todo, el coche de verdad: su bus CAN y las centralitas. Encima, el punto donde esto se conecta al mundo físico, que es el dongle ELM327 enchufado al conector OBD-II del coche, ese que está debajo del volante. Se une al portátil por USB o por WiFi. Los dos van en azul porque son las dos únicas piezas que no son código mío.
+De ahí para arriba ya es software. El transporte OBD abre el puerto serie o el socket, negocia el protocolo del bus y traduce comandos. La persistencia guarda lo relacional en SQLite y lo vectorial en LanceDB. Y el servidor MCP expone las dieciséis herramientas al modelo, que está a la derecha.
+En el centro, en oscuro, el núcleo: los casos de uso y el dominio, con las fórmulas de la norma y los catálogos. Ese bloque no sabe nada de lo que hay debajo. Y arriba el mecánico, con la interfaz.
+Dos detalles. Las flechas son de ida y vuelta porque todo son peticiones y respuestas. Y las discontinuas del centro son lo que hace que esto sea un sistema y no una tubería: cuando el agente pide una herramienta, vuelve a entrar por los mismos adaptadores. Lee el coche por el mismo transporte y escribe en el mismo catálogo. No hay puerta trasera para la IA.
+Para la demo de hoy, el tramo físico se sustituye por tres emuladores ELM327 escuchando en tres puertos TCP. Todo lo de arriba es idéntico.
+[~80 s · acumulado 3:00]</a:t>
             </a:r>
             <a:endParaRPr lang="en-US" dirty="0"/>
           </a:p>
@@ -9671,8 +9671,8 @@
         </p:nvSpPr>
         <p:spPr>
           <a:xfrm>
-            <a:off x="640080" y="411480"/>
-            <a:ext cx="10881360" cy="640080"/>
+            <a:off x="640080" y="365760"/>
+            <a:ext cx="10881360" cy="594360"/>
           </a:xfrm>
           <a:prstGeom prst="rect">
             <a:avLst/>
@@ -9688,7 +9688,7 @@
               <a:buNone/>
             </a:pPr>
             <a:r>
-              <a:rPr lang="en-US" sz="3000" b="1" dirty="0">
+              <a:rPr lang="en-US" sz="2900" b="1" dirty="0">
                 <a:solidFill>
                   <a:srgbClr val="1A1C2E"/>
                 </a:solidFill>
@@ -9698,7 +9698,7 @@
               </a:rPr>
               <a:t>El sistema de un vistazo</a:t>
             </a:r>
-            <a:endParaRPr lang="en-US" sz="3000" dirty="0"/>
+            <a:endParaRPr lang="en-US" sz="2900" dirty="0"/>
           </a:p>
         </p:txBody>
       </p:sp>
@@ -9710,8 +9710,8 @@
         </p:nvSpPr>
         <p:spPr>
           <a:xfrm>
-            <a:off x="640080" y="1115568"/>
-            <a:ext cx="10881360" cy="292608"/>
+            <a:off x="640080" y="1024128"/>
+            <a:ext cx="10881360" cy="274320"/>
           </a:xfrm>
           <a:prstGeom prst="rect">
             <a:avLst/>
@@ -9735,7 +9735,7 @@
                 <a:ea typeface="Calibri" pitchFamily="34" charset="-122"/>
                 <a:cs typeface="Calibri" pitchFamily="34" charset="-120"/>
               </a:rPr>
-              <a:t>Quién llama a quién. Todo lo de fuera entra por un puerto.</a:t>
+              <a:t>Del conector físico del coche hasta el modelo. Todo entra por un puerto.</a:t>
             </a:r>
             <a:endParaRPr lang="en-US" sz="1400" dirty="0"/>
           </a:p>
@@ -9749,12 +9749,12 @@
         </p:nvSpPr>
         <p:spPr>
           <a:xfrm>
-            <a:off x="4709160" y="1572768"/>
-            <a:ext cx="2743200" cy="658368"/>
+            <a:off x="4709160" y="1417320"/>
+            <a:ext cx="2743200" cy="603504"/>
           </a:xfrm>
           <a:prstGeom prst="roundRect">
             <a:avLst>
-              <a:gd name="adj" fmla="val 6944"/>
+              <a:gd name="adj" fmla="val 7576"/>
             </a:avLst>
           </a:prstGeom>
           <a:solidFill>
@@ -9776,8 +9776,8 @@
         </p:nvSpPr>
         <p:spPr>
           <a:xfrm>
-            <a:off x="4782312" y="1664208"/>
-            <a:ext cx="2596896" cy="256032"/>
+            <a:off x="4782312" y="1490472"/>
+            <a:ext cx="2596896" cy="237744"/>
           </a:xfrm>
           <a:prstGeom prst="rect">
             <a:avLst/>
@@ -9793,7 +9793,7 @@
               <a:buNone/>
             </a:pPr>
             <a:r>
-              <a:rPr lang="en-US" sz="1100" b="1" dirty="0">
+              <a:rPr lang="en-US" sz="1050" b="1" dirty="0">
                 <a:solidFill>
                   <a:srgbClr val="1A1C2E"/>
                 </a:solidFill>
@@ -9803,7 +9803,7 @@
               </a:rPr>
               <a:t>El mecánico</a:t>
             </a:r>
-            <a:endParaRPr lang="en-US" sz="1100" dirty="0"/>
+            <a:endParaRPr lang="en-US" sz="1050" dirty="0"/>
           </a:p>
         </p:txBody>
       </p:sp>
@@ -9815,8 +9815,8 @@
         </p:nvSpPr>
         <p:spPr>
           <a:xfrm>
-            <a:off x="4782312" y="1920240"/>
-            <a:ext cx="2596896" cy="384048"/>
+            <a:off x="4782312" y="1728216"/>
+            <a:ext cx="2596896" cy="365760"/>
           </a:xfrm>
           <a:prstGeom prst="rect">
             <a:avLst/>
@@ -9830,12 +9830,12 @@
           <a:p>
             <a:pPr algn="ctr" indent="0" marL="0">
               <a:lnSpc>
-                <a:spcPts val="1100"/>
+                <a:spcPts val="1050"/>
               </a:lnSpc>
               <a:buNone/>
             </a:pPr>
             <a:r>
-              <a:rPr lang="en-US" sz="900" dirty="0">
+              <a:rPr lang="en-US" sz="850" dirty="0">
                 <a:solidFill>
                   <a:srgbClr val="5A5F73"/>
                 </a:solidFill>
@@ -9845,7 +9845,7 @@
               </a:rPr>
               <a:t>React 19 · sesión JWT</a:t>
             </a:r>
-            <a:endParaRPr lang="en-US" sz="900" dirty="0"/>
+            <a:endParaRPr lang="en-US" sz="850" dirty="0"/>
           </a:p>
         </p:txBody>
       </p:sp>
@@ -9857,8 +9857,8 @@
         </p:nvSpPr>
         <p:spPr>
           <a:xfrm>
-            <a:off x="6080760" y="2231136"/>
-            <a:ext cx="0" cy="310896"/>
+            <a:off x="6080760" y="2020824"/>
+            <a:ext cx="0" cy="283464"/>
           </a:xfrm>
           <a:prstGeom prst="line">
             <a:avLst/>
@@ -9882,12 +9882,12 @@
         </p:nvSpPr>
         <p:spPr>
           <a:xfrm>
-            <a:off x="960120" y="2542032"/>
-            <a:ext cx="10881360" cy="777240"/>
+            <a:off x="960120" y="2304288"/>
+            <a:ext cx="10881360" cy="713232"/>
           </a:xfrm>
           <a:prstGeom prst="roundRect">
             <a:avLst>
-              <a:gd name="adj" fmla="val 5882"/>
+              <a:gd name="adj" fmla="val 6410"/>
             </a:avLst>
           </a:prstGeom>
           <a:solidFill>
@@ -9909,8 +9909,8 @@
         </p:nvSpPr>
         <p:spPr>
           <a:xfrm>
-            <a:off x="1033272" y="2633472"/>
-            <a:ext cx="10735056" cy="256032"/>
+            <a:off x="1033272" y="2377440"/>
+            <a:ext cx="10735056" cy="237744"/>
           </a:xfrm>
           <a:prstGeom prst="rect">
             <a:avLst/>
@@ -9926,7 +9926,7 @@
               <a:buNone/>
             </a:pPr>
             <a:r>
-              <a:rPr lang="en-US" sz="1100" b="1" dirty="0">
+              <a:rPr lang="en-US" sz="1050" b="1" dirty="0">
                 <a:solidFill>
                   <a:srgbClr val="FFFFFF"/>
                 </a:solidFill>
@@ -9936,7 +9936,7 @@
               </a:rPr>
               <a:t>API: casos de uso + dominio</a:t>
             </a:r>
-            <a:endParaRPr lang="en-US" sz="1100" dirty="0"/>
+            <a:endParaRPr lang="en-US" sz="1050" dirty="0"/>
           </a:p>
         </p:txBody>
       </p:sp>
@@ -9948,8 +9948,8 @@
         </p:nvSpPr>
         <p:spPr>
           <a:xfrm>
-            <a:off x="1033272" y="2889504"/>
-            <a:ext cx="10735056" cy="384048"/>
+            <a:off x="1033272" y="2615184"/>
+            <a:ext cx="10735056" cy="365760"/>
           </a:xfrm>
           <a:prstGeom prst="rect">
             <a:avLst/>
@@ -9963,12 +9963,12 @@
           <a:p>
             <a:pPr algn="ctr" indent="0" marL="0">
               <a:lnSpc>
-                <a:spcPts val="1100"/>
+                <a:spcPts val="1050"/>
               </a:lnSpc>
               <a:buNone/>
             </a:pPr>
             <a:r>
-              <a:rPr lang="en-US" sz="900" dirty="0">
+              <a:rPr lang="en-US" sz="850" dirty="0">
                 <a:solidFill>
                   <a:srgbClr val="B8BCCC"/>
                 </a:solidFill>
@@ -9978,7 +9978,7 @@
               </a:rPr>
               <a:t>fórmulas SAE J1979 · catálogos · decodificación del VIN</a:t>
             </a:r>
-            <a:endParaRPr lang="en-US" sz="900" dirty="0"/>
+            <a:endParaRPr lang="en-US" sz="850" dirty="0"/>
           </a:p>
         </p:txBody>
       </p:sp>
@@ -9990,8 +9990,8 @@
         </p:nvSpPr>
         <p:spPr>
           <a:xfrm>
-            <a:off x="2560320" y="3319272"/>
-            <a:ext cx="0" cy="475488"/>
+            <a:off x="2560320" y="3017520"/>
+            <a:ext cx="0" cy="292608"/>
           </a:xfrm>
           <a:prstGeom prst="line">
             <a:avLst/>
@@ -10015,8 +10015,8 @@
         </p:nvSpPr>
         <p:spPr>
           <a:xfrm>
-            <a:off x="6400800" y="3319272"/>
-            <a:ext cx="0" cy="475488"/>
+            <a:off x="6400800" y="3017520"/>
+            <a:ext cx="0" cy="292608"/>
           </a:xfrm>
           <a:prstGeom prst="line">
             <a:avLst/>
@@ -10040,8 +10040,8 @@
         </p:nvSpPr>
         <p:spPr>
           <a:xfrm>
-            <a:off x="10241280" y="3319272"/>
-            <a:ext cx="0" cy="475488"/>
+            <a:off x="10241280" y="3017520"/>
+            <a:ext cx="0" cy="292608"/>
           </a:xfrm>
           <a:prstGeom prst="line">
             <a:avLst/>
@@ -10065,12 +10065,12 @@
         </p:nvSpPr>
         <p:spPr>
           <a:xfrm>
-            <a:off x="960120" y="3794760"/>
-            <a:ext cx="3200400" cy="868680"/>
+            <a:off x="960120" y="3310128"/>
+            <a:ext cx="3200400" cy="795528"/>
           </a:xfrm>
           <a:prstGeom prst="roundRect">
             <a:avLst>
-              <a:gd name="adj" fmla="val 5263"/>
+              <a:gd name="adj" fmla="val 5747"/>
             </a:avLst>
           </a:prstGeom>
           <a:solidFill>
@@ -10092,8 +10092,8 @@
         </p:nvSpPr>
         <p:spPr>
           <a:xfrm>
-            <a:off x="1033272" y="3886200"/>
-            <a:ext cx="3054096" cy="256032"/>
+            <a:off x="1033272" y="3383280"/>
+            <a:ext cx="3054096" cy="237744"/>
           </a:xfrm>
           <a:prstGeom prst="rect">
             <a:avLst/>
@@ -10109,7 +10109,7 @@
               <a:buNone/>
             </a:pPr>
             <a:r>
-              <a:rPr lang="en-US" sz="1100" b="1" dirty="0">
+              <a:rPr lang="en-US" sz="1050" b="1" dirty="0">
                 <a:solidFill>
                   <a:srgbClr val="1A1C2E"/>
                 </a:solidFill>
@@ -10119,7 +10119,7 @@
               </a:rPr>
               <a:t>Transporte OBD</a:t>
             </a:r>
-            <a:endParaRPr lang="en-US" sz="1100" dirty="0"/>
+            <a:endParaRPr lang="en-US" sz="1050" dirty="0"/>
           </a:p>
         </p:txBody>
       </p:sp>
@@ -10131,8 +10131,8 @@
         </p:nvSpPr>
         <p:spPr>
           <a:xfrm>
-            <a:off x="1033272" y="4142232"/>
-            <a:ext cx="3054096" cy="384048"/>
+            <a:off x="1033272" y="3621024"/>
+            <a:ext cx="3054096" cy="365760"/>
           </a:xfrm>
           <a:prstGeom prst="rect">
             <a:avLst/>
@@ -10146,12 +10146,12 @@
           <a:p>
             <a:pPr algn="ctr" indent="0" marL="0">
               <a:lnSpc>
-                <a:spcPts val="1100"/>
+                <a:spcPts val="1050"/>
               </a:lnSpc>
               <a:buNone/>
             </a:pPr>
             <a:r>
-              <a:rPr lang="en-US" sz="900" dirty="0">
+              <a:rPr lang="en-US" sz="850" dirty="0">
                 <a:solidFill>
                   <a:srgbClr val="5A5F73"/>
                 </a:solidFill>
@@ -10159,19 +10159,19 @@
                 <a:ea typeface="Calibri" pitchFamily="34" charset="-122"/>
                 <a:cs typeface="Calibri" pitchFamily="34" charset="-120"/>
               </a:rPr>
-              <a:t>ELM327 por serie o TCP</a:t>
-            </a:r>
-            <a:endParaRPr lang="en-US" sz="900" dirty="0"/>
+              <a:t>abre el puerto serie o el socket</a:t>
+            </a:r>
+            <a:endParaRPr lang="en-US" sz="850" dirty="0"/>
           </a:p>
           <a:p>
             <a:pPr algn="ctr" indent="0" marL="0">
               <a:lnSpc>
-                <a:spcPts val="1100"/>
+                <a:spcPts val="1050"/>
               </a:lnSpc>
               <a:buNone/>
             </a:pPr>
             <a:r>
-              <a:rPr lang="en-US" sz="900" dirty="0">
+              <a:rPr lang="en-US" sz="850" dirty="0">
                 <a:solidFill>
                   <a:srgbClr val="5A5F73"/>
                 </a:solidFill>
@@ -10179,9 +10179,9 @@
                 <a:ea typeface="Calibri" pitchFamily="34" charset="-122"/>
                 <a:cs typeface="Calibri" pitchFamily="34" charset="-120"/>
               </a:rPr>
-              <a:t>negocia el protocolo</a:t>
-            </a:r>
-            <a:endParaRPr lang="en-US" sz="900" dirty="0"/>
+              <a:t>y negocia el protocolo</a:t>
+            </a:r>
+            <a:endParaRPr lang="en-US" sz="850" dirty="0"/>
           </a:p>
         </p:txBody>
       </p:sp>
@@ -10193,12 +10193,12 @@
         </p:nvSpPr>
         <p:spPr>
           <a:xfrm>
-            <a:off x="4800600" y="3794760"/>
-            <a:ext cx="3200400" cy="868680"/>
+            <a:off x="4800600" y="3310128"/>
+            <a:ext cx="3200400" cy="795528"/>
           </a:xfrm>
           <a:prstGeom prst="roundRect">
             <a:avLst>
-              <a:gd name="adj" fmla="val 5263"/>
+              <a:gd name="adj" fmla="val 5747"/>
             </a:avLst>
           </a:prstGeom>
           <a:solidFill>
@@ -10220,8 +10220,8 @@
         </p:nvSpPr>
         <p:spPr>
           <a:xfrm>
-            <a:off x="4873752" y="3886200"/>
-            <a:ext cx="3054096" cy="256032"/>
+            <a:off x="4873752" y="3383280"/>
+            <a:ext cx="3054096" cy="237744"/>
           </a:xfrm>
           <a:prstGeom prst="rect">
             <a:avLst/>
@@ -10237,7 +10237,7 @@
               <a:buNone/>
             </a:pPr>
             <a:r>
-              <a:rPr lang="en-US" sz="1100" b="1" dirty="0">
+              <a:rPr lang="en-US" sz="1050" b="1" dirty="0">
                 <a:solidFill>
                   <a:srgbClr val="1A1C2E"/>
                 </a:solidFill>
@@ -10247,7 +10247,7 @@
               </a:rPr>
               <a:t>Persistencia</a:t>
             </a:r>
-            <a:endParaRPr lang="en-US" sz="1100" dirty="0"/>
+            <a:endParaRPr lang="en-US" sz="1050" dirty="0"/>
           </a:p>
         </p:txBody>
       </p:sp>
@@ -10259,8 +10259,8 @@
         </p:nvSpPr>
         <p:spPr>
           <a:xfrm>
-            <a:off x="4873752" y="4142232"/>
-            <a:ext cx="3054096" cy="384048"/>
+            <a:off x="4873752" y="3621024"/>
+            <a:ext cx="3054096" cy="365760"/>
           </a:xfrm>
           <a:prstGeom prst="rect">
             <a:avLst/>
@@ -10274,12 +10274,12 @@
           <a:p>
             <a:pPr algn="ctr" indent="0" marL="0">
               <a:lnSpc>
-                <a:spcPts val="1100"/>
+                <a:spcPts val="1050"/>
               </a:lnSpc>
               <a:buNone/>
             </a:pPr>
             <a:r>
-              <a:rPr lang="en-US" sz="900" dirty="0">
+              <a:rPr lang="en-US" sz="850" dirty="0">
                 <a:solidFill>
                   <a:srgbClr val="5A5F73"/>
                 </a:solidFill>
@@ -10289,17 +10289,17 @@
               </a:rPr>
               <a:t>SQLite · 13 tablas</a:t>
             </a:r>
-            <a:endParaRPr lang="en-US" sz="900" dirty="0"/>
+            <a:endParaRPr lang="en-US" sz="850" dirty="0"/>
           </a:p>
           <a:p>
             <a:pPr algn="ctr" indent="0" marL="0">
               <a:lnSpc>
-                <a:spcPts val="1100"/>
+                <a:spcPts val="1050"/>
               </a:lnSpc>
               <a:buNone/>
             </a:pPr>
             <a:r>
-              <a:rPr lang="en-US" sz="900" dirty="0">
+              <a:rPr lang="en-US" sz="850" dirty="0">
                 <a:solidFill>
                   <a:srgbClr val="5A5F73"/>
                 </a:solidFill>
@@ -10309,7 +10309,7 @@
               </a:rPr>
               <a:t>LanceDB · 4 índices</a:t>
             </a:r>
-            <a:endParaRPr lang="en-US" sz="900" dirty="0"/>
+            <a:endParaRPr lang="en-US" sz="850" dirty="0"/>
           </a:p>
         </p:txBody>
       </p:sp>
@@ -10321,12 +10321,12 @@
         </p:nvSpPr>
         <p:spPr>
           <a:xfrm>
-            <a:off x="8641080" y="3794760"/>
-            <a:ext cx="3200400" cy="868680"/>
+            <a:off x="8641080" y="3310128"/>
+            <a:ext cx="3200400" cy="795528"/>
           </a:xfrm>
           <a:prstGeom prst="roundRect">
             <a:avLst>
-              <a:gd name="adj" fmla="val 5263"/>
+              <a:gd name="adj" fmla="val 5747"/>
             </a:avLst>
           </a:prstGeom>
           <a:solidFill>
@@ -10348,8 +10348,8 @@
         </p:nvSpPr>
         <p:spPr>
           <a:xfrm>
-            <a:off x="8714232" y="3886200"/>
-            <a:ext cx="3054096" cy="256032"/>
+            <a:off x="8714232" y="3383280"/>
+            <a:ext cx="3054096" cy="237744"/>
           </a:xfrm>
           <a:prstGeom prst="rect">
             <a:avLst/>
@@ -10365,7 +10365,7 @@
               <a:buNone/>
             </a:pPr>
             <a:r>
-              <a:rPr lang="en-US" sz="1100" b="1" dirty="0">
+              <a:rPr lang="en-US" sz="1050" b="1" dirty="0">
                 <a:solidFill>
                   <a:srgbClr val="1A1C2E"/>
                 </a:solidFill>
@@ -10375,7 +10375,7 @@
               </a:rPr>
               <a:t>Servidor MCP</a:t>
             </a:r>
-            <a:endParaRPr lang="en-US" sz="1100" dirty="0"/>
+            <a:endParaRPr lang="en-US" sz="1050" dirty="0"/>
           </a:p>
         </p:txBody>
       </p:sp>
@@ -10387,8 +10387,8 @@
         </p:nvSpPr>
         <p:spPr>
           <a:xfrm>
-            <a:off x="8714232" y="4142232"/>
-            <a:ext cx="3054096" cy="384048"/>
+            <a:off x="8714232" y="3621024"/>
+            <a:ext cx="3054096" cy="365760"/>
           </a:xfrm>
           <a:prstGeom prst="rect">
             <a:avLst/>
@@ -10402,12 +10402,12 @@
           <a:p>
             <a:pPr algn="ctr" indent="0" marL="0">
               <a:lnSpc>
-                <a:spcPts val="1100"/>
+                <a:spcPts val="1050"/>
               </a:lnSpc>
               <a:buNone/>
             </a:pPr>
             <a:r>
-              <a:rPr lang="en-US" sz="900" dirty="0">
+              <a:rPr lang="en-US" sz="850" dirty="0">
                 <a:solidFill>
                   <a:srgbClr val="5A5F73"/>
                 </a:solidFill>
@@ -10417,17 +10417,17 @@
               </a:rPr>
               <a:t>16 herramientas</a:t>
             </a:r>
-            <a:endParaRPr lang="en-US" sz="900" dirty="0"/>
+            <a:endParaRPr lang="en-US" sz="850" dirty="0"/>
           </a:p>
           <a:p>
             <a:pPr algn="ctr" indent="0" marL="0">
               <a:lnSpc>
-                <a:spcPts val="1100"/>
+                <a:spcPts val="1050"/>
               </a:lnSpc>
               <a:buNone/>
             </a:pPr>
             <a:r>
-              <a:rPr lang="en-US" sz="900" dirty="0">
+              <a:rPr lang="en-US" sz="850" dirty="0">
                 <a:solidFill>
                   <a:srgbClr val="5A5F73"/>
                 </a:solidFill>
@@ -10437,7 +10437,7 @@
               </a:rPr>
               <a:t>declaradas con su esquema</a:t>
             </a:r>
-            <a:endParaRPr lang="en-US" sz="900" dirty="0"/>
+            <a:endParaRPr lang="en-US" sz="850" dirty="0"/>
           </a:p>
         </p:txBody>
       </p:sp>
@@ -10449,7 +10449,7 @@
         </p:nvSpPr>
         <p:spPr>
           <a:xfrm>
-            <a:off x="4233672" y="4233672"/>
+            <a:off x="4233672" y="3712464"/>
             <a:ext cx="493776" cy="0"/>
           </a:xfrm>
           <a:prstGeom prst="line">
@@ -10473,7 +10473,7 @@
         </p:nvSpPr>
         <p:spPr>
           <a:xfrm>
-            <a:off x="8074152" y="4233672"/>
+            <a:off x="8074152" y="3712464"/>
             <a:ext cx="493776" cy="0"/>
           </a:xfrm>
           <a:prstGeom prst="line">
@@ -10497,8 +10497,8 @@
         </p:nvSpPr>
         <p:spPr>
           <a:xfrm>
-            <a:off x="2560320" y="4663440"/>
-            <a:ext cx="0" cy="566928"/>
+            <a:off x="2560320" y="4105656"/>
+            <a:ext cx="0" cy="301752"/>
           </a:xfrm>
           <a:prstGeom prst="line">
             <a:avLst/>
@@ -10522,8 +10522,8 @@
         </p:nvSpPr>
         <p:spPr>
           <a:xfrm>
-            <a:off x="10241280" y="4663440"/>
-            <a:ext cx="0" cy="566928"/>
+            <a:off x="10241280" y="4105656"/>
+            <a:ext cx="0" cy="301752"/>
           </a:xfrm>
           <a:prstGeom prst="line">
             <a:avLst/>
@@ -10547,12 +10547,140 @@
         </p:nvSpPr>
         <p:spPr>
           <a:xfrm>
-            <a:off x="960120" y="5230368"/>
-            <a:ext cx="3200400" cy="822960"/>
+            <a:off x="960120" y="4407408"/>
+            <a:ext cx="3200400" cy="731520"/>
           </a:xfrm>
           <a:prstGeom prst="roundRect">
             <a:avLst>
-              <a:gd name="adj" fmla="val 5556"/>
+              <a:gd name="adj" fmla="val 6250"/>
+            </a:avLst>
+          </a:prstGeom>
+          <a:solidFill>
+            <a:srgbClr val="FFFFFF"/>
+          </a:solidFill>
+          <a:ln w="22225">
+            <a:solidFill>
+              <a:srgbClr val="202CFC"/>
+            </a:solidFill>
+            <a:prstDash val="solid"/>
+          </a:ln>
+        </p:spPr>
+      </p:sp>
+      <p:sp>
+        <p:nvSpPr>
+          <p:cNvPr id="28" name="Text 26"/>
+          <p:cNvSpPr/>
+          <p:nvPr/>
+        </p:nvSpPr>
+        <p:spPr>
+          <a:xfrm>
+            <a:off x="1033272" y="4480560"/>
+            <a:ext cx="3054096" cy="237744"/>
+          </a:xfrm>
+          <a:prstGeom prst="rect">
+            <a:avLst/>
+          </a:prstGeom>
+          <a:noFill/>
+          <a:ln/>
+        </p:spPr>
+        <p:txBody>
+          <a:bodyPr wrap="square" lIns="0" tIns="0" rIns="0" bIns="0" rtlCol="0" anchor="ctr"/>
+          <a:lstStyle/>
+          <a:p>
+            <a:pPr algn="ctr" indent="0" marL="0">
+              <a:buNone/>
+            </a:pPr>
+            <a:r>
+              <a:rPr lang="en-US" sz="1050" b="1" dirty="0">
+                <a:solidFill>
+                  <a:srgbClr val="1A1C2E"/>
+                </a:solidFill>
+                <a:latin typeface="Arial" pitchFamily="34" charset="0"/>
+                <a:ea typeface="Arial" pitchFamily="34" charset="-122"/>
+                <a:cs typeface="Arial" pitchFamily="34" charset="-120"/>
+              </a:rPr>
+              <a:t>Dongle ELM327</a:t>
+            </a:r>
+            <a:endParaRPr lang="en-US" sz="1050" dirty="0"/>
+          </a:p>
+        </p:txBody>
+      </p:sp>
+      <p:sp>
+        <p:nvSpPr>
+          <p:cNvPr id="29" name="Text 27"/>
+          <p:cNvSpPr/>
+          <p:nvPr/>
+        </p:nvSpPr>
+        <p:spPr>
+          <a:xfrm>
+            <a:off x="1033272" y="4718304"/>
+            <a:ext cx="3054096" cy="365760"/>
+          </a:xfrm>
+          <a:prstGeom prst="rect">
+            <a:avLst/>
+          </a:prstGeom>
+          <a:noFill/>
+          <a:ln/>
+        </p:spPr>
+        <p:txBody>
+          <a:bodyPr wrap="square" lIns="0" tIns="0" rIns="0" bIns="0" rtlCol="0" anchor="t"/>
+          <a:lstStyle/>
+          <a:p>
+            <a:pPr algn="ctr" indent="0" marL="0">
+              <a:lnSpc>
+                <a:spcPts val="1050"/>
+              </a:lnSpc>
+              <a:buNone/>
+            </a:pPr>
+            <a:r>
+              <a:rPr lang="en-US" sz="850" dirty="0">
+                <a:solidFill>
+                  <a:srgbClr val="5A5F73"/>
+                </a:solidFill>
+                <a:latin typeface="Calibri" pitchFamily="34" charset="0"/>
+                <a:ea typeface="Calibri" pitchFamily="34" charset="-122"/>
+                <a:cs typeface="Calibri" pitchFamily="34" charset="-120"/>
+              </a:rPr>
+              <a:t>enchufado al conector OBD-II</a:t>
+            </a:r>
+            <a:endParaRPr lang="en-US" sz="850" dirty="0"/>
+          </a:p>
+          <a:p>
+            <a:pPr algn="ctr" indent="0" marL="0">
+              <a:lnSpc>
+                <a:spcPts val="1050"/>
+              </a:lnSpc>
+              <a:buNone/>
+            </a:pPr>
+            <a:r>
+              <a:rPr lang="en-US" sz="850" dirty="0">
+                <a:solidFill>
+                  <a:srgbClr val="5A5F73"/>
+                </a:solidFill>
+                <a:latin typeface="Calibri" pitchFamily="34" charset="0"/>
+                <a:ea typeface="Calibri" pitchFamily="34" charset="-122"/>
+                <a:cs typeface="Calibri" pitchFamily="34" charset="-120"/>
+              </a:rPr>
+              <a:t>del coche · USB o WiFi</a:t>
+            </a:r>
+            <a:endParaRPr lang="en-US" sz="850" dirty="0"/>
+          </a:p>
+        </p:txBody>
+      </p:sp>
+      <p:sp>
+        <p:nvSpPr>
+          <p:cNvPr id="30" name="Shape 28"/>
+          <p:cNvSpPr/>
+          <p:nvPr/>
+        </p:nvSpPr>
+        <p:spPr>
+          <a:xfrm>
+            <a:off x="8641080" y="4407408"/>
+            <a:ext cx="3200400" cy="731520"/>
+          </a:xfrm>
+          <a:prstGeom prst="roundRect">
+            <a:avLst>
+              <a:gd name="adj" fmla="val 6250"/>
             </a:avLst>
           </a:prstGeom>
           <a:solidFill>
@@ -10568,14 +10696,14 @@
       </p:sp>
       <p:sp>
         <p:nvSpPr>
-          <p:cNvPr id="28" name="Text 26"/>
-          <p:cNvSpPr/>
-          <p:nvPr/>
-        </p:nvSpPr>
-        <p:spPr>
-          <a:xfrm>
-            <a:off x="1033272" y="5321808"/>
-            <a:ext cx="3054096" cy="256032"/>
+          <p:cNvPr id="31" name="Text 29"/>
+          <p:cNvSpPr/>
+          <p:nvPr/>
+        </p:nvSpPr>
+        <p:spPr>
+          <a:xfrm>
+            <a:off x="8714232" y="4480560"/>
+            <a:ext cx="3054096" cy="237744"/>
           </a:xfrm>
           <a:prstGeom prst="rect">
             <a:avLst/>
@@ -10591,7 +10719,7 @@
               <a:buNone/>
             </a:pPr>
             <a:r>
-              <a:rPr lang="en-US" sz="1100" b="1" dirty="0">
+              <a:rPr lang="en-US" sz="1050" b="1" dirty="0">
                 <a:solidFill>
                   <a:srgbClr val="1A1C2E"/>
                 </a:solidFill>
@@ -10599,22 +10727,237 @@
                 <a:ea typeface="Arial" pitchFamily="34" charset="-122"/>
                 <a:cs typeface="Arial" pitchFamily="34" charset="-120"/>
               </a:rPr>
+              <a:t>El modelo</a:t>
+            </a:r>
+            <a:endParaRPr lang="en-US" sz="1050" dirty="0"/>
+          </a:p>
+        </p:txBody>
+      </p:sp>
+      <p:sp>
+        <p:nvSpPr>
+          <p:cNvPr id="32" name="Text 30"/>
+          <p:cNvSpPr/>
+          <p:nvPr/>
+        </p:nvSpPr>
+        <p:spPr>
+          <a:xfrm>
+            <a:off x="8714232" y="4718304"/>
+            <a:ext cx="3054096" cy="365760"/>
+          </a:xfrm>
+          <a:prstGeom prst="rect">
+            <a:avLst/>
+          </a:prstGeom>
+          <a:noFill/>
+          <a:ln/>
+        </p:spPr>
+        <p:txBody>
+          <a:bodyPr wrap="square" lIns="0" tIns="0" rIns="0" bIns="0" rtlCol="0" anchor="t"/>
+          <a:lstStyle/>
+          <a:p>
+            <a:pPr algn="ctr" indent="0" marL="0">
+              <a:lnSpc>
+                <a:spcPts val="1050"/>
+              </a:lnSpc>
+              <a:buNone/>
+            </a:pPr>
+            <a:r>
+              <a:rPr lang="en-US" sz="850" dirty="0">
+                <a:solidFill>
+                  <a:srgbClr val="5A5F73"/>
+                </a:solidFill>
+                <a:latin typeface="Calibri" pitchFamily="34" charset="0"/>
+                <a:ea typeface="Calibri" pitchFamily="34" charset="-122"/>
+                <a:cs typeface="Calibri" pitchFamily="34" charset="-120"/>
+              </a:rPr>
+              <a:t>Anthropic u OpenAI</a:t>
+            </a:r>
+            <a:endParaRPr lang="en-US" sz="850" dirty="0"/>
+          </a:p>
+          <a:p>
+            <a:pPr algn="ctr" indent="0" marL="0">
+              <a:lnSpc>
+                <a:spcPts val="1050"/>
+              </a:lnSpc>
+              <a:buNone/>
+            </a:pPr>
+            <a:r>
+              <a:rPr lang="en-US" sz="850" dirty="0">
+                <a:solidFill>
+                  <a:srgbClr val="5A5F73"/>
+                </a:solidFill>
+                <a:latin typeface="Calibri" pitchFamily="34" charset="0"/>
+                <a:ea typeface="Calibri" pitchFamily="34" charset="-122"/>
+                <a:cs typeface="Calibri" pitchFamily="34" charset="-120"/>
+              </a:rPr>
+              <a:t>y búsqueda web con presupuesto</a:t>
+            </a:r>
+            <a:endParaRPr lang="en-US" sz="850" dirty="0"/>
+          </a:p>
+        </p:txBody>
+      </p:sp>
+      <p:sp>
+        <p:nvSpPr>
+          <p:cNvPr id="33" name="Shape 31"/>
+          <p:cNvSpPr/>
+          <p:nvPr/>
+        </p:nvSpPr>
+        <p:spPr>
+          <a:xfrm>
+            <a:off x="2560320" y="5138928"/>
+            <a:ext cx="0" cy="301752"/>
+          </a:xfrm>
+          <a:prstGeom prst="line">
+            <a:avLst/>
+          </a:prstGeom>
+          <a:noFill/>
+          <a:ln w="15875">
+            <a:solidFill>
+              <a:srgbClr val="202CFC"/>
+            </a:solidFill>
+            <a:prstDash val="solid"/>
+            <a:headEnd type="triangle"/>
+            <a:tailEnd type="triangle"/>
+          </a:ln>
+        </p:spPr>
+      </p:sp>
+      <p:sp>
+        <p:nvSpPr>
+          <p:cNvPr id="34" name="Shape 32"/>
+          <p:cNvSpPr/>
+          <p:nvPr/>
+        </p:nvSpPr>
+        <p:spPr>
+          <a:xfrm>
+            <a:off x="960120" y="5440680"/>
+            <a:ext cx="3200400" cy="713232"/>
+          </a:xfrm>
+          <a:prstGeom prst="roundRect">
+            <a:avLst>
+              <a:gd name="adj" fmla="val 6410"/>
+            </a:avLst>
+          </a:prstGeom>
+          <a:solidFill>
+            <a:srgbClr val="FFFFFF"/>
+          </a:solidFill>
+          <a:ln w="22225">
+            <a:solidFill>
+              <a:srgbClr val="202CFC"/>
+            </a:solidFill>
+            <a:prstDash val="solid"/>
+          </a:ln>
+        </p:spPr>
+      </p:sp>
+      <p:sp>
+        <p:nvSpPr>
+          <p:cNvPr id="35" name="Text 33"/>
+          <p:cNvSpPr/>
+          <p:nvPr/>
+        </p:nvSpPr>
+        <p:spPr>
+          <a:xfrm>
+            <a:off x="1033272" y="5513832"/>
+            <a:ext cx="3054096" cy="237744"/>
+          </a:xfrm>
+          <a:prstGeom prst="rect">
+            <a:avLst/>
+          </a:prstGeom>
+          <a:noFill/>
+          <a:ln/>
+        </p:spPr>
+        <p:txBody>
+          <a:bodyPr wrap="square" lIns="0" tIns="0" rIns="0" bIns="0" rtlCol="0" anchor="ctr"/>
+          <a:lstStyle/>
+          <a:p>
+            <a:pPr algn="ctr" indent="0" marL="0">
+              <a:buNone/>
+            </a:pPr>
+            <a:r>
+              <a:rPr lang="en-US" sz="1050" b="1" dirty="0">
+                <a:solidFill>
+                  <a:srgbClr val="1A1C2E"/>
+                </a:solidFill>
+                <a:latin typeface="Arial" pitchFamily="34" charset="0"/>
+                <a:ea typeface="Arial" pitchFamily="34" charset="-122"/>
+                <a:cs typeface="Arial" pitchFamily="34" charset="-120"/>
+              </a:rPr>
               <a:t>El coche</a:t>
             </a:r>
-            <a:endParaRPr lang="en-US" sz="1100" dirty="0"/>
-          </a:p>
-        </p:txBody>
-      </p:sp>
-      <p:sp>
-        <p:nvSpPr>
-          <p:cNvPr id="29" name="Text 27"/>
-          <p:cNvSpPr/>
-          <p:nvPr/>
-        </p:nvSpPr>
-        <p:spPr>
-          <a:xfrm>
-            <a:off x="1033272" y="5577840"/>
-            <a:ext cx="3054096" cy="384048"/>
+            <a:endParaRPr lang="en-US" sz="1050" dirty="0"/>
+          </a:p>
+        </p:txBody>
+      </p:sp>
+      <p:sp>
+        <p:nvSpPr>
+          <p:cNvPr id="36" name="Text 34"/>
+          <p:cNvSpPr/>
+          <p:nvPr/>
+        </p:nvSpPr>
+        <p:spPr>
+          <a:xfrm>
+            <a:off x="1033272" y="5751576"/>
+            <a:ext cx="3054096" cy="365760"/>
+          </a:xfrm>
+          <a:prstGeom prst="rect">
+            <a:avLst/>
+          </a:prstGeom>
+          <a:noFill/>
+          <a:ln/>
+        </p:spPr>
+        <p:txBody>
+          <a:bodyPr wrap="square" lIns="0" tIns="0" rIns="0" bIns="0" rtlCol="0" anchor="t"/>
+          <a:lstStyle/>
+          <a:p>
+            <a:pPr algn="ctr" indent="0" marL="0">
+              <a:lnSpc>
+                <a:spcPts val="1050"/>
+              </a:lnSpc>
+              <a:buNone/>
+            </a:pPr>
+            <a:r>
+              <a:rPr lang="en-US" sz="850" dirty="0">
+                <a:solidFill>
+                  <a:srgbClr val="5A5F73"/>
+                </a:solidFill>
+                <a:latin typeface="Calibri" pitchFamily="34" charset="0"/>
+                <a:ea typeface="Calibri" pitchFamily="34" charset="-122"/>
+                <a:cs typeface="Calibri" pitchFamily="34" charset="-120"/>
+              </a:rPr>
+              <a:t>bus CAN · ISO 15765-4</a:t>
+            </a:r>
+            <a:endParaRPr lang="en-US" sz="850" dirty="0"/>
+          </a:p>
+          <a:p>
+            <a:pPr algn="ctr" indent="0" marL="0">
+              <a:lnSpc>
+                <a:spcPts val="1050"/>
+              </a:lnSpc>
+              <a:buNone/>
+            </a:pPr>
+            <a:r>
+              <a:rPr lang="en-US" sz="850" dirty="0">
+                <a:solidFill>
+                  <a:srgbClr val="5A5F73"/>
+                </a:solidFill>
+                <a:latin typeface="Calibri" pitchFamily="34" charset="0"/>
+                <a:ea typeface="Calibri" pitchFamily="34" charset="-122"/>
+                <a:cs typeface="Calibri" pitchFamily="34" charset="-120"/>
+              </a:rPr>
+              <a:t>centralita del motor y las demás</a:t>
+            </a:r>
+            <a:endParaRPr lang="en-US" sz="850" dirty="0"/>
+          </a:p>
+        </p:txBody>
+      </p:sp>
+      <p:sp>
+        <p:nvSpPr>
+          <p:cNvPr id="37" name="Text 35"/>
+          <p:cNvSpPr/>
+          <p:nvPr/>
+        </p:nvSpPr>
+        <p:spPr>
+          <a:xfrm>
+            <a:off x="4343400" y="4617720"/>
+            <a:ext cx="4114800" cy="548640"/>
           </a:xfrm>
           <a:prstGeom prst="rect">
             <a:avLst/>
@@ -10633,7 +10976,7 @@
               <a:buNone/>
             </a:pPr>
             <a:r>
-              <a:rPr lang="en-US" sz="900" dirty="0">
+              <a:rPr lang="en-US" sz="900" i="1" dirty="0">
                 <a:solidFill>
                   <a:srgbClr val="5A5F73"/>
                 </a:solidFill>
@@ -10641,10 +10984,32 @@
                 <a:ea typeface="Calibri" pitchFamily="34" charset="-122"/>
                 <a:cs typeface="Calibri" pitchFamily="34" charset="-120"/>
               </a:rPr>
-              <a:t>bus CAN · ISO 15765-4</a:t>
+              <a:t>En la demo, este tramo se sustituye por tres emuladores ELM327 escuchando en tres puertos TCP.</a:t>
             </a:r>
             <a:endParaRPr lang="en-US" sz="900" dirty="0"/>
           </a:p>
+        </p:txBody>
+      </p:sp>
+      <p:sp>
+        <p:nvSpPr>
+          <p:cNvPr id="38" name="Text 36"/>
+          <p:cNvSpPr/>
+          <p:nvPr/>
+        </p:nvSpPr>
+        <p:spPr>
+          <a:xfrm>
+            <a:off x="4343400" y="5440680"/>
+            <a:ext cx="4114800" cy="457200"/>
+          </a:xfrm>
+          <a:prstGeom prst="rect">
+            <a:avLst/>
+          </a:prstGeom>
+          <a:noFill/>
+          <a:ln/>
+        </p:spPr>
+        <p:txBody>
+          <a:bodyPr wrap="square" lIns="0" tIns="0" rIns="0" bIns="0" rtlCol="0" anchor="t"/>
+          <a:lstStyle/>
           <a:p>
             <a:pPr algn="ctr" indent="0" marL="0">
               <a:lnSpc>
@@ -10653,7 +11018,7 @@
               <a:buNone/>
             </a:pPr>
             <a:r>
-              <a:rPr lang="en-US" sz="900" dirty="0">
+              <a:rPr lang="en-US" sz="900" i="1" dirty="0">
                 <a:solidFill>
                   <a:srgbClr val="5A5F73"/>
                 </a:solidFill>
@@ -10661,7 +11026,7 @@
                 <a:ea typeface="Calibri" pitchFamily="34" charset="-122"/>
                 <a:cs typeface="Calibri" pitchFamily="34" charset="-120"/>
               </a:rPr>
-              <a:t>o uno de los 3 emuladores</a:t>
+              <a:t>Las herramientas del agente vuelven a entrar por los mismos adaptadores.</a:t>
             </a:r>
             <a:endParaRPr lang="en-US" sz="900" dirty="0"/>
           </a:p>
@@ -10669,41 +11034,34 @@
       </p:sp>
       <p:sp>
         <p:nvSpPr>
-          <p:cNvPr id="30" name="Shape 28"/>
-          <p:cNvSpPr/>
-          <p:nvPr/>
-        </p:nvSpPr>
-        <p:spPr>
-          <a:xfrm>
-            <a:off x="8641080" y="5230368"/>
-            <a:ext cx="3200400" cy="822960"/>
-          </a:xfrm>
-          <a:prstGeom prst="roundRect">
-            <a:avLst>
-              <a:gd name="adj" fmla="val 5556"/>
-            </a:avLst>
+          <p:cNvPr id="39" name="Shape 37"/>
+          <p:cNvSpPr/>
+          <p:nvPr/>
+        </p:nvSpPr>
+        <p:spPr>
+          <a:xfrm>
+            <a:off x="777240" y="6263640"/>
+            <a:ext cx="219456" cy="219456"/>
+          </a:xfrm>
+          <a:prstGeom prst="rect">
+            <a:avLst/>
           </a:prstGeom>
           <a:solidFill>
-            <a:srgbClr val="FFFFFF"/>
+            <a:srgbClr val="202CFC"/>
           </a:solidFill>
-          <a:ln w="12700">
-            <a:solidFill>
-              <a:srgbClr val="C9CCD8"/>
-            </a:solidFill>
-            <a:prstDash val="solid"/>
-          </a:ln>
-        </p:spPr>
-      </p:sp>
-      <p:sp>
-        <p:nvSpPr>
-          <p:cNvPr id="31" name="Text 29"/>
-          <p:cNvSpPr/>
-          <p:nvPr/>
-        </p:nvSpPr>
-        <p:spPr>
-          <a:xfrm>
-            <a:off x="8714232" y="5321808"/>
-            <a:ext cx="3054096" cy="256032"/>
+          <a:ln/>
+        </p:spPr>
+      </p:sp>
+      <p:sp>
+        <p:nvSpPr>
+          <p:cNvPr id="40" name="Text 38"/>
+          <p:cNvSpPr/>
+          <p:nvPr/>
+        </p:nvSpPr>
+        <p:spPr>
+          <a:xfrm>
+            <a:off x="777240" y="6263640"/>
+            <a:ext cx="219456" cy="219456"/>
           </a:xfrm>
           <a:prstGeom prst="rect">
             <a:avLst/>
@@ -10719,154 +11077,30 @@
               <a:buNone/>
             </a:pPr>
             <a:r>
-              <a:rPr lang="en-US" sz="1100" b="1" dirty="0">
-                <a:solidFill>
-                  <a:srgbClr val="1A1C2E"/>
+              <a:rPr lang="en-US" sz="816" b="1" dirty="0">
+                <a:solidFill>
+                  <a:srgbClr val="FFFFFF"/>
                 </a:solidFill>
                 <a:latin typeface="Arial" pitchFamily="34" charset="0"/>
                 <a:ea typeface="Arial" pitchFamily="34" charset="-122"/>
                 <a:cs typeface="Arial" pitchFamily="34" charset="-120"/>
               </a:rPr>
-              <a:t>El modelo</a:t>
-            </a:r>
-            <a:endParaRPr lang="en-US" sz="1100" dirty="0"/>
-          </a:p>
-        </p:txBody>
-      </p:sp>
-      <p:sp>
-        <p:nvSpPr>
-          <p:cNvPr id="32" name="Text 30"/>
-          <p:cNvSpPr/>
-          <p:nvPr/>
-        </p:nvSpPr>
-        <p:spPr>
-          <a:xfrm>
-            <a:off x="8714232" y="5577840"/>
-            <a:ext cx="3054096" cy="384048"/>
-          </a:xfrm>
-          <a:prstGeom prst="rect">
-            <a:avLst/>
-          </a:prstGeom>
-          <a:noFill/>
-          <a:ln/>
-        </p:spPr>
-        <p:txBody>
-          <a:bodyPr wrap="square" lIns="0" tIns="0" rIns="0" bIns="0" rtlCol="0" anchor="t"/>
-          <a:lstStyle/>
-          <a:p>
-            <a:pPr algn="ctr" indent="0" marL="0">
-              <a:lnSpc>
-                <a:spcPts val="1100"/>
-              </a:lnSpc>
-              <a:buNone/>
-            </a:pPr>
-            <a:r>
-              <a:rPr lang="en-US" sz="900" dirty="0">
-                <a:solidFill>
-                  <a:srgbClr val="5A5F73"/>
-                </a:solidFill>
-                <a:latin typeface="Calibri" pitchFamily="34" charset="0"/>
-                <a:ea typeface="Calibri" pitchFamily="34" charset="-122"/>
-                <a:cs typeface="Calibri" pitchFamily="34" charset="-120"/>
-              </a:rPr>
-              <a:t>Anthropic u OpenAI</a:t>
-            </a:r>
-            <a:endParaRPr lang="en-US" sz="900" dirty="0"/>
-          </a:p>
-          <a:p>
-            <a:pPr algn="ctr" indent="0" marL="0">
-              <a:lnSpc>
-                <a:spcPts val="1100"/>
-              </a:lnSpc>
-              <a:buNone/>
-            </a:pPr>
-            <a:r>
-              <a:rPr lang="en-US" sz="900" dirty="0">
-                <a:solidFill>
-                  <a:srgbClr val="5A5F73"/>
-                </a:solidFill>
-                <a:latin typeface="Calibri" pitchFamily="34" charset="0"/>
-                <a:ea typeface="Calibri" pitchFamily="34" charset="-122"/>
-                <a:cs typeface="Calibri" pitchFamily="34" charset="-120"/>
-              </a:rPr>
-              <a:t>y búsqueda web con presupuesto</a:t>
-            </a:r>
-            <a:endParaRPr lang="en-US" sz="900" dirty="0"/>
-          </a:p>
-        </p:txBody>
-      </p:sp>
-      <p:sp>
-        <p:nvSpPr>
-          <p:cNvPr id="33" name="Text 31"/>
-          <p:cNvSpPr/>
-          <p:nvPr/>
-        </p:nvSpPr>
-        <p:spPr>
-          <a:xfrm>
-            <a:off x="4434840" y="6172200"/>
-            <a:ext cx="3931920" cy="548640"/>
-          </a:xfrm>
-          <a:prstGeom prst="rect">
-            <a:avLst/>
-          </a:prstGeom>
-          <a:noFill/>
-          <a:ln/>
-        </p:spPr>
-        <p:txBody>
-          <a:bodyPr wrap="square" lIns="0" tIns="0" rIns="0" bIns="0" rtlCol="0" anchor="t"/>
-          <a:lstStyle/>
-          <a:p>
-            <a:pPr algn="ctr" indent="0" marL="0">
-              <a:lnSpc>
-                <a:spcPts val="1100"/>
-              </a:lnSpc>
-              <a:buNone/>
-            </a:pPr>
-            <a:r>
-              <a:rPr lang="en-US" sz="900" i="1" dirty="0">
-                <a:solidFill>
-                  <a:srgbClr val="5A5F73"/>
-                </a:solidFill>
-                <a:latin typeface="Calibri" pitchFamily="34" charset="0"/>
-                <a:ea typeface="Calibri" pitchFamily="34" charset="-122"/>
-                <a:cs typeface="Calibri" pitchFamily="34" charset="-120"/>
-              </a:rPr>
-              <a:t>Las herramientas del agente vuelven a entrar por los mismos adaptadores: leen el coche y escriben en el catálogo.</a:t>
-            </a:r>
-            <a:endParaRPr lang="en-US" sz="900" dirty="0"/>
-          </a:p>
-        </p:txBody>
-      </p:sp>
-      <p:sp>
-        <p:nvSpPr>
-          <p:cNvPr id="34" name="Shape 32"/>
-          <p:cNvSpPr/>
-          <p:nvPr/>
-        </p:nvSpPr>
-        <p:spPr>
-          <a:xfrm>
-            <a:off x="777240" y="6263640"/>
-            <a:ext cx="219456" cy="219456"/>
-          </a:xfrm>
-          <a:prstGeom prst="rect">
-            <a:avLst/>
-          </a:prstGeom>
-          <a:solidFill>
-            <a:srgbClr val="202CFC"/>
-          </a:solidFill>
-          <a:ln/>
-        </p:spPr>
-      </p:sp>
-      <p:sp>
-        <p:nvSpPr>
-          <p:cNvPr id="35" name="Text 33"/>
-          <p:cNvSpPr/>
-          <p:nvPr/>
-        </p:nvSpPr>
-        <p:spPr>
-          <a:xfrm>
-            <a:off x="777240" y="6263640"/>
-            <a:ext cx="219456" cy="219456"/>
+              <a:t>BIG</a:t>
+            </a:r>
+            <a:endParaRPr lang="en-US" sz="816" dirty="0"/>
+          </a:p>
+        </p:txBody>
+      </p:sp>
+      <p:sp>
+        <p:nvSpPr>
+          <p:cNvPr id="41" name="Text 39"/>
+          <p:cNvSpPr/>
+          <p:nvPr/>
+        </p:nvSpPr>
+        <p:spPr>
+          <a:xfrm>
+            <a:off x="1078992" y="6263640"/>
+            <a:ext cx="658368" cy="219456"/>
           </a:xfrm>
           <a:prstGeom prst="rect">
             <a:avLst/>
@@ -10878,19 +11112,19 @@
           <a:bodyPr wrap="square" lIns="0" tIns="0" rIns="0" bIns="0" rtlCol="0" anchor="ctr"/>
           <a:lstStyle/>
           <a:p>
-            <a:pPr algn="ctr" indent="0" marL="0">
-              <a:buNone/>
-            </a:pPr>
-            <a:r>
-              <a:rPr lang="en-US" sz="816" b="1" dirty="0">
-                <a:solidFill>
-                  <a:srgbClr val="FFFFFF"/>
+            <a:pPr algn="l" indent="0" marL="0">
+              <a:buNone/>
+            </a:pPr>
+            <a:r>
+              <a:rPr lang="en-US" sz="816" dirty="0">
+                <a:solidFill>
+                  <a:srgbClr val="1A1C2E"/>
                 </a:solidFill>
                 <a:latin typeface="Arial" pitchFamily="34" charset="0"/>
                 <a:ea typeface="Arial" pitchFamily="34" charset="-122"/>
                 <a:cs typeface="Arial" pitchFamily="34" charset="-120"/>
               </a:rPr>
-              <a:t>BIG</a:t>
+              <a:t>school</a:t>
             </a:r>
             <a:endParaRPr lang="en-US" sz="816" dirty="0"/>
           </a:p>
@@ -10898,46 +11132,7 @@
       </p:sp>
       <p:sp>
         <p:nvSpPr>
-          <p:cNvPr id="36" name="Text 34"/>
-          <p:cNvSpPr/>
-          <p:nvPr/>
-        </p:nvSpPr>
-        <p:spPr>
-          <a:xfrm>
-            <a:off x="1078992" y="6263640"/>
-            <a:ext cx="658368" cy="219456"/>
-          </a:xfrm>
-          <a:prstGeom prst="rect">
-            <a:avLst/>
-          </a:prstGeom>
-          <a:noFill/>
-          <a:ln/>
-        </p:spPr>
-        <p:txBody>
-          <a:bodyPr wrap="square" lIns="0" tIns="0" rIns="0" bIns="0" rtlCol="0" anchor="ctr"/>
-          <a:lstStyle/>
-          <a:p>
-            <a:pPr algn="l" indent="0" marL="0">
-              <a:buNone/>
-            </a:pPr>
-            <a:r>
-              <a:rPr lang="en-US" sz="816" dirty="0">
-                <a:solidFill>
-                  <a:srgbClr val="1A1C2E"/>
-                </a:solidFill>
-                <a:latin typeface="Arial" pitchFamily="34" charset="0"/>
-                <a:ea typeface="Arial" pitchFamily="34" charset="-122"/>
-                <a:cs typeface="Arial" pitchFamily="34" charset="-120"/>
-              </a:rPr>
-              <a:t>school</a:t>
-            </a:r>
-            <a:endParaRPr lang="en-US" sz="816" dirty="0"/>
-          </a:p>
-        </p:txBody>
-      </p:sp>
-      <p:sp>
-        <p:nvSpPr>
-          <p:cNvPr id="37" name="Text 35"/>
+          <p:cNvPr id="42" name="Text 40"/>
           <p:cNvSpPr/>
           <p:nvPr/>
         </p:nvSpPr>

</xml_diff>

<commit_message>
docs(tfm): quitar tecnologias del diagrama de flujo
</commit_message>
<xml_diff>
--- a/docs/presentacion/tfm-intelligent-automotive-diagnostics.pptx
+++ b/docs/presentacion/tfm-intelligent-automotive-diagnostics.pptx
@@ -9735,7 +9735,7 @@
                 <a:ea typeface="Calibri" pitchFamily="34" charset="-122"/>
                 <a:cs typeface="Calibri" pitchFamily="34" charset="-120"/>
               </a:rPr>
-              <a:t>Del conector físico del coche hasta el modelo. Todo entra por un puerto.</a:t>
+              <a:t>Quién llama a quién, del conector del coche hasta el modelo.</a:t>
             </a:r>
             <a:endParaRPr lang="en-US" sz="1400" dirty="0"/>
           </a:p>
@@ -9843,7 +9843,27 @@
                 <a:ea typeface="Calibri" pitchFamily="34" charset="-122"/>
                 <a:cs typeface="Calibri" pitchFamily="34" charset="-120"/>
               </a:rPr>
-              <a:t>React 19 · sesión JWT</a:t>
+              <a:t>consulta el coche</a:t>
+            </a:r>
+            <a:endParaRPr lang="en-US" sz="850" dirty="0"/>
+          </a:p>
+          <a:p>
+            <a:pPr algn="ctr" indent="0" marL="0">
+              <a:lnSpc>
+                <a:spcPts val="1050"/>
+              </a:lnSpc>
+              <a:buNone/>
+            </a:pPr>
+            <a:r>
+              <a:rPr lang="en-US" sz="850" dirty="0">
+                <a:solidFill>
+                  <a:srgbClr val="5A5F73"/>
+                </a:solidFill>
+                <a:latin typeface="Calibri" pitchFamily="34" charset="0"/>
+                <a:ea typeface="Calibri" pitchFamily="34" charset="-122"/>
+                <a:cs typeface="Calibri" pitchFamily="34" charset="-120"/>
+              </a:rPr>
+              <a:t>y pregunta al agente</a:t>
             </a:r>
             <a:endParaRPr lang="en-US" sz="850" dirty="0"/>
           </a:p>
@@ -9934,7 +9954,7 @@
                 <a:ea typeface="Arial" pitchFamily="34" charset="-122"/>
                 <a:cs typeface="Arial" pitchFamily="34" charset="-120"/>
               </a:rPr>
-              <a:t>API: casos de uso + dominio</a:t>
+              <a:t>El núcleo</a:t>
             </a:r>
             <a:endParaRPr lang="en-US" sz="1050" dirty="0"/>
           </a:p>
@@ -9976,7 +9996,7 @@
                 <a:ea typeface="Calibri" pitchFamily="34" charset="-122"/>
                 <a:cs typeface="Calibri" pitchFamily="34" charset="-120"/>
               </a:rPr>
-              <a:t>fórmulas SAE J1979 · catálogos · decodificación del VIN</a:t>
+              <a:t>casos de uso y reglas del dominio · decide qué se pide y valida lo que vuelve</a:t>
             </a:r>
             <a:endParaRPr lang="en-US" sz="850" dirty="0"/>
           </a:p>
@@ -10117,7 +10137,7 @@
                 <a:ea typeface="Arial" pitchFamily="34" charset="-122"/>
                 <a:cs typeface="Arial" pitchFamily="34" charset="-120"/>
               </a:rPr>
-              <a:t>Transporte OBD</a:t>
+              <a:t>Lectura del coche</a:t>
             </a:r>
             <a:endParaRPr lang="en-US" sz="1050" dirty="0"/>
           </a:p>
@@ -10159,7 +10179,7 @@
                 <a:ea typeface="Calibri" pitchFamily="34" charset="-122"/>
                 <a:cs typeface="Calibri" pitchFamily="34" charset="-120"/>
               </a:rPr>
-              <a:t>abre el puerto serie o el socket</a:t>
+              <a:t>pide modos y PIDs</a:t>
             </a:r>
             <a:endParaRPr lang="en-US" sz="850" dirty="0"/>
           </a:p>
@@ -10179,7 +10199,7 @@
                 <a:ea typeface="Calibri" pitchFamily="34" charset="-122"/>
                 <a:cs typeface="Calibri" pitchFamily="34" charset="-120"/>
               </a:rPr>
-              <a:t>y negocia el protocolo</a:t>
+              <a:t>y traduce lo que vuelve</a:t>
             </a:r>
             <a:endParaRPr lang="en-US" sz="850" dirty="0"/>
           </a:p>
@@ -10245,7 +10265,7 @@
                 <a:ea typeface="Arial" pitchFamily="34" charset="-122"/>
                 <a:cs typeface="Arial" pitchFamily="34" charset="-120"/>
               </a:rPr>
-              <a:t>Persistencia</a:t>
+              <a:t>Bases de datos</a:t>
             </a:r>
             <a:endParaRPr lang="en-US" sz="1050" dirty="0"/>
           </a:p>
@@ -10287,7 +10307,7 @@
                 <a:ea typeface="Calibri" pitchFamily="34" charset="-122"/>
                 <a:cs typeface="Calibri" pitchFamily="34" charset="-120"/>
               </a:rPr>
-              <a:t>SQLite · 13 tablas</a:t>
+              <a:t>la relacional</a:t>
             </a:r>
             <a:endParaRPr lang="en-US" sz="850" dirty="0"/>
           </a:p>
@@ -10307,7 +10327,7 @@
                 <a:ea typeface="Calibri" pitchFamily="34" charset="-122"/>
                 <a:cs typeface="Calibri" pitchFamily="34" charset="-120"/>
               </a:rPr>
-              <a:t>LanceDB · 4 índices</a:t>
+              <a:t>y la vectorial</a:t>
             </a:r>
             <a:endParaRPr lang="en-US" sz="850" dirty="0"/>
           </a:p>
@@ -10373,7 +10393,7 @@
                 <a:ea typeface="Arial" pitchFamily="34" charset="-122"/>
                 <a:cs typeface="Arial" pitchFamily="34" charset="-120"/>
               </a:rPr>
-              <a:t>Servidor MCP</a:t>
+              <a:t>Herramientas del agente</a:t>
             </a:r>
             <a:endParaRPr lang="en-US" sz="1050" dirty="0"/>
           </a:p>
@@ -10415,7 +10435,7 @@
                 <a:ea typeface="Calibri" pitchFamily="34" charset="-122"/>
                 <a:cs typeface="Calibri" pitchFamily="34" charset="-120"/>
               </a:rPr>
-              <a:t>16 herramientas</a:t>
+              <a:t>lo único que el modelo</a:t>
             </a:r>
             <a:endParaRPr lang="en-US" sz="850" dirty="0"/>
           </a:p>
@@ -10435,7 +10455,7 @@
                 <a:ea typeface="Calibri" pitchFamily="34" charset="-122"/>
                 <a:cs typeface="Calibri" pitchFamily="34" charset="-120"/>
               </a:rPr>
-              <a:t>declaradas con su esquema</a:t>
+              <a:t>puede llegar a pedir</a:t>
             </a:r>
             <a:endParaRPr lang="en-US" sz="850" dirty="0"/>
           </a:p>
@@ -10599,7 +10619,7 @@
                 <a:ea typeface="Arial" pitchFamily="34" charset="-122"/>
                 <a:cs typeface="Arial" pitchFamily="34" charset="-120"/>
               </a:rPr>
-              <a:t>Dongle ELM327</a:t>
+              <a:t>El adaptador</a:t>
             </a:r>
             <a:endParaRPr lang="en-US" sz="1050" dirty="0"/>
           </a:p>
@@ -10641,7 +10661,7 @@
                 <a:ea typeface="Calibri" pitchFamily="34" charset="-122"/>
                 <a:cs typeface="Calibri" pitchFamily="34" charset="-120"/>
               </a:rPr>
-              <a:t>enchufado al conector OBD-II</a:t>
+              <a:t>enchufado al conector</a:t>
             </a:r>
             <a:endParaRPr lang="en-US" sz="850" dirty="0"/>
           </a:p>
@@ -10661,7 +10681,7 @@
                 <a:ea typeface="Calibri" pitchFamily="34" charset="-122"/>
                 <a:cs typeface="Calibri" pitchFamily="34" charset="-120"/>
               </a:rPr>
-              <a:t>del coche · USB o WiFi</a:t>
+              <a:t>de diagnóstico del coche</a:t>
             </a:r>
             <a:endParaRPr lang="en-US" sz="850" dirty="0"/>
           </a:p>
@@ -10769,7 +10789,7 @@
                 <a:ea typeface="Calibri" pitchFamily="34" charset="-122"/>
                 <a:cs typeface="Calibri" pitchFamily="34" charset="-120"/>
               </a:rPr>
-              <a:t>Anthropic u OpenAI</a:t>
+              <a:t>razona y va pidiendo</a:t>
             </a:r>
             <a:endParaRPr lang="en-US" sz="850" dirty="0"/>
           </a:p>
@@ -10789,7 +10809,7 @@
                 <a:ea typeface="Calibri" pitchFamily="34" charset="-122"/>
                 <a:cs typeface="Calibri" pitchFamily="34" charset="-120"/>
               </a:rPr>
-              <a:t>y búsqueda web con presupuesto</a:t>
+              <a:t>las herramientas que necesita</a:t>
             </a:r>
             <a:endParaRPr lang="en-US" sz="850" dirty="0"/>
           </a:p>
@@ -10922,7 +10942,7 @@
                 <a:ea typeface="Calibri" pitchFamily="34" charset="-122"/>
                 <a:cs typeface="Calibri" pitchFamily="34" charset="-120"/>
               </a:rPr>
-              <a:t>bus CAN · ISO 15765-4</a:t>
+              <a:t>el motor y el resto</a:t>
             </a:r>
             <a:endParaRPr lang="en-US" sz="850" dirty="0"/>
           </a:p>
@@ -10942,7 +10962,7 @@
                 <a:ea typeface="Calibri" pitchFamily="34" charset="-122"/>
                 <a:cs typeface="Calibri" pitchFamily="34" charset="-120"/>
               </a:rPr>
-              <a:t>centralita del motor y las demás</a:t>
+              <a:t>de centralitas</a:t>
             </a:r>
             <a:endParaRPr lang="en-US" sz="850" dirty="0"/>
           </a:p>
@@ -10984,7 +11004,7 @@
                 <a:ea typeface="Calibri" pitchFamily="34" charset="-122"/>
                 <a:cs typeface="Calibri" pitchFamily="34" charset="-120"/>
               </a:rPr>
-              <a:t>En la demo, este tramo se sustituye por tres emuladores ELM327 escuchando en tres puertos TCP.</a:t>
+              <a:t>En la demo este tramo va emulado. De aquí para arriba, todo es idéntico.</a:t>
             </a:r>
             <a:endParaRPr lang="en-US" sz="900" dirty="0"/>
           </a:p>

</xml_diff>

<commit_message>
docs(tfm): rehacer como flujo de trabajo desde el arranque
</commit_message>
<xml_diff>
--- a/docs/presentacion/tfm-intelligent-automotive-diagnostics.pptx
+++ b/docs/presentacion/tfm-intelligent-automotive-diagnostics.pptx
@@ -1627,13 +1627,13 @@
           <a:p>
             <a:r>
               <a:rPr lang="en-US" dirty="0"/>
-              <a:t>Esta es la foto entera, de abajo a arriba.
-Abajo del todo, el coche de verdad: su bus CAN y las centralitas. Encima, el punto donde esto se conecta al mundo físico, que es el dongle ELM327 enchufado al conector OBD-II del coche, ese que está debajo del volante. Se une al portátil por USB o por WiFi. Los dos van en azul porque son las dos únicas piezas que no son código mío.
-De ahí para arriba ya es software. El transporte OBD abre el puerto serie o el socket, negocia el protocolo del bus y traduce comandos. La persistencia guarda lo relacional en SQLite y lo vectorial en LanceDB. Y el servidor MCP expone las dieciséis herramientas al modelo, que está a la derecha.
-En el centro, en oscuro, el núcleo: los casos de uso y el dominio, con las fórmulas de la norma y los catálogos. Ese bloque no sabe nada de lo que hay debajo. Y arriba el mecánico, con la interfaz.
-Dos detalles. Las flechas son de ida y vuelta porque todo son peticiones y respuestas. Y las discontinuas del centro son lo que hace que esto sea un sistema y no una tubería: cuando el agente pide una herramienta, vuelve a entrar por los mismos adaptadores. Lee el coche por el mismo transporte y escribe en el mismo catálogo. No hay puerta trasera para la IA.
-Para la demo de hoy, el tramo físico se sustituye por tres emuladores ELM327 escuchando en tres puertos TCP. Todo lo de arriba es idéntico.
-[~80 s · acumulado 3:00]</a:t>
+              <a:t>Este es el recorrido de trabajo, de principio a fin.
+Empieza donde empieza de verdad: se enchufa el adaptador al conector de diagnóstico del coche y se pulsa iniciar. A partir de ahí va solo.
+Lo primero, preguntarle al coche el bastidor para saber qué vehículo es. Después un barrido del bus, para ver qué centralitas responden. Luego se leen los datos en vivo, los códigos de avería y el freeze frame. Y con eso se calcula la severidad y sale todo en pantalla.
+Fijaos en la línea: hasta ese punto no ha intervenido la IA. Si no hay modelo configurado, o si el taller no tiene internet, el mecánico ya tiene su diagnóstico.
+De ahí para abajo es opcional, y solo pasa si el mecánico pregunta al agente. Antes de llamarlo se buscan casos parecidos de diagnósticos anteriores. El agente pide lo que le falta: mirar el catálogo, leer más cosas del coche, o buscar en la web. Y responde con la explicación, la severidad y qué conviene revisar.
+Y el último paso es el que hace que esto crezca: el caso se guarda, y queda disponible para el siguiente coche que entre con síntomas parecidos.
+[~75 s · acumulado 2:55]</a:t>
             </a:r>
             <a:endParaRPr lang="en-US" dirty="0"/>
           </a:p>
@@ -9671,8 +9671,8 @@
         </p:nvSpPr>
         <p:spPr>
           <a:xfrm>
-            <a:off x="640080" y="365760"/>
-            <a:ext cx="10881360" cy="594360"/>
+            <a:off x="777240" y="457200"/>
+            <a:ext cx="10607040" cy="640080"/>
           </a:xfrm>
           <a:prstGeom prst="rect">
             <a:avLst/>
@@ -9688,7 +9688,7 @@
               <a:buNone/>
             </a:pPr>
             <a:r>
-              <a:rPr lang="en-US" sz="2900" b="1" dirty="0">
+              <a:rPr lang="en-US" sz="3200" b="1" dirty="0">
                 <a:solidFill>
                   <a:srgbClr val="1A1C2E"/>
                 </a:solidFill>
@@ -9696,9 +9696,9 @@
                 <a:ea typeface="Arial" pitchFamily="34" charset="-122"/>
                 <a:cs typeface="Arial" pitchFamily="34" charset="-120"/>
               </a:rPr>
-              <a:t>El sistema de un vistazo</a:t>
-            </a:r>
-            <a:endParaRPr lang="en-US" sz="2900" dirty="0"/>
+              <a:t>El flujo de trabajo</a:t>
+            </a:r>
+            <a:endParaRPr lang="en-US" sz="3200" dirty="0"/>
           </a:p>
         </p:txBody>
       </p:sp>
@@ -9710,8 +9710,8 @@
         </p:nvSpPr>
         <p:spPr>
           <a:xfrm>
-            <a:off x="640080" y="1024128"/>
-            <a:ext cx="10881360" cy="274320"/>
+            <a:off x="777240" y="1188720"/>
+            <a:ext cx="10607040" cy="320040"/>
           </a:xfrm>
           <a:prstGeom prst="rect">
             <a:avLst/>
@@ -9727,7 +9727,7 @@
               <a:buNone/>
             </a:pPr>
             <a:r>
-              <a:rPr lang="en-US" sz="1400" dirty="0">
+              <a:rPr lang="en-US" sz="1500" dirty="0">
                 <a:solidFill>
                   <a:srgbClr val="5A5F73"/>
                 </a:solidFill>
@@ -9735,9 +9735,9 @@
                 <a:ea typeface="Calibri" pitchFamily="34" charset="-122"/>
                 <a:cs typeface="Calibri" pitchFamily="34" charset="-120"/>
               </a:rPr>
-              <a:t>Quién llama a quién, del conector del coche hasta el modelo.</a:t>
-            </a:r>
-            <a:endParaRPr lang="en-US" sz="1400" dirty="0"/>
+              <a:t>Qué pasa desde que enchufas el adaptador hasta que el caso queda guardado.</a:t>
+            </a:r>
+            <a:endParaRPr lang="en-US" sz="1500" dirty="0"/>
           </a:p>
         </p:txBody>
       </p:sp>
@@ -9749,18 +9749,14 @@
         </p:nvSpPr>
         <p:spPr>
           <a:xfrm>
-            <a:off x="4709160" y="1417320"/>
-            <a:ext cx="2743200" cy="603504"/>
-          </a:xfrm>
-          <a:prstGeom prst="roundRect">
-            <a:avLst>
-              <a:gd name="adj" fmla="val 7576"/>
-            </a:avLst>
-          </a:prstGeom>
-          <a:solidFill>
-            <a:srgbClr val="FFFFFF"/>
-          </a:solidFill>
-          <a:ln w="12700">
+            <a:off x="1234440" y="2075688"/>
+            <a:ext cx="0" cy="3803904"/>
+          </a:xfrm>
+          <a:prstGeom prst="line">
+            <a:avLst/>
+          </a:prstGeom>
+          <a:noFill/>
+          <a:ln w="19050">
             <a:solidFill>
               <a:srgbClr val="C9CCD8"/>
             </a:solidFill>
@@ -9770,14 +9766,34 @@
       </p:sp>
       <p:sp>
         <p:nvSpPr>
-          <p:cNvPr id="5" name="Text 3"/>
-          <p:cNvSpPr/>
-          <p:nvPr/>
-        </p:nvSpPr>
-        <p:spPr>
-          <a:xfrm>
-            <a:off x="4782312" y="1490472"/>
-            <a:ext cx="2596896" cy="237744"/>
+          <p:cNvPr id="5" name="Shape 3"/>
+          <p:cNvSpPr/>
+          <p:nvPr/>
+        </p:nvSpPr>
+        <p:spPr>
+          <a:xfrm>
+            <a:off x="1078992" y="1920240"/>
+            <a:ext cx="310896" cy="310896"/>
+          </a:xfrm>
+          <a:prstGeom prst="ellipse">
+            <a:avLst/>
+          </a:prstGeom>
+          <a:solidFill>
+            <a:srgbClr val="202CFC"/>
+          </a:solidFill>
+          <a:ln/>
+        </p:spPr>
+      </p:sp>
+      <p:sp>
+        <p:nvSpPr>
+          <p:cNvPr id="6" name="Text 4"/>
+          <p:cNvSpPr/>
+          <p:nvPr/>
+        </p:nvSpPr>
+        <p:spPr>
+          <a:xfrm>
+            <a:off x="1078992" y="1920240"/>
+            <a:ext cx="310896" cy="310896"/>
           </a:xfrm>
           <a:prstGeom prst="rect">
             <a:avLst/>
@@ -9793,160 +9809,105 @@
               <a:buNone/>
             </a:pPr>
             <a:r>
-              <a:rPr lang="en-US" sz="1050" b="1" dirty="0">
-                <a:solidFill>
-                  <a:srgbClr val="1A1C2E"/>
+              <a:rPr lang="en-US" sz="1100" b="1" dirty="0">
+                <a:solidFill>
+                  <a:srgbClr val="FFFFFF"/>
                 </a:solidFill>
                 <a:latin typeface="Arial" pitchFamily="34" charset="0"/>
                 <a:ea typeface="Arial" pitchFamily="34" charset="-122"/>
                 <a:cs typeface="Arial" pitchFamily="34" charset="-120"/>
               </a:rPr>
-              <a:t>El mecánico</a:t>
-            </a:r>
-            <a:endParaRPr lang="en-US" sz="1050" dirty="0"/>
-          </a:p>
-        </p:txBody>
-      </p:sp>
-      <p:sp>
-        <p:nvSpPr>
-          <p:cNvPr id="6" name="Text 4"/>
-          <p:cNvSpPr/>
-          <p:nvPr/>
-        </p:nvSpPr>
-        <p:spPr>
-          <a:xfrm>
-            <a:off x="4782312" y="1728216"/>
-            <a:ext cx="2596896" cy="365760"/>
-          </a:xfrm>
-          <a:prstGeom prst="rect">
-            <a:avLst/>
-          </a:prstGeom>
-          <a:noFill/>
-          <a:ln/>
-        </p:spPr>
-        <p:txBody>
-          <a:bodyPr wrap="square" lIns="0" tIns="0" rIns="0" bIns="0" rtlCol="0" anchor="t"/>
+              <a:t>1</a:t>
+            </a:r>
+            <a:endParaRPr lang="en-US" sz="1100" dirty="0"/>
+          </a:p>
+        </p:txBody>
+      </p:sp>
+      <p:sp>
+        <p:nvSpPr>
+          <p:cNvPr id="7" name="Text 5"/>
+          <p:cNvSpPr/>
+          <p:nvPr/>
+        </p:nvSpPr>
+        <p:spPr>
+          <a:xfrm>
+            <a:off x="1618488" y="1901952"/>
+            <a:ext cx="9601200" cy="365760"/>
+          </a:xfrm>
+          <a:prstGeom prst="rect">
+            <a:avLst/>
+          </a:prstGeom>
+          <a:noFill/>
+          <a:ln/>
+        </p:spPr>
+        <p:txBody>
+          <a:bodyPr wrap="square" lIns="0" tIns="0" rIns="0" bIns="0" rtlCol="0" anchor="ctr"/>
+          <a:lstStyle/>
+          <a:p>
+            <a:pPr indent="0" marL="0">
+              <a:buNone/>
+            </a:pPr>
+            <a:r>
+              <a:rPr lang="en-US" sz="1500" dirty="0">
+                <a:solidFill>
+                  <a:srgbClr val="1A1C2E"/>
+                </a:solidFill>
+                <a:latin typeface="Calibri" pitchFamily="34" charset="0"/>
+                <a:ea typeface="Calibri" pitchFamily="34" charset="-122"/>
+                <a:cs typeface="Calibri" pitchFamily="34" charset="-120"/>
+              </a:rPr>
+              <a:t>Se enchufa el adaptador al coche y se pulsa «Iniciar diagnóstico»</a:t>
+            </a:r>
+            <a:endParaRPr lang="en-US" sz="1500" dirty="0"/>
+          </a:p>
+        </p:txBody>
+      </p:sp>
+      <p:sp>
+        <p:nvSpPr>
+          <p:cNvPr id="8" name="Shape 6"/>
+          <p:cNvSpPr/>
+          <p:nvPr/>
+        </p:nvSpPr>
+        <p:spPr>
+          <a:xfrm>
+            <a:off x="1078992" y="2395728"/>
+            <a:ext cx="310896" cy="310896"/>
+          </a:xfrm>
+          <a:prstGeom prst="ellipse">
+            <a:avLst/>
+          </a:prstGeom>
+          <a:solidFill>
+            <a:srgbClr val="202CFC"/>
+          </a:solidFill>
+          <a:ln/>
+        </p:spPr>
+      </p:sp>
+      <p:sp>
+        <p:nvSpPr>
+          <p:cNvPr id="9" name="Text 7"/>
+          <p:cNvSpPr/>
+          <p:nvPr/>
+        </p:nvSpPr>
+        <p:spPr>
+          <a:xfrm>
+            <a:off x="1078992" y="2395728"/>
+            <a:ext cx="310896" cy="310896"/>
+          </a:xfrm>
+          <a:prstGeom prst="rect">
+            <a:avLst/>
+          </a:prstGeom>
+          <a:noFill/>
+          <a:ln/>
+        </p:spPr>
+        <p:txBody>
+          <a:bodyPr wrap="square" lIns="0" tIns="0" rIns="0" bIns="0" rtlCol="0" anchor="ctr"/>
           <a:lstStyle/>
           <a:p>
             <a:pPr algn="ctr" indent="0" marL="0">
-              <a:lnSpc>
-                <a:spcPts val="1050"/>
-              </a:lnSpc>
-              <a:buNone/>
-            </a:pPr>
-            <a:r>
-              <a:rPr lang="en-US" sz="850" dirty="0">
-                <a:solidFill>
-                  <a:srgbClr val="5A5F73"/>
-                </a:solidFill>
-                <a:latin typeface="Calibri" pitchFamily="34" charset="0"/>
-                <a:ea typeface="Calibri" pitchFamily="34" charset="-122"/>
-                <a:cs typeface="Calibri" pitchFamily="34" charset="-120"/>
-              </a:rPr>
-              <a:t>consulta el coche</a:t>
-            </a:r>
-            <a:endParaRPr lang="en-US" sz="850" dirty="0"/>
-          </a:p>
-          <a:p>
-            <a:pPr algn="ctr" indent="0" marL="0">
-              <a:lnSpc>
-                <a:spcPts val="1050"/>
-              </a:lnSpc>
-              <a:buNone/>
-            </a:pPr>
-            <a:r>
-              <a:rPr lang="en-US" sz="850" dirty="0">
-                <a:solidFill>
-                  <a:srgbClr val="5A5F73"/>
-                </a:solidFill>
-                <a:latin typeface="Calibri" pitchFamily="34" charset="0"/>
-                <a:ea typeface="Calibri" pitchFamily="34" charset="-122"/>
-                <a:cs typeface="Calibri" pitchFamily="34" charset="-120"/>
-              </a:rPr>
-              <a:t>y pregunta al agente</a:t>
-            </a:r>
-            <a:endParaRPr lang="en-US" sz="850" dirty="0"/>
-          </a:p>
-        </p:txBody>
-      </p:sp>
-      <p:sp>
-        <p:nvSpPr>
-          <p:cNvPr id="7" name="Shape 5"/>
-          <p:cNvSpPr/>
-          <p:nvPr/>
-        </p:nvSpPr>
-        <p:spPr>
-          <a:xfrm>
-            <a:off x="6080760" y="2020824"/>
-            <a:ext cx="0" cy="283464"/>
-          </a:xfrm>
-          <a:prstGeom prst="line">
-            <a:avLst/>
-          </a:prstGeom>
-          <a:noFill/>
-          <a:ln w="15875">
-            <a:solidFill>
-              <a:srgbClr val="202CFC"/>
-            </a:solidFill>
-            <a:prstDash val="solid"/>
-            <a:headEnd type="triangle"/>
-            <a:tailEnd type="triangle"/>
-          </a:ln>
-        </p:spPr>
-      </p:sp>
-      <p:sp>
-        <p:nvSpPr>
-          <p:cNvPr id="8" name="Shape 6"/>
-          <p:cNvSpPr/>
-          <p:nvPr/>
-        </p:nvSpPr>
-        <p:spPr>
-          <a:xfrm>
-            <a:off x="960120" y="2304288"/>
-            <a:ext cx="10881360" cy="713232"/>
-          </a:xfrm>
-          <a:prstGeom prst="roundRect">
-            <a:avLst>
-              <a:gd name="adj" fmla="val 6410"/>
-            </a:avLst>
-          </a:prstGeom>
-          <a:solidFill>
-            <a:srgbClr val="1A1C2E"/>
-          </a:solidFill>
-          <a:ln w="12700">
-            <a:solidFill>
-              <a:srgbClr val="1A1C2E"/>
-            </a:solidFill>
-            <a:prstDash val="solid"/>
-          </a:ln>
-        </p:spPr>
-      </p:sp>
-      <p:sp>
-        <p:nvSpPr>
-          <p:cNvPr id="9" name="Text 7"/>
-          <p:cNvSpPr/>
-          <p:nvPr/>
-        </p:nvSpPr>
-        <p:spPr>
-          <a:xfrm>
-            <a:off x="1033272" y="2377440"/>
-            <a:ext cx="10735056" cy="237744"/>
-          </a:xfrm>
-          <a:prstGeom prst="rect">
-            <a:avLst/>
-          </a:prstGeom>
-          <a:noFill/>
-          <a:ln/>
-        </p:spPr>
-        <p:txBody>
-          <a:bodyPr wrap="square" lIns="0" tIns="0" rIns="0" bIns="0" rtlCol="0" anchor="ctr"/>
-          <a:lstStyle/>
-          <a:p>
-            <a:pPr algn="ctr" indent="0" marL="0">
-              <a:buNone/>
-            </a:pPr>
-            <a:r>
-              <a:rPr lang="en-US" sz="1050" b="1" dirty="0">
+              <a:buNone/>
+            </a:pPr>
+            <a:r>
+              <a:rPr lang="en-US" sz="1100" b="1" dirty="0">
                 <a:solidFill>
                   <a:srgbClr val="FFFFFF"/>
                 </a:solidFill>
@@ -9954,9 +9915,9 @@
                 <a:ea typeface="Arial" pitchFamily="34" charset="-122"/>
                 <a:cs typeface="Arial" pitchFamily="34" charset="-120"/>
               </a:rPr>
-              <a:t>El núcleo</a:t>
-            </a:r>
-            <a:endParaRPr lang="en-US" sz="1050" dirty="0"/>
+              <a:t>2</a:t>
+            </a:r>
+            <a:endParaRPr lang="en-US" sz="1100" dirty="0"/>
           </a:p>
         </p:txBody>
       </p:sp>
@@ -9968,1102 +9929,637 @@
         </p:nvSpPr>
         <p:spPr>
           <a:xfrm>
-            <a:off x="1033272" y="2615184"/>
-            <a:ext cx="10735056" cy="365760"/>
-          </a:xfrm>
-          <a:prstGeom prst="rect">
-            <a:avLst/>
-          </a:prstGeom>
-          <a:noFill/>
-          <a:ln/>
-        </p:spPr>
-        <p:txBody>
-          <a:bodyPr wrap="square" lIns="0" tIns="0" rIns="0" bIns="0" rtlCol="0" anchor="t"/>
+            <a:off x="1618488" y="2377440"/>
+            <a:ext cx="9601200" cy="365760"/>
+          </a:xfrm>
+          <a:prstGeom prst="rect">
+            <a:avLst/>
+          </a:prstGeom>
+          <a:noFill/>
+          <a:ln/>
+        </p:spPr>
+        <p:txBody>
+          <a:bodyPr wrap="square" lIns="0" tIns="0" rIns="0" bIns="0" rtlCol="0" anchor="ctr"/>
+          <a:lstStyle/>
+          <a:p>
+            <a:pPr indent="0" marL="0">
+              <a:buNone/>
+            </a:pPr>
+            <a:r>
+              <a:rPr lang="en-US" sz="1500" dirty="0">
+                <a:solidFill>
+                  <a:srgbClr val="1A1C2E"/>
+                </a:solidFill>
+                <a:latin typeface="Calibri" pitchFamily="34" charset="0"/>
+                <a:ea typeface="Calibri" pitchFamily="34" charset="-122"/>
+                <a:cs typeface="Calibri" pitchFamily="34" charset="-120"/>
+              </a:rPr>
+              <a:t>Se pregunta el bastidor y se identifica el vehículo</a:t>
+            </a:r>
+            <a:endParaRPr lang="en-US" sz="1500" dirty="0"/>
+          </a:p>
+        </p:txBody>
+      </p:sp>
+      <p:sp>
+        <p:nvSpPr>
+          <p:cNvPr id="11" name="Shape 9"/>
+          <p:cNvSpPr/>
+          <p:nvPr/>
+        </p:nvSpPr>
+        <p:spPr>
+          <a:xfrm>
+            <a:off x="1078992" y="2871216"/>
+            <a:ext cx="310896" cy="310896"/>
+          </a:xfrm>
+          <a:prstGeom prst="ellipse">
+            <a:avLst/>
+          </a:prstGeom>
+          <a:solidFill>
+            <a:srgbClr val="202CFC"/>
+          </a:solidFill>
+          <a:ln/>
+        </p:spPr>
+      </p:sp>
+      <p:sp>
+        <p:nvSpPr>
+          <p:cNvPr id="12" name="Text 10"/>
+          <p:cNvSpPr/>
+          <p:nvPr/>
+        </p:nvSpPr>
+        <p:spPr>
+          <a:xfrm>
+            <a:off x="1078992" y="2871216"/>
+            <a:ext cx="310896" cy="310896"/>
+          </a:xfrm>
+          <a:prstGeom prst="rect">
+            <a:avLst/>
+          </a:prstGeom>
+          <a:noFill/>
+          <a:ln/>
+        </p:spPr>
+        <p:txBody>
+          <a:bodyPr wrap="square" lIns="0" tIns="0" rIns="0" bIns="0" rtlCol="0" anchor="ctr"/>
           <a:lstStyle/>
           <a:p>
             <a:pPr algn="ctr" indent="0" marL="0">
-              <a:lnSpc>
-                <a:spcPts val="1050"/>
-              </a:lnSpc>
-              <a:buNone/>
-            </a:pPr>
-            <a:r>
-              <a:rPr lang="en-US" sz="850" dirty="0">
-                <a:solidFill>
-                  <a:srgbClr val="B8BCCC"/>
-                </a:solidFill>
-                <a:latin typeface="Calibri" pitchFamily="34" charset="0"/>
-                <a:ea typeface="Calibri" pitchFamily="34" charset="-122"/>
-                <a:cs typeface="Calibri" pitchFamily="34" charset="-120"/>
-              </a:rPr>
-              <a:t>casos de uso y reglas del dominio · decide qué se pide y valida lo que vuelve</a:t>
-            </a:r>
-            <a:endParaRPr lang="en-US" sz="850" dirty="0"/>
-          </a:p>
-        </p:txBody>
-      </p:sp>
-      <p:sp>
-        <p:nvSpPr>
-          <p:cNvPr id="11" name="Shape 9"/>
-          <p:cNvSpPr/>
-          <p:nvPr/>
-        </p:nvSpPr>
-        <p:spPr>
-          <a:xfrm>
-            <a:off x="2560320" y="3017520"/>
-            <a:ext cx="0" cy="292608"/>
-          </a:xfrm>
-          <a:prstGeom prst="line">
-            <a:avLst/>
-          </a:prstGeom>
-          <a:noFill/>
-          <a:ln w="15875">
-            <a:solidFill>
-              <a:srgbClr val="202CFC"/>
-            </a:solidFill>
-            <a:prstDash val="solid"/>
-            <a:headEnd type="triangle"/>
-            <a:tailEnd type="triangle"/>
-          </a:ln>
-        </p:spPr>
-      </p:sp>
-      <p:sp>
-        <p:nvSpPr>
-          <p:cNvPr id="12" name="Shape 10"/>
-          <p:cNvSpPr/>
-          <p:nvPr/>
-        </p:nvSpPr>
-        <p:spPr>
-          <a:xfrm>
-            <a:off x="6400800" y="3017520"/>
-            <a:ext cx="0" cy="292608"/>
-          </a:xfrm>
-          <a:prstGeom prst="line">
-            <a:avLst/>
-          </a:prstGeom>
-          <a:noFill/>
-          <a:ln w="15875">
-            <a:solidFill>
-              <a:srgbClr val="202CFC"/>
-            </a:solidFill>
-            <a:prstDash val="solid"/>
-            <a:headEnd type="triangle"/>
-            <a:tailEnd type="triangle"/>
-          </a:ln>
-        </p:spPr>
-      </p:sp>
-      <p:sp>
-        <p:nvSpPr>
-          <p:cNvPr id="13" name="Shape 11"/>
-          <p:cNvSpPr/>
-          <p:nvPr/>
-        </p:nvSpPr>
-        <p:spPr>
-          <a:xfrm>
-            <a:off x="10241280" y="3017520"/>
-            <a:ext cx="0" cy="292608"/>
-          </a:xfrm>
-          <a:prstGeom prst="line">
-            <a:avLst/>
-          </a:prstGeom>
-          <a:noFill/>
-          <a:ln w="15875">
-            <a:solidFill>
-              <a:srgbClr val="202CFC"/>
-            </a:solidFill>
-            <a:prstDash val="solid"/>
-            <a:headEnd type="triangle"/>
-            <a:tailEnd type="triangle"/>
-          </a:ln>
-        </p:spPr>
-      </p:sp>
-      <p:sp>
-        <p:nvSpPr>
-          <p:cNvPr id="14" name="Shape 12"/>
-          <p:cNvSpPr/>
-          <p:nvPr/>
-        </p:nvSpPr>
-        <p:spPr>
-          <a:xfrm>
-            <a:off x="960120" y="3310128"/>
-            <a:ext cx="3200400" cy="795528"/>
-          </a:xfrm>
-          <a:prstGeom prst="roundRect">
-            <a:avLst>
-              <a:gd name="adj" fmla="val 5747"/>
-            </a:avLst>
-          </a:prstGeom>
-          <a:solidFill>
-            <a:srgbClr val="FFFFFF"/>
-          </a:solidFill>
-          <a:ln w="12700">
-            <a:solidFill>
-              <a:srgbClr val="C9CCD8"/>
-            </a:solidFill>
-            <a:prstDash val="solid"/>
-          </a:ln>
-        </p:spPr>
-      </p:sp>
-      <p:sp>
-        <p:nvSpPr>
-          <p:cNvPr id="15" name="Text 13"/>
-          <p:cNvSpPr/>
-          <p:nvPr/>
-        </p:nvSpPr>
-        <p:spPr>
-          <a:xfrm>
-            <a:off x="1033272" y="3383280"/>
-            <a:ext cx="3054096" cy="237744"/>
-          </a:xfrm>
-          <a:prstGeom prst="rect">
-            <a:avLst/>
-          </a:prstGeom>
-          <a:noFill/>
-          <a:ln/>
-        </p:spPr>
-        <p:txBody>
-          <a:bodyPr wrap="square" lIns="0" tIns="0" rIns="0" bIns="0" rtlCol="0" anchor="ctr"/>
-          <a:lstStyle/>
-          <a:p>
-            <a:pPr algn="ctr" indent="0" marL="0">
-              <a:buNone/>
-            </a:pPr>
-            <a:r>
-              <a:rPr lang="en-US" sz="1050" b="1" dirty="0">
-                <a:solidFill>
-                  <a:srgbClr val="1A1C2E"/>
+              <a:buNone/>
+            </a:pPr>
+            <a:r>
+              <a:rPr lang="en-US" sz="1100" b="1" dirty="0">
+                <a:solidFill>
+                  <a:srgbClr val="FFFFFF"/>
                 </a:solidFill>
                 <a:latin typeface="Arial" pitchFamily="34" charset="0"/>
                 <a:ea typeface="Arial" pitchFamily="34" charset="-122"/>
                 <a:cs typeface="Arial" pitchFamily="34" charset="-120"/>
               </a:rPr>
-              <a:t>Lectura del coche</a:t>
-            </a:r>
-            <a:endParaRPr lang="en-US" sz="1050" dirty="0"/>
-          </a:p>
-        </p:txBody>
-      </p:sp>
-      <p:sp>
-        <p:nvSpPr>
-          <p:cNvPr id="16" name="Text 14"/>
-          <p:cNvSpPr/>
-          <p:nvPr/>
-        </p:nvSpPr>
-        <p:spPr>
-          <a:xfrm>
-            <a:off x="1033272" y="3621024"/>
-            <a:ext cx="3054096" cy="365760"/>
-          </a:xfrm>
-          <a:prstGeom prst="rect">
-            <a:avLst/>
-          </a:prstGeom>
-          <a:noFill/>
-          <a:ln/>
-        </p:spPr>
-        <p:txBody>
-          <a:bodyPr wrap="square" lIns="0" tIns="0" rIns="0" bIns="0" rtlCol="0" anchor="t"/>
+              <a:t>3</a:t>
+            </a:r>
+            <a:endParaRPr lang="en-US" sz="1100" dirty="0"/>
+          </a:p>
+        </p:txBody>
+      </p:sp>
+      <p:sp>
+        <p:nvSpPr>
+          <p:cNvPr id="13" name="Text 11"/>
+          <p:cNvSpPr/>
+          <p:nvPr/>
+        </p:nvSpPr>
+        <p:spPr>
+          <a:xfrm>
+            <a:off x="1618488" y="2852928"/>
+            <a:ext cx="9601200" cy="365760"/>
+          </a:xfrm>
+          <a:prstGeom prst="rect">
+            <a:avLst/>
+          </a:prstGeom>
+          <a:noFill/>
+          <a:ln/>
+        </p:spPr>
+        <p:txBody>
+          <a:bodyPr wrap="square" lIns="0" tIns="0" rIns="0" bIns="0" rtlCol="0" anchor="ctr"/>
+          <a:lstStyle/>
+          <a:p>
+            <a:pPr indent="0" marL="0">
+              <a:buNone/>
+            </a:pPr>
+            <a:r>
+              <a:rPr lang="en-US" sz="1500" dirty="0">
+                <a:solidFill>
+                  <a:srgbClr val="1A1C2E"/>
+                </a:solidFill>
+                <a:latin typeface="Calibri" pitchFamily="34" charset="0"/>
+                <a:ea typeface="Calibri" pitchFamily="34" charset="-122"/>
+                <a:cs typeface="Calibri" pitchFamily="34" charset="-120"/>
+              </a:rPr>
+              <a:t>Se barre el bus para ver qué centralitas responden</a:t>
+            </a:r>
+            <a:endParaRPr lang="en-US" sz="1500" dirty="0"/>
+          </a:p>
+        </p:txBody>
+      </p:sp>
+      <p:sp>
+        <p:nvSpPr>
+          <p:cNvPr id="14" name="Shape 12"/>
+          <p:cNvSpPr/>
+          <p:nvPr/>
+        </p:nvSpPr>
+        <p:spPr>
+          <a:xfrm>
+            <a:off x="1078992" y="3346704"/>
+            <a:ext cx="310896" cy="310896"/>
+          </a:xfrm>
+          <a:prstGeom prst="ellipse">
+            <a:avLst/>
+          </a:prstGeom>
+          <a:solidFill>
+            <a:srgbClr val="202CFC"/>
+          </a:solidFill>
+          <a:ln/>
+        </p:spPr>
+      </p:sp>
+      <p:sp>
+        <p:nvSpPr>
+          <p:cNvPr id="15" name="Text 13"/>
+          <p:cNvSpPr/>
+          <p:nvPr/>
+        </p:nvSpPr>
+        <p:spPr>
+          <a:xfrm>
+            <a:off x="1078992" y="3346704"/>
+            <a:ext cx="310896" cy="310896"/>
+          </a:xfrm>
+          <a:prstGeom prst="rect">
+            <a:avLst/>
+          </a:prstGeom>
+          <a:noFill/>
+          <a:ln/>
+        </p:spPr>
+        <p:txBody>
+          <a:bodyPr wrap="square" lIns="0" tIns="0" rIns="0" bIns="0" rtlCol="0" anchor="ctr"/>
           <a:lstStyle/>
           <a:p>
             <a:pPr algn="ctr" indent="0" marL="0">
-              <a:lnSpc>
-                <a:spcPts val="1050"/>
-              </a:lnSpc>
-              <a:buNone/>
-            </a:pPr>
-            <a:r>
-              <a:rPr lang="en-US" sz="850" dirty="0">
-                <a:solidFill>
-                  <a:srgbClr val="5A5F73"/>
-                </a:solidFill>
-                <a:latin typeface="Calibri" pitchFamily="34" charset="0"/>
-                <a:ea typeface="Calibri" pitchFamily="34" charset="-122"/>
-                <a:cs typeface="Calibri" pitchFamily="34" charset="-120"/>
-              </a:rPr>
-              <a:t>pide modos y PIDs</a:t>
-            </a:r>
-            <a:endParaRPr lang="en-US" sz="850" dirty="0"/>
-          </a:p>
-          <a:p>
-            <a:pPr algn="ctr" indent="0" marL="0">
-              <a:lnSpc>
-                <a:spcPts val="1050"/>
-              </a:lnSpc>
-              <a:buNone/>
-            </a:pPr>
-            <a:r>
-              <a:rPr lang="en-US" sz="850" dirty="0">
-                <a:solidFill>
-                  <a:srgbClr val="5A5F73"/>
-                </a:solidFill>
-                <a:latin typeface="Calibri" pitchFamily="34" charset="0"/>
-                <a:ea typeface="Calibri" pitchFamily="34" charset="-122"/>
-                <a:cs typeface="Calibri" pitchFamily="34" charset="-120"/>
-              </a:rPr>
-              <a:t>y traduce lo que vuelve</a:t>
-            </a:r>
-            <a:endParaRPr lang="en-US" sz="850" dirty="0"/>
-          </a:p>
-        </p:txBody>
-      </p:sp>
-      <p:sp>
-        <p:nvSpPr>
-          <p:cNvPr id="17" name="Shape 15"/>
-          <p:cNvSpPr/>
-          <p:nvPr/>
-        </p:nvSpPr>
-        <p:spPr>
-          <a:xfrm>
-            <a:off x="4800600" y="3310128"/>
-            <a:ext cx="3200400" cy="795528"/>
-          </a:xfrm>
-          <a:prstGeom prst="roundRect">
-            <a:avLst>
-              <a:gd name="adj" fmla="val 5747"/>
-            </a:avLst>
-          </a:prstGeom>
-          <a:solidFill>
-            <a:srgbClr val="FFFFFF"/>
-          </a:solidFill>
-          <a:ln w="12700">
-            <a:solidFill>
-              <a:srgbClr val="C9CCD8"/>
-            </a:solidFill>
-            <a:prstDash val="solid"/>
-          </a:ln>
-        </p:spPr>
-      </p:sp>
-      <p:sp>
-        <p:nvSpPr>
-          <p:cNvPr id="18" name="Text 16"/>
-          <p:cNvSpPr/>
-          <p:nvPr/>
-        </p:nvSpPr>
-        <p:spPr>
-          <a:xfrm>
-            <a:off x="4873752" y="3383280"/>
-            <a:ext cx="3054096" cy="237744"/>
-          </a:xfrm>
-          <a:prstGeom prst="rect">
-            <a:avLst/>
-          </a:prstGeom>
-          <a:noFill/>
-          <a:ln/>
-        </p:spPr>
-        <p:txBody>
-          <a:bodyPr wrap="square" lIns="0" tIns="0" rIns="0" bIns="0" rtlCol="0" anchor="ctr"/>
-          <a:lstStyle/>
-          <a:p>
-            <a:pPr algn="ctr" indent="0" marL="0">
-              <a:buNone/>
-            </a:pPr>
-            <a:r>
-              <a:rPr lang="en-US" sz="1050" b="1" dirty="0">
-                <a:solidFill>
-                  <a:srgbClr val="1A1C2E"/>
+              <a:buNone/>
+            </a:pPr>
+            <a:r>
+              <a:rPr lang="en-US" sz="1100" b="1" dirty="0">
+                <a:solidFill>
+                  <a:srgbClr val="FFFFFF"/>
                 </a:solidFill>
                 <a:latin typeface="Arial" pitchFamily="34" charset="0"/>
                 <a:ea typeface="Arial" pitchFamily="34" charset="-122"/>
                 <a:cs typeface="Arial" pitchFamily="34" charset="-120"/>
               </a:rPr>
-              <a:t>Bases de datos</a:t>
-            </a:r>
-            <a:endParaRPr lang="en-US" sz="1050" dirty="0"/>
-          </a:p>
-        </p:txBody>
-      </p:sp>
-      <p:sp>
-        <p:nvSpPr>
-          <p:cNvPr id="19" name="Text 17"/>
-          <p:cNvSpPr/>
-          <p:nvPr/>
-        </p:nvSpPr>
-        <p:spPr>
-          <a:xfrm>
-            <a:off x="4873752" y="3621024"/>
-            <a:ext cx="3054096" cy="365760"/>
-          </a:xfrm>
-          <a:prstGeom prst="rect">
-            <a:avLst/>
-          </a:prstGeom>
-          <a:noFill/>
-          <a:ln/>
-        </p:spPr>
-        <p:txBody>
-          <a:bodyPr wrap="square" lIns="0" tIns="0" rIns="0" bIns="0" rtlCol="0" anchor="t"/>
+              <a:t>4</a:t>
+            </a:r>
+            <a:endParaRPr lang="en-US" sz="1100" dirty="0"/>
+          </a:p>
+        </p:txBody>
+      </p:sp>
+      <p:sp>
+        <p:nvSpPr>
+          <p:cNvPr id="16" name="Text 14"/>
+          <p:cNvSpPr/>
+          <p:nvPr/>
+        </p:nvSpPr>
+        <p:spPr>
+          <a:xfrm>
+            <a:off x="1618488" y="3328416"/>
+            <a:ext cx="9601200" cy="365760"/>
+          </a:xfrm>
+          <a:prstGeom prst="rect">
+            <a:avLst/>
+          </a:prstGeom>
+          <a:noFill/>
+          <a:ln/>
+        </p:spPr>
+        <p:txBody>
+          <a:bodyPr wrap="square" lIns="0" tIns="0" rIns="0" bIns="0" rtlCol="0" anchor="ctr"/>
+          <a:lstStyle/>
+          <a:p>
+            <a:pPr indent="0" marL="0">
+              <a:buNone/>
+            </a:pPr>
+            <a:r>
+              <a:rPr lang="en-US" sz="1500" dirty="0">
+                <a:solidFill>
+                  <a:srgbClr val="1A1C2E"/>
+                </a:solidFill>
+                <a:latin typeface="Calibri" pitchFamily="34" charset="0"/>
+                <a:ea typeface="Calibri" pitchFamily="34" charset="-122"/>
+                <a:cs typeface="Calibri" pitchFamily="34" charset="-120"/>
+              </a:rPr>
+              <a:t>Se leen los datos en vivo, los códigos de avería y el freeze frame</a:t>
+            </a:r>
+            <a:endParaRPr lang="en-US" sz="1500" dirty="0"/>
+          </a:p>
+        </p:txBody>
+      </p:sp>
+      <p:sp>
+        <p:nvSpPr>
+          <p:cNvPr id="17" name="Shape 15"/>
+          <p:cNvSpPr/>
+          <p:nvPr/>
+        </p:nvSpPr>
+        <p:spPr>
+          <a:xfrm>
+            <a:off x="1078992" y="3822192"/>
+            <a:ext cx="310896" cy="310896"/>
+          </a:xfrm>
+          <a:prstGeom prst="ellipse">
+            <a:avLst/>
+          </a:prstGeom>
+          <a:solidFill>
+            <a:srgbClr val="202CFC"/>
+          </a:solidFill>
+          <a:ln/>
+        </p:spPr>
+      </p:sp>
+      <p:sp>
+        <p:nvSpPr>
+          <p:cNvPr id="18" name="Text 16"/>
+          <p:cNvSpPr/>
+          <p:nvPr/>
+        </p:nvSpPr>
+        <p:spPr>
+          <a:xfrm>
+            <a:off x="1078992" y="3822192"/>
+            <a:ext cx="310896" cy="310896"/>
+          </a:xfrm>
+          <a:prstGeom prst="rect">
+            <a:avLst/>
+          </a:prstGeom>
+          <a:noFill/>
+          <a:ln/>
+        </p:spPr>
+        <p:txBody>
+          <a:bodyPr wrap="square" lIns="0" tIns="0" rIns="0" bIns="0" rtlCol="0" anchor="ctr"/>
           <a:lstStyle/>
           <a:p>
             <a:pPr algn="ctr" indent="0" marL="0">
-              <a:lnSpc>
-                <a:spcPts val="1050"/>
-              </a:lnSpc>
-              <a:buNone/>
-            </a:pPr>
-            <a:r>
-              <a:rPr lang="en-US" sz="850" dirty="0">
-                <a:solidFill>
-                  <a:srgbClr val="5A5F73"/>
-                </a:solidFill>
-                <a:latin typeface="Calibri" pitchFamily="34" charset="0"/>
-                <a:ea typeface="Calibri" pitchFamily="34" charset="-122"/>
-                <a:cs typeface="Calibri" pitchFamily="34" charset="-120"/>
-              </a:rPr>
-              <a:t>la relacional</a:t>
-            </a:r>
-            <a:endParaRPr lang="en-US" sz="850" dirty="0"/>
-          </a:p>
-          <a:p>
-            <a:pPr algn="ctr" indent="0" marL="0">
-              <a:lnSpc>
-                <a:spcPts val="1050"/>
-              </a:lnSpc>
-              <a:buNone/>
-            </a:pPr>
-            <a:r>
-              <a:rPr lang="en-US" sz="850" dirty="0">
-                <a:solidFill>
-                  <a:srgbClr val="5A5F73"/>
-                </a:solidFill>
-                <a:latin typeface="Calibri" pitchFamily="34" charset="0"/>
-                <a:ea typeface="Calibri" pitchFamily="34" charset="-122"/>
-                <a:cs typeface="Calibri" pitchFamily="34" charset="-120"/>
-              </a:rPr>
-              <a:t>y la vectorial</a:t>
-            </a:r>
-            <a:endParaRPr lang="en-US" sz="850" dirty="0"/>
-          </a:p>
-        </p:txBody>
-      </p:sp>
-      <p:sp>
-        <p:nvSpPr>
-          <p:cNvPr id="20" name="Shape 18"/>
-          <p:cNvSpPr/>
-          <p:nvPr/>
-        </p:nvSpPr>
-        <p:spPr>
-          <a:xfrm>
-            <a:off x="8641080" y="3310128"/>
-            <a:ext cx="3200400" cy="795528"/>
-          </a:xfrm>
-          <a:prstGeom prst="roundRect">
-            <a:avLst>
-              <a:gd name="adj" fmla="val 5747"/>
-            </a:avLst>
-          </a:prstGeom>
-          <a:solidFill>
-            <a:srgbClr val="FFFFFF"/>
-          </a:solidFill>
-          <a:ln w="12700">
-            <a:solidFill>
-              <a:srgbClr val="C9CCD8"/>
-            </a:solidFill>
-            <a:prstDash val="solid"/>
-          </a:ln>
-        </p:spPr>
-      </p:sp>
-      <p:sp>
-        <p:nvSpPr>
-          <p:cNvPr id="21" name="Text 19"/>
-          <p:cNvSpPr/>
-          <p:nvPr/>
-        </p:nvSpPr>
-        <p:spPr>
-          <a:xfrm>
-            <a:off x="8714232" y="3383280"/>
-            <a:ext cx="3054096" cy="237744"/>
-          </a:xfrm>
-          <a:prstGeom prst="rect">
-            <a:avLst/>
-          </a:prstGeom>
-          <a:noFill/>
-          <a:ln/>
-        </p:spPr>
-        <p:txBody>
-          <a:bodyPr wrap="square" lIns="0" tIns="0" rIns="0" bIns="0" rtlCol="0" anchor="ctr"/>
-          <a:lstStyle/>
-          <a:p>
-            <a:pPr algn="ctr" indent="0" marL="0">
-              <a:buNone/>
-            </a:pPr>
-            <a:r>
-              <a:rPr lang="en-US" sz="1050" b="1" dirty="0">
-                <a:solidFill>
-                  <a:srgbClr val="1A1C2E"/>
+              <a:buNone/>
+            </a:pPr>
+            <a:r>
+              <a:rPr lang="en-US" sz="1100" b="1" dirty="0">
+                <a:solidFill>
+                  <a:srgbClr val="FFFFFF"/>
                 </a:solidFill>
                 <a:latin typeface="Arial" pitchFamily="34" charset="0"/>
                 <a:ea typeface="Arial" pitchFamily="34" charset="-122"/>
                 <a:cs typeface="Arial" pitchFamily="34" charset="-120"/>
               </a:rPr>
-              <a:t>Herramientas del agente</a:t>
-            </a:r>
-            <a:endParaRPr lang="en-US" sz="1050" dirty="0"/>
-          </a:p>
-        </p:txBody>
-      </p:sp>
-      <p:sp>
-        <p:nvSpPr>
-          <p:cNvPr id="22" name="Text 20"/>
-          <p:cNvSpPr/>
-          <p:nvPr/>
-        </p:nvSpPr>
-        <p:spPr>
-          <a:xfrm>
-            <a:off x="8714232" y="3621024"/>
-            <a:ext cx="3054096" cy="365760"/>
-          </a:xfrm>
-          <a:prstGeom prst="rect">
-            <a:avLst/>
-          </a:prstGeom>
-          <a:noFill/>
-          <a:ln/>
-        </p:spPr>
-        <p:txBody>
-          <a:bodyPr wrap="square" lIns="0" tIns="0" rIns="0" bIns="0" rtlCol="0" anchor="t"/>
+              <a:t>5</a:t>
+            </a:r>
+            <a:endParaRPr lang="en-US" sz="1100" dirty="0"/>
+          </a:p>
+        </p:txBody>
+      </p:sp>
+      <p:sp>
+        <p:nvSpPr>
+          <p:cNvPr id="19" name="Text 17"/>
+          <p:cNvSpPr/>
+          <p:nvPr/>
+        </p:nvSpPr>
+        <p:spPr>
+          <a:xfrm>
+            <a:off x="1618488" y="3803904"/>
+            <a:ext cx="9601200" cy="365760"/>
+          </a:xfrm>
+          <a:prstGeom prst="rect">
+            <a:avLst/>
+          </a:prstGeom>
+          <a:noFill/>
+          <a:ln/>
+        </p:spPr>
+        <p:txBody>
+          <a:bodyPr wrap="square" lIns="0" tIns="0" rIns="0" bIns="0" rtlCol="0" anchor="ctr"/>
+          <a:lstStyle/>
+          <a:p>
+            <a:pPr indent="0" marL="0">
+              <a:buNone/>
+            </a:pPr>
+            <a:r>
+              <a:rPr lang="en-US" sz="1500" dirty="0">
+                <a:solidFill>
+                  <a:srgbClr val="1A1C2E"/>
+                </a:solidFill>
+                <a:latin typeface="Calibri" pitchFamily="34" charset="0"/>
+                <a:ea typeface="Calibri" pitchFamily="34" charset="-122"/>
+                <a:cs typeface="Calibri" pitchFamily="34" charset="-120"/>
+              </a:rPr>
+              <a:t>Se calcula la severidad y todo sale en pantalla</a:t>
+            </a:r>
+            <a:endParaRPr lang="en-US" sz="1500" dirty="0"/>
+          </a:p>
+        </p:txBody>
+      </p:sp>
+      <p:sp>
+        <p:nvSpPr>
+          <p:cNvPr id="20" name="Shape 18"/>
+          <p:cNvSpPr/>
+          <p:nvPr/>
+        </p:nvSpPr>
+        <p:spPr>
+          <a:xfrm>
+            <a:off x="1078992" y="4297680"/>
+            <a:ext cx="310896" cy="310896"/>
+          </a:xfrm>
+          <a:prstGeom prst="ellipse">
+            <a:avLst/>
+          </a:prstGeom>
+          <a:solidFill>
+            <a:srgbClr val="202CFC"/>
+          </a:solidFill>
+          <a:ln/>
+        </p:spPr>
+      </p:sp>
+      <p:sp>
+        <p:nvSpPr>
+          <p:cNvPr id="21" name="Text 19"/>
+          <p:cNvSpPr/>
+          <p:nvPr/>
+        </p:nvSpPr>
+        <p:spPr>
+          <a:xfrm>
+            <a:off x="1078992" y="4297680"/>
+            <a:ext cx="310896" cy="310896"/>
+          </a:xfrm>
+          <a:prstGeom prst="rect">
+            <a:avLst/>
+          </a:prstGeom>
+          <a:noFill/>
+          <a:ln/>
+        </p:spPr>
+        <p:txBody>
+          <a:bodyPr wrap="square" lIns="0" tIns="0" rIns="0" bIns="0" rtlCol="0" anchor="ctr"/>
           <a:lstStyle/>
           <a:p>
             <a:pPr algn="ctr" indent="0" marL="0">
-              <a:lnSpc>
-                <a:spcPts val="1050"/>
-              </a:lnSpc>
-              <a:buNone/>
-            </a:pPr>
-            <a:r>
-              <a:rPr lang="en-US" sz="850" dirty="0">
-                <a:solidFill>
-                  <a:srgbClr val="5A5F73"/>
-                </a:solidFill>
-                <a:latin typeface="Calibri" pitchFamily="34" charset="0"/>
-                <a:ea typeface="Calibri" pitchFamily="34" charset="-122"/>
-                <a:cs typeface="Calibri" pitchFamily="34" charset="-120"/>
-              </a:rPr>
-              <a:t>lo único que el modelo</a:t>
-            </a:r>
-            <a:endParaRPr lang="en-US" sz="850" dirty="0"/>
-          </a:p>
-          <a:p>
-            <a:pPr algn="ctr" indent="0" marL="0">
-              <a:lnSpc>
-                <a:spcPts val="1050"/>
-              </a:lnSpc>
-              <a:buNone/>
-            </a:pPr>
-            <a:r>
-              <a:rPr lang="en-US" sz="850" dirty="0">
-                <a:solidFill>
-                  <a:srgbClr val="5A5F73"/>
-                </a:solidFill>
-                <a:latin typeface="Calibri" pitchFamily="34" charset="0"/>
-                <a:ea typeface="Calibri" pitchFamily="34" charset="-122"/>
-                <a:cs typeface="Calibri" pitchFamily="34" charset="-120"/>
-              </a:rPr>
-              <a:t>puede llegar a pedir</a:t>
-            </a:r>
-            <a:endParaRPr lang="en-US" sz="850" dirty="0"/>
-          </a:p>
-        </p:txBody>
-      </p:sp>
-      <p:sp>
-        <p:nvSpPr>
-          <p:cNvPr id="23" name="Shape 21"/>
-          <p:cNvSpPr/>
-          <p:nvPr/>
-        </p:nvSpPr>
-        <p:spPr>
-          <a:xfrm>
-            <a:off x="4233672" y="3712464"/>
-            <a:ext cx="493776" cy="0"/>
-          </a:xfrm>
-          <a:prstGeom prst="line">
-            <a:avLst/>
-          </a:prstGeom>
-          <a:noFill/>
-          <a:ln w="12700">
-            <a:solidFill>
-              <a:srgbClr val="9AA0B4"/>
-            </a:solidFill>
-            <a:prstDash val="dash"/>
-            <a:headEnd type="triangle"/>
-          </a:ln>
-        </p:spPr>
-      </p:sp>
-      <p:sp>
-        <p:nvSpPr>
-          <p:cNvPr id="24" name="Shape 22"/>
-          <p:cNvSpPr/>
-          <p:nvPr/>
-        </p:nvSpPr>
-        <p:spPr>
-          <a:xfrm>
-            <a:off x="8074152" y="3712464"/>
-            <a:ext cx="493776" cy="0"/>
-          </a:xfrm>
-          <a:prstGeom prst="line">
-            <a:avLst/>
-          </a:prstGeom>
-          <a:noFill/>
-          <a:ln w="12700">
-            <a:solidFill>
-              <a:srgbClr val="9AA0B4"/>
-            </a:solidFill>
-            <a:prstDash val="dash"/>
-            <a:headEnd type="triangle"/>
-          </a:ln>
-        </p:spPr>
-      </p:sp>
-      <p:sp>
-        <p:nvSpPr>
-          <p:cNvPr id="25" name="Shape 23"/>
-          <p:cNvSpPr/>
-          <p:nvPr/>
-        </p:nvSpPr>
-        <p:spPr>
-          <a:xfrm>
-            <a:off x="2560320" y="4105656"/>
-            <a:ext cx="0" cy="301752"/>
-          </a:xfrm>
-          <a:prstGeom prst="line">
-            <a:avLst/>
-          </a:prstGeom>
-          <a:noFill/>
-          <a:ln w="15875">
-            <a:solidFill>
-              <a:srgbClr val="202CFC"/>
-            </a:solidFill>
-            <a:prstDash val="solid"/>
-            <a:headEnd type="triangle"/>
-            <a:tailEnd type="triangle"/>
-          </a:ln>
-        </p:spPr>
-      </p:sp>
-      <p:sp>
-        <p:nvSpPr>
-          <p:cNvPr id="26" name="Shape 24"/>
-          <p:cNvSpPr/>
-          <p:nvPr/>
-        </p:nvSpPr>
-        <p:spPr>
-          <a:xfrm>
-            <a:off x="10241280" y="4105656"/>
-            <a:ext cx="0" cy="301752"/>
-          </a:xfrm>
-          <a:prstGeom prst="line">
-            <a:avLst/>
-          </a:prstGeom>
-          <a:noFill/>
-          <a:ln w="15875">
-            <a:solidFill>
-              <a:srgbClr val="202CFC"/>
-            </a:solidFill>
-            <a:prstDash val="solid"/>
-            <a:headEnd type="triangle"/>
-            <a:tailEnd type="triangle"/>
-          </a:ln>
-        </p:spPr>
-      </p:sp>
-      <p:sp>
-        <p:nvSpPr>
-          <p:cNvPr id="27" name="Shape 25"/>
-          <p:cNvSpPr/>
-          <p:nvPr/>
-        </p:nvSpPr>
-        <p:spPr>
-          <a:xfrm>
-            <a:off x="960120" y="4407408"/>
-            <a:ext cx="3200400" cy="731520"/>
-          </a:xfrm>
-          <a:prstGeom prst="roundRect">
-            <a:avLst>
-              <a:gd name="adj" fmla="val 6250"/>
-            </a:avLst>
-          </a:prstGeom>
-          <a:solidFill>
-            <a:srgbClr val="FFFFFF"/>
-          </a:solidFill>
-          <a:ln w="22225">
-            <a:solidFill>
-              <a:srgbClr val="202CFC"/>
-            </a:solidFill>
-            <a:prstDash val="solid"/>
-          </a:ln>
-        </p:spPr>
-      </p:sp>
-      <p:sp>
-        <p:nvSpPr>
-          <p:cNvPr id="28" name="Text 26"/>
-          <p:cNvSpPr/>
-          <p:nvPr/>
-        </p:nvSpPr>
-        <p:spPr>
-          <a:xfrm>
-            <a:off x="1033272" y="4480560"/>
-            <a:ext cx="3054096" cy="237744"/>
-          </a:xfrm>
-          <a:prstGeom prst="rect">
-            <a:avLst/>
-          </a:prstGeom>
-          <a:noFill/>
-          <a:ln/>
-        </p:spPr>
-        <p:txBody>
-          <a:bodyPr wrap="square" lIns="0" tIns="0" rIns="0" bIns="0" rtlCol="0" anchor="ctr"/>
-          <a:lstStyle/>
-          <a:p>
-            <a:pPr algn="ctr" indent="0" marL="0">
-              <a:buNone/>
-            </a:pPr>
-            <a:r>
-              <a:rPr lang="en-US" sz="1050" b="1" dirty="0">
-                <a:solidFill>
-                  <a:srgbClr val="1A1C2E"/>
+              <a:buNone/>
+            </a:pPr>
+            <a:r>
+              <a:rPr lang="en-US" sz="1100" b="1" dirty="0">
+                <a:solidFill>
+                  <a:srgbClr val="FFFFFF"/>
                 </a:solidFill>
                 <a:latin typeface="Arial" pitchFamily="34" charset="0"/>
                 <a:ea typeface="Arial" pitchFamily="34" charset="-122"/>
                 <a:cs typeface="Arial" pitchFamily="34" charset="-120"/>
               </a:rPr>
-              <a:t>El adaptador</a:t>
-            </a:r>
-            <a:endParaRPr lang="en-US" sz="1050" dirty="0"/>
-          </a:p>
-        </p:txBody>
-      </p:sp>
-      <p:sp>
-        <p:nvSpPr>
-          <p:cNvPr id="29" name="Text 27"/>
-          <p:cNvSpPr/>
-          <p:nvPr/>
-        </p:nvSpPr>
-        <p:spPr>
-          <a:xfrm>
-            <a:off x="1033272" y="4718304"/>
-            <a:ext cx="3054096" cy="365760"/>
-          </a:xfrm>
-          <a:prstGeom prst="rect">
-            <a:avLst/>
-          </a:prstGeom>
-          <a:noFill/>
-          <a:ln/>
-        </p:spPr>
-        <p:txBody>
-          <a:bodyPr wrap="square" lIns="0" tIns="0" rIns="0" bIns="0" rtlCol="0" anchor="t"/>
+              <a:t>6</a:t>
+            </a:r>
+            <a:endParaRPr lang="en-US" sz="1100" dirty="0"/>
+          </a:p>
+        </p:txBody>
+      </p:sp>
+      <p:sp>
+        <p:nvSpPr>
+          <p:cNvPr id="22" name="Text 20"/>
+          <p:cNvSpPr/>
+          <p:nvPr/>
+        </p:nvSpPr>
+        <p:spPr>
+          <a:xfrm>
+            <a:off x="1618488" y="4279392"/>
+            <a:ext cx="9601200" cy="365760"/>
+          </a:xfrm>
+          <a:prstGeom prst="rect">
+            <a:avLst/>
+          </a:prstGeom>
+          <a:noFill/>
+          <a:ln/>
+        </p:spPr>
+        <p:txBody>
+          <a:bodyPr wrap="square" lIns="0" tIns="0" rIns="0" bIns="0" rtlCol="0" anchor="ctr"/>
+          <a:lstStyle/>
+          <a:p>
+            <a:pPr indent="0" marL="0">
+              <a:buNone/>
+            </a:pPr>
+            <a:r>
+              <a:rPr lang="en-US" sz="1500" dirty="0">
+                <a:solidFill>
+                  <a:srgbClr val="1A1C2E"/>
+                </a:solidFill>
+                <a:latin typeface="Calibri" pitchFamily="34" charset="0"/>
+                <a:ea typeface="Calibri" pitchFamily="34" charset="-122"/>
+                <a:cs typeface="Calibri" pitchFamily="34" charset="-120"/>
+              </a:rPr>
+              <a:t>Si el mecánico pregunta al agente, se buscan antes casos parecidos</a:t>
+            </a:r>
+            <a:endParaRPr lang="en-US" sz="1500" dirty="0"/>
+          </a:p>
+        </p:txBody>
+      </p:sp>
+      <p:sp>
+        <p:nvSpPr>
+          <p:cNvPr id="23" name="Shape 21"/>
+          <p:cNvSpPr/>
+          <p:nvPr/>
+        </p:nvSpPr>
+        <p:spPr>
+          <a:xfrm>
+            <a:off x="1078992" y="4773168"/>
+            <a:ext cx="310896" cy="310896"/>
+          </a:xfrm>
+          <a:prstGeom prst="ellipse">
+            <a:avLst/>
+          </a:prstGeom>
+          <a:solidFill>
+            <a:srgbClr val="202CFC"/>
+          </a:solidFill>
+          <a:ln/>
+        </p:spPr>
+      </p:sp>
+      <p:sp>
+        <p:nvSpPr>
+          <p:cNvPr id="24" name="Text 22"/>
+          <p:cNvSpPr/>
+          <p:nvPr/>
+        </p:nvSpPr>
+        <p:spPr>
+          <a:xfrm>
+            <a:off x="1078992" y="4773168"/>
+            <a:ext cx="310896" cy="310896"/>
+          </a:xfrm>
+          <a:prstGeom prst="rect">
+            <a:avLst/>
+          </a:prstGeom>
+          <a:noFill/>
+          <a:ln/>
+        </p:spPr>
+        <p:txBody>
+          <a:bodyPr wrap="square" lIns="0" tIns="0" rIns="0" bIns="0" rtlCol="0" anchor="ctr"/>
           <a:lstStyle/>
           <a:p>
             <a:pPr algn="ctr" indent="0" marL="0">
-              <a:lnSpc>
-                <a:spcPts val="1050"/>
-              </a:lnSpc>
-              <a:buNone/>
-            </a:pPr>
-            <a:r>
-              <a:rPr lang="en-US" sz="850" dirty="0">
-                <a:solidFill>
-                  <a:srgbClr val="5A5F73"/>
-                </a:solidFill>
-                <a:latin typeface="Calibri" pitchFamily="34" charset="0"/>
-                <a:ea typeface="Calibri" pitchFamily="34" charset="-122"/>
-                <a:cs typeface="Calibri" pitchFamily="34" charset="-120"/>
-              </a:rPr>
-              <a:t>enchufado al conector</a:t>
-            </a:r>
-            <a:endParaRPr lang="en-US" sz="850" dirty="0"/>
-          </a:p>
-          <a:p>
-            <a:pPr algn="ctr" indent="0" marL="0">
-              <a:lnSpc>
-                <a:spcPts val="1050"/>
-              </a:lnSpc>
-              <a:buNone/>
-            </a:pPr>
-            <a:r>
-              <a:rPr lang="en-US" sz="850" dirty="0">
-                <a:solidFill>
-                  <a:srgbClr val="5A5F73"/>
-                </a:solidFill>
-                <a:latin typeface="Calibri" pitchFamily="34" charset="0"/>
-                <a:ea typeface="Calibri" pitchFamily="34" charset="-122"/>
-                <a:cs typeface="Calibri" pitchFamily="34" charset="-120"/>
-              </a:rPr>
-              <a:t>de diagnóstico del coche</a:t>
-            </a:r>
-            <a:endParaRPr lang="en-US" sz="850" dirty="0"/>
-          </a:p>
-        </p:txBody>
-      </p:sp>
-      <p:sp>
-        <p:nvSpPr>
-          <p:cNvPr id="30" name="Shape 28"/>
-          <p:cNvSpPr/>
-          <p:nvPr/>
-        </p:nvSpPr>
-        <p:spPr>
-          <a:xfrm>
-            <a:off x="8641080" y="4407408"/>
-            <a:ext cx="3200400" cy="731520"/>
-          </a:xfrm>
-          <a:prstGeom prst="roundRect">
-            <a:avLst>
-              <a:gd name="adj" fmla="val 6250"/>
-            </a:avLst>
-          </a:prstGeom>
-          <a:solidFill>
-            <a:srgbClr val="FFFFFF"/>
-          </a:solidFill>
-          <a:ln w="12700">
-            <a:solidFill>
-              <a:srgbClr val="C9CCD8"/>
-            </a:solidFill>
-            <a:prstDash val="solid"/>
-          </a:ln>
-        </p:spPr>
-      </p:sp>
-      <p:sp>
-        <p:nvSpPr>
-          <p:cNvPr id="31" name="Text 29"/>
-          <p:cNvSpPr/>
-          <p:nvPr/>
-        </p:nvSpPr>
-        <p:spPr>
-          <a:xfrm>
-            <a:off x="8714232" y="4480560"/>
-            <a:ext cx="3054096" cy="237744"/>
-          </a:xfrm>
-          <a:prstGeom prst="rect">
-            <a:avLst/>
-          </a:prstGeom>
-          <a:noFill/>
-          <a:ln/>
-        </p:spPr>
-        <p:txBody>
-          <a:bodyPr wrap="square" lIns="0" tIns="0" rIns="0" bIns="0" rtlCol="0" anchor="ctr"/>
-          <a:lstStyle/>
-          <a:p>
-            <a:pPr algn="ctr" indent="0" marL="0">
-              <a:buNone/>
-            </a:pPr>
-            <a:r>
-              <a:rPr lang="en-US" sz="1050" b="1" dirty="0">
-                <a:solidFill>
-                  <a:srgbClr val="1A1C2E"/>
+              <a:buNone/>
+            </a:pPr>
+            <a:r>
+              <a:rPr lang="en-US" sz="1100" b="1" dirty="0">
+                <a:solidFill>
+                  <a:srgbClr val="FFFFFF"/>
                 </a:solidFill>
                 <a:latin typeface="Arial" pitchFamily="34" charset="0"/>
                 <a:ea typeface="Arial" pitchFamily="34" charset="-122"/>
                 <a:cs typeface="Arial" pitchFamily="34" charset="-120"/>
               </a:rPr>
-              <a:t>El modelo</a:t>
-            </a:r>
-            <a:endParaRPr lang="en-US" sz="1050" dirty="0"/>
-          </a:p>
-        </p:txBody>
-      </p:sp>
-      <p:sp>
-        <p:nvSpPr>
-          <p:cNvPr id="32" name="Text 30"/>
-          <p:cNvSpPr/>
-          <p:nvPr/>
-        </p:nvSpPr>
-        <p:spPr>
-          <a:xfrm>
-            <a:off x="8714232" y="4718304"/>
-            <a:ext cx="3054096" cy="365760"/>
-          </a:xfrm>
-          <a:prstGeom prst="rect">
-            <a:avLst/>
-          </a:prstGeom>
-          <a:noFill/>
-          <a:ln/>
-        </p:spPr>
-        <p:txBody>
-          <a:bodyPr wrap="square" lIns="0" tIns="0" rIns="0" bIns="0" rtlCol="0" anchor="t"/>
+              <a:t>7</a:t>
+            </a:r>
+            <a:endParaRPr lang="en-US" sz="1100" dirty="0"/>
+          </a:p>
+        </p:txBody>
+      </p:sp>
+      <p:sp>
+        <p:nvSpPr>
+          <p:cNvPr id="25" name="Text 23"/>
+          <p:cNvSpPr/>
+          <p:nvPr/>
+        </p:nvSpPr>
+        <p:spPr>
+          <a:xfrm>
+            <a:off x="1618488" y="4754880"/>
+            <a:ext cx="9601200" cy="365760"/>
+          </a:xfrm>
+          <a:prstGeom prst="rect">
+            <a:avLst/>
+          </a:prstGeom>
+          <a:noFill/>
+          <a:ln/>
+        </p:spPr>
+        <p:txBody>
+          <a:bodyPr wrap="square" lIns="0" tIns="0" rIns="0" bIns="0" rtlCol="0" anchor="ctr"/>
+          <a:lstStyle/>
+          <a:p>
+            <a:pPr indent="0" marL="0">
+              <a:buNone/>
+            </a:pPr>
+            <a:r>
+              <a:rPr lang="en-US" sz="1500" dirty="0">
+                <a:solidFill>
+                  <a:srgbClr val="1A1C2E"/>
+                </a:solidFill>
+                <a:latin typeface="Calibri" pitchFamily="34" charset="0"/>
+                <a:ea typeface="Calibri" pitchFamily="34" charset="-122"/>
+                <a:cs typeface="Calibri" pitchFamily="34" charset="-120"/>
+              </a:rPr>
+              <a:t>El agente pide lo que le falta: el catálogo, más lecturas del coche o la web</a:t>
+            </a:r>
+            <a:endParaRPr lang="en-US" sz="1500" dirty="0"/>
+          </a:p>
+        </p:txBody>
+      </p:sp>
+      <p:sp>
+        <p:nvSpPr>
+          <p:cNvPr id="26" name="Shape 24"/>
+          <p:cNvSpPr/>
+          <p:nvPr/>
+        </p:nvSpPr>
+        <p:spPr>
+          <a:xfrm>
+            <a:off x="1078992" y="5248656"/>
+            <a:ext cx="310896" cy="310896"/>
+          </a:xfrm>
+          <a:prstGeom prst="ellipse">
+            <a:avLst/>
+          </a:prstGeom>
+          <a:solidFill>
+            <a:srgbClr val="202CFC"/>
+          </a:solidFill>
+          <a:ln/>
+        </p:spPr>
+      </p:sp>
+      <p:sp>
+        <p:nvSpPr>
+          <p:cNvPr id="27" name="Text 25"/>
+          <p:cNvSpPr/>
+          <p:nvPr/>
+        </p:nvSpPr>
+        <p:spPr>
+          <a:xfrm>
+            <a:off x="1078992" y="5248656"/>
+            <a:ext cx="310896" cy="310896"/>
+          </a:xfrm>
+          <a:prstGeom prst="rect">
+            <a:avLst/>
+          </a:prstGeom>
+          <a:noFill/>
+          <a:ln/>
+        </p:spPr>
+        <p:txBody>
+          <a:bodyPr wrap="square" lIns="0" tIns="0" rIns="0" bIns="0" rtlCol="0" anchor="ctr"/>
           <a:lstStyle/>
           <a:p>
             <a:pPr algn="ctr" indent="0" marL="0">
-              <a:lnSpc>
-                <a:spcPts val="1050"/>
-              </a:lnSpc>
-              <a:buNone/>
-            </a:pPr>
-            <a:r>
-              <a:rPr lang="en-US" sz="850" dirty="0">
-                <a:solidFill>
-                  <a:srgbClr val="5A5F73"/>
-                </a:solidFill>
-                <a:latin typeface="Calibri" pitchFamily="34" charset="0"/>
-                <a:ea typeface="Calibri" pitchFamily="34" charset="-122"/>
-                <a:cs typeface="Calibri" pitchFamily="34" charset="-120"/>
-              </a:rPr>
-              <a:t>razona y va pidiendo</a:t>
-            </a:r>
-            <a:endParaRPr lang="en-US" sz="850" dirty="0"/>
-          </a:p>
-          <a:p>
-            <a:pPr algn="ctr" indent="0" marL="0">
-              <a:lnSpc>
-                <a:spcPts val="1050"/>
-              </a:lnSpc>
-              <a:buNone/>
-            </a:pPr>
-            <a:r>
-              <a:rPr lang="en-US" sz="850" dirty="0">
-                <a:solidFill>
-                  <a:srgbClr val="5A5F73"/>
-                </a:solidFill>
-                <a:latin typeface="Calibri" pitchFamily="34" charset="0"/>
-                <a:ea typeface="Calibri" pitchFamily="34" charset="-122"/>
-                <a:cs typeface="Calibri" pitchFamily="34" charset="-120"/>
-              </a:rPr>
-              <a:t>las herramientas que necesita</a:t>
-            </a:r>
-            <a:endParaRPr lang="en-US" sz="850" dirty="0"/>
-          </a:p>
-        </p:txBody>
-      </p:sp>
-      <p:sp>
-        <p:nvSpPr>
-          <p:cNvPr id="33" name="Shape 31"/>
-          <p:cNvSpPr/>
-          <p:nvPr/>
-        </p:nvSpPr>
-        <p:spPr>
-          <a:xfrm>
-            <a:off x="2560320" y="5138928"/>
-            <a:ext cx="0" cy="301752"/>
-          </a:xfrm>
-          <a:prstGeom prst="line">
-            <a:avLst/>
-          </a:prstGeom>
-          <a:noFill/>
-          <a:ln w="15875">
-            <a:solidFill>
-              <a:srgbClr val="202CFC"/>
-            </a:solidFill>
-            <a:prstDash val="solid"/>
-            <a:headEnd type="triangle"/>
-            <a:tailEnd type="triangle"/>
-          </a:ln>
-        </p:spPr>
-      </p:sp>
-      <p:sp>
-        <p:nvSpPr>
-          <p:cNvPr id="34" name="Shape 32"/>
-          <p:cNvSpPr/>
-          <p:nvPr/>
-        </p:nvSpPr>
-        <p:spPr>
-          <a:xfrm>
-            <a:off x="960120" y="5440680"/>
-            <a:ext cx="3200400" cy="713232"/>
-          </a:xfrm>
-          <a:prstGeom prst="roundRect">
-            <a:avLst>
-              <a:gd name="adj" fmla="val 6410"/>
-            </a:avLst>
-          </a:prstGeom>
-          <a:solidFill>
-            <a:srgbClr val="FFFFFF"/>
-          </a:solidFill>
-          <a:ln w="22225">
-            <a:solidFill>
-              <a:srgbClr val="202CFC"/>
-            </a:solidFill>
-            <a:prstDash val="solid"/>
-          </a:ln>
-        </p:spPr>
-      </p:sp>
-      <p:sp>
-        <p:nvSpPr>
-          <p:cNvPr id="35" name="Text 33"/>
-          <p:cNvSpPr/>
-          <p:nvPr/>
-        </p:nvSpPr>
-        <p:spPr>
-          <a:xfrm>
-            <a:off x="1033272" y="5513832"/>
-            <a:ext cx="3054096" cy="237744"/>
-          </a:xfrm>
-          <a:prstGeom prst="rect">
-            <a:avLst/>
-          </a:prstGeom>
-          <a:noFill/>
-          <a:ln/>
-        </p:spPr>
-        <p:txBody>
-          <a:bodyPr wrap="square" lIns="0" tIns="0" rIns="0" bIns="0" rtlCol="0" anchor="ctr"/>
-          <a:lstStyle/>
-          <a:p>
-            <a:pPr algn="ctr" indent="0" marL="0">
-              <a:buNone/>
-            </a:pPr>
-            <a:r>
-              <a:rPr lang="en-US" sz="1050" b="1" dirty="0">
-                <a:solidFill>
-                  <a:srgbClr val="1A1C2E"/>
+              <a:buNone/>
+            </a:pPr>
+            <a:r>
+              <a:rPr lang="en-US" sz="1100" b="1" dirty="0">
+                <a:solidFill>
+                  <a:srgbClr val="FFFFFF"/>
                 </a:solidFill>
                 <a:latin typeface="Arial" pitchFamily="34" charset="0"/>
                 <a:ea typeface="Arial" pitchFamily="34" charset="-122"/>
                 <a:cs typeface="Arial" pitchFamily="34" charset="-120"/>
               </a:rPr>
-              <a:t>El coche</a:t>
-            </a:r>
-            <a:endParaRPr lang="en-US" sz="1050" dirty="0"/>
-          </a:p>
-        </p:txBody>
-      </p:sp>
-      <p:sp>
-        <p:nvSpPr>
-          <p:cNvPr id="36" name="Text 34"/>
-          <p:cNvSpPr/>
-          <p:nvPr/>
-        </p:nvSpPr>
-        <p:spPr>
-          <a:xfrm>
-            <a:off x="1033272" y="5751576"/>
-            <a:ext cx="3054096" cy="365760"/>
-          </a:xfrm>
-          <a:prstGeom prst="rect">
-            <a:avLst/>
-          </a:prstGeom>
-          <a:noFill/>
-          <a:ln/>
-        </p:spPr>
-        <p:txBody>
-          <a:bodyPr wrap="square" lIns="0" tIns="0" rIns="0" bIns="0" rtlCol="0" anchor="t"/>
-          <a:lstStyle/>
-          <a:p>
-            <a:pPr algn="ctr" indent="0" marL="0">
-              <a:lnSpc>
-                <a:spcPts val="1050"/>
-              </a:lnSpc>
-              <a:buNone/>
-            </a:pPr>
-            <a:r>
-              <a:rPr lang="en-US" sz="850" dirty="0">
-                <a:solidFill>
-                  <a:srgbClr val="5A5F73"/>
-                </a:solidFill>
-                <a:latin typeface="Calibri" pitchFamily="34" charset="0"/>
-                <a:ea typeface="Calibri" pitchFamily="34" charset="-122"/>
-                <a:cs typeface="Calibri" pitchFamily="34" charset="-120"/>
-              </a:rPr>
-              <a:t>el motor y el resto</a:t>
-            </a:r>
-            <a:endParaRPr lang="en-US" sz="850" dirty="0"/>
-          </a:p>
-          <a:p>
-            <a:pPr algn="ctr" indent="0" marL="0">
-              <a:lnSpc>
-                <a:spcPts val="1050"/>
-              </a:lnSpc>
-              <a:buNone/>
-            </a:pPr>
-            <a:r>
-              <a:rPr lang="en-US" sz="850" dirty="0">
-                <a:solidFill>
-                  <a:srgbClr val="5A5F73"/>
-                </a:solidFill>
-                <a:latin typeface="Calibri" pitchFamily="34" charset="0"/>
-                <a:ea typeface="Calibri" pitchFamily="34" charset="-122"/>
-                <a:cs typeface="Calibri" pitchFamily="34" charset="-120"/>
-              </a:rPr>
-              <a:t>de centralitas</a:t>
-            </a:r>
-            <a:endParaRPr lang="en-US" sz="850" dirty="0"/>
-          </a:p>
-        </p:txBody>
-      </p:sp>
-      <p:sp>
-        <p:nvSpPr>
-          <p:cNvPr id="37" name="Text 35"/>
-          <p:cNvSpPr/>
-          <p:nvPr/>
-        </p:nvSpPr>
-        <p:spPr>
-          <a:xfrm>
-            <a:off x="4343400" y="4617720"/>
-            <a:ext cx="4114800" cy="548640"/>
-          </a:xfrm>
-          <a:prstGeom prst="rect">
-            <a:avLst/>
-          </a:prstGeom>
-          <a:noFill/>
-          <a:ln/>
-        </p:spPr>
-        <p:txBody>
-          <a:bodyPr wrap="square" lIns="0" tIns="0" rIns="0" bIns="0" rtlCol="0" anchor="t"/>
-          <a:lstStyle/>
-          <a:p>
-            <a:pPr algn="ctr" indent="0" marL="0">
-              <a:lnSpc>
-                <a:spcPts val="1100"/>
-              </a:lnSpc>
-              <a:buNone/>
-            </a:pPr>
-            <a:r>
-              <a:rPr lang="en-US" sz="900" i="1" dirty="0">
-                <a:solidFill>
-                  <a:srgbClr val="5A5F73"/>
-                </a:solidFill>
-                <a:latin typeface="Calibri" pitchFamily="34" charset="0"/>
-                <a:ea typeface="Calibri" pitchFamily="34" charset="-122"/>
-                <a:cs typeface="Calibri" pitchFamily="34" charset="-120"/>
-              </a:rPr>
-              <a:t>En la demo este tramo va emulado. De aquí para arriba, todo es idéntico.</a:t>
-            </a:r>
-            <a:endParaRPr lang="en-US" sz="900" dirty="0"/>
-          </a:p>
-        </p:txBody>
-      </p:sp>
-      <p:sp>
-        <p:nvSpPr>
-          <p:cNvPr id="38" name="Text 36"/>
-          <p:cNvSpPr/>
-          <p:nvPr/>
-        </p:nvSpPr>
-        <p:spPr>
-          <a:xfrm>
-            <a:off x="4343400" y="5440680"/>
-            <a:ext cx="4114800" cy="457200"/>
-          </a:xfrm>
-          <a:prstGeom prst="rect">
-            <a:avLst/>
-          </a:prstGeom>
-          <a:noFill/>
-          <a:ln/>
-        </p:spPr>
-        <p:txBody>
-          <a:bodyPr wrap="square" lIns="0" tIns="0" rIns="0" bIns="0" rtlCol="0" anchor="t"/>
-          <a:lstStyle/>
-          <a:p>
-            <a:pPr algn="ctr" indent="0" marL="0">
-              <a:lnSpc>
-                <a:spcPts val="1100"/>
-              </a:lnSpc>
-              <a:buNone/>
-            </a:pPr>
-            <a:r>
-              <a:rPr lang="en-US" sz="900" i="1" dirty="0">
-                <a:solidFill>
-                  <a:srgbClr val="5A5F73"/>
-                </a:solidFill>
-                <a:latin typeface="Calibri" pitchFamily="34" charset="0"/>
-                <a:ea typeface="Calibri" pitchFamily="34" charset="-122"/>
-                <a:cs typeface="Calibri" pitchFamily="34" charset="-120"/>
-              </a:rPr>
-              <a:t>Las herramientas del agente vuelven a entrar por los mismos adaptadores.</a:t>
-            </a:r>
-            <a:endParaRPr lang="en-US" sz="900" dirty="0"/>
-          </a:p>
-        </p:txBody>
-      </p:sp>
-      <p:sp>
-        <p:nvSpPr>
-          <p:cNvPr id="39" name="Shape 37"/>
-          <p:cNvSpPr/>
-          <p:nvPr/>
-        </p:nvSpPr>
-        <p:spPr>
-          <a:xfrm>
-            <a:off x="777240" y="6263640"/>
-            <a:ext cx="219456" cy="219456"/>
-          </a:xfrm>
-          <a:prstGeom prst="rect">
+              <a:t>8</a:t>
+            </a:r>
+            <a:endParaRPr lang="en-US" sz="1100" dirty="0"/>
+          </a:p>
+        </p:txBody>
+      </p:sp>
+      <p:sp>
+        <p:nvSpPr>
+          <p:cNvPr id="28" name="Text 26"/>
+          <p:cNvSpPr/>
+          <p:nvPr/>
+        </p:nvSpPr>
+        <p:spPr>
+          <a:xfrm>
+            <a:off x="1618488" y="5230368"/>
+            <a:ext cx="9601200" cy="365760"/>
+          </a:xfrm>
+          <a:prstGeom prst="rect">
+            <a:avLst/>
+          </a:prstGeom>
+          <a:noFill/>
+          <a:ln/>
+        </p:spPr>
+        <p:txBody>
+          <a:bodyPr wrap="square" lIns="0" tIns="0" rIns="0" bIns="0" rtlCol="0" anchor="ctr"/>
+          <a:lstStyle/>
+          <a:p>
+            <a:pPr indent="0" marL="0">
+              <a:buNone/>
+            </a:pPr>
+            <a:r>
+              <a:rPr lang="en-US" sz="1500" dirty="0">
+                <a:solidFill>
+                  <a:srgbClr val="1A1C2E"/>
+                </a:solidFill>
+                <a:latin typeface="Calibri" pitchFamily="34" charset="0"/>
+                <a:ea typeface="Calibri" pitchFamily="34" charset="-122"/>
+                <a:cs typeface="Calibri" pitchFamily="34" charset="-120"/>
+              </a:rPr>
+              <a:t>Responde con la explicación, la severidad y qué conviene revisar</a:t>
+            </a:r>
+            <a:endParaRPr lang="en-US" sz="1500" dirty="0"/>
+          </a:p>
+        </p:txBody>
+      </p:sp>
+      <p:sp>
+        <p:nvSpPr>
+          <p:cNvPr id="29" name="Shape 27"/>
+          <p:cNvSpPr/>
+          <p:nvPr/>
+        </p:nvSpPr>
+        <p:spPr>
+          <a:xfrm>
+            <a:off x="1078992" y="5724144"/>
+            <a:ext cx="310896" cy="310896"/>
+          </a:xfrm>
+          <a:prstGeom prst="ellipse">
             <a:avLst/>
           </a:prstGeom>
           <a:solidFill>
@@ -11074,14 +10570,14 @@
       </p:sp>
       <p:sp>
         <p:nvSpPr>
-          <p:cNvPr id="40" name="Text 38"/>
-          <p:cNvSpPr/>
-          <p:nvPr/>
-        </p:nvSpPr>
-        <p:spPr>
-          <a:xfrm>
-            <a:off x="777240" y="6263640"/>
-            <a:ext cx="219456" cy="219456"/>
+          <p:cNvPr id="30" name="Text 28"/>
+          <p:cNvSpPr/>
+          <p:nvPr/>
+        </p:nvSpPr>
+        <p:spPr>
+          <a:xfrm>
+            <a:off x="1078992" y="5724144"/>
+            <a:ext cx="310896" cy="310896"/>
           </a:xfrm>
           <a:prstGeom prst="rect">
             <a:avLst/>
@@ -11097,7 +10593,7 @@
               <a:buNone/>
             </a:pPr>
             <a:r>
-              <a:rPr lang="en-US" sz="816" b="1" dirty="0">
+              <a:rPr lang="en-US" sz="1100" b="1" dirty="0">
                 <a:solidFill>
                   <a:srgbClr val="FFFFFF"/>
                 </a:solidFill>
@@ -11105,22 +10601,22 @@
                 <a:ea typeface="Arial" pitchFamily="34" charset="-122"/>
                 <a:cs typeface="Arial" pitchFamily="34" charset="-120"/>
               </a:rPr>
-              <a:t>BIG</a:t>
-            </a:r>
-            <a:endParaRPr lang="en-US" sz="816" dirty="0"/>
-          </a:p>
-        </p:txBody>
-      </p:sp>
-      <p:sp>
-        <p:nvSpPr>
-          <p:cNvPr id="41" name="Text 39"/>
-          <p:cNvSpPr/>
-          <p:nvPr/>
-        </p:nvSpPr>
-        <p:spPr>
-          <a:xfrm>
-            <a:off x="1078992" y="6263640"/>
-            <a:ext cx="658368" cy="219456"/>
+              <a:t>9</a:t>
+            </a:r>
+            <a:endParaRPr lang="en-US" sz="1100" dirty="0"/>
+          </a:p>
+        </p:txBody>
+      </p:sp>
+      <p:sp>
+        <p:nvSpPr>
+          <p:cNvPr id="31" name="Text 29"/>
+          <p:cNvSpPr/>
+          <p:nvPr/>
+        </p:nvSpPr>
+        <p:spPr>
+          <a:xfrm>
+            <a:off x="1618488" y="5705856"/>
+            <a:ext cx="9601200" cy="365760"/>
           </a:xfrm>
           <a:prstGeom prst="rect">
             <a:avLst/>
@@ -11132,18 +10628,178 @@
           <a:bodyPr wrap="square" lIns="0" tIns="0" rIns="0" bIns="0" rtlCol="0" anchor="ctr"/>
           <a:lstStyle/>
           <a:p>
-            <a:pPr algn="l" indent="0" marL="0">
-              <a:buNone/>
-            </a:pPr>
-            <a:r>
-              <a:rPr lang="en-US" sz="816" dirty="0">
-                <a:solidFill>
-                  <a:srgbClr val="1A1C2E"/>
+            <a:pPr indent="0" marL="0">
+              <a:buNone/>
+            </a:pPr>
+            <a:r>
+              <a:rPr lang="en-US" sz="1500" dirty="0">
+                <a:solidFill>
+                  <a:srgbClr val="1A1C2E"/>
+                </a:solidFill>
+                <a:latin typeface="Calibri" pitchFamily="34" charset="0"/>
+                <a:ea typeface="Calibri" pitchFamily="34" charset="-122"/>
+                <a:cs typeface="Calibri" pitchFamily="34" charset="-120"/>
+              </a:rPr>
+              <a:t>El caso se guarda, y queda disponible para el siguiente coche</a:t>
+            </a:r>
+            <a:endParaRPr lang="en-US" sz="1500" dirty="0"/>
+          </a:p>
+        </p:txBody>
+      </p:sp>
+      <p:sp>
+        <p:nvSpPr>
+          <p:cNvPr id="32" name="Shape 30"/>
+          <p:cNvSpPr/>
+          <p:nvPr/>
+        </p:nvSpPr>
+        <p:spPr>
+          <a:xfrm>
+            <a:off x="777240" y="4233672"/>
+            <a:ext cx="10607040" cy="0"/>
+          </a:xfrm>
+          <a:prstGeom prst="line">
+            <a:avLst/>
+          </a:prstGeom>
+          <a:noFill/>
+          <a:ln w="12700">
+            <a:solidFill>
+              <a:srgbClr val="D8DAE4"/>
+            </a:solidFill>
+            <a:prstDash val="dash"/>
+          </a:ln>
+        </p:spPr>
+      </p:sp>
+      <p:sp>
+        <p:nvSpPr>
+          <p:cNvPr id="33" name="Text 31"/>
+          <p:cNvSpPr/>
+          <p:nvPr/>
+        </p:nvSpPr>
+        <p:spPr>
+          <a:xfrm>
+            <a:off x="8778240" y="4059936"/>
+            <a:ext cx="2606040" cy="274320"/>
+          </a:xfrm>
+          <a:prstGeom prst="rect">
+            <a:avLst/>
+          </a:prstGeom>
+          <a:noFill/>
+          <a:ln/>
+        </p:spPr>
+        <p:txBody>
+          <a:bodyPr wrap="square" lIns="0" tIns="0" rIns="0" bIns="0" rtlCol="0" anchor="ctr"/>
+          <a:lstStyle/>
+          <a:p>
+            <a:pPr algn="r" indent="0" marL="0">
+              <a:buNone/>
+            </a:pPr>
+            <a:r>
+              <a:rPr lang="en-US" sz="1100" i="1" dirty="0">
+                <a:solidFill>
+                  <a:srgbClr val="5A5F73"/>
+                </a:solidFill>
+                <a:latin typeface="Calibri" pitchFamily="34" charset="0"/>
+                <a:ea typeface="Calibri" pitchFamily="34" charset="-122"/>
+                <a:cs typeface="Calibri" pitchFamily="34" charset="-120"/>
+              </a:rPr>
+              <a:t>hasta aquí, sin IA</a:t>
+            </a:r>
+            <a:endParaRPr lang="en-US" sz="1100" dirty="0"/>
+          </a:p>
+        </p:txBody>
+      </p:sp>
+      <p:sp>
+        <p:nvSpPr>
+          <p:cNvPr id="34" name="Shape 32"/>
+          <p:cNvSpPr/>
+          <p:nvPr/>
+        </p:nvSpPr>
+        <p:spPr>
+          <a:xfrm>
+            <a:off x="777240" y="6263640"/>
+            <a:ext cx="219456" cy="219456"/>
+          </a:xfrm>
+          <a:prstGeom prst="rect">
+            <a:avLst/>
+          </a:prstGeom>
+          <a:solidFill>
+            <a:srgbClr val="202CFC"/>
+          </a:solidFill>
+          <a:ln/>
+        </p:spPr>
+      </p:sp>
+      <p:sp>
+        <p:nvSpPr>
+          <p:cNvPr id="35" name="Text 33"/>
+          <p:cNvSpPr/>
+          <p:nvPr/>
+        </p:nvSpPr>
+        <p:spPr>
+          <a:xfrm>
+            <a:off x="777240" y="6263640"/>
+            <a:ext cx="219456" cy="219456"/>
+          </a:xfrm>
+          <a:prstGeom prst="rect">
+            <a:avLst/>
+          </a:prstGeom>
+          <a:noFill/>
+          <a:ln/>
+        </p:spPr>
+        <p:txBody>
+          <a:bodyPr wrap="square" lIns="0" tIns="0" rIns="0" bIns="0" rtlCol="0" anchor="ctr"/>
+          <a:lstStyle/>
+          <a:p>
+            <a:pPr algn="ctr" indent="0" marL="0">
+              <a:buNone/>
+            </a:pPr>
+            <a:r>
+              <a:rPr lang="en-US" sz="816" b="1" dirty="0">
+                <a:solidFill>
+                  <a:srgbClr val="FFFFFF"/>
                 </a:solidFill>
                 <a:latin typeface="Arial" pitchFamily="34" charset="0"/>
                 <a:ea typeface="Arial" pitchFamily="34" charset="-122"/>
                 <a:cs typeface="Arial" pitchFamily="34" charset="-120"/>
               </a:rPr>
+              <a:t>BIG</a:t>
+            </a:r>
+            <a:endParaRPr lang="en-US" sz="816" dirty="0"/>
+          </a:p>
+        </p:txBody>
+      </p:sp>
+      <p:sp>
+        <p:nvSpPr>
+          <p:cNvPr id="36" name="Text 34"/>
+          <p:cNvSpPr/>
+          <p:nvPr/>
+        </p:nvSpPr>
+        <p:spPr>
+          <a:xfrm>
+            <a:off x="1078992" y="6263640"/>
+            <a:ext cx="658368" cy="219456"/>
+          </a:xfrm>
+          <a:prstGeom prst="rect">
+            <a:avLst/>
+          </a:prstGeom>
+          <a:noFill/>
+          <a:ln/>
+        </p:spPr>
+        <p:txBody>
+          <a:bodyPr wrap="square" lIns="0" tIns="0" rIns="0" bIns="0" rtlCol="0" anchor="ctr"/>
+          <a:lstStyle/>
+          <a:p>
+            <a:pPr algn="l" indent="0" marL="0">
+              <a:buNone/>
+            </a:pPr>
+            <a:r>
+              <a:rPr lang="en-US" sz="816" dirty="0">
+                <a:solidFill>
+                  <a:srgbClr val="1A1C2E"/>
+                </a:solidFill>
+                <a:latin typeface="Arial" pitchFamily="34" charset="0"/>
+                <a:ea typeface="Arial" pitchFamily="34" charset="-122"/>
+                <a:cs typeface="Arial" pitchFamily="34" charset="-120"/>
+              </a:rPr>
               <a:t>school</a:t>
             </a:r>
             <a:endParaRPr lang="en-US" sz="816" dirty="0"/>
@@ -11152,7 +10808,7 @@
       </p:sp>
       <p:sp>
         <p:nvSpPr>
-          <p:cNvPr id="42" name="Text 40"/>
+          <p:cNvPr id="37" name="Text 35"/>
           <p:cNvSpPr/>
           <p:nvPr/>
         </p:nvSpPr>

</xml_diff>

<commit_message>
docs(tfm): flujo de trabajo como diagrama con decision
</commit_message>
<xml_diff>
--- a/docs/presentacion/tfm-intelligent-automotive-diagnostics.pptx
+++ b/docs/presentacion/tfm-intelligent-automotive-diagnostics.pptx
@@ -1627,12 +1627,12 @@
           <a:p>
             <a:r>
               <a:rPr lang="en-US" dirty="0"/>
-              <a:t>Este es el recorrido de trabajo, de principio a fin.
-Empieza donde empieza de verdad: se enchufa el adaptador al conector de diagnóstico del coche y se pulsa iniciar. A partir de ahí va solo.
-Lo primero, preguntarle al coche el bastidor para saber qué vehículo es. Después un barrido del bus, para ver qué centralitas responden. Luego se leen los datos en vivo, los códigos de avería y el freeze frame. Y con eso se calcula la severidad y sale todo en pantalla.
-Fijaos en la línea: hasta ese punto no ha intervenido la IA. Si no hay modelo configurado, o si el taller no tiene internet, el mecánico ya tiene su diagnóstico.
-De ahí para abajo es opcional, y solo pasa si el mecánico pregunta al agente. Antes de llamarlo se buscan casos parecidos de diagnósticos anteriores. El agente pide lo que le falta: mirar el catálogo, leer más cosas del coche, o buscar en la web. Y responde con la explicación, la severidad y qué conviene revisar.
-Y el último paso es el que hace que esto crezca: el caso se guarda, y queda disponible para el siguiente coche que entre con síntomas parecidos.
+              <a:t>Este es el flujo de trabajo completo.
+Arranca arriba a la izquierda, donde arranca de verdad: se enchufa el adaptador al conector del coche y se pulsa iniciar. A partir de ahí va solo. Se lee el bastidor y se identifica el vehículo, se barre el bus para ver qué centralitas responden, se leen los datos en vivo, las averías y el freeze frame, y se calcula la severidad. Todo eso sale en pantalla.
+Y llega la decisión: ¿el mecánico pregunta al agente o no?
+Si no pregunta, se acaba ahí y la sesión queda guardada. Eso es importante: sin IA de por medio, el mecánico ya tiene un diagnóstico. Si no hay modelo configurado o el taller no tiene internet, la herramienta sigue sirviendo.
+Si pregunta, se pasa a la columna de la derecha. Antes de llamar al modelo se buscan casos parecidos de diagnósticos anteriores. El agente va pidiendo lo que le falta: el catálogo, más lecturas del coche o una búsqueda web. Responde con la explicación, la severidad y qué conviene revisar. Y el caso se indexa.
+Ese último paso es el que hace que el sistema mejore: queda disponible para el siguiente coche que entre con síntomas parecidos.
 [~75 s · acumulado 2:55]</a:t>
             </a:r>
             <a:endParaRPr lang="en-US" dirty="0"/>
@@ -9671,8 +9671,8 @@
         </p:nvSpPr>
         <p:spPr>
           <a:xfrm>
-            <a:off x="777240" y="457200"/>
-            <a:ext cx="10607040" cy="640080"/>
+            <a:off x="777240" y="384048"/>
+            <a:ext cx="10607040" cy="594360"/>
           </a:xfrm>
           <a:prstGeom prst="rect">
             <a:avLst/>
@@ -9688,7 +9688,7 @@
               <a:buNone/>
             </a:pPr>
             <a:r>
-              <a:rPr lang="en-US" sz="3200" b="1" dirty="0">
+              <a:rPr lang="en-US" sz="3000" b="1" dirty="0">
                 <a:solidFill>
                   <a:srgbClr val="1A1C2E"/>
                 </a:solidFill>
@@ -9698,7 +9698,7 @@
               </a:rPr>
               <a:t>El flujo de trabajo</a:t>
             </a:r>
-            <a:endParaRPr lang="en-US" sz="3200" dirty="0"/>
+            <a:endParaRPr lang="en-US" sz="3000" dirty="0"/>
           </a:p>
         </p:txBody>
       </p:sp>
@@ -9710,8 +9710,8 @@
         </p:nvSpPr>
         <p:spPr>
           <a:xfrm>
-            <a:off x="777240" y="1188720"/>
-            <a:ext cx="10607040" cy="320040"/>
+            <a:off x="777240" y="1078992"/>
+            <a:ext cx="10607040" cy="274320"/>
           </a:xfrm>
           <a:prstGeom prst="rect">
             <a:avLst/>
@@ -9727,7 +9727,7 @@
               <a:buNone/>
             </a:pPr>
             <a:r>
-              <a:rPr lang="en-US" sz="1500" dirty="0">
+              <a:rPr lang="en-US" sz="1400" dirty="0">
                 <a:solidFill>
                   <a:srgbClr val="5A5F73"/>
                 </a:solidFill>
@@ -9735,9 +9735,9 @@
                 <a:ea typeface="Calibri" pitchFamily="34" charset="-122"/>
                 <a:cs typeface="Calibri" pitchFamily="34" charset="-120"/>
               </a:rPr>
-              <a:t>Qué pasa desde que enchufas el adaptador hasta que el caso queda guardado.</a:t>
-            </a:r>
-            <a:endParaRPr lang="en-US" sz="1500" dirty="0"/>
+              <a:t>Desde que enchufas el adaptador hasta que el caso queda guardado.</a:t>
+            </a:r>
+            <a:endParaRPr lang="en-US" sz="1400" dirty="0"/>
           </a:p>
         </p:txBody>
       </p:sp>
@@ -9749,14 +9749,107 @@
         </p:nvSpPr>
         <p:spPr>
           <a:xfrm>
-            <a:off x="1234440" y="2075688"/>
-            <a:ext cx="0" cy="3803904"/>
-          </a:xfrm>
-          <a:prstGeom prst="line">
-            <a:avLst/>
-          </a:prstGeom>
-          <a:noFill/>
-          <a:ln w="19050">
+            <a:off x="868680" y="1572768"/>
+            <a:ext cx="4206240" cy="457200"/>
+          </a:xfrm>
+          <a:prstGeom prst="roundRect">
+            <a:avLst>
+              <a:gd name="adj" fmla="val 50000"/>
+            </a:avLst>
+          </a:prstGeom>
+          <a:solidFill>
+            <a:srgbClr val="1A1C2E"/>
+          </a:solidFill>
+          <a:ln w="12700">
+            <a:solidFill>
+              <a:srgbClr val="1A1C2E"/>
+            </a:solidFill>
+            <a:prstDash val="solid"/>
+          </a:ln>
+        </p:spPr>
+      </p:sp>
+      <p:sp>
+        <p:nvSpPr>
+          <p:cNvPr id="5" name="Text 3"/>
+          <p:cNvSpPr/>
+          <p:nvPr/>
+        </p:nvSpPr>
+        <p:spPr>
+          <a:xfrm>
+            <a:off x="978408" y="1572768"/>
+            <a:ext cx="3986784" cy="457200"/>
+          </a:xfrm>
+          <a:prstGeom prst="rect">
+            <a:avLst/>
+          </a:prstGeom>
+          <a:noFill/>
+          <a:ln/>
+        </p:spPr>
+        <p:txBody>
+          <a:bodyPr wrap="square" lIns="0" tIns="0" rIns="0" bIns="0" rtlCol="0" anchor="ctr"/>
+          <a:lstStyle/>
+          <a:p>
+            <a:pPr algn="ctr" indent="0" marL="0">
+              <a:lnSpc>
+                <a:spcPts val="1400"/>
+              </a:lnSpc>
+              <a:buNone/>
+            </a:pPr>
+            <a:r>
+              <a:rPr lang="en-US" sz="1200" b="1" dirty="0">
+                <a:solidFill>
+                  <a:srgbClr val="FFFFFF"/>
+                </a:solidFill>
+                <a:latin typeface="Calibri" pitchFamily="34" charset="0"/>
+                <a:ea typeface="Calibri" pitchFamily="34" charset="-122"/>
+                <a:cs typeface="Calibri" pitchFamily="34" charset="-120"/>
+              </a:rPr>
+              <a:t>Se enchufa el adaptador</a:t>
+            </a:r>
+            <a:endParaRPr lang="en-US" sz="1200" dirty="0"/>
+          </a:p>
+          <a:p>
+            <a:pPr algn="ctr" indent="0" marL="0">
+              <a:lnSpc>
+                <a:spcPts val="1400"/>
+              </a:lnSpc>
+              <a:buNone/>
+            </a:pPr>
+            <a:r>
+              <a:rPr lang="en-US" sz="1200" b="1" dirty="0">
+                <a:solidFill>
+                  <a:srgbClr val="FFFFFF"/>
+                </a:solidFill>
+                <a:latin typeface="Calibri" pitchFamily="34" charset="0"/>
+                <a:ea typeface="Calibri" pitchFamily="34" charset="-122"/>
+                <a:cs typeface="Calibri" pitchFamily="34" charset="-120"/>
+              </a:rPr>
+              <a:t>y se pulsa «Iniciar diagnóstico»</a:t>
+            </a:r>
+            <a:endParaRPr lang="en-US" sz="1200" dirty="0"/>
+          </a:p>
+        </p:txBody>
+      </p:sp>
+      <p:sp>
+        <p:nvSpPr>
+          <p:cNvPr id="6" name="Shape 4"/>
+          <p:cNvSpPr/>
+          <p:nvPr/>
+        </p:nvSpPr>
+        <p:spPr>
+          <a:xfrm>
+            <a:off x="868680" y="2176272"/>
+            <a:ext cx="4206240" cy="457200"/>
+          </a:xfrm>
+          <a:prstGeom prst="rect">
+            <a:avLst>
+              <a:gd name="adj" fmla="val 50000"/>
+            </a:avLst>
+          </a:prstGeom>
+          <a:solidFill>
+            <a:srgbClr val="FFFFFF"/>
+          </a:solidFill>
+          <a:ln w="12700">
             <a:solidFill>
               <a:srgbClr val="C9CCD8"/>
             </a:solidFill>
@@ -9766,16 +9859,1156 @@
       </p:sp>
       <p:sp>
         <p:nvSpPr>
-          <p:cNvPr id="5" name="Shape 3"/>
-          <p:cNvSpPr/>
-          <p:nvPr/>
-        </p:nvSpPr>
-        <p:spPr>
-          <a:xfrm>
-            <a:off x="1078992" y="1920240"/>
-            <a:ext cx="310896" cy="310896"/>
-          </a:xfrm>
-          <a:prstGeom prst="ellipse">
+          <p:cNvPr id="7" name="Text 5"/>
+          <p:cNvSpPr/>
+          <p:nvPr/>
+        </p:nvSpPr>
+        <p:spPr>
+          <a:xfrm>
+            <a:off x="978408" y="2176272"/>
+            <a:ext cx="3986784" cy="457200"/>
+          </a:xfrm>
+          <a:prstGeom prst="rect">
+            <a:avLst/>
+          </a:prstGeom>
+          <a:noFill/>
+          <a:ln/>
+        </p:spPr>
+        <p:txBody>
+          <a:bodyPr wrap="square" lIns="0" tIns="0" rIns="0" bIns="0" rtlCol="0" anchor="ctr"/>
+          <a:lstStyle/>
+          <a:p>
+            <a:pPr algn="ctr" indent="0" marL="0">
+              <a:lnSpc>
+                <a:spcPts val="1400"/>
+              </a:lnSpc>
+              <a:buNone/>
+            </a:pPr>
+            <a:r>
+              <a:rPr lang="en-US" sz="1200" dirty="0">
+                <a:solidFill>
+                  <a:srgbClr val="1A1C2E"/>
+                </a:solidFill>
+                <a:latin typeface="Calibri" pitchFamily="34" charset="0"/>
+                <a:ea typeface="Calibri" pitchFamily="34" charset="-122"/>
+                <a:cs typeface="Calibri" pitchFamily="34" charset="-120"/>
+              </a:rPr>
+              <a:t>Se lee el bastidor y se identifica el vehículo</a:t>
+            </a:r>
+            <a:endParaRPr lang="en-US" sz="1200" dirty="0"/>
+          </a:p>
+        </p:txBody>
+      </p:sp>
+      <p:sp>
+        <p:nvSpPr>
+          <p:cNvPr id="8" name="Shape 6"/>
+          <p:cNvSpPr/>
+          <p:nvPr/>
+        </p:nvSpPr>
+        <p:spPr>
+          <a:xfrm>
+            <a:off x="2971800" y="2029968"/>
+            <a:ext cx="0" cy="146304"/>
+          </a:xfrm>
+          <a:prstGeom prst="line">
+            <a:avLst/>
+          </a:prstGeom>
+          <a:noFill/>
+          <a:ln w="15875">
+            <a:solidFill>
+              <a:srgbClr val="202CFC"/>
+            </a:solidFill>
+            <a:prstDash val="solid"/>
+            <a:tailEnd type="triangle"/>
+          </a:ln>
+        </p:spPr>
+      </p:sp>
+      <p:sp>
+        <p:nvSpPr>
+          <p:cNvPr id="9" name="Shape 7"/>
+          <p:cNvSpPr/>
+          <p:nvPr/>
+        </p:nvSpPr>
+        <p:spPr>
+          <a:xfrm>
+            <a:off x="868680" y="2779776"/>
+            <a:ext cx="4206240" cy="457200"/>
+          </a:xfrm>
+          <a:prstGeom prst="rect">
+            <a:avLst>
+              <a:gd name="adj" fmla="val 50000"/>
+            </a:avLst>
+          </a:prstGeom>
+          <a:solidFill>
+            <a:srgbClr val="FFFFFF"/>
+          </a:solidFill>
+          <a:ln w="12700">
+            <a:solidFill>
+              <a:srgbClr val="C9CCD8"/>
+            </a:solidFill>
+            <a:prstDash val="solid"/>
+          </a:ln>
+        </p:spPr>
+      </p:sp>
+      <p:sp>
+        <p:nvSpPr>
+          <p:cNvPr id="10" name="Text 8"/>
+          <p:cNvSpPr/>
+          <p:nvPr/>
+        </p:nvSpPr>
+        <p:spPr>
+          <a:xfrm>
+            <a:off x="978408" y="2779776"/>
+            <a:ext cx="3986784" cy="457200"/>
+          </a:xfrm>
+          <a:prstGeom prst="rect">
+            <a:avLst/>
+          </a:prstGeom>
+          <a:noFill/>
+          <a:ln/>
+        </p:spPr>
+        <p:txBody>
+          <a:bodyPr wrap="square" lIns="0" tIns="0" rIns="0" bIns="0" rtlCol="0" anchor="ctr"/>
+          <a:lstStyle/>
+          <a:p>
+            <a:pPr algn="ctr" indent="0" marL="0">
+              <a:lnSpc>
+                <a:spcPts val="1400"/>
+              </a:lnSpc>
+              <a:buNone/>
+            </a:pPr>
+            <a:r>
+              <a:rPr lang="en-US" sz="1200" dirty="0">
+                <a:solidFill>
+                  <a:srgbClr val="1A1C2E"/>
+                </a:solidFill>
+                <a:latin typeface="Calibri" pitchFamily="34" charset="0"/>
+                <a:ea typeface="Calibri" pitchFamily="34" charset="-122"/>
+                <a:cs typeface="Calibri" pitchFamily="34" charset="-120"/>
+              </a:rPr>
+              <a:t>Se barre el bus: qué centralitas responden</a:t>
+            </a:r>
+            <a:endParaRPr lang="en-US" sz="1200" dirty="0"/>
+          </a:p>
+        </p:txBody>
+      </p:sp>
+      <p:sp>
+        <p:nvSpPr>
+          <p:cNvPr id="11" name="Shape 9"/>
+          <p:cNvSpPr/>
+          <p:nvPr/>
+        </p:nvSpPr>
+        <p:spPr>
+          <a:xfrm>
+            <a:off x="2971800" y="2633472"/>
+            <a:ext cx="0" cy="146304"/>
+          </a:xfrm>
+          <a:prstGeom prst="line">
+            <a:avLst/>
+          </a:prstGeom>
+          <a:noFill/>
+          <a:ln w="15875">
+            <a:solidFill>
+              <a:srgbClr val="202CFC"/>
+            </a:solidFill>
+            <a:prstDash val="solid"/>
+            <a:tailEnd type="triangle"/>
+          </a:ln>
+        </p:spPr>
+      </p:sp>
+      <p:sp>
+        <p:nvSpPr>
+          <p:cNvPr id="12" name="Shape 10"/>
+          <p:cNvSpPr/>
+          <p:nvPr/>
+        </p:nvSpPr>
+        <p:spPr>
+          <a:xfrm>
+            <a:off x="868680" y="3383280"/>
+            <a:ext cx="4206240" cy="457200"/>
+          </a:xfrm>
+          <a:prstGeom prst="rect">
+            <a:avLst>
+              <a:gd name="adj" fmla="val 50000"/>
+            </a:avLst>
+          </a:prstGeom>
+          <a:solidFill>
+            <a:srgbClr val="FFFFFF"/>
+          </a:solidFill>
+          <a:ln w="12700">
+            <a:solidFill>
+              <a:srgbClr val="C9CCD8"/>
+            </a:solidFill>
+            <a:prstDash val="solid"/>
+          </a:ln>
+        </p:spPr>
+      </p:sp>
+      <p:sp>
+        <p:nvSpPr>
+          <p:cNvPr id="13" name="Text 11"/>
+          <p:cNvSpPr/>
+          <p:nvPr/>
+        </p:nvSpPr>
+        <p:spPr>
+          <a:xfrm>
+            <a:off x="978408" y="3383280"/>
+            <a:ext cx="3986784" cy="457200"/>
+          </a:xfrm>
+          <a:prstGeom prst="rect">
+            <a:avLst/>
+          </a:prstGeom>
+          <a:noFill/>
+          <a:ln/>
+        </p:spPr>
+        <p:txBody>
+          <a:bodyPr wrap="square" lIns="0" tIns="0" rIns="0" bIns="0" rtlCol="0" anchor="ctr"/>
+          <a:lstStyle/>
+          <a:p>
+            <a:pPr algn="ctr" indent="0" marL="0">
+              <a:lnSpc>
+                <a:spcPts val="1400"/>
+              </a:lnSpc>
+              <a:buNone/>
+            </a:pPr>
+            <a:r>
+              <a:rPr lang="en-US" sz="1200" dirty="0">
+                <a:solidFill>
+                  <a:srgbClr val="1A1C2E"/>
+                </a:solidFill>
+                <a:latin typeface="Calibri" pitchFamily="34" charset="0"/>
+                <a:ea typeface="Calibri" pitchFamily="34" charset="-122"/>
+                <a:cs typeface="Calibri" pitchFamily="34" charset="-120"/>
+              </a:rPr>
+              <a:t>Se leen datos en vivo, averías y freeze frame</a:t>
+            </a:r>
+            <a:endParaRPr lang="en-US" sz="1200" dirty="0"/>
+          </a:p>
+        </p:txBody>
+      </p:sp>
+      <p:sp>
+        <p:nvSpPr>
+          <p:cNvPr id="14" name="Shape 12"/>
+          <p:cNvSpPr/>
+          <p:nvPr/>
+        </p:nvSpPr>
+        <p:spPr>
+          <a:xfrm>
+            <a:off x="2971800" y="3236976"/>
+            <a:ext cx="0" cy="146304"/>
+          </a:xfrm>
+          <a:prstGeom prst="line">
+            <a:avLst/>
+          </a:prstGeom>
+          <a:noFill/>
+          <a:ln w="15875">
+            <a:solidFill>
+              <a:srgbClr val="202CFC"/>
+            </a:solidFill>
+            <a:prstDash val="solid"/>
+            <a:tailEnd type="triangle"/>
+          </a:ln>
+        </p:spPr>
+      </p:sp>
+      <p:sp>
+        <p:nvSpPr>
+          <p:cNvPr id="15" name="Shape 13"/>
+          <p:cNvSpPr/>
+          <p:nvPr/>
+        </p:nvSpPr>
+        <p:spPr>
+          <a:xfrm>
+            <a:off x="868680" y="3986784"/>
+            <a:ext cx="4206240" cy="457200"/>
+          </a:xfrm>
+          <a:prstGeom prst="rect">
+            <a:avLst>
+              <a:gd name="adj" fmla="val 50000"/>
+            </a:avLst>
+          </a:prstGeom>
+          <a:solidFill>
+            <a:srgbClr val="FFFFFF"/>
+          </a:solidFill>
+          <a:ln w="12700">
+            <a:solidFill>
+              <a:srgbClr val="C9CCD8"/>
+            </a:solidFill>
+            <a:prstDash val="solid"/>
+          </a:ln>
+        </p:spPr>
+      </p:sp>
+      <p:sp>
+        <p:nvSpPr>
+          <p:cNvPr id="16" name="Text 14"/>
+          <p:cNvSpPr/>
+          <p:nvPr/>
+        </p:nvSpPr>
+        <p:spPr>
+          <a:xfrm>
+            <a:off x="978408" y="3986784"/>
+            <a:ext cx="3986784" cy="457200"/>
+          </a:xfrm>
+          <a:prstGeom prst="rect">
+            <a:avLst/>
+          </a:prstGeom>
+          <a:noFill/>
+          <a:ln/>
+        </p:spPr>
+        <p:txBody>
+          <a:bodyPr wrap="square" lIns="0" tIns="0" rIns="0" bIns="0" rtlCol="0" anchor="ctr"/>
+          <a:lstStyle/>
+          <a:p>
+            <a:pPr algn="ctr" indent="0" marL="0">
+              <a:lnSpc>
+                <a:spcPts val="1400"/>
+              </a:lnSpc>
+              <a:buNone/>
+            </a:pPr>
+            <a:r>
+              <a:rPr lang="en-US" sz="1200" dirty="0">
+                <a:solidFill>
+                  <a:srgbClr val="1A1C2E"/>
+                </a:solidFill>
+                <a:latin typeface="Calibri" pitchFamily="34" charset="0"/>
+                <a:ea typeface="Calibri" pitchFamily="34" charset="-122"/>
+                <a:cs typeface="Calibri" pitchFamily="34" charset="-120"/>
+              </a:rPr>
+              <a:t>Se calcula la severidad y sale en pantalla</a:t>
+            </a:r>
+            <a:endParaRPr lang="en-US" sz="1200" dirty="0"/>
+          </a:p>
+        </p:txBody>
+      </p:sp>
+      <p:sp>
+        <p:nvSpPr>
+          <p:cNvPr id="17" name="Shape 15"/>
+          <p:cNvSpPr/>
+          <p:nvPr/>
+        </p:nvSpPr>
+        <p:spPr>
+          <a:xfrm>
+            <a:off x="2971800" y="3840480"/>
+            <a:ext cx="0" cy="146304"/>
+          </a:xfrm>
+          <a:prstGeom prst="line">
+            <a:avLst/>
+          </a:prstGeom>
+          <a:noFill/>
+          <a:ln w="15875">
+            <a:solidFill>
+              <a:srgbClr val="202CFC"/>
+            </a:solidFill>
+            <a:prstDash val="solid"/>
+            <a:tailEnd type="triangle"/>
+          </a:ln>
+        </p:spPr>
+      </p:sp>
+      <p:sp>
+        <p:nvSpPr>
+          <p:cNvPr id="18" name="Shape 16"/>
+          <p:cNvSpPr/>
+          <p:nvPr/>
+        </p:nvSpPr>
+        <p:spPr>
+          <a:xfrm>
+            <a:off x="2971800" y="4443984"/>
+            <a:ext cx="0" cy="146304"/>
+          </a:xfrm>
+          <a:prstGeom prst="line">
+            <a:avLst/>
+          </a:prstGeom>
+          <a:noFill/>
+          <a:ln w="15875">
+            <a:solidFill>
+              <a:srgbClr val="202CFC"/>
+            </a:solidFill>
+            <a:prstDash val="solid"/>
+            <a:tailEnd type="triangle"/>
+          </a:ln>
+        </p:spPr>
+      </p:sp>
+      <p:sp>
+        <p:nvSpPr>
+          <p:cNvPr id="19" name="Shape 17"/>
+          <p:cNvSpPr/>
+          <p:nvPr/>
+        </p:nvSpPr>
+        <p:spPr>
+          <a:xfrm>
+            <a:off x="1371600" y="4590288"/>
+            <a:ext cx="3200400" cy="713232"/>
+          </a:xfrm>
+          <a:prstGeom prst="diamond">
+            <a:avLst>
+              <a:gd name="adj" fmla="val 32051"/>
+            </a:avLst>
+          </a:prstGeom>
+          <a:solidFill>
+            <a:srgbClr val="FFFFFF"/>
+          </a:solidFill>
+          <a:ln w="12700">
+            <a:solidFill>
+              <a:srgbClr val="202CFC"/>
+            </a:solidFill>
+            <a:prstDash val="solid"/>
+          </a:ln>
+        </p:spPr>
+      </p:sp>
+      <p:sp>
+        <p:nvSpPr>
+          <p:cNvPr id="20" name="Text 18"/>
+          <p:cNvSpPr/>
+          <p:nvPr/>
+        </p:nvSpPr>
+        <p:spPr>
+          <a:xfrm>
+            <a:off x="1481328" y="4590288"/>
+            <a:ext cx="2980944" cy="713232"/>
+          </a:xfrm>
+          <a:prstGeom prst="rect">
+            <a:avLst/>
+          </a:prstGeom>
+          <a:noFill/>
+          <a:ln/>
+        </p:spPr>
+        <p:txBody>
+          <a:bodyPr wrap="square" lIns="0" tIns="0" rIns="0" bIns="0" rtlCol="0" anchor="ctr"/>
+          <a:lstStyle/>
+          <a:p>
+            <a:pPr algn="ctr" indent="0" marL="0">
+              <a:lnSpc>
+                <a:spcPts val="1400"/>
+              </a:lnSpc>
+              <a:buNone/>
+            </a:pPr>
+            <a:r>
+              <a:rPr lang="en-US" sz="1100" dirty="0">
+                <a:solidFill>
+                  <a:srgbClr val="1A1C2E"/>
+                </a:solidFill>
+                <a:latin typeface="Calibri" pitchFamily="34" charset="0"/>
+                <a:ea typeface="Calibri" pitchFamily="34" charset="-122"/>
+                <a:cs typeface="Calibri" pitchFamily="34" charset="-120"/>
+              </a:rPr>
+              <a:t>¿El mecánico pregunta</a:t>
+            </a:r>
+            <a:endParaRPr lang="en-US" sz="1100" dirty="0"/>
+          </a:p>
+          <a:p>
+            <a:pPr algn="ctr" indent="0" marL="0">
+              <a:lnSpc>
+                <a:spcPts val="1400"/>
+              </a:lnSpc>
+              <a:buNone/>
+            </a:pPr>
+            <a:r>
+              <a:rPr lang="en-US" sz="1100" dirty="0">
+                <a:solidFill>
+                  <a:srgbClr val="1A1C2E"/>
+                </a:solidFill>
+                <a:latin typeface="Calibri" pitchFamily="34" charset="0"/>
+                <a:ea typeface="Calibri" pitchFamily="34" charset="-122"/>
+                <a:cs typeface="Calibri" pitchFamily="34" charset="-120"/>
+              </a:rPr>
+              <a:t>al agente?</a:t>
+            </a:r>
+            <a:endParaRPr lang="en-US" sz="1100" dirty="0"/>
+          </a:p>
+        </p:txBody>
+      </p:sp>
+      <p:sp>
+        <p:nvSpPr>
+          <p:cNvPr id="21" name="Shape 19"/>
+          <p:cNvSpPr/>
+          <p:nvPr/>
+        </p:nvSpPr>
+        <p:spPr>
+          <a:xfrm>
+            <a:off x="2971800" y="5303520"/>
+            <a:ext cx="0" cy="256032"/>
+          </a:xfrm>
+          <a:prstGeom prst="line">
+            <a:avLst/>
+          </a:prstGeom>
+          <a:noFill/>
+          <a:ln w="15875">
+            <a:solidFill>
+              <a:srgbClr val="202CFC"/>
+            </a:solidFill>
+            <a:prstDash val="solid"/>
+            <a:tailEnd type="triangle"/>
+          </a:ln>
+        </p:spPr>
+      </p:sp>
+      <p:sp>
+        <p:nvSpPr>
+          <p:cNvPr id="22" name="Shape 20"/>
+          <p:cNvSpPr/>
+          <p:nvPr/>
+        </p:nvSpPr>
+        <p:spPr>
+          <a:xfrm>
+            <a:off x="868680" y="5559552"/>
+            <a:ext cx="4206240" cy="457200"/>
+          </a:xfrm>
+          <a:prstGeom prst="roundRect">
+            <a:avLst>
+              <a:gd name="adj" fmla="val 50000"/>
+            </a:avLst>
+          </a:prstGeom>
+          <a:solidFill>
+            <a:srgbClr val="1A1C2E"/>
+          </a:solidFill>
+          <a:ln w="12700">
+            <a:solidFill>
+              <a:srgbClr val="1A1C2E"/>
+            </a:solidFill>
+            <a:prstDash val="solid"/>
+          </a:ln>
+        </p:spPr>
+      </p:sp>
+      <p:sp>
+        <p:nvSpPr>
+          <p:cNvPr id="23" name="Text 21"/>
+          <p:cNvSpPr/>
+          <p:nvPr/>
+        </p:nvSpPr>
+        <p:spPr>
+          <a:xfrm>
+            <a:off x="978408" y="5559552"/>
+            <a:ext cx="3986784" cy="457200"/>
+          </a:xfrm>
+          <a:prstGeom prst="rect">
+            <a:avLst/>
+          </a:prstGeom>
+          <a:noFill/>
+          <a:ln/>
+        </p:spPr>
+        <p:txBody>
+          <a:bodyPr wrap="square" lIns="0" tIns="0" rIns="0" bIns="0" rtlCol="0" anchor="ctr"/>
+          <a:lstStyle/>
+          <a:p>
+            <a:pPr algn="ctr" indent="0" marL="0">
+              <a:lnSpc>
+                <a:spcPts val="1400"/>
+              </a:lnSpc>
+              <a:buNone/>
+            </a:pPr>
+            <a:r>
+              <a:rPr lang="en-US" sz="1200" b="1" dirty="0">
+                <a:solidFill>
+                  <a:srgbClr val="FFFFFF"/>
+                </a:solidFill>
+                <a:latin typeface="Calibri" pitchFamily="34" charset="0"/>
+                <a:ea typeface="Calibri" pitchFamily="34" charset="-122"/>
+                <a:cs typeface="Calibri" pitchFamily="34" charset="-120"/>
+              </a:rPr>
+              <a:t>La sesión queda guardada</a:t>
+            </a:r>
+            <a:endParaRPr lang="en-US" sz="1200" dirty="0"/>
+          </a:p>
+        </p:txBody>
+      </p:sp>
+      <p:sp>
+        <p:nvSpPr>
+          <p:cNvPr id="24" name="Text 22"/>
+          <p:cNvSpPr/>
+          <p:nvPr/>
+        </p:nvSpPr>
+        <p:spPr>
+          <a:xfrm>
+            <a:off x="3063240" y="5312664"/>
+            <a:ext cx="457200" cy="228600"/>
+          </a:xfrm>
+          <a:prstGeom prst="rect">
+            <a:avLst/>
+          </a:prstGeom>
+          <a:noFill/>
+          <a:ln/>
+        </p:spPr>
+        <p:txBody>
+          <a:bodyPr wrap="square" lIns="0" tIns="0" rIns="0" bIns="0" rtlCol="0" anchor="ctr"/>
+          <a:lstStyle/>
+          <a:p>
+            <a:pPr indent="0" marL="0">
+              <a:buNone/>
+            </a:pPr>
+            <a:r>
+              <a:rPr lang="en-US" sz="1100" i="1" dirty="0">
+                <a:solidFill>
+                  <a:srgbClr val="5A5F73"/>
+                </a:solidFill>
+                <a:latin typeface="Calibri" pitchFamily="34" charset="0"/>
+                <a:ea typeface="Calibri" pitchFamily="34" charset="-122"/>
+                <a:cs typeface="Calibri" pitchFamily="34" charset="-120"/>
+              </a:rPr>
+              <a:t>no</a:t>
+            </a:r>
+            <a:endParaRPr lang="en-US" sz="1100" dirty="0"/>
+          </a:p>
+        </p:txBody>
+      </p:sp>
+      <p:sp>
+        <p:nvSpPr>
+          <p:cNvPr id="25" name="Shape 23"/>
+          <p:cNvSpPr/>
+          <p:nvPr/>
+        </p:nvSpPr>
+        <p:spPr>
+          <a:xfrm>
+            <a:off x="4572000" y="4946904"/>
+            <a:ext cx="1554480" cy="0"/>
+          </a:xfrm>
+          <a:prstGeom prst="line">
+            <a:avLst/>
+          </a:prstGeom>
+          <a:noFill/>
+          <a:ln w="15875">
+            <a:solidFill>
+              <a:srgbClr val="202CFC"/>
+            </a:solidFill>
+            <a:prstDash val="solid"/>
+          </a:ln>
+        </p:spPr>
+      </p:sp>
+      <p:sp>
+        <p:nvSpPr>
+          <p:cNvPr id="26" name="Shape 24"/>
+          <p:cNvSpPr/>
+          <p:nvPr/>
+        </p:nvSpPr>
+        <p:spPr>
+          <a:xfrm>
+            <a:off x="6126480" y="1801368"/>
+            <a:ext cx="0" cy="3145536"/>
+          </a:xfrm>
+          <a:prstGeom prst="line">
+            <a:avLst/>
+          </a:prstGeom>
+          <a:noFill/>
+          <a:ln w="15875">
+            <a:solidFill>
+              <a:srgbClr val="202CFC"/>
+            </a:solidFill>
+            <a:prstDash val="solid"/>
+          </a:ln>
+        </p:spPr>
+      </p:sp>
+      <p:sp>
+        <p:nvSpPr>
+          <p:cNvPr id="27" name="Shape 25"/>
+          <p:cNvSpPr/>
+          <p:nvPr/>
+        </p:nvSpPr>
+        <p:spPr>
+          <a:xfrm>
+            <a:off x="6126480" y="1801368"/>
+            <a:ext cx="960120" cy="0"/>
+          </a:xfrm>
+          <a:prstGeom prst="line">
+            <a:avLst/>
+          </a:prstGeom>
+          <a:noFill/>
+          <a:ln w="15875">
+            <a:solidFill>
+              <a:srgbClr val="202CFC"/>
+            </a:solidFill>
+            <a:prstDash val="solid"/>
+            <a:tailEnd type="triangle"/>
+          </a:ln>
+        </p:spPr>
+      </p:sp>
+      <p:sp>
+        <p:nvSpPr>
+          <p:cNvPr id="28" name="Text 26"/>
+          <p:cNvSpPr/>
+          <p:nvPr/>
+        </p:nvSpPr>
+        <p:spPr>
+          <a:xfrm>
+            <a:off x="4709160" y="4690872"/>
+            <a:ext cx="457200" cy="228600"/>
+          </a:xfrm>
+          <a:prstGeom prst="rect">
+            <a:avLst/>
+          </a:prstGeom>
+          <a:noFill/>
+          <a:ln/>
+        </p:spPr>
+        <p:txBody>
+          <a:bodyPr wrap="square" lIns="0" tIns="0" rIns="0" bIns="0" rtlCol="0" anchor="ctr"/>
+          <a:lstStyle/>
+          <a:p>
+            <a:pPr indent="0" marL="0">
+              <a:buNone/>
+            </a:pPr>
+            <a:r>
+              <a:rPr lang="en-US" sz="1100" i="1" dirty="0">
+                <a:solidFill>
+                  <a:srgbClr val="5A5F73"/>
+                </a:solidFill>
+                <a:latin typeface="Calibri" pitchFamily="34" charset="0"/>
+                <a:ea typeface="Calibri" pitchFamily="34" charset="-122"/>
+                <a:cs typeface="Calibri" pitchFamily="34" charset="-120"/>
+              </a:rPr>
+              <a:t>sí</a:t>
+            </a:r>
+            <a:endParaRPr lang="en-US" sz="1100" dirty="0"/>
+          </a:p>
+        </p:txBody>
+      </p:sp>
+      <p:sp>
+        <p:nvSpPr>
+          <p:cNvPr id="29" name="Shape 27"/>
+          <p:cNvSpPr/>
+          <p:nvPr/>
+        </p:nvSpPr>
+        <p:spPr>
+          <a:xfrm>
+            <a:off x="7086600" y="1572768"/>
+            <a:ext cx="4206240" cy="457200"/>
+          </a:xfrm>
+          <a:prstGeom prst="rect">
+            <a:avLst>
+              <a:gd name="adj" fmla="val 50000"/>
+            </a:avLst>
+          </a:prstGeom>
+          <a:solidFill>
+            <a:srgbClr val="FFFFFF"/>
+          </a:solidFill>
+          <a:ln w="12700">
+            <a:solidFill>
+              <a:srgbClr val="C9CCD8"/>
+            </a:solidFill>
+            <a:prstDash val="solid"/>
+          </a:ln>
+        </p:spPr>
+      </p:sp>
+      <p:sp>
+        <p:nvSpPr>
+          <p:cNvPr id="30" name="Text 28"/>
+          <p:cNvSpPr/>
+          <p:nvPr/>
+        </p:nvSpPr>
+        <p:spPr>
+          <a:xfrm>
+            <a:off x="7196328" y="1572768"/>
+            <a:ext cx="3986784" cy="457200"/>
+          </a:xfrm>
+          <a:prstGeom prst="rect">
+            <a:avLst/>
+          </a:prstGeom>
+          <a:noFill/>
+          <a:ln/>
+        </p:spPr>
+        <p:txBody>
+          <a:bodyPr wrap="square" lIns="0" tIns="0" rIns="0" bIns="0" rtlCol="0" anchor="ctr"/>
+          <a:lstStyle/>
+          <a:p>
+            <a:pPr algn="ctr" indent="0" marL="0">
+              <a:lnSpc>
+                <a:spcPts val="1400"/>
+              </a:lnSpc>
+              <a:buNone/>
+            </a:pPr>
+            <a:r>
+              <a:rPr lang="en-US" sz="1200" dirty="0">
+                <a:solidFill>
+                  <a:srgbClr val="1A1C2E"/>
+                </a:solidFill>
+                <a:latin typeface="Calibri" pitchFamily="34" charset="0"/>
+                <a:ea typeface="Calibri" pitchFamily="34" charset="-122"/>
+                <a:cs typeface="Calibri" pitchFamily="34" charset="-120"/>
+              </a:rPr>
+              <a:t>Se buscan casos parecidos de otros diagnósticos</a:t>
+            </a:r>
+            <a:endParaRPr lang="en-US" sz="1200" dirty="0"/>
+          </a:p>
+        </p:txBody>
+      </p:sp>
+      <p:sp>
+        <p:nvSpPr>
+          <p:cNvPr id="31" name="Shape 29"/>
+          <p:cNvSpPr/>
+          <p:nvPr/>
+        </p:nvSpPr>
+        <p:spPr>
+          <a:xfrm>
+            <a:off x="7086600" y="2176272"/>
+            <a:ext cx="4206240" cy="457200"/>
+          </a:xfrm>
+          <a:prstGeom prst="rect">
+            <a:avLst>
+              <a:gd name="adj" fmla="val 50000"/>
+            </a:avLst>
+          </a:prstGeom>
+          <a:solidFill>
+            <a:srgbClr val="FFFFFF"/>
+          </a:solidFill>
+          <a:ln w="12700">
+            <a:solidFill>
+              <a:srgbClr val="C9CCD8"/>
+            </a:solidFill>
+            <a:prstDash val="solid"/>
+          </a:ln>
+        </p:spPr>
+      </p:sp>
+      <p:sp>
+        <p:nvSpPr>
+          <p:cNvPr id="32" name="Text 30"/>
+          <p:cNvSpPr/>
+          <p:nvPr/>
+        </p:nvSpPr>
+        <p:spPr>
+          <a:xfrm>
+            <a:off x="7196328" y="2176272"/>
+            <a:ext cx="3986784" cy="457200"/>
+          </a:xfrm>
+          <a:prstGeom prst="rect">
+            <a:avLst/>
+          </a:prstGeom>
+          <a:noFill/>
+          <a:ln/>
+        </p:spPr>
+        <p:txBody>
+          <a:bodyPr wrap="square" lIns="0" tIns="0" rIns="0" bIns="0" rtlCol="0" anchor="ctr"/>
+          <a:lstStyle/>
+          <a:p>
+            <a:pPr algn="ctr" indent="0" marL="0">
+              <a:lnSpc>
+                <a:spcPts val="1400"/>
+              </a:lnSpc>
+              <a:buNone/>
+            </a:pPr>
+            <a:r>
+              <a:rPr lang="en-US" sz="1200" dirty="0">
+                <a:solidFill>
+                  <a:srgbClr val="1A1C2E"/>
+                </a:solidFill>
+                <a:latin typeface="Calibri" pitchFamily="34" charset="0"/>
+                <a:ea typeface="Calibri" pitchFamily="34" charset="-122"/>
+                <a:cs typeface="Calibri" pitchFamily="34" charset="-120"/>
+              </a:rPr>
+              <a:t>El agente pide lo que le falta</a:t>
+            </a:r>
+            <a:endParaRPr lang="en-US" sz="1200" dirty="0"/>
+          </a:p>
+        </p:txBody>
+      </p:sp>
+      <p:sp>
+        <p:nvSpPr>
+          <p:cNvPr id="33" name="Shape 31"/>
+          <p:cNvSpPr/>
+          <p:nvPr/>
+        </p:nvSpPr>
+        <p:spPr>
+          <a:xfrm>
+            <a:off x="9189720" y="2029968"/>
+            <a:ext cx="0" cy="146304"/>
+          </a:xfrm>
+          <a:prstGeom prst="line">
+            <a:avLst/>
+          </a:prstGeom>
+          <a:noFill/>
+          <a:ln w="15875">
+            <a:solidFill>
+              <a:srgbClr val="202CFC"/>
+            </a:solidFill>
+            <a:prstDash val="solid"/>
+            <a:tailEnd type="triangle"/>
+          </a:ln>
+        </p:spPr>
+      </p:sp>
+      <p:sp>
+        <p:nvSpPr>
+          <p:cNvPr id="34" name="Shape 32"/>
+          <p:cNvSpPr/>
+          <p:nvPr/>
+        </p:nvSpPr>
+        <p:spPr>
+          <a:xfrm>
+            <a:off x="7086600" y="2779776"/>
+            <a:ext cx="4206240" cy="457200"/>
+          </a:xfrm>
+          <a:prstGeom prst="rect">
+            <a:avLst>
+              <a:gd name="adj" fmla="val 50000"/>
+            </a:avLst>
+          </a:prstGeom>
+          <a:solidFill>
+            <a:srgbClr val="FFFFFF"/>
+          </a:solidFill>
+          <a:ln w="12700">
+            <a:solidFill>
+              <a:srgbClr val="C9CCD8"/>
+            </a:solidFill>
+            <a:prstDash val="solid"/>
+          </a:ln>
+        </p:spPr>
+      </p:sp>
+      <p:sp>
+        <p:nvSpPr>
+          <p:cNvPr id="35" name="Text 33"/>
+          <p:cNvSpPr/>
+          <p:nvPr/>
+        </p:nvSpPr>
+        <p:spPr>
+          <a:xfrm>
+            <a:off x="7196328" y="2779776"/>
+            <a:ext cx="3986784" cy="457200"/>
+          </a:xfrm>
+          <a:prstGeom prst="rect">
+            <a:avLst/>
+          </a:prstGeom>
+          <a:noFill/>
+          <a:ln/>
+        </p:spPr>
+        <p:txBody>
+          <a:bodyPr wrap="square" lIns="0" tIns="0" rIns="0" bIns="0" rtlCol="0" anchor="ctr"/>
+          <a:lstStyle/>
+          <a:p>
+            <a:pPr algn="ctr" indent="0" marL="0">
+              <a:lnSpc>
+                <a:spcPts val="1400"/>
+              </a:lnSpc>
+              <a:buNone/>
+            </a:pPr>
+            <a:r>
+              <a:rPr lang="en-US" sz="1200" dirty="0">
+                <a:solidFill>
+                  <a:srgbClr val="1A1C2E"/>
+                </a:solidFill>
+                <a:latin typeface="Calibri" pitchFamily="34" charset="0"/>
+                <a:ea typeface="Calibri" pitchFamily="34" charset="-122"/>
+                <a:cs typeface="Calibri" pitchFamily="34" charset="-120"/>
+              </a:rPr>
+              <a:t>Responde: explicación, severidad y qué revisar</a:t>
+            </a:r>
+            <a:endParaRPr lang="en-US" sz="1200" dirty="0"/>
+          </a:p>
+        </p:txBody>
+      </p:sp>
+      <p:sp>
+        <p:nvSpPr>
+          <p:cNvPr id="36" name="Shape 34"/>
+          <p:cNvSpPr/>
+          <p:nvPr/>
+        </p:nvSpPr>
+        <p:spPr>
+          <a:xfrm>
+            <a:off x="9189720" y="2633472"/>
+            <a:ext cx="0" cy="146304"/>
+          </a:xfrm>
+          <a:prstGeom prst="line">
+            <a:avLst/>
+          </a:prstGeom>
+          <a:noFill/>
+          <a:ln w="15875">
+            <a:solidFill>
+              <a:srgbClr val="202CFC"/>
+            </a:solidFill>
+            <a:prstDash val="solid"/>
+            <a:tailEnd type="triangle"/>
+          </a:ln>
+        </p:spPr>
+      </p:sp>
+      <p:sp>
+        <p:nvSpPr>
+          <p:cNvPr id="37" name="Shape 35"/>
+          <p:cNvSpPr/>
+          <p:nvPr/>
+        </p:nvSpPr>
+        <p:spPr>
+          <a:xfrm>
+            <a:off x="7086600" y="3383280"/>
+            <a:ext cx="4206240" cy="457200"/>
+          </a:xfrm>
+          <a:prstGeom prst="rect">
+            <a:avLst>
+              <a:gd name="adj" fmla="val 50000"/>
+            </a:avLst>
+          </a:prstGeom>
+          <a:solidFill>
+            <a:srgbClr val="FFFFFF"/>
+          </a:solidFill>
+          <a:ln w="12700">
+            <a:solidFill>
+              <a:srgbClr val="C9CCD8"/>
+            </a:solidFill>
+            <a:prstDash val="solid"/>
+          </a:ln>
+        </p:spPr>
+      </p:sp>
+      <p:sp>
+        <p:nvSpPr>
+          <p:cNvPr id="38" name="Text 36"/>
+          <p:cNvSpPr/>
+          <p:nvPr/>
+        </p:nvSpPr>
+        <p:spPr>
+          <a:xfrm>
+            <a:off x="7196328" y="3383280"/>
+            <a:ext cx="3986784" cy="457200"/>
+          </a:xfrm>
+          <a:prstGeom prst="rect">
+            <a:avLst/>
+          </a:prstGeom>
+          <a:noFill/>
+          <a:ln/>
+        </p:spPr>
+        <p:txBody>
+          <a:bodyPr wrap="square" lIns="0" tIns="0" rIns="0" bIns="0" rtlCol="0" anchor="ctr"/>
+          <a:lstStyle/>
+          <a:p>
+            <a:pPr algn="ctr" indent="0" marL="0">
+              <a:lnSpc>
+                <a:spcPts val="1400"/>
+              </a:lnSpc>
+              <a:buNone/>
+            </a:pPr>
+            <a:r>
+              <a:rPr lang="en-US" sz="1200" dirty="0">
+                <a:solidFill>
+                  <a:srgbClr val="1A1C2E"/>
+                </a:solidFill>
+                <a:latin typeface="Calibri" pitchFamily="34" charset="0"/>
+                <a:ea typeface="Calibri" pitchFamily="34" charset="-122"/>
+                <a:cs typeface="Calibri" pitchFamily="34" charset="-120"/>
+              </a:rPr>
+              <a:t>El caso se indexa en el catálogo</a:t>
+            </a:r>
+            <a:endParaRPr lang="en-US" sz="1200" dirty="0"/>
+          </a:p>
+        </p:txBody>
+      </p:sp>
+      <p:sp>
+        <p:nvSpPr>
+          <p:cNvPr id="39" name="Shape 37"/>
+          <p:cNvSpPr/>
+          <p:nvPr/>
+        </p:nvSpPr>
+        <p:spPr>
+          <a:xfrm>
+            <a:off x="9189720" y="3236976"/>
+            <a:ext cx="0" cy="146304"/>
+          </a:xfrm>
+          <a:prstGeom prst="line">
+            <a:avLst/>
+          </a:prstGeom>
+          <a:noFill/>
+          <a:ln w="15875">
+            <a:solidFill>
+              <a:srgbClr val="202CFC"/>
+            </a:solidFill>
+            <a:prstDash val="solid"/>
+            <a:tailEnd type="triangle"/>
+          </a:ln>
+        </p:spPr>
+      </p:sp>
+      <p:sp>
+        <p:nvSpPr>
+          <p:cNvPr id="40" name="Shape 38"/>
+          <p:cNvSpPr/>
+          <p:nvPr/>
+        </p:nvSpPr>
+        <p:spPr>
+          <a:xfrm>
+            <a:off x="7086600" y="3986784"/>
+            <a:ext cx="4206240" cy="457200"/>
+          </a:xfrm>
+          <a:prstGeom prst="roundRect">
+            <a:avLst>
+              <a:gd name="adj" fmla="val 50000"/>
+            </a:avLst>
+          </a:prstGeom>
+          <a:solidFill>
+            <a:srgbClr val="1A1C2E"/>
+          </a:solidFill>
+          <a:ln w="12700">
+            <a:solidFill>
+              <a:srgbClr val="1A1C2E"/>
+            </a:solidFill>
+            <a:prstDash val="solid"/>
+          </a:ln>
+        </p:spPr>
+      </p:sp>
+      <p:sp>
+        <p:nvSpPr>
+          <p:cNvPr id="41" name="Text 39"/>
+          <p:cNvSpPr/>
+          <p:nvPr/>
+        </p:nvSpPr>
+        <p:spPr>
+          <a:xfrm>
+            <a:off x="7196328" y="3986784"/>
+            <a:ext cx="3986784" cy="457200"/>
+          </a:xfrm>
+          <a:prstGeom prst="rect">
+            <a:avLst/>
+          </a:prstGeom>
+          <a:noFill/>
+          <a:ln/>
+        </p:spPr>
+        <p:txBody>
+          <a:bodyPr wrap="square" lIns="0" tIns="0" rIns="0" bIns="0" rtlCol="0" anchor="ctr"/>
+          <a:lstStyle/>
+          <a:p>
+            <a:pPr algn="ctr" indent="0" marL="0">
+              <a:lnSpc>
+                <a:spcPts val="1400"/>
+              </a:lnSpc>
+              <a:buNone/>
+            </a:pPr>
+            <a:r>
+              <a:rPr lang="en-US" sz="1200" b="1" dirty="0">
+                <a:solidFill>
+                  <a:srgbClr val="FFFFFF"/>
+                </a:solidFill>
+                <a:latin typeface="Calibri" pitchFamily="34" charset="0"/>
+                <a:ea typeface="Calibri" pitchFamily="34" charset="-122"/>
+                <a:cs typeface="Calibri" pitchFamily="34" charset="-120"/>
+              </a:rPr>
+              <a:t>Queda disponible para el siguiente coche</a:t>
+            </a:r>
+            <a:endParaRPr lang="en-US" sz="1200" dirty="0"/>
+          </a:p>
+        </p:txBody>
+      </p:sp>
+      <p:sp>
+        <p:nvSpPr>
+          <p:cNvPr id="42" name="Shape 40"/>
+          <p:cNvSpPr/>
+          <p:nvPr/>
+        </p:nvSpPr>
+        <p:spPr>
+          <a:xfrm>
+            <a:off x="9189720" y="3840480"/>
+            <a:ext cx="0" cy="146304"/>
+          </a:xfrm>
+          <a:prstGeom prst="line">
+            <a:avLst/>
+          </a:prstGeom>
+          <a:noFill/>
+          <a:ln w="15875">
+            <a:solidFill>
+              <a:srgbClr val="202CFC"/>
+            </a:solidFill>
+            <a:prstDash val="solid"/>
+            <a:tailEnd type="triangle"/>
+          </a:ln>
+        </p:spPr>
+      </p:sp>
+      <p:sp>
+        <p:nvSpPr>
+          <p:cNvPr id="43" name="Shape 41"/>
+          <p:cNvSpPr/>
+          <p:nvPr/>
+        </p:nvSpPr>
+        <p:spPr>
+          <a:xfrm>
+            <a:off x="777240" y="6263640"/>
+            <a:ext cx="219456" cy="219456"/>
+          </a:xfrm>
+          <a:prstGeom prst="rect">
             <a:avLst/>
           </a:prstGeom>
           <a:solidFill>
@@ -9786,14 +11019,14 @@
       </p:sp>
       <p:sp>
         <p:nvSpPr>
-          <p:cNvPr id="6" name="Text 4"/>
-          <p:cNvSpPr/>
-          <p:nvPr/>
-        </p:nvSpPr>
-        <p:spPr>
-          <a:xfrm>
-            <a:off x="1078992" y="1920240"/>
-            <a:ext cx="310896" cy="310896"/>
+          <p:cNvPr id="44" name="Text 42"/>
+          <p:cNvSpPr/>
+          <p:nvPr/>
+        </p:nvSpPr>
+        <p:spPr>
+          <a:xfrm>
+            <a:off x="777240" y="6263640"/>
+            <a:ext cx="219456" cy="219456"/>
           </a:xfrm>
           <a:prstGeom prst="rect">
             <a:avLst/>
@@ -9809,7 +11042,7 @@
               <a:buNone/>
             </a:pPr>
             <a:r>
-              <a:rPr lang="en-US" sz="1100" b="1" dirty="0">
+              <a:rPr lang="en-US" sz="816" b="1" dirty="0">
                 <a:solidFill>
                   <a:srgbClr val="FFFFFF"/>
                 </a:solidFill>
@@ -9817,22 +11050,22 @@
                 <a:ea typeface="Arial" pitchFamily="34" charset="-122"/>
                 <a:cs typeface="Arial" pitchFamily="34" charset="-120"/>
               </a:rPr>
-              <a:t>1</a:t>
-            </a:r>
-            <a:endParaRPr lang="en-US" sz="1100" dirty="0"/>
-          </a:p>
-        </p:txBody>
-      </p:sp>
-      <p:sp>
-        <p:nvSpPr>
-          <p:cNvPr id="7" name="Text 5"/>
-          <p:cNvSpPr/>
-          <p:nvPr/>
-        </p:nvSpPr>
-        <p:spPr>
-          <a:xfrm>
-            <a:off x="1618488" y="1901952"/>
-            <a:ext cx="9601200" cy="365760"/>
+              <a:t>BIG</a:t>
+            </a:r>
+            <a:endParaRPr lang="en-US" sz="816" dirty="0"/>
+          </a:p>
+        </p:txBody>
+      </p:sp>
+      <p:sp>
+        <p:nvSpPr>
+          <p:cNvPr id="45" name="Text 43"/>
+          <p:cNvSpPr/>
+          <p:nvPr/>
+        </p:nvSpPr>
+        <p:spPr>
+          <a:xfrm>
+            <a:off x="1078992" y="6263640"/>
+            <a:ext cx="658368" cy="219456"/>
           </a:xfrm>
           <a:prstGeom prst="rect">
             <a:avLst/>
@@ -9844,924 +11077,19 @@
           <a:bodyPr wrap="square" lIns="0" tIns="0" rIns="0" bIns="0" rtlCol="0" anchor="ctr"/>
           <a:lstStyle/>
           <a:p>
-            <a:pPr indent="0" marL="0">
-              <a:buNone/>
-            </a:pPr>
-            <a:r>
-              <a:rPr lang="en-US" sz="1500" dirty="0">
-                <a:solidFill>
-                  <a:srgbClr val="1A1C2E"/>
-                </a:solidFill>
-                <a:latin typeface="Calibri" pitchFamily="34" charset="0"/>
-                <a:ea typeface="Calibri" pitchFamily="34" charset="-122"/>
-                <a:cs typeface="Calibri" pitchFamily="34" charset="-120"/>
-              </a:rPr>
-              <a:t>Se enchufa el adaptador al coche y se pulsa «Iniciar diagnóstico»</a:t>
-            </a:r>
-            <a:endParaRPr lang="en-US" sz="1500" dirty="0"/>
-          </a:p>
-        </p:txBody>
-      </p:sp>
-      <p:sp>
-        <p:nvSpPr>
-          <p:cNvPr id="8" name="Shape 6"/>
-          <p:cNvSpPr/>
-          <p:nvPr/>
-        </p:nvSpPr>
-        <p:spPr>
-          <a:xfrm>
-            <a:off x="1078992" y="2395728"/>
-            <a:ext cx="310896" cy="310896"/>
-          </a:xfrm>
-          <a:prstGeom prst="ellipse">
-            <a:avLst/>
-          </a:prstGeom>
-          <a:solidFill>
-            <a:srgbClr val="202CFC"/>
-          </a:solidFill>
-          <a:ln/>
-        </p:spPr>
-      </p:sp>
-      <p:sp>
-        <p:nvSpPr>
-          <p:cNvPr id="9" name="Text 7"/>
-          <p:cNvSpPr/>
-          <p:nvPr/>
-        </p:nvSpPr>
-        <p:spPr>
-          <a:xfrm>
-            <a:off x="1078992" y="2395728"/>
-            <a:ext cx="310896" cy="310896"/>
-          </a:xfrm>
-          <a:prstGeom prst="rect">
-            <a:avLst/>
-          </a:prstGeom>
-          <a:noFill/>
-          <a:ln/>
-        </p:spPr>
-        <p:txBody>
-          <a:bodyPr wrap="square" lIns="0" tIns="0" rIns="0" bIns="0" rtlCol="0" anchor="ctr"/>
-          <a:lstStyle/>
-          <a:p>
-            <a:pPr algn="ctr" indent="0" marL="0">
-              <a:buNone/>
-            </a:pPr>
-            <a:r>
-              <a:rPr lang="en-US" sz="1100" b="1" dirty="0">
-                <a:solidFill>
-                  <a:srgbClr val="FFFFFF"/>
+            <a:pPr algn="l" indent="0" marL="0">
+              <a:buNone/>
+            </a:pPr>
+            <a:r>
+              <a:rPr lang="en-US" sz="816" dirty="0">
+                <a:solidFill>
+                  <a:srgbClr val="1A1C2E"/>
                 </a:solidFill>
                 <a:latin typeface="Arial" pitchFamily="34" charset="0"/>
                 <a:ea typeface="Arial" pitchFamily="34" charset="-122"/>
                 <a:cs typeface="Arial" pitchFamily="34" charset="-120"/>
               </a:rPr>
-              <a:t>2</a:t>
-            </a:r>
-            <a:endParaRPr lang="en-US" sz="1100" dirty="0"/>
-          </a:p>
-        </p:txBody>
-      </p:sp>
-      <p:sp>
-        <p:nvSpPr>
-          <p:cNvPr id="10" name="Text 8"/>
-          <p:cNvSpPr/>
-          <p:nvPr/>
-        </p:nvSpPr>
-        <p:spPr>
-          <a:xfrm>
-            <a:off x="1618488" y="2377440"/>
-            <a:ext cx="9601200" cy="365760"/>
-          </a:xfrm>
-          <a:prstGeom prst="rect">
-            <a:avLst/>
-          </a:prstGeom>
-          <a:noFill/>
-          <a:ln/>
-        </p:spPr>
-        <p:txBody>
-          <a:bodyPr wrap="square" lIns="0" tIns="0" rIns="0" bIns="0" rtlCol="0" anchor="ctr"/>
-          <a:lstStyle/>
-          <a:p>
-            <a:pPr indent="0" marL="0">
-              <a:buNone/>
-            </a:pPr>
-            <a:r>
-              <a:rPr lang="en-US" sz="1500" dirty="0">
-                <a:solidFill>
-                  <a:srgbClr val="1A1C2E"/>
-                </a:solidFill>
-                <a:latin typeface="Calibri" pitchFamily="34" charset="0"/>
-                <a:ea typeface="Calibri" pitchFamily="34" charset="-122"/>
-                <a:cs typeface="Calibri" pitchFamily="34" charset="-120"/>
-              </a:rPr>
-              <a:t>Se pregunta el bastidor y se identifica el vehículo</a:t>
-            </a:r>
-            <a:endParaRPr lang="en-US" sz="1500" dirty="0"/>
-          </a:p>
-        </p:txBody>
-      </p:sp>
-      <p:sp>
-        <p:nvSpPr>
-          <p:cNvPr id="11" name="Shape 9"/>
-          <p:cNvSpPr/>
-          <p:nvPr/>
-        </p:nvSpPr>
-        <p:spPr>
-          <a:xfrm>
-            <a:off x="1078992" y="2871216"/>
-            <a:ext cx="310896" cy="310896"/>
-          </a:xfrm>
-          <a:prstGeom prst="ellipse">
-            <a:avLst/>
-          </a:prstGeom>
-          <a:solidFill>
-            <a:srgbClr val="202CFC"/>
-          </a:solidFill>
-          <a:ln/>
-        </p:spPr>
-      </p:sp>
-      <p:sp>
-        <p:nvSpPr>
-          <p:cNvPr id="12" name="Text 10"/>
-          <p:cNvSpPr/>
-          <p:nvPr/>
-        </p:nvSpPr>
-        <p:spPr>
-          <a:xfrm>
-            <a:off x="1078992" y="2871216"/>
-            <a:ext cx="310896" cy="310896"/>
-          </a:xfrm>
-          <a:prstGeom prst="rect">
-            <a:avLst/>
-          </a:prstGeom>
-          <a:noFill/>
-          <a:ln/>
-        </p:spPr>
-        <p:txBody>
-          <a:bodyPr wrap="square" lIns="0" tIns="0" rIns="0" bIns="0" rtlCol="0" anchor="ctr"/>
-          <a:lstStyle/>
-          <a:p>
-            <a:pPr algn="ctr" indent="0" marL="0">
-              <a:buNone/>
-            </a:pPr>
-            <a:r>
-              <a:rPr lang="en-US" sz="1100" b="1" dirty="0">
-                <a:solidFill>
-                  <a:srgbClr val="FFFFFF"/>
-                </a:solidFill>
-                <a:latin typeface="Arial" pitchFamily="34" charset="0"/>
-                <a:ea typeface="Arial" pitchFamily="34" charset="-122"/>
-                <a:cs typeface="Arial" pitchFamily="34" charset="-120"/>
-              </a:rPr>
-              <a:t>3</a:t>
-            </a:r>
-            <a:endParaRPr lang="en-US" sz="1100" dirty="0"/>
-          </a:p>
-        </p:txBody>
-      </p:sp>
-      <p:sp>
-        <p:nvSpPr>
-          <p:cNvPr id="13" name="Text 11"/>
-          <p:cNvSpPr/>
-          <p:nvPr/>
-        </p:nvSpPr>
-        <p:spPr>
-          <a:xfrm>
-            <a:off x="1618488" y="2852928"/>
-            <a:ext cx="9601200" cy="365760"/>
-          </a:xfrm>
-          <a:prstGeom prst="rect">
-            <a:avLst/>
-          </a:prstGeom>
-          <a:noFill/>
-          <a:ln/>
-        </p:spPr>
-        <p:txBody>
-          <a:bodyPr wrap="square" lIns="0" tIns="0" rIns="0" bIns="0" rtlCol="0" anchor="ctr"/>
-          <a:lstStyle/>
-          <a:p>
-            <a:pPr indent="0" marL="0">
-              <a:buNone/>
-            </a:pPr>
-            <a:r>
-              <a:rPr lang="en-US" sz="1500" dirty="0">
-                <a:solidFill>
-                  <a:srgbClr val="1A1C2E"/>
-                </a:solidFill>
-                <a:latin typeface="Calibri" pitchFamily="34" charset="0"/>
-                <a:ea typeface="Calibri" pitchFamily="34" charset="-122"/>
-                <a:cs typeface="Calibri" pitchFamily="34" charset="-120"/>
-              </a:rPr>
-              <a:t>Se barre el bus para ver qué centralitas responden</a:t>
-            </a:r>
-            <a:endParaRPr lang="en-US" sz="1500" dirty="0"/>
-          </a:p>
-        </p:txBody>
-      </p:sp>
-      <p:sp>
-        <p:nvSpPr>
-          <p:cNvPr id="14" name="Shape 12"/>
-          <p:cNvSpPr/>
-          <p:nvPr/>
-        </p:nvSpPr>
-        <p:spPr>
-          <a:xfrm>
-            <a:off x="1078992" y="3346704"/>
-            <a:ext cx="310896" cy="310896"/>
-          </a:xfrm>
-          <a:prstGeom prst="ellipse">
-            <a:avLst/>
-          </a:prstGeom>
-          <a:solidFill>
-            <a:srgbClr val="202CFC"/>
-          </a:solidFill>
-          <a:ln/>
-        </p:spPr>
-      </p:sp>
-      <p:sp>
-        <p:nvSpPr>
-          <p:cNvPr id="15" name="Text 13"/>
-          <p:cNvSpPr/>
-          <p:nvPr/>
-        </p:nvSpPr>
-        <p:spPr>
-          <a:xfrm>
-            <a:off x="1078992" y="3346704"/>
-            <a:ext cx="310896" cy="310896"/>
-          </a:xfrm>
-          <a:prstGeom prst="rect">
-            <a:avLst/>
-          </a:prstGeom>
-          <a:noFill/>
-          <a:ln/>
-        </p:spPr>
-        <p:txBody>
-          <a:bodyPr wrap="square" lIns="0" tIns="0" rIns="0" bIns="0" rtlCol="0" anchor="ctr"/>
-          <a:lstStyle/>
-          <a:p>
-            <a:pPr algn="ctr" indent="0" marL="0">
-              <a:buNone/>
-            </a:pPr>
-            <a:r>
-              <a:rPr lang="en-US" sz="1100" b="1" dirty="0">
-                <a:solidFill>
-                  <a:srgbClr val="FFFFFF"/>
-                </a:solidFill>
-                <a:latin typeface="Arial" pitchFamily="34" charset="0"/>
-                <a:ea typeface="Arial" pitchFamily="34" charset="-122"/>
-                <a:cs typeface="Arial" pitchFamily="34" charset="-120"/>
-              </a:rPr>
-              <a:t>4</a:t>
-            </a:r>
-            <a:endParaRPr lang="en-US" sz="1100" dirty="0"/>
-          </a:p>
-        </p:txBody>
-      </p:sp>
-      <p:sp>
-        <p:nvSpPr>
-          <p:cNvPr id="16" name="Text 14"/>
-          <p:cNvSpPr/>
-          <p:nvPr/>
-        </p:nvSpPr>
-        <p:spPr>
-          <a:xfrm>
-            <a:off x="1618488" y="3328416"/>
-            <a:ext cx="9601200" cy="365760"/>
-          </a:xfrm>
-          <a:prstGeom prst="rect">
-            <a:avLst/>
-          </a:prstGeom>
-          <a:noFill/>
-          <a:ln/>
-        </p:spPr>
-        <p:txBody>
-          <a:bodyPr wrap="square" lIns="0" tIns="0" rIns="0" bIns="0" rtlCol="0" anchor="ctr"/>
-          <a:lstStyle/>
-          <a:p>
-            <a:pPr indent="0" marL="0">
-              <a:buNone/>
-            </a:pPr>
-            <a:r>
-              <a:rPr lang="en-US" sz="1500" dirty="0">
-                <a:solidFill>
-                  <a:srgbClr val="1A1C2E"/>
-                </a:solidFill>
-                <a:latin typeface="Calibri" pitchFamily="34" charset="0"/>
-                <a:ea typeface="Calibri" pitchFamily="34" charset="-122"/>
-                <a:cs typeface="Calibri" pitchFamily="34" charset="-120"/>
-              </a:rPr>
-              <a:t>Se leen los datos en vivo, los códigos de avería y el freeze frame</a:t>
-            </a:r>
-            <a:endParaRPr lang="en-US" sz="1500" dirty="0"/>
-          </a:p>
-        </p:txBody>
-      </p:sp>
-      <p:sp>
-        <p:nvSpPr>
-          <p:cNvPr id="17" name="Shape 15"/>
-          <p:cNvSpPr/>
-          <p:nvPr/>
-        </p:nvSpPr>
-        <p:spPr>
-          <a:xfrm>
-            <a:off x="1078992" y="3822192"/>
-            <a:ext cx="310896" cy="310896"/>
-          </a:xfrm>
-          <a:prstGeom prst="ellipse">
-            <a:avLst/>
-          </a:prstGeom>
-          <a:solidFill>
-            <a:srgbClr val="202CFC"/>
-          </a:solidFill>
-          <a:ln/>
-        </p:spPr>
-      </p:sp>
-      <p:sp>
-        <p:nvSpPr>
-          <p:cNvPr id="18" name="Text 16"/>
-          <p:cNvSpPr/>
-          <p:nvPr/>
-        </p:nvSpPr>
-        <p:spPr>
-          <a:xfrm>
-            <a:off x="1078992" y="3822192"/>
-            <a:ext cx="310896" cy="310896"/>
-          </a:xfrm>
-          <a:prstGeom prst="rect">
-            <a:avLst/>
-          </a:prstGeom>
-          <a:noFill/>
-          <a:ln/>
-        </p:spPr>
-        <p:txBody>
-          <a:bodyPr wrap="square" lIns="0" tIns="0" rIns="0" bIns="0" rtlCol="0" anchor="ctr"/>
-          <a:lstStyle/>
-          <a:p>
-            <a:pPr algn="ctr" indent="0" marL="0">
-              <a:buNone/>
-            </a:pPr>
-            <a:r>
-              <a:rPr lang="en-US" sz="1100" b="1" dirty="0">
-                <a:solidFill>
-                  <a:srgbClr val="FFFFFF"/>
-                </a:solidFill>
-                <a:latin typeface="Arial" pitchFamily="34" charset="0"/>
-                <a:ea typeface="Arial" pitchFamily="34" charset="-122"/>
-                <a:cs typeface="Arial" pitchFamily="34" charset="-120"/>
-              </a:rPr>
-              <a:t>5</a:t>
-            </a:r>
-            <a:endParaRPr lang="en-US" sz="1100" dirty="0"/>
-          </a:p>
-        </p:txBody>
-      </p:sp>
-      <p:sp>
-        <p:nvSpPr>
-          <p:cNvPr id="19" name="Text 17"/>
-          <p:cNvSpPr/>
-          <p:nvPr/>
-        </p:nvSpPr>
-        <p:spPr>
-          <a:xfrm>
-            <a:off x="1618488" y="3803904"/>
-            <a:ext cx="9601200" cy="365760"/>
-          </a:xfrm>
-          <a:prstGeom prst="rect">
-            <a:avLst/>
-          </a:prstGeom>
-          <a:noFill/>
-          <a:ln/>
-        </p:spPr>
-        <p:txBody>
-          <a:bodyPr wrap="square" lIns="0" tIns="0" rIns="0" bIns="0" rtlCol="0" anchor="ctr"/>
-          <a:lstStyle/>
-          <a:p>
-            <a:pPr indent="0" marL="0">
-              <a:buNone/>
-            </a:pPr>
-            <a:r>
-              <a:rPr lang="en-US" sz="1500" dirty="0">
-                <a:solidFill>
-                  <a:srgbClr val="1A1C2E"/>
-                </a:solidFill>
-                <a:latin typeface="Calibri" pitchFamily="34" charset="0"/>
-                <a:ea typeface="Calibri" pitchFamily="34" charset="-122"/>
-                <a:cs typeface="Calibri" pitchFamily="34" charset="-120"/>
-              </a:rPr>
-              <a:t>Se calcula la severidad y todo sale en pantalla</a:t>
-            </a:r>
-            <a:endParaRPr lang="en-US" sz="1500" dirty="0"/>
-          </a:p>
-        </p:txBody>
-      </p:sp>
-      <p:sp>
-        <p:nvSpPr>
-          <p:cNvPr id="20" name="Shape 18"/>
-          <p:cNvSpPr/>
-          <p:nvPr/>
-        </p:nvSpPr>
-        <p:spPr>
-          <a:xfrm>
-            <a:off x="1078992" y="4297680"/>
-            <a:ext cx="310896" cy="310896"/>
-          </a:xfrm>
-          <a:prstGeom prst="ellipse">
-            <a:avLst/>
-          </a:prstGeom>
-          <a:solidFill>
-            <a:srgbClr val="202CFC"/>
-          </a:solidFill>
-          <a:ln/>
-        </p:spPr>
-      </p:sp>
-      <p:sp>
-        <p:nvSpPr>
-          <p:cNvPr id="21" name="Text 19"/>
-          <p:cNvSpPr/>
-          <p:nvPr/>
-        </p:nvSpPr>
-        <p:spPr>
-          <a:xfrm>
-            <a:off x="1078992" y="4297680"/>
-            <a:ext cx="310896" cy="310896"/>
-          </a:xfrm>
-          <a:prstGeom prst="rect">
-            <a:avLst/>
-          </a:prstGeom>
-          <a:noFill/>
-          <a:ln/>
-        </p:spPr>
-        <p:txBody>
-          <a:bodyPr wrap="square" lIns="0" tIns="0" rIns="0" bIns="0" rtlCol="0" anchor="ctr"/>
-          <a:lstStyle/>
-          <a:p>
-            <a:pPr algn="ctr" indent="0" marL="0">
-              <a:buNone/>
-            </a:pPr>
-            <a:r>
-              <a:rPr lang="en-US" sz="1100" b="1" dirty="0">
-                <a:solidFill>
-                  <a:srgbClr val="FFFFFF"/>
-                </a:solidFill>
-                <a:latin typeface="Arial" pitchFamily="34" charset="0"/>
-                <a:ea typeface="Arial" pitchFamily="34" charset="-122"/>
-                <a:cs typeface="Arial" pitchFamily="34" charset="-120"/>
-              </a:rPr>
-              <a:t>6</a:t>
-            </a:r>
-            <a:endParaRPr lang="en-US" sz="1100" dirty="0"/>
-          </a:p>
-        </p:txBody>
-      </p:sp>
-      <p:sp>
-        <p:nvSpPr>
-          <p:cNvPr id="22" name="Text 20"/>
-          <p:cNvSpPr/>
-          <p:nvPr/>
-        </p:nvSpPr>
-        <p:spPr>
-          <a:xfrm>
-            <a:off x="1618488" y="4279392"/>
-            <a:ext cx="9601200" cy="365760"/>
-          </a:xfrm>
-          <a:prstGeom prst="rect">
-            <a:avLst/>
-          </a:prstGeom>
-          <a:noFill/>
-          <a:ln/>
-        </p:spPr>
-        <p:txBody>
-          <a:bodyPr wrap="square" lIns="0" tIns="0" rIns="0" bIns="0" rtlCol="0" anchor="ctr"/>
-          <a:lstStyle/>
-          <a:p>
-            <a:pPr indent="0" marL="0">
-              <a:buNone/>
-            </a:pPr>
-            <a:r>
-              <a:rPr lang="en-US" sz="1500" dirty="0">
-                <a:solidFill>
-                  <a:srgbClr val="1A1C2E"/>
-                </a:solidFill>
-                <a:latin typeface="Calibri" pitchFamily="34" charset="0"/>
-                <a:ea typeface="Calibri" pitchFamily="34" charset="-122"/>
-                <a:cs typeface="Calibri" pitchFamily="34" charset="-120"/>
-              </a:rPr>
-              <a:t>Si el mecánico pregunta al agente, se buscan antes casos parecidos</a:t>
-            </a:r>
-            <a:endParaRPr lang="en-US" sz="1500" dirty="0"/>
-          </a:p>
-        </p:txBody>
-      </p:sp>
-      <p:sp>
-        <p:nvSpPr>
-          <p:cNvPr id="23" name="Shape 21"/>
-          <p:cNvSpPr/>
-          <p:nvPr/>
-        </p:nvSpPr>
-        <p:spPr>
-          <a:xfrm>
-            <a:off x="1078992" y="4773168"/>
-            <a:ext cx="310896" cy="310896"/>
-          </a:xfrm>
-          <a:prstGeom prst="ellipse">
-            <a:avLst/>
-          </a:prstGeom>
-          <a:solidFill>
-            <a:srgbClr val="202CFC"/>
-          </a:solidFill>
-          <a:ln/>
-        </p:spPr>
-      </p:sp>
-      <p:sp>
-        <p:nvSpPr>
-          <p:cNvPr id="24" name="Text 22"/>
-          <p:cNvSpPr/>
-          <p:nvPr/>
-        </p:nvSpPr>
-        <p:spPr>
-          <a:xfrm>
-            <a:off x="1078992" y="4773168"/>
-            <a:ext cx="310896" cy="310896"/>
-          </a:xfrm>
-          <a:prstGeom prst="rect">
-            <a:avLst/>
-          </a:prstGeom>
-          <a:noFill/>
-          <a:ln/>
-        </p:spPr>
-        <p:txBody>
-          <a:bodyPr wrap="square" lIns="0" tIns="0" rIns="0" bIns="0" rtlCol="0" anchor="ctr"/>
-          <a:lstStyle/>
-          <a:p>
-            <a:pPr algn="ctr" indent="0" marL="0">
-              <a:buNone/>
-            </a:pPr>
-            <a:r>
-              <a:rPr lang="en-US" sz="1100" b="1" dirty="0">
-                <a:solidFill>
-                  <a:srgbClr val="FFFFFF"/>
-                </a:solidFill>
-                <a:latin typeface="Arial" pitchFamily="34" charset="0"/>
-                <a:ea typeface="Arial" pitchFamily="34" charset="-122"/>
-                <a:cs typeface="Arial" pitchFamily="34" charset="-120"/>
-              </a:rPr>
-              <a:t>7</a:t>
-            </a:r>
-            <a:endParaRPr lang="en-US" sz="1100" dirty="0"/>
-          </a:p>
-        </p:txBody>
-      </p:sp>
-      <p:sp>
-        <p:nvSpPr>
-          <p:cNvPr id="25" name="Text 23"/>
-          <p:cNvSpPr/>
-          <p:nvPr/>
-        </p:nvSpPr>
-        <p:spPr>
-          <a:xfrm>
-            <a:off x="1618488" y="4754880"/>
-            <a:ext cx="9601200" cy="365760"/>
-          </a:xfrm>
-          <a:prstGeom prst="rect">
-            <a:avLst/>
-          </a:prstGeom>
-          <a:noFill/>
-          <a:ln/>
-        </p:spPr>
-        <p:txBody>
-          <a:bodyPr wrap="square" lIns="0" tIns="0" rIns="0" bIns="0" rtlCol="0" anchor="ctr"/>
-          <a:lstStyle/>
-          <a:p>
-            <a:pPr indent="0" marL="0">
-              <a:buNone/>
-            </a:pPr>
-            <a:r>
-              <a:rPr lang="en-US" sz="1500" dirty="0">
-                <a:solidFill>
-                  <a:srgbClr val="1A1C2E"/>
-                </a:solidFill>
-                <a:latin typeface="Calibri" pitchFamily="34" charset="0"/>
-                <a:ea typeface="Calibri" pitchFamily="34" charset="-122"/>
-                <a:cs typeface="Calibri" pitchFamily="34" charset="-120"/>
-              </a:rPr>
-              <a:t>El agente pide lo que le falta: el catálogo, más lecturas del coche o la web</a:t>
-            </a:r>
-            <a:endParaRPr lang="en-US" sz="1500" dirty="0"/>
-          </a:p>
-        </p:txBody>
-      </p:sp>
-      <p:sp>
-        <p:nvSpPr>
-          <p:cNvPr id="26" name="Shape 24"/>
-          <p:cNvSpPr/>
-          <p:nvPr/>
-        </p:nvSpPr>
-        <p:spPr>
-          <a:xfrm>
-            <a:off x="1078992" y="5248656"/>
-            <a:ext cx="310896" cy="310896"/>
-          </a:xfrm>
-          <a:prstGeom prst="ellipse">
-            <a:avLst/>
-          </a:prstGeom>
-          <a:solidFill>
-            <a:srgbClr val="202CFC"/>
-          </a:solidFill>
-          <a:ln/>
-        </p:spPr>
-      </p:sp>
-      <p:sp>
-        <p:nvSpPr>
-          <p:cNvPr id="27" name="Text 25"/>
-          <p:cNvSpPr/>
-          <p:nvPr/>
-        </p:nvSpPr>
-        <p:spPr>
-          <a:xfrm>
-            <a:off x="1078992" y="5248656"/>
-            <a:ext cx="310896" cy="310896"/>
-          </a:xfrm>
-          <a:prstGeom prst="rect">
-            <a:avLst/>
-          </a:prstGeom>
-          <a:noFill/>
-          <a:ln/>
-        </p:spPr>
-        <p:txBody>
-          <a:bodyPr wrap="square" lIns="0" tIns="0" rIns="0" bIns="0" rtlCol="0" anchor="ctr"/>
-          <a:lstStyle/>
-          <a:p>
-            <a:pPr algn="ctr" indent="0" marL="0">
-              <a:buNone/>
-            </a:pPr>
-            <a:r>
-              <a:rPr lang="en-US" sz="1100" b="1" dirty="0">
-                <a:solidFill>
-                  <a:srgbClr val="FFFFFF"/>
-                </a:solidFill>
-                <a:latin typeface="Arial" pitchFamily="34" charset="0"/>
-                <a:ea typeface="Arial" pitchFamily="34" charset="-122"/>
-                <a:cs typeface="Arial" pitchFamily="34" charset="-120"/>
-              </a:rPr>
-              <a:t>8</a:t>
-            </a:r>
-            <a:endParaRPr lang="en-US" sz="1100" dirty="0"/>
-          </a:p>
-        </p:txBody>
-      </p:sp>
-      <p:sp>
-        <p:nvSpPr>
-          <p:cNvPr id="28" name="Text 26"/>
-          <p:cNvSpPr/>
-          <p:nvPr/>
-        </p:nvSpPr>
-        <p:spPr>
-          <a:xfrm>
-            <a:off x="1618488" y="5230368"/>
-            <a:ext cx="9601200" cy="365760"/>
-          </a:xfrm>
-          <a:prstGeom prst="rect">
-            <a:avLst/>
-          </a:prstGeom>
-          <a:noFill/>
-          <a:ln/>
-        </p:spPr>
-        <p:txBody>
-          <a:bodyPr wrap="square" lIns="0" tIns="0" rIns="0" bIns="0" rtlCol="0" anchor="ctr"/>
-          <a:lstStyle/>
-          <a:p>
-            <a:pPr indent="0" marL="0">
-              <a:buNone/>
-            </a:pPr>
-            <a:r>
-              <a:rPr lang="en-US" sz="1500" dirty="0">
-                <a:solidFill>
-                  <a:srgbClr val="1A1C2E"/>
-                </a:solidFill>
-                <a:latin typeface="Calibri" pitchFamily="34" charset="0"/>
-                <a:ea typeface="Calibri" pitchFamily="34" charset="-122"/>
-                <a:cs typeface="Calibri" pitchFamily="34" charset="-120"/>
-              </a:rPr>
-              <a:t>Responde con la explicación, la severidad y qué conviene revisar</a:t>
-            </a:r>
-            <a:endParaRPr lang="en-US" sz="1500" dirty="0"/>
-          </a:p>
-        </p:txBody>
-      </p:sp>
-      <p:sp>
-        <p:nvSpPr>
-          <p:cNvPr id="29" name="Shape 27"/>
-          <p:cNvSpPr/>
-          <p:nvPr/>
-        </p:nvSpPr>
-        <p:spPr>
-          <a:xfrm>
-            <a:off x="1078992" y="5724144"/>
-            <a:ext cx="310896" cy="310896"/>
-          </a:xfrm>
-          <a:prstGeom prst="ellipse">
-            <a:avLst/>
-          </a:prstGeom>
-          <a:solidFill>
-            <a:srgbClr val="202CFC"/>
-          </a:solidFill>
-          <a:ln/>
-        </p:spPr>
-      </p:sp>
-      <p:sp>
-        <p:nvSpPr>
-          <p:cNvPr id="30" name="Text 28"/>
-          <p:cNvSpPr/>
-          <p:nvPr/>
-        </p:nvSpPr>
-        <p:spPr>
-          <a:xfrm>
-            <a:off x="1078992" y="5724144"/>
-            <a:ext cx="310896" cy="310896"/>
-          </a:xfrm>
-          <a:prstGeom prst="rect">
-            <a:avLst/>
-          </a:prstGeom>
-          <a:noFill/>
-          <a:ln/>
-        </p:spPr>
-        <p:txBody>
-          <a:bodyPr wrap="square" lIns="0" tIns="0" rIns="0" bIns="0" rtlCol="0" anchor="ctr"/>
-          <a:lstStyle/>
-          <a:p>
-            <a:pPr algn="ctr" indent="0" marL="0">
-              <a:buNone/>
-            </a:pPr>
-            <a:r>
-              <a:rPr lang="en-US" sz="1100" b="1" dirty="0">
-                <a:solidFill>
-                  <a:srgbClr val="FFFFFF"/>
-                </a:solidFill>
-                <a:latin typeface="Arial" pitchFamily="34" charset="0"/>
-                <a:ea typeface="Arial" pitchFamily="34" charset="-122"/>
-                <a:cs typeface="Arial" pitchFamily="34" charset="-120"/>
-              </a:rPr>
-              <a:t>9</a:t>
-            </a:r>
-            <a:endParaRPr lang="en-US" sz="1100" dirty="0"/>
-          </a:p>
-        </p:txBody>
-      </p:sp>
-      <p:sp>
-        <p:nvSpPr>
-          <p:cNvPr id="31" name="Text 29"/>
-          <p:cNvSpPr/>
-          <p:nvPr/>
-        </p:nvSpPr>
-        <p:spPr>
-          <a:xfrm>
-            <a:off x="1618488" y="5705856"/>
-            <a:ext cx="9601200" cy="365760"/>
-          </a:xfrm>
-          <a:prstGeom prst="rect">
-            <a:avLst/>
-          </a:prstGeom>
-          <a:noFill/>
-          <a:ln/>
-        </p:spPr>
-        <p:txBody>
-          <a:bodyPr wrap="square" lIns="0" tIns="0" rIns="0" bIns="0" rtlCol="0" anchor="ctr"/>
-          <a:lstStyle/>
-          <a:p>
-            <a:pPr indent="0" marL="0">
-              <a:buNone/>
-            </a:pPr>
-            <a:r>
-              <a:rPr lang="en-US" sz="1500" dirty="0">
-                <a:solidFill>
-                  <a:srgbClr val="1A1C2E"/>
-                </a:solidFill>
-                <a:latin typeface="Calibri" pitchFamily="34" charset="0"/>
-                <a:ea typeface="Calibri" pitchFamily="34" charset="-122"/>
-                <a:cs typeface="Calibri" pitchFamily="34" charset="-120"/>
-              </a:rPr>
-              <a:t>El caso se guarda, y queda disponible para el siguiente coche</a:t>
-            </a:r>
-            <a:endParaRPr lang="en-US" sz="1500" dirty="0"/>
-          </a:p>
-        </p:txBody>
-      </p:sp>
-      <p:sp>
-        <p:nvSpPr>
-          <p:cNvPr id="32" name="Shape 30"/>
-          <p:cNvSpPr/>
-          <p:nvPr/>
-        </p:nvSpPr>
-        <p:spPr>
-          <a:xfrm>
-            <a:off x="777240" y="4233672"/>
-            <a:ext cx="10607040" cy="0"/>
-          </a:xfrm>
-          <a:prstGeom prst="line">
-            <a:avLst/>
-          </a:prstGeom>
-          <a:noFill/>
-          <a:ln w="12700">
-            <a:solidFill>
-              <a:srgbClr val="D8DAE4"/>
-            </a:solidFill>
-            <a:prstDash val="dash"/>
-          </a:ln>
-        </p:spPr>
-      </p:sp>
-      <p:sp>
-        <p:nvSpPr>
-          <p:cNvPr id="33" name="Text 31"/>
-          <p:cNvSpPr/>
-          <p:nvPr/>
-        </p:nvSpPr>
-        <p:spPr>
-          <a:xfrm>
-            <a:off x="8778240" y="4059936"/>
-            <a:ext cx="2606040" cy="274320"/>
-          </a:xfrm>
-          <a:prstGeom prst="rect">
-            <a:avLst/>
-          </a:prstGeom>
-          <a:noFill/>
-          <a:ln/>
-        </p:spPr>
-        <p:txBody>
-          <a:bodyPr wrap="square" lIns="0" tIns="0" rIns="0" bIns="0" rtlCol="0" anchor="ctr"/>
-          <a:lstStyle/>
-          <a:p>
-            <a:pPr algn="r" indent="0" marL="0">
-              <a:buNone/>
-            </a:pPr>
-            <a:r>
-              <a:rPr lang="en-US" sz="1100" i="1" dirty="0">
-                <a:solidFill>
-                  <a:srgbClr val="5A5F73"/>
-                </a:solidFill>
-                <a:latin typeface="Calibri" pitchFamily="34" charset="0"/>
-                <a:ea typeface="Calibri" pitchFamily="34" charset="-122"/>
-                <a:cs typeface="Calibri" pitchFamily="34" charset="-120"/>
-              </a:rPr>
-              <a:t>hasta aquí, sin IA</a:t>
-            </a:r>
-            <a:endParaRPr lang="en-US" sz="1100" dirty="0"/>
-          </a:p>
-        </p:txBody>
-      </p:sp>
-      <p:sp>
-        <p:nvSpPr>
-          <p:cNvPr id="34" name="Shape 32"/>
-          <p:cNvSpPr/>
-          <p:nvPr/>
-        </p:nvSpPr>
-        <p:spPr>
-          <a:xfrm>
-            <a:off x="777240" y="6263640"/>
-            <a:ext cx="219456" cy="219456"/>
-          </a:xfrm>
-          <a:prstGeom prst="rect">
-            <a:avLst/>
-          </a:prstGeom>
-          <a:solidFill>
-            <a:srgbClr val="202CFC"/>
-          </a:solidFill>
-          <a:ln/>
-        </p:spPr>
-      </p:sp>
-      <p:sp>
-        <p:nvSpPr>
-          <p:cNvPr id="35" name="Text 33"/>
-          <p:cNvSpPr/>
-          <p:nvPr/>
-        </p:nvSpPr>
-        <p:spPr>
-          <a:xfrm>
-            <a:off x="777240" y="6263640"/>
-            <a:ext cx="219456" cy="219456"/>
-          </a:xfrm>
-          <a:prstGeom prst="rect">
-            <a:avLst/>
-          </a:prstGeom>
-          <a:noFill/>
-          <a:ln/>
-        </p:spPr>
-        <p:txBody>
-          <a:bodyPr wrap="square" lIns="0" tIns="0" rIns="0" bIns="0" rtlCol="0" anchor="ctr"/>
-          <a:lstStyle/>
-          <a:p>
-            <a:pPr algn="ctr" indent="0" marL="0">
-              <a:buNone/>
-            </a:pPr>
-            <a:r>
-              <a:rPr lang="en-US" sz="816" b="1" dirty="0">
-                <a:solidFill>
-                  <a:srgbClr val="FFFFFF"/>
-                </a:solidFill>
-                <a:latin typeface="Arial" pitchFamily="34" charset="0"/>
-                <a:ea typeface="Arial" pitchFamily="34" charset="-122"/>
-                <a:cs typeface="Arial" pitchFamily="34" charset="-120"/>
-              </a:rPr>
-              <a:t>BIG</a:t>
+              <a:t>school</a:t>
             </a:r>
             <a:endParaRPr lang="en-US" sz="816" dirty="0"/>
           </a:p>
@@ -10769,46 +11097,7 @@
       </p:sp>
       <p:sp>
         <p:nvSpPr>
-          <p:cNvPr id="36" name="Text 34"/>
-          <p:cNvSpPr/>
-          <p:nvPr/>
-        </p:nvSpPr>
-        <p:spPr>
-          <a:xfrm>
-            <a:off x="1078992" y="6263640"/>
-            <a:ext cx="658368" cy="219456"/>
-          </a:xfrm>
-          <a:prstGeom prst="rect">
-            <a:avLst/>
-          </a:prstGeom>
-          <a:noFill/>
-          <a:ln/>
-        </p:spPr>
-        <p:txBody>
-          <a:bodyPr wrap="square" lIns="0" tIns="0" rIns="0" bIns="0" rtlCol="0" anchor="ctr"/>
-          <a:lstStyle/>
-          <a:p>
-            <a:pPr algn="l" indent="0" marL="0">
-              <a:buNone/>
-            </a:pPr>
-            <a:r>
-              <a:rPr lang="en-US" sz="816" dirty="0">
-                <a:solidFill>
-                  <a:srgbClr val="1A1C2E"/>
-                </a:solidFill>
-                <a:latin typeface="Arial" pitchFamily="34" charset="0"/>
-                <a:ea typeface="Arial" pitchFamily="34" charset="-122"/>
-                <a:cs typeface="Arial" pitchFamily="34" charset="-120"/>
-              </a:rPr>
-              <a:t>school</a:t>
-            </a:r>
-            <a:endParaRPr lang="en-US" sz="816" dirty="0"/>
-          </a:p>
-        </p:txBody>
-      </p:sp>
-      <p:sp>
-        <p:nvSpPr>
-          <p:cNvPr id="37" name="Text 35"/>
+          <p:cNvPr id="46" name="Text 44"/>
           <p:cNvSpPr/>
           <p:nvPr/>
         </p:nvSpPr>

</xml_diff>

<commit_message>
docs(tfm): titulares y subtitulos en registro formal
</commit_message>
<xml_diff>
--- a/docs/presentacion/tfm-intelligent-automotive-diagnostics.pptx
+++ b/docs/presentacion/tfm-intelligent-automotive-diagnostics.pptx
@@ -2812,7 +2812,7 @@
                 <a:ea typeface="Arial" pitchFamily="34" charset="-122"/>
                 <a:cs typeface="Arial" pitchFamily="34" charset="-120"/>
               </a:rPr>
-              <a:t>La base vectorial: qué guarda y con qué confianza</a:t>
+              <a:t>Base de datos vectorial e índice de confianza</a:t>
             </a:r>
             <a:endParaRPr lang="en-US" sz="3400" dirty="0"/>
           </a:p>
@@ -2851,7 +2851,7 @@
                 <a:ea typeface="Calibri" pitchFamily="34" charset="-122"/>
                 <a:cs typeface="Calibri" pitchFamily="34" charset="-120"/>
               </a:rPr>
-              <a:t>Los datos del taller van en SQLite. Aquí solo va lo que el sistema aprende.</a:t>
+              <a:t>Almacena el conocimiento que el sistema adquiere durante los diagnósticos.</a:t>
             </a:r>
             <a:endParaRPr lang="en-US" sz="1600" dirty="0"/>
           </a:p>
@@ -3023,7 +3023,7 @@
                 <a:ea typeface="Arial" pitchFamily="34" charset="-122"/>
                 <a:cs typeface="Arial" pitchFamily="34" charset="-120"/>
               </a:rPr>
-              <a:t>Un caso resuelto, tal cual se guarda</a:t>
+              <a:t>Ejemplo de entrada indexada</a:t>
             </a:r>
             <a:endParaRPr lang="en-US" sz="1500" dirty="0"/>
           </a:p>
@@ -3455,7 +3455,7 @@
                 <a:ea typeface="Calibri" pitchFamily="34" charset="-122"/>
                 <a:cs typeface="Calibri" pitchFamily="34" charset="-120"/>
               </a:rPr>
-              <a:t>Se lo ponemos nosotros al guardar, según de dónde salga el dato. Es lo que pondera las búsquedas.</a:t>
+              <a:t>Se asigna al indexar, según la procedencia del dato. Es lo que pondera las búsquedas.</a:t>
             </a:r>
             <a:endParaRPr lang="en-US" sz="1300" dirty="0"/>
           </a:p>
@@ -4029,7 +4029,7 @@
                 <a:ea typeface="Arial" pitchFamily="34" charset="-122"/>
                 <a:cs typeface="Arial" pitchFamily="34" charset="-120"/>
               </a:rPr>
-              <a:t>MCP: las 16 herramientas del agente</a:t>
+              <a:t>Model Context Protocol: herramientas del agente</a:t>
             </a:r>
             <a:endParaRPr lang="en-US" sz="3400" dirty="0"/>
           </a:p>
@@ -4068,7 +4068,7 @@
                 <a:ea typeface="Calibri" pitchFamily="34" charset="-122"/>
                 <a:cs typeface="Calibri" pitchFamily="34" charset="-120"/>
               </a:rPr>
-              <a:t>El modelo no toca el coche. Pide una herramienta, y el sistema decide si se ejecuta.</a:t>
+              <a:t>El modelo no accede al vehículo: solicita herramientas y el sistema decide si se ejecutan.</a:t>
             </a:r>
             <a:endParaRPr lang="en-US" sz="1700" dirty="0"/>
           </a:p>
@@ -4886,7 +4886,7 @@
                 <a:ea typeface="Arial" pitchFamily="34" charset="-122"/>
                 <a:cs typeface="Arial" pitchFamily="34" charset="-120"/>
               </a:rPr>
-              <a:t>El ciclo de razonamiento del agente</a:t>
+              <a:t>Ciclo de razonamiento del agente</a:t>
             </a:r>
             <a:endParaRPr lang="en-US" sz="3400" dirty="0"/>
           </a:p>
@@ -4925,7 +4925,7 @@
                 <a:ea typeface="Calibri" pitchFamily="34" charset="-122"/>
                 <a:cs typeface="Calibri" pitchFamily="34" charset="-120"/>
               </a:rPr>
-              <a:t>Del botón de iniciar diagnóstico a la respuesta que lee el mecánico.</a:t>
+              <a:t>Del inicio del diagnóstico hasta la respuesta que recibe el mecánico.</a:t>
             </a:r>
             <a:endParaRPr lang="en-US" sz="1700" dirty="0"/>
           </a:p>
@@ -4964,7 +4964,7 @@
                 <a:ea typeface="Arial" pitchFamily="34" charset="-122"/>
                 <a:cs typeface="Arial" pitchFamily="34" charset="-120"/>
               </a:rPr>
-              <a:t>El ciclo</a:t>
+              <a:t>Ciclo de ejecución</a:t>
             </a:r>
             <a:endParaRPr lang="en-US" sz="1900" dirty="0"/>
           </a:p>
@@ -5489,7 +5489,7 @@
                 <a:ea typeface="Arial" pitchFamily="34" charset="-122"/>
                 <a:cs typeface="Arial" pitchFamily="34" charset="-120"/>
               </a:rPr>
-              <a:t>El prompt lleva 11 bloques</a:t>
+              <a:t>System prompt: 11 bloques</a:t>
             </a:r>
             <a:endParaRPr lang="en-US" sz="1900" dirty="0"/>
           </a:p>
@@ -5863,7 +5863,7 @@
                 <a:ea typeface="Arial" pitchFamily="34" charset="-122"/>
                 <a:cs typeface="Arial" pitchFamily="34" charset="-120"/>
               </a:rPr>
-              <a:t>Los modelos: lenguaje y embeddings</a:t>
+              <a:t>Modelos empleados: lenguaje y embeddings</a:t>
             </a:r>
             <a:endParaRPr lang="en-US" sz="3400" dirty="0"/>
           </a:p>
@@ -5902,7 +5902,7 @@
                 <a:ea typeface="Calibri" pitchFamily="34" charset="-122"/>
                 <a:cs typeface="Calibri" pitchFamily="34" charset="-120"/>
               </a:rPr>
-              <a:t>Uno razona y se puede cambiar. El otro convierte texto en vectores y va dentro.</a:t>
+              <a:t>Uno razona y es intercambiable; el otro genera los vectores y se ejecuta en local.</a:t>
             </a:r>
             <a:endParaRPr lang="en-US" sz="1700" dirty="0"/>
           </a:p>
@@ -6463,7 +6463,7 @@
                 <a:ea typeface="Arial" pitchFamily="34" charset="-122"/>
                 <a:cs typeface="Arial" pitchFamily="34" charset="-120"/>
               </a:rPr>
-              <a:t>Resultados: la aplicación funcionando</a:t>
+              <a:t>Resultados: la aplicación en funcionamiento</a:t>
             </a:r>
             <a:endParaRPr lang="en-US" sz="3200" dirty="0"/>
           </a:p>
@@ -6502,7 +6502,7 @@
                 <a:ea typeface="Calibri" pitchFamily="34" charset="-122"/>
                 <a:cs typeface="Calibri" pitchFamily="34" charset="-120"/>
               </a:rPr>
-              <a:t>Audi A3 2.0 TDI. Todo lo que se ve viene leído del bus, nada está escrito a mano.</a:t>
+              <a:t>Audi A3 2.0 TDI. Todos los datos proceden del bus del vehículo.</a:t>
             </a:r>
             <a:endParaRPr lang="en-US" sz="1500" dirty="0"/>
           </a:p>
@@ -6990,7 +6990,7 @@
                 <a:ea typeface="Arial" pitchFamily="34" charset="-122"/>
                 <a:cs typeface="Arial" pitchFamily="34" charset="-120"/>
               </a:rPr>
-              <a:t>Calidad: TDD, integración continua y seguridad</a:t>
+              <a:t>Calidad, integración continua y seguridad</a:t>
             </a:r>
             <a:endParaRPr lang="en-US" sz="3400" dirty="0"/>
           </a:p>
@@ -7029,7 +7029,7 @@
                 <a:ea typeface="Calibri" pitchFamily="34" charset="-122"/>
                 <a:cs typeface="Calibri" pitchFamily="34" charset="-120"/>
               </a:rPr>
-              <a:t>Un solo programador, así que el que avisa de las roturas es el CI.</a:t>
+              <a:t>Un único desarrollador: la integración continua es la red de seguridad.</a:t>
             </a:r>
             <a:endParaRPr lang="en-US" sz="1700" dirty="0"/>
           </a:p>
@@ -7068,7 +7068,7 @@
                 <a:ea typeface="Arial" pitchFamily="34" charset="-122"/>
                 <a:cs typeface="Arial" pitchFamily="34" charset="-120"/>
               </a:rPr>
-              <a:t>Cómo se escribe</a:t>
+              <a:t>Desarrollo</a:t>
             </a:r>
             <a:endParaRPr lang="en-US" sz="1900" dirty="0"/>
           </a:p>
@@ -7225,7 +7225,7 @@
                 <a:ea typeface="Arial" pitchFamily="34" charset="-122"/>
                 <a:cs typeface="Arial" pitchFamily="34" charset="-120"/>
               </a:rPr>
-              <a:t>Qué se comprueba en cada push</a:t>
+              <a:t>Verificaciones en cada push</a:t>
             </a:r>
             <a:endParaRPr lang="en-US" sz="1900" dirty="0"/>
           </a:p>
@@ -7590,7 +7590,7 @@
                 <a:ea typeface="Calibri" pitchFamily="34" charset="-122"/>
                 <a:cs typeface="Calibri" pitchFamily="34" charset="-120"/>
               </a:rPr>
-              <a:t>Lo que me llevo de haber construido esto con IA.</a:t>
+              <a:t>Balance de haber desarrollado el proyecto con asistencia de IA.</a:t>
             </a:r>
             <a:endParaRPr lang="en-US" sz="1700" dirty="0"/>
           </a:p>
@@ -7629,7 +7629,7 @@
                 <a:ea typeface="Arial" pitchFamily="34" charset="-122"/>
                 <a:cs typeface="Arial" pitchFamily="34" charset="-120"/>
               </a:rPr>
-              <a:t>Lo que acelera</a:t>
+              <a:t>Lo que aporta</a:t>
             </a:r>
             <a:endParaRPr lang="en-US" sz="2000" dirty="0"/>
           </a:p>
@@ -7762,7 +7762,7 @@
                 <a:ea typeface="Arial" pitchFamily="34" charset="-122"/>
                 <a:cs typeface="Arial" pitchFamily="34" charset="-120"/>
               </a:rPr>
-              <a:t>Lo que hay que poner</a:t>
+              <a:t>Lo que exige</a:t>
             </a:r>
             <a:endParaRPr lang="en-US" sz="2000" dirty="0"/>
           </a:p>
@@ -8401,7 +8401,7 @@
                 <a:ea typeface="Arial" pitchFamily="34" charset="-122"/>
                 <a:cs typeface="Arial" pitchFamily="34" charset="-120"/>
               </a:rPr>
-              <a:t>Una herramienta de diagnóstico de averías de coche</a:t>
+              <a:t>Diagnóstico de averías de vehículos asistido por IA</a:t>
             </a:r>
             <a:endParaRPr lang="en-US" sz="3200" dirty="0"/>
           </a:p>
@@ -8440,7 +8440,7 @@
                 <a:ea typeface="Calibri" pitchFamily="34" charset="-122"/>
                 <a:cs typeface="Calibri" pitchFamily="34" charset="-120"/>
               </a:rPr>
-              <a:t>Se enchufa al coche, lee sus centralitas y le dice al mecánico qué le pasa y por dónde mirar.</a:t>
+              <a:t>Se conecta al vehículo, interpreta los datos de sus centralitas y propone las causas de la avería.</a:t>
             </a:r>
             <a:endParaRPr lang="en-US" sz="1700" dirty="0"/>
           </a:p>
@@ -8479,7 +8479,7 @@
                 <a:ea typeface="Arial" pitchFamily="34" charset="-122"/>
                 <a:cs typeface="Arial" pitchFamily="34" charset="-120"/>
               </a:rPr>
-              <a:t>El escáner de hoy se queda aquí</a:t>
+              <a:t>Lo que aporta un escáner convencional</a:t>
             </a:r>
             <a:endParaRPr lang="en-US" sz="1900" dirty="0"/>
           </a:p>
@@ -8755,7 +8755,7 @@
                 <a:ea typeface="Calibri" pitchFamily="34" charset="-122"/>
                 <a:cs typeface="Calibri" pitchFamily="34" charset="-120"/>
               </a:rPr>
-              <a:t>Y así hasta diez. Es lo que ha registrado la centralita, no lo que está roto.</a:t>
+              <a:t>Hasta diez códigos. Registran el síntoma, no la causa que lo provoca.</a:t>
             </a:r>
             <a:endParaRPr lang="en-US" sz="1500" dirty="0"/>
           </a:p>
@@ -8794,7 +8794,7 @@
                 <a:ea typeface="Arial" pitchFamily="34" charset="-122"/>
                 <a:cs typeface="Arial" pitchFamily="34" charset="-120"/>
               </a:rPr>
-              <a:t>Esta herramienta sigue desde ahí</a:t>
+              <a:t>Lo que añade esta herramienta</a:t>
             </a:r>
             <a:endParaRPr lang="en-US" sz="1900" dirty="0"/>
           </a:p>
@@ -9120,7 +9120,7 @@
                 <a:ea typeface="Arial" pitchFamily="34" charset="-122"/>
                 <a:cs typeface="Arial" pitchFamily="34" charset="-120"/>
               </a:rPr>
-              <a:t>El flujo de trabajo, de principio a fin</a:t>
+              <a:t>Flujo de trabajo</a:t>
             </a:r>
             <a:endParaRPr lang="en-US" sz="3000" dirty="0"/>
           </a:p>
@@ -9159,7 +9159,7 @@
                 <a:ea typeface="Calibri" pitchFamily="34" charset="-122"/>
                 <a:cs typeface="Calibri" pitchFamily="34" charset="-120"/>
               </a:rPr>
-              <a:t>Desde que enchufas el adaptador hasta que el caso queda guardado.</a:t>
+              <a:t>Desde la conexión del adaptador hasta el registro del caso resuelto.</a:t>
             </a:r>
             <a:endParaRPr lang="en-US" sz="1400" dirty="0"/>
           </a:p>
@@ -9228,7 +9228,7 @@
                 <a:ea typeface="Calibri" pitchFamily="34" charset="-122"/>
                 <a:cs typeface="Calibri" pitchFamily="34" charset="-120"/>
               </a:rPr>
-              <a:t>Se enchufa el adaptador</a:t>
+              <a:t>Se conecta el adaptador</a:t>
             </a:r>
             <a:endParaRPr lang="en-US" sz="1200" dirty="0"/>
           </a:p>
@@ -9248,7 +9248,7 @@
                 <a:ea typeface="Calibri" pitchFamily="34" charset="-122"/>
                 <a:cs typeface="Calibri" pitchFamily="34" charset="-120"/>
               </a:rPr>
-              <a:t>y se pulsa «Iniciar diagnóstico»</a:t>
+              <a:t>y se inicia el diagnóstico</a:t>
             </a:r>
             <a:endParaRPr lang="en-US" sz="1200" dirty="0"/>
           </a:p>
@@ -9410,7 +9410,7 @@
                 <a:ea typeface="Calibri" pitchFamily="34" charset="-122"/>
                 <a:cs typeface="Calibri" pitchFamily="34" charset="-120"/>
               </a:rPr>
-              <a:t>Se barre el bus: qué centralitas responden</a:t>
+              <a:t>Barrido del bus: centralitas que responden</a:t>
             </a:r>
             <a:endParaRPr lang="en-US" sz="1200" dirty="0"/>
           </a:p>
@@ -9596,7 +9596,7 @@
                 <a:ea typeface="Calibri" pitchFamily="34" charset="-122"/>
                 <a:cs typeface="Calibri" pitchFamily="34" charset="-120"/>
               </a:rPr>
-              <a:t>Se calcula la severidad y sale en pantalla</a:t>
+              <a:t>Se calcula la severidad y se muestra el resultado</a:t>
             </a:r>
             <a:endParaRPr lang="en-US" sz="1200" dirty="0"/>
           </a:p>
@@ -9713,7 +9713,7 @@
                 <a:ea typeface="Calibri" pitchFamily="34" charset="-122"/>
                 <a:cs typeface="Calibri" pitchFamily="34" charset="-120"/>
               </a:rPr>
-              <a:t>¿El mecánico pregunta</a:t>
+              <a:t>¿Se consulta</a:t>
             </a:r>
             <a:endParaRPr lang="en-US" sz="1100" dirty="0"/>
           </a:p>
@@ -10112,7 +10112,7 @@
                 <a:ea typeface="Calibri" pitchFamily="34" charset="-122"/>
                 <a:cs typeface="Calibri" pitchFamily="34" charset="-120"/>
               </a:rPr>
-              <a:t>El agente pide lo que le falta</a:t>
+              <a:t>El agente solicita la información que necesita</a:t>
             </a:r>
             <a:endParaRPr lang="en-US" sz="1200" dirty="0"/>
           </a:p>
@@ -10205,7 +10205,7 @@
                 <a:ea typeface="Calibri" pitchFamily="34" charset="-122"/>
                 <a:cs typeface="Calibri" pitchFamily="34" charset="-120"/>
               </a:rPr>
-              <a:t>Responde: explicación, severidad y qué revisar</a:t>
+              <a:t>Devuelve explicación, severidad y comprobaciones</a:t>
             </a:r>
             <a:endParaRPr lang="en-US" sz="1200" dirty="0"/>
           </a:p>
@@ -10391,7 +10391,7 @@
                 <a:ea typeface="Calibri" pitchFamily="34" charset="-122"/>
                 <a:cs typeface="Calibri" pitchFamily="34" charset="-120"/>
               </a:rPr>
-              <a:t>Queda disponible para el siguiente coche</a:t>
+              <a:t>Disponible para diagnósticos posteriores</a:t>
             </a:r>
             <a:endParaRPr lang="en-US" sz="1200" dirty="0"/>
           </a:p>
@@ -10623,7 +10623,7 @@
                 <a:ea typeface="Arial" pitchFamily="34" charset="-122"/>
                 <a:cs typeface="Arial" pitchFamily="34" charset="-120"/>
               </a:rPr>
-              <a:t>Dos formas de diagnosticar: por reglas y con IA</a:t>
+              <a:t>Diagnóstico determinista y diagnóstico cognitivo</a:t>
             </a:r>
             <a:endParaRPr lang="en-US" sz="3400" dirty="0"/>
           </a:p>
@@ -10662,7 +10662,7 @@
                 <a:ea typeface="Calibri" pitchFamily="34" charset="-122"/>
                 <a:cs typeface="Calibri" pitchFamily="34" charset="-120"/>
               </a:rPr>
-              <a:t>El determinista está siempre. El cognitivo, solo si hay un modelo configurado.</a:t>
+              <a:t>El determinista siempre está disponible; el cognitivo requiere un modelo configurado.</a:t>
             </a:r>
             <a:endParaRPr lang="en-US" sz="1700" dirty="0"/>
           </a:p>
@@ -11271,7 +11271,7 @@
                 <a:ea typeface="Calibri" pitchFamily="34" charset="-122"/>
                 <a:cs typeface="Calibri" pitchFamily="34" charset="-120"/>
               </a:rPr>
-              <a:t>TypeScript de punta a punta, y cada pieza detrás de un puerto.</a:t>
+              <a:t>TypeScript en todo el proyecto, y cada dependencia externa detrás de un puerto.</a:t>
             </a:r>
             <a:endParaRPr lang="en-US" sz="1600" dirty="0"/>
           </a:p>
@@ -12181,7 +12181,7 @@
                 <a:ea typeface="Arial" pitchFamily="34" charset="-122"/>
                 <a:cs typeface="Arial" pitchFamily="34" charset="-120"/>
               </a:rPr>
-              <a:t>Arquitectura: Clean Architecture + Hexagonal</a:t>
+              <a:t>Arquitectura: Clean Architecture y patrón hexagonal</a:t>
             </a:r>
             <a:endParaRPr lang="en-US" sz="3400" dirty="0"/>
           </a:p>
@@ -12967,7 +12967,7 @@
                 <a:ea typeface="Arial" pitchFamily="34" charset="-122"/>
                 <a:cs typeface="Arial" pitchFamily="34" charset="-120"/>
               </a:rPr>
-              <a:t>Lectura del coche por OBD-II</a:t>
+              <a:t>Adquisición de datos mediante OBD-II</a:t>
             </a:r>
             <a:endParaRPr lang="en-US" sz="3400" dirty="0"/>
           </a:p>
@@ -13006,7 +13006,7 @@
                 <a:ea typeface="Calibri" pitchFamily="34" charset="-122"/>
                 <a:cs typeface="Calibri" pitchFamily="34" charset="-120"/>
               </a:rPr>
-              <a:t>Un ejemplo: pedirle las revoluciones del motor.</a:t>
+              <a:t>Ejemplo: lectura del régimen de giro del motor.</a:t>
             </a:r>
             <a:endParaRPr lang="en-US" sz="1700" dirty="0"/>
           </a:p>
@@ -13909,7 +13909,7 @@
                 <a:ea typeface="Arial" pitchFamily="34" charset="-122"/>
                 <a:cs typeface="Arial" pitchFamily="34" charset="-120"/>
               </a:rPr>
-              <a:t>Persistencia: una base relacional y una vectorial</a:t>
+              <a:t>Persistencia: modelo relacional y modelo vectorial</a:t>
             </a:r>
             <a:endParaRPr lang="en-US" sz="3400" dirty="0"/>
           </a:p>
@@ -13948,7 +13948,7 @@
                 <a:ea typeface="Calibri" pitchFamily="34" charset="-122"/>
                 <a:cs typeface="Calibri" pitchFamily="34" charset="-120"/>
               </a:rPr>
-              <a:t>En una se busca por clave. En la otra, por parecido.</a:t>
+              <a:t>Una responde por clave exacta; la otra, por similitud semántica.</a:t>
             </a:r>
             <a:endParaRPr lang="en-US" sz="1700" dirty="0"/>
           </a:p>
@@ -14446,7 +14446,7 @@
                 <a:ea typeface="Arial" pitchFamily="34" charset="-122"/>
                 <a:cs typeface="Arial" pitchFamily="34" charset="-120"/>
               </a:rPr>
-              <a:t>La base relacional: qué guarda</a:t>
+              <a:t>Base de datos relacional</a:t>
             </a:r>
             <a:endParaRPr lang="en-US" sz="3400" dirty="0"/>
           </a:p>
@@ -14485,7 +14485,7 @@
                 <a:ea typeface="Calibri" pitchFamily="34" charset="-122"/>
                 <a:cs typeface="Calibri" pitchFamily="34" charset="-120"/>
               </a:rPr>
-              <a:t>13 tablas. Todo lo que se puede pedir por una clave exacta.</a:t>
+              <a:t>13 tablas: todo aquello que se consulta por una clave conocida.</a:t>
             </a:r>
             <a:endParaRPr lang="en-US" sz="1700" dirty="0"/>
           </a:p>

</xml_diff>

<commit_message>
docs(tfm): slide de integracion y despliegue continuos
</commit_message>
<xml_diff>
--- a/docs/presentacion/tfm-intelligent-automotive-diagnostics.pptx
+++ b/docs/presentacion/tfm-intelligent-automotive-diagnostics.pptx
@@ -22,9 +22,10 @@
     <p:sldId id="270" r:id="rId16"/>
     <p:sldId id="271" r:id="rId17"/>
     <p:sldId id="272" r:id="rId18"/>
+    <p:sldId id="273" r:id="rId19"/>
   </p:sldIdLst>
   <p:notesMasterIdLst>
-    <p:notesMasterId r:id="rId19"/>
+    <p:notesMasterId r:id="rId20"/>
   </p:notesMasterIdLst>
   <p:sldSz cx="12192000" cy="6858000"/>
   <p:notesSz cx="6858000" cy="12192000"/>
@@ -614,7 +615,7 @@
 Y luego está el índice de confianza, que se lo ponemos nosotros al guardar según de dónde venga el dato. Si lo encontró el agente en internet entra con 0,3. Si viene de un diagnóstico anterior, 0,5. Si lo aportó el mecánico a mano, 0,8, porque una persona delante del coche sabe más que una web cualquiera. Y si se ha leído del propio coche por OBD es un hecho: 1,0. Comprobar un dato contra el coche sube la web a 0,7 y al mecánico a 0,9.
 Ese índice no es decorativo: es lo que pondera las búsquedas. Cuando al agente le llegan dos respuestas que se contradicen, gana la que más confianza tiene.
 [Si preguntan por el escalado] Hay dos mecanismos distintos y conviene no mezclarlos. Que el mecánico aporte o confirme un dato sube su confianza a 0,8, y validarlo contra el coche lo lleva a 0,9: eso está implementado y funciona. Lo que dejé fuera a propósito es subir la confianza de un caso cada vez que se reutiliza con acierto. La función existe y está testeada, pero no la llamo desde ningún flujo, porque para eso haría falta saber que el diagnóstico acertó de verdad, y nadie le dice al sistema si el coche se arregló. Inventármelo habría degradado el catálogo.
-[~70 s · acumulado 10:45]</a:t>
+[~70 s · acumulado 10:05]</a:t>
             </a:r>
             <a:endParaRPr lang="en-US" dirty="0"/>
           </a:p>
@@ -707,7 +708,7 @@
 ¿Y por qué MCP? Primero, porque es el estándar que existe hoy para que un modelo pida herramientas. No es un protocolo de propósito general: sirve exactamente para esto.
 Y segundo, que para mí es lo importante: el modelo solo puede actuar a través de esas dieciséis. No hay otra puerta. No ejecuta código, no consulta la base de datos por su cuenta, no llama a ningún otro endpoint. Si quiere saber a cuántas revoluciones está el motor, tiene que pedir la herramienta de leer un PID, y ahí decido yo si se ejecuta y con qué argumentos. Eso acota lo que el agente puede hacer, y en un sistema que se conecta a un coche de verdad no es un detalle menor.
 Además, cada herramienta declara su esquema, así que los argumentos se validan antes de ejecutar nada. Y el servidor MCP vive en infraestructura: es un adaptador más, el modelo nunca ve el dominio. Como es un protocolo, ese mismo servidor serviría a cualquier otro cliente que lo hable.
-[~75 s · acumulado 12:00]</a:t>
+[~75 s · acumulado 11:20]</a:t>
             </a:r>
             <a:endParaRPr lang="en-US" dirty="0"/>
           </a:p>
@@ -802,7 +803,7 @@
 Cuando termina, devuelve dos cosas: la explicación en lenguaje normal para el mecánico, y un bloque JSON con la severidad, la confianza y las recomendaciones, que es lo que la aplicación pinta en pantalla. Si no hay explicación, se lanza un error a propósito y no se guarda nada: un caso vacío en el catálogo volvería luego como "caso similar" y contaminaría los diagnósticos siguientes.
 Y por último el caso se indexa con confianza 0,5, que es la de diagnóstico anterior.
 El system prompt tiene once bloques. No es solo decirle "eres un mecánico": hay bloques de exploración, de consultar el catálogo antes de inventar, de aprendizaje para PIDs, DTCs y ECUs, de ámbito, de no revelar sus propias tripas, de contenido no fiable y del formato de salida.
-[~80 s · acumulado 13:20]</a:t>
+[~80 s · acumulado 12:40]</a:t>
             </a:r>
             <a:endParaRPr lang="en-US" dirty="0"/>
           </a:p>
@@ -894,7 +895,7 @@
 El de lenguaje es el que razona, y es intercambiable: una variable de entorno decide si va contra Anthropic o contra OpenAI. Los dos clientes implementan el mismo puerto, así que la capa de aplicación no se entera de cuál hay detrás. Y el adaptador de OpenAI no vale solo para OpenAI: sirve para cualquier proveedor compatible con su API —DeepSeek, Groq, Mistral, xAI— cambiando la URL base. Si no hay ninguno configurado, el diagnóstico determinista sigue funcionando.
 El de embeddings es distinto: no se cambia, va dentro. Es un modelo pequeño que corre en la propia máquina con transformers.js. Coge un texto —la descripción de un PID, la narrativa de un diagnóstico— y lo convierte en 384 números, normalizados, que es lo que se guarda en la base vectorial. Buscar por parecido es comparar esos vectores.
 Que corra en local significa tres cosas: no hace falta clave, no hay latencia de red y no se paga por consulta. Y como es multilingüe, español e inglés caen cerca en ese espacio: por eso "presión de aceite" encuentra una ficha que pone "oil pressure", que es justo lo que un buscador de texto no hace.
-[~65 s · acumulado 14:25]</a:t>
+[~65 s · acumulado 13:45]</a:t>
             </a:r>
             <a:endParaRPr lang="en-US" dirty="0"/>
           </a:p>
@@ -987,7 +988,7 @@
 Al lado, la telemetría en vivo, y debajo los PIDs que este vehículo declara soportar, que no son una lista fija: se leen del bitmask del PID 00.
 Abajo a la izquierda, las averías. Tres códigos confirmados, y las tres pestañas son los servicios 03, 07 y 0A del estándar: almacenadas, pendientes y permanentes.
 Y a la derecha el informe, que se congela con la sesión: si dentro de seis meses alguien abre ese diagnóstico, ve exactamente lo que se vio ese día.
-[~2 min contando la demo. Si hay vídeo del coche real, va aquí. · acumulado 16:25]</a:t>
+[~2 min contando la demo. Si hay vídeo del coche real, va aquí. · acumulado 15:45]</a:t>
             </a:r>
             <a:endParaRPr lang="en-US" dirty="0"/>
           </a:p>
@@ -1081,7 +1082,7 @@
 Cada cambio va documentado con OpenSpec antes de escribirse: hay 45 cambios especificados y archivados, con su diseño, sus specs y sus tareas.
 En cada push, el CI corre lint, formato, los tests, el build y el typecheck, para las dos aplicaciones en paralelo sobre Node 22. Y pasa una auditoría de dependencias que tumba la build si aparece una vulnerabilidad crítica.
 En seguridad, el documento cubre las diez categorías del OWASP API Top 10 de 2023, una a una, con lo que hace el código en cada caso. Incluidos los riesgos residuales, que están escritos y asumidos, no escondidos.
-[~60 s · acumulado 17:25]</a:t>
+[~60 s · acumulado 16:45]</a:t>
             </a:r>
             <a:endParaRPr lang="en-US" dirty="0"/>
           </a:p>
@@ -1169,12 +1170,12 @@
           <a:p>
             <a:r>
               <a:rPr lang="en-US" dirty="0"/>
-              <a:t>Para terminar, lo que me llevo de haber hecho esto.
-Lo primero, que con IA se pueden construir cosas complejas mucho más rápido. Un proyecto como este, con su arquitectura, su capa de OBD, su base vectorial y su agente, antes habría sido cuestión de meses o de años. Y no solo va más rápido: se aprenden más cosas por el camino, porque te metes en herramientas y frameworks que de otra forma ni habrías tocado.
-Pero hay una segunda parte, y la quiero decir igual de claro. La IA también se equivoca, y hay que estar encima de lo que se sube. No vale con fiarse.
-Y no lo digo en abstracto: preparando esta misma presentación encontré que el umbral de cobertura del núcleo apuntaba a un fichero que se había renombrado, así que llevaba semanas sin exigir nada. Estaba verde, y no comprobaba lo que decía comprobar. Lo he documentado en la deuda conocida del proyecto.
-Así que sí, acelera mucho. Pero no es todo tan bonito como parece: hay que dedicarle tiempo a revisar.
-[~45 s · acumulado 18:10]</a:t>
+              <a:t>Todo el ciclo está automatizado con GitHub Actions, y son dos flujos distintos.
+El de integración continua se ejecuta en cada push y en cada pull request contra main y develop. Levanta las dos aplicaciones en paralelo sobre Node 22 y pasa lint, formato, las pruebas, la compilación y el typecheck. Y remata con una auditoría de dependencias que detiene la entrega si aparece una vulnerabilidad crítica.
+El de despliegue se dispara solo cuando algo entra en main, que es la rama de releases. Construye tres imágenes Docker: la API, la interfaz y el emulador ELM327. Usa caché de la propia plataforma, así que las construcciones sucesivas son rápidas. Las publica en el registro de contenedores de GitHub.
+Y después entra por SSH al servidor, descarga las imágenes nuevas, levanta los contenedores con la configuración de producción y limpia las imágenes viejas. Sin que yo toque nada.
+La consecuencia práctica es que integrar en main es publicar. La aplicación está desplegada y accesible, no es una demo que solo corre en mi portátil.
+[~55 s · acumulado 17:40]</a:t>
             </a:r>
             <a:endParaRPr lang="en-US" dirty="0"/>
           </a:p>
@@ -1262,8 +1263,12 @@
           <a:p>
             <a:r>
               <a:rPr lang="en-US" dirty="0"/>
-              <a:t>Y hasta aquí. Muchas gracias por la atención.
-[Quedarse callado y esperar las preguntas. El backup está detrás.]</a:t>
+              <a:t>Para terminar, lo que me llevo de haber hecho esto.
+Lo primero, que con IA se pueden construir cosas complejas mucho más rápido. Un proyecto como este, con su arquitectura, su capa de OBD, su base vectorial y su agente, antes habría sido cuestión de meses o de años. Y no solo va más rápido: se aprenden más cosas por el camino, porque te metes en herramientas y frameworks que de otra forma ni habrías tocado.
+Pero hay una segunda parte, y la quiero decir igual de claro. La IA también se equivoca, y hay que estar encima de lo que se sube. No vale con fiarse.
+Y no lo digo en abstracto: preparando esta misma presentación encontré que el umbral de cobertura del núcleo apuntaba a un fichero que se había renombrado, así que llevaba semanas sin exigir nada. Estaba verde, y no comprobaba lo que decía comprobar. Lo he documentado en la deuda conocida del proyecto.
+Así que sí, acelera mucho. Pero no es todo tan bonito como parece: hay que dedicarle tiempo a revisar.
+[~45 s · acumulado 18:25]</a:t>
             </a:r>
             <a:endParaRPr lang="en-US" dirty="0"/>
           </a:p>
@@ -1287,6 +1292,95 @@
             <a:fld id="{F7021451-1387-4CA6-816F-3879F97B5CBC}" type="slidenum">
               <a:rPr lang="en-US"/>
               <a:t>17</a:t>
+            </a:fld>
+            <a:endParaRPr lang="en-US"/>
+          </a:p>
+        </p:txBody>
+      </p:sp>
+    </p:spTree>
+    <p:extLst>
+      <p:ext uri="{BB962C8B-B14F-4D97-AF65-F5344CB8AC3E}">
+        <p14:creationId xmlns:p14="http://schemas.microsoft.com/office/powerpoint/2010/main" val="1024086991"/>
+      </p:ext>
+    </p:extLst>
+  </p:cSld>
+  <p:clrMapOvr>
+    <a:masterClrMapping/>
+  </p:clrMapOvr>
+</p:notes>
+</file>
+
+<file path=ppt/notesSlides/notesSlide18.xml><?xml version="1.0" encoding="utf-8"?>
+<p:notes xmlns:a="http://schemas.openxmlformats.org/drawingml/2006/main" xmlns:r="http://schemas.openxmlformats.org/officeDocument/2006/relationships" xmlns:p="http://schemas.openxmlformats.org/presentationml/2006/main">
+  <p:cSld>
+    <p:spTree>
+      <p:nvGrpSpPr>
+        <p:cNvPr id="1" name=""/>
+        <p:cNvGrpSpPr/>
+        <p:nvPr/>
+      </p:nvGrpSpPr>
+      <p:grpSpPr>
+        <a:xfrm>
+          <a:off x="0" y="0"/>
+          <a:ext cx="0" cy="0"/>
+          <a:chOff x="0" y="0"/>
+          <a:chExt cx="0" cy="0"/>
+        </a:xfrm>
+      </p:grpSpPr>
+      <p:sp>
+        <p:nvSpPr>
+          <p:cNvPr id="2" name="Slide Image Placeholder 1"/>
+          <p:cNvSpPr>
+            <a:spLocks noGrp="1" noRot="1" noChangeAspect="1"/>
+          </p:cNvSpPr>
+          <p:nvPr>
+            <p:ph type="sldImg"/>
+          </p:nvPr>
+        </p:nvSpPr>
+        <p:spPr/>
+      </p:sp>
+      <p:sp>
+        <p:nvSpPr>
+          <p:cNvPr id="3" name="Notes Placeholder 2"/>
+          <p:cNvSpPr>
+            <a:spLocks noGrp="1"/>
+          </p:cNvSpPr>
+          <p:nvPr>
+            <p:ph type="body" idx="1"/>
+          </p:nvPr>
+        </p:nvSpPr>
+        <p:spPr/>
+        <p:txBody>
+          <a:bodyPr/>
+          <a:lstStyle/>
+          <a:p>
+            <a:r>
+              <a:rPr lang="en-US" dirty="0"/>
+              <a:t>Y hasta aquí. Muchas gracias por la atención.
+[Quedarse callado y esperar las preguntas. El backup está detrás.]</a:t>
+            </a:r>
+            <a:endParaRPr lang="en-US" dirty="0"/>
+          </a:p>
+        </p:txBody>
+      </p:sp>
+      <p:sp>
+        <p:nvSpPr>
+          <p:cNvPr id="4" name="Slide Number Placeholder 3"/>
+          <p:cNvSpPr>
+            <a:spLocks noGrp="1"/>
+          </p:cNvSpPr>
+          <p:nvPr>
+            <p:ph type="sldNum" sz="quarter" idx="10"/>
+          </p:nvPr>
+        </p:nvSpPr>
+        <p:spPr/>
+        <p:txBody>
+          <a:bodyPr/>
+          <a:lstStyle/>
+          <a:p>
+            <a:fld id="{F7021451-1387-4CA6-816F-3879F97B5CBC}" type="slidenum">
+              <a:rPr lang="en-US"/>
+              <a:t>18</a:t>
             </a:fld>
             <a:endParaRPr lang="en-US"/>
           </a:p>
@@ -1449,7 +1543,7 @@
 Si no pregunta, se acaba ahí y la sesión queda guardada. Eso es importante: sin IA de por medio, el mecánico ya tiene un diagnóstico. Si no hay modelo configurado o el taller no tiene internet, la herramienta sigue sirviendo.
 Si pregunta, se pasa a la columna de la derecha. Antes de llamar al modelo se buscan casos parecidos de diagnósticos anteriores. El agente va pidiendo lo que le falta: el catálogo, más lecturas del coche o una búsqueda web. Responde con la explicación, la severidad y qué conviene revisar. Y el caso se indexa.
 Ese último paso es el que hace que el sistema mejore: queda disponible para el siguiente coche que entre con síntomas parecidos.
-[~75 s · acumulado 3:10]</a:t>
+[~75 s · acumulado 2:30]</a:t>
             </a:r>
             <a:endParaRPr lang="en-US" dirty="0"/>
           </a:p>
@@ -1541,7 +1635,7 @@
 El determinista es el de toda la vida. Lee cuatro PIDs fijos —revoluciones, temperatura de refrigerante, velocidad y temperatura de admisión—, los códigos de avería y el freeze frame. Y la criticidad no me la invento: sale de una regla en el dominio, computeSeverity. Si no hay códigos es baja; si hay freeze frame es crítica, porque significa que la centralita congeló el momento del fallo; y si hay códigos sin freeze frame es alta. Solo necesita el coche conectado, responde al momento, y no aprende nada.
 El cognitivo es el otro. Ahí no hay una lista fija de PIDs: el agente decide qué le hace falta leer y va llamando a las herramientas según lo que encuentra. A cambio necesita tres cosas: el coche, la API del modelo y los índices vectoriales. Tarda más, con un límite de sesenta segundos. Y es el único que aprende: indexa los PIDs y DTCs nuevos y guarda el caso resuelto.
 Por eso conviven. Si no hay modelo configurado, o si no hay internet en el taller, el determinista sigue funcionando.
-[~65 s · acumulado 4:15]</a:t>
+[~65 s · acumulado 3:35]</a:t>
             </a:r>
             <a:endParaRPr lang="en-US" dirty="0"/>
           </a:p>
@@ -1635,7 +1729,7 @@
 El agente usa el SDK oficial de MCP, y por debajo el de Anthropic o el de OpenAI según lo que esté configurado. El acceso al coche es un ELM327, por puerto serie o por TCP, y para la demo un emulador escrito en Python.
 La interfaz es React 19 con Vite y TanStack, y las pruebas son Vitest para unidad, supertest para los endpoints y Playwright para el extremo a extremo. Y la entrega va con GitHub Actions, Docker y Caddy delante.
 Lo importante no es la lista: es que todo lo que aparece de la tercera fila para abajo está detrás de un puerto, así que se puede sustituir sin tocar la lógica.
-[~55 s · acumulado 5:10]</a:t>
+[~55 s · acumulado 4:30]</a:t>
             </a:r>
             <a:endParaRPr lang="en-US" dirty="0"/>
           </a:p>
@@ -1727,7 +1821,7 @@
 ¿Y por qué no orientada a eventos? Porque aquí no hay varios servicios que desacoplar: es un solo proceso. El flujo es síncrono, el mecánico pregunta y se queda esperando. Un broker y colas me traerían consistencia eventual y mucha más superficie de depuración sin ganar nada. Y soy un solo programador: cuantas más piezas móviles, más sitio donde romper.
 Abajo está el ejemplo concreto de este proyecto. En el dominio, los value objects y los catálogos. En aplicación, los casos de uso y los puertos, que dicen qué hace falta pero no cómo. Y en infraestructura el cómo: Express, Drizzle sobre SQLite, LanceDB, el servidor MCP y el transporte del ELM327.
 El dominio no sabe que existe SQLite, ni Express, ni ningún modelo de lenguaje.
-[~80 s · acumulado 6:30]</a:t>
+[~80 s · acumulado 5:50]</a:t>
             </a:r>
             <a:endParaRPr lang="en-US" dirty="0"/>
           </a:p>
@@ -1821,7 +1915,7 @@
 La centralita contesta 41 0C 0B B8. El 41 es el 01 más cuarenta, que es como la norma marca que es una respuesta. El 0C confirma qué PID contesta. Y los dos últimos bytes son el dato en crudo.
 Ese dato no son revoluciones todavía. Hay que aplicarle la fórmula del PID: A por 256 más B, dividido entre 4. Con 0B y B8, eso da 750 revoluciones.
 Esa fórmula la fija la SAE J1979, y por eso está en el dominio y no en el código que habla con el cable.
-[~70 s · acumulado 7:40]</a:t>
+[~70 s · acumulado 7:00]</a:t>
             </a:r>
             <a:endParaRPr lang="en-US" dirty="0"/>
           </a:p>
@@ -1914,7 +2008,7 @@
 En la vectorial va ese mismo conocimiento pero indexado por significado, más los diagnósticos ya resueltos, que solo están ahí. La diferencia no es qué se guarda, es cómo se busca: en SQLite pregunto por una clave, y en la vectorial pido "enséñame algo parecido a esto".
 Y no vale con una sola. SQLite tiene buscador de texto, pero busca palabras: si el mecánico escribe "presión de aceite", no encuentra una ficha que ponga "oil pressure". La búsqueda vectorial sí, porque compara significado.
 Las dos son embebidas: un fichero y un directorio en disco. Cero servidores.
-[~55 s · acumulado 8:35]</a:t>
+[~55 s · acumulado 7:55]</a:t>
             </a:r>
             <a:endParaRPr lang="en-US" dirty="0"/>
           </a:p>
@@ -2006,7 +2100,7 @@
 Los usuarios, que pueden ser particulares o talleres, con su rol. Los vehículos, identificados por su VIN, y las ECUs que se le han descubierto a cada uno en el bus. Las sesiones de diagnóstico, y de cada una el informe congelado, tal como salió ese día. Las lecturas de PID, guardando tanto el hexadecimal crudo que devolvió la centralita como el valor ya convertido. Y los logs y la auditoría de cada petición HTTP, que es requisito de OWASP.
 Al arrancar, la base se siembra: veinte PIDs de la norma SAE J1979, veintitrés códigos DTC estándar y veintisiete fabricantes por su código WMI, que es lo que permite sacar la marca de un VIN. Pero el catálogo no se queda ahí: cuando el agente lee un PID que no conoce, se inserta solo en esta base con confianza 0,3 y una fórmula asumida, marcado como auto-descubierto. Vale como pista, no como dato confirmado, hasta que se valida contra el coche.
 Es un fichero en disco, sin servidor. PostgreSQL se descartó porque a esta escala solo añadía un servicio, una red y un backup que mantener, sin resolver ningún problema que yo tuviera.
-[~60 s · acumulado 9:35]</a:t>
+[~60 s · acumulado 8:55]</a:t>
             </a:r>
             <a:endParaRPr lang="en-US" dirty="0"/>
           </a:p>
@@ -6990,7 +7084,7 @@
                 <a:ea typeface="Arial" pitchFamily="34" charset="-122"/>
                 <a:cs typeface="Arial" pitchFamily="34" charset="-120"/>
               </a:rPr>
-              <a:t>Calidad, integración continua y seguridad</a:t>
+              <a:t>Calidad del código y seguridad</a:t>
             </a:r>
             <a:endParaRPr lang="en-US" sz="3400" dirty="0"/>
           </a:p>
@@ -7029,7 +7123,7 @@
                 <a:ea typeface="Calibri" pitchFamily="34" charset="-122"/>
                 <a:cs typeface="Calibri" pitchFamily="34" charset="-120"/>
               </a:rPr>
-              <a:t>Un único desarrollador: la integración continua es la red de seguridad.</a:t>
+              <a:t>Un único desarrollador: las comprobaciones automáticas son la red de seguridad.</a:t>
             </a:r>
             <a:endParaRPr lang="en-US" sz="1700" dirty="0"/>
           </a:p>
@@ -7526,8 +7620,8 @@
         </p:nvSpPr>
         <p:spPr>
           <a:xfrm>
-            <a:off x="777240" y="640080"/>
-            <a:ext cx="10607040" cy="777240"/>
+            <a:off x="777240" y="502920"/>
+            <a:ext cx="10607040" cy="685800"/>
           </a:xfrm>
           <a:prstGeom prst="rect">
             <a:avLst/>
@@ -7543,7 +7637,7 @@
               <a:buNone/>
             </a:pPr>
             <a:r>
-              <a:rPr lang="en-US" sz="3400" b="1" dirty="0">
+              <a:rPr lang="en-US" sz="3200" b="1" dirty="0">
                 <a:solidFill>
                   <a:srgbClr val="1A1C2E"/>
                 </a:solidFill>
@@ -7551,9 +7645,9 @@
                 <a:ea typeface="Arial" pitchFamily="34" charset="-122"/>
                 <a:cs typeface="Arial" pitchFamily="34" charset="-120"/>
               </a:rPr>
-              <a:t>Conclusiones</a:t>
-            </a:r>
-            <a:endParaRPr lang="en-US" sz="3400" dirty="0"/>
+              <a:t>Integración y despliegue continuos</a:t>
+            </a:r>
+            <a:endParaRPr lang="en-US" sz="3200" dirty="0"/>
           </a:p>
         </p:txBody>
       </p:sp>
@@ -7565,8 +7659,8 @@
         </p:nvSpPr>
         <p:spPr>
           <a:xfrm>
-            <a:off x="777240" y="1508760"/>
-            <a:ext cx="10607040" cy="365760"/>
+            <a:off x="777240" y="1261872"/>
+            <a:ext cx="10607040" cy="320040"/>
           </a:xfrm>
           <a:prstGeom prst="rect">
             <a:avLst/>
@@ -7582,7 +7676,7 @@
               <a:buNone/>
             </a:pPr>
             <a:r>
-              <a:rPr lang="en-US" sz="1700" dirty="0">
+              <a:rPr lang="en-US" sz="1500" dirty="0">
                 <a:solidFill>
                   <a:srgbClr val="5A5F73"/>
                 </a:solidFill>
@@ -7590,61 +7684,777 @@
                 <a:ea typeface="Calibri" pitchFamily="34" charset="-122"/>
                 <a:cs typeface="Calibri" pitchFamily="34" charset="-120"/>
               </a:rPr>
-              <a:t>Balance de haber desarrollado el proyecto con asistencia de IA.</a:t>
-            </a:r>
-            <a:endParaRPr lang="en-US" sz="1700" dirty="0"/>
-          </a:p>
-        </p:txBody>
-      </p:sp>
-      <p:sp>
-        <p:nvSpPr>
-          <p:cNvPr id="4" name="Text 2"/>
-          <p:cNvSpPr/>
-          <p:nvPr/>
-        </p:nvSpPr>
-        <p:spPr>
-          <a:xfrm>
-            <a:off x="777240" y="2286000"/>
-            <a:ext cx="4846320" cy="365760"/>
-          </a:xfrm>
-          <a:prstGeom prst="rect">
-            <a:avLst/>
-          </a:prstGeom>
-          <a:noFill/>
-          <a:ln/>
-        </p:spPr>
-        <p:txBody>
-          <a:bodyPr wrap="square" lIns="0" tIns="0" rIns="0" bIns="0" rtlCol="0" anchor="t"/>
-          <a:lstStyle/>
-          <a:p>
-            <a:pPr indent="0" marL="0">
-              <a:buNone/>
-            </a:pPr>
-            <a:r>
-              <a:rPr lang="en-US" sz="2000" b="1" dirty="0">
-                <a:solidFill>
-                  <a:srgbClr val="202CFC"/>
+              <a:t>Todo automatizado en GitHub Actions: integrar en main publica la nueva versión en producción.</a:t>
+            </a:r>
+            <a:endParaRPr lang="en-US" sz="1500" dirty="0"/>
+          </a:p>
+        </p:txBody>
+      </p:sp>
+      <p:sp>
+        <p:nvSpPr>
+          <p:cNvPr id="4" name="Shape 2"/>
+          <p:cNvSpPr/>
+          <p:nvPr/>
+        </p:nvSpPr>
+        <p:spPr>
+          <a:xfrm>
+            <a:off x="777240" y="1874520"/>
+            <a:ext cx="1828800" cy="868680"/>
+          </a:xfrm>
+          <a:prstGeom prst="roundRect">
+            <a:avLst>
+              <a:gd name="adj" fmla="val 6316"/>
+            </a:avLst>
+          </a:prstGeom>
+          <a:solidFill>
+            <a:srgbClr val="FFFFFF"/>
+          </a:solidFill>
+          <a:ln w="12700">
+            <a:solidFill>
+              <a:srgbClr val="C9CCD8"/>
+            </a:solidFill>
+            <a:prstDash val="solid"/>
+          </a:ln>
+        </p:spPr>
+      </p:sp>
+      <p:sp>
+        <p:nvSpPr>
+          <p:cNvPr id="5" name="Text 3"/>
+          <p:cNvSpPr/>
+          <p:nvPr/>
+        </p:nvSpPr>
+        <p:spPr>
+          <a:xfrm>
+            <a:off x="850392" y="1993392"/>
+            <a:ext cx="1682496" cy="274320"/>
+          </a:xfrm>
+          <a:prstGeom prst="rect">
+            <a:avLst/>
+          </a:prstGeom>
+          <a:noFill/>
+          <a:ln/>
+        </p:spPr>
+        <p:txBody>
+          <a:bodyPr wrap="square" lIns="0" tIns="0" rIns="0" bIns="0" rtlCol="0" anchor="ctr"/>
+          <a:lstStyle/>
+          <a:p>
+            <a:pPr algn="ctr" indent="0" marL="0">
+              <a:buNone/>
+            </a:pPr>
+            <a:r>
+              <a:rPr lang="en-US" sz="1100" b="1" dirty="0">
+                <a:solidFill>
+                  <a:srgbClr val="1A1C2E"/>
                 </a:solidFill>
                 <a:latin typeface="Arial" pitchFamily="34" charset="0"/>
                 <a:ea typeface="Arial" pitchFamily="34" charset="-122"/>
                 <a:cs typeface="Arial" pitchFamily="34" charset="-120"/>
               </a:rPr>
-              <a:t>Lo que aporta</a:t>
-            </a:r>
-            <a:endParaRPr lang="en-US" sz="2000" dirty="0"/>
-          </a:p>
-        </p:txBody>
-      </p:sp>
-      <p:sp>
-        <p:nvSpPr>
-          <p:cNvPr id="5" name="Text 3"/>
-          <p:cNvSpPr/>
-          <p:nvPr/>
-        </p:nvSpPr>
-        <p:spPr>
-          <a:xfrm>
-            <a:off x="777240" y="2834640"/>
-            <a:ext cx="4846320" cy="2468880"/>
+              <a:t>Integración en main</a:t>
+            </a:r>
+            <a:endParaRPr lang="en-US" sz="1100" dirty="0"/>
+          </a:p>
+        </p:txBody>
+      </p:sp>
+      <p:sp>
+        <p:nvSpPr>
+          <p:cNvPr id="6" name="Text 4"/>
+          <p:cNvSpPr/>
+          <p:nvPr/>
+        </p:nvSpPr>
+        <p:spPr>
+          <a:xfrm>
+            <a:off x="850392" y="2276856"/>
+            <a:ext cx="1682496" cy="384048"/>
+          </a:xfrm>
+          <a:prstGeom prst="rect">
+            <a:avLst/>
+          </a:prstGeom>
+          <a:noFill/>
+          <a:ln/>
+        </p:spPr>
+        <p:txBody>
+          <a:bodyPr wrap="square" lIns="0" tIns="0" rIns="0" bIns="0" rtlCol="0" anchor="t"/>
+          <a:lstStyle/>
+          <a:p>
+            <a:pPr algn="ctr" indent="0" marL="0">
+              <a:lnSpc>
+                <a:spcPts val="1200"/>
+              </a:lnSpc>
+              <a:buNone/>
+            </a:pPr>
+            <a:r>
+              <a:rPr lang="en-US" sz="950" dirty="0">
+                <a:solidFill>
+                  <a:srgbClr val="5A5F73"/>
+                </a:solidFill>
+                <a:latin typeface="Calibri" pitchFamily="34" charset="0"/>
+                <a:ea typeface="Calibri" pitchFamily="34" charset="-122"/>
+                <a:cs typeface="Calibri" pitchFamily="34" charset="-120"/>
+              </a:rPr>
+              <a:t>push o merge</a:t>
+            </a:r>
+            <a:endParaRPr lang="en-US" sz="950" dirty="0"/>
+          </a:p>
+        </p:txBody>
+      </p:sp>
+      <p:sp>
+        <p:nvSpPr>
+          <p:cNvPr id="7" name="Shape 5"/>
+          <p:cNvSpPr/>
+          <p:nvPr/>
+        </p:nvSpPr>
+        <p:spPr>
+          <a:xfrm>
+            <a:off x="2679192" y="2308860"/>
+            <a:ext cx="219456" cy="0"/>
+          </a:xfrm>
+          <a:prstGeom prst="line">
+            <a:avLst/>
+          </a:prstGeom>
+          <a:noFill/>
+          <a:ln w="19050">
+            <a:solidFill>
+              <a:srgbClr val="202CFC"/>
+            </a:solidFill>
+            <a:prstDash val="solid"/>
+            <a:tailEnd type="triangle"/>
+          </a:ln>
+        </p:spPr>
+      </p:sp>
+      <p:sp>
+        <p:nvSpPr>
+          <p:cNvPr id="8" name="Shape 6"/>
+          <p:cNvSpPr/>
+          <p:nvPr/>
+        </p:nvSpPr>
+        <p:spPr>
+          <a:xfrm>
+            <a:off x="2971800" y="1874520"/>
+            <a:ext cx="1828800" cy="868680"/>
+          </a:xfrm>
+          <a:prstGeom prst="roundRect">
+            <a:avLst>
+              <a:gd name="adj" fmla="val 6316"/>
+            </a:avLst>
+          </a:prstGeom>
+          <a:solidFill>
+            <a:srgbClr val="FFFFFF"/>
+          </a:solidFill>
+          <a:ln w="12700">
+            <a:solidFill>
+              <a:srgbClr val="C9CCD8"/>
+            </a:solidFill>
+            <a:prstDash val="solid"/>
+          </a:ln>
+        </p:spPr>
+      </p:sp>
+      <p:sp>
+        <p:nvSpPr>
+          <p:cNvPr id="9" name="Text 7"/>
+          <p:cNvSpPr/>
+          <p:nvPr/>
+        </p:nvSpPr>
+        <p:spPr>
+          <a:xfrm>
+            <a:off x="3044952" y="1993392"/>
+            <a:ext cx="1682496" cy="274320"/>
+          </a:xfrm>
+          <a:prstGeom prst="rect">
+            <a:avLst/>
+          </a:prstGeom>
+          <a:noFill/>
+          <a:ln/>
+        </p:spPr>
+        <p:txBody>
+          <a:bodyPr wrap="square" lIns="0" tIns="0" rIns="0" bIns="0" rtlCol="0" anchor="ctr"/>
+          <a:lstStyle/>
+          <a:p>
+            <a:pPr algn="ctr" indent="0" marL="0">
+              <a:buNone/>
+            </a:pPr>
+            <a:r>
+              <a:rPr lang="en-US" sz="1100" b="1" dirty="0">
+                <a:solidFill>
+                  <a:srgbClr val="1A1C2E"/>
+                </a:solidFill>
+                <a:latin typeface="Arial" pitchFamily="34" charset="0"/>
+                <a:ea typeface="Arial" pitchFamily="34" charset="-122"/>
+                <a:cs typeface="Arial" pitchFamily="34" charset="-120"/>
+              </a:rPr>
+              <a:t>Verificación</a:t>
+            </a:r>
+            <a:endParaRPr lang="en-US" sz="1100" dirty="0"/>
+          </a:p>
+        </p:txBody>
+      </p:sp>
+      <p:sp>
+        <p:nvSpPr>
+          <p:cNvPr id="10" name="Text 8"/>
+          <p:cNvSpPr/>
+          <p:nvPr/>
+        </p:nvSpPr>
+        <p:spPr>
+          <a:xfrm>
+            <a:off x="3044952" y="2276856"/>
+            <a:ext cx="1682496" cy="384048"/>
+          </a:xfrm>
+          <a:prstGeom prst="rect">
+            <a:avLst/>
+          </a:prstGeom>
+          <a:noFill/>
+          <a:ln/>
+        </p:spPr>
+        <p:txBody>
+          <a:bodyPr wrap="square" lIns="0" tIns="0" rIns="0" bIns="0" rtlCol="0" anchor="t"/>
+          <a:lstStyle/>
+          <a:p>
+            <a:pPr algn="ctr" indent="0" marL="0">
+              <a:lnSpc>
+                <a:spcPts val="1200"/>
+              </a:lnSpc>
+              <a:buNone/>
+            </a:pPr>
+            <a:r>
+              <a:rPr lang="en-US" sz="950" dirty="0">
+                <a:solidFill>
+                  <a:srgbClr val="5A5F73"/>
+                </a:solidFill>
+                <a:latin typeface="Calibri" pitchFamily="34" charset="0"/>
+                <a:ea typeface="Calibri" pitchFamily="34" charset="-122"/>
+                <a:cs typeface="Calibri" pitchFamily="34" charset="-120"/>
+              </a:rPr>
+              <a:t>lint, tests,</a:t>
+            </a:r>
+            <a:endParaRPr lang="en-US" sz="950" dirty="0"/>
+          </a:p>
+          <a:p>
+            <a:pPr algn="ctr" indent="0" marL="0">
+              <a:lnSpc>
+                <a:spcPts val="1200"/>
+              </a:lnSpc>
+              <a:buNone/>
+            </a:pPr>
+            <a:r>
+              <a:rPr lang="en-US" sz="950" dirty="0">
+                <a:solidFill>
+                  <a:srgbClr val="5A5F73"/>
+                </a:solidFill>
+                <a:latin typeface="Calibri" pitchFamily="34" charset="0"/>
+                <a:ea typeface="Calibri" pitchFamily="34" charset="-122"/>
+                <a:cs typeface="Calibri" pitchFamily="34" charset="-120"/>
+              </a:rPr>
+              <a:t>build y typecheck</a:t>
+            </a:r>
+            <a:endParaRPr lang="en-US" sz="950" dirty="0"/>
+          </a:p>
+        </p:txBody>
+      </p:sp>
+      <p:sp>
+        <p:nvSpPr>
+          <p:cNvPr id="11" name="Shape 9"/>
+          <p:cNvSpPr/>
+          <p:nvPr/>
+        </p:nvSpPr>
+        <p:spPr>
+          <a:xfrm>
+            <a:off x="4873752" y="2308860"/>
+            <a:ext cx="219456" cy="0"/>
+          </a:xfrm>
+          <a:prstGeom prst="line">
+            <a:avLst/>
+          </a:prstGeom>
+          <a:noFill/>
+          <a:ln w="19050">
+            <a:solidFill>
+              <a:srgbClr val="202CFC"/>
+            </a:solidFill>
+            <a:prstDash val="solid"/>
+            <a:tailEnd type="triangle"/>
+          </a:ln>
+        </p:spPr>
+      </p:sp>
+      <p:sp>
+        <p:nvSpPr>
+          <p:cNvPr id="12" name="Shape 10"/>
+          <p:cNvSpPr/>
+          <p:nvPr/>
+        </p:nvSpPr>
+        <p:spPr>
+          <a:xfrm>
+            <a:off x="5166360" y="1874520"/>
+            <a:ext cx="1828800" cy="868680"/>
+          </a:xfrm>
+          <a:prstGeom prst="roundRect">
+            <a:avLst>
+              <a:gd name="adj" fmla="val 6316"/>
+            </a:avLst>
+          </a:prstGeom>
+          <a:solidFill>
+            <a:srgbClr val="FFFFFF"/>
+          </a:solidFill>
+          <a:ln w="12700">
+            <a:solidFill>
+              <a:srgbClr val="C9CCD8"/>
+            </a:solidFill>
+            <a:prstDash val="solid"/>
+          </a:ln>
+        </p:spPr>
+      </p:sp>
+      <p:sp>
+        <p:nvSpPr>
+          <p:cNvPr id="13" name="Text 11"/>
+          <p:cNvSpPr/>
+          <p:nvPr/>
+        </p:nvSpPr>
+        <p:spPr>
+          <a:xfrm>
+            <a:off x="5239512" y="1993392"/>
+            <a:ext cx="1682496" cy="274320"/>
+          </a:xfrm>
+          <a:prstGeom prst="rect">
+            <a:avLst/>
+          </a:prstGeom>
+          <a:noFill/>
+          <a:ln/>
+        </p:spPr>
+        <p:txBody>
+          <a:bodyPr wrap="square" lIns="0" tIns="0" rIns="0" bIns="0" rtlCol="0" anchor="ctr"/>
+          <a:lstStyle/>
+          <a:p>
+            <a:pPr algn="ctr" indent="0" marL="0">
+              <a:buNone/>
+            </a:pPr>
+            <a:r>
+              <a:rPr lang="en-US" sz="1100" b="1" dirty="0">
+                <a:solidFill>
+                  <a:srgbClr val="1A1C2E"/>
+                </a:solidFill>
+                <a:latin typeface="Arial" pitchFamily="34" charset="0"/>
+                <a:ea typeface="Arial" pitchFamily="34" charset="-122"/>
+                <a:cs typeface="Arial" pitchFamily="34" charset="-120"/>
+              </a:rPr>
+              <a:t>Construcción</a:t>
+            </a:r>
+            <a:endParaRPr lang="en-US" sz="1100" dirty="0"/>
+          </a:p>
+        </p:txBody>
+      </p:sp>
+      <p:sp>
+        <p:nvSpPr>
+          <p:cNvPr id="14" name="Text 12"/>
+          <p:cNvSpPr/>
+          <p:nvPr/>
+        </p:nvSpPr>
+        <p:spPr>
+          <a:xfrm>
+            <a:off x="5239512" y="2276856"/>
+            <a:ext cx="1682496" cy="384048"/>
+          </a:xfrm>
+          <a:prstGeom prst="rect">
+            <a:avLst/>
+          </a:prstGeom>
+          <a:noFill/>
+          <a:ln/>
+        </p:spPr>
+        <p:txBody>
+          <a:bodyPr wrap="square" lIns="0" tIns="0" rIns="0" bIns="0" rtlCol="0" anchor="t"/>
+          <a:lstStyle/>
+          <a:p>
+            <a:pPr algn="ctr" indent="0" marL="0">
+              <a:lnSpc>
+                <a:spcPts val="1200"/>
+              </a:lnSpc>
+              <a:buNone/>
+            </a:pPr>
+            <a:r>
+              <a:rPr lang="en-US" sz="950" dirty="0">
+                <a:solidFill>
+                  <a:srgbClr val="5A5F73"/>
+                </a:solidFill>
+                <a:latin typeface="Calibri" pitchFamily="34" charset="0"/>
+                <a:ea typeface="Calibri" pitchFamily="34" charset="-122"/>
+                <a:cs typeface="Calibri" pitchFamily="34" charset="-120"/>
+              </a:rPr>
+              <a:t>tres imágenes</a:t>
+            </a:r>
+            <a:endParaRPr lang="en-US" sz="950" dirty="0"/>
+          </a:p>
+          <a:p>
+            <a:pPr algn="ctr" indent="0" marL="0">
+              <a:lnSpc>
+                <a:spcPts val="1200"/>
+              </a:lnSpc>
+              <a:buNone/>
+            </a:pPr>
+            <a:r>
+              <a:rPr lang="en-US" sz="950" dirty="0">
+                <a:solidFill>
+                  <a:srgbClr val="5A5F73"/>
+                </a:solidFill>
+                <a:latin typeface="Calibri" pitchFamily="34" charset="0"/>
+                <a:ea typeface="Calibri" pitchFamily="34" charset="-122"/>
+                <a:cs typeface="Calibri" pitchFamily="34" charset="-120"/>
+              </a:rPr>
+              <a:t>Docker</a:t>
+            </a:r>
+            <a:endParaRPr lang="en-US" sz="950" dirty="0"/>
+          </a:p>
+        </p:txBody>
+      </p:sp>
+      <p:sp>
+        <p:nvSpPr>
+          <p:cNvPr id="15" name="Shape 13"/>
+          <p:cNvSpPr/>
+          <p:nvPr/>
+        </p:nvSpPr>
+        <p:spPr>
+          <a:xfrm>
+            <a:off x="7068312" y="2308860"/>
+            <a:ext cx="219456" cy="0"/>
+          </a:xfrm>
+          <a:prstGeom prst="line">
+            <a:avLst/>
+          </a:prstGeom>
+          <a:noFill/>
+          <a:ln w="19050">
+            <a:solidFill>
+              <a:srgbClr val="202CFC"/>
+            </a:solidFill>
+            <a:prstDash val="solid"/>
+            <a:tailEnd type="triangle"/>
+          </a:ln>
+        </p:spPr>
+      </p:sp>
+      <p:sp>
+        <p:nvSpPr>
+          <p:cNvPr id="16" name="Shape 14"/>
+          <p:cNvSpPr/>
+          <p:nvPr/>
+        </p:nvSpPr>
+        <p:spPr>
+          <a:xfrm>
+            <a:off x="7360920" y="1874520"/>
+            <a:ext cx="1828800" cy="868680"/>
+          </a:xfrm>
+          <a:prstGeom prst="roundRect">
+            <a:avLst>
+              <a:gd name="adj" fmla="val 6316"/>
+            </a:avLst>
+          </a:prstGeom>
+          <a:solidFill>
+            <a:srgbClr val="FFFFFF"/>
+          </a:solidFill>
+          <a:ln w="12700">
+            <a:solidFill>
+              <a:srgbClr val="C9CCD8"/>
+            </a:solidFill>
+            <a:prstDash val="solid"/>
+          </a:ln>
+        </p:spPr>
+      </p:sp>
+      <p:sp>
+        <p:nvSpPr>
+          <p:cNvPr id="17" name="Text 15"/>
+          <p:cNvSpPr/>
+          <p:nvPr/>
+        </p:nvSpPr>
+        <p:spPr>
+          <a:xfrm>
+            <a:off x="7434072" y="1993392"/>
+            <a:ext cx="1682496" cy="274320"/>
+          </a:xfrm>
+          <a:prstGeom prst="rect">
+            <a:avLst/>
+          </a:prstGeom>
+          <a:noFill/>
+          <a:ln/>
+        </p:spPr>
+        <p:txBody>
+          <a:bodyPr wrap="square" lIns="0" tIns="0" rIns="0" bIns="0" rtlCol="0" anchor="ctr"/>
+          <a:lstStyle/>
+          <a:p>
+            <a:pPr algn="ctr" indent="0" marL="0">
+              <a:buNone/>
+            </a:pPr>
+            <a:r>
+              <a:rPr lang="en-US" sz="1100" b="1" dirty="0">
+                <a:solidFill>
+                  <a:srgbClr val="1A1C2E"/>
+                </a:solidFill>
+                <a:latin typeface="Arial" pitchFamily="34" charset="0"/>
+                <a:ea typeface="Arial" pitchFamily="34" charset="-122"/>
+                <a:cs typeface="Arial" pitchFamily="34" charset="-120"/>
+              </a:rPr>
+              <a:t>Publicación</a:t>
+            </a:r>
+            <a:endParaRPr lang="en-US" sz="1100" dirty="0"/>
+          </a:p>
+        </p:txBody>
+      </p:sp>
+      <p:sp>
+        <p:nvSpPr>
+          <p:cNvPr id="18" name="Text 16"/>
+          <p:cNvSpPr/>
+          <p:nvPr/>
+        </p:nvSpPr>
+        <p:spPr>
+          <a:xfrm>
+            <a:off x="7434072" y="2276856"/>
+            <a:ext cx="1682496" cy="384048"/>
+          </a:xfrm>
+          <a:prstGeom prst="rect">
+            <a:avLst/>
+          </a:prstGeom>
+          <a:noFill/>
+          <a:ln/>
+        </p:spPr>
+        <p:txBody>
+          <a:bodyPr wrap="square" lIns="0" tIns="0" rIns="0" bIns="0" rtlCol="0" anchor="t"/>
+          <a:lstStyle/>
+          <a:p>
+            <a:pPr algn="ctr" indent="0" marL="0">
+              <a:lnSpc>
+                <a:spcPts val="1200"/>
+              </a:lnSpc>
+              <a:buNone/>
+            </a:pPr>
+            <a:r>
+              <a:rPr lang="en-US" sz="950" dirty="0">
+                <a:solidFill>
+                  <a:srgbClr val="5A5F73"/>
+                </a:solidFill>
+                <a:latin typeface="Calibri" pitchFamily="34" charset="0"/>
+                <a:ea typeface="Calibri" pitchFamily="34" charset="-122"/>
+                <a:cs typeface="Calibri" pitchFamily="34" charset="-120"/>
+              </a:rPr>
+              <a:t>registro de</a:t>
+            </a:r>
+            <a:endParaRPr lang="en-US" sz="950" dirty="0"/>
+          </a:p>
+          <a:p>
+            <a:pPr algn="ctr" indent="0" marL="0">
+              <a:lnSpc>
+                <a:spcPts val="1200"/>
+              </a:lnSpc>
+              <a:buNone/>
+            </a:pPr>
+            <a:r>
+              <a:rPr lang="en-US" sz="950" dirty="0">
+                <a:solidFill>
+                  <a:srgbClr val="5A5F73"/>
+                </a:solidFill>
+                <a:latin typeface="Calibri" pitchFamily="34" charset="0"/>
+                <a:ea typeface="Calibri" pitchFamily="34" charset="-122"/>
+                <a:cs typeface="Calibri" pitchFamily="34" charset="-120"/>
+              </a:rPr>
+              <a:t>contenedores</a:t>
+            </a:r>
+            <a:endParaRPr lang="en-US" sz="950" dirty="0"/>
+          </a:p>
+        </p:txBody>
+      </p:sp>
+      <p:sp>
+        <p:nvSpPr>
+          <p:cNvPr id="19" name="Shape 17"/>
+          <p:cNvSpPr/>
+          <p:nvPr/>
+        </p:nvSpPr>
+        <p:spPr>
+          <a:xfrm>
+            <a:off x="9262872" y="2308860"/>
+            <a:ext cx="219456" cy="0"/>
+          </a:xfrm>
+          <a:prstGeom prst="line">
+            <a:avLst/>
+          </a:prstGeom>
+          <a:noFill/>
+          <a:ln w="19050">
+            <a:solidFill>
+              <a:srgbClr val="202CFC"/>
+            </a:solidFill>
+            <a:prstDash val="solid"/>
+            <a:tailEnd type="triangle"/>
+          </a:ln>
+        </p:spPr>
+      </p:sp>
+      <p:sp>
+        <p:nvSpPr>
+          <p:cNvPr id="20" name="Shape 18"/>
+          <p:cNvSpPr/>
+          <p:nvPr/>
+        </p:nvSpPr>
+        <p:spPr>
+          <a:xfrm>
+            <a:off x="9555480" y="1874520"/>
+            <a:ext cx="1828800" cy="868680"/>
+          </a:xfrm>
+          <a:prstGeom prst="roundRect">
+            <a:avLst>
+              <a:gd name="adj" fmla="val 6316"/>
+            </a:avLst>
+          </a:prstGeom>
+          <a:solidFill>
+            <a:srgbClr val="1A1C2E"/>
+          </a:solidFill>
+          <a:ln w="12700">
+            <a:solidFill>
+              <a:srgbClr val="1A1C2E"/>
+            </a:solidFill>
+            <a:prstDash val="solid"/>
+          </a:ln>
+        </p:spPr>
+      </p:sp>
+      <p:sp>
+        <p:nvSpPr>
+          <p:cNvPr id="21" name="Text 19"/>
+          <p:cNvSpPr/>
+          <p:nvPr/>
+        </p:nvSpPr>
+        <p:spPr>
+          <a:xfrm>
+            <a:off x="9628632" y="1993392"/>
+            <a:ext cx="1682496" cy="274320"/>
+          </a:xfrm>
+          <a:prstGeom prst="rect">
+            <a:avLst/>
+          </a:prstGeom>
+          <a:noFill/>
+          <a:ln/>
+        </p:spPr>
+        <p:txBody>
+          <a:bodyPr wrap="square" lIns="0" tIns="0" rIns="0" bIns="0" rtlCol="0" anchor="ctr"/>
+          <a:lstStyle/>
+          <a:p>
+            <a:pPr algn="ctr" indent="0" marL="0">
+              <a:buNone/>
+            </a:pPr>
+            <a:r>
+              <a:rPr lang="en-US" sz="1100" b="1" dirty="0">
+                <a:solidFill>
+                  <a:srgbClr val="FFFFFF"/>
+                </a:solidFill>
+                <a:latin typeface="Arial" pitchFamily="34" charset="0"/>
+                <a:ea typeface="Arial" pitchFamily="34" charset="-122"/>
+                <a:cs typeface="Arial" pitchFamily="34" charset="-120"/>
+              </a:rPr>
+              <a:t>Producción</a:t>
+            </a:r>
+            <a:endParaRPr lang="en-US" sz="1100" dirty="0"/>
+          </a:p>
+        </p:txBody>
+      </p:sp>
+      <p:sp>
+        <p:nvSpPr>
+          <p:cNvPr id="22" name="Text 20"/>
+          <p:cNvSpPr/>
+          <p:nvPr/>
+        </p:nvSpPr>
+        <p:spPr>
+          <a:xfrm>
+            <a:off x="9628632" y="2276856"/>
+            <a:ext cx="1682496" cy="384048"/>
+          </a:xfrm>
+          <a:prstGeom prst="rect">
+            <a:avLst/>
+          </a:prstGeom>
+          <a:noFill/>
+          <a:ln/>
+        </p:spPr>
+        <p:txBody>
+          <a:bodyPr wrap="square" lIns="0" tIns="0" rIns="0" bIns="0" rtlCol="0" anchor="t"/>
+          <a:lstStyle/>
+          <a:p>
+            <a:pPr algn="ctr" indent="0" marL="0">
+              <a:lnSpc>
+                <a:spcPts val="1200"/>
+              </a:lnSpc>
+              <a:buNone/>
+            </a:pPr>
+            <a:r>
+              <a:rPr lang="en-US" sz="950" dirty="0">
+                <a:solidFill>
+                  <a:srgbClr val="B8BCCC"/>
+                </a:solidFill>
+                <a:latin typeface="Calibri" pitchFamily="34" charset="0"/>
+                <a:ea typeface="Calibri" pitchFamily="34" charset="-122"/>
+                <a:cs typeface="Calibri" pitchFamily="34" charset="-120"/>
+              </a:rPr>
+              <a:t>el servidor levanta</a:t>
+            </a:r>
+            <a:endParaRPr lang="en-US" sz="950" dirty="0"/>
+          </a:p>
+          <a:p>
+            <a:pPr algn="ctr" indent="0" marL="0">
+              <a:lnSpc>
+                <a:spcPts val="1200"/>
+              </a:lnSpc>
+              <a:buNone/>
+            </a:pPr>
+            <a:r>
+              <a:rPr lang="en-US" sz="950" dirty="0">
+                <a:solidFill>
+                  <a:srgbClr val="B8BCCC"/>
+                </a:solidFill>
+                <a:latin typeface="Calibri" pitchFamily="34" charset="0"/>
+                <a:ea typeface="Calibri" pitchFamily="34" charset="-122"/>
+                <a:cs typeface="Calibri" pitchFamily="34" charset="-120"/>
+              </a:rPr>
+              <a:t>la nueva versión</a:t>
+            </a:r>
+            <a:endParaRPr lang="en-US" sz="950" dirty="0"/>
+          </a:p>
+        </p:txBody>
+      </p:sp>
+      <p:sp>
+        <p:nvSpPr>
+          <p:cNvPr id="23" name="Text 21"/>
+          <p:cNvSpPr/>
+          <p:nvPr/>
+        </p:nvSpPr>
+        <p:spPr>
+          <a:xfrm>
+            <a:off x="777240" y="3127248"/>
+            <a:ext cx="4846320" cy="365760"/>
+          </a:xfrm>
+          <a:prstGeom prst="rect">
+            <a:avLst/>
+          </a:prstGeom>
+          <a:noFill/>
+          <a:ln/>
+        </p:spPr>
+        <p:txBody>
+          <a:bodyPr wrap="square" lIns="0" tIns="0" rIns="0" bIns="0" rtlCol="0" anchor="t"/>
+          <a:lstStyle/>
+          <a:p>
+            <a:pPr indent="0" marL="0">
+              <a:buNone/>
+            </a:pPr>
+            <a:r>
+              <a:rPr lang="en-US" sz="1900" b="1" dirty="0">
+                <a:solidFill>
+                  <a:srgbClr val="202CFC"/>
+                </a:solidFill>
+                <a:latin typeface="Arial" pitchFamily="34" charset="0"/>
+                <a:ea typeface="Arial" pitchFamily="34" charset="-122"/>
+                <a:cs typeface="Arial" pitchFamily="34" charset="-120"/>
+              </a:rPr>
+              <a:t>Integración continua</a:t>
+            </a:r>
+            <a:endParaRPr lang="en-US" sz="1900" dirty="0"/>
+          </a:p>
+        </p:txBody>
+      </p:sp>
+      <p:sp>
+        <p:nvSpPr>
+          <p:cNvPr id="24" name="Text 22"/>
+          <p:cNvSpPr/>
+          <p:nvPr/>
+        </p:nvSpPr>
+        <p:spPr>
+          <a:xfrm>
+            <a:off x="777240" y="3657600"/>
+            <a:ext cx="4846320" cy="2377440"/>
           </a:xfrm>
           <a:prstGeom prst="rect">
             <a:avLst/>
@@ -7658,86 +8468,110 @@
           <a:p>
             <a:pPr marL="342900" indent="-342900">
               <a:lnSpc>
-                <a:spcPts val="2200"/>
+                <a:spcPts val="2100"/>
               </a:lnSpc>
               <a:spcAft>
-                <a:spcPts val="1300"/>
+                <a:spcPts val="1100"/>
               </a:spcAft>
               <a:buSzPct val="100000"/>
               <a:buChar char="•"/>
             </a:pPr>
             <a:r>
-              <a:rPr lang="en-US" sz="1600" dirty="0">
-                <a:solidFill>
-                  <a:srgbClr val="1A1C2E"/>
-                </a:solidFill>
-                <a:latin typeface="Calibri" pitchFamily="34" charset="0"/>
-                <a:ea typeface="Calibri" pitchFamily="34" charset="-122"/>
-                <a:cs typeface="Calibri" pitchFamily="34" charset="-120"/>
-              </a:rPr>
-              <a:t>Se pueden construir cosas complejas mucho más rápido</a:t>
-            </a:r>
-            <a:endParaRPr lang="en-US" sz="1600" dirty="0"/>
+              <a:rPr lang="en-US" sz="1500" dirty="0">
+                <a:solidFill>
+                  <a:srgbClr val="1A1C2E"/>
+                </a:solidFill>
+                <a:latin typeface="Calibri" pitchFamily="34" charset="0"/>
+                <a:ea typeface="Calibri" pitchFamily="34" charset="-122"/>
+                <a:cs typeface="Calibri" pitchFamily="34" charset="-120"/>
+              </a:rPr>
+              <a:t>En cada push y en cada pull request</a:t>
+            </a:r>
+            <a:endParaRPr lang="en-US" sz="1500" dirty="0"/>
           </a:p>
           <a:p>
             <a:pPr marL="342900" indent="-342900">
               <a:lnSpc>
-                <a:spcPts val="2200"/>
+                <a:spcPts val="2100"/>
               </a:lnSpc>
               <a:spcAft>
-                <a:spcPts val="1300"/>
+                <a:spcPts val="1100"/>
               </a:spcAft>
               <a:buSzPct val="100000"/>
               <a:buChar char="•"/>
             </a:pPr>
             <a:r>
-              <a:rPr lang="en-US" sz="1600" dirty="0">
-                <a:solidFill>
-                  <a:srgbClr val="1A1C2E"/>
-                </a:solidFill>
-                <a:latin typeface="Calibri" pitchFamily="34" charset="0"/>
-                <a:ea typeface="Calibri" pitchFamily="34" charset="-122"/>
-                <a:cs typeface="Calibri" pitchFamily="34" charset="-120"/>
-              </a:rPr>
-              <a:t>Lo que antes eran meses o años, ahora son semanas</a:t>
-            </a:r>
-            <a:endParaRPr lang="en-US" sz="1600" dirty="0"/>
+              <a:rPr lang="en-US" sz="1500" dirty="0">
+                <a:solidFill>
+                  <a:srgbClr val="1A1C2E"/>
+                </a:solidFill>
+                <a:latin typeface="Calibri" pitchFamily="34" charset="0"/>
+                <a:ea typeface="Calibri" pitchFamily="34" charset="-122"/>
+                <a:cs typeface="Calibri" pitchFamily="34" charset="-120"/>
+              </a:rPr>
+              <a:t>Las dos aplicaciones en paralelo, sobre Node 22</a:t>
+            </a:r>
+            <a:endParaRPr lang="en-US" sz="1500" dirty="0"/>
           </a:p>
           <a:p>
             <a:pPr marL="342900" indent="-342900">
               <a:lnSpc>
-                <a:spcPts val="2200"/>
+                <a:spcPts val="2100"/>
               </a:lnSpc>
               <a:spcAft>
-                <a:spcPts val="1300"/>
+                <a:spcPts val="1100"/>
               </a:spcAft>
               <a:buSzPct val="100000"/>
               <a:buChar char="•"/>
             </a:pPr>
             <a:r>
-              <a:rPr lang="en-US" sz="1600" dirty="0">
-                <a:solidFill>
-                  <a:srgbClr val="1A1C2E"/>
-                </a:solidFill>
-                <a:latin typeface="Calibri" pitchFamily="34" charset="0"/>
-                <a:ea typeface="Calibri" pitchFamily="34" charset="-122"/>
-                <a:cs typeface="Calibri" pitchFamily="34" charset="-120"/>
-              </a:rPr>
-              <a:t>Y se aprende más por el camino: herramientas y frameworks que no habrías tocado</a:t>
-            </a:r>
-            <a:endParaRPr lang="en-US" sz="1600" dirty="0"/>
-          </a:p>
-        </p:txBody>
-      </p:sp>
-      <p:sp>
-        <p:nvSpPr>
-          <p:cNvPr id="6" name="Text 4"/>
-          <p:cNvSpPr/>
-          <p:nvPr/>
-        </p:nvSpPr>
-        <p:spPr>
-          <a:xfrm>
-            <a:off x="6537960" y="2286000"/>
+              <a:rPr lang="en-US" sz="1500" dirty="0">
+                <a:solidFill>
+                  <a:srgbClr val="1A1C2E"/>
+                </a:solidFill>
+                <a:latin typeface="Calibri" pitchFamily="34" charset="0"/>
+                <a:ea typeface="Calibri" pitchFamily="34" charset="-122"/>
+                <a:cs typeface="Calibri" pitchFamily="34" charset="-120"/>
+              </a:rPr>
+              <a:t>Lint, formato, pruebas, compilación y typecheck</a:t>
+            </a:r>
+            <a:endParaRPr lang="en-US" sz="1500" dirty="0"/>
+          </a:p>
+          <a:p>
+            <a:pPr marL="342900" indent="-342900">
+              <a:lnSpc>
+                <a:spcPts val="2100"/>
+              </a:lnSpc>
+              <a:spcAft>
+                <a:spcPts val="1100"/>
+              </a:spcAft>
+              <a:buSzPct val="100000"/>
+              <a:buChar char="•"/>
+            </a:pPr>
+            <a:r>
+              <a:rPr lang="en-US" sz="1500" dirty="0">
+                <a:solidFill>
+                  <a:srgbClr val="1A1C2E"/>
+                </a:solidFill>
+                <a:latin typeface="Calibri" pitchFamily="34" charset="0"/>
+                <a:ea typeface="Calibri" pitchFamily="34" charset="-122"/>
+                <a:cs typeface="Calibri" pitchFamily="34" charset="-120"/>
+              </a:rPr>
+              <a:t>Auditoría de dependencias, que detiene la entrega ante una vulnerabilidad crítica</a:t>
+            </a:r>
+            <a:endParaRPr lang="en-US" sz="1500" dirty="0"/>
+          </a:p>
+        </p:txBody>
+      </p:sp>
+      <p:sp>
+        <p:nvSpPr>
+          <p:cNvPr id="25" name="Text 23"/>
+          <p:cNvSpPr/>
+          <p:nvPr/>
+        </p:nvSpPr>
+        <p:spPr>
+          <a:xfrm>
+            <a:off x="6537960" y="3127248"/>
             <a:ext cx="4846320" cy="365760"/>
           </a:xfrm>
           <a:prstGeom prst="rect">
@@ -7754,7 +8588,7 @@
               <a:buNone/>
             </a:pPr>
             <a:r>
-              <a:rPr lang="en-US" sz="2000" b="1" dirty="0">
+              <a:rPr lang="en-US" sz="1900" b="1" dirty="0">
                 <a:solidFill>
                   <a:srgbClr val="202CFC"/>
                 </a:solidFill>
@@ -7762,22 +8596,22 @@
                 <a:ea typeface="Arial" pitchFamily="34" charset="-122"/>
                 <a:cs typeface="Arial" pitchFamily="34" charset="-120"/>
               </a:rPr>
-              <a:t>Lo que exige</a:t>
-            </a:r>
-            <a:endParaRPr lang="en-US" sz="2000" dirty="0"/>
-          </a:p>
-        </p:txBody>
-      </p:sp>
-      <p:sp>
-        <p:nvSpPr>
-          <p:cNvPr id="7" name="Text 5"/>
-          <p:cNvSpPr/>
-          <p:nvPr/>
-        </p:nvSpPr>
-        <p:spPr>
-          <a:xfrm>
-            <a:off x="6537960" y="2834640"/>
-            <a:ext cx="4846320" cy="2468880"/>
+              <a:t>Despliegue continuo</a:t>
+            </a:r>
+            <a:endParaRPr lang="en-US" sz="1900" dirty="0"/>
+          </a:p>
+        </p:txBody>
+      </p:sp>
+      <p:sp>
+        <p:nvSpPr>
+          <p:cNvPr id="26" name="Text 24"/>
+          <p:cNvSpPr/>
+          <p:nvPr/>
+        </p:nvSpPr>
+        <p:spPr>
+          <a:xfrm>
+            <a:off x="6537960" y="3657600"/>
+            <a:ext cx="4846320" cy="2377440"/>
           </a:xfrm>
           <a:prstGeom prst="rect">
             <a:avLst/>
@@ -7791,80 +8625,104 @@
           <a:p>
             <a:pPr marL="342900" indent="-342900">
               <a:lnSpc>
-                <a:spcPts val="2200"/>
+                <a:spcPts val="2100"/>
               </a:lnSpc>
               <a:spcAft>
-                <a:spcPts val="1300"/>
+                <a:spcPts val="1100"/>
               </a:spcAft>
               <a:buSzPct val="100000"/>
               <a:buChar char="•"/>
             </a:pPr>
             <a:r>
-              <a:rPr lang="en-US" sz="1600" dirty="0">
-                <a:solidFill>
-                  <a:srgbClr val="1A1C2E"/>
-                </a:solidFill>
-                <a:latin typeface="Calibri" pitchFamily="34" charset="0"/>
-                <a:ea typeface="Calibri" pitchFamily="34" charset="-122"/>
-                <a:cs typeface="Calibri" pitchFamily="34" charset="-120"/>
-              </a:rPr>
-              <a:t>Acelera, pero también se equivoca</a:t>
-            </a:r>
-            <a:endParaRPr lang="en-US" sz="1600" dirty="0"/>
+              <a:rPr lang="en-US" sz="1500" dirty="0">
+                <a:solidFill>
+                  <a:srgbClr val="1A1C2E"/>
+                </a:solidFill>
+                <a:latin typeface="Calibri" pitchFamily="34" charset="0"/>
+                <a:ea typeface="Calibri" pitchFamily="34" charset="-122"/>
+                <a:cs typeface="Calibri" pitchFamily="34" charset="-120"/>
+              </a:rPr>
+              <a:t>Se dispara al integrar en la rama de releases</a:t>
+            </a:r>
+            <a:endParaRPr lang="en-US" sz="1500" dirty="0"/>
           </a:p>
           <a:p>
             <a:pPr marL="342900" indent="-342900">
               <a:lnSpc>
-                <a:spcPts val="2200"/>
+                <a:spcPts val="2100"/>
               </a:lnSpc>
               <a:spcAft>
-                <a:spcPts val="1300"/>
+                <a:spcPts val="1100"/>
               </a:spcAft>
               <a:buSzPct val="100000"/>
               <a:buChar char="•"/>
             </a:pPr>
             <a:r>
-              <a:rPr lang="en-US" sz="1600" dirty="0">
-                <a:solidFill>
-                  <a:srgbClr val="1A1C2E"/>
-                </a:solidFill>
-                <a:latin typeface="Calibri" pitchFamily="34" charset="0"/>
-                <a:ea typeface="Calibri" pitchFamily="34" charset="-122"/>
-                <a:cs typeface="Calibri" pitchFamily="34" charset="-120"/>
-              </a:rPr>
-              <a:t>Hay que revisar lo que se sube, no vale con fiarse</a:t>
-            </a:r>
-            <a:endParaRPr lang="en-US" sz="1600" dirty="0"/>
+              <a:rPr lang="en-US" sz="1500" dirty="0">
+                <a:solidFill>
+                  <a:srgbClr val="1A1C2E"/>
+                </a:solidFill>
+                <a:latin typeface="Calibri" pitchFamily="34" charset="0"/>
+                <a:ea typeface="Calibri" pitchFamily="34" charset="-122"/>
+                <a:cs typeface="Calibri" pitchFamily="34" charset="-120"/>
+              </a:rPr>
+              <a:t>Construye tres imágenes: API, interfaz y emulador</a:t>
+            </a:r>
+            <a:endParaRPr lang="en-US" sz="1500" dirty="0"/>
           </a:p>
           <a:p>
             <a:pPr marL="342900" indent="-342900">
               <a:lnSpc>
-                <a:spcPts val="2200"/>
+                <a:spcPts val="2100"/>
               </a:lnSpc>
               <a:spcAft>
-                <a:spcPts val="1300"/>
+                <a:spcPts val="1100"/>
               </a:spcAft>
               <a:buSzPct val="100000"/>
               <a:buChar char="•"/>
             </a:pPr>
             <a:r>
-              <a:rPr lang="en-US" sz="1600" dirty="0">
-                <a:solidFill>
-                  <a:srgbClr val="1A1C2E"/>
-                </a:solidFill>
-                <a:latin typeface="Calibri" pitchFamily="34" charset="0"/>
-                <a:ea typeface="Calibri" pitchFamily="34" charset="-122"/>
-                <a:cs typeface="Calibri" pitchFamily="34" charset="-120"/>
-              </a:rPr>
-              <a:t>No es todo tan bonito como parece: hay que dedicarle tiempo</a:t>
-            </a:r>
-            <a:endParaRPr lang="en-US" sz="1600" dirty="0"/>
-          </a:p>
-        </p:txBody>
-      </p:sp>
-      <p:sp>
-        <p:nvSpPr>
-          <p:cNvPr id="8" name="Shape 6"/>
+              <a:rPr lang="en-US" sz="1500" dirty="0">
+                <a:solidFill>
+                  <a:srgbClr val="1A1C2E"/>
+                </a:solidFill>
+                <a:latin typeface="Calibri" pitchFamily="34" charset="0"/>
+                <a:ea typeface="Calibri" pitchFamily="34" charset="-122"/>
+                <a:cs typeface="Calibri" pitchFamily="34" charset="-120"/>
+              </a:rPr>
+              <a:t>Las publica en el registro de contenedores de GitHub</a:t>
+            </a:r>
+            <a:endParaRPr lang="en-US" sz="1500" dirty="0"/>
+          </a:p>
+          <a:p>
+            <a:pPr marL="342900" indent="-342900">
+              <a:lnSpc>
+                <a:spcPts val="2100"/>
+              </a:lnSpc>
+              <a:spcAft>
+                <a:spcPts val="1100"/>
+              </a:spcAft>
+              <a:buSzPct val="100000"/>
+              <a:buChar char="•"/>
+            </a:pPr>
+            <a:r>
+              <a:rPr lang="en-US" sz="1500" dirty="0">
+                <a:solidFill>
+                  <a:srgbClr val="1A1C2E"/>
+                </a:solidFill>
+                <a:latin typeface="Calibri" pitchFamily="34" charset="0"/>
+                <a:ea typeface="Calibri" pitchFamily="34" charset="-122"/>
+                <a:cs typeface="Calibri" pitchFamily="34" charset="-120"/>
+              </a:rPr>
+              <a:t>Y el servidor las descarga y levanta la nueva versión, sin intervención manual</a:t>
+            </a:r>
+            <a:endParaRPr lang="en-US" sz="1500" dirty="0"/>
+          </a:p>
+        </p:txBody>
+      </p:sp>
+      <p:sp>
+        <p:nvSpPr>
+          <p:cNvPr id="27" name="Shape 25"/>
           <p:cNvSpPr/>
           <p:nvPr/>
         </p:nvSpPr>
@@ -7884,7 +8742,7 @@
       </p:sp>
       <p:sp>
         <p:nvSpPr>
-          <p:cNvPr id="9" name="Text 7"/>
+          <p:cNvPr id="28" name="Text 26"/>
           <p:cNvSpPr/>
           <p:nvPr/>
         </p:nvSpPr>
@@ -7923,7 +8781,7 @@
       </p:sp>
       <p:sp>
         <p:nvSpPr>
-          <p:cNvPr id="10" name="Text 8"/>
+          <p:cNvPr id="29" name="Text 27"/>
           <p:cNvSpPr/>
           <p:nvPr/>
         </p:nvSpPr>
@@ -7962,7 +8820,7 @@
       </p:sp>
       <p:sp>
         <p:nvSpPr>
-          <p:cNvPr id="11" name="Text 9"/>
+          <p:cNvPr id="30" name="Text 28"/>
           <p:cNvSpPr/>
           <p:nvPr/>
         </p:nvSpPr>
@@ -8010,6 +8868,519 @@
 <file path=ppt/slides/slide17.xml><?xml version="1.0" encoding="utf-8"?>
 <p:sld xmlns:a="http://schemas.openxmlformats.org/drawingml/2006/main" xmlns:r="http://schemas.openxmlformats.org/officeDocument/2006/relationships" xmlns:p="http://schemas.openxmlformats.org/presentationml/2006/main">
   <p:cSld name="Slide 17">
+    <p:bg>
+      <p:bgPr>
+        <a:solidFill>
+          <a:srgbClr val="FFFFFF"/>
+        </a:solidFill>
+      </p:bgPr>
+    </p:bg>
+    <p:spTree>
+      <p:nvGrpSpPr>
+        <p:cNvPr id="1" name=""/>
+        <p:cNvGrpSpPr/>
+        <p:nvPr/>
+      </p:nvGrpSpPr>
+      <p:grpSpPr>
+        <a:xfrm>
+          <a:off x="0" y="0"/>
+          <a:ext cx="0" cy="0"/>
+          <a:chOff x="0" y="0"/>
+          <a:chExt cx="0" cy="0"/>
+        </a:xfrm>
+      </p:grpSpPr>
+      <p:sp>
+        <p:nvSpPr>
+          <p:cNvPr id="2" name="Text 0"/>
+          <p:cNvSpPr/>
+          <p:nvPr/>
+        </p:nvSpPr>
+        <p:spPr>
+          <a:xfrm>
+            <a:off x="777240" y="640080"/>
+            <a:ext cx="10607040" cy="777240"/>
+          </a:xfrm>
+          <a:prstGeom prst="rect">
+            <a:avLst/>
+          </a:prstGeom>
+          <a:noFill/>
+          <a:ln/>
+        </p:spPr>
+        <p:txBody>
+          <a:bodyPr wrap="square" lIns="0" tIns="0" rIns="0" bIns="0" rtlCol="0" anchor="t"/>
+          <a:lstStyle/>
+          <a:p>
+            <a:pPr indent="0" marL="0">
+              <a:buNone/>
+            </a:pPr>
+            <a:r>
+              <a:rPr lang="en-US" sz="3400" b="1" dirty="0">
+                <a:solidFill>
+                  <a:srgbClr val="1A1C2E"/>
+                </a:solidFill>
+                <a:latin typeface="Arial" pitchFamily="34" charset="0"/>
+                <a:ea typeface="Arial" pitchFamily="34" charset="-122"/>
+                <a:cs typeface="Arial" pitchFamily="34" charset="-120"/>
+              </a:rPr>
+              <a:t>Conclusiones</a:t>
+            </a:r>
+            <a:endParaRPr lang="en-US" sz="3400" dirty="0"/>
+          </a:p>
+        </p:txBody>
+      </p:sp>
+      <p:sp>
+        <p:nvSpPr>
+          <p:cNvPr id="3" name="Text 1"/>
+          <p:cNvSpPr/>
+          <p:nvPr/>
+        </p:nvSpPr>
+        <p:spPr>
+          <a:xfrm>
+            <a:off x="777240" y="1508760"/>
+            <a:ext cx="10607040" cy="365760"/>
+          </a:xfrm>
+          <a:prstGeom prst="rect">
+            <a:avLst/>
+          </a:prstGeom>
+          <a:noFill/>
+          <a:ln/>
+        </p:spPr>
+        <p:txBody>
+          <a:bodyPr wrap="square" lIns="0" tIns="0" rIns="0" bIns="0" rtlCol="0" anchor="t"/>
+          <a:lstStyle/>
+          <a:p>
+            <a:pPr indent="0" marL="0">
+              <a:buNone/>
+            </a:pPr>
+            <a:r>
+              <a:rPr lang="en-US" sz="1700" dirty="0">
+                <a:solidFill>
+                  <a:srgbClr val="5A5F73"/>
+                </a:solidFill>
+                <a:latin typeface="Calibri" pitchFamily="34" charset="0"/>
+                <a:ea typeface="Calibri" pitchFamily="34" charset="-122"/>
+                <a:cs typeface="Calibri" pitchFamily="34" charset="-120"/>
+              </a:rPr>
+              <a:t>Balance de haber desarrollado el proyecto con asistencia de IA.</a:t>
+            </a:r>
+            <a:endParaRPr lang="en-US" sz="1700" dirty="0"/>
+          </a:p>
+        </p:txBody>
+      </p:sp>
+      <p:sp>
+        <p:nvSpPr>
+          <p:cNvPr id="4" name="Text 2"/>
+          <p:cNvSpPr/>
+          <p:nvPr/>
+        </p:nvSpPr>
+        <p:spPr>
+          <a:xfrm>
+            <a:off x="777240" y="2286000"/>
+            <a:ext cx="4846320" cy="365760"/>
+          </a:xfrm>
+          <a:prstGeom prst="rect">
+            <a:avLst/>
+          </a:prstGeom>
+          <a:noFill/>
+          <a:ln/>
+        </p:spPr>
+        <p:txBody>
+          <a:bodyPr wrap="square" lIns="0" tIns="0" rIns="0" bIns="0" rtlCol="0" anchor="t"/>
+          <a:lstStyle/>
+          <a:p>
+            <a:pPr indent="0" marL="0">
+              <a:buNone/>
+            </a:pPr>
+            <a:r>
+              <a:rPr lang="en-US" sz="2000" b="1" dirty="0">
+                <a:solidFill>
+                  <a:srgbClr val="202CFC"/>
+                </a:solidFill>
+                <a:latin typeface="Arial" pitchFamily="34" charset="0"/>
+                <a:ea typeface="Arial" pitchFamily="34" charset="-122"/>
+                <a:cs typeface="Arial" pitchFamily="34" charset="-120"/>
+              </a:rPr>
+              <a:t>Lo que aporta</a:t>
+            </a:r>
+            <a:endParaRPr lang="en-US" sz="2000" dirty="0"/>
+          </a:p>
+        </p:txBody>
+      </p:sp>
+      <p:sp>
+        <p:nvSpPr>
+          <p:cNvPr id="5" name="Text 3"/>
+          <p:cNvSpPr/>
+          <p:nvPr/>
+        </p:nvSpPr>
+        <p:spPr>
+          <a:xfrm>
+            <a:off x="777240" y="2834640"/>
+            <a:ext cx="4846320" cy="2468880"/>
+          </a:xfrm>
+          <a:prstGeom prst="rect">
+            <a:avLst/>
+          </a:prstGeom>
+          <a:noFill/>
+          <a:ln/>
+        </p:spPr>
+        <p:txBody>
+          <a:bodyPr wrap="square" lIns="0" tIns="0" rIns="0" bIns="0" rtlCol="0" anchor="t"/>
+          <a:lstStyle/>
+          <a:p>
+            <a:pPr marL="342900" indent="-342900">
+              <a:lnSpc>
+                <a:spcPts val="2200"/>
+              </a:lnSpc>
+              <a:spcAft>
+                <a:spcPts val="1300"/>
+              </a:spcAft>
+              <a:buSzPct val="100000"/>
+              <a:buChar char="•"/>
+            </a:pPr>
+            <a:r>
+              <a:rPr lang="en-US" sz="1600" dirty="0">
+                <a:solidFill>
+                  <a:srgbClr val="1A1C2E"/>
+                </a:solidFill>
+                <a:latin typeface="Calibri" pitchFamily="34" charset="0"/>
+                <a:ea typeface="Calibri" pitchFamily="34" charset="-122"/>
+                <a:cs typeface="Calibri" pitchFamily="34" charset="-120"/>
+              </a:rPr>
+              <a:t>Se pueden construir cosas complejas mucho más rápido</a:t>
+            </a:r>
+            <a:endParaRPr lang="en-US" sz="1600" dirty="0"/>
+          </a:p>
+          <a:p>
+            <a:pPr marL="342900" indent="-342900">
+              <a:lnSpc>
+                <a:spcPts val="2200"/>
+              </a:lnSpc>
+              <a:spcAft>
+                <a:spcPts val="1300"/>
+              </a:spcAft>
+              <a:buSzPct val="100000"/>
+              <a:buChar char="•"/>
+            </a:pPr>
+            <a:r>
+              <a:rPr lang="en-US" sz="1600" dirty="0">
+                <a:solidFill>
+                  <a:srgbClr val="1A1C2E"/>
+                </a:solidFill>
+                <a:latin typeface="Calibri" pitchFamily="34" charset="0"/>
+                <a:ea typeface="Calibri" pitchFamily="34" charset="-122"/>
+                <a:cs typeface="Calibri" pitchFamily="34" charset="-120"/>
+              </a:rPr>
+              <a:t>Lo que antes eran meses o años, ahora son semanas</a:t>
+            </a:r>
+            <a:endParaRPr lang="en-US" sz="1600" dirty="0"/>
+          </a:p>
+          <a:p>
+            <a:pPr marL="342900" indent="-342900">
+              <a:lnSpc>
+                <a:spcPts val="2200"/>
+              </a:lnSpc>
+              <a:spcAft>
+                <a:spcPts val="1300"/>
+              </a:spcAft>
+              <a:buSzPct val="100000"/>
+              <a:buChar char="•"/>
+            </a:pPr>
+            <a:r>
+              <a:rPr lang="en-US" sz="1600" dirty="0">
+                <a:solidFill>
+                  <a:srgbClr val="1A1C2E"/>
+                </a:solidFill>
+                <a:latin typeface="Calibri" pitchFamily="34" charset="0"/>
+                <a:ea typeface="Calibri" pitchFamily="34" charset="-122"/>
+                <a:cs typeface="Calibri" pitchFamily="34" charset="-120"/>
+              </a:rPr>
+              <a:t>Y se aprende más por el camino: herramientas y frameworks que no habrías tocado</a:t>
+            </a:r>
+            <a:endParaRPr lang="en-US" sz="1600" dirty="0"/>
+          </a:p>
+        </p:txBody>
+      </p:sp>
+      <p:sp>
+        <p:nvSpPr>
+          <p:cNvPr id="6" name="Text 4"/>
+          <p:cNvSpPr/>
+          <p:nvPr/>
+        </p:nvSpPr>
+        <p:spPr>
+          <a:xfrm>
+            <a:off x="6537960" y="2286000"/>
+            <a:ext cx="4846320" cy="365760"/>
+          </a:xfrm>
+          <a:prstGeom prst="rect">
+            <a:avLst/>
+          </a:prstGeom>
+          <a:noFill/>
+          <a:ln/>
+        </p:spPr>
+        <p:txBody>
+          <a:bodyPr wrap="square" lIns="0" tIns="0" rIns="0" bIns="0" rtlCol="0" anchor="t"/>
+          <a:lstStyle/>
+          <a:p>
+            <a:pPr indent="0" marL="0">
+              <a:buNone/>
+            </a:pPr>
+            <a:r>
+              <a:rPr lang="en-US" sz="2000" b="1" dirty="0">
+                <a:solidFill>
+                  <a:srgbClr val="202CFC"/>
+                </a:solidFill>
+                <a:latin typeface="Arial" pitchFamily="34" charset="0"/>
+                <a:ea typeface="Arial" pitchFamily="34" charset="-122"/>
+                <a:cs typeface="Arial" pitchFamily="34" charset="-120"/>
+              </a:rPr>
+              <a:t>Lo que exige</a:t>
+            </a:r>
+            <a:endParaRPr lang="en-US" sz="2000" dirty="0"/>
+          </a:p>
+        </p:txBody>
+      </p:sp>
+      <p:sp>
+        <p:nvSpPr>
+          <p:cNvPr id="7" name="Text 5"/>
+          <p:cNvSpPr/>
+          <p:nvPr/>
+        </p:nvSpPr>
+        <p:spPr>
+          <a:xfrm>
+            <a:off x="6537960" y="2834640"/>
+            <a:ext cx="4846320" cy="2468880"/>
+          </a:xfrm>
+          <a:prstGeom prst="rect">
+            <a:avLst/>
+          </a:prstGeom>
+          <a:noFill/>
+          <a:ln/>
+        </p:spPr>
+        <p:txBody>
+          <a:bodyPr wrap="square" lIns="0" tIns="0" rIns="0" bIns="0" rtlCol="0" anchor="t"/>
+          <a:lstStyle/>
+          <a:p>
+            <a:pPr marL="342900" indent="-342900">
+              <a:lnSpc>
+                <a:spcPts val="2200"/>
+              </a:lnSpc>
+              <a:spcAft>
+                <a:spcPts val="1300"/>
+              </a:spcAft>
+              <a:buSzPct val="100000"/>
+              <a:buChar char="•"/>
+            </a:pPr>
+            <a:r>
+              <a:rPr lang="en-US" sz="1600" dirty="0">
+                <a:solidFill>
+                  <a:srgbClr val="1A1C2E"/>
+                </a:solidFill>
+                <a:latin typeface="Calibri" pitchFamily="34" charset="0"/>
+                <a:ea typeface="Calibri" pitchFamily="34" charset="-122"/>
+                <a:cs typeface="Calibri" pitchFamily="34" charset="-120"/>
+              </a:rPr>
+              <a:t>Acelera, pero también se equivoca</a:t>
+            </a:r>
+            <a:endParaRPr lang="en-US" sz="1600" dirty="0"/>
+          </a:p>
+          <a:p>
+            <a:pPr marL="342900" indent="-342900">
+              <a:lnSpc>
+                <a:spcPts val="2200"/>
+              </a:lnSpc>
+              <a:spcAft>
+                <a:spcPts val="1300"/>
+              </a:spcAft>
+              <a:buSzPct val="100000"/>
+              <a:buChar char="•"/>
+            </a:pPr>
+            <a:r>
+              <a:rPr lang="en-US" sz="1600" dirty="0">
+                <a:solidFill>
+                  <a:srgbClr val="1A1C2E"/>
+                </a:solidFill>
+                <a:latin typeface="Calibri" pitchFamily="34" charset="0"/>
+                <a:ea typeface="Calibri" pitchFamily="34" charset="-122"/>
+                <a:cs typeface="Calibri" pitchFamily="34" charset="-120"/>
+              </a:rPr>
+              <a:t>Hay que revisar lo que se sube, no vale con fiarse</a:t>
+            </a:r>
+            <a:endParaRPr lang="en-US" sz="1600" dirty="0"/>
+          </a:p>
+          <a:p>
+            <a:pPr marL="342900" indent="-342900">
+              <a:lnSpc>
+                <a:spcPts val="2200"/>
+              </a:lnSpc>
+              <a:spcAft>
+                <a:spcPts val="1300"/>
+              </a:spcAft>
+              <a:buSzPct val="100000"/>
+              <a:buChar char="•"/>
+            </a:pPr>
+            <a:r>
+              <a:rPr lang="en-US" sz="1600" dirty="0">
+                <a:solidFill>
+                  <a:srgbClr val="1A1C2E"/>
+                </a:solidFill>
+                <a:latin typeface="Calibri" pitchFamily="34" charset="0"/>
+                <a:ea typeface="Calibri" pitchFamily="34" charset="-122"/>
+                <a:cs typeface="Calibri" pitchFamily="34" charset="-120"/>
+              </a:rPr>
+              <a:t>No es todo tan bonito como parece: hay que dedicarle tiempo</a:t>
+            </a:r>
+            <a:endParaRPr lang="en-US" sz="1600" dirty="0"/>
+          </a:p>
+        </p:txBody>
+      </p:sp>
+      <p:sp>
+        <p:nvSpPr>
+          <p:cNvPr id="8" name="Shape 6"/>
+          <p:cNvSpPr/>
+          <p:nvPr/>
+        </p:nvSpPr>
+        <p:spPr>
+          <a:xfrm>
+            <a:off x="777240" y="6263640"/>
+            <a:ext cx="219456" cy="219456"/>
+          </a:xfrm>
+          <a:prstGeom prst="rect">
+            <a:avLst/>
+          </a:prstGeom>
+          <a:solidFill>
+            <a:srgbClr val="202CFC"/>
+          </a:solidFill>
+          <a:ln/>
+        </p:spPr>
+      </p:sp>
+      <p:sp>
+        <p:nvSpPr>
+          <p:cNvPr id="9" name="Text 7"/>
+          <p:cNvSpPr/>
+          <p:nvPr/>
+        </p:nvSpPr>
+        <p:spPr>
+          <a:xfrm>
+            <a:off x="777240" y="6263640"/>
+            <a:ext cx="219456" cy="219456"/>
+          </a:xfrm>
+          <a:prstGeom prst="rect">
+            <a:avLst/>
+          </a:prstGeom>
+          <a:noFill/>
+          <a:ln/>
+        </p:spPr>
+        <p:txBody>
+          <a:bodyPr wrap="square" lIns="0" tIns="0" rIns="0" bIns="0" rtlCol="0" anchor="ctr"/>
+          <a:lstStyle/>
+          <a:p>
+            <a:pPr algn="ctr" indent="0" marL="0">
+              <a:buNone/>
+            </a:pPr>
+            <a:r>
+              <a:rPr lang="en-US" sz="816" b="1" dirty="0">
+                <a:solidFill>
+                  <a:srgbClr val="FFFFFF"/>
+                </a:solidFill>
+                <a:latin typeface="Arial" pitchFamily="34" charset="0"/>
+                <a:ea typeface="Arial" pitchFamily="34" charset="-122"/>
+                <a:cs typeface="Arial" pitchFamily="34" charset="-120"/>
+              </a:rPr>
+              <a:t>BIG</a:t>
+            </a:r>
+            <a:endParaRPr lang="en-US" sz="816" dirty="0"/>
+          </a:p>
+        </p:txBody>
+      </p:sp>
+      <p:sp>
+        <p:nvSpPr>
+          <p:cNvPr id="10" name="Text 8"/>
+          <p:cNvSpPr/>
+          <p:nvPr/>
+        </p:nvSpPr>
+        <p:spPr>
+          <a:xfrm>
+            <a:off x="1078992" y="6263640"/>
+            <a:ext cx="658368" cy="219456"/>
+          </a:xfrm>
+          <a:prstGeom prst="rect">
+            <a:avLst/>
+          </a:prstGeom>
+          <a:noFill/>
+          <a:ln/>
+        </p:spPr>
+        <p:txBody>
+          <a:bodyPr wrap="square" lIns="0" tIns="0" rIns="0" bIns="0" rtlCol="0" anchor="ctr"/>
+          <a:lstStyle/>
+          <a:p>
+            <a:pPr algn="l" indent="0" marL="0">
+              <a:buNone/>
+            </a:pPr>
+            <a:r>
+              <a:rPr lang="en-US" sz="816" dirty="0">
+                <a:solidFill>
+                  <a:srgbClr val="1A1C2E"/>
+                </a:solidFill>
+                <a:latin typeface="Arial" pitchFamily="34" charset="0"/>
+                <a:ea typeface="Arial" pitchFamily="34" charset="-122"/>
+                <a:cs typeface="Arial" pitchFamily="34" charset="-120"/>
+              </a:rPr>
+              <a:t>school</a:t>
+            </a:r>
+            <a:endParaRPr lang="en-US" sz="816" dirty="0"/>
+          </a:p>
+        </p:txBody>
+      </p:sp>
+      <p:sp>
+        <p:nvSpPr>
+          <p:cNvPr id="11" name="Text 9"/>
+          <p:cNvSpPr/>
+          <p:nvPr/>
+        </p:nvSpPr>
+        <p:spPr>
+          <a:xfrm>
+            <a:off x="11064240" y="6263640"/>
+            <a:ext cx="320040" cy="219456"/>
+          </a:xfrm>
+          <a:prstGeom prst="rect">
+            <a:avLst/>
+          </a:prstGeom>
+          <a:noFill/>
+          <a:ln/>
+        </p:spPr>
+        <p:txBody>
+          <a:bodyPr wrap="square" lIns="0" tIns="0" rIns="0" bIns="0" rtlCol="0" anchor="ctr"/>
+          <a:lstStyle/>
+          <a:p>
+            <a:pPr algn="r" indent="0" marL="0">
+              <a:buNone/>
+            </a:pPr>
+            <a:r>
+              <a:rPr lang="en-US" sz="1000" dirty="0">
+                <a:solidFill>
+                  <a:srgbClr val="5A5F73"/>
+                </a:solidFill>
+                <a:latin typeface="Calibri" pitchFamily="34" charset="0"/>
+                <a:ea typeface="Calibri" pitchFamily="34" charset="-122"/>
+                <a:cs typeface="Calibri" pitchFamily="34" charset="-120"/>
+              </a:rPr>
+              <a:t>17</a:t>
+            </a:r>
+            <a:endParaRPr lang="en-US" sz="1000" dirty="0"/>
+          </a:p>
+        </p:txBody>
+      </p:sp>
+    </p:spTree>
+  </p:cSld>
+  <p:clrMapOvr>
+    <a:masterClrMapping/>
+  </p:clrMapOvr>
+</p:sld>
+</file>
+
+<file path=ppt/slides/slide18.xml><?xml version="1.0" encoding="utf-8"?>
+<p:sld xmlns:a="http://schemas.openxmlformats.org/drawingml/2006/main" xmlns:r="http://schemas.openxmlformats.org/officeDocument/2006/relationships" xmlns:p="http://schemas.openxmlformats.org/presentationml/2006/main">
+  <p:cSld name="Slide 18">
     <p:bg>
       <p:bgPr>
         <a:solidFill>

</xml_diff>

<commit_message>
docs(tfm): ajustar el slide de CI/CD y el contador de slides del generador
</commit_message>
<xml_diff>
--- a/docs/presentacion/tfm-intelligent-automotive-diagnostics.pptx
+++ b/docs/presentacion/tfm-intelligent-automotive-diagnostics.pptx
@@ -8642,7 +8642,7 @@
                 <a:ea typeface="Calibri" pitchFamily="34" charset="-122"/>
                 <a:cs typeface="Calibri" pitchFamily="34" charset="-120"/>
               </a:rPr>
-              <a:t>Se dispara al integrar en la rama de releases</a:t>
+              <a:t>Se dispara al integrar en main</a:t>
             </a:r>
             <a:endParaRPr lang="en-US" sz="1500" dirty="0"/>
           </a:p>
@@ -8714,7 +8714,7 @@
                 <a:ea typeface="Calibri" pitchFamily="34" charset="-122"/>
                 <a:cs typeface="Calibri" pitchFamily="34" charset="-120"/>
               </a:rPr>
-              <a:t>Y el servidor las descarga y levanta la nueva versión, sin intervención manual</a:t>
+              <a:t>El servidor las descarga y levanta la nueva versión, sin intervención manual</a:t>
             </a:r>
             <a:endParaRPr lang="en-US" sz="1500" dirty="0"/>
           </a:p>

</xml_diff>

<commit_message>
docs(tfm): rehacer el slide de arquitectura con las ventajas reales del proyecto
</commit_message>
<xml_diff>
--- a/docs/presentacion/tfm-intelligent-automotive-diagnostics.pptx
+++ b/docs/presentacion/tfm-intelligent-automotive-diagnostics.pptx
@@ -1817,11 +1817,14 @@
           <a:p>
             <a:r>
               <a:rPr lang="en-US" dirty="0"/>
-              <a:t>¿Por qué Clean Architecture y no otra cosa? Porque en este proyecto el dominio no es algo que me haya inventado yo: son normas. SAE J1979, ISO 15031, ISO 15765-4 para el bus CAN, ISO 3779 para el VIN. Las fórmulas que convierten cada PID en una magnitud física, y la decodificación del bastidor. Eso no lo cambia nadie, y no puede estar mezclado con el acceso a datos ni con el modelo de lenguaje.
-¿Y por qué no orientada a eventos? Porque aquí no hay varios servicios que desacoplar: es un solo proceso. El flujo es síncrono, el mecánico pregunta y se queda esperando. Un broker y colas me traerían consistencia eventual y mucha más superficie de depuración sin ganar nada. Y soy un solo programador: cuantas más piezas móviles, más sitio donde romper.
-Abajo está el ejemplo concreto de este proyecto. En el dominio, los value objects y los catálogos. En aplicación, los casos de uso y los puertos, que dicen qué hace falta pero no cómo. Y en infraestructura el cómo: Express, Drizzle sobre SQLite, LanceDB, el servidor MCP y el transporte del ELM327.
-El dominio no sabe que existe SQLite, ni Express, ni ningún modelo de lenguaje.
-[~80 s · acumulado 5:50]</a:t>
+              <a:t>Sobre la arquitectura no os voy a contar la teoría, que ya la conocéis. Os cuento qué me ha dado a mí, en este proyecto concreto.
+Lo primero, y es lo más importante: he construido y probado una aplicación de diagnóstico de vehículos sin tener el vehículo delante. Leer del coche es un puerto, y detrás hay dos adaptadores intercambiables: el lector ELM327 y un emulador. Tres vehículos emulados, un Audi, una Kawasaki y un Toyota. La aplicación no distingue cuál tiene delante.
+Lo segundo, la conexión física la pude decidir al final. El transporte del lector es otro puerto: hay una implementación por red y otra por puerto serie, con una capa de reintentos por encima. Pasar de una a otra no toca el resto de la aplicación.
+Lo tercero. Cuando ya tenía funcionando el diagnóstico determinista, el que aplica las normas, añadí el cognitivo. El servidor MCP entró como un adaptador de infraestructura más, y los casos de uso que ya funcionaban se quedaron exactamente igual.
+Y lo cuarto, hay dos clientes de modelo de lenguaje, y el código de diagnóstico es el mismo para los dos. En las pruebas el modelo se sustituye por un doble, así que el flujo cognitivo se verifica entero sin llamar a un modelo real.
+Abajo está el ejemplo de arriba dibujado: un caso de uso, un puerto, y dos adaptadores detrás.
+La contrapartida está reconocida en el ADR: son más ficheros que un monolito, y el punto donde se cablea todo crece con cada adaptador nuevo. A cambio, dos mil ciento setenta y una pruebas corren sin coche, sin servidor y sin modelo.
+[~85 s · acumulado 5:50]</a:t>
             </a:r>
             <a:endParaRPr lang="en-US" dirty="0"/>
           </a:p>
@@ -13552,7 +13555,7 @@
                 <a:ea typeface="Arial" pitchFamily="34" charset="-122"/>
                 <a:cs typeface="Arial" pitchFamily="34" charset="-120"/>
               </a:rPr>
-              <a:t>Arquitectura: Clean Architecture y patrón hexagonal</a:t>
+              <a:t>Arquitectura: impacto en el desarrollo del proyecto</a:t>
             </a:r>
             <a:endParaRPr lang="en-US" sz="3400" dirty="0"/>
           </a:p>
@@ -13591,7 +13594,7 @@
                 <a:ea typeface="Calibri" pitchFamily="34" charset="-122"/>
                 <a:cs typeface="Calibri" pitchFamily="34" charset="-120"/>
               </a:rPr>
-              <a:t>Aquí el dominio son normas. Y las normas no las cambia nadie.</a:t>
+              <a:t>Qué ha permitido hacer, en concreto, mientras se construía.</a:t>
             </a:r>
             <a:endParaRPr lang="en-US" sz="1700" dirty="0"/>
           </a:p>
@@ -13605,8 +13608,8 @@
         </p:nvSpPr>
         <p:spPr>
           <a:xfrm>
-            <a:off x="777240" y="2148840"/>
-            <a:ext cx="4846320" cy="365760"/>
+            <a:off x="777240" y="2103120"/>
+            <a:ext cx="457200" cy="292608"/>
           </a:xfrm>
           <a:prstGeom prst="rect">
             <a:avLst/>
@@ -13622,7 +13625,7 @@
               <a:buNone/>
             </a:pPr>
             <a:r>
-              <a:rPr lang="en-US" sz="1900" b="1" dirty="0">
+              <a:rPr lang="en-US" sz="1600" b="1" dirty="0">
                 <a:solidFill>
                   <a:srgbClr val="202CFC"/>
                 </a:solidFill>
@@ -13630,9 +13633,9 @@
                 <a:ea typeface="Arial" pitchFamily="34" charset="-122"/>
                 <a:cs typeface="Arial" pitchFamily="34" charset="-120"/>
               </a:rPr>
-              <a:t>Por qué Clean + Hexagonal</a:t>
-            </a:r>
-            <a:endParaRPr lang="en-US" sz="1900" dirty="0"/>
+              <a:t>01</a:t>
+            </a:r>
+            <a:endParaRPr lang="en-US" sz="1600" dirty="0"/>
           </a:p>
         </p:txBody>
       </p:sp>
@@ -13644,8 +13647,8 @@
         </p:nvSpPr>
         <p:spPr>
           <a:xfrm>
-            <a:off x="777240" y="2697480"/>
-            <a:ext cx="4846320" cy="1828800"/>
+            <a:off x="1325880" y="2103120"/>
+            <a:ext cx="10058400" cy="292608"/>
           </a:xfrm>
           <a:prstGeom prst="rect">
             <a:avLst/>
@@ -13657,115 +13660,60 @@
           <a:bodyPr wrap="square" lIns="0" tIns="0" rIns="0" bIns="0" rtlCol="0" anchor="t"/>
           <a:lstStyle/>
           <a:p>
-            <a:pPr marL="342900" indent="-342900">
-              <a:lnSpc>
-                <a:spcPts val="2100"/>
-              </a:lnSpc>
-              <a:spcAft>
-                <a:spcPts val="1000"/>
-              </a:spcAft>
-              <a:buSzPct val="100000"/>
-              <a:buChar char="•"/>
-            </a:pPr>
-            <a:r>
-              <a:rPr lang="en-US" sz="1500" dirty="0">
-                <a:solidFill>
-                  <a:srgbClr val="1A1C2E"/>
-                </a:solidFill>
-                <a:latin typeface="Calibri" pitchFamily="34" charset="0"/>
-                <a:ea typeface="Calibri" pitchFamily="34" charset="-122"/>
-                <a:cs typeface="Calibri" pitchFamily="34" charset="-120"/>
-              </a:rPr>
-              <a:t>El dominio son normas: SAE J1979, ISO 15031, ISO 3779</a:t>
-            </a:r>
-            <a:endParaRPr lang="en-US" sz="1500" dirty="0"/>
-          </a:p>
-          <a:p>
-            <a:pPr marL="342900" indent="-342900">
-              <a:lnSpc>
-                <a:spcPts val="2100"/>
-              </a:lnSpc>
-              <a:spcAft>
-                <a:spcPts val="1000"/>
-              </a:spcAft>
-              <a:buSzPct val="100000"/>
-              <a:buChar char="•"/>
-            </a:pPr>
-            <a:r>
-              <a:rPr lang="en-US" sz="1500" dirty="0">
-                <a:solidFill>
-                  <a:srgbClr val="1A1C2E"/>
-                </a:solidFill>
-                <a:latin typeface="Calibri" pitchFamily="34" charset="0"/>
-                <a:ea typeface="Calibri" pitchFamily="34" charset="-122"/>
-                <a:cs typeface="Calibri" pitchFamily="34" charset="-120"/>
-              </a:rPr>
-              <a:t>Las fórmulas de cada PID y la decodificación del VIN</a:t>
-            </a:r>
-            <a:endParaRPr lang="en-US" sz="1500" dirty="0"/>
-          </a:p>
-          <a:p>
-            <a:pPr marL="342900" indent="-342900">
-              <a:lnSpc>
-                <a:spcPts val="2100"/>
-              </a:lnSpc>
-              <a:spcAft>
-                <a:spcPts val="1000"/>
-              </a:spcAft>
-              <a:buSzPct val="100000"/>
-              <a:buChar char="•"/>
-            </a:pPr>
-            <a:r>
-              <a:rPr lang="en-US" sz="1500" dirty="0">
-                <a:solidFill>
-                  <a:srgbClr val="1A1C2E"/>
-                </a:solidFill>
-                <a:latin typeface="Calibri" pitchFamily="34" charset="0"/>
-                <a:ea typeface="Calibri" pitchFamily="34" charset="-122"/>
-                <a:cs typeface="Calibri" pitchFamily="34" charset="-120"/>
-              </a:rPr>
-              <a:t>Nada de eso se mezcla con la base de datos ni con el LLM</a:t>
-            </a:r>
-            <a:endParaRPr lang="en-US" sz="1500" dirty="0"/>
-          </a:p>
-        </p:txBody>
-      </p:sp>
-      <p:sp>
-        <p:nvSpPr>
-          <p:cNvPr id="6" name="Text 4"/>
-          <p:cNvSpPr/>
-          <p:nvPr/>
-        </p:nvSpPr>
-        <p:spPr>
-          <a:xfrm>
-            <a:off x="6537960" y="2148840"/>
-            <a:ext cx="4846320" cy="365760"/>
-          </a:xfrm>
-          <a:prstGeom prst="rect">
-            <a:avLst/>
-          </a:prstGeom>
-          <a:noFill/>
-          <a:ln/>
-        </p:spPr>
-        <p:txBody>
-          <a:bodyPr wrap="square" lIns="0" tIns="0" rIns="0" bIns="0" rtlCol="0" anchor="t"/>
-          <a:lstStyle/>
-          <a:p>
             <a:pPr indent="0" marL="0">
               <a:buNone/>
             </a:pPr>
             <a:r>
-              <a:rPr lang="en-US" sz="1900" b="1" dirty="0">
-                <a:solidFill>
-                  <a:srgbClr val="5A5F73"/>
+              <a:rPr lang="en-US" sz="1700" b="1" dirty="0">
+                <a:solidFill>
+                  <a:srgbClr val="1A1C2E"/>
                 </a:solidFill>
                 <a:latin typeface="Arial" pitchFamily="34" charset="0"/>
                 <a:ea typeface="Arial" pitchFamily="34" charset="-122"/>
                 <a:cs typeface="Arial" pitchFamily="34" charset="-120"/>
               </a:rPr>
-              <a:t>Por qué no orientada a eventos</a:t>
-            </a:r>
-            <a:endParaRPr lang="en-US" sz="1900" dirty="0"/>
+              <a:t>El proyecto se ha desarrollado sin el vehículo</a:t>
+            </a:r>
+            <a:endParaRPr lang="en-US" sz="1700" dirty="0"/>
+          </a:p>
+        </p:txBody>
+      </p:sp>
+      <p:sp>
+        <p:nvSpPr>
+          <p:cNvPr id="6" name="Text 4"/>
+          <p:cNvSpPr/>
+          <p:nvPr/>
+        </p:nvSpPr>
+        <p:spPr>
+          <a:xfrm>
+            <a:off x="1325880" y="2404872"/>
+            <a:ext cx="10058400" cy="292608"/>
+          </a:xfrm>
+          <a:prstGeom prst="rect">
+            <a:avLst/>
+          </a:prstGeom>
+          <a:noFill/>
+          <a:ln/>
+        </p:spPr>
+        <p:txBody>
+          <a:bodyPr wrap="square" lIns="0" tIns="0" rIns="0" bIns="0" rtlCol="0" anchor="t"/>
+          <a:lstStyle/>
+          <a:p>
+            <a:pPr indent="0" marL="0">
+              <a:buNone/>
+            </a:pPr>
+            <a:r>
+              <a:rPr lang="en-US" sz="1400" dirty="0">
+                <a:solidFill>
+                  <a:srgbClr val="5A5F73"/>
+                </a:solidFill>
+                <a:latin typeface="Calibri" pitchFamily="34" charset="0"/>
+                <a:ea typeface="Calibri" pitchFamily="34" charset="-122"/>
+                <a:cs typeface="Calibri" pitchFamily="34" charset="-120"/>
+              </a:rPr>
+              <a:t>Todo el desarrollo y las pruebas se han hecho contra emuladores: Audi, Kawasaki y Toyota.</a:t>
+            </a:r>
+            <a:endParaRPr lang="en-US" sz="1400" dirty="0"/>
           </a:p>
         </p:txBody>
       </p:sp>
@@ -13777,8 +13725,8 @@
         </p:nvSpPr>
         <p:spPr>
           <a:xfrm>
-            <a:off x="6537960" y="2697480"/>
-            <a:ext cx="4846320" cy="1828800"/>
+            <a:off x="777240" y="2825496"/>
+            <a:ext cx="457200" cy="292608"/>
           </a:xfrm>
           <a:prstGeom prst="rect">
             <a:avLst/>
@@ -13790,113 +13738,370 @@
           <a:bodyPr wrap="square" lIns="0" tIns="0" rIns="0" bIns="0" rtlCol="0" anchor="t"/>
           <a:lstStyle/>
           <a:p>
-            <a:pPr marL="342900" indent="-342900">
-              <a:lnSpc>
-                <a:spcPts val="2100"/>
-              </a:lnSpc>
-              <a:spcAft>
-                <a:spcPts val="1000"/>
-              </a:spcAft>
-              <a:buSzPct val="100000"/>
-              <a:buChar char="•"/>
-            </a:pPr>
-            <a:r>
-              <a:rPr lang="en-US" sz="1500" dirty="0">
-                <a:solidFill>
-                  <a:srgbClr val="1A1C2E"/>
-                </a:solidFill>
-                <a:latin typeface="Calibri" pitchFamily="34" charset="0"/>
-                <a:ea typeface="Calibri" pitchFamily="34" charset="-122"/>
-                <a:cs typeface="Calibri" pitchFamily="34" charset="-120"/>
-              </a:rPr>
-              <a:t>Es un proceso: no hay servicios que desacoplar</a:t>
-            </a:r>
-            <a:endParaRPr lang="en-US" sz="1500" dirty="0"/>
-          </a:p>
-          <a:p>
-            <a:pPr marL="342900" indent="-342900">
-              <a:lnSpc>
-                <a:spcPts val="2100"/>
-              </a:lnSpc>
-              <a:spcAft>
-                <a:spcPts val="1000"/>
-              </a:spcAft>
-              <a:buSzPct val="100000"/>
-              <a:buChar char="•"/>
-            </a:pPr>
-            <a:r>
-              <a:rPr lang="en-US" sz="1500" dirty="0">
-                <a:solidFill>
-                  <a:srgbClr val="1A1C2E"/>
-                </a:solidFill>
-                <a:latin typeface="Calibri" pitchFamily="34" charset="0"/>
-                <a:ea typeface="Calibri" pitchFamily="34" charset="-122"/>
-                <a:cs typeface="Calibri" pitchFamily="34" charset="-120"/>
-              </a:rPr>
-              <a:t>El mecánico pregunta y espera: el flujo es síncrono</a:t>
-            </a:r>
-            <a:endParaRPr lang="en-US" sz="1500" dirty="0"/>
-          </a:p>
-          <a:p>
-            <a:pPr marL="342900" indent="-342900">
-              <a:lnSpc>
-                <a:spcPts val="2100"/>
-              </a:lnSpc>
-              <a:spcAft>
-                <a:spcPts val="1000"/>
-              </a:spcAft>
-              <a:buSzPct val="100000"/>
-              <a:buChar char="•"/>
-            </a:pPr>
-            <a:r>
-              <a:rPr lang="en-US" sz="1500" dirty="0">
-                <a:solidFill>
-                  <a:srgbClr val="1A1C2E"/>
-                </a:solidFill>
-                <a:latin typeface="Calibri" pitchFamily="34" charset="0"/>
-                <a:ea typeface="Calibri" pitchFamily="34" charset="-122"/>
-                <a:cs typeface="Calibri" pitchFamily="34" charset="-120"/>
-              </a:rPr>
-              <a:t>Un solo programador: más piezas es más sitio donde romper</a:t>
-            </a:r>
-            <a:endParaRPr lang="en-US" sz="1500" dirty="0"/>
-          </a:p>
-        </p:txBody>
-      </p:sp>
-      <p:sp>
-        <p:nvSpPr>
-          <p:cNvPr id="8" name="Text 6"/>
-          <p:cNvSpPr/>
-          <p:nvPr/>
-        </p:nvSpPr>
-        <p:spPr>
-          <a:xfrm>
-            <a:off x="777240" y="4709160"/>
-            <a:ext cx="10607040" cy="292608"/>
-          </a:xfrm>
-          <a:prstGeom prst="rect">
-            <a:avLst/>
-          </a:prstGeom>
-          <a:noFill/>
-          <a:ln/>
-        </p:spPr>
-        <p:txBody>
-          <a:bodyPr wrap="square" lIns="0" tIns="0" rIns="0" bIns="0" rtlCol="0" anchor="t"/>
-          <a:lstStyle/>
-          <a:p>
             <a:pPr indent="0" marL="0">
               <a:buNone/>
             </a:pPr>
             <a:r>
-              <a:rPr lang="en-US" sz="1500" b="1" dirty="0">
-                <a:solidFill>
-                  <a:srgbClr val="1A1C2E"/>
+              <a:rPr lang="en-US" sz="1600" b="1" dirty="0">
+                <a:solidFill>
+                  <a:srgbClr val="202CFC"/>
                 </a:solidFill>
                 <a:latin typeface="Arial" pitchFamily="34" charset="0"/>
                 <a:ea typeface="Arial" pitchFamily="34" charset="-122"/>
                 <a:cs typeface="Arial" pitchFamily="34" charset="-120"/>
               </a:rPr>
-              <a:t>En este proyecto</a:t>
+              <a:t>02</a:t>
+            </a:r>
+            <a:endParaRPr lang="en-US" sz="1600" dirty="0"/>
+          </a:p>
+        </p:txBody>
+      </p:sp>
+      <p:sp>
+        <p:nvSpPr>
+          <p:cNvPr id="8" name="Text 6"/>
+          <p:cNvSpPr/>
+          <p:nvPr/>
+        </p:nvSpPr>
+        <p:spPr>
+          <a:xfrm>
+            <a:off x="1325880" y="2825496"/>
+            <a:ext cx="10058400" cy="292608"/>
+          </a:xfrm>
+          <a:prstGeom prst="rect">
+            <a:avLst/>
+          </a:prstGeom>
+          <a:noFill/>
+          <a:ln/>
+        </p:spPr>
+        <p:txBody>
+          <a:bodyPr wrap="square" lIns="0" tIns="0" rIns="0" bIns="0" rtlCol="0" anchor="t"/>
+          <a:lstStyle/>
+          <a:p>
+            <a:pPr indent="0" marL="0">
+              <a:buNone/>
+            </a:pPr>
+            <a:r>
+              <a:rPr lang="en-US" sz="1700" b="1" dirty="0">
+                <a:solidFill>
+                  <a:srgbClr val="1A1C2E"/>
+                </a:solidFill>
+                <a:latin typeface="Arial" pitchFamily="34" charset="0"/>
+                <a:ea typeface="Arial" pitchFamily="34" charset="-122"/>
+                <a:cs typeface="Arial" pitchFamily="34" charset="-120"/>
+              </a:rPr>
+              <a:t>La forma de conectarse al coche se decidió al final</a:t>
+            </a:r>
+            <a:endParaRPr lang="en-US" sz="1700" dirty="0"/>
+          </a:p>
+        </p:txBody>
+      </p:sp>
+      <p:sp>
+        <p:nvSpPr>
+          <p:cNvPr id="9" name="Text 7"/>
+          <p:cNvSpPr/>
+          <p:nvPr/>
+        </p:nvSpPr>
+        <p:spPr>
+          <a:xfrm>
+            <a:off x="1325880" y="3127248"/>
+            <a:ext cx="10058400" cy="292608"/>
+          </a:xfrm>
+          <a:prstGeom prst="rect">
+            <a:avLst/>
+          </a:prstGeom>
+          <a:noFill/>
+          <a:ln/>
+        </p:spPr>
+        <p:txBody>
+          <a:bodyPr wrap="square" lIns="0" tIns="0" rIns="0" bIns="0" rtlCol="0" anchor="t"/>
+          <a:lstStyle/>
+          <a:p>
+            <a:pPr indent="0" marL="0">
+              <a:buNone/>
+            </a:pPr>
+            <a:r>
+              <a:rPr lang="en-US" sz="1400" dirty="0">
+                <a:solidFill>
+                  <a:srgbClr val="5A5F73"/>
+                </a:solidFill>
+                <a:latin typeface="Calibri" pitchFamily="34" charset="0"/>
+                <a:ea typeface="Calibri" pitchFamily="34" charset="-122"/>
+                <a:cs typeface="Calibri" pitchFamily="34" charset="-120"/>
+              </a:rPr>
+              <a:t>El transporte del lector es otro puerto: por red o por puerto serie, con reintentos por encima.</a:t>
+            </a:r>
+            <a:endParaRPr lang="en-US" sz="1400" dirty="0"/>
+          </a:p>
+        </p:txBody>
+      </p:sp>
+      <p:sp>
+        <p:nvSpPr>
+          <p:cNvPr id="10" name="Text 8"/>
+          <p:cNvSpPr/>
+          <p:nvPr/>
+        </p:nvSpPr>
+        <p:spPr>
+          <a:xfrm>
+            <a:off x="777240" y="3547872"/>
+            <a:ext cx="457200" cy="292608"/>
+          </a:xfrm>
+          <a:prstGeom prst="rect">
+            <a:avLst/>
+          </a:prstGeom>
+          <a:noFill/>
+          <a:ln/>
+        </p:spPr>
+        <p:txBody>
+          <a:bodyPr wrap="square" lIns="0" tIns="0" rIns="0" bIns="0" rtlCol="0" anchor="t"/>
+          <a:lstStyle/>
+          <a:p>
+            <a:pPr indent="0" marL="0">
+              <a:buNone/>
+            </a:pPr>
+            <a:r>
+              <a:rPr lang="en-US" sz="1600" b="1" dirty="0">
+                <a:solidFill>
+                  <a:srgbClr val="202CFC"/>
+                </a:solidFill>
+                <a:latin typeface="Arial" pitchFamily="34" charset="0"/>
+                <a:ea typeface="Arial" pitchFamily="34" charset="-122"/>
+                <a:cs typeface="Arial" pitchFamily="34" charset="-120"/>
+              </a:rPr>
+              <a:t>03</a:t>
+            </a:r>
+            <a:endParaRPr lang="en-US" sz="1600" dirty="0"/>
+          </a:p>
+        </p:txBody>
+      </p:sp>
+      <p:sp>
+        <p:nvSpPr>
+          <p:cNvPr id="11" name="Text 9"/>
+          <p:cNvSpPr/>
+          <p:nvPr/>
+        </p:nvSpPr>
+        <p:spPr>
+          <a:xfrm>
+            <a:off x="1325880" y="3547872"/>
+            <a:ext cx="10058400" cy="292608"/>
+          </a:xfrm>
+          <a:prstGeom prst="rect">
+            <a:avLst/>
+          </a:prstGeom>
+          <a:noFill/>
+          <a:ln/>
+        </p:spPr>
+        <p:txBody>
+          <a:bodyPr wrap="square" lIns="0" tIns="0" rIns="0" bIns="0" rtlCol="0" anchor="t"/>
+          <a:lstStyle/>
+          <a:p>
+            <a:pPr indent="0" marL="0">
+              <a:buNone/>
+            </a:pPr>
+            <a:r>
+              <a:rPr lang="en-US" sz="1700" b="1" dirty="0">
+                <a:solidFill>
+                  <a:srgbClr val="1A1C2E"/>
+                </a:solidFill>
+                <a:latin typeface="Arial" pitchFamily="34" charset="0"/>
+                <a:ea typeface="Arial" pitchFamily="34" charset="-122"/>
+                <a:cs typeface="Arial" pitchFamily="34" charset="-120"/>
+              </a:rPr>
+              <a:t>El diagnóstico cognitivo se añadió sin tocar el determinista</a:t>
+            </a:r>
+            <a:endParaRPr lang="en-US" sz="1700" dirty="0"/>
+          </a:p>
+        </p:txBody>
+      </p:sp>
+      <p:sp>
+        <p:nvSpPr>
+          <p:cNvPr id="12" name="Text 10"/>
+          <p:cNvSpPr/>
+          <p:nvPr/>
+        </p:nvSpPr>
+        <p:spPr>
+          <a:xfrm>
+            <a:off x="1325880" y="3849624"/>
+            <a:ext cx="10058400" cy="292608"/>
+          </a:xfrm>
+          <a:prstGeom prst="rect">
+            <a:avLst/>
+          </a:prstGeom>
+          <a:noFill/>
+          <a:ln/>
+        </p:spPr>
+        <p:txBody>
+          <a:bodyPr wrap="square" lIns="0" tIns="0" rIns="0" bIns="0" rtlCol="0" anchor="t"/>
+          <a:lstStyle/>
+          <a:p>
+            <a:pPr indent="0" marL="0">
+              <a:buNone/>
+            </a:pPr>
+            <a:r>
+              <a:rPr lang="en-US" sz="1400" dirty="0">
+                <a:solidFill>
+                  <a:srgbClr val="5A5F73"/>
+                </a:solidFill>
+                <a:latin typeface="Calibri" pitchFamily="34" charset="0"/>
+                <a:ea typeface="Calibri" pitchFamily="34" charset="-122"/>
+                <a:cs typeface="Calibri" pitchFamily="34" charset="-120"/>
+              </a:rPr>
+              <a:t>El servidor MCP entró como un adaptador más. Los casos de uso que ya funcionaban no se modificaron.</a:t>
+            </a:r>
+            <a:endParaRPr lang="en-US" sz="1400" dirty="0"/>
+          </a:p>
+        </p:txBody>
+      </p:sp>
+      <p:sp>
+        <p:nvSpPr>
+          <p:cNvPr id="13" name="Text 11"/>
+          <p:cNvSpPr/>
+          <p:nvPr/>
+        </p:nvSpPr>
+        <p:spPr>
+          <a:xfrm>
+            <a:off x="777240" y="4270248"/>
+            <a:ext cx="457200" cy="292608"/>
+          </a:xfrm>
+          <a:prstGeom prst="rect">
+            <a:avLst/>
+          </a:prstGeom>
+          <a:noFill/>
+          <a:ln/>
+        </p:spPr>
+        <p:txBody>
+          <a:bodyPr wrap="square" lIns="0" tIns="0" rIns="0" bIns="0" rtlCol="0" anchor="t"/>
+          <a:lstStyle/>
+          <a:p>
+            <a:pPr indent="0" marL="0">
+              <a:buNone/>
+            </a:pPr>
+            <a:r>
+              <a:rPr lang="en-US" sz="1600" b="1" dirty="0">
+                <a:solidFill>
+                  <a:srgbClr val="202CFC"/>
+                </a:solidFill>
+                <a:latin typeface="Arial" pitchFamily="34" charset="0"/>
+                <a:ea typeface="Arial" pitchFamily="34" charset="-122"/>
+                <a:cs typeface="Arial" pitchFamily="34" charset="-120"/>
+              </a:rPr>
+              <a:t>04</a:t>
+            </a:r>
+            <a:endParaRPr lang="en-US" sz="1600" dirty="0"/>
+          </a:p>
+        </p:txBody>
+      </p:sp>
+      <p:sp>
+        <p:nvSpPr>
+          <p:cNvPr id="14" name="Text 12"/>
+          <p:cNvSpPr/>
+          <p:nvPr/>
+        </p:nvSpPr>
+        <p:spPr>
+          <a:xfrm>
+            <a:off x="1325880" y="4270248"/>
+            <a:ext cx="10058400" cy="292608"/>
+          </a:xfrm>
+          <a:prstGeom prst="rect">
+            <a:avLst/>
+          </a:prstGeom>
+          <a:noFill/>
+          <a:ln/>
+        </p:spPr>
+        <p:txBody>
+          <a:bodyPr wrap="square" lIns="0" tIns="0" rIns="0" bIns="0" rtlCol="0" anchor="t"/>
+          <a:lstStyle/>
+          <a:p>
+            <a:pPr indent="0" marL="0">
+              <a:buNone/>
+            </a:pPr>
+            <a:r>
+              <a:rPr lang="en-US" sz="1700" b="1" dirty="0">
+                <a:solidFill>
+                  <a:srgbClr val="1A1C2E"/>
+                </a:solidFill>
+                <a:latin typeface="Arial" pitchFamily="34" charset="0"/>
+                <a:ea typeface="Arial" pitchFamily="34" charset="-122"/>
+                <a:cs typeface="Arial" pitchFamily="34" charset="-120"/>
+              </a:rPr>
+              <a:t>Dos proveedores de modelo con el mismo código de diagnóstico</a:t>
+            </a:r>
+            <a:endParaRPr lang="en-US" sz="1700" dirty="0"/>
+          </a:p>
+        </p:txBody>
+      </p:sp>
+      <p:sp>
+        <p:nvSpPr>
+          <p:cNvPr id="15" name="Text 13"/>
+          <p:cNvSpPr/>
+          <p:nvPr/>
+        </p:nvSpPr>
+        <p:spPr>
+          <a:xfrm>
+            <a:off x="1325880" y="4572000"/>
+            <a:ext cx="10058400" cy="292608"/>
+          </a:xfrm>
+          <a:prstGeom prst="rect">
+            <a:avLst/>
+          </a:prstGeom>
+          <a:noFill/>
+          <a:ln/>
+        </p:spPr>
+        <p:txBody>
+          <a:bodyPr wrap="square" lIns="0" tIns="0" rIns="0" bIns="0" rtlCol="0" anchor="t"/>
+          <a:lstStyle/>
+          <a:p>
+            <a:pPr indent="0" marL="0">
+              <a:buNone/>
+            </a:pPr>
+            <a:r>
+              <a:rPr lang="en-US" sz="1400" dirty="0">
+                <a:solidFill>
+                  <a:srgbClr val="5A5F73"/>
+                </a:solidFill>
+                <a:latin typeface="Calibri" pitchFamily="34" charset="0"/>
+                <a:ea typeface="Calibri" pitchFamily="34" charset="-122"/>
+                <a:cs typeface="Calibri" pitchFamily="34" charset="-120"/>
+              </a:rPr>
+              <a:t>En las pruebas el modelo se sustituye por un doble: el flujo se verifica sin llamar a uno real.</a:t>
+            </a:r>
+            <a:endParaRPr lang="en-US" sz="1400" dirty="0"/>
+          </a:p>
+        </p:txBody>
+      </p:sp>
+      <p:sp>
+        <p:nvSpPr>
+          <p:cNvPr id="16" name="Text 14"/>
+          <p:cNvSpPr/>
+          <p:nvPr/>
+        </p:nvSpPr>
+        <p:spPr>
+          <a:xfrm>
+            <a:off x="777240" y="5029200"/>
+            <a:ext cx="10607040" cy="274320"/>
+          </a:xfrm>
+          <a:prstGeom prst="rect">
+            <a:avLst/>
+          </a:prstGeom>
+          <a:noFill/>
+          <a:ln/>
+        </p:spPr>
+        <p:txBody>
+          <a:bodyPr wrap="square" lIns="0" tIns="0" rIns="0" bIns="0" rtlCol="0" anchor="t"/>
+          <a:lstStyle/>
+          <a:p>
+            <a:pPr indent="0" marL="0">
+              <a:buNone/>
+            </a:pPr>
+            <a:r>
+              <a:rPr lang="en-US" sz="1500" b="1" dirty="0">
+                <a:solidFill>
+                  <a:srgbClr val="1A1C2E"/>
+                </a:solidFill>
+                <a:latin typeface="Arial" pitchFamily="34" charset="0"/>
+                <a:ea typeface="Arial" pitchFamily="34" charset="-122"/>
+                <a:cs typeface="Arial" pitchFamily="34" charset="-120"/>
+              </a:rPr>
+              <a:t>Un ejemplo</a:t>
             </a:r>
             <a:endParaRPr lang="en-US" sz="1500" dirty="0"/>
           </a:p>
@@ -13904,14 +14109,14 @@
       </p:sp>
       <p:sp>
         <p:nvSpPr>
-          <p:cNvPr id="9" name="Text 7"/>
-          <p:cNvSpPr/>
-          <p:nvPr/>
-        </p:nvSpPr>
-        <p:spPr>
-          <a:xfrm>
-            <a:off x="777240" y="5120640"/>
-            <a:ext cx="1737360" cy="310896"/>
+          <p:cNvPr id="17" name="Text 15"/>
+          <p:cNvSpPr/>
+          <p:nvPr/>
+        </p:nvSpPr>
+        <p:spPr>
+          <a:xfrm>
+            <a:off x="777240" y="5413248"/>
+            <a:ext cx="2651760" cy="329184"/>
           </a:xfrm>
           <a:prstGeom prst="rect">
             <a:avLst/>
@@ -13923,34 +14128,34 @@
           <a:bodyPr wrap="square" lIns="0" tIns="0" rIns="0" bIns="0" rtlCol="0" anchor="ctr"/>
           <a:lstStyle/>
           <a:p>
-            <a:pPr indent="0" marL="0">
-              <a:buNone/>
-            </a:pPr>
-            <a:r>
-              <a:rPr lang="en-US" sz="1400" b="1" dirty="0">
-                <a:solidFill>
-                  <a:srgbClr val="202CFC"/>
-                </a:solidFill>
-                <a:latin typeface="Calibri" pitchFamily="34" charset="0"/>
-                <a:ea typeface="Calibri" pitchFamily="34" charset="-122"/>
-                <a:cs typeface="Calibri" pitchFamily="34" charset="-120"/>
-              </a:rPr>
-              <a:t>Dominio</a:t>
-            </a:r>
-            <a:endParaRPr lang="en-US" sz="1400" dirty="0"/>
-          </a:p>
-        </p:txBody>
-      </p:sp>
-      <p:sp>
-        <p:nvSpPr>
-          <p:cNvPr id="10" name="Text 8"/>
-          <p:cNvSpPr/>
-          <p:nvPr/>
-        </p:nvSpPr>
-        <p:spPr>
-          <a:xfrm>
-            <a:off x="2560320" y="5120640"/>
-            <a:ext cx="8778240" cy="310896"/>
+            <a:pPr algn="l" indent="0" marL="0">
+              <a:buNone/>
+            </a:pPr>
+            <a:r>
+              <a:rPr lang="en-US" sz="1300" dirty="0">
+                <a:solidFill>
+                  <a:srgbClr val="1A1C2E"/>
+                </a:solidFill>
+                <a:latin typeface="Calibri" pitchFamily="34" charset="0"/>
+                <a:ea typeface="Calibri" pitchFamily="34" charset="-122"/>
+                <a:cs typeface="Calibri" pitchFamily="34" charset="-120"/>
+              </a:rPr>
+              <a:t>Caso de uso de diagnóstico</a:t>
+            </a:r>
+            <a:endParaRPr lang="en-US" sz="1300" dirty="0"/>
+          </a:p>
+        </p:txBody>
+      </p:sp>
+      <p:sp>
+        <p:nvSpPr>
+          <p:cNvPr id="18" name="Text 16"/>
+          <p:cNvSpPr/>
+          <p:nvPr/>
+        </p:nvSpPr>
+        <p:spPr>
+          <a:xfrm>
+            <a:off x="3429000" y="5413248"/>
+            <a:ext cx="457200" cy="329184"/>
           </a:xfrm>
           <a:prstGeom prst="rect">
             <a:avLst/>
@@ -13962,11 +14167,167 @@
           <a:bodyPr wrap="square" lIns="0" tIns="0" rIns="0" bIns="0" rtlCol="0" anchor="ctr"/>
           <a:lstStyle/>
           <a:p>
-            <a:pPr indent="0" marL="0">
-              <a:buNone/>
-            </a:pPr>
-            <a:r>
-              <a:rPr lang="en-US" sz="1400" dirty="0">
+            <a:pPr algn="ctr" indent="0" marL="0">
+              <a:buNone/>
+            </a:pPr>
+            <a:r>
+              <a:rPr lang="en-US" sz="1600" b="1" dirty="0">
+                <a:solidFill>
+                  <a:srgbClr val="8A93FF"/>
+                </a:solidFill>
+                <a:latin typeface="Calibri" pitchFamily="34" charset="0"/>
+                <a:ea typeface="Calibri" pitchFamily="34" charset="-122"/>
+                <a:cs typeface="Calibri" pitchFamily="34" charset="-120"/>
+              </a:rPr>
+              <a:t>→</a:t>
+            </a:r>
+            <a:endParaRPr lang="en-US" sz="1600" dirty="0"/>
+          </a:p>
+        </p:txBody>
+      </p:sp>
+      <p:sp>
+        <p:nvSpPr>
+          <p:cNvPr id="19" name="Text 17"/>
+          <p:cNvSpPr/>
+          <p:nvPr/>
+        </p:nvSpPr>
+        <p:spPr>
+          <a:xfrm>
+            <a:off x="4023360" y="5413248"/>
+            <a:ext cx="2834640" cy="329184"/>
+          </a:xfrm>
+          <a:prstGeom prst="rect">
+            <a:avLst/>
+          </a:prstGeom>
+          <a:noFill/>
+          <a:ln/>
+        </p:spPr>
+        <p:txBody>
+          <a:bodyPr wrap="square" lIns="0" tIns="0" rIns="0" bIns="0" rtlCol="0" anchor="ctr"/>
+          <a:lstStyle/>
+          <a:p>
+            <a:pPr algn="l" indent="0" marL="0">
+              <a:buNone/>
+            </a:pPr>
+            <a:r>
+              <a:rPr lang="en-US" sz="1300" dirty="0">
+                <a:solidFill>
+                  <a:srgbClr val="1A1C2E"/>
+                </a:solidFill>
+                <a:latin typeface="Calibri" pitchFamily="34" charset="0"/>
+                <a:ea typeface="Calibri" pitchFamily="34" charset="-122"/>
+                <a:cs typeface="Calibri" pitchFamily="34" charset="-120"/>
+              </a:rPr>
+              <a:t>Puerto de lectura del vehículo</a:t>
+            </a:r>
+            <a:endParaRPr lang="en-US" sz="1300" dirty="0"/>
+          </a:p>
+        </p:txBody>
+      </p:sp>
+      <p:sp>
+        <p:nvSpPr>
+          <p:cNvPr id="20" name="Text 18"/>
+          <p:cNvSpPr/>
+          <p:nvPr/>
+        </p:nvSpPr>
+        <p:spPr>
+          <a:xfrm>
+            <a:off x="6858000" y="5193792"/>
+            <a:ext cx="457200" cy="329184"/>
+          </a:xfrm>
+          <a:prstGeom prst="rect">
+            <a:avLst/>
+          </a:prstGeom>
+          <a:noFill/>
+          <a:ln/>
+        </p:spPr>
+        <p:txBody>
+          <a:bodyPr wrap="square" lIns="0" tIns="0" rIns="0" bIns="0" rtlCol="0" anchor="ctr"/>
+          <a:lstStyle/>
+          <a:p>
+            <a:pPr algn="ctr" indent="0" marL="0">
+              <a:buNone/>
+            </a:pPr>
+            <a:r>
+              <a:rPr lang="en-US" sz="1600" b="1" dirty="0">
+                <a:solidFill>
+                  <a:srgbClr val="8A93FF"/>
+                </a:solidFill>
+                <a:latin typeface="Calibri" pitchFamily="34" charset="0"/>
+                <a:ea typeface="Calibri" pitchFamily="34" charset="-122"/>
+                <a:cs typeface="Calibri" pitchFamily="34" charset="-120"/>
+              </a:rPr>
+              <a:t>→</a:t>
+            </a:r>
+            <a:endParaRPr lang="en-US" sz="1600" dirty="0"/>
+          </a:p>
+        </p:txBody>
+      </p:sp>
+      <p:sp>
+        <p:nvSpPr>
+          <p:cNvPr id="21" name="Text 19"/>
+          <p:cNvSpPr/>
+          <p:nvPr/>
+        </p:nvSpPr>
+        <p:spPr>
+          <a:xfrm>
+            <a:off x="6858000" y="5632704"/>
+            <a:ext cx="457200" cy="329184"/>
+          </a:xfrm>
+          <a:prstGeom prst="rect">
+            <a:avLst/>
+          </a:prstGeom>
+          <a:noFill/>
+          <a:ln/>
+        </p:spPr>
+        <p:txBody>
+          <a:bodyPr wrap="square" lIns="0" tIns="0" rIns="0" bIns="0" rtlCol="0" anchor="ctr"/>
+          <a:lstStyle/>
+          <a:p>
+            <a:pPr algn="ctr" indent="0" marL="0">
+              <a:buNone/>
+            </a:pPr>
+            <a:r>
+              <a:rPr lang="en-US" sz="1600" b="1" dirty="0">
+                <a:solidFill>
+                  <a:srgbClr val="8A93FF"/>
+                </a:solidFill>
+                <a:latin typeface="Calibri" pitchFamily="34" charset="0"/>
+                <a:ea typeface="Calibri" pitchFamily="34" charset="-122"/>
+                <a:cs typeface="Calibri" pitchFamily="34" charset="-120"/>
+              </a:rPr>
+              <a:t>→</a:t>
+            </a:r>
+            <a:endParaRPr lang="en-US" sz="1600" dirty="0"/>
+          </a:p>
+        </p:txBody>
+      </p:sp>
+      <p:sp>
+        <p:nvSpPr>
+          <p:cNvPr id="22" name="Text 20"/>
+          <p:cNvSpPr/>
+          <p:nvPr/>
+        </p:nvSpPr>
+        <p:spPr>
+          <a:xfrm>
+            <a:off x="7452360" y="5193792"/>
+            <a:ext cx="3840480" cy="329184"/>
+          </a:xfrm>
+          <a:prstGeom prst="rect">
+            <a:avLst/>
+          </a:prstGeom>
+          <a:noFill/>
+          <a:ln/>
+        </p:spPr>
+        <p:txBody>
+          <a:bodyPr wrap="square" lIns="0" tIns="0" rIns="0" bIns="0" rtlCol="0" anchor="ctr"/>
+          <a:lstStyle/>
+          <a:p>
+            <a:pPr algn="l" indent="0" marL="0">
+              <a:buNone/>
+            </a:pPr>
+            <a:r>
+              <a:rPr lang="en-US" sz="1300" dirty="0">
                 <a:solidFill>
                   <a:srgbClr val="5A5F73"/>
                 </a:solidFill>
@@ -13974,22 +14335,22 @@
                 <a:ea typeface="Calibri" pitchFamily="34" charset="-122"/>
                 <a:cs typeface="Calibri" pitchFamily="34" charset="-120"/>
               </a:rPr>
-              <a:t>Vin, DtcCode, PidCode, Formula, catálogos de PID y DTC</a:t>
-            </a:r>
-            <a:endParaRPr lang="en-US" sz="1400" dirty="0"/>
-          </a:p>
-        </p:txBody>
-      </p:sp>
-      <p:sp>
-        <p:nvSpPr>
-          <p:cNvPr id="11" name="Text 9"/>
-          <p:cNvSpPr/>
-          <p:nvPr/>
-        </p:nvSpPr>
-        <p:spPr>
-          <a:xfrm>
-            <a:off x="777240" y="5486400"/>
-            <a:ext cx="1737360" cy="310896"/>
+              <a:t>Lector ELM327 conectado al coche</a:t>
+            </a:r>
+            <a:endParaRPr lang="en-US" sz="1300" dirty="0"/>
+          </a:p>
+        </p:txBody>
+      </p:sp>
+      <p:sp>
+        <p:nvSpPr>
+          <p:cNvPr id="23" name="Text 21"/>
+          <p:cNvSpPr/>
+          <p:nvPr/>
+        </p:nvSpPr>
+        <p:spPr>
+          <a:xfrm>
+            <a:off x="7452360" y="5632704"/>
+            <a:ext cx="3840480" cy="329184"/>
           </a:xfrm>
           <a:prstGeom prst="rect">
             <a:avLst/>
@@ -14001,50 +14362,11 @@
           <a:bodyPr wrap="square" lIns="0" tIns="0" rIns="0" bIns="0" rtlCol="0" anchor="ctr"/>
           <a:lstStyle/>
           <a:p>
-            <a:pPr indent="0" marL="0">
-              <a:buNone/>
-            </a:pPr>
-            <a:r>
-              <a:rPr lang="en-US" sz="1400" b="1" dirty="0">
-                <a:solidFill>
-                  <a:srgbClr val="202CFC"/>
-                </a:solidFill>
-                <a:latin typeface="Calibri" pitchFamily="34" charset="0"/>
-                <a:ea typeface="Calibri" pitchFamily="34" charset="-122"/>
-                <a:cs typeface="Calibri" pitchFamily="34" charset="-120"/>
-              </a:rPr>
-              <a:t>Aplicación</a:t>
-            </a:r>
-            <a:endParaRPr lang="en-US" sz="1400" dirty="0"/>
-          </a:p>
-        </p:txBody>
-      </p:sp>
-      <p:sp>
-        <p:nvSpPr>
-          <p:cNvPr id="12" name="Text 10"/>
-          <p:cNvSpPr/>
-          <p:nvPr/>
-        </p:nvSpPr>
-        <p:spPr>
-          <a:xfrm>
-            <a:off x="2560320" y="5486400"/>
-            <a:ext cx="8778240" cy="310896"/>
-          </a:xfrm>
-          <a:prstGeom prst="rect">
-            <a:avLst/>
-          </a:prstGeom>
-          <a:noFill/>
-          <a:ln/>
-        </p:spPr>
-        <p:txBody>
-          <a:bodyPr wrap="square" lIns="0" tIns="0" rIns="0" bIns="0" rtlCol="0" anchor="ctr"/>
-          <a:lstStyle/>
-          <a:p>
-            <a:pPr indent="0" marL="0">
-              <a:buNone/>
-            </a:pPr>
-            <a:r>
-              <a:rPr lang="en-US" sz="1400" dirty="0">
+            <a:pPr algn="l" indent="0" marL="0">
+              <a:buNone/>
+            </a:pPr>
+            <a:r>
+              <a:rPr lang="en-US" sz="1300" dirty="0">
                 <a:solidFill>
                   <a:srgbClr val="5A5F73"/>
                 </a:solidFill>
@@ -14052,93 +14374,15 @@
                 <a:ea typeface="Calibri" pitchFamily="34" charset="-122"/>
                 <a:cs typeface="Calibri" pitchFamily="34" charset="-120"/>
               </a:rPr>
-              <a:t>IdentifyVehicle, ExecuteCognitiveDiagnosis, ObdRepository, LlmClientPort</a:t>
-            </a:r>
-            <a:endParaRPr lang="en-US" sz="1400" dirty="0"/>
-          </a:p>
-        </p:txBody>
-      </p:sp>
-      <p:sp>
-        <p:nvSpPr>
-          <p:cNvPr id="13" name="Text 11"/>
-          <p:cNvSpPr/>
-          <p:nvPr/>
-        </p:nvSpPr>
-        <p:spPr>
-          <a:xfrm>
-            <a:off x="777240" y="5852160"/>
-            <a:ext cx="1737360" cy="310896"/>
-          </a:xfrm>
-          <a:prstGeom prst="rect">
-            <a:avLst/>
-          </a:prstGeom>
-          <a:noFill/>
-          <a:ln/>
-        </p:spPr>
-        <p:txBody>
-          <a:bodyPr wrap="square" lIns="0" tIns="0" rIns="0" bIns="0" rtlCol="0" anchor="ctr"/>
-          <a:lstStyle/>
-          <a:p>
-            <a:pPr indent="0" marL="0">
-              <a:buNone/>
-            </a:pPr>
-            <a:r>
-              <a:rPr lang="en-US" sz="1400" b="1" dirty="0">
-                <a:solidFill>
-                  <a:srgbClr val="202CFC"/>
-                </a:solidFill>
-                <a:latin typeface="Calibri" pitchFamily="34" charset="0"/>
-                <a:ea typeface="Calibri" pitchFamily="34" charset="-122"/>
-                <a:cs typeface="Calibri" pitchFamily="34" charset="-120"/>
-              </a:rPr>
-              <a:t>Infraestructura</a:t>
-            </a:r>
-            <a:endParaRPr lang="en-US" sz="1400" dirty="0"/>
-          </a:p>
-        </p:txBody>
-      </p:sp>
-      <p:sp>
-        <p:nvSpPr>
-          <p:cNvPr id="14" name="Text 12"/>
-          <p:cNvSpPr/>
-          <p:nvPr/>
-        </p:nvSpPr>
-        <p:spPr>
-          <a:xfrm>
-            <a:off x="2560320" y="5852160"/>
-            <a:ext cx="8778240" cy="310896"/>
-          </a:xfrm>
-          <a:prstGeom prst="rect">
-            <a:avLst/>
-          </a:prstGeom>
-          <a:noFill/>
-          <a:ln/>
-        </p:spPr>
-        <p:txBody>
-          <a:bodyPr wrap="square" lIns="0" tIns="0" rIns="0" bIns="0" rtlCol="0" anchor="ctr"/>
-          <a:lstStyle/>
-          <a:p>
-            <a:pPr indent="0" marL="0">
-              <a:buNone/>
-            </a:pPr>
-            <a:r>
-              <a:rPr lang="en-US" sz="1400" dirty="0">
-                <a:solidFill>
-                  <a:srgbClr val="5A5F73"/>
-                </a:solidFill>
-                <a:latin typeface="Calibri" pitchFamily="34" charset="0"/>
-                <a:ea typeface="Calibri" pitchFamily="34" charset="-122"/>
-                <a:cs typeface="Calibri" pitchFamily="34" charset="-120"/>
-              </a:rPr>
-              <a:t>Express, Drizzle + SQLite, LanceDB, servidor MCP, transporte ELM327</a:t>
-            </a:r>
-            <a:endParaRPr lang="en-US" sz="1400" dirty="0"/>
-          </a:p>
-        </p:txBody>
-      </p:sp>
-      <p:sp>
-        <p:nvSpPr>
-          <p:cNvPr id="15" name="Shape 13"/>
+              <a:t>Emulador en el portátil</a:t>
+            </a:r>
+            <a:endParaRPr lang="en-US" sz="1300" dirty="0"/>
+          </a:p>
+        </p:txBody>
+      </p:sp>
+      <p:sp>
+        <p:nvSpPr>
+          <p:cNvPr id="24" name="Shape 22"/>
           <p:cNvSpPr/>
           <p:nvPr/>
         </p:nvSpPr>
@@ -14158,7 +14402,7 @@
       </p:sp>
       <p:sp>
         <p:nvSpPr>
-          <p:cNvPr id="16" name="Text 14"/>
+          <p:cNvPr id="25" name="Text 23"/>
           <p:cNvSpPr/>
           <p:nvPr/>
         </p:nvSpPr>
@@ -14197,7 +14441,7 @@
       </p:sp>
       <p:sp>
         <p:nvSpPr>
-          <p:cNvPr id="17" name="Text 15"/>
+          <p:cNvPr id="26" name="Text 24"/>
           <p:cNvSpPr/>
           <p:nvPr/>
         </p:nvSpPr>
@@ -14236,7 +14480,7 @@
       </p:sp>
       <p:sp>
         <p:nvSpPr>
-          <p:cNvPr id="18" name="Text 16"/>
+          <p:cNvPr id="27" name="Text 25"/>
           <p:cNvSpPr/>
           <p:nvPr/>
         </p:nvSpPr>

</xml_diff>

<commit_message>
docs(tfm): nombrar la arquitectura en el titulo del slide 6
</commit_message>
<xml_diff>
--- a/docs/presentacion/tfm-intelligent-automotive-diagnostics.pptx
+++ b/docs/presentacion/tfm-intelligent-automotive-diagnostics.pptx
@@ -1817,7 +1817,7 @@
           <a:p>
             <a:r>
               <a:rPr lang="en-US" dirty="0"/>
-              <a:t>Sobre la arquitectura no os voy a contar la teoría, que ya la conocéis. Os cuento qué me ha dado a mí, en este proyecto concreto.
+              <a:t>La arquitectura es Clean Architecture con puertos y adaptadores. Tres capas: dominio, aplicación e infraestructura, y las dependencias siempre apuntando hacia dentro. La teoría ya la conocéis, así que os cuento qué me ha dado a mí, en este proyecto concreto.
 Lo primero, y es lo más importante: he construido y probado una aplicación de diagnóstico de vehículos sin tener el vehículo delante. Leer del coche es un puerto, y detrás hay dos adaptadores intercambiables: el lector ELM327 y un emulador. Tres vehículos emulados, un Audi, una Kawasaki y un Toyota. La aplicación no distingue cuál tiene delante.
 Lo segundo, la conexión física la pude decidir al final. El transporte del lector es otro puerto: hay una implementación por red y otra por puerto serie, con una capa de reintentos por encima. Pasar de una a otra no toca el resto de la aplicación.
 Lo tercero. Cuando ya tenía funcionando el diagnóstico determinista, el que aplica las normas, añadí el cognitivo. El servidor MCP entró como un adaptador de infraestructura más, y los casos de uso que ya funcionaban se quedaron exactamente igual.
@@ -13555,7 +13555,7 @@
                 <a:ea typeface="Arial" pitchFamily="34" charset="-122"/>
                 <a:cs typeface="Arial" pitchFamily="34" charset="-120"/>
               </a:rPr>
-              <a:t>Arquitectura: impacto en el desarrollo del proyecto</a:t>
+              <a:t>Clean Architecture con puertos y adaptadores</a:t>
             </a:r>
             <a:endParaRPr lang="en-US" sz="3400" dirty="0"/>
           </a:p>
@@ -13569,7 +13569,7 @@
         </p:nvSpPr>
         <p:spPr>
           <a:xfrm>
-            <a:off x="777240" y="1508760"/>
+            <a:off x="777240" y="1481328"/>
             <a:ext cx="10607040" cy="365760"/>
           </a:xfrm>
           <a:prstGeom prst="rect">
@@ -13594,7 +13594,7 @@
                 <a:ea typeface="Calibri" pitchFamily="34" charset="-122"/>
                 <a:cs typeface="Calibri" pitchFamily="34" charset="-120"/>
               </a:rPr>
-              <a:t>Qué ha permitido hacer, en concreto, mientras se construía.</a:t>
+              <a:t>Tres capas —dominio, aplicación e infraestructura— con las dependencias siempre hacia dentro.</a:t>
             </a:r>
             <a:endParaRPr lang="en-US" sz="1700" dirty="0"/>
           </a:p>
@@ -13608,8 +13608,8 @@
         </p:nvSpPr>
         <p:spPr>
           <a:xfrm>
-            <a:off x="777240" y="2103120"/>
-            <a:ext cx="457200" cy="292608"/>
+            <a:off x="777240" y="2011680"/>
+            <a:ext cx="10607040" cy="274320"/>
           </a:xfrm>
           <a:prstGeom prst="rect">
             <a:avLst/>
@@ -13625,7 +13625,7 @@
               <a:buNone/>
             </a:pPr>
             <a:r>
-              <a:rPr lang="en-US" sz="1600" b="1" dirty="0">
+              <a:rPr lang="en-US" sz="1500" b="1" dirty="0">
                 <a:solidFill>
                   <a:srgbClr val="202CFC"/>
                 </a:solidFill>
@@ -13633,9 +13633,9 @@
                 <a:ea typeface="Arial" pitchFamily="34" charset="-122"/>
                 <a:cs typeface="Arial" pitchFamily="34" charset="-120"/>
               </a:rPr>
-              <a:t>01</a:t>
-            </a:r>
-            <a:endParaRPr lang="en-US" sz="1600" dirty="0"/>
+              <a:t>Qué ha aportado en este proyecto</a:t>
+            </a:r>
+            <a:endParaRPr lang="en-US" sz="1500" dirty="0"/>
           </a:p>
         </p:txBody>
       </p:sp>
@@ -13647,8 +13647,8 @@
         </p:nvSpPr>
         <p:spPr>
           <a:xfrm>
-            <a:off x="1325880" y="2103120"/>
-            <a:ext cx="10058400" cy="292608"/>
+            <a:off x="777240" y="2450592"/>
+            <a:ext cx="457200" cy="292608"/>
           </a:xfrm>
           <a:prstGeom prst="rect">
             <a:avLst/>
@@ -13664,17 +13664,17 @@
               <a:buNone/>
             </a:pPr>
             <a:r>
-              <a:rPr lang="en-US" sz="1700" b="1" dirty="0">
-                <a:solidFill>
-                  <a:srgbClr val="1A1C2E"/>
+              <a:rPr lang="en-US" sz="1600" b="1" dirty="0">
+                <a:solidFill>
+                  <a:srgbClr val="202CFC"/>
                 </a:solidFill>
                 <a:latin typeface="Arial" pitchFamily="34" charset="0"/>
                 <a:ea typeface="Arial" pitchFamily="34" charset="-122"/>
                 <a:cs typeface="Arial" pitchFamily="34" charset="-120"/>
               </a:rPr>
-              <a:t>El proyecto se ha desarrollado sin el vehículo</a:t>
-            </a:r>
-            <a:endParaRPr lang="en-US" sz="1700" dirty="0"/>
+              <a:t>01</a:t>
+            </a:r>
+            <a:endParaRPr lang="en-US" sz="1600" dirty="0"/>
           </a:p>
         </p:txBody>
       </p:sp>
@@ -13686,7 +13686,7 @@
         </p:nvSpPr>
         <p:spPr>
           <a:xfrm>
-            <a:off x="1325880" y="2404872"/>
+            <a:off x="1325880" y="2450592"/>
             <a:ext cx="10058400" cy="292608"/>
           </a:xfrm>
           <a:prstGeom prst="rect">
@@ -13703,56 +13703,56 @@
               <a:buNone/>
             </a:pPr>
             <a:r>
-              <a:rPr lang="en-US" sz="1400" dirty="0">
-                <a:solidFill>
-                  <a:srgbClr val="5A5F73"/>
-                </a:solidFill>
-                <a:latin typeface="Calibri" pitchFamily="34" charset="0"/>
-                <a:ea typeface="Calibri" pitchFamily="34" charset="-122"/>
-                <a:cs typeface="Calibri" pitchFamily="34" charset="-120"/>
-              </a:rPr>
-              <a:t>Todo el desarrollo y las pruebas se han hecho contra emuladores: Audi, Kawasaki y Toyota.</a:t>
-            </a:r>
-            <a:endParaRPr lang="en-US" sz="1400" dirty="0"/>
-          </a:p>
-        </p:txBody>
-      </p:sp>
-      <p:sp>
-        <p:nvSpPr>
-          <p:cNvPr id="7" name="Text 5"/>
-          <p:cNvSpPr/>
-          <p:nvPr/>
-        </p:nvSpPr>
-        <p:spPr>
-          <a:xfrm>
-            <a:off x="777240" y="2825496"/>
-            <a:ext cx="457200" cy="292608"/>
-          </a:xfrm>
-          <a:prstGeom prst="rect">
-            <a:avLst/>
-          </a:prstGeom>
-          <a:noFill/>
-          <a:ln/>
-        </p:spPr>
-        <p:txBody>
-          <a:bodyPr wrap="square" lIns="0" tIns="0" rIns="0" bIns="0" rtlCol="0" anchor="t"/>
-          <a:lstStyle/>
-          <a:p>
-            <a:pPr indent="0" marL="0">
-              <a:buNone/>
-            </a:pPr>
-            <a:r>
-              <a:rPr lang="en-US" sz="1600" b="1" dirty="0">
-                <a:solidFill>
-                  <a:srgbClr val="202CFC"/>
+              <a:rPr lang="en-US" sz="1700" b="1" dirty="0">
+                <a:solidFill>
+                  <a:srgbClr val="1A1C2E"/>
                 </a:solidFill>
                 <a:latin typeface="Arial" pitchFamily="34" charset="0"/>
                 <a:ea typeface="Arial" pitchFamily="34" charset="-122"/>
                 <a:cs typeface="Arial" pitchFamily="34" charset="-120"/>
               </a:rPr>
-              <a:t>02</a:t>
-            </a:r>
-            <a:endParaRPr lang="en-US" sz="1600" dirty="0"/>
+              <a:t>El proyecto se ha desarrollado sin el vehículo</a:t>
+            </a:r>
+            <a:endParaRPr lang="en-US" sz="1700" dirty="0"/>
+          </a:p>
+        </p:txBody>
+      </p:sp>
+      <p:sp>
+        <p:nvSpPr>
+          <p:cNvPr id="7" name="Text 5"/>
+          <p:cNvSpPr/>
+          <p:nvPr/>
+        </p:nvSpPr>
+        <p:spPr>
+          <a:xfrm>
+            <a:off x="1325880" y="2752344"/>
+            <a:ext cx="10058400" cy="292608"/>
+          </a:xfrm>
+          <a:prstGeom prst="rect">
+            <a:avLst/>
+          </a:prstGeom>
+          <a:noFill/>
+          <a:ln/>
+        </p:spPr>
+        <p:txBody>
+          <a:bodyPr wrap="square" lIns="0" tIns="0" rIns="0" bIns="0" rtlCol="0" anchor="t"/>
+          <a:lstStyle/>
+          <a:p>
+            <a:pPr indent="0" marL="0">
+              <a:buNone/>
+            </a:pPr>
+            <a:r>
+              <a:rPr lang="en-US" sz="1400" dirty="0">
+                <a:solidFill>
+                  <a:srgbClr val="5A5F73"/>
+                </a:solidFill>
+                <a:latin typeface="Calibri" pitchFamily="34" charset="0"/>
+                <a:ea typeface="Calibri" pitchFamily="34" charset="-122"/>
+                <a:cs typeface="Calibri" pitchFamily="34" charset="-120"/>
+              </a:rPr>
+              <a:t>Todo el desarrollo y las pruebas se han hecho contra emuladores: Audi, Kawasaki y Toyota.</a:t>
+            </a:r>
+            <a:endParaRPr lang="en-US" sz="1400" dirty="0"/>
           </a:p>
         </p:txBody>
       </p:sp>
@@ -13764,8 +13764,8 @@
         </p:nvSpPr>
         <p:spPr>
           <a:xfrm>
-            <a:off x="1325880" y="2825496"/>
-            <a:ext cx="10058400" cy="292608"/>
+            <a:off x="777240" y="3118104"/>
+            <a:ext cx="457200" cy="292608"/>
           </a:xfrm>
           <a:prstGeom prst="rect">
             <a:avLst/>
@@ -13781,17 +13781,17 @@
               <a:buNone/>
             </a:pPr>
             <a:r>
-              <a:rPr lang="en-US" sz="1700" b="1" dirty="0">
-                <a:solidFill>
-                  <a:srgbClr val="1A1C2E"/>
+              <a:rPr lang="en-US" sz="1600" b="1" dirty="0">
+                <a:solidFill>
+                  <a:srgbClr val="202CFC"/>
                 </a:solidFill>
                 <a:latin typeface="Arial" pitchFamily="34" charset="0"/>
                 <a:ea typeface="Arial" pitchFamily="34" charset="-122"/>
                 <a:cs typeface="Arial" pitchFamily="34" charset="-120"/>
               </a:rPr>
-              <a:t>La forma de conectarse al coche se decidió al final</a:t>
-            </a:r>
-            <a:endParaRPr lang="en-US" sz="1700" dirty="0"/>
+              <a:t>02</a:t>
+            </a:r>
+            <a:endParaRPr lang="en-US" sz="1600" dirty="0"/>
           </a:p>
         </p:txBody>
       </p:sp>
@@ -13803,7 +13803,7 @@
         </p:nvSpPr>
         <p:spPr>
           <a:xfrm>
-            <a:off x="1325880" y="3127248"/>
+            <a:off x="1325880" y="3118104"/>
             <a:ext cx="10058400" cy="292608"/>
           </a:xfrm>
           <a:prstGeom prst="rect">
@@ -13820,56 +13820,56 @@
               <a:buNone/>
             </a:pPr>
             <a:r>
-              <a:rPr lang="en-US" sz="1400" dirty="0">
-                <a:solidFill>
-                  <a:srgbClr val="5A5F73"/>
-                </a:solidFill>
-                <a:latin typeface="Calibri" pitchFamily="34" charset="0"/>
-                <a:ea typeface="Calibri" pitchFamily="34" charset="-122"/>
-                <a:cs typeface="Calibri" pitchFamily="34" charset="-120"/>
-              </a:rPr>
-              <a:t>El transporte del lector es otro puerto: por red o por puerto serie, con reintentos por encima.</a:t>
-            </a:r>
-            <a:endParaRPr lang="en-US" sz="1400" dirty="0"/>
-          </a:p>
-        </p:txBody>
-      </p:sp>
-      <p:sp>
-        <p:nvSpPr>
-          <p:cNvPr id="10" name="Text 8"/>
-          <p:cNvSpPr/>
-          <p:nvPr/>
-        </p:nvSpPr>
-        <p:spPr>
-          <a:xfrm>
-            <a:off x="777240" y="3547872"/>
-            <a:ext cx="457200" cy="292608"/>
-          </a:xfrm>
-          <a:prstGeom prst="rect">
-            <a:avLst/>
-          </a:prstGeom>
-          <a:noFill/>
-          <a:ln/>
-        </p:spPr>
-        <p:txBody>
-          <a:bodyPr wrap="square" lIns="0" tIns="0" rIns="0" bIns="0" rtlCol="0" anchor="t"/>
-          <a:lstStyle/>
-          <a:p>
-            <a:pPr indent="0" marL="0">
-              <a:buNone/>
-            </a:pPr>
-            <a:r>
-              <a:rPr lang="en-US" sz="1600" b="1" dirty="0">
-                <a:solidFill>
-                  <a:srgbClr val="202CFC"/>
+              <a:rPr lang="en-US" sz="1700" b="1" dirty="0">
+                <a:solidFill>
+                  <a:srgbClr val="1A1C2E"/>
                 </a:solidFill>
                 <a:latin typeface="Arial" pitchFamily="34" charset="0"/>
                 <a:ea typeface="Arial" pitchFamily="34" charset="-122"/>
                 <a:cs typeface="Arial" pitchFamily="34" charset="-120"/>
               </a:rPr>
-              <a:t>03</a:t>
-            </a:r>
-            <a:endParaRPr lang="en-US" sz="1600" dirty="0"/>
+              <a:t>La forma de conectarse al coche se decidió al final</a:t>
+            </a:r>
+            <a:endParaRPr lang="en-US" sz="1700" dirty="0"/>
+          </a:p>
+        </p:txBody>
+      </p:sp>
+      <p:sp>
+        <p:nvSpPr>
+          <p:cNvPr id="10" name="Text 8"/>
+          <p:cNvSpPr/>
+          <p:nvPr/>
+        </p:nvSpPr>
+        <p:spPr>
+          <a:xfrm>
+            <a:off x="1325880" y="3419856"/>
+            <a:ext cx="10058400" cy="292608"/>
+          </a:xfrm>
+          <a:prstGeom prst="rect">
+            <a:avLst/>
+          </a:prstGeom>
+          <a:noFill/>
+          <a:ln/>
+        </p:spPr>
+        <p:txBody>
+          <a:bodyPr wrap="square" lIns="0" tIns="0" rIns="0" bIns="0" rtlCol="0" anchor="t"/>
+          <a:lstStyle/>
+          <a:p>
+            <a:pPr indent="0" marL="0">
+              <a:buNone/>
+            </a:pPr>
+            <a:r>
+              <a:rPr lang="en-US" sz="1400" dirty="0">
+                <a:solidFill>
+                  <a:srgbClr val="5A5F73"/>
+                </a:solidFill>
+                <a:latin typeface="Calibri" pitchFamily="34" charset="0"/>
+                <a:ea typeface="Calibri" pitchFamily="34" charset="-122"/>
+                <a:cs typeface="Calibri" pitchFamily="34" charset="-120"/>
+              </a:rPr>
+              <a:t>El transporte del lector es otro puerto: por red o por puerto serie, con reintentos por encima.</a:t>
+            </a:r>
+            <a:endParaRPr lang="en-US" sz="1400" dirty="0"/>
           </a:p>
         </p:txBody>
       </p:sp>
@@ -13881,8 +13881,8 @@
         </p:nvSpPr>
         <p:spPr>
           <a:xfrm>
-            <a:off x="1325880" y="3547872"/>
-            <a:ext cx="10058400" cy="292608"/>
+            <a:off x="777240" y="3785616"/>
+            <a:ext cx="457200" cy="292608"/>
           </a:xfrm>
           <a:prstGeom prst="rect">
             <a:avLst/>
@@ -13898,17 +13898,17 @@
               <a:buNone/>
             </a:pPr>
             <a:r>
-              <a:rPr lang="en-US" sz="1700" b="1" dirty="0">
-                <a:solidFill>
-                  <a:srgbClr val="1A1C2E"/>
+              <a:rPr lang="en-US" sz="1600" b="1" dirty="0">
+                <a:solidFill>
+                  <a:srgbClr val="202CFC"/>
                 </a:solidFill>
                 <a:latin typeface="Arial" pitchFamily="34" charset="0"/>
                 <a:ea typeface="Arial" pitchFamily="34" charset="-122"/>
                 <a:cs typeface="Arial" pitchFamily="34" charset="-120"/>
               </a:rPr>
-              <a:t>El diagnóstico cognitivo se añadió sin tocar el determinista</a:t>
-            </a:r>
-            <a:endParaRPr lang="en-US" sz="1700" dirty="0"/>
+              <a:t>03</a:t>
+            </a:r>
+            <a:endParaRPr lang="en-US" sz="1600" dirty="0"/>
           </a:p>
         </p:txBody>
       </p:sp>
@@ -13920,7 +13920,7 @@
         </p:nvSpPr>
         <p:spPr>
           <a:xfrm>
-            <a:off x="1325880" y="3849624"/>
+            <a:off x="1325880" y="3785616"/>
             <a:ext cx="10058400" cy="292608"/>
           </a:xfrm>
           <a:prstGeom prst="rect">
@@ -13937,56 +13937,56 @@
               <a:buNone/>
             </a:pPr>
             <a:r>
-              <a:rPr lang="en-US" sz="1400" dirty="0">
-                <a:solidFill>
-                  <a:srgbClr val="5A5F73"/>
-                </a:solidFill>
-                <a:latin typeface="Calibri" pitchFamily="34" charset="0"/>
-                <a:ea typeface="Calibri" pitchFamily="34" charset="-122"/>
-                <a:cs typeface="Calibri" pitchFamily="34" charset="-120"/>
-              </a:rPr>
-              <a:t>El servidor MCP entró como un adaptador más. Los casos de uso que ya funcionaban no se modificaron.</a:t>
-            </a:r>
-            <a:endParaRPr lang="en-US" sz="1400" dirty="0"/>
-          </a:p>
-        </p:txBody>
-      </p:sp>
-      <p:sp>
-        <p:nvSpPr>
-          <p:cNvPr id="13" name="Text 11"/>
-          <p:cNvSpPr/>
-          <p:nvPr/>
-        </p:nvSpPr>
-        <p:spPr>
-          <a:xfrm>
-            <a:off x="777240" y="4270248"/>
-            <a:ext cx="457200" cy="292608"/>
-          </a:xfrm>
-          <a:prstGeom prst="rect">
-            <a:avLst/>
-          </a:prstGeom>
-          <a:noFill/>
-          <a:ln/>
-        </p:spPr>
-        <p:txBody>
-          <a:bodyPr wrap="square" lIns="0" tIns="0" rIns="0" bIns="0" rtlCol="0" anchor="t"/>
-          <a:lstStyle/>
-          <a:p>
-            <a:pPr indent="0" marL="0">
-              <a:buNone/>
-            </a:pPr>
-            <a:r>
-              <a:rPr lang="en-US" sz="1600" b="1" dirty="0">
-                <a:solidFill>
-                  <a:srgbClr val="202CFC"/>
+              <a:rPr lang="en-US" sz="1700" b="1" dirty="0">
+                <a:solidFill>
+                  <a:srgbClr val="1A1C2E"/>
                 </a:solidFill>
                 <a:latin typeface="Arial" pitchFamily="34" charset="0"/>
                 <a:ea typeface="Arial" pitchFamily="34" charset="-122"/>
                 <a:cs typeface="Arial" pitchFamily="34" charset="-120"/>
               </a:rPr>
-              <a:t>04</a:t>
-            </a:r>
-            <a:endParaRPr lang="en-US" sz="1600" dirty="0"/>
+              <a:t>El diagnóstico cognitivo se añadió sin tocar el determinista</a:t>
+            </a:r>
+            <a:endParaRPr lang="en-US" sz="1700" dirty="0"/>
+          </a:p>
+        </p:txBody>
+      </p:sp>
+      <p:sp>
+        <p:nvSpPr>
+          <p:cNvPr id="13" name="Text 11"/>
+          <p:cNvSpPr/>
+          <p:nvPr/>
+        </p:nvSpPr>
+        <p:spPr>
+          <a:xfrm>
+            <a:off x="1325880" y="4087368"/>
+            <a:ext cx="10058400" cy="292608"/>
+          </a:xfrm>
+          <a:prstGeom prst="rect">
+            <a:avLst/>
+          </a:prstGeom>
+          <a:noFill/>
+          <a:ln/>
+        </p:spPr>
+        <p:txBody>
+          <a:bodyPr wrap="square" lIns="0" tIns="0" rIns="0" bIns="0" rtlCol="0" anchor="t"/>
+          <a:lstStyle/>
+          <a:p>
+            <a:pPr indent="0" marL="0">
+              <a:buNone/>
+            </a:pPr>
+            <a:r>
+              <a:rPr lang="en-US" sz="1400" dirty="0">
+                <a:solidFill>
+                  <a:srgbClr val="5A5F73"/>
+                </a:solidFill>
+                <a:latin typeface="Calibri" pitchFamily="34" charset="0"/>
+                <a:ea typeface="Calibri" pitchFamily="34" charset="-122"/>
+                <a:cs typeface="Calibri" pitchFamily="34" charset="-120"/>
+              </a:rPr>
+              <a:t>El servidor MCP entró como un adaptador más. Los casos de uso que ya funcionaban no se modificaron.</a:t>
+            </a:r>
+            <a:endParaRPr lang="en-US" sz="1400" dirty="0"/>
           </a:p>
         </p:txBody>
       </p:sp>
@@ -13998,8 +13998,8 @@
         </p:nvSpPr>
         <p:spPr>
           <a:xfrm>
-            <a:off x="1325880" y="4270248"/>
-            <a:ext cx="10058400" cy="292608"/>
+            <a:off x="777240" y="4453128"/>
+            <a:ext cx="457200" cy="292608"/>
           </a:xfrm>
           <a:prstGeom prst="rect">
             <a:avLst/>
@@ -14015,17 +14015,17 @@
               <a:buNone/>
             </a:pPr>
             <a:r>
-              <a:rPr lang="en-US" sz="1700" b="1" dirty="0">
-                <a:solidFill>
-                  <a:srgbClr val="1A1C2E"/>
+              <a:rPr lang="en-US" sz="1600" b="1" dirty="0">
+                <a:solidFill>
+                  <a:srgbClr val="202CFC"/>
                 </a:solidFill>
                 <a:latin typeface="Arial" pitchFamily="34" charset="0"/>
                 <a:ea typeface="Arial" pitchFamily="34" charset="-122"/>
                 <a:cs typeface="Arial" pitchFamily="34" charset="-120"/>
               </a:rPr>
-              <a:t>Dos proveedores de modelo con el mismo código de diagnóstico</a:t>
-            </a:r>
-            <a:endParaRPr lang="en-US" sz="1700" dirty="0"/>
+              <a:t>04</a:t>
+            </a:r>
+            <a:endParaRPr lang="en-US" sz="1600" dirty="0"/>
           </a:p>
         </p:txBody>
       </p:sp>
@@ -14037,7 +14037,7 @@
         </p:nvSpPr>
         <p:spPr>
           <a:xfrm>
-            <a:off x="1325880" y="4572000"/>
+            <a:off x="1325880" y="4453128"/>
             <a:ext cx="10058400" cy="292608"/>
           </a:xfrm>
           <a:prstGeom prst="rect">
@@ -14054,46 +14054,7 @@
               <a:buNone/>
             </a:pPr>
             <a:r>
-              <a:rPr lang="en-US" sz="1400" dirty="0">
-                <a:solidFill>
-                  <a:srgbClr val="5A5F73"/>
-                </a:solidFill>
-                <a:latin typeface="Calibri" pitchFamily="34" charset="0"/>
-                <a:ea typeface="Calibri" pitchFamily="34" charset="-122"/>
-                <a:cs typeface="Calibri" pitchFamily="34" charset="-120"/>
-              </a:rPr>
-              <a:t>En las pruebas el modelo se sustituye por un doble: el flujo se verifica sin llamar a uno real.</a:t>
-            </a:r>
-            <a:endParaRPr lang="en-US" sz="1400" dirty="0"/>
-          </a:p>
-        </p:txBody>
-      </p:sp>
-      <p:sp>
-        <p:nvSpPr>
-          <p:cNvPr id="16" name="Text 14"/>
-          <p:cNvSpPr/>
-          <p:nvPr/>
-        </p:nvSpPr>
-        <p:spPr>
-          <a:xfrm>
-            <a:off x="777240" y="5029200"/>
-            <a:ext cx="10607040" cy="274320"/>
-          </a:xfrm>
-          <a:prstGeom prst="rect">
-            <a:avLst/>
-          </a:prstGeom>
-          <a:noFill/>
-          <a:ln/>
-        </p:spPr>
-        <p:txBody>
-          <a:bodyPr wrap="square" lIns="0" tIns="0" rIns="0" bIns="0" rtlCol="0" anchor="t"/>
-          <a:lstStyle/>
-          <a:p>
-            <a:pPr indent="0" marL="0">
-              <a:buNone/>
-            </a:pPr>
-            <a:r>
-              <a:rPr lang="en-US" sz="1500" b="1" dirty="0">
+              <a:rPr lang="en-US" sz="1700" b="1" dirty="0">
                 <a:solidFill>
                   <a:srgbClr val="1A1C2E"/>
                 </a:solidFill>
@@ -14101,6 +14062,84 @@
                 <a:ea typeface="Arial" pitchFamily="34" charset="-122"/>
                 <a:cs typeface="Arial" pitchFamily="34" charset="-120"/>
               </a:rPr>
+              <a:t>Dos proveedores de modelo con el mismo código de diagnóstico</a:t>
+            </a:r>
+            <a:endParaRPr lang="en-US" sz="1700" dirty="0"/>
+          </a:p>
+        </p:txBody>
+      </p:sp>
+      <p:sp>
+        <p:nvSpPr>
+          <p:cNvPr id="16" name="Text 14"/>
+          <p:cNvSpPr/>
+          <p:nvPr/>
+        </p:nvSpPr>
+        <p:spPr>
+          <a:xfrm>
+            <a:off x="1325880" y="4754880"/>
+            <a:ext cx="10058400" cy="292608"/>
+          </a:xfrm>
+          <a:prstGeom prst="rect">
+            <a:avLst/>
+          </a:prstGeom>
+          <a:noFill/>
+          <a:ln/>
+        </p:spPr>
+        <p:txBody>
+          <a:bodyPr wrap="square" lIns="0" tIns="0" rIns="0" bIns="0" rtlCol="0" anchor="t"/>
+          <a:lstStyle/>
+          <a:p>
+            <a:pPr indent="0" marL="0">
+              <a:buNone/>
+            </a:pPr>
+            <a:r>
+              <a:rPr lang="en-US" sz="1400" dirty="0">
+                <a:solidFill>
+                  <a:srgbClr val="5A5F73"/>
+                </a:solidFill>
+                <a:latin typeface="Calibri" pitchFamily="34" charset="0"/>
+                <a:ea typeface="Calibri" pitchFamily="34" charset="-122"/>
+                <a:cs typeface="Calibri" pitchFamily="34" charset="-120"/>
+              </a:rPr>
+              <a:t>En las pruebas el modelo se sustituye por un doble: el flujo se verifica sin llamar a uno real.</a:t>
+            </a:r>
+            <a:endParaRPr lang="en-US" sz="1400" dirty="0"/>
+          </a:p>
+        </p:txBody>
+      </p:sp>
+      <p:sp>
+        <p:nvSpPr>
+          <p:cNvPr id="17" name="Text 15"/>
+          <p:cNvSpPr/>
+          <p:nvPr/>
+        </p:nvSpPr>
+        <p:spPr>
+          <a:xfrm>
+            <a:off x="777240" y="5175504"/>
+            <a:ext cx="10607040" cy="274320"/>
+          </a:xfrm>
+          <a:prstGeom prst="rect">
+            <a:avLst/>
+          </a:prstGeom>
+          <a:noFill/>
+          <a:ln/>
+        </p:spPr>
+        <p:txBody>
+          <a:bodyPr wrap="square" lIns="0" tIns="0" rIns="0" bIns="0" rtlCol="0" anchor="t"/>
+          <a:lstStyle/>
+          <a:p>
+            <a:pPr indent="0" marL="0">
+              <a:buNone/>
+            </a:pPr>
+            <a:r>
+              <a:rPr lang="en-US" sz="1500" b="1" dirty="0">
+                <a:solidFill>
+                  <a:srgbClr val="1A1C2E"/>
+                </a:solidFill>
+                <a:latin typeface="Arial" pitchFamily="34" charset="0"/>
+                <a:ea typeface="Arial" pitchFamily="34" charset="-122"/>
+                <a:cs typeface="Arial" pitchFamily="34" charset="-120"/>
+              </a:rPr>
               <a:t>Un ejemplo</a:t>
             </a:r>
             <a:endParaRPr lang="en-US" sz="1500" dirty="0"/>
@@ -14109,13 +14148,13 @@
       </p:sp>
       <p:sp>
         <p:nvSpPr>
-          <p:cNvPr id="17" name="Text 15"/>
-          <p:cNvSpPr/>
-          <p:nvPr/>
-        </p:nvSpPr>
-        <p:spPr>
-          <a:xfrm>
-            <a:off x="777240" y="5413248"/>
+          <p:cNvPr id="18" name="Text 16"/>
+          <p:cNvSpPr/>
+          <p:nvPr/>
+        </p:nvSpPr>
+        <p:spPr>
+          <a:xfrm>
+            <a:off x="777240" y="5559552"/>
             <a:ext cx="2651760" cy="329184"/>
           </a:xfrm>
           <a:prstGeom prst="rect">
@@ -14148,13 +14187,13 @@
       </p:sp>
       <p:sp>
         <p:nvSpPr>
-          <p:cNvPr id="18" name="Text 16"/>
-          <p:cNvSpPr/>
-          <p:nvPr/>
-        </p:nvSpPr>
-        <p:spPr>
-          <a:xfrm>
-            <a:off x="3429000" y="5413248"/>
+          <p:cNvPr id="19" name="Text 17"/>
+          <p:cNvSpPr/>
+          <p:nvPr/>
+        </p:nvSpPr>
+        <p:spPr>
+          <a:xfrm>
+            <a:off x="3429000" y="5559552"/>
             <a:ext cx="457200" cy="329184"/>
           </a:xfrm>
           <a:prstGeom prst="rect">
@@ -14187,13 +14226,13 @@
       </p:sp>
       <p:sp>
         <p:nvSpPr>
-          <p:cNvPr id="19" name="Text 17"/>
-          <p:cNvSpPr/>
-          <p:nvPr/>
-        </p:nvSpPr>
-        <p:spPr>
-          <a:xfrm>
-            <a:off x="4023360" y="5413248"/>
+          <p:cNvPr id="20" name="Text 18"/>
+          <p:cNvSpPr/>
+          <p:nvPr/>
+        </p:nvSpPr>
+        <p:spPr>
+          <a:xfrm>
+            <a:off x="4023360" y="5559552"/>
             <a:ext cx="2834640" cy="329184"/>
           </a:xfrm>
           <a:prstGeom prst="rect">
@@ -14226,13 +14265,13 @@
       </p:sp>
       <p:sp>
         <p:nvSpPr>
-          <p:cNvPr id="20" name="Text 18"/>
-          <p:cNvSpPr/>
-          <p:nvPr/>
-        </p:nvSpPr>
-        <p:spPr>
-          <a:xfrm>
-            <a:off x="6858000" y="5193792"/>
+          <p:cNvPr id="21" name="Text 19"/>
+          <p:cNvSpPr/>
+          <p:nvPr/>
+        </p:nvSpPr>
+        <p:spPr>
+          <a:xfrm>
+            <a:off x="6858000" y="5358384"/>
             <a:ext cx="457200" cy="329184"/>
           </a:xfrm>
           <a:prstGeom prst="rect">
@@ -14265,13 +14304,13 @@
       </p:sp>
       <p:sp>
         <p:nvSpPr>
-          <p:cNvPr id="21" name="Text 19"/>
-          <p:cNvSpPr/>
-          <p:nvPr/>
-        </p:nvSpPr>
-        <p:spPr>
-          <a:xfrm>
-            <a:off x="6858000" y="5632704"/>
+          <p:cNvPr id="22" name="Text 20"/>
+          <p:cNvSpPr/>
+          <p:nvPr/>
+        </p:nvSpPr>
+        <p:spPr>
+          <a:xfrm>
+            <a:off x="6858000" y="5760720"/>
             <a:ext cx="457200" cy="329184"/>
           </a:xfrm>
           <a:prstGeom prst="rect">
@@ -14304,13 +14343,13 @@
       </p:sp>
       <p:sp>
         <p:nvSpPr>
-          <p:cNvPr id="22" name="Text 20"/>
-          <p:cNvSpPr/>
-          <p:nvPr/>
-        </p:nvSpPr>
-        <p:spPr>
-          <a:xfrm>
-            <a:off x="7452360" y="5193792"/>
+          <p:cNvPr id="23" name="Text 21"/>
+          <p:cNvSpPr/>
+          <p:nvPr/>
+        </p:nvSpPr>
+        <p:spPr>
+          <a:xfrm>
+            <a:off x="7452360" y="5358384"/>
             <a:ext cx="3840480" cy="329184"/>
           </a:xfrm>
           <a:prstGeom prst="rect">
@@ -14343,13 +14382,13 @@
       </p:sp>
       <p:sp>
         <p:nvSpPr>
-          <p:cNvPr id="23" name="Text 21"/>
-          <p:cNvSpPr/>
-          <p:nvPr/>
-        </p:nvSpPr>
-        <p:spPr>
-          <a:xfrm>
-            <a:off x="7452360" y="5632704"/>
+          <p:cNvPr id="24" name="Text 22"/>
+          <p:cNvSpPr/>
+          <p:nvPr/>
+        </p:nvSpPr>
+        <p:spPr>
+          <a:xfrm>
+            <a:off x="7452360" y="5760720"/>
             <a:ext cx="3840480" cy="329184"/>
           </a:xfrm>
           <a:prstGeom prst="rect">
@@ -14382,7 +14421,7 @@
       </p:sp>
       <p:sp>
         <p:nvSpPr>
-          <p:cNvPr id="24" name="Shape 22"/>
+          <p:cNvPr id="25" name="Shape 23"/>
           <p:cNvSpPr/>
           <p:nvPr/>
         </p:nvSpPr>
@@ -14402,7 +14441,7 @@
       </p:sp>
       <p:sp>
         <p:nvSpPr>
-          <p:cNvPr id="25" name="Text 23"/>
+          <p:cNvPr id="26" name="Text 24"/>
           <p:cNvSpPr/>
           <p:nvPr/>
         </p:nvSpPr>
@@ -14441,7 +14480,7 @@
       </p:sp>
       <p:sp>
         <p:nvSpPr>
-          <p:cNvPr id="26" name="Text 24"/>
+          <p:cNvPr id="27" name="Text 25"/>
           <p:cNvSpPr/>
           <p:nvPr/>
         </p:nvSpPr>
@@ -14480,7 +14519,7 @@
       </p:sp>
       <p:sp>
         <p:nvSpPr>
-          <p:cNvPr id="27" name="Text 25"/>
+          <p:cNvPr id="28" name="Text 26"/>
           <p:cNvSpPr/>
           <p:nvPr/>
         </p:nvSpPr>

</xml_diff>

<commit_message>
docs(tfm): acortar el titulo del slide 6 a Clean Architecture + Hexagonal
</commit_message>
<xml_diff>
--- a/docs/presentacion/tfm-intelligent-automotive-diagnostics.pptx
+++ b/docs/presentacion/tfm-intelligent-automotive-diagnostics.pptx
@@ -1817,7 +1817,7 @@
           <a:p>
             <a:r>
               <a:rPr lang="en-US" dirty="0"/>
-              <a:t>La arquitectura es Clean Architecture con puertos y adaptadores. Tres capas: dominio, aplicación e infraestructura, y las dependencias siempre apuntando hacia dentro. La teoría ya la conocéis, así que os cuento qué me ha dado a mí, en este proyecto concreto.
+              <a:t>La arquitectura es Clean Architecture combinada con el patrón hexagonal. Tres capas: dominio, aplicación e infraestructura, y las dependencias siempre apuntando hacia dentro. La teoría ya la conocéis, así que os cuento qué me ha dado a mí, en este proyecto concreto.
 Lo primero, y es lo más importante: he construido y probado una aplicación de diagnóstico de vehículos sin tener el vehículo delante. Leer del coche es un puerto, y detrás hay dos adaptadores intercambiables: el lector ELM327 y un emulador. Tres vehículos emulados, un Audi, una Kawasaki y un Toyota. La aplicación no distingue cuál tiene delante.
 Lo segundo, la conexión física la pude decidir al final. El transporte del lector es otro puerto: hay una implementación por red y otra por puerto serie, con una capa de reintentos por encima. Pasar de una a otra no toca el resto de la aplicación.
 Lo tercero. Cuando ya tenía funcionando el diagnóstico determinista, el que aplica las normas, añadí el cognitivo. El servidor MCP entró como un adaptador de infraestructura más, y los casos de uso que ya funcionaban se quedaron exactamente igual.
@@ -13555,7 +13555,7 @@
                 <a:ea typeface="Arial" pitchFamily="34" charset="-122"/>
                 <a:cs typeface="Arial" pitchFamily="34" charset="-120"/>
               </a:rPr>
-              <a:t>Clean Architecture con puertos y adaptadores</a:t>
+              <a:t>Clean Architecture + Hexagonal</a:t>
             </a:r>
             <a:endParaRPr lang="en-US" sz="3400" dirty="0"/>
           </a:p>

</xml_diff>

<commit_message>
docs(tfm): anadir la exigencia de testabilidad de las normas al slide 6
</commit_message>
<xml_diff>
--- a/docs/presentacion/tfm-intelligent-automotive-diagnostics.pptx
+++ b/docs/presentacion/tfm-intelligent-automotive-diagnostics.pptx
@@ -1817,7 +1817,9 @@
           <a:p>
             <a:r>
               <a:rPr lang="en-US" dirty="0"/>
-              <a:t>La arquitectura es Clean Architecture combinada con el patrón hexagonal. Tres capas: dominio, aplicación e infraestructura, y las dependencias siempre apuntando hacia dentro. La teoría ya la conocéis, así que os cuento qué me ha dado a mí, en este proyecto concreto.
+              <a:t>La arquitectura es Clean Architecture combinada con el patrón hexagonal. Tres capas: dominio, aplicación e infraestructura, y las dependencias siempre apuntando hacia dentro.
+La elegí por una razón concreta: aquí el dominio no es algo que me haya inventado yo, son normas. SAE J1979, ISO 15031 y la ISO 3779 del bastidor. Si el proyecto tiene que cumplir una norma, tengo que poder demostrar que la cumple, y eso significa poder verificar cada fórmula y cada decodificación por separado, sin base de datos, sin servidor y sin coche delante. Esa exigencia de testabilidad es la que manda que las normas vivan en el dominio y todo lo demás quede detrás de un puerto.
+La teoría ya la conocéis, así que os cuento qué me ha dado a mí, en este proyecto concreto.
 Lo primero, y es lo más importante: he construido y probado una aplicación de diagnóstico de vehículos sin tener el vehículo delante. Leer del coche es un puerto, y detrás hay dos adaptadores intercambiables: el lector ELM327 y un emulador. Tres vehículos emulados, un Audi, una Kawasaki y un Toyota. La aplicación no distingue cuál tiene delante.
 Lo segundo, la conexión física la pude decidir al final. El transporte del lector es otro puerto: hay una implementación por red y otra por puerto serie, con una capa de reintentos por encima. Pasar de una a otra no toca el resto de la aplicación.
 Lo tercero. Cuando ya tenía funcionando el diagnóstico determinista, el que aplica las normas, añadí el cognitivo. El servidor MCP entró como un adaptador de infraestructura más, y los casos de uso que ya funcionaban se quedaron exactamente igual.
@@ -13608,7 +13610,46 @@
         </p:nvSpPr>
         <p:spPr>
           <a:xfrm>
-            <a:off x="777240" y="2011680"/>
+            <a:off x="777240" y="1810512"/>
+            <a:ext cx="10607040" cy="329184"/>
+          </a:xfrm>
+          <a:prstGeom prst="rect">
+            <a:avLst/>
+          </a:prstGeom>
+          <a:noFill/>
+          <a:ln/>
+        </p:spPr>
+        <p:txBody>
+          <a:bodyPr wrap="square" lIns="0" tIns="0" rIns="0" bIns="0" rtlCol="0" anchor="t"/>
+          <a:lstStyle/>
+          <a:p>
+            <a:pPr indent="0" marL="0">
+              <a:buNone/>
+            </a:pPr>
+            <a:r>
+              <a:rPr lang="en-US" sz="1500" dirty="0">
+                <a:solidFill>
+                  <a:srgbClr val="5A5F73"/>
+                </a:solidFill>
+                <a:latin typeface="Calibri" pitchFamily="34" charset="0"/>
+                <a:ea typeface="Calibri" pitchFamily="34" charset="-122"/>
+                <a:cs typeface="Calibri" pitchFamily="34" charset="-120"/>
+              </a:rPr>
+              <a:t>El dominio son normas —SAE J1979, ISO 15031, ISO 3779—: había que poder verificarlas una a una, aisladas.</a:t>
+            </a:r>
+            <a:endParaRPr lang="en-US" sz="1500" dirty="0"/>
+          </a:p>
+        </p:txBody>
+      </p:sp>
+      <p:sp>
+        <p:nvSpPr>
+          <p:cNvPr id="5" name="Text 3"/>
+          <p:cNvSpPr/>
+          <p:nvPr/>
+        </p:nvSpPr>
+        <p:spPr>
+          <a:xfrm>
+            <a:off x="777240" y="2194560"/>
             <a:ext cx="10607040" cy="274320"/>
           </a:xfrm>
           <a:prstGeom prst="rect">
@@ -13641,13 +13682,13 @@
       </p:sp>
       <p:sp>
         <p:nvSpPr>
-          <p:cNvPr id="5" name="Text 3"/>
-          <p:cNvSpPr/>
-          <p:nvPr/>
-        </p:nvSpPr>
-        <p:spPr>
-          <a:xfrm>
-            <a:off x="777240" y="2450592"/>
+          <p:cNvPr id="6" name="Text 4"/>
+          <p:cNvSpPr/>
+          <p:nvPr/>
+        </p:nvSpPr>
+        <p:spPr>
+          <a:xfrm>
+            <a:off x="777240" y="2560320"/>
             <a:ext cx="457200" cy="292608"/>
           </a:xfrm>
           <a:prstGeom prst="rect">
@@ -13680,13 +13721,13 @@
       </p:sp>
       <p:sp>
         <p:nvSpPr>
-          <p:cNvPr id="6" name="Text 4"/>
-          <p:cNvSpPr/>
-          <p:nvPr/>
-        </p:nvSpPr>
-        <p:spPr>
-          <a:xfrm>
-            <a:off x="1325880" y="2450592"/>
+          <p:cNvPr id="7" name="Text 5"/>
+          <p:cNvSpPr/>
+          <p:nvPr/>
+        </p:nvSpPr>
+        <p:spPr>
+          <a:xfrm>
+            <a:off x="1325880" y="2560320"/>
             <a:ext cx="10058400" cy="292608"/>
           </a:xfrm>
           <a:prstGeom prst="rect">
@@ -13719,13 +13760,13 @@
       </p:sp>
       <p:sp>
         <p:nvSpPr>
-          <p:cNvPr id="7" name="Text 5"/>
-          <p:cNvSpPr/>
-          <p:nvPr/>
-        </p:nvSpPr>
-        <p:spPr>
-          <a:xfrm>
-            <a:off x="1325880" y="2752344"/>
+          <p:cNvPr id="8" name="Text 6"/>
+          <p:cNvSpPr/>
+          <p:nvPr/>
+        </p:nvSpPr>
+        <p:spPr>
+          <a:xfrm>
+            <a:off x="1325880" y="2862072"/>
             <a:ext cx="10058400" cy="292608"/>
           </a:xfrm>
           <a:prstGeom prst="rect">
@@ -13758,13 +13799,13 @@
       </p:sp>
       <p:sp>
         <p:nvSpPr>
-          <p:cNvPr id="8" name="Text 6"/>
-          <p:cNvSpPr/>
-          <p:nvPr/>
-        </p:nvSpPr>
-        <p:spPr>
-          <a:xfrm>
-            <a:off x="777240" y="3118104"/>
+          <p:cNvPr id="9" name="Text 7"/>
+          <p:cNvSpPr/>
+          <p:nvPr/>
+        </p:nvSpPr>
+        <p:spPr>
+          <a:xfrm>
+            <a:off x="777240" y="3200400"/>
             <a:ext cx="457200" cy="292608"/>
           </a:xfrm>
           <a:prstGeom prst="rect">
@@ -13797,13 +13838,13 @@
       </p:sp>
       <p:sp>
         <p:nvSpPr>
-          <p:cNvPr id="9" name="Text 7"/>
-          <p:cNvSpPr/>
-          <p:nvPr/>
-        </p:nvSpPr>
-        <p:spPr>
-          <a:xfrm>
-            <a:off x="1325880" y="3118104"/>
+          <p:cNvPr id="10" name="Text 8"/>
+          <p:cNvSpPr/>
+          <p:nvPr/>
+        </p:nvSpPr>
+        <p:spPr>
+          <a:xfrm>
+            <a:off x="1325880" y="3200400"/>
             <a:ext cx="10058400" cy="292608"/>
           </a:xfrm>
           <a:prstGeom prst="rect">
@@ -13836,13 +13877,13 @@
       </p:sp>
       <p:sp>
         <p:nvSpPr>
-          <p:cNvPr id="10" name="Text 8"/>
-          <p:cNvSpPr/>
-          <p:nvPr/>
-        </p:nvSpPr>
-        <p:spPr>
-          <a:xfrm>
-            <a:off x="1325880" y="3419856"/>
+          <p:cNvPr id="11" name="Text 9"/>
+          <p:cNvSpPr/>
+          <p:nvPr/>
+        </p:nvSpPr>
+        <p:spPr>
+          <a:xfrm>
+            <a:off x="1325880" y="3502152"/>
             <a:ext cx="10058400" cy="292608"/>
           </a:xfrm>
           <a:prstGeom prst="rect">
@@ -13875,13 +13916,13 @@
       </p:sp>
       <p:sp>
         <p:nvSpPr>
-          <p:cNvPr id="11" name="Text 9"/>
-          <p:cNvSpPr/>
-          <p:nvPr/>
-        </p:nvSpPr>
-        <p:spPr>
-          <a:xfrm>
-            <a:off x="777240" y="3785616"/>
+          <p:cNvPr id="12" name="Text 10"/>
+          <p:cNvSpPr/>
+          <p:nvPr/>
+        </p:nvSpPr>
+        <p:spPr>
+          <a:xfrm>
+            <a:off x="777240" y="3840480"/>
             <a:ext cx="457200" cy="292608"/>
           </a:xfrm>
           <a:prstGeom prst="rect">
@@ -13914,13 +13955,13 @@
       </p:sp>
       <p:sp>
         <p:nvSpPr>
-          <p:cNvPr id="12" name="Text 10"/>
-          <p:cNvSpPr/>
-          <p:nvPr/>
-        </p:nvSpPr>
-        <p:spPr>
-          <a:xfrm>
-            <a:off x="1325880" y="3785616"/>
+          <p:cNvPr id="13" name="Text 11"/>
+          <p:cNvSpPr/>
+          <p:nvPr/>
+        </p:nvSpPr>
+        <p:spPr>
+          <a:xfrm>
+            <a:off x="1325880" y="3840480"/>
             <a:ext cx="10058400" cy="292608"/>
           </a:xfrm>
           <a:prstGeom prst="rect">
@@ -13953,13 +13994,13 @@
       </p:sp>
       <p:sp>
         <p:nvSpPr>
-          <p:cNvPr id="13" name="Text 11"/>
-          <p:cNvSpPr/>
-          <p:nvPr/>
-        </p:nvSpPr>
-        <p:spPr>
-          <a:xfrm>
-            <a:off x="1325880" y="4087368"/>
+          <p:cNvPr id="14" name="Text 12"/>
+          <p:cNvSpPr/>
+          <p:nvPr/>
+        </p:nvSpPr>
+        <p:spPr>
+          <a:xfrm>
+            <a:off x="1325880" y="4142232"/>
             <a:ext cx="10058400" cy="292608"/>
           </a:xfrm>
           <a:prstGeom prst="rect">
@@ -13992,13 +14033,13 @@
       </p:sp>
       <p:sp>
         <p:nvSpPr>
-          <p:cNvPr id="14" name="Text 12"/>
-          <p:cNvSpPr/>
-          <p:nvPr/>
-        </p:nvSpPr>
-        <p:spPr>
-          <a:xfrm>
-            <a:off x="777240" y="4453128"/>
+          <p:cNvPr id="15" name="Text 13"/>
+          <p:cNvSpPr/>
+          <p:nvPr/>
+        </p:nvSpPr>
+        <p:spPr>
+          <a:xfrm>
+            <a:off x="777240" y="4480560"/>
             <a:ext cx="457200" cy="292608"/>
           </a:xfrm>
           <a:prstGeom prst="rect">
@@ -14031,13 +14072,13 @@
       </p:sp>
       <p:sp>
         <p:nvSpPr>
-          <p:cNvPr id="15" name="Text 13"/>
-          <p:cNvSpPr/>
-          <p:nvPr/>
-        </p:nvSpPr>
-        <p:spPr>
-          <a:xfrm>
-            <a:off x="1325880" y="4453128"/>
+          <p:cNvPr id="16" name="Text 14"/>
+          <p:cNvSpPr/>
+          <p:nvPr/>
+        </p:nvSpPr>
+        <p:spPr>
+          <a:xfrm>
+            <a:off x="1325880" y="4480560"/>
             <a:ext cx="10058400" cy="292608"/>
           </a:xfrm>
           <a:prstGeom prst="rect">
@@ -14070,13 +14111,13 @@
       </p:sp>
       <p:sp>
         <p:nvSpPr>
-          <p:cNvPr id="16" name="Text 14"/>
-          <p:cNvSpPr/>
-          <p:nvPr/>
-        </p:nvSpPr>
-        <p:spPr>
-          <a:xfrm>
-            <a:off x="1325880" y="4754880"/>
+          <p:cNvPr id="17" name="Text 15"/>
+          <p:cNvSpPr/>
+          <p:nvPr/>
+        </p:nvSpPr>
+        <p:spPr>
+          <a:xfrm>
+            <a:off x="1325880" y="4782312"/>
             <a:ext cx="10058400" cy="292608"/>
           </a:xfrm>
           <a:prstGeom prst="rect">
@@ -14109,7 +14150,7 @@
       </p:sp>
       <p:sp>
         <p:nvSpPr>
-          <p:cNvPr id="17" name="Text 15"/>
+          <p:cNvPr id="18" name="Text 16"/>
           <p:cNvSpPr/>
           <p:nvPr/>
         </p:nvSpPr>
@@ -14148,7 +14189,7 @@
       </p:sp>
       <p:sp>
         <p:nvSpPr>
-          <p:cNvPr id="18" name="Text 16"/>
+          <p:cNvPr id="19" name="Text 17"/>
           <p:cNvSpPr/>
           <p:nvPr/>
         </p:nvSpPr>
@@ -14187,7 +14228,7 @@
       </p:sp>
       <p:sp>
         <p:nvSpPr>
-          <p:cNvPr id="19" name="Text 17"/>
+          <p:cNvPr id="20" name="Text 18"/>
           <p:cNvSpPr/>
           <p:nvPr/>
         </p:nvSpPr>
@@ -14226,7 +14267,7 @@
       </p:sp>
       <p:sp>
         <p:nvSpPr>
-          <p:cNvPr id="20" name="Text 18"/>
+          <p:cNvPr id="21" name="Text 19"/>
           <p:cNvSpPr/>
           <p:nvPr/>
         </p:nvSpPr>
@@ -14265,7 +14306,7 @@
       </p:sp>
       <p:sp>
         <p:nvSpPr>
-          <p:cNvPr id="21" name="Text 19"/>
+          <p:cNvPr id="22" name="Text 20"/>
           <p:cNvSpPr/>
           <p:nvPr/>
         </p:nvSpPr>
@@ -14304,7 +14345,7 @@
       </p:sp>
       <p:sp>
         <p:nvSpPr>
-          <p:cNvPr id="22" name="Text 20"/>
+          <p:cNvPr id="23" name="Text 21"/>
           <p:cNvSpPr/>
           <p:nvPr/>
         </p:nvSpPr>
@@ -14343,7 +14384,7 @@
       </p:sp>
       <p:sp>
         <p:nvSpPr>
-          <p:cNvPr id="23" name="Text 21"/>
+          <p:cNvPr id="24" name="Text 22"/>
           <p:cNvSpPr/>
           <p:nvPr/>
         </p:nvSpPr>
@@ -14382,7 +14423,7 @@
       </p:sp>
       <p:sp>
         <p:nvSpPr>
-          <p:cNvPr id="24" name="Text 22"/>
+          <p:cNvPr id="25" name="Text 23"/>
           <p:cNvSpPr/>
           <p:nvPr/>
         </p:nvSpPr>
@@ -14421,7 +14462,7 @@
       </p:sp>
       <p:sp>
         <p:nvSpPr>
-          <p:cNvPr id="25" name="Shape 23"/>
+          <p:cNvPr id="26" name="Shape 24"/>
           <p:cNvSpPr/>
           <p:nvPr/>
         </p:nvSpPr>
@@ -14441,7 +14482,7 @@
       </p:sp>
       <p:sp>
         <p:nvSpPr>
-          <p:cNvPr id="26" name="Text 24"/>
+          <p:cNvPr id="27" name="Text 25"/>
           <p:cNvSpPr/>
           <p:nvPr/>
         </p:nvSpPr>
@@ -14480,7 +14521,7 @@
       </p:sp>
       <p:sp>
         <p:nvSpPr>
-          <p:cNvPr id="27" name="Text 25"/>
+          <p:cNvPr id="28" name="Text 26"/>
           <p:cNvSpPr/>
           <p:nvPr/>
         </p:nvSpPr>
@@ -14519,7 +14560,7 @@
       </p:sp>
       <p:sp>
         <p:nvSpPr>
-          <p:cNvPr id="28" name="Text 26"/>
+          <p:cNvPr id="29" name="Text 27"/>
           <p:cNvSpPr/>
           <p:nvPr/>
         </p:nvSpPr>

</xml_diff>

<commit_message>
docs(tfm): decir sin rodeos que las normas ISO exigian alta testabilidad
</commit_message>
<xml_diff>
--- a/docs/presentacion/tfm-intelligent-automotive-diagnostics.pptx
+++ b/docs/presentacion/tfm-intelligent-automotive-diagnostics.pptx
@@ -1818,7 +1818,7 @@
             <a:r>
               <a:rPr lang="en-US" dirty="0"/>
               <a:t>La arquitectura es Clean Architecture combinada con el patrón hexagonal. Tres capas: dominio, aplicación e infraestructura, y las dependencias siempre apuntando hacia dentro.
-La elegí por una razón concreta: aquí el dominio no es algo que me haya inventado yo, son normas. SAE J1979, ISO 15031 y la ISO 3779 del bastidor. Si el proyecto tiene que cumplir una norma, tengo que poder demostrar que la cumple, y eso significa poder verificar cada fórmula y cada decodificación por separado, sin base de datos, sin servidor y sin coche delante. Esa exigencia de testabilidad es la que manda que las normas vivan en el dominio y todo lo demás quede detrás de un puerto.
+La elegí por una razón concreta: aquí el dominio no es algo que me haya inventado yo, son normas. SAE J1979, ISO 15031 y la ISO 3779 del bastidor. Todo eso hay que probarlo con test, así que necesitaba una testabilidad alta. Por eso las normas van en el dominio, sin dependencias, y todo lo demás queda detrás de un puerto.
 La teoría ya la conocéis, así que os cuento qué me ha dado a mí, en este proyecto concreto.
 Lo primero, y es lo más importante: he construido y probado una aplicación de diagnóstico de vehículos sin tener el vehículo delante. Leer del coche es un puerto, y detrás hay dos adaptadores intercambiables: el lector ELM327 y un emulador. Tres vehículos emulados, un Audi, una Kawasaki y un Toyota. La aplicación no distingue cuál tiene delante.
 Lo segundo, la conexión física la pude decidir al final. El transporte del lector es otro puerto: hay una implementación por red y otra por puerto serie, con una capa de reintentos por encima. Pasar de una a otra no toca el resto de la aplicación.
@@ -13635,7 +13635,7 @@
                 <a:ea typeface="Calibri" pitchFamily="34" charset="-122"/>
                 <a:cs typeface="Calibri" pitchFamily="34" charset="-120"/>
               </a:rPr>
-              <a:t>El dominio son normas —SAE J1979, ISO 15031, ISO 3779—: había que poder verificarlas una a una, aisladas.</a:t>
+              <a:t>El dominio son normas —SAE J1979, ISO 15031, ISO 3779— y hay que probarlas: hacía falta alta testabilidad.</a:t>
             </a:r>
             <a:endParaRPr lang="en-US" sz="1500" dirty="0"/>
           </a:p>

</xml_diff>

<commit_message>
docs(tfm): la testabilidad pasa a ser el punto 5 del slide de arquitectura
</commit_message>
<xml_diff>
--- a/docs/presentacion/tfm-intelligent-automotive-diagnostics.pptx
+++ b/docs/presentacion/tfm-intelligent-automotive-diagnostics.pptx
@@ -1823,7 +1823,8 @@
 Lo primero, y es lo más importante: he construido y probado una aplicación de diagnóstico de vehículos sin tener el vehículo delante. Leer del coche es un puerto, y detrás hay dos adaptadores intercambiables: el lector ELM327 y un emulador. Tres vehículos emulados, un Audi, una Kawasaki y un Toyota. La aplicación no distingue cuál tiene delante.
 Lo segundo, la conexión física la pude decidir al final. El transporte del lector es otro puerto: hay una implementación por red y otra por puerto serie, con una capa de reintentos por encima. Pasar de una a otra no toca el resto de la aplicación.
 Lo tercero. Cuando ya tenía funcionando el diagnóstico determinista, el que aplica las normas, añadí el cognitivo. El servidor MCP entró como un adaptador de infraestructura más, y los casos de uso que ya funcionaban se quedaron exactamente igual.
-Y lo cuarto, hay dos clientes de modelo de lenguaje, y el código de diagnóstico es el mismo para los dos. En las pruebas el modelo se sustituye por un doble, así que el flujo cognitivo se verifica entero sin llamar a un modelo real.
+Lo cuarto, hay dos clientes de modelo de lenguaje, y el código de diagnóstico es el mismo para los dos. En las pruebas el modelo se sustituye por un doble, así que el flujo cognitivo se verifica entero sin llamar a un modelo real.
+Y lo quinto, que es lo que ata todo lo anterior: la testabilidad. Las normativas ISO hay que probarlas con test, y en el dominio no dependen de nada, así que se prueban solas. Dos mil ciento setenta y una pruebas que corren sin coche, sin servidor y sin modelo.
 Abajo está el ejemplo de arriba dibujado: un caso de uso, un puerto, y dos adaptadores detrás.
 La contrapartida está reconocida en el ADR: son más ficheros que un monolito, y el punto donde se cablea todo crece con cada adaptador nuevo. A cambio, dos mil ciento setenta y una pruebas corren sin coche, sin servidor y sin modelo.
 [~85 s · acumulado 5:50]</a:t>
@@ -13610,46 +13611,7 @@
         </p:nvSpPr>
         <p:spPr>
           <a:xfrm>
-            <a:off x="777240" y="1810512"/>
-            <a:ext cx="10607040" cy="329184"/>
-          </a:xfrm>
-          <a:prstGeom prst="rect">
-            <a:avLst/>
-          </a:prstGeom>
-          <a:noFill/>
-          <a:ln/>
-        </p:spPr>
-        <p:txBody>
-          <a:bodyPr wrap="square" lIns="0" tIns="0" rIns="0" bIns="0" rtlCol="0" anchor="t"/>
-          <a:lstStyle/>
-          <a:p>
-            <a:pPr indent="0" marL="0">
-              <a:buNone/>
-            </a:pPr>
-            <a:r>
-              <a:rPr lang="en-US" sz="1500" dirty="0">
-                <a:solidFill>
-                  <a:srgbClr val="5A5F73"/>
-                </a:solidFill>
-                <a:latin typeface="Calibri" pitchFamily="34" charset="0"/>
-                <a:ea typeface="Calibri" pitchFamily="34" charset="-122"/>
-                <a:cs typeface="Calibri" pitchFamily="34" charset="-120"/>
-              </a:rPr>
-              <a:t>El dominio son normas —SAE J1979, ISO 15031, ISO 3779— y hay que probarlas: hacía falta alta testabilidad.</a:t>
-            </a:r>
-            <a:endParaRPr lang="en-US" sz="1500" dirty="0"/>
-          </a:p>
-        </p:txBody>
-      </p:sp>
-      <p:sp>
-        <p:nvSpPr>
-          <p:cNvPr id="5" name="Text 3"/>
-          <p:cNvSpPr/>
-          <p:nvPr/>
-        </p:nvSpPr>
-        <p:spPr>
-          <a:xfrm>
-            <a:off x="777240" y="2194560"/>
+            <a:off x="777240" y="1965960"/>
             <a:ext cx="10607040" cy="274320"/>
           </a:xfrm>
           <a:prstGeom prst="rect">
@@ -13682,13 +13644,13 @@
       </p:sp>
       <p:sp>
         <p:nvSpPr>
-          <p:cNvPr id="6" name="Text 4"/>
-          <p:cNvSpPr/>
-          <p:nvPr/>
-        </p:nvSpPr>
-        <p:spPr>
-          <a:xfrm>
-            <a:off x="777240" y="2560320"/>
+          <p:cNvPr id="5" name="Text 3"/>
+          <p:cNvSpPr/>
+          <p:nvPr/>
+        </p:nvSpPr>
+        <p:spPr>
+          <a:xfrm>
+            <a:off x="777240" y="2331720"/>
             <a:ext cx="457200" cy="292608"/>
           </a:xfrm>
           <a:prstGeom prst="rect">
@@ -13721,13 +13683,13 @@
       </p:sp>
       <p:sp>
         <p:nvSpPr>
-          <p:cNvPr id="7" name="Text 5"/>
-          <p:cNvSpPr/>
-          <p:nvPr/>
-        </p:nvSpPr>
-        <p:spPr>
-          <a:xfrm>
-            <a:off x="1325880" y="2560320"/>
+          <p:cNvPr id="6" name="Text 4"/>
+          <p:cNvSpPr/>
+          <p:nvPr/>
+        </p:nvSpPr>
+        <p:spPr>
+          <a:xfrm>
+            <a:off x="1325880" y="2331720"/>
             <a:ext cx="10058400" cy="292608"/>
           </a:xfrm>
           <a:prstGeom prst="rect">
@@ -13760,52 +13722,52 @@
       </p:sp>
       <p:sp>
         <p:nvSpPr>
+          <p:cNvPr id="7" name="Text 5"/>
+          <p:cNvSpPr/>
+          <p:nvPr/>
+        </p:nvSpPr>
+        <p:spPr>
+          <a:xfrm>
+            <a:off x="1325880" y="2624328"/>
+            <a:ext cx="10058400" cy="292608"/>
+          </a:xfrm>
+          <a:prstGeom prst="rect">
+            <a:avLst/>
+          </a:prstGeom>
+          <a:noFill/>
+          <a:ln/>
+        </p:spPr>
+        <p:txBody>
+          <a:bodyPr wrap="square" lIns="0" tIns="0" rIns="0" bIns="0" rtlCol="0" anchor="t"/>
+          <a:lstStyle/>
+          <a:p>
+            <a:pPr indent="0" marL="0">
+              <a:buNone/>
+            </a:pPr>
+            <a:r>
+              <a:rPr lang="en-US" sz="1400" dirty="0">
+                <a:solidFill>
+                  <a:srgbClr val="5A5F73"/>
+                </a:solidFill>
+                <a:latin typeface="Calibri" pitchFamily="34" charset="0"/>
+                <a:ea typeface="Calibri" pitchFamily="34" charset="-122"/>
+                <a:cs typeface="Calibri" pitchFamily="34" charset="-120"/>
+              </a:rPr>
+              <a:t>Todo el desarrollo y las pruebas se han hecho contra emuladores: Audi, Kawasaki y Toyota.</a:t>
+            </a:r>
+            <a:endParaRPr lang="en-US" sz="1400" dirty="0"/>
+          </a:p>
+        </p:txBody>
+      </p:sp>
+      <p:sp>
+        <p:nvSpPr>
           <p:cNvPr id="8" name="Text 6"/>
           <p:cNvSpPr/>
           <p:nvPr/>
         </p:nvSpPr>
         <p:spPr>
           <a:xfrm>
-            <a:off x="1325880" y="2862072"/>
-            <a:ext cx="10058400" cy="292608"/>
-          </a:xfrm>
-          <a:prstGeom prst="rect">
-            <a:avLst/>
-          </a:prstGeom>
-          <a:noFill/>
-          <a:ln/>
-        </p:spPr>
-        <p:txBody>
-          <a:bodyPr wrap="square" lIns="0" tIns="0" rIns="0" bIns="0" rtlCol="0" anchor="t"/>
-          <a:lstStyle/>
-          <a:p>
-            <a:pPr indent="0" marL="0">
-              <a:buNone/>
-            </a:pPr>
-            <a:r>
-              <a:rPr lang="en-US" sz="1400" dirty="0">
-                <a:solidFill>
-                  <a:srgbClr val="5A5F73"/>
-                </a:solidFill>
-                <a:latin typeface="Calibri" pitchFamily="34" charset="0"/>
-                <a:ea typeface="Calibri" pitchFamily="34" charset="-122"/>
-                <a:cs typeface="Calibri" pitchFamily="34" charset="-120"/>
-              </a:rPr>
-              <a:t>Todo el desarrollo y las pruebas se han hecho contra emuladores: Audi, Kawasaki y Toyota.</a:t>
-            </a:r>
-            <a:endParaRPr lang="en-US" sz="1400" dirty="0"/>
-          </a:p>
-        </p:txBody>
-      </p:sp>
-      <p:sp>
-        <p:nvSpPr>
-          <p:cNvPr id="9" name="Text 7"/>
-          <p:cNvSpPr/>
-          <p:nvPr/>
-        </p:nvSpPr>
-        <p:spPr>
-          <a:xfrm>
-            <a:off x="777240" y="3200400"/>
+            <a:off x="777240" y="2953512"/>
             <a:ext cx="457200" cy="292608"/>
           </a:xfrm>
           <a:prstGeom prst="rect">
@@ -13838,13 +13800,13 @@
       </p:sp>
       <p:sp>
         <p:nvSpPr>
-          <p:cNvPr id="10" name="Text 8"/>
-          <p:cNvSpPr/>
-          <p:nvPr/>
-        </p:nvSpPr>
-        <p:spPr>
-          <a:xfrm>
-            <a:off x="1325880" y="3200400"/>
+          <p:cNvPr id="9" name="Text 7"/>
+          <p:cNvSpPr/>
+          <p:nvPr/>
+        </p:nvSpPr>
+        <p:spPr>
+          <a:xfrm>
+            <a:off x="1325880" y="2953512"/>
             <a:ext cx="10058400" cy="292608"/>
           </a:xfrm>
           <a:prstGeom prst="rect">
@@ -13877,52 +13839,52 @@
       </p:sp>
       <p:sp>
         <p:nvSpPr>
+          <p:cNvPr id="10" name="Text 8"/>
+          <p:cNvSpPr/>
+          <p:nvPr/>
+        </p:nvSpPr>
+        <p:spPr>
+          <a:xfrm>
+            <a:off x="1325880" y="3246120"/>
+            <a:ext cx="10058400" cy="292608"/>
+          </a:xfrm>
+          <a:prstGeom prst="rect">
+            <a:avLst/>
+          </a:prstGeom>
+          <a:noFill/>
+          <a:ln/>
+        </p:spPr>
+        <p:txBody>
+          <a:bodyPr wrap="square" lIns="0" tIns="0" rIns="0" bIns="0" rtlCol="0" anchor="t"/>
+          <a:lstStyle/>
+          <a:p>
+            <a:pPr indent="0" marL="0">
+              <a:buNone/>
+            </a:pPr>
+            <a:r>
+              <a:rPr lang="en-US" sz="1400" dirty="0">
+                <a:solidFill>
+                  <a:srgbClr val="5A5F73"/>
+                </a:solidFill>
+                <a:latin typeface="Calibri" pitchFamily="34" charset="0"/>
+                <a:ea typeface="Calibri" pitchFamily="34" charset="-122"/>
+                <a:cs typeface="Calibri" pitchFamily="34" charset="-120"/>
+              </a:rPr>
+              <a:t>El transporte del lector es otro puerto: por red o por puerto serie, con reintentos por encima.</a:t>
+            </a:r>
+            <a:endParaRPr lang="en-US" sz="1400" dirty="0"/>
+          </a:p>
+        </p:txBody>
+      </p:sp>
+      <p:sp>
+        <p:nvSpPr>
           <p:cNvPr id="11" name="Text 9"/>
           <p:cNvSpPr/>
           <p:nvPr/>
         </p:nvSpPr>
         <p:spPr>
           <a:xfrm>
-            <a:off x="1325880" y="3502152"/>
-            <a:ext cx="10058400" cy="292608"/>
-          </a:xfrm>
-          <a:prstGeom prst="rect">
-            <a:avLst/>
-          </a:prstGeom>
-          <a:noFill/>
-          <a:ln/>
-        </p:spPr>
-        <p:txBody>
-          <a:bodyPr wrap="square" lIns="0" tIns="0" rIns="0" bIns="0" rtlCol="0" anchor="t"/>
-          <a:lstStyle/>
-          <a:p>
-            <a:pPr indent="0" marL="0">
-              <a:buNone/>
-            </a:pPr>
-            <a:r>
-              <a:rPr lang="en-US" sz="1400" dirty="0">
-                <a:solidFill>
-                  <a:srgbClr val="5A5F73"/>
-                </a:solidFill>
-                <a:latin typeface="Calibri" pitchFamily="34" charset="0"/>
-                <a:ea typeface="Calibri" pitchFamily="34" charset="-122"/>
-                <a:cs typeface="Calibri" pitchFamily="34" charset="-120"/>
-              </a:rPr>
-              <a:t>El transporte del lector es otro puerto: por red o por puerto serie, con reintentos por encima.</a:t>
-            </a:r>
-            <a:endParaRPr lang="en-US" sz="1400" dirty="0"/>
-          </a:p>
-        </p:txBody>
-      </p:sp>
-      <p:sp>
-        <p:nvSpPr>
-          <p:cNvPr id="12" name="Text 10"/>
-          <p:cNvSpPr/>
-          <p:nvPr/>
-        </p:nvSpPr>
-        <p:spPr>
-          <a:xfrm>
-            <a:off x="777240" y="3840480"/>
+            <a:off x="777240" y="3575304"/>
             <a:ext cx="457200" cy="292608"/>
           </a:xfrm>
           <a:prstGeom prst="rect">
@@ -13955,13 +13917,13 @@
       </p:sp>
       <p:sp>
         <p:nvSpPr>
-          <p:cNvPr id="13" name="Text 11"/>
-          <p:cNvSpPr/>
-          <p:nvPr/>
-        </p:nvSpPr>
-        <p:spPr>
-          <a:xfrm>
-            <a:off x="1325880" y="3840480"/>
+          <p:cNvPr id="12" name="Text 10"/>
+          <p:cNvSpPr/>
+          <p:nvPr/>
+        </p:nvSpPr>
+        <p:spPr>
+          <a:xfrm>
+            <a:off x="1325880" y="3575304"/>
             <a:ext cx="10058400" cy="292608"/>
           </a:xfrm>
           <a:prstGeom prst="rect">
@@ -13994,52 +13956,52 @@
       </p:sp>
       <p:sp>
         <p:nvSpPr>
+          <p:cNvPr id="13" name="Text 11"/>
+          <p:cNvSpPr/>
+          <p:nvPr/>
+        </p:nvSpPr>
+        <p:spPr>
+          <a:xfrm>
+            <a:off x="1325880" y="3867912"/>
+            <a:ext cx="10058400" cy="292608"/>
+          </a:xfrm>
+          <a:prstGeom prst="rect">
+            <a:avLst/>
+          </a:prstGeom>
+          <a:noFill/>
+          <a:ln/>
+        </p:spPr>
+        <p:txBody>
+          <a:bodyPr wrap="square" lIns="0" tIns="0" rIns="0" bIns="0" rtlCol="0" anchor="t"/>
+          <a:lstStyle/>
+          <a:p>
+            <a:pPr indent="0" marL="0">
+              <a:buNone/>
+            </a:pPr>
+            <a:r>
+              <a:rPr lang="en-US" sz="1400" dirty="0">
+                <a:solidFill>
+                  <a:srgbClr val="5A5F73"/>
+                </a:solidFill>
+                <a:latin typeface="Calibri" pitchFamily="34" charset="0"/>
+                <a:ea typeface="Calibri" pitchFamily="34" charset="-122"/>
+                <a:cs typeface="Calibri" pitchFamily="34" charset="-120"/>
+              </a:rPr>
+              <a:t>El servidor MCP entró como un adaptador más. Los casos de uso que ya funcionaban no se modificaron.</a:t>
+            </a:r>
+            <a:endParaRPr lang="en-US" sz="1400" dirty="0"/>
+          </a:p>
+        </p:txBody>
+      </p:sp>
+      <p:sp>
+        <p:nvSpPr>
           <p:cNvPr id="14" name="Text 12"/>
           <p:cNvSpPr/>
           <p:nvPr/>
         </p:nvSpPr>
         <p:spPr>
           <a:xfrm>
-            <a:off x="1325880" y="4142232"/>
-            <a:ext cx="10058400" cy="292608"/>
-          </a:xfrm>
-          <a:prstGeom prst="rect">
-            <a:avLst/>
-          </a:prstGeom>
-          <a:noFill/>
-          <a:ln/>
-        </p:spPr>
-        <p:txBody>
-          <a:bodyPr wrap="square" lIns="0" tIns="0" rIns="0" bIns="0" rtlCol="0" anchor="t"/>
-          <a:lstStyle/>
-          <a:p>
-            <a:pPr indent="0" marL="0">
-              <a:buNone/>
-            </a:pPr>
-            <a:r>
-              <a:rPr lang="en-US" sz="1400" dirty="0">
-                <a:solidFill>
-                  <a:srgbClr val="5A5F73"/>
-                </a:solidFill>
-                <a:latin typeface="Calibri" pitchFamily="34" charset="0"/>
-                <a:ea typeface="Calibri" pitchFamily="34" charset="-122"/>
-                <a:cs typeface="Calibri" pitchFamily="34" charset="-120"/>
-              </a:rPr>
-              <a:t>El servidor MCP entró como un adaptador más. Los casos de uso que ya funcionaban no se modificaron.</a:t>
-            </a:r>
-            <a:endParaRPr lang="en-US" sz="1400" dirty="0"/>
-          </a:p>
-        </p:txBody>
-      </p:sp>
-      <p:sp>
-        <p:nvSpPr>
-          <p:cNvPr id="15" name="Text 13"/>
-          <p:cNvSpPr/>
-          <p:nvPr/>
-        </p:nvSpPr>
-        <p:spPr>
-          <a:xfrm>
-            <a:off x="777240" y="4480560"/>
+            <a:off x="777240" y="4197096"/>
             <a:ext cx="457200" cy="292608"/>
           </a:xfrm>
           <a:prstGeom prst="rect">
@@ -14072,13 +14034,13 @@
       </p:sp>
       <p:sp>
         <p:nvSpPr>
-          <p:cNvPr id="16" name="Text 14"/>
-          <p:cNvSpPr/>
-          <p:nvPr/>
-        </p:nvSpPr>
-        <p:spPr>
-          <a:xfrm>
-            <a:off x="1325880" y="4480560"/>
+          <p:cNvPr id="15" name="Text 13"/>
+          <p:cNvSpPr/>
+          <p:nvPr/>
+        </p:nvSpPr>
+        <p:spPr>
+          <a:xfrm>
+            <a:off x="1325880" y="4197096"/>
             <a:ext cx="10058400" cy="292608"/>
           </a:xfrm>
           <a:prstGeom prst="rect">
@@ -14111,14 +14073,53 @@
       </p:sp>
       <p:sp>
         <p:nvSpPr>
+          <p:cNvPr id="16" name="Text 14"/>
+          <p:cNvSpPr/>
+          <p:nvPr/>
+        </p:nvSpPr>
+        <p:spPr>
+          <a:xfrm>
+            <a:off x="1325880" y="4489704"/>
+            <a:ext cx="10058400" cy="292608"/>
+          </a:xfrm>
+          <a:prstGeom prst="rect">
+            <a:avLst/>
+          </a:prstGeom>
+          <a:noFill/>
+          <a:ln/>
+        </p:spPr>
+        <p:txBody>
+          <a:bodyPr wrap="square" lIns="0" tIns="0" rIns="0" bIns="0" rtlCol="0" anchor="t"/>
+          <a:lstStyle/>
+          <a:p>
+            <a:pPr indent="0" marL="0">
+              <a:buNone/>
+            </a:pPr>
+            <a:r>
+              <a:rPr lang="en-US" sz="1400" dirty="0">
+                <a:solidFill>
+                  <a:srgbClr val="5A5F73"/>
+                </a:solidFill>
+                <a:latin typeface="Calibri" pitchFamily="34" charset="0"/>
+                <a:ea typeface="Calibri" pitchFamily="34" charset="-122"/>
+                <a:cs typeface="Calibri" pitchFamily="34" charset="-120"/>
+              </a:rPr>
+              <a:t>En las pruebas el modelo se sustituye por un doble: el flujo se verifica sin llamar a uno real.</a:t>
+            </a:r>
+            <a:endParaRPr lang="en-US" sz="1400" dirty="0"/>
+          </a:p>
+        </p:txBody>
+      </p:sp>
+      <p:sp>
+        <p:nvSpPr>
           <p:cNvPr id="17" name="Text 15"/>
           <p:cNvSpPr/>
           <p:nvPr/>
         </p:nvSpPr>
         <p:spPr>
           <a:xfrm>
-            <a:off x="1325880" y="4782312"/>
-            <a:ext cx="10058400" cy="292608"/>
+            <a:off x="777240" y="4818888"/>
+            <a:ext cx="457200" cy="292608"/>
           </a:xfrm>
           <a:prstGeom prst="rect">
             <a:avLst/>
@@ -14134,53 +14135,131 @@
               <a:buNone/>
             </a:pPr>
             <a:r>
-              <a:rPr lang="en-US" sz="1400" dirty="0">
-                <a:solidFill>
-                  <a:srgbClr val="5A5F73"/>
-                </a:solidFill>
-                <a:latin typeface="Calibri" pitchFamily="34" charset="0"/>
-                <a:ea typeface="Calibri" pitchFamily="34" charset="-122"/>
-                <a:cs typeface="Calibri" pitchFamily="34" charset="-120"/>
-              </a:rPr>
-              <a:t>En las pruebas el modelo se sustituye por un doble: el flujo se verifica sin llamar a uno real.</a:t>
-            </a:r>
-            <a:endParaRPr lang="en-US" sz="1400" dirty="0"/>
-          </a:p>
-        </p:txBody>
-      </p:sp>
-      <p:sp>
-        <p:nvSpPr>
-          <p:cNvPr id="18" name="Text 16"/>
-          <p:cNvSpPr/>
-          <p:nvPr/>
-        </p:nvSpPr>
-        <p:spPr>
-          <a:xfrm>
-            <a:off x="777240" y="5175504"/>
-            <a:ext cx="10607040" cy="274320"/>
-          </a:xfrm>
-          <a:prstGeom prst="rect">
-            <a:avLst/>
-          </a:prstGeom>
-          <a:noFill/>
-          <a:ln/>
-        </p:spPr>
-        <p:txBody>
-          <a:bodyPr wrap="square" lIns="0" tIns="0" rIns="0" bIns="0" rtlCol="0" anchor="t"/>
-          <a:lstStyle/>
-          <a:p>
-            <a:pPr indent="0" marL="0">
-              <a:buNone/>
-            </a:pPr>
-            <a:r>
-              <a:rPr lang="en-US" sz="1500" b="1" dirty="0">
-                <a:solidFill>
-                  <a:srgbClr val="1A1C2E"/>
+              <a:rPr lang="en-US" sz="1600" b="1" dirty="0">
+                <a:solidFill>
+                  <a:srgbClr val="202CFC"/>
                 </a:solidFill>
                 <a:latin typeface="Arial" pitchFamily="34" charset="0"/>
                 <a:ea typeface="Arial" pitchFamily="34" charset="-122"/>
                 <a:cs typeface="Arial" pitchFamily="34" charset="-120"/>
               </a:rPr>
+              <a:t>05</a:t>
+            </a:r>
+            <a:endParaRPr lang="en-US" sz="1600" dirty="0"/>
+          </a:p>
+        </p:txBody>
+      </p:sp>
+      <p:sp>
+        <p:nvSpPr>
+          <p:cNvPr id="18" name="Text 16"/>
+          <p:cNvSpPr/>
+          <p:nvPr/>
+        </p:nvSpPr>
+        <p:spPr>
+          <a:xfrm>
+            <a:off x="1325880" y="4818888"/>
+            <a:ext cx="10058400" cy="292608"/>
+          </a:xfrm>
+          <a:prstGeom prst="rect">
+            <a:avLst/>
+          </a:prstGeom>
+          <a:noFill/>
+          <a:ln/>
+        </p:spPr>
+        <p:txBody>
+          <a:bodyPr wrap="square" lIns="0" tIns="0" rIns="0" bIns="0" rtlCol="0" anchor="t"/>
+          <a:lstStyle/>
+          <a:p>
+            <a:pPr indent="0" marL="0">
+              <a:buNone/>
+            </a:pPr>
+            <a:r>
+              <a:rPr lang="en-US" sz="1700" b="1" dirty="0">
+                <a:solidFill>
+                  <a:srgbClr val="1A1C2E"/>
+                </a:solidFill>
+                <a:latin typeface="Arial" pitchFamily="34" charset="0"/>
+                <a:ea typeface="Arial" pitchFamily="34" charset="-122"/>
+                <a:cs typeface="Arial" pitchFamily="34" charset="-120"/>
+              </a:rPr>
+              <a:t>Alta testabilidad, que es lo que exigen las normas</a:t>
+            </a:r>
+            <a:endParaRPr lang="en-US" sz="1700" dirty="0"/>
+          </a:p>
+        </p:txBody>
+      </p:sp>
+      <p:sp>
+        <p:nvSpPr>
+          <p:cNvPr id="19" name="Text 17"/>
+          <p:cNvSpPr/>
+          <p:nvPr/>
+        </p:nvSpPr>
+        <p:spPr>
+          <a:xfrm>
+            <a:off x="1325880" y="5111496"/>
+            <a:ext cx="10058400" cy="292608"/>
+          </a:xfrm>
+          <a:prstGeom prst="rect">
+            <a:avLst/>
+          </a:prstGeom>
+          <a:noFill/>
+          <a:ln/>
+        </p:spPr>
+        <p:txBody>
+          <a:bodyPr wrap="square" lIns="0" tIns="0" rIns="0" bIns="0" rtlCol="0" anchor="t"/>
+          <a:lstStyle/>
+          <a:p>
+            <a:pPr indent="0" marL="0">
+              <a:buNone/>
+            </a:pPr>
+            <a:r>
+              <a:rPr lang="en-US" sz="1400" dirty="0">
+                <a:solidFill>
+                  <a:srgbClr val="5A5F73"/>
+                </a:solidFill>
+                <a:latin typeface="Calibri" pitchFamily="34" charset="0"/>
+                <a:ea typeface="Calibri" pitchFamily="34" charset="-122"/>
+                <a:cs typeface="Calibri" pitchFamily="34" charset="-120"/>
+              </a:rPr>
+              <a:t>Las normativas ISO hay que probarlas con test: 2171 pruebas sin coche, sin servidor y sin modelo.</a:t>
+            </a:r>
+            <a:endParaRPr lang="en-US" sz="1400" dirty="0"/>
+          </a:p>
+        </p:txBody>
+      </p:sp>
+      <p:sp>
+        <p:nvSpPr>
+          <p:cNvPr id="20" name="Text 18"/>
+          <p:cNvSpPr/>
+          <p:nvPr/>
+        </p:nvSpPr>
+        <p:spPr>
+          <a:xfrm>
+            <a:off x="777240" y="5468112"/>
+            <a:ext cx="10607040" cy="274320"/>
+          </a:xfrm>
+          <a:prstGeom prst="rect">
+            <a:avLst/>
+          </a:prstGeom>
+          <a:noFill/>
+          <a:ln/>
+        </p:spPr>
+        <p:txBody>
+          <a:bodyPr wrap="square" lIns="0" tIns="0" rIns="0" bIns="0" rtlCol="0" anchor="t"/>
+          <a:lstStyle/>
+          <a:p>
+            <a:pPr indent="0" marL="0">
+              <a:buNone/>
+            </a:pPr>
+            <a:r>
+              <a:rPr lang="en-US" sz="1500" b="1" dirty="0">
+                <a:solidFill>
+                  <a:srgbClr val="1A1C2E"/>
+                </a:solidFill>
+                <a:latin typeface="Arial" pitchFamily="34" charset="0"/>
+                <a:ea typeface="Arial" pitchFamily="34" charset="-122"/>
+                <a:cs typeface="Arial" pitchFamily="34" charset="-120"/>
+              </a:rPr>
               <a:t>Un ejemplo</a:t>
             </a:r>
             <a:endParaRPr lang="en-US" sz="1500" dirty="0"/>
@@ -14189,13 +14268,13 @@
       </p:sp>
       <p:sp>
         <p:nvSpPr>
-          <p:cNvPr id="19" name="Text 17"/>
-          <p:cNvSpPr/>
-          <p:nvPr/>
-        </p:nvSpPr>
-        <p:spPr>
-          <a:xfrm>
-            <a:off x="777240" y="5559552"/>
+          <p:cNvPr id="21" name="Text 19"/>
+          <p:cNvSpPr/>
+          <p:nvPr/>
+        </p:nvSpPr>
+        <p:spPr>
+          <a:xfrm>
+            <a:off x="777240" y="5797296"/>
             <a:ext cx="2651760" cy="329184"/>
           </a:xfrm>
           <a:prstGeom prst="rect">
@@ -14228,13 +14307,13 @@
       </p:sp>
       <p:sp>
         <p:nvSpPr>
-          <p:cNvPr id="20" name="Text 18"/>
-          <p:cNvSpPr/>
-          <p:nvPr/>
-        </p:nvSpPr>
-        <p:spPr>
-          <a:xfrm>
-            <a:off x="3429000" y="5559552"/>
+          <p:cNvPr id="22" name="Text 20"/>
+          <p:cNvSpPr/>
+          <p:nvPr/>
+        </p:nvSpPr>
+        <p:spPr>
+          <a:xfrm>
+            <a:off x="3429000" y="5797296"/>
             <a:ext cx="457200" cy="329184"/>
           </a:xfrm>
           <a:prstGeom prst="rect">
@@ -14267,13 +14346,13 @@
       </p:sp>
       <p:sp>
         <p:nvSpPr>
-          <p:cNvPr id="21" name="Text 19"/>
-          <p:cNvSpPr/>
-          <p:nvPr/>
-        </p:nvSpPr>
-        <p:spPr>
-          <a:xfrm>
-            <a:off x="4023360" y="5559552"/>
+          <p:cNvPr id="23" name="Text 21"/>
+          <p:cNvSpPr/>
+          <p:nvPr/>
+        </p:nvSpPr>
+        <p:spPr>
+          <a:xfrm>
+            <a:off x="4023360" y="5797296"/>
             <a:ext cx="2834640" cy="329184"/>
           </a:xfrm>
           <a:prstGeom prst="rect">
@@ -14306,13 +14385,13 @@
       </p:sp>
       <p:sp>
         <p:nvSpPr>
-          <p:cNvPr id="22" name="Text 20"/>
-          <p:cNvSpPr/>
-          <p:nvPr/>
-        </p:nvSpPr>
-        <p:spPr>
-          <a:xfrm>
-            <a:off x="6858000" y="5358384"/>
+          <p:cNvPr id="24" name="Text 22"/>
+          <p:cNvSpPr/>
+          <p:nvPr/>
+        </p:nvSpPr>
+        <p:spPr>
+          <a:xfrm>
+            <a:off x="6858000" y="5797296"/>
             <a:ext cx="457200" cy="329184"/>
           </a:xfrm>
           <a:prstGeom prst="rect">
@@ -14345,14 +14424,14 @@
       </p:sp>
       <p:sp>
         <p:nvSpPr>
-          <p:cNvPr id="23" name="Text 21"/>
-          <p:cNvSpPr/>
-          <p:nvPr/>
-        </p:nvSpPr>
-        <p:spPr>
-          <a:xfrm>
-            <a:off x="6858000" y="5760720"/>
-            <a:ext cx="457200" cy="329184"/>
+          <p:cNvPr id="25" name="Text 23"/>
+          <p:cNvSpPr/>
+          <p:nvPr/>
+        </p:nvSpPr>
+        <p:spPr>
+          <a:xfrm>
+            <a:off x="7452360" y="5797296"/>
+            <a:ext cx="4023360" cy="329184"/>
           </a:xfrm>
           <a:prstGeom prst="rect">
             <a:avLst/>
@@ -14364,45 +14443,6 @@
           <a:bodyPr wrap="square" lIns="0" tIns="0" rIns="0" bIns="0" rtlCol="0" anchor="ctr"/>
           <a:lstStyle/>
           <a:p>
-            <a:pPr algn="ctr" indent="0" marL="0">
-              <a:buNone/>
-            </a:pPr>
-            <a:r>
-              <a:rPr lang="en-US" sz="1600" b="1" dirty="0">
-                <a:solidFill>
-                  <a:srgbClr val="8A93FF"/>
-                </a:solidFill>
-                <a:latin typeface="Calibri" pitchFamily="34" charset="0"/>
-                <a:ea typeface="Calibri" pitchFamily="34" charset="-122"/>
-                <a:cs typeface="Calibri" pitchFamily="34" charset="-120"/>
-              </a:rPr>
-              <a:t>→</a:t>
-            </a:r>
-            <a:endParaRPr lang="en-US" sz="1600" dirty="0"/>
-          </a:p>
-        </p:txBody>
-      </p:sp>
-      <p:sp>
-        <p:nvSpPr>
-          <p:cNvPr id="24" name="Text 22"/>
-          <p:cNvSpPr/>
-          <p:nvPr/>
-        </p:nvSpPr>
-        <p:spPr>
-          <a:xfrm>
-            <a:off x="7452360" y="5358384"/>
-            <a:ext cx="3840480" cy="329184"/>
-          </a:xfrm>
-          <a:prstGeom prst="rect">
-            <a:avLst/>
-          </a:prstGeom>
-          <a:noFill/>
-          <a:ln/>
-        </p:spPr>
-        <p:txBody>
-          <a:bodyPr wrap="square" lIns="0" tIns="0" rIns="0" bIns="0" rtlCol="0" anchor="ctr"/>
-          <a:lstStyle/>
-          <a:p>
             <a:pPr algn="l" indent="0" marL="0">
               <a:buNone/>
             </a:pPr>
@@ -14415,46 +14455,7 @@
                 <a:ea typeface="Calibri" pitchFamily="34" charset="-122"/>
                 <a:cs typeface="Calibri" pitchFamily="34" charset="-120"/>
               </a:rPr>
-              <a:t>Lector ELM327 conectado al coche</a:t>
-            </a:r>
-            <a:endParaRPr lang="en-US" sz="1300" dirty="0"/>
-          </a:p>
-        </p:txBody>
-      </p:sp>
-      <p:sp>
-        <p:nvSpPr>
-          <p:cNvPr id="25" name="Text 23"/>
-          <p:cNvSpPr/>
-          <p:nvPr/>
-        </p:nvSpPr>
-        <p:spPr>
-          <a:xfrm>
-            <a:off x="7452360" y="5760720"/>
-            <a:ext cx="3840480" cy="329184"/>
-          </a:xfrm>
-          <a:prstGeom prst="rect">
-            <a:avLst/>
-          </a:prstGeom>
-          <a:noFill/>
-          <a:ln/>
-        </p:spPr>
-        <p:txBody>
-          <a:bodyPr wrap="square" lIns="0" tIns="0" rIns="0" bIns="0" rtlCol="0" anchor="ctr"/>
-          <a:lstStyle/>
-          <a:p>
-            <a:pPr algn="l" indent="0" marL="0">
-              <a:buNone/>
-            </a:pPr>
-            <a:r>
-              <a:rPr lang="en-US" sz="1300" dirty="0">
-                <a:solidFill>
-                  <a:srgbClr val="5A5F73"/>
-                </a:solidFill>
-                <a:latin typeface="Calibri" pitchFamily="34" charset="0"/>
-                <a:ea typeface="Calibri" pitchFamily="34" charset="-122"/>
-                <a:cs typeface="Calibri" pitchFamily="34" charset="-120"/>
-              </a:rPr>
-              <a:t>Emulador en el portátil</a:t>
+              <a:t>Lector ELM327 conectado al coche o emulador</a:t>
             </a:r>
             <a:endParaRPr lang="en-US" sz="1300" dirty="0"/>
           </a:p>

</xml_diff>

<commit_message>
docs(tfm): dejar solo los titulares en el slide de arquitectura
</commit_message>
<xml_diff>
--- a/docs/presentacion/tfm-intelligent-automotive-diagnostics.pptx
+++ b/docs/presentacion/tfm-intelligent-automotive-diagnostics.pptx
@@ -13650,8 +13650,8 @@
         </p:nvSpPr>
         <p:spPr>
           <a:xfrm>
-            <a:off x="777240" y="2331720"/>
-            <a:ext cx="457200" cy="292608"/>
+            <a:off x="777240" y="2450592"/>
+            <a:ext cx="457200" cy="329184"/>
           </a:xfrm>
           <a:prstGeom prst="rect">
             <a:avLst/>
@@ -13667,7 +13667,7 @@
               <a:buNone/>
             </a:pPr>
             <a:r>
-              <a:rPr lang="en-US" sz="1600" b="1" dirty="0">
+              <a:rPr lang="en-US" sz="1700" b="1" dirty="0">
                 <a:solidFill>
                   <a:srgbClr val="202CFC"/>
                 </a:solidFill>
@@ -13677,7 +13677,7 @@
               </a:rPr>
               <a:t>01</a:t>
             </a:r>
-            <a:endParaRPr lang="en-US" sz="1600" dirty="0"/>
+            <a:endParaRPr lang="en-US" sz="1700" dirty="0"/>
           </a:p>
         </p:txBody>
       </p:sp>
@@ -13689,8 +13689,8 @@
         </p:nvSpPr>
         <p:spPr>
           <a:xfrm>
-            <a:off x="1325880" y="2331720"/>
-            <a:ext cx="10058400" cy="292608"/>
+            <a:off x="1325880" y="2450592"/>
+            <a:ext cx="10058400" cy="329184"/>
           </a:xfrm>
           <a:prstGeom prst="rect">
             <a:avLst/>
@@ -13706,7 +13706,7 @@
               <a:buNone/>
             </a:pPr>
             <a:r>
-              <a:rPr lang="en-US" sz="1700" b="1" dirty="0">
+              <a:rPr lang="en-US" sz="1800" b="1" dirty="0">
                 <a:solidFill>
                   <a:srgbClr val="1A1C2E"/>
                 </a:solidFill>
@@ -13716,7 +13716,7 @@
               </a:rPr>
               <a:t>El proyecto se ha desarrollado sin el vehículo</a:t>
             </a:r>
-            <a:endParaRPr lang="en-US" sz="1700" dirty="0"/>
+            <a:endParaRPr lang="en-US" sz="1800" dirty="0"/>
           </a:p>
         </p:txBody>
       </p:sp>
@@ -13728,8 +13728,8 @@
         </p:nvSpPr>
         <p:spPr>
           <a:xfrm>
-            <a:off x="1325880" y="2624328"/>
-            <a:ext cx="10058400" cy="292608"/>
+            <a:off x="777240" y="2980944"/>
+            <a:ext cx="457200" cy="329184"/>
           </a:xfrm>
           <a:prstGeom prst="rect">
             <a:avLst/>
@@ -13745,46 +13745,7 @@
               <a:buNone/>
             </a:pPr>
             <a:r>
-              <a:rPr lang="en-US" sz="1400" dirty="0">
-                <a:solidFill>
-                  <a:srgbClr val="5A5F73"/>
-                </a:solidFill>
-                <a:latin typeface="Calibri" pitchFamily="34" charset="0"/>
-                <a:ea typeface="Calibri" pitchFamily="34" charset="-122"/>
-                <a:cs typeface="Calibri" pitchFamily="34" charset="-120"/>
-              </a:rPr>
-              <a:t>Todo el desarrollo y las pruebas se han hecho contra emuladores: Audi, Kawasaki y Toyota.</a:t>
-            </a:r>
-            <a:endParaRPr lang="en-US" sz="1400" dirty="0"/>
-          </a:p>
-        </p:txBody>
-      </p:sp>
-      <p:sp>
-        <p:nvSpPr>
-          <p:cNvPr id="8" name="Text 6"/>
-          <p:cNvSpPr/>
-          <p:nvPr/>
-        </p:nvSpPr>
-        <p:spPr>
-          <a:xfrm>
-            <a:off x="777240" y="2953512"/>
-            <a:ext cx="457200" cy="292608"/>
-          </a:xfrm>
-          <a:prstGeom prst="rect">
-            <a:avLst/>
-          </a:prstGeom>
-          <a:noFill/>
-          <a:ln/>
-        </p:spPr>
-        <p:txBody>
-          <a:bodyPr wrap="square" lIns="0" tIns="0" rIns="0" bIns="0" rtlCol="0" anchor="t"/>
-          <a:lstStyle/>
-          <a:p>
-            <a:pPr indent="0" marL="0">
-              <a:buNone/>
-            </a:pPr>
-            <a:r>
-              <a:rPr lang="en-US" sz="1600" b="1" dirty="0">
+              <a:rPr lang="en-US" sz="1700" b="1" dirty="0">
                 <a:solidFill>
                   <a:srgbClr val="202CFC"/>
                 </a:solidFill>
@@ -13794,20 +13755,20 @@
               </a:rPr>
               <a:t>02</a:t>
             </a:r>
-            <a:endParaRPr lang="en-US" sz="1600" dirty="0"/>
-          </a:p>
-        </p:txBody>
-      </p:sp>
-      <p:sp>
-        <p:nvSpPr>
-          <p:cNvPr id="9" name="Text 7"/>
-          <p:cNvSpPr/>
-          <p:nvPr/>
-        </p:nvSpPr>
-        <p:spPr>
-          <a:xfrm>
-            <a:off x="1325880" y="2953512"/>
-            <a:ext cx="10058400" cy="292608"/>
+            <a:endParaRPr lang="en-US" sz="1700" dirty="0"/>
+          </a:p>
+        </p:txBody>
+      </p:sp>
+      <p:sp>
+        <p:nvSpPr>
+          <p:cNvPr id="8" name="Text 6"/>
+          <p:cNvSpPr/>
+          <p:nvPr/>
+        </p:nvSpPr>
+        <p:spPr>
+          <a:xfrm>
+            <a:off x="1325880" y="2980944"/>
+            <a:ext cx="10058400" cy="329184"/>
           </a:xfrm>
           <a:prstGeom prst="rect">
             <a:avLst/>
@@ -13823,7 +13784,7 @@
               <a:buNone/>
             </a:pPr>
             <a:r>
-              <a:rPr lang="en-US" sz="1700" b="1" dirty="0">
+              <a:rPr lang="en-US" sz="1800" b="1" dirty="0">
                 <a:solidFill>
                   <a:srgbClr val="1A1C2E"/>
                 </a:solidFill>
@@ -13833,20 +13794,20 @@
               </a:rPr>
               <a:t>La forma de conectarse al coche se decidió al final</a:t>
             </a:r>
-            <a:endParaRPr lang="en-US" sz="1700" dirty="0"/>
-          </a:p>
-        </p:txBody>
-      </p:sp>
-      <p:sp>
-        <p:nvSpPr>
-          <p:cNvPr id="10" name="Text 8"/>
-          <p:cNvSpPr/>
-          <p:nvPr/>
-        </p:nvSpPr>
-        <p:spPr>
-          <a:xfrm>
-            <a:off x="1325880" y="3246120"/>
-            <a:ext cx="10058400" cy="292608"/>
+            <a:endParaRPr lang="en-US" sz="1800" dirty="0"/>
+          </a:p>
+        </p:txBody>
+      </p:sp>
+      <p:sp>
+        <p:nvSpPr>
+          <p:cNvPr id="9" name="Text 7"/>
+          <p:cNvSpPr/>
+          <p:nvPr/>
+        </p:nvSpPr>
+        <p:spPr>
+          <a:xfrm>
+            <a:off x="777240" y="3511296"/>
+            <a:ext cx="457200" cy="329184"/>
           </a:xfrm>
           <a:prstGeom prst="rect">
             <a:avLst/>
@@ -13862,46 +13823,7 @@
               <a:buNone/>
             </a:pPr>
             <a:r>
-              <a:rPr lang="en-US" sz="1400" dirty="0">
-                <a:solidFill>
-                  <a:srgbClr val="5A5F73"/>
-                </a:solidFill>
-                <a:latin typeface="Calibri" pitchFamily="34" charset="0"/>
-                <a:ea typeface="Calibri" pitchFamily="34" charset="-122"/>
-                <a:cs typeface="Calibri" pitchFamily="34" charset="-120"/>
-              </a:rPr>
-              <a:t>El transporte del lector es otro puerto: por red o por puerto serie, con reintentos por encima.</a:t>
-            </a:r>
-            <a:endParaRPr lang="en-US" sz="1400" dirty="0"/>
-          </a:p>
-        </p:txBody>
-      </p:sp>
-      <p:sp>
-        <p:nvSpPr>
-          <p:cNvPr id="11" name="Text 9"/>
-          <p:cNvSpPr/>
-          <p:nvPr/>
-        </p:nvSpPr>
-        <p:spPr>
-          <a:xfrm>
-            <a:off x="777240" y="3575304"/>
-            <a:ext cx="457200" cy="292608"/>
-          </a:xfrm>
-          <a:prstGeom prst="rect">
-            <a:avLst/>
-          </a:prstGeom>
-          <a:noFill/>
-          <a:ln/>
-        </p:spPr>
-        <p:txBody>
-          <a:bodyPr wrap="square" lIns="0" tIns="0" rIns="0" bIns="0" rtlCol="0" anchor="t"/>
-          <a:lstStyle/>
-          <a:p>
-            <a:pPr indent="0" marL="0">
-              <a:buNone/>
-            </a:pPr>
-            <a:r>
-              <a:rPr lang="en-US" sz="1600" b="1" dirty="0">
+              <a:rPr lang="en-US" sz="1700" b="1" dirty="0">
                 <a:solidFill>
                   <a:srgbClr val="202CFC"/>
                 </a:solidFill>
@@ -13911,20 +13833,20 @@
               </a:rPr>
               <a:t>03</a:t>
             </a:r>
-            <a:endParaRPr lang="en-US" sz="1600" dirty="0"/>
-          </a:p>
-        </p:txBody>
-      </p:sp>
-      <p:sp>
-        <p:nvSpPr>
-          <p:cNvPr id="12" name="Text 10"/>
-          <p:cNvSpPr/>
-          <p:nvPr/>
-        </p:nvSpPr>
-        <p:spPr>
-          <a:xfrm>
-            <a:off x="1325880" y="3575304"/>
-            <a:ext cx="10058400" cy="292608"/>
+            <a:endParaRPr lang="en-US" sz="1700" dirty="0"/>
+          </a:p>
+        </p:txBody>
+      </p:sp>
+      <p:sp>
+        <p:nvSpPr>
+          <p:cNvPr id="10" name="Text 8"/>
+          <p:cNvSpPr/>
+          <p:nvPr/>
+        </p:nvSpPr>
+        <p:spPr>
+          <a:xfrm>
+            <a:off x="1325880" y="3511296"/>
+            <a:ext cx="10058400" cy="329184"/>
           </a:xfrm>
           <a:prstGeom prst="rect">
             <a:avLst/>
@@ -13940,7 +13862,7 @@
               <a:buNone/>
             </a:pPr>
             <a:r>
-              <a:rPr lang="en-US" sz="1700" b="1" dirty="0">
+              <a:rPr lang="en-US" sz="1800" b="1" dirty="0">
                 <a:solidFill>
                   <a:srgbClr val="1A1C2E"/>
                 </a:solidFill>
@@ -13950,20 +13872,20 @@
               </a:rPr>
               <a:t>El diagnóstico cognitivo se añadió sin tocar el determinista</a:t>
             </a:r>
-            <a:endParaRPr lang="en-US" sz="1700" dirty="0"/>
-          </a:p>
-        </p:txBody>
-      </p:sp>
-      <p:sp>
-        <p:nvSpPr>
-          <p:cNvPr id="13" name="Text 11"/>
-          <p:cNvSpPr/>
-          <p:nvPr/>
-        </p:nvSpPr>
-        <p:spPr>
-          <a:xfrm>
-            <a:off x="1325880" y="3867912"/>
-            <a:ext cx="10058400" cy="292608"/>
+            <a:endParaRPr lang="en-US" sz="1800" dirty="0"/>
+          </a:p>
+        </p:txBody>
+      </p:sp>
+      <p:sp>
+        <p:nvSpPr>
+          <p:cNvPr id="11" name="Text 9"/>
+          <p:cNvSpPr/>
+          <p:nvPr/>
+        </p:nvSpPr>
+        <p:spPr>
+          <a:xfrm>
+            <a:off x="777240" y="4041648"/>
+            <a:ext cx="457200" cy="329184"/>
           </a:xfrm>
           <a:prstGeom prst="rect">
             <a:avLst/>
@@ -13979,46 +13901,7 @@
               <a:buNone/>
             </a:pPr>
             <a:r>
-              <a:rPr lang="en-US" sz="1400" dirty="0">
-                <a:solidFill>
-                  <a:srgbClr val="5A5F73"/>
-                </a:solidFill>
-                <a:latin typeface="Calibri" pitchFamily="34" charset="0"/>
-                <a:ea typeface="Calibri" pitchFamily="34" charset="-122"/>
-                <a:cs typeface="Calibri" pitchFamily="34" charset="-120"/>
-              </a:rPr>
-              <a:t>El servidor MCP entró como un adaptador más. Los casos de uso que ya funcionaban no se modificaron.</a:t>
-            </a:r>
-            <a:endParaRPr lang="en-US" sz="1400" dirty="0"/>
-          </a:p>
-        </p:txBody>
-      </p:sp>
-      <p:sp>
-        <p:nvSpPr>
-          <p:cNvPr id="14" name="Text 12"/>
-          <p:cNvSpPr/>
-          <p:nvPr/>
-        </p:nvSpPr>
-        <p:spPr>
-          <a:xfrm>
-            <a:off x="777240" y="4197096"/>
-            <a:ext cx="457200" cy="292608"/>
-          </a:xfrm>
-          <a:prstGeom prst="rect">
-            <a:avLst/>
-          </a:prstGeom>
-          <a:noFill/>
-          <a:ln/>
-        </p:spPr>
-        <p:txBody>
-          <a:bodyPr wrap="square" lIns="0" tIns="0" rIns="0" bIns="0" rtlCol="0" anchor="t"/>
-          <a:lstStyle/>
-          <a:p>
-            <a:pPr indent="0" marL="0">
-              <a:buNone/>
-            </a:pPr>
-            <a:r>
-              <a:rPr lang="en-US" sz="1600" b="1" dirty="0">
+              <a:rPr lang="en-US" sz="1700" b="1" dirty="0">
                 <a:solidFill>
                   <a:srgbClr val="202CFC"/>
                 </a:solidFill>
@@ -14028,20 +13911,20 @@
               </a:rPr>
               <a:t>04</a:t>
             </a:r>
-            <a:endParaRPr lang="en-US" sz="1600" dirty="0"/>
-          </a:p>
-        </p:txBody>
-      </p:sp>
-      <p:sp>
-        <p:nvSpPr>
-          <p:cNvPr id="15" name="Text 13"/>
-          <p:cNvSpPr/>
-          <p:nvPr/>
-        </p:nvSpPr>
-        <p:spPr>
-          <a:xfrm>
-            <a:off x="1325880" y="4197096"/>
-            <a:ext cx="10058400" cy="292608"/>
+            <a:endParaRPr lang="en-US" sz="1700" dirty="0"/>
+          </a:p>
+        </p:txBody>
+      </p:sp>
+      <p:sp>
+        <p:nvSpPr>
+          <p:cNvPr id="12" name="Text 10"/>
+          <p:cNvSpPr/>
+          <p:nvPr/>
+        </p:nvSpPr>
+        <p:spPr>
+          <a:xfrm>
+            <a:off x="1325880" y="4041648"/>
+            <a:ext cx="10058400" cy="329184"/>
           </a:xfrm>
           <a:prstGeom prst="rect">
             <a:avLst/>
@@ -14057,7 +13940,7 @@
               <a:buNone/>
             </a:pPr>
             <a:r>
-              <a:rPr lang="en-US" sz="1700" b="1" dirty="0">
+              <a:rPr lang="en-US" sz="1800" b="1" dirty="0">
                 <a:solidFill>
                   <a:srgbClr val="1A1C2E"/>
                 </a:solidFill>
@@ -14067,20 +13950,20 @@
               </a:rPr>
               <a:t>Dos proveedores de modelo con el mismo código de diagnóstico</a:t>
             </a:r>
-            <a:endParaRPr lang="en-US" sz="1700" dirty="0"/>
-          </a:p>
-        </p:txBody>
-      </p:sp>
-      <p:sp>
-        <p:nvSpPr>
-          <p:cNvPr id="16" name="Text 14"/>
-          <p:cNvSpPr/>
-          <p:nvPr/>
-        </p:nvSpPr>
-        <p:spPr>
-          <a:xfrm>
-            <a:off x="1325880" y="4489704"/>
-            <a:ext cx="10058400" cy="292608"/>
+            <a:endParaRPr lang="en-US" sz="1800" dirty="0"/>
+          </a:p>
+        </p:txBody>
+      </p:sp>
+      <p:sp>
+        <p:nvSpPr>
+          <p:cNvPr id="13" name="Text 11"/>
+          <p:cNvSpPr/>
+          <p:nvPr/>
+        </p:nvSpPr>
+        <p:spPr>
+          <a:xfrm>
+            <a:off x="777240" y="4572000"/>
+            <a:ext cx="457200" cy="329184"/>
           </a:xfrm>
           <a:prstGeom prst="rect">
             <a:avLst/>
@@ -14096,46 +13979,7 @@
               <a:buNone/>
             </a:pPr>
             <a:r>
-              <a:rPr lang="en-US" sz="1400" dirty="0">
-                <a:solidFill>
-                  <a:srgbClr val="5A5F73"/>
-                </a:solidFill>
-                <a:latin typeface="Calibri" pitchFamily="34" charset="0"/>
-                <a:ea typeface="Calibri" pitchFamily="34" charset="-122"/>
-                <a:cs typeface="Calibri" pitchFamily="34" charset="-120"/>
-              </a:rPr>
-              <a:t>En las pruebas el modelo se sustituye por un doble: el flujo se verifica sin llamar a uno real.</a:t>
-            </a:r>
-            <a:endParaRPr lang="en-US" sz="1400" dirty="0"/>
-          </a:p>
-        </p:txBody>
-      </p:sp>
-      <p:sp>
-        <p:nvSpPr>
-          <p:cNvPr id="17" name="Text 15"/>
-          <p:cNvSpPr/>
-          <p:nvPr/>
-        </p:nvSpPr>
-        <p:spPr>
-          <a:xfrm>
-            <a:off x="777240" y="4818888"/>
-            <a:ext cx="457200" cy="292608"/>
-          </a:xfrm>
-          <a:prstGeom prst="rect">
-            <a:avLst/>
-          </a:prstGeom>
-          <a:noFill/>
-          <a:ln/>
-        </p:spPr>
-        <p:txBody>
-          <a:bodyPr wrap="square" lIns="0" tIns="0" rIns="0" bIns="0" rtlCol="0" anchor="t"/>
-          <a:lstStyle/>
-          <a:p>
-            <a:pPr indent="0" marL="0">
-              <a:buNone/>
-            </a:pPr>
-            <a:r>
-              <a:rPr lang="en-US" sz="1600" b="1" dirty="0">
+              <a:rPr lang="en-US" sz="1700" b="1" dirty="0">
                 <a:solidFill>
                   <a:srgbClr val="202CFC"/>
                 </a:solidFill>
@@ -14145,20 +13989,20 @@
               </a:rPr>
               <a:t>05</a:t>
             </a:r>
-            <a:endParaRPr lang="en-US" sz="1600" dirty="0"/>
-          </a:p>
-        </p:txBody>
-      </p:sp>
-      <p:sp>
-        <p:nvSpPr>
-          <p:cNvPr id="18" name="Text 16"/>
-          <p:cNvSpPr/>
-          <p:nvPr/>
-        </p:nvSpPr>
-        <p:spPr>
-          <a:xfrm>
-            <a:off x="1325880" y="4818888"/>
-            <a:ext cx="10058400" cy="292608"/>
+            <a:endParaRPr lang="en-US" sz="1700" dirty="0"/>
+          </a:p>
+        </p:txBody>
+      </p:sp>
+      <p:sp>
+        <p:nvSpPr>
+          <p:cNvPr id="14" name="Text 12"/>
+          <p:cNvSpPr/>
+          <p:nvPr/>
+        </p:nvSpPr>
+        <p:spPr>
+          <a:xfrm>
+            <a:off x="1325880" y="4572000"/>
+            <a:ext cx="10058400" cy="329184"/>
           </a:xfrm>
           <a:prstGeom prst="rect">
             <a:avLst/>
@@ -14174,7 +14018,7 @@
               <a:buNone/>
             </a:pPr>
             <a:r>
-              <a:rPr lang="en-US" sz="1700" b="1" dirty="0">
+              <a:rPr lang="en-US" sz="1800" b="1" dirty="0">
                 <a:solidFill>
                   <a:srgbClr val="1A1C2E"/>
                 </a:solidFill>
@@ -14184,58 +14028,19 @@
               </a:rPr>
               <a:t>Alta testabilidad, que es lo que exigen las normas</a:t>
             </a:r>
-            <a:endParaRPr lang="en-US" sz="1700" dirty="0"/>
-          </a:p>
-        </p:txBody>
-      </p:sp>
-      <p:sp>
-        <p:nvSpPr>
-          <p:cNvPr id="19" name="Text 17"/>
-          <p:cNvSpPr/>
-          <p:nvPr/>
-        </p:nvSpPr>
-        <p:spPr>
-          <a:xfrm>
-            <a:off x="1325880" y="5111496"/>
-            <a:ext cx="10058400" cy="292608"/>
-          </a:xfrm>
-          <a:prstGeom prst="rect">
-            <a:avLst/>
-          </a:prstGeom>
-          <a:noFill/>
-          <a:ln/>
-        </p:spPr>
-        <p:txBody>
-          <a:bodyPr wrap="square" lIns="0" tIns="0" rIns="0" bIns="0" rtlCol="0" anchor="t"/>
-          <a:lstStyle/>
-          <a:p>
-            <a:pPr indent="0" marL="0">
-              <a:buNone/>
-            </a:pPr>
-            <a:r>
-              <a:rPr lang="en-US" sz="1400" dirty="0">
-                <a:solidFill>
-                  <a:srgbClr val="5A5F73"/>
-                </a:solidFill>
-                <a:latin typeface="Calibri" pitchFamily="34" charset="0"/>
-                <a:ea typeface="Calibri" pitchFamily="34" charset="-122"/>
-                <a:cs typeface="Calibri" pitchFamily="34" charset="-120"/>
-              </a:rPr>
-              <a:t>Las normativas ISO hay que probarlas con test: 2171 pruebas sin coche, sin servidor y sin modelo.</a:t>
-            </a:r>
-            <a:endParaRPr lang="en-US" sz="1400" dirty="0"/>
-          </a:p>
-        </p:txBody>
-      </p:sp>
-      <p:sp>
-        <p:nvSpPr>
-          <p:cNvPr id="20" name="Text 18"/>
-          <p:cNvSpPr/>
-          <p:nvPr/>
-        </p:nvSpPr>
-        <p:spPr>
-          <a:xfrm>
-            <a:off x="777240" y="5468112"/>
+            <a:endParaRPr lang="en-US" sz="1800" dirty="0"/>
+          </a:p>
+        </p:txBody>
+      </p:sp>
+      <p:sp>
+        <p:nvSpPr>
+          <p:cNvPr id="15" name="Text 13"/>
+          <p:cNvSpPr/>
+          <p:nvPr/>
+        </p:nvSpPr>
+        <p:spPr>
+          <a:xfrm>
+            <a:off x="777240" y="5175504"/>
             <a:ext cx="10607040" cy="274320"/>
           </a:xfrm>
           <a:prstGeom prst="rect">
@@ -14268,14 +14073,209 @@
       </p:sp>
       <p:sp>
         <p:nvSpPr>
+          <p:cNvPr id="16" name="Text 14"/>
+          <p:cNvSpPr/>
+          <p:nvPr/>
+        </p:nvSpPr>
+        <p:spPr>
+          <a:xfrm>
+            <a:off x="777240" y="5559552"/>
+            <a:ext cx="2651760" cy="329184"/>
+          </a:xfrm>
+          <a:prstGeom prst="rect">
+            <a:avLst/>
+          </a:prstGeom>
+          <a:noFill/>
+          <a:ln/>
+        </p:spPr>
+        <p:txBody>
+          <a:bodyPr wrap="square" lIns="0" tIns="0" rIns="0" bIns="0" rtlCol="0" anchor="ctr"/>
+          <a:lstStyle/>
+          <a:p>
+            <a:pPr algn="l" indent="0" marL="0">
+              <a:buNone/>
+            </a:pPr>
+            <a:r>
+              <a:rPr lang="en-US" sz="1300" dirty="0">
+                <a:solidFill>
+                  <a:srgbClr val="1A1C2E"/>
+                </a:solidFill>
+                <a:latin typeface="Calibri" pitchFamily="34" charset="0"/>
+                <a:ea typeface="Calibri" pitchFamily="34" charset="-122"/>
+                <a:cs typeface="Calibri" pitchFamily="34" charset="-120"/>
+              </a:rPr>
+              <a:t>Caso de uso de diagnóstico</a:t>
+            </a:r>
+            <a:endParaRPr lang="en-US" sz="1300" dirty="0"/>
+          </a:p>
+        </p:txBody>
+      </p:sp>
+      <p:sp>
+        <p:nvSpPr>
+          <p:cNvPr id="17" name="Text 15"/>
+          <p:cNvSpPr/>
+          <p:nvPr/>
+        </p:nvSpPr>
+        <p:spPr>
+          <a:xfrm>
+            <a:off x="3429000" y="5559552"/>
+            <a:ext cx="457200" cy="329184"/>
+          </a:xfrm>
+          <a:prstGeom prst="rect">
+            <a:avLst/>
+          </a:prstGeom>
+          <a:noFill/>
+          <a:ln/>
+        </p:spPr>
+        <p:txBody>
+          <a:bodyPr wrap="square" lIns="0" tIns="0" rIns="0" bIns="0" rtlCol="0" anchor="ctr"/>
+          <a:lstStyle/>
+          <a:p>
+            <a:pPr algn="ctr" indent="0" marL="0">
+              <a:buNone/>
+            </a:pPr>
+            <a:r>
+              <a:rPr lang="en-US" sz="1600" b="1" dirty="0">
+                <a:solidFill>
+                  <a:srgbClr val="8A93FF"/>
+                </a:solidFill>
+                <a:latin typeface="Calibri" pitchFamily="34" charset="0"/>
+                <a:ea typeface="Calibri" pitchFamily="34" charset="-122"/>
+                <a:cs typeface="Calibri" pitchFamily="34" charset="-120"/>
+              </a:rPr>
+              <a:t>→</a:t>
+            </a:r>
+            <a:endParaRPr lang="en-US" sz="1600" dirty="0"/>
+          </a:p>
+        </p:txBody>
+      </p:sp>
+      <p:sp>
+        <p:nvSpPr>
+          <p:cNvPr id="18" name="Text 16"/>
+          <p:cNvSpPr/>
+          <p:nvPr/>
+        </p:nvSpPr>
+        <p:spPr>
+          <a:xfrm>
+            <a:off x="4023360" y="5559552"/>
+            <a:ext cx="2834640" cy="329184"/>
+          </a:xfrm>
+          <a:prstGeom prst="rect">
+            <a:avLst/>
+          </a:prstGeom>
+          <a:noFill/>
+          <a:ln/>
+        </p:spPr>
+        <p:txBody>
+          <a:bodyPr wrap="square" lIns="0" tIns="0" rIns="0" bIns="0" rtlCol="0" anchor="ctr"/>
+          <a:lstStyle/>
+          <a:p>
+            <a:pPr algn="l" indent="0" marL="0">
+              <a:buNone/>
+            </a:pPr>
+            <a:r>
+              <a:rPr lang="en-US" sz="1300" dirty="0">
+                <a:solidFill>
+                  <a:srgbClr val="1A1C2E"/>
+                </a:solidFill>
+                <a:latin typeface="Calibri" pitchFamily="34" charset="0"/>
+                <a:ea typeface="Calibri" pitchFamily="34" charset="-122"/>
+                <a:cs typeface="Calibri" pitchFamily="34" charset="-120"/>
+              </a:rPr>
+              <a:t>Puerto de lectura del vehículo</a:t>
+            </a:r>
+            <a:endParaRPr lang="en-US" sz="1300" dirty="0"/>
+          </a:p>
+        </p:txBody>
+      </p:sp>
+      <p:sp>
+        <p:nvSpPr>
+          <p:cNvPr id="19" name="Text 17"/>
+          <p:cNvSpPr/>
+          <p:nvPr/>
+        </p:nvSpPr>
+        <p:spPr>
+          <a:xfrm>
+            <a:off x="6858000" y="5358384"/>
+            <a:ext cx="457200" cy="329184"/>
+          </a:xfrm>
+          <a:prstGeom prst="rect">
+            <a:avLst/>
+          </a:prstGeom>
+          <a:noFill/>
+          <a:ln/>
+        </p:spPr>
+        <p:txBody>
+          <a:bodyPr wrap="square" lIns="0" tIns="0" rIns="0" bIns="0" rtlCol="0" anchor="ctr"/>
+          <a:lstStyle/>
+          <a:p>
+            <a:pPr algn="ctr" indent="0" marL="0">
+              <a:buNone/>
+            </a:pPr>
+            <a:r>
+              <a:rPr lang="en-US" sz="1600" b="1" dirty="0">
+                <a:solidFill>
+                  <a:srgbClr val="8A93FF"/>
+                </a:solidFill>
+                <a:latin typeface="Calibri" pitchFamily="34" charset="0"/>
+                <a:ea typeface="Calibri" pitchFamily="34" charset="-122"/>
+                <a:cs typeface="Calibri" pitchFamily="34" charset="-120"/>
+              </a:rPr>
+              <a:t>→</a:t>
+            </a:r>
+            <a:endParaRPr lang="en-US" sz="1600" dirty="0"/>
+          </a:p>
+        </p:txBody>
+      </p:sp>
+      <p:sp>
+        <p:nvSpPr>
+          <p:cNvPr id="20" name="Text 18"/>
+          <p:cNvSpPr/>
+          <p:nvPr/>
+        </p:nvSpPr>
+        <p:spPr>
+          <a:xfrm>
+            <a:off x="6858000" y="5760720"/>
+            <a:ext cx="457200" cy="329184"/>
+          </a:xfrm>
+          <a:prstGeom prst="rect">
+            <a:avLst/>
+          </a:prstGeom>
+          <a:noFill/>
+          <a:ln/>
+        </p:spPr>
+        <p:txBody>
+          <a:bodyPr wrap="square" lIns="0" tIns="0" rIns="0" bIns="0" rtlCol="0" anchor="ctr"/>
+          <a:lstStyle/>
+          <a:p>
+            <a:pPr algn="ctr" indent="0" marL="0">
+              <a:buNone/>
+            </a:pPr>
+            <a:r>
+              <a:rPr lang="en-US" sz="1600" b="1" dirty="0">
+                <a:solidFill>
+                  <a:srgbClr val="8A93FF"/>
+                </a:solidFill>
+                <a:latin typeface="Calibri" pitchFamily="34" charset="0"/>
+                <a:ea typeface="Calibri" pitchFamily="34" charset="-122"/>
+                <a:cs typeface="Calibri" pitchFamily="34" charset="-120"/>
+              </a:rPr>
+              <a:t>→</a:t>
+            </a:r>
+            <a:endParaRPr lang="en-US" sz="1600" dirty="0"/>
+          </a:p>
+        </p:txBody>
+      </p:sp>
+      <p:sp>
+        <p:nvSpPr>
           <p:cNvPr id="21" name="Text 19"/>
           <p:cNvSpPr/>
           <p:nvPr/>
         </p:nvSpPr>
         <p:spPr>
           <a:xfrm>
-            <a:off x="777240" y="5797296"/>
-            <a:ext cx="2651760" cy="329184"/>
+            <a:off x="7452360" y="5358384"/>
+            <a:ext cx="3840480" cy="329184"/>
           </a:xfrm>
           <a:prstGeom prst="rect">
             <a:avLst/>
@@ -14293,13 +14293,13 @@
             <a:r>
               <a:rPr lang="en-US" sz="1300" dirty="0">
                 <a:solidFill>
-                  <a:srgbClr val="1A1C2E"/>
-                </a:solidFill>
-                <a:latin typeface="Calibri" pitchFamily="34" charset="0"/>
-                <a:ea typeface="Calibri" pitchFamily="34" charset="-122"/>
-                <a:cs typeface="Calibri" pitchFamily="34" charset="-120"/>
-              </a:rPr>
-              <a:t>Caso de uso de diagnóstico</a:t>
+                  <a:srgbClr val="5A5F73"/>
+                </a:solidFill>
+                <a:latin typeface="Calibri" pitchFamily="34" charset="0"/>
+                <a:ea typeface="Calibri" pitchFamily="34" charset="-122"/>
+                <a:cs typeface="Calibri" pitchFamily="34" charset="-120"/>
+              </a:rPr>
+              <a:t>Lector ELM327 conectado al coche</a:t>
             </a:r>
             <a:endParaRPr lang="en-US" sz="1300" dirty="0"/>
           </a:p>
@@ -14313,8 +14313,8 @@
         </p:nvSpPr>
         <p:spPr>
           <a:xfrm>
-            <a:off x="3429000" y="5797296"/>
-            <a:ext cx="457200" cy="329184"/>
+            <a:off x="7452360" y="5760720"/>
+            <a:ext cx="3840480" cy="329184"/>
           </a:xfrm>
           <a:prstGeom prst="rect">
             <a:avLst/>
@@ -14326,58 +14326,19 @@
           <a:bodyPr wrap="square" lIns="0" tIns="0" rIns="0" bIns="0" rtlCol="0" anchor="ctr"/>
           <a:lstStyle/>
           <a:p>
-            <a:pPr algn="ctr" indent="0" marL="0">
-              <a:buNone/>
-            </a:pPr>
-            <a:r>
-              <a:rPr lang="en-US" sz="1600" b="1" dirty="0">
-                <a:solidFill>
-                  <a:srgbClr val="8A93FF"/>
-                </a:solidFill>
-                <a:latin typeface="Calibri" pitchFamily="34" charset="0"/>
-                <a:ea typeface="Calibri" pitchFamily="34" charset="-122"/>
-                <a:cs typeface="Calibri" pitchFamily="34" charset="-120"/>
-              </a:rPr>
-              <a:t>→</a:t>
-            </a:r>
-            <a:endParaRPr lang="en-US" sz="1600" dirty="0"/>
-          </a:p>
-        </p:txBody>
-      </p:sp>
-      <p:sp>
-        <p:nvSpPr>
-          <p:cNvPr id="23" name="Text 21"/>
-          <p:cNvSpPr/>
-          <p:nvPr/>
-        </p:nvSpPr>
-        <p:spPr>
-          <a:xfrm>
-            <a:off x="4023360" y="5797296"/>
-            <a:ext cx="2834640" cy="329184"/>
-          </a:xfrm>
-          <a:prstGeom prst="rect">
-            <a:avLst/>
-          </a:prstGeom>
-          <a:noFill/>
-          <a:ln/>
-        </p:spPr>
-        <p:txBody>
-          <a:bodyPr wrap="square" lIns="0" tIns="0" rIns="0" bIns="0" rtlCol="0" anchor="ctr"/>
-          <a:lstStyle/>
-          <a:p>
             <a:pPr algn="l" indent="0" marL="0">
               <a:buNone/>
             </a:pPr>
             <a:r>
               <a:rPr lang="en-US" sz="1300" dirty="0">
                 <a:solidFill>
-                  <a:srgbClr val="1A1C2E"/>
-                </a:solidFill>
-                <a:latin typeface="Calibri" pitchFamily="34" charset="0"/>
-                <a:ea typeface="Calibri" pitchFamily="34" charset="-122"/>
-                <a:cs typeface="Calibri" pitchFamily="34" charset="-120"/>
-              </a:rPr>
-              <a:t>Puerto de lectura del vehículo</a:t>
+                  <a:srgbClr val="5A5F73"/>
+                </a:solidFill>
+                <a:latin typeface="Calibri" pitchFamily="34" charset="0"/>
+                <a:ea typeface="Calibri" pitchFamily="34" charset="-122"/>
+                <a:cs typeface="Calibri" pitchFamily="34" charset="-120"/>
+              </a:rPr>
+              <a:t>Emulador en el portátil</a:t>
             </a:r>
             <a:endParaRPr lang="en-US" sz="1300" dirty="0"/>
           </a:p>
@@ -14385,85 +14346,7 @@
       </p:sp>
       <p:sp>
         <p:nvSpPr>
-          <p:cNvPr id="24" name="Text 22"/>
-          <p:cNvSpPr/>
-          <p:nvPr/>
-        </p:nvSpPr>
-        <p:spPr>
-          <a:xfrm>
-            <a:off x="6858000" y="5797296"/>
-            <a:ext cx="457200" cy="329184"/>
-          </a:xfrm>
-          <a:prstGeom prst="rect">
-            <a:avLst/>
-          </a:prstGeom>
-          <a:noFill/>
-          <a:ln/>
-        </p:spPr>
-        <p:txBody>
-          <a:bodyPr wrap="square" lIns="0" tIns="0" rIns="0" bIns="0" rtlCol="0" anchor="ctr"/>
-          <a:lstStyle/>
-          <a:p>
-            <a:pPr algn="ctr" indent="0" marL="0">
-              <a:buNone/>
-            </a:pPr>
-            <a:r>
-              <a:rPr lang="en-US" sz="1600" b="1" dirty="0">
-                <a:solidFill>
-                  <a:srgbClr val="8A93FF"/>
-                </a:solidFill>
-                <a:latin typeface="Calibri" pitchFamily="34" charset="0"/>
-                <a:ea typeface="Calibri" pitchFamily="34" charset="-122"/>
-                <a:cs typeface="Calibri" pitchFamily="34" charset="-120"/>
-              </a:rPr>
-              <a:t>→</a:t>
-            </a:r>
-            <a:endParaRPr lang="en-US" sz="1600" dirty="0"/>
-          </a:p>
-        </p:txBody>
-      </p:sp>
-      <p:sp>
-        <p:nvSpPr>
-          <p:cNvPr id="25" name="Text 23"/>
-          <p:cNvSpPr/>
-          <p:nvPr/>
-        </p:nvSpPr>
-        <p:spPr>
-          <a:xfrm>
-            <a:off x="7452360" y="5797296"/>
-            <a:ext cx="4023360" cy="329184"/>
-          </a:xfrm>
-          <a:prstGeom prst="rect">
-            <a:avLst/>
-          </a:prstGeom>
-          <a:noFill/>
-          <a:ln/>
-        </p:spPr>
-        <p:txBody>
-          <a:bodyPr wrap="square" lIns="0" tIns="0" rIns="0" bIns="0" rtlCol="0" anchor="ctr"/>
-          <a:lstStyle/>
-          <a:p>
-            <a:pPr algn="l" indent="0" marL="0">
-              <a:buNone/>
-            </a:pPr>
-            <a:r>
-              <a:rPr lang="en-US" sz="1300" dirty="0">
-                <a:solidFill>
-                  <a:srgbClr val="5A5F73"/>
-                </a:solidFill>
-                <a:latin typeface="Calibri" pitchFamily="34" charset="0"/>
-                <a:ea typeface="Calibri" pitchFamily="34" charset="-122"/>
-                <a:cs typeface="Calibri" pitchFamily="34" charset="-120"/>
-              </a:rPr>
-              <a:t>Lector ELM327 conectado al coche o emulador</a:t>
-            </a:r>
-            <a:endParaRPr lang="en-US" sz="1300" dirty="0"/>
-          </a:p>
-        </p:txBody>
-      </p:sp>
-      <p:sp>
-        <p:nvSpPr>
-          <p:cNvPr id="26" name="Shape 24"/>
+          <p:cNvPr id="23" name="Shape 21"/>
           <p:cNvSpPr/>
           <p:nvPr/>
         </p:nvSpPr>
@@ -14483,7 +14366,7 @@
       </p:sp>
       <p:sp>
         <p:nvSpPr>
-          <p:cNvPr id="27" name="Text 25"/>
+          <p:cNvPr id="24" name="Text 22"/>
           <p:cNvSpPr/>
           <p:nvPr/>
         </p:nvSpPr>
@@ -14522,7 +14405,7 @@
       </p:sp>
       <p:sp>
         <p:nvSpPr>
-          <p:cNvPr id="28" name="Text 26"/>
+          <p:cNvPr id="25" name="Text 23"/>
           <p:cNvSpPr/>
           <p:nvPr/>
         </p:nvSpPr>
@@ -14561,7 +14444,7 @@
       </p:sp>
       <p:sp>
         <p:nvSpPr>
-          <p:cNvPr id="29" name="Text 27"/>
+          <p:cNvPr id="26" name="Text 24"/>
           <p:cNvSpPr/>
           <p:nvPr/>
         </p:nvSpPr>

</xml_diff>

<commit_message>
docs(tfm): slide con las diez categorias OWASP y su mitigacion real
</commit_message>
<xml_diff>
--- a/docs/presentacion/tfm-intelligent-automotive-diagnostics.pptx
+++ b/docs/presentacion/tfm-intelligent-automotive-diagnostics.pptx
@@ -23,9 +23,10 @@
     <p:sldId id="271" r:id="rId17"/>
     <p:sldId id="272" r:id="rId18"/>
     <p:sldId id="273" r:id="rId19"/>
+    <p:sldId id="274" r:id="rId20"/>
   </p:sldIdLst>
   <p:notesMasterIdLst>
-    <p:notesMasterId r:id="rId20"/>
+    <p:notesMasterId r:id="rId21"/>
   </p:notesMasterIdLst>
   <p:sldSz cx="12192000" cy="6858000"/>
   <p:notesSz cx="6858000" cy="12192000"/>
@@ -1170,12 +1171,13 @@
           <a:p>
             <a:r>
               <a:rPr lang="en-US" dirty="0"/>
-              <a:t>Todo el ciclo está automatizado con GitHub Actions, y son dos flujos distintos.
-El de integración continua se ejecuta en cada push y en cada pull request contra main y develop. Levanta las dos aplicaciones en paralelo sobre Node 22 y pasa lint, formato, las pruebas, la compilación y el typecheck. Y remata con una auditoría de dependencias que detiene la entrega si aparece una vulnerabilidad crítica.
-El de despliegue se dispara solo cuando algo entra en main, que es la rama de releases. Construye tres imágenes Docker: la API, la interfaz y el emulador ELM327. Usa caché de la propia plataforma, así que las construcciones sucesivas son rápidas. Las publica en el registro de contenedores de GitHub.
-Y después entra por SSH al servidor, descarga las imágenes nuevas, levanta los contenedores con la configuración de producción y limpia las imágenes viejas. Sin que yo toque nada.
-La consecuencia práctica es que integrar en main es publicar. La aplicación está desplegada y accesible, no es una demo que solo corre en mi portátil.
-[~55 s · acumulado 17:40]</a:t>
+              <a:t>Esta es la tabla de seguridad. No la voy a leer entera, pero quiero que se vea que las diez categorías están cubiertas con una medida concreta y no con una declaración de intenciones.
+Destaco cuatro. La primera: cuando pides una sesión de diagnóstico que no es tuya, la API responde 404 y no 403, para no confirmar siquiera que existe.
+La cuarta: los límites de peticiones no son uno global, van por familia. El diagnóstico cognitivo, que es el que cuesta dinero porque llama al modelo, tiene el más estricto, cinco por minuto.
+La sexta es la que más me importa por lo que hay al otro lado: el borrado de códigos de avería es el único flujo destructivo sobre el coche, así que tiene su propio límite y se puede apagar entero con una variable de entorno. Y además el adaptador valida el modo OBD contra una lista blanca antes de tocar el socket, con un test de invariante que falla si alguien añade un método que emita un servicio de control.
+Y la décima: todo lo que viene de fuera —la búsqueda web y los casos previos de otros talleres— llega al modelo etiquetado como material no fiable, y el system prompt le dice que eso es referencia y nunca una orden.
+Los riesgos residuales están escritos y asumidos, no escondidos: los tokens en localStorage, la ausencia de MFA, la base sin cifrar en disco y los límites de peticiones en memoria.
+[~60 s · acumulado 17:45]</a:t>
             </a:r>
             <a:endParaRPr lang="en-US" dirty="0"/>
           </a:p>
@@ -1263,12 +1265,12 @@
           <a:p>
             <a:r>
               <a:rPr lang="en-US" dirty="0"/>
-              <a:t>Para terminar, lo que me llevo de haber hecho esto.
-Lo primero, que con IA se pueden construir cosas complejas mucho más rápido. Un proyecto como este, con su arquitectura, su capa de OBD, su base vectorial y su agente, antes habría sido cuestión de meses o de años. Y no solo va más rápido: se aprenden más cosas por el camino, porque te metes en herramientas y frameworks que de otra forma ni habrías tocado.
-Pero hay una segunda parte, y la quiero decir igual de claro. La IA también se equivoca, y hay que estar encima de lo que se sube. No vale con fiarse.
-Y no lo digo en abstracto: preparando esta misma presentación encontré que el umbral de cobertura del núcleo apuntaba a un fichero que se había renombrado, así que llevaba semanas sin exigir nada. Estaba verde, y no comprobaba lo que decía comprobar. Lo he documentado en la deuda conocida del proyecto.
-Así que sí, acelera mucho. Pero no es todo tan bonito como parece: hay que dedicarle tiempo a revisar.
-[~45 s · acumulado 18:25]</a:t>
+              <a:t>Todo el ciclo está automatizado con GitHub Actions, y son dos flujos distintos.
+El de integración continua se ejecuta en cada push y en cada pull request contra main y develop. Levanta las dos aplicaciones en paralelo sobre Node 22 y pasa lint, formato, las pruebas, la compilación y el typecheck. Y remata con una auditoría de dependencias que detiene la entrega si aparece una vulnerabilidad crítica.
+El de despliegue se dispara solo cuando algo entra en main, que es la rama de releases. Construye tres imágenes Docker: la API, la interfaz y el emulador ELM327. Usa caché de la propia plataforma, así que las construcciones sucesivas son rápidas. Las publica en el registro de contenedores de GitHub.
+Y después entra por SSH al servidor, descarga las imágenes nuevas, levanta los contenedores con la configuración de producción y limpia las imágenes viejas. Sin que yo toque nada.
+La consecuencia práctica es que integrar en main es publicar. La aplicación está desplegada y accesible, no es una demo que solo corre en mi portátil.
+[~55 s · acumulado 18:40]</a:t>
             </a:r>
             <a:endParaRPr lang="en-US" dirty="0"/>
           </a:p>
@@ -1356,8 +1358,12 @@
           <a:p>
             <a:r>
               <a:rPr lang="en-US" dirty="0"/>
-              <a:t>Y hasta aquí. Muchas gracias por la atención.
-[Quedarse callado y esperar las preguntas. El backup está detrás.]</a:t>
+              <a:t>Para terminar, lo que me llevo de haber hecho esto.
+Lo primero, que con IA se pueden construir cosas complejas mucho más rápido. Un proyecto como este, con su arquitectura, su capa de OBD, su base vectorial y su agente, antes habría sido cuestión de meses o de años. Y no solo va más rápido: se aprenden más cosas por el camino, porque te metes en herramientas y frameworks que de otra forma ni habrías tocado.
+Pero hay una segunda parte, y la quiero decir igual de claro. La IA también se equivoca, y hay que estar encima de lo que se sube. No vale con fiarse.
+Y no lo digo en abstracto: preparando esta misma presentación encontré que el umbral de cobertura del núcleo apuntaba a un fichero que se había renombrado, así que llevaba semanas sin exigir nada. Estaba verde, y no comprobaba lo que decía comprobar. Lo he documentado en la deuda conocida del proyecto.
+Así que sí, acelera mucho. Pero no es todo tan bonito como parece: hay que dedicarle tiempo a revisar.
+[~45 s · acumulado 19:25]</a:t>
             </a:r>
             <a:endParaRPr lang="en-US" dirty="0"/>
           </a:p>
@@ -1381,6 +1387,95 @@
             <a:fld id="{F7021451-1387-4CA6-816F-3879F97B5CBC}" type="slidenum">
               <a:rPr lang="en-US"/>
               <a:t>18</a:t>
+            </a:fld>
+            <a:endParaRPr lang="en-US"/>
+          </a:p>
+        </p:txBody>
+      </p:sp>
+    </p:spTree>
+    <p:extLst>
+      <p:ext uri="{BB962C8B-B14F-4D97-AF65-F5344CB8AC3E}">
+        <p14:creationId xmlns:p14="http://schemas.microsoft.com/office/powerpoint/2010/main" val="1024086991"/>
+      </p:ext>
+    </p:extLst>
+  </p:cSld>
+  <p:clrMapOvr>
+    <a:masterClrMapping/>
+  </p:clrMapOvr>
+</p:notes>
+</file>
+
+<file path=ppt/notesSlides/notesSlide19.xml><?xml version="1.0" encoding="utf-8"?>
+<p:notes xmlns:a="http://schemas.openxmlformats.org/drawingml/2006/main" xmlns:r="http://schemas.openxmlformats.org/officeDocument/2006/relationships" xmlns:p="http://schemas.openxmlformats.org/presentationml/2006/main">
+  <p:cSld>
+    <p:spTree>
+      <p:nvGrpSpPr>
+        <p:cNvPr id="1" name=""/>
+        <p:cNvGrpSpPr/>
+        <p:nvPr/>
+      </p:nvGrpSpPr>
+      <p:grpSpPr>
+        <a:xfrm>
+          <a:off x="0" y="0"/>
+          <a:ext cx="0" cy="0"/>
+          <a:chOff x="0" y="0"/>
+          <a:chExt cx="0" cy="0"/>
+        </a:xfrm>
+      </p:grpSpPr>
+      <p:sp>
+        <p:nvSpPr>
+          <p:cNvPr id="2" name="Slide Image Placeholder 1"/>
+          <p:cNvSpPr>
+            <a:spLocks noGrp="1" noRot="1" noChangeAspect="1"/>
+          </p:cNvSpPr>
+          <p:nvPr>
+            <p:ph type="sldImg"/>
+          </p:nvPr>
+        </p:nvSpPr>
+        <p:spPr/>
+      </p:sp>
+      <p:sp>
+        <p:nvSpPr>
+          <p:cNvPr id="3" name="Notes Placeholder 2"/>
+          <p:cNvSpPr>
+            <a:spLocks noGrp="1"/>
+          </p:cNvSpPr>
+          <p:nvPr>
+            <p:ph type="body" idx="1"/>
+          </p:nvPr>
+        </p:nvSpPr>
+        <p:spPr/>
+        <p:txBody>
+          <a:bodyPr/>
+          <a:lstStyle/>
+          <a:p>
+            <a:r>
+              <a:rPr lang="en-US" dirty="0"/>
+              <a:t>Y hasta aquí. Muchas gracias por la atención.
+[Quedarse callado y esperar las preguntas. El backup está detrás.]</a:t>
+            </a:r>
+            <a:endParaRPr lang="en-US" dirty="0"/>
+          </a:p>
+        </p:txBody>
+      </p:sp>
+      <p:sp>
+        <p:nvSpPr>
+          <p:cNvPr id="4" name="Slide Number Placeholder 3"/>
+          <p:cNvSpPr>
+            <a:spLocks noGrp="1"/>
+          </p:cNvSpPr>
+          <p:nvPr>
+            <p:ph type="sldNum" sz="quarter" idx="10"/>
+          </p:nvPr>
+        </p:nvSpPr>
+        <p:spPr/>
+        <p:txBody>
+          <a:bodyPr/>
+          <a:lstStyle/>
+          <a:p>
+            <a:fld id="{F7021451-1387-4CA6-816F-3879F97B5CBC}" type="slidenum">
+              <a:rPr lang="en-US"/>
+              <a:t>19</a:t>
             </a:fld>
             <a:endParaRPr lang="en-US"/>
           </a:p>
@@ -7626,8 +7721,8 @@
         </p:nvSpPr>
         <p:spPr>
           <a:xfrm>
-            <a:off x="777240" y="502920"/>
-            <a:ext cx="10607040" cy="685800"/>
+            <a:off x="777240" y="640080"/>
+            <a:ext cx="10607040" cy="777240"/>
           </a:xfrm>
           <a:prstGeom prst="rect">
             <a:avLst/>
@@ -7643,7 +7738,7 @@
               <a:buNone/>
             </a:pPr>
             <a:r>
-              <a:rPr lang="en-US" sz="3200" b="1" dirty="0">
+              <a:rPr lang="en-US" sz="3400" b="1" dirty="0">
                 <a:solidFill>
                   <a:srgbClr val="1A1C2E"/>
                 </a:solidFill>
@@ -7651,9 +7746,9 @@
                 <a:ea typeface="Arial" pitchFamily="34" charset="-122"/>
                 <a:cs typeface="Arial" pitchFamily="34" charset="-120"/>
               </a:rPr>
-              <a:t>Integración y despliegue continuos</a:t>
-            </a:r>
-            <a:endParaRPr lang="en-US" sz="3200" dirty="0"/>
+              <a:t>OWASP API Top 10 2023</a:t>
+            </a:r>
+            <a:endParaRPr lang="en-US" sz="3400" dirty="0"/>
           </a:p>
         </p:txBody>
       </p:sp>
@@ -7665,8 +7760,8 @@
         </p:nvSpPr>
         <p:spPr>
           <a:xfrm>
-            <a:off x="777240" y="1261872"/>
-            <a:ext cx="10607040" cy="320040"/>
+            <a:off x="777240" y="1481328"/>
+            <a:ext cx="10607040" cy="365760"/>
           </a:xfrm>
           <a:prstGeom prst="rect">
             <a:avLst/>
@@ -7682,7 +7777,7 @@
               <a:buNone/>
             </a:pPr>
             <a:r>
-              <a:rPr lang="en-US" sz="1500" dirty="0">
+              <a:rPr lang="en-US" sz="1700" dirty="0">
                 <a:solidFill>
                   <a:srgbClr val="5A5F73"/>
                 </a:solidFill>
@@ -7690,49 +7785,22 @@
                 <a:ea typeface="Calibri" pitchFamily="34" charset="-122"/>
                 <a:cs typeface="Calibri" pitchFamily="34" charset="-120"/>
               </a:rPr>
-              <a:t>Todo automatizado en GitHub Actions: integrar en main publica la nueva versión en producción.</a:t>
-            </a:r>
-            <a:endParaRPr lang="en-US" sz="1500" dirty="0"/>
-          </a:p>
-        </p:txBody>
-      </p:sp>
-      <p:sp>
-        <p:nvSpPr>
-          <p:cNvPr id="4" name="Shape 2"/>
-          <p:cNvSpPr/>
-          <p:nvPr/>
-        </p:nvSpPr>
-        <p:spPr>
-          <a:xfrm>
-            <a:off x="777240" y="1874520"/>
-            <a:ext cx="1828800" cy="868680"/>
-          </a:xfrm>
-          <a:prstGeom prst="roundRect">
-            <a:avLst>
-              <a:gd name="adj" fmla="val 6316"/>
-            </a:avLst>
-          </a:prstGeom>
-          <a:solidFill>
-            <a:srgbClr val="FFFFFF"/>
-          </a:solidFill>
-          <a:ln w="12700">
-            <a:solidFill>
-              <a:srgbClr val="C9CCD8"/>
-            </a:solidFill>
-            <a:prstDash val="solid"/>
-          </a:ln>
-        </p:spPr>
-      </p:sp>
-      <p:sp>
-        <p:nvSpPr>
-          <p:cNvPr id="5" name="Text 3"/>
-          <p:cNvSpPr/>
-          <p:nvPr/>
-        </p:nvSpPr>
-        <p:spPr>
-          <a:xfrm>
-            <a:off x="850392" y="1993392"/>
-            <a:ext cx="1682496" cy="274320"/>
+              <a:t>Las diez categorías, con la medida que se aplicó en el código.</a:t>
+            </a:r>
+            <a:endParaRPr lang="en-US" sz="1700" dirty="0"/>
+          </a:p>
+        </p:txBody>
+      </p:sp>
+      <p:sp>
+        <p:nvSpPr>
+          <p:cNvPr id="4" name="Text 2"/>
+          <p:cNvSpPr/>
+          <p:nvPr/>
+        </p:nvSpPr>
+        <p:spPr>
+          <a:xfrm>
+            <a:off x="777240" y="2084832"/>
+            <a:ext cx="685800" cy="365760"/>
           </a:xfrm>
           <a:prstGeom prst="rect">
             <a:avLst/>
@@ -7744,127 +7812,34 @@
           <a:bodyPr wrap="square" lIns="0" tIns="0" rIns="0" bIns="0" rtlCol="0" anchor="ctr"/>
           <a:lstStyle/>
           <a:p>
-            <a:pPr algn="ctr" indent="0" marL="0">
-              <a:buNone/>
-            </a:pPr>
-            <a:r>
-              <a:rPr lang="en-US" sz="1100" b="1" dirty="0">
-                <a:solidFill>
-                  <a:srgbClr val="1A1C2E"/>
+            <a:pPr indent="0" marL="0">
+              <a:buNone/>
+            </a:pPr>
+            <a:r>
+              <a:rPr lang="en-US" sz="1200" b="1" dirty="0">
+                <a:solidFill>
+                  <a:srgbClr val="202CFC"/>
                 </a:solidFill>
                 <a:latin typeface="Arial" pitchFamily="34" charset="0"/>
                 <a:ea typeface="Arial" pitchFamily="34" charset="-122"/>
                 <a:cs typeface="Arial" pitchFamily="34" charset="-120"/>
               </a:rPr>
-              <a:t>Integración en main</a:t>
-            </a:r>
-            <a:endParaRPr lang="en-US" sz="1100" dirty="0"/>
-          </a:p>
-        </p:txBody>
-      </p:sp>
-      <p:sp>
-        <p:nvSpPr>
-          <p:cNvPr id="6" name="Text 4"/>
-          <p:cNvSpPr/>
-          <p:nvPr/>
-        </p:nvSpPr>
-        <p:spPr>
-          <a:xfrm>
-            <a:off x="850392" y="2276856"/>
-            <a:ext cx="1682496" cy="384048"/>
-          </a:xfrm>
-          <a:prstGeom prst="rect">
-            <a:avLst/>
-          </a:prstGeom>
-          <a:noFill/>
-          <a:ln/>
-        </p:spPr>
-        <p:txBody>
-          <a:bodyPr wrap="square" lIns="0" tIns="0" rIns="0" bIns="0" rtlCol="0" anchor="t"/>
-          <a:lstStyle/>
-          <a:p>
-            <a:pPr algn="ctr" indent="0" marL="0">
-              <a:lnSpc>
-                <a:spcPts val="1200"/>
-              </a:lnSpc>
-              <a:buNone/>
-            </a:pPr>
-            <a:r>
-              <a:rPr lang="en-US" sz="950" dirty="0">
-                <a:solidFill>
-                  <a:srgbClr val="5A5F73"/>
-                </a:solidFill>
-                <a:latin typeface="Calibri" pitchFamily="34" charset="0"/>
-                <a:ea typeface="Calibri" pitchFamily="34" charset="-122"/>
-                <a:cs typeface="Calibri" pitchFamily="34" charset="-120"/>
-              </a:rPr>
-              <a:t>push o merge</a:t>
-            </a:r>
-            <a:endParaRPr lang="en-US" sz="950" dirty="0"/>
-          </a:p>
-        </p:txBody>
-      </p:sp>
-      <p:sp>
-        <p:nvSpPr>
-          <p:cNvPr id="7" name="Shape 5"/>
-          <p:cNvSpPr/>
-          <p:nvPr/>
-        </p:nvSpPr>
-        <p:spPr>
-          <a:xfrm>
-            <a:off x="2679192" y="2308860"/>
-            <a:ext cx="219456" cy="0"/>
-          </a:xfrm>
-          <a:prstGeom prst="line">
-            <a:avLst/>
-          </a:prstGeom>
-          <a:noFill/>
-          <a:ln w="19050">
-            <a:solidFill>
-              <a:srgbClr val="202CFC"/>
-            </a:solidFill>
-            <a:prstDash val="solid"/>
-            <a:tailEnd type="triangle"/>
-          </a:ln>
-        </p:spPr>
-      </p:sp>
-      <p:sp>
-        <p:nvSpPr>
-          <p:cNvPr id="8" name="Shape 6"/>
-          <p:cNvSpPr/>
-          <p:nvPr/>
-        </p:nvSpPr>
-        <p:spPr>
-          <a:xfrm>
-            <a:off x="2971800" y="1874520"/>
-            <a:ext cx="1828800" cy="868680"/>
-          </a:xfrm>
-          <a:prstGeom prst="roundRect">
-            <a:avLst>
-              <a:gd name="adj" fmla="val 6316"/>
-            </a:avLst>
-          </a:prstGeom>
-          <a:solidFill>
-            <a:srgbClr val="FFFFFF"/>
-          </a:solidFill>
-          <a:ln w="12700">
-            <a:solidFill>
-              <a:srgbClr val="C9CCD8"/>
-            </a:solidFill>
-            <a:prstDash val="solid"/>
-          </a:ln>
-        </p:spPr>
-      </p:sp>
-      <p:sp>
-        <p:nvSpPr>
-          <p:cNvPr id="9" name="Text 7"/>
-          <p:cNvSpPr/>
-          <p:nvPr/>
-        </p:nvSpPr>
-        <p:spPr>
-          <a:xfrm>
-            <a:off x="3044952" y="1993392"/>
-            <a:ext cx="1682496" cy="274320"/>
+              <a:t>API1</a:t>
+            </a:r>
+            <a:endParaRPr lang="en-US" sz="1200" dirty="0"/>
+          </a:p>
+        </p:txBody>
+      </p:sp>
+      <p:sp>
+        <p:nvSpPr>
+          <p:cNvPr id="5" name="Text 3"/>
+          <p:cNvSpPr/>
+          <p:nvPr/>
+        </p:nvSpPr>
+        <p:spPr>
+          <a:xfrm>
+            <a:off x="1481328" y="2084832"/>
+            <a:ext cx="2834640" cy="365760"/>
           </a:xfrm>
           <a:prstGeom prst="rect">
             <a:avLst/>
@@ -7876,11 +7851,11 @@
           <a:bodyPr wrap="square" lIns="0" tIns="0" rIns="0" bIns="0" rtlCol="0" anchor="ctr"/>
           <a:lstStyle/>
           <a:p>
-            <a:pPr algn="ctr" indent="0" marL="0">
-              <a:buNone/>
-            </a:pPr>
-            <a:r>
-              <a:rPr lang="en-US" sz="1100" b="1" dirty="0">
+            <a:pPr indent="0" marL="0">
+              <a:buNone/>
+            </a:pPr>
+            <a:r>
+              <a:rPr lang="en-US" sz="1200" b="1" dirty="0">
                 <a:solidFill>
                   <a:srgbClr val="1A1C2E"/>
                 </a:solidFill>
@@ -7888,41 +7863,38 @@
                 <a:ea typeface="Arial" pitchFamily="34" charset="-122"/>
                 <a:cs typeface="Arial" pitchFamily="34" charset="-120"/>
               </a:rPr>
-              <a:t>Verificación</a:t>
-            </a:r>
-            <a:endParaRPr lang="en-US" sz="1100" dirty="0"/>
-          </a:p>
-        </p:txBody>
-      </p:sp>
-      <p:sp>
-        <p:nvSpPr>
-          <p:cNvPr id="10" name="Text 8"/>
-          <p:cNvSpPr/>
-          <p:nvPr/>
-        </p:nvSpPr>
-        <p:spPr>
-          <a:xfrm>
-            <a:off x="3044952" y="2276856"/>
-            <a:ext cx="1682496" cy="384048"/>
-          </a:xfrm>
-          <a:prstGeom prst="rect">
-            <a:avLst/>
-          </a:prstGeom>
-          <a:noFill/>
-          <a:ln/>
-        </p:spPr>
-        <p:txBody>
-          <a:bodyPr wrap="square" lIns="0" tIns="0" rIns="0" bIns="0" rtlCol="0" anchor="t"/>
-          <a:lstStyle/>
-          <a:p>
-            <a:pPr algn="ctr" indent="0" marL="0">
-              <a:lnSpc>
-                <a:spcPts val="1200"/>
-              </a:lnSpc>
-              <a:buNone/>
-            </a:pPr>
-            <a:r>
-              <a:rPr lang="en-US" sz="950" dirty="0">
+              <a:t>Autorización de objeto</a:t>
+            </a:r>
+            <a:endParaRPr lang="en-US" sz="1200" dirty="0"/>
+          </a:p>
+        </p:txBody>
+      </p:sp>
+      <p:sp>
+        <p:nvSpPr>
+          <p:cNvPr id="6" name="Text 4"/>
+          <p:cNvSpPr/>
+          <p:nvPr/>
+        </p:nvSpPr>
+        <p:spPr>
+          <a:xfrm>
+            <a:off x="4389120" y="2084832"/>
+            <a:ext cx="6995160" cy="365760"/>
+          </a:xfrm>
+          <a:prstGeom prst="rect">
+            <a:avLst/>
+          </a:prstGeom>
+          <a:noFill/>
+          <a:ln/>
+        </p:spPr>
+        <p:txBody>
+          <a:bodyPr wrap="square" lIns="0" tIns="0" rIns="0" bIns="0" rtlCol="0" anchor="ctr"/>
+          <a:lstStyle/>
+          <a:p>
+            <a:pPr indent="0" marL="0">
+              <a:buNone/>
+            </a:pPr>
+            <a:r>
+              <a:rPr lang="en-US" sz="1300" dirty="0">
                 <a:solidFill>
                   <a:srgbClr val="5A5F73"/>
                 </a:solidFill>
@@ -7930,93 +7902,22 @@
                 <a:ea typeface="Calibri" pitchFamily="34" charset="-122"/>
                 <a:cs typeface="Calibri" pitchFamily="34" charset="-120"/>
               </a:rPr>
-              <a:t>lint, tests,</a:t>
-            </a:r>
-            <a:endParaRPr lang="en-US" sz="950" dirty="0"/>
-          </a:p>
-          <a:p>
-            <a:pPr algn="ctr" indent="0" marL="0">
-              <a:lnSpc>
-                <a:spcPts val="1200"/>
-              </a:lnSpc>
-              <a:buNone/>
-            </a:pPr>
-            <a:r>
-              <a:rPr lang="en-US" sz="950" dirty="0">
-                <a:solidFill>
-                  <a:srgbClr val="5A5F73"/>
-                </a:solidFill>
-                <a:latin typeface="Calibri" pitchFamily="34" charset="0"/>
-                <a:ea typeface="Calibri" pitchFamily="34" charset="-122"/>
-                <a:cs typeface="Calibri" pitchFamily="34" charset="-120"/>
-              </a:rPr>
-              <a:t>build y typecheck</a:t>
-            </a:r>
-            <a:endParaRPr lang="en-US" sz="950" dirty="0"/>
-          </a:p>
-        </p:txBody>
-      </p:sp>
-      <p:sp>
-        <p:nvSpPr>
-          <p:cNvPr id="11" name="Shape 9"/>
-          <p:cNvSpPr/>
-          <p:nvPr/>
-        </p:nvSpPr>
-        <p:spPr>
-          <a:xfrm>
-            <a:off x="4873752" y="2308860"/>
-            <a:ext cx="219456" cy="0"/>
-          </a:xfrm>
-          <a:prstGeom prst="line">
-            <a:avLst/>
-          </a:prstGeom>
-          <a:noFill/>
-          <a:ln w="19050">
-            <a:solidFill>
-              <a:srgbClr val="202CFC"/>
-            </a:solidFill>
-            <a:prstDash val="solid"/>
-            <a:tailEnd type="triangle"/>
-          </a:ln>
-        </p:spPr>
-      </p:sp>
-      <p:sp>
-        <p:nvSpPr>
-          <p:cNvPr id="12" name="Shape 10"/>
-          <p:cNvSpPr/>
-          <p:nvPr/>
-        </p:nvSpPr>
-        <p:spPr>
-          <a:xfrm>
-            <a:off x="5166360" y="1874520"/>
-            <a:ext cx="1828800" cy="868680"/>
-          </a:xfrm>
-          <a:prstGeom prst="roundRect">
-            <a:avLst>
-              <a:gd name="adj" fmla="val 6316"/>
-            </a:avLst>
-          </a:prstGeom>
-          <a:solidFill>
-            <a:srgbClr val="FFFFFF"/>
-          </a:solidFill>
-          <a:ln w="12700">
-            <a:solidFill>
-              <a:srgbClr val="C9CCD8"/>
-            </a:solidFill>
-            <a:prstDash val="solid"/>
-          </a:ln>
-        </p:spPr>
-      </p:sp>
-      <p:sp>
-        <p:nvSpPr>
-          <p:cNvPr id="13" name="Text 11"/>
-          <p:cNvSpPr/>
-          <p:nvPr/>
-        </p:nvSpPr>
-        <p:spPr>
-          <a:xfrm>
-            <a:off x="5239512" y="1993392"/>
-            <a:ext cx="1682496" cy="274320"/>
+              <a:t>Las consultas filtran por propietario: la sesión de otro usuario devuelve 404, no 403</a:t>
+            </a:r>
+            <a:endParaRPr lang="en-US" sz="1300" dirty="0"/>
+          </a:p>
+        </p:txBody>
+      </p:sp>
+      <p:sp>
+        <p:nvSpPr>
+          <p:cNvPr id="7" name="Text 5"/>
+          <p:cNvSpPr/>
+          <p:nvPr/>
+        </p:nvSpPr>
+        <p:spPr>
+          <a:xfrm>
+            <a:off x="777240" y="2487168"/>
+            <a:ext cx="685800" cy="365760"/>
           </a:xfrm>
           <a:prstGeom prst="rect">
             <a:avLst/>
@@ -8028,147 +7929,34 @@
           <a:bodyPr wrap="square" lIns="0" tIns="0" rIns="0" bIns="0" rtlCol="0" anchor="ctr"/>
           <a:lstStyle/>
           <a:p>
-            <a:pPr algn="ctr" indent="0" marL="0">
-              <a:buNone/>
-            </a:pPr>
-            <a:r>
-              <a:rPr lang="en-US" sz="1100" b="1" dirty="0">
-                <a:solidFill>
-                  <a:srgbClr val="1A1C2E"/>
+            <a:pPr indent="0" marL="0">
+              <a:buNone/>
+            </a:pPr>
+            <a:r>
+              <a:rPr lang="en-US" sz="1200" b="1" dirty="0">
+                <a:solidFill>
+                  <a:srgbClr val="202CFC"/>
                 </a:solidFill>
                 <a:latin typeface="Arial" pitchFamily="34" charset="0"/>
                 <a:ea typeface="Arial" pitchFamily="34" charset="-122"/>
                 <a:cs typeface="Arial" pitchFamily="34" charset="-120"/>
               </a:rPr>
-              <a:t>Construcción</a:t>
-            </a:r>
-            <a:endParaRPr lang="en-US" sz="1100" dirty="0"/>
-          </a:p>
-        </p:txBody>
-      </p:sp>
-      <p:sp>
-        <p:nvSpPr>
-          <p:cNvPr id="14" name="Text 12"/>
-          <p:cNvSpPr/>
-          <p:nvPr/>
-        </p:nvSpPr>
-        <p:spPr>
-          <a:xfrm>
-            <a:off x="5239512" y="2276856"/>
-            <a:ext cx="1682496" cy="384048"/>
-          </a:xfrm>
-          <a:prstGeom prst="rect">
-            <a:avLst/>
-          </a:prstGeom>
-          <a:noFill/>
-          <a:ln/>
-        </p:spPr>
-        <p:txBody>
-          <a:bodyPr wrap="square" lIns="0" tIns="0" rIns="0" bIns="0" rtlCol="0" anchor="t"/>
-          <a:lstStyle/>
-          <a:p>
-            <a:pPr algn="ctr" indent="0" marL="0">
-              <a:lnSpc>
-                <a:spcPts val="1200"/>
-              </a:lnSpc>
-              <a:buNone/>
-            </a:pPr>
-            <a:r>
-              <a:rPr lang="en-US" sz="950" dirty="0">
-                <a:solidFill>
-                  <a:srgbClr val="5A5F73"/>
-                </a:solidFill>
-                <a:latin typeface="Calibri" pitchFamily="34" charset="0"/>
-                <a:ea typeface="Calibri" pitchFamily="34" charset="-122"/>
-                <a:cs typeface="Calibri" pitchFamily="34" charset="-120"/>
-              </a:rPr>
-              <a:t>tres imágenes</a:t>
-            </a:r>
-            <a:endParaRPr lang="en-US" sz="950" dirty="0"/>
-          </a:p>
-          <a:p>
-            <a:pPr algn="ctr" indent="0" marL="0">
-              <a:lnSpc>
-                <a:spcPts val="1200"/>
-              </a:lnSpc>
-              <a:buNone/>
-            </a:pPr>
-            <a:r>
-              <a:rPr lang="en-US" sz="950" dirty="0">
-                <a:solidFill>
-                  <a:srgbClr val="5A5F73"/>
-                </a:solidFill>
-                <a:latin typeface="Calibri" pitchFamily="34" charset="0"/>
-                <a:ea typeface="Calibri" pitchFamily="34" charset="-122"/>
-                <a:cs typeface="Calibri" pitchFamily="34" charset="-120"/>
-              </a:rPr>
-              <a:t>Docker</a:t>
-            </a:r>
-            <a:endParaRPr lang="en-US" sz="950" dirty="0"/>
-          </a:p>
-        </p:txBody>
-      </p:sp>
-      <p:sp>
-        <p:nvSpPr>
-          <p:cNvPr id="15" name="Shape 13"/>
-          <p:cNvSpPr/>
-          <p:nvPr/>
-        </p:nvSpPr>
-        <p:spPr>
-          <a:xfrm>
-            <a:off x="7068312" y="2308860"/>
-            <a:ext cx="219456" cy="0"/>
-          </a:xfrm>
-          <a:prstGeom prst="line">
-            <a:avLst/>
-          </a:prstGeom>
-          <a:noFill/>
-          <a:ln w="19050">
-            <a:solidFill>
-              <a:srgbClr val="202CFC"/>
-            </a:solidFill>
-            <a:prstDash val="solid"/>
-            <a:tailEnd type="triangle"/>
-          </a:ln>
-        </p:spPr>
-      </p:sp>
-      <p:sp>
-        <p:nvSpPr>
-          <p:cNvPr id="16" name="Shape 14"/>
-          <p:cNvSpPr/>
-          <p:nvPr/>
-        </p:nvSpPr>
-        <p:spPr>
-          <a:xfrm>
-            <a:off x="7360920" y="1874520"/>
-            <a:ext cx="1828800" cy="868680"/>
-          </a:xfrm>
-          <a:prstGeom prst="roundRect">
-            <a:avLst>
-              <a:gd name="adj" fmla="val 6316"/>
-            </a:avLst>
-          </a:prstGeom>
-          <a:solidFill>
-            <a:srgbClr val="FFFFFF"/>
-          </a:solidFill>
-          <a:ln w="12700">
-            <a:solidFill>
-              <a:srgbClr val="C9CCD8"/>
-            </a:solidFill>
-            <a:prstDash val="solid"/>
-          </a:ln>
-        </p:spPr>
-      </p:sp>
-      <p:sp>
-        <p:nvSpPr>
-          <p:cNvPr id="17" name="Text 15"/>
-          <p:cNvSpPr/>
-          <p:nvPr/>
-        </p:nvSpPr>
-        <p:spPr>
-          <a:xfrm>
-            <a:off x="7434072" y="1993392"/>
-            <a:ext cx="1682496" cy="274320"/>
+              <a:t>API2</a:t>
+            </a:r>
+            <a:endParaRPr lang="en-US" sz="1200" dirty="0"/>
+          </a:p>
+        </p:txBody>
+      </p:sp>
+      <p:sp>
+        <p:nvSpPr>
+          <p:cNvPr id="8" name="Text 6"/>
+          <p:cNvSpPr/>
+          <p:nvPr/>
+        </p:nvSpPr>
+        <p:spPr>
+          <a:xfrm>
+            <a:off x="1481328" y="2487168"/>
+            <a:ext cx="2834640" cy="365760"/>
           </a:xfrm>
           <a:prstGeom prst="rect">
             <a:avLst/>
@@ -8180,11 +7968,11 @@
           <a:bodyPr wrap="square" lIns="0" tIns="0" rIns="0" bIns="0" rtlCol="0" anchor="ctr"/>
           <a:lstStyle/>
           <a:p>
-            <a:pPr algn="ctr" indent="0" marL="0">
-              <a:buNone/>
-            </a:pPr>
-            <a:r>
-              <a:rPr lang="en-US" sz="1100" b="1" dirty="0">
+            <a:pPr indent="0" marL="0">
+              <a:buNone/>
+            </a:pPr>
+            <a:r>
+              <a:rPr lang="en-US" sz="1200" b="1" dirty="0">
                 <a:solidFill>
                   <a:srgbClr val="1A1C2E"/>
                 </a:solidFill>
@@ -8192,41 +7980,38 @@
                 <a:ea typeface="Arial" pitchFamily="34" charset="-122"/>
                 <a:cs typeface="Arial" pitchFamily="34" charset="-120"/>
               </a:rPr>
-              <a:t>Publicación</a:t>
-            </a:r>
-            <a:endParaRPr lang="en-US" sz="1100" dirty="0"/>
-          </a:p>
-        </p:txBody>
-      </p:sp>
-      <p:sp>
-        <p:nvSpPr>
-          <p:cNvPr id="18" name="Text 16"/>
-          <p:cNvSpPr/>
-          <p:nvPr/>
-        </p:nvSpPr>
-        <p:spPr>
-          <a:xfrm>
-            <a:off x="7434072" y="2276856"/>
-            <a:ext cx="1682496" cy="384048"/>
-          </a:xfrm>
-          <a:prstGeom prst="rect">
-            <a:avLst/>
-          </a:prstGeom>
-          <a:noFill/>
-          <a:ln/>
-        </p:spPr>
-        <p:txBody>
-          <a:bodyPr wrap="square" lIns="0" tIns="0" rIns="0" bIns="0" rtlCol="0" anchor="t"/>
-          <a:lstStyle/>
-          <a:p>
-            <a:pPr algn="ctr" indent="0" marL="0">
-              <a:lnSpc>
-                <a:spcPts val="1200"/>
-              </a:lnSpc>
-              <a:buNone/>
-            </a:pPr>
-            <a:r>
-              <a:rPr lang="en-US" sz="950" dirty="0">
+              <a:t>Autenticación</a:t>
+            </a:r>
+            <a:endParaRPr lang="en-US" sz="1200" dirty="0"/>
+          </a:p>
+        </p:txBody>
+      </p:sp>
+      <p:sp>
+        <p:nvSpPr>
+          <p:cNvPr id="9" name="Text 7"/>
+          <p:cNvSpPr/>
+          <p:nvPr/>
+        </p:nvSpPr>
+        <p:spPr>
+          <a:xfrm>
+            <a:off x="4389120" y="2487168"/>
+            <a:ext cx="6995160" cy="365760"/>
+          </a:xfrm>
+          <a:prstGeom prst="rect">
+            <a:avLst/>
+          </a:prstGeom>
+          <a:noFill/>
+          <a:ln/>
+        </p:spPr>
+        <p:txBody>
+          <a:bodyPr wrap="square" lIns="0" tIns="0" rIns="0" bIns="0" rtlCol="0" anchor="ctr"/>
+          <a:lstStyle/>
+          <a:p>
+            <a:pPr indent="0" marL="0">
+              <a:buNone/>
+            </a:pPr>
+            <a:r>
+              <a:rPr lang="en-US" sz="1300" dirty="0">
                 <a:solidFill>
                   <a:srgbClr val="5A5F73"/>
                 </a:solidFill>
@@ -8234,93 +8019,22 @@
                 <a:ea typeface="Calibri" pitchFamily="34" charset="-122"/>
                 <a:cs typeface="Calibri" pitchFamily="34" charset="-120"/>
               </a:rPr>
-              <a:t>registro de</a:t>
-            </a:r>
-            <a:endParaRPr lang="en-US" sz="950" dirty="0"/>
-          </a:p>
-          <a:p>
-            <a:pPr algn="ctr" indent="0" marL="0">
-              <a:lnSpc>
-                <a:spcPts val="1200"/>
-              </a:lnSpc>
-              <a:buNone/>
-            </a:pPr>
-            <a:r>
-              <a:rPr lang="en-US" sz="950" dirty="0">
-                <a:solidFill>
-                  <a:srgbClr val="5A5F73"/>
-                </a:solidFill>
-                <a:latin typeface="Calibri" pitchFamily="34" charset="0"/>
-                <a:ea typeface="Calibri" pitchFamily="34" charset="-122"/>
-                <a:cs typeface="Calibri" pitchFamily="34" charset="-120"/>
-              </a:rPr>
-              <a:t>contenedores</a:t>
-            </a:r>
-            <a:endParaRPr lang="en-US" sz="950" dirty="0"/>
-          </a:p>
-        </p:txBody>
-      </p:sp>
-      <p:sp>
-        <p:nvSpPr>
-          <p:cNvPr id="19" name="Shape 17"/>
-          <p:cNvSpPr/>
-          <p:nvPr/>
-        </p:nvSpPr>
-        <p:spPr>
-          <a:xfrm>
-            <a:off x="9262872" y="2308860"/>
-            <a:ext cx="219456" cy="0"/>
-          </a:xfrm>
-          <a:prstGeom prst="line">
-            <a:avLst/>
-          </a:prstGeom>
-          <a:noFill/>
-          <a:ln w="19050">
-            <a:solidFill>
-              <a:srgbClr val="202CFC"/>
-            </a:solidFill>
-            <a:prstDash val="solid"/>
-            <a:tailEnd type="triangle"/>
-          </a:ln>
-        </p:spPr>
-      </p:sp>
-      <p:sp>
-        <p:nvSpPr>
-          <p:cNvPr id="20" name="Shape 18"/>
-          <p:cNvSpPr/>
-          <p:nvPr/>
-        </p:nvSpPr>
-        <p:spPr>
-          <a:xfrm>
-            <a:off x="9555480" y="1874520"/>
-            <a:ext cx="1828800" cy="868680"/>
-          </a:xfrm>
-          <a:prstGeom prst="roundRect">
-            <a:avLst>
-              <a:gd name="adj" fmla="val 6316"/>
-            </a:avLst>
-          </a:prstGeom>
-          <a:solidFill>
-            <a:srgbClr val="1A1C2E"/>
-          </a:solidFill>
-          <a:ln w="12700">
-            <a:solidFill>
-              <a:srgbClr val="1A1C2E"/>
-            </a:solidFill>
-            <a:prstDash val="solid"/>
-          </a:ln>
-        </p:spPr>
-      </p:sp>
-      <p:sp>
-        <p:nvSpPr>
-          <p:cNvPr id="21" name="Text 19"/>
-          <p:cNvSpPr/>
-          <p:nvPr/>
-        </p:nvSpPr>
-        <p:spPr>
-          <a:xfrm>
-            <a:off x="9628632" y="1993392"/>
-            <a:ext cx="1682496" cy="274320"/>
+              <a:t>bcrypt de 12 rondas, rotación de refresh tokens y bloqueo de cuenta a los 5 fallos</a:t>
+            </a:r>
+            <a:endParaRPr lang="en-US" sz="1300" dirty="0"/>
+          </a:p>
+        </p:txBody>
+      </p:sp>
+      <p:sp>
+        <p:nvSpPr>
+          <p:cNvPr id="10" name="Text 8"/>
+          <p:cNvSpPr/>
+          <p:nvPr/>
+        </p:nvSpPr>
+        <p:spPr>
+          <a:xfrm>
+            <a:off x="777240" y="2889504"/>
+            <a:ext cx="685800" cy="365760"/>
           </a:xfrm>
           <a:prstGeom prst="rect">
             <a:avLst/>
@@ -8332,269 +8046,128 @@
           <a:bodyPr wrap="square" lIns="0" tIns="0" rIns="0" bIns="0" rtlCol="0" anchor="ctr"/>
           <a:lstStyle/>
           <a:p>
-            <a:pPr algn="ctr" indent="0" marL="0">
-              <a:buNone/>
-            </a:pPr>
-            <a:r>
-              <a:rPr lang="en-US" sz="1100" b="1" dirty="0">
-                <a:solidFill>
-                  <a:srgbClr val="FFFFFF"/>
+            <a:pPr indent="0" marL="0">
+              <a:buNone/>
+            </a:pPr>
+            <a:r>
+              <a:rPr lang="en-US" sz="1200" b="1" dirty="0">
+                <a:solidFill>
+                  <a:srgbClr val="202CFC"/>
                 </a:solidFill>
                 <a:latin typeface="Arial" pitchFamily="34" charset="0"/>
                 <a:ea typeface="Arial" pitchFamily="34" charset="-122"/>
                 <a:cs typeface="Arial" pitchFamily="34" charset="-120"/>
               </a:rPr>
-              <a:t>Producción</a:t>
-            </a:r>
-            <a:endParaRPr lang="en-US" sz="1100" dirty="0"/>
-          </a:p>
-        </p:txBody>
-      </p:sp>
-      <p:sp>
-        <p:nvSpPr>
-          <p:cNvPr id="22" name="Text 20"/>
-          <p:cNvSpPr/>
-          <p:nvPr/>
-        </p:nvSpPr>
-        <p:spPr>
-          <a:xfrm>
-            <a:off x="9628632" y="2276856"/>
-            <a:ext cx="1682496" cy="384048"/>
-          </a:xfrm>
-          <a:prstGeom prst="rect">
-            <a:avLst/>
-          </a:prstGeom>
-          <a:noFill/>
-          <a:ln/>
-        </p:spPr>
-        <p:txBody>
-          <a:bodyPr wrap="square" lIns="0" tIns="0" rIns="0" bIns="0" rtlCol="0" anchor="t"/>
-          <a:lstStyle/>
-          <a:p>
-            <a:pPr algn="ctr" indent="0" marL="0">
-              <a:lnSpc>
-                <a:spcPts val="1200"/>
-              </a:lnSpc>
-              <a:buNone/>
-            </a:pPr>
-            <a:r>
-              <a:rPr lang="en-US" sz="950" dirty="0">
-                <a:solidFill>
-                  <a:srgbClr val="B8BCCC"/>
-                </a:solidFill>
-                <a:latin typeface="Calibri" pitchFamily="34" charset="0"/>
-                <a:ea typeface="Calibri" pitchFamily="34" charset="-122"/>
-                <a:cs typeface="Calibri" pitchFamily="34" charset="-120"/>
-              </a:rPr>
-              <a:t>el servidor levanta</a:t>
-            </a:r>
-            <a:endParaRPr lang="en-US" sz="950" dirty="0"/>
-          </a:p>
-          <a:p>
-            <a:pPr algn="ctr" indent="0" marL="0">
-              <a:lnSpc>
-                <a:spcPts val="1200"/>
-              </a:lnSpc>
-              <a:buNone/>
-            </a:pPr>
-            <a:r>
-              <a:rPr lang="en-US" sz="950" dirty="0">
-                <a:solidFill>
-                  <a:srgbClr val="B8BCCC"/>
-                </a:solidFill>
-                <a:latin typeface="Calibri" pitchFamily="34" charset="0"/>
-                <a:ea typeface="Calibri" pitchFamily="34" charset="-122"/>
-                <a:cs typeface="Calibri" pitchFamily="34" charset="-120"/>
-              </a:rPr>
-              <a:t>la nueva versión</a:t>
-            </a:r>
-            <a:endParaRPr lang="en-US" sz="950" dirty="0"/>
-          </a:p>
-        </p:txBody>
-      </p:sp>
-      <p:sp>
-        <p:nvSpPr>
-          <p:cNvPr id="23" name="Text 21"/>
-          <p:cNvSpPr/>
-          <p:nvPr/>
-        </p:nvSpPr>
-        <p:spPr>
-          <a:xfrm>
-            <a:off x="777240" y="3127248"/>
-            <a:ext cx="4846320" cy="365760"/>
-          </a:xfrm>
-          <a:prstGeom prst="rect">
-            <a:avLst/>
-          </a:prstGeom>
-          <a:noFill/>
-          <a:ln/>
-        </p:spPr>
-        <p:txBody>
-          <a:bodyPr wrap="square" lIns="0" tIns="0" rIns="0" bIns="0" rtlCol="0" anchor="t"/>
-          <a:lstStyle/>
-          <a:p>
-            <a:pPr indent="0" marL="0">
-              <a:buNone/>
-            </a:pPr>
-            <a:r>
-              <a:rPr lang="en-US" sz="1900" b="1" dirty="0">
-                <a:solidFill>
-                  <a:srgbClr val="202CFC"/>
+              <a:t>API3</a:t>
+            </a:r>
+            <a:endParaRPr lang="en-US" sz="1200" dirty="0"/>
+          </a:p>
+        </p:txBody>
+      </p:sp>
+      <p:sp>
+        <p:nvSpPr>
+          <p:cNvPr id="11" name="Text 9"/>
+          <p:cNvSpPr/>
+          <p:nvPr/>
+        </p:nvSpPr>
+        <p:spPr>
+          <a:xfrm>
+            <a:off x="1481328" y="2889504"/>
+            <a:ext cx="2834640" cy="365760"/>
+          </a:xfrm>
+          <a:prstGeom prst="rect">
+            <a:avLst/>
+          </a:prstGeom>
+          <a:noFill/>
+          <a:ln/>
+        </p:spPr>
+        <p:txBody>
+          <a:bodyPr wrap="square" lIns="0" tIns="0" rIns="0" bIns="0" rtlCol="0" anchor="ctr"/>
+          <a:lstStyle/>
+          <a:p>
+            <a:pPr indent="0" marL="0">
+              <a:buNone/>
+            </a:pPr>
+            <a:r>
+              <a:rPr lang="en-US" sz="1200" b="1" dirty="0">
+                <a:solidFill>
+                  <a:srgbClr val="1A1C2E"/>
                 </a:solidFill>
                 <a:latin typeface="Arial" pitchFamily="34" charset="0"/>
                 <a:ea typeface="Arial" pitchFamily="34" charset="-122"/>
                 <a:cs typeface="Arial" pitchFamily="34" charset="-120"/>
               </a:rPr>
-              <a:t>Integración continua</a:t>
-            </a:r>
-            <a:endParaRPr lang="en-US" sz="1900" dirty="0"/>
-          </a:p>
-        </p:txBody>
-      </p:sp>
-      <p:sp>
-        <p:nvSpPr>
-          <p:cNvPr id="24" name="Text 22"/>
-          <p:cNvSpPr/>
-          <p:nvPr/>
-        </p:nvSpPr>
-        <p:spPr>
-          <a:xfrm>
-            <a:off x="777240" y="3657600"/>
-            <a:ext cx="4846320" cy="2377440"/>
-          </a:xfrm>
-          <a:prstGeom prst="rect">
-            <a:avLst/>
-          </a:prstGeom>
-          <a:noFill/>
-          <a:ln/>
-        </p:spPr>
-        <p:txBody>
-          <a:bodyPr wrap="square" lIns="0" tIns="0" rIns="0" bIns="0" rtlCol="0" anchor="t"/>
-          <a:lstStyle/>
-          <a:p>
-            <a:pPr marL="342900" indent="-342900">
-              <a:lnSpc>
-                <a:spcPts val="2100"/>
-              </a:lnSpc>
-              <a:spcAft>
-                <a:spcPts val="1100"/>
-              </a:spcAft>
-              <a:buSzPct val="100000"/>
-              <a:buChar char="•"/>
-            </a:pPr>
-            <a:r>
-              <a:rPr lang="en-US" sz="1500" dirty="0">
-                <a:solidFill>
-                  <a:srgbClr val="1A1C2E"/>
-                </a:solidFill>
-                <a:latin typeface="Calibri" pitchFamily="34" charset="0"/>
-                <a:ea typeface="Calibri" pitchFamily="34" charset="-122"/>
-                <a:cs typeface="Calibri" pitchFamily="34" charset="-120"/>
-              </a:rPr>
-              <a:t>En cada push y en cada pull request</a:t>
-            </a:r>
-            <a:endParaRPr lang="en-US" sz="1500" dirty="0"/>
-          </a:p>
-          <a:p>
-            <a:pPr marL="342900" indent="-342900">
-              <a:lnSpc>
-                <a:spcPts val="2100"/>
-              </a:lnSpc>
-              <a:spcAft>
-                <a:spcPts val="1100"/>
-              </a:spcAft>
-              <a:buSzPct val="100000"/>
-              <a:buChar char="•"/>
-            </a:pPr>
-            <a:r>
-              <a:rPr lang="en-US" sz="1500" dirty="0">
-                <a:solidFill>
-                  <a:srgbClr val="1A1C2E"/>
-                </a:solidFill>
-                <a:latin typeface="Calibri" pitchFamily="34" charset="0"/>
-                <a:ea typeface="Calibri" pitchFamily="34" charset="-122"/>
-                <a:cs typeface="Calibri" pitchFamily="34" charset="-120"/>
-              </a:rPr>
-              <a:t>Las dos aplicaciones en paralelo, sobre Node 22</a:t>
-            </a:r>
-            <a:endParaRPr lang="en-US" sz="1500" dirty="0"/>
-          </a:p>
-          <a:p>
-            <a:pPr marL="342900" indent="-342900">
-              <a:lnSpc>
-                <a:spcPts val="2100"/>
-              </a:lnSpc>
-              <a:spcAft>
-                <a:spcPts val="1100"/>
-              </a:spcAft>
-              <a:buSzPct val="100000"/>
-              <a:buChar char="•"/>
-            </a:pPr>
-            <a:r>
-              <a:rPr lang="en-US" sz="1500" dirty="0">
-                <a:solidFill>
-                  <a:srgbClr val="1A1C2E"/>
-                </a:solidFill>
-                <a:latin typeface="Calibri" pitchFamily="34" charset="0"/>
-                <a:ea typeface="Calibri" pitchFamily="34" charset="-122"/>
-                <a:cs typeface="Calibri" pitchFamily="34" charset="-120"/>
-              </a:rPr>
-              <a:t>Lint, formato, pruebas, compilación y typecheck</a:t>
-            </a:r>
-            <a:endParaRPr lang="en-US" sz="1500" dirty="0"/>
-          </a:p>
-          <a:p>
-            <a:pPr marL="342900" indent="-342900">
-              <a:lnSpc>
-                <a:spcPts val="2100"/>
-              </a:lnSpc>
-              <a:spcAft>
-                <a:spcPts val="1100"/>
-              </a:spcAft>
-              <a:buSzPct val="100000"/>
-              <a:buChar char="•"/>
-            </a:pPr>
-            <a:r>
-              <a:rPr lang="en-US" sz="1500" dirty="0">
-                <a:solidFill>
-                  <a:srgbClr val="1A1C2E"/>
-                </a:solidFill>
-                <a:latin typeface="Calibri" pitchFamily="34" charset="0"/>
-                <a:ea typeface="Calibri" pitchFamily="34" charset="-122"/>
-                <a:cs typeface="Calibri" pitchFamily="34" charset="-120"/>
-              </a:rPr>
-              <a:t>Auditoría de dependencias, que detiene la entrega ante una vulnerabilidad crítica</a:t>
-            </a:r>
-            <a:endParaRPr lang="en-US" sz="1500" dirty="0"/>
-          </a:p>
-        </p:txBody>
-      </p:sp>
-      <p:sp>
-        <p:nvSpPr>
-          <p:cNvPr id="25" name="Text 23"/>
-          <p:cNvSpPr/>
-          <p:nvPr/>
-        </p:nvSpPr>
-        <p:spPr>
-          <a:xfrm>
-            <a:off x="6537960" y="3127248"/>
-            <a:ext cx="4846320" cy="365760"/>
-          </a:xfrm>
-          <a:prstGeom prst="rect">
-            <a:avLst/>
-          </a:prstGeom>
-          <a:noFill/>
-          <a:ln/>
-        </p:spPr>
-        <p:txBody>
-          <a:bodyPr wrap="square" lIns="0" tIns="0" rIns="0" bIns="0" rtlCol="0" anchor="t"/>
-          <a:lstStyle/>
-          <a:p>
-            <a:pPr indent="0" marL="0">
-              <a:buNone/>
-            </a:pPr>
-            <a:r>
-              <a:rPr lang="en-US" sz="1900" b="1" dirty="0">
+              <a:t>Propiedades del objeto</a:t>
+            </a:r>
+            <a:endParaRPr lang="en-US" sz="1200" dirty="0"/>
+          </a:p>
+        </p:txBody>
+      </p:sp>
+      <p:sp>
+        <p:nvSpPr>
+          <p:cNvPr id="12" name="Text 10"/>
+          <p:cNvSpPr/>
+          <p:nvPr/>
+        </p:nvSpPr>
+        <p:spPr>
+          <a:xfrm>
+            <a:off x="4389120" y="2889504"/>
+            <a:ext cx="6995160" cy="365760"/>
+          </a:xfrm>
+          <a:prstGeom prst="rect">
+            <a:avLst/>
+          </a:prstGeom>
+          <a:noFill/>
+          <a:ln/>
+        </p:spPr>
+        <p:txBody>
+          <a:bodyPr wrap="square" lIns="0" tIns="0" rIns="0" bIns="0" rtlCol="0" anchor="ctr"/>
+          <a:lstStyle/>
+          <a:p>
+            <a:pPr indent="0" marL="0">
+              <a:buNone/>
+            </a:pPr>
+            <a:r>
+              <a:rPr lang="en-US" sz="1300" dirty="0">
+                <a:solidFill>
+                  <a:srgbClr val="5A5F73"/>
+                </a:solidFill>
+                <a:latin typeface="Calibri" pitchFamily="34" charset="0"/>
+                <a:ea typeface="Calibri" pitchFamily="34" charset="-122"/>
+                <a:cs typeface="Calibri" pitchFamily="34" charset="-120"/>
+              </a:rPr>
+              <a:t>Los esquemas Zod son la allowlist de campos: lo no declarado no entra</a:t>
+            </a:r>
+            <a:endParaRPr lang="en-US" sz="1300" dirty="0"/>
+          </a:p>
+        </p:txBody>
+      </p:sp>
+      <p:sp>
+        <p:nvSpPr>
+          <p:cNvPr id="13" name="Text 11"/>
+          <p:cNvSpPr/>
+          <p:nvPr/>
+        </p:nvSpPr>
+        <p:spPr>
+          <a:xfrm>
+            <a:off x="777240" y="3291840"/>
+            <a:ext cx="685800" cy="365760"/>
+          </a:xfrm>
+          <a:prstGeom prst="rect">
+            <a:avLst/>
+          </a:prstGeom>
+          <a:noFill/>
+          <a:ln/>
+        </p:spPr>
+        <p:txBody>
+          <a:bodyPr wrap="square" lIns="0" tIns="0" rIns="0" bIns="0" rtlCol="0" anchor="ctr"/>
+          <a:lstStyle/>
+          <a:p>
+            <a:pPr indent="0" marL="0">
+              <a:buNone/>
+            </a:pPr>
+            <a:r>
+              <a:rPr lang="en-US" sz="1200" b="1" dirty="0">
                 <a:solidFill>
                   <a:srgbClr val="202CFC"/>
                 </a:solidFill>
@@ -8602,9 +8175,477 @@
                 <a:ea typeface="Arial" pitchFamily="34" charset="-122"/>
                 <a:cs typeface="Arial" pitchFamily="34" charset="-120"/>
               </a:rPr>
-              <a:t>Despliegue continuo</a:t>
-            </a:r>
-            <a:endParaRPr lang="en-US" sz="1900" dirty="0"/>
+              <a:t>API4</a:t>
+            </a:r>
+            <a:endParaRPr lang="en-US" sz="1200" dirty="0"/>
+          </a:p>
+        </p:txBody>
+      </p:sp>
+      <p:sp>
+        <p:nvSpPr>
+          <p:cNvPr id="14" name="Text 12"/>
+          <p:cNvSpPr/>
+          <p:nvPr/>
+        </p:nvSpPr>
+        <p:spPr>
+          <a:xfrm>
+            <a:off x="1481328" y="3291840"/>
+            <a:ext cx="2834640" cy="365760"/>
+          </a:xfrm>
+          <a:prstGeom prst="rect">
+            <a:avLst/>
+          </a:prstGeom>
+          <a:noFill/>
+          <a:ln/>
+        </p:spPr>
+        <p:txBody>
+          <a:bodyPr wrap="square" lIns="0" tIns="0" rIns="0" bIns="0" rtlCol="0" anchor="ctr"/>
+          <a:lstStyle/>
+          <a:p>
+            <a:pPr indent="0" marL="0">
+              <a:buNone/>
+            </a:pPr>
+            <a:r>
+              <a:rPr lang="en-US" sz="1200" b="1" dirty="0">
+                <a:solidFill>
+                  <a:srgbClr val="1A1C2E"/>
+                </a:solidFill>
+                <a:latin typeface="Arial" pitchFamily="34" charset="0"/>
+                <a:ea typeface="Arial" pitchFamily="34" charset="-122"/>
+                <a:cs typeface="Arial" pitchFamily="34" charset="-120"/>
+              </a:rPr>
+              <a:t>Consumo de recursos</a:t>
+            </a:r>
+            <a:endParaRPr lang="en-US" sz="1200" dirty="0"/>
+          </a:p>
+        </p:txBody>
+      </p:sp>
+      <p:sp>
+        <p:nvSpPr>
+          <p:cNvPr id="15" name="Text 13"/>
+          <p:cNvSpPr/>
+          <p:nvPr/>
+        </p:nvSpPr>
+        <p:spPr>
+          <a:xfrm>
+            <a:off x="4389120" y="3291840"/>
+            <a:ext cx="6995160" cy="365760"/>
+          </a:xfrm>
+          <a:prstGeom prst="rect">
+            <a:avLst/>
+          </a:prstGeom>
+          <a:noFill/>
+          <a:ln/>
+        </p:spPr>
+        <p:txBody>
+          <a:bodyPr wrap="square" lIns="0" tIns="0" rIns="0" bIns="0" rtlCol="0" anchor="ctr"/>
+          <a:lstStyle/>
+          <a:p>
+            <a:pPr indent="0" marL="0">
+              <a:buNone/>
+            </a:pPr>
+            <a:r>
+              <a:rPr lang="en-US" sz="1300" dirty="0">
+                <a:solidFill>
+                  <a:srgbClr val="5A5F73"/>
+                </a:solidFill>
+                <a:latin typeface="Calibri" pitchFamily="34" charset="0"/>
+                <a:ea typeface="Calibri" pitchFamily="34" charset="-122"/>
+                <a:cs typeface="Calibri" pitchFamily="34" charset="-120"/>
+              </a:rPr>
+              <a:t>Límites por familia: login 5/min, diagnóstico 20/min, cognitivo 5/min; body de 10 KB</a:t>
+            </a:r>
+            <a:endParaRPr lang="en-US" sz="1300" dirty="0"/>
+          </a:p>
+        </p:txBody>
+      </p:sp>
+      <p:sp>
+        <p:nvSpPr>
+          <p:cNvPr id="16" name="Text 14"/>
+          <p:cNvSpPr/>
+          <p:nvPr/>
+        </p:nvSpPr>
+        <p:spPr>
+          <a:xfrm>
+            <a:off x="777240" y="3694176"/>
+            <a:ext cx="685800" cy="365760"/>
+          </a:xfrm>
+          <a:prstGeom prst="rect">
+            <a:avLst/>
+          </a:prstGeom>
+          <a:noFill/>
+          <a:ln/>
+        </p:spPr>
+        <p:txBody>
+          <a:bodyPr wrap="square" lIns="0" tIns="0" rIns="0" bIns="0" rtlCol="0" anchor="ctr"/>
+          <a:lstStyle/>
+          <a:p>
+            <a:pPr indent="0" marL="0">
+              <a:buNone/>
+            </a:pPr>
+            <a:r>
+              <a:rPr lang="en-US" sz="1200" b="1" dirty="0">
+                <a:solidFill>
+                  <a:srgbClr val="202CFC"/>
+                </a:solidFill>
+                <a:latin typeface="Arial" pitchFamily="34" charset="0"/>
+                <a:ea typeface="Arial" pitchFamily="34" charset="-122"/>
+                <a:cs typeface="Arial" pitchFamily="34" charset="-120"/>
+              </a:rPr>
+              <a:t>API5</a:t>
+            </a:r>
+            <a:endParaRPr lang="en-US" sz="1200" dirty="0"/>
+          </a:p>
+        </p:txBody>
+      </p:sp>
+      <p:sp>
+        <p:nvSpPr>
+          <p:cNvPr id="17" name="Text 15"/>
+          <p:cNvSpPr/>
+          <p:nvPr/>
+        </p:nvSpPr>
+        <p:spPr>
+          <a:xfrm>
+            <a:off x="1481328" y="3694176"/>
+            <a:ext cx="2834640" cy="365760"/>
+          </a:xfrm>
+          <a:prstGeom prst="rect">
+            <a:avLst/>
+          </a:prstGeom>
+          <a:noFill/>
+          <a:ln/>
+        </p:spPr>
+        <p:txBody>
+          <a:bodyPr wrap="square" lIns="0" tIns="0" rIns="0" bIns="0" rtlCol="0" anchor="ctr"/>
+          <a:lstStyle/>
+          <a:p>
+            <a:pPr indent="0" marL="0">
+              <a:buNone/>
+            </a:pPr>
+            <a:r>
+              <a:rPr lang="en-US" sz="1200" b="1" dirty="0">
+                <a:solidFill>
+                  <a:srgbClr val="1A1C2E"/>
+                </a:solidFill>
+                <a:latin typeface="Arial" pitchFamily="34" charset="0"/>
+                <a:ea typeface="Arial" pitchFamily="34" charset="-122"/>
+                <a:cs typeface="Arial" pitchFamily="34" charset="-120"/>
+              </a:rPr>
+              <a:t>Autorización de función</a:t>
+            </a:r>
+            <a:endParaRPr lang="en-US" sz="1200" dirty="0"/>
+          </a:p>
+        </p:txBody>
+      </p:sp>
+      <p:sp>
+        <p:nvSpPr>
+          <p:cNvPr id="18" name="Text 16"/>
+          <p:cNvSpPr/>
+          <p:nvPr/>
+        </p:nvSpPr>
+        <p:spPr>
+          <a:xfrm>
+            <a:off x="4389120" y="3694176"/>
+            <a:ext cx="6995160" cy="365760"/>
+          </a:xfrm>
+          <a:prstGeom prst="rect">
+            <a:avLst/>
+          </a:prstGeom>
+          <a:noFill/>
+          <a:ln/>
+        </p:spPr>
+        <p:txBody>
+          <a:bodyPr wrap="square" lIns="0" tIns="0" rIns="0" bIns="0" rtlCol="0" anchor="ctr"/>
+          <a:lstStyle/>
+          <a:p>
+            <a:pPr indent="0" marL="0">
+              <a:buNone/>
+            </a:pPr>
+            <a:r>
+              <a:rPr lang="en-US" sz="1300" dirty="0">
+                <a:solidFill>
+                  <a:srgbClr val="5A5F73"/>
+                </a:solidFill>
+                <a:latin typeface="Calibri" pitchFamily="34" charset="0"/>
+                <a:ea typeface="Calibri" pitchFamily="34" charset="-122"/>
+                <a:cs typeface="Calibri" pitchFamily="34" charset="-120"/>
+              </a:rPr>
+              <a:t>Todo /api tras el middleware de sesión; administración tras requireAdmin</a:t>
+            </a:r>
+            <a:endParaRPr lang="en-US" sz="1300" dirty="0"/>
+          </a:p>
+        </p:txBody>
+      </p:sp>
+      <p:sp>
+        <p:nvSpPr>
+          <p:cNvPr id="19" name="Text 17"/>
+          <p:cNvSpPr/>
+          <p:nvPr/>
+        </p:nvSpPr>
+        <p:spPr>
+          <a:xfrm>
+            <a:off x="777240" y="4096512"/>
+            <a:ext cx="685800" cy="365760"/>
+          </a:xfrm>
+          <a:prstGeom prst="rect">
+            <a:avLst/>
+          </a:prstGeom>
+          <a:noFill/>
+          <a:ln/>
+        </p:spPr>
+        <p:txBody>
+          <a:bodyPr wrap="square" lIns="0" tIns="0" rIns="0" bIns="0" rtlCol="0" anchor="ctr"/>
+          <a:lstStyle/>
+          <a:p>
+            <a:pPr indent="0" marL="0">
+              <a:buNone/>
+            </a:pPr>
+            <a:r>
+              <a:rPr lang="en-US" sz="1200" b="1" dirty="0">
+                <a:solidFill>
+                  <a:srgbClr val="202CFC"/>
+                </a:solidFill>
+                <a:latin typeface="Arial" pitchFamily="34" charset="0"/>
+                <a:ea typeface="Arial" pitchFamily="34" charset="-122"/>
+                <a:cs typeface="Arial" pitchFamily="34" charset="-120"/>
+              </a:rPr>
+              <a:t>API6</a:t>
+            </a:r>
+            <a:endParaRPr lang="en-US" sz="1200" dirty="0"/>
+          </a:p>
+        </p:txBody>
+      </p:sp>
+      <p:sp>
+        <p:nvSpPr>
+          <p:cNvPr id="20" name="Text 18"/>
+          <p:cNvSpPr/>
+          <p:nvPr/>
+        </p:nvSpPr>
+        <p:spPr>
+          <a:xfrm>
+            <a:off x="1481328" y="4096512"/>
+            <a:ext cx="2834640" cy="365760"/>
+          </a:xfrm>
+          <a:prstGeom prst="rect">
+            <a:avLst/>
+          </a:prstGeom>
+          <a:noFill/>
+          <a:ln/>
+        </p:spPr>
+        <p:txBody>
+          <a:bodyPr wrap="square" lIns="0" tIns="0" rIns="0" bIns="0" rtlCol="0" anchor="ctr"/>
+          <a:lstStyle/>
+          <a:p>
+            <a:pPr indent="0" marL="0">
+              <a:buNone/>
+            </a:pPr>
+            <a:r>
+              <a:rPr lang="en-US" sz="1200" b="1" dirty="0">
+                <a:solidFill>
+                  <a:srgbClr val="1A1C2E"/>
+                </a:solidFill>
+                <a:latin typeface="Arial" pitchFamily="34" charset="0"/>
+                <a:ea typeface="Arial" pitchFamily="34" charset="-122"/>
+                <a:cs typeface="Arial" pitchFamily="34" charset="-120"/>
+              </a:rPr>
+              <a:t>Flujos de negocio sensibles</a:t>
+            </a:r>
+            <a:endParaRPr lang="en-US" sz="1200" dirty="0"/>
+          </a:p>
+        </p:txBody>
+      </p:sp>
+      <p:sp>
+        <p:nvSpPr>
+          <p:cNvPr id="21" name="Text 19"/>
+          <p:cNvSpPr/>
+          <p:nvPr/>
+        </p:nvSpPr>
+        <p:spPr>
+          <a:xfrm>
+            <a:off x="4389120" y="4096512"/>
+            <a:ext cx="6995160" cy="365760"/>
+          </a:xfrm>
+          <a:prstGeom prst="rect">
+            <a:avLst/>
+          </a:prstGeom>
+          <a:noFill/>
+          <a:ln/>
+        </p:spPr>
+        <p:txBody>
+          <a:bodyPr wrap="square" lIns="0" tIns="0" rIns="0" bIns="0" rtlCol="0" anchor="ctr"/>
+          <a:lstStyle/>
+          <a:p>
+            <a:pPr indent="0" marL="0">
+              <a:buNone/>
+            </a:pPr>
+            <a:r>
+              <a:rPr lang="en-US" sz="1300" dirty="0">
+                <a:solidFill>
+                  <a:srgbClr val="5A5F73"/>
+                </a:solidFill>
+                <a:latin typeface="Calibri" pitchFamily="34" charset="0"/>
+                <a:ea typeface="Calibri" pitchFamily="34" charset="-122"/>
+                <a:cs typeface="Calibri" pitchFamily="34" charset="-120"/>
+              </a:rPr>
+              <a:t>El borrado de códigos de avería lleva límite propio y se apaga con OBD_READ_ONLY</a:t>
+            </a:r>
+            <a:endParaRPr lang="en-US" sz="1300" dirty="0"/>
+          </a:p>
+        </p:txBody>
+      </p:sp>
+      <p:sp>
+        <p:nvSpPr>
+          <p:cNvPr id="22" name="Text 20"/>
+          <p:cNvSpPr/>
+          <p:nvPr/>
+        </p:nvSpPr>
+        <p:spPr>
+          <a:xfrm>
+            <a:off x="777240" y="4498848"/>
+            <a:ext cx="685800" cy="365760"/>
+          </a:xfrm>
+          <a:prstGeom prst="rect">
+            <a:avLst/>
+          </a:prstGeom>
+          <a:noFill/>
+          <a:ln/>
+        </p:spPr>
+        <p:txBody>
+          <a:bodyPr wrap="square" lIns="0" tIns="0" rIns="0" bIns="0" rtlCol="0" anchor="ctr"/>
+          <a:lstStyle/>
+          <a:p>
+            <a:pPr indent="0" marL="0">
+              <a:buNone/>
+            </a:pPr>
+            <a:r>
+              <a:rPr lang="en-US" sz="1200" b="1" dirty="0">
+                <a:solidFill>
+                  <a:srgbClr val="202CFC"/>
+                </a:solidFill>
+                <a:latin typeface="Arial" pitchFamily="34" charset="0"/>
+                <a:ea typeface="Arial" pitchFamily="34" charset="-122"/>
+                <a:cs typeface="Arial" pitchFamily="34" charset="-120"/>
+              </a:rPr>
+              <a:t>API7</a:t>
+            </a:r>
+            <a:endParaRPr lang="en-US" sz="1200" dirty="0"/>
+          </a:p>
+        </p:txBody>
+      </p:sp>
+      <p:sp>
+        <p:nvSpPr>
+          <p:cNvPr id="23" name="Text 21"/>
+          <p:cNvSpPr/>
+          <p:nvPr/>
+        </p:nvSpPr>
+        <p:spPr>
+          <a:xfrm>
+            <a:off x="1481328" y="4498848"/>
+            <a:ext cx="2834640" cy="365760"/>
+          </a:xfrm>
+          <a:prstGeom prst="rect">
+            <a:avLst/>
+          </a:prstGeom>
+          <a:noFill/>
+          <a:ln/>
+        </p:spPr>
+        <p:txBody>
+          <a:bodyPr wrap="square" lIns="0" tIns="0" rIns="0" bIns="0" rtlCol="0" anchor="ctr"/>
+          <a:lstStyle/>
+          <a:p>
+            <a:pPr indent="0" marL="0">
+              <a:buNone/>
+            </a:pPr>
+            <a:r>
+              <a:rPr lang="en-US" sz="1200" b="1" dirty="0">
+                <a:solidFill>
+                  <a:srgbClr val="1A1C2E"/>
+                </a:solidFill>
+                <a:latin typeface="Arial" pitchFamily="34" charset="0"/>
+                <a:ea typeface="Arial" pitchFamily="34" charset="-122"/>
+                <a:cs typeface="Arial" pitchFamily="34" charset="-120"/>
+              </a:rPr>
+              <a:t>SSRF</a:t>
+            </a:r>
+            <a:endParaRPr lang="en-US" sz="1200" dirty="0"/>
+          </a:p>
+        </p:txBody>
+      </p:sp>
+      <p:sp>
+        <p:nvSpPr>
+          <p:cNvPr id="24" name="Text 22"/>
+          <p:cNvSpPr/>
+          <p:nvPr/>
+        </p:nvSpPr>
+        <p:spPr>
+          <a:xfrm>
+            <a:off x="4389120" y="4498848"/>
+            <a:ext cx="6995160" cy="365760"/>
+          </a:xfrm>
+          <a:prstGeom prst="rect">
+            <a:avLst/>
+          </a:prstGeom>
+          <a:noFill/>
+          <a:ln/>
+        </p:spPr>
+        <p:txBody>
+          <a:bodyPr wrap="square" lIns="0" tIns="0" rIns="0" bIns="0" rtlCol="0" anchor="ctr"/>
+          <a:lstStyle/>
+          <a:p>
+            <a:pPr indent="0" marL="0">
+              <a:buNone/>
+            </a:pPr>
+            <a:r>
+              <a:rPr lang="en-US" sz="1300" dirty="0">
+                <a:solidFill>
+                  <a:srgbClr val="5A5F73"/>
+                </a:solidFill>
+                <a:latin typeface="Calibri" pitchFamily="34" charset="0"/>
+                <a:ea typeface="Calibri" pitchFamily="34" charset="-122"/>
+                <a:cs typeface="Calibri" pitchFamily="34" charset="-120"/>
+              </a:rPr>
+              <a:t>El usuario no controla ninguna URL de salida: proveedor fijo y timeout de 30 s</a:t>
+            </a:r>
+            <a:endParaRPr lang="en-US" sz="1300" dirty="0"/>
+          </a:p>
+        </p:txBody>
+      </p:sp>
+      <p:sp>
+        <p:nvSpPr>
+          <p:cNvPr id="25" name="Text 23"/>
+          <p:cNvSpPr/>
+          <p:nvPr/>
+        </p:nvSpPr>
+        <p:spPr>
+          <a:xfrm>
+            <a:off x="777240" y="4901184"/>
+            <a:ext cx="685800" cy="365760"/>
+          </a:xfrm>
+          <a:prstGeom prst="rect">
+            <a:avLst/>
+          </a:prstGeom>
+          <a:noFill/>
+          <a:ln/>
+        </p:spPr>
+        <p:txBody>
+          <a:bodyPr wrap="square" lIns="0" tIns="0" rIns="0" bIns="0" rtlCol="0" anchor="ctr"/>
+          <a:lstStyle/>
+          <a:p>
+            <a:pPr indent="0" marL="0">
+              <a:buNone/>
+            </a:pPr>
+            <a:r>
+              <a:rPr lang="en-US" sz="1200" b="1" dirty="0">
+                <a:solidFill>
+                  <a:srgbClr val="202CFC"/>
+                </a:solidFill>
+                <a:latin typeface="Arial" pitchFamily="34" charset="0"/>
+                <a:ea typeface="Arial" pitchFamily="34" charset="-122"/>
+                <a:cs typeface="Arial" pitchFamily="34" charset="-120"/>
+              </a:rPr>
+              <a:t>API8</a:t>
+            </a:r>
+            <a:endParaRPr lang="en-US" sz="1200" dirty="0"/>
           </a:p>
         </p:txBody>
       </p:sp>
@@ -8616,119 +8657,313 @@
         </p:nvSpPr>
         <p:spPr>
           <a:xfrm>
-            <a:off x="6537960" y="3657600"/>
-            <a:ext cx="4846320" cy="2377440"/>
-          </a:xfrm>
-          <a:prstGeom prst="rect">
-            <a:avLst/>
-          </a:prstGeom>
-          <a:noFill/>
-          <a:ln/>
-        </p:spPr>
-        <p:txBody>
-          <a:bodyPr wrap="square" lIns="0" tIns="0" rIns="0" bIns="0" rtlCol="0" anchor="t"/>
-          <a:lstStyle/>
-          <a:p>
-            <a:pPr marL="342900" indent="-342900">
-              <a:lnSpc>
-                <a:spcPts val="2100"/>
-              </a:lnSpc>
-              <a:spcAft>
-                <a:spcPts val="1100"/>
-              </a:spcAft>
-              <a:buSzPct val="100000"/>
-              <a:buChar char="•"/>
-            </a:pPr>
-            <a:r>
-              <a:rPr lang="en-US" sz="1500" dirty="0">
-                <a:solidFill>
-                  <a:srgbClr val="1A1C2E"/>
-                </a:solidFill>
-                <a:latin typeface="Calibri" pitchFamily="34" charset="0"/>
-                <a:ea typeface="Calibri" pitchFamily="34" charset="-122"/>
-                <a:cs typeface="Calibri" pitchFamily="34" charset="-120"/>
-              </a:rPr>
-              <a:t>Se dispara al integrar en main</a:t>
-            </a:r>
-            <a:endParaRPr lang="en-US" sz="1500" dirty="0"/>
-          </a:p>
-          <a:p>
-            <a:pPr marL="342900" indent="-342900">
-              <a:lnSpc>
-                <a:spcPts val="2100"/>
-              </a:lnSpc>
-              <a:spcAft>
-                <a:spcPts val="1100"/>
-              </a:spcAft>
-              <a:buSzPct val="100000"/>
-              <a:buChar char="•"/>
-            </a:pPr>
-            <a:r>
-              <a:rPr lang="en-US" sz="1500" dirty="0">
-                <a:solidFill>
-                  <a:srgbClr val="1A1C2E"/>
-                </a:solidFill>
-                <a:latin typeface="Calibri" pitchFamily="34" charset="0"/>
-                <a:ea typeface="Calibri" pitchFamily="34" charset="-122"/>
-                <a:cs typeface="Calibri" pitchFamily="34" charset="-120"/>
-              </a:rPr>
-              <a:t>Construye tres imágenes: API, interfaz y emulador</a:t>
-            </a:r>
-            <a:endParaRPr lang="en-US" sz="1500" dirty="0"/>
-          </a:p>
-          <a:p>
-            <a:pPr marL="342900" indent="-342900">
-              <a:lnSpc>
-                <a:spcPts val="2100"/>
-              </a:lnSpc>
-              <a:spcAft>
-                <a:spcPts val="1100"/>
-              </a:spcAft>
-              <a:buSzPct val="100000"/>
-              <a:buChar char="•"/>
-            </a:pPr>
-            <a:r>
-              <a:rPr lang="en-US" sz="1500" dirty="0">
-                <a:solidFill>
-                  <a:srgbClr val="1A1C2E"/>
-                </a:solidFill>
-                <a:latin typeface="Calibri" pitchFamily="34" charset="0"/>
-                <a:ea typeface="Calibri" pitchFamily="34" charset="-122"/>
-                <a:cs typeface="Calibri" pitchFamily="34" charset="-120"/>
-              </a:rPr>
-              <a:t>Las publica en el registro de contenedores de GitHub</a:t>
-            </a:r>
-            <a:endParaRPr lang="en-US" sz="1500" dirty="0"/>
-          </a:p>
-          <a:p>
-            <a:pPr marL="342900" indent="-342900">
-              <a:lnSpc>
-                <a:spcPts val="2100"/>
-              </a:lnSpc>
-              <a:spcAft>
-                <a:spcPts val="1100"/>
-              </a:spcAft>
-              <a:buSzPct val="100000"/>
-              <a:buChar char="•"/>
-            </a:pPr>
-            <a:r>
-              <a:rPr lang="en-US" sz="1500" dirty="0">
-                <a:solidFill>
-                  <a:srgbClr val="1A1C2E"/>
-                </a:solidFill>
-                <a:latin typeface="Calibri" pitchFamily="34" charset="0"/>
-                <a:ea typeface="Calibri" pitchFamily="34" charset="-122"/>
-                <a:cs typeface="Calibri" pitchFamily="34" charset="-120"/>
-              </a:rPr>
-              <a:t>El servidor las descarga y levanta la nueva versión, sin intervención manual</a:t>
-            </a:r>
-            <a:endParaRPr lang="en-US" sz="1500" dirty="0"/>
-          </a:p>
-        </p:txBody>
-      </p:sp>
-      <p:sp>
-        <p:nvSpPr>
-          <p:cNvPr id="27" name="Shape 25"/>
+            <a:off x="1481328" y="4901184"/>
+            <a:ext cx="2834640" cy="365760"/>
+          </a:xfrm>
+          <a:prstGeom prst="rect">
+            <a:avLst/>
+          </a:prstGeom>
+          <a:noFill/>
+          <a:ln/>
+        </p:spPr>
+        <p:txBody>
+          <a:bodyPr wrap="square" lIns="0" tIns="0" rIns="0" bIns="0" rtlCol="0" anchor="ctr"/>
+          <a:lstStyle/>
+          <a:p>
+            <a:pPr indent="0" marL="0">
+              <a:buNone/>
+            </a:pPr>
+            <a:r>
+              <a:rPr lang="en-US" sz="1200" b="1" dirty="0">
+                <a:solidFill>
+                  <a:srgbClr val="1A1C2E"/>
+                </a:solidFill>
+                <a:latin typeface="Arial" pitchFamily="34" charset="0"/>
+                <a:ea typeface="Arial" pitchFamily="34" charset="-122"/>
+                <a:cs typeface="Arial" pitchFamily="34" charset="-120"/>
+              </a:rPr>
+              <a:t>Configuración</a:t>
+            </a:r>
+            <a:endParaRPr lang="en-US" sz="1200" dirty="0"/>
+          </a:p>
+        </p:txBody>
+      </p:sp>
+      <p:sp>
+        <p:nvSpPr>
+          <p:cNvPr id="27" name="Text 25"/>
+          <p:cNvSpPr/>
+          <p:nvPr/>
+        </p:nvSpPr>
+        <p:spPr>
+          <a:xfrm>
+            <a:off x="4389120" y="4901184"/>
+            <a:ext cx="6995160" cy="365760"/>
+          </a:xfrm>
+          <a:prstGeom prst="rect">
+            <a:avLst/>
+          </a:prstGeom>
+          <a:noFill/>
+          <a:ln/>
+        </p:spPr>
+        <p:txBody>
+          <a:bodyPr wrap="square" lIns="0" tIns="0" rIns="0" bIns="0" rtlCol="0" anchor="ctr"/>
+          <a:lstStyle/>
+          <a:p>
+            <a:pPr indent="0" marL="0">
+              <a:buNone/>
+            </a:pPr>
+            <a:r>
+              <a:rPr lang="en-US" sz="1300" dirty="0">
+                <a:solidFill>
+                  <a:srgbClr val="5A5F73"/>
+                </a:solidFill>
+                <a:latin typeface="Calibri" pitchFamily="34" charset="0"/>
+                <a:ea typeface="Calibri" pitchFamily="34" charset="-122"/>
+                <a:cs typeface="Calibri" pitchFamily="34" charset="-120"/>
+              </a:rPr>
+              <a:t>Helmet 8 con CSP default-src none, HSTS de un año y allowlist de CORS</a:t>
+            </a:r>
+            <a:endParaRPr lang="en-US" sz="1300" dirty="0"/>
+          </a:p>
+        </p:txBody>
+      </p:sp>
+      <p:sp>
+        <p:nvSpPr>
+          <p:cNvPr id="28" name="Text 26"/>
+          <p:cNvSpPr/>
+          <p:nvPr/>
+        </p:nvSpPr>
+        <p:spPr>
+          <a:xfrm>
+            <a:off x="777240" y="5303520"/>
+            <a:ext cx="685800" cy="365760"/>
+          </a:xfrm>
+          <a:prstGeom prst="rect">
+            <a:avLst/>
+          </a:prstGeom>
+          <a:noFill/>
+          <a:ln/>
+        </p:spPr>
+        <p:txBody>
+          <a:bodyPr wrap="square" lIns="0" tIns="0" rIns="0" bIns="0" rtlCol="0" anchor="ctr"/>
+          <a:lstStyle/>
+          <a:p>
+            <a:pPr indent="0" marL="0">
+              <a:buNone/>
+            </a:pPr>
+            <a:r>
+              <a:rPr lang="en-US" sz="1200" b="1" dirty="0">
+                <a:solidFill>
+                  <a:srgbClr val="202CFC"/>
+                </a:solidFill>
+                <a:latin typeface="Arial" pitchFamily="34" charset="0"/>
+                <a:ea typeface="Arial" pitchFamily="34" charset="-122"/>
+                <a:cs typeface="Arial" pitchFamily="34" charset="-120"/>
+              </a:rPr>
+              <a:t>API9</a:t>
+            </a:r>
+            <a:endParaRPr lang="en-US" sz="1200" dirty="0"/>
+          </a:p>
+        </p:txBody>
+      </p:sp>
+      <p:sp>
+        <p:nvSpPr>
+          <p:cNvPr id="29" name="Text 27"/>
+          <p:cNvSpPr/>
+          <p:nvPr/>
+        </p:nvSpPr>
+        <p:spPr>
+          <a:xfrm>
+            <a:off x="1481328" y="5303520"/>
+            <a:ext cx="2834640" cy="365760"/>
+          </a:xfrm>
+          <a:prstGeom prst="rect">
+            <a:avLst/>
+          </a:prstGeom>
+          <a:noFill/>
+          <a:ln/>
+        </p:spPr>
+        <p:txBody>
+          <a:bodyPr wrap="square" lIns="0" tIns="0" rIns="0" bIns="0" rtlCol="0" anchor="ctr"/>
+          <a:lstStyle/>
+          <a:p>
+            <a:pPr indent="0" marL="0">
+              <a:buNone/>
+            </a:pPr>
+            <a:r>
+              <a:rPr lang="en-US" sz="1200" b="1" dirty="0">
+                <a:solidFill>
+                  <a:srgbClr val="1A1C2E"/>
+                </a:solidFill>
+                <a:latin typeface="Arial" pitchFamily="34" charset="0"/>
+                <a:ea typeface="Arial" pitchFamily="34" charset="-122"/>
+                <a:cs typeface="Arial" pitchFamily="34" charset="-120"/>
+              </a:rPr>
+              <a:t>Inventario de la API</a:t>
+            </a:r>
+            <a:endParaRPr lang="en-US" sz="1200" dirty="0"/>
+          </a:p>
+        </p:txBody>
+      </p:sp>
+      <p:sp>
+        <p:nvSpPr>
+          <p:cNvPr id="30" name="Text 28"/>
+          <p:cNvSpPr/>
+          <p:nvPr/>
+        </p:nvSpPr>
+        <p:spPr>
+          <a:xfrm>
+            <a:off x="4389120" y="5303520"/>
+            <a:ext cx="6995160" cy="365760"/>
+          </a:xfrm>
+          <a:prstGeom prst="rect">
+            <a:avLst/>
+          </a:prstGeom>
+          <a:noFill/>
+          <a:ln/>
+        </p:spPr>
+        <p:txBody>
+          <a:bodyPr wrap="square" lIns="0" tIns="0" rIns="0" bIns="0" rtlCol="0" anchor="ctr"/>
+          <a:lstStyle/>
+          <a:p>
+            <a:pPr indent="0" marL="0">
+              <a:buNone/>
+            </a:pPr>
+            <a:r>
+              <a:rPr lang="en-US" sz="1300" dirty="0">
+                <a:solidFill>
+                  <a:srgbClr val="5A5F73"/>
+                </a:solidFill>
+                <a:latin typeface="Calibri" pitchFamily="34" charset="0"/>
+                <a:ea typeface="Calibri" pitchFamily="34" charset="-122"/>
+                <a:cs typeface="Calibri" pitchFamily="34" charset="-120"/>
+              </a:rPr>
+              <a:t>Especificación OpenAPI versionada y servida por la propia API</a:t>
+            </a:r>
+            <a:endParaRPr lang="en-US" sz="1300" dirty="0"/>
+          </a:p>
+        </p:txBody>
+      </p:sp>
+      <p:sp>
+        <p:nvSpPr>
+          <p:cNvPr id="31" name="Text 29"/>
+          <p:cNvSpPr/>
+          <p:nvPr/>
+        </p:nvSpPr>
+        <p:spPr>
+          <a:xfrm>
+            <a:off x="777240" y="5705856"/>
+            <a:ext cx="685800" cy="365760"/>
+          </a:xfrm>
+          <a:prstGeom prst="rect">
+            <a:avLst/>
+          </a:prstGeom>
+          <a:noFill/>
+          <a:ln/>
+        </p:spPr>
+        <p:txBody>
+          <a:bodyPr wrap="square" lIns="0" tIns="0" rIns="0" bIns="0" rtlCol="0" anchor="ctr"/>
+          <a:lstStyle/>
+          <a:p>
+            <a:pPr indent="0" marL="0">
+              <a:buNone/>
+            </a:pPr>
+            <a:r>
+              <a:rPr lang="en-US" sz="1200" b="1" dirty="0">
+                <a:solidFill>
+                  <a:srgbClr val="202CFC"/>
+                </a:solidFill>
+                <a:latin typeface="Arial" pitchFamily="34" charset="0"/>
+                <a:ea typeface="Arial" pitchFamily="34" charset="-122"/>
+                <a:cs typeface="Arial" pitchFamily="34" charset="-120"/>
+              </a:rPr>
+              <a:t>API10</a:t>
+            </a:r>
+            <a:endParaRPr lang="en-US" sz="1200" dirty="0"/>
+          </a:p>
+        </p:txBody>
+      </p:sp>
+      <p:sp>
+        <p:nvSpPr>
+          <p:cNvPr id="32" name="Text 30"/>
+          <p:cNvSpPr/>
+          <p:nvPr/>
+        </p:nvSpPr>
+        <p:spPr>
+          <a:xfrm>
+            <a:off x="1481328" y="5705856"/>
+            <a:ext cx="2834640" cy="365760"/>
+          </a:xfrm>
+          <a:prstGeom prst="rect">
+            <a:avLst/>
+          </a:prstGeom>
+          <a:noFill/>
+          <a:ln/>
+        </p:spPr>
+        <p:txBody>
+          <a:bodyPr wrap="square" lIns="0" tIns="0" rIns="0" bIns="0" rtlCol="0" anchor="ctr"/>
+          <a:lstStyle/>
+          <a:p>
+            <a:pPr indent="0" marL="0">
+              <a:buNone/>
+            </a:pPr>
+            <a:r>
+              <a:rPr lang="en-US" sz="1200" b="1" dirty="0">
+                <a:solidFill>
+                  <a:srgbClr val="1A1C2E"/>
+                </a:solidFill>
+                <a:latin typeface="Arial" pitchFamily="34" charset="0"/>
+                <a:ea typeface="Arial" pitchFamily="34" charset="-122"/>
+                <a:cs typeface="Arial" pitchFamily="34" charset="-120"/>
+              </a:rPr>
+              <a:t>Consumo de APIs externas</a:t>
+            </a:r>
+            <a:endParaRPr lang="en-US" sz="1200" dirty="0"/>
+          </a:p>
+        </p:txBody>
+      </p:sp>
+      <p:sp>
+        <p:nvSpPr>
+          <p:cNvPr id="33" name="Text 31"/>
+          <p:cNvSpPr/>
+          <p:nvPr/>
+        </p:nvSpPr>
+        <p:spPr>
+          <a:xfrm>
+            <a:off x="4389120" y="5705856"/>
+            <a:ext cx="6995160" cy="365760"/>
+          </a:xfrm>
+          <a:prstGeom prst="rect">
+            <a:avLst/>
+          </a:prstGeom>
+          <a:noFill/>
+          <a:ln/>
+        </p:spPr>
+        <p:txBody>
+          <a:bodyPr wrap="square" lIns="0" tIns="0" rIns="0" bIns="0" rtlCol="0" anchor="ctr"/>
+          <a:lstStyle/>
+          <a:p>
+            <a:pPr indent="0" marL="0">
+              <a:buNone/>
+            </a:pPr>
+            <a:r>
+              <a:rPr lang="en-US" sz="1300" dirty="0">
+                <a:solidFill>
+                  <a:srgbClr val="5A5F73"/>
+                </a:solidFill>
+                <a:latin typeface="Calibri" pitchFamily="34" charset="0"/>
+                <a:ea typeface="Calibri" pitchFamily="34" charset="-122"/>
+                <a:cs typeface="Calibri" pitchFamily="34" charset="-120"/>
+              </a:rPr>
+              <a:t>Lo recuperado llega al modelo marcado como no fiable, nunca como instrucción</a:t>
+            </a:r>
+            <a:endParaRPr lang="en-US" sz="1300" dirty="0"/>
+          </a:p>
+        </p:txBody>
+      </p:sp>
+      <p:sp>
+        <p:nvSpPr>
+          <p:cNvPr id="34" name="Shape 32"/>
           <p:cNvSpPr/>
           <p:nvPr/>
         </p:nvSpPr>
@@ -8748,7 +8983,7 @@
       </p:sp>
       <p:sp>
         <p:nvSpPr>
-          <p:cNvPr id="28" name="Text 26"/>
+          <p:cNvPr id="35" name="Text 33"/>
           <p:cNvSpPr/>
           <p:nvPr/>
         </p:nvSpPr>
@@ -8787,7 +9022,7 @@
       </p:sp>
       <p:sp>
         <p:nvSpPr>
-          <p:cNvPr id="29" name="Text 27"/>
+          <p:cNvPr id="36" name="Text 34"/>
           <p:cNvSpPr/>
           <p:nvPr/>
         </p:nvSpPr>
@@ -8826,7 +9061,7 @@
       </p:sp>
       <p:sp>
         <p:nvSpPr>
-          <p:cNvPr id="30" name="Text 28"/>
+          <p:cNvPr id="37" name="Text 35"/>
           <p:cNvSpPr/>
           <p:nvPr/>
         </p:nvSpPr>
@@ -8903,8 +9138,8 @@
         </p:nvSpPr>
         <p:spPr>
           <a:xfrm>
-            <a:off x="777240" y="640080"/>
-            <a:ext cx="10607040" cy="777240"/>
+            <a:off x="777240" y="502920"/>
+            <a:ext cx="10607040" cy="685800"/>
           </a:xfrm>
           <a:prstGeom prst="rect">
             <a:avLst/>
@@ -8920,7 +9155,7 @@
               <a:buNone/>
             </a:pPr>
             <a:r>
-              <a:rPr lang="en-US" sz="3400" b="1" dirty="0">
+              <a:rPr lang="en-US" sz="3200" b="1" dirty="0">
                 <a:solidFill>
                   <a:srgbClr val="1A1C2E"/>
                 </a:solidFill>
@@ -8928,9 +9163,9 @@
                 <a:ea typeface="Arial" pitchFamily="34" charset="-122"/>
                 <a:cs typeface="Arial" pitchFamily="34" charset="-120"/>
               </a:rPr>
-              <a:t>Conclusiones</a:t>
-            </a:r>
-            <a:endParaRPr lang="en-US" sz="3400" dirty="0"/>
+              <a:t>Integración y despliegue continuos</a:t>
+            </a:r>
+            <a:endParaRPr lang="en-US" sz="3200" dirty="0"/>
           </a:p>
         </p:txBody>
       </p:sp>
@@ -8942,8 +9177,8 @@
         </p:nvSpPr>
         <p:spPr>
           <a:xfrm>
-            <a:off x="777240" y="1508760"/>
-            <a:ext cx="10607040" cy="365760"/>
+            <a:off x="777240" y="1261872"/>
+            <a:ext cx="10607040" cy="320040"/>
           </a:xfrm>
           <a:prstGeom prst="rect">
             <a:avLst/>
@@ -8959,7 +9194,7 @@
               <a:buNone/>
             </a:pPr>
             <a:r>
-              <a:rPr lang="en-US" sz="1700" dirty="0">
+              <a:rPr lang="en-US" sz="1500" dirty="0">
                 <a:solidFill>
                   <a:srgbClr val="5A5F73"/>
                 </a:solidFill>
@@ -8967,61 +9202,777 @@
                 <a:ea typeface="Calibri" pitchFamily="34" charset="-122"/>
                 <a:cs typeface="Calibri" pitchFamily="34" charset="-120"/>
               </a:rPr>
-              <a:t>Balance de haber desarrollado el proyecto con asistencia de IA.</a:t>
-            </a:r>
-            <a:endParaRPr lang="en-US" sz="1700" dirty="0"/>
-          </a:p>
-        </p:txBody>
-      </p:sp>
-      <p:sp>
-        <p:nvSpPr>
-          <p:cNvPr id="4" name="Text 2"/>
-          <p:cNvSpPr/>
-          <p:nvPr/>
-        </p:nvSpPr>
-        <p:spPr>
-          <a:xfrm>
-            <a:off x="777240" y="2286000"/>
-            <a:ext cx="4846320" cy="365760"/>
-          </a:xfrm>
-          <a:prstGeom prst="rect">
-            <a:avLst/>
-          </a:prstGeom>
-          <a:noFill/>
-          <a:ln/>
-        </p:spPr>
-        <p:txBody>
-          <a:bodyPr wrap="square" lIns="0" tIns="0" rIns="0" bIns="0" rtlCol="0" anchor="t"/>
-          <a:lstStyle/>
-          <a:p>
-            <a:pPr indent="0" marL="0">
-              <a:buNone/>
-            </a:pPr>
-            <a:r>
-              <a:rPr lang="en-US" sz="2000" b="1" dirty="0">
-                <a:solidFill>
-                  <a:srgbClr val="202CFC"/>
+              <a:t>Todo automatizado en GitHub Actions: integrar en main publica la nueva versión en producción.</a:t>
+            </a:r>
+            <a:endParaRPr lang="en-US" sz="1500" dirty="0"/>
+          </a:p>
+        </p:txBody>
+      </p:sp>
+      <p:sp>
+        <p:nvSpPr>
+          <p:cNvPr id="4" name="Shape 2"/>
+          <p:cNvSpPr/>
+          <p:nvPr/>
+        </p:nvSpPr>
+        <p:spPr>
+          <a:xfrm>
+            <a:off x="777240" y="1874520"/>
+            <a:ext cx="1828800" cy="868680"/>
+          </a:xfrm>
+          <a:prstGeom prst="roundRect">
+            <a:avLst>
+              <a:gd name="adj" fmla="val 6316"/>
+            </a:avLst>
+          </a:prstGeom>
+          <a:solidFill>
+            <a:srgbClr val="FFFFFF"/>
+          </a:solidFill>
+          <a:ln w="12700">
+            <a:solidFill>
+              <a:srgbClr val="C9CCD8"/>
+            </a:solidFill>
+            <a:prstDash val="solid"/>
+          </a:ln>
+        </p:spPr>
+      </p:sp>
+      <p:sp>
+        <p:nvSpPr>
+          <p:cNvPr id="5" name="Text 3"/>
+          <p:cNvSpPr/>
+          <p:nvPr/>
+        </p:nvSpPr>
+        <p:spPr>
+          <a:xfrm>
+            <a:off x="850392" y="1993392"/>
+            <a:ext cx="1682496" cy="274320"/>
+          </a:xfrm>
+          <a:prstGeom prst="rect">
+            <a:avLst/>
+          </a:prstGeom>
+          <a:noFill/>
+          <a:ln/>
+        </p:spPr>
+        <p:txBody>
+          <a:bodyPr wrap="square" lIns="0" tIns="0" rIns="0" bIns="0" rtlCol="0" anchor="ctr"/>
+          <a:lstStyle/>
+          <a:p>
+            <a:pPr algn="ctr" indent="0" marL="0">
+              <a:buNone/>
+            </a:pPr>
+            <a:r>
+              <a:rPr lang="en-US" sz="1100" b="1" dirty="0">
+                <a:solidFill>
+                  <a:srgbClr val="1A1C2E"/>
                 </a:solidFill>
                 <a:latin typeface="Arial" pitchFamily="34" charset="0"/>
                 <a:ea typeface="Arial" pitchFamily="34" charset="-122"/>
                 <a:cs typeface="Arial" pitchFamily="34" charset="-120"/>
               </a:rPr>
-              <a:t>Lo que aporta</a:t>
-            </a:r>
-            <a:endParaRPr lang="en-US" sz="2000" dirty="0"/>
-          </a:p>
-        </p:txBody>
-      </p:sp>
-      <p:sp>
-        <p:nvSpPr>
-          <p:cNvPr id="5" name="Text 3"/>
-          <p:cNvSpPr/>
-          <p:nvPr/>
-        </p:nvSpPr>
-        <p:spPr>
-          <a:xfrm>
-            <a:off x="777240" y="2834640"/>
-            <a:ext cx="4846320" cy="2468880"/>
+              <a:t>Integración en main</a:t>
+            </a:r>
+            <a:endParaRPr lang="en-US" sz="1100" dirty="0"/>
+          </a:p>
+        </p:txBody>
+      </p:sp>
+      <p:sp>
+        <p:nvSpPr>
+          <p:cNvPr id="6" name="Text 4"/>
+          <p:cNvSpPr/>
+          <p:nvPr/>
+        </p:nvSpPr>
+        <p:spPr>
+          <a:xfrm>
+            <a:off x="850392" y="2276856"/>
+            <a:ext cx="1682496" cy="384048"/>
+          </a:xfrm>
+          <a:prstGeom prst="rect">
+            <a:avLst/>
+          </a:prstGeom>
+          <a:noFill/>
+          <a:ln/>
+        </p:spPr>
+        <p:txBody>
+          <a:bodyPr wrap="square" lIns="0" tIns="0" rIns="0" bIns="0" rtlCol="0" anchor="t"/>
+          <a:lstStyle/>
+          <a:p>
+            <a:pPr algn="ctr" indent="0" marL="0">
+              <a:lnSpc>
+                <a:spcPts val="1200"/>
+              </a:lnSpc>
+              <a:buNone/>
+            </a:pPr>
+            <a:r>
+              <a:rPr lang="en-US" sz="950" dirty="0">
+                <a:solidFill>
+                  <a:srgbClr val="5A5F73"/>
+                </a:solidFill>
+                <a:latin typeface="Calibri" pitchFamily="34" charset="0"/>
+                <a:ea typeface="Calibri" pitchFamily="34" charset="-122"/>
+                <a:cs typeface="Calibri" pitchFamily="34" charset="-120"/>
+              </a:rPr>
+              <a:t>push o merge</a:t>
+            </a:r>
+            <a:endParaRPr lang="en-US" sz="950" dirty="0"/>
+          </a:p>
+        </p:txBody>
+      </p:sp>
+      <p:sp>
+        <p:nvSpPr>
+          <p:cNvPr id="7" name="Shape 5"/>
+          <p:cNvSpPr/>
+          <p:nvPr/>
+        </p:nvSpPr>
+        <p:spPr>
+          <a:xfrm>
+            <a:off x="2679192" y="2308860"/>
+            <a:ext cx="219456" cy="0"/>
+          </a:xfrm>
+          <a:prstGeom prst="line">
+            <a:avLst/>
+          </a:prstGeom>
+          <a:noFill/>
+          <a:ln w="19050">
+            <a:solidFill>
+              <a:srgbClr val="202CFC"/>
+            </a:solidFill>
+            <a:prstDash val="solid"/>
+            <a:tailEnd type="triangle"/>
+          </a:ln>
+        </p:spPr>
+      </p:sp>
+      <p:sp>
+        <p:nvSpPr>
+          <p:cNvPr id="8" name="Shape 6"/>
+          <p:cNvSpPr/>
+          <p:nvPr/>
+        </p:nvSpPr>
+        <p:spPr>
+          <a:xfrm>
+            <a:off x="2971800" y="1874520"/>
+            <a:ext cx="1828800" cy="868680"/>
+          </a:xfrm>
+          <a:prstGeom prst="roundRect">
+            <a:avLst>
+              <a:gd name="adj" fmla="val 6316"/>
+            </a:avLst>
+          </a:prstGeom>
+          <a:solidFill>
+            <a:srgbClr val="FFFFFF"/>
+          </a:solidFill>
+          <a:ln w="12700">
+            <a:solidFill>
+              <a:srgbClr val="C9CCD8"/>
+            </a:solidFill>
+            <a:prstDash val="solid"/>
+          </a:ln>
+        </p:spPr>
+      </p:sp>
+      <p:sp>
+        <p:nvSpPr>
+          <p:cNvPr id="9" name="Text 7"/>
+          <p:cNvSpPr/>
+          <p:nvPr/>
+        </p:nvSpPr>
+        <p:spPr>
+          <a:xfrm>
+            <a:off x="3044952" y="1993392"/>
+            <a:ext cx="1682496" cy="274320"/>
+          </a:xfrm>
+          <a:prstGeom prst="rect">
+            <a:avLst/>
+          </a:prstGeom>
+          <a:noFill/>
+          <a:ln/>
+        </p:spPr>
+        <p:txBody>
+          <a:bodyPr wrap="square" lIns="0" tIns="0" rIns="0" bIns="0" rtlCol="0" anchor="ctr"/>
+          <a:lstStyle/>
+          <a:p>
+            <a:pPr algn="ctr" indent="0" marL="0">
+              <a:buNone/>
+            </a:pPr>
+            <a:r>
+              <a:rPr lang="en-US" sz="1100" b="1" dirty="0">
+                <a:solidFill>
+                  <a:srgbClr val="1A1C2E"/>
+                </a:solidFill>
+                <a:latin typeface="Arial" pitchFamily="34" charset="0"/>
+                <a:ea typeface="Arial" pitchFamily="34" charset="-122"/>
+                <a:cs typeface="Arial" pitchFamily="34" charset="-120"/>
+              </a:rPr>
+              <a:t>Verificación</a:t>
+            </a:r>
+            <a:endParaRPr lang="en-US" sz="1100" dirty="0"/>
+          </a:p>
+        </p:txBody>
+      </p:sp>
+      <p:sp>
+        <p:nvSpPr>
+          <p:cNvPr id="10" name="Text 8"/>
+          <p:cNvSpPr/>
+          <p:nvPr/>
+        </p:nvSpPr>
+        <p:spPr>
+          <a:xfrm>
+            <a:off x="3044952" y="2276856"/>
+            <a:ext cx="1682496" cy="384048"/>
+          </a:xfrm>
+          <a:prstGeom prst="rect">
+            <a:avLst/>
+          </a:prstGeom>
+          <a:noFill/>
+          <a:ln/>
+        </p:spPr>
+        <p:txBody>
+          <a:bodyPr wrap="square" lIns="0" tIns="0" rIns="0" bIns="0" rtlCol="0" anchor="t"/>
+          <a:lstStyle/>
+          <a:p>
+            <a:pPr algn="ctr" indent="0" marL="0">
+              <a:lnSpc>
+                <a:spcPts val="1200"/>
+              </a:lnSpc>
+              <a:buNone/>
+            </a:pPr>
+            <a:r>
+              <a:rPr lang="en-US" sz="950" dirty="0">
+                <a:solidFill>
+                  <a:srgbClr val="5A5F73"/>
+                </a:solidFill>
+                <a:latin typeface="Calibri" pitchFamily="34" charset="0"/>
+                <a:ea typeface="Calibri" pitchFamily="34" charset="-122"/>
+                <a:cs typeface="Calibri" pitchFamily="34" charset="-120"/>
+              </a:rPr>
+              <a:t>lint, tests,</a:t>
+            </a:r>
+            <a:endParaRPr lang="en-US" sz="950" dirty="0"/>
+          </a:p>
+          <a:p>
+            <a:pPr algn="ctr" indent="0" marL="0">
+              <a:lnSpc>
+                <a:spcPts val="1200"/>
+              </a:lnSpc>
+              <a:buNone/>
+            </a:pPr>
+            <a:r>
+              <a:rPr lang="en-US" sz="950" dirty="0">
+                <a:solidFill>
+                  <a:srgbClr val="5A5F73"/>
+                </a:solidFill>
+                <a:latin typeface="Calibri" pitchFamily="34" charset="0"/>
+                <a:ea typeface="Calibri" pitchFamily="34" charset="-122"/>
+                <a:cs typeface="Calibri" pitchFamily="34" charset="-120"/>
+              </a:rPr>
+              <a:t>build y typecheck</a:t>
+            </a:r>
+            <a:endParaRPr lang="en-US" sz="950" dirty="0"/>
+          </a:p>
+        </p:txBody>
+      </p:sp>
+      <p:sp>
+        <p:nvSpPr>
+          <p:cNvPr id="11" name="Shape 9"/>
+          <p:cNvSpPr/>
+          <p:nvPr/>
+        </p:nvSpPr>
+        <p:spPr>
+          <a:xfrm>
+            <a:off x="4873752" y="2308860"/>
+            <a:ext cx="219456" cy="0"/>
+          </a:xfrm>
+          <a:prstGeom prst="line">
+            <a:avLst/>
+          </a:prstGeom>
+          <a:noFill/>
+          <a:ln w="19050">
+            <a:solidFill>
+              <a:srgbClr val="202CFC"/>
+            </a:solidFill>
+            <a:prstDash val="solid"/>
+            <a:tailEnd type="triangle"/>
+          </a:ln>
+        </p:spPr>
+      </p:sp>
+      <p:sp>
+        <p:nvSpPr>
+          <p:cNvPr id="12" name="Shape 10"/>
+          <p:cNvSpPr/>
+          <p:nvPr/>
+        </p:nvSpPr>
+        <p:spPr>
+          <a:xfrm>
+            <a:off x="5166360" y="1874520"/>
+            <a:ext cx="1828800" cy="868680"/>
+          </a:xfrm>
+          <a:prstGeom prst="roundRect">
+            <a:avLst>
+              <a:gd name="adj" fmla="val 6316"/>
+            </a:avLst>
+          </a:prstGeom>
+          <a:solidFill>
+            <a:srgbClr val="FFFFFF"/>
+          </a:solidFill>
+          <a:ln w="12700">
+            <a:solidFill>
+              <a:srgbClr val="C9CCD8"/>
+            </a:solidFill>
+            <a:prstDash val="solid"/>
+          </a:ln>
+        </p:spPr>
+      </p:sp>
+      <p:sp>
+        <p:nvSpPr>
+          <p:cNvPr id="13" name="Text 11"/>
+          <p:cNvSpPr/>
+          <p:nvPr/>
+        </p:nvSpPr>
+        <p:spPr>
+          <a:xfrm>
+            <a:off x="5239512" y="1993392"/>
+            <a:ext cx="1682496" cy="274320"/>
+          </a:xfrm>
+          <a:prstGeom prst="rect">
+            <a:avLst/>
+          </a:prstGeom>
+          <a:noFill/>
+          <a:ln/>
+        </p:spPr>
+        <p:txBody>
+          <a:bodyPr wrap="square" lIns="0" tIns="0" rIns="0" bIns="0" rtlCol="0" anchor="ctr"/>
+          <a:lstStyle/>
+          <a:p>
+            <a:pPr algn="ctr" indent="0" marL="0">
+              <a:buNone/>
+            </a:pPr>
+            <a:r>
+              <a:rPr lang="en-US" sz="1100" b="1" dirty="0">
+                <a:solidFill>
+                  <a:srgbClr val="1A1C2E"/>
+                </a:solidFill>
+                <a:latin typeface="Arial" pitchFamily="34" charset="0"/>
+                <a:ea typeface="Arial" pitchFamily="34" charset="-122"/>
+                <a:cs typeface="Arial" pitchFamily="34" charset="-120"/>
+              </a:rPr>
+              <a:t>Construcción</a:t>
+            </a:r>
+            <a:endParaRPr lang="en-US" sz="1100" dirty="0"/>
+          </a:p>
+        </p:txBody>
+      </p:sp>
+      <p:sp>
+        <p:nvSpPr>
+          <p:cNvPr id="14" name="Text 12"/>
+          <p:cNvSpPr/>
+          <p:nvPr/>
+        </p:nvSpPr>
+        <p:spPr>
+          <a:xfrm>
+            <a:off x="5239512" y="2276856"/>
+            <a:ext cx="1682496" cy="384048"/>
+          </a:xfrm>
+          <a:prstGeom prst="rect">
+            <a:avLst/>
+          </a:prstGeom>
+          <a:noFill/>
+          <a:ln/>
+        </p:spPr>
+        <p:txBody>
+          <a:bodyPr wrap="square" lIns="0" tIns="0" rIns="0" bIns="0" rtlCol="0" anchor="t"/>
+          <a:lstStyle/>
+          <a:p>
+            <a:pPr algn="ctr" indent="0" marL="0">
+              <a:lnSpc>
+                <a:spcPts val="1200"/>
+              </a:lnSpc>
+              <a:buNone/>
+            </a:pPr>
+            <a:r>
+              <a:rPr lang="en-US" sz="950" dirty="0">
+                <a:solidFill>
+                  <a:srgbClr val="5A5F73"/>
+                </a:solidFill>
+                <a:latin typeface="Calibri" pitchFamily="34" charset="0"/>
+                <a:ea typeface="Calibri" pitchFamily="34" charset="-122"/>
+                <a:cs typeface="Calibri" pitchFamily="34" charset="-120"/>
+              </a:rPr>
+              <a:t>tres imágenes</a:t>
+            </a:r>
+            <a:endParaRPr lang="en-US" sz="950" dirty="0"/>
+          </a:p>
+          <a:p>
+            <a:pPr algn="ctr" indent="0" marL="0">
+              <a:lnSpc>
+                <a:spcPts val="1200"/>
+              </a:lnSpc>
+              <a:buNone/>
+            </a:pPr>
+            <a:r>
+              <a:rPr lang="en-US" sz="950" dirty="0">
+                <a:solidFill>
+                  <a:srgbClr val="5A5F73"/>
+                </a:solidFill>
+                <a:latin typeface="Calibri" pitchFamily="34" charset="0"/>
+                <a:ea typeface="Calibri" pitchFamily="34" charset="-122"/>
+                <a:cs typeface="Calibri" pitchFamily="34" charset="-120"/>
+              </a:rPr>
+              <a:t>Docker</a:t>
+            </a:r>
+            <a:endParaRPr lang="en-US" sz="950" dirty="0"/>
+          </a:p>
+        </p:txBody>
+      </p:sp>
+      <p:sp>
+        <p:nvSpPr>
+          <p:cNvPr id="15" name="Shape 13"/>
+          <p:cNvSpPr/>
+          <p:nvPr/>
+        </p:nvSpPr>
+        <p:spPr>
+          <a:xfrm>
+            <a:off x="7068312" y="2308860"/>
+            <a:ext cx="219456" cy="0"/>
+          </a:xfrm>
+          <a:prstGeom prst="line">
+            <a:avLst/>
+          </a:prstGeom>
+          <a:noFill/>
+          <a:ln w="19050">
+            <a:solidFill>
+              <a:srgbClr val="202CFC"/>
+            </a:solidFill>
+            <a:prstDash val="solid"/>
+            <a:tailEnd type="triangle"/>
+          </a:ln>
+        </p:spPr>
+      </p:sp>
+      <p:sp>
+        <p:nvSpPr>
+          <p:cNvPr id="16" name="Shape 14"/>
+          <p:cNvSpPr/>
+          <p:nvPr/>
+        </p:nvSpPr>
+        <p:spPr>
+          <a:xfrm>
+            <a:off x="7360920" y="1874520"/>
+            <a:ext cx="1828800" cy="868680"/>
+          </a:xfrm>
+          <a:prstGeom prst="roundRect">
+            <a:avLst>
+              <a:gd name="adj" fmla="val 6316"/>
+            </a:avLst>
+          </a:prstGeom>
+          <a:solidFill>
+            <a:srgbClr val="FFFFFF"/>
+          </a:solidFill>
+          <a:ln w="12700">
+            <a:solidFill>
+              <a:srgbClr val="C9CCD8"/>
+            </a:solidFill>
+            <a:prstDash val="solid"/>
+          </a:ln>
+        </p:spPr>
+      </p:sp>
+      <p:sp>
+        <p:nvSpPr>
+          <p:cNvPr id="17" name="Text 15"/>
+          <p:cNvSpPr/>
+          <p:nvPr/>
+        </p:nvSpPr>
+        <p:spPr>
+          <a:xfrm>
+            <a:off x="7434072" y="1993392"/>
+            <a:ext cx="1682496" cy="274320"/>
+          </a:xfrm>
+          <a:prstGeom prst="rect">
+            <a:avLst/>
+          </a:prstGeom>
+          <a:noFill/>
+          <a:ln/>
+        </p:spPr>
+        <p:txBody>
+          <a:bodyPr wrap="square" lIns="0" tIns="0" rIns="0" bIns="0" rtlCol="0" anchor="ctr"/>
+          <a:lstStyle/>
+          <a:p>
+            <a:pPr algn="ctr" indent="0" marL="0">
+              <a:buNone/>
+            </a:pPr>
+            <a:r>
+              <a:rPr lang="en-US" sz="1100" b="1" dirty="0">
+                <a:solidFill>
+                  <a:srgbClr val="1A1C2E"/>
+                </a:solidFill>
+                <a:latin typeface="Arial" pitchFamily="34" charset="0"/>
+                <a:ea typeface="Arial" pitchFamily="34" charset="-122"/>
+                <a:cs typeface="Arial" pitchFamily="34" charset="-120"/>
+              </a:rPr>
+              <a:t>Publicación</a:t>
+            </a:r>
+            <a:endParaRPr lang="en-US" sz="1100" dirty="0"/>
+          </a:p>
+        </p:txBody>
+      </p:sp>
+      <p:sp>
+        <p:nvSpPr>
+          <p:cNvPr id="18" name="Text 16"/>
+          <p:cNvSpPr/>
+          <p:nvPr/>
+        </p:nvSpPr>
+        <p:spPr>
+          <a:xfrm>
+            <a:off x="7434072" y="2276856"/>
+            <a:ext cx="1682496" cy="384048"/>
+          </a:xfrm>
+          <a:prstGeom prst="rect">
+            <a:avLst/>
+          </a:prstGeom>
+          <a:noFill/>
+          <a:ln/>
+        </p:spPr>
+        <p:txBody>
+          <a:bodyPr wrap="square" lIns="0" tIns="0" rIns="0" bIns="0" rtlCol="0" anchor="t"/>
+          <a:lstStyle/>
+          <a:p>
+            <a:pPr algn="ctr" indent="0" marL="0">
+              <a:lnSpc>
+                <a:spcPts val="1200"/>
+              </a:lnSpc>
+              <a:buNone/>
+            </a:pPr>
+            <a:r>
+              <a:rPr lang="en-US" sz="950" dirty="0">
+                <a:solidFill>
+                  <a:srgbClr val="5A5F73"/>
+                </a:solidFill>
+                <a:latin typeface="Calibri" pitchFamily="34" charset="0"/>
+                <a:ea typeface="Calibri" pitchFamily="34" charset="-122"/>
+                <a:cs typeface="Calibri" pitchFamily="34" charset="-120"/>
+              </a:rPr>
+              <a:t>registro de</a:t>
+            </a:r>
+            <a:endParaRPr lang="en-US" sz="950" dirty="0"/>
+          </a:p>
+          <a:p>
+            <a:pPr algn="ctr" indent="0" marL="0">
+              <a:lnSpc>
+                <a:spcPts val="1200"/>
+              </a:lnSpc>
+              <a:buNone/>
+            </a:pPr>
+            <a:r>
+              <a:rPr lang="en-US" sz="950" dirty="0">
+                <a:solidFill>
+                  <a:srgbClr val="5A5F73"/>
+                </a:solidFill>
+                <a:latin typeface="Calibri" pitchFamily="34" charset="0"/>
+                <a:ea typeface="Calibri" pitchFamily="34" charset="-122"/>
+                <a:cs typeface="Calibri" pitchFamily="34" charset="-120"/>
+              </a:rPr>
+              <a:t>contenedores</a:t>
+            </a:r>
+            <a:endParaRPr lang="en-US" sz="950" dirty="0"/>
+          </a:p>
+        </p:txBody>
+      </p:sp>
+      <p:sp>
+        <p:nvSpPr>
+          <p:cNvPr id="19" name="Shape 17"/>
+          <p:cNvSpPr/>
+          <p:nvPr/>
+        </p:nvSpPr>
+        <p:spPr>
+          <a:xfrm>
+            <a:off x="9262872" y="2308860"/>
+            <a:ext cx="219456" cy="0"/>
+          </a:xfrm>
+          <a:prstGeom prst="line">
+            <a:avLst/>
+          </a:prstGeom>
+          <a:noFill/>
+          <a:ln w="19050">
+            <a:solidFill>
+              <a:srgbClr val="202CFC"/>
+            </a:solidFill>
+            <a:prstDash val="solid"/>
+            <a:tailEnd type="triangle"/>
+          </a:ln>
+        </p:spPr>
+      </p:sp>
+      <p:sp>
+        <p:nvSpPr>
+          <p:cNvPr id="20" name="Shape 18"/>
+          <p:cNvSpPr/>
+          <p:nvPr/>
+        </p:nvSpPr>
+        <p:spPr>
+          <a:xfrm>
+            <a:off x="9555480" y="1874520"/>
+            <a:ext cx="1828800" cy="868680"/>
+          </a:xfrm>
+          <a:prstGeom prst="roundRect">
+            <a:avLst>
+              <a:gd name="adj" fmla="val 6316"/>
+            </a:avLst>
+          </a:prstGeom>
+          <a:solidFill>
+            <a:srgbClr val="1A1C2E"/>
+          </a:solidFill>
+          <a:ln w="12700">
+            <a:solidFill>
+              <a:srgbClr val="1A1C2E"/>
+            </a:solidFill>
+            <a:prstDash val="solid"/>
+          </a:ln>
+        </p:spPr>
+      </p:sp>
+      <p:sp>
+        <p:nvSpPr>
+          <p:cNvPr id="21" name="Text 19"/>
+          <p:cNvSpPr/>
+          <p:nvPr/>
+        </p:nvSpPr>
+        <p:spPr>
+          <a:xfrm>
+            <a:off x="9628632" y="1993392"/>
+            <a:ext cx="1682496" cy="274320"/>
+          </a:xfrm>
+          <a:prstGeom prst="rect">
+            <a:avLst/>
+          </a:prstGeom>
+          <a:noFill/>
+          <a:ln/>
+        </p:spPr>
+        <p:txBody>
+          <a:bodyPr wrap="square" lIns="0" tIns="0" rIns="0" bIns="0" rtlCol="0" anchor="ctr"/>
+          <a:lstStyle/>
+          <a:p>
+            <a:pPr algn="ctr" indent="0" marL="0">
+              <a:buNone/>
+            </a:pPr>
+            <a:r>
+              <a:rPr lang="en-US" sz="1100" b="1" dirty="0">
+                <a:solidFill>
+                  <a:srgbClr val="FFFFFF"/>
+                </a:solidFill>
+                <a:latin typeface="Arial" pitchFamily="34" charset="0"/>
+                <a:ea typeface="Arial" pitchFamily="34" charset="-122"/>
+                <a:cs typeface="Arial" pitchFamily="34" charset="-120"/>
+              </a:rPr>
+              <a:t>Producción</a:t>
+            </a:r>
+            <a:endParaRPr lang="en-US" sz="1100" dirty="0"/>
+          </a:p>
+        </p:txBody>
+      </p:sp>
+      <p:sp>
+        <p:nvSpPr>
+          <p:cNvPr id="22" name="Text 20"/>
+          <p:cNvSpPr/>
+          <p:nvPr/>
+        </p:nvSpPr>
+        <p:spPr>
+          <a:xfrm>
+            <a:off x="9628632" y="2276856"/>
+            <a:ext cx="1682496" cy="384048"/>
+          </a:xfrm>
+          <a:prstGeom prst="rect">
+            <a:avLst/>
+          </a:prstGeom>
+          <a:noFill/>
+          <a:ln/>
+        </p:spPr>
+        <p:txBody>
+          <a:bodyPr wrap="square" lIns="0" tIns="0" rIns="0" bIns="0" rtlCol="0" anchor="t"/>
+          <a:lstStyle/>
+          <a:p>
+            <a:pPr algn="ctr" indent="0" marL="0">
+              <a:lnSpc>
+                <a:spcPts val="1200"/>
+              </a:lnSpc>
+              <a:buNone/>
+            </a:pPr>
+            <a:r>
+              <a:rPr lang="en-US" sz="950" dirty="0">
+                <a:solidFill>
+                  <a:srgbClr val="B8BCCC"/>
+                </a:solidFill>
+                <a:latin typeface="Calibri" pitchFamily="34" charset="0"/>
+                <a:ea typeface="Calibri" pitchFamily="34" charset="-122"/>
+                <a:cs typeface="Calibri" pitchFamily="34" charset="-120"/>
+              </a:rPr>
+              <a:t>el servidor levanta</a:t>
+            </a:r>
+            <a:endParaRPr lang="en-US" sz="950" dirty="0"/>
+          </a:p>
+          <a:p>
+            <a:pPr algn="ctr" indent="0" marL="0">
+              <a:lnSpc>
+                <a:spcPts val="1200"/>
+              </a:lnSpc>
+              <a:buNone/>
+            </a:pPr>
+            <a:r>
+              <a:rPr lang="en-US" sz="950" dirty="0">
+                <a:solidFill>
+                  <a:srgbClr val="B8BCCC"/>
+                </a:solidFill>
+                <a:latin typeface="Calibri" pitchFamily="34" charset="0"/>
+                <a:ea typeface="Calibri" pitchFamily="34" charset="-122"/>
+                <a:cs typeface="Calibri" pitchFamily="34" charset="-120"/>
+              </a:rPr>
+              <a:t>la nueva versión</a:t>
+            </a:r>
+            <a:endParaRPr lang="en-US" sz="950" dirty="0"/>
+          </a:p>
+        </p:txBody>
+      </p:sp>
+      <p:sp>
+        <p:nvSpPr>
+          <p:cNvPr id="23" name="Text 21"/>
+          <p:cNvSpPr/>
+          <p:nvPr/>
+        </p:nvSpPr>
+        <p:spPr>
+          <a:xfrm>
+            <a:off x="777240" y="3127248"/>
+            <a:ext cx="4846320" cy="365760"/>
+          </a:xfrm>
+          <a:prstGeom prst="rect">
+            <a:avLst/>
+          </a:prstGeom>
+          <a:noFill/>
+          <a:ln/>
+        </p:spPr>
+        <p:txBody>
+          <a:bodyPr wrap="square" lIns="0" tIns="0" rIns="0" bIns="0" rtlCol="0" anchor="t"/>
+          <a:lstStyle/>
+          <a:p>
+            <a:pPr indent="0" marL="0">
+              <a:buNone/>
+            </a:pPr>
+            <a:r>
+              <a:rPr lang="en-US" sz="1900" b="1" dirty="0">
+                <a:solidFill>
+                  <a:srgbClr val="202CFC"/>
+                </a:solidFill>
+                <a:latin typeface="Arial" pitchFamily="34" charset="0"/>
+                <a:ea typeface="Arial" pitchFamily="34" charset="-122"/>
+                <a:cs typeface="Arial" pitchFamily="34" charset="-120"/>
+              </a:rPr>
+              <a:t>Integración continua</a:t>
+            </a:r>
+            <a:endParaRPr lang="en-US" sz="1900" dirty="0"/>
+          </a:p>
+        </p:txBody>
+      </p:sp>
+      <p:sp>
+        <p:nvSpPr>
+          <p:cNvPr id="24" name="Text 22"/>
+          <p:cNvSpPr/>
+          <p:nvPr/>
+        </p:nvSpPr>
+        <p:spPr>
+          <a:xfrm>
+            <a:off x="777240" y="3657600"/>
+            <a:ext cx="4846320" cy="2377440"/>
           </a:xfrm>
           <a:prstGeom prst="rect">
             <a:avLst/>
@@ -9035,86 +9986,110 @@
           <a:p>
             <a:pPr marL="342900" indent="-342900">
               <a:lnSpc>
-                <a:spcPts val="2200"/>
+                <a:spcPts val="2100"/>
               </a:lnSpc>
               <a:spcAft>
-                <a:spcPts val="1300"/>
+                <a:spcPts val="1100"/>
               </a:spcAft>
               <a:buSzPct val="100000"/>
               <a:buChar char="•"/>
             </a:pPr>
             <a:r>
-              <a:rPr lang="en-US" sz="1600" dirty="0">
-                <a:solidFill>
-                  <a:srgbClr val="1A1C2E"/>
-                </a:solidFill>
-                <a:latin typeface="Calibri" pitchFamily="34" charset="0"/>
-                <a:ea typeface="Calibri" pitchFamily="34" charset="-122"/>
-                <a:cs typeface="Calibri" pitchFamily="34" charset="-120"/>
-              </a:rPr>
-              <a:t>Se pueden construir cosas complejas mucho más rápido</a:t>
-            </a:r>
-            <a:endParaRPr lang="en-US" sz="1600" dirty="0"/>
+              <a:rPr lang="en-US" sz="1500" dirty="0">
+                <a:solidFill>
+                  <a:srgbClr val="1A1C2E"/>
+                </a:solidFill>
+                <a:latin typeface="Calibri" pitchFamily="34" charset="0"/>
+                <a:ea typeface="Calibri" pitchFamily="34" charset="-122"/>
+                <a:cs typeface="Calibri" pitchFamily="34" charset="-120"/>
+              </a:rPr>
+              <a:t>En cada push y en cada pull request</a:t>
+            </a:r>
+            <a:endParaRPr lang="en-US" sz="1500" dirty="0"/>
           </a:p>
           <a:p>
             <a:pPr marL="342900" indent="-342900">
               <a:lnSpc>
-                <a:spcPts val="2200"/>
+                <a:spcPts val="2100"/>
               </a:lnSpc>
               <a:spcAft>
-                <a:spcPts val="1300"/>
+                <a:spcPts val="1100"/>
               </a:spcAft>
               <a:buSzPct val="100000"/>
               <a:buChar char="•"/>
             </a:pPr>
             <a:r>
-              <a:rPr lang="en-US" sz="1600" dirty="0">
-                <a:solidFill>
-                  <a:srgbClr val="1A1C2E"/>
-                </a:solidFill>
-                <a:latin typeface="Calibri" pitchFamily="34" charset="0"/>
-                <a:ea typeface="Calibri" pitchFamily="34" charset="-122"/>
-                <a:cs typeface="Calibri" pitchFamily="34" charset="-120"/>
-              </a:rPr>
-              <a:t>Lo que antes eran meses o años, ahora son semanas</a:t>
-            </a:r>
-            <a:endParaRPr lang="en-US" sz="1600" dirty="0"/>
+              <a:rPr lang="en-US" sz="1500" dirty="0">
+                <a:solidFill>
+                  <a:srgbClr val="1A1C2E"/>
+                </a:solidFill>
+                <a:latin typeface="Calibri" pitchFamily="34" charset="0"/>
+                <a:ea typeface="Calibri" pitchFamily="34" charset="-122"/>
+                <a:cs typeface="Calibri" pitchFamily="34" charset="-120"/>
+              </a:rPr>
+              <a:t>Las dos aplicaciones en paralelo, sobre Node 22</a:t>
+            </a:r>
+            <a:endParaRPr lang="en-US" sz="1500" dirty="0"/>
           </a:p>
           <a:p>
             <a:pPr marL="342900" indent="-342900">
               <a:lnSpc>
-                <a:spcPts val="2200"/>
+                <a:spcPts val="2100"/>
               </a:lnSpc>
               <a:spcAft>
-                <a:spcPts val="1300"/>
+                <a:spcPts val="1100"/>
               </a:spcAft>
               <a:buSzPct val="100000"/>
               <a:buChar char="•"/>
             </a:pPr>
             <a:r>
-              <a:rPr lang="en-US" sz="1600" dirty="0">
-                <a:solidFill>
-                  <a:srgbClr val="1A1C2E"/>
-                </a:solidFill>
-                <a:latin typeface="Calibri" pitchFamily="34" charset="0"/>
-                <a:ea typeface="Calibri" pitchFamily="34" charset="-122"/>
-                <a:cs typeface="Calibri" pitchFamily="34" charset="-120"/>
-              </a:rPr>
-              <a:t>Y se aprende más por el camino: herramientas y frameworks que no habrías tocado</a:t>
-            </a:r>
-            <a:endParaRPr lang="en-US" sz="1600" dirty="0"/>
-          </a:p>
-        </p:txBody>
-      </p:sp>
-      <p:sp>
-        <p:nvSpPr>
-          <p:cNvPr id="6" name="Text 4"/>
-          <p:cNvSpPr/>
-          <p:nvPr/>
-        </p:nvSpPr>
-        <p:spPr>
-          <a:xfrm>
-            <a:off x="6537960" y="2286000"/>
+              <a:rPr lang="en-US" sz="1500" dirty="0">
+                <a:solidFill>
+                  <a:srgbClr val="1A1C2E"/>
+                </a:solidFill>
+                <a:latin typeface="Calibri" pitchFamily="34" charset="0"/>
+                <a:ea typeface="Calibri" pitchFamily="34" charset="-122"/>
+                <a:cs typeface="Calibri" pitchFamily="34" charset="-120"/>
+              </a:rPr>
+              <a:t>Lint, formato, pruebas, compilación y typecheck</a:t>
+            </a:r>
+            <a:endParaRPr lang="en-US" sz="1500" dirty="0"/>
+          </a:p>
+          <a:p>
+            <a:pPr marL="342900" indent="-342900">
+              <a:lnSpc>
+                <a:spcPts val="2100"/>
+              </a:lnSpc>
+              <a:spcAft>
+                <a:spcPts val="1100"/>
+              </a:spcAft>
+              <a:buSzPct val="100000"/>
+              <a:buChar char="•"/>
+            </a:pPr>
+            <a:r>
+              <a:rPr lang="en-US" sz="1500" dirty="0">
+                <a:solidFill>
+                  <a:srgbClr val="1A1C2E"/>
+                </a:solidFill>
+                <a:latin typeface="Calibri" pitchFamily="34" charset="0"/>
+                <a:ea typeface="Calibri" pitchFamily="34" charset="-122"/>
+                <a:cs typeface="Calibri" pitchFamily="34" charset="-120"/>
+              </a:rPr>
+              <a:t>Auditoría de dependencias, que detiene la entrega ante una vulnerabilidad crítica</a:t>
+            </a:r>
+            <a:endParaRPr lang="en-US" sz="1500" dirty="0"/>
+          </a:p>
+        </p:txBody>
+      </p:sp>
+      <p:sp>
+        <p:nvSpPr>
+          <p:cNvPr id="25" name="Text 23"/>
+          <p:cNvSpPr/>
+          <p:nvPr/>
+        </p:nvSpPr>
+        <p:spPr>
+          <a:xfrm>
+            <a:off x="6537960" y="3127248"/>
             <a:ext cx="4846320" cy="365760"/>
           </a:xfrm>
           <a:prstGeom prst="rect">
@@ -9131,7 +10106,7 @@
               <a:buNone/>
             </a:pPr>
             <a:r>
-              <a:rPr lang="en-US" sz="2000" b="1" dirty="0">
+              <a:rPr lang="en-US" sz="1900" b="1" dirty="0">
                 <a:solidFill>
                   <a:srgbClr val="202CFC"/>
                 </a:solidFill>
@@ -9139,22 +10114,22 @@
                 <a:ea typeface="Arial" pitchFamily="34" charset="-122"/>
                 <a:cs typeface="Arial" pitchFamily="34" charset="-120"/>
               </a:rPr>
-              <a:t>Lo que exige</a:t>
-            </a:r>
-            <a:endParaRPr lang="en-US" sz="2000" dirty="0"/>
-          </a:p>
-        </p:txBody>
-      </p:sp>
-      <p:sp>
-        <p:nvSpPr>
-          <p:cNvPr id="7" name="Text 5"/>
-          <p:cNvSpPr/>
-          <p:nvPr/>
-        </p:nvSpPr>
-        <p:spPr>
-          <a:xfrm>
-            <a:off x="6537960" y="2834640"/>
-            <a:ext cx="4846320" cy="2468880"/>
+              <a:t>Despliegue continuo</a:t>
+            </a:r>
+            <a:endParaRPr lang="en-US" sz="1900" dirty="0"/>
+          </a:p>
+        </p:txBody>
+      </p:sp>
+      <p:sp>
+        <p:nvSpPr>
+          <p:cNvPr id="26" name="Text 24"/>
+          <p:cNvSpPr/>
+          <p:nvPr/>
+        </p:nvSpPr>
+        <p:spPr>
+          <a:xfrm>
+            <a:off x="6537960" y="3657600"/>
+            <a:ext cx="4846320" cy="2377440"/>
           </a:xfrm>
           <a:prstGeom prst="rect">
             <a:avLst/>
@@ -9168,80 +10143,104 @@
           <a:p>
             <a:pPr marL="342900" indent="-342900">
               <a:lnSpc>
-                <a:spcPts val="2200"/>
+                <a:spcPts val="2100"/>
               </a:lnSpc>
               <a:spcAft>
-                <a:spcPts val="1300"/>
+                <a:spcPts val="1100"/>
               </a:spcAft>
               <a:buSzPct val="100000"/>
               <a:buChar char="•"/>
             </a:pPr>
             <a:r>
-              <a:rPr lang="en-US" sz="1600" dirty="0">
-                <a:solidFill>
-                  <a:srgbClr val="1A1C2E"/>
-                </a:solidFill>
-                <a:latin typeface="Calibri" pitchFamily="34" charset="0"/>
-                <a:ea typeface="Calibri" pitchFamily="34" charset="-122"/>
-                <a:cs typeface="Calibri" pitchFamily="34" charset="-120"/>
-              </a:rPr>
-              <a:t>Acelera, pero también se equivoca</a:t>
-            </a:r>
-            <a:endParaRPr lang="en-US" sz="1600" dirty="0"/>
+              <a:rPr lang="en-US" sz="1500" dirty="0">
+                <a:solidFill>
+                  <a:srgbClr val="1A1C2E"/>
+                </a:solidFill>
+                <a:latin typeface="Calibri" pitchFamily="34" charset="0"/>
+                <a:ea typeface="Calibri" pitchFamily="34" charset="-122"/>
+                <a:cs typeface="Calibri" pitchFamily="34" charset="-120"/>
+              </a:rPr>
+              <a:t>Se dispara al integrar en main</a:t>
+            </a:r>
+            <a:endParaRPr lang="en-US" sz="1500" dirty="0"/>
           </a:p>
           <a:p>
             <a:pPr marL="342900" indent="-342900">
               <a:lnSpc>
-                <a:spcPts val="2200"/>
+                <a:spcPts val="2100"/>
               </a:lnSpc>
               <a:spcAft>
-                <a:spcPts val="1300"/>
+                <a:spcPts val="1100"/>
               </a:spcAft>
               <a:buSzPct val="100000"/>
               <a:buChar char="•"/>
             </a:pPr>
             <a:r>
-              <a:rPr lang="en-US" sz="1600" dirty="0">
-                <a:solidFill>
-                  <a:srgbClr val="1A1C2E"/>
-                </a:solidFill>
-                <a:latin typeface="Calibri" pitchFamily="34" charset="0"/>
-                <a:ea typeface="Calibri" pitchFamily="34" charset="-122"/>
-                <a:cs typeface="Calibri" pitchFamily="34" charset="-120"/>
-              </a:rPr>
-              <a:t>Hay que revisar lo que se sube, no vale con fiarse</a:t>
-            </a:r>
-            <a:endParaRPr lang="en-US" sz="1600" dirty="0"/>
+              <a:rPr lang="en-US" sz="1500" dirty="0">
+                <a:solidFill>
+                  <a:srgbClr val="1A1C2E"/>
+                </a:solidFill>
+                <a:latin typeface="Calibri" pitchFamily="34" charset="0"/>
+                <a:ea typeface="Calibri" pitchFamily="34" charset="-122"/>
+                <a:cs typeface="Calibri" pitchFamily="34" charset="-120"/>
+              </a:rPr>
+              <a:t>Construye tres imágenes: API, interfaz y emulador</a:t>
+            </a:r>
+            <a:endParaRPr lang="en-US" sz="1500" dirty="0"/>
           </a:p>
           <a:p>
             <a:pPr marL="342900" indent="-342900">
               <a:lnSpc>
-                <a:spcPts val="2200"/>
+                <a:spcPts val="2100"/>
               </a:lnSpc>
               <a:spcAft>
-                <a:spcPts val="1300"/>
+                <a:spcPts val="1100"/>
               </a:spcAft>
               <a:buSzPct val="100000"/>
               <a:buChar char="•"/>
             </a:pPr>
             <a:r>
-              <a:rPr lang="en-US" sz="1600" dirty="0">
-                <a:solidFill>
-                  <a:srgbClr val="1A1C2E"/>
-                </a:solidFill>
-                <a:latin typeface="Calibri" pitchFamily="34" charset="0"/>
-                <a:ea typeface="Calibri" pitchFamily="34" charset="-122"/>
-                <a:cs typeface="Calibri" pitchFamily="34" charset="-120"/>
-              </a:rPr>
-              <a:t>No es todo tan bonito como parece: hay que dedicarle tiempo</a:t>
-            </a:r>
-            <a:endParaRPr lang="en-US" sz="1600" dirty="0"/>
-          </a:p>
-        </p:txBody>
-      </p:sp>
-      <p:sp>
-        <p:nvSpPr>
-          <p:cNvPr id="8" name="Shape 6"/>
+              <a:rPr lang="en-US" sz="1500" dirty="0">
+                <a:solidFill>
+                  <a:srgbClr val="1A1C2E"/>
+                </a:solidFill>
+                <a:latin typeface="Calibri" pitchFamily="34" charset="0"/>
+                <a:ea typeface="Calibri" pitchFamily="34" charset="-122"/>
+                <a:cs typeface="Calibri" pitchFamily="34" charset="-120"/>
+              </a:rPr>
+              <a:t>Las publica en el registro de contenedores de GitHub</a:t>
+            </a:r>
+            <a:endParaRPr lang="en-US" sz="1500" dirty="0"/>
+          </a:p>
+          <a:p>
+            <a:pPr marL="342900" indent="-342900">
+              <a:lnSpc>
+                <a:spcPts val="2100"/>
+              </a:lnSpc>
+              <a:spcAft>
+                <a:spcPts val="1100"/>
+              </a:spcAft>
+              <a:buSzPct val="100000"/>
+              <a:buChar char="•"/>
+            </a:pPr>
+            <a:r>
+              <a:rPr lang="en-US" sz="1500" dirty="0">
+                <a:solidFill>
+                  <a:srgbClr val="1A1C2E"/>
+                </a:solidFill>
+                <a:latin typeface="Calibri" pitchFamily="34" charset="0"/>
+                <a:ea typeface="Calibri" pitchFamily="34" charset="-122"/>
+                <a:cs typeface="Calibri" pitchFamily="34" charset="-120"/>
+              </a:rPr>
+              <a:t>El servidor las descarga y levanta la nueva versión, sin intervención manual</a:t>
+            </a:r>
+            <a:endParaRPr lang="en-US" sz="1500" dirty="0"/>
+          </a:p>
+        </p:txBody>
+      </p:sp>
+      <p:sp>
+        <p:nvSpPr>
+          <p:cNvPr id="27" name="Shape 25"/>
           <p:cNvSpPr/>
           <p:nvPr/>
         </p:nvSpPr>
@@ -9261,7 +10260,7 @@
       </p:sp>
       <p:sp>
         <p:nvSpPr>
-          <p:cNvPr id="9" name="Text 7"/>
+          <p:cNvPr id="28" name="Text 26"/>
           <p:cNvSpPr/>
           <p:nvPr/>
         </p:nvSpPr>
@@ -9300,7 +10299,7 @@
       </p:sp>
       <p:sp>
         <p:nvSpPr>
-          <p:cNvPr id="10" name="Text 8"/>
+          <p:cNvPr id="29" name="Text 27"/>
           <p:cNvSpPr/>
           <p:nvPr/>
         </p:nvSpPr>
@@ -9339,7 +10338,7 @@
       </p:sp>
       <p:sp>
         <p:nvSpPr>
-          <p:cNvPr id="11" name="Text 9"/>
+          <p:cNvPr id="30" name="Text 28"/>
           <p:cNvSpPr/>
           <p:nvPr/>
         </p:nvSpPr>
@@ -9387,6 +10386,519 @@
 <file path=ppt/slides/slide18.xml><?xml version="1.0" encoding="utf-8"?>
 <p:sld xmlns:a="http://schemas.openxmlformats.org/drawingml/2006/main" xmlns:r="http://schemas.openxmlformats.org/officeDocument/2006/relationships" xmlns:p="http://schemas.openxmlformats.org/presentationml/2006/main">
   <p:cSld name="Slide 18">
+    <p:bg>
+      <p:bgPr>
+        <a:solidFill>
+          <a:srgbClr val="FFFFFF"/>
+        </a:solidFill>
+      </p:bgPr>
+    </p:bg>
+    <p:spTree>
+      <p:nvGrpSpPr>
+        <p:cNvPr id="1" name=""/>
+        <p:cNvGrpSpPr/>
+        <p:nvPr/>
+      </p:nvGrpSpPr>
+      <p:grpSpPr>
+        <a:xfrm>
+          <a:off x="0" y="0"/>
+          <a:ext cx="0" cy="0"/>
+          <a:chOff x="0" y="0"/>
+          <a:chExt cx="0" cy="0"/>
+        </a:xfrm>
+      </p:grpSpPr>
+      <p:sp>
+        <p:nvSpPr>
+          <p:cNvPr id="2" name="Text 0"/>
+          <p:cNvSpPr/>
+          <p:nvPr/>
+        </p:nvSpPr>
+        <p:spPr>
+          <a:xfrm>
+            <a:off x="777240" y="640080"/>
+            <a:ext cx="10607040" cy="777240"/>
+          </a:xfrm>
+          <a:prstGeom prst="rect">
+            <a:avLst/>
+          </a:prstGeom>
+          <a:noFill/>
+          <a:ln/>
+        </p:spPr>
+        <p:txBody>
+          <a:bodyPr wrap="square" lIns="0" tIns="0" rIns="0" bIns="0" rtlCol="0" anchor="t"/>
+          <a:lstStyle/>
+          <a:p>
+            <a:pPr indent="0" marL="0">
+              <a:buNone/>
+            </a:pPr>
+            <a:r>
+              <a:rPr lang="en-US" sz="3400" b="1" dirty="0">
+                <a:solidFill>
+                  <a:srgbClr val="1A1C2E"/>
+                </a:solidFill>
+                <a:latin typeface="Arial" pitchFamily="34" charset="0"/>
+                <a:ea typeface="Arial" pitchFamily="34" charset="-122"/>
+                <a:cs typeface="Arial" pitchFamily="34" charset="-120"/>
+              </a:rPr>
+              <a:t>Conclusiones</a:t>
+            </a:r>
+            <a:endParaRPr lang="en-US" sz="3400" dirty="0"/>
+          </a:p>
+        </p:txBody>
+      </p:sp>
+      <p:sp>
+        <p:nvSpPr>
+          <p:cNvPr id="3" name="Text 1"/>
+          <p:cNvSpPr/>
+          <p:nvPr/>
+        </p:nvSpPr>
+        <p:spPr>
+          <a:xfrm>
+            <a:off x="777240" y="1508760"/>
+            <a:ext cx="10607040" cy="365760"/>
+          </a:xfrm>
+          <a:prstGeom prst="rect">
+            <a:avLst/>
+          </a:prstGeom>
+          <a:noFill/>
+          <a:ln/>
+        </p:spPr>
+        <p:txBody>
+          <a:bodyPr wrap="square" lIns="0" tIns="0" rIns="0" bIns="0" rtlCol="0" anchor="t"/>
+          <a:lstStyle/>
+          <a:p>
+            <a:pPr indent="0" marL="0">
+              <a:buNone/>
+            </a:pPr>
+            <a:r>
+              <a:rPr lang="en-US" sz="1700" dirty="0">
+                <a:solidFill>
+                  <a:srgbClr val="5A5F73"/>
+                </a:solidFill>
+                <a:latin typeface="Calibri" pitchFamily="34" charset="0"/>
+                <a:ea typeface="Calibri" pitchFamily="34" charset="-122"/>
+                <a:cs typeface="Calibri" pitchFamily="34" charset="-120"/>
+              </a:rPr>
+              <a:t>Balance de haber desarrollado el proyecto con asistencia de IA.</a:t>
+            </a:r>
+            <a:endParaRPr lang="en-US" sz="1700" dirty="0"/>
+          </a:p>
+        </p:txBody>
+      </p:sp>
+      <p:sp>
+        <p:nvSpPr>
+          <p:cNvPr id="4" name="Text 2"/>
+          <p:cNvSpPr/>
+          <p:nvPr/>
+        </p:nvSpPr>
+        <p:spPr>
+          <a:xfrm>
+            <a:off x="777240" y="2286000"/>
+            <a:ext cx="4846320" cy="365760"/>
+          </a:xfrm>
+          <a:prstGeom prst="rect">
+            <a:avLst/>
+          </a:prstGeom>
+          <a:noFill/>
+          <a:ln/>
+        </p:spPr>
+        <p:txBody>
+          <a:bodyPr wrap="square" lIns="0" tIns="0" rIns="0" bIns="0" rtlCol="0" anchor="t"/>
+          <a:lstStyle/>
+          <a:p>
+            <a:pPr indent="0" marL="0">
+              <a:buNone/>
+            </a:pPr>
+            <a:r>
+              <a:rPr lang="en-US" sz="2000" b="1" dirty="0">
+                <a:solidFill>
+                  <a:srgbClr val="202CFC"/>
+                </a:solidFill>
+                <a:latin typeface="Arial" pitchFamily="34" charset="0"/>
+                <a:ea typeface="Arial" pitchFamily="34" charset="-122"/>
+                <a:cs typeface="Arial" pitchFamily="34" charset="-120"/>
+              </a:rPr>
+              <a:t>Lo que aporta</a:t>
+            </a:r>
+            <a:endParaRPr lang="en-US" sz="2000" dirty="0"/>
+          </a:p>
+        </p:txBody>
+      </p:sp>
+      <p:sp>
+        <p:nvSpPr>
+          <p:cNvPr id="5" name="Text 3"/>
+          <p:cNvSpPr/>
+          <p:nvPr/>
+        </p:nvSpPr>
+        <p:spPr>
+          <a:xfrm>
+            <a:off x="777240" y="2834640"/>
+            <a:ext cx="4846320" cy="2468880"/>
+          </a:xfrm>
+          <a:prstGeom prst="rect">
+            <a:avLst/>
+          </a:prstGeom>
+          <a:noFill/>
+          <a:ln/>
+        </p:spPr>
+        <p:txBody>
+          <a:bodyPr wrap="square" lIns="0" tIns="0" rIns="0" bIns="0" rtlCol="0" anchor="t"/>
+          <a:lstStyle/>
+          <a:p>
+            <a:pPr marL="342900" indent="-342900">
+              <a:lnSpc>
+                <a:spcPts val="2200"/>
+              </a:lnSpc>
+              <a:spcAft>
+                <a:spcPts val="1300"/>
+              </a:spcAft>
+              <a:buSzPct val="100000"/>
+              <a:buChar char="•"/>
+            </a:pPr>
+            <a:r>
+              <a:rPr lang="en-US" sz="1600" dirty="0">
+                <a:solidFill>
+                  <a:srgbClr val="1A1C2E"/>
+                </a:solidFill>
+                <a:latin typeface="Calibri" pitchFamily="34" charset="0"/>
+                <a:ea typeface="Calibri" pitchFamily="34" charset="-122"/>
+                <a:cs typeface="Calibri" pitchFamily="34" charset="-120"/>
+              </a:rPr>
+              <a:t>Se pueden construir cosas complejas mucho más rápido</a:t>
+            </a:r>
+            <a:endParaRPr lang="en-US" sz="1600" dirty="0"/>
+          </a:p>
+          <a:p>
+            <a:pPr marL="342900" indent="-342900">
+              <a:lnSpc>
+                <a:spcPts val="2200"/>
+              </a:lnSpc>
+              <a:spcAft>
+                <a:spcPts val="1300"/>
+              </a:spcAft>
+              <a:buSzPct val="100000"/>
+              <a:buChar char="•"/>
+            </a:pPr>
+            <a:r>
+              <a:rPr lang="en-US" sz="1600" dirty="0">
+                <a:solidFill>
+                  <a:srgbClr val="1A1C2E"/>
+                </a:solidFill>
+                <a:latin typeface="Calibri" pitchFamily="34" charset="0"/>
+                <a:ea typeface="Calibri" pitchFamily="34" charset="-122"/>
+                <a:cs typeface="Calibri" pitchFamily="34" charset="-120"/>
+              </a:rPr>
+              <a:t>Lo que antes eran meses o años, ahora son semanas</a:t>
+            </a:r>
+            <a:endParaRPr lang="en-US" sz="1600" dirty="0"/>
+          </a:p>
+          <a:p>
+            <a:pPr marL="342900" indent="-342900">
+              <a:lnSpc>
+                <a:spcPts val="2200"/>
+              </a:lnSpc>
+              <a:spcAft>
+                <a:spcPts val="1300"/>
+              </a:spcAft>
+              <a:buSzPct val="100000"/>
+              <a:buChar char="•"/>
+            </a:pPr>
+            <a:r>
+              <a:rPr lang="en-US" sz="1600" dirty="0">
+                <a:solidFill>
+                  <a:srgbClr val="1A1C2E"/>
+                </a:solidFill>
+                <a:latin typeface="Calibri" pitchFamily="34" charset="0"/>
+                <a:ea typeface="Calibri" pitchFamily="34" charset="-122"/>
+                <a:cs typeface="Calibri" pitchFamily="34" charset="-120"/>
+              </a:rPr>
+              <a:t>Y se aprende más por el camino: herramientas y frameworks que no habrías tocado</a:t>
+            </a:r>
+            <a:endParaRPr lang="en-US" sz="1600" dirty="0"/>
+          </a:p>
+        </p:txBody>
+      </p:sp>
+      <p:sp>
+        <p:nvSpPr>
+          <p:cNvPr id="6" name="Text 4"/>
+          <p:cNvSpPr/>
+          <p:nvPr/>
+        </p:nvSpPr>
+        <p:spPr>
+          <a:xfrm>
+            <a:off x="6537960" y="2286000"/>
+            <a:ext cx="4846320" cy="365760"/>
+          </a:xfrm>
+          <a:prstGeom prst="rect">
+            <a:avLst/>
+          </a:prstGeom>
+          <a:noFill/>
+          <a:ln/>
+        </p:spPr>
+        <p:txBody>
+          <a:bodyPr wrap="square" lIns="0" tIns="0" rIns="0" bIns="0" rtlCol="0" anchor="t"/>
+          <a:lstStyle/>
+          <a:p>
+            <a:pPr indent="0" marL="0">
+              <a:buNone/>
+            </a:pPr>
+            <a:r>
+              <a:rPr lang="en-US" sz="2000" b="1" dirty="0">
+                <a:solidFill>
+                  <a:srgbClr val="202CFC"/>
+                </a:solidFill>
+                <a:latin typeface="Arial" pitchFamily="34" charset="0"/>
+                <a:ea typeface="Arial" pitchFamily="34" charset="-122"/>
+                <a:cs typeface="Arial" pitchFamily="34" charset="-120"/>
+              </a:rPr>
+              <a:t>Lo que exige</a:t>
+            </a:r>
+            <a:endParaRPr lang="en-US" sz="2000" dirty="0"/>
+          </a:p>
+        </p:txBody>
+      </p:sp>
+      <p:sp>
+        <p:nvSpPr>
+          <p:cNvPr id="7" name="Text 5"/>
+          <p:cNvSpPr/>
+          <p:nvPr/>
+        </p:nvSpPr>
+        <p:spPr>
+          <a:xfrm>
+            <a:off x="6537960" y="2834640"/>
+            <a:ext cx="4846320" cy="2468880"/>
+          </a:xfrm>
+          <a:prstGeom prst="rect">
+            <a:avLst/>
+          </a:prstGeom>
+          <a:noFill/>
+          <a:ln/>
+        </p:spPr>
+        <p:txBody>
+          <a:bodyPr wrap="square" lIns="0" tIns="0" rIns="0" bIns="0" rtlCol="0" anchor="t"/>
+          <a:lstStyle/>
+          <a:p>
+            <a:pPr marL="342900" indent="-342900">
+              <a:lnSpc>
+                <a:spcPts val="2200"/>
+              </a:lnSpc>
+              <a:spcAft>
+                <a:spcPts val="1300"/>
+              </a:spcAft>
+              <a:buSzPct val="100000"/>
+              <a:buChar char="•"/>
+            </a:pPr>
+            <a:r>
+              <a:rPr lang="en-US" sz="1600" dirty="0">
+                <a:solidFill>
+                  <a:srgbClr val="1A1C2E"/>
+                </a:solidFill>
+                <a:latin typeface="Calibri" pitchFamily="34" charset="0"/>
+                <a:ea typeface="Calibri" pitchFamily="34" charset="-122"/>
+                <a:cs typeface="Calibri" pitchFamily="34" charset="-120"/>
+              </a:rPr>
+              <a:t>Acelera, pero también se equivoca</a:t>
+            </a:r>
+            <a:endParaRPr lang="en-US" sz="1600" dirty="0"/>
+          </a:p>
+          <a:p>
+            <a:pPr marL="342900" indent="-342900">
+              <a:lnSpc>
+                <a:spcPts val="2200"/>
+              </a:lnSpc>
+              <a:spcAft>
+                <a:spcPts val="1300"/>
+              </a:spcAft>
+              <a:buSzPct val="100000"/>
+              <a:buChar char="•"/>
+            </a:pPr>
+            <a:r>
+              <a:rPr lang="en-US" sz="1600" dirty="0">
+                <a:solidFill>
+                  <a:srgbClr val="1A1C2E"/>
+                </a:solidFill>
+                <a:latin typeface="Calibri" pitchFamily="34" charset="0"/>
+                <a:ea typeface="Calibri" pitchFamily="34" charset="-122"/>
+                <a:cs typeface="Calibri" pitchFamily="34" charset="-120"/>
+              </a:rPr>
+              <a:t>Hay que revisar lo que se sube, no vale con fiarse</a:t>
+            </a:r>
+            <a:endParaRPr lang="en-US" sz="1600" dirty="0"/>
+          </a:p>
+          <a:p>
+            <a:pPr marL="342900" indent="-342900">
+              <a:lnSpc>
+                <a:spcPts val="2200"/>
+              </a:lnSpc>
+              <a:spcAft>
+                <a:spcPts val="1300"/>
+              </a:spcAft>
+              <a:buSzPct val="100000"/>
+              <a:buChar char="•"/>
+            </a:pPr>
+            <a:r>
+              <a:rPr lang="en-US" sz="1600" dirty="0">
+                <a:solidFill>
+                  <a:srgbClr val="1A1C2E"/>
+                </a:solidFill>
+                <a:latin typeface="Calibri" pitchFamily="34" charset="0"/>
+                <a:ea typeface="Calibri" pitchFamily="34" charset="-122"/>
+                <a:cs typeface="Calibri" pitchFamily="34" charset="-120"/>
+              </a:rPr>
+              <a:t>No es todo tan bonito como parece: hay que dedicarle tiempo</a:t>
+            </a:r>
+            <a:endParaRPr lang="en-US" sz="1600" dirty="0"/>
+          </a:p>
+        </p:txBody>
+      </p:sp>
+      <p:sp>
+        <p:nvSpPr>
+          <p:cNvPr id="8" name="Shape 6"/>
+          <p:cNvSpPr/>
+          <p:nvPr/>
+        </p:nvSpPr>
+        <p:spPr>
+          <a:xfrm>
+            <a:off x="777240" y="6263640"/>
+            <a:ext cx="219456" cy="219456"/>
+          </a:xfrm>
+          <a:prstGeom prst="rect">
+            <a:avLst/>
+          </a:prstGeom>
+          <a:solidFill>
+            <a:srgbClr val="202CFC"/>
+          </a:solidFill>
+          <a:ln/>
+        </p:spPr>
+      </p:sp>
+      <p:sp>
+        <p:nvSpPr>
+          <p:cNvPr id="9" name="Text 7"/>
+          <p:cNvSpPr/>
+          <p:nvPr/>
+        </p:nvSpPr>
+        <p:spPr>
+          <a:xfrm>
+            <a:off x="777240" y="6263640"/>
+            <a:ext cx="219456" cy="219456"/>
+          </a:xfrm>
+          <a:prstGeom prst="rect">
+            <a:avLst/>
+          </a:prstGeom>
+          <a:noFill/>
+          <a:ln/>
+        </p:spPr>
+        <p:txBody>
+          <a:bodyPr wrap="square" lIns="0" tIns="0" rIns="0" bIns="0" rtlCol="0" anchor="ctr"/>
+          <a:lstStyle/>
+          <a:p>
+            <a:pPr algn="ctr" indent="0" marL="0">
+              <a:buNone/>
+            </a:pPr>
+            <a:r>
+              <a:rPr lang="en-US" sz="816" b="1" dirty="0">
+                <a:solidFill>
+                  <a:srgbClr val="FFFFFF"/>
+                </a:solidFill>
+                <a:latin typeface="Arial" pitchFamily="34" charset="0"/>
+                <a:ea typeface="Arial" pitchFamily="34" charset="-122"/>
+                <a:cs typeface="Arial" pitchFamily="34" charset="-120"/>
+              </a:rPr>
+              <a:t>BIG</a:t>
+            </a:r>
+            <a:endParaRPr lang="en-US" sz="816" dirty="0"/>
+          </a:p>
+        </p:txBody>
+      </p:sp>
+      <p:sp>
+        <p:nvSpPr>
+          <p:cNvPr id="10" name="Text 8"/>
+          <p:cNvSpPr/>
+          <p:nvPr/>
+        </p:nvSpPr>
+        <p:spPr>
+          <a:xfrm>
+            <a:off x="1078992" y="6263640"/>
+            <a:ext cx="658368" cy="219456"/>
+          </a:xfrm>
+          <a:prstGeom prst="rect">
+            <a:avLst/>
+          </a:prstGeom>
+          <a:noFill/>
+          <a:ln/>
+        </p:spPr>
+        <p:txBody>
+          <a:bodyPr wrap="square" lIns="0" tIns="0" rIns="0" bIns="0" rtlCol="0" anchor="ctr"/>
+          <a:lstStyle/>
+          <a:p>
+            <a:pPr algn="l" indent="0" marL="0">
+              <a:buNone/>
+            </a:pPr>
+            <a:r>
+              <a:rPr lang="en-US" sz="816" dirty="0">
+                <a:solidFill>
+                  <a:srgbClr val="1A1C2E"/>
+                </a:solidFill>
+                <a:latin typeface="Arial" pitchFamily="34" charset="0"/>
+                <a:ea typeface="Arial" pitchFamily="34" charset="-122"/>
+                <a:cs typeface="Arial" pitchFamily="34" charset="-120"/>
+              </a:rPr>
+              <a:t>school</a:t>
+            </a:r>
+            <a:endParaRPr lang="en-US" sz="816" dirty="0"/>
+          </a:p>
+        </p:txBody>
+      </p:sp>
+      <p:sp>
+        <p:nvSpPr>
+          <p:cNvPr id="11" name="Text 9"/>
+          <p:cNvSpPr/>
+          <p:nvPr/>
+        </p:nvSpPr>
+        <p:spPr>
+          <a:xfrm>
+            <a:off x="11064240" y="6263640"/>
+            <a:ext cx="320040" cy="219456"/>
+          </a:xfrm>
+          <a:prstGeom prst="rect">
+            <a:avLst/>
+          </a:prstGeom>
+          <a:noFill/>
+          <a:ln/>
+        </p:spPr>
+        <p:txBody>
+          <a:bodyPr wrap="square" lIns="0" tIns="0" rIns="0" bIns="0" rtlCol="0" anchor="ctr"/>
+          <a:lstStyle/>
+          <a:p>
+            <a:pPr algn="r" indent="0" marL="0">
+              <a:buNone/>
+            </a:pPr>
+            <a:r>
+              <a:rPr lang="en-US" sz="1000" dirty="0">
+                <a:solidFill>
+                  <a:srgbClr val="5A5F73"/>
+                </a:solidFill>
+                <a:latin typeface="Calibri" pitchFamily="34" charset="0"/>
+                <a:ea typeface="Calibri" pitchFamily="34" charset="-122"/>
+                <a:cs typeface="Calibri" pitchFamily="34" charset="-120"/>
+              </a:rPr>
+              <a:t>18</a:t>
+            </a:r>
+            <a:endParaRPr lang="en-US" sz="1000" dirty="0"/>
+          </a:p>
+        </p:txBody>
+      </p:sp>
+    </p:spTree>
+  </p:cSld>
+  <p:clrMapOvr>
+    <a:masterClrMapping/>
+  </p:clrMapOvr>
+</p:sld>
+</file>
+
+<file path=ppt/slides/slide19.xml><?xml version="1.0" encoding="utf-8"?>
+<p:sld xmlns:a="http://schemas.openxmlformats.org/drawingml/2006/main" xmlns:r="http://schemas.openxmlformats.org/officeDocument/2006/relationships" xmlns:p="http://schemas.openxmlformats.org/presentationml/2006/main">
+  <p:cSld name="Slide 19">
     <p:bg>
       <p:bgPr>
         <a:solidFill>

</xml_diff>

<commit_message>
docs(tfm): usar los nombres oficiales de las categorias OWASP
</commit_message>
<xml_diff>
--- a/docs/presentacion/tfm-intelligent-automotive-diagnostics.pptx
+++ b/docs/presentacion/tfm-intelligent-automotive-diagnostics.pptx
@@ -7785,7 +7785,7 @@
                 <a:ea typeface="Calibri" pitchFamily="34" charset="-122"/>
                 <a:cs typeface="Calibri" pitchFamily="34" charset="-120"/>
               </a:rPr>
-              <a:t>Las diez categorías, con la medida que se aplicó en el código.</a:t>
+              <a:t>Los diez identificadores oficiales, con la medida que se aplicó en el código.</a:t>
             </a:r>
             <a:endParaRPr lang="en-US" sz="1700" dirty="0"/>
           </a:p>
@@ -7839,7 +7839,7 @@
         <p:spPr>
           <a:xfrm>
             <a:off x="1481328" y="2084832"/>
-            <a:ext cx="2834640" cy="365760"/>
+            <a:ext cx="3429000" cy="365760"/>
           </a:xfrm>
           <a:prstGeom prst="rect">
             <a:avLst/>
@@ -7863,7 +7863,7 @@
                 <a:ea typeface="Arial" pitchFamily="34" charset="-122"/>
                 <a:cs typeface="Arial" pitchFamily="34" charset="-120"/>
               </a:rPr>
-              <a:t>Autorización de objeto</a:t>
+              <a:t>Autorización a nivel de objeto</a:t>
             </a:r>
             <a:endParaRPr lang="en-US" sz="1200" dirty="0"/>
           </a:p>
@@ -7877,8 +7877,8 @@
         </p:nvSpPr>
         <p:spPr>
           <a:xfrm>
-            <a:off x="4389120" y="2084832"/>
-            <a:ext cx="6995160" cy="365760"/>
+            <a:off x="4983480" y="2084832"/>
+            <a:ext cx="6400800" cy="365760"/>
           </a:xfrm>
           <a:prstGeom prst="rect">
             <a:avLst/>
@@ -7894,7 +7894,7 @@
               <a:buNone/>
             </a:pPr>
             <a:r>
-              <a:rPr lang="en-US" sz="1300" dirty="0">
+              <a:rPr lang="en-US" sz="1200" dirty="0">
                 <a:solidFill>
                   <a:srgbClr val="5A5F73"/>
                 </a:solidFill>
@@ -7904,7 +7904,7 @@
               </a:rPr>
               <a:t>Las consultas filtran por propietario: la sesión de otro usuario devuelve 404, no 403</a:t>
             </a:r>
-            <a:endParaRPr lang="en-US" sz="1300" dirty="0"/>
+            <a:endParaRPr lang="en-US" sz="1200" dirty="0"/>
           </a:p>
         </p:txBody>
       </p:sp>
@@ -7956,7 +7956,7 @@
         <p:spPr>
           <a:xfrm>
             <a:off x="1481328" y="2487168"/>
-            <a:ext cx="2834640" cy="365760"/>
+            <a:ext cx="3429000" cy="365760"/>
           </a:xfrm>
           <a:prstGeom prst="rect">
             <a:avLst/>
@@ -7980,7 +7980,7 @@
                 <a:ea typeface="Arial" pitchFamily="34" charset="-122"/>
                 <a:cs typeface="Arial" pitchFamily="34" charset="-120"/>
               </a:rPr>
-              <a:t>Autenticación</a:t>
+              <a:t>Autenticación rota</a:t>
             </a:r>
             <a:endParaRPr lang="en-US" sz="1200" dirty="0"/>
           </a:p>
@@ -7994,8 +7994,8 @@
         </p:nvSpPr>
         <p:spPr>
           <a:xfrm>
-            <a:off x="4389120" y="2487168"/>
-            <a:ext cx="6995160" cy="365760"/>
+            <a:off x="4983480" y="2487168"/>
+            <a:ext cx="6400800" cy="365760"/>
           </a:xfrm>
           <a:prstGeom prst="rect">
             <a:avLst/>
@@ -8011,7 +8011,7 @@
               <a:buNone/>
             </a:pPr>
             <a:r>
-              <a:rPr lang="en-US" sz="1300" dirty="0">
+              <a:rPr lang="en-US" sz="1200" dirty="0">
                 <a:solidFill>
                   <a:srgbClr val="5A5F73"/>
                 </a:solidFill>
@@ -8021,7 +8021,7 @@
               </a:rPr>
               <a:t>bcrypt de 12 rondas, rotación de refresh tokens y bloqueo de cuenta a los 5 fallos</a:t>
             </a:r>
-            <a:endParaRPr lang="en-US" sz="1300" dirty="0"/>
+            <a:endParaRPr lang="en-US" sz="1200" dirty="0"/>
           </a:p>
         </p:txBody>
       </p:sp>
@@ -8073,7 +8073,7 @@
         <p:spPr>
           <a:xfrm>
             <a:off x="1481328" y="2889504"/>
-            <a:ext cx="2834640" cy="365760"/>
+            <a:ext cx="3429000" cy="365760"/>
           </a:xfrm>
           <a:prstGeom prst="rect">
             <a:avLst/>
@@ -8097,7 +8097,7 @@
                 <a:ea typeface="Arial" pitchFamily="34" charset="-122"/>
                 <a:cs typeface="Arial" pitchFamily="34" charset="-120"/>
               </a:rPr>
-              <a:t>Propiedades del objeto</a:t>
+              <a:t>Autorización a nivel de propiedad</a:t>
             </a:r>
             <a:endParaRPr lang="en-US" sz="1200" dirty="0"/>
           </a:p>
@@ -8111,8 +8111,8 @@
         </p:nvSpPr>
         <p:spPr>
           <a:xfrm>
-            <a:off x="4389120" y="2889504"/>
-            <a:ext cx="6995160" cy="365760"/>
+            <a:off x="4983480" y="2889504"/>
+            <a:ext cx="6400800" cy="365760"/>
           </a:xfrm>
           <a:prstGeom prst="rect">
             <a:avLst/>
@@ -8128,7 +8128,7 @@
               <a:buNone/>
             </a:pPr>
             <a:r>
-              <a:rPr lang="en-US" sz="1300" dirty="0">
+              <a:rPr lang="en-US" sz="1200" dirty="0">
                 <a:solidFill>
                   <a:srgbClr val="5A5F73"/>
                 </a:solidFill>
@@ -8138,7 +8138,7 @@
               </a:rPr>
               <a:t>Los esquemas Zod son la allowlist de campos: lo no declarado no entra</a:t>
             </a:r>
-            <a:endParaRPr lang="en-US" sz="1300" dirty="0"/>
+            <a:endParaRPr lang="en-US" sz="1200" dirty="0"/>
           </a:p>
         </p:txBody>
       </p:sp>
@@ -8190,7 +8190,7 @@
         <p:spPr>
           <a:xfrm>
             <a:off x="1481328" y="3291840"/>
-            <a:ext cx="2834640" cy="365760"/>
+            <a:ext cx="3429000" cy="365760"/>
           </a:xfrm>
           <a:prstGeom prst="rect">
             <a:avLst/>
@@ -8214,7 +8214,7 @@
                 <a:ea typeface="Arial" pitchFamily="34" charset="-122"/>
                 <a:cs typeface="Arial" pitchFamily="34" charset="-120"/>
               </a:rPr>
-              <a:t>Consumo de recursos</a:t>
+              <a:t>Consumo de recursos sin restricción</a:t>
             </a:r>
             <a:endParaRPr lang="en-US" sz="1200" dirty="0"/>
           </a:p>
@@ -8228,8 +8228,8 @@
         </p:nvSpPr>
         <p:spPr>
           <a:xfrm>
-            <a:off x="4389120" y="3291840"/>
-            <a:ext cx="6995160" cy="365760"/>
+            <a:off x="4983480" y="3291840"/>
+            <a:ext cx="6400800" cy="365760"/>
           </a:xfrm>
           <a:prstGeom prst="rect">
             <a:avLst/>
@@ -8245,7 +8245,7 @@
               <a:buNone/>
             </a:pPr>
             <a:r>
-              <a:rPr lang="en-US" sz="1300" dirty="0">
+              <a:rPr lang="en-US" sz="1200" dirty="0">
                 <a:solidFill>
                   <a:srgbClr val="5A5F73"/>
                 </a:solidFill>
@@ -8253,9 +8253,9 @@
                 <a:ea typeface="Calibri" pitchFamily="34" charset="-122"/>
                 <a:cs typeface="Calibri" pitchFamily="34" charset="-120"/>
               </a:rPr>
-              <a:t>Límites por familia: login 5/min, diagnóstico 20/min, cognitivo 5/min; body de 10 KB</a:t>
-            </a:r>
-            <a:endParaRPr lang="en-US" sz="1300" dirty="0"/>
+              <a:t>Límites por familia: login 5/min, diagnóstico 20/min, cognitivo 5/min</a:t>
+            </a:r>
+            <a:endParaRPr lang="en-US" sz="1200" dirty="0"/>
           </a:p>
         </p:txBody>
       </p:sp>
@@ -8307,7 +8307,7 @@
         <p:spPr>
           <a:xfrm>
             <a:off x="1481328" y="3694176"/>
-            <a:ext cx="2834640" cy="365760"/>
+            <a:ext cx="3429000" cy="365760"/>
           </a:xfrm>
           <a:prstGeom prst="rect">
             <a:avLst/>
@@ -8331,7 +8331,7 @@
                 <a:ea typeface="Arial" pitchFamily="34" charset="-122"/>
                 <a:cs typeface="Arial" pitchFamily="34" charset="-120"/>
               </a:rPr>
-              <a:t>Autorización de función</a:t>
+              <a:t>Autorización a nivel de función</a:t>
             </a:r>
             <a:endParaRPr lang="en-US" sz="1200" dirty="0"/>
           </a:p>
@@ -8345,8 +8345,8 @@
         </p:nvSpPr>
         <p:spPr>
           <a:xfrm>
-            <a:off x="4389120" y="3694176"/>
-            <a:ext cx="6995160" cy="365760"/>
+            <a:off x="4983480" y="3694176"/>
+            <a:ext cx="6400800" cy="365760"/>
           </a:xfrm>
           <a:prstGeom prst="rect">
             <a:avLst/>
@@ -8362,7 +8362,7 @@
               <a:buNone/>
             </a:pPr>
             <a:r>
-              <a:rPr lang="en-US" sz="1300" dirty="0">
+              <a:rPr lang="en-US" sz="1200" dirty="0">
                 <a:solidFill>
                   <a:srgbClr val="5A5F73"/>
                 </a:solidFill>
@@ -8372,7 +8372,7 @@
               </a:rPr>
               <a:t>Todo /api tras el middleware de sesión; administración tras requireAdmin</a:t>
             </a:r>
-            <a:endParaRPr lang="en-US" sz="1300" dirty="0"/>
+            <a:endParaRPr lang="en-US" sz="1200" dirty="0"/>
           </a:p>
         </p:txBody>
       </p:sp>
@@ -8424,7 +8424,7 @@
         <p:spPr>
           <a:xfrm>
             <a:off x="1481328" y="4096512"/>
-            <a:ext cx="2834640" cy="365760"/>
+            <a:ext cx="3429000" cy="365760"/>
           </a:xfrm>
           <a:prstGeom prst="rect">
             <a:avLst/>
@@ -8448,7 +8448,7 @@
                 <a:ea typeface="Arial" pitchFamily="34" charset="-122"/>
                 <a:cs typeface="Arial" pitchFamily="34" charset="-120"/>
               </a:rPr>
-              <a:t>Flujos de negocio sensibles</a:t>
+              <a:t>Acceso a flujos de negocio sensibles</a:t>
             </a:r>
             <a:endParaRPr lang="en-US" sz="1200" dirty="0"/>
           </a:p>
@@ -8462,8 +8462,8 @@
         </p:nvSpPr>
         <p:spPr>
           <a:xfrm>
-            <a:off x="4389120" y="4096512"/>
-            <a:ext cx="6995160" cy="365760"/>
+            <a:off x="4983480" y="4096512"/>
+            <a:ext cx="6400800" cy="365760"/>
           </a:xfrm>
           <a:prstGeom prst="rect">
             <a:avLst/>
@@ -8479,7 +8479,7 @@
               <a:buNone/>
             </a:pPr>
             <a:r>
-              <a:rPr lang="en-US" sz="1300" dirty="0">
+              <a:rPr lang="en-US" sz="1200" dirty="0">
                 <a:solidFill>
                   <a:srgbClr val="5A5F73"/>
                 </a:solidFill>
@@ -8489,7 +8489,7 @@
               </a:rPr>
               <a:t>El borrado de códigos de avería lleva límite propio y se apaga con OBD_READ_ONLY</a:t>
             </a:r>
-            <a:endParaRPr lang="en-US" sz="1300" dirty="0"/>
+            <a:endParaRPr lang="en-US" sz="1200" dirty="0"/>
           </a:p>
         </p:txBody>
       </p:sp>
@@ -8541,7 +8541,7 @@
         <p:spPr>
           <a:xfrm>
             <a:off x="1481328" y="4498848"/>
-            <a:ext cx="2834640" cy="365760"/>
+            <a:ext cx="3429000" cy="365760"/>
           </a:xfrm>
           <a:prstGeom prst="rect">
             <a:avLst/>
@@ -8565,7 +8565,7 @@
                 <a:ea typeface="Arial" pitchFamily="34" charset="-122"/>
                 <a:cs typeface="Arial" pitchFamily="34" charset="-120"/>
               </a:rPr>
-              <a:t>SSRF</a:t>
+              <a:t>Server Side Request Forgery</a:t>
             </a:r>
             <a:endParaRPr lang="en-US" sz="1200" dirty="0"/>
           </a:p>
@@ -8579,8 +8579,8 @@
         </p:nvSpPr>
         <p:spPr>
           <a:xfrm>
-            <a:off x="4389120" y="4498848"/>
-            <a:ext cx="6995160" cy="365760"/>
+            <a:off x="4983480" y="4498848"/>
+            <a:ext cx="6400800" cy="365760"/>
           </a:xfrm>
           <a:prstGeom prst="rect">
             <a:avLst/>
@@ -8596,7 +8596,7 @@
               <a:buNone/>
             </a:pPr>
             <a:r>
-              <a:rPr lang="en-US" sz="1300" dirty="0">
+              <a:rPr lang="en-US" sz="1200" dirty="0">
                 <a:solidFill>
                   <a:srgbClr val="5A5F73"/>
                 </a:solidFill>
@@ -8606,7 +8606,7 @@
               </a:rPr>
               <a:t>El usuario no controla ninguna URL de salida: proveedor fijo y timeout de 30 s</a:t>
             </a:r>
-            <a:endParaRPr lang="en-US" sz="1300" dirty="0"/>
+            <a:endParaRPr lang="en-US" sz="1200" dirty="0"/>
           </a:p>
         </p:txBody>
       </p:sp>
@@ -8658,7 +8658,7 @@
         <p:spPr>
           <a:xfrm>
             <a:off x="1481328" y="4901184"/>
-            <a:ext cx="2834640" cy="365760"/>
+            <a:ext cx="3429000" cy="365760"/>
           </a:xfrm>
           <a:prstGeom prst="rect">
             <a:avLst/>
@@ -8682,7 +8682,7 @@
                 <a:ea typeface="Arial" pitchFamily="34" charset="-122"/>
                 <a:cs typeface="Arial" pitchFamily="34" charset="-120"/>
               </a:rPr>
-              <a:t>Configuración</a:t>
+              <a:t>Configuración de seguridad incorrecta</a:t>
             </a:r>
             <a:endParaRPr lang="en-US" sz="1200" dirty="0"/>
           </a:p>
@@ -8696,8 +8696,8 @@
         </p:nvSpPr>
         <p:spPr>
           <a:xfrm>
-            <a:off x="4389120" y="4901184"/>
-            <a:ext cx="6995160" cy="365760"/>
+            <a:off x="4983480" y="4901184"/>
+            <a:ext cx="6400800" cy="365760"/>
           </a:xfrm>
           <a:prstGeom prst="rect">
             <a:avLst/>
@@ -8713,7 +8713,7 @@
               <a:buNone/>
             </a:pPr>
             <a:r>
-              <a:rPr lang="en-US" sz="1300" dirty="0">
+              <a:rPr lang="en-US" sz="1200" dirty="0">
                 <a:solidFill>
                   <a:srgbClr val="5A5F73"/>
                 </a:solidFill>
@@ -8723,7 +8723,7 @@
               </a:rPr>
               <a:t>Helmet 8 con CSP default-src none, HSTS de un año y allowlist de CORS</a:t>
             </a:r>
-            <a:endParaRPr lang="en-US" sz="1300" dirty="0"/>
+            <a:endParaRPr lang="en-US" sz="1200" dirty="0"/>
           </a:p>
         </p:txBody>
       </p:sp>
@@ -8775,7 +8775,7 @@
         <p:spPr>
           <a:xfrm>
             <a:off x="1481328" y="5303520"/>
-            <a:ext cx="2834640" cy="365760"/>
+            <a:ext cx="3429000" cy="365760"/>
           </a:xfrm>
           <a:prstGeom prst="rect">
             <a:avLst/>
@@ -8799,7 +8799,7 @@
                 <a:ea typeface="Arial" pitchFamily="34" charset="-122"/>
                 <a:cs typeface="Arial" pitchFamily="34" charset="-120"/>
               </a:rPr>
-              <a:t>Inventario de la API</a:t>
+              <a:t>Gestión indebida del inventario</a:t>
             </a:r>
             <a:endParaRPr lang="en-US" sz="1200" dirty="0"/>
           </a:p>
@@ -8813,8 +8813,8 @@
         </p:nvSpPr>
         <p:spPr>
           <a:xfrm>
-            <a:off x="4389120" y="5303520"/>
-            <a:ext cx="6995160" cy="365760"/>
+            <a:off x="4983480" y="5303520"/>
+            <a:ext cx="6400800" cy="365760"/>
           </a:xfrm>
           <a:prstGeom prst="rect">
             <a:avLst/>
@@ -8830,7 +8830,7 @@
               <a:buNone/>
             </a:pPr>
             <a:r>
-              <a:rPr lang="en-US" sz="1300" dirty="0">
+              <a:rPr lang="en-US" sz="1200" dirty="0">
                 <a:solidFill>
                   <a:srgbClr val="5A5F73"/>
                 </a:solidFill>
@@ -8840,7 +8840,7 @@
               </a:rPr>
               <a:t>Especificación OpenAPI versionada y servida por la propia API</a:t>
             </a:r>
-            <a:endParaRPr lang="en-US" sz="1300" dirty="0"/>
+            <a:endParaRPr lang="en-US" sz="1200" dirty="0"/>
           </a:p>
         </p:txBody>
       </p:sp>
@@ -8892,7 +8892,7 @@
         <p:spPr>
           <a:xfrm>
             <a:off x="1481328" y="5705856"/>
-            <a:ext cx="2834640" cy="365760"/>
+            <a:ext cx="3429000" cy="365760"/>
           </a:xfrm>
           <a:prstGeom prst="rect">
             <a:avLst/>
@@ -8916,7 +8916,7 @@
                 <a:ea typeface="Arial" pitchFamily="34" charset="-122"/>
                 <a:cs typeface="Arial" pitchFamily="34" charset="-120"/>
               </a:rPr>
-              <a:t>Consumo de APIs externas</a:t>
+              <a:t>Consumo inseguro de APIs</a:t>
             </a:r>
             <a:endParaRPr lang="en-US" sz="1200" dirty="0"/>
           </a:p>
@@ -8930,8 +8930,8 @@
         </p:nvSpPr>
         <p:spPr>
           <a:xfrm>
-            <a:off x="4389120" y="5705856"/>
-            <a:ext cx="6995160" cy="365760"/>
+            <a:off x="4983480" y="5705856"/>
+            <a:ext cx="6400800" cy="365760"/>
           </a:xfrm>
           <a:prstGeom prst="rect">
             <a:avLst/>
@@ -8947,7 +8947,7 @@
               <a:buNone/>
             </a:pPr>
             <a:r>
-              <a:rPr lang="en-US" sz="1300" dirty="0">
+              <a:rPr lang="en-US" sz="1200" dirty="0">
                 <a:solidFill>
                   <a:srgbClr val="5A5F73"/>
                 </a:solidFill>
@@ -8957,7 +8957,7 @@
               </a:rPr>
               <a:t>Lo recuperado llega al modelo marcado como no fiable, nunca como instrucción</a:t>
             </a:r>
-            <a:endParaRPr lang="en-US" sz="1300" dirty="0"/>
+            <a:endParaRPr lang="en-US" sz="1200" dirty="0"/>
           </a:p>
         </p:txBody>
       </p:sp>

</xml_diff>

<commit_message>
docs(tfm): nombres OWASP tal cual los publica el proyecto
</commit_message>
<xml_diff>
--- a/docs/presentacion/tfm-intelligent-automotive-diagnostics.pptx
+++ b/docs/presentacion/tfm-intelligent-automotive-diagnostics.pptx
@@ -7785,7 +7785,7 @@
                 <a:ea typeface="Calibri" pitchFamily="34" charset="-122"/>
                 <a:cs typeface="Calibri" pitchFamily="34" charset="-120"/>
               </a:rPr>
-              <a:t>Los diez identificadores oficiales, con la medida que se aplicó en el código.</a:t>
+              <a:t>Las diez categorías, con su nombre oficial y la medida que se aplicó en el código.</a:t>
             </a:r>
             <a:endParaRPr lang="en-US" sz="1700" dirty="0"/>
           </a:p>
@@ -7800,7 +7800,7 @@
         <p:spPr>
           <a:xfrm>
             <a:off x="777240" y="2084832"/>
-            <a:ext cx="685800" cy="365760"/>
+            <a:ext cx="731520" cy="365760"/>
           </a:xfrm>
           <a:prstGeom prst="rect">
             <a:avLst/>
@@ -7816,7 +7816,7 @@
               <a:buNone/>
             </a:pPr>
             <a:r>
-              <a:rPr lang="en-US" sz="1200" b="1" dirty="0">
+              <a:rPr lang="en-US" sz="1100" b="1" dirty="0">
                 <a:solidFill>
                   <a:srgbClr val="202CFC"/>
                 </a:solidFill>
@@ -7826,7 +7826,7 @@
               </a:rPr>
               <a:t>API1</a:t>
             </a:r>
-            <a:endParaRPr lang="en-US" sz="1200" dirty="0"/>
+            <a:endParaRPr lang="en-US" sz="1100" dirty="0"/>
           </a:p>
         </p:txBody>
       </p:sp>
@@ -7838,8 +7838,8 @@
         </p:nvSpPr>
         <p:spPr>
           <a:xfrm>
-            <a:off x="1481328" y="2084832"/>
-            <a:ext cx="3429000" cy="365760"/>
+            <a:off x="1508760" y="2084832"/>
+            <a:ext cx="3977640" cy="365760"/>
           </a:xfrm>
           <a:prstGeom prst="rect">
             <a:avLst/>
@@ -7855,7 +7855,7 @@
               <a:buNone/>
             </a:pPr>
             <a:r>
-              <a:rPr lang="en-US" sz="1200" b="1" dirty="0">
+              <a:rPr lang="en-US" sz="1150" b="1" dirty="0">
                 <a:solidFill>
                   <a:srgbClr val="1A1C2E"/>
                 </a:solidFill>
@@ -7863,7 +7863,46 @@
                 <a:ea typeface="Arial" pitchFamily="34" charset="-122"/>
                 <a:cs typeface="Arial" pitchFamily="34" charset="-120"/>
               </a:rPr>
-              <a:t>Autorización a nivel de objeto</a:t>
+              <a:t>Broken Object Level Authorization</a:t>
+            </a:r>
+            <a:endParaRPr lang="en-US" sz="1150" dirty="0"/>
+          </a:p>
+        </p:txBody>
+      </p:sp>
+      <p:sp>
+        <p:nvSpPr>
+          <p:cNvPr id="6" name="Text 4"/>
+          <p:cNvSpPr/>
+          <p:nvPr/>
+        </p:nvSpPr>
+        <p:spPr>
+          <a:xfrm>
+            <a:off x="5577840" y="2084832"/>
+            <a:ext cx="5806440" cy="365760"/>
+          </a:xfrm>
+          <a:prstGeom prst="rect">
+            <a:avLst/>
+          </a:prstGeom>
+          <a:noFill/>
+          <a:ln/>
+        </p:spPr>
+        <p:txBody>
+          <a:bodyPr wrap="square" lIns="0" tIns="0" rIns="0" bIns="0" rtlCol="0" anchor="ctr"/>
+          <a:lstStyle/>
+          <a:p>
+            <a:pPr indent="0" marL="0">
+              <a:buNone/>
+            </a:pPr>
+            <a:r>
+              <a:rPr lang="en-US" sz="1200" dirty="0">
+                <a:solidFill>
+                  <a:srgbClr val="5A5F73"/>
+                </a:solidFill>
+                <a:latin typeface="Calibri" pitchFamily="34" charset="0"/>
+                <a:ea typeface="Calibri" pitchFamily="34" charset="-122"/>
+                <a:cs typeface="Calibri" pitchFamily="34" charset="-120"/>
+              </a:rPr>
+              <a:t>La sesión de otro usuario devuelve 404, no 403</a:t>
             </a:r>
             <a:endParaRPr lang="en-US" sz="1200" dirty="0"/>
           </a:p>
@@ -7871,14 +7910,14 @@
       </p:sp>
       <p:sp>
         <p:nvSpPr>
-          <p:cNvPr id="6" name="Text 4"/>
-          <p:cNvSpPr/>
-          <p:nvPr/>
-        </p:nvSpPr>
-        <p:spPr>
-          <a:xfrm>
-            <a:off x="4983480" y="2084832"/>
-            <a:ext cx="6400800" cy="365760"/>
+          <p:cNvPr id="7" name="Text 5"/>
+          <p:cNvSpPr/>
+          <p:nvPr/>
+        </p:nvSpPr>
+        <p:spPr>
+          <a:xfrm>
+            <a:off x="777240" y="2487168"/>
+            <a:ext cx="731520" cy="365760"/>
           </a:xfrm>
           <a:prstGeom prst="rect">
             <a:avLst/>
@@ -7894,46 +7933,7 @@
               <a:buNone/>
             </a:pPr>
             <a:r>
-              <a:rPr lang="en-US" sz="1200" dirty="0">
-                <a:solidFill>
-                  <a:srgbClr val="5A5F73"/>
-                </a:solidFill>
-                <a:latin typeface="Calibri" pitchFamily="34" charset="0"/>
-                <a:ea typeface="Calibri" pitchFamily="34" charset="-122"/>
-                <a:cs typeface="Calibri" pitchFamily="34" charset="-120"/>
-              </a:rPr>
-              <a:t>Las consultas filtran por propietario: la sesión de otro usuario devuelve 404, no 403</a:t>
-            </a:r>
-            <a:endParaRPr lang="en-US" sz="1200" dirty="0"/>
-          </a:p>
-        </p:txBody>
-      </p:sp>
-      <p:sp>
-        <p:nvSpPr>
-          <p:cNvPr id="7" name="Text 5"/>
-          <p:cNvSpPr/>
-          <p:nvPr/>
-        </p:nvSpPr>
-        <p:spPr>
-          <a:xfrm>
-            <a:off x="777240" y="2487168"/>
-            <a:ext cx="685800" cy="365760"/>
-          </a:xfrm>
-          <a:prstGeom prst="rect">
-            <a:avLst/>
-          </a:prstGeom>
-          <a:noFill/>
-          <a:ln/>
-        </p:spPr>
-        <p:txBody>
-          <a:bodyPr wrap="square" lIns="0" tIns="0" rIns="0" bIns="0" rtlCol="0" anchor="ctr"/>
-          <a:lstStyle/>
-          <a:p>
-            <a:pPr indent="0" marL="0">
-              <a:buNone/>
-            </a:pPr>
-            <a:r>
-              <a:rPr lang="en-US" sz="1200" b="1" dirty="0">
+              <a:rPr lang="en-US" sz="1100" b="1" dirty="0">
                 <a:solidFill>
                   <a:srgbClr val="202CFC"/>
                 </a:solidFill>
@@ -7943,7 +7943,7 @@
               </a:rPr>
               <a:t>API2</a:t>
             </a:r>
-            <a:endParaRPr lang="en-US" sz="1200" dirty="0"/>
+            <a:endParaRPr lang="en-US" sz="1100" dirty="0"/>
           </a:p>
         </p:txBody>
       </p:sp>
@@ -7955,8 +7955,8 @@
         </p:nvSpPr>
         <p:spPr>
           <a:xfrm>
-            <a:off x="1481328" y="2487168"/>
-            <a:ext cx="3429000" cy="365760"/>
+            <a:off x="1508760" y="2487168"/>
+            <a:ext cx="3977640" cy="365760"/>
           </a:xfrm>
           <a:prstGeom prst="rect">
             <a:avLst/>
@@ -7972,7 +7972,7 @@
               <a:buNone/>
             </a:pPr>
             <a:r>
-              <a:rPr lang="en-US" sz="1200" b="1" dirty="0">
+              <a:rPr lang="en-US" sz="1150" b="1" dirty="0">
                 <a:solidFill>
                   <a:srgbClr val="1A1C2E"/>
                 </a:solidFill>
@@ -7980,7 +7980,46 @@
                 <a:ea typeface="Arial" pitchFamily="34" charset="-122"/>
                 <a:cs typeface="Arial" pitchFamily="34" charset="-120"/>
               </a:rPr>
-              <a:t>Autenticación rota</a:t>
+              <a:t>Broken Authentication</a:t>
+            </a:r>
+            <a:endParaRPr lang="en-US" sz="1150" dirty="0"/>
+          </a:p>
+        </p:txBody>
+      </p:sp>
+      <p:sp>
+        <p:nvSpPr>
+          <p:cNvPr id="9" name="Text 7"/>
+          <p:cNvSpPr/>
+          <p:nvPr/>
+        </p:nvSpPr>
+        <p:spPr>
+          <a:xfrm>
+            <a:off x="5577840" y="2487168"/>
+            <a:ext cx="5806440" cy="365760"/>
+          </a:xfrm>
+          <a:prstGeom prst="rect">
+            <a:avLst/>
+          </a:prstGeom>
+          <a:noFill/>
+          <a:ln/>
+        </p:spPr>
+        <p:txBody>
+          <a:bodyPr wrap="square" lIns="0" tIns="0" rIns="0" bIns="0" rtlCol="0" anchor="ctr"/>
+          <a:lstStyle/>
+          <a:p>
+            <a:pPr indent="0" marL="0">
+              <a:buNone/>
+            </a:pPr>
+            <a:r>
+              <a:rPr lang="en-US" sz="1200" dirty="0">
+                <a:solidFill>
+                  <a:srgbClr val="5A5F73"/>
+                </a:solidFill>
+                <a:latin typeface="Calibri" pitchFamily="34" charset="0"/>
+                <a:ea typeface="Calibri" pitchFamily="34" charset="-122"/>
+                <a:cs typeface="Calibri" pitchFamily="34" charset="-120"/>
+              </a:rPr>
+              <a:t>bcrypt 12 rondas, rotación de refresh y bloqueo a los 5 fallos</a:t>
             </a:r>
             <a:endParaRPr lang="en-US" sz="1200" dirty="0"/>
           </a:p>
@@ -7988,14 +8027,14 @@
       </p:sp>
       <p:sp>
         <p:nvSpPr>
-          <p:cNvPr id="9" name="Text 7"/>
-          <p:cNvSpPr/>
-          <p:nvPr/>
-        </p:nvSpPr>
-        <p:spPr>
-          <a:xfrm>
-            <a:off x="4983480" y="2487168"/>
-            <a:ext cx="6400800" cy="365760"/>
+          <p:cNvPr id="10" name="Text 8"/>
+          <p:cNvSpPr/>
+          <p:nvPr/>
+        </p:nvSpPr>
+        <p:spPr>
+          <a:xfrm>
+            <a:off x="777240" y="2889504"/>
+            <a:ext cx="731520" cy="365760"/>
           </a:xfrm>
           <a:prstGeom prst="rect">
             <a:avLst/>
@@ -8011,46 +8050,7 @@
               <a:buNone/>
             </a:pPr>
             <a:r>
-              <a:rPr lang="en-US" sz="1200" dirty="0">
-                <a:solidFill>
-                  <a:srgbClr val="5A5F73"/>
-                </a:solidFill>
-                <a:latin typeface="Calibri" pitchFamily="34" charset="0"/>
-                <a:ea typeface="Calibri" pitchFamily="34" charset="-122"/>
-                <a:cs typeface="Calibri" pitchFamily="34" charset="-120"/>
-              </a:rPr>
-              <a:t>bcrypt de 12 rondas, rotación de refresh tokens y bloqueo de cuenta a los 5 fallos</a:t>
-            </a:r>
-            <a:endParaRPr lang="en-US" sz="1200" dirty="0"/>
-          </a:p>
-        </p:txBody>
-      </p:sp>
-      <p:sp>
-        <p:nvSpPr>
-          <p:cNvPr id="10" name="Text 8"/>
-          <p:cNvSpPr/>
-          <p:nvPr/>
-        </p:nvSpPr>
-        <p:spPr>
-          <a:xfrm>
-            <a:off x="777240" y="2889504"/>
-            <a:ext cx="685800" cy="365760"/>
-          </a:xfrm>
-          <a:prstGeom prst="rect">
-            <a:avLst/>
-          </a:prstGeom>
-          <a:noFill/>
-          <a:ln/>
-        </p:spPr>
-        <p:txBody>
-          <a:bodyPr wrap="square" lIns="0" tIns="0" rIns="0" bIns="0" rtlCol="0" anchor="ctr"/>
-          <a:lstStyle/>
-          <a:p>
-            <a:pPr indent="0" marL="0">
-              <a:buNone/>
-            </a:pPr>
-            <a:r>
-              <a:rPr lang="en-US" sz="1200" b="1" dirty="0">
+              <a:rPr lang="en-US" sz="1100" b="1" dirty="0">
                 <a:solidFill>
                   <a:srgbClr val="202CFC"/>
                 </a:solidFill>
@@ -8060,7 +8060,7 @@
               </a:rPr>
               <a:t>API3</a:t>
             </a:r>
-            <a:endParaRPr lang="en-US" sz="1200" dirty="0"/>
+            <a:endParaRPr lang="en-US" sz="1100" dirty="0"/>
           </a:p>
         </p:txBody>
       </p:sp>
@@ -8072,8 +8072,8 @@
         </p:nvSpPr>
         <p:spPr>
           <a:xfrm>
-            <a:off x="1481328" y="2889504"/>
-            <a:ext cx="3429000" cy="365760"/>
+            <a:off x="1508760" y="2889504"/>
+            <a:ext cx="3977640" cy="365760"/>
           </a:xfrm>
           <a:prstGeom prst="rect">
             <a:avLst/>
@@ -8089,7 +8089,7 @@
               <a:buNone/>
             </a:pPr>
             <a:r>
-              <a:rPr lang="en-US" sz="1200" b="1" dirty="0">
+              <a:rPr lang="en-US" sz="1150" b="1" dirty="0">
                 <a:solidFill>
                   <a:srgbClr val="1A1C2E"/>
                 </a:solidFill>
@@ -8097,7 +8097,46 @@
                 <a:ea typeface="Arial" pitchFamily="34" charset="-122"/>
                 <a:cs typeface="Arial" pitchFamily="34" charset="-120"/>
               </a:rPr>
-              <a:t>Autorización a nivel de propiedad</a:t>
+              <a:t>Broken Object Property Level Authorization</a:t>
+            </a:r>
+            <a:endParaRPr lang="en-US" sz="1150" dirty="0"/>
+          </a:p>
+        </p:txBody>
+      </p:sp>
+      <p:sp>
+        <p:nvSpPr>
+          <p:cNvPr id="12" name="Text 10"/>
+          <p:cNvSpPr/>
+          <p:nvPr/>
+        </p:nvSpPr>
+        <p:spPr>
+          <a:xfrm>
+            <a:off x="5577840" y="2889504"/>
+            <a:ext cx="5806440" cy="365760"/>
+          </a:xfrm>
+          <a:prstGeom prst="rect">
+            <a:avLst/>
+          </a:prstGeom>
+          <a:noFill/>
+          <a:ln/>
+        </p:spPr>
+        <p:txBody>
+          <a:bodyPr wrap="square" lIns="0" tIns="0" rIns="0" bIns="0" rtlCol="0" anchor="ctr"/>
+          <a:lstStyle/>
+          <a:p>
+            <a:pPr indent="0" marL="0">
+              <a:buNone/>
+            </a:pPr>
+            <a:r>
+              <a:rPr lang="en-US" sz="1200" dirty="0">
+                <a:solidFill>
+                  <a:srgbClr val="5A5F73"/>
+                </a:solidFill>
+                <a:latin typeface="Calibri" pitchFamily="34" charset="0"/>
+                <a:ea typeface="Calibri" pitchFamily="34" charset="-122"/>
+                <a:cs typeface="Calibri" pitchFamily="34" charset="-120"/>
+              </a:rPr>
+              <a:t>Los esquemas Zod son la allowlist de campos</a:t>
             </a:r>
             <a:endParaRPr lang="en-US" sz="1200" dirty="0"/>
           </a:p>
@@ -8105,14 +8144,14 @@
       </p:sp>
       <p:sp>
         <p:nvSpPr>
-          <p:cNvPr id="12" name="Text 10"/>
-          <p:cNvSpPr/>
-          <p:nvPr/>
-        </p:nvSpPr>
-        <p:spPr>
-          <a:xfrm>
-            <a:off x="4983480" y="2889504"/>
-            <a:ext cx="6400800" cy="365760"/>
+          <p:cNvPr id="13" name="Text 11"/>
+          <p:cNvSpPr/>
+          <p:nvPr/>
+        </p:nvSpPr>
+        <p:spPr>
+          <a:xfrm>
+            <a:off x="777240" y="3291840"/>
+            <a:ext cx="731520" cy="365760"/>
           </a:xfrm>
           <a:prstGeom prst="rect">
             <a:avLst/>
@@ -8128,46 +8167,7 @@
               <a:buNone/>
             </a:pPr>
             <a:r>
-              <a:rPr lang="en-US" sz="1200" dirty="0">
-                <a:solidFill>
-                  <a:srgbClr val="5A5F73"/>
-                </a:solidFill>
-                <a:latin typeface="Calibri" pitchFamily="34" charset="0"/>
-                <a:ea typeface="Calibri" pitchFamily="34" charset="-122"/>
-                <a:cs typeface="Calibri" pitchFamily="34" charset="-120"/>
-              </a:rPr>
-              <a:t>Los esquemas Zod son la allowlist de campos: lo no declarado no entra</a:t>
-            </a:r>
-            <a:endParaRPr lang="en-US" sz="1200" dirty="0"/>
-          </a:p>
-        </p:txBody>
-      </p:sp>
-      <p:sp>
-        <p:nvSpPr>
-          <p:cNvPr id="13" name="Text 11"/>
-          <p:cNvSpPr/>
-          <p:nvPr/>
-        </p:nvSpPr>
-        <p:spPr>
-          <a:xfrm>
-            <a:off x="777240" y="3291840"/>
-            <a:ext cx="685800" cy="365760"/>
-          </a:xfrm>
-          <a:prstGeom prst="rect">
-            <a:avLst/>
-          </a:prstGeom>
-          <a:noFill/>
-          <a:ln/>
-        </p:spPr>
-        <p:txBody>
-          <a:bodyPr wrap="square" lIns="0" tIns="0" rIns="0" bIns="0" rtlCol="0" anchor="ctr"/>
-          <a:lstStyle/>
-          <a:p>
-            <a:pPr indent="0" marL="0">
-              <a:buNone/>
-            </a:pPr>
-            <a:r>
-              <a:rPr lang="en-US" sz="1200" b="1" dirty="0">
+              <a:rPr lang="en-US" sz="1100" b="1" dirty="0">
                 <a:solidFill>
                   <a:srgbClr val="202CFC"/>
                 </a:solidFill>
@@ -8177,7 +8177,7 @@
               </a:rPr>
               <a:t>API4</a:t>
             </a:r>
-            <a:endParaRPr lang="en-US" sz="1200" dirty="0"/>
+            <a:endParaRPr lang="en-US" sz="1100" dirty="0"/>
           </a:p>
         </p:txBody>
       </p:sp>
@@ -8189,8 +8189,8 @@
         </p:nvSpPr>
         <p:spPr>
           <a:xfrm>
-            <a:off x="1481328" y="3291840"/>
-            <a:ext cx="3429000" cy="365760"/>
+            <a:off x="1508760" y="3291840"/>
+            <a:ext cx="3977640" cy="365760"/>
           </a:xfrm>
           <a:prstGeom prst="rect">
             <a:avLst/>
@@ -8206,7 +8206,7 @@
               <a:buNone/>
             </a:pPr>
             <a:r>
-              <a:rPr lang="en-US" sz="1200" b="1" dirty="0">
+              <a:rPr lang="en-US" sz="1150" b="1" dirty="0">
                 <a:solidFill>
                   <a:srgbClr val="1A1C2E"/>
                 </a:solidFill>
@@ -8214,7 +8214,46 @@
                 <a:ea typeface="Arial" pitchFamily="34" charset="-122"/>
                 <a:cs typeface="Arial" pitchFamily="34" charset="-120"/>
               </a:rPr>
-              <a:t>Consumo de recursos sin restricción</a:t>
+              <a:t>Unrestricted Resource Consumption</a:t>
+            </a:r>
+            <a:endParaRPr lang="en-US" sz="1150" dirty="0"/>
+          </a:p>
+        </p:txBody>
+      </p:sp>
+      <p:sp>
+        <p:nvSpPr>
+          <p:cNvPr id="15" name="Text 13"/>
+          <p:cNvSpPr/>
+          <p:nvPr/>
+        </p:nvSpPr>
+        <p:spPr>
+          <a:xfrm>
+            <a:off x="5577840" y="3291840"/>
+            <a:ext cx="5806440" cy="365760"/>
+          </a:xfrm>
+          <a:prstGeom prst="rect">
+            <a:avLst/>
+          </a:prstGeom>
+          <a:noFill/>
+          <a:ln/>
+        </p:spPr>
+        <p:txBody>
+          <a:bodyPr wrap="square" lIns="0" tIns="0" rIns="0" bIns="0" rtlCol="0" anchor="ctr"/>
+          <a:lstStyle/>
+          <a:p>
+            <a:pPr indent="0" marL="0">
+              <a:buNone/>
+            </a:pPr>
+            <a:r>
+              <a:rPr lang="en-US" sz="1200" dirty="0">
+                <a:solidFill>
+                  <a:srgbClr val="5A5F73"/>
+                </a:solidFill>
+                <a:latin typeface="Calibri" pitchFamily="34" charset="0"/>
+                <a:ea typeface="Calibri" pitchFamily="34" charset="-122"/>
+                <a:cs typeface="Calibri" pitchFamily="34" charset="-120"/>
+              </a:rPr>
+              <a:t>login 5/min, diagnóstico 20/min, cognitivo 5/min</a:t>
             </a:r>
             <a:endParaRPr lang="en-US" sz="1200" dirty="0"/>
           </a:p>
@@ -8222,14 +8261,14 @@
       </p:sp>
       <p:sp>
         <p:nvSpPr>
-          <p:cNvPr id="15" name="Text 13"/>
-          <p:cNvSpPr/>
-          <p:nvPr/>
-        </p:nvSpPr>
-        <p:spPr>
-          <a:xfrm>
-            <a:off x="4983480" y="3291840"/>
-            <a:ext cx="6400800" cy="365760"/>
+          <p:cNvPr id="16" name="Text 14"/>
+          <p:cNvSpPr/>
+          <p:nvPr/>
+        </p:nvSpPr>
+        <p:spPr>
+          <a:xfrm>
+            <a:off x="777240" y="3694176"/>
+            <a:ext cx="731520" cy="365760"/>
           </a:xfrm>
           <a:prstGeom prst="rect">
             <a:avLst/>
@@ -8245,46 +8284,7 @@
               <a:buNone/>
             </a:pPr>
             <a:r>
-              <a:rPr lang="en-US" sz="1200" dirty="0">
-                <a:solidFill>
-                  <a:srgbClr val="5A5F73"/>
-                </a:solidFill>
-                <a:latin typeface="Calibri" pitchFamily="34" charset="0"/>
-                <a:ea typeface="Calibri" pitchFamily="34" charset="-122"/>
-                <a:cs typeface="Calibri" pitchFamily="34" charset="-120"/>
-              </a:rPr>
-              <a:t>Límites por familia: login 5/min, diagnóstico 20/min, cognitivo 5/min</a:t>
-            </a:r>
-            <a:endParaRPr lang="en-US" sz="1200" dirty="0"/>
-          </a:p>
-        </p:txBody>
-      </p:sp>
-      <p:sp>
-        <p:nvSpPr>
-          <p:cNvPr id="16" name="Text 14"/>
-          <p:cNvSpPr/>
-          <p:nvPr/>
-        </p:nvSpPr>
-        <p:spPr>
-          <a:xfrm>
-            <a:off x="777240" y="3694176"/>
-            <a:ext cx="685800" cy="365760"/>
-          </a:xfrm>
-          <a:prstGeom prst="rect">
-            <a:avLst/>
-          </a:prstGeom>
-          <a:noFill/>
-          <a:ln/>
-        </p:spPr>
-        <p:txBody>
-          <a:bodyPr wrap="square" lIns="0" tIns="0" rIns="0" bIns="0" rtlCol="0" anchor="ctr"/>
-          <a:lstStyle/>
-          <a:p>
-            <a:pPr indent="0" marL="0">
-              <a:buNone/>
-            </a:pPr>
-            <a:r>
-              <a:rPr lang="en-US" sz="1200" b="1" dirty="0">
+              <a:rPr lang="en-US" sz="1100" b="1" dirty="0">
                 <a:solidFill>
                   <a:srgbClr val="202CFC"/>
                 </a:solidFill>
@@ -8294,7 +8294,7 @@
               </a:rPr>
               <a:t>API5</a:t>
             </a:r>
-            <a:endParaRPr lang="en-US" sz="1200" dirty="0"/>
+            <a:endParaRPr lang="en-US" sz="1100" dirty="0"/>
           </a:p>
         </p:txBody>
       </p:sp>
@@ -8306,8 +8306,8 @@
         </p:nvSpPr>
         <p:spPr>
           <a:xfrm>
-            <a:off x="1481328" y="3694176"/>
-            <a:ext cx="3429000" cy="365760"/>
+            <a:off x="1508760" y="3694176"/>
+            <a:ext cx="3977640" cy="365760"/>
           </a:xfrm>
           <a:prstGeom prst="rect">
             <a:avLst/>
@@ -8323,7 +8323,7 @@
               <a:buNone/>
             </a:pPr>
             <a:r>
-              <a:rPr lang="en-US" sz="1200" b="1" dirty="0">
+              <a:rPr lang="en-US" sz="1150" b="1" dirty="0">
                 <a:solidFill>
                   <a:srgbClr val="1A1C2E"/>
                 </a:solidFill>
@@ -8331,7 +8331,46 @@
                 <a:ea typeface="Arial" pitchFamily="34" charset="-122"/>
                 <a:cs typeface="Arial" pitchFamily="34" charset="-120"/>
               </a:rPr>
-              <a:t>Autorización a nivel de función</a:t>
+              <a:t>Broken Function Level Authorization</a:t>
+            </a:r>
+            <a:endParaRPr lang="en-US" sz="1150" dirty="0"/>
+          </a:p>
+        </p:txBody>
+      </p:sp>
+      <p:sp>
+        <p:nvSpPr>
+          <p:cNvPr id="18" name="Text 16"/>
+          <p:cNvSpPr/>
+          <p:nvPr/>
+        </p:nvSpPr>
+        <p:spPr>
+          <a:xfrm>
+            <a:off x="5577840" y="3694176"/>
+            <a:ext cx="5806440" cy="365760"/>
+          </a:xfrm>
+          <a:prstGeom prst="rect">
+            <a:avLst/>
+          </a:prstGeom>
+          <a:noFill/>
+          <a:ln/>
+        </p:spPr>
+        <p:txBody>
+          <a:bodyPr wrap="square" lIns="0" tIns="0" rIns="0" bIns="0" rtlCol="0" anchor="ctr"/>
+          <a:lstStyle/>
+          <a:p>
+            <a:pPr indent="0" marL="0">
+              <a:buNone/>
+            </a:pPr>
+            <a:r>
+              <a:rPr lang="en-US" sz="1200" dirty="0">
+                <a:solidFill>
+                  <a:srgbClr val="5A5F73"/>
+                </a:solidFill>
+                <a:latin typeface="Calibri" pitchFamily="34" charset="0"/>
+                <a:ea typeface="Calibri" pitchFamily="34" charset="-122"/>
+                <a:cs typeface="Calibri" pitchFamily="34" charset="-120"/>
+              </a:rPr>
+              <a:t>Todo /api autenticado; administración tras requireAdmin</a:t>
             </a:r>
             <a:endParaRPr lang="en-US" sz="1200" dirty="0"/>
           </a:p>
@@ -8339,14 +8378,14 @@
       </p:sp>
       <p:sp>
         <p:nvSpPr>
-          <p:cNvPr id="18" name="Text 16"/>
-          <p:cNvSpPr/>
-          <p:nvPr/>
-        </p:nvSpPr>
-        <p:spPr>
-          <a:xfrm>
-            <a:off x="4983480" y="3694176"/>
-            <a:ext cx="6400800" cy="365760"/>
+          <p:cNvPr id="19" name="Text 17"/>
+          <p:cNvSpPr/>
+          <p:nvPr/>
+        </p:nvSpPr>
+        <p:spPr>
+          <a:xfrm>
+            <a:off x="777240" y="4096512"/>
+            <a:ext cx="731520" cy="365760"/>
           </a:xfrm>
           <a:prstGeom prst="rect">
             <a:avLst/>
@@ -8362,46 +8401,7 @@
               <a:buNone/>
             </a:pPr>
             <a:r>
-              <a:rPr lang="en-US" sz="1200" dirty="0">
-                <a:solidFill>
-                  <a:srgbClr val="5A5F73"/>
-                </a:solidFill>
-                <a:latin typeface="Calibri" pitchFamily="34" charset="0"/>
-                <a:ea typeface="Calibri" pitchFamily="34" charset="-122"/>
-                <a:cs typeface="Calibri" pitchFamily="34" charset="-120"/>
-              </a:rPr>
-              <a:t>Todo /api tras el middleware de sesión; administración tras requireAdmin</a:t>
-            </a:r>
-            <a:endParaRPr lang="en-US" sz="1200" dirty="0"/>
-          </a:p>
-        </p:txBody>
-      </p:sp>
-      <p:sp>
-        <p:nvSpPr>
-          <p:cNvPr id="19" name="Text 17"/>
-          <p:cNvSpPr/>
-          <p:nvPr/>
-        </p:nvSpPr>
-        <p:spPr>
-          <a:xfrm>
-            <a:off x="777240" y="4096512"/>
-            <a:ext cx="685800" cy="365760"/>
-          </a:xfrm>
-          <a:prstGeom prst="rect">
-            <a:avLst/>
-          </a:prstGeom>
-          <a:noFill/>
-          <a:ln/>
-        </p:spPr>
-        <p:txBody>
-          <a:bodyPr wrap="square" lIns="0" tIns="0" rIns="0" bIns="0" rtlCol="0" anchor="ctr"/>
-          <a:lstStyle/>
-          <a:p>
-            <a:pPr indent="0" marL="0">
-              <a:buNone/>
-            </a:pPr>
-            <a:r>
-              <a:rPr lang="en-US" sz="1200" b="1" dirty="0">
+              <a:rPr lang="en-US" sz="1100" b="1" dirty="0">
                 <a:solidFill>
                   <a:srgbClr val="202CFC"/>
                 </a:solidFill>
@@ -8411,7 +8411,7 @@
               </a:rPr>
               <a:t>API6</a:t>
             </a:r>
-            <a:endParaRPr lang="en-US" sz="1200" dirty="0"/>
+            <a:endParaRPr lang="en-US" sz="1100" dirty="0"/>
           </a:p>
         </p:txBody>
       </p:sp>
@@ -8423,8 +8423,8 @@
         </p:nvSpPr>
         <p:spPr>
           <a:xfrm>
-            <a:off x="1481328" y="4096512"/>
-            <a:ext cx="3429000" cy="365760"/>
+            <a:off x="1508760" y="4096512"/>
+            <a:ext cx="3977640" cy="365760"/>
           </a:xfrm>
           <a:prstGeom prst="rect">
             <a:avLst/>
@@ -8440,7 +8440,7 @@
               <a:buNone/>
             </a:pPr>
             <a:r>
-              <a:rPr lang="en-US" sz="1200" b="1" dirty="0">
+              <a:rPr lang="en-US" sz="1150" b="1" dirty="0">
                 <a:solidFill>
                   <a:srgbClr val="1A1C2E"/>
                 </a:solidFill>
@@ -8448,7 +8448,46 @@
                 <a:ea typeface="Arial" pitchFamily="34" charset="-122"/>
                 <a:cs typeface="Arial" pitchFamily="34" charset="-120"/>
               </a:rPr>
-              <a:t>Acceso a flujos de negocio sensibles</a:t>
+              <a:t>Unrestricted Access to Sensitive Business Flows</a:t>
+            </a:r>
+            <a:endParaRPr lang="en-US" sz="1150" dirty="0"/>
+          </a:p>
+        </p:txBody>
+      </p:sp>
+      <p:sp>
+        <p:nvSpPr>
+          <p:cNvPr id="21" name="Text 19"/>
+          <p:cNvSpPr/>
+          <p:nvPr/>
+        </p:nvSpPr>
+        <p:spPr>
+          <a:xfrm>
+            <a:off x="5577840" y="4096512"/>
+            <a:ext cx="5806440" cy="365760"/>
+          </a:xfrm>
+          <a:prstGeom prst="rect">
+            <a:avLst/>
+          </a:prstGeom>
+          <a:noFill/>
+          <a:ln/>
+        </p:spPr>
+        <p:txBody>
+          <a:bodyPr wrap="square" lIns="0" tIns="0" rIns="0" bIns="0" rtlCol="0" anchor="ctr"/>
+          <a:lstStyle/>
+          <a:p>
+            <a:pPr indent="0" marL="0">
+              <a:buNone/>
+            </a:pPr>
+            <a:r>
+              <a:rPr lang="en-US" sz="1200" dirty="0">
+                <a:solidFill>
+                  <a:srgbClr val="5A5F73"/>
+                </a:solidFill>
+                <a:latin typeface="Calibri" pitchFamily="34" charset="0"/>
+                <a:ea typeface="Calibri" pitchFamily="34" charset="-122"/>
+                <a:cs typeface="Calibri" pitchFamily="34" charset="-120"/>
+              </a:rPr>
+              <a:t>Borrado de códigos con límite propio y apagable por entorno</a:t>
             </a:r>
             <a:endParaRPr lang="en-US" sz="1200" dirty="0"/>
           </a:p>
@@ -8456,14 +8495,14 @@
       </p:sp>
       <p:sp>
         <p:nvSpPr>
-          <p:cNvPr id="21" name="Text 19"/>
-          <p:cNvSpPr/>
-          <p:nvPr/>
-        </p:nvSpPr>
-        <p:spPr>
-          <a:xfrm>
-            <a:off x="4983480" y="4096512"/>
-            <a:ext cx="6400800" cy="365760"/>
+          <p:cNvPr id="22" name="Text 20"/>
+          <p:cNvSpPr/>
+          <p:nvPr/>
+        </p:nvSpPr>
+        <p:spPr>
+          <a:xfrm>
+            <a:off x="777240" y="4498848"/>
+            <a:ext cx="731520" cy="365760"/>
           </a:xfrm>
           <a:prstGeom prst="rect">
             <a:avLst/>
@@ -8479,46 +8518,7 @@
               <a:buNone/>
             </a:pPr>
             <a:r>
-              <a:rPr lang="en-US" sz="1200" dirty="0">
-                <a:solidFill>
-                  <a:srgbClr val="5A5F73"/>
-                </a:solidFill>
-                <a:latin typeface="Calibri" pitchFamily="34" charset="0"/>
-                <a:ea typeface="Calibri" pitchFamily="34" charset="-122"/>
-                <a:cs typeface="Calibri" pitchFamily="34" charset="-120"/>
-              </a:rPr>
-              <a:t>El borrado de códigos de avería lleva límite propio y se apaga con OBD_READ_ONLY</a:t>
-            </a:r>
-            <a:endParaRPr lang="en-US" sz="1200" dirty="0"/>
-          </a:p>
-        </p:txBody>
-      </p:sp>
-      <p:sp>
-        <p:nvSpPr>
-          <p:cNvPr id="22" name="Text 20"/>
-          <p:cNvSpPr/>
-          <p:nvPr/>
-        </p:nvSpPr>
-        <p:spPr>
-          <a:xfrm>
-            <a:off x="777240" y="4498848"/>
-            <a:ext cx="685800" cy="365760"/>
-          </a:xfrm>
-          <a:prstGeom prst="rect">
-            <a:avLst/>
-          </a:prstGeom>
-          <a:noFill/>
-          <a:ln/>
-        </p:spPr>
-        <p:txBody>
-          <a:bodyPr wrap="square" lIns="0" tIns="0" rIns="0" bIns="0" rtlCol="0" anchor="ctr"/>
-          <a:lstStyle/>
-          <a:p>
-            <a:pPr indent="0" marL="0">
-              <a:buNone/>
-            </a:pPr>
-            <a:r>
-              <a:rPr lang="en-US" sz="1200" b="1" dirty="0">
+              <a:rPr lang="en-US" sz="1100" b="1" dirty="0">
                 <a:solidFill>
                   <a:srgbClr val="202CFC"/>
                 </a:solidFill>
@@ -8528,7 +8528,7 @@
               </a:rPr>
               <a:t>API7</a:t>
             </a:r>
-            <a:endParaRPr lang="en-US" sz="1200" dirty="0"/>
+            <a:endParaRPr lang="en-US" sz="1100" dirty="0"/>
           </a:p>
         </p:txBody>
       </p:sp>
@@ -8540,8 +8540,8 @@
         </p:nvSpPr>
         <p:spPr>
           <a:xfrm>
-            <a:off x="1481328" y="4498848"/>
-            <a:ext cx="3429000" cy="365760"/>
+            <a:off x="1508760" y="4498848"/>
+            <a:ext cx="3977640" cy="365760"/>
           </a:xfrm>
           <a:prstGeom prst="rect">
             <a:avLst/>
@@ -8557,7 +8557,7 @@
               <a:buNone/>
             </a:pPr>
             <a:r>
-              <a:rPr lang="en-US" sz="1200" b="1" dirty="0">
+              <a:rPr lang="en-US" sz="1150" b="1" dirty="0">
                 <a:solidFill>
                   <a:srgbClr val="1A1C2E"/>
                 </a:solidFill>
@@ -8567,20 +8567,59 @@
               </a:rPr>
               <a:t>Server Side Request Forgery</a:t>
             </a:r>
+            <a:endParaRPr lang="en-US" sz="1150" dirty="0"/>
+          </a:p>
+        </p:txBody>
+      </p:sp>
+      <p:sp>
+        <p:nvSpPr>
+          <p:cNvPr id="24" name="Text 22"/>
+          <p:cNvSpPr/>
+          <p:nvPr/>
+        </p:nvSpPr>
+        <p:spPr>
+          <a:xfrm>
+            <a:off x="5577840" y="4498848"/>
+            <a:ext cx="5806440" cy="365760"/>
+          </a:xfrm>
+          <a:prstGeom prst="rect">
+            <a:avLst/>
+          </a:prstGeom>
+          <a:noFill/>
+          <a:ln/>
+        </p:spPr>
+        <p:txBody>
+          <a:bodyPr wrap="square" lIns="0" tIns="0" rIns="0" bIns="0" rtlCol="0" anchor="ctr"/>
+          <a:lstStyle/>
+          <a:p>
+            <a:pPr indent="0" marL="0">
+              <a:buNone/>
+            </a:pPr>
+            <a:r>
+              <a:rPr lang="en-US" sz="1200" dirty="0">
+                <a:solidFill>
+                  <a:srgbClr val="5A5F73"/>
+                </a:solidFill>
+                <a:latin typeface="Calibri" pitchFamily="34" charset="0"/>
+                <a:ea typeface="Calibri" pitchFamily="34" charset="-122"/>
+                <a:cs typeface="Calibri" pitchFamily="34" charset="-120"/>
+              </a:rPr>
+              <a:t>El usuario no controla ninguna URL de salida</a:t>
+            </a:r>
             <a:endParaRPr lang="en-US" sz="1200" dirty="0"/>
           </a:p>
         </p:txBody>
       </p:sp>
       <p:sp>
         <p:nvSpPr>
-          <p:cNvPr id="24" name="Text 22"/>
-          <p:cNvSpPr/>
-          <p:nvPr/>
-        </p:nvSpPr>
-        <p:spPr>
-          <a:xfrm>
-            <a:off x="4983480" y="4498848"/>
-            <a:ext cx="6400800" cy="365760"/>
+          <p:cNvPr id="25" name="Text 23"/>
+          <p:cNvSpPr/>
+          <p:nvPr/>
+        </p:nvSpPr>
+        <p:spPr>
+          <a:xfrm>
+            <a:off x="777240" y="4901184"/>
+            <a:ext cx="731520" cy="365760"/>
           </a:xfrm>
           <a:prstGeom prst="rect">
             <a:avLst/>
@@ -8596,46 +8635,7 @@
               <a:buNone/>
             </a:pPr>
             <a:r>
-              <a:rPr lang="en-US" sz="1200" dirty="0">
-                <a:solidFill>
-                  <a:srgbClr val="5A5F73"/>
-                </a:solidFill>
-                <a:latin typeface="Calibri" pitchFamily="34" charset="0"/>
-                <a:ea typeface="Calibri" pitchFamily="34" charset="-122"/>
-                <a:cs typeface="Calibri" pitchFamily="34" charset="-120"/>
-              </a:rPr>
-              <a:t>El usuario no controla ninguna URL de salida: proveedor fijo y timeout de 30 s</a:t>
-            </a:r>
-            <a:endParaRPr lang="en-US" sz="1200" dirty="0"/>
-          </a:p>
-        </p:txBody>
-      </p:sp>
-      <p:sp>
-        <p:nvSpPr>
-          <p:cNvPr id="25" name="Text 23"/>
-          <p:cNvSpPr/>
-          <p:nvPr/>
-        </p:nvSpPr>
-        <p:spPr>
-          <a:xfrm>
-            <a:off x="777240" y="4901184"/>
-            <a:ext cx="685800" cy="365760"/>
-          </a:xfrm>
-          <a:prstGeom prst="rect">
-            <a:avLst/>
-          </a:prstGeom>
-          <a:noFill/>
-          <a:ln/>
-        </p:spPr>
-        <p:txBody>
-          <a:bodyPr wrap="square" lIns="0" tIns="0" rIns="0" bIns="0" rtlCol="0" anchor="ctr"/>
-          <a:lstStyle/>
-          <a:p>
-            <a:pPr indent="0" marL="0">
-              <a:buNone/>
-            </a:pPr>
-            <a:r>
-              <a:rPr lang="en-US" sz="1200" b="1" dirty="0">
+              <a:rPr lang="en-US" sz="1100" b="1" dirty="0">
                 <a:solidFill>
                   <a:srgbClr val="202CFC"/>
                 </a:solidFill>
@@ -8645,7 +8645,7 @@
               </a:rPr>
               <a:t>API8</a:t>
             </a:r>
-            <a:endParaRPr lang="en-US" sz="1200" dirty="0"/>
+            <a:endParaRPr lang="en-US" sz="1100" dirty="0"/>
           </a:p>
         </p:txBody>
       </p:sp>
@@ -8657,8 +8657,8 @@
         </p:nvSpPr>
         <p:spPr>
           <a:xfrm>
-            <a:off x="1481328" y="4901184"/>
-            <a:ext cx="3429000" cy="365760"/>
+            <a:off x="1508760" y="4901184"/>
+            <a:ext cx="3977640" cy="365760"/>
           </a:xfrm>
           <a:prstGeom prst="rect">
             <a:avLst/>
@@ -8674,7 +8674,7 @@
               <a:buNone/>
             </a:pPr>
             <a:r>
-              <a:rPr lang="en-US" sz="1200" b="1" dirty="0">
+              <a:rPr lang="en-US" sz="1150" b="1" dirty="0">
                 <a:solidFill>
                   <a:srgbClr val="1A1C2E"/>
                 </a:solidFill>
@@ -8682,7 +8682,46 @@
                 <a:ea typeface="Arial" pitchFamily="34" charset="-122"/>
                 <a:cs typeface="Arial" pitchFamily="34" charset="-120"/>
               </a:rPr>
-              <a:t>Configuración de seguridad incorrecta</a:t>
+              <a:t>Security Misconfiguration</a:t>
+            </a:r>
+            <a:endParaRPr lang="en-US" sz="1150" dirty="0"/>
+          </a:p>
+        </p:txBody>
+      </p:sp>
+      <p:sp>
+        <p:nvSpPr>
+          <p:cNvPr id="27" name="Text 25"/>
+          <p:cNvSpPr/>
+          <p:nvPr/>
+        </p:nvSpPr>
+        <p:spPr>
+          <a:xfrm>
+            <a:off x="5577840" y="4901184"/>
+            <a:ext cx="5806440" cy="365760"/>
+          </a:xfrm>
+          <a:prstGeom prst="rect">
+            <a:avLst/>
+          </a:prstGeom>
+          <a:noFill/>
+          <a:ln/>
+        </p:spPr>
+        <p:txBody>
+          <a:bodyPr wrap="square" lIns="0" tIns="0" rIns="0" bIns="0" rtlCol="0" anchor="ctr"/>
+          <a:lstStyle/>
+          <a:p>
+            <a:pPr indent="0" marL="0">
+              <a:buNone/>
+            </a:pPr>
+            <a:r>
+              <a:rPr lang="en-US" sz="1200" dirty="0">
+                <a:solidFill>
+                  <a:srgbClr val="5A5F73"/>
+                </a:solidFill>
+                <a:latin typeface="Calibri" pitchFamily="34" charset="0"/>
+                <a:ea typeface="Calibri" pitchFamily="34" charset="-122"/>
+                <a:cs typeface="Calibri" pitchFamily="34" charset="-120"/>
+              </a:rPr>
+              <a:t>Helmet 8: CSP, HSTS de un año y allowlist de CORS</a:t>
             </a:r>
             <a:endParaRPr lang="en-US" sz="1200" dirty="0"/>
           </a:p>
@@ -8690,14 +8729,14 @@
       </p:sp>
       <p:sp>
         <p:nvSpPr>
-          <p:cNvPr id="27" name="Text 25"/>
-          <p:cNvSpPr/>
-          <p:nvPr/>
-        </p:nvSpPr>
-        <p:spPr>
-          <a:xfrm>
-            <a:off x="4983480" y="4901184"/>
-            <a:ext cx="6400800" cy="365760"/>
+          <p:cNvPr id="28" name="Text 26"/>
+          <p:cNvSpPr/>
+          <p:nvPr/>
+        </p:nvSpPr>
+        <p:spPr>
+          <a:xfrm>
+            <a:off x="777240" y="5303520"/>
+            <a:ext cx="731520" cy="365760"/>
           </a:xfrm>
           <a:prstGeom prst="rect">
             <a:avLst/>
@@ -8713,46 +8752,7 @@
               <a:buNone/>
             </a:pPr>
             <a:r>
-              <a:rPr lang="en-US" sz="1200" dirty="0">
-                <a:solidFill>
-                  <a:srgbClr val="5A5F73"/>
-                </a:solidFill>
-                <a:latin typeface="Calibri" pitchFamily="34" charset="0"/>
-                <a:ea typeface="Calibri" pitchFamily="34" charset="-122"/>
-                <a:cs typeface="Calibri" pitchFamily="34" charset="-120"/>
-              </a:rPr>
-              <a:t>Helmet 8 con CSP default-src none, HSTS de un año y allowlist de CORS</a:t>
-            </a:r>
-            <a:endParaRPr lang="en-US" sz="1200" dirty="0"/>
-          </a:p>
-        </p:txBody>
-      </p:sp>
-      <p:sp>
-        <p:nvSpPr>
-          <p:cNvPr id="28" name="Text 26"/>
-          <p:cNvSpPr/>
-          <p:nvPr/>
-        </p:nvSpPr>
-        <p:spPr>
-          <a:xfrm>
-            <a:off x="777240" y="5303520"/>
-            <a:ext cx="685800" cy="365760"/>
-          </a:xfrm>
-          <a:prstGeom prst="rect">
-            <a:avLst/>
-          </a:prstGeom>
-          <a:noFill/>
-          <a:ln/>
-        </p:spPr>
-        <p:txBody>
-          <a:bodyPr wrap="square" lIns="0" tIns="0" rIns="0" bIns="0" rtlCol="0" anchor="ctr"/>
-          <a:lstStyle/>
-          <a:p>
-            <a:pPr indent="0" marL="0">
-              <a:buNone/>
-            </a:pPr>
-            <a:r>
-              <a:rPr lang="en-US" sz="1200" b="1" dirty="0">
+              <a:rPr lang="en-US" sz="1100" b="1" dirty="0">
                 <a:solidFill>
                   <a:srgbClr val="202CFC"/>
                 </a:solidFill>
@@ -8762,7 +8762,7 @@
               </a:rPr>
               <a:t>API9</a:t>
             </a:r>
-            <a:endParaRPr lang="en-US" sz="1200" dirty="0"/>
+            <a:endParaRPr lang="en-US" sz="1100" dirty="0"/>
           </a:p>
         </p:txBody>
       </p:sp>
@@ -8774,8 +8774,8 @@
         </p:nvSpPr>
         <p:spPr>
           <a:xfrm>
-            <a:off x="1481328" y="5303520"/>
-            <a:ext cx="3429000" cy="365760"/>
+            <a:off x="1508760" y="5303520"/>
+            <a:ext cx="3977640" cy="365760"/>
           </a:xfrm>
           <a:prstGeom prst="rect">
             <a:avLst/>
@@ -8791,7 +8791,7 @@
               <a:buNone/>
             </a:pPr>
             <a:r>
-              <a:rPr lang="en-US" sz="1200" b="1" dirty="0">
+              <a:rPr lang="en-US" sz="1150" b="1" dirty="0">
                 <a:solidFill>
                   <a:srgbClr val="1A1C2E"/>
                 </a:solidFill>
@@ -8799,7 +8799,46 @@
                 <a:ea typeface="Arial" pitchFamily="34" charset="-122"/>
                 <a:cs typeface="Arial" pitchFamily="34" charset="-120"/>
               </a:rPr>
-              <a:t>Gestión indebida del inventario</a:t>
+              <a:t>Improper Inventory Management</a:t>
+            </a:r>
+            <a:endParaRPr lang="en-US" sz="1150" dirty="0"/>
+          </a:p>
+        </p:txBody>
+      </p:sp>
+      <p:sp>
+        <p:nvSpPr>
+          <p:cNvPr id="30" name="Text 28"/>
+          <p:cNvSpPr/>
+          <p:nvPr/>
+        </p:nvSpPr>
+        <p:spPr>
+          <a:xfrm>
+            <a:off x="5577840" y="5303520"/>
+            <a:ext cx="5806440" cy="365760"/>
+          </a:xfrm>
+          <a:prstGeom prst="rect">
+            <a:avLst/>
+          </a:prstGeom>
+          <a:noFill/>
+          <a:ln/>
+        </p:spPr>
+        <p:txBody>
+          <a:bodyPr wrap="square" lIns="0" tIns="0" rIns="0" bIns="0" rtlCol="0" anchor="ctr"/>
+          <a:lstStyle/>
+          <a:p>
+            <a:pPr indent="0" marL="0">
+              <a:buNone/>
+            </a:pPr>
+            <a:r>
+              <a:rPr lang="en-US" sz="1200" dirty="0">
+                <a:solidFill>
+                  <a:srgbClr val="5A5F73"/>
+                </a:solidFill>
+                <a:latin typeface="Calibri" pitchFamily="34" charset="0"/>
+                <a:ea typeface="Calibri" pitchFamily="34" charset="-122"/>
+                <a:cs typeface="Calibri" pitchFamily="34" charset="-120"/>
+              </a:rPr>
+              <a:t>Especificación OpenAPI versionada, servida por la API</a:t>
             </a:r>
             <a:endParaRPr lang="en-US" sz="1200" dirty="0"/>
           </a:p>
@@ -8807,14 +8846,14 @@
       </p:sp>
       <p:sp>
         <p:nvSpPr>
-          <p:cNvPr id="30" name="Text 28"/>
-          <p:cNvSpPr/>
-          <p:nvPr/>
-        </p:nvSpPr>
-        <p:spPr>
-          <a:xfrm>
-            <a:off x="4983480" y="5303520"/>
-            <a:ext cx="6400800" cy="365760"/>
+          <p:cNvPr id="31" name="Text 29"/>
+          <p:cNvSpPr/>
+          <p:nvPr/>
+        </p:nvSpPr>
+        <p:spPr>
+          <a:xfrm>
+            <a:off x="777240" y="5705856"/>
+            <a:ext cx="731520" cy="365760"/>
           </a:xfrm>
           <a:prstGeom prst="rect">
             <a:avLst/>
@@ -8830,46 +8869,7 @@
               <a:buNone/>
             </a:pPr>
             <a:r>
-              <a:rPr lang="en-US" sz="1200" dirty="0">
-                <a:solidFill>
-                  <a:srgbClr val="5A5F73"/>
-                </a:solidFill>
-                <a:latin typeface="Calibri" pitchFamily="34" charset="0"/>
-                <a:ea typeface="Calibri" pitchFamily="34" charset="-122"/>
-                <a:cs typeface="Calibri" pitchFamily="34" charset="-120"/>
-              </a:rPr>
-              <a:t>Especificación OpenAPI versionada y servida por la propia API</a:t>
-            </a:r>
-            <a:endParaRPr lang="en-US" sz="1200" dirty="0"/>
-          </a:p>
-        </p:txBody>
-      </p:sp>
-      <p:sp>
-        <p:nvSpPr>
-          <p:cNvPr id="31" name="Text 29"/>
-          <p:cNvSpPr/>
-          <p:nvPr/>
-        </p:nvSpPr>
-        <p:spPr>
-          <a:xfrm>
-            <a:off x="777240" y="5705856"/>
-            <a:ext cx="685800" cy="365760"/>
-          </a:xfrm>
-          <a:prstGeom prst="rect">
-            <a:avLst/>
-          </a:prstGeom>
-          <a:noFill/>
-          <a:ln/>
-        </p:spPr>
-        <p:txBody>
-          <a:bodyPr wrap="square" lIns="0" tIns="0" rIns="0" bIns="0" rtlCol="0" anchor="ctr"/>
-          <a:lstStyle/>
-          <a:p>
-            <a:pPr indent="0" marL="0">
-              <a:buNone/>
-            </a:pPr>
-            <a:r>
-              <a:rPr lang="en-US" sz="1200" b="1" dirty="0">
+              <a:rPr lang="en-US" sz="1100" b="1" dirty="0">
                 <a:solidFill>
                   <a:srgbClr val="202CFC"/>
                 </a:solidFill>
@@ -8879,7 +8879,7 @@
               </a:rPr>
               <a:t>API10</a:t>
             </a:r>
-            <a:endParaRPr lang="en-US" sz="1200" dirty="0"/>
+            <a:endParaRPr lang="en-US" sz="1100" dirty="0"/>
           </a:p>
         </p:txBody>
       </p:sp>
@@ -8891,8 +8891,8 @@
         </p:nvSpPr>
         <p:spPr>
           <a:xfrm>
-            <a:off x="1481328" y="5705856"/>
-            <a:ext cx="3429000" cy="365760"/>
+            <a:off x="1508760" y="5705856"/>
+            <a:ext cx="3977640" cy="365760"/>
           </a:xfrm>
           <a:prstGeom prst="rect">
             <a:avLst/>
@@ -8908,7 +8908,7 @@
               <a:buNone/>
             </a:pPr>
             <a:r>
-              <a:rPr lang="en-US" sz="1200" b="1" dirty="0">
+              <a:rPr lang="en-US" sz="1150" b="1" dirty="0">
                 <a:solidFill>
                   <a:srgbClr val="1A1C2E"/>
                 </a:solidFill>
@@ -8916,9 +8916,9 @@
                 <a:ea typeface="Arial" pitchFamily="34" charset="-122"/>
                 <a:cs typeface="Arial" pitchFamily="34" charset="-120"/>
               </a:rPr>
-              <a:t>Consumo inseguro de APIs</a:t>
-            </a:r>
-            <a:endParaRPr lang="en-US" sz="1200" dirty="0"/>
+              <a:t>Unsafe Consumption of APIs</a:t>
+            </a:r>
+            <a:endParaRPr lang="en-US" sz="1150" dirty="0"/>
           </a:p>
         </p:txBody>
       </p:sp>
@@ -8930,8 +8930,8 @@
         </p:nvSpPr>
         <p:spPr>
           <a:xfrm>
-            <a:off x="4983480" y="5705856"/>
-            <a:ext cx="6400800" cy="365760"/>
+            <a:off x="5577840" y="5705856"/>
+            <a:ext cx="5806440" cy="365760"/>
           </a:xfrm>
           <a:prstGeom prst="rect">
             <a:avLst/>
@@ -8955,7 +8955,7 @@
                 <a:ea typeface="Calibri" pitchFamily="34" charset="-122"/>
                 <a:cs typeface="Calibri" pitchFamily="34" charset="-120"/>
               </a:rPr>
-              <a:t>Lo recuperado llega al modelo marcado como no fiable, nunca como instrucción</a:t>
+              <a:t>Lo recuperado llega al modelo marcado como no fiable</a:t>
             </a:r>
             <a:endParaRPr lang="en-US" sz="1200" dirty="0"/>
           </a:p>

</xml_diff>

<commit_message>
docs(tfm): explicar por que la lista de APIs y no la de web
</commit_message>
<xml_diff>
--- a/docs/presentacion/tfm-intelligent-automotive-diagnostics.pptx
+++ b/docs/presentacion/tfm-intelligent-automotive-diagnostics.pptx
@@ -1171,7 +1171,8 @@
           <a:p>
             <a:r>
               <a:rPr lang="en-US" dirty="0"/>
-              <a:t>Esta es la tabla de seguridad. No la voy a leer entera, pero quiero que se vea que las diez categorías están cubiertas con una medida concreta y no con una declaración de intenciones.
+              <a:t>Esta es la tabla de seguridad. Uso el API Security Top 10 y no el Top 10 de aplicaciones web porque lo que este proyecto expone es una API REST: sus tres primeros riesgos son fallos de autorización a nivel de objeto, de propiedad y de función, que en la lista web ni siquiera aparecen como categorías propias.
+No la voy a leer entera, pero quiero que se vea que las diez categorías están cubiertas con una medida concreta y no con una declaración de intenciones.
 Destaco cuatro. La primera: cuando pides una sesión de diagnóstico que no es tuya, la API responde 404 y no 403, para no confirmar siquiera que existe.
 La cuarta: los límites de peticiones no son uno global, van por familia. El diagnóstico cognitivo, que es el que cuesta dinero porque llama al modelo, tiene el más estricto, cinco por minuto.
 La sexta es la que más me importa por lo que hay al otro lado: el borrado de códigos de avería es el único flujo destructivo sobre el coche, así que tiene su propio límite y se puede apagar entero con una variable de entorno. Y además el adaptador valida el modo OBD contra una lista blanca antes de tocar el socket, con un test de invariante que falla si alguien añade un método que emita un servicio de control.
@@ -7785,7 +7786,7 @@
                 <a:ea typeface="Calibri" pitchFamily="34" charset="-122"/>
                 <a:cs typeface="Calibri" pitchFamily="34" charset="-120"/>
               </a:rPr>
-              <a:t>Las diez categorías, con su nombre oficial y la medida que se aplicó en el código.</a:t>
+              <a:t>El backend es una API REST, así que la lista que aplica es la de APIs.</a:t>
             </a:r>
             <a:endParaRPr lang="en-US" sz="1700" dirty="0"/>
           </a:p>

</xml_diff>

<commit_message>
docs(tfm): slide de seguridad de la interfaz y riesgos asumidos
</commit_message>
<xml_diff>
--- a/docs/presentacion/tfm-intelligent-automotive-diagnostics.pptx
+++ b/docs/presentacion/tfm-intelligent-automotive-diagnostics.pptx
@@ -24,9 +24,10 @@
     <p:sldId id="272" r:id="rId18"/>
     <p:sldId id="273" r:id="rId19"/>
     <p:sldId id="274" r:id="rId20"/>
+    <p:sldId id="275" r:id="rId21"/>
   </p:sldIdLst>
   <p:notesMasterIdLst>
-    <p:notesMasterId r:id="rId21"/>
+    <p:notesMasterId r:id="rId22"/>
   </p:notesMasterIdLst>
   <p:sldSz cx="12192000" cy="6858000"/>
   <p:notesSz cx="6858000" cy="12192000"/>
@@ -1266,12 +1267,11 @@
           <a:p>
             <a:r>
               <a:rPr lang="en-US" dirty="0"/>
-              <a:t>Todo el ciclo está automatizado con GitHub Actions, y son dos flujos distintos.
-El de integración continua se ejecuta en cada push y en cada pull request contra main y develop. Levanta las dos aplicaciones en paralelo sobre Node 22 y pasa lint, formato, las pruebas, la compilación y el typecheck. Y remata con una auditoría de dependencias que detiene la entrega si aparece una vulnerabilidad crítica.
-El de despliegue se dispara solo cuando algo entra en main, que es la rama de releases. Construye tres imágenes Docker: la API, la interfaz y el emulador ELM327. Usa caché de la propia plataforma, así que las construcciones sucesivas son rápidas. Las publica en el registro de contenedores de GitHub.
-Y después entra por SSH al servidor, descarga las imágenes nuevas, levanta los contenedores con la configuración de producción y limpia las imágenes viejas. Sin que yo toque nada.
-La consecuencia práctica es que integrar en main es publicar. La aplicación está desplegada y accesible, no es una demo que solo corre en mi portátil.
-[~55 s · acumulado 18:40]</a:t>
+              <a:t>La lista anterior es la de APIs y cubre el backend. La interfaz es otra cosa: es una aplicación web, y ahí lo que aplica es el Top 10 clásico.
+React escapa el HTML por defecto, y no se inyecta marcado en crudo en ningún sitio con datos que vengan del usuario, que es por donde entra el XSS. La interfaz sirve su propia cabecera de Content Security Policy, con default-src propio y sin scripts de terceros. Los formularios validan con los mismos esquemas Zod que usa la API, así que la validación de cliente y la de servidor no se pueden desincronizar.
+Y una decisión consciente: el token viaja en cabecera Bearer y no en cookie. Eso elimina el CSRF de raíz, pero obliga a guardarlo en el navegador.
+Ahí está el primero de los riesgos que asumo: si hubiera un XSS, el token es robable. Lo compenso con lo de antes, que es no dar superficie de XSS. Los otros tres son de alcance: no hay doble factor, la base de datos no está cifrada en disco y los límites de peticiones viven en memoria, así que un reinicio los resetea. Para una instancia única de un TFM es asumible, y está escrito en el modelo de seguridad, no escondido.
+[~50 s · acumulado 18:35]</a:t>
             </a:r>
             <a:endParaRPr lang="en-US" dirty="0"/>
           </a:p>
@@ -1359,12 +1359,12 @@
           <a:p>
             <a:r>
               <a:rPr lang="en-US" dirty="0"/>
-              <a:t>Para terminar, lo que me llevo de haber hecho esto.
-Lo primero, que con IA se pueden construir cosas complejas mucho más rápido. Un proyecto como este, con su arquitectura, su capa de OBD, su base vectorial y su agente, antes habría sido cuestión de meses o de años. Y no solo va más rápido: se aprenden más cosas por el camino, porque te metes en herramientas y frameworks que de otra forma ni habrías tocado.
-Pero hay una segunda parte, y la quiero decir igual de claro. La IA también se equivoca, y hay que estar encima de lo que se sube. No vale con fiarse.
-Y no lo digo en abstracto: preparando esta misma presentación encontré que el umbral de cobertura del núcleo apuntaba a un fichero que se había renombrado, así que llevaba semanas sin exigir nada. Estaba verde, y no comprobaba lo que decía comprobar. Lo he documentado en la deuda conocida del proyecto.
-Así que sí, acelera mucho. Pero no es todo tan bonito como parece: hay que dedicarle tiempo a revisar.
-[~45 s · acumulado 19:25]</a:t>
+              <a:t>Todo el ciclo está automatizado con GitHub Actions, y son dos flujos distintos.
+El de integración continua se ejecuta en cada push y en cada pull request contra main y develop. Levanta las dos aplicaciones en paralelo sobre Node 22 y pasa lint, formato, las pruebas, la compilación y el typecheck. Y remata con una auditoría de dependencias que detiene la entrega si aparece una vulnerabilidad crítica.
+El de despliegue se dispara solo cuando algo entra en main, que es la rama de releases. Construye tres imágenes Docker: la API, la interfaz y el emulador ELM327. Usa caché de la propia plataforma, así que las construcciones sucesivas son rápidas. Las publica en el registro de contenedores de GitHub.
+Y después entra por SSH al servidor, descarga las imágenes nuevas, levanta los contenedores con la configuración de producción y limpia las imágenes viejas. Sin que yo toque nada.
+La consecuencia práctica es que integrar en main es publicar. La aplicación está desplegada y accesible, no es una demo que solo corre en mi portátil.
+[~55 s · acumulado 19:30]</a:t>
             </a:r>
             <a:endParaRPr lang="en-US" dirty="0"/>
           </a:p>
@@ -1452,8 +1452,12 @@
           <a:p>
             <a:r>
               <a:rPr lang="en-US" dirty="0"/>
-              <a:t>Y hasta aquí. Muchas gracias por la atención.
-[Quedarse callado y esperar las preguntas. El backup está detrás.]</a:t>
+              <a:t>Para terminar, lo que me llevo de haber hecho esto.
+Lo primero, que con IA se pueden construir cosas complejas mucho más rápido. Un proyecto como este, con su arquitectura, su capa de OBD, su base vectorial y su agente, antes habría sido cuestión de meses o de años. Y no solo va más rápido: se aprenden más cosas por el camino, porque te metes en herramientas y frameworks que de otra forma ni habrías tocado.
+Pero hay una segunda parte, y la quiero decir igual de claro. La IA también se equivoca, y hay que estar encima de lo que se sube. No vale con fiarse.
+Y no lo digo en abstracto: preparando esta misma presentación encontré que el umbral de cobertura del núcleo apuntaba a un fichero que se había renombrado, así que llevaba semanas sin exigir nada. Estaba verde, y no comprobaba lo que decía comprobar. Lo he documentado en la deuda conocida del proyecto.
+Así que sí, acelera mucho. Pero no es todo tan bonito como parece: hay que dedicarle tiempo a revisar.
+[~45 s · acumulado 20:15]</a:t>
             </a:r>
             <a:endParaRPr lang="en-US" dirty="0"/>
           </a:p>
@@ -1569,6 +1573,95 @@
             <a:fld id="{F7021451-1387-4CA6-816F-3879F97B5CBC}" type="slidenum">
               <a:rPr lang="en-US"/>
               <a:t>2</a:t>
+            </a:fld>
+            <a:endParaRPr lang="en-US"/>
+          </a:p>
+        </p:txBody>
+      </p:sp>
+    </p:spTree>
+    <p:extLst>
+      <p:ext uri="{BB962C8B-B14F-4D97-AF65-F5344CB8AC3E}">
+        <p14:creationId xmlns:p14="http://schemas.microsoft.com/office/powerpoint/2010/main" val="1024086991"/>
+      </p:ext>
+    </p:extLst>
+  </p:cSld>
+  <p:clrMapOvr>
+    <a:masterClrMapping/>
+  </p:clrMapOvr>
+</p:notes>
+</file>
+
+<file path=ppt/notesSlides/notesSlide20.xml><?xml version="1.0" encoding="utf-8"?>
+<p:notes xmlns:a="http://schemas.openxmlformats.org/drawingml/2006/main" xmlns:r="http://schemas.openxmlformats.org/officeDocument/2006/relationships" xmlns:p="http://schemas.openxmlformats.org/presentationml/2006/main">
+  <p:cSld>
+    <p:spTree>
+      <p:nvGrpSpPr>
+        <p:cNvPr id="1" name=""/>
+        <p:cNvGrpSpPr/>
+        <p:nvPr/>
+      </p:nvGrpSpPr>
+      <p:grpSpPr>
+        <a:xfrm>
+          <a:off x="0" y="0"/>
+          <a:ext cx="0" cy="0"/>
+          <a:chOff x="0" y="0"/>
+          <a:chExt cx="0" cy="0"/>
+        </a:xfrm>
+      </p:grpSpPr>
+      <p:sp>
+        <p:nvSpPr>
+          <p:cNvPr id="2" name="Slide Image Placeholder 1"/>
+          <p:cNvSpPr>
+            <a:spLocks noGrp="1" noRot="1" noChangeAspect="1"/>
+          </p:cNvSpPr>
+          <p:nvPr>
+            <p:ph type="sldImg"/>
+          </p:nvPr>
+        </p:nvSpPr>
+        <p:spPr/>
+      </p:sp>
+      <p:sp>
+        <p:nvSpPr>
+          <p:cNvPr id="3" name="Notes Placeholder 2"/>
+          <p:cNvSpPr>
+            <a:spLocks noGrp="1"/>
+          </p:cNvSpPr>
+          <p:nvPr>
+            <p:ph type="body" idx="1"/>
+          </p:nvPr>
+        </p:nvSpPr>
+        <p:spPr/>
+        <p:txBody>
+          <a:bodyPr/>
+          <a:lstStyle/>
+          <a:p>
+            <a:r>
+              <a:rPr lang="en-US" dirty="0"/>
+              <a:t>Y hasta aquí. Muchas gracias por la atención.
+[Quedarse callado y esperar las preguntas. El backup está detrás.]</a:t>
+            </a:r>
+            <a:endParaRPr lang="en-US" dirty="0"/>
+          </a:p>
+        </p:txBody>
+      </p:sp>
+      <p:sp>
+        <p:nvSpPr>
+          <p:cNvPr id="4" name="Slide Number Placeholder 3"/>
+          <p:cNvSpPr>
+            <a:spLocks noGrp="1"/>
+          </p:cNvSpPr>
+          <p:nvPr>
+            <p:ph type="sldNum" sz="quarter" idx="10"/>
+          </p:nvPr>
+        </p:nvSpPr>
+        <p:spPr/>
+        <p:txBody>
+          <a:bodyPr/>
+          <a:lstStyle/>
+          <a:p>
+            <a:fld id="{F7021451-1387-4CA6-816F-3879F97B5CBC}" type="slidenum">
+              <a:rPr lang="en-US"/>
+              <a:t>20</a:t>
             </a:fld>
             <a:endParaRPr lang="en-US"/>
           </a:p>
@@ -9139,8 +9232,8 @@
         </p:nvSpPr>
         <p:spPr>
           <a:xfrm>
-            <a:off x="777240" y="502920"/>
-            <a:ext cx="10607040" cy="685800"/>
+            <a:off x="777240" y="640080"/>
+            <a:ext cx="10607040" cy="777240"/>
           </a:xfrm>
           <a:prstGeom prst="rect">
             <a:avLst/>
@@ -9156,7 +9249,7 @@
               <a:buNone/>
             </a:pPr>
             <a:r>
-              <a:rPr lang="en-US" sz="3200" b="1" dirty="0">
+              <a:rPr lang="en-US" sz="3400" b="1" dirty="0">
                 <a:solidFill>
                   <a:srgbClr val="1A1C2E"/>
                 </a:solidFill>
@@ -9164,9 +9257,9 @@
                 <a:ea typeface="Arial" pitchFamily="34" charset="-122"/>
                 <a:cs typeface="Arial" pitchFamily="34" charset="-120"/>
               </a:rPr>
-              <a:t>Integración y despliegue continuos</a:t>
-            </a:r>
-            <a:endParaRPr lang="en-US" sz="3200" dirty="0"/>
+              <a:t>La interfaz y los riesgos asumidos</a:t>
+            </a:r>
+            <a:endParaRPr lang="en-US" sz="3400" dirty="0"/>
           </a:p>
         </p:txBody>
       </p:sp>
@@ -9178,8 +9271,8 @@
         </p:nvSpPr>
         <p:spPr>
           <a:xfrm>
-            <a:off x="777240" y="1261872"/>
-            <a:ext cx="10607040" cy="320040"/>
+            <a:off x="777240" y="1508760"/>
+            <a:ext cx="10607040" cy="365760"/>
           </a:xfrm>
           <a:prstGeom prst="rect">
             <a:avLst/>
@@ -9195,7 +9288,7 @@
               <a:buNone/>
             </a:pPr>
             <a:r>
-              <a:rPr lang="en-US" sz="1500" dirty="0">
+              <a:rPr lang="en-US" sz="1700" dirty="0">
                 <a:solidFill>
                   <a:srgbClr val="5A5F73"/>
                 </a:solidFill>
@@ -9203,762 +9296,46 @@
                 <a:ea typeface="Calibri" pitchFamily="34" charset="-122"/>
                 <a:cs typeface="Calibri" pitchFamily="34" charset="-120"/>
               </a:rPr>
-              <a:t>Todo automatizado en GitHub Actions: integrar en main publica la nueva versión en producción.</a:t>
-            </a:r>
-            <a:endParaRPr lang="en-US" sz="1500" dirty="0"/>
-          </a:p>
-        </p:txBody>
-      </p:sp>
-      <p:sp>
-        <p:nvSpPr>
-          <p:cNvPr id="4" name="Shape 2"/>
-          <p:cNvSpPr/>
-          <p:nvPr/>
-        </p:nvSpPr>
-        <p:spPr>
-          <a:xfrm>
-            <a:off x="777240" y="1874520"/>
-            <a:ext cx="1828800" cy="868680"/>
-          </a:xfrm>
-          <a:prstGeom prst="roundRect">
-            <a:avLst>
-              <a:gd name="adj" fmla="val 6316"/>
-            </a:avLst>
-          </a:prstGeom>
-          <a:solidFill>
-            <a:srgbClr val="FFFFFF"/>
-          </a:solidFill>
-          <a:ln w="12700">
-            <a:solidFill>
-              <a:srgbClr val="C9CCD8"/>
-            </a:solidFill>
-            <a:prstDash val="solid"/>
-          </a:ln>
-        </p:spPr>
-      </p:sp>
-      <p:sp>
-        <p:nvSpPr>
-          <p:cNvPr id="5" name="Text 3"/>
-          <p:cNvSpPr/>
-          <p:nvPr/>
-        </p:nvSpPr>
-        <p:spPr>
-          <a:xfrm>
-            <a:off x="850392" y="1993392"/>
-            <a:ext cx="1682496" cy="274320"/>
-          </a:xfrm>
-          <a:prstGeom prst="rect">
-            <a:avLst/>
-          </a:prstGeom>
-          <a:noFill/>
-          <a:ln/>
-        </p:spPr>
-        <p:txBody>
-          <a:bodyPr wrap="square" lIns="0" tIns="0" rIns="0" bIns="0" rtlCol="0" anchor="ctr"/>
-          <a:lstStyle/>
-          <a:p>
-            <a:pPr algn="ctr" indent="0" marL="0">
-              <a:buNone/>
-            </a:pPr>
-            <a:r>
-              <a:rPr lang="en-US" sz="1100" b="1" dirty="0">
-                <a:solidFill>
-                  <a:srgbClr val="1A1C2E"/>
+              <a:t>La interfaz es una aplicación web, así que ahí manda el Top 10 de aplicaciones web.</a:t>
+            </a:r>
+            <a:endParaRPr lang="en-US" sz="1700" dirty="0"/>
+          </a:p>
+        </p:txBody>
+      </p:sp>
+      <p:sp>
+        <p:nvSpPr>
+          <p:cNvPr id="4" name="Text 2"/>
+          <p:cNvSpPr/>
+          <p:nvPr/>
+        </p:nvSpPr>
+        <p:spPr>
+          <a:xfrm>
+            <a:off x="777240" y="2240280"/>
+            <a:ext cx="4846320" cy="365760"/>
+          </a:xfrm>
+          <a:prstGeom prst="rect">
+            <a:avLst/>
+          </a:prstGeom>
+          <a:noFill/>
+          <a:ln/>
+        </p:spPr>
+        <p:txBody>
+          <a:bodyPr wrap="square" lIns="0" tIns="0" rIns="0" bIns="0" rtlCol="0" anchor="t"/>
+          <a:lstStyle/>
+          <a:p>
+            <a:pPr indent="0" marL="0">
+              <a:buNone/>
+            </a:pPr>
+            <a:r>
+              <a:rPr lang="en-US" sz="1900" b="1" dirty="0">
+                <a:solidFill>
+                  <a:srgbClr val="202CFC"/>
                 </a:solidFill>
                 <a:latin typeface="Arial" pitchFamily="34" charset="0"/>
                 <a:ea typeface="Arial" pitchFamily="34" charset="-122"/>
                 <a:cs typeface="Arial" pitchFamily="34" charset="-120"/>
               </a:rPr>
-              <a:t>Integración en main</a:t>
-            </a:r>
-            <a:endParaRPr lang="en-US" sz="1100" dirty="0"/>
-          </a:p>
-        </p:txBody>
-      </p:sp>
-      <p:sp>
-        <p:nvSpPr>
-          <p:cNvPr id="6" name="Text 4"/>
-          <p:cNvSpPr/>
-          <p:nvPr/>
-        </p:nvSpPr>
-        <p:spPr>
-          <a:xfrm>
-            <a:off x="850392" y="2276856"/>
-            <a:ext cx="1682496" cy="384048"/>
-          </a:xfrm>
-          <a:prstGeom prst="rect">
-            <a:avLst/>
-          </a:prstGeom>
-          <a:noFill/>
-          <a:ln/>
-        </p:spPr>
-        <p:txBody>
-          <a:bodyPr wrap="square" lIns="0" tIns="0" rIns="0" bIns="0" rtlCol="0" anchor="t"/>
-          <a:lstStyle/>
-          <a:p>
-            <a:pPr algn="ctr" indent="0" marL="0">
-              <a:lnSpc>
-                <a:spcPts val="1200"/>
-              </a:lnSpc>
-              <a:buNone/>
-            </a:pPr>
-            <a:r>
-              <a:rPr lang="en-US" sz="950" dirty="0">
-                <a:solidFill>
-                  <a:srgbClr val="5A5F73"/>
-                </a:solidFill>
-                <a:latin typeface="Calibri" pitchFamily="34" charset="0"/>
-                <a:ea typeface="Calibri" pitchFamily="34" charset="-122"/>
-                <a:cs typeface="Calibri" pitchFamily="34" charset="-120"/>
-              </a:rPr>
-              <a:t>push o merge</a:t>
-            </a:r>
-            <a:endParaRPr lang="en-US" sz="950" dirty="0"/>
-          </a:p>
-        </p:txBody>
-      </p:sp>
-      <p:sp>
-        <p:nvSpPr>
-          <p:cNvPr id="7" name="Shape 5"/>
-          <p:cNvSpPr/>
-          <p:nvPr/>
-        </p:nvSpPr>
-        <p:spPr>
-          <a:xfrm>
-            <a:off x="2679192" y="2308860"/>
-            <a:ext cx="219456" cy="0"/>
-          </a:xfrm>
-          <a:prstGeom prst="line">
-            <a:avLst/>
-          </a:prstGeom>
-          <a:noFill/>
-          <a:ln w="19050">
-            <a:solidFill>
-              <a:srgbClr val="202CFC"/>
-            </a:solidFill>
-            <a:prstDash val="solid"/>
-            <a:tailEnd type="triangle"/>
-          </a:ln>
-        </p:spPr>
-      </p:sp>
-      <p:sp>
-        <p:nvSpPr>
-          <p:cNvPr id="8" name="Shape 6"/>
-          <p:cNvSpPr/>
-          <p:nvPr/>
-        </p:nvSpPr>
-        <p:spPr>
-          <a:xfrm>
-            <a:off x="2971800" y="1874520"/>
-            <a:ext cx="1828800" cy="868680"/>
-          </a:xfrm>
-          <a:prstGeom prst="roundRect">
-            <a:avLst>
-              <a:gd name="adj" fmla="val 6316"/>
-            </a:avLst>
-          </a:prstGeom>
-          <a:solidFill>
-            <a:srgbClr val="FFFFFF"/>
-          </a:solidFill>
-          <a:ln w="12700">
-            <a:solidFill>
-              <a:srgbClr val="C9CCD8"/>
-            </a:solidFill>
-            <a:prstDash val="solid"/>
-          </a:ln>
-        </p:spPr>
-      </p:sp>
-      <p:sp>
-        <p:nvSpPr>
-          <p:cNvPr id="9" name="Text 7"/>
-          <p:cNvSpPr/>
-          <p:nvPr/>
-        </p:nvSpPr>
-        <p:spPr>
-          <a:xfrm>
-            <a:off x="3044952" y="1993392"/>
-            <a:ext cx="1682496" cy="274320"/>
-          </a:xfrm>
-          <a:prstGeom prst="rect">
-            <a:avLst/>
-          </a:prstGeom>
-          <a:noFill/>
-          <a:ln/>
-        </p:spPr>
-        <p:txBody>
-          <a:bodyPr wrap="square" lIns="0" tIns="0" rIns="0" bIns="0" rtlCol="0" anchor="ctr"/>
-          <a:lstStyle/>
-          <a:p>
-            <a:pPr algn="ctr" indent="0" marL="0">
-              <a:buNone/>
-            </a:pPr>
-            <a:r>
-              <a:rPr lang="en-US" sz="1100" b="1" dirty="0">
-                <a:solidFill>
-                  <a:srgbClr val="1A1C2E"/>
-                </a:solidFill>
-                <a:latin typeface="Arial" pitchFamily="34" charset="0"/>
-                <a:ea typeface="Arial" pitchFamily="34" charset="-122"/>
-                <a:cs typeface="Arial" pitchFamily="34" charset="-120"/>
-              </a:rPr>
-              <a:t>Verificación</a:t>
-            </a:r>
-            <a:endParaRPr lang="en-US" sz="1100" dirty="0"/>
-          </a:p>
-        </p:txBody>
-      </p:sp>
-      <p:sp>
-        <p:nvSpPr>
-          <p:cNvPr id="10" name="Text 8"/>
-          <p:cNvSpPr/>
-          <p:nvPr/>
-        </p:nvSpPr>
-        <p:spPr>
-          <a:xfrm>
-            <a:off x="3044952" y="2276856"/>
-            <a:ext cx="1682496" cy="384048"/>
-          </a:xfrm>
-          <a:prstGeom prst="rect">
-            <a:avLst/>
-          </a:prstGeom>
-          <a:noFill/>
-          <a:ln/>
-        </p:spPr>
-        <p:txBody>
-          <a:bodyPr wrap="square" lIns="0" tIns="0" rIns="0" bIns="0" rtlCol="0" anchor="t"/>
-          <a:lstStyle/>
-          <a:p>
-            <a:pPr algn="ctr" indent="0" marL="0">
-              <a:lnSpc>
-                <a:spcPts val="1200"/>
-              </a:lnSpc>
-              <a:buNone/>
-            </a:pPr>
-            <a:r>
-              <a:rPr lang="en-US" sz="950" dirty="0">
-                <a:solidFill>
-                  <a:srgbClr val="5A5F73"/>
-                </a:solidFill>
-                <a:latin typeface="Calibri" pitchFamily="34" charset="0"/>
-                <a:ea typeface="Calibri" pitchFamily="34" charset="-122"/>
-                <a:cs typeface="Calibri" pitchFamily="34" charset="-120"/>
-              </a:rPr>
-              <a:t>lint, tests,</a:t>
-            </a:r>
-            <a:endParaRPr lang="en-US" sz="950" dirty="0"/>
-          </a:p>
-          <a:p>
-            <a:pPr algn="ctr" indent="0" marL="0">
-              <a:lnSpc>
-                <a:spcPts val="1200"/>
-              </a:lnSpc>
-              <a:buNone/>
-            </a:pPr>
-            <a:r>
-              <a:rPr lang="en-US" sz="950" dirty="0">
-                <a:solidFill>
-                  <a:srgbClr val="5A5F73"/>
-                </a:solidFill>
-                <a:latin typeface="Calibri" pitchFamily="34" charset="0"/>
-                <a:ea typeface="Calibri" pitchFamily="34" charset="-122"/>
-                <a:cs typeface="Calibri" pitchFamily="34" charset="-120"/>
-              </a:rPr>
-              <a:t>build y typecheck</a:t>
-            </a:r>
-            <a:endParaRPr lang="en-US" sz="950" dirty="0"/>
-          </a:p>
-        </p:txBody>
-      </p:sp>
-      <p:sp>
-        <p:nvSpPr>
-          <p:cNvPr id="11" name="Shape 9"/>
-          <p:cNvSpPr/>
-          <p:nvPr/>
-        </p:nvSpPr>
-        <p:spPr>
-          <a:xfrm>
-            <a:off x="4873752" y="2308860"/>
-            <a:ext cx="219456" cy="0"/>
-          </a:xfrm>
-          <a:prstGeom prst="line">
-            <a:avLst/>
-          </a:prstGeom>
-          <a:noFill/>
-          <a:ln w="19050">
-            <a:solidFill>
-              <a:srgbClr val="202CFC"/>
-            </a:solidFill>
-            <a:prstDash val="solid"/>
-            <a:tailEnd type="triangle"/>
-          </a:ln>
-        </p:spPr>
-      </p:sp>
-      <p:sp>
-        <p:nvSpPr>
-          <p:cNvPr id="12" name="Shape 10"/>
-          <p:cNvSpPr/>
-          <p:nvPr/>
-        </p:nvSpPr>
-        <p:spPr>
-          <a:xfrm>
-            <a:off x="5166360" y="1874520"/>
-            <a:ext cx="1828800" cy="868680"/>
-          </a:xfrm>
-          <a:prstGeom prst="roundRect">
-            <a:avLst>
-              <a:gd name="adj" fmla="val 6316"/>
-            </a:avLst>
-          </a:prstGeom>
-          <a:solidFill>
-            <a:srgbClr val="FFFFFF"/>
-          </a:solidFill>
-          <a:ln w="12700">
-            <a:solidFill>
-              <a:srgbClr val="C9CCD8"/>
-            </a:solidFill>
-            <a:prstDash val="solid"/>
-          </a:ln>
-        </p:spPr>
-      </p:sp>
-      <p:sp>
-        <p:nvSpPr>
-          <p:cNvPr id="13" name="Text 11"/>
-          <p:cNvSpPr/>
-          <p:nvPr/>
-        </p:nvSpPr>
-        <p:spPr>
-          <a:xfrm>
-            <a:off x="5239512" y="1993392"/>
-            <a:ext cx="1682496" cy="274320"/>
-          </a:xfrm>
-          <a:prstGeom prst="rect">
-            <a:avLst/>
-          </a:prstGeom>
-          <a:noFill/>
-          <a:ln/>
-        </p:spPr>
-        <p:txBody>
-          <a:bodyPr wrap="square" lIns="0" tIns="0" rIns="0" bIns="0" rtlCol="0" anchor="ctr"/>
-          <a:lstStyle/>
-          <a:p>
-            <a:pPr algn="ctr" indent="0" marL="0">
-              <a:buNone/>
-            </a:pPr>
-            <a:r>
-              <a:rPr lang="en-US" sz="1100" b="1" dirty="0">
-                <a:solidFill>
-                  <a:srgbClr val="1A1C2E"/>
-                </a:solidFill>
-                <a:latin typeface="Arial" pitchFamily="34" charset="0"/>
-                <a:ea typeface="Arial" pitchFamily="34" charset="-122"/>
-                <a:cs typeface="Arial" pitchFamily="34" charset="-120"/>
-              </a:rPr>
-              <a:t>Construcción</a:t>
-            </a:r>
-            <a:endParaRPr lang="en-US" sz="1100" dirty="0"/>
-          </a:p>
-        </p:txBody>
-      </p:sp>
-      <p:sp>
-        <p:nvSpPr>
-          <p:cNvPr id="14" name="Text 12"/>
-          <p:cNvSpPr/>
-          <p:nvPr/>
-        </p:nvSpPr>
-        <p:spPr>
-          <a:xfrm>
-            <a:off x="5239512" y="2276856"/>
-            <a:ext cx="1682496" cy="384048"/>
-          </a:xfrm>
-          <a:prstGeom prst="rect">
-            <a:avLst/>
-          </a:prstGeom>
-          <a:noFill/>
-          <a:ln/>
-        </p:spPr>
-        <p:txBody>
-          <a:bodyPr wrap="square" lIns="0" tIns="0" rIns="0" bIns="0" rtlCol="0" anchor="t"/>
-          <a:lstStyle/>
-          <a:p>
-            <a:pPr algn="ctr" indent="0" marL="0">
-              <a:lnSpc>
-                <a:spcPts val="1200"/>
-              </a:lnSpc>
-              <a:buNone/>
-            </a:pPr>
-            <a:r>
-              <a:rPr lang="en-US" sz="950" dirty="0">
-                <a:solidFill>
-                  <a:srgbClr val="5A5F73"/>
-                </a:solidFill>
-                <a:latin typeface="Calibri" pitchFamily="34" charset="0"/>
-                <a:ea typeface="Calibri" pitchFamily="34" charset="-122"/>
-                <a:cs typeface="Calibri" pitchFamily="34" charset="-120"/>
-              </a:rPr>
-              <a:t>tres imágenes</a:t>
-            </a:r>
-            <a:endParaRPr lang="en-US" sz="950" dirty="0"/>
-          </a:p>
-          <a:p>
-            <a:pPr algn="ctr" indent="0" marL="0">
-              <a:lnSpc>
-                <a:spcPts val="1200"/>
-              </a:lnSpc>
-              <a:buNone/>
-            </a:pPr>
-            <a:r>
-              <a:rPr lang="en-US" sz="950" dirty="0">
-                <a:solidFill>
-                  <a:srgbClr val="5A5F73"/>
-                </a:solidFill>
-                <a:latin typeface="Calibri" pitchFamily="34" charset="0"/>
-                <a:ea typeface="Calibri" pitchFamily="34" charset="-122"/>
-                <a:cs typeface="Calibri" pitchFamily="34" charset="-120"/>
-              </a:rPr>
-              <a:t>Docker</a:t>
-            </a:r>
-            <a:endParaRPr lang="en-US" sz="950" dirty="0"/>
-          </a:p>
-        </p:txBody>
-      </p:sp>
-      <p:sp>
-        <p:nvSpPr>
-          <p:cNvPr id="15" name="Shape 13"/>
-          <p:cNvSpPr/>
-          <p:nvPr/>
-        </p:nvSpPr>
-        <p:spPr>
-          <a:xfrm>
-            <a:off x="7068312" y="2308860"/>
-            <a:ext cx="219456" cy="0"/>
-          </a:xfrm>
-          <a:prstGeom prst="line">
-            <a:avLst/>
-          </a:prstGeom>
-          <a:noFill/>
-          <a:ln w="19050">
-            <a:solidFill>
-              <a:srgbClr val="202CFC"/>
-            </a:solidFill>
-            <a:prstDash val="solid"/>
-            <a:tailEnd type="triangle"/>
-          </a:ln>
-        </p:spPr>
-      </p:sp>
-      <p:sp>
-        <p:nvSpPr>
-          <p:cNvPr id="16" name="Shape 14"/>
-          <p:cNvSpPr/>
-          <p:nvPr/>
-        </p:nvSpPr>
-        <p:spPr>
-          <a:xfrm>
-            <a:off x="7360920" y="1874520"/>
-            <a:ext cx="1828800" cy="868680"/>
-          </a:xfrm>
-          <a:prstGeom prst="roundRect">
-            <a:avLst>
-              <a:gd name="adj" fmla="val 6316"/>
-            </a:avLst>
-          </a:prstGeom>
-          <a:solidFill>
-            <a:srgbClr val="FFFFFF"/>
-          </a:solidFill>
-          <a:ln w="12700">
-            <a:solidFill>
-              <a:srgbClr val="C9CCD8"/>
-            </a:solidFill>
-            <a:prstDash val="solid"/>
-          </a:ln>
-        </p:spPr>
-      </p:sp>
-      <p:sp>
-        <p:nvSpPr>
-          <p:cNvPr id="17" name="Text 15"/>
-          <p:cNvSpPr/>
-          <p:nvPr/>
-        </p:nvSpPr>
-        <p:spPr>
-          <a:xfrm>
-            <a:off x="7434072" y="1993392"/>
-            <a:ext cx="1682496" cy="274320"/>
-          </a:xfrm>
-          <a:prstGeom prst="rect">
-            <a:avLst/>
-          </a:prstGeom>
-          <a:noFill/>
-          <a:ln/>
-        </p:spPr>
-        <p:txBody>
-          <a:bodyPr wrap="square" lIns="0" tIns="0" rIns="0" bIns="0" rtlCol="0" anchor="ctr"/>
-          <a:lstStyle/>
-          <a:p>
-            <a:pPr algn="ctr" indent="0" marL="0">
-              <a:buNone/>
-            </a:pPr>
-            <a:r>
-              <a:rPr lang="en-US" sz="1100" b="1" dirty="0">
-                <a:solidFill>
-                  <a:srgbClr val="1A1C2E"/>
-                </a:solidFill>
-                <a:latin typeface="Arial" pitchFamily="34" charset="0"/>
-                <a:ea typeface="Arial" pitchFamily="34" charset="-122"/>
-                <a:cs typeface="Arial" pitchFamily="34" charset="-120"/>
-              </a:rPr>
-              <a:t>Publicación</a:t>
-            </a:r>
-            <a:endParaRPr lang="en-US" sz="1100" dirty="0"/>
-          </a:p>
-        </p:txBody>
-      </p:sp>
-      <p:sp>
-        <p:nvSpPr>
-          <p:cNvPr id="18" name="Text 16"/>
-          <p:cNvSpPr/>
-          <p:nvPr/>
-        </p:nvSpPr>
-        <p:spPr>
-          <a:xfrm>
-            <a:off x="7434072" y="2276856"/>
-            <a:ext cx="1682496" cy="384048"/>
-          </a:xfrm>
-          <a:prstGeom prst="rect">
-            <a:avLst/>
-          </a:prstGeom>
-          <a:noFill/>
-          <a:ln/>
-        </p:spPr>
-        <p:txBody>
-          <a:bodyPr wrap="square" lIns="0" tIns="0" rIns="0" bIns="0" rtlCol="0" anchor="t"/>
-          <a:lstStyle/>
-          <a:p>
-            <a:pPr algn="ctr" indent="0" marL="0">
-              <a:lnSpc>
-                <a:spcPts val="1200"/>
-              </a:lnSpc>
-              <a:buNone/>
-            </a:pPr>
-            <a:r>
-              <a:rPr lang="en-US" sz="950" dirty="0">
-                <a:solidFill>
-                  <a:srgbClr val="5A5F73"/>
-                </a:solidFill>
-                <a:latin typeface="Calibri" pitchFamily="34" charset="0"/>
-                <a:ea typeface="Calibri" pitchFamily="34" charset="-122"/>
-                <a:cs typeface="Calibri" pitchFamily="34" charset="-120"/>
-              </a:rPr>
-              <a:t>registro de</a:t>
-            </a:r>
-            <a:endParaRPr lang="en-US" sz="950" dirty="0"/>
-          </a:p>
-          <a:p>
-            <a:pPr algn="ctr" indent="0" marL="0">
-              <a:lnSpc>
-                <a:spcPts val="1200"/>
-              </a:lnSpc>
-              <a:buNone/>
-            </a:pPr>
-            <a:r>
-              <a:rPr lang="en-US" sz="950" dirty="0">
-                <a:solidFill>
-                  <a:srgbClr val="5A5F73"/>
-                </a:solidFill>
-                <a:latin typeface="Calibri" pitchFamily="34" charset="0"/>
-                <a:ea typeface="Calibri" pitchFamily="34" charset="-122"/>
-                <a:cs typeface="Calibri" pitchFamily="34" charset="-120"/>
-              </a:rPr>
-              <a:t>contenedores</a:t>
-            </a:r>
-            <a:endParaRPr lang="en-US" sz="950" dirty="0"/>
-          </a:p>
-        </p:txBody>
-      </p:sp>
-      <p:sp>
-        <p:nvSpPr>
-          <p:cNvPr id="19" name="Shape 17"/>
-          <p:cNvSpPr/>
-          <p:nvPr/>
-        </p:nvSpPr>
-        <p:spPr>
-          <a:xfrm>
-            <a:off x="9262872" y="2308860"/>
-            <a:ext cx="219456" cy="0"/>
-          </a:xfrm>
-          <a:prstGeom prst="line">
-            <a:avLst/>
-          </a:prstGeom>
-          <a:noFill/>
-          <a:ln w="19050">
-            <a:solidFill>
-              <a:srgbClr val="202CFC"/>
-            </a:solidFill>
-            <a:prstDash val="solid"/>
-            <a:tailEnd type="triangle"/>
-          </a:ln>
-        </p:spPr>
-      </p:sp>
-      <p:sp>
-        <p:nvSpPr>
-          <p:cNvPr id="20" name="Shape 18"/>
-          <p:cNvSpPr/>
-          <p:nvPr/>
-        </p:nvSpPr>
-        <p:spPr>
-          <a:xfrm>
-            <a:off x="9555480" y="1874520"/>
-            <a:ext cx="1828800" cy="868680"/>
-          </a:xfrm>
-          <a:prstGeom prst="roundRect">
-            <a:avLst>
-              <a:gd name="adj" fmla="val 6316"/>
-            </a:avLst>
-          </a:prstGeom>
-          <a:solidFill>
-            <a:srgbClr val="1A1C2E"/>
-          </a:solidFill>
-          <a:ln w="12700">
-            <a:solidFill>
-              <a:srgbClr val="1A1C2E"/>
-            </a:solidFill>
-            <a:prstDash val="solid"/>
-          </a:ln>
-        </p:spPr>
-      </p:sp>
-      <p:sp>
-        <p:nvSpPr>
-          <p:cNvPr id="21" name="Text 19"/>
-          <p:cNvSpPr/>
-          <p:nvPr/>
-        </p:nvSpPr>
-        <p:spPr>
-          <a:xfrm>
-            <a:off x="9628632" y="1993392"/>
-            <a:ext cx="1682496" cy="274320"/>
-          </a:xfrm>
-          <a:prstGeom prst="rect">
-            <a:avLst/>
-          </a:prstGeom>
-          <a:noFill/>
-          <a:ln/>
-        </p:spPr>
-        <p:txBody>
-          <a:bodyPr wrap="square" lIns="0" tIns="0" rIns="0" bIns="0" rtlCol="0" anchor="ctr"/>
-          <a:lstStyle/>
-          <a:p>
-            <a:pPr algn="ctr" indent="0" marL="0">
-              <a:buNone/>
-            </a:pPr>
-            <a:r>
-              <a:rPr lang="en-US" sz="1100" b="1" dirty="0">
-                <a:solidFill>
-                  <a:srgbClr val="FFFFFF"/>
-                </a:solidFill>
-                <a:latin typeface="Arial" pitchFamily="34" charset="0"/>
-                <a:ea typeface="Arial" pitchFamily="34" charset="-122"/>
-                <a:cs typeface="Arial" pitchFamily="34" charset="-120"/>
-              </a:rPr>
-              <a:t>Producción</a:t>
-            </a:r>
-            <a:endParaRPr lang="en-US" sz="1100" dirty="0"/>
-          </a:p>
-        </p:txBody>
-      </p:sp>
-      <p:sp>
-        <p:nvSpPr>
-          <p:cNvPr id="22" name="Text 20"/>
-          <p:cNvSpPr/>
-          <p:nvPr/>
-        </p:nvSpPr>
-        <p:spPr>
-          <a:xfrm>
-            <a:off x="9628632" y="2276856"/>
-            <a:ext cx="1682496" cy="384048"/>
-          </a:xfrm>
-          <a:prstGeom prst="rect">
-            <a:avLst/>
-          </a:prstGeom>
-          <a:noFill/>
-          <a:ln/>
-        </p:spPr>
-        <p:txBody>
-          <a:bodyPr wrap="square" lIns="0" tIns="0" rIns="0" bIns="0" rtlCol="0" anchor="t"/>
-          <a:lstStyle/>
-          <a:p>
-            <a:pPr algn="ctr" indent="0" marL="0">
-              <a:lnSpc>
-                <a:spcPts val="1200"/>
-              </a:lnSpc>
-              <a:buNone/>
-            </a:pPr>
-            <a:r>
-              <a:rPr lang="en-US" sz="950" dirty="0">
-                <a:solidFill>
-                  <a:srgbClr val="B8BCCC"/>
-                </a:solidFill>
-                <a:latin typeface="Calibri" pitchFamily="34" charset="0"/>
-                <a:ea typeface="Calibri" pitchFamily="34" charset="-122"/>
-                <a:cs typeface="Calibri" pitchFamily="34" charset="-120"/>
-              </a:rPr>
-              <a:t>el servidor levanta</a:t>
-            </a:r>
-            <a:endParaRPr lang="en-US" sz="950" dirty="0"/>
-          </a:p>
-          <a:p>
-            <a:pPr algn="ctr" indent="0" marL="0">
-              <a:lnSpc>
-                <a:spcPts val="1200"/>
-              </a:lnSpc>
-              <a:buNone/>
-            </a:pPr>
-            <a:r>
-              <a:rPr lang="en-US" sz="950" dirty="0">
-                <a:solidFill>
-                  <a:srgbClr val="B8BCCC"/>
-                </a:solidFill>
-                <a:latin typeface="Calibri" pitchFamily="34" charset="0"/>
-                <a:ea typeface="Calibri" pitchFamily="34" charset="-122"/>
-                <a:cs typeface="Calibri" pitchFamily="34" charset="-120"/>
-              </a:rPr>
-              <a:t>la nueva versión</a:t>
-            </a:r>
-            <a:endParaRPr lang="en-US" sz="950" dirty="0"/>
-          </a:p>
-        </p:txBody>
-      </p:sp>
-      <p:sp>
-        <p:nvSpPr>
-          <p:cNvPr id="23" name="Text 21"/>
-          <p:cNvSpPr/>
-          <p:nvPr/>
-        </p:nvSpPr>
-        <p:spPr>
-          <a:xfrm>
-            <a:off x="777240" y="3127248"/>
-            <a:ext cx="4846320" cy="365760"/>
-          </a:xfrm>
-          <a:prstGeom prst="rect">
-            <a:avLst/>
-          </a:prstGeom>
-          <a:noFill/>
-          <a:ln/>
-        </p:spPr>
-        <p:txBody>
-          <a:bodyPr wrap="square" lIns="0" tIns="0" rIns="0" bIns="0" rtlCol="0" anchor="t"/>
-          <a:lstStyle/>
-          <a:p>
-            <a:pPr indent="0" marL="0">
-              <a:buNone/>
-            </a:pPr>
-            <a:r>
-              <a:rPr lang="en-US" sz="1900" b="1" dirty="0">
-                <a:solidFill>
-                  <a:srgbClr val="202CFC"/>
-                </a:solidFill>
-                <a:latin typeface="Arial" pitchFamily="34" charset="0"/>
-                <a:ea typeface="Arial" pitchFamily="34" charset="-122"/>
-                <a:cs typeface="Arial" pitchFamily="34" charset="-120"/>
-              </a:rPr>
-              <a:t>Integración continua</a:t>
+              <a:t>Medidas en la interfaz</a:t>
             </a:r>
             <a:endParaRPr lang="en-US" sz="1900" dirty="0"/>
           </a:p>
@@ -9966,14 +9343,14 @@
       </p:sp>
       <p:sp>
         <p:nvSpPr>
-          <p:cNvPr id="24" name="Text 22"/>
-          <p:cNvSpPr/>
-          <p:nvPr/>
-        </p:nvSpPr>
-        <p:spPr>
-          <a:xfrm>
-            <a:off x="777240" y="3657600"/>
-            <a:ext cx="4846320" cy="2377440"/>
+          <p:cNvPr id="5" name="Text 3"/>
+          <p:cNvSpPr/>
+          <p:nvPr/>
+        </p:nvSpPr>
+        <p:spPr>
+          <a:xfrm>
+            <a:off x="777240" y="2788920"/>
+            <a:ext cx="4846320" cy="2926080"/>
           </a:xfrm>
           <a:prstGeom prst="rect">
             <a:avLst/>
@@ -10004,7 +9381,7 @@
                 <a:ea typeface="Calibri" pitchFamily="34" charset="-122"/>
                 <a:cs typeface="Calibri" pitchFamily="34" charset="-120"/>
               </a:rPr>
-              <a:t>En cada push y en cada pull request</a:t>
+              <a:t>React escapa el HTML por defecto, y no hay inyección directa de marcado sobre datos de usuario</a:t>
             </a:r>
             <a:endParaRPr lang="en-US" sz="1500" dirty="0"/>
           </a:p>
@@ -10028,7 +9405,7 @@
                 <a:ea typeface="Calibri" pitchFamily="34" charset="-122"/>
                 <a:cs typeface="Calibri" pitchFamily="34" charset="-120"/>
               </a:rPr>
-              <a:t>Las dos aplicaciones en paralelo, sobre Node 22</a:t>
+              <a:t>Cabecera CSP propia: default-src 'self', sin scripts de terceros</a:t>
             </a:r>
             <a:endParaRPr lang="en-US" sz="1500" dirty="0"/>
           </a:p>
@@ -10052,7 +9429,7 @@
                 <a:ea typeface="Calibri" pitchFamily="34" charset="-122"/>
                 <a:cs typeface="Calibri" pitchFamily="34" charset="-120"/>
               </a:rPr>
-              <a:t>Lint, formato, pruebas, compilación y typecheck</a:t>
+              <a:t>Validación con Zod también en el cliente, en todos los formularios</a:t>
             </a:r>
             <a:endParaRPr lang="en-US" sz="1500" dirty="0"/>
           </a:p>
@@ -10076,7 +9453,7 @@
                 <a:ea typeface="Calibri" pitchFamily="34" charset="-122"/>
                 <a:cs typeface="Calibri" pitchFamily="34" charset="-120"/>
               </a:rPr>
-              <a:t>Auditoría de dependencias, que detiene la entrega ante una vulnerabilidad crítica</a:t>
+              <a:t>El token viaja en cabecera Bearer y no en cookie, así que no hay CSRF</a:t>
             </a:r>
             <a:endParaRPr lang="en-US" sz="1500" dirty="0"/>
           </a:p>
@@ -10084,13 +9461,13 @@
       </p:sp>
       <p:sp>
         <p:nvSpPr>
-          <p:cNvPr id="25" name="Text 23"/>
-          <p:cNvSpPr/>
-          <p:nvPr/>
-        </p:nvSpPr>
-        <p:spPr>
-          <a:xfrm>
-            <a:off x="6537960" y="3127248"/>
+          <p:cNvPr id="6" name="Text 4"/>
+          <p:cNvSpPr/>
+          <p:nvPr/>
+        </p:nvSpPr>
+        <p:spPr>
+          <a:xfrm>
+            <a:off x="6537960" y="2240280"/>
             <a:ext cx="4846320" cy="365760"/>
           </a:xfrm>
           <a:prstGeom prst="rect">
@@ -10115,7 +9492,7 @@
                 <a:ea typeface="Arial" pitchFamily="34" charset="-122"/>
                 <a:cs typeface="Arial" pitchFamily="34" charset="-120"/>
               </a:rPr>
-              <a:t>Despliegue continuo</a:t>
+              <a:t>Riesgos asumidos, no escondidos</a:t>
             </a:r>
             <a:endParaRPr lang="en-US" sz="1900" dirty="0"/>
           </a:p>
@@ -10123,14 +9500,14 @@
       </p:sp>
       <p:sp>
         <p:nvSpPr>
-          <p:cNvPr id="26" name="Text 24"/>
-          <p:cNvSpPr/>
-          <p:nvPr/>
-        </p:nvSpPr>
-        <p:spPr>
-          <a:xfrm>
-            <a:off x="6537960" y="3657600"/>
-            <a:ext cx="4846320" cy="2377440"/>
+          <p:cNvPr id="7" name="Text 5"/>
+          <p:cNvSpPr/>
+          <p:nvPr/>
+        </p:nvSpPr>
+        <p:spPr>
+          <a:xfrm>
+            <a:off x="6537960" y="2788920"/>
+            <a:ext cx="4846320" cy="2926080"/>
           </a:xfrm>
           <a:prstGeom prst="rect">
             <a:avLst/>
@@ -10161,7 +9538,7 @@
                 <a:ea typeface="Calibri" pitchFamily="34" charset="-122"/>
                 <a:cs typeface="Calibri" pitchFamily="34" charset="-120"/>
               </a:rPr>
-              <a:t>Se dispara al integrar en main</a:t>
+              <a:t>El token vive en localStorage: quedaría expuesto ante un XSS</a:t>
             </a:r>
             <a:endParaRPr lang="en-US" sz="1500" dirty="0"/>
           </a:p>
@@ -10185,7 +9562,7 @@
                 <a:ea typeface="Calibri" pitchFamily="34" charset="-122"/>
                 <a:cs typeface="Calibri" pitchFamily="34" charset="-120"/>
               </a:rPr>
-              <a:t>Construye tres imágenes: API, interfaz y emulador</a:t>
+              <a:t>No hay doble factor de autenticación</a:t>
             </a:r>
             <a:endParaRPr lang="en-US" sz="1500" dirty="0"/>
           </a:p>
@@ -10209,7 +9586,7 @@
                 <a:ea typeface="Calibri" pitchFamily="34" charset="-122"/>
                 <a:cs typeface="Calibri" pitchFamily="34" charset="-120"/>
               </a:rPr>
-              <a:t>Las publica en el registro de contenedores de GitHub</a:t>
+              <a:t>La base de datos no está cifrada en disco</a:t>
             </a:r>
             <a:endParaRPr lang="en-US" sz="1500" dirty="0"/>
           </a:p>
@@ -10233,7 +9610,7 @@
                 <a:ea typeface="Calibri" pitchFamily="34" charset="-122"/>
                 <a:cs typeface="Calibri" pitchFamily="34" charset="-120"/>
               </a:rPr>
-              <a:t>El servidor las descarga y levanta la nueva versión, sin intervención manual</a:t>
+              <a:t>Los límites de peticiones viven en memoria y se pierden al reiniciar</a:t>
             </a:r>
             <a:endParaRPr lang="en-US" sz="1500" dirty="0"/>
           </a:p>
@@ -10241,7 +9618,7 @@
       </p:sp>
       <p:sp>
         <p:nvSpPr>
-          <p:cNvPr id="27" name="Shape 25"/>
+          <p:cNvPr id="8" name="Shape 6"/>
           <p:cNvSpPr/>
           <p:nvPr/>
         </p:nvSpPr>
@@ -10261,7 +9638,7 @@
       </p:sp>
       <p:sp>
         <p:nvSpPr>
-          <p:cNvPr id="28" name="Text 26"/>
+          <p:cNvPr id="9" name="Text 7"/>
           <p:cNvSpPr/>
           <p:nvPr/>
         </p:nvSpPr>
@@ -10300,7 +9677,7 @@
       </p:sp>
       <p:sp>
         <p:nvSpPr>
-          <p:cNvPr id="29" name="Text 27"/>
+          <p:cNvPr id="10" name="Text 8"/>
           <p:cNvSpPr/>
           <p:nvPr/>
         </p:nvSpPr>
@@ -10339,7 +9716,7 @@
       </p:sp>
       <p:sp>
         <p:nvSpPr>
-          <p:cNvPr id="30" name="Text 28"/>
+          <p:cNvPr id="11" name="Text 9"/>
           <p:cNvSpPr/>
           <p:nvPr/>
         </p:nvSpPr>
@@ -10416,8 +9793,8 @@
         </p:nvSpPr>
         <p:spPr>
           <a:xfrm>
-            <a:off x="777240" y="640080"/>
-            <a:ext cx="10607040" cy="777240"/>
+            <a:off x="777240" y="502920"/>
+            <a:ext cx="10607040" cy="685800"/>
           </a:xfrm>
           <a:prstGeom prst="rect">
             <a:avLst/>
@@ -10433,7 +9810,7 @@
               <a:buNone/>
             </a:pPr>
             <a:r>
-              <a:rPr lang="en-US" sz="3400" b="1" dirty="0">
+              <a:rPr lang="en-US" sz="3200" b="1" dirty="0">
                 <a:solidFill>
                   <a:srgbClr val="1A1C2E"/>
                 </a:solidFill>
@@ -10441,9 +9818,9 @@
                 <a:ea typeface="Arial" pitchFamily="34" charset="-122"/>
                 <a:cs typeface="Arial" pitchFamily="34" charset="-120"/>
               </a:rPr>
-              <a:t>Conclusiones</a:t>
-            </a:r>
-            <a:endParaRPr lang="en-US" sz="3400" dirty="0"/>
+              <a:t>Integración y despliegue continuos</a:t>
+            </a:r>
+            <a:endParaRPr lang="en-US" sz="3200" dirty="0"/>
           </a:p>
         </p:txBody>
       </p:sp>
@@ -10455,8 +9832,8 @@
         </p:nvSpPr>
         <p:spPr>
           <a:xfrm>
-            <a:off x="777240" y="1508760"/>
-            <a:ext cx="10607040" cy="365760"/>
+            <a:off x="777240" y="1261872"/>
+            <a:ext cx="10607040" cy="320040"/>
           </a:xfrm>
           <a:prstGeom prst="rect">
             <a:avLst/>
@@ -10472,7 +9849,7 @@
               <a:buNone/>
             </a:pPr>
             <a:r>
-              <a:rPr lang="en-US" sz="1700" dirty="0">
+              <a:rPr lang="en-US" sz="1500" dirty="0">
                 <a:solidFill>
                   <a:srgbClr val="5A5F73"/>
                 </a:solidFill>
@@ -10480,61 +9857,777 @@
                 <a:ea typeface="Calibri" pitchFamily="34" charset="-122"/>
                 <a:cs typeface="Calibri" pitchFamily="34" charset="-120"/>
               </a:rPr>
-              <a:t>Balance de haber desarrollado el proyecto con asistencia de IA.</a:t>
-            </a:r>
-            <a:endParaRPr lang="en-US" sz="1700" dirty="0"/>
-          </a:p>
-        </p:txBody>
-      </p:sp>
-      <p:sp>
-        <p:nvSpPr>
-          <p:cNvPr id="4" name="Text 2"/>
-          <p:cNvSpPr/>
-          <p:nvPr/>
-        </p:nvSpPr>
-        <p:spPr>
-          <a:xfrm>
-            <a:off x="777240" y="2286000"/>
-            <a:ext cx="4846320" cy="365760"/>
-          </a:xfrm>
-          <a:prstGeom prst="rect">
-            <a:avLst/>
-          </a:prstGeom>
-          <a:noFill/>
-          <a:ln/>
-        </p:spPr>
-        <p:txBody>
-          <a:bodyPr wrap="square" lIns="0" tIns="0" rIns="0" bIns="0" rtlCol="0" anchor="t"/>
-          <a:lstStyle/>
-          <a:p>
-            <a:pPr indent="0" marL="0">
-              <a:buNone/>
-            </a:pPr>
-            <a:r>
-              <a:rPr lang="en-US" sz="2000" b="1" dirty="0">
-                <a:solidFill>
-                  <a:srgbClr val="202CFC"/>
+              <a:t>Todo automatizado en GitHub Actions: integrar en main publica la nueva versión en producción.</a:t>
+            </a:r>
+            <a:endParaRPr lang="en-US" sz="1500" dirty="0"/>
+          </a:p>
+        </p:txBody>
+      </p:sp>
+      <p:sp>
+        <p:nvSpPr>
+          <p:cNvPr id="4" name="Shape 2"/>
+          <p:cNvSpPr/>
+          <p:nvPr/>
+        </p:nvSpPr>
+        <p:spPr>
+          <a:xfrm>
+            <a:off x="777240" y="1874520"/>
+            <a:ext cx="1828800" cy="868680"/>
+          </a:xfrm>
+          <a:prstGeom prst="roundRect">
+            <a:avLst>
+              <a:gd name="adj" fmla="val 6316"/>
+            </a:avLst>
+          </a:prstGeom>
+          <a:solidFill>
+            <a:srgbClr val="FFFFFF"/>
+          </a:solidFill>
+          <a:ln w="12700">
+            <a:solidFill>
+              <a:srgbClr val="C9CCD8"/>
+            </a:solidFill>
+            <a:prstDash val="solid"/>
+          </a:ln>
+        </p:spPr>
+      </p:sp>
+      <p:sp>
+        <p:nvSpPr>
+          <p:cNvPr id="5" name="Text 3"/>
+          <p:cNvSpPr/>
+          <p:nvPr/>
+        </p:nvSpPr>
+        <p:spPr>
+          <a:xfrm>
+            <a:off x="850392" y="1993392"/>
+            <a:ext cx="1682496" cy="274320"/>
+          </a:xfrm>
+          <a:prstGeom prst="rect">
+            <a:avLst/>
+          </a:prstGeom>
+          <a:noFill/>
+          <a:ln/>
+        </p:spPr>
+        <p:txBody>
+          <a:bodyPr wrap="square" lIns="0" tIns="0" rIns="0" bIns="0" rtlCol="0" anchor="ctr"/>
+          <a:lstStyle/>
+          <a:p>
+            <a:pPr algn="ctr" indent="0" marL="0">
+              <a:buNone/>
+            </a:pPr>
+            <a:r>
+              <a:rPr lang="en-US" sz="1100" b="1" dirty="0">
+                <a:solidFill>
+                  <a:srgbClr val="1A1C2E"/>
                 </a:solidFill>
                 <a:latin typeface="Arial" pitchFamily="34" charset="0"/>
                 <a:ea typeface="Arial" pitchFamily="34" charset="-122"/>
                 <a:cs typeface="Arial" pitchFamily="34" charset="-120"/>
               </a:rPr>
-              <a:t>Lo que aporta</a:t>
-            </a:r>
-            <a:endParaRPr lang="en-US" sz="2000" dirty="0"/>
-          </a:p>
-        </p:txBody>
-      </p:sp>
-      <p:sp>
-        <p:nvSpPr>
-          <p:cNvPr id="5" name="Text 3"/>
-          <p:cNvSpPr/>
-          <p:nvPr/>
-        </p:nvSpPr>
-        <p:spPr>
-          <a:xfrm>
-            <a:off x="777240" y="2834640"/>
-            <a:ext cx="4846320" cy="2468880"/>
+              <a:t>Integración en main</a:t>
+            </a:r>
+            <a:endParaRPr lang="en-US" sz="1100" dirty="0"/>
+          </a:p>
+        </p:txBody>
+      </p:sp>
+      <p:sp>
+        <p:nvSpPr>
+          <p:cNvPr id="6" name="Text 4"/>
+          <p:cNvSpPr/>
+          <p:nvPr/>
+        </p:nvSpPr>
+        <p:spPr>
+          <a:xfrm>
+            <a:off x="850392" y="2276856"/>
+            <a:ext cx="1682496" cy="384048"/>
+          </a:xfrm>
+          <a:prstGeom prst="rect">
+            <a:avLst/>
+          </a:prstGeom>
+          <a:noFill/>
+          <a:ln/>
+        </p:spPr>
+        <p:txBody>
+          <a:bodyPr wrap="square" lIns="0" tIns="0" rIns="0" bIns="0" rtlCol="0" anchor="t"/>
+          <a:lstStyle/>
+          <a:p>
+            <a:pPr algn="ctr" indent="0" marL="0">
+              <a:lnSpc>
+                <a:spcPts val="1200"/>
+              </a:lnSpc>
+              <a:buNone/>
+            </a:pPr>
+            <a:r>
+              <a:rPr lang="en-US" sz="950" dirty="0">
+                <a:solidFill>
+                  <a:srgbClr val="5A5F73"/>
+                </a:solidFill>
+                <a:latin typeface="Calibri" pitchFamily="34" charset="0"/>
+                <a:ea typeface="Calibri" pitchFamily="34" charset="-122"/>
+                <a:cs typeface="Calibri" pitchFamily="34" charset="-120"/>
+              </a:rPr>
+              <a:t>push o merge</a:t>
+            </a:r>
+            <a:endParaRPr lang="en-US" sz="950" dirty="0"/>
+          </a:p>
+        </p:txBody>
+      </p:sp>
+      <p:sp>
+        <p:nvSpPr>
+          <p:cNvPr id="7" name="Shape 5"/>
+          <p:cNvSpPr/>
+          <p:nvPr/>
+        </p:nvSpPr>
+        <p:spPr>
+          <a:xfrm>
+            <a:off x="2679192" y="2308860"/>
+            <a:ext cx="219456" cy="0"/>
+          </a:xfrm>
+          <a:prstGeom prst="line">
+            <a:avLst/>
+          </a:prstGeom>
+          <a:noFill/>
+          <a:ln w="19050">
+            <a:solidFill>
+              <a:srgbClr val="202CFC"/>
+            </a:solidFill>
+            <a:prstDash val="solid"/>
+            <a:tailEnd type="triangle"/>
+          </a:ln>
+        </p:spPr>
+      </p:sp>
+      <p:sp>
+        <p:nvSpPr>
+          <p:cNvPr id="8" name="Shape 6"/>
+          <p:cNvSpPr/>
+          <p:nvPr/>
+        </p:nvSpPr>
+        <p:spPr>
+          <a:xfrm>
+            <a:off x="2971800" y="1874520"/>
+            <a:ext cx="1828800" cy="868680"/>
+          </a:xfrm>
+          <a:prstGeom prst="roundRect">
+            <a:avLst>
+              <a:gd name="adj" fmla="val 6316"/>
+            </a:avLst>
+          </a:prstGeom>
+          <a:solidFill>
+            <a:srgbClr val="FFFFFF"/>
+          </a:solidFill>
+          <a:ln w="12700">
+            <a:solidFill>
+              <a:srgbClr val="C9CCD8"/>
+            </a:solidFill>
+            <a:prstDash val="solid"/>
+          </a:ln>
+        </p:spPr>
+      </p:sp>
+      <p:sp>
+        <p:nvSpPr>
+          <p:cNvPr id="9" name="Text 7"/>
+          <p:cNvSpPr/>
+          <p:nvPr/>
+        </p:nvSpPr>
+        <p:spPr>
+          <a:xfrm>
+            <a:off x="3044952" y="1993392"/>
+            <a:ext cx="1682496" cy="274320"/>
+          </a:xfrm>
+          <a:prstGeom prst="rect">
+            <a:avLst/>
+          </a:prstGeom>
+          <a:noFill/>
+          <a:ln/>
+        </p:spPr>
+        <p:txBody>
+          <a:bodyPr wrap="square" lIns="0" tIns="0" rIns="0" bIns="0" rtlCol="0" anchor="ctr"/>
+          <a:lstStyle/>
+          <a:p>
+            <a:pPr algn="ctr" indent="0" marL="0">
+              <a:buNone/>
+            </a:pPr>
+            <a:r>
+              <a:rPr lang="en-US" sz="1100" b="1" dirty="0">
+                <a:solidFill>
+                  <a:srgbClr val="1A1C2E"/>
+                </a:solidFill>
+                <a:latin typeface="Arial" pitchFamily="34" charset="0"/>
+                <a:ea typeface="Arial" pitchFamily="34" charset="-122"/>
+                <a:cs typeface="Arial" pitchFamily="34" charset="-120"/>
+              </a:rPr>
+              <a:t>Verificación</a:t>
+            </a:r>
+            <a:endParaRPr lang="en-US" sz="1100" dirty="0"/>
+          </a:p>
+        </p:txBody>
+      </p:sp>
+      <p:sp>
+        <p:nvSpPr>
+          <p:cNvPr id="10" name="Text 8"/>
+          <p:cNvSpPr/>
+          <p:nvPr/>
+        </p:nvSpPr>
+        <p:spPr>
+          <a:xfrm>
+            <a:off x="3044952" y="2276856"/>
+            <a:ext cx="1682496" cy="384048"/>
+          </a:xfrm>
+          <a:prstGeom prst="rect">
+            <a:avLst/>
+          </a:prstGeom>
+          <a:noFill/>
+          <a:ln/>
+        </p:spPr>
+        <p:txBody>
+          <a:bodyPr wrap="square" lIns="0" tIns="0" rIns="0" bIns="0" rtlCol="0" anchor="t"/>
+          <a:lstStyle/>
+          <a:p>
+            <a:pPr algn="ctr" indent="0" marL="0">
+              <a:lnSpc>
+                <a:spcPts val="1200"/>
+              </a:lnSpc>
+              <a:buNone/>
+            </a:pPr>
+            <a:r>
+              <a:rPr lang="en-US" sz="950" dirty="0">
+                <a:solidFill>
+                  <a:srgbClr val="5A5F73"/>
+                </a:solidFill>
+                <a:latin typeface="Calibri" pitchFamily="34" charset="0"/>
+                <a:ea typeface="Calibri" pitchFamily="34" charset="-122"/>
+                <a:cs typeface="Calibri" pitchFamily="34" charset="-120"/>
+              </a:rPr>
+              <a:t>lint, tests,</a:t>
+            </a:r>
+            <a:endParaRPr lang="en-US" sz="950" dirty="0"/>
+          </a:p>
+          <a:p>
+            <a:pPr algn="ctr" indent="0" marL="0">
+              <a:lnSpc>
+                <a:spcPts val="1200"/>
+              </a:lnSpc>
+              <a:buNone/>
+            </a:pPr>
+            <a:r>
+              <a:rPr lang="en-US" sz="950" dirty="0">
+                <a:solidFill>
+                  <a:srgbClr val="5A5F73"/>
+                </a:solidFill>
+                <a:latin typeface="Calibri" pitchFamily="34" charset="0"/>
+                <a:ea typeface="Calibri" pitchFamily="34" charset="-122"/>
+                <a:cs typeface="Calibri" pitchFamily="34" charset="-120"/>
+              </a:rPr>
+              <a:t>build y typecheck</a:t>
+            </a:r>
+            <a:endParaRPr lang="en-US" sz="950" dirty="0"/>
+          </a:p>
+        </p:txBody>
+      </p:sp>
+      <p:sp>
+        <p:nvSpPr>
+          <p:cNvPr id="11" name="Shape 9"/>
+          <p:cNvSpPr/>
+          <p:nvPr/>
+        </p:nvSpPr>
+        <p:spPr>
+          <a:xfrm>
+            <a:off x="4873752" y="2308860"/>
+            <a:ext cx="219456" cy="0"/>
+          </a:xfrm>
+          <a:prstGeom prst="line">
+            <a:avLst/>
+          </a:prstGeom>
+          <a:noFill/>
+          <a:ln w="19050">
+            <a:solidFill>
+              <a:srgbClr val="202CFC"/>
+            </a:solidFill>
+            <a:prstDash val="solid"/>
+            <a:tailEnd type="triangle"/>
+          </a:ln>
+        </p:spPr>
+      </p:sp>
+      <p:sp>
+        <p:nvSpPr>
+          <p:cNvPr id="12" name="Shape 10"/>
+          <p:cNvSpPr/>
+          <p:nvPr/>
+        </p:nvSpPr>
+        <p:spPr>
+          <a:xfrm>
+            <a:off x="5166360" y="1874520"/>
+            <a:ext cx="1828800" cy="868680"/>
+          </a:xfrm>
+          <a:prstGeom prst="roundRect">
+            <a:avLst>
+              <a:gd name="adj" fmla="val 6316"/>
+            </a:avLst>
+          </a:prstGeom>
+          <a:solidFill>
+            <a:srgbClr val="FFFFFF"/>
+          </a:solidFill>
+          <a:ln w="12700">
+            <a:solidFill>
+              <a:srgbClr val="C9CCD8"/>
+            </a:solidFill>
+            <a:prstDash val="solid"/>
+          </a:ln>
+        </p:spPr>
+      </p:sp>
+      <p:sp>
+        <p:nvSpPr>
+          <p:cNvPr id="13" name="Text 11"/>
+          <p:cNvSpPr/>
+          <p:nvPr/>
+        </p:nvSpPr>
+        <p:spPr>
+          <a:xfrm>
+            <a:off x="5239512" y="1993392"/>
+            <a:ext cx="1682496" cy="274320"/>
+          </a:xfrm>
+          <a:prstGeom prst="rect">
+            <a:avLst/>
+          </a:prstGeom>
+          <a:noFill/>
+          <a:ln/>
+        </p:spPr>
+        <p:txBody>
+          <a:bodyPr wrap="square" lIns="0" tIns="0" rIns="0" bIns="0" rtlCol="0" anchor="ctr"/>
+          <a:lstStyle/>
+          <a:p>
+            <a:pPr algn="ctr" indent="0" marL="0">
+              <a:buNone/>
+            </a:pPr>
+            <a:r>
+              <a:rPr lang="en-US" sz="1100" b="1" dirty="0">
+                <a:solidFill>
+                  <a:srgbClr val="1A1C2E"/>
+                </a:solidFill>
+                <a:latin typeface="Arial" pitchFamily="34" charset="0"/>
+                <a:ea typeface="Arial" pitchFamily="34" charset="-122"/>
+                <a:cs typeface="Arial" pitchFamily="34" charset="-120"/>
+              </a:rPr>
+              <a:t>Construcción</a:t>
+            </a:r>
+            <a:endParaRPr lang="en-US" sz="1100" dirty="0"/>
+          </a:p>
+        </p:txBody>
+      </p:sp>
+      <p:sp>
+        <p:nvSpPr>
+          <p:cNvPr id="14" name="Text 12"/>
+          <p:cNvSpPr/>
+          <p:nvPr/>
+        </p:nvSpPr>
+        <p:spPr>
+          <a:xfrm>
+            <a:off x="5239512" y="2276856"/>
+            <a:ext cx="1682496" cy="384048"/>
+          </a:xfrm>
+          <a:prstGeom prst="rect">
+            <a:avLst/>
+          </a:prstGeom>
+          <a:noFill/>
+          <a:ln/>
+        </p:spPr>
+        <p:txBody>
+          <a:bodyPr wrap="square" lIns="0" tIns="0" rIns="0" bIns="0" rtlCol="0" anchor="t"/>
+          <a:lstStyle/>
+          <a:p>
+            <a:pPr algn="ctr" indent="0" marL="0">
+              <a:lnSpc>
+                <a:spcPts val="1200"/>
+              </a:lnSpc>
+              <a:buNone/>
+            </a:pPr>
+            <a:r>
+              <a:rPr lang="en-US" sz="950" dirty="0">
+                <a:solidFill>
+                  <a:srgbClr val="5A5F73"/>
+                </a:solidFill>
+                <a:latin typeface="Calibri" pitchFamily="34" charset="0"/>
+                <a:ea typeface="Calibri" pitchFamily="34" charset="-122"/>
+                <a:cs typeface="Calibri" pitchFamily="34" charset="-120"/>
+              </a:rPr>
+              <a:t>tres imágenes</a:t>
+            </a:r>
+            <a:endParaRPr lang="en-US" sz="950" dirty="0"/>
+          </a:p>
+          <a:p>
+            <a:pPr algn="ctr" indent="0" marL="0">
+              <a:lnSpc>
+                <a:spcPts val="1200"/>
+              </a:lnSpc>
+              <a:buNone/>
+            </a:pPr>
+            <a:r>
+              <a:rPr lang="en-US" sz="950" dirty="0">
+                <a:solidFill>
+                  <a:srgbClr val="5A5F73"/>
+                </a:solidFill>
+                <a:latin typeface="Calibri" pitchFamily="34" charset="0"/>
+                <a:ea typeface="Calibri" pitchFamily="34" charset="-122"/>
+                <a:cs typeface="Calibri" pitchFamily="34" charset="-120"/>
+              </a:rPr>
+              <a:t>Docker</a:t>
+            </a:r>
+            <a:endParaRPr lang="en-US" sz="950" dirty="0"/>
+          </a:p>
+        </p:txBody>
+      </p:sp>
+      <p:sp>
+        <p:nvSpPr>
+          <p:cNvPr id="15" name="Shape 13"/>
+          <p:cNvSpPr/>
+          <p:nvPr/>
+        </p:nvSpPr>
+        <p:spPr>
+          <a:xfrm>
+            <a:off x="7068312" y="2308860"/>
+            <a:ext cx="219456" cy="0"/>
+          </a:xfrm>
+          <a:prstGeom prst="line">
+            <a:avLst/>
+          </a:prstGeom>
+          <a:noFill/>
+          <a:ln w="19050">
+            <a:solidFill>
+              <a:srgbClr val="202CFC"/>
+            </a:solidFill>
+            <a:prstDash val="solid"/>
+            <a:tailEnd type="triangle"/>
+          </a:ln>
+        </p:spPr>
+      </p:sp>
+      <p:sp>
+        <p:nvSpPr>
+          <p:cNvPr id="16" name="Shape 14"/>
+          <p:cNvSpPr/>
+          <p:nvPr/>
+        </p:nvSpPr>
+        <p:spPr>
+          <a:xfrm>
+            <a:off x="7360920" y="1874520"/>
+            <a:ext cx="1828800" cy="868680"/>
+          </a:xfrm>
+          <a:prstGeom prst="roundRect">
+            <a:avLst>
+              <a:gd name="adj" fmla="val 6316"/>
+            </a:avLst>
+          </a:prstGeom>
+          <a:solidFill>
+            <a:srgbClr val="FFFFFF"/>
+          </a:solidFill>
+          <a:ln w="12700">
+            <a:solidFill>
+              <a:srgbClr val="C9CCD8"/>
+            </a:solidFill>
+            <a:prstDash val="solid"/>
+          </a:ln>
+        </p:spPr>
+      </p:sp>
+      <p:sp>
+        <p:nvSpPr>
+          <p:cNvPr id="17" name="Text 15"/>
+          <p:cNvSpPr/>
+          <p:nvPr/>
+        </p:nvSpPr>
+        <p:spPr>
+          <a:xfrm>
+            <a:off x="7434072" y="1993392"/>
+            <a:ext cx="1682496" cy="274320"/>
+          </a:xfrm>
+          <a:prstGeom prst="rect">
+            <a:avLst/>
+          </a:prstGeom>
+          <a:noFill/>
+          <a:ln/>
+        </p:spPr>
+        <p:txBody>
+          <a:bodyPr wrap="square" lIns="0" tIns="0" rIns="0" bIns="0" rtlCol="0" anchor="ctr"/>
+          <a:lstStyle/>
+          <a:p>
+            <a:pPr algn="ctr" indent="0" marL="0">
+              <a:buNone/>
+            </a:pPr>
+            <a:r>
+              <a:rPr lang="en-US" sz="1100" b="1" dirty="0">
+                <a:solidFill>
+                  <a:srgbClr val="1A1C2E"/>
+                </a:solidFill>
+                <a:latin typeface="Arial" pitchFamily="34" charset="0"/>
+                <a:ea typeface="Arial" pitchFamily="34" charset="-122"/>
+                <a:cs typeface="Arial" pitchFamily="34" charset="-120"/>
+              </a:rPr>
+              <a:t>Publicación</a:t>
+            </a:r>
+            <a:endParaRPr lang="en-US" sz="1100" dirty="0"/>
+          </a:p>
+        </p:txBody>
+      </p:sp>
+      <p:sp>
+        <p:nvSpPr>
+          <p:cNvPr id="18" name="Text 16"/>
+          <p:cNvSpPr/>
+          <p:nvPr/>
+        </p:nvSpPr>
+        <p:spPr>
+          <a:xfrm>
+            <a:off x="7434072" y="2276856"/>
+            <a:ext cx="1682496" cy="384048"/>
+          </a:xfrm>
+          <a:prstGeom prst="rect">
+            <a:avLst/>
+          </a:prstGeom>
+          <a:noFill/>
+          <a:ln/>
+        </p:spPr>
+        <p:txBody>
+          <a:bodyPr wrap="square" lIns="0" tIns="0" rIns="0" bIns="0" rtlCol="0" anchor="t"/>
+          <a:lstStyle/>
+          <a:p>
+            <a:pPr algn="ctr" indent="0" marL="0">
+              <a:lnSpc>
+                <a:spcPts val="1200"/>
+              </a:lnSpc>
+              <a:buNone/>
+            </a:pPr>
+            <a:r>
+              <a:rPr lang="en-US" sz="950" dirty="0">
+                <a:solidFill>
+                  <a:srgbClr val="5A5F73"/>
+                </a:solidFill>
+                <a:latin typeface="Calibri" pitchFamily="34" charset="0"/>
+                <a:ea typeface="Calibri" pitchFamily="34" charset="-122"/>
+                <a:cs typeface="Calibri" pitchFamily="34" charset="-120"/>
+              </a:rPr>
+              <a:t>registro de</a:t>
+            </a:r>
+            <a:endParaRPr lang="en-US" sz="950" dirty="0"/>
+          </a:p>
+          <a:p>
+            <a:pPr algn="ctr" indent="0" marL="0">
+              <a:lnSpc>
+                <a:spcPts val="1200"/>
+              </a:lnSpc>
+              <a:buNone/>
+            </a:pPr>
+            <a:r>
+              <a:rPr lang="en-US" sz="950" dirty="0">
+                <a:solidFill>
+                  <a:srgbClr val="5A5F73"/>
+                </a:solidFill>
+                <a:latin typeface="Calibri" pitchFamily="34" charset="0"/>
+                <a:ea typeface="Calibri" pitchFamily="34" charset="-122"/>
+                <a:cs typeface="Calibri" pitchFamily="34" charset="-120"/>
+              </a:rPr>
+              <a:t>contenedores</a:t>
+            </a:r>
+            <a:endParaRPr lang="en-US" sz="950" dirty="0"/>
+          </a:p>
+        </p:txBody>
+      </p:sp>
+      <p:sp>
+        <p:nvSpPr>
+          <p:cNvPr id="19" name="Shape 17"/>
+          <p:cNvSpPr/>
+          <p:nvPr/>
+        </p:nvSpPr>
+        <p:spPr>
+          <a:xfrm>
+            <a:off x="9262872" y="2308860"/>
+            <a:ext cx="219456" cy="0"/>
+          </a:xfrm>
+          <a:prstGeom prst="line">
+            <a:avLst/>
+          </a:prstGeom>
+          <a:noFill/>
+          <a:ln w="19050">
+            <a:solidFill>
+              <a:srgbClr val="202CFC"/>
+            </a:solidFill>
+            <a:prstDash val="solid"/>
+            <a:tailEnd type="triangle"/>
+          </a:ln>
+        </p:spPr>
+      </p:sp>
+      <p:sp>
+        <p:nvSpPr>
+          <p:cNvPr id="20" name="Shape 18"/>
+          <p:cNvSpPr/>
+          <p:nvPr/>
+        </p:nvSpPr>
+        <p:spPr>
+          <a:xfrm>
+            <a:off x="9555480" y="1874520"/>
+            <a:ext cx="1828800" cy="868680"/>
+          </a:xfrm>
+          <a:prstGeom prst="roundRect">
+            <a:avLst>
+              <a:gd name="adj" fmla="val 6316"/>
+            </a:avLst>
+          </a:prstGeom>
+          <a:solidFill>
+            <a:srgbClr val="1A1C2E"/>
+          </a:solidFill>
+          <a:ln w="12700">
+            <a:solidFill>
+              <a:srgbClr val="1A1C2E"/>
+            </a:solidFill>
+            <a:prstDash val="solid"/>
+          </a:ln>
+        </p:spPr>
+      </p:sp>
+      <p:sp>
+        <p:nvSpPr>
+          <p:cNvPr id="21" name="Text 19"/>
+          <p:cNvSpPr/>
+          <p:nvPr/>
+        </p:nvSpPr>
+        <p:spPr>
+          <a:xfrm>
+            <a:off x="9628632" y="1993392"/>
+            <a:ext cx="1682496" cy="274320"/>
+          </a:xfrm>
+          <a:prstGeom prst="rect">
+            <a:avLst/>
+          </a:prstGeom>
+          <a:noFill/>
+          <a:ln/>
+        </p:spPr>
+        <p:txBody>
+          <a:bodyPr wrap="square" lIns="0" tIns="0" rIns="0" bIns="0" rtlCol="0" anchor="ctr"/>
+          <a:lstStyle/>
+          <a:p>
+            <a:pPr algn="ctr" indent="0" marL="0">
+              <a:buNone/>
+            </a:pPr>
+            <a:r>
+              <a:rPr lang="en-US" sz="1100" b="1" dirty="0">
+                <a:solidFill>
+                  <a:srgbClr val="FFFFFF"/>
+                </a:solidFill>
+                <a:latin typeface="Arial" pitchFamily="34" charset="0"/>
+                <a:ea typeface="Arial" pitchFamily="34" charset="-122"/>
+                <a:cs typeface="Arial" pitchFamily="34" charset="-120"/>
+              </a:rPr>
+              <a:t>Producción</a:t>
+            </a:r>
+            <a:endParaRPr lang="en-US" sz="1100" dirty="0"/>
+          </a:p>
+        </p:txBody>
+      </p:sp>
+      <p:sp>
+        <p:nvSpPr>
+          <p:cNvPr id="22" name="Text 20"/>
+          <p:cNvSpPr/>
+          <p:nvPr/>
+        </p:nvSpPr>
+        <p:spPr>
+          <a:xfrm>
+            <a:off x="9628632" y="2276856"/>
+            <a:ext cx="1682496" cy="384048"/>
+          </a:xfrm>
+          <a:prstGeom prst="rect">
+            <a:avLst/>
+          </a:prstGeom>
+          <a:noFill/>
+          <a:ln/>
+        </p:spPr>
+        <p:txBody>
+          <a:bodyPr wrap="square" lIns="0" tIns="0" rIns="0" bIns="0" rtlCol="0" anchor="t"/>
+          <a:lstStyle/>
+          <a:p>
+            <a:pPr algn="ctr" indent="0" marL="0">
+              <a:lnSpc>
+                <a:spcPts val="1200"/>
+              </a:lnSpc>
+              <a:buNone/>
+            </a:pPr>
+            <a:r>
+              <a:rPr lang="en-US" sz="950" dirty="0">
+                <a:solidFill>
+                  <a:srgbClr val="B8BCCC"/>
+                </a:solidFill>
+                <a:latin typeface="Calibri" pitchFamily="34" charset="0"/>
+                <a:ea typeface="Calibri" pitchFamily="34" charset="-122"/>
+                <a:cs typeface="Calibri" pitchFamily="34" charset="-120"/>
+              </a:rPr>
+              <a:t>el servidor levanta</a:t>
+            </a:r>
+            <a:endParaRPr lang="en-US" sz="950" dirty="0"/>
+          </a:p>
+          <a:p>
+            <a:pPr algn="ctr" indent="0" marL="0">
+              <a:lnSpc>
+                <a:spcPts val="1200"/>
+              </a:lnSpc>
+              <a:buNone/>
+            </a:pPr>
+            <a:r>
+              <a:rPr lang="en-US" sz="950" dirty="0">
+                <a:solidFill>
+                  <a:srgbClr val="B8BCCC"/>
+                </a:solidFill>
+                <a:latin typeface="Calibri" pitchFamily="34" charset="0"/>
+                <a:ea typeface="Calibri" pitchFamily="34" charset="-122"/>
+                <a:cs typeface="Calibri" pitchFamily="34" charset="-120"/>
+              </a:rPr>
+              <a:t>la nueva versión</a:t>
+            </a:r>
+            <a:endParaRPr lang="en-US" sz="950" dirty="0"/>
+          </a:p>
+        </p:txBody>
+      </p:sp>
+      <p:sp>
+        <p:nvSpPr>
+          <p:cNvPr id="23" name="Text 21"/>
+          <p:cNvSpPr/>
+          <p:nvPr/>
+        </p:nvSpPr>
+        <p:spPr>
+          <a:xfrm>
+            <a:off x="777240" y="3127248"/>
+            <a:ext cx="4846320" cy="365760"/>
+          </a:xfrm>
+          <a:prstGeom prst="rect">
+            <a:avLst/>
+          </a:prstGeom>
+          <a:noFill/>
+          <a:ln/>
+        </p:spPr>
+        <p:txBody>
+          <a:bodyPr wrap="square" lIns="0" tIns="0" rIns="0" bIns="0" rtlCol="0" anchor="t"/>
+          <a:lstStyle/>
+          <a:p>
+            <a:pPr indent="0" marL="0">
+              <a:buNone/>
+            </a:pPr>
+            <a:r>
+              <a:rPr lang="en-US" sz="1900" b="1" dirty="0">
+                <a:solidFill>
+                  <a:srgbClr val="202CFC"/>
+                </a:solidFill>
+                <a:latin typeface="Arial" pitchFamily="34" charset="0"/>
+                <a:ea typeface="Arial" pitchFamily="34" charset="-122"/>
+                <a:cs typeface="Arial" pitchFamily="34" charset="-120"/>
+              </a:rPr>
+              <a:t>Integración continua</a:t>
+            </a:r>
+            <a:endParaRPr lang="en-US" sz="1900" dirty="0"/>
+          </a:p>
+        </p:txBody>
+      </p:sp>
+      <p:sp>
+        <p:nvSpPr>
+          <p:cNvPr id="24" name="Text 22"/>
+          <p:cNvSpPr/>
+          <p:nvPr/>
+        </p:nvSpPr>
+        <p:spPr>
+          <a:xfrm>
+            <a:off x="777240" y="3657600"/>
+            <a:ext cx="4846320" cy="2377440"/>
           </a:xfrm>
           <a:prstGeom prst="rect">
             <a:avLst/>
@@ -10548,86 +10641,110 @@
           <a:p>
             <a:pPr marL="342900" indent="-342900">
               <a:lnSpc>
-                <a:spcPts val="2200"/>
+                <a:spcPts val="2100"/>
               </a:lnSpc>
               <a:spcAft>
-                <a:spcPts val="1300"/>
+                <a:spcPts val="1100"/>
               </a:spcAft>
               <a:buSzPct val="100000"/>
               <a:buChar char="•"/>
             </a:pPr>
             <a:r>
-              <a:rPr lang="en-US" sz="1600" dirty="0">
-                <a:solidFill>
-                  <a:srgbClr val="1A1C2E"/>
-                </a:solidFill>
-                <a:latin typeface="Calibri" pitchFamily="34" charset="0"/>
-                <a:ea typeface="Calibri" pitchFamily="34" charset="-122"/>
-                <a:cs typeface="Calibri" pitchFamily="34" charset="-120"/>
-              </a:rPr>
-              <a:t>Se pueden construir cosas complejas mucho más rápido</a:t>
-            </a:r>
-            <a:endParaRPr lang="en-US" sz="1600" dirty="0"/>
+              <a:rPr lang="en-US" sz="1500" dirty="0">
+                <a:solidFill>
+                  <a:srgbClr val="1A1C2E"/>
+                </a:solidFill>
+                <a:latin typeface="Calibri" pitchFamily="34" charset="0"/>
+                <a:ea typeface="Calibri" pitchFamily="34" charset="-122"/>
+                <a:cs typeface="Calibri" pitchFamily="34" charset="-120"/>
+              </a:rPr>
+              <a:t>En cada push y en cada pull request</a:t>
+            </a:r>
+            <a:endParaRPr lang="en-US" sz="1500" dirty="0"/>
           </a:p>
           <a:p>
             <a:pPr marL="342900" indent="-342900">
               <a:lnSpc>
-                <a:spcPts val="2200"/>
+                <a:spcPts val="2100"/>
               </a:lnSpc>
               <a:spcAft>
-                <a:spcPts val="1300"/>
+                <a:spcPts val="1100"/>
               </a:spcAft>
               <a:buSzPct val="100000"/>
               <a:buChar char="•"/>
             </a:pPr>
             <a:r>
-              <a:rPr lang="en-US" sz="1600" dirty="0">
-                <a:solidFill>
-                  <a:srgbClr val="1A1C2E"/>
-                </a:solidFill>
-                <a:latin typeface="Calibri" pitchFamily="34" charset="0"/>
-                <a:ea typeface="Calibri" pitchFamily="34" charset="-122"/>
-                <a:cs typeface="Calibri" pitchFamily="34" charset="-120"/>
-              </a:rPr>
-              <a:t>Lo que antes eran meses o años, ahora son semanas</a:t>
-            </a:r>
-            <a:endParaRPr lang="en-US" sz="1600" dirty="0"/>
+              <a:rPr lang="en-US" sz="1500" dirty="0">
+                <a:solidFill>
+                  <a:srgbClr val="1A1C2E"/>
+                </a:solidFill>
+                <a:latin typeface="Calibri" pitchFamily="34" charset="0"/>
+                <a:ea typeface="Calibri" pitchFamily="34" charset="-122"/>
+                <a:cs typeface="Calibri" pitchFamily="34" charset="-120"/>
+              </a:rPr>
+              <a:t>Las dos aplicaciones en paralelo, sobre Node 22</a:t>
+            </a:r>
+            <a:endParaRPr lang="en-US" sz="1500" dirty="0"/>
           </a:p>
           <a:p>
             <a:pPr marL="342900" indent="-342900">
               <a:lnSpc>
-                <a:spcPts val="2200"/>
+                <a:spcPts val="2100"/>
               </a:lnSpc>
               <a:spcAft>
-                <a:spcPts val="1300"/>
+                <a:spcPts val="1100"/>
               </a:spcAft>
               <a:buSzPct val="100000"/>
               <a:buChar char="•"/>
             </a:pPr>
             <a:r>
-              <a:rPr lang="en-US" sz="1600" dirty="0">
-                <a:solidFill>
-                  <a:srgbClr val="1A1C2E"/>
-                </a:solidFill>
-                <a:latin typeface="Calibri" pitchFamily="34" charset="0"/>
-                <a:ea typeface="Calibri" pitchFamily="34" charset="-122"/>
-                <a:cs typeface="Calibri" pitchFamily="34" charset="-120"/>
-              </a:rPr>
-              <a:t>Y se aprende más por el camino: herramientas y frameworks que no habrías tocado</a:t>
-            </a:r>
-            <a:endParaRPr lang="en-US" sz="1600" dirty="0"/>
-          </a:p>
-        </p:txBody>
-      </p:sp>
-      <p:sp>
-        <p:nvSpPr>
-          <p:cNvPr id="6" name="Text 4"/>
-          <p:cNvSpPr/>
-          <p:nvPr/>
-        </p:nvSpPr>
-        <p:spPr>
-          <a:xfrm>
-            <a:off x="6537960" y="2286000"/>
+              <a:rPr lang="en-US" sz="1500" dirty="0">
+                <a:solidFill>
+                  <a:srgbClr val="1A1C2E"/>
+                </a:solidFill>
+                <a:latin typeface="Calibri" pitchFamily="34" charset="0"/>
+                <a:ea typeface="Calibri" pitchFamily="34" charset="-122"/>
+                <a:cs typeface="Calibri" pitchFamily="34" charset="-120"/>
+              </a:rPr>
+              <a:t>Lint, formato, pruebas, compilación y typecheck</a:t>
+            </a:r>
+            <a:endParaRPr lang="en-US" sz="1500" dirty="0"/>
+          </a:p>
+          <a:p>
+            <a:pPr marL="342900" indent="-342900">
+              <a:lnSpc>
+                <a:spcPts val="2100"/>
+              </a:lnSpc>
+              <a:spcAft>
+                <a:spcPts val="1100"/>
+              </a:spcAft>
+              <a:buSzPct val="100000"/>
+              <a:buChar char="•"/>
+            </a:pPr>
+            <a:r>
+              <a:rPr lang="en-US" sz="1500" dirty="0">
+                <a:solidFill>
+                  <a:srgbClr val="1A1C2E"/>
+                </a:solidFill>
+                <a:latin typeface="Calibri" pitchFamily="34" charset="0"/>
+                <a:ea typeface="Calibri" pitchFamily="34" charset="-122"/>
+                <a:cs typeface="Calibri" pitchFamily="34" charset="-120"/>
+              </a:rPr>
+              <a:t>Auditoría de dependencias, que detiene la entrega ante una vulnerabilidad crítica</a:t>
+            </a:r>
+            <a:endParaRPr lang="en-US" sz="1500" dirty="0"/>
+          </a:p>
+        </p:txBody>
+      </p:sp>
+      <p:sp>
+        <p:nvSpPr>
+          <p:cNvPr id="25" name="Text 23"/>
+          <p:cNvSpPr/>
+          <p:nvPr/>
+        </p:nvSpPr>
+        <p:spPr>
+          <a:xfrm>
+            <a:off x="6537960" y="3127248"/>
             <a:ext cx="4846320" cy="365760"/>
           </a:xfrm>
           <a:prstGeom prst="rect">
@@ -10644,7 +10761,7 @@
               <a:buNone/>
             </a:pPr>
             <a:r>
-              <a:rPr lang="en-US" sz="2000" b="1" dirty="0">
+              <a:rPr lang="en-US" sz="1900" b="1" dirty="0">
                 <a:solidFill>
                   <a:srgbClr val="202CFC"/>
                 </a:solidFill>
@@ -10652,22 +10769,22 @@
                 <a:ea typeface="Arial" pitchFamily="34" charset="-122"/>
                 <a:cs typeface="Arial" pitchFamily="34" charset="-120"/>
               </a:rPr>
-              <a:t>Lo que exige</a:t>
-            </a:r>
-            <a:endParaRPr lang="en-US" sz="2000" dirty="0"/>
-          </a:p>
-        </p:txBody>
-      </p:sp>
-      <p:sp>
-        <p:nvSpPr>
-          <p:cNvPr id="7" name="Text 5"/>
-          <p:cNvSpPr/>
-          <p:nvPr/>
-        </p:nvSpPr>
-        <p:spPr>
-          <a:xfrm>
-            <a:off x="6537960" y="2834640"/>
-            <a:ext cx="4846320" cy="2468880"/>
+              <a:t>Despliegue continuo</a:t>
+            </a:r>
+            <a:endParaRPr lang="en-US" sz="1900" dirty="0"/>
+          </a:p>
+        </p:txBody>
+      </p:sp>
+      <p:sp>
+        <p:nvSpPr>
+          <p:cNvPr id="26" name="Text 24"/>
+          <p:cNvSpPr/>
+          <p:nvPr/>
+        </p:nvSpPr>
+        <p:spPr>
+          <a:xfrm>
+            <a:off x="6537960" y="3657600"/>
+            <a:ext cx="4846320" cy="2377440"/>
           </a:xfrm>
           <a:prstGeom prst="rect">
             <a:avLst/>
@@ -10681,80 +10798,104 @@
           <a:p>
             <a:pPr marL="342900" indent="-342900">
               <a:lnSpc>
-                <a:spcPts val="2200"/>
+                <a:spcPts val="2100"/>
               </a:lnSpc>
               <a:spcAft>
-                <a:spcPts val="1300"/>
+                <a:spcPts val="1100"/>
               </a:spcAft>
               <a:buSzPct val="100000"/>
               <a:buChar char="•"/>
             </a:pPr>
             <a:r>
-              <a:rPr lang="en-US" sz="1600" dirty="0">
-                <a:solidFill>
-                  <a:srgbClr val="1A1C2E"/>
-                </a:solidFill>
-                <a:latin typeface="Calibri" pitchFamily="34" charset="0"/>
-                <a:ea typeface="Calibri" pitchFamily="34" charset="-122"/>
-                <a:cs typeface="Calibri" pitchFamily="34" charset="-120"/>
-              </a:rPr>
-              <a:t>Acelera, pero también se equivoca</a:t>
-            </a:r>
-            <a:endParaRPr lang="en-US" sz="1600" dirty="0"/>
+              <a:rPr lang="en-US" sz="1500" dirty="0">
+                <a:solidFill>
+                  <a:srgbClr val="1A1C2E"/>
+                </a:solidFill>
+                <a:latin typeface="Calibri" pitchFamily="34" charset="0"/>
+                <a:ea typeface="Calibri" pitchFamily="34" charset="-122"/>
+                <a:cs typeface="Calibri" pitchFamily="34" charset="-120"/>
+              </a:rPr>
+              <a:t>Se dispara al integrar en main</a:t>
+            </a:r>
+            <a:endParaRPr lang="en-US" sz="1500" dirty="0"/>
           </a:p>
           <a:p>
             <a:pPr marL="342900" indent="-342900">
               <a:lnSpc>
-                <a:spcPts val="2200"/>
+                <a:spcPts val="2100"/>
               </a:lnSpc>
               <a:spcAft>
-                <a:spcPts val="1300"/>
+                <a:spcPts val="1100"/>
               </a:spcAft>
               <a:buSzPct val="100000"/>
               <a:buChar char="•"/>
             </a:pPr>
             <a:r>
-              <a:rPr lang="en-US" sz="1600" dirty="0">
-                <a:solidFill>
-                  <a:srgbClr val="1A1C2E"/>
-                </a:solidFill>
-                <a:latin typeface="Calibri" pitchFamily="34" charset="0"/>
-                <a:ea typeface="Calibri" pitchFamily="34" charset="-122"/>
-                <a:cs typeface="Calibri" pitchFamily="34" charset="-120"/>
-              </a:rPr>
-              <a:t>Hay que revisar lo que se sube, no vale con fiarse</a:t>
-            </a:r>
-            <a:endParaRPr lang="en-US" sz="1600" dirty="0"/>
+              <a:rPr lang="en-US" sz="1500" dirty="0">
+                <a:solidFill>
+                  <a:srgbClr val="1A1C2E"/>
+                </a:solidFill>
+                <a:latin typeface="Calibri" pitchFamily="34" charset="0"/>
+                <a:ea typeface="Calibri" pitchFamily="34" charset="-122"/>
+                <a:cs typeface="Calibri" pitchFamily="34" charset="-120"/>
+              </a:rPr>
+              <a:t>Construye tres imágenes: API, interfaz y emulador</a:t>
+            </a:r>
+            <a:endParaRPr lang="en-US" sz="1500" dirty="0"/>
           </a:p>
           <a:p>
             <a:pPr marL="342900" indent="-342900">
               <a:lnSpc>
-                <a:spcPts val="2200"/>
+                <a:spcPts val="2100"/>
               </a:lnSpc>
               <a:spcAft>
-                <a:spcPts val="1300"/>
+                <a:spcPts val="1100"/>
               </a:spcAft>
               <a:buSzPct val="100000"/>
               <a:buChar char="•"/>
             </a:pPr>
             <a:r>
-              <a:rPr lang="en-US" sz="1600" dirty="0">
-                <a:solidFill>
-                  <a:srgbClr val="1A1C2E"/>
-                </a:solidFill>
-                <a:latin typeface="Calibri" pitchFamily="34" charset="0"/>
-                <a:ea typeface="Calibri" pitchFamily="34" charset="-122"/>
-                <a:cs typeface="Calibri" pitchFamily="34" charset="-120"/>
-              </a:rPr>
-              <a:t>No es todo tan bonito como parece: hay que dedicarle tiempo</a:t>
-            </a:r>
-            <a:endParaRPr lang="en-US" sz="1600" dirty="0"/>
-          </a:p>
-        </p:txBody>
-      </p:sp>
-      <p:sp>
-        <p:nvSpPr>
-          <p:cNvPr id="8" name="Shape 6"/>
+              <a:rPr lang="en-US" sz="1500" dirty="0">
+                <a:solidFill>
+                  <a:srgbClr val="1A1C2E"/>
+                </a:solidFill>
+                <a:latin typeface="Calibri" pitchFamily="34" charset="0"/>
+                <a:ea typeface="Calibri" pitchFamily="34" charset="-122"/>
+                <a:cs typeface="Calibri" pitchFamily="34" charset="-120"/>
+              </a:rPr>
+              <a:t>Las publica en el registro de contenedores de GitHub</a:t>
+            </a:r>
+            <a:endParaRPr lang="en-US" sz="1500" dirty="0"/>
+          </a:p>
+          <a:p>
+            <a:pPr marL="342900" indent="-342900">
+              <a:lnSpc>
+                <a:spcPts val="2100"/>
+              </a:lnSpc>
+              <a:spcAft>
+                <a:spcPts val="1100"/>
+              </a:spcAft>
+              <a:buSzPct val="100000"/>
+              <a:buChar char="•"/>
+            </a:pPr>
+            <a:r>
+              <a:rPr lang="en-US" sz="1500" dirty="0">
+                <a:solidFill>
+                  <a:srgbClr val="1A1C2E"/>
+                </a:solidFill>
+                <a:latin typeface="Calibri" pitchFamily="34" charset="0"/>
+                <a:ea typeface="Calibri" pitchFamily="34" charset="-122"/>
+                <a:cs typeface="Calibri" pitchFamily="34" charset="-120"/>
+              </a:rPr>
+              <a:t>El servidor las descarga y levanta la nueva versión, sin intervención manual</a:t>
+            </a:r>
+            <a:endParaRPr lang="en-US" sz="1500" dirty="0"/>
+          </a:p>
+        </p:txBody>
+      </p:sp>
+      <p:sp>
+        <p:nvSpPr>
+          <p:cNvPr id="27" name="Shape 25"/>
           <p:cNvSpPr/>
           <p:nvPr/>
         </p:nvSpPr>
@@ -10774,7 +10915,7 @@
       </p:sp>
       <p:sp>
         <p:nvSpPr>
-          <p:cNvPr id="9" name="Text 7"/>
+          <p:cNvPr id="28" name="Text 26"/>
           <p:cNvSpPr/>
           <p:nvPr/>
         </p:nvSpPr>
@@ -10813,7 +10954,7 @@
       </p:sp>
       <p:sp>
         <p:nvSpPr>
-          <p:cNvPr id="10" name="Text 8"/>
+          <p:cNvPr id="29" name="Text 27"/>
           <p:cNvSpPr/>
           <p:nvPr/>
         </p:nvSpPr>
@@ -10852,7 +10993,7 @@
       </p:sp>
       <p:sp>
         <p:nvSpPr>
-          <p:cNvPr id="11" name="Text 9"/>
+          <p:cNvPr id="30" name="Text 28"/>
           <p:cNvSpPr/>
           <p:nvPr/>
         </p:nvSpPr>
@@ -10923,34 +11064,358 @@
       </p:grpSpPr>
       <p:sp>
         <p:nvSpPr>
-          <p:cNvPr id="2" name="Shape 0"/>
-          <p:cNvSpPr/>
-          <p:nvPr/>
-        </p:nvSpPr>
-        <p:spPr>
-          <a:xfrm>
-            <a:off x="6720840" y="-91440"/>
-            <a:ext cx="5760720" cy="7040880"/>
-          </a:xfrm>
-          <a:prstGeom prst="rect">
-            <a:avLst/>
-          </a:prstGeom>
-          <a:solidFill>
-            <a:srgbClr val="1A1C2E"/>
-          </a:solidFill>
-          <a:ln/>
-        </p:spPr>
-      </p:sp>
-      <p:sp>
-        <p:nvSpPr>
-          <p:cNvPr id="3" name="Shape 1"/>
-          <p:cNvSpPr/>
-          <p:nvPr/>
-        </p:nvSpPr>
-        <p:spPr>
-          <a:xfrm>
-            <a:off x="777240" y="685800"/>
-            <a:ext cx="475488" cy="475488"/>
+          <p:cNvPr id="2" name="Text 0"/>
+          <p:cNvSpPr/>
+          <p:nvPr/>
+        </p:nvSpPr>
+        <p:spPr>
+          <a:xfrm>
+            <a:off x="777240" y="640080"/>
+            <a:ext cx="10607040" cy="777240"/>
+          </a:xfrm>
+          <a:prstGeom prst="rect">
+            <a:avLst/>
+          </a:prstGeom>
+          <a:noFill/>
+          <a:ln/>
+        </p:spPr>
+        <p:txBody>
+          <a:bodyPr wrap="square" lIns="0" tIns="0" rIns="0" bIns="0" rtlCol="0" anchor="t"/>
+          <a:lstStyle/>
+          <a:p>
+            <a:pPr indent="0" marL="0">
+              <a:buNone/>
+            </a:pPr>
+            <a:r>
+              <a:rPr lang="en-US" sz="3400" b="1" dirty="0">
+                <a:solidFill>
+                  <a:srgbClr val="1A1C2E"/>
+                </a:solidFill>
+                <a:latin typeface="Arial" pitchFamily="34" charset="0"/>
+                <a:ea typeface="Arial" pitchFamily="34" charset="-122"/>
+                <a:cs typeface="Arial" pitchFamily="34" charset="-120"/>
+              </a:rPr>
+              <a:t>Conclusiones</a:t>
+            </a:r>
+            <a:endParaRPr lang="en-US" sz="3400" dirty="0"/>
+          </a:p>
+        </p:txBody>
+      </p:sp>
+      <p:sp>
+        <p:nvSpPr>
+          <p:cNvPr id="3" name="Text 1"/>
+          <p:cNvSpPr/>
+          <p:nvPr/>
+        </p:nvSpPr>
+        <p:spPr>
+          <a:xfrm>
+            <a:off x="777240" y="1508760"/>
+            <a:ext cx="10607040" cy="365760"/>
+          </a:xfrm>
+          <a:prstGeom prst="rect">
+            <a:avLst/>
+          </a:prstGeom>
+          <a:noFill/>
+          <a:ln/>
+        </p:spPr>
+        <p:txBody>
+          <a:bodyPr wrap="square" lIns="0" tIns="0" rIns="0" bIns="0" rtlCol="0" anchor="t"/>
+          <a:lstStyle/>
+          <a:p>
+            <a:pPr indent="0" marL="0">
+              <a:buNone/>
+            </a:pPr>
+            <a:r>
+              <a:rPr lang="en-US" sz="1700" dirty="0">
+                <a:solidFill>
+                  <a:srgbClr val="5A5F73"/>
+                </a:solidFill>
+                <a:latin typeface="Calibri" pitchFamily="34" charset="0"/>
+                <a:ea typeface="Calibri" pitchFamily="34" charset="-122"/>
+                <a:cs typeface="Calibri" pitchFamily="34" charset="-120"/>
+              </a:rPr>
+              <a:t>Balance de haber desarrollado el proyecto con asistencia de IA.</a:t>
+            </a:r>
+            <a:endParaRPr lang="en-US" sz="1700" dirty="0"/>
+          </a:p>
+        </p:txBody>
+      </p:sp>
+      <p:sp>
+        <p:nvSpPr>
+          <p:cNvPr id="4" name="Text 2"/>
+          <p:cNvSpPr/>
+          <p:nvPr/>
+        </p:nvSpPr>
+        <p:spPr>
+          <a:xfrm>
+            <a:off x="777240" y="2286000"/>
+            <a:ext cx="4846320" cy="365760"/>
+          </a:xfrm>
+          <a:prstGeom prst="rect">
+            <a:avLst/>
+          </a:prstGeom>
+          <a:noFill/>
+          <a:ln/>
+        </p:spPr>
+        <p:txBody>
+          <a:bodyPr wrap="square" lIns="0" tIns="0" rIns="0" bIns="0" rtlCol="0" anchor="t"/>
+          <a:lstStyle/>
+          <a:p>
+            <a:pPr indent="0" marL="0">
+              <a:buNone/>
+            </a:pPr>
+            <a:r>
+              <a:rPr lang="en-US" sz="2000" b="1" dirty="0">
+                <a:solidFill>
+                  <a:srgbClr val="202CFC"/>
+                </a:solidFill>
+                <a:latin typeface="Arial" pitchFamily="34" charset="0"/>
+                <a:ea typeface="Arial" pitchFamily="34" charset="-122"/>
+                <a:cs typeface="Arial" pitchFamily="34" charset="-120"/>
+              </a:rPr>
+              <a:t>Lo que aporta</a:t>
+            </a:r>
+            <a:endParaRPr lang="en-US" sz="2000" dirty="0"/>
+          </a:p>
+        </p:txBody>
+      </p:sp>
+      <p:sp>
+        <p:nvSpPr>
+          <p:cNvPr id="5" name="Text 3"/>
+          <p:cNvSpPr/>
+          <p:nvPr/>
+        </p:nvSpPr>
+        <p:spPr>
+          <a:xfrm>
+            <a:off x="777240" y="2834640"/>
+            <a:ext cx="4846320" cy="2468880"/>
+          </a:xfrm>
+          <a:prstGeom prst="rect">
+            <a:avLst/>
+          </a:prstGeom>
+          <a:noFill/>
+          <a:ln/>
+        </p:spPr>
+        <p:txBody>
+          <a:bodyPr wrap="square" lIns="0" tIns="0" rIns="0" bIns="0" rtlCol="0" anchor="t"/>
+          <a:lstStyle/>
+          <a:p>
+            <a:pPr marL="342900" indent="-342900">
+              <a:lnSpc>
+                <a:spcPts val="2200"/>
+              </a:lnSpc>
+              <a:spcAft>
+                <a:spcPts val="1300"/>
+              </a:spcAft>
+              <a:buSzPct val="100000"/>
+              <a:buChar char="•"/>
+            </a:pPr>
+            <a:r>
+              <a:rPr lang="en-US" sz="1600" dirty="0">
+                <a:solidFill>
+                  <a:srgbClr val="1A1C2E"/>
+                </a:solidFill>
+                <a:latin typeface="Calibri" pitchFamily="34" charset="0"/>
+                <a:ea typeface="Calibri" pitchFamily="34" charset="-122"/>
+                <a:cs typeface="Calibri" pitchFamily="34" charset="-120"/>
+              </a:rPr>
+              <a:t>Se pueden construir cosas complejas mucho más rápido</a:t>
+            </a:r>
+            <a:endParaRPr lang="en-US" sz="1600" dirty="0"/>
+          </a:p>
+          <a:p>
+            <a:pPr marL="342900" indent="-342900">
+              <a:lnSpc>
+                <a:spcPts val="2200"/>
+              </a:lnSpc>
+              <a:spcAft>
+                <a:spcPts val="1300"/>
+              </a:spcAft>
+              <a:buSzPct val="100000"/>
+              <a:buChar char="•"/>
+            </a:pPr>
+            <a:r>
+              <a:rPr lang="en-US" sz="1600" dirty="0">
+                <a:solidFill>
+                  <a:srgbClr val="1A1C2E"/>
+                </a:solidFill>
+                <a:latin typeface="Calibri" pitchFamily="34" charset="0"/>
+                <a:ea typeface="Calibri" pitchFamily="34" charset="-122"/>
+                <a:cs typeface="Calibri" pitchFamily="34" charset="-120"/>
+              </a:rPr>
+              <a:t>Lo que antes eran meses o años, ahora son semanas</a:t>
+            </a:r>
+            <a:endParaRPr lang="en-US" sz="1600" dirty="0"/>
+          </a:p>
+          <a:p>
+            <a:pPr marL="342900" indent="-342900">
+              <a:lnSpc>
+                <a:spcPts val="2200"/>
+              </a:lnSpc>
+              <a:spcAft>
+                <a:spcPts val="1300"/>
+              </a:spcAft>
+              <a:buSzPct val="100000"/>
+              <a:buChar char="•"/>
+            </a:pPr>
+            <a:r>
+              <a:rPr lang="en-US" sz="1600" dirty="0">
+                <a:solidFill>
+                  <a:srgbClr val="1A1C2E"/>
+                </a:solidFill>
+                <a:latin typeface="Calibri" pitchFamily="34" charset="0"/>
+                <a:ea typeface="Calibri" pitchFamily="34" charset="-122"/>
+                <a:cs typeface="Calibri" pitchFamily="34" charset="-120"/>
+              </a:rPr>
+              <a:t>Y se aprende más por el camino: herramientas y frameworks que no habrías tocado</a:t>
+            </a:r>
+            <a:endParaRPr lang="en-US" sz="1600" dirty="0"/>
+          </a:p>
+        </p:txBody>
+      </p:sp>
+      <p:sp>
+        <p:nvSpPr>
+          <p:cNvPr id="6" name="Text 4"/>
+          <p:cNvSpPr/>
+          <p:nvPr/>
+        </p:nvSpPr>
+        <p:spPr>
+          <a:xfrm>
+            <a:off x="6537960" y="2286000"/>
+            <a:ext cx="4846320" cy="365760"/>
+          </a:xfrm>
+          <a:prstGeom prst="rect">
+            <a:avLst/>
+          </a:prstGeom>
+          <a:noFill/>
+          <a:ln/>
+        </p:spPr>
+        <p:txBody>
+          <a:bodyPr wrap="square" lIns="0" tIns="0" rIns="0" bIns="0" rtlCol="0" anchor="t"/>
+          <a:lstStyle/>
+          <a:p>
+            <a:pPr indent="0" marL="0">
+              <a:buNone/>
+            </a:pPr>
+            <a:r>
+              <a:rPr lang="en-US" sz="2000" b="1" dirty="0">
+                <a:solidFill>
+                  <a:srgbClr val="202CFC"/>
+                </a:solidFill>
+                <a:latin typeface="Arial" pitchFamily="34" charset="0"/>
+                <a:ea typeface="Arial" pitchFamily="34" charset="-122"/>
+                <a:cs typeface="Arial" pitchFamily="34" charset="-120"/>
+              </a:rPr>
+              <a:t>Lo que exige</a:t>
+            </a:r>
+            <a:endParaRPr lang="en-US" sz="2000" dirty="0"/>
+          </a:p>
+        </p:txBody>
+      </p:sp>
+      <p:sp>
+        <p:nvSpPr>
+          <p:cNvPr id="7" name="Text 5"/>
+          <p:cNvSpPr/>
+          <p:nvPr/>
+        </p:nvSpPr>
+        <p:spPr>
+          <a:xfrm>
+            <a:off x="6537960" y="2834640"/>
+            <a:ext cx="4846320" cy="2468880"/>
+          </a:xfrm>
+          <a:prstGeom prst="rect">
+            <a:avLst/>
+          </a:prstGeom>
+          <a:noFill/>
+          <a:ln/>
+        </p:spPr>
+        <p:txBody>
+          <a:bodyPr wrap="square" lIns="0" tIns="0" rIns="0" bIns="0" rtlCol="0" anchor="t"/>
+          <a:lstStyle/>
+          <a:p>
+            <a:pPr marL="342900" indent="-342900">
+              <a:lnSpc>
+                <a:spcPts val="2200"/>
+              </a:lnSpc>
+              <a:spcAft>
+                <a:spcPts val="1300"/>
+              </a:spcAft>
+              <a:buSzPct val="100000"/>
+              <a:buChar char="•"/>
+            </a:pPr>
+            <a:r>
+              <a:rPr lang="en-US" sz="1600" dirty="0">
+                <a:solidFill>
+                  <a:srgbClr val="1A1C2E"/>
+                </a:solidFill>
+                <a:latin typeface="Calibri" pitchFamily="34" charset="0"/>
+                <a:ea typeface="Calibri" pitchFamily="34" charset="-122"/>
+                <a:cs typeface="Calibri" pitchFamily="34" charset="-120"/>
+              </a:rPr>
+              <a:t>Acelera, pero también se equivoca</a:t>
+            </a:r>
+            <a:endParaRPr lang="en-US" sz="1600" dirty="0"/>
+          </a:p>
+          <a:p>
+            <a:pPr marL="342900" indent="-342900">
+              <a:lnSpc>
+                <a:spcPts val="2200"/>
+              </a:lnSpc>
+              <a:spcAft>
+                <a:spcPts val="1300"/>
+              </a:spcAft>
+              <a:buSzPct val="100000"/>
+              <a:buChar char="•"/>
+            </a:pPr>
+            <a:r>
+              <a:rPr lang="en-US" sz="1600" dirty="0">
+                <a:solidFill>
+                  <a:srgbClr val="1A1C2E"/>
+                </a:solidFill>
+                <a:latin typeface="Calibri" pitchFamily="34" charset="0"/>
+                <a:ea typeface="Calibri" pitchFamily="34" charset="-122"/>
+                <a:cs typeface="Calibri" pitchFamily="34" charset="-120"/>
+              </a:rPr>
+              <a:t>Hay que revisar lo que se sube, no vale con fiarse</a:t>
+            </a:r>
+            <a:endParaRPr lang="en-US" sz="1600" dirty="0"/>
+          </a:p>
+          <a:p>
+            <a:pPr marL="342900" indent="-342900">
+              <a:lnSpc>
+                <a:spcPts val="2200"/>
+              </a:lnSpc>
+              <a:spcAft>
+                <a:spcPts val="1300"/>
+              </a:spcAft>
+              <a:buSzPct val="100000"/>
+              <a:buChar char="•"/>
+            </a:pPr>
+            <a:r>
+              <a:rPr lang="en-US" sz="1600" dirty="0">
+                <a:solidFill>
+                  <a:srgbClr val="1A1C2E"/>
+                </a:solidFill>
+                <a:latin typeface="Calibri" pitchFamily="34" charset="0"/>
+                <a:ea typeface="Calibri" pitchFamily="34" charset="-122"/>
+                <a:cs typeface="Calibri" pitchFamily="34" charset="-120"/>
+              </a:rPr>
+              <a:t>No es todo tan bonito como parece: hay que dedicarle tiempo</a:t>
+            </a:r>
+            <a:endParaRPr lang="en-US" sz="1600" dirty="0"/>
+          </a:p>
+        </p:txBody>
+      </p:sp>
+      <p:sp>
+        <p:nvSpPr>
+          <p:cNvPr id="8" name="Shape 6"/>
+          <p:cNvSpPr/>
+          <p:nvPr/>
+        </p:nvSpPr>
+        <p:spPr>
+          <a:xfrm>
+            <a:off x="777240" y="6263640"/>
+            <a:ext cx="219456" cy="219456"/>
           </a:xfrm>
           <a:prstGeom prst="rect">
             <a:avLst/>
@@ -10963,14 +11428,14 @@
       </p:sp>
       <p:sp>
         <p:nvSpPr>
-          <p:cNvPr id="4" name="Text 2"/>
-          <p:cNvSpPr/>
-          <p:nvPr/>
-        </p:nvSpPr>
-        <p:spPr>
-          <a:xfrm>
-            <a:off x="777240" y="685800"/>
-            <a:ext cx="475488" cy="475488"/>
+          <p:cNvPr id="9" name="Text 7"/>
+          <p:cNvSpPr/>
+          <p:nvPr/>
+        </p:nvSpPr>
+        <p:spPr>
+          <a:xfrm>
+            <a:off x="777240" y="6263640"/>
+            <a:ext cx="219456" cy="219456"/>
           </a:xfrm>
           <a:prstGeom prst="rect">
             <a:avLst/>
@@ -10986,7 +11451,7 @@
               <a:buNone/>
             </a:pPr>
             <a:r>
-              <a:rPr lang="en-US" sz="1768" b="1" dirty="0">
+              <a:rPr lang="en-US" sz="816" b="1" dirty="0">
                 <a:solidFill>
                   <a:srgbClr val="FFFFFF"/>
                 </a:solidFill>
@@ -10996,20 +11461,20 @@
               </a:rPr>
               <a:t>BIG</a:t>
             </a:r>
-            <a:endParaRPr lang="en-US" sz="1768" dirty="0"/>
-          </a:p>
-        </p:txBody>
-      </p:sp>
-      <p:sp>
-        <p:nvSpPr>
-          <p:cNvPr id="5" name="Text 3"/>
-          <p:cNvSpPr/>
-          <p:nvPr/>
-        </p:nvSpPr>
-        <p:spPr>
-          <a:xfrm>
-            <a:off x="1335024" y="685800"/>
-            <a:ext cx="1426464" cy="475488"/>
+            <a:endParaRPr lang="en-US" sz="816" dirty="0"/>
+          </a:p>
+        </p:txBody>
+      </p:sp>
+      <p:sp>
+        <p:nvSpPr>
+          <p:cNvPr id="10" name="Text 8"/>
+          <p:cNvSpPr/>
+          <p:nvPr/>
+        </p:nvSpPr>
+        <p:spPr>
+          <a:xfrm>
+            <a:off x="1078992" y="6263640"/>
+            <a:ext cx="658368" cy="219456"/>
           </a:xfrm>
           <a:prstGeom prst="rect">
             <a:avLst/>
@@ -11025,7 +11490,7 @@
               <a:buNone/>
             </a:pPr>
             <a:r>
-              <a:rPr lang="en-US" sz="1768" dirty="0">
+              <a:rPr lang="en-US" sz="816" dirty="0">
                 <a:solidFill>
                   <a:srgbClr val="1A1C2E"/>
                 </a:solidFill>
@@ -11035,59 +11500,20 @@
               </a:rPr>
               <a:t>school</a:t>
             </a:r>
-            <a:endParaRPr lang="en-US" sz="1768" dirty="0"/>
-          </a:p>
-        </p:txBody>
-      </p:sp>
-      <p:sp>
-        <p:nvSpPr>
-          <p:cNvPr id="6" name="Text 4"/>
-          <p:cNvSpPr/>
-          <p:nvPr/>
-        </p:nvSpPr>
-        <p:spPr>
-          <a:xfrm>
-            <a:off x="777240" y="2651760"/>
-            <a:ext cx="5577840" cy="914400"/>
-          </a:xfrm>
-          <a:prstGeom prst="rect">
-            <a:avLst/>
-          </a:prstGeom>
-          <a:noFill/>
-          <a:ln/>
-        </p:spPr>
-        <p:txBody>
-          <a:bodyPr wrap="square" lIns="0" tIns="0" rIns="0" bIns="0" rtlCol="0" anchor="t"/>
-          <a:lstStyle/>
-          <a:p>
-            <a:pPr indent="0" marL="0">
-              <a:buNone/>
-            </a:pPr>
-            <a:r>
-              <a:rPr lang="en-US" sz="4000" b="1" dirty="0">
-                <a:solidFill>
-                  <a:srgbClr val="1A1C2E"/>
-                </a:solidFill>
-                <a:latin typeface="Arial" pitchFamily="34" charset="0"/>
-                <a:ea typeface="Arial" pitchFamily="34" charset="-122"/>
-                <a:cs typeface="Arial" pitchFamily="34" charset="-120"/>
-              </a:rPr>
-              <a:t>Gracias por la atención</a:t>
-            </a:r>
-            <a:endParaRPr lang="en-US" sz="4000" dirty="0"/>
-          </a:p>
-        </p:txBody>
-      </p:sp>
-      <p:sp>
-        <p:nvSpPr>
-          <p:cNvPr id="7" name="Text 5"/>
-          <p:cNvSpPr/>
-          <p:nvPr/>
-        </p:nvSpPr>
-        <p:spPr>
-          <a:xfrm>
-            <a:off x="777240" y="5349240"/>
-            <a:ext cx="5486400" cy="320040"/>
+            <a:endParaRPr lang="en-US" sz="816" dirty="0"/>
+          </a:p>
+        </p:txBody>
+      </p:sp>
+      <p:sp>
+        <p:nvSpPr>
+          <p:cNvPr id="11" name="Text 9"/>
+          <p:cNvSpPr/>
+          <p:nvPr/>
+        </p:nvSpPr>
+        <p:spPr>
+          <a:xfrm>
+            <a:off x="11064240" y="6263640"/>
+            <a:ext cx="320040" cy="219456"/>
           </a:xfrm>
           <a:prstGeom prst="rect">
             <a:avLst/>
@@ -11099,50 +11525,11 @@
           <a:bodyPr wrap="square" lIns="0" tIns="0" rIns="0" bIns="0" rtlCol="0" anchor="ctr"/>
           <a:lstStyle/>
           <a:p>
-            <a:pPr indent="0" marL="0">
-              <a:buNone/>
-            </a:pPr>
-            <a:r>
-              <a:rPr lang="en-US" sz="1500" b="1" dirty="0">
-                <a:solidFill>
-                  <a:srgbClr val="1A1C2E"/>
-                </a:solidFill>
-                <a:latin typeface="Arial" pitchFamily="34" charset="0"/>
-                <a:ea typeface="Arial" pitchFamily="34" charset="-122"/>
-                <a:cs typeface="Arial" pitchFamily="34" charset="-120"/>
-              </a:rPr>
-              <a:t>Jesús Ángel Novillo Lucas-Vaquero</a:t>
-            </a:r>
-            <a:endParaRPr lang="en-US" sz="1500" dirty="0"/>
-          </a:p>
-        </p:txBody>
-      </p:sp>
-      <p:sp>
-        <p:nvSpPr>
-          <p:cNvPr id="8" name="Text 6"/>
-          <p:cNvSpPr/>
-          <p:nvPr/>
-        </p:nvSpPr>
-        <p:spPr>
-          <a:xfrm>
-            <a:off x="777240" y="5687568"/>
-            <a:ext cx="5669280" cy="320040"/>
-          </a:xfrm>
-          <a:prstGeom prst="rect">
-            <a:avLst/>
-          </a:prstGeom>
-          <a:noFill/>
-          <a:ln/>
-        </p:spPr>
-        <p:txBody>
-          <a:bodyPr wrap="square" lIns="0" tIns="0" rIns="0" bIns="0" rtlCol="0" anchor="ctr"/>
-          <a:lstStyle/>
-          <a:p>
-            <a:pPr indent="0" marL="0">
-              <a:buNone/>
-            </a:pPr>
-            <a:r>
-              <a:rPr lang="en-US" sz="1200" dirty="0">
+            <a:pPr algn="r" indent="0" marL="0">
+              <a:buNone/>
+            </a:pPr>
+            <a:r>
+              <a:rPr lang="en-US" sz="1000" dirty="0">
                 <a:solidFill>
                   <a:srgbClr val="5A5F73"/>
                 </a:solidFill>
@@ -11150,82 +11537,12 @@
                 <a:ea typeface="Calibri" pitchFamily="34" charset="-122"/>
                 <a:cs typeface="Calibri" pitchFamily="34" charset="-120"/>
               </a:rPr>
-              <a:t>Máster en Desarrollo con IA  ·  BIG school</a:t>
-            </a:r>
-            <a:endParaRPr lang="en-US" sz="1200" dirty="0"/>
-          </a:p>
-        </p:txBody>
-      </p:sp>
-      <p:sp>
-        <p:nvSpPr>
-          <p:cNvPr id="9" name="Text 7"/>
-          <p:cNvSpPr/>
-          <p:nvPr/>
-        </p:nvSpPr>
-        <p:spPr>
-          <a:xfrm>
-            <a:off x="7114032" y="2148840"/>
-            <a:ext cx="4663440" cy="274320"/>
-          </a:xfrm>
-          <a:prstGeom prst="rect">
-            <a:avLst/>
-          </a:prstGeom>
-          <a:noFill/>
-          <a:ln/>
-        </p:spPr>
-        <p:txBody>
-          <a:bodyPr wrap="square" lIns="0" tIns="0" rIns="0" bIns="0" rtlCol="0" anchor="ctr"/>
-          <a:lstStyle/>
-          <a:p>
-            <a:pPr indent="0" marL="0">
-              <a:buNone/>
-            </a:pPr>
-            <a:r>
-              <a:rPr lang="en-US" sz="1000" b="1" spc="200" kern="0" dirty="0">
-                <a:solidFill>
-                  <a:srgbClr val="FFFFFF"/>
-                </a:solidFill>
-                <a:latin typeface="Calibri" pitchFamily="34" charset="0"/>
-                <a:ea typeface="Calibri" pitchFamily="34" charset="-122"/>
-                <a:cs typeface="Calibri" pitchFamily="34" charset="-120"/>
-              </a:rPr>
-              <a:t>EL INFORME DE LA SESIÓN</a:t>
+              <a:t>19</a:t>
             </a:r>
             <a:endParaRPr lang="en-US" sz="1000" dirty="0"/>
           </a:p>
         </p:txBody>
       </p:sp>
-      <p:pic>
-        <p:nvPicPr>
-          <p:cNvPr id="10" name="Image 0" descr="/home/user/intelligent-automotive-diagnostics/docs/presentacion/capturas/demo/08-informe.png">    </p:cNvPr>
-          <p:cNvPicPr>
-            <a:picLocks noChangeAspect="1"/>
-          </p:cNvPicPr>
-          <p:nvPr/>
-        </p:nvPicPr>
-        <p:blipFill>
-          <a:blip r:embed="rId1"/>
-          <a:stretch>
-            <a:fillRect/>
-          </a:stretch>
-        </p:blipFill>
-        <p:spPr>
-          <a:xfrm>
-            <a:off x="7114032" y="2697480"/>
-            <a:ext cx="4654296" cy="1746504"/>
-          </a:xfrm>
-          <a:prstGeom prst="rect">
-            <a:avLst/>
-          </a:prstGeom>
-          <a:effectLst>
-            <a:outerShdw sx="100000" sy="100000" kx="0" ky="0" algn="bl" rotWithShape="0" blurRad="254000" dist="63500" dir="8100000">
-              <a:srgbClr val="000000">
-                <a:alpha val="50000"/>
-              </a:srgbClr>
-            </a:outerShdw>
-          </a:effectLst>
-        </p:spPr>
-      </p:pic>
     </p:spTree>
   </p:cSld>
   <p:clrMapOvr>
@@ -11945,6 +12262,343 @@
           </a:p>
         </p:txBody>
       </p:sp>
+    </p:spTree>
+  </p:cSld>
+  <p:clrMapOvr>
+    <a:masterClrMapping/>
+  </p:clrMapOvr>
+</p:sld>
+</file>
+
+<file path=ppt/slides/slide20.xml><?xml version="1.0" encoding="utf-8"?>
+<p:sld xmlns:a="http://schemas.openxmlformats.org/drawingml/2006/main" xmlns:r="http://schemas.openxmlformats.org/officeDocument/2006/relationships" xmlns:p="http://schemas.openxmlformats.org/presentationml/2006/main">
+  <p:cSld name="Slide 20">
+    <p:bg>
+      <p:bgPr>
+        <a:solidFill>
+          <a:srgbClr val="FFFFFF"/>
+        </a:solidFill>
+      </p:bgPr>
+    </p:bg>
+    <p:spTree>
+      <p:nvGrpSpPr>
+        <p:cNvPr id="1" name=""/>
+        <p:cNvGrpSpPr/>
+        <p:nvPr/>
+      </p:nvGrpSpPr>
+      <p:grpSpPr>
+        <a:xfrm>
+          <a:off x="0" y="0"/>
+          <a:ext cx="0" cy="0"/>
+          <a:chOff x="0" y="0"/>
+          <a:chExt cx="0" cy="0"/>
+        </a:xfrm>
+      </p:grpSpPr>
+      <p:sp>
+        <p:nvSpPr>
+          <p:cNvPr id="2" name="Shape 0"/>
+          <p:cNvSpPr/>
+          <p:nvPr/>
+        </p:nvSpPr>
+        <p:spPr>
+          <a:xfrm>
+            <a:off x="6720840" y="-91440"/>
+            <a:ext cx="5760720" cy="7040880"/>
+          </a:xfrm>
+          <a:prstGeom prst="rect">
+            <a:avLst/>
+          </a:prstGeom>
+          <a:solidFill>
+            <a:srgbClr val="1A1C2E"/>
+          </a:solidFill>
+          <a:ln/>
+        </p:spPr>
+      </p:sp>
+      <p:sp>
+        <p:nvSpPr>
+          <p:cNvPr id="3" name="Shape 1"/>
+          <p:cNvSpPr/>
+          <p:nvPr/>
+        </p:nvSpPr>
+        <p:spPr>
+          <a:xfrm>
+            <a:off x="777240" y="685800"/>
+            <a:ext cx="475488" cy="475488"/>
+          </a:xfrm>
+          <a:prstGeom prst="rect">
+            <a:avLst/>
+          </a:prstGeom>
+          <a:solidFill>
+            <a:srgbClr val="202CFC"/>
+          </a:solidFill>
+          <a:ln/>
+        </p:spPr>
+      </p:sp>
+      <p:sp>
+        <p:nvSpPr>
+          <p:cNvPr id="4" name="Text 2"/>
+          <p:cNvSpPr/>
+          <p:nvPr/>
+        </p:nvSpPr>
+        <p:spPr>
+          <a:xfrm>
+            <a:off x="777240" y="685800"/>
+            <a:ext cx="475488" cy="475488"/>
+          </a:xfrm>
+          <a:prstGeom prst="rect">
+            <a:avLst/>
+          </a:prstGeom>
+          <a:noFill/>
+          <a:ln/>
+        </p:spPr>
+        <p:txBody>
+          <a:bodyPr wrap="square" lIns="0" tIns="0" rIns="0" bIns="0" rtlCol="0" anchor="ctr"/>
+          <a:lstStyle/>
+          <a:p>
+            <a:pPr algn="ctr" indent="0" marL="0">
+              <a:buNone/>
+            </a:pPr>
+            <a:r>
+              <a:rPr lang="en-US" sz="1768" b="1" dirty="0">
+                <a:solidFill>
+                  <a:srgbClr val="FFFFFF"/>
+                </a:solidFill>
+                <a:latin typeface="Arial" pitchFamily="34" charset="0"/>
+                <a:ea typeface="Arial" pitchFamily="34" charset="-122"/>
+                <a:cs typeface="Arial" pitchFamily="34" charset="-120"/>
+              </a:rPr>
+              <a:t>BIG</a:t>
+            </a:r>
+            <a:endParaRPr lang="en-US" sz="1768" dirty="0"/>
+          </a:p>
+        </p:txBody>
+      </p:sp>
+      <p:sp>
+        <p:nvSpPr>
+          <p:cNvPr id="5" name="Text 3"/>
+          <p:cNvSpPr/>
+          <p:nvPr/>
+        </p:nvSpPr>
+        <p:spPr>
+          <a:xfrm>
+            <a:off x="1335024" y="685800"/>
+            <a:ext cx="1426464" cy="475488"/>
+          </a:xfrm>
+          <a:prstGeom prst="rect">
+            <a:avLst/>
+          </a:prstGeom>
+          <a:noFill/>
+          <a:ln/>
+        </p:spPr>
+        <p:txBody>
+          <a:bodyPr wrap="square" lIns="0" tIns="0" rIns="0" bIns="0" rtlCol="0" anchor="ctr"/>
+          <a:lstStyle/>
+          <a:p>
+            <a:pPr algn="l" indent="0" marL="0">
+              <a:buNone/>
+            </a:pPr>
+            <a:r>
+              <a:rPr lang="en-US" sz="1768" dirty="0">
+                <a:solidFill>
+                  <a:srgbClr val="1A1C2E"/>
+                </a:solidFill>
+                <a:latin typeface="Arial" pitchFamily="34" charset="0"/>
+                <a:ea typeface="Arial" pitchFamily="34" charset="-122"/>
+                <a:cs typeface="Arial" pitchFamily="34" charset="-120"/>
+              </a:rPr>
+              <a:t>school</a:t>
+            </a:r>
+            <a:endParaRPr lang="en-US" sz="1768" dirty="0"/>
+          </a:p>
+        </p:txBody>
+      </p:sp>
+      <p:sp>
+        <p:nvSpPr>
+          <p:cNvPr id="6" name="Text 4"/>
+          <p:cNvSpPr/>
+          <p:nvPr/>
+        </p:nvSpPr>
+        <p:spPr>
+          <a:xfrm>
+            <a:off x="777240" y="2651760"/>
+            <a:ext cx="5577840" cy="914400"/>
+          </a:xfrm>
+          <a:prstGeom prst="rect">
+            <a:avLst/>
+          </a:prstGeom>
+          <a:noFill/>
+          <a:ln/>
+        </p:spPr>
+        <p:txBody>
+          <a:bodyPr wrap="square" lIns="0" tIns="0" rIns="0" bIns="0" rtlCol="0" anchor="t"/>
+          <a:lstStyle/>
+          <a:p>
+            <a:pPr indent="0" marL="0">
+              <a:buNone/>
+            </a:pPr>
+            <a:r>
+              <a:rPr lang="en-US" sz="4000" b="1" dirty="0">
+                <a:solidFill>
+                  <a:srgbClr val="1A1C2E"/>
+                </a:solidFill>
+                <a:latin typeface="Arial" pitchFamily="34" charset="0"/>
+                <a:ea typeface="Arial" pitchFamily="34" charset="-122"/>
+                <a:cs typeface="Arial" pitchFamily="34" charset="-120"/>
+              </a:rPr>
+              <a:t>Gracias por la atención</a:t>
+            </a:r>
+            <a:endParaRPr lang="en-US" sz="4000" dirty="0"/>
+          </a:p>
+        </p:txBody>
+      </p:sp>
+      <p:sp>
+        <p:nvSpPr>
+          <p:cNvPr id="7" name="Text 5"/>
+          <p:cNvSpPr/>
+          <p:nvPr/>
+        </p:nvSpPr>
+        <p:spPr>
+          <a:xfrm>
+            <a:off x="777240" y="5349240"/>
+            <a:ext cx="5486400" cy="320040"/>
+          </a:xfrm>
+          <a:prstGeom prst="rect">
+            <a:avLst/>
+          </a:prstGeom>
+          <a:noFill/>
+          <a:ln/>
+        </p:spPr>
+        <p:txBody>
+          <a:bodyPr wrap="square" lIns="0" tIns="0" rIns="0" bIns="0" rtlCol="0" anchor="ctr"/>
+          <a:lstStyle/>
+          <a:p>
+            <a:pPr indent="0" marL="0">
+              <a:buNone/>
+            </a:pPr>
+            <a:r>
+              <a:rPr lang="en-US" sz="1500" b="1" dirty="0">
+                <a:solidFill>
+                  <a:srgbClr val="1A1C2E"/>
+                </a:solidFill>
+                <a:latin typeface="Arial" pitchFamily="34" charset="0"/>
+                <a:ea typeface="Arial" pitchFamily="34" charset="-122"/>
+                <a:cs typeface="Arial" pitchFamily="34" charset="-120"/>
+              </a:rPr>
+              <a:t>Jesús Ángel Novillo Lucas-Vaquero</a:t>
+            </a:r>
+            <a:endParaRPr lang="en-US" sz="1500" dirty="0"/>
+          </a:p>
+        </p:txBody>
+      </p:sp>
+      <p:sp>
+        <p:nvSpPr>
+          <p:cNvPr id="8" name="Text 6"/>
+          <p:cNvSpPr/>
+          <p:nvPr/>
+        </p:nvSpPr>
+        <p:spPr>
+          <a:xfrm>
+            <a:off x="777240" y="5687568"/>
+            <a:ext cx="5669280" cy="320040"/>
+          </a:xfrm>
+          <a:prstGeom prst="rect">
+            <a:avLst/>
+          </a:prstGeom>
+          <a:noFill/>
+          <a:ln/>
+        </p:spPr>
+        <p:txBody>
+          <a:bodyPr wrap="square" lIns="0" tIns="0" rIns="0" bIns="0" rtlCol="0" anchor="ctr"/>
+          <a:lstStyle/>
+          <a:p>
+            <a:pPr indent="0" marL="0">
+              <a:buNone/>
+            </a:pPr>
+            <a:r>
+              <a:rPr lang="en-US" sz="1200" dirty="0">
+                <a:solidFill>
+                  <a:srgbClr val="5A5F73"/>
+                </a:solidFill>
+                <a:latin typeface="Calibri" pitchFamily="34" charset="0"/>
+                <a:ea typeface="Calibri" pitchFamily="34" charset="-122"/>
+                <a:cs typeface="Calibri" pitchFamily="34" charset="-120"/>
+              </a:rPr>
+              <a:t>Máster en Desarrollo con IA  ·  BIG school</a:t>
+            </a:r>
+            <a:endParaRPr lang="en-US" sz="1200" dirty="0"/>
+          </a:p>
+        </p:txBody>
+      </p:sp>
+      <p:sp>
+        <p:nvSpPr>
+          <p:cNvPr id="9" name="Text 7"/>
+          <p:cNvSpPr/>
+          <p:nvPr/>
+        </p:nvSpPr>
+        <p:spPr>
+          <a:xfrm>
+            <a:off x="7114032" y="2148840"/>
+            <a:ext cx="4663440" cy="274320"/>
+          </a:xfrm>
+          <a:prstGeom prst="rect">
+            <a:avLst/>
+          </a:prstGeom>
+          <a:noFill/>
+          <a:ln/>
+        </p:spPr>
+        <p:txBody>
+          <a:bodyPr wrap="square" lIns="0" tIns="0" rIns="0" bIns="0" rtlCol="0" anchor="ctr"/>
+          <a:lstStyle/>
+          <a:p>
+            <a:pPr indent="0" marL="0">
+              <a:buNone/>
+            </a:pPr>
+            <a:r>
+              <a:rPr lang="en-US" sz="1000" b="1" spc="200" kern="0" dirty="0">
+                <a:solidFill>
+                  <a:srgbClr val="FFFFFF"/>
+                </a:solidFill>
+                <a:latin typeface="Calibri" pitchFamily="34" charset="0"/>
+                <a:ea typeface="Calibri" pitchFamily="34" charset="-122"/>
+                <a:cs typeface="Calibri" pitchFamily="34" charset="-120"/>
+              </a:rPr>
+              <a:t>EL INFORME DE LA SESIÓN</a:t>
+            </a:r>
+            <a:endParaRPr lang="en-US" sz="1000" dirty="0"/>
+          </a:p>
+        </p:txBody>
+      </p:sp>
+      <p:pic>
+        <p:nvPicPr>
+          <p:cNvPr id="10" name="Image 0" descr="/home/user/intelligent-automotive-diagnostics/docs/presentacion/capturas/demo/08-informe.png">    </p:cNvPr>
+          <p:cNvPicPr>
+            <a:picLocks noChangeAspect="1"/>
+          </p:cNvPicPr>
+          <p:nvPr/>
+        </p:nvPicPr>
+        <p:blipFill>
+          <a:blip r:embed="rId1"/>
+          <a:stretch>
+            <a:fillRect/>
+          </a:stretch>
+        </p:blipFill>
+        <p:spPr>
+          <a:xfrm>
+            <a:off x="7114032" y="2697480"/>
+            <a:ext cx="4654296" cy="1746504"/>
+          </a:xfrm>
+          <a:prstGeom prst="rect">
+            <a:avLst/>
+          </a:prstGeom>
+          <a:effectLst>
+            <a:outerShdw sx="100000" sy="100000" kx="0" ky="0" algn="bl" rotWithShape="0" blurRad="254000" dist="63500" dir="8100000">
+              <a:srgbClr val="000000">
+                <a:alpha val="50000"/>
+              </a:srgbClr>
+            </a:outerShdw>
+          </a:effectLst>
+        </p:spPr>
+      </p:pic>
     </p:spTree>
   </p:cSld>
   <p:clrMapOvr>

</xml_diff>

<commit_message>
docs(tfm): quitar de la slide de calidad lo que repetian CI/CD y OWASP
</commit_message>
<xml_diff>
--- a/docs/presentacion/tfm-intelligent-automotive-diagnostics.pptx
+++ b/docs/presentacion/tfm-intelligent-automotive-diagnostics.pptx
@@ -1078,12 +1078,11 @@
           <a:p>
             <a:r>
               <a:rPr lang="en-US" dirty="0"/>
-              <a:t>Este proyecto lo he hecho yo solo, así que lo que avisa de las roturas no es un compañero: es el CI.
+              <a:t>Este proyecto lo he hecho yo solo, así que lo que avisa de las roturas no es un compañero: son las comprobaciones automáticas.
 El código se escribe con TDD, primero el test que falla y luego el código mínimo que lo pasa. Ahora mismo hay 2.171 pruebas en verde repartidas en 209 ficheros, entre el backend y el frontend.
-Y la cobertura no se mide de media, que es la trampa habitual: está configurada por fichero. Un fichero sin tests no puede esconderse detrás de otro que esté muy cubierto.
-Cada cambio va documentado con OpenSpec antes de escribirse: hay 45 cambios especificados y archivados, con su diseño, sus specs y sus tareas.
-En cada push, el CI corre lint, formato, los tests, el build y el typecheck, para las dos aplicaciones en paralelo sobre Node 22. Y pasa una auditoría de dependencias que tumba la build si aparece una vulnerabilidad crítica.
-En seguridad, el documento cubre las diez categorías del OWASP API Top 10 de 2023, una a una, con lo que hace el código en cada caso. Incluidos los riesgos residuales, que están escritos y asumidos, no escondidos.
+Y cada cambio se especifica antes de escribirse, con OpenSpec: hay 45 cambios documentados y archivados, con su diseño, sus specs y sus tareas. Eso es lo que hace que un proyecto de una sola persona no dependa de lo que yo recuerde.
+De la cobertura quiero destacar una cosa, porque es donde se hace la trampa habitual. No se mide de media: se exige fichero a fichero. Con la media, un fichero sin tests se esconde detrás de otro que esté muy cubierto y el número global sigue saliendo bonito. Aquí cada fichero tiene que llegar por su cuenta al 80% de líneas y al 90% de funciones.
+Y la infraestructura está excluida a propósito: el cableado de dependencias, los adaptadores que solo delegan y los controladores no se cubren con tests de cobertura, los valida el compilador. Esa lista de exclusiones está escrita en la configuración, no es un olvido.
 [~60 s · acumulado 16:45]</a:t>
             </a:r>
             <a:endParaRPr lang="en-US" dirty="0"/>
@@ -7279,7 +7278,7 @@
                 <a:ea typeface="Arial" pitchFamily="34" charset="-122"/>
                 <a:cs typeface="Arial" pitchFamily="34" charset="-120"/>
               </a:rPr>
-              <a:t>Calidad del código y seguridad</a:t>
+              <a:t>Calidad del código</a:t>
             </a:r>
             <a:endParaRPr lang="en-US" sz="3400" dirty="0"/>
           </a:p>
@@ -7451,7 +7450,7 @@
                 <a:ea typeface="Calibri" pitchFamily="34" charset="-122"/>
                 <a:cs typeface="Calibri" pitchFamily="34" charset="-120"/>
               </a:rPr>
-              <a:t>La cobertura se exige fichero a fichero, no de media</a:t>
+              <a:t>Cada cambio se especifica antes de escribirse</a:t>
             </a:r>
             <a:endParaRPr lang="en-US" sz="1500" dirty="0"/>
           </a:p>
@@ -7475,7 +7474,7 @@
                 <a:ea typeface="Calibri" pitchFamily="34" charset="-122"/>
                 <a:cs typeface="Calibri" pitchFamily="34" charset="-120"/>
               </a:rPr>
-              <a:t>45 cambios especificados y archivados con OpenSpec</a:t>
+              <a:t>45 cambios documentados y archivados con OpenSpec</a:t>
             </a:r>
             <a:endParaRPr lang="en-US" sz="1500" dirty="0"/>
           </a:p>
@@ -7514,7 +7513,7 @@
                 <a:ea typeface="Arial" pitchFamily="34" charset="-122"/>
                 <a:cs typeface="Arial" pitchFamily="34" charset="-120"/>
               </a:rPr>
-              <a:t>Verificaciones en cada push</a:t>
+              <a:t>Cobertura</a:t>
             </a:r>
             <a:endParaRPr lang="en-US" sz="1900" dirty="0"/>
           </a:p>
@@ -7560,7 +7559,7 @@
                 <a:ea typeface="Calibri" pitchFamily="34" charset="-122"/>
                 <a:cs typeface="Calibri" pitchFamily="34" charset="-120"/>
               </a:rPr>
-              <a:t>Lint, formato, tests, build y typecheck</a:t>
+              <a:t>Se exige fichero a fichero, no de media</a:t>
             </a:r>
             <a:endParaRPr lang="en-US" sz="1500" dirty="0"/>
           </a:p>
@@ -7584,7 +7583,7 @@
                 <a:ea typeface="Calibri" pitchFamily="34" charset="-122"/>
                 <a:cs typeface="Calibri" pitchFamily="34" charset="-120"/>
               </a:rPr>
-              <a:t>Las dos apps en paralelo, sobre Node 22</a:t>
+              <a:t>Ningún fichero se esconde detrás de otro muy cubierto</a:t>
             </a:r>
             <a:endParaRPr lang="en-US" sz="1500" dirty="0"/>
           </a:p>
@@ -7608,7 +7607,7 @@
                 <a:ea typeface="Calibri" pitchFamily="34" charset="-122"/>
                 <a:cs typeface="Calibri" pitchFamily="34" charset="-120"/>
               </a:rPr>
-              <a:t>Auditoría de dependencias que rompe si hay algo crítico</a:t>
+              <a:t>Mínimos por fichero: 80% de líneas y 90% de funciones</a:t>
             </a:r>
             <a:endParaRPr lang="en-US" sz="1500" dirty="0"/>
           </a:p>
@@ -7632,7 +7631,7 @@
                 <a:ea typeface="Calibri" pitchFamily="34" charset="-122"/>
                 <a:cs typeface="Calibri" pitchFamily="34" charset="-120"/>
               </a:rPr>
-              <a:t>OWASP API Top 10 2023: las diez categorías, documentadas</a:t>
+              <a:t>La infraestructura se excluye a propósito, con la lista escrita</a:t>
             </a:r>
             <a:endParaRPr lang="en-US" sz="1500" dirty="0"/>
           </a:p>

</xml_diff>

<commit_message>
docs(tfm): resincronizar el deck con los 19 commits nuevos de develop
</commit_message>
<xml_diff>
--- a/docs/presentacion/tfm-intelligent-automotive-diagnostics.pptx
+++ b/docs/presentacion/tfm-intelligent-automotive-diagnostics.pptx
@@ -1079,7 +1079,7 @@
             <a:r>
               <a:rPr lang="en-US" dirty="0"/>
               <a:t>Este proyecto lo he hecho yo solo, así que lo que avisa de las roturas no es un compañero: son las comprobaciones automáticas.
-El código se escribe con TDD, primero el test que falla y luego el código mínimo que lo pasa. Ahora mismo hay 2.171 pruebas en verde repartidas en 209 ficheros, entre el backend y el frontend.
+El código se escribe con TDD, primero el test que falla y luego el código mínimo que lo pasa. Ahora mismo hay 2.403 pruebas en verde repartidas en 219 ficheros, entre el backend y el frontend.
 Y cada cambio se especifica antes de escribirse, con OpenSpec: hay 45 cambios documentados y archivados, con su diseño, sus specs y sus tareas. Eso es lo que hace que un proyecto de una sola persona no dependa de lo que yo recuerde.
 De la cobertura quiero destacar una cosa, porque es donde se hace la trampa habitual. No se mide de media: se exige fichero a fichero. Con la media, un fichero sin tests se esconde detrás de otro que esté muy cubierto y el número global sigue saliendo bonito. Aquí cada fichero tiene que llegar por su cuenta al 80% de líneas y al 90% de funciones.
 Y la infraestructura está excluida a propósito: el cableado de dependencias, los adaptadores que solo delegan y los controladores no se cubren con tests de cobertura, los valida el compilador. Esa lista de exclusiones está escrita en la configuración, no es un olvido.
@@ -1267,9 +1267,10 @@
             <a:r>
               <a:rPr lang="en-US" dirty="0"/>
               <a:t>La lista anterior es la de APIs y cubre el backend. La interfaz es otra cosa: es una aplicación web, y ahí lo que aplica es el Top 10 clásico.
-React escapa el HTML por defecto, y no se inyecta marcado en crudo en ningún sitio con datos que vengan del usuario, que es por donde entra el XSS. La interfaz sirve su propia cabecera de Content Security Policy, con default-src propio y sin scripts de terceros. Los formularios validan con los mismos esquemas Zod que usa la API, así que la validación de cliente y la de servidor no se pueden desincronizar.
+React escapa el HTML por defecto, y no se inyecta marcado en crudo en ningún sitio con datos que vengan del usuario, que es por donde entra el XSS. La política de seguridad de contenido la sirve el nginx que sirve la interfaz, con script-src propio y sin scripts en línea, y hay una comprobación en la integración continua que arranca nginx y verifica que las cabeceras salen. Los formularios validan con los mismos esquemas Zod que usa la API.
 Y una decisión consciente: el token viaja en cabecera Bearer y no en cookie. Eso elimina el CSRF de raíz, pero obliga a guardarlo en el navegador.
-Ahí está el primero de los riesgos que asumo: si hubiera un XSS, el token es robable. Lo compenso con lo de antes, que es no dar superficie de XSS. Los otros tres son de alcance: no hay doble factor, la base de datos no está cifrada en disco y los límites de peticiones viven en memoria, así que un reinicio los resetea. Para una instancia única de un TFM es asumible, y está escrito en el modelo de seguridad, no escondido.
+A la derecha está lo que sigue abierto, y quiero ser claro con esto porque esta semana se ha movido. El segundo factor ya no falta: hay TOTP con alta por código QR, diez códigos de recuperación de un solo uso guardados hasheados, y es obligatorio para administradores. Los contadores del límite de peticiones tampoco se pierden ya al reiniciar: viven en la base de datos.
+Lo que queda abierto son tres cosas. El token en el navegador, con el trabajo ya definido para pasarlo a cookie httpOnly. El cifrado en reposo, que es una decisión sin tomar entre cifrar el disco del servidor o usar SQLCipher; entre tanto, el secreto del segundo factor, que es el dato que de verdad sería una llave, va cifrado columna a columna con AES-256-GCM y la clave no vive en la base. Y que el segundo factor sea opcional para el usuario corriente, que es decisión de producto.
 [~50 s · acumulado 18:35]</a:t>
             </a:r>
             <a:endParaRPr lang="en-US" dirty="0"/>
@@ -7426,7 +7427,7 @@
                 <a:ea typeface="Calibri" pitchFamily="34" charset="-122"/>
                 <a:cs typeface="Calibri" pitchFamily="34" charset="-120"/>
               </a:rPr>
-              <a:t>2.171 pruebas en verde, en 209 ficheros</a:t>
+              <a:t>2.403 pruebas en verde, en 219 ficheros</a:t>
             </a:r>
             <a:endParaRPr lang="en-US" sz="1500" dirty="0"/>
           </a:p>
@@ -8112,7 +8113,7 @@
                 <a:ea typeface="Calibri" pitchFamily="34" charset="-122"/>
                 <a:cs typeface="Calibri" pitchFamily="34" charset="-120"/>
               </a:rPr>
-              <a:t>bcrypt 12 rondas, rotación de refresh y bloqueo a los 5 fallos</a:t>
+              <a:t>bcrypt 12 rondas, segundo factor TOTP y bloqueo de cuenta a los 5 fallos</a:t>
             </a:r>
             <a:endParaRPr lang="en-US" sz="1200" dirty="0"/>
           </a:p>
@@ -8346,7 +8347,7 @@
                 <a:ea typeface="Calibri" pitchFamily="34" charset="-122"/>
                 <a:cs typeface="Calibri" pitchFamily="34" charset="-120"/>
               </a:rPr>
-              <a:t>login 5/min, diagnóstico 20/min, cognitivo 5/min</a:t>
+              <a:t>login 5/min, diagnóstico 20/min; contadores persistidos en base de datos</a:t>
             </a:r>
             <a:endParaRPr lang="en-US" sz="1200" dirty="0"/>
           </a:p>
@@ -8463,7 +8464,7 @@
                 <a:ea typeface="Calibri" pitchFamily="34" charset="-122"/>
                 <a:cs typeface="Calibri" pitchFamily="34" charset="-120"/>
               </a:rPr>
-              <a:t>Todo /api autenticado; administración tras requireAdmin</a:t>
+              <a:t>Todo /api autenticado; el panel de administración exige segundo factor</a:t>
             </a:r>
             <a:endParaRPr lang="en-US" sz="1200" dirty="0"/>
           </a:p>
@@ -8814,7 +8815,7 @@
                 <a:ea typeface="Calibri" pitchFamily="34" charset="-122"/>
                 <a:cs typeface="Calibri" pitchFamily="34" charset="-120"/>
               </a:rPr>
-              <a:t>Helmet 8: CSP, HSTS de un año y allowlist de CORS</a:t>
+              <a:t>Helmet 8 en la API, CSP propia en la interfaz, puertos solo en loopback</a:t>
             </a:r>
             <a:endParaRPr lang="en-US" sz="1200" dirty="0"/>
           </a:p>
@@ -9256,7 +9257,7 @@
                 <a:ea typeface="Arial" pitchFamily="34" charset="-122"/>
                 <a:cs typeface="Arial" pitchFamily="34" charset="-120"/>
               </a:rPr>
-              <a:t>La interfaz y los riesgos asumidos</a:t>
+              <a:t>La interfaz y los riesgos abiertos</a:t>
             </a:r>
             <a:endParaRPr lang="en-US" sz="3400" dirty="0"/>
           </a:p>
@@ -9404,7 +9405,7 @@
                 <a:ea typeface="Calibri" pitchFamily="34" charset="-122"/>
                 <a:cs typeface="Calibri" pitchFamily="34" charset="-120"/>
               </a:rPr>
-              <a:t>Cabecera CSP propia: default-src 'self', sin scripts de terceros</a:t>
+              <a:t>La CSP la sirve nginx, con script-src 'self' y sin scripts en línea</a:t>
             </a:r>
             <a:endParaRPr lang="en-US" sz="1500" dirty="0"/>
           </a:p>
@@ -9491,7 +9492,7 @@
                 <a:ea typeface="Arial" pitchFamily="34" charset="-122"/>
                 <a:cs typeface="Arial" pitchFamily="34" charset="-120"/>
               </a:rPr>
-              <a:t>Riesgos asumidos, no escondidos</a:t>
+              <a:t>Lo que queda abierto</a:t>
             </a:r>
             <a:endParaRPr lang="en-US" sz="1900" dirty="0"/>
           </a:p>
@@ -9561,7 +9562,7 @@
                 <a:ea typeface="Calibri" pitchFamily="34" charset="-122"/>
                 <a:cs typeface="Calibri" pitchFamily="34" charset="-120"/>
               </a:rPr>
-              <a:t>No hay doble factor de autenticación</a:t>
+              <a:t>Pasarlo a cookie httpOnly está pendiente, y arrastra proteger CSRF</a:t>
             </a:r>
             <a:endParaRPr lang="en-US" sz="1500" dirty="0"/>
           </a:p>
@@ -9585,7 +9586,7 @@
                 <a:ea typeface="Calibri" pitchFamily="34" charset="-122"/>
                 <a:cs typeface="Calibri" pitchFamily="34" charset="-120"/>
               </a:rPr>
-              <a:t>La base de datos no está cifrada en disco</a:t>
+              <a:t>La base no está cifrada en reposo; el secreto TOTP sí, con AES-256-GCM</a:t>
             </a:r>
             <a:endParaRPr lang="en-US" sz="1500" dirty="0"/>
           </a:p>
@@ -9609,7 +9610,7 @@
                 <a:ea typeface="Calibri" pitchFamily="34" charset="-122"/>
                 <a:cs typeface="Calibri" pitchFamily="34" charset="-120"/>
               </a:rPr>
-              <a:t>Los límites de peticiones viven en memoria y se pierden al reiniciar</a:t>
+              <a:t>El segundo factor es opcional, salvo para administradores</a:t>
             </a:r>
             <a:endParaRPr lang="en-US" sz="1500" dirty="0"/>
           </a:p>
@@ -9856,7 +9857,7 @@
                 <a:ea typeface="Calibri" pitchFamily="34" charset="-122"/>
                 <a:cs typeface="Calibri" pitchFamily="34" charset="-120"/>
               </a:rPr>
-              <a:t>Todo automatizado en GitHub Actions: integrar en main publica la nueva versión en producción.</a:t>
+              <a:t>Integrar en main publica en producción, pero solo si la verificación ha pasado antes.</a:t>
             </a:r>
             <a:endParaRPr lang="en-US" sz="1500" dirty="0"/>
           </a:p>
@@ -10096,7 +10097,7 @@
                 <a:ea typeface="Calibri" pitchFamily="34" charset="-122"/>
                 <a:cs typeface="Calibri" pitchFamily="34" charset="-120"/>
               </a:rPr>
-              <a:t>lint, tests,</a:t>
+              <a:t>lint, tests, e2e</a:t>
             </a:r>
             <a:endParaRPr lang="en-US" sz="950" dirty="0"/>
           </a:p>
@@ -10116,7 +10117,7 @@
                 <a:ea typeface="Calibri" pitchFamily="34" charset="-122"/>
                 <a:cs typeface="Calibri" pitchFamily="34" charset="-120"/>
               </a:rPr>
-              <a:t>build y typecheck</a:t>
+              <a:t>y cabeceras</a:t>
             </a:r>
             <a:endParaRPr lang="en-US" sz="950" dirty="0"/>
           </a:p>
@@ -10552,7 +10553,7 @@
                 <a:ea typeface="Calibri" pitchFamily="34" charset="-122"/>
                 <a:cs typeface="Calibri" pitchFamily="34" charset="-120"/>
               </a:rPr>
-              <a:t>el servidor levanta</a:t>
+              <a:t>se levanta</a:t>
             </a:r>
             <a:endParaRPr lang="en-US" sz="950" dirty="0"/>
           </a:p>
@@ -10572,7 +10573,7 @@
                 <a:ea typeface="Calibri" pitchFamily="34" charset="-122"/>
                 <a:cs typeface="Calibri" pitchFamily="34" charset="-120"/>
               </a:rPr>
-              <a:t>la nueva versión</a:t>
+              <a:t>y se comprueba</a:t>
             </a:r>
             <a:endParaRPr lang="en-US" sz="950" dirty="0"/>
           </a:p>
@@ -10681,7 +10682,7 @@
                 <a:ea typeface="Calibri" pitchFamily="34" charset="-122"/>
                 <a:cs typeface="Calibri" pitchFamily="34" charset="-120"/>
               </a:rPr>
-              <a:t>Las dos aplicaciones en paralelo, sobre Node 22</a:t>
+              <a:t>Las dos aplicaciones en paralelo</a:t>
             </a:r>
             <a:endParaRPr lang="en-US" sz="1500" dirty="0"/>
           </a:p>
@@ -10705,7 +10706,7 @@
                 <a:ea typeface="Calibri" pitchFamily="34" charset="-122"/>
                 <a:cs typeface="Calibri" pitchFamily="34" charset="-120"/>
               </a:rPr>
-              <a:t>Lint, formato, pruebas, compilación y typecheck</a:t>
+              <a:t>Lint, formato, pruebas y typecheck</a:t>
             </a:r>
             <a:endParaRPr lang="en-US" sz="1500" dirty="0"/>
           </a:p>
@@ -10729,71 +10730,10 @@
                 <a:ea typeface="Calibri" pitchFamily="34" charset="-122"/>
                 <a:cs typeface="Calibri" pitchFamily="34" charset="-120"/>
               </a:rPr>
-              <a:t>Auditoría de dependencias, que detiene la entrega ante una vulnerabilidad crítica</a:t>
+              <a:t>Recorridos de extremo a extremo y cabeceras</a:t>
             </a:r>
             <a:endParaRPr lang="en-US" sz="1500" dirty="0"/>
           </a:p>
-        </p:txBody>
-      </p:sp>
-      <p:sp>
-        <p:nvSpPr>
-          <p:cNvPr id="25" name="Text 23"/>
-          <p:cNvSpPr/>
-          <p:nvPr/>
-        </p:nvSpPr>
-        <p:spPr>
-          <a:xfrm>
-            <a:off x="6537960" y="3127248"/>
-            <a:ext cx="4846320" cy="365760"/>
-          </a:xfrm>
-          <a:prstGeom prst="rect">
-            <a:avLst/>
-          </a:prstGeom>
-          <a:noFill/>
-          <a:ln/>
-        </p:spPr>
-        <p:txBody>
-          <a:bodyPr wrap="square" lIns="0" tIns="0" rIns="0" bIns="0" rtlCol="0" anchor="t"/>
-          <a:lstStyle/>
-          <a:p>
-            <a:pPr indent="0" marL="0">
-              <a:buNone/>
-            </a:pPr>
-            <a:r>
-              <a:rPr lang="en-US" sz="1900" b="1" dirty="0">
-                <a:solidFill>
-                  <a:srgbClr val="202CFC"/>
-                </a:solidFill>
-                <a:latin typeface="Arial" pitchFamily="34" charset="0"/>
-                <a:ea typeface="Arial" pitchFamily="34" charset="-122"/>
-                <a:cs typeface="Arial" pitchFamily="34" charset="-120"/>
-              </a:rPr>
-              <a:t>Despliegue continuo</a:t>
-            </a:r>
-            <a:endParaRPr lang="en-US" sz="1900" dirty="0"/>
-          </a:p>
-        </p:txBody>
-      </p:sp>
-      <p:sp>
-        <p:nvSpPr>
-          <p:cNvPr id="26" name="Text 24"/>
-          <p:cNvSpPr/>
-          <p:nvPr/>
-        </p:nvSpPr>
-        <p:spPr>
-          <a:xfrm>
-            <a:off x="6537960" y="3657600"/>
-            <a:ext cx="4846320" cy="2377440"/>
-          </a:xfrm>
-          <a:prstGeom prst="rect">
-            <a:avLst/>
-          </a:prstGeom>
-          <a:noFill/>
-          <a:ln/>
-        </p:spPr>
-        <p:txBody>
-          <a:bodyPr wrap="square" lIns="0" tIns="0" rIns="0" bIns="0" rtlCol="0" anchor="t"/>
-          <a:lstStyle/>
           <a:p>
             <a:pPr marL="342900" indent="-342900">
               <a:lnSpc>
@@ -10814,10 +10754,71 @@
                 <a:ea typeface="Calibri" pitchFamily="34" charset="-122"/>
                 <a:cs typeface="Calibri" pitchFamily="34" charset="-120"/>
               </a:rPr>
-              <a:t>Se dispara al integrar en main</a:t>
+              <a:t>Auditoría de dependencias, que detiene si algo es crítico</a:t>
             </a:r>
             <a:endParaRPr lang="en-US" sz="1500" dirty="0"/>
           </a:p>
+        </p:txBody>
+      </p:sp>
+      <p:sp>
+        <p:nvSpPr>
+          <p:cNvPr id="25" name="Text 23"/>
+          <p:cNvSpPr/>
+          <p:nvPr/>
+        </p:nvSpPr>
+        <p:spPr>
+          <a:xfrm>
+            <a:off x="6537960" y="3127248"/>
+            <a:ext cx="4846320" cy="365760"/>
+          </a:xfrm>
+          <a:prstGeom prst="rect">
+            <a:avLst/>
+          </a:prstGeom>
+          <a:noFill/>
+          <a:ln/>
+        </p:spPr>
+        <p:txBody>
+          <a:bodyPr wrap="square" lIns="0" tIns="0" rIns="0" bIns="0" rtlCol="0" anchor="t"/>
+          <a:lstStyle/>
+          <a:p>
+            <a:pPr indent="0" marL="0">
+              <a:buNone/>
+            </a:pPr>
+            <a:r>
+              <a:rPr lang="en-US" sz="1900" b="1" dirty="0">
+                <a:solidFill>
+                  <a:srgbClr val="202CFC"/>
+                </a:solidFill>
+                <a:latin typeface="Arial" pitchFamily="34" charset="0"/>
+                <a:ea typeface="Arial" pitchFamily="34" charset="-122"/>
+                <a:cs typeface="Arial" pitchFamily="34" charset="-120"/>
+              </a:rPr>
+              <a:t>Despliegue continuo</a:t>
+            </a:r>
+            <a:endParaRPr lang="en-US" sz="1900" dirty="0"/>
+          </a:p>
+        </p:txBody>
+      </p:sp>
+      <p:sp>
+        <p:nvSpPr>
+          <p:cNvPr id="26" name="Text 24"/>
+          <p:cNvSpPr/>
+          <p:nvPr/>
+        </p:nvSpPr>
+        <p:spPr>
+          <a:xfrm>
+            <a:off x="6537960" y="3657600"/>
+            <a:ext cx="4846320" cy="2377440"/>
+          </a:xfrm>
+          <a:prstGeom prst="rect">
+            <a:avLst/>
+          </a:prstGeom>
+          <a:noFill/>
+          <a:ln/>
+        </p:spPr>
+        <p:txBody>
+          <a:bodyPr wrap="square" lIns="0" tIns="0" rIns="0" bIns="0" rtlCol="0" anchor="t"/>
+          <a:lstStyle/>
           <a:p>
             <a:pPr marL="342900" indent="-342900">
               <a:lnSpc>
@@ -10838,7 +10839,7 @@
                 <a:ea typeface="Calibri" pitchFamily="34" charset="-122"/>
                 <a:cs typeface="Calibri" pitchFamily="34" charset="-120"/>
               </a:rPr>
-              <a:t>Construye tres imágenes: API, interfaz y emulador</a:t>
+              <a:t>Solo arranca si la verificación ha terminado en verde</a:t>
             </a:r>
             <a:endParaRPr lang="en-US" sz="1500" dirty="0"/>
           </a:p>
@@ -10862,7 +10863,7 @@
                 <a:ea typeface="Calibri" pitchFamily="34" charset="-122"/>
                 <a:cs typeface="Calibri" pitchFamily="34" charset="-120"/>
               </a:rPr>
-              <a:t>Las publica en el registro de contenedores de GitHub</a:t>
+              <a:t>Construye tres imágenes: API, interfaz y emulador</a:t>
             </a:r>
             <a:endParaRPr lang="en-US" sz="1500" dirty="0"/>
           </a:p>
@@ -10886,7 +10887,31 @@
                 <a:ea typeface="Calibri" pitchFamily="34" charset="-122"/>
                 <a:cs typeface="Calibri" pitchFamily="34" charset="-120"/>
               </a:rPr>
-              <a:t>El servidor las descarga y levanta la nueva versión, sin intervención manual</a:t>
+              <a:t>Las publica etiquetadas por commit, no solo como «latest»</a:t>
+            </a:r>
+            <a:endParaRPr lang="en-US" sz="1500" dirty="0"/>
+          </a:p>
+          <a:p>
+            <a:pPr marL="342900" indent="-342900">
+              <a:lnSpc>
+                <a:spcPts val="2100"/>
+              </a:lnSpc>
+              <a:spcAft>
+                <a:spcPts val="1100"/>
+              </a:spcAft>
+              <a:buSzPct val="100000"/>
+              <a:buChar char="•"/>
+            </a:pPr>
+            <a:r>
+              <a:rPr lang="en-US" sz="1500" dirty="0">
+                <a:solidFill>
+                  <a:srgbClr val="1A1C2E"/>
+                </a:solidFill>
+                <a:latin typeface="Calibri" pitchFamily="34" charset="0"/>
+                <a:ea typeface="Calibri" pitchFamily="34" charset="-122"/>
+                <a:cs typeface="Calibri" pitchFamily="34" charset="-120"/>
+              </a:rPr>
+              <a:t>Tras levantar comprueba la API, la interfaz y la web pública, o falla</a:t>
             </a:r>
             <a:endParaRPr lang="en-US" sz="1500" dirty="0"/>
           </a:p>

</xml_diff>

<commit_message>
docs(tfm): la 17 cuenta las mitigaciones, no una lista de agujeros
</commit_message>
<xml_diff>
--- a/docs/presentacion/tfm-intelligent-automotive-diagnostics.pptx
+++ b/docs/presentacion/tfm-intelligent-automotive-diagnostics.pptx
@@ -1269,8 +1269,9 @@
               <a:t>La lista anterior es la de APIs y cubre el backend. La interfaz es otra cosa: es una aplicación web, y ahí lo que aplica es el Top 10 clásico.
 React escapa el HTML por defecto, y no se inyecta marcado en crudo en ningún sitio con datos que vengan del usuario, que es por donde entra el XSS. La política de seguridad de contenido la sirve el nginx que sirve la interfaz, con script-src propio y sin scripts en línea, y hay una comprobación en la integración continua que arranca nginx y verifica que las cabeceras salen. Los formularios validan con los mismos esquemas Zod que usa la API.
 Y una decisión consciente: el token viaja en cabecera Bearer y no en cookie. Eso elimina el CSRF de raíz, pero obliga a guardarlo en el navegador.
-A la derecha está lo que sigue abierto, y quiero ser claro con esto porque esta semana se ha movido. El segundo factor ya no falta: hay TOTP con alta por código QR, diez códigos de recuperación de un solo uso guardados hasheados, y es obligatorio para administradores. Los contadores del límite de peticiones tampoco se pierden ya al reiniciar: viven en la base de datos.
-Lo que queda abierto son tres cosas. El token en el navegador, con el trabajo ya definido para pasarlo a cookie httpOnly. El cifrado en reposo, que es una decisión sin tomar entre cifrar el disco del servidor o usar SQLCipher; entre tanto, el secreto del segundo factor, que es el dato que de verdad sería una llave, va cifrado columna a columna con AES-256-GCM y la clave no vive en la base. Y que el segundo factor sea opcional para el usuario corriente, que es decisión de producto.
+A la derecha están los riesgos que quedan, y quiero ser claro con esto porque esta semana se ha movido. El segundo factor ya no falta: hay TOTP con alta por código QR, diez códigos de recuperación de un solo uso guardados hasheados, y es obligatorio para administradores. Los contadores del límite de peticiones tampoco se pierden ya al reiniciar: viven en la base de datos.
+Del token en el navegador: sigue en localStorage, y la respuesta no es esconderlo sino que no haya por dónde leerlo. React escapa, no hay marcado en crudo, y la política de contenido no admite scripts en línea. Y si aun así se robara, el bloqueo de cuenta y la rotación de refresco acotan la ventana. Pasarlo a cookie httpOnly está definido como trabajo, con su protección CSRF.
+De la base sin cifrar en reposo: el dato que de verdad sería una llave es el secreto del segundo factor, y ese va cifrado columna a columna con AES-256-GCM, con la clave fuera de la base. Un volcado del fichero ya no basta para anular el segundo factor. Cifrar el disco entero es una decisión de despliegue, no de código, y está sin tomar.
 [~50 s · acumulado 18:35]</a:t>
             </a:r>
             <a:endParaRPr lang="en-US" dirty="0"/>
@@ -9257,7 +9258,7 @@
                 <a:ea typeface="Arial" pitchFamily="34" charset="-122"/>
                 <a:cs typeface="Arial" pitchFamily="34" charset="-120"/>
               </a:rPr>
-              <a:t>La interfaz y los riesgos abiertos</a:t>
+              <a:t>Seguridad de la interfaz</a:t>
             </a:r>
             <a:endParaRPr lang="en-US" sz="3400" dirty="0"/>
           </a:p>
@@ -9492,7 +9493,7 @@
                 <a:ea typeface="Arial" pitchFamily="34" charset="-122"/>
                 <a:cs typeface="Arial" pitchFamily="34" charset="-120"/>
               </a:rPr>
-              <a:t>Lo que queda abierto</a:t>
+              <a:t>Riesgos y cómo se acotan</a:t>
             </a:r>
             <a:endParaRPr lang="en-US" sz="1900" dirty="0"/>
           </a:p>
@@ -9538,7 +9539,7 @@
                 <a:ea typeface="Calibri" pitchFamily="34" charset="-122"/>
                 <a:cs typeface="Calibri" pitchFamily="34" charset="-120"/>
               </a:rPr>
-              <a:t>El token vive en localStorage: quedaría expuesto ante un XSS</a:t>
+              <a:t>El token en localStorage lo acota una interfaz sin superficie de XSS</a:t>
             </a:r>
             <a:endParaRPr lang="en-US" sz="1500" dirty="0"/>
           </a:p>
@@ -9562,7 +9563,7 @@
                 <a:ea typeface="Calibri" pitchFamily="34" charset="-122"/>
                 <a:cs typeface="Calibri" pitchFamily="34" charset="-120"/>
               </a:rPr>
-              <a:t>Pasarlo a cookie httpOnly está pendiente, y arrastra proteger CSRF</a:t>
+              <a:t>Y si aun así se robara, el bloqueo de cuenta y la rotación de refresco acotan el daño</a:t>
             </a:r>
             <a:endParaRPr lang="en-US" sz="1500" dirty="0"/>
           </a:p>
@@ -9586,7 +9587,7 @@
                 <a:ea typeface="Calibri" pitchFamily="34" charset="-122"/>
                 <a:cs typeface="Calibri" pitchFamily="34" charset="-120"/>
               </a:rPr>
-              <a:t>La base no está cifrada en reposo; el secreto TOTP sí, con AES-256-GCM</a:t>
+              <a:t>El secreto del segundo factor va cifrado con AES-256-GCM, con la clave fuera de la base</a:t>
             </a:r>
             <a:endParaRPr lang="en-US" sz="1500" dirty="0"/>
           </a:p>
@@ -9610,7 +9611,7 @@
                 <a:ea typeface="Calibri" pitchFamily="34" charset="-122"/>
                 <a:cs typeface="Calibri" pitchFamily="34" charset="-120"/>
               </a:rPr>
-              <a:t>El segundo factor es opcional, salvo para administradores</a:t>
+              <a:t>El segundo factor es obligatorio para administradores</a:t>
             </a:r>
             <a:endParaRPr lang="en-US" sz="1500" dirty="0"/>
           </a:p>

</xml_diff>

<commit_message>
docs(tfm): la 17 pasa a tabla, igual que la de OWASP API
</commit_message>
<xml_diff>
--- a/docs/presentacion/tfm-intelligent-automotive-diagnostics.pptx
+++ b/docs/presentacion/tfm-intelligent-automotive-diagnostics.pptx
@@ -1266,12 +1266,10 @@
           <a:p>
             <a:r>
               <a:rPr lang="en-US" dirty="0"/>
-              <a:t>La lista anterior es la de APIs y cubre el backend. La interfaz es otra cosa: es una aplicación web, y ahí lo que aplica es el Top 10 clásico.
-React escapa el HTML por defecto, y no se inyecta marcado en crudo en ningún sitio con datos que vengan del usuario, que es por donde entra el XSS. La política de seguridad de contenido la sirve el nginx que sirve la interfaz, con script-src propio y sin scripts en línea, y hay una comprobación en la integración continua que arranca nginx y verifica que las cabeceras salen. Los formularios validan con los mismos esquemas Zod que usa la API.
-Y una decisión consciente: el token viaja en cabecera Bearer y no en cookie. Eso elimina el CSRF de raíz, pero obliga a guardarlo en el navegador.
-A la derecha están los riesgos que quedan, y quiero ser claro con esto porque esta semana se ha movido. El segundo factor ya no falta: hay TOTP con alta por código QR, diez códigos de recuperación de un solo uso guardados hasheados, y es obligatorio para administradores. Los contadores del límite de peticiones tampoco se pierden ya al reiniciar: viven en la base de datos.
-Del token en el navegador: sigue en localStorage, y la respuesta no es esconderlo sino que no haya por dónde leerlo. React escapa, no hay marcado en crudo, y la política de contenido no admite scripts en línea. Y si aun así se robara, el bloqueo de cuenta y la rotación de refresco acotan la ventana. Pasarlo a cookie httpOnly está definido como trabajo, con su protección CSRF.
-De la base sin cifrar en reposo: el dato que de verdad sería una llave es el secreto del segundo factor, y ese va cifrado columna a columna con AES-256-GCM, con la clave fuera de la base. Un volcado del fichero ya no basta para anular el segundo factor. Cifrar el disco entero es una decisión de despliegue, no de código, y está sin tomar.
+              <a:t>La lista anterior cubre el backend, que es una API. La interfaz es otra cosa: es una aplicación web, y ahí aplica el Top 10 clásico. Mismo ejercicio: las diez categorías con la medida concreta.
+Destaco lo que es propio de la interfaz. React escapa el HTML por defecto y no se inyecta marcado en crudo en ningún sitio con datos del usuario, que es por donde entra el XSS. La política de contenido la sirve el nginx que sirve la interfaz, con script-src propio y sin scripts en línea, y hay una comprobación en integración continua que arranca nginx y verifica que las cabeceras salen. Los formularios validan con los mismos esquemas Zod que usa la API, así que cliente y servidor no se pueden desincronizar.
+En la A05 quiero pararme: hasta esta semana los contenedores publicaban sus puertos en todas las interfaces, o sea que se podía llegar a la API por la IP del servidor sin pasar por el proxy, y con ello saltarse el TLS y falsear la IP de origen. Ahora la API y la interfaz solo se publican en loopback y los emuladores no se publican en absoluto. Desde fuera solo queda el 443.
+Y una decisión consciente en la A02: el token viaja en cabecera Bearer y no en cookie. Eso elimina el CSRF de raíz, y a cambio vive en el navegador. La respuesta a eso no es esconderlo, es que no haya por dónde leerlo, que es todo lo de arriba. El secreto del segundo factor, que sí sería una llave, va cifrado con AES-256-GCM y su clave no vive en la base de datos.
 [~50 s · acumulado 18:35]</a:t>
             </a:r>
             <a:endParaRPr lang="en-US" dirty="0"/>
@@ -9258,7 +9256,7 @@
                 <a:ea typeface="Arial" pitchFamily="34" charset="-122"/>
                 <a:cs typeface="Arial" pitchFamily="34" charset="-120"/>
               </a:rPr>
-              <a:t>Seguridad de la interfaz</a:t>
+              <a:t>OWASP Top 10 2021</a:t>
             </a:r>
             <a:endParaRPr lang="en-US" sz="3400" dirty="0"/>
           </a:p>
@@ -9272,7 +9270,7 @@
         </p:nvSpPr>
         <p:spPr>
           <a:xfrm>
-            <a:off x="777240" y="1508760"/>
+            <a:off x="777240" y="1481328"/>
             <a:ext cx="10607040" cy="365760"/>
           </a:xfrm>
           <a:prstGeom prst="rect">
@@ -9297,7 +9295,7 @@
                 <a:ea typeface="Calibri" pitchFamily="34" charset="-122"/>
                 <a:cs typeface="Calibri" pitchFamily="34" charset="-120"/>
               </a:rPr>
-              <a:t>La interfaz es una aplicación web, así que ahí manda el Top 10 de aplicaciones web.</a:t>
+              <a:t>La interfaz es una aplicación web: el mismo ejercicio con la lista de aplicaciones web.</a:t>
             </a:r>
             <a:endParaRPr lang="en-US" sz="1700" dirty="0"/>
           </a:p>
@@ -9311,24 +9309,24 @@
         </p:nvSpPr>
         <p:spPr>
           <a:xfrm>
-            <a:off x="777240" y="2240280"/>
-            <a:ext cx="4846320" cy="365760"/>
-          </a:xfrm>
-          <a:prstGeom prst="rect">
-            <a:avLst/>
-          </a:prstGeom>
-          <a:noFill/>
-          <a:ln/>
-        </p:spPr>
-        <p:txBody>
-          <a:bodyPr wrap="square" lIns="0" tIns="0" rIns="0" bIns="0" rtlCol="0" anchor="t"/>
-          <a:lstStyle/>
-          <a:p>
-            <a:pPr indent="0" marL="0">
-              <a:buNone/>
-            </a:pPr>
-            <a:r>
-              <a:rPr lang="en-US" sz="1900" b="1" dirty="0">
+            <a:off x="777240" y="2084832"/>
+            <a:ext cx="731520" cy="365760"/>
+          </a:xfrm>
+          <a:prstGeom prst="rect">
+            <a:avLst/>
+          </a:prstGeom>
+          <a:noFill/>
+          <a:ln/>
+        </p:spPr>
+        <p:txBody>
+          <a:bodyPr wrap="square" lIns="0" tIns="0" rIns="0" bIns="0" rtlCol="0" anchor="ctr"/>
+          <a:lstStyle/>
+          <a:p>
+            <a:pPr indent="0" marL="0">
+              <a:buNone/>
+            </a:pPr>
+            <a:r>
+              <a:rPr lang="en-US" sz="1100" b="1" dirty="0">
                 <a:solidFill>
                   <a:srgbClr val="202CFC"/>
                 </a:solidFill>
@@ -9336,9 +9334,9 @@
                 <a:ea typeface="Arial" pitchFamily="34" charset="-122"/>
                 <a:cs typeface="Arial" pitchFamily="34" charset="-120"/>
               </a:rPr>
-              <a:t>Medidas en la interfaz</a:t>
-            </a:r>
-            <a:endParaRPr lang="en-US" sz="1900" dirty="0"/>
+              <a:t>A01</a:t>
+            </a:r>
+            <a:endParaRPr lang="en-US" sz="1100" dirty="0"/>
           </a:p>
         </p:txBody>
       </p:sp>
@@ -9350,152 +9348,73 @@
         </p:nvSpPr>
         <p:spPr>
           <a:xfrm>
-            <a:off x="777240" y="2788920"/>
-            <a:ext cx="4846320" cy="2926080"/>
-          </a:xfrm>
-          <a:prstGeom prst="rect">
-            <a:avLst/>
-          </a:prstGeom>
-          <a:noFill/>
-          <a:ln/>
-        </p:spPr>
-        <p:txBody>
-          <a:bodyPr wrap="square" lIns="0" tIns="0" rIns="0" bIns="0" rtlCol="0" anchor="t"/>
-          <a:lstStyle/>
-          <a:p>
-            <a:pPr marL="342900" indent="-342900">
-              <a:lnSpc>
-                <a:spcPts val="2100"/>
-              </a:lnSpc>
-              <a:spcAft>
-                <a:spcPts val="1100"/>
-              </a:spcAft>
-              <a:buSzPct val="100000"/>
-              <a:buChar char="•"/>
-            </a:pPr>
-            <a:r>
-              <a:rPr lang="en-US" sz="1500" dirty="0">
-                <a:solidFill>
-                  <a:srgbClr val="1A1C2E"/>
-                </a:solidFill>
-                <a:latin typeface="Calibri" pitchFamily="34" charset="0"/>
-                <a:ea typeface="Calibri" pitchFamily="34" charset="-122"/>
-                <a:cs typeface="Calibri" pitchFamily="34" charset="-120"/>
-              </a:rPr>
-              <a:t>React escapa el HTML por defecto, y no hay inyección directa de marcado sobre datos de usuario</a:t>
-            </a:r>
-            <a:endParaRPr lang="en-US" sz="1500" dirty="0"/>
-          </a:p>
-          <a:p>
-            <a:pPr marL="342900" indent="-342900">
-              <a:lnSpc>
-                <a:spcPts val="2100"/>
-              </a:lnSpc>
-              <a:spcAft>
-                <a:spcPts val="1100"/>
-              </a:spcAft>
-              <a:buSzPct val="100000"/>
-              <a:buChar char="•"/>
-            </a:pPr>
-            <a:r>
-              <a:rPr lang="en-US" sz="1500" dirty="0">
-                <a:solidFill>
-                  <a:srgbClr val="1A1C2E"/>
-                </a:solidFill>
-                <a:latin typeface="Calibri" pitchFamily="34" charset="0"/>
-                <a:ea typeface="Calibri" pitchFamily="34" charset="-122"/>
-                <a:cs typeface="Calibri" pitchFamily="34" charset="-120"/>
-              </a:rPr>
-              <a:t>La CSP la sirve nginx, con script-src 'self' y sin scripts en línea</a:t>
-            </a:r>
-            <a:endParaRPr lang="en-US" sz="1500" dirty="0"/>
-          </a:p>
-          <a:p>
-            <a:pPr marL="342900" indent="-342900">
-              <a:lnSpc>
-                <a:spcPts val="2100"/>
-              </a:lnSpc>
-              <a:spcAft>
-                <a:spcPts val="1100"/>
-              </a:spcAft>
-              <a:buSzPct val="100000"/>
-              <a:buChar char="•"/>
-            </a:pPr>
-            <a:r>
-              <a:rPr lang="en-US" sz="1500" dirty="0">
-                <a:solidFill>
-                  <a:srgbClr val="1A1C2E"/>
-                </a:solidFill>
-                <a:latin typeface="Calibri" pitchFamily="34" charset="0"/>
-                <a:ea typeface="Calibri" pitchFamily="34" charset="-122"/>
-                <a:cs typeface="Calibri" pitchFamily="34" charset="-120"/>
-              </a:rPr>
-              <a:t>Validación con Zod también en el cliente, en todos los formularios</a:t>
-            </a:r>
-            <a:endParaRPr lang="en-US" sz="1500" dirty="0"/>
-          </a:p>
-          <a:p>
-            <a:pPr marL="342900" indent="-342900">
-              <a:lnSpc>
-                <a:spcPts val="2100"/>
-              </a:lnSpc>
-              <a:spcAft>
-                <a:spcPts val="1100"/>
-              </a:spcAft>
-              <a:buSzPct val="100000"/>
-              <a:buChar char="•"/>
-            </a:pPr>
-            <a:r>
-              <a:rPr lang="en-US" sz="1500" dirty="0">
-                <a:solidFill>
-                  <a:srgbClr val="1A1C2E"/>
-                </a:solidFill>
-                <a:latin typeface="Calibri" pitchFamily="34" charset="0"/>
-                <a:ea typeface="Calibri" pitchFamily="34" charset="-122"/>
-                <a:cs typeface="Calibri" pitchFamily="34" charset="-120"/>
-              </a:rPr>
-              <a:t>El token viaja en cabecera Bearer y no en cookie, así que no hay CSRF</a:t>
-            </a:r>
-            <a:endParaRPr lang="en-US" sz="1500" dirty="0"/>
-          </a:p>
-        </p:txBody>
-      </p:sp>
-      <p:sp>
-        <p:nvSpPr>
-          <p:cNvPr id="6" name="Text 4"/>
-          <p:cNvSpPr/>
-          <p:nvPr/>
-        </p:nvSpPr>
-        <p:spPr>
-          <a:xfrm>
-            <a:off x="6537960" y="2240280"/>
-            <a:ext cx="4846320" cy="365760"/>
-          </a:xfrm>
-          <a:prstGeom prst="rect">
-            <a:avLst/>
-          </a:prstGeom>
-          <a:noFill/>
-          <a:ln/>
-        </p:spPr>
-        <p:txBody>
-          <a:bodyPr wrap="square" lIns="0" tIns="0" rIns="0" bIns="0" rtlCol="0" anchor="t"/>
-          <a:lstStyle/>
-          <a:p>
-            <a:pPr indent="0" marL="0">
-              <a:buNone/>
-            </a:pPr>
-            <a:r>
-              <a:rPr lang="en-US" sz="1900" b="1" dirty="0">
-                <a:solidFill>
-                  <a:srgbClr val="202CFC"/>
+            <a:off x="1508760" y="2084832"/>
+            <a:ext cx="3977640" cy="365760"/>
+          </a:xfrm>
+          <a:prstGeom prst="rect">
+            <a:avLst/>
+          </a:prstGeom>
+          <a:noFill/>
+          <a:ln/>
+        </p:spPr>
+        <p:txBody>
+          <a:bodyPr wrap="square" lIns="0" tIns="0" rIns="0" bIns="0" rtlCol="0" anchor="ctr"/>
+          <a:lstStyle/>
+          <a:p>
+            <a:pPr indent="0" marL="0">
+              <a:buNone/>
+            </a:pPr>
+            <a:r>
+              <a:rPr lang="en-US" sz="1150" b="1" dirty="0">
+                <a:solidFill>
+                  <a:srgbClr val="1A1C2E"/>
                 </a:solidFill>
                 <a:latin typeface="Arial" pitchFamily="34" charset="0"/>
                 <a:ea typeface="Arial" pitchFamily="34" charset="-122"/>
                 <a:cs typeface="Arial" pitchFamily="34" charset="-120"/>
               </a:rPr>
-              <a:t>Riesgos y cómo se acotan</a:t>
-            </a:r>
-            <a:endParaRPr lang="en-US" sz="1900" dirty="0"/>
+              <a:t>Broken Access Control</a:t>
+            </a:r>
+            <a:endParaRPr lang="en-US" sz="1150" dirty="0"/>
+          </a:p>
+        </p:txBody>
+      </p:sp>
+      <p:sp>
+        <p:nvSpPr>
+          <p:cNvPr id="6" name="Text 4"/>
+          <p:cNvSpPr/>
+          <p:nvPr/>
+        </p:nvSpPr>
+        <p:spPr>
+          <a:xfrm>
+            <a:off x="5577840" y="2084832"/>
+            <a:ext cx="5806440" cy="365760"/>
+          </a:xfrm>
+          <a:prstGeom prst="rect">
+            <a:avLst/>
+          </a:prstGeom>
+          <a:noFill/>
+          <a:ln/>
+        </p:spPr>
+        <p:txBody>
+          <a:bodyPr wrap="square" lIns="0" tIns="0" rIns="0" bIns="0" rtlCol="0" anchor="ctr"/>
+          <a:lstStyle/>
+          <a:p>
+            <a:pPr indent="0" marL="0">
+              <a:buNone/>
+            </a:pPr>
+            <a:r>
+              <a:rPr lang="en-US" sz="1200" dirty="0">
+                <a:solidFill>
+                  <a:srgbClr val="5A5F73"/>
+                </a:solidFill>
+                <a:latin typeface="Calibri" pitchFamily="34" charset="0"/>
+                <a:ea typeface="Calibri" pitchFamily="34" charset="-122"/>
+                <a:cs typeface="Calibri" pitchFamily="34" charset="-120"/>
+              </a:rPr>
+              <a:t>Sesión en todo /api; administración con segundo factor</a:t>
+            </a:r>
+            <a:endParaRPr lang="en-US" sz="1200" dirty="0"/>
           </a:p>
         </p:txBody>
       </p:sp>
@@ -9507,119 +9426,1054 @@
         </p:nvSpPr>
         <p:spPr>
           <a:xfrm>
-            <a:off x="6537960" y="2788920"/>
-            <a:ext cx="4846320" cy="2926080"/>
-          </a:xfrm>
-          <a:prstGeom prst="rect">
-            <a:avLst/>
-          </a:prstGeom>
-          <a:noFill/>
-          <a:ln/>
-        </p:spPr>
-        <p:txBody>
-          <a:bodyPr wrap="square" lIns="0" tIns="0" rIns="0" bIns="0" rtlCol="0" anchor="t"/>
-          <a:lstStyle/>
-          <a:p>
-            <a:pPr marL="342900" indent="-342900">
-              <a:lnSpc>
-                <a:spcPts val="2100"/>
-              </a:lnSpc>
-              <a:spcAft>
-                <a:spcPts val="1100"/>
-              </a:spcAft>
-              <a:buSzPct val="100000"/>
-              <a:buChar char="•"/>
-            </a:pPr>
-            <a:r>
-              <a:rPr lang="en-US" sz="1500" dirty="0">
-                <a:solidFill>
-                  <a:srgbClr val="1A1C2E"/>
-                </a:solidFill>
-                <a:latin typeface="Calibri" pitchFamily="34" charset="0"/>
-                <a:ea typeface="Calibri" pitchFamily="34" charset="-122"/>
-                <a:cs typeface="Calibri" pitchFamily="34" charset="-120"/>
-              </a:rPr>
-              <a:t>El token en localStorage lo acota una interfaz sin superficie de XSS</a:t>
-            </a:r>
-            <a:endParaRPr lang="en-US" sz="1500" dirty="0"/>
-          </a:p>
-          <a:p>
-            <a:pPr marL="342900" indent="-342900">
-              <a:lnSpc>
-                <a:spcPts val="2100"/>
-              </a:lnSpc>
-              <a:spcAft>
-                <a:spcPts val="1100"/>
-              </a:spcAft>
-              <a:buSzPct val="100000"/>
-              <a:buChar char="•"/>
-            </a:pPr>
-            <a:r>
-              <a:rPr lang="en-US" sz="1500" dirty="0">
-                <a:solidFill>
-                  <a:srgbClr val="1A1C2E"/>
-                </a:solidFill>
-                <a:latin typeface="Calibri" pitchFamily="34" charset="0"/>
-                <a:ea typeface="Calibri" pitchFamily="34" charset="-122"/>
-                <a:cs typeface="Calibri" pitchFamily="34" charset="-120"/>
-              </a:rPr>
-              <a:t>Y si aun así se robara, el bloqueo de cuenta y la rotación de refresco acotan el daño</a:t>
-            </a:r>
-            <a:endParaRPr lang="en-US" sz="1500" dirty="0"/>
-          </a:p>
-          <a:p>
-            <a:pPr marL="342900" indent="-342900">
-              <a:lnSpc>
-                <a:spcPts val="2100"/>
-              </a:lnSpc>
-              <a:spcAft>
-                <a:spcPts val="1100"/>
-              </a:spcAft>
-              <a:buSzPct val="100000"/>
-              <a:buChar char="•"/>
-            </a:pPr>
-            <a:r>
-              <a:rPr lang="en-US" sz="1500" dirty="0">
-                <a:solidFill>
-                  <a:srgbClr val="1A1C2E"/>
-                </a:solidFill>
-                <a:latin typeface="Calibri" pitchFamily="34" charset="0"/>
-                <a:ea typeface="Calibri" pitchFamily="34" charset="-122"/>
-                <a:cs typeface="Calibri" pitchFamily="34" charset="-120"/>
-              </a:rPr>
-              <a:t>El secreto del segundo factor va cifrado con AES-256-GCM, con la clave fuera de la base</a:t>
-            </a:r>
-            <a:endParaRPr lang="en-US" sz="1500" dirty="0"/>
-          </a:p>
-          <a:p>
-            <a:pPr marL="342900" indent="-342900">
-              <a:lnSpc>
-                <a:spcPts val="2100"/>
-              </a:lnSpc>
-              <a:spcAft>
-                <a:spcPts val="1100"/>
-              </a:spcAft>
-              <a:buSzPct val="100000"/>
-              <a:buChar char="•"/>
-            </a:pPr>
-            <a:r>
-              <a:rPr lang="en-US" sz="1500" dirty="0">
-                <a:solidFill>
-                  <a:srgbClr val="1A1C2E"/>
-                </a:solidFill>
-                <a:latin typeface="Calibri" pitchFamily="34" charset="0"/>
-                <a:ea typeface="Calibri" pitchFamily="34" charset="-122"/>
-                <a:cs typeface="Calibri" pitchFamily="34" charset="-120"/>
-              </a:rPr>
-              <a:t>El segundo factor es obligatorio para administradores</a:t>
-            </a:r>
-            <a:endParaRPr lang="en-US" sz="1500" dirty="0"/>
-          </a:p>
-        </p:txBody>
-      </p:sp>
-      <p:sp>
-        <p:nvSpPr>
-          <p:cNvPr id="8" name="Shape 6"/>
+            <a:off x="777240" y="2487168"/>
+            <a:ext cx="731520" cy="365760"/>
+          </a:xfrm>
+          <a:prstGeom prst="rect">
+            <a:avLst/>
+          </a:prstGeom>
+          <a:noFill/>
+          <a:ln/>
+        </p:spPr>
+        <p:txBody>
+          <a:bodyPr wrap="square" lIns="0" tIns="0" rIns="0" bIns="0" rtlCol="0" anchor="ctr"/>
+          <a:lstStyle/>
+          <a:p>
+            <a:pPr indent="0" marL="0">
+              <a:buNone/>
+            </a:pPr>
+            <a:r>
+              <a:rPr lang="en-US" sz="1100" b="1" dirty="0">
+                <a:solidFill>
+                  <a:srgbClr val="202CFC"/>
+                </a:solidFill>
+                <a:latin typeface="Arial" pitchFamily="34" charset="0"/>
+                <a:ea typeface="Arial" pitchFamily="34" charset="-122"/>
+                <a:cs typeface="Arial" pitchFamily="34" charset="-120"/>
+              </a:rPr>
+              <a:t>A02</a:t>
+            </a:r>
+            <a:endParaRPr lang="en-US" sz="1100" dirty="0"/>
+          </a:p>
+        </p:txBody>
+      </p:sp>
+      <p:sp>
+        <p:nvSpPr>
+          <p:cNvPr id="8" name="Text 6"/>
+          <p:cNvSpPr/>
+          <p:nvPr/>
+        </p:nvSpPr>
+        <p:spPr>
+          <a:xfrm>
+            <a:off x="1508760" y="2487168"/>
+            <a:ext cx="3977640" cy="365760"/>
+          </a:xfrm>
+          <a:prstGeom prst="rect">
+            <a:avLst/>
+          </a:prstGeom>
+          <a:noFill/>
+          <a:ln/>
+        </p:spPr>
+        <p:txBody>
+          <a:bodyPr wrap="square" lIns="0" tIns="0" rIns="0" bIns="0" rtlCol="0" anchor="ctr"/>
+          <a:lstStyle/>
+          <a:p>
+            <a:pPr indent="0" marL="0">
+              <a:buNone/>
+            </a:pPr>
+            <a:r>
+              <a:rPr lang="en-US" sz="1150" b="1" dirty="0">
+                <a:solidFill>
+                  <a:srgbClr val="1A1C2E"/>
+                </a:solidFill>
+                <a:latin typeface="Arial" pitchFamily="34" charset="0"/>
+                <a:ea typeface="Arial" pitchFamily="34" charset="-122"/>
+                <a:cs typeface="Arial" pitchFamily="34" charset="-120"/>
+              </a:rPr>
+              <a:t>Cryptographic Failures</a:t>
+            </a:r>
+            <a:endParaRPr lang="en-US" sz="1150" dirty="0"/>
+          </a:p>
+        </p:txBody>
+      </p:sp>
+      <p:sp>
+        <p:nvSpPr>
+          <p:cNvPr id="9" name="Text 7"/>
+          <p:cNvSpPr/>
+          <p:nvPr/>
+        </p:nvSpPr>
+        <p:spPr>
+          <a:xfrm>
+            <a:off x="5577840" y="2487168"/>
+            <a:ext cx="5806440" cy="365760"/>
+          </a:xfrm>
+          <a:prstGeom prst="rect">
+            <a:avLst/>
+          </a:prstGeom>
+          <a:noFill/>
+          <a:ln/>
+        </p:spPr>
+        <p:txBody>
+          <a:bodyPr wrap="square" lIns="0" tIns="0" rIns="0" bIns="0" rtlCol="0" anchor="ctr"/>
+          <a:lstStyle/>
+          <a:p>
+            <a:pPr indent="0" marL="0">
+              <a:buNone/>
+            </a:pPr>
+            <a:r>
+              <a:rPr lang="en-US" sz="1200" dirty="0">
+                <a:solidFill>
+                  <a:srgbClr val="5A5F73"/>
+                </a:solidFill>
+                <a:latin typeface="Calibri" pitchFamily="34" charset="0"/>
+                <a:ea typeface="Calibri" pitchFamily="34" charset="-122"/>
+                <a:cs typeface="Calibri" pitchFamily="34" charset="-120"/>
+              </a:rPr>
+              <a:t>bcrypt 12 rondas, secretos separados y TOTP cifrado</a:t>
+            </a:r>
+            <a:endParaRPr lang="en-US" sz="1200" dirty="0"/>
+          </a:p>
+        </p:txBody>
+      </p:sp>
+      <p:sp>
+        <p:nvSpPr>
+          <p:cNvPr id="10" name="Text 8"/>
+          <p:cNvSpPr/>
+          <p:nvPr/>
+        </p:nvSpPr>
+        <p:spPr>
+          <a:xfrm>
+            <a:off x="777240" y="2889504"/>
+            <a:ext cx="731520" cy="365760"/>
+          </a:xfrm>
+          <a:prstGeom prst="rect">
+            <a:avLst/>
+          </a:prstGeom>
+          <a:noFill/>
+          <a:ln/>
+        </p:spPr>
+        <p:txBody>
+          <a:bodyPr wrap="square" lIns="0" tIns="0" rIns="0" bIns="0" rtlCol="0" anchor="ctr"/>
+          <a:lstStyle/>
+          <a:p>
+            <a:pPr indent="0" marL="0">
+              <a:buNone/>
+            </a:pPr>
+            <a:r>
+              <a:rPr lang="en-US" sz="1100" b="1" dirty="0">
+                <a:solidFill>
+                  <a:srgbClr val="202CFC"/>
+                </a:solidFill>
+                <a:latin typeface="Arial" pitchFamily="34" charset="0"/>
+                <a:ea typeface="Arial" pitchFamily="34" charset="-122"/>
+                <a:cs typeface="Arial" pitchFamily="34" charset="-120"/>
+              </a:rPr>
+              <a:t>A03</a:t>
+            </a:r>
+            <a:endParaRPr lang="en-US" sz="1100" dirty="0"/>
+          </a:p>
+        </p:txBody>
+      </p:sp>
+      <p:sp>
+        <p:nvSpPr>
+          <p:cNvPr id="11" name="Text 9"/>
+          <p:cNvSpPr/>
+          <p:nvPr/>
+        </p:nvSpPr>
+        <p:spPr>
+          <a:xfrm>
+            <a:off x="1508760" y="2889504"/>
+            <a:ext cx="3977640" cy="365760"/>
+          </a:xfrm>
+          <a:prstGeom prst="rect">
+            <a:avLst/>
+          </a:prstGeom>
+          <a:noFill/>
+          <a:ln/>
+        </p:spPr>
+        <p:txBody>
+          <a:bodyPr wrap="square" lIns="0" tIns="0" rIns="0" bIns="0" rtlCol="0" anchor="ctr"/>
+          <a:lstStyle/>
+          <a:p>
+            <a:pPr indent="0" marL="0">
+              <a:buNone/>
+            </a:pPr>
+            <a:r>
+              <a:rPr lang="en-US" sz="1150" b="1" dirty="0">
+                <a:solidFill>
+                  <a:srgbClr val="1A1C2E"/>
+                </a:solidFill>
+                <a:latin typeface="Arial" pitchFamily="34" charset="0"/>
+                <a:ea typeface="Arial" pitchFamily="34" charset="-122"/>
+                <a:cs typeface="Arial" pitchFamily="34" charset="-120"/>
+              </a:rPr>
+              <a:t>Injection</a:t>
+            </a:r>
+            <a:endParaRPr lang="en-US" sz="1150" dirty="0"/>
+          </a:p>
+        </p:txBody>
+      </p:sp>
+      <p:sp>
+        <p:nvSpPr>
+          <p:cNvPr id="12" name="Text 10"/>
+          <p:cNvSpPr/>
+          <p:nvPr/>
+        </p:nvSpPr>
+        <p:spPr>
+          <a:xfrm>
+            <a:off x="5577840" y="2889504"/>
+            <a:ext cx="5806440" cy="365760"/>
+          </a:xfrm>
+          <a:prstGeom prst="rect">
+            <a:avLst/>
+          </a:prstGeom>
+          <a:noFill/>
+          <a:ln/>
+        </p:spPr>
+        <p:txBody>
+          <a:bodyPr wrap="square" lIns="0" tIns="0" rIns="0" bIns="0" rtlCol="0" anchor="ctr"/>
+          <a:lstStyle/>
+          <a:p>
+            <a:pPr indent="0" marL="0">
+              <a:buNone/>
+            </a:pPr>
+            <a:r>
+              <a:rPr lang="en-US" sz="1200" dirty="0">
+                <a:solidFill>
+                  <a:srgbClr val="5A5F73"/>
+                </a:solidFill>
+                <a:latin typeface="Calibri" pitchFamily="34" charset="0"/>
+                <a:ea typeface="Calibri" pitchFamily="34" charset="-122"/>
+                <a:cs typeface="Calibri" pitchFamily="34" charset="-120"/>
+              </a:rPr>
+              <a:t>Consultas parametrizadas con Drizzle y validación Zod</a:t>
+            </a:r>
+            <a:endParaRPr lang="en-US" sz="1200" dirty="0"/>
+          </a:p>
+        </p:txBody>
+      </p:sp>
+      <p:sp>
+        <p:nvSpPr>
+          <p:cNvPr id="13" name="Text 11"/>
+          <p:cNvSpPr/>
+          <p:nvPr/>
+        </p:nvSpPr>
+        <p:spPr>
+          <a:xfrm>
+            <a:off x="777240" y="3291840"/>
+            <a:ext cx="731520" cy="365760"/>
+          </a:xfrm>
+          <a:prstGeom prst="rect">
+            <a:avLst/>
+          </a:prstGeom>
+          <a:noFill/>
+          <a:ln/>
+        </p:spPr>
+        <p:txBody>
+          <a:bodyPr wrap="square" lIns="0" tIns="0" rIns="0" bIns="0" rtlCol="0" anchor="ctr"/>
+          <a:lstStyle/>
+          <a:p>
+            <a:pPr indent="0" marL="0">
+              <a:buNone/>
+            </a:pPr>
+            <a:r>
+              <a:rPr lang="en-US" sz="1100" b="1" dirty="0">
+                <a:solidFill>
+                  <a:srgbClr val="202CFC"/>
+                </a:solidFill>
+                <a:latin typeface="Arial" pitchFamily="34" charset="0"/>
+                <a:ea typeface="Arial" pitchFamily="34" charset="-122"/>
+                <a:cs typeface="Arial" pitchFamily="34" charset="-120"/>
+              </a:rPr>
+              <a:t>A04</a:t>
+            </a:r>
+            <a:endParaRPr lang="en-US" sz="1100" dirty="0"/>
+          </a:p>
+        </p:txBody>
+      </p:sp>
+      <p:sp>
+        <p:nvSpPr>
+          <p:cNvPr id="14" name="Text 12"/>
+          <p:cNvSpPr/>
+          <p:nvPr/>
+        </p:nvSpPr>
+        <p:spPr>
+          <a:xfrm>
+            <a:off x="1508760" y="3291840"/>
+            <a:ext cx="3977640" cy="365760"/>
+          </a:xfrm>
+          <a:prstGeom prst="rect">
+            <a:avLst/>
+          </a:prstGeom>
+          <a:noFill/>
+          <a:ln/>
+        </p:spPr>
+        <p:txBody>
+          <a:bodyPr wrap="square" lIns="0" tIns="0" rIns="0" bIns="0" rtlCol="0" anchor="ctr"/>
+          <a:lstStyle/>
+          <a:p>
+            <a:pPr indent="0" marL="0">
+              <a:buNone/>
+            </a:pPr>
+            <a:r>
+              <a:rPr lang="en-US" sz="1150" b="1" dirty="0">
+                <a:solidFill>
+                  <a:srgbClr val="1A1C2E"/>
+                </a:solidFill>
+                <a:latin typeface="Arial" pitchFamily="34" charset="0"/>
+                <a:ea typeface="Arial" pitchFamily="34" charset="-122"/>
+                <a:cs typeface="Arial" pitchFamily="34" charset="-120"/>
+              </a:rPr>
+              <a:t>Insecure Design</a:t>
+            </a:r>
+            <a:endParaRPr lang="en-US" sz="1150" dirty="0"/>
+          </a:p>
+        </p:txBody>
+      </p:sp>
+      <p:sp>
+        <p:nvSpPr>
+          <p:cNvPr id="15" name="Text 13"/>
+          <p:cNvSpPr/>
+          <p:nvPr/>
+        </p:nvSpPr>
+        <p:spPr>
+          <a:xfrm>
+            <a:off x="5577840" y="3291840"/>
+            <a:ext cx="5806440" cy="365760"/>
+          </a:xfrm>
+          <a:prstGeom prst="rect">
+            <a:avLst/>
+          </a:prstGeom>
+          <a:noFill/>
+          <a:ln/>
+        </p:spPr>
+        <p:txBody>
+          <a:bodyPr wrap="square" lIns="0" tIns="0" rIns="0" bIns="0" rtlCol="0" anchor="ctr"/>
+          <a:lstStyle/>
+          <a:p>
+            <a:pPr indent="0" marL="0">
+              <a:buNone/>
+            </a:pPr>
+            <a:r>
+              <a:rPr lang="en-US" sz="1200" dirty="0">
+                <a:solidFill>
+                  <a:srgbClr val="5A5F73"/>
+                </a:solidFill>
+                <a:latin typeface="Calibri" pitchFamily="34" charset="0"/>
+                <a:ea typeface="Calibri" pitchFamily="34" charset="-122"/>
+                <a:cs typeface="Calibri" pitchFamily="34" charset="-120"/>
+              </a:rPr>
+              <a:t>Capas separadas, DTOs validados y límites por endpoint</a:t>
+            </a:r>
+            <a:endParaRPr lang="en-US" sz="1200" dirty="0"/>
+          </a:p>
+        </p:txBody>
+      </p:sp>
+      <p:sp>
+        <p:nvSpPr>
+          <p:cNvPr id="16" name="Text 14"/>
+          <p:cNvSpPr/>
+          <p:nvPr/>
+        </p:nvSpPr>
+        <p:spPr>
+          <a:xfrm>
+            <a:off x="777240" y="3694176"/>
+            <a:ext cx="731520" cy="365760"/>
+          </a:xfrm>
+          <a:prstGeom prst="rect">
+            <a:avLst/>
+          </a:prstGeom>
+          <a:noFill/>
+          <a:ln/>
+        </p:spPr>
+        <p:txBody>
+          <a:bodyPr wrap="square" lIns="0" tIns="0" rIns="0" bIns="0" rtlCol="0" anchor="ctr"/>
+          <a:lstStyle/>
+          <a:p>
+            <a:pPr indent="0" marL="0">
+              <a:buNone/>
+            </a:pPr>
+            <a:r>
+              <a:rPr lang="en-US" sz="1100" b="1" dirty="0">
+                <a:solidFill>
+                  <a:srgbClr val="202CFC"/>
+                </a:solidFill>
+                <a:latin typeface="Arial" pitchFamily="34" charset="0"/>
+                <a:ea typeface="Arial" pitchFamily="34" charset="-122"/>
+                <a:cs typeface="Arial" pitchFamily="34" charset="-120"/>
+              </a:rPr>
+              <a:t>A05</a:t>
+            </a:r>
+            <a:endParaRPr lang="en-US" sz="1100" dirty="0"/>
+          </a:p>
+        </p:txBody>
+      </p:sp>
+      <p:sp>
+        <p:nvSpPr>
+          <p:cNvPr id="17" name="Text 15"/>
+          <p:cNvSpPr/>
+          <p:nvPr/>
+        </p:nvSpPr>
+        <p:spPr>
+          <a:xfrm>
+            <a:off x="1508760" y="3694176"/>
+            <a:ext cx="3977640" cy="365760"/>
+          </a:xfrm>
+          <a:prstGeom prst="rect">
+            <a:avLst/>
+          </a:prstGeom>
+          <a:noFill/>
+          <a:ln/>
+        </p:spPr>
+        <p:txBody>
+          <a:bodyPr wrap="square" lIns="0" tIns="0" rIns="0" bIns="0" rtlCol="0" anchor="ctr"/>
+          <a:lstStyle/>
+          <a:p>
+            <a:pPr indent="0" marL="0">
+              <a:buNone/>
+            </a:pPr>
+            <a:r>
+              <a:rPr lang="en-US" sz="1150" b="1" dirty="0">
+                <a:solidFill>
+                  <a:srgbClr val="1A1C2E"/>
+                </a:solidFill>
+                <a:latin typeface="Arial" pitchFamily="34" charset="0"/>
+                <a:ea typeface="Arial" pitchFamily="34" charset="-122"/>
+                <a:cs typeface="Arial" pitchFamily="34" charset="-120"/>
+              </a:rPr>
+              <a:t>Security Misconfiguration</a:t>
+            </a:r>
+            <a:endParaRPr lang="en-US" sz="1150" dirty="0"/>
+          </a:p>
+        </p:txBody>
+      </p:sp>
+      <p:sp>
+        <p:nvSpPr>
+          <p:cNvPr id="18" name="Text 16"/>
+          <p:cNvSpPr/>
+          <p:nvPr/>
+        </p:nvSpPr>
+        <p:spPr>
+          <a:xfrm>
+            <a:off x="5577840" y="3694176"/>
+            <a:ext cx="5806440" cy="365760"/>
+          </a:xfrm>
+          <a:prstGeom prst="rect">
+            <a:avLst/>
+          </a:prstGeom>
+          <a:noFill/>
+          <a:ln/>
+        </p:spPr>
+        <p:txBody>
+          <a:bodyPr wrap="square" lIns="0" tIns="0" rIns="0" bIns="0" rtlCol="0" anchor="ctr"/>
+          <a:lstStyle/>
+          <a:p>
+            <a:pPr indent="0" marL="0">
+              <a:buNone/>
+            </a:pPr>
+            <a:r>
+              <a:rPr lang="en-US" sz="1200" dirty="0">
+                <a:solidFill>
+                  <a:srgbClr val="5A5F73"/>
+                </a:solidFill>
+                <a:latin typeface="Calibri" pitchFamily="34" charset="0"/>
+                <a:ea typeface="Calibri" pitchFamily="34" charset="-122"/>
+                <a:cs typeface="Calibri" pitchFamily="34" charset="-120"/>
+              </a:rPr>
+              <a:t>Helmet en la API, CSP en la interfaz, puertos en loopback</a:t>
+            </a:r>
+            <a:endParaRPr lang="en-US" sz="1200" dirty="0"/>
+          </a:p>
+        </p:txBody>
+      </p:sp>
+      <p:sp>
+        <p:nvSpPr>
+          <p:cNvPr id="19" name="Text 17"/>
+          <p:cNvSpPr/>
+          <p:nvPr/>
+        </p:nvSpPr>
+        <p:spPr>
+          <a:xfrm>
+            <a:off x="777240" y="4096512"/>
+            <a:ext cx="731520" cy="365760"/>
+          </a:xfrm>
+          <a:prstGeom prst="rect">
+            <a:avLst/>
+          </a:prstGeom>
+          <a:noFill/>
+          <a:ln/>
+        </p:spPr>
+        <p:txBody>
+          <a:bodyPr wrap="square" lIns="0" tIns="0" rIns="0" bIns="0" rtlCol="0" anchor="ctr"/>
+          <a:lstStyle/>
+          <a:p>
+            <a:pPr indent="0" marL="0">
+              <a:buNone/>
+            </a:pPr>
+            <a:r>
+              <a:rPr lang="en-US" sz="1100" b="1" dirty="0">
+                <a:solidFill>
+                  <a:srgbClr val="202CFC"/>
+                </a:solidFill>
+                <a:latin typeface="Arial" pitchFamily="34" charset="0"/>
+                <a:ea typeface="Arial" pitchFamily="34" charset="-122"/>
+                <a:cs typeface="Arial" pitchFamily="34" charset="-120"/>
+              </a:rPr>
+              <a:t>A06</a:t>
+            </a:r>
+            <a:endParaRPr lang="en-US" sz="1100" dirty="0"/>
+          </a:p>
+        </p:txBody>
+      </p:sp>
+      <p:sp>
+        <p:nvSpPr>
+          <p:cNvPr id="20" name="Text 18"/>
+          <p:cNvSpPr/>
+          <p:nvPr/>
+        </p:nvSpPr>
+        <p:spPr>
+          <a:xfrm>
+            <a:off x="1508760" y="4096512"/>
+            <a:ext cx="3977640" cy="365760"/>
+          </a:xfrm>
+          <a:prstGeom prst="rect">
+            <a:avLst/>
+          </a:prstGeom>
+          <a:noFill/>
+          <a:ln/>
+        </p:spPr>
+        <p:txBody>
+          <a:bodyPr wrap="square" lIns="0" tIns="0" rIns="0" bIns="0" rtlCol="0" anchor="ctr"/>
+          <a:lstStyle/>
+          <a:p>
+            <a:pPr indent="0" marL="0">
+              <a:buNone/>
+            </a:pPr>
+            <a:r>
+              <a:rPr lang="en-US" sz="1150" b="1" dirty="0">
+                <a:solidFill>
+                  <a:srgbClr val="1A1C2E"/>
+                </a:solidFill>
+                <a:latin typeface="Arial" pitchFamily="34" charset="0"/>
+                <a:ea typeface="Arial" pitchFamily="34" charset="-122"/>
+                <a:cs typeface="Arial" pitchFamily="34" charset="-120"/>
+              </a:rPr>
+              <a:t>Vulnerable and Outdated Components</a:t>
+            </a:r>
+            <a:endParaRPr lang="en-US" sz="1150" dirty="0"/>
+          </a:p>
+        </p:txBody>
+      </p:sp>
+      <p:sp>
+        <p:nvSpPr>
+          <p:cNvPr id="21" name="Text 19"/>
+          <p:cNvSpPr/>
+          <p:nvPr/>
+        </p:nvSpPr>
+        <p:spPr>
+          <a:xfrm>
+            <a:off x="5577840" y="4096512"/>
+            <a:ext cx="5806440" cy="365760"/>
+          </a:xfrm>
+          <a:prstGeom prst="rect">
+            <a:avLst/>
+          </a:prstGeom>
+          <a:noFill/>
+          <a:ln/>
+        </p:spPr>
+        <p:txBody>
+          <a:bodyPr wrap="square" lIns="0" tIns="0" rIns="0" bIns="0" rtlCol="0" anchor="ctr"/>
+          <a:lstStyle/>
+          <a:p>
+            <a:pPr indent="0" marL="0">
+              <a:buNone/>
+            </a:pPr>
+            <a:r>
+              <a:rPr lang="en-US" sz="1200" dirty="0">
+                <a:solidFill>
+                  <a:srgbClr val="5A5F73"/>
+                </a:solidFill>
+                <a:latin typeface="Calibri" pitchFamily="34" charset="0"/>
+                <a:ea typeface="Calibri" pitchFamily="34" charset="-122"/>
+                <a:cs typeface="Calibri" pitchFamily="34" charset="-120"/>
+              </a:rPr>
+              <a:t>Auditoría de dependencias en cada push, y es bloqueante</a:t>
+            </a:r>
+            <a:endParaRPr lang="en-US" sz="1200" dirty="0"/>
+          </a:p>
+        </p:txBody>
+      </p:sp>
+      <p:sp>
+        <p:nvSpPr>
+          <p:cNvPr id="22" name="Text 20"/>
+          <p:cNvSpPr/>
+          <p:nvPr/>
+        </p:nvSpPr>
+        <p:spPr>
+          <a:xfrm>
+            <a:off x="777240" y="4498848"/>
+            <a:ext cx="731520" cy="365760"/>
+          </a:xfrm>
+          <a:prstGeom prst="rect">
+            <a:avLst/>
+          </a:prstGeom>
+          <a:noFill/>
+          <a:ln/>
+        </p:spPr>
+        <p:txBody>
+          <a:bodyPr wrap="square" lIns="0" tIns="0" rIns="0" bIns="0" rtlCol="0" anchor="ctr"/>
+          <a:lstStyle/>
+          <a:p>
+            <a:pPr indent="0" marL="0">
+              <a:buNone/>
+            </a:pPr>
+            <a:r>
+              <a:rPr lang="en-US" sz="1100" b="1" dirty="0">
+                <a:solidFill>
+                  <a:srgbClr val="202CFC"/>
+                </a:solidFill>
+                <a:latin typeface="Arial" pitchFamily="34" charset="0"/>
+                <a:ea typeface="Arial" pitchFamily="34" charset="-122"/>
+                <a:cs typeface="Arial" pitchFamily="34" charset="-120"/>
+              </a:rPr>
+              <a:t>A07</a:t>
+            </a:r>
+            <a:endParaRPr lang="en-US" sz="1100" dirty="0"/>
+          </a:p>
+        </p:txBody>
+      </p:sp>
+      <p:sp>
+        <p:nvSpPr>
+          <p:cNvPr id="23" name="Text 21"/>
+          <p:cNvSpPr/>
+          <p:nvPr/>
+        </p:nvSpPr>
+        <p:spPr>
+          <a:xfrm>
+            <a:off x="1508760" y="4498848"/>
+            <a:ext cx="3977640" cy="365760"/>
+          </a:xfrm>
+          <a:prstGeom prst="rect">
+            <a:avLst/>
+          </a:prstGeom>
+          <a:noFill/>
+          <a:ln/>
+        </p:spPr>
+        <p:txBody>
+          <a:bodyPr wrap="square" lIns="0" tIns="0" rIns="0" bIns="0" rtlCol="0" anchor="ctr"/>
+          <a:lstStyle/>
+          <a:p>
+            <a:pPr indent="0" marL="0">
+              <a:buNone/>
+            </a:pPr>
+            <a:r>
+              <a:rPr lang="en-US" sz="1150" b="1" dirty="0">
+                <a:solidFill>
+                  <a:srgbClr val="1A1C2E"/>
+                </a:solidFill>
+                <a:latin typeface="Arial" pitchFamily="34" charset="0"/>
+                <a:ea typeface="Arial" pitchFamily="34" charset="-122"/>
+                <a:cs typeface="Arial" pitchFamily="34" charset="-120"/>
+              </a:rPr>
+              <a:t>Identification and Authentication Failures</a:t>
+            </a:r>
+            <a:endParaRPr lang="en-US" sz="1150" dirty="0"/>
+          </a:p>
+        </p:txBody>
+      </p:sp>
+      <p:sp>
+        <p:nvSpPr>
+          <p:cNvPr id="24" name="Text 22"/>
+          <p:cNvSpPr/>
+          <p:nvPr/>
+        </p:nvSpPr>
+        <p:spPr>
+          <a:xfrm>
+            <a:off x="5577840" y="4498848"/>
+            <a:ext cx="5806440" cy="365760"/>
+          </a:xfrm>
+          <a:prstGeom prst="rect">
+            <a:avLst/>
+          </a:prstGeom>
+          <a:noFill/>
+          <a:ln/>
+        </p:spPr>
+        <p:txBody>
+          <a:bodyPr wrap="square" lIns="0" tIns="0" rIns="0" bIns="0" rtlCol="0" anchor="ctr"/>
+          <a:lstStyle/>
+          <a:p>
+            <a:pPr indent="0" marL="0">
+              <a:buNone/>
+            </a:pPr>
+            <a:r>
+              <a:rPr lang="en-US" sz="1200" dirty="0">
+                <a:solidFill>
+                  <a:srgbClr val="5A5F73"/>
+                </a:solidFill>
+                <a:latin typeface="Calibri" pitchFamily="34" charset="0"/>
+                <a:ea typeface="Calibri" pitchFamily="34" charset="-122"/>
+                <a:cs typeface="Calibri" pitchFamily="34" charset="-120"/>
+              </a:rPr>
+              <a:t>Segundo factor, bloqueo de cuenta y contraseña con reglas</a:t>
+            </a:r>
+            <a:endParaRPr lang="en-US" sz="1200" dirty="0"/>
+          </a:p>
+        </p:txBody>
+      </p:sp>
+      <p:sp>
+        <p:nvSpPr>
+          <p:cNvPr id="25" name="Text 23"/>
+          <p:cNvSpPr/>
+          <p:nvPr/>
+        </p:nvSpPr>
+        <p:spPr>
+          <a:xfrm>
+            <a:off x="777240" y="4901184"/>
+            <a:ext cx="731520" cy="365760"/>
+          </a:xfrm>
+          <a:prstGeom prst="rect">
+            <a:avLst/>
+          </a:prstGeom>
+          <a:noFill/>
+          <a:ln/>
+        </p:spPr>
+        <p:txBody>
+          <a:bodyPr wrap="square" lIns="0" tIns="0" rIns="0" bIns="0" rtlCol="0" anchor="ctr"/>
+          <a:lstStyle/>
+          <a:p>
+            <a:pPr indent="0" marL="0">
+              <a:buNone/>
+            </a:pPr>
+            <a:r>
+              <a:rPr lang="en-US" sz="1100" b="1" dirty="0">
+                <a:solidFill>
+                  <a:srgbClr val="202CFC"/>
+                </a:solidFill>
+                <a:latin typeface="Arial" pitchFamily="34" charset="0"/>
+                <a:ea typeface="Arial" pitchFamily="34" charset="-122"/>
+                <a:cs typeface="Arial" pitchFamily="34" charset="-120"/>
+              </a:rPr>
+              <a:t>A08</a:t>
+            </a:r>
+            <a:endParaRPr lang="en-US" sz="1100" dirty="0"/>
+          </a:p>
+        </p:txBody>
+      </p:sp>
+      <p:sp>
+        <p:nvSpPr>
+          <p:cNvPr id="26" name="Text 24"/>
+          <p:cNvSpPr/>
+          <p:nvPr/>
+        </p:nvSpPr>
+        <p:spPr>
+          <a:xfrm>
+            <a:off x="1508760" y="4901184"/>
+            <a:ext cx="3977640" cy="365760"/>
+          </a:xfrm>
+          <a:prstGeom prst="rect">
+            <a:avLst/>
+          </a:prstGeom>
+          <a:noFill/>
+          <a:ln/>
+        </p:spPr>
+        <p:txBody>
+          <a:bodyPr wrap="square" lIns="0" tIns="0" rIns="0" bIns="0" rtlCol="0" anchor="ctr"/>
+          <a:lstStyle/>
+          <a:p>
+            <a:pPr indent="0" marL="0">
+              <a:buNone/>
+            </a:pPr>
+            <a:r>
+              <a:rPr lang="en-US" sz="1150" b="1" dirty="0">
+                <a:solidFill>
+                  <a:srgbClr val="1A1C2E"/>
+                </a:solidFill>
+                <a:latin typeface="Arial" pitchFamily="34" charset="0"/>
+                <a:ea typeface="Arial" pitchFamily="34" charset="-122"/>
+                <a:cs typeface="Arial" pitchFamily="34" charset="-120"/>
+              </a:rPr>
+              <a:t>Software and Data Integrity Failures</a:t>
+            </a:r>
+            <a:endParaRPr lang="en-US" sz="1150" dirty="0"/>
+          </a:p>
+        </p:txBody>
+      </p:sp>
+      <p:sp>
+        <p:nvSpPr>
+          <p:cNvPr id="27" name="Text 25"/>
+          <p:cNvSpPr/>
+          <p:nvPr/>
+        </p:nvSpPr>
+        <p:spPr>
+          <a:xfrm>
+            <a:off x="5577840" y="4901184"/>
+            <a:ext cx="5806440" cy="365760"/>
+          </a:xfrm>
+          <a:prstGeom prst="rect">
+            <a:avLst/>
+          </a:prstGeom>
+          <a:noFill/>
+          <a:ln/>
+        </p:spPr>
+        <p:txBody>
+          <a:bodyPr wrap="square" lIns="0" tIns="0" rIns="0" bIns="0" rtlCol="0" anchor="ctr"/>
+          <a:lstStyle/>
+          <a:p>
+            <a:pPr indent="0" marL="0">
+              <a:buNone/>
+            </a:pPr>
+            <a:r>
+              <a:rPr lang="en-US" sz="1200" dirty="0">
+                <a:solidFill>
+                  <a:srgbClr val="5A5F73"/>
+                </a:solidFill>
+                <a:latin typeface="Calibri" pitchFamily="34" charset="0"/>
+                <a:ea typeface="Calibri" pitchFamily="34" charset="-122"/>
+                <a:cs typeface="Calibri" pitchFamily="34" charset="-120"/>
+              </a:rPr>
+              <a:t>Lockfile, imágenes por commit y despliegue solo tras CI verde</a:t>
+            </a:r>
+            <a:endParaRPr lang="en-US" sz="1200" dirty="0"/>
+          </a:p>
+        </p:txBody>
+      </p:sp>
+      <p:sp>
+        <p:nvSpPr>
+          <p:cNvPr id="28" name="Text 26"/>
+          <p:cNvSpPr/>
+          <p:nvPr/>
+        </p:nvSpPr>
+        <p:spPr>
+          <a:xfrm>
+            <a:off x="777240" y="5303520"/>
+            <a:ext cx="731520" cy="365760"/>
+          </a:xfrm>
+          <a:prstGeom prst="rect">
+            <a:avLst/>
+          </a:prstGeom>
+          <a:noFill/>
+          <a:ln/>
+        </p:spPr>
+        <p:txBody>
+          <a:bodyPr wrap="square" lIns="0" tIns="0" rIns="0" bIns="0" rtlCol="0" anchor="ctr"/>
+          <a:lstStyle/>
+          <a:p>
+            <a:pPr indent="0" marL="0">
+              <a:buNone/>
+            </a:pPr>
+            <a:r>
+              <a:rPr lang="en-US" sz="1100" b="1" dirty="0">
+                <a:solidFill>
+                  <a:srgbClr val="202CFC"/>
+                </a:solidFill>
+                <a:latin typeface="Arial" pitchFamily="34" charset="0"/>
+                <a:ea typeface="Arial" pitchFamily="34" charset="-122"/>
+                <a:cs typeface="Arial" pitchFamily="34" charset="-120"/>
+              </a:rPr>
+              <a:t>A09</a:t>
+            </a:r>
+            <a:endParaRPr lang="en-US" sz="1100" dirty="0"/>
+          </a:p>
+        </p:txBody>
+      </p:sp>
+      <p:sp>
+        <p:nvSpPr>
+          <p:cNvPr id="29" name="Text 27"/>
+          <p:cNvSpPr/>
+          <p:nvPr/>
+        </p:nvSpPr>
+        <p:spPr>
+          <a:xfrm>
+            <a:off x="1508760" y="5303520"/>
+            <a:ext cx="3977640" cy="365760"/>
+          </a:xfrm>
+          <a:prstGeom prst="rect">
+            <a:avLst/>
+          </a:prstGeom>
+          <a:noFill/>
+          <a:ln/>
+        </p:spPr>
+        <p:txBody>
+          <a:bodyPr wrap="square" lIns="0" tIns="0" rIns="0" bIns="0" rtlCol="0" anchor="ctr"/>
+          <a:lstStyle/>
+          <a:p>
+            <a:pPr indent="0" marL="0">
+              <a:buNone/>
+            </a:pPr>
+            <a:r>
+              <a:rPr lang="en-US" sz="1150" b="1" dirty="0">
+                <a:solidFill>
+                  <a:srgbClr val="1A1C2E"/>
+                </a:solidFill>
+                <a:latin typeface="Arial" pitchFamily="34" charset="0"/>
+                <a:ea typeface="Arial" pitchFamily="34" charset="-122"/>
+                <a:cs typeface="Arial" pitchFamily="34" charset="-120"/>
+              </a:rPr>
+              <a:t>Security Logging and Monitoring Failures</a:t>
+            </a:r>
+            <a:endParaRPr lang="en-US" sz="1150" dirty="0"/>
+          </a:p>
+        </p:txBody>
+      </p:sp>
+      <p:sp>
+        <p:nvSpPr>
+          <p:cNvPr id="30" name="Text 28"/>
+          <p:cNvSpPr/>
+          <p:nvPr/>
+        </p:nvSpPr>
+        <p:spPr>
+          <a:xfrm>
+            <a:off x="5577840" y="5303520"/>
+            <a:ext cx="5806440" cy="365760"/>
+          </a:xfrm>
+          <a:prstGeom prst="rect">
+            <a:avLst/>
+          </a:prstGeom>
+          <a:noFill/>
+          <a:ln/>
+        </p:spPr>
+        <p:txBody>
+          <a:bodyPr wrap="square" lIns="0" tIns="0" rIns="0" bIns="0" rtlCol="0" anchor="ctr"/>
+          <a:lstStyle/>
+          <a:p>
+            <a:pPr indent="0" marL="0">
+              <a:buNone/>
+            </a:pPr>
+            <a:r>
+              <a:rPr lang="en-US" sz="1200" dirty="0">
+                <a:solidFill>
+                  <a:srgbClr val="5A5F73"/>
+                </a:solidFill>
+                <a:latin typeface="Calibri" pitchFamily="34" charset="0"/>
+                <a:ea typeface="Calibri" pitchFamily="34" charset="-122"/>
+                <a:cs typeface="Calibri" pitchFamily="34" charset="-120"/>
+              </a:rPr>
+              <a:t>Registro estructurado y auditoría con IP, usuario y duración</a:t>
+            </a:r>
+            <a:endParaRPr lang="en-US" sz="1200" dirty="0"/>
+          </a:p>
+        </p:txBody>
+      </p:sp>
+      <p:sp>
+        <p:nvSpPr>
+          <p:cNvPr id="31" name="Text 29"/>
+          <p:cNvSpPr/>
+          <p:nvPr/>
+        </p:nvSpPr>
+        <p:spPr>
+          <a:xfrm>
+            <a:off x="777240" y="5705856"/>
+            <a:ext cx="731520" cy="365760"/>
+          </a:xfrm>
+          <a:prstGeom prst="rect">
+            <a:avLst/>
+          </a:prstGeom>
+          <a:noFill/>
+          <a:ln/>
+        </p:spPr>
+        <p:txBody>
+          <a:bodyPr wrap="square" lIns="0" tIns="0" rIns="0" bIns="0" rtlCol="0" anchor="ctr"/>
+          <a:lstStyle/>
+          <a:p>
+            <a:pPr indent="0" marL="0">
+              <a:buNone/>
+            </a:pPr>
+            <a:r>
+              <a:rPr lang="en-US" sz="1100" b="1" dirty="0">
+                <a:solidFill>
+                  <a:srgbClr val="202CFC"/>
+                </a:solidFill>
+                <a:latin typeface="Arial" pitchFamily="34" charset="0"/>
+                <a:ea typeface="Arial" pitchFamily="34" charset="-122"/>
+                <a:cs typeface="Arial" pitchFamily="34" charset="-120"/>
+              </a:rPr>
+              <a:t>A10</a:t>
+            </a:r>
+            <a:endParaRPr lang="en-US" sz="1100" dirty="0"/>
+          </a:p>
+        </p:txBody>
+      </p:sp>
+      <p:sp>
+        <p:nvSpPr>
+          <p:cNvPr id="32" name="Text 30"/>
+          <p:cNvSpPr/>
+          <p:nvPr/>
+        </p:nvSpPr>
+        <p:spPr>
+          <a:xfrm>
+            <a:off x="1508760" y="5705856"/>
+            <a:ext cx="3977640" cy="365760"/>
+          </a:xfrm>
+          <a:prstGeom prst="rect">
+            <a:avLst/>
+          </a:prstGeom>
+          <a:noFill/>
+          <a:ln/>
+        </p:spPr>
+        <p:txBody>
+          <a:bodyPr wrap="square" lIns="0" tIns="0" rIns="0" bIns="0" rtlCol="0" anchor="ctr"/>
+          <a:lstStyle/>
+          <a:p>
+            <a:pPr indent="0" marL="0">
+              <a:buNone/>
+            </a:pPr>
+            <a:r>
+              <a:rPr lang="en-US" sz="1150" b="1" dirty="0">
+                <a:solidFill>
+                  <a:srgbClr val="1A1C2E"/>
+                </a:solidFill>
+                <a:latin typeface="Arial" pitchFamily="34" charset="0"/>
+                <a:ea typeface="Arial" pitchFamily="34" charset="-122"/>
+                <a:cs typeface="Arial" pitchFamily="34" charset="-120"/>
+              </a:rPr>
+              <a:t>Server-Side Request Forgery</a:t>
+            </a:r>
+            <a:endParaRPr lang="en-US" sz="1150" dirty="0"/>
+          </a:p>
+        </p:txBody>
+      </p:sp>
+      <p:sp>
+        <p:nvSpPr>
+          <p:cNvPr id="33" name="Text 31"/>
+          <p:cNvSpPr/>
+          <p:nvPr/>
+        </p:nvSpPr>
+        <p:spPr>
+          <a:xfrm>
+            <a:off x="5577840" y="5705856"/>
+            <a:ext cx="5806440" cy="365760"/>
+          </a:xfrm>
+          <a:prstGeom prst="rect">
+            <a:avLst/>
+          </a:prstGeom>
+          <a:noFill/>
+          <a:ln/>
+        </p:spPr>
+        <p:txBody>
+          <a:bodyPr wrap="square" lIns="0" tIns="0" rIns="0" bIns="0" rtlCol="0" anchor="ctr"/>
+          <a:lstStyle/>
+          <a:p>
+            <a:pPr indent="0" marL="0">
+              <a:buNone/>
+            </a:pPr>
+            <a:r>
+              <a:rPr lang="en-US" sz="1200" dirty="0">
+                <a:solidFill>
+                  <a:srgbClr val="5A5F73"/>
+                </a:solidFill>
+                <a:latin typeface="Calibri" pitchFamily="34" charset="0"/>
+                <a:ea typeface="Calibri" pitchFamily="34" charset="-122"/>
+                <a:cs typeface="Calibri" pitchFamily="34" charset="-120"/>
+              </a:rPr>
+              <a:t>El usuario no controla ninguna URL de salida</a:t>
+            </a:r>
+            <a:endParaRPr lang="en-US" sz="1200" dirty="0"/>
+          </a:p>
+        </p:txBody>
+      </p:sp>
+      <p:sp>
+        <p:nvSpPr>
+          <p:cNvPr id="34" name="Shape 32"/>
           <p:cNvSpPr/>
           <p:nvPr/>
         </p:nvSpPr>
@@ -9639,7 +10493,7 @@
       </p:sp>
       <p:sp>
         <p:nvSpPr>
-          <p:cNvPr id="9" name="Text 7"/>
+          <p:cNvPr id="35" name="Text 33"/>
           <p:cNvSpPr/>
           <p:nvPr/>
         </p:nvSpPr>
@@ -9678,7 +10532,7 @@
       </p:sp>
       <p:sp>
         <p:nvSpPr>
-          <p:cNvPr id="10" name="Text 8"/>
+          <p:cNvPr id="36" name="Text 34"/>
           <p:cNvSpPr/>
           <p:nvPr/>
         </p:nvSpPr>
@@ -9717,7 +10571,7 @@
       </p:sp>
       <p:sp>
         <p:nvSpPr>
-          <p:cNvPr id="11" name="Text 9"/>
+          <p:cNvPr id="37" name="Text 35"/>
           <p:cNvSpPr/>
           <p:nvPr/>
         </p:nvSpPr>

</xml_diff>

<commit_message>
docs(tfm): Top 10 web a la edicion 2025 y agrupar proceso y seguridad
</commit_message>
<xml_diff>
--- a/docs/presentacion/tfm-intelligent-automotive-diagnostics.pptx
+++ b/docs/presentacion/tfm-intelligent-automotive-diagnostics.pptx
@@ -1171,14 +1171,12 @@
           <a:p>
             <a:r>
               <a:rPr lang="en-US" dirty="0"/>
-              <a:t>Esta es la tabla de seguridad. Uso el API Security Top 10 y no el Top 10 de aplicaciones web porque lo que este proyecto expone es una API REST: sus tres primeros riesgos son fallos de autorización a nivel de objeto, de propiedad y de función, que en la lista web ni siquiera aparecen como categorías propias.
-No la voy a leer entera, pero quiero que se vea que las diez categorías están cubiertas con una medida concreta y no con una declaración de intenciones.
-Destaco cuatro. La primera: cuando pides una sesión de diagnóstico que no es tuya, la API responde 404 y no 403, para no confirmar siquiera que existe.
-La cuarta: los límites de peticiones no son uno global, van por familia. El diagnóstico cognitivo, que es el que cuesta dinero porque llama al modelo, tiene el más estricto, cinco por minuto.
-La sexta es la que más me importa por lo que hay al otro lado: el borrado de códigos de avería es el único flujo destructivo sobre el coche, así que tiene su propio límite y se puede apagar entero con una variable de entorno. Y además el adaptador valida el modo OBD contra una lista blanca antes de tocar el socket, con un test de invariante que falla si alguien añade un método que emita un servicio de control.
-Y la décima: todo lo que viene de fuera —la búsqueda web y los casos previos de otros talleres— llega al modelo etiquetado como material no fiable, y el system prompt le dice que eso es referencia y nunca una orden.
-Los riesgos residuales están escritos y asumidos, no escondidos: los tokens en localStorage, la ausencia de MFA, la base sin cifrar en disco y los límites de peticiones en memoria.
-[~60 s · acumulado 17:45]</a:t>
+              <a:t>Todo el ciclo está automatizado con GitHub Actions, y son dos flujos distintos.
+El de integración continua se ejecuta en cada push y en cada pull request contra main y develop. Levanta las dos aplicaciones en paralelo sobre Node 22 y pasa lint, formato, las pruebas, la compilación y el typecheck. Y remata con una auditoría de dependencias que detiene la entrega si aparece una vulnerabilidad crítica.
+El de despliegue se dispara solo cuando algo entra en main, que es la rama de releases. Construye tres imágenes Docker: la API, la interfaz y el emulador ELM327. Usa caché de la propia plataforma, así que las construcciones sucesivas son rápidas. Las publica en el registro de contenedores de GitHub.
+Y después entra por SSH al servidor, descarga las imágenes nuevas, levanta los contenedores con la configuración de producción y limpia las imágenes viejas. Sin que yo toque nada.
+La consecuencia práctica es que integrar en main es publicar. La aplicación está desplegada y accesible, no es una demo que solo corre en mi portátil.
+[~55 s · acumulado 17:40]</a:t>
             </a:r>
             <a:endParaRPr lang="en-US" dirty="0"/>
           </a:p>
@@ -1266,11 +1264,14 @@
           <a:p>
             <a:r>
               <a:rPr lang="en-US" dirty="0"/>
-              <a:t>La lista anterior cubre el backend, que es una API. La interfaz es otra cosa: es una aplicación web, y ahí aplica el Top 10 clásico. Mismo ejercicio: las diez categorías con la medida concreta.
-Destaco lo que es propio de la interfaz. React escapa el HTML por defecto y no se inyecta marcado en crudo en ningún sitio con datos del usuario, que es por donde entra el XSS. La política de contenido la sirve el nginx que sirve la interfaz, con script-src propio y sin scripts en línea, y hay una comprobación en integración continua que arranca nginx y verifica que las cabeceras salen. Los formularios validan con los mismos esquemas Zod que usa la API, así que cliente y servidor no se pueden desincronizar.
-En la A05 quiero pararme: hasta esta semana los contenedores publicaban sus puertos en todas las interfaces, o sea que se podía llegar a la API por la IP del servidor sin pasar por el proxy, y con ello saltarse el TLS y falsear la IP de origen. Ahora la API y la interfaz solo se publican en loopback y los emuladores no se publican en absoluto. Desde fuera solo queda el 443.
-Y una decisión consciente en la A02: el token viaja en cabecera Bearer y no en cookie. Eso elimina el CSRF de raíz, y a cambio vive en el navegador. La respuesta a eso no es esconderlo, es que no haya por dónde leerlo, que es todo lo de arriba. El secreto del segundo factor, que sí sería una llave, va cifrado con AES-256-GCM y su clave no vive en la base de datos.
-[~50 s · acumulado 18:35]</a:t>
+              <a:t>Esta es la tabla de seguridad. Uso el API Security Top 10 y no el Top 10 de aplicaciones web porque lo que este proyecto expone es una API REST: sus tres primeros riesgos son fallos de autorización a nivel de objeto, de propiedad y de función, que en la lista web ni siquiera aparecen como categorías propias.
+No la voy a leer entera, pero quiero que se vea que las diez categorías están cubiertas con una medida concreta y no con una declaración de intenciones.
+Destaco cuatro. La primera: cuando pides una sesión de diagnóstico que no es tuya, la API responde 404 y no 403, para no confirmar siquiera que existe.
+La cuarta: los límites de peticiones no son uno global, van por familia. El diagnóstico cognitivo, que es el que cuesta dinero porque llama al modelo, tiene el más estricto, cinco por minuto.
+La sexta es la que más me importa por lo que hay al otro lado: el borrado de códigos de avería es el único flujo destructivo sobre el coche, así que tiene su propio límite y se puede apagar entero con una variable de entorno. Y además el adaptador valida el modo OBD contra una lista blanca antes de tocar el socket, con un test de invariante que falla si alguien añade un método que emita un servicio de control.
+Y la décima: todo lo que viene de fuera —la búsqueda web y los casos previos de otros talleres— llega al modelo etiquetado como material no fiable, y el system prompt le dice que eso es referencia y nunca una orden.
+Los riesgos residuales están escritos y asumidos, no escondidos: los tokens en localStorage, la ausencia de MFA, la base sin cifrar en disco y los límites de peticiones en memoria.
+[~60 s · acumulado 18:40]</a:t>
             </a:r>
             <a:endParaRPr lang="en-US" dirty="0"/>
           </a:p>
@@ -1358,12 +1359,11 @@
           <a:p>
             <a:r>
               <a:rPr lang="en-US" dirty="0"/>
-              <a:t>Todo el ciclo está automatizado con GitHub Actions, y son dos flujos distintos.
-El de integración continua se ejecuta en cada push y en cada pull request contra main y develop. Levanta las dos aplicaciones en paralelo sobre Node 22 y pasa lint, formato, las pruebas, la compilación y el typecheck. Y remata con una auditoría de dependencias que detiene la entrega si aparece una vulnerabilidad crítica.
-El de despliegue se dispara solo cuando algo entra en main, que es la rama de releases. Construye tres imágenes Docker: la API, la interfaz y el emulador ELM327. Usa caché de la propia plataforma, así que las construcciones sucesivas son rápidas. Las publica en el registro de contenedores de GitHub.
-Y después entra por SSH al servidor, descarga las imágenes nuevas, levanta los contenedores con la configuración de producción y limpia las imágenes viejas. Sin que yo toque nada.
-La consecuencia práctica es que integrar en main es publicar. La aplicación está desplegada y accesible, no es una demo que solo corre en mi portátil.
-[~55 s · acumulado 19:30]</a:t>
+              <a:t>La lista anterior cubre el backend, que es una API. La interfaz es otra cosa: es una aplicación web, y ahí aplica el Top 10 general, en su edición de 2025. Mismo ejercicio: las diez categorías con la medida concreta.
+Destaco lo que es propio de la interfaz. React escapa el HTML por defecto y no se inyecta marcado en crudo en ningún sitio con datos del usuario, que es por donde entra el XSS. La política de contenido la sirve el nginx que sirve la interfaz, con script-src propio y sin scripts en línea, y hay una comprobación en integración continua que arranca nginx y verifica que las cabeceras salen. Los formularios validan con los mismos esquemas Zod que usa la API, así que cliente y servidor no se pueden desincronizar.
+En la A02 quiero pararme: hasta esta semana los contenedores publicaban sus puertos en todas las interfaces, o sea que se podía llegar a la API por la IP del servidor sin pasar por el proxy, y con ello saltarse el TLS y falsear la IP de origen. Ahora la API y la interfaz solo se publican en loopback y los emuladores no se publican en absoluto. Desde fuera solo queda el 443.
+Y una decisión consciente en la A04: el token viaja en cabecera Bearer y no en cookie. Eso elimina el CSRF de raíz, y a cambio vive en el navegador. La respuesta a eso no es esconderlo, es que no haya por dónde leerlo, que es todo lo de arriba. El secreto del segundo factor, que sí sería una llave, va cifrado con AES-256-GCM y su clave no vive en la base de datos.
+[~50 s · acumulado 19:30]</a:t>
             </a:r>
             <a:endParaRPr lang="en-US" dirty="0"/>
           </a:p>
@@ -7814,8 +7814,8 @@
         </p:nvSpPr>
         <p:spPr>
           <a:xfrm>
-            <a:off x="777240" y="640080"/>
-            <a:ext cx="10607040" cy="777240"/>
+            <a:off x="777240" y="502920"/>
+            <a:ext cx="10607040" cy="685800"/>
           </a:xfrm>
           <a:prstGeom prst="rect">
             <a:avLst/>
@@ -7831,7 +7831,7 @@
               <a:buNone/>
             </a:pPr>
             <a:r>
-              <a:rPr lang="en-US" sz="3400" b="1" dirty="0">
+              <a:rPr lang="en-US" sz="3200" b="1" dirty="0">
                 <a:solidFill>
                   <a:srgbClr val="1A1C2E"/>
                 </a:solidFill>
@@ -7839,9 +7839,9 @@
                 <a:ea typeface="Arial" pitchFamily="34" charset="-122"/>
                 <a:cs typeface="Arial" pitchFamily="34" charset="-120"/>
               </a:rPr>
-              <a:t>OWASP API Top 10 2023</a:t>
-            </a:r>
-            <a:endParaRPr lang="en-US" sz="3400" dirty="0"/>
+              <a:t>Integración y despliegue continuos</a:t>
+            </a:r>
+            <a:endParaRPr lang="en-US" sz="3200" dirty="0"/>
           </a:p>
         </p:txBody>
       </p:sp>
@@ -7853,8 +7853,8 @@
         </p:nvSpPr>
         <p:spPr>
           <a:xfrm>
-            <a:off x="777240" y="1481328"/>
-            <a:ext cx="10607040" cy="365760"/>
+            <a:off x="777240" y="1261872"/>
+            <a:ext cx="10607040" cy="320040"/>
           </a:xfrm>
           <a:prstGeom prst="rect">
             <a:avLst/>
@@ -7870,7 +7870,7 @@
               <a:buNone/>
             </a:pPr>
             <a:r>
-              <a:rPr lang="en-US" sz="1700" dirty="0">
+              <a:rPr lang="en-US" sz="1500" dirty="0">
                 <a:solidFill>
                   <a:srgbClr val="5A5F73"/>
                 </a:solidFill>
@@ -7878,46 +7878,73 @@
                 <a:ea typeface="Calibri" pitchFamily="34" charset="-122"/>
                 <a:cs typeface="Calibri" pitchFamily="34" charset="-120"/>
               </a:rPr>
-              <a:t>El backend es una API REST, así que la lista que aplica es la de APIs.</a:t>
-            </a:r>
-            <a:endParaRPr lang="en-US" sz="1700" dirty="0"/>
-          </a:p>
-        </p:txBody>
-      </p:sp>
-      <p:sp>
-        <p:nvSpPr>
-          <p:cNvPr id="4" name="Text 2"/>
-          <p:cNvSpPr/>
-          <p:nvPr/>
-        </p:nvSpPr>
-        <p:spPr>
-          <a:xfrm>
-            <a:off x="777240" y="2084832"/>
-            <a:ext cx="731520" cy="365760"/>
-          </a:xfrm>
-          <a:prstGeom prst="rect">
-            <a:avLst/>
-          </a:prstGeom>
-          <a:noFill/>
-          <a:ln/>
-        </p:spPr>
-        <p:txBody>
-          <a:bodyPr wrap="square" lIns="0" tIns="0" rIns="0" bIns="0" rtlCol="0" anchor="ctr"/>
-          <a:lstStyle/>
-          <a:p>
-            <a:pPr indent="0" marL="0">
+              <a:t>Integrar en main publica en producción, pero solo si la verificación ha pasado antes.</a:t>
+            </a:r>
+            <a:endParaRPr lang="en-US" sz="1500" dirty="0"/>
+          </a:p>
+        </p:txBody>
+      </p:sp>
+      <p:sp>
+        <p:nvSpPr>
+          <p:cNvPr id="4" name="Shape 2"/>
+          <p:cNvSpPr/>
+          <p:nvPr/>
+        </p:nvSpPr>
+        <p:spPr>
+          <a:xfrm>
+            <a:off x="777240" y="1874520"/>
+            <a:ext cx="1828800" cy="868680"/>
+          </a:xfrm>
+          <a:prstGeom prst="roundRect">
+            <a:avLst>
+              <a:gd name="adj" fmla="val 6316"/>
+            </a:avLst>
+          </a:prstGeom>
+          <a:solidFill>
+            <a:srgbClr val="FFFFFF"/>
+          </a:solidFill>
+          <a:ln w="12700">
+            <a:solidFill>
+              <a:srgbClr val="C9CCD8"/>
+            </a:solidFill>
+            <a:prstDash val="solid"/>
+          </a:ln>
+        </p:spPr>
+      </p:sp>
+      <p:sp>
+        <p:nvSpPr>
+          <p:cNvPr id="5" name="Text 3"/>
+          <p:cNvSpPr/>
+          <p:nvPr/>
+        </p:nvSpPr>
+        <p:spPr>
+          <a:xfrm>
+            <a:off x="850392" y="1993392"/>
+            <a:ext cx="1682496" cy="274320"/>
+          </a:xfrm>
+          <a:prstGeom prst="rect">
+            <a:avLst/>
+          </a:prstGeom>
+          <a:noFill/>
+          <a:ln/>
+        </p:spPr>
+        <p:txBody>
+          <a:bodyPr wrap="square" lIns="0" tIns="0" rIns="0" bIns="0" rtlCol="0" anchor="ctr"/>
+          <a:lstStyle/>
+          <a:p>
+            <a:pPr algn="ctr" indent="0" marL="0">
               <a:buNone/>
             </a:pPr>
             <a:r>
               <a:rPr lang="en-US" sz="1100" b="1" dirty="0">
                 <a:solidFill>
-                  <a:srgbClr val="202CFC"/>
+                  <a:srgbClr val="1A1C2E"/>
                 </a:solidFill>
                 <a:latin typeface="Arial" pitchFamily="34" charset="0"/>
                 <a:ea typeface="Arial" pitchFamily="34" charset="-122"/>
                 <a:cs typeface="Arial" pitchFamily="34" charset="-120"/>
               </a:rPr>
-              <a:t>API1</a:t>
+              <a:t>Integración en main</a:t>
             </a:r>
             <a:endParaRPr lang="en-US" sz="1100" dirty="0"/>
           </a:p>
@@ -7925,30 +7952,123 @@
       </p:sp>
       <p:sp>
         <p:nvSpPr>
-          <p:cNvPr id="5" name="Text 3"/>
-          <p:cNvSpPr/>
-          <p:nvPr/>
-        </p:nvSpPr>
-        <p:spPr>
-          <a:xfrm>
-            <a:off x="1508760" y="2084832"/>
-            <a:ext cx="3977640" cy="365760"/>
-          </a:xfrm>
-          <a:prstGeom prst="rect">
-            <a:avLst/>
-          </a:prstGeom>
-          <a:noFill/>
-          <a:ln/>
-        </p:spPr>
-        <p:txBody>
-          <a:bodyPr wrap="square" lIns="0" tIns="0" rIns="0" bIns="0" rtlCol="0" anchor="ctr"/>
-          <a:lstStyle/>
-          <a:p>
-            <a:pPr indent="0" marL="0">
-              <a:buNone/>
-            </a:pPr>
-            <a:r>
-              <a:rPr lang="en-US" sz="1150" b="1" dirty="0">
+          <p:cNvPr id="6" name="Text 4"/>
+          <p:cNvSpPr/>
+          <p:nvPr/>
+        </p:nvSpPr>
+        <p:spPr>
+          <a:xfrm>
+            <a:off x="850392" y="2276856"/>
+            <a:ext cx="1682496" cy="384048"/>
+          </a:xfrm>
+          <a:prstGeom prst="rect">
+            <a:avLst/>
+          </a:prstGeom>
+          <a:noFill/>
+          <a:ln/>
+        </p:spPr>
+        <p:txBody>
+          <a:bodyPr wrap="square" lIns="0" tIns="0" rIns="0" bIns="0" rtlCol="0" anchor="t"/>
+          <a:lstStyle/>
+          <a:p>
+            <a:pPr algn="ctr" indent="0" marL="0">
+              <a:lnSpc>
+                <a:spcPts val="1200"/>
+              </a:lnSpc>
+              <a:buNone/>
+            </a:pPr>
+            <a:r>
+              <a:rPr lang="en-US" sz="950" dirty="0">
+                <a:solidFill>
+                  <a:srgbClr val="5A5F73"/>
+                </a:solidFill>
+                <a:latin typeface="Calibri" pitchFamily="34" charset="0"/>
+                <a:ea typeface="Calibri" pitchFamily="34" charset="-122"/>
+                <a:cs typeface="Calibri" pitchFamily="34" charset="-120"/>
+              </a:rPr>
+              <a:t>push o merge</a:t>
+            </a:r>
+            <a:endParaRPr lang="en-US" sz="950" dirty="0"/>
+          </a:p>
+        </p:txBody>
+      </p:sp>
+      <p:sp>
+        <p:nvSpPr>
+          <p:cNvPr id="7" name="Shape 5"/>
+          <p:cNvSpPr/>
+          <p:nvPr/>
+        </p:nvSpPr>
+        <p:spPr>
+          <a:xfrm>
+            <a:off x="2679192" y="2308860"/>
+            <a:ext cx="219456" cy="0"/>
+          </a:xfrm>
+          <a:prstGeom prst="line">
+            <a:avLst/>
+          </a:prstGeom>
+          <a:noFill/>
+          <a:ln w="19050">
+            <a:solidFill>
+              <a:srgbClr val="202CFC"/>
+            </a:solidFill>
+            <a:prstDash val="solid"/>
+            <a:tailEnd type="triangle"/>
+          </a:ln>
+        </p:spPr>
+      </p:sp>
+      <p:sp>
+        <p:nvSpPr>
+          <p:cNvPr id="8" name="Shape 6"/>
+          <p:cNvSpPr/>
+          <p:nvPr/>
+        </p:nvSpPr>
+        <p:spPr>
+          <a:xfrm>
+            <a:off x="2971800" y="1874520"/>
+            <a:ext cx="1828800" cy="868680"/>
+          </a:xfrm>
+          <a:prstGeom prst="roundRect">
+            <a:avLst>
+              <a:gd name="adj" fmla="val 6316"/>
+            </a:avLst>
+          </a:prstGeom>
+          <a:solidFill>
+            <a:srgbClr val="FFFFFF"/>
+          </a:solidFill>
+          <a:ln w="12700">
+            <a:solidFill>
+              <a:srgbClr val="C9CCD8"/>
+            </a:solidFill>
+            <a:prstDash val="solid"/>
+          </a:ln>
+        </p:spPr>
+      </p:sp>
+      <p:sp>
+        <p:nvSpPr>
+          <p:cNvPr id="9" name="Text 7"/>
+          <p:cNvSpPr/>
+          <p:nvPr/>
+        </p:nvSpPr>
+        <p:spPr>
+          <a:xfrm>
+            <a:off x="3044952" y="1993392"/>
+            <a:ext cx="1682496" cy="274320"/>
+          </a:xfrm>
+          <a:prstGeom prst="rect">
+            <a:avLst/>
+          </a:prstGeom>
+          <a:noFill/>
+          <a:ln/>
+        </p:spPr>
+        <p:txBody>
+          <a:bodyPr wrap="square" lIns="0" tIns="0" rIns="0" bIns="0" rtlCol="0" anchor="ctr"/>
+          <a:lstStyle/>
+          <a:p>
+            <a:pPr algn="ctr" indent="0" marL="0">
+              <a:buNone/>
+            </a:pPr>
+            <a:r>
+              <a:rPr lang="en-US" sz="1100" b="1" dirty="0">
                 <a:solidFill>
                   <a:srgbClr val="1A1C2E"/>
                 </a:solidFill>
@@ -7956,38 +8076,41 @@
                 <a:ea typeface="Arial" pitchFamily="34" charset="-122"/>
                 <a:cs typeface="Arial" pitchFamily="34" charset="-120"/>
               </a:rPr>
-              <a:t>Broken Object Level Authorization</a:t>
-            </a:r>
-            <a:endParaRPr lang="en-US" sz="1150" dirty="0"/>
-          </a:p>
-        </p:txBody>
-      </p:sp>
-      <p:sp>
-        <p:nvSpPr>
-          <p:cNvPr id="6" name="Text 4"/>
-          <p:cNvSpPr/>
-          <p:nvPr/>
-        </p:nvSpPr>
-        <p:spPr>
-          <a:xfrm>
-            <a:off x="5577840" y="2084832"/>
-            <a:ext cx="5806440" cy="365760"/>
-          </a:xfrm>
-          <a:prstGeom prst="rect">
-            <a:avLst/>
-          </a:prstGeom>
-          <a:noFill/>
-          <a:ln/>
-        </p:spPr>
-        <p:txBody>
-          <a:bodyPr wrap="square" lIns="0" tIns="0" rIns="0" bIns="0" rtlCol="0" anchor="ctr"/>
-          <a:lstStyle/>
-          <a:p>
-            <a:pPr indent="0" marL="0">
-              <a:buNone/>
-            </a:pPr>
-            <a:r>
-              <a:rPr lang="en-US" sz="1200" dirty="0">
+              <a:t>Verificación</a:t>
+            </a:r>
+            <a:endParaRPr lang="en-US" sz="1100" dirty="0"/>
+          </a:p>
+        </p:txBody>
+      </p:sp>
+      <p:sp>
+        <p:nvSpPr>
+          <p:cNvPr id="10" name="Text 8"/>
+          <p:cNvSpPr/>
+          <p:nvPr/>
+        </p:nvSpPr>
+        <p:spPr>
+          <a:xfrm>
+            <a:off x="3044952" y="2276856"/>
+            <a:ext cx="1682496" cy="384048"/>
+          </a:xfrm>
+          <a:prstGeom prst="rect">
+            <a:avLst/>
+          </a:prstGeom>
+          <a:noFill/>
+          <a:ln/>
+        </p:spPr>
+        <p:txBody>
+          <a:bodyPr wrap="square" lIns="0" tIns="0" rIns="0" bIns="0" rtlCol="0" anchor="t"/>
+          <a:lstStyle/>
+          <a:p>
+            <a:pPr algn="ctr" indent="0" marL="0">
+              <a:lnSpc>
+                <a:spcPts val="1200"/>
+              </a:lnSpc>
+              <a:buNone/>
+            </a:pPr>
+            <a:r>
+              <a:rPr lang="en-US" sz="950" dirty="0">
                 <a:solidFill>
                   <a:srgbClr val="5A5F73"/>
                 </a:solidFill>
@@ -7995,46 +8118,117 @@
                 <a:ea typeface="Calibri" pitchFamily="34" charset="-122"/>
                 <a:cs typeface="Calibri" pitchFamily="34" charset="-120"/>
               </a:rPr>
-              <a:t>La sesión de otro usuario devuelve 404, no 403</a:t>
-            </a:r>
-            <a:endParaRPr lang="en-US" sz="1200" dirty="0"/>
-          </a:p>
-        </p:txBody>
-      </p:sp>
-      <p:sp>
-        <p:nvSpPr>
-          <p:cNvPr id="7" name="Text 5"/>
-          <p:cNvSpPr/>
-          <p:nvPr/>
-        </p:nvSpPr>
-        <p:spPr>
-          <a:xfrm>
-            <a:off x="777240" y="2487168"/>
-            <a:ext cx="731520" cy="365760"/>
-          </a:xfrm>
-          <a:prstGeom prst="rect">
-            <a:avLst/>
-          </a:prstGeom>
-          <a:noFill/>
-          <a:ln/>
-        </p:spPr>
-        <p:txBody>
-          <a:bodyPr wrap="square" lIns="0" tIns="0" rIns="0" bIns="0" rtlCol="0" anchor="ctr"/>
-          <a:lstStyle/>
-          <a:p>
-            <a:pPr indent="0" marL="0">
+              <a:t>lint, tests, e2e</a:t>
+            </a:r>
+            <a:endParaRPr lang="en-US" sz="950" dirty="0"/>
+          </a:p>
+          <a:p>
+            <a:pPr algn="ctr" indent="0" marL="0">
+              <a:lnSpc>
+                <a:spcPts val="1200"/>
+              </a:lnSpc>
+              <a:buNone/>
+            </a:pPr>
+            <a:r>
+              <a:rPr lang="en-US" sz="950" dirty="0">
+                <a:solidFill>
+                  <a:srgbClr val="5A5F73"/>
+                </a:solidFill>
+                <a:latin typeface="Calibri" pitchFamily="34" charset="0"/>
+                <a:ea typeface="Calibri" pitchFamily="34" charset="-122"/>
+                <a:cs typeface="Calibri" pitchFamily="34" charset="-120"/>
+              </a:rPr>
+              <a:t>y cabeceras</a:t>
+            </a:r>
+            <a:endParaRPr lang="en-US" sz="950" dirty="0"/>
+          </a:p>
+        </p:txBody>
+      </p:sp>
+      <p:sp>
+        <p:nvSpPr>
+          <p:cNvPr id="11" name="Shape 9"/>
+          <p:cNvSpPr/>
+          <p:nvPr/>
+        </p:nvSpPr>
+        <p:spPr>
+          <a:xfrm>
+            <a:off x="4873752" y="2308860"/>
+            <a:ext cx="219456" cy="0"/>
+          </a:xfrm>
+          <a:prstGeom prst="line">
+            <a:avLst/>
+          </a:prstGeom>
+          <a:noFill/>
+          <a:ln w="19050">
+            <a:solidFill>
+              <a:srgbClr val="202CFC"/>
+            </a:solidFill>
+            <a:prstDash val="solid"/>
+            <a:tailEnd type="triangle"/>
+          </a:ln>
+        </p:spPr>
+      </p:sp>
+      <p:sp>
+        <p:nvSpPr>
+          <p:cNvPr id="12" name="Shape 10"/>
+          <p:cNvSpPr/>
+          <p:nvPr/>
+        </p:nvSpPr>
+        <p:spPr>
+          <a:xfrm>
+            <a:off x="5166360" y="1874520"/>
+            <a:ext cx="1828800" cy="868680"/>
+          </a:xfrm>
+          <a:prstGeom prst="roundRect">
+            <a:avLst>
+              <a:gd name="adj" fmla="val 6316"/>
+            </a:avLst>
+          </a:prstGeom>
+          <a:solidFill>
+            <a:srgbClr val="FFFFFF"/>
+          </a:solidFill>
+          <a:ln w="12700">
+            <a:solidFill>
+              <a:srgbClr val="C9CCD8"/>
+            </a:solidFill>
+            <a:prstDash val="solid"/>
+          </a:ln>
+        </p:spPr>
+      </p:sp>
+      <p:sp>
+        <p:nvSpPr>
+          <p:cNvPr id="13" name="Text 11"/>
+          <p:cNvSpPr/>
+          <p:nvPr/>
+        </p:nvSpPr>
+        <p:spPr>
+          <a:xfrm>
+            <a:off x="5239512" y="1993392"/>
+            <a:ext cx="1682496" cy="274320"/>
+          </a:xfrm>
+          <a:prstGeom prst="rect">
+            <a:avLst/>
+          </a:prstGeom>
+          <a:noFill/>
+          <a:ln/>
+        </p:spPr>
+        <p:txBody>
+          <a:bodyPr wrap="square" lIns="0" tIns="0" rIns="0" bIns="0" rtlCol="0" anchor="ctr"/>
+          <a:lstStyle/>
+          <a:p>
+            <a:pPr algn="ctr" indent="0" marL="0">
               <a:buNone/>
             </a:pPr>
             <a:r>
               <a:rPr lang="en-US" sz="1100" b="1" dirty="0">
                 <a:solidFill>
-                  <a:srgbClr val="202CFC"/>
+                  <a:srgbClr val="1A1C2E"/>
                 </a:solidFill>
                 <a:latin typeface="Arial" pitchFamily="34" charset="0"/>
                 <a:ea typeface="Arial" pitchFamily="34" charset="-122"/>
                 <a:cs typeface="Arial" pitchFamily="34" charset="-120"/>
               </a:rPr>
-              <a:t>API2</a:t>
+              <a:t>Construcción</a:t>
             </a:r>
             <a:endParaRPr lang="en-US" sz="1100" dirty="0"/>
           </a:p>
@@ -8042,30 +8236,143 @@
       </p:sp>
       <p:sp>
         <p:nvSpPr>
-          <p:cNvPr id="8" name="Text 6"/>
-          <p:cNvSpPr/>
-          <p:nvPr/>
-        </p:nvSpPr>
-        <p:spPr>
-          <a:xfrm>
-            <a:off x="1508760" y="2487168"/>
-            <a:ext cx="3977640" cy="365760"/>
-          </a:xfrm>
-          <a:prstGeom prst="rect">
-            <a:avLst/>
-          </a:prstGeom>
-          <a:noFill/>
-          <a:ln/>
-        </p:spPr>
-        <p:txBody>
-          <a:bodyPr wrap="square" lIns="0" tIns="0" rIns="0" bIns="0" rtlCol="0" anchor="ctr"/>
-          <a:lstStyle/>
-          <a:p>
-            <a:pPr indent="0" marL="0">
-              <a:buNone/>
-            </a:pPr>
-            <a:r>
-              <a:rPr lang="en-US" sz="1150" b="1" dirty="0">
+          <p:cNvPr id="14" name="Text 12"/>
+          <p:cNvSpPr/>
+          <p:nvPr/>
+        </p:nvSpPr>
+        <p:spPr>
+          <a:xfrm>
+            <a:off x="5239512" y="2276856"/>
+            <a:ext cx="1682496" cy="384048"/>
+          </a:xfrm>
+          <a:prstGeom prst="rect">
+            <a:avLst/>
+          </a:prstGeom>
+          <a:noFill/>
+          <a:ln/>
+        </p:spPr>
+        <p:txBody>
+          <a:bodyPr wrap="square" lIns="0" tIns="0" rIns="0" bIns="0" rtlCol="0" anchor="t"/>
+          <a:lstStyle/>
+          <a:p>
+            <a:pPr algn="ctr" indent="0" marL="0">
+              <a:lnSpc>
+                <a:spcPts val="1200"/>
+              </a:lnSpc>
+              <a:buNone/>
+            </a:pPr>
+            <a:r>
+              <a:rPr lang="en-US" sz="950" dirty="0">
+                <a:solidFill>
+                  <a:srgbClr val="5A5F73"/>
+                </a:solidFill>
+                <a:latin typeface="Calibri" pitchFamily="34" charset="0"/>
+                <a:ea typeface="Calibri" pitchFamily="34" charset="-122"/>
+                <a:cs typeface="Calibri" pitchFamily="34" charset="-120"/>
+              </a:rPr>
+              <a:t>tres imágenes</a:t>
+            </a:r>
+            <a:endParaRPr lang="en-US" sz="950" dirty="0"/>
+          </a:p>
+          <a:p>
+            <a:pPr algn="ctr" indent="0" marL="0">
+              <a:lnSpc>
+                <a:spcPts val="1200"/>
+              </a:lnSpc>
+              <a:buNone/>
+            </a:pPr>
+            <a:r>
+              <a:rPr lang="en-US" sz="950" dirty="0">
+                <a:solidFill>
+                  <a:srgbClr val="5A5F73"/>
+                </a:solidFill>
+                <a:latin typeface="Calibri" pitchFamily="34" charset="0"/>
+                <a:ea typeface="Calibri" pitchFamily="34" charset="-122"/>
+                <a:cs typeface="Calibri" pitchFamily="34" charset="-120"/>
+              </a:rPr>
+              <a:t>Docker</a:t>
+            </a:r>
+            <a:endParaRPr lang="en-US" sz="950" dirty="0"/>
+          </a:p>
+        </p:txBody>
+      </p:sp>
+      <p:sp>
+        <p:nvSpPr>
+          <p:cNvPr id="15" name="Shape 13"/>
+          <p:cNvSpPr/>
+          <p:nvPr/>
+        </p:nvSpPr>
+        <p:spPr>
+          <a:xfrm>
+            <a:off x="7068312" y="2308860"/>
+            <a:ext cx="219456" cy="0"/>
+          </a:xfrm>
+          <a:prstGeom prst="line">
+            <a:avLst/>
+          </a:prstGeom>
+          <a:noFill/>
+          <a:ln w="19050">
+            <a:solidFill>
+              <a:srgbClr val="202CFC"/>
+            </a:solidFill>
+            <a:prstDash val="solid"/>
+            <a:tailEnd type="triangle"/>
+          </a:ln>
+        </p:spPr>
+      </p:sp>
+      <p:sp>
+        <p:nvSpPr>
+          <p:cNvPr id="16" name="Shape 14"/>
+          <p:cNvSpPr/>
+          <p:nvPr/>
+        </p:nvSpPr>
+        <p:spPr>
+          <a:xfrm>
+            <a:off x="7360920" y="1874520"/>
+            <a:ext cx="1828800" cy="868680"/>
+          </a:xfrm>
+          <a:prstGeom prst="roundRect">
+            <a:avLst>
+              <a:gd name="adj" fmla="val 6316"/>
+            </a:avLst>
+          </a:prstGeom>
+          <a:solidFill>
+            <a:srgbClr val="FFFFFF"/>
+          </a:solidFill>
+          <a:ln w="12700">
+            <a:solidFill>
+              <a:srgbClr val="C9CCD8"/>
+            </a:solidFill>
+            <a:prstDash val="solid"/>
+          </a:ln>
+        </p:spPr>
+      </p:sp>
+      <p:sp>
+        <p:nvSpPr>
+          <p:cNvPr id="17" name="Text 15"/>
+          <p:cNvSpPr/>
+          <p:nvPr/>
+        </p:nvSpPr>
+        <p:spPr>
+          <a:xfrm>
+            <a:off x="7434072" y="1993392"/>
+            <a:ext cx="1682496" cy="274320"/>
+          </a:xfrm>
+          <a:prstGeom prst="rect">
+            <a:avLst/>
+          </a:prstGeom>
+          <a:noFill/>
+          <a:ln/>
+        </p:spPr>
+        <p:txBody>
+          <a:bodyPr wrap="square" lIns="0" tIns="0" rIns="0" bIns="0" rtlCol="0" anchor="ctr"/>
+          <a:lstStyle/>
+          <a:p>
+            <a:pPr algn="ctr" indent="0" marL="0">
+              <a:buNone/>
+            </a:pPr>
+            <a:r>
+              <a:rPr lang="en-US" sz="1100" b="1" dirty="0">
                 <a:solidFill>
                   <a:srgbClr val="1A1C2E"/>
                 </a:solidFill>
@@ -8073,38 +8380,41 @@
                 <a:ea typeface="Arial" pitchFamily="34" charset="-122"/>
                 <a:cs typeface="Arial" pitchFamily="34" charset="-120"/>
               </a:rPr>
-              <a:t>Broken Authentication</a:t>
-            </a:r>
-            <a:endParaRPr lang="en-US" sz="1150" dirty="0"/>
-          </a:p>
-        </p:txBody>
-      </p:sp>
-      <p:sp>
-        <p:nvSpPr>
-          <p:cNvPr id="9" name="Text 7"/>
-          <p:cNvSpPr/>
-          <p:nvPr/>
-        </p:nvSpPr>
-        <p:spPr>
-          <a:xfrm>
-            <a:off x="5577840" y="2487168"/>
-            <a:ext cx="5806440" cy="365760"/>
-          </a:xfrm>
-          <a:prstGeom prst="rect">
-            <a:avLst/>
-          </a:prstGeom>
-          <a:noFill/>
-          <a:ln/>
-        </p:spPr>
-        <p:txBody>
-          <a:bodyPr wrap="square" lIns="0" tIns="0" rIns="0" bIns="0" rtlCol="0" anchor="ctr"/>
-          <a:lstStyle/>
-          <a:p>
-            <a:pPr indent="0" marL="0">
-              <a:buNone/>
-            </a:pPr>
-            <a:r>
-              <a:rPr lang="en-US" sz="1200" dirty="0">
+              <a:t>Publicación</a:t>
+            </a:r>
+            <a:endParaRPr lang="en-US"